<commit_message>
feat: integrate real Sagents runtime
</commit_message>
<xml_diff>
--- a/submission/proteinloop-hackathon-deck.pptx
+++ b/submission/proteinloop-hackathon-deck.pptx
@@ -2,22 +2,22 @@
 <file path=ppt/presentation.xml><?xml version="1.0" encoding="utf-8"?>
 <p:presentation xmlns:p="http://schemas.openxmlformats.org/presentationml/2006/main">
   <p:sldMasterIdLst>
-    <p:sldMasterId xmlns:r="http://schemas.openxmlformats.org/officeDocument/2006/relationships" id="2147483648" r:id="R43837baa72064bab"/>
+    <p:sldMasterId xmlns:r="http://schemas.openxmlformats.org/officeDocument/2006/relationships" id="2147483648" r:id="Rf7608c7ee40f4b41"/>
   </p:sldMasterIdLst>
   <p:notesMasterIdLst>
-    <p:notesMasterId xmlns:r="http://schemas.openxmlformats.org/officeDocument/2006/relationships" r:id="R127e2e0b6cd94863"/>
+    <p:notesMasterId xmlns:r="http://schemas.openxmlformats.org/officeDocument/2006/relationships" r:id="Rc2ce643b976144c2"/>
   </p:notesMasterIdLst>
   <p:sldIdLst>
-    <p:sldId xmlns:r="http://schemas.openxmlformats.org/officeDocument/2006/relationships" id="256" r:id="R66d4bf1f9ed840d7"/>
-    <p:sldId xmlns:r="http://schemas.openxmlformats.org/officeDocument/2006/relationships" id="257" r:id="R981d52ccd0b34ca4"/>
-    <p:sldId xmlns:r="http://schemas.openxmlformats.org/officeDocument/2006/relationships" id="258" r:id="R0ae38c7a4da64991"/>
-    <p:sldId xmlns:r="http://schemas.openxmlformats.org/officeDocument/2006/relationships" id="259" r:id="R8ca531981d044175"/>
-    <p:sldId xmlns:r="http://schemas.openxmlformats.org/officeDocument/2006/relationships" id="260" r:id="Re9f83c3b6b4d4bb2"/>
-    <p:sldId xmlns:r="http://schemas.openxmlformats.org/officeDocument/2006/relationships" id="261" r:id="R70797816b5b64951"/>
-    <p:sldId xmlns:r="http://schemas.openxmlformats.org/officeDocument/2006/relationships" id="262" r:id="R76e0de61b00f44c2"/>
-    <p:sldId xmlns:r="http://schemas.openxmlformats.org/officeDocument/2006/relationships" id="263" r:id="Ra1991aca02314540"/>
-    <p:sldId xmlns:r="http://schemas.openxmlformats.org/officeDocument/2006/relationships" id="264" r:id="R88e5f74198934d7b"/>
-    <p:sldId xmlns:r="http://schemas.openxmlformats.org/officeDocument/2006/relationships" id="265" r:id="R7363d52d8a094b94"/>
+    <p:sldId xmlns:r="http://schemas.openxmlformats.org/officeDocument/2006/relationships" id="256" r:id="Rcfc3ddf41ab84f0c"/>
+    <p:sldId xmlns:r="http://schemas.openxmlformats.org/officeDocument/2006/relationships" id="257" r:id="R2ea3c416b81d4ba9"/>
+    <p:sldId xmlns:r="http://schemas.openxmlformats.org/officeDocument/2006/relationships" id="258" r:id="R4d1fbca9d52a4d05"/>
+    <p:sldId xmlns:r="http://schemas.openxmlformats.org/officeDocument/2006/relationships" id="259" r:id="Ref2d39aec695471c"/>
+    <p:sldId xmlns:r="http://schemas.openxmlformats.org/officeDocument/2006/relationships" id="260" r:id="R1695f2f944604c06"/>
+    <p:sldId xmlns:r="http://schemas.openxmlformats.org/officeDocument/2006/relationships" id="261" r:id="Ra1de72f6c5e449c6"/>
+    <p:sldId xmlns:r="http://schemas.openxmlformats.org/officeDocument/2006/relationships" id="262" r:id="R7f4f24de679045ef"/>
+    <p:sldId xmlns:r="http://schemas.openxmlformats.org/officeDocument/2006/relationships" id="263" r:id="R1f8a6433d8aa4838"/>
+    <p:sldId xmlns:r="http://schemas.openxmlformats.org/officeDocument/2006/relationships" id="264" r:id="Ree8ff28bf3c543e5"/>
+    <p:sldId xmlns:r="http://schemas.openxmlformats.org/officeDocument/2006/relationships" id="265" r:id="R4aa78653b5f940ff"/>
   </p:sldIdLst>
   <p:sldSz cx="12192000" cy="6858000"/>
   <p:notesSz cx="6858000" cy="9144000"/>
@@ -1158,7 +1158,7 @@
   </p:cSld>
   <p:clrMap bg1="lt1" tx1="dk1" bg2="lt2" tx2="dk2" accent1="accent1" accent2="accent2" accent3="accent3" accent4="accent4" accent5="accent5" accent6="accent6" hlink="hlink" folHlink="folHlink"/>
   <p:sldLayoutIdLst>
-    <p:sldLayoutId xmlns:r="http://schemas.openxmlformats.org/officeDocument/2006/relationships" id="2147483649" r:id="R1eddf0bcdf114524"/>
+    <p:sldLayoutId xmlns:r="http://schemas.openxmlformats.org/officeDocument/2006/relationships" id="2147483649" r:id="R6a5580a0e11f4743"/>
   </p:sldLayoutIdLst>
   <p:txStyles>
     <p:titleStyle>
@@ -1457,7 +1457,7 @@
           <p:cNvPr id="1" name="">
             <a:extLst xmlns:a="http://schemas.openxmlformats.org/drawingml/2006/main">
               <a:ext uri="{FF2B5EF4-FFF2-40B4-BE49-F238E27FC236}">
-                <a16:creationId xmlns:a16="http://schemas.microsoft.com/office/drawing/2014/main" id="{1CEA2A21-0312-498F-9566-4957B44FA459}"/>
+                <a16:creationId xmlns:a16="http://schemas.microsoft.com/office/drawing/2014/main" id="{24BD6496-B2FB-4C5C-ADE9-E2F7704D4D6D}"/>
               </a:ext>
             </a:extLst>
           </p:cNvPr>
@@ -1492,7 +1492,7 @@
           <p:cNvPr id="2" name="">
             <a:extLst xmlns:a="http://schemas.openxmlformats.org/drawingml/2006/main">
               <a:ext uri="{FF2B5EF4-FFF2-40B4-BE49-F238E27FC236}">
-                <a16:creationId xmlns:a16="http://schemas.microsoft.com/office/drawing/2014/main" id="{071A98CF-7E26-4BF1-86A6-B2F6C371B511}"/>
+                <a16:creationId xmlns:a16="http://schemas.microsoft.com/office/drawing/2014/main" id="{C4249AF8-DF9D-491C-B95C-8D8DDC017EBE}"/>
               </a:ext>
             </a:extLst>
           </p:cNvPr>
@@ -1527,7 +1527,7 @@
           <p:cNvPr id="3" name="">
             <a:extLst xmlns:a="http://schemas.openxmlformats.org/drawingml/2006/main">
               <a:ext uri="{FF2B5EF4-FFF2-40B4-BE49-F238E27FC236}">
-                <a16:creationId xmlns:a16="http://schemas.microsoft.com/office/drawing/2014/main" id="{95FEBC73-7DC2-4E77-8B4D-A2E7C53D3243}"/>
+                <a16:creationId xmlns:a16="http://schemas.microsoft.com/office/drawing/2014/main" id="{07C4E2D1-158B-4771-8A96-C2D590AAA3F9}"/>
               </a:ext>
             </a:extLst>
           </p:cNvPr>
@@ -1591,7 +1591,7 @@
           <p:cNvPr id="4" name="">
             <a:extLst xmlns:a="http://schemas.openxmlformats.org/drawingml/2006/main">
               <a:ext uri="{FF2B5EF4-FFF2-40B4-BE49-F238E27FC236}">
-                <a16:creationId xmlns:a16="http://schemas.microsoft.com/office/drawing/2014/main" id="{7F5A1DBA-9EB2-499E-A14A-AFE6188BD1BA}"/>
+                <a16:creationId xmlns:a16="http://schemas.microsoft.com/office/drawing/2014/main" id="{78449027-FED6-40CC-BA6C-4A12B5B0C96A}"/>
               </a:ext>
             </a:extLst>
           </p:cNvPr>
@@ -1655,7 +1655,7 @@
           <p:cNvPr id="5" name="">
             <a:extLst xmlns:a="http://schemas.openxmlformats.org/drawingml/2006/main">
               <a:ext uri="{FF2B5EF4-FFF2-40B4-BE49-F238E27FC236}">
-                <a16:creationId xmlns:a16="http://schemas.microsoft.com/office/drawing/2014/main" id="{FA6EAC8E-8497-4043-9496-24B5CB997A66}"/>
+                <a16:creationId xmlns:a16="http://schemas.microsoft.com/office/drawing/2014/main" id="{4D8AF43D-F264-4EFE-B1DE-A96FBA0B3077}"/>
               </a:ext>
             </a:extLst>
           </p:cNvPr>
@@ -1690,7 +1690,7 @@
           <p:cNvPr id="6" name="">
             <a:extLst xmlns:a="http://schemas.openxmlformats.org/drawingml/2006/main">
               <a:ext uri="{FF2B5EF4-FFF2-40B4-BE49-F238E27FC236}">
-                <a16:creationId xmlns:a16="http://schemas.microsoft.com/office/drawing/2014/main" id="{6884F6E1-01F9-489D-860F-17F73C4D5B81}"/>
+                <a16:creationId xmlns:a16="http://schemas.microsoft.com/office/drawing/2014/main" id="{0972CD58-E46E-4CC0-B718-061DB85D1959}"/>
               </a:ext>
             </a:extLst>
           </p:cNvPr>
@@ -1754,7 +1754,7 @@
           <p:cNvPr id="7" name="">
             <a:extLst xmlns:a="http://schemas.openxmlformats.org/drawingml/2006/main">
               <a:ext uri="{FF2B5EF4-FFF2-40B4-BE49-F238E27FC236}">
-                <a16:creationId xmlns:a16="http://schemas.microsoft.com/office/drawing/2014/main" id="{C67795A1-CB24-406A-80AC-CD924E839392}"/>
+                <a16:creationId xmlns:a16="http://schemas.microsoft.com/office/drawing/2014/main" id="{A9DA74A6-011E-42B7-8105-72D6ADC54886}"/>
               </a:ext>
             </a:extLst>
           </p:cNvPr>
@@ -1818,7 +1818,7 @@
           <p:cNvPr id="8" name="">
             <a:extLst xmlns:a="http://schemas.openxmlformats.org/drawingml/2006/main">
               <a:ext uri="{FF2B5EF4-FFF2-40B4-BE49-F238E27FC236}">
-                <a16:creationId xmlns:a16="http://schemas.microsoft.com/office/drawing/2014/main" id="{057DD12B-BFAF-4627-A4C8-B6337CC1B202}"/>
+                <a16:creationId xmlns:a16="http://schemas.microsoft.com/office/drawing/2014/main" id="{8804B4B7-BA03-4402-AE69-95137F1D970A}"/>
               </a:ext>
             </a:extLst>
           </p:cNvPr>
@@ -1853,7 +1853,7 @@
           <p:cNvPr id="9" name="">
             <a:extLst xmlns:a="http://schemas.openxmlformats.org/drawingml/2006/main">
               <a:ext uri="{FF2B5EF4-FFF2-40B4-BE49-F238E27FC236}">
-                <a16:creationId xmlns:a16="http://schemas.microsoft.com/office/drawing/2014/main" id="{0E534D2A-00A3-49A2-ABEC-E1D1E9895233}"/>
+                <a16:creationId xmlns:a16="http://schemas.microsoft.com/office/drawing/2014/main" id="{B8ED059E-588C-483D-BF1D-753D89A34270}"/>
               </a:ext>
             </a:extLst>
           </p:cNvPr>
@@ -1917,7 +1917,7 @@
           <p:cNvPr id="10" name="">
             <a:extLst xmlns:a="http://schemas.openxmlformats.org/drawingml/2006/main">
               <a:ext uri="{FF2B5EF4-FFF2-40B4-BE49-F238E27FC236}">
-                <a16:creationId xmlns:a16="http://schemas.microsoft.com/office/drawing/2014/main" id="{DCAE5DEB-5079-42C4-BB72-65324BD999D8}"/>
+                <a16:creationId xmlns:a16="http://schemas.microsoft.com/office/drawing/2014/main" id="{392583F6-E8DB-4CBE-AE6C-0B2210715432}"/>
               </a:ext>
             </a:extLst>
           </p:cNvPr>
@@ -1981,7 +1981,7 @@
           <p:cNvPr id="11" name="">
             <a:extLst xmlns:a="http://schemas.openxmlformats.org/drawingml/2006/main">
               <a:ext uri="{FF2B5EF4-FFF2-40B4-BE49-F238E27FC236}">
-                <a16:creationId xmlns:a16="http://schemas.microsoft.com/office/drawing/2014/main" id="{F19E4F3E-2289-42F1-89E0-FAFA6D6B39F9}"/>
+                <a16:creationId xmlns:a16="http://schemas.microsoft.com/office/drawing/2014/main" id="{80DAAA57-CF19-48FB-88B7-A88123D1FFB5}"/>
               </a:ext>
             </a:extLst>
           </p:cNvPr>
@@ -2045,7 +2045,7 @@
           <p:cNvPr id="12" name="">
             <a:extLst xmlns:a="http://schemas.openxmlformats.org/drawingml/2006/main">
               <a:ext uri="{FF2B5EF4-FFF2-40B4-BE49-F238E27FC236}">
-                <a16:creationId xmlns:a16="http://schemas.microsoft.com/office/drawing/2014/main" id="{CC32DBFD-D688-416A-A4BD-D45BC9B0E0DC}"/>
+                <a16:creationId xmlns:a16="http://schemas.microsoft.com/office/drawing/2014/main" id="{DA763DA0-2A6F-47B9-8522-A65D2243FB84}"/>
               </a:ext>
             </a:extLst>
           </p:cNvPr>
@@ -2080,7 +2080,7 @@
           <p:cNvPr id="13" name="">
             <a:extLst xmlns:a="http://schemas.openxmlformats.org/drawingml/2006/main">
               <a:ext uri="{FF2B5EF4-FFF2-40B4-BE49-F238E27FC236}">
-                <a16:creationId xmlns:a16="http://schemas.microsoft.com/office/drawing/2014/main" id="{8135FDE3-1E17-4DC6-BC3F-6EF9820489E8}"/>
+                <a16:creationId xmlns:a16="http://schemas.microsoft.com/office/drawing/2014/main" id="{114AFE0F-551D-4CFA-9EF3-301F9E5D6F86}"/>
               </a:ext>
             </a:extLst>
           </p:cNvPr>
@@ -2144,7 +2144,7 @@
           <p:cNvPr id="14" name="">
             <a:extLst xmlns:a="http://schemas.openxmlformats.org/drawingml/2006/main">
               <a:ext uri="{FF2B5EF4-FFF2-40B4-BE49-F238E27FC236}">
-                <a16:creationId xmlns:a16="http://schemas.microsoft.com/office/drawing/2014/main" id="{38734273-293C-42F9-AEB8-F62CAC90E157}"/>
+                <a16:creationId xmlns:a16="http://schemas.microsoft.com/office/drawing/2014/main" id="{5FBFD0C2-BBA1-4F52-A937-29A109798D18}"/>
               </a:ext>
             </a:extLst>
           </p:cNvPr>
@@ -2208,7 +2208,7 @@
           <p:cNvPr id="15" name="">
             <a:extLst xmlns:a="http://schemas.openxmlformats.org/drawingml/2006/main">
               <a:ext uri="{FF2B5EF4-FFF2-40B4-BE49-F238E27FC236}">
-                <a16:creationId xmlns:a16="http://schemas.microsoft.com/office/drawing/2014/main" id="{C6B113F9-C650-4651-A2CE-5281F86D956F}"/>
+                <a16:creationId xmlns:a16="http://schemas.microsoft.com/office/drawing/2014/main" id="{C4AB8A1A-1C24-44FA-9696-8E560D700A91}"/>
               </a:ext>
             </a:extLst>
           </p:cNvPr>
@@ -2272,7 +2272,7 @@
           <p:cNvPr id="16" name="">
             <a:extLst xmlns:a="http://schemas.openxmlformats.org/drawingml/2006/main">
               <a:ext uri="{FF2B5EF4-FFF2-40B4-BE49-F238E27FC236}">
-                <a16:creationId xmlns:a16="http://schemas.microsoft.com/office/drawing/2014/main" id="{D318D52A-CFE7-417C-82AB-E83AE261E936}"/>
+                <a16:creationId xmlns:a16="http://schemas.microsoft.com/office/drawing/2014/main" id="{7566BE01-51F7-439B-95F7-910257131160}"/>
               </a:ext>
             </a:extLst>
           </p:cNvPr>
@@ -2307,7 +2307,7 @@
           <p:cNvPr id="17" name="">
             <a:extLst xmlns:a="http://schemas.openxmlformats.org/drawingml/2006/main">
               <a:ext uri="{FF2B5EF4-FFF2-40B4-BE49-F238E27FC236}">
-                <a16:creationId xmlns:a16="http://schemas.microsoft.com/office/drawing/2014/main" id="{9C7390C4-3CA3-417E-9F5C-23460E2AC01D}"/>
+                <a16:creationId xmlns:a16="http://schemas.microsoft.com/office/drawing/2014/main" id="{F5708F3A-6FE5-4FED-82A1-EDC075642BE2}"/>
               </a:ext>
             </a:extLst>
           </p:cNvPr>
@@ -2371,7 +2371,7 @@
           <p:cNvPr id="18" name="">
             <a:extLst xmlns:a="http://schemas.openxmlformats.org/drawingml/2006/main">
               <a:ext uri="{FF2B5EF4-FFF2-40B4-BE49-F238E27FC236}">
-                <a16:creationId xmlns:a16="http://schemas.microsoft.com/office/drawing/2014/main" id="{ED2B25DA-1817-4189-8AEB-D62A8F94A62B}"/>
+                <a16:creationId xmlns:a16="http://schemas.microsoft.com/office/drawing/2014/main" id="{5DDF29A5-07F4-4DF0-A82C-DD6CB0CE758B}"/>
               </a:ext>
             </a:extLst>
           </p:cNvPr>
@@ -2435,7 +2435,7 @@
           <p:cNvPr id="19" name="">
             <a:extLst xmlns:a="http://schemas.openxmlformats.org/drawingml/2006/main">
               <a:ext uri="{FF2B5EF4-FFF2-40B4-BE49-F238E27FC236}">
-                <a16:creationId xmlns:a16="http://schemas.microsoft.com/office/drawing/2014/main" id="{7DE8E5B8-4507-4CD9-879C-BCEE19DE5199}"/>
+                <a16:creationId xmlns:a16="http://schemas.microsoft.com/office/drawing/2014/main" id="{ADC6E8DA-9336-427E-A58B-9D9FAA100F1B}"/>
               </a:ext>
             </a:extLst>
           </p:cNvPr>
@@ -2499,7 +2499,7 @@
           <p:cNvPr id="20" name="">
             <a:extLst xmlns:a="http://schemas.openxmlformats.org/drawingml/2006/main">
               <a:ext uri="{FF2B5EF4-FFF2-40B4-BE49-F238E27FC236}">
-                <a16:creationId xmlns:a16="http://schemas.microsoft.com/office/drawing/2014/main" id="{ED459E1F-A062-4181-AA10-A604FDB7BA42}"/>
+                <a16:creationId xmlns:a16="http://schemas.microsoft.com/office/drawing/2014/main" id="{E7252D9F-5786-4EE1-B88C-0C450B029C59}"/>
               </a:ext>
             </a:extLst>
           </p:cNvPr>
@@ -2655,7 +2655,7 @@
           <p:cNvPr id="21" name="">
             <a:extLst xmlns:a="http://schemas.openxmlformats.org/drawingml/2006/main">
               <a:ext uri="{FF2B5EF4-FFF2-40B4-BE49-F238E27FC236}">
-                <a16:creationId xmlns:a16="http://schemas.microsoft.com/office/drawing/2014/main" id="{D1D05229-7999-4F33-B615-82AE32B23024}"/>
+                <a16:creationId xmlns:a16="http://schemas.microsoft.com/office/drawing/2014/main" id="{AF522A38-3971-4F95-B8F8-13966A36487D}"/>
               </a:ext>
             </a:extLst>
           </p:cNvPr>
@@ -2719,7 +2719,7 @@
           <p:cNvPr id="22" name="">
             <a:extLst xmlns:a="http://schemas.openxmlformats.org/drawingml/2006/main">
               <a:ext uri="{FF2B5EF4-FFF2-40B4-BE49-F238E27FC236}">
-                <a16:creationId xmlns:a16="http://schemas.microsoft.com/office/drawing/2014/main" id="{46FE2332-FDA5-41A5-8CC3-CE86BC47B354}"/>
+                <a16:creationId xmlns:a16="http://schemas.microsoft.com/office/drawing/2014/main" id="{F1495999-D7A3-4257-8D03-A95A231FFFE6}"/>
               </a:ext>
             </a:extLst>
           </p:cNvPr>
@@ -2781,7 +2781,7 @@
     </p:spTree>
     <p:extLst>
       <p:ext uri="{BB962C8B-B14F-4D97-AF65-F5344CB8AC3E}">
-        <p14:creationId xmlns:p14="http://schemas.microsoft.com/office/powerpoint/2010/main" val="1931970604"/>
+        <p14:creationId xmlns:p14="http://schemas.microsoft.com/office/powerpoint/2010/main" val="1881312866"/>
       </p:ext>
     </p:extLst>
   </p:cSld>
@@ -2805,7 +2805,7 @@
           <p:cNvPr id="1" name="">
             <a:extLst xmlns:a="http://schemas.openxmlformats.org/drawingml/2006/main">
               <a:ext uri="{FF2B5EF4-FFF2-40B4-BE49-F238E27FC236}">
-                <a16:creationId xmlns:a16="http://schemas.microsoft.com/office/drawing/2014/main" id="{EF184FDE-B206-4ACE-B61C-3E8F76D9FD7C}"/>
+                <a16:creationId xmlns:a16="http://schemas.microsoft.com/office/drawing/2014/main" id="{47DEF0C5-9777-4EDB-A19F-8E85046FFB3C}"/>
               </a:ext>
             </a:extLst>
           </p:cNvPr>
@@ -2840,7 +2840,7 @@
           <p:cNvPr id="2" name="">
             <a:extLst xmlns:a="http://schemas.openxmlformats.org/drawingml/2006/main">
               <a:ext uri="{FF2B5EF4-FFF2-40B4-BE49-F238E27FC236}">
-                <a16:creationId xmlns:a16="http://schemas.microsoft.com/office/drawing/2014/main" id="{8D660EAB-4638-456A-928B-4A08E4887D87}"/>
+                <a16:creationId xmlns:a16="http://schemas.microsoft.com/office/drawing/2014/main" id="{A04F95EA-52E7-420D-92B3-8646685731EE}"/>
               </a:ext>
             </a:extLst>
           </p:cNvPr>
@@ -2875,7 +2875,7 @@
           <p:cNvPr id="3" name="">
             <a:extLst xmlns:a="http://schemas.openxmlformats.org/drawingml/2006/main">
               <a:ext uri="{FF2B5EF4-FFF2-40B4-BE49-F238E27FC236}">
-                <a16:creationId xmlns:a16="http://schemas.microsoft.com/office/drawing/2014/main" id="{94CD5EF0-8925-4D5A-864A-541680AB43EA}"/>
+                <a16:creationId xmlns:a16="http://schemas.microsoft.com/office/drawing/2014/main" id="{FF3EA0EC-63F7-4C8A-8F62-D10E79197E0C}"/>
               </a:ext>
             </a:extLst>
           </p:cNvPr>
@@ -2939,7 +2939,7 @@
           <p:cNvPr id="4" name="">
             <a:extLst xmlns:a="http://schemas.openxmlformats.org/drawingml/2006/main">
               <a:ext uri="{FF2B5EF4-FFF2-40B4-BE49-F238E27FC236}">
-                <a16:creationId xmlns:a16="http://schemas.microsoft.com/office/drawing/2014/main" id="{50E1A8B7-2D84-492F-9A24-5C0E3E567F04}"/>
+                <a16:creationId xmlns:a16="http://schemas.microsoft.com/office/drawing/2014/main" id="{E12D44B8-26B8-404E-8B71-890467DD6843}"/>
               </a:ext>
             </a:extLst>
           </p:cNvPr>
@@ -3003,7 +3003,7 @@
           <p:cNvPr id="5" name="">
             <a:extLst xmlns:a="http://schemas.openxmlformats.org/drawingml/2006/main">
               <a:ext uri="{FF2B5EF4-FFF2-40B4-BE49-F238E27FC236}">
-                <a16:creationId xmlns:a16="http://schemas.microsoft.com/office/drawing/2014/main" id="{DA1E01F3-3B76-4E20-89A7-3588EEC6A24C}"/>
+                <a16:creationId xmlns:a16="http://schemas.microsoft.com/office/drawing/2014/main" id="{500E357E-68A4-4B1B-B75D-D5F4293B3CE1}"/>
               </a:ext>
             </a:extLst>
           </p:cNvPr>
@@ -3067,7 +3067,7 @@
           <p:cNvPr id="6" name="">
             <a:extLst xmlns:a="http://schemas.openxmlformats.org/drawingml/2006/main">
               <a:ext uri="{FF2B5EF4-FFF2-40B4-BE49-F238E27FC236}">
-                <a16:creationId xmlns:a16="http://schemas.microsoft.com/office/drawing/2014/main" id="{052E5E95-45A9-4917-8F3E-2DC003442F97}"/>
+                <a16:creationId xmlns:a16="http://schemas.microsoft.com/office/drawing/2014/main" id="{694CF6CF-2DD6-4A9F-9FD2-A753828A01A6}"/>
               </a:ext>
             </a:extLst>
           </p:cNvPr>
@@ -3131,7 +3131,7 @@
           <p:cNvPr id="7" name="">
             <a:extLst xmlns:a="http://schemas.openxmlformats.org/drawingml/2006/main">
               <a:ext uri="{FF2B5EF4-FFF2-40B4-BE49-F238E27FC236}">
-                <a16:creationId xmlns:a16="http://schemas.microsoft.com/office/drawing/2014/main" id="{DEFEBF66-666E-40EF-BFB5-13012B94B4D7}"/>
+                <a16:creationId xmlns:a16="http://schemas.microsoft.com/office/drawing/2014/main" id="{079B29C3-C599-4C7D-B5A2-B3F0F7694BE1}"/>
               </a:ext>
             </a:extLst>
           </p:cNvPr>
@@ -3164,7 +3164,7 @@
           <p:cNvPr id="8" name="">
             <a:extLst xmlns:a="http://schemas.openxmlformats.org/drawingml/2006/main">
               <a:ext uri="{FF2B5EF4-FFF2-40B4-BE49-F238E27FC236}">
-                <a16:creationId xmlns:a16="http://schemas.microsoft.com/office/drawing/2014/main" id="{F065FB8B-CC8A-4170-A83D-3482F408F01C}"/>
+                <a16:creationId xmlns:a16="http://schemas.microsoft.com/office/drawing/2014/main" id="{423C4637-C9B0-4B16-83B2-920996CA388C}"/>
               </a:ext>
             </a:extLst>
           </p:cNvPr>
@@ -3228,7 +3228,7 @@
           <p:cNvPr id="9" name="">
             <a:extLst xmlns:a="http://schemas.openxmlformats.org/drawingml/2006/main">
               <a:ext uri="{FF2B5EF4-FFF2-40B4-BE49-F238E27FC236}">
-                <a16:creationId xmlns:a16="http://schemas.microsoft.com/office/drawing/2014/main" id="{62FFC675-C041-45E0-AAE3-CA45BB85ED51}"/>
+                <a16:creationId xmlns:a16="http://schemas.microsoft.com/office/drawing/2014/main" id="{E4C177C8-0FDE-455F-9B5D-332DA59ED7C7}"/>
               </a:ext>
             </a:extLst>
           </p:cNvPr>
@@ -3292,7 +3292,7 @@
           <p:cNvPr id="10" name="">
             <a:extLst xmlns:a="http://schemas.openxmlformats.org/drawingml/2006/main">
               <a:ext uri="{FF2B5EF4-FFF2-40B4-BE49-F238E27FC236}">
-                <a16:creationId xmlns:a16="http://schemas.microsoft.com/office/drawing/2014/main" id="{6CFD1328-8EBE-4E30-A55F-20209AA53621}"/>
+                <a16:creationId xmlns:a16="http://schemas.microsoft.com/office/drawing/2014/main" id="{50B3468B-7072-4D9E-88D8-09DC198A0067}"/>
               </a:ext>
             </a:extLst>
           </p:cNvPr>
@@ -3325,7 +3325,7 @@
           <p:cNvPr id="11" name="">
             <a:extLst xmlns:a="http://schemas.openxmlformats.org/drawingml/2006/main">
               <a:ext uri="{FF2B5EF4-FFF2-40B4-BE49-F238E27FC236}">
-                <a16:creationId xmlns:a16="http://schemas.microsoft.com/office/drawing/2014/main" id="{0F0D98B3-BDE8-4B74-B472-55A0A492252C}"/>
+                <a16:creationId xmlns:a16="http://schemas.microsoft.com/office/drawing/2014/main" id="{CBD64003-DBC0-4FA4-A9B2-2A13533CDE5F}"/>
               </a:ext>
             </a:extLst>
           </p:cNvPr>
@@ -3389,7 +3389,7 @@
           <p:cNvPr id="12" name="">
             <a:extLst xmlns:a="http://schemas.openxmlformats.org/drawingml/2006/main">
               <a:ext uri="{FF2B5EF4-FFF2-40B4-BE49-F238E27FC236}">
-                <a16:creationId xmlns:a16="http://schemas.microsoft.com/office/drawing/2014/main" id="{FA4F626E-C484-4B28-A24B-91919BF85E17}"/>
+                <a16:creationId xmlns:a16="http://schemas.microsoft.com/office/drawing/2014/main" id="{BCB7895C-5E40-45E8-9904-454DAB41B5BA}"/>
               </a:ext>
             </a:extLst>
           </p:cNvPr>
@@ -3443,7 +3443,7 @@
                 <a:ea typeface="Aptos"/>
                 <a:cs typeface="Aptos"/>
               </a:rPr>
-              <a:t>Physics verifier, RLVR scoring, HITL approvals, self-healing mesh, AMD Gemma path.</a:t>
+              <a:t>Real Sagents, physics verifier, RLVR scoring, resumable HITL, mesh model, AMD Gemma path.</a:t>
             </a:r>
           </a:p>
         </p:txBody>
@@ -3453,7 +3453,7 @@
           <p:cNvPr id="13" name="">
             <a:extLst xmlns:a="http://schemas.openxmlformats.org/drawingml/2006/main">
               <a:ext uri="{FF2B5EF4-FFF2-40B4-BE49-F238E27FC236}">
-                <a16:creationId xmlns:a16="http://schemas.microsoft.com/office/drawing/2014/main" id="{5827FDE8-0FB7-4A6F-B154-FC72CF782A5B}"/>
+                <a16:creationId xmlns:a16="http://schemas.microsoft.com/office/drawing/2014/main" id="{F2298C40-8E3A-4BAE-94CB-6E412BA377DF}"/>
               </a:ext>
             </a:extLst>
           </p:cNvPr>
@@ -3486,7 +3486,7 @@
           <p:cNvPr id="14" name="">
             <a:extLst xmlns:a="http://schemas.openxmlformats.org/drawingml/2006/main">
               <a:ext uri="{FF2B5EF4-FFF2-40B4-BE49-F238E27FC236}">
-                <a16:creationId xmlns:a16="http://schemas.microsoft.com/office/drawing/2014/main" id="{3E47E878-4931-43F9-BE86-628733D8439B}"/>
+                <a16:creationId xmlns:a16="http://schemas.microsoft.com/office/drawing/2014/main" id="{865F23E2-D6AE-4E2A-935B-5E01F0E38FD3}"/>
               </a:ext>
             </a:extLst>
           </p:cNvPr>
@@ -3550,7 +3550,7 @@
           <p:cNvPr id="15" name="">
             <a:extLst xmlns:a="http://schemas.openxmlformats.org/drawingml/2006/main">
               <a:ext uri="{FF2B5EF4-FFF2-40B4-BE49-F238E27FC236}">
-                <a16:creationId xmlns:a16="http://schemas.microsoft.com/office/drawing/2014/main" id="{045DE53F-1C67-48A4-A025-F3CF1A15F7BF}"/>
+                <a16:creationId xmlns:a16="http://schemas.microsoft.com/office/drawing/2014/main" id="{18799F74-1D7D-4B76-8B9C-52F49CD7F38B}"/>
               </a:ext>
             </a:extLst>
           </p:cNvPr>
@@ -3604,7 +3604,7 @@
                 <a:ea typeface="Aptos"/>
                 <a:cs typeface="Aptos"/>
               </a:rPr>
-              <a:t>Docker Compose app, simulator API, dashboard, producer route, traces, deployment docs.</a:t>
+              <a:t>Docker app, local Gemma E2B, five-agent loop, producer approval, and evidence packets.</a:t>
             </a:r>
           </a:p>
         </p:txBody>
@@ -3614,7 +3614,7 @@
           <p:cNvPr id="16" name="">
             <a:extLst xmlns:a="http://schemas.openxmlformats.org/drawingml/2006/main">
               <a:ext uri="{FF2B5EF4-FFF2-40B4-BE49-F238E27FC236}">
-                <a16:creationId xmlns:a16="http://schemas.microsoft.com/office/drawing/2014/main" id="{79424D1A-91BC-4102-88F1-49FD595D62AE}"/>
+                <a16:creationId xmlns:a16="http://schemas.microsoft.com/office/drawing/2014/main" id="{03087293-8BBC-4359-8D8C-73C8E83B7A3B}"/>
               </a:ext>
             </a:extLst>
           </p:cNvPr>
@@ -3678,7 +3678,7 @@
           <p:cNvPr id="17" name="">
             <a:extLst xmlns:a="http://schemas.openxmlformats.org/drawingml/2006/main">
               <a:ext uri="{FF2B5EF4-FFF2-40B4-BE49-F238E27FC236}">
-                <a16:creationId xmlns:a16="http://schemas.microsoft.com/office/drawing/2014/main" id="{0A88819D-9230-4B81-9A7F-67F3F361569D}"/>
+                <a16:creationId xmlns:a16="http://schemas.microsoft.com/office/drawing/2014/main" id="{3BE8DF8A-7BB2-4CF1-9615-94B18F9373AA}"/>
               </a:ext>
             </a:extLst>
           </p:cNvPr>
@@ -3742,7 +3742,7 @@
           <p:cNvPr id="18" name="">
             <a:extLst xmlns:a="http://schemas.openxmlformats.org/drawingml/2006/main">
               <a:ext uri="{FF2B5EF4-FFF2-40B4-BE49-F238E27FC236}">
-                <a16:creationId xmlns:a16="http://schemas.microsoft.com/office/drawing/2014/main" id="{9DE50CE4-32D8-4BCE-A4E1-2B90C93D6D2D}"/>
+                <a16:creationId xmlns:a16="http://schemas.microsoft.com/office/drawing/2014/main" id="{F8727D72-22F7-4926-BB01-DCFDF1FFC7FC}"/>
               </a:ext>
             </a:extLst>
           </p:cNvPr>
@@ -3804,7 +3804,7 @@
     </p:spTree>
     <p:extLst>
       <p:ext uri="{BB962C8B-B14F-4D97-AF65-F5344CB8AC3E}">
-        <p14:creationId xmlns:p14="http://schemas.microsoft.com/office/powerpoint/2010/main" val="1797271127"/>
+        <p14:creationId xmlns:p14="http://schemas.microsoft.com/office/powerpoint/2010/main" val="2011880339"/>
       </p:ext>
     </p:extLst>
   </p:cSld>
@@ -3828,7 +3828,7 @@
           <p:cNvPr id="1" name="">
             <a:extLst xmlns:a="http://schemas.openxmlformats.org/drawingml/2006/main">
               <a:ext uri="{FF2B5EF4-FFF2-40B4-BE49-F238E27FC236}">
-                <a16:creationId xmlns:a16="http://schemas.microsoft.com/office/drawing/2014/main" id="{F4514255-77B2-43BF-A44D-7EA65CB3F86E}"/>
+                <a16:creationId xmlns:a16="http://schemas.microsoft.com/office/drawing/2014/main" id="{93A2A204-4D4D-4CBD-8EC8-FA708DE4EB48}"/>
               </a:ext>
             </a:extLst>
           </p:cNvPr>
@@ -3863,7 +3863,7 @@
           <p:cNvPr id="2" name="">
             <a:extLst xmlns:a="http://schemas.openxmlformats.org/drawingml/2006/main">
               <a:ext uri="{FF2B5EF4-FFF2-40B4-BE49-F238E27FC236}">
-                <a16:creationId xmlns:a16="http://schemas.microsoft.com/office/drawing/2014/main" id="{F73177E8-11CF-4053-B2C3-29E8B7241A9E}"/>
+                <a16:creationId xmlns:a16="http://schemas.microsoft.com/office/drawing/2014/main" id="{5704AFA5-926F-42D0-82DC-C06C10E42074}"/>
               </a:ext>
             </a:extLst>
           </p:cNvPr>
@@ -3898,7 +3898,7 @@
           <p:cNvPr id="3" name="">
             <a:extLst xmlns:a="http://schemas.openxmlformats.org/drawingml/2006/main">
               <a:ext uri="{FF2B5EF4-FFF2-40B4-BE49-F238E27FC236}">
-                <a16:creationId xmlns:a16="http://schemas.microsoft.com/office/drawing/2014/main" id="{DBCF55CA-3B6F-4FFA-B1AD-B1F2DA26B432}"/>
+                <a16:creationId xmlns:a16="http://schemas.microsoft.com/office/drawing/2014/main" id="{D91AEF6B-14A9-4167-91B8-17EDE89C7823}"/>
               </a:ext>
             </a:extLst>
           </p:cNvPr>
@@ -3962,7 +3962,7 @@
           <p:cNvPr id="4" name="">
             <a:extLst xmlns:a="http://schemas.openxmlformats.org/drawingml/2006/main">
               <a:ext uri="{FF2B5EF4-FFF2-40B4-BE49-F238E27FC236}">
-                <a16:creationId xmlns:a16="http://schemas.microsoft.com/office/drawing/2014/main" id="{B31C2C4A-3BB0-4839-B004-C2287036FC1F}"/>
+                <a16:creationId xmlns:a16="http://schemas.microsoft.com/office/drawing/2014/main" id="{2D4C5446-B025-4E7B-84F7-E3BAED11D477}"/>
               </a:ext>
             </a:extLst>
           </p:cNvPr>
@@ -4026,7 +4026,7 @@
           <p:cNvPr id="5" name="">
             <a:extLst xmlns:a="http://schemas.openxmlformats.org/drawingml/2006/main">
               <a:ext uri="{FF2B5EF4-FFF2-40B4-BE49-F238E27FC236}">
-                <a16:creationId xmlns:a16="http://schemas.microsoft.com/office/drawing/2014/main" id="{E0DDBE1B-2607-4710-9C9D-0455C4E72C15}"/>
+                <a16:creationId xmlns:a16="http://schemas.microsoft.com/office/drawing/2014/main" id="{8C1D8F2B-336A-4D12-A2B4-29CC7450B0C2}"/>
               </a:ext>
             </a:extLst>
           </p:cNvPr>
@@ -4090,7 +4090,7 @@
           <p:cNvPr id="6" name="">
             <a:extLst xmlns:a="http://schemas.openxmlformats.org/drawingml/2006/main">
               <a:ext uri="{FF2B5EF4-FFF2-40B4-BE49-F238E27FC236}">
-                <a16:creationId xmlns:a16="http://schemas.microsoft.com/office/drawing/2014/main" id="{E5880653-4394-4893-8195-7C5729B750B5}"/>
+                <a16:creationId xmlns:a16="http://schemas.microsoft.com/office/drawing/2014/main" id="{4F738B84-BF9D-4F48-A2C9-7051671A56AF}"/>
               </a:ext>
             </a:extLst>
           </p:cNvPr>
@@ -4154,7 +4154,7 @@
           <p:cNvPr id="7" name="">
             <a:extLst xmlns:a="http://schemas.openxmlformats.org/drawingml/2006/main">
               <a:ext uri="{FF2B5EF4-FFF2-40B4-BE49-F238E27FC236}">
-                <a16:creationId xmlns:a16="http://schemas.microsoft.com/office/drawing/2014/main" id="{809C7126-DD70-4651-8A9E-605C84D74FD8}"/>
+                <a16:creationId xmlns:a16="http://schemas.microsoft.com/office/drawing/2014/main" id="{2901D38A-CE71-42DA-A93D-F789D6C0443F}"/>
               </a:ext>
             </a:extLst>
           </p:cNvPr>
@@ -4187,7 +4187,7 @@
           <p:cNvPr id="8" name="">
             <a:extLst xmlns:a="http://schemas.openxmlformats.org/drawingml/2006/main">
               <a:ext uri="{FF2B5EF4-FFF2-40B4-BE49-F238E27FC236}">
-                <a16:creationId xmlns:a16="http://schemas.microsoft.com/office/drawing/2014/main" id="{2CA8875A-362A-4806-8BF7-A9B3D573F470}"/>
+                <a16:creationId xmlns:a16="http://schemas.microsoft.com/office/drawing/2014/main" id="{A13804ED-C3D0-49FC-84C8-A390FA0CD0BE}"/>
               </a:ext>
             </a:extLst>
           </p:cNvPr>
@@ -4251,7 +4251,7 @@
           <p:cNvPr id="9" name="">
             <a:extLst xmlns:a="http://schemas.openxmlformats.org/drawingml/2006/main">
               <a:ext uri="{FF2B5EF4-FFF2-40B4-BE49-F238E27FC236}">
-                <a16:creationId xmlns:a16="http://schemas.microsoft.com/office/drawing/2014/main" id="{A4FFD8BE-8EB7-4995-B9DD-F32B4C9FE9CB}"/>
+                <a16:creationId xmlns:a16="http://schemas.microsoft.com/office/drawing/2014/main" id="{8302219D-D251-4B5C-81B0-5F03BA955102}"/>
               </a:ext>
             </a:extLst>
           </p:cNvPr>
@@ -4315,7 +4315,7 @@
           <p:cNvPr id="10" name="">
             <a:extLst xmlns:a="http://schemas.openxmlformats.org/drawingml/2006/main">
               <a:ext uri="{FF2B5EF4-FFF2-40B4-BE49-F238E27FC236}">
-                <a16:creationId xmlns:a16="http://schemas.microsoft.com/office/drawing/2014/main" id="{4307AB45-555E-45C9-8846-DAD2C95D8E4B}"/>
+                <a16:creationId xmlns:a16="http://schemas.microsoft.com/office/drawing/2014/main" id="{C8175700-24B3-483D-9C97-7AEE747E7987}"/>
               </a:ext>
             </a:extLst>
           </p:cNvPr>
@@ -4348,7 +4348,7 @@
           <p:cNvPr id="11" name="">
             <a:extLst xmlns:a="http://schemas.openxmlformats.org/drawingml/2006/main">
               <a:ext uri="{FF2B5EF4-FFF2-40B4-BE49-F238E27FC236}">
-                <a16:creationId xmlns:a16="http://schemas.microsoft.com/office/drawing/2014/main" id="{424A0E0B-D2C4-4FE9-82D0-E0E328C4F7FD}"/>
+                <a16:creationId xmlns:a16="http://schemas.microsoft.com/office/drawing/2014/main" id="{BB81B3DB-D7B0-4D10-AEC5-BE534D97ED67}"/>
               </a:ext>
             </a:extLst>
           </p:cNvPr>
@@ -4412,7 +4412,7 @@
           <p:cNvPr id="12" name="">
             <a:extLst xmlns:a="http://schemas.openxmlformats.org/drawingml/2006/main">
               <a:ext uri="{FF2B5EF4-FFF2-40B4-BE49-F238E27FC236}">
-                <a16:creationId xmlns:a16="http://schemas.microsoft.com/office/drawing/2014/main" id="{2A7686EA-0283-418A-808E-73A0F0A6E02D}"/>
+                <a16:creationId xmlns:a16="http://schemas.microsoft.com/office/drawing/2014/main" id="{F1DE2C82-5F3F-4438-9E6E-EEB4E5DFC7B3}"/>
               </a:ext>
             </a:extLst>
           </p:cNvPr>
@@ -4476,7 +4476,7 @@
           <p:cNvPr id="13" name="">
             <a:extLst xmlns:a="http://schemas.openxmlformats.org/drawingml/2006/main">
               <a:ext uri="{FF2B5EF4-FFF2-40B4-BE49-F238E27FC236}">
-                <a16:creationId xmlns:a16="http://schemas.microsoft.com/office/drawing/2014/main" id="{AD67FBA3-257C-4FA9-8040-3E2583C3103B}"/>
+                <a16:creationId xmlns:a16="http://schemas.microsoft.com/office/drawing/2014/main" id="{33A1F405-6C2D-4171-9BEB-776C57080545}"/>
               </a:ext>
             </a:extLst>
           </p:cNvPr>
@@ -4509,7 +4509,7 @@
           <p:cNvPr id="14" name="">
             <a:extLst xmlns:a="http://schemas.openxmlformats.org/drawingml/2006/main">
               <a:ext uri="{FF2B5EF4-FFF2-40B4-BE49-F238E27FC236}">
-                <a16:creationId xmlns:a16="http://schemas.microsoft.com/office/drawing/2014/main" id="{0AC7D64E-EAFD-4F59-9FDA-771A35D033B8}"/>
+                <a16:creationId xmlns:a16="http://schemas.microsoft.com/office/drawing/2014/main" id="{3A0D0651-332C-446A-BF67-858D8FCC799B}"/>
               </a:ext>
             </a:extLst>
           </p:cNvPr>
@@ -4573,7 +4573,7 @@
           <p:cNvPr id="15" name="">
             <a:extLst xmlns:a="http://schemas.openxmlformats.org/drawingml/2006/main">
               <a:ext uri="{FF2B5EF4-FFF2-40B4-BE49-F238E27FC236}">
-                <a16:creationId xmlns:a16="http://schemas.microsoft.com/office/drawing/2014/main" id="{9B99D1DE-099D-4289-89B1-8AE3F342FEC4}"/>
+                <a16:creationId xmlns:a16="http://schemas.microsoft.com/office/drawing/2014/main" id="{7081D0BF-5F88-4D80-A18E-89E491514DBA}"/>
               </a:ext>
             </a:extLst>
           </p:cNvPr>
@@ -4637,7 +4637,7 @@
           <p:cNvPr id="16" name="">
             <a:extLst xmlns:a="http://schemas.openxmlformats.org/drawingml/2006/main">
               <a:ext uri="{FF2B5EF4-FFF2-40B4-BE49-F238E27FC236}">
-                <a16:creationId xmlns:a16="http://schemas.microsoft.com/office/drawing/2014/main" id="{CEBEE6D7-A609-4AFB-954F-47A19EC9BE59}"/>
+                <a16:creationId xmlns:a16="http://schemas.microsoft.com/office/drawing/2014/main" id="{752D3BBB-8359-413F-98EF-51631B034346}"/>
               </a:ext>
             </a:extLst>
           </p:cNvPr>
@@ -4701,7 +4701,7 @@
           <p:cNvPr id="17" name="">
             <a:extLst xmlns:a="http://schemas.openxmlformats.org/drawingml/2006/main">
               <a:ext uri="{FF2B5EF4-FFF2-40B4-BE49-F238E27FC236}">
-                <a16:creationId xmlns:a16="http://schemas.microsoft.com/office/drawing/2014/main" id="{41236309-60F6-4A8A-9000-913C7D2D0C0D}"/>
+                <a16:creationId xmlns:a16="http://schemas.microsoft.com/office/drawing/2014/main" id="{EDAE304D-3BDB-486E-8873-88E0E20A312D}"/>
               </a:ext>
             </a:extLst>
           </p:cNvPr>
@@ -4763,7 +4763,7 @@
     </p:spTree>
     <p:extLst>
       <p:ext uri="{BB962C8B-B14F-4D97-AF65-F5344CB8AC3E}">
-        <p14:creationId xmlns:p14="http://schemas.microsoft.com/office/powerpoint/2010/main" val="555445408"/>
+        <p14:creationId xmlns:p14="http://schemas.microsoft.com/office/powerpoint/2010/main" val="1517068359"/>
       </p:ext>
     </p:extLst>
   </p:cSld>
@@ -4787,7 +4787,7 @@
           <p:cNvPr id="1" name="">
             <a:extLst xmlns:a="http://schemas.openxmlformats.org/drawingml/2006/main">
               <a:ext uri="{FF2B5EF4-FFF2-40B4-BE49-F238E27FC236}">
-                <a16:creationId xmlns:a16="http://schemas.microsoft.com/office/drawing/2014/main" id="{D13315E3-0A89-4DD1-B7EF-EFE8F900357A}"/>
+                <a16:creationId xmlns:a16="http://schemas.microsoft.com/office/drawing/2014/main" id="{BD19B0E2-4DE5-43EF-9FE4-A92AE37A3438}"/>
               </a:ext>
             </a:extLst>
           </p:cNvPr>
@@ -4822,7 +4822,7 @@
           <p:cNvPr id="2" name="">
             <a:extLst xmlns:a="http://schemas.openxmlformats.org/drawingml/2006/main">
               <a:ext uri="{FF2B5EF4-FFF2-40B4-BE49-F238E27FC236}">
-                <a16:creationId xmlns:a16="http://schemas.microsoft.com/office/drawing/2014/main" id="{66821AD1-616D-4069-8E3B-51EB348486EE}"/>
+                <a16:creationId xmlns:a16="http://schemas.microsoft.com/office/drawing/2014/main" id="{A18A1298-446E-483F-9C73-A5A4832893EB}"/>
               </a:ext>
             </a:extLst>
           </p:cNvPr>
@@ -4857,7 +4857,7 @@
           <p:cNvPr id="3" name="">
             <a:extLst xmlns:a="http://schemas.openxmlformats.org/drawingml/2006/main">
               <a:ext uri="{FF2B5EF4-FFF2-40B4-BE49-F238E27FC236}">
-                <a16:creationId xmlns:a16="http://schemas.microsoft.com/office/drawing/2014/main" id="{20C0593F-336E-4751-9D75-7243703031CE}"/>
+                <a16:creationId xmlns:a16="http://schemas.microsoft.com/office/drawing/2014/main" id="{B734211C-2A27-43D0-B050-D0CF7AEE274E}"/>
               </a:ext>
             </a:extLst>
           </p:cNvPr>
@@ -4921,7 +4921,7 @@
           <p:cNvPr id="4" name="">
             <a:extLst xmlns:a="http://schemas.openxmlformats.org/drawingml/2006/main">
               <a:ext uri="{FF2B5EF4-FFF2-40B4-BE49-F238E27FC236}">
-                <a16:creationId xmlns:a16="http://schemas.microsoft.com/office/drawing/2014/main" id="{123F0880-D431-4D4B-A801-D9DB73988C9F}"/>
+                <a16:creationId xmlns:a16="http://schemas.microsoft.com/office/drawing/2014/main" id="{6A9DAD3C-9901-4C0B-8277-801AE241CB01}"/>
               </a:ext>
             </a:extLst>
           </p:cNvPr>
@@ -4985,7 +4985,7 @@
           <p:cNvPr id="5" name="">
             <a:extLst xmlns:a="http://schemas.openxmlformats.org/drawingml/2006/main">
               <a:ext uri="{FF2B5EF4-FFF2-40B4-BE49-F238E27FC236}">
-                <a16:creationId xmlns:a16="http://schemas.microsoft.com/office/drawing/2014/main" id="{FDEC63E7-78DC-4895-A1EA-414B14AF3871}"/>
+                <a16:creationId xmlns:a16="http://schemas.microsoft.com/office/drawing/2014/main" id="{013F0C4B-B657-48B0-AD2B-5355C5B359DF}"/>
               </a:ext>
             </a:extLst>
           </p:cNvPr>
@@ -5049,7 +5049,7 @@
           <p:cNvPr id="6" name="">
             <a:extLst xmlns:a="http://schemas.openxmlformats.org/drawingml/2006/main">
               <a:ext uri="{FF2B5EF4-FFF2-40B4-BE49-F238E27FC236}">
-                <a16:creationId xmlns:a16="http://schemas.microsoft.com/office/drawing/2014/main" id="{2E5226CB-C824-4D4C-8BB4-DD904460227D}"/>
+                <a16:creationId xmlns:a16="http://schemas.microsoft.com/office/drawing/2014/main" id="{B4999F5E-ED3E-4324-9D83-16EDB9C939CD}"/>
               </a:ext>
             </a:extLst>
           </p:cNvPr>
@@ -5113,7 +5113,7 @@
           <p:cNvPr id="7" name="">
             <a:extLst xmlns:a="http://schemas.openxmlformats.org/drawingml/2006/main">
               <a:ext uri="{FF2B5EF4-FFF2-40B4-BE49-F238E27FC236}">
-                <a16:creationId xmlns:a16="http://schemas.microsoft.com/office/drawing/2014/main" id="{787A0A4A-76D7-47B7-A8C6-93EEB9D0EA20}"/>
+                <a16:creationId xmlns:a16="http://schemas.microsoft.com/office/drawing/2014/main" id="{621C5141-E256-4555-9EC8-E9495202A152}"/>
               </a:ext>
             </a:extLst>
           </p:cNvPr>
@@ -5146,7 +5146,7 @@
           <p:cNvPr id="8" name="">
             <a:extLst xmlns:a="http://schemas.openxmlformats.org/drawingml/2006/main">
               <a:ext uri="{FF2B5EF4-FFF2-40B4-BE49-F238E27FC236}">
-                <a16:creationId xmlns:a16="http://schemas.microsoft.com/office/drawing/2014/main" id="{FAB482C9-23F6-44DD-8F7B-A663F407DA74}"/>
+                <a16:creationId xmlns:a16="http://schemas.microsoft.com/office/drawing/2014/main" id="{BF10B47C-6D82-4C45-AEB7-38D396B3C4EF}"/>
               </a:ext>
             </a:extLst>
           </p:cNvPr>
@@ -5210,7 +5210,7 @@
           <p:cNvPr id="9" name="">
             <a:extLst xmlns:a="http://schemas.openxmlformats.org/drawingml/2006/main">
               <a:ext uri="{FF2B5EF4-FFF2-40B4-BE49-F238E27FC236}">
-                <a16:creationId xmlns:a16="http://schemas.microsoft.com/office/drawing/2014/main" id="{28606228-B39F-417C-B7B0-1002EB0BCA1F}"/>
+                <a16:creationId xmlns:a16="http://schemas.microsoft.com/office/drawing/2014/main" id="{15569BD4-221A-40C5-8390-0E4BCCE0C1F7}"/>
               </a:ext>
             </a:extLst>
           </p:cNvPr>
@@ -5274,7 +5274,7 @@
           <p:cNvPr id="10" name="">
             <a:extLst xmlns:a="http://schemas.openxmlformats.org/drawingml/2006/main">
               <a:ext uri="{FF2B5EF4-FFF2-40B4-BE49-F238E27FC236}">
-                <a16:creationId xmlns:a16="http://schemas.microsoft.com/office/drawing/2014/main" id="{2112E6B2-323B-4D8F-A774-92FAC0A975ED}"/>
+                <a16:creationId xmlns:a16="http://schemas.microsoft.com/office/drawing/2014/main" id="{7B583500-4581-4B11-8E40-B9FD5DCE0B7F}"/>
               </a:ext>
             </a:extLst>
           </p:cNvPr>
@@ -5338,7 +5338,7 @@
           <p:cNvPr id="11" name="">
             <a:extLst xmlns:a="http://schemas.openxmlformats.org/drawingml/2006/main">
               <a:ext uri="{FF2B5EF4-FFF2-40B4-BE49-F238E27FC236}">
-                <a16:creationId xmlns:a16="http://schemas.microsoft.com/office/drawing/2014/main" id="{B3AA8C0D-4D76-47F8-84E5-6F72D2646B75}"/>
+                <a16:creationId xmlns:a16="http://schemas.microsoft.com/office/drawing/2014/main" id="{6F0C6D40-A878-4129-A53F-993BD2164C0A}"/>
               </a:ext>
             </a:extLst>
           </p:cNvPr>
@@ -5371,7 +5371,7 @@
           <p:cNvPr id="12" name="">
             <a:extLst xmlns:a="http://schemas.openxmlformats.org/drawingml/2006/main">
               <a:ext uri="{FF2B5EF4-FFF2-40B4-BE49-F238E27FC236}">
-                <a16:creationId xmlns:a16="http://schemas.microsoft.com/office/drawing/2014/main" id="{03612C2A-EB81-47BD-B4DE-41BB3F5E73AF}"/>
+                <a16:creationId xmlns:a16="http://schemas.microsoft.com/office/drawing/2014/main" id="{7C0F9D5D-D554-4B2C-9217-EBEC37271C01}"/>
               </a:ext>
             </a:extLst>
           </p:cNvPr>
@@ -5435,7 +5435,7 @@
           <p:cNvPr id="13" name="">
             <a:extLst xmlns:a="http://schemas.openxmlformats.org/drawingml/2006/main">
               <a:ext uri="{FF2B5EF4-FFF2-40B4-BE49-F238E27FC236}">
-                <a16:creationId xmlns:a16="http://schemas.microsoft.com/office/drawing/2014/main" id="{AAD23E33-D739-4BA2-B938-1863B4D3072D}"/>
+                <a16:creationId xmlns:a16="http://schemas.microsoft.com/office/drawing/2014/main" id="{43F7E004-D654-4E2D-B83A-F3C462FE4152}"/>
               </a:ext>
             </a:extLst>
           </p:cNvPr>
@@ -5499,7 +5499,7 @@
           <p:cNvPr id="14" name="">
             <a:extLst xmlns:a="http://schemas.openxmlformats.org/drawingml/2006/main">
               <a:ext uri="{FF2B5EF4-FFF2-40B4-BE49-F238E27FC236}">
-                <a16:creationId xmlns:a16="http://schemas.microsoft.com/office/drawing/2014/main" id="{3803A760-002D-4FBB-9CDB-390CD07D2F2A}"/>
+                <a16:creationId xmlns:a16="http://schemas.microsoft.com/office/drawing/2014/main" id="{8A92EA54-58F0-44B8-AA18-5CF27D7ABFD0}"/>
               </a:ext>
             </a:extLst>
           </p:cNvPr>
@@ -5563,7 +5563,7 @@
           <p:cNvPr id="15" name="">
             <a:extLst xmlns:a="http://schemas.openxmlformats.org/drawingml/2006/main">
               <a:ext uri="{FF2B5EF4-FFF2-40B4-BE49-F238E27FC236}">
-                <a16:creationId xmlns:a16="http://schemas.microsoft.com/office/drawing/2014/main" id="{7C3F00E7-9FFC-40A2-87ED-F475F6667F6E}"/>
+                <a16:creationId xmlns:a16="http://schemas.microsoft.com/office/drawing/2014/main" id="{DB205B4D-6169-486C-B1C5-295E1129BD7F}"/>
               </a:ext>
             </a:extLst>
           </p:cNvPr>
@@ -5596,7 +5596,7 @@
           <p:cNvPr id="16" name="">
             <a:extLst xmlns:a="http://schemas.openxmlformats.org/drawingml/2006/main">
               <a:ext uri="{FF2B5EF4-FFF2-40B4-BE49-F238E27FC236}">
-                <a16:creationId xmlns:a16="http://schemas.microsoft.com/office/drawing/2014/main" id="{2C31DDB1-29FE-4795-8ABD-0970487BCD8E}"/>
+                <a16:creationId xmlns:a16="http://schemas.microsoft.com/office/drawing/2014/main" id="{38D36E0E-779A-4B36-9CB1-F8E97539F325}"/>
               </a:ext>
             </a:extLst>
           </p:cNvPr>
@@ -5660,7 +5660,7 @@
           <p:cNvPr id="17" name="">
             <a:extLst xmlns:a="http://schemas.openxmlformats.org/drawingml/2006/main">
               <a:ext uri="{FF2B5EF4-FFF2-40B4-BE49-F238E27FC236}">
-                <a16:creationId xmlns:a16="http://schemas.microsoft.com/office/drawing/2014/main" id="{6C580EF9-141E-4543-843F-BA0180FC3574}"/>
+                <a16:creationId xmlns:a16="http://schemas.microsoft.com/office/drawing/2014/main" id="{EE67A029-5014-4DF1-9B17-B9D04446BD1B}"/>
               </a:ext>
             </a:extLst>
           </p:cNvPr>
@@ -5724,7 +5724,7 @@
           <p:cNvPr id="18" name="">
             <a:extLst xmlns:a="http://schemas.openxmlformats.org/drawingml/2006/main">
               <a:ext uri="{FF2B5EF4-FFF2-40B4-BE49-F238E27FC236}">
-                <a16:creationId xmlns:a16="http://schemas.microsoft.com/office/drawing/2014/main" id="{F42BF412-5B80-4C7D-AB61-6FCC30B4CD4A}"/>
+                <a16:creationId xmlns:a16="http://schemas.microsoft.com/office/drawing/2014/main" id="{B1A36A4C-B5E0-4198-949F-4076AA4A51D6}"/>
               </a:ext>
             </a:extLst>
           </p:cNvPr>
@@ -5788,7 +5788,7 @@
           <p:cNvPr id="19" name="">
             <a:extLst xmlns:a="http://schemas.openxmlformats.org/drawingml/2006/main">
               <a:ext uri="{FF2B5EF4-FFF2-40B4-BE49-F238E27FC236}">
-                <a16:creationId xmlns:a16="http://schemas.microsoft.com/office/drawing/2014/main" id="{5FF41C11-0ADB-482B-86C0-623FAA1EF114}"/>
+                <a16:creationId xmlns:a16="http://schemas.microsoft.com/office/drawing/2014/main" id="{3C5D6C47-82C5-4768-9BE1-0871682BB4A8}"/>
               </a:ext>
             </a:extLst>
           </p:cNvPr>
@@ -5821,7 +5821,7 @@
           <p:cNvPr id="20" name="">
             <a:extLst xmlns:a="http://schemas.openxmlformats.org/drawingml/2006/main">
               <a:ext uri="{FF2B5EF4-FFF2-40B4-BE49-F238E27FC236}">
-                <a16:creationId xmlns:a16="http://schemas.microsoft.com/office/drawing/2014/main" id="{1BC79723-3A94-45B4-861F-63BC844CAE0C}"/>
+                <a16:creationId xmlns:a16="http://schemas.microsoft.com/office/drawing/2014/main" id="{4FC63DB1-336A-4927-A3EE-D8649700CF79}"/>
               </a:ext>
             </a:extLst>
           </p:cNvPr>
@@ -5885,7 +5885,7 @@
           <p:cNvPr id="21" name="">
             <a:extLst xmlns:a="http://schemas.openxmlformats.org/drawingml/2006/main">
               <a:ext uri="{FF2B5EF4-FFF2-40B4-BE49-F238E27FC236}">
-                <a16:creationId xmlns:a16="http://schemas.microsoft.com/office/drawing/2014/main" id="{4F5A7A27-D483-44E7-BEE0-CD56E5D0C5BE}"/>
+                <a16:creationId xmlns:a16="http://schemas.microsoft.com/office/drawing/2014/main" id="{BA1EF492-CCD5-4EC6-916F-CC24CF42E990}"/>
               </a:ext>
             </a:extLst>
           </p:cNvPr>
@@ -5949,7 +5949,7 @@
           <p:cNvPr id="22" name="">
             <a:extLst xmlns:a="http://schemas.openxmlformats.org/drawingml/2006/main">
               <a:ext uri="{FF2B5EF4-FFF2-40B4-BE49-F238E27FC236}">
-                <a16:creationId xmlns:a16="http://schemas.microsoft.com/office/drawing/2014/main" id="{7F5EB3E5-890B-4718-A782-FD755EF150A8}"/>
+                <a16:creationId xmlns:a16="http://schemas.microsoft.com/office/drawing/2014/main" id="{068BC411-DFC2-4519-AF5B-8DE31E333109}"/>
               </a:ext>
             </a:extLst>
           </p:cNvPr>
@@ -5982,7 +5982,7 @@
           <p:cNvPr id="23" name="">
             <a:extLst xmlns:a="http://schemas.openxmlformats.org/drawingml/2006/main">
               <a:ext uri="{FF2B5EF4-FFF2-40B4-BE49-F238E27FC236}">
-                <a16:creationId xmlns:a16="http://schemas.microsoft.com/office/drawing/2014/main" id="{92EDC3EB-D3E9-4B28-8CFC-BD157BF57C03}"/>
+                <a16:creationId xmlns:a16="http://schemas.microsoft.com/office/drawing/2014/main" id="{F8412D12-1134-43FC-B1DA-0FD55448DE02}"/>
               </a:ext>
             </a:extLst>
           </p:cNvPr>
@@ -6046,7 +6046,7 @@
           <p:cNvPr id="24" name="">
             <a:extLst xmlns:a="http://schemas.openxmlformats.org/drawingml/2006/main">
               <a:ext uri="{FF2B5EF4-FFF2-40B4-BE49-F238E27FC236}">
-                <a16:creationId xmlns:a16="http://schemas.microsoft.com/office/drawing/2014/main" id="{45658026-1624-48E3-8856-2CD43BE631BC}"/>
+                <a16:creationId xmlns:a16="http://schemas.microsoft.com/office/drawing/2014/main" id="{37617875-1F18-4151-B5C5-B1FD40F9FDD9}"/>
               </a:ext>
             </a:extLst>
           </p:cNvPr>
@@ -6110,7 +6110,7 @@
           <p:cNvPr id="25" name="">
             <a:extLst xmlns:a="http://schemas.openxmlformats.org/drawingml/2006/main">
               <a:ext uri="{FF2B5EF4-FFF2-40B4-BE49-F238E27FC236}">
-                <a16:creationId xmlns:a16="http://schemas.microsoft.com/office/drawing/2014/main" id="{6F061F23-236C-4799-8905-BD571654FCC4}"/>
+                <a16:creationId xmlns:a16="http://schemas.microsoft.com/office/drawing/2014/main" id="{F6BB822E-CC2C-4BDC-B6AD-1E1E7E3111E7}"/>
               </a:ext>
             </a:extLst>
           </p:cNvPr>
@@ -6174,7 +6174,7 @@
           <p:cNvPr id="26" name="">
             <a:extLst xmlns:a="http://schemas.openxmlformats.org/drawingml/2006/main">
               <a:ext uri="{FF2B5EF4-FFF2-40B4-BE49-F238E27FC236}">
-                <a16:creationId xmlns:a16="http://schemas.microsoft.com/office/drawing/2014/main" id="{B99433FA-C7E1-4D32-AF22-113CB50B00C5}"/>
+                <a16:creationId xmlns:a16="http://schemas.microsoft.com/office/drawing/2014/main" id="{F21D0AC7-EE46-4008-9490-7C5ABE4B02DB}"/>
               </a:ext>
             </a:extLst>
           </p:cNvPr>
@@ -6236,7 +6236,7 @@
     </p:spTree>
     <p:extLst>
       <p:ext uri="{BB962C8B-B14F-4D97-AF65-F5344CB8AC3E}">
-        <p14:creationId xmlns:p14="http://schemas.microsoft.com/office/powerpoint/2010/main" val="2071943761"/>
+        <p14:creationId xmlns:p14="http://schemas.microsoft.com/office/powerpoint/2010/main" val="1551004395"/>
       </p:ext>
     </p:extLst>
   </p:cSld>
@@ -6260,7 +6260,7 @@
           <p:cNvPr id="1" name="">
             <a:extLst xmlns:a="http://schemas.openxmlformats.org/drawingml/2006/main">
               <a:ext uri="{FF2B5EF4-FFF2-40B4-BE49-F238E27FC236}">
-                <a16:creationId xmlns:a16="http://schemas.microsoft.com/office/drawing/2014/main" id="{26CDC88E-C7B7-449D-BC5F-302B2FE7084E}"/>
+                <a16:creationId xmlns:a16="http://schemas.microsoft.com/office/drawing/2014/main" id="{B84A1E0F-A0EF-4EBB-A5A8-D3FAE22AE6FA}"/>
               </a:ext>
             </a:extLst>
           </p:cNvPr>
@@ -6295,7 +6295,7 @@
           <p:cNvPr id="2" name="">
             <a:extLst xmlns:a="http://schemas.openxmlformats.org/drawingml/2006/main">
               <a:ext uri="{FF2B5EF4-FFF2-40B4-BE49-F238E27FC236}">
-                <a16:creationId xmlns:a16="http://schemas.microsoft.com/office/drawing/2014/main" id="{00751BDD-6688-43C7-86D7-F155291FCA8A}"/>
+                <a16:creationId xmlns:a16="http://schemas.microsoft.com/office/drawing/2014/main" id="{16B2044C-7187-4B1F-A5A3-2A5E5DD70B01}"/>
               </a:ext>
             </a:extLst>
           </p:cNvPr>
@@ -6330,7 +6330,7 @@
           <p:cNvPr id="3" name="">
             <a:extLst xmlns:a="http://schemas.openxmlformats.org/drawingml/2006/main">
               <a:ext uri="{FF2B5EF4-FFF2-40B4-BE49-F238E27FC236}">
-                <a16:creationId xmlns:a16="http://schemas.microsoft.com/office/drawing/2014/main" id="{0CEEA0D1-3BE6-4C8F-99F7-B5C955DAEC86}"/>
+                <a16:creationId xmlns:a16="http://schemas.microsoft.com/office/drawing/2014/main" id="{32F39198-2FDD-4FEB-B8E4-313917C71C91}"/>
               </a:ext>
             </a:extLst>
           </p:cNvPr>
@@ -6394,7 +6394,7 @@
           <p:cNvPr id="4" name="">
             <a:extLst xmlns:a="http://schemas.openxmlformats.org/drawingml/2006/main">
               <a:ext uri="{FF2B5EF4-FFF2-40B4-BE49-F238E27FC236}">
-                <a16:creationId xmlns:a16="http://schemas.microsoft.com/office/drawing/2014/main" id="{E1E71671-223B-42F7-8E12-48D1AF63385C}"/>
+                <a16:creationId xmlns:a16="http://schemas.microsoft.com/office/drawing/2014/main" id="{BD4576CA-0733-4130-B175-EB4CF8BFC411}"/>
               </a:ext>
             </a:extLst>
           </p:cNvPr>
@@ -6458,7 +6458,7 @@
           <p:cNvPr id="5" name="">
             <a:extLst xmlns:a="http://schemas.openxmlformats.org/drawingml/2006/main">
               <a:ext uri="{FF2B5EF4-FFF2-40B4-BE49-F238E27FC236}">
-                <a16:creationId xmlns:a16="http://schemas.microsoft.com/office/drawing/2014/main" id="{FC564781-F006-4164-BEFA-DEBCC9B0C258}"/>
+                <a16:creationId xmlns:a16="http://schemas.microsoft.com/office/drawing/2014/main" id="{77DC2302-232F-46AC-B7E5-B0A24546D93D}"/>
               </a:ext>
             </a:extLst>
           </p:cNvPr>
@@ -6522,7 +6522,7 @@
           <p:cNvPr id="6" name="">
             <a:extLst xmlns:a="http://schemas.openxmlformats.org/drawingml/2006/main">
               <a:ext uri="{FF2B5EF4-FFF2-40B4-BE49-F238E27FC236}">
-                <a16:creationId xmlns:a16="http://schemas.microsoft.com/office/drawing/2014/main" id="{DA603AE6-54D1-4DFA-883A-DEC5B5DCD976}"/>
+                <a16:creationId xmlns:a16="http://schemas.microsoft.com/office/drawing/2014/main" id="{1201A519-EAB1-4E8A-A397-6C2A2A307F9B}"/>
               </a:ext>
             </a:extLst>
           </p:cNvPr>
@@ -6586,7 +6586,7 @@
           <p:cNvPr id="7" name="">
             <a:extLst xmlns:a="http://schemas.openxmlformats.org/drawingml/2006/main">
               <a:ext uri="{FF2B5EF4-FFF2-40B4-BE49-F238E27FC236}">
-                <a16:creationId xmlns:a16="http://schemas.microsoft.com/office/drawing/2014/main" id="{4A26C7E1-A3DB-4F98-8E47-9E0229206D69}"/>
+                <a16:creationId xmlns:a16="http://schemas.microsoft.com/office/drawing/2014/main" id="{7E7BA54C-CE9D-405F-91D6-FA543749421B}"/>
               </a:ext>
             </a:extLst>
           </p:cNvPr>
@@ -6619,7 +6619,7 @@
           <p:cNvPr id="8" name="">
             <a:extLst xmlns:a="http://schemas.openxmlformats.org/drawingml/2006/main">
               <a:ext uri="{FF2B5EF4-FFF2-40B4-BE49-F238E27FC236}">
-                <a16:creationId xmlns:a16="http://schemas.microsoft.com/office/drawing/2014/main" id="{967414ED-D0B0-488C-985F-1FD4F3EFDE16}"/>
+                <a16:creationId xmlns:a16="http://schemas.microsoft.com/office/drawing/2014/main" id="{81B4F7C9-BE4B-47DD-87B9-1026D8B05C2D}"/>
               </a:ext>
             </a:extLst>
           </p:cNvPr>
@@ -6683,7 +6683,7 @@
           <p:cNvPr id="9" name="">
             <a:extLst xmlns:a="http://schemas.openxmlformats.org/drawingml/2006/main">
               <a:ext uri="{FF2B5EF4-FFF2-40B4-BE49-F238E27FC236}">
-                <a16:creationId xmlns:a16="http://schemas.microsoft.com/office/drawing/2014/main" id="{52748D88-7791-44B2-AFFC-0C12B0D00036}"/>
+                <a16:creationId xmlns:a16="http://schemas.microsoft.com/office/drawing/2014/main" id="{8EA1FAAE-99DD-450A-A33D-A7668D5FBC30}"/>
               </a:ext>
             </a:extLst>
           </p:cNvPr>
@@ -6737,7 +6737,7 @@
                 <a:ea typeface="Aptos"/>
                 <a:cs typeface="Aptos"/>
               </a:rPr>
-              <a:t>OpenAI-compatible Gemma or deterministic stub proposes JSON action.</a:t>
+              <a:t>Four Gemma subagents report to a Sagents supervisor.</a:t>
             </a:r>
           </a:p>
         </p:txBody>
@@ -6747,7 +6747,7 @@
           <p:cNvPr id="10" name="">
             <a:extLst xmlns:a="http://schemas.openxmlformats.org/drawingml/2006/main">
               <a:ext uri="{FF2B5EF4-FFF2-40B4-BE49-F238E27FC236}">
-                <a16:creationId xmlns:a16="http://schemas.microsoft.com/office/drawing/2014/main" id="{ABB0B399-41F3-4D3B-B4F0-1D85E4751475}"/>
+                <a16:creationId xmlns:a16="http://schemas.microsoft.com/office/drawing/2014/main" id="{E1FEAA79-C900-4FAA-ADA9-502DB52BD1C8}"/>
               </a:ext>
             </a:extLst>
           </p:cNvPr>
@@ -6811,7 +6811,7 @@
           <p:cNvPr id="11" name="">
             <a:extLst xmlns:a="http://schemas.openxmlformats.org/drawingml/2006/main">
               <a:ext uri="{FF2B5EF4-FFF2-40B4-BE49-F238E27FC236}">
-                <a16:creationId xmlns:a16="http://schemas.microsoft.com/office/drawing/2014/main" id="{2C84D4DA-95C4-48A0-A651-195F55AB17B0}"/>
+                <a16:creationId xmlns:a16="http://schemas.microsoft.com/office/drawing/2014/main" id="{D50F4D77-25B5-4981-85B6-303B750877A2}"/>
               </a:ext>
             </a:extLst>
           </p:cNvPr>
@@ -6844,7 +6844,7 @@
           <p:cNvPr id="12" name="">
             <a:extLst xmlns:a="http://schemas.openxmlformats.org/drawingml/2006/main">
               <a:ext uri="{FF2B5EF4-FFF2-40B4-BE49-F238E27FC236}">
-                <a16:creationId xmlns:a16="http://schemas.microsoft.com/office/drawing/2014/main" id="{31910503-C25B-4888-B555-83EC2236DF95}"/>
+                <a16:creationId xmlns:a16="http://schemas.microsoft.com/office/drawing/2014/main" id="{1B081FDC-7DE8-4C38-A78D-F090644AA727}"/>
               </a:ext>
             </a:extLst>
           </p:cNvPr>
@@ -6908,7 +6908,7 @@
           <p:cNvPr id="13" name="">
             <a:extLst xmlns:a="http://schemas.openxmlformats.org/drawingml/2006/main">
               <a:ext uri="{FF2B5EF4-FFF2-40B4-BE49-F238E27FC236}">
-                <a16:creationId xmlns:a16="http://schemas.microsoft.com/office/drawing/2014/main" id="{522D01A8-EF2D-49D9-B7A6-785D1DF4F0C9}"/>
+                <a16:creationId xmlns:a16="http://schemas.microsoft.com/office/drawing/2014/main" id="{D1B54F09-CCAC-472E-AD14-A574927CFB8E}"/>
               </a:ext>
             </a:extLst>
           </p:cNvPr>
@@ -6972,7 +6972,7 @@
           <p:cNvPr id="14" name="">
             <a:extLst xmlns:a="http://schemas.openxmlformats.org/drawingml/2006/main">
               <a:ext uri="{FF2B5EF4-FFF2-40B4-BE49-F238E27FC236}">
-                <a16:creationId xmlns:a16="http://schemas.microsoft.com/office/drawing/2014/main" id="{C9C86FCB-FE28-46B3-A351-BFF22EBDAFC2}"/>
+                <a16:creationId xmlns:a16="http://schemas.microsoft.com/office/drawing/2014/main" id="{2EDDF161-C803-4563-9A56-01CEA21586F7}"/>
               </a:ext>
             </a:extLst>
           </p:cNvPr>
@@ -7036,7 +7036,7 @@
           <p:cNvPr id="15" name="">
             <a:extLst xmlns:a="http://schemas.openxmlformats.org/drawingml/2006/main">
               <a:ext uri="{FF2B5EF4-FFF2-40B4-BE49-F238E27FC236}">
-                <a16:creationId xmlns:a16="http://schemas.microsoft.com/office/drawing/2014/main" id="{C2B0CB37-02A8-4619-AEDB-CD68AE21CBEB}"/>
+                <a16:creationId xmlns:a16="http://schemas.microsoft.com/office/drawing/2014/main" id="{0636609C-60E2-4966-8FE4-06A52DE82C7C}"/>
               </a:ext>
             </a:extLst>
           </p:cNvPr>
@@ -7069,7 +7069,7 @@
           <p:cNvPr id="16" name="">
             <a:extLst xmlns:a="http://schemas.openxmlformats.org/drawingml/2006/main">
               <a:ext uri="{FF2B5EF4-FFF2-40B4-BE49-F238E27FC236}">
-                <a16:creationId xmlns:a16="http://schemas.microsoft.com/office/drawing/2014/main" id="{3A64F1B2-5AB8-4553-9150-C99C77DD9F8A}"/>
+                <a16:creationId xmlns:a16="http://schemas.microsoft.com/office/drawing/2014/main" id="{1C0D2557-3599-419D-9166-80BD09E5D75D}"/>
               </a:ext>
             </a:extLst>
           </p:cNvPr>
@@ -7133,7 +7133,7 @@
           <p:cNvPr id="17" name="">
             <a:extLst xmlns:a="http://schemas.openxmlformats.org/drawingml/2006/main">
               <a:ext uri="{FF2B5EF4-FFF2-40B4-BE49-F238E27FC236}">
-                <a16:creationId xmlns:a16="http://schemas.microsoft.com/office/drawing/2014/main" id="{AAE82B0C-44F3-4709-A485-0D9389548782}"/>
+                <a16:creationId xmlns:a16="http://schemas.microsoft.com/office/drawing/2014/main" id="{828FA002-01E5-4B77-ADDC-C42019353D75}"/>
               </a:ext>
             </a:extLst>
           </p:cNvPr>
@@ -7197,7 +7197,7 @@
           <p:cNvPr id="18" name="">
             <a:extLst xmlns:a="http://schemas.openxmlformats.org/drawingml/2006/main">
               <a:ext uri="{FF2B5EF4-FFF2-40B4-BE49-F238E27FC236}">
-                <a16:creationId xmlns:a16="http://schemas.microsoft.com/office/drawing/2014/main" id="{A8948101-08EF-410F-8A69-471FA28B285E}"/>
+                <a16:creationId xmlns:a16="http://schemas.microsoft.com/office/drawing/2014/main" id="{D0B39E5B-E1FD-4788-AB34-F55C15C73DF3}"/>
               </a:ext>
             </a:extLst>
           </p:cNvPr>
@@ -7261,19 +7261,19 @@
           <p:cNvPr id="19" name="">
             <a:extLst xmlns:a="http://schemas.openxmlformats.org/drawingml/2006/main">
               <a:ext uri="{FF2B5EF4-FFF2-40B4-BE49-F238E27FC236}">
-                <a16:creationId xmlns:a16="http://schemas.microsoft.com/office/drawing/2014/main" id="{3AE885E4-39E6-4280-8613-E7D6E352D4D7}"/>
-              </a:ext>
-            </a:extLst>
-          </p:cNvPr>
-          <p:cNvSpPr>
-            <a:spLocks xmlns:a="http://schemas.openxmlformats.org/drawingml/2006/main" noGrp="1"/>
-          </p:cNvSpPr>
-          <p:nvPr/>
-        </p:nvSpPr>
-        <p:spPr>
-          <a:xfrm xmlns:a="http://schemas.openxmlformats.org/drawingml/2006/main">
-            <a:off x="9239250" y="2362200"/>
-            <a:ext cx="2000250" cy="1295400"/>
+                <a16:creationId xmlns:a16="http://schemas.microsoft.com/office/drawing/2014/main" id="{EEFB2214-4F23-4789-AF00-42E2DF40B00D}"/>
+              </a:ext>
+            </a:extLst>
+          </p:cNvPr>
+          <p:cNvSpPr>
+            <a:spLocks xmlns:a="http://schemas.openxmlformats.org/drawingml/2006/main" noGrp="1"/>
+          </p:cNvSpPr>
+          <p:nvPr/>
+        </p:nvSpPr>
+        <p:spPr>
+          <a:xfrm xmlns:a="http://schemas.openxmlformats.org/drawingml/2006/main">
+            <a:off x="9048750" y="2362200"/>
+            <a:ext cx="2190750" cy="1295400"/>
           </a:xfrm>
           <a:prstGeom xmlns:a="http://schemas.openxmlformats.org/drawingml/2006/main" prst="rect">
             <a:avLst/>
@@ -7294,19 +7294,19 @@
           <p:cNvPr id="20" name="">
             <a:extLst xmlns:a="http://schemas.openxmlformats.org/drawingml/2006/main">
               <a:ext uri="{FF2B5EF4-FFF2-40B4-BE49-F238E27FC236}">
-                <a16:creationId xmlns:a16="http://schemas.microsoft.com/office/drawing/2014/main" id="{C0F1C3EB-DD3C-4F0D-9F69-91C974A8DDBE}"/>
-              </a:ext>
-            </a:extLst>
-          </p:cNvPr>
-          <p:cNvSpPr>
-            <a:spLocks xmlns:a="http://schemas.openxmlformats.org/drawingml/2006/main" noGrp="1"/>
-          </p:cNvSpPr>
-          <p:nvPr/>
-        </p:nvSpPr>
-        <p:spPr>
-          <a:xfrm xmlns:a="http://schemas.openxmlformats.org/drawingml/2006/main">
-            <a:off x="9410700" y="2495550"/>
-            <a:ext cx="1657350" cy="285750"/>
+                <a16:creationId xmlns:a16="http://schemas.microsoft.com/office/drawing/2014/main" id="{5FFCB9E5-B29E-418B-BD66-ECCF5B65CEBF}"/>
+              </a:ext>
+            </a:extLst>
+          </p:cNvPr>
+          <p:cNvSpPr>
+            <a:spLocks xmlns:a="http://schemas.openxmlformats.org/drawingml/2006/main" noGrp="1"/>
+          </p:cNvSpPr>
+          <p:nvPr/>
+        </p:nvSpPr>
+        <p:spPr>
+          <a:xfrm xmlns:a="http://schemas.openxmlformats.org/drawingml/2006/main">
+            <a:off x="9220200" y="2495550"/>
+            <a:ext cx="1847850" cy="285750"/>
           </a:xfrm>
           <a:prstGeom xmlns:a="http://schemas.openxmlformats.org/drawingml/2006/main" prst="rect">
             <a:avLst/>
@@ -7348,7 +7348,7 @@
                 <a:ea typeface="Aptos"/>
                 <a:cs typeface="Aptos"/>
               </a:rPr>
-              <a:t>until_tool</a:t>
+              <a:t>until_tool_success</a:t>
             </a:r>
           </a:p>
         </p:txBody>
@@ -7358,19 +7358,19 @@
           <p:cNvPr id="21" name="">
             <a:extLst xmlns:a="http://schemas.openxmlformats.org/drawingml/2006/main">
               <a:ext uri="{FF2B5EF4-FFF2-40B4-BE49-F238E27FC236}">
-                <a16:creationId xmlns:a16="http://schemas.microsoft.com/office/drawing/2014/main" id="{F2876EBE-AAF8-4D87-820E-98F0FDBC265B}"/>
-              </a:ext>
-            </a:extLst>
-          </p:cNvPr>
-          <p:cNvSpPr>
-            <a:spLocks xmlns:a="http://schemas.openxmlformats.org/drawingml/2006/main" noGrp="1"/>
-          </p:cNvSpPr>
-          <p:nvPr/>
-        </p:nvSpPr>
-        <p:spPr>
-          <a:xfrm xmlns:a="http://schemas.openxmlformats.org/drawingml/2006/main">
-            <a:off x="9410700" y="2838450"/>
-            <a:ext cx="1657350" cy="647700"/>
+                <a16:creationId xmlns:a16="http://schemas.microsoft.com/office/drawing/2014/main" id="{966F7A5A-AE49-49B1-AAEF-973568676F83}"/>
+              </a:ext>
+            </a:extLst>
+          </p:cNvPr>
+          <p:cNvSpPr>
+            <a:spLocks xmlns:a="http://schemas.openxmlformats.org/drawingml/2006/main" noGrp="1"/>
+          </p:cNvSpPr>
+          <p:nvPr/>
+        </p:nvSpPr>
+        <p:spPr>
+          <a:xfrm xmlns:a="http://schemas.openxmlformats.org/drawingml/2006/main">
+            <a:off x="9220200" y="2838450"/>
+            <a:ext cx="1847850" cy="647700"/>
           </a:xfrm>
           <a:prstGeom xmlns:a="http://schemas.openxmlformats.org/drawingml/2006/main" prst="rect">
             <a:avLst/>
@@ -7412,7 +7412,7 @@
                 <a:ea typeface="Aptos"/>
                 <a:cs typeface="Aptos"/>
               </a:rPr>
-              <a:t>Stops with structured cycle completion data.</a:t>
+              <a:t>Stops only on an accepted close_cycle result.</a:t>
             </a:r>
           </a:p>
         </p:txBody>
@@ -7422,7 +7422,7 @@
           <p:cNvPr id="22" name="">
             <a:extLst xmlns:a="http://schemas.openxmlformats.org/drawingml/2006/main">
               <a:ext uri="{FF2B5EF4-FFF2-40B4-BE49-F238E27FC236}">
-                <a16:creationId xmlns:a16="http://schemas.microsoft.com/office/drawing/2014/main" id="{9E50F021-30E0-4D18-8198-5B6D6B32DBF8}"/>
+                <a16:creationId xmlns:a16="http://schemas.microsoft.com/office/drawing/2014/main" id="{AE1CFF33-26F6-4DE5-A7B2-258E0B435184}"/>
               </a:ext>
             </a:extLst>
           </p:cNvPr>
@@ -7455,7 +7455,7 @@
           <p:cNvPr id="23" name="">
             <a:extLst xmlns:a="http://schemas.openxmlformats.org/drawingml/2006/main">
               <a:ext uri="{FF2B5EF4-FFF2-40B4-BE49-F238E27FC236}">
-                <a16:creationId xmlns:a16="http://schemas.microsoft.com/office/drawing/2014/main" id="{ED143F88-A439-426C-84B1-83FFBDE6810D}"/>
+                <a16:creationId xmlns:a16="http://schemas.microsoft.com/office/drawing/2014/main" id="{E02C7C85-364A-4505-A39B-CC96B57CFABC}"/>
               </a:ext>
             </a:extLst>
           </p:cNvPr>
@@ -7519,7 +7519,7 @@
           <p:cNvPr id="24" name="">
             <a:extLst xmlns:a="http://schemas.openxmlformats.org/drawingml/2006/main">
               <a:ext uri="{FF2B5EF4-FFF2-40B4-BE49-F238E27FC236}">
-                <a16:creationId xmlns:a16="http://schemas.microsoft.com/office/drawing/2014/main" id="{A5793C74-4EBE-4456-99F9-4826E2AF1042}"/>
+                <a16:creationId xmlns:a16="http://schemas.microsoft.com/office/drawing/2014/main" id="{4075A442-034D-49F4-94DD-13CE916C61BE}"/>
               </a:ext>
             </a:extLst>
           </p:cNvPr>
@@ -7583,7 +7583,7 @@
           <p:cNvPr id="25" name="">
             <a:extLst xmlns:a="http://schemas.openxmlformats.org/drawingml/2006/main">
               <a:ext uri="{FF2B5EF4-FFF2-40B4-BE49-F238E27FC236}">
-                <a16:creationId xmlns:a16="http://schemas.microsoft.com/office/drawing/2014/main" id="{1716F992-D482-42F0-9BAF-2E5F21E0F61A}"/>
+                <a16:creationId xmlns:a16="http://schemas.microsoft.com/office/drawing/2014/main" id="{B2212A53-B74C-4F22-A304-C632A9DAD6F8}"/>
               </a:ext>
             </a:extLst>
           </p:cNvPr>
@@ -7647,7 +7647,7 @@
           <p:cNvPr id="26" name="">
             <a:extLst xmlns:a="http://schemas.openxmlformats.org/drawingml/2006/main">
               <a:ext uri="{FF2B5EF4-FFF2-40B4-BE49-F238E27FC236}">
-                <a16:creationId xmlns:a16="http://schemas.microsoft.com/office/drawing/2014/main" id="{DB2683FF-EC62-4AE1-BA67-AD7C4DAFC517}"/>
+                <a16:creationId xmlns:a16="http://schemas.microsoft.com/office/drawing/2014/main" id="{10B04277-EE1C-41D3-B5E0-03E9787EC7E0}"/>
               </a:ext>
             </a:extLst>
           </p:cNvPr>
@@ -7709,7 +7709,7 @@
     </p:spTree>
     <p:extLst>
       <p:ext uri="{BB962C8B-B14F-4D97-AF65-F5344CB8AC3E}">
-        <p14:creationId xmlns:p14="http://schemas.microsoft.com/office/powerpoint/2010/main" val="1776783206"/>
+        <p14:creationId xmlns:p14="http://schemas.microsoft.com/office/powerpoint/2010/main" val="451957049"/>
       </p:ext>
     </p:extLst>
   </p:cSld>
@@ -7733,7 +7733,7 @@
           <p:cNvPr id="1" name="">
             <a:extLst xmlns:a="http://schemas.openxmlformats.org/drawingml/2006/main">
               <a:ext uri="{FF2B5EF4-FFF2-40B4-BE49-F238E27FC236}">
-                <a16:creationId xmlns:a16="http://schemas.microsoft.com/office/drawing/2014/main" id="{3F32DFAE-A7D2-477C-BEFE-57A7A95B5684}"/>
+                <a16:creationId xmlns:a16="http://schemas.microsoft.com/office/drawing/2014/main" id="{A8F6A767-8711-4ECB-BCEC-A3307247EA42}"/>
               </a:ext>
             </a:extLst>
           </p:cNvPr>
@@ -7768,7 +7768,7 @@
           <p:cNvPr id="2" name="">
             <a:extLst xmlns:a="http://schemas.openxmlformats.org/drawingml/2006/main">
               <a:ext uri="{FF2B5EF4-FFF2-40B4-BE49-F238E27FC236}">
-                <a16:creationId xmlns:a16="http://schemas.microsoft.com/office/drawing/2014/main" id="{B11A8D82-20EB-416B-963E-0957DC7EF79E}"/>
+                <a16:creationId xmlns:a16="http://schemas.microsoft.com/office/drawing/2014/main" id="{19D6499F-605F-47DB-8A5B-0CAB8761C982}"/>
               </a:ext>
             </a:extLst>
           </p:cNvPr>
@@ -7803,7 +7803,7 @@
           <p:cNvPr id="3" name="">
             <a:extLst xmlns:a="http://schemas.openxmlformats.org/drawingml/2006/main">
               <a:ext uri="{FF2B5EF4-FFF2-40B4-BE49-F238E27FC236}">
-                <a16:creationId xmlns:a16="http://schemas.microsoft.com/office/drawing/2014/main" id="{CCF69561-0A31-4394-A0FB-427A32B1D939}"/>
+                <a16:creationId xmlns:a16="http://schemas.microsoft.com/office/drawing/2014/main" id="{DC69DEF2-0E09-40DD-AC9E-06383E42C2D4}"/>
               </a:ext>
             </a:extLst>
           </p:cNvPr>
@@ -7867,7 +7867,7 @@
           <p:cNvPr id="4" name="">
             <a:extLst xmlns:a="http://schemas.openxmlformats.org/drawingml/2006/main">
               <a:ext uri="{FF2B5EF4-FFF2-40B4-BE49-F238E27FC236}">
-                <a16:creationId xmlns:a16="http://schemas.microsoft.com/office/drawing/2014/main" id="{4C953482-0EF8-498E-86E3-5423E6BA7F39}"/>
+                <a16:creationId xmlns:a16="http://schemas.microsoft.com/office/drawing/2014/main" id="{4F75B6E5-30C2-4275-A2A3-4D0C37FD2009}"/>
               </a:ext>
             </a:extLst>
           </p:cNvPr>
@@ -7931,7 +7931,7 @@
           <p:cNvPr id="5" name="">
             <a:extLst xmlns:a="http://schemas.openxmlformats.org/drawingml/2006/main">
               <a:ext uri="{FF2B5EF4-FFF2-40B4-BE49-F238E27FC236}">
-                <a16:creationId xmlns:a16="http://schemas.microsoft.com/office/drawing/2014/main" id="{1BA15783-86BC-4C40-8EB3-FAF26B108B22}"/>
+                <a16:creationId xmlns:a16="http://schemas.microsoft.com/office/drawing/2014/main" id="{A688F5DF-E2A4-4447-B13A-2FB1922000D7}"/>
               </a:ext>
             </a:extLst>
           </p:cNvPr>
@@ -7995,7 +7995,7 @@
           <p:cNvPr id="6" name="">
             <a:extLst xmlns:a="http://schemas.openxmlformats.org/drawingml/2006/main">
               <a:ext uri="{FF2B5EF4-FFF2-40B4-BE49-F238E27FC236}">
-                <a16:creationId xmlns:a16="http://schemas.microsoft.com/office/drawing/2014/main" id="{0754DD3D-CF44-40A8-87CF-00D193F77F70}"/>
+                <a16:creationId xmlns:a16="http://schemas.microsoft.com/office/drawing/2014/main" id="{CBB7DF24-FD62-453A-8605-512A43165CDD}"/>
               </a:ext>
             </a:extLst>
           </p:cNvPr>
@@ -8059,7 +8059,7 @@
           <p:cNvPr id="7" name="">
             <a:extLst xmlns:a="http://schemas.openxmlformats.org/drawingml/2006/main">
               <a:ext uri="{FF2B5EF4-FFF2-40B4-BE49-F238E27FC236}">
-                <a16:creationId xmlns:a16="http://schemas.microsoft.com/office/drawing/2014/main" id="{79C16C96-994F-486D-86A3-C1E42079B599}"/>
+                <a16:creationId xmlns:a16="http://schemas.microsoft.com/office/drawing/2014/main" id="{583C8424-7653-48F0-AFF0-9E494EC52A25}"/>
               </a:ext>
             </a:extLst>
           </p:cNvPr>
@@ -8094,7 +8094,7 @@
           <p:cNvPr id="8" name="">
             <a:extLst xmlns:a="http://schemas.openxmlformats.org/drawingml/2006/main">
               <a:ext uri="{FF2B5EF4-FFF2-40B4-BE49-F238E27FC236}">
-                <a16:creationId xmlns:a16="http://schemas.microsoft.com/office/drawing/2014/main" id="{4CF66AF0-AFCA-4F5E-BCBD-3053DB064F63}"/>
+                <a16:creationId xmlns:a16="http://schemas.microsoft.com/office/drawing/2014/main" id="{948F4D01-059C-48F4-B891-798C333CFDEB}"/>
               </a:ext>
             </a:extLst>
           </p:cNvPr>
@@ -8158,7 +8158,7 @@
           <p:cNvPr id="9" name="">
             <a:extLst xmlns:a="http://schemas.openxmlformats.org/drawingml/2006/main">
               <a:ext uri="{FF2B5EF4-FFF2-40B4-BE49-F238E27FC236}">
-                <a16:creationId xmlns:a16="http://schemas.microsoft.com/office/drawing/2014/main" id="{D6A09458-539F-4186-9CB5-EC1C4A776036}"/>
+                <a16:creationId xmlns:a16="http://schemas.microsoft.com/office/drawing/2014/main" id="{D391CB9F-64AE-4273-868C-CDA90E3543B8}"/>
               </a:ext>
             </a:extLst>
           </p:cNvPr>
@@ -8212,7 +8212,7 @@
                 <a:ea typeface="Aptos"/>
                 <a:cs typeface="Aptos"/>
               </a:rPr>
-              <a:t>18</a:t>
+              <a:t>131</a:t>
             </a:r>
           </a:p>
         </p:txBody>
@@ -8222,7 +8222,7 @@
           <p:cNvPr id="10" name="">
             <a:extLst xmlns:a="http://schemas.openxmlformats.org/drawingml/2006/main">
               <a:ext uri="{FF2B5EF4-FFF2-40B4-BE49-F238E27FC236}">
-                <a16:creationId xmlns:a16="http://schemas.microsoft.com/office/drawing/2014/main" id="{CA518EDC-E4B2-4873-BDD6-8B3FF8F78EA0}"/>
+                <a16:creationId xmlns:a16="http://schemas.microsoft.com/office/drawing/2014/main" id="{F49DE55B-5CDB-4982-9F45-2749154E310C}"/>
               </a:ext>
             </a:extLst>
           </p:cNvPr>
@@ -8276,7 +8276,7 @@
                 <a:ea typeface="Aptos"/>
                 <a:cs typeface="Aptos"/>
               </a:rPr>
-              <a:t>sim/API/RLVR/forecast</a:t>
+              <a:t>sim/API/evidence/deploy</a:t>
             </a:r>
           </a:p>
         </p:txBody>
@@ -8286,7 +8286,7 @@
           <p:cNvPr id="11" name="">
             <a:extLst xmlns:a="http://schemas.openxmlformats.org/drawingml/2006/main">
               <a:ext uri="{FF2B5EF4-FFF2-40B4-BE49-F238E27FC236}">
-                <a16:creationId xmlns:a16="http://schemas.microsoft.com/office/drawing/2014/main" id="{2F70C199-161F-4221-94D0-2D1EA48D2CB0}"/>
+                <a16:creationId xmlns:a16="http://schemas.microsoft.com/office/drawing/2014/main" id="{DA035F68-74EC-4264-9CAE-14A23D1DAD38}"/>
               </a:ext>
             </a:extLst>
           </p:cNvPr>
@@ -8321,7 +8321,7 @@
           <p:cNvPr id="12" name="">
             <a:extLst xmlns:a="http://schemas.openxmlformats.org/drawingml/2006/main">
               <a:ext uri="{FF2B5EF4-FFF2-40B4-BE49-F238E27FC236}">
-                <a16:creationId xmlns:a16="http://schemas.microsoft.com/office/drawing/2014/main" id="{31F2D6A0-F800-4F68-AD25-4386ED4C7D1F}"/>
+                <a16:creationId xmlns:a16="http://schemas.microsoft.com/office/drawing/2014/main" id="{09BEBA3D-87AF-4B2C-8635-17788CB662BF}"/>
               </a:ext>
             </a:extLst>
           </p:cNvPr>
@@ -8385,7 +8385,7 @@
           <p:cNvPr id="13" name="">
             <a:extLst xmlns:a="http://schemas.openxmlformats.org/drawingml/2006/main">
               <a:ext uri="{FF2B5EF4-FFF2-40B4-BE49-F238E27FC236}">
-                <a16:creationId xmlns:a16="http://schemas.microsoft.com/office/drawing/2014/main" id="{330C38D9-58A4-431E-8D70-CF2863E03F1D}"/>
+                <a16:creationId xmlns:a16="http://schemas.microsoft.com/office/drawing/2014/main" id="{98127E37-7E8F-422B-9C48-FE95C2767D4C}"/>
               </a:ext>
             </a:extLst>
           </p:cNvPr>
@@ -8439,7 +8439,7 @@
                 <a:ea typeface="Aptos"/>
                 <a:cs typeface="Aptos"/>
               </a:rPr>
-              <a:t>44</a:t>
+              <a:t>75</a:t>
             </a:r>
           </a:p>
         </p:txBody>
@@ -8449,7 +8449,7 @@
           <p:cNvPr id="14" name="">
             <a:extLst xmlns:a="http://schemas.openxmlformats.org/drawingml/2006/main">
               <a:ext uri="{FF2B5EF4-FFF2-40B4-BE49-F238E27FC236}">
-                <a16:creationId xmlns:a16="http://schemas.microsoft.com/office/drawing/2014/main" id="{C4F09C0F-FDF6-461D-BDEF-F6F614F3ACEF}"/>
+                <a16:creationId xmlns:a16="http://schemas.microsoft.com/office/drawing/2014/main" id="{B5D27572-262F-4C36-9821-33C29816AAF0}"/>
               </a:ext>
             </a:extLst>
           </p:cNvPr>
@@ -8503,7 +8503,7 @@
                 <a:ea typeface="Aptos"/>
                 <a:cs typeface="Aptos"/>
               </a:rPr>
-              <a:t>dashboard + agent flows</a:t>
+              <a:t>Sagents + LiveView + HITL</a:t>
             </a:r>
           </a:p>
         </p:txBody>
@@ -8513,7 +8513,7 @@
           <p:cNvPr id="15" name="">
             <a:extLst xmlns:a="http://schemas.openxmlformats.org/drawingml/2006/main">
               <a:ext uri="{FF2B5EF4-FFF2-40B4-BE49-F238E27FC236}">
-                <a16:creationId xmlns:a16="http://schemas.microsoft.com/office/drawing/2014/main" id="{081CA2FA-7CC7-4423-83C8-A6651441743C}"/>
+                <a16:creationId xmlns:a16="http://schemas.microsoft.com/office/drawing/2014/main" id="{84236CDF-E3F1-425A-AC71-930AE1CB5932}"/>
               </a:ext>
             </a:extLst>
           </p:cNvPr>
@@ -8548,7 +8548,7 @@
           <p:cNvPr id="16" name="">
             <a:extLst xmlns:a="http://schemas.openxmlformats.org/drawingml/2006/main">
               <a:ext uri="{FF2B5EF4-FFF2-40B4-BE49-F238E27FC236}">
-                <a16:creationId xmlns:a16="http://schemas.microsoft.com/office/drawing/2014/main" id="{502AAA08-85D7-423D-A7BA-2305390EB3A8}"/>
+                <a16:creationId xmlns:a16="http://schemas.microsoft.com/office/drawing/2014/main" id="{940536B8-B1E8-41E5-AE6A-EB5969E5B712}"/>
               </a:ext>
             </a:extLst>
           </p:cNvPr>
@@ -8612,7 +8612,7 @@
           <p:cNvPr id="17" name="">
             <a:extLst xmlns:a="http://schemas.openxmlformats.org/drawingml/2006/main">
               <a:ext uri="{FF2B5EF4-FFF2-40B4-BE49-F238E27FC236}">
-                <a16:creationId xmlns:a16="http://schemas.microsoft.com/office/drawing/2014/main" id="{54D18051-16C7-47C1-A9C4-E3D0A94A63BE}"/>
+                <a16:creationId xmlns:a16="http://schemas.microsoft.com/office/drawing/2014/main" id="{643442FA-7C3D-46B8-A65F-EF3CD98A5309}"/>
               </a:ext>
             </a:extLst>
           </p:cNvPr>
@@ -8676,7 +8676,7 @@
           <p:cNvPr id="18" name="">
             <a:extLst xmlns:a="http://schemas.openxmlformats.org/drawingml/2006/main">
               <a:ext uri="{FF2B5EF4-FFF2-40B4-BE49-F238E27FC236}">
-                <a16:creationId xmlns:a16="http://schemas.microsoft.com/office/drawing/2014/main" id="{2DF28BDD-C719-4466-A8C7-0EE1420BF8F2}"/>
+                <a16:creationId xmlns:a16="http://schemas.microsoft.com/office/drawing/2014/main" id="{810A17E6-5357-4BB5-A7F2-CEC8ABFBA18E}"/>
               </a:ext>
             </a:extLst>
           </p:cNvPr>
@@ -8740,7 +8740,7 @@
           <p:cNvPr id="19" name="">
             <a:extLst xmlns:a="http://schemas.openxmlformats.org/drawingml/2006/main">
               <a:ext uri="{FF2B5EF4-FFF2-40B4-BE49-F238E27FC236}">
-                <a16:creationId xmlns:a16="http://schemas.microsoft.com/office/drawing/2014/main" id="{CD8389A0-51C5-4BBA-AD8C-B66BE5B5AC77}"/>
+                <a16:creationId xmlns:a16="http://schemas.microsoft.com/office/drawing/2014/main" id="{00C7B2F9-99D5-4CA8-A513-FB49C273C634}"/>
               </a:ext>
             </a:extLst>
           </p:cNvPr>
@@ -8775,7 +8775,7 @@
           <p:cNvPr id="20" name="">
             <a:extLst xmlns:a="http://schemas.openxmlformats.org/drawingml/2006/main">
               <a:ext uri="{FF2B5EF4-FFF2-40B4-BE49-F238E27FC236}">
-                <a16:creationId xmlns:a16="http://schemas.microsoft.com/office/drawing/2014/main" id="{C237825B-F6A2-4C68-A089-51D2128595F0}"/>
+                <a16:creationId xmlns:a16="http://schemas.microsoft.com/office/drawing/2014/main" id="{22EE9B66-43DF-45BD-97D1-A8A2C6394C87}"/>
               </a:ext>
             </a:extLst>
           </p:cNvPr>
@@ -8839,7 +8839,7 @@
           <p:cNvPr id="21" name="">
             <a:extLst xmlns:a="http://schemas.openxmlformats.org/drawingml/2006/main">
               <a:ext uri="{FF2B5EF4-FFF2-40B4-BE49-F238E27FC236}">
-                <a16:creationId xmlns:a16="http://schemas.microsoft.com/office/drawing/2014/main" id="{64F73EED-F56C-498E-A790-54E04E869ED7}"/>
+                <a16:creationId xmlns:a16="http://schemas.microsoft.com/office/drawing/2014/main" id="{9C2979B8-EEB6-4A10-8F61-6766CA86D5FC}"/>
               </a:ext>
             </a:extLst>
           </p:cNvPr>
@@ -8903,7 +8903,7 @@
           <p:cNvPr id="22" name="">
             <a:extLst xmlns:a="http://schemas.openxmlformats.org/drawingml/2006/main">
               <a:ext uri="{FF2B5EF4-FFF2-40B4-BE49-F238E27FC236}">
-                <a16:creationId xmlns:a16="http://schemas.microsoft.com/office/drawing/2014/main" id="{CE8154AE-5892-42E2-BAB9-1B25BF998396}"/>
+                <a16:creationId xmlns:a16="http://schemas.microsoft.com/office/drawing/2014/main" id="{20184F56-97E4-414D-8FD3-53CE6484844F}"/>
               </a:ext>
             </a:extLst>
           </p:cNvPr>
@@ -8967,7 +8967,7 @@
           <p:cNvPr id="23" name="">
             <a:extLst xmlns:a="http://schemas.openxmlformats.org/drawingml/2006/main">
               <a:ext uri="{FF2B5EF4-FFF2-40B4-BE49-F238E27FC236}">
-                <a16:creationId xmlns:a16="http://schemas.microsoft.com/office/drawing/2014/main" id="{24D3F26A-89DA-4583-A2F5-21810F5C3107}"/>
+                <a16:creationId xmlns:a16="http://schemas.microsoft.com/office/drawing/2014/main" id="{FF20E23B-1949-4C41-9474-DF74A716EEC6}"/>
               </a:ext>
             </a:extLst>
           </p:cNvPr>
@@ -9000,7 +9000,7 @@
           <p:cNvPr id="24" name="">
             <a:extLst xmlns:a="http://schemas.openxmlformats.org/drawingml/2006/main">
               <a:ext uri="{FF2B5EF4-FFF2-40B4-BE49-F238E27FC236}">
-                <a16:creationId xmlns:a16="http://schemas.microsoft.com/office/drawing/2014/main" id="{2EB4A0E7-ED6C-492F-9D98-4C3EE1265F51}"/>
+                <a16:creationId xmlns:a16="http://schemas.microsoft.com/office/drawing/2014/main" id="{C1B547EC-F023-469F-A768-04C5E31AC274}"/>
               </a:ext>
             </a:extLst>
           </p:cNvPr>
@@ -9064,7 +9064,7 @@
           <p:cNvPr id="25" name="">
             <a:extLst xmlns:a="http://schemas.openxmlformats.org/drawingml/2006/main">
               <a:ext uri="{FF2B5EF4-FFF2-40B4-BE49-F238E27FC236}">
-                <a16:creationId xmlns:a16="http://schemas.microsoft.com/office/drawing/2014/main" id="{AA3E046B-54C3-4A4A-A25A-4243A7C7EAE6}"/>
+                <a16:creationId xmlns:a16="http://schemas.microsoft.com/office/drawing/2014/main" id="{C29C4285-6029-4C80-8554-D7787175BC3A}"/>
               </a:ext>
             </a:extLst>
           </p:cNvPr>
@@ -9118,7 +9118,7 @@
                 <a:ea typeface="Aptos"/>
                 <a:cs typeface="Aptos"/>
               </a:rPr>
-              <a:t>Run demo cascade -&gt; inspect trace timeline -&gt; view RLVR reward verifier -&gt; run verified loop.</a:t>
+              <a:t>Run demo cascade -&gt; inspect RLVR evidence -&gt; run four real Sagents/Gemma agents -&gt; verify close_cycle.</a:t>
             </a:r>
           </a:p>
         </p:txBody>
@@ -9128,7 +9128,7 @@
           <p:cNvPr id="26" name="">
             <a:extLst xmlns:a="http://schemas.openxmlformats.org/drawingml/2006/main">
               <a:ext uri="{FF2B5EF4-FFF2-40B4-BE49-F238E27FC236}">
-                <a16:creationId xmlns:a16="http://schemas.microsoft.com/office/drawing/2014/main" id="{D3E47CD5-ACD1-4A4D-A32C-5597CD67D1E4}"/>
+                <a16:creationId xmlns:a16="http://schemas.microsoft.com/office/drawing/2014/main" id="{90A3353C-89C9-46B9-83BB-792DECF0F689}"/>
               </a:ext>
             </a:extLst>
           </p:cNvPr>
@@ -9192,7 +9192,7 @@
           <p:cNvPr id="27" name="">
             <a:extLst xmlns:a="http://schemas.openxmlformats.org/drawingml/2006/main">
               <a:ext uri="{FF2B5EF4-FFF2-40B4-BE49-F238E27FC236}">
-                <a16:creationId xmlns:a16="http://schemas.microsoft.com/office/drawing/2014/main" id="{ADBA03C6-8177-48CF-9377-811F93D05D96}"/>
+                <a16:creationId xmlns:a16="http://schemas.microsoft.com/office/drawing/2014/main" id="{96880364-4BE1-46AF-BEA4-EA4143B1B39B}"/>
               </a:ext>
             </a:extLst>
           </p:cNvPr>
@@ -9254,7 +9254,7 @@
     </p:spTree>
     <p:extLst>
       <p:ext uri="{BB962C8B-B14F-4D97-AF65-F5344CB8AC3E}">
-        <p14:creationId xmlns:p14="http://schemas.microsoft.com/office/powerpoint/2010/main" val="531625498"/>
+        <p14:creationId xmlns:p14="http://schemas.microsoft.com/office/powerpoint/2010/main" val="1716266816"/>
       </p:ext>
     </p:extLst>
   </p:cSld>
@@ -9278,7 +9278,7 @@
           <p:cNvPr id="1" name="">
             <a:extLst xmlns:a="http://schemas.openxmlformats.org/drawingml/2006/main">
               <a:ext uri="{FF2B5EF4-FFF2-40B4-BE49-F238E27FC236}">
-                <a16:creationId xmlns:a16="http://schemas.microsoft.com/office/drawing/2014/main" id="{0071CEED-E9A8-4D7D-AAFB-A1057BB07F54}"/>
+                <a16:creationId xmlns:a16="http://schemas.microsoft.com/office/drawing/2014/main" id="{975CFCA0-9E84-4311-A1EA-2C4D64102D43}"/>
               </a:ext>
             </a:extLst>
           </p:cNvPr>
@@ -9313,7 +9313,7 @@
           <p:cNvPr id="2" name="">
             <a:extLst xmlns:a="http://schemas.openxmlformats.org/drawingml/2006/main">
               <a:ext uri="{FF2B5EF4-FFF2-40B4-BE49-F238E27FC236}">
-                <a16:creationId xmlns:a16="http://schemas.microsoft.com/office/drawing/2014/main" id="{F5C46EE4-E7FB-4059-B301-986F31483A23}"/>
+                <a16:creationId xmlns:a16="http://schemas.microsoft.com/office/drawing/2014/main" id="{9A9FAF44-C478-4B2B-8AF9-66497FCC670F}"/>
               </a:ext>
             </a:extLst>
           </p:cNvPr>
@@ -9348,7 +9348,7 @@
           <p:cNvPr id="3" name="">
             <a:extLst xmlns:a="http://schemas.openxmlformats.org/drawingml/2006/main">
               <a:ext uri="{FF2B5EF4-FFF2-40B4-BE49-F238E27FC236}">
-                <a16:creationId xmlns:a16="http://schemas.microsoft.com/office/drawing/2014/main" id="{DA5CF5D4-FF1D-4155-8DDC-CDA57A11F24C}"/>
+                <a16:creationId xmlns:a16="http://schemas.microsoft.com/office/drawing/2014/main" id="{5F347DF0-C842-4C1A-9599-2BE7C172E4D9}"/>
               </a:ext>
             </a:extLst>
           </p:cNvPr>
@@ -9412,7 +9412,7 @@
           <p:cNvPr id="4" name="">
             <a:extLst xmlns:a="http://schemas.openxmlformats.org/drawingml/2006/main">
               <a:ext uri="{FF2B5EF4-FFF2-40B4-BE49-F238E27FC236}">
-                <a16:creationId xmlns:a16="http://schemas.microsoft.com/office/drawing/2014/main" id="{8B07E8FB-AFB9-4820-8108-E0C4190AB90F}"/>
+                <a16:creationId xmlns:a16="http://schemas.microsoft.com/office/drawing/2014/main" id="{C2545BFB-106B-40BB-A519-44C21D98611B}"/>
               </a:ext>
             </a:extLst>
           </p:cNvPr>
@@ -9476,7 +9476,7 @@
           <p:cNvPr id="5" name="">
             <a:extLst xmlns:a="http://schemas.openxmlformats.org/drawingml/2006/main">
               <a:ext uri="{FF2B5EF4-FFF2-40B4-BE49-F238E27FC236}">
-                <a16:creationId xmlns:a16="http://schemas.microsoft.com/office/drawing/2014/main" id="{4AE6FA86-1E22-4AD8-BA0A-4687B108E0C0}"/>
+                <a16:creationId xmlns:a16="http://schemas.microsoft.com/office/drawing/2014/main" id="{BE5C23FA-E9CD-440B-96C0-89A79E942A2C}"/>
               </a:ext>
             </a:extLst>
           </p:cNvPr>
@@ -9540,7 +9540,7 @@
           <p:cNvPr id="6" name="">
             <a:extLst xmlns:a="http://schemas.openxmlformats.org/drawingml/2006/main">
               <a:ext uri="{FF2B5EF4-FFF2-40B4-BE49-F238E27FC236}">
-                <a16:creationId xmlns:a16="http://schemas.microsoft.com/office/drawing/2014/main" id="{7AA3B141-BE81-4A4B-B9CB-8FC78BD881B6}"/>
+                <a16:creationId xmlns:a16="http://schemas.microsoft.com/office/drawing/2014/main" id="{300C345A-E59E-4010-9271-D9B6C99D5C00}"/>
               </a:ext>
             </a:extLst>
           </p:cNvPr>
@@ -9604,7 +9604,7 @@
           <p:cNvPr id="7" name="">
             <a:extLst xmlns:a="http://schemas.openxmlformats.org/drawingml/2006/main">
               <a:ext uri="{FF2B5EF4-FFF2-40B4-BE49-F238E27FC236}">
-                <a16:creationId xmlns:a16="http://schemas.microsoft.com/office/drawing/2014/main" id="{A69B8699-F6D9-4242-B0DD-597F6782C49D}"/>
+                <a16:creationId xmlns:a16="http://schemas.microsoft.com/office/drawing/2014/main" id="{4CA4EA53-97E2-43DE-8A53-37319502E7EE}"/>
               </a:ext>
             </a:extLst>
           </p:cNvPr>
@@ -9637,7 +9637,7 @@
           <p:cNvPr id="8" name="">
             <a:extLst xmlns:a="http://schemas.openxmlformats.org/drawingml/2006/main">
               <a:ext uri="{FF2B5EF4-FFF2-40B4-BE49-F238E27FC236}">
-                <a16:creationId xmlns:a16="http://schemas.microsoft.com/office/drawing/2014/main" id="{548CFB29-EA7B-4B4A-BA22-64E5A1DFDC14}"/>
+                <a16:creationId xmlns:a16="http://schemas.microsoft.com/office/drawing/2014/main" id="{41A8247F-2D69-423D-8324-2F84113A63A8}"/>
               </a:ext>
             </a:extLst>
           </p:cNvPr>
@@ -9701,7 +9701,7 @@
           <p:cNvPr id="9" name="">
             <a:extLst xmlns:a="http://schemas.openxmlformats.org/drawingml/2006/main">
               <a:ext uri="{FF2B5EF4-FFF2-40B4-BE49-F238E27FC236}">
-                <a16:creationId xmlns:a16="http://schemas.microsoft.com/office/drawing/2014/main" id="{A182B9CD-714E-4F6B-8E36-9ADAAD0C1E47}"/>
+                <a16:creationId xmlns:a16="http://schemas.microsoft.com/office/drawing/2014/main" id="{086ECE59-D559-422E-9694-782450783171}"/>
               </a:ext>
             </a:extLst>
           </p:cNvPr>
@@ -9765,7 +9765,7 @@
           <p:cNvPr id="10" name="">
             <a:extLst xmlns:a="http://schemas.openxmlformats.org/drawingml/2006/main">
               <a:ext uri="{FF2B5EF4-FFF2-40B4-BE49-F238E27FC236}">
-                <a16:creationId xmlns:a16="http://schemas.microsoft.com/office/drawing/2014/main" id="{3E4AE6A6-FE6D-4610-8004-62FF1B106C37}"/>
+                <a16:creationId xmlns:a16="http://schemas.microsoft.com/office/drawing/2014/main" id="{FE7FD4E7-1457-4920-AE98-2FFFAEB98FBB}"/>
               </a:ext>
             </a:extLst>
           </p:cNvPr>
@@ -9798,7 +9798,7 @@
           <p:cNvPr id="11" name="">
             <a:extLst xmlns:a="http://schemas.openxmlformats.org/drawingml/2006/main">
               <a:ext uri="{FF2B5EF4-FFF2-40B4-BE49-F238E27FC236}">
-                <a16:creationId xmlns:a16="http://schemas.microsoft.com/office/drawing/2014/main" id="{EF467900-5E18-4C3C-9CB7-AB8A166EB0A0}"/>
+                <a16:creationId xmlns:a16="http://schemas.microsoft.com/office/drawing/2014/main" id="{43910DBA-EB00-4AB1-81C1-B7732E9D371E}"/>
               </a:ext>
             </a:extLst>
           </p:cNvPr>
@@ -9862,7 +9862,7 @@
           <p:cNvPr id="12" name="">
             <a:extLst xmlns:a="http://schemas.openxmlformats.org/drawingml/2006/main">
               <a:ext uri="{FF2B5EF4-FFF2-40B4-BE49-F238E27FC236}">
-                <a16:creationId xmlns:a16="http://schemas.microsoft.com/office/drawing/2014/main" id="{EDE722E0-9616-4215-86D3-7CE421588629}"/>
+                <a16:creationId xmlns:a16="http://schemas.microsoft.com/office/drawing/2014/main" id="{27857BF5-BB8D-4E68-AF7F-C453F9FCAB3C}"/>
               </a:ext>
             </a:extLst>
           </p:cNvPr>
@@ -9926,7 +9926,7 @@
           <p:cNvPr id="13" name="">
             <a:extLst xmlns:a="http://schemas.openxmlformats.org/drawingml/2006/main">
               <a:ext uri="{FF2B5EF4-FFF2-40B4-BE49-F238E27FC236}">
-                <a16:creationId xmlns:a16="http://schemas.microsoft.com/office/drawing/2014/main" id="{2DCF7FEF-DDAD-405F-B7F5-D03B9596CD85}"/>
+                <a16:creationId xmlns:a16="http://schemas.microsoft.com/office/drawing/2014/main" id="{1E0138BC-66F9-4503-887D-81D5D6A4A397}"/>
               </a:ext>
             </a:extLst>
           </p:cNvPr>
@@ -9959,7 +9959,7 @@
           <p:cNvPr id="14" name="">
             <a:extLst xmlns:a="http://schemas.openxmlformats.org/drawingml/2006/main">
               <a:ext uri="{FF2B5EF4-FFF2-40B4-BE49-F238E27FC236}">
-                <a16:creationId xmlns:a16="http://schemas.microsoft.com/office/drawing/2014/main" id="{1DF5CE12-EAE4-400E-8BD0-4FE9BF0E22DB}"/>
+                <a16:creationId xmlns:a16="http://schemas.microsoft.com/office/drawing/2014/main" id="{F72340A8-17B5-4E70-9A6C-0B90FD7711BE}"/>
               </a:ext>
             </a:extLst>
           </p:cNvPr>
@@ -10023,7 +10023,7 @@
           <p:cNvPr id="15" name="">
             <a:extLst xmlns:a="http://schemas.openxmlformats.org/drawingml/2006/main">
               <a:ext uri="{FF2B5EF4-FFF2-40B4-BE49-F238E27FC236}">
-                <a16:creationId xmlns:a16="http://schemas.microsoft.com/office/drawing/2014/main" id="{F000A8C0-11E6-4027-9572-646CEC59CD31}"/>
+                <a16:creationId xmlns:a16="http://schemas.microsoft.com/office/drawing/2014/main" id="{6A23BC01-2C5E-4A72-B23B-698F42E49506}"/>
               </a:ext>
             </a:extLst>
           </p:cNvPr>
@@ -10087,7 +10087,7 @@
           <p:cNvPr id="16" name="">
             <a:extLst xmlns:a="http://schemas.openxmlformats.org/drawingml/2006/main">
               <a:ext uri="{FF2B5EF4-FFF2-40B4-BE49-F238E27FC236}">
-                <a16:creationId xmlns:a16="http://schemas.microsoft.com/office/drawing/2014/main" id="{7E1D9E05-3A90-4E71-BDF8-1884B61DA02A}"/>
+                <a16:creationId xmlns:a16="http://schemas.microsoft.com/office/drawing/2014/main" id="{C7DF3F11-B670-466B-8F33-69734446A921}"/>
               </a:ext>
             </a:extLst>
           </p:cNvPr>
@@ -10151,7 +10151,7 @@
           <p:cNvPr id="17" name="">
             <a:extLst xmlns:a="http://schemas.openxmlformats.org/drawingml/2006/main">
               <a:ext uri="{FF2B5EF4-FFF2-40B4-BE49-F238E27FC236}">
-                <a16:creationId xmlns:a16="http://schemas.microsoft.com/office/drawing/2014/main" id="{155FE92B-39B8-4C44-985F-ABF8F7E9CB3D}"/>
+                <a16:creationId xmlns:a16="http://schemas.microsoft.com/office/drawing/2014/main" id="{501CE341-BF0E-4C69-9AD9-252CDE006033}"/>
               </a:ext>
             </a:extLst>
           </p:cNvPr>
@@ -10213,7 +10213,7 @@
     </p:spTree>
     <p:extLst>
       <p:ext uri="{BB962C8B-B14F-4D97-AF65-F5344CB8AC3E}">
-        <p14:creationId xmlns:p14="http://schemas.microsoft.com/office/powerpoint/2010/main" val="201864692"/>
+        <p14:creationId xmlns:p14="http://schemas.microsoft.com/office/powerpoint/2010/main" val="1162429555"/>
       </p:ext>
     </p:extLst>
   </p:cSld>
@@ -10237,7 +10237,7 @@
           <p:cNvPr id="1" name="">
             <a:extLst xmlns:a="http://schemas.openxmlformats.org/drawingml/2006/main">
               <a:ext uri="{FF2B5EF4-FFF2-40B4-BE49-F238E27FC236}">
-                <a16:creationId xmlns:a16="http://schemas.microsoft.com/office/drawing/2014/main" id="{1DB41680-A3D4-4904-8A4E-C59E4821D324}"/>
+                <a16:creationId xmlns:a16="http://schemas.microsoft.com/office/drawing/2014/main" id="{12734C82-BA57-4A92-9570-1B93E8A59E63}"/>
               </a:ext>
             </a:extLst>
           </p:cNvPr>
@@ -10272,7 +10272,7 @@
           <p:cNvPr id="2" name="">
             <a:extLst xmlns:a="http://schemas.openxmlformats.org/drawingml/2006/main">
               <a:ext uri="{FF2B5EF4-FFF2-40B4-BE49-F238E27FC236}">
-                <a16:creationId xmlns:a16="http://schemas.microsoft.com/office/drawing/2014/main" id="{9EC44BC8-B756-4F30-B638-7651C8DB5789}"/>
+                <a16:creationId xmlns:a16="http://schemas.microsoft.com/office/drawing/2014/main" id="{211E2A9D-049B-4D78-8964-843BF51E4DD1}"/>
               </a:ext>
             </a:extLst>
           </p:cNvPr>
@@ -10307,7 +10307,7 @@
           <p:cNvPr id="3" name="">
             <a:extLst xmlns:a="http://schemas.openxmlformats.org/drawingml/2006/main">
               <a:ext uri="{FF2B5EF4-FFF2-40B4-BE49-F238E27FC236}">
-                <a16:creationId xmlns:a16="http://schemas.microsoft.com/office/drawing/2014/main" id="{F0879AD2-28DB-4B2B-8B37-78CA40BBCA1C}"/>
+                <a16:creationId xmlns:a16="http://schemas.microsoft.com/office/drawing/2014/main" id="{9B80D1F3-4155-4F98-A71D-90FBCC888A7D}"/>
               </a:ext>
             </a:extLst>
           </p:cNvPr>
@@ -10371,7 +10371,7 @@
           <p:cNvPr id="4" name="">
             <a:extLst xmlns:a="http://schemas.openxmlformats.org/drawingml/2006/main">
               <a:ext uri="{FF2B5EF4-FFF2-40B4-BE49-F238E27FC236}">
-                <a16:creationId xmlns:a16="http://schemas.microsoft.com/office/drawing/2014/main" id="{215A4769-6500-4502-865D-D6123A5035DD}"/>
+                <a16:creationId xmlns:a16="http://schemas.microsoft.com/office/drawing/2014/main" id="{7B1A90BF-1A91-4663-90DA-1B1A4975B9FA}"/>
               </a:ext>
             </a:extLst>
           </p:cNvPr>
@@ -10435,7 +10435,7 @@
           <p:cNvPr id="5" name="">
             <a:extLst xmlns:a="http://schemas.openxmlformats.org/drawingml/2006/main">
               <a:ext uri="{FF2B5EF4-FFF2-40B4-BE49-F238E27FC236}">
-                <a16:creationId xmlns:a16="http://schemas.microsoft.com/office/drawing/2014/main" id="{C389DD3A-FFD6-4A8F-9027-95C9295302CD}"/>
+                <a16:creationId xmlns:a16="http://schemas.microsoft.com/office/drawing/2014/main" id="{2A819E19-C301-4D95-BCCA-3509308EC9BC}"/>
               </a:ext>
             </a:extLst>
           </p:cNvPr>
@@ -10499,7 +10499,7 @@
           <p:cNvPr id="6" name="">
             <a:extLst xmlns:a="http://schemas.openxmlformats.org/drawingml/2006/main">
               <a:ext uri="{FF2B5EF4-FFF2-40B4-BE49-F238E27FC236}">
-                <a16:creationId xmlns:a16="http://schemas.microsoft.com/office/drawing/2014/main" id="{7DAB378C-49E5-4B53-A1E1-45CE4D5F1455}"/>
+                <a16:creationId xmlns:a16="http://schemas.microsoft.com/office/drawing/2014/main" id="{6438445E-F385-44A2-8909-D1C1B1E3D871}"/>
               </a:ext>
             </a:extLst>
           </p:cNvPr>
@@ -10563,7 +10563,7 @@
           <p:cNvPr id="7" name="">
             <a:extLst xmlns:a="http://schemas.openxmlformats.org/drawingml/2006/main">
               <a:ext uri="{FF2B5EF4-FFF2-40B4-BE49-F238E27FC236}">
-                <a16:creationId xmlns:a16="http://schemas.microsoft.com/office/drawing/2014/main" id="{9B1773D9-EAF2-4B9C-9B94-87814D02241E}"/>
+                <a16:creationId xmlns:a16="http://schemas.microsoft.com/office/drawing/2014/main" id="{A478E31F-2E9C-43A6-84E6-F8175DF1A9DD}"/>
               </a:ext>
             </a:extLst>
           </p:cNvPr>
@@ -10596,7 +10596,7 @@
           <p:cNvPr id="8" name="">
             <a:extLst xmlns:a="http://schemas.openxmlformats.org/drawingml/2006/main">
               <a:ext uri="{FF2B5EF4-FFF2-40B4-BE49-F238E27FC236}">
-                <a16:creationId xmlns:a16="http://schemas.microsoft.com/office/drawing/2014/main" id="{64683B93-F862-4AEB-A09C-C50C0CC50CDD}"/>
+                <a16:creationId xmlns:a16="http://schemas.microsoft.com/office/drawing/2014/main" id="{E1845A25-9B70-4F0C-AB71-DC22A3D68864}"/>
               </a:ext>
             </a:extLst>
           </p:cNvPr>
@@ -10660,7 +10660,7 @@
           <p:cNvPr id="9" name="">
             <a:extLst xmlns:a="http://schemas.openxmlformats.org/drawingml/2006/main">
               <a:ext uri="{FF2B5EF4-FFF2-40B4-BE49-F238E27FC236}">
-                <a16:creationId xmlns:a16="http://schemas.microsoft.com/office/drawing/2014/main" id="{DD4B12D7-6766-4042-8239-B9DB922B43D7}"/>
+                <a16:creationId xmlns:a16="http://schemas.microsoft.com/office/drawing/2014/main" id="{1544BDAD-52D6-4E9E-A479-23A66834C229}"/>
               </a:ext>
             </a:extLst>
           </p:cNvPr>
@@ -10724,7 +10724,7 @@
           <p:cNvPr id="10" name="">
             <a:extLst xmlns:a="http://schemas.openxmlformats.org/drawingml/2006/main">
               <a:ext uri="{FF2B5EF4-FFF2-40B4-BE49-F238E27FC236}">
-                <a16:creationId xmlns:a16="http://schemas.microsoft.com/office/drawing/2014/main" id="{039A2D60-88E3-4875-9F72-B5A4E1A5DE7A}"/>
+                <a16:creationId xmlns:a16="http://schemas.microsoft.com/office/drawing/2014/main" id="{DE1A7792-3F5C-4949-9B79-CC26D53E04A0}"/>
               </a:ext>
             </a:extLst>
           </p:cNvPr>
@@ -10788,7 +10788,7 @@
           <p:cNvPr id="11" name="">
             <a:extLst xmlns:a="http://schemas.openxmlformats.org/drawingml/2006/main">
               <a:ext uri="{FF2B5EF4-FFF2-40B4-BE49-F238E27FC236}">
-                <a16:creationId xmlns:a16="http://schemas.microsoft.com/office/drawing/2014/main" id="{36781547-E8AA-4227-A8D1-B272F4492B9C}"/>
+                <a16:creationId xmlns:a16="http://schemas.microsoft.com/office/drawing/2014/main" id="{5DEB1789-373B-4849-9CDE-5AB28382B8D8}"/>
               </a:ext>
             </a:extLst>
           </p:cNvPr>
@@ -10821,7 +10821,7 @@
           <p:cNvPr id="12" name="">
             <a:extLst xmlns:a="http://schemas.openxmlformats.org/drawingml/2006/main">
               <a:ext uri="{FF2B5EF4-FFF2-40B4-BE49-F238E27FC236}">
-                <a16:creationId xmlns:a16="http://schemas.microsoft.com/office/drawing/2014/main" id="{7030206E-7F99-4F23-94F2-7507D137C543}"/>
+                <a16:creationId xmlns:a16="http://schemas.microsoft.com/office/drawing/2014/main" id="{935A1360-DDD3-45CE-A8C6-D9DE06D6042F}"/>
               </a:ext>
             </a:extLst>
           </p:cNvPr>
@@ -10885,7 +10885,7 @@
           <p:cNvPr id="13" name="">
             <a:extLst xmlns:a="http://schemas.openxmlformats.org/drawingml/2006/main">
               <a:ext uri="{FF2B5EF4-FFF2-40B4-BE49-F238E27FC236}">
-                <a16:creationId xmlns:a16="http://schemas.microsoft.com/office/drawing/2014/main" id="{7A9E0256-6049-4BB1-AB6A-5F57FE9FAFBA}"/>
+                <a16:creationId xmlns:a16="http://schemas.microsoft.com/office/drawing/2014/main" id="{DC0D994A-66D5-4599-BB17-3A856B3AA16D}"/>
               </a:ext>
             </a:extLst>
           </p:cNvPr>
@@ -10949,7 +10949,7 @@
           <p:cNvPr id="14" name="">
             <a:extLst xmlns:a="http://schemas.openxmlformats.org/drawingml/2006/main">
               <a:ext uri="{FF2B5EF4-FFF2-40B4-BE49-F238E27FC236}">
-                <a16:creationId xmlns:a16="http://schemas.microsoft.com/office/drawing/2014/main" id="{8E735663-61A1-437F-812E-4467EE2C5A45}"/>
+                <a16:creationId xmlns:a16="http://schemas.microsoft.com/office/drawing/2014/main" id="{201A01DF-A93B-412E-95B0-4028E367BDCB}"/>
               </a:ext>
             </a:extLst>
           </p:cNvPr>
@@ -11013,7 +11013,7 @@
           <p:cNvPr id="15" name="">
             <a:extLst xmlns:a="http://schemas.openxmlformats.org/drawingml/2006/main">
               <a:ext uri="{FF2B5EF4-FFF2-40B4-BE49-F238E27FC236}">
-                <a16:creationId xmlns:a16="http://schemas.microsoft.com/office/drawing/2014/main" id="{1BC30F6A-4A2C-4401-ABC4-2768F295FED8}"/>
+                <a16:creationId xmlns:a16="http://schemas.microsoft.com/office/drawing/2014/main" id="{5BAC612B-6837-4EFF-946E-AC7A6998C35E}"/>
               </a:ext>
             </a:extLst>
           </p:cNvPr>
@@ -11046,7 +11046,7 @@
           <p:cNvPr id="16" name="">
             <a:extLst xmlns:a="http://schemas.openxmlformats.org/drawingml/2006/main">
               <a:ext uri="{FF2B5EF4-FFF2-40B4-BE49-F238E27FC236}">
-                <a16:creationId xmlns:a16="http://schemas.microsoft.com/office/drawing/2014/main" id="{1088A188-7EC7-4CAB-A072-1A1EA7EB2520}"/>
+                <a16:creationId xmlns:a16="http://schemas.microsoft.com/office/drawing/2014/main" id="{BCD1EEE7-9389-421A-9F7F-9C596495776B}"/>
               </a:ext>
             </a:extLst>
           </p:cNvPr>
@@ -11110,7 +11110,7 @@
           <p:cNvPr id="17" name="">
             <a:extLst xmlns:a="http://schemas.openxmlformats.org/drawingml/2006/main">
               <a:ext uri="{FF2B5EF4-FFF2-40B4-BE49-F238E27FC236}">
-                <a16:creationId xmlns:a16="http://schemas.microsoft.com/office/drawing/2014/main" id="{5D137540-CACC-465C-A073-0304D3483B77}"/>
+                <a16:creationId xmlns:a16="http://schemas.microsoft.com/office/drawing/2014/main" id="{3F7C49D4-0FA9-42A9-A121-582755FE8F0B}"/>
               </a:ext>
             </a:extLst>
           </p:cNvPr>
@@ -11174,7 +11174,7 @@
           <p:cNvPr id="18" name="">
             <a:extLst xmlns:a="http://schemas.openxmlformats.org/drawingml/2006/main">
               <a:ext uri="{FF2B5EF4-FFF2-40B4-BE49-F238E27FC236}">
-                <a16:creationId xmlns:a16="http://schemas.microsoft.com/office/drawing/2014/main" id="{239FC885-81B0-4773-9936-C7792220BBA0}"/>
+                <a16:creationId xmlns:a16="http://schemas.microsoft.com/office/drawing/2014/main" id="{F155EC94-3DC4-4B67-ADDA-EA4797417D40}"/>
               </a:ext>
             </a:extLst>
           </p:cNvPr>
@@ -11207,7 +11207,7 @@
           <p:cNvPr id="19" name="">
             <a:extLst xmlns:a="http://schemas.openxmlformats.org/drawingml/2006/main">
               <a:ext uri="{FF2B5EF4-FFF2-40B4-BE49-F238E27FC236}">
-                <a16:creationId xmlns:a16="http://schemas.microsoft.com/office/drawing/2014/main" id="{F23AECA5-3962-444B-BA5D-D78FD489924F}"/>
+                <a16:creationId xmlns:a16="http://schemas.microsoft.com/office/drawing/2014/main" id="{5A6AC410-6F8F-4EFD-87F1-A16E01208498}"/>
               </a:ext>
             </a:extLst>
           </p:cNvPr>
@@ -11271,7 +11271,7 @@
           <p:cNvPr id="20" name="">
             <a:extLst xmlns:a="http://schemas.openxmlformats.org/drawingml/2006/main">
               <a:ext uri="{FF2B5EF4-FFF2-40B4-BE49-F238E27FC236}">
-                <a16:creationId xmlns:a16="http://schemas.microsoft.com/office/drawing/2014/main" id="{6E41A625-9AE1-4B2C-99AE-E927A3C09D9F}"/>
+                <a16:creationId xmlns:a16="http://schemas.microsoft.com/office/drawing/2014/main" id="{36BA5A64-1CE8-4945-972B-8FDA632B7140}"/>
               </a:ext>
             </a:extLst>
           </p:cNvPr>
@@ -11335,7 +11335,7 @@
           <p:cNvPr id="21" name="">
             <a:extLst xmlns:a="http://schemas.openxmlformats.org/drawingml/2006/main">
               <a:ext uri="{FF2B5EF4-FFF2-40B4-BE49-F238E27FC236}">
-                <a16:creationId xmlns:a16="http://schemas.microsoft.com/office/drawing/2014/main" id="{33664E14-C79D-407A-A82B-F2E09145BD70}"/>
+                <a16:creationId xmlns:a16="http://schemas.microsoft.com/office/drawing/2014/main" id="{88925E3B-811D-462B-8263-D9D4E1E3B356}"/>
               </a:ext>
             </a:extLst>
           </p:cNvPr>
@@ -11399,7 +11399,7 @@
           <p:cNvPr id="22" name="">
             <a:extLst xmlns:a="http://schemas.openxmlformats.org/drawingml/2006/main">
               <a:ext uri="{FF2B5EF4-FFF2-40B4-BE49-F238E27FC236}">
-                <a16:creationId xmlns:a16="http://schemas.microsoft.com/office/drawing/2014/main" id="{383D7BAE-C2E5-43ED-BD1A-D0FFC7142109}"/>
+                <a16:creationId xmlns:a16="http://schemas.microsoft.com/office/drawing/2014/main" id="{A165019A-08AD-4D4D-B607-40DEB240E903}"/>
               </a:ext>
             </a:extLst>
           </p:cNvPr>
@@ -11461,7 +11461,7 @@
     </p:spTree>
     <p:extLst>
       <p:ext uri="{BB962C8B-B14F-4D97-AF65-F5344CB8AC3E}">
-        <p14:creationId xmlns:p14="http://schemas.microsoft.com/office/powerpoint/2010/main" val="2066964176"/>
+        <p14:creationId xmlns:p14="http://schemas.microsoft.com/office/powerpoint/2010/main" val="1217616342"/>
       </p:ext>
     </p:extLst>
   </p:cSld>
@@ -11485,7 +11485,7 @@
           <p:cNvPr id="1" name="">
             <a:extLst xmlns:a="http://schemas.openxmlformats.org/drawingml/2006/main">
               <a:ext uri="{FF2B5EF4-FFF2-40B4-BE49-F238E27FC236}">
-                <a16:creationId xmlns:a16="http://schemas.microsoft.com/office/drawing/2014/main" id="{11B2C363-E4A8-45BA-8852-DF0D02258AB4}"/>
+                <a16:creationId xmlns:a16="http://schemas.microsoft.com/office/drawing/2014/main" id="{8D6F9B3A-95B3-4403-8A83-09397486FB13}"/>
               </a:ext>
             </a:extLst>
           </p:cNvPr>
@@ -11520,7 +11520,7 @@
           <p:cNvPr id="2" name="">
             <a:extLst xmlns:a="http://schemas.openxmlformats.org/drawingml/2006/main">
               <a:ext uri="{FF2B5EF4-FFF2-40B4-BE49-F238E27FC236}">
-                <a16:creationId xmlns:a16="http://schemas.microsoft.com/office/drawing/2014/main" id="{7D1565D8-5912-459A-A163-30D8679B45A2}"/>
+                <a16:creationId xmlns:a16="http://schemas.microsoft.com/office/drawing/2014/main" id="{DDF3C9BE-0EAC-42A7-B895-89E455D457ED}"/>
               </a:ext>
             </a:extLst>
           </p:cNvPr>
@@ -11555,7 +11555,7 @@
           <p:cNvPr id="3" name="">
             <a:extLst xmlns:a="http://schemas.openxmlformats.org/drawingml/2006/main">
               <a:ext uri="{FF2B5EF4-FFF2-40B4-BE49-F238E27FC236}">
-                <a16:creationId xmlns:a16="http://schemas.microsoft.com/office/drawing/2014/main" id="{6CDBF2F1-DC12-40EE-B0A3-60DEC6F35C9C}"/>
+                <a16:creationId xmlns:a16="http://schemas.microsoft.com/office/drawing/2014/main" id="{B69DDFDF-577A-415C-A63F-F4EC6F225BF2}"/>
               </a:ext>
             </a:extLst>
           </p:cNvPr>
@@ -11619,7 +11619,7 @@
           <p:cNvPr id="4" name="">
             <a:extLst xmlns:a="http://schemas.openxmlformats.org/drawingml/2006/main">
               <a:ext uri="{FF2B5EF4-FFF2-40B4-BE49-F238E27FC236}">
-                <a16:creationId xmlns:a16="http://schemas.microsoft.com/office/drawing/2014/main" id="{612D2AF6-4B18-47AD-A76F-B2AA3BBAF85D}"/>
+                <a16:creationId xmlns:a16="http://schemas.microsoft.com/office/drawing/2014/main" id="{2788CF8E-A10B-43AD-BB88-17F158771E3B}"/>
               </a:ext>
             </a:extLst>
           </p:cNvPr>
@@ -11683,7 +11683,7 @@
           <p:cNvPr id="5" name="">
             <a:extLst xmlns:a="http://schemas.openxmlformats.org/drawingml/2006/main">
               <a:ext uri="{FF2B5EF4-FFF2-40B4-BE49-F238E27FC236}">
-                <a16:creationId xmlns:a16="http://schemas.microsoft.com/office/drawing/2014/main" id="{61E9AF8B-7FAA-4707-B456-98001A07BC3D}"/>
+                <a16:creationId xmlns:a16="http://schemas.microsoft.com/office/drawing/2014/main" id="{0F4E2AE2-1893-4260-A3AC-1507B9915DEA}"/>
               </a:ext>
             </a:extLst>
           </p:cNvPr>
@@ -11747,7 +11747,7 @@
           <p:cNvPr id="6" name="">
             <a:extLst xmlns:a="http://schemas.openxmlformats.org/drawingml/2006/main">
               <a:ext uri="{FF2B5EF4-FFF2-40B4-BE49-F238E27FC236}">
-                <a16:creationId xmlns:a16="http://schemas.microsoft.com/office/drawing/2014/main" id="{0B053BDE-1476-416E-83D5-8B9417845165}"/>
+                <a16:creationId xmlns:a16="http://schemas.microsoft.com/office/drawing/2014/main" id="{6854B780-0503-4FFD-926B-372813D327AA}"/>
               </a:ext>
             </a:extLst>
           </p:cNvPr>
@@ -11811,7 +11811,7 @@
           <p:cNvPr id="7" name="">
             <a:extLst xmlns:a="http://schemas.openxmlformats.org/drawingml/2006/main">
               <a:ext uri="{FF2B5EF4-FFF2-40B4-BE49-F238E27FC236}">
-                <a16:creationId xmlns:a16="http://schemas.microsoft.com/office/drawing/2014/main" id="{B6530F27-EDA9-4783-8386-34C241F72A08}"/>
+                <a16:creationId xmlns:a16="http://schemas.microsoft.com/office/drawing/2014/main" id="{EB05B9FB-1674-4A96-ADB5-A5CEEF747AEB}"/>
               </a:ext>
             </a:extLst>
           </p:cNvPr>
@@ -11844,7 +11844,7 @@
           <p:cNvPr id="8" name="">
             <a:extLst xmlns:a="http://schemas.openxmlformats.org/drawingml/2006/main">
               <a:ext uri="{FF2B5EF4-FFF2-40B4-BE49-F238E27FC236}">
-                <a16:creationId xmlns:a16="http://schemas.microsoft.com/office/drawing/2014/main" id="{1CE39982-056A-4629-8945-2180A41C58F5}"/>
+                <a16:creationId xmlns:a16="http://schemas.microsoft.com/office/drawing/2014/main" id="{D19C04AC-1657-496D-89A7-DE90FD2DDB02}"/>
               </a:ext>
             </a:extLst>
           </p:cNvPr>
@@ -11908,7 +11908,7 @@
           <p:cNvPr id="9" name="">
             <a:extLst xmlns:a="http://schemas.openxmlformats.org/drawingml/2006/main">
               <a:ext uri="{FF2B5EF4-FFF2-40B4-BE49-F238E27FC236}">
-                <a16:creationId xmlns:a16="http://schemas.microsoft.com/office/drawing/2014/main" id="{7EF50989-8822-47FD-A4D6-2BE942E3AE9E}"/>
+                <a16:creationId xmlns:a16="http://schemas.microsoft.com/office/drawing/2014/main" id="{1494A035-F27C-4EA8-A722-CC8F38DF82B8}"/>
               </a:ext>
             </a:extLst>
           </p:cNvPr>
@@ -11962,7 +11962,7 @@
                 <a:ea typeface="Aptos"/>
                 <a:cs typeface="Aptos"/>
               </a:rPr>
-              <a:t>Producer accepts the pending action; simulator verifier still gates execution.</a:t>
+              <a:t>Agent.resume executes the interrupted Sagents tool exactly once after producer approval.</a:t>
             </a:r>
           </a:p>
         </p:txBody>
@@ -11972,7 +11972,7 @@
           <p:cNvPr id="10" name="">
             <a:extLst xmlns:a="http://schemas.openxmlformats.org/drawingml/2006/main">
               <a:ext uri="{FF2B5EF4-FFF2-40B4-BE49-F238E27FC236}">
-                <a16:creationId xmlns:a16="http://schemas.microsoft.com/office/drawing/2014/main" id="{44A2EAB2-9B64-456D-A0F0-97AFAB0BF3BA}"/>
+                <a16:creationId xmlns:a16="http://schemas.microsoft.com/office/drawing/2014/main" id="{1AD970BA-BA2B-48A7-A9CC-D321379A5CBA}"/>
               </a:ext>
             </a:extLst>
           </p:cNvPr>
@@ -12005,7 +12005,7 @@
           <p:cNvPr id="11" name="">
             <a:extLst xmlns:a="http://schemas.openxmlformats.org/drawingml/2006/main">
               <a:ext uri="{FF2B5EF4-FFF2-40B4-BE49-F238E27FC236}">
-                <a16:creationId xmlns:a16="http://schemas.microsoft.com/office/drawing/2014/main" id="{3334DBC4-8647-472E-AF2B-AD7641C57722}"/>
+                <a16:creationId xmlns:a16="http://schemas.microsoft.com/office/drawing/2014/main" id="{8A21249A-AF4E-4450-97F4-D34FCAFF79E1}"/>
               </a:ext>
             </a:extLst>
           </p:cNvPr>
@@ -12059,7 +12059,7 @@
                 <a:ea typeface="Aptos"/>
                 <a:cs typeface="Aptos"/>
               </a:rPr>
-              <a:t>Edit</a:t>
+              <a:t>Edit / Reject</a:t>
             </a:r>
           </a:p>
         </p:txBody>
@@ -12069,7 +12069,7 @@
           <p:cNvPr id="12" name="">
             <a:extLst xmlns:a="http://schemas.openxmlformats.org/drawingml/2006/main">
               <a:ext uri="{FF2B5EF4-FFF2-40B4-BE49-F238E27FC236}">
-                <a16:creationId xmlns:a16="http://schemas.microsoft.com/office/drawing/2014/main" id="{A5876085-04FF-4501-BC8B-EA5E2CF8D742}"/>
+                <a16:creationId xmlns:a16="http://schemas.microsoft.com/office/drawing/2014/main" id="{DF67E499-500E-468E-8511-1225D439561B}"/>
               </a:ext>
             </a:extLst>
           </p:cNvPr>
@@ -12123,7 +12123,7 @@
                 <a:ea typeface="Aptos"/>
                 <a:cs typeface="Aptos"/>
               </a:rPr>
-              <a:t>Solo mitad reduces irreversible water exchange and harvest before verification.</a:t>
+              <a:t>Solo mitad is re-verified; rejection resumes with zero simulator mutation.</a:t>
             </a:r>
           </a:p>
         </p:txBody>
@@ -12133,7 +12133,7 @@
           <p:cNvPr id="13" name="">
             <a:extLst xmlns:a="http://schemas.openxmlformats.org/drawingml/2006/main">
               <a:ext uri="{FF2B5EF4-FFF2-40B4-BE49-F238E27FC236}">
-                <a16:creationId xmlns:a16="http://schemas.microsoft.com/office/drawing/2014/main" id="{82BDFDD5-FF34-4B1E-B0E9-9C1D04806D77}"/>
+                <a16:creationId xmlns:a16="http://schemas.microsoft.com/office/drawing/2014/main" id="{66A42672-B23F-42C9-BD7C-67BA3A5BD43D}"/>
               </a:ext>
             </a:extLst>
           </p:cNvPr>
@@ -12166,7 +12166,7 @@
           <p:cNvPr id="14" name="">
             <a:extLst xmlns:a="http://schemas.openxmlformats.org/drawingml/2006/main">
               <a:ext uri="{FF2B5EF4-FFF2-40B4-BE49-F238E27FC236}">
-                <a16:creationId xmlns:a16="http://schemas.microsoft.com/office/drawing/2014/main" id="{88003D6D-2820-4F6A-9E23-00A2113C4A8C}"/>
+                <a16:creationId xmlns:a16="http://schemas.microsoft.com/office/drawing/2014/main" id="{17F84962-2C50-4630-9C8F-FE304AB79F08}"/>
               </a:ext>
             </a:extLst>
           </p:cNvPr>
@@ -12230,7 +12230,7 @@
           <p:cNvPr id="15" name="">
             <a:extLst xmlns:a="http://schemas.openxmlformats.org/drawingml/2006/main">
               <a:ext uri="{FF2B5EF4-FFF2-40B4-BE49-F238E27FC236}">
-                <a16:creationId xmlns:a16="http://schemas.microsoft.com/office/drawing/2014/main" id="{DE73105F-CC71-4254-A17A-3E7BA8DD4274}"/>
+                <a16:creationId xmlns:a16="http://schemas.microsoft.com/office/drawing/2014/main" id="{69F480E6-FADF-4059-A6C5-C933A2FFA56B}"/>
               </a:ext>
             </a:extLst>
           </p:cNvPr>
@@ -12294,7 +12294,7 @@
           <p:cNvPr id="16" name="">
             <a:extLst xmlns:a="http://schemas.openxmlformats.org/drawingml/2006/main">
               <a:ext uri="{FF2B5EF4-FFF2-40B4-BE49-F238E27FC236}">
-                <a16:creationId xmlns:a16="http://schemas.microsoft.com/office/drawing/2014/main" id="{EB046806-C1B6-45CE-B81F-CCA1DDC17577}"/>
+                <a16:creationId xmlns:a16="http://schemas.microsoft.com/office/drawing/2014/main" id="{307BA486-BB35-4AB8-8216-1180E6B81B5F}"/>
               </a:ext>
             </a:extLst>
           </p:cNvPr>
@@ -12358,7 +12358,7 @@
           <p:cNvPr id="17" name="">
             <a:extLst xmlns:a="http://schemas.openxmlformats.org/drawingml/2006/main">
               <a:ext uri="{FF2B5EF4-FFF2-40B4-BE49-F238E27FC236}">
-                <a16:creationId xmlns:a16="http://schemas.microsoft.com/office/drawing/2014/main" id="{B9F4D619-517F-4963-978D-53A1E9E74237}"/>
+                <a16:creationId xmlns:a16="http://schemas.microsoft.com/office/drawing/2014/main" id="{AFDCAB50-0561-4075-9E79-16FD37C649F7}"/>
               </a:ext>
             </a:extLst>
           </p:cNvPr>
@@ -12420,7 +12420,7 @@
     </p:spTree>
     <p:extLst>
       <p:ext uri="{BB962C8B-B14F-4D97-AF65-F5344CB8AC3E}">
-        <p14:creationId xmlns:p14="http://schemas.microsoft.com/office/powerpoint/2010/main" val="845599114"/>
+        <p14:creationId xmlns:p14="http://schemas.microsoft.com/office/powerpoint/2010/main" val="1575960991"/>
       </p:ext>
     </p:extLst>
   </p:cSld>
@@ -12444,7 +12444,7 @@
           <p:cNvPr id="1" name="">
             <a:extLst xmlns:a="http://schemas.openxmlformats.org/drawingml/2006/main">
               <a:ext uri="{FF2B5EF4-FFF2-40B4-BE49-F238E27FC236}">
-                <a16:creationId xmlns:a16="http://schemas.microsoft.com/office/drawing/2014/main" id="{E961603D-E007-4689-979E-5E0D529A0E73}"/>
+                <a16:creationId xmlns:a16="http://schemas.microsoft.com/office/drawing/2014/main" id="{E1830D12-13A8-4CE6-9BC6-E5812B2BC2E1}"/>
               </a:ext>
             </a:extLst>
           </p:cNvPr>
@@ -12479,7 +12479,7 @@
           <p:cNvPr id="2" name="">
             <a:extLst xmlns:a="http://schemas.openxmlformats.org/drawingml/2006/main">
               <a:ext uri="{FF2B5EF4-FFF2-40B4-BE49-F238E27FC236}">
-                <a16:creationId xmlns:a16="http://schemas.microsoft.com/office/drawing/2014/main" id="{BCFE8D72-88F5-4D08-9DC4-1B631DB06A48}"/>
+                <a16:creationId xmlns:a16="http://schemas.microsoft.com/office/drawing/2014/main" id="{89B97856-A5CD-454B-8340-D598B9020F6C}"/>
               </a:ext>
             </a:extLst>
           </p:cNvPr>
@@ -12514,7 +12514,7 @@
           <p:cNvPr id="3" name="">
             <a:extLst xmlns:a="http://schemas.openxmlformats.org/drawingml/2006/main">
               <a:ext uri="{FF2B5EF4-FFF2-40B4-BE49-F238E27FC236}">
-                <a16:creationId xmlns:a16="http://schemas.microsoft.com/office/drawing/2014/main" id="{6BC9C64E-E377-4C8B-9274-648E830BB4A4}"/>
+                <a16:creationId xmlns:a16="http://schemas.microsoft.com/office/drawing/2014/main" id="{3A5F680B-AAB6-44B6-8249-8D63932DD00F}"/>
               </a:ext>
             </a:extLst>
           </p:cNvPr>
@@ -12578,7 +12578,7 @@
           <p:cNvPr id="4" name="">
             <a:extLst xmlns:a="http://schemas.openxmlformats.org/drawingml/2006/main">
               <a:ext uri="{FF2B5EF4-FFF2-40B4-BE49-F238E27FC236}">
-                <a16:creationId xmlns:a16="http://schemas.microsoft.com/office/drawing/2014/main" id="{7B9CE816-D816-494C-897D-0E77EB2D206D}"/>
+                <a16:creationId xmlns:a16="http://schemas.microsoft.com/office/drawing/2014/main" id="{B5C39897-2C4E-46C1-9FD7-7C9FB2A222A9}"/>
               </a:ext>
             </a:extLst>
           </p:cNvPr>
@@ -12642,7 +12642,7 @@
           <p:cNvPr id="5" name="">
             <a:extLst xmlns:a="http://schemas.openxmlformats.org/drawingml/2006/main">
               <a:ext uri="{FF2B5EF4-FFF2-40B4-BE49-F238E27FC236}">
-                <a16:creationId xmlns:a16="http://schemas.microsoft.com/office/drawing/2014/main" id="{6422CD08-AFDA-4F94-80E0-C3ED5AFD9A78}"/>
+                <a16:creationId xmlns:a16="http://schemas.microsoft.com/office/drawing/2014/main" id="{4D1DCACD-AC40-417A-8922-8DC32DEC5635}"/>
               </a:ext>
             </a:extLst>
           </p:cNvPr>
@@ -12696,7 +12696,7 @@
                 <a:ea typeface="Aptos Display"/>
                 <a:cs typeface="Aptos Display"/>
               </a:rPr>
-              <a:t>The model boundary is already OpenAI-compatible</a:t>
+              <a:t>Gemma already powers the real Sagents runtime</a:t>
             </a:r>
           </a:p>
         </p:txBody>
@@ -12706,7 +12706,7 @@
           <p:cNvPr id="6" name="">
             <a:extLst xmlns:a="http://schemas.openxmlformats.org/drawingml/2006/main">
               <a:ext uri="{FF2B5EF4-FFF2-40B4-BE49-F238E27FC236}">
-                <a16:creationId xmlns:a16="http://schemas.microsoft.com/office/drawing/2014/main" id="{CDD89B34-761E-4612-B0B2-5A42C276B02A}"/>
+                <a16:creationId xmlns:a16="http://schemas.microsoft.com/office/drawing/2014/main" id="{A9FF5E37-D72F-4898-A2ED-83963AB78FD6}"/>
               </a:ext>
             </a:extLst>
           </p:cNvPr>
@@ -12760,7 +12760,7 @@
                 <a:ea typeface="Aptos"/>
                 <a:cs typeface="Aptos"/>
               </a:rPr>
-              <a:t>Local stubs keep the demo runnable; AMD-hosted Gemma can be swapped in by setting GEMMA_ENDPOINT.</a:t>
+              <a:t>Local E2B proves the loop offline; AMD-hosted Gemma uses the same GEMMA_ENDPOINT contract.</a:t>
             </a:r>
           </a:p>
         </p:txBody>
@@ -12770,7 +12770,7 @@
           <p:cNvPr id="7" name="">
             <a:extLst xmlns:a="http://schemas.openxmlformats.org/drawingml/2006/main">
               <a:ext uri="{FF2B5EF4-FFF2-40B4-BE49-F238E27FC236}">
-                <a16:creationId xmlns:a16="http://schemas.microsoft.com/office/drawing/2014/main" id="{55EA9B66-D7F6-4F9B-AF47-15D9D53F8974}"/>
+                <a16:creationId xmlns:a16="http://schemas.microsoft.com/office/drawing/2014/main" id="{DEC782A2-B6F7-427B-9310-4A627B02DE23}"/>
               </a:ext>
             </a:extLst>
           </p:cNvPr>
@@ -12803,7 +12803,7 @@
           <p:cNvPr id="8" name="">
             <a:extLst xmlns:a="http://schemas.openxmlformats.org/drawingml/2006/main">
               <a:ext uri="{FF2B5EF4-FFF2-40B4-BE49-F238E27FC236}">
-                <a16:creationId xmlns:a16="http://schemas.microsoft.com/office/drawing/2014/main" id="{0D161AA3-F39D-4ED6-B0EB-B42A511DFEDD}"/>
+                <a16:creationId xmlns:a16="http://schemas.microsoft.com/office/drawing/2014/main" id="{0B1CCF46-BD28-4AFC-97B4-BB21C8DD8EA8}"/>
               </a:ext>
             </a:extLst>
           </p:cNvPr>
@@ -12857,7 +12857,7 @@
                 <a:ea typeface="Aptos"/>
                 <a:cs typeface="Aptos"/>
               </a:rPr>
-              <a:t>Phoenix harness</a:t>
+              <a:t>Sagents 0.9.0</a:t>
             </a:r>
           </a:p>
         </p:txBody>
@@ -12867,7 +12867,7 @@
           <p:cNvPr id="9" name="">
             <a:extLst xmlns:a="http://schemas.openxmlformats.org/drawingml/2006/main">
               <a:ext uri="{FF2B5EF4-FFF2-40B4-BE49-F238E27FC236}">
-                <a16:creationId xmlns:a16="http://schemas.microsoft.com/office/drawing/2014/main" id="{541AE8E5-72AD-4E09-9580-F80BEDD32AC3}"/>
+                <a16:creationId xmlns:a16="http://schemas.microsoft.com/office/drawing/2014/main" id="{5158D5B1-CEDF-48AB-B52E-CBDB3DBE7D4B}"/>
               </a:ext>
             </a:extLst>
           </p:cNvPr>
@@ -12921,7 +12921,7 @@
                 <a:ea typeface="Aptos"/>
                 <a:cs typeface="Aptos"/>
               </a:rPr>
-              <a:t>Provider selector runs safe, unsafe, or OpenAI-compatible proposals.</a:t>
+              <a:t>Five agents, custom safety mode, until_tool_success, and resumable HITL.</a:t>
             </a:r>
           </a:p>
         </p:txBody>
@@ -12931,7 +12931,7 @@
           <p:cNvPr id="10" name="">
             <a:extLst xmlns:a="http://schemas.openxmlformats.org/drawingml/2006/main">
               <a:ext uri="{FF2B5EF4-FFF2-40B4-BE49-F238E27FC236}">
-                <a16:creationId xmlns:a16="http://schemas.microsoft.com/office/drawing/2014/main" id="{4611D7ED-1399-4E2A-84CE-8F7CD06C448E}"/>
+                <a16:creationId xmlns:a16="http://schemas.microsoft.com/office/drawing/2014/main" id="{6906E812-A3DC-4EA1-B435-F5ACF4C0B7F7}"/>
               </a:ext>
             </a:extLst>
           </p:cNvPr>
@@ -12995,7 +12995,7 @@
           <p:cNvPr id="11" name="">
             <a:extLst xmlns:a="http://schemas.openxmlformats.org/drawingml/2006/main">
               <a:ext uri="{FF2B5EF4-FFF2-40B4-BE49-F238E27FC236}">
-                <a16:creationId xmlns:a16="http://schemas.microsoft.com/office/drawing/2014/main" id="{91177CB2-B2CA-426D-92FA-40862F160976}"/>
+                <a16:creationId xmlns:a16="http://schemas.microsoft.com/office/drawing/2014/main" id="{01B73A02-7FF9-4DDD-A569-5C60C9BDB8C6}"/>
               </a:ext>
             </a:extLst>
           </p:cNvPr>
@@ -13028,7 +13028,7 @@
           <p:cNvPr id="12" name="">
             <a:extLst xmlns:a="http://schemas.openxmlformats.org/drawingml/2006/main">
               <a:ext uri="{FF2B5EF4-FFF2-40B4-BE49-F238E27FC236}">
-                <a16:creationId xmlns:a16="http://schemas.microsoft.com/office/drawing/2014/main" id="{5F191CDA-C4DF-4B46-AE6D-79D7685304DB}"/>
+                <a16:creationId xmlns:a16="http://schemas.microsoft.com/office/drawing/2014/main" id="{268DB2AE-48ED-4F1F-9F12-0ABC6AF7F39D}"/>
               </a:ext>
             </a:extLst>
           </p:cNvPr>
@@ -13092,7 +13092,7 @@
           <p:cNvPr id="13" name="">
             <a:extLst xmlns:a="http://schemas.openxmlformats.org/drawingml/2006/main">
               <a:ext uri="{FF2B5EF4-FFF2-40B4-BE49-F238E27FC236}">
-                <a16:creationId xmlns:a16="http://schemas.microsoft.com/office/drawing/2014/main" id="{B30F1723-5C00-4FA5-97EE-6DA271709A6D}"/>
+                <a16:creationId xmlns:a16="http://schemas.microsoft.com/office/drawing/2014/main" id="{D8DA8C88-2A4E-4CC6-ACBA-E79B0B8ED601}"/>
               </a:ext>
             </a:extLst>
           </p:cNvPr>
@@ -13156,7 +13156,7 @@
           <p:cNvPr id="14" name="">
             <a:extLst xmlns:a="http://schemas.openxmlformats.org/drawingml/2006/main">
               <a:ext uri="{FF2B5EF4-FFF2-40B4-BE49-F238E27FC236}">
-                <a16:creationId xmlns:a16="http://schemas.microsoft.com/office/drawing/2014/main" id="{0F8221E8-BC0D-4A05-9164-2EF252BD8047}"/>
+                <a16:creationId xmlns:a16="http://schemas.microsoft.com/office/drawing/2014/main" id="{F6A0B8AF-82D6-4495-B1D5-490259B8DA3D}"/>
               </a:ext>
             </a:extLst>
           </p:cNvPr>
@@ -13220,7 +13220,7 @@
           <p:cNvPr id="15" name="">
             <a:extLst xmlns:a="http://schemas.openxmlformats.org/drawingml/2006/main">
               <a:ext uri="{FF2B5EF4-FFF2-40B4-BE49-F238E27FC236}">
-                <a16:creationId xmlns:a16="http://schemas.microsoft.com/office/drawing/2014/main" id="{0DD19640-2851-4B12-8EC3-4843529DAF63}"/>
+                <a16:creationId xmlns:a16="http://schemas.microsoft.com/office/drawing/2014/main" id="{34A48475-FB99-4905-893C-1A5A79D17F46}"/>
               </a:ext>
             </a:extLst>
           </p:cNvPr>
@@ -13253,7 +13253,7 @@
           <p:cNvPr id="16" name="">
             <a:extLst xmlns:a="http://schemas.openxmlformats.org/drawingml/2006/main">
               <a:ext uri="{FF2B5EF4-FFF2-40B4-BE49-F238E27FC236}">
-                <a16:creationId xmlns:a16="http://schemas.microsoft.com/office/drawing/2014/main" id="{5F43ECE6-C2C4-44F1-ABE0-B98FF5B9B177}"/>
+                <a16:creationId xmlns:a16="http://schemas.microsoft.com/office/drawing/2014/main" id="{229EB372-C2D3-49C7-882F-54AE46C6C1F2}"/>
               </a:ext>
             </a:extLst>
           </p:cNvPr>
@@ -13317,7 +13317,7 @@
           <p:cNvPr id="17" name="">
             <a:extLst xmlns:a="http://schemas.openxmlformats.org/drawingml/2006/main">
               <a:ext uri="{FF2B5EF4-FFF2-40B4-BE49-F238E27FC236}">
-                <a16:creationId xmlns:a16="http://schemas.microsoft.com/office/drawing/2014/main" id="{574001E6-2102-452A-871B-DB15CCC59C52}"/>
+                <a16:creationId xmlns:a16="http://schemas.microsoft.com/office/drawing/2014/main" id="{04D995B1-2815-4CFA-9245-F3D10AF56534}"/>
               </a:ext>
             </a:extLst>
           </p:cNvPr>
@@ -13381,7 +13381,7 @@
           <p:cNvPr id="18" name="">
             <a:extLst xmlns:a="http://schemas.openxmlformats.org/drawingml/2006/main">
               <a:ext uri="{FF2B5EF4-FFF2-40B4-BE49-F238E27FC236}">
-                <a16:creationId xmlns:a16="http://schemas.microsoft.com/office/drawing/2014/main" id="{D0DC40E7-1EAD-4EBE-AD19-8858F4BDC663}"/>
+                <a16:creationId xmlns:a16="http://schemas.microsoft.com/office/drawing/2014/main" id="{2EC9B8F7-0EAF-47FC-A7C3-2E2F195D908F}"/>
               </a:ext>
             </a:extLst>
           </p:cNvPr>
@@ -13414,7 +13414,7 @@
           <p:cNvPr id="19" name="">
             <a:extLst xmlns:a="http://schemas.openxmlformats.org/drawingml/2006/main">
               <a:ext uri="{FF2B5EF4-FFF2-40B4-BE49-F238E27FC236}">
-                <a16:creationId xmlns:a16="http://schemas.microsoft.com/office/drawing/2014/main" id="{C73F68FF-C445-4BB6-83AB-B9BB9344AF65}"/>
+                <a16:creationId xmlns:a16="http://schemas.microsoft.com/office/drawing/2014/main" id="{E9D338E2-0655-49F4-80C6-74020E3D7F4D}"/>
               </a:ext>
             </a:extLst>
           </p:cNvPr>
@@ -13478,7 +13478,7 @@
           <p:cNvPr id="20" name="">
             <a:extLst xmlns:a="http://schemas.openxmlformats.org/drawingml/2006/main">
               <a:ext uri="{FF2B5EF4-FFF2-40B4-BE49-F238E27FC236}">
-                <a16:creationId xmlns:a16="http://schemas.microsoft.com/office/drawing/2014/main" id="{62161A58-F824-4D38-8CF2-370383ADB51E}"/>
+                <a16:creationId xmlns:a16="http://schemas.microsoft.com/office/drawing/2014/main" id="{B2C15674-A2D6-4F92-B397-AA62D7960F6F}"/>
               </a:ext>
             </a:extLst>
           </p:cNvPr>
@@ -13542,7 +13542,7 @@
           <p:cNvPr id="21" name="">
             <a:extLst xmlns:a="http://schemas.openxmlformats.org/drawingml/2006/main">
               <a:ext uri="{FF2B5EF4-FFF2-40B4-BE49-F238E27FC236}">
-                <a16:creationId xmlns:a16="http://schemas.microsoft.com/office/drawing/2014/main" id="{EE488C09-448B-4BF8-831F-9AE0264CBB26}"/>
+                <a16:creationId xmlns:a16="http://schemas.microsoft.com/office/drawing/2014/main" id="{557ACF10-674B-4BBA-AFFF-91542822A1FF}"/>
               </a:ext>
             </a:extLst>
           </p:cNvPr>
@@ -13606,7 +13606,7 @@
           <p:cNvPr id="22" name="">
             <a:extLst xmlns:a="http://schemas.openxmlformats.org/drawingml/2006/main">
               <a:ext uri="{FF2B5EF4-FFF2-40B4-BE49-F238E27FC236}">
-                <a16:creationId xmlns:a16="http://schemas.microsoft.com/office/drawing/2014/main" id="{77B5819B-1BD7-4D20-B1D5-EC40C22BF691}"/>
+                <a16:creationId xmlns:a16="http://schemas.microsoft.com/office/drawing/2014/main" id="{9E77EAE9-6429-495A-9E60-86740A4F2F45}"/>
               </a:ext>
             </a:extLst>
           </p:cNvPr>
@@ -13668,7 +13668,7 @@
     </p:spTree>
     <p:extLst>
       <p:ext uri="{BB962C8B-B14F-4D97-AF65-F5344CB8AC3E}">
-        <p14:creationId xmlns:p14="http://schemas.microsoft.com/office/powerpoint/2010/main" val="1970699127"/>
+        <p14:creationId xmlns:p14="http://schemas.microsoft.com/office/powerpoint/2010/main" val="1618042089"/>
       </p:ext>
     </p:extLst>
   </p:cSld>

</xml_diff>

<commit_message>
feat: prove Horde failover and live DECT link
</commit_message>
<xml_diff>
--- a/submission/proteinloop-hackathon-deck.pptx
+++ b/submission/proteinloop-hackathon-deck.pptx
@@ -2,22 +2,22 @@
 <file path=ppt/presentation.xml><?xml version="1.0" encoding="utf-8"?>
 <p:presentation xmlns:p="http://schemas.openxmlformats.org/presentationml/2006/main">
   <p:sldMasterIdLst>
-    <p:sldMasterId xmlns:r="http://schemas.openxmlformats.org/officeDocument/2006/relationships" id="2147483648" r:id="Rf7608c7ee40f4b41"/>
+    <p:sldMasterId xmlns:r="http://schemas.openxmlformats.org/officeDocument/2006/relationships" id="2147483648" r:id="Rb49b9e36dea84cef"/>
   </p:sldMasterIdLst>
   <p:notesMasterIdLst>
-    <p:notesMasterId xmlns:r="http://schemas.openxmlformats.org/officeDocument/2006/relationships" r:id="Rc2ce643b976144c2"/>
+    <p:notesMasterId xmlns:r="http://schemas.openxmlformats.org/officeDocument/2006/relationships" r:id="R846e12746a004354"/>
   </p:notesMasterIdLst>
   <p:sldIdLst>
-    <p:sldId xmlns:r="http://schemas.openxmlformats.org/officeDocument/2006/relationships" id="256" r:id="Rcfc3ddf41ab84f0c"/>
-    <p:sldId xmlns:r="http://schemas.openxmlformats.org/officeDocument/2006/relationships" id="257" r:id="R2ea3c416b81d4ba9"/>
-    <p:sldId xmlns:r="http://schemas.openxmlformats.org/officeDocument/2006/relationships" id="258" r:id="R4d1fbca9d52a4d05"/>
-    <p:sldId xmlns:r="http://schemas.openxmlformats.org/officeDocument/2006/relationships" id="259" r:id="Ref2d39aec695471c"/>
-    <p:sldId xmlns:r="http://schemas.openxmlformats.org/officeDocument/2006/relationships" id="260" r:id="R1695f2f944604c06"/>
-    <p:sldId xmlns:r="http://schemas.openxmlformats.org/officeDocument/2006/relationships" id="261" r:id="Ra1de72f6c5e449c6"/>
-    <p:sldId xmlns:r="http://schemas.openxmlformats.org/officeDocument/2006/relationships" id="262" r:id="R7f4f24de679045ef"/>
-    <p:sldId xmlns:r="http://schemas.openxmlformats.org/officeDocument/2006/relationships" id="263" r:id="R1f8a6433d8aa4838"/>
-    <p:sldId xmlns:r="http://schemas.openxmlformats.org/officeDocument/2006/relationships" id="264" r:id="Ree8ff28bf3c543e5"/>
-    <p:sldId xmlns:r="http://schemas.openxmlformats.org/officeDocument/2006/relationships" id="265" r:id="R4aa78653b5f940ff"/>
+    <p:sldId xmlns:r="http://schemas.openxmlformats.org/officeDocument/2006/relationships" id="256" r:id="R5ce8ba05787b4089"/>
+    <p:sldId xmlns:r="http://schemas.openxmlformats.org/officeDocument/2006/relationships" id="257" r:id="R50fee8c593bc4f1b"/>
+    <p:sldId xmlns:r="http://schemas.openxmlformats.org/officeDocument/2006/relationships" id="258" r:id="R72b9f041c9c74b82"/>
+    <p:sldId xmlns:r="http://schemas.openxmlformats.org/officeDocument/2006/relationships" id="259" r:id="R711059c9d11a46d4"/>
+    <p:sldId xmlns:r="http://schemas.openxmlformats.org/officeDocument/2006/relationships" id="260" r:id="R006dde05754a4bc7"/>
+    <p:sldId xmlns:r="http://schemas.openxmlformats.org/officeDocument/2006/relationships" id="261" r:id="R330203f7e32443ac"/>
+    <p:sldId xmlns:r="http://schemas.openxmlformats.org/officeDocument/2006/relationships" id="262" r:id="R918bf42168b547a0"/>
+    <p:sldId xmlns:r="http://schemas.openxmlformats.org/officeDocument/2006/relationships" id="263" r:id="Rabb324c8be9c4f4a"/>
+    <p:sldId xmlns:r="http://schemas.openxmlformats.org/officeDocument/2006/relationships" id="264" r:id="R0dd0360107ec4011"/>
+    <p:sldId xmlns:r="http://schemas.openxmlformats.org/officeDocument/2006/relationships" id="265" r:id="Rd85d606df2d04d8a"/>
   </p:sldIdLst>
   <p:sldSz cx="12192000" cy="6858000"/>
   <p:notesSz cx="6858000" cy="9144000"/>
@@ -1158,7 +1158,7 @@
   </p:cSld>
   <p:clrMap bg1="lt1" tx1="dk1" bg2="lt2" tx2="dk2" accent1="accent1" accent2="accent2" accent3="accent3" accent4="accent4" accent5="accent5" accent6="accent6" hlink="hlink" folHlink="folHlink"/>
   <p:sldLayoutIdLst>
-    <p:sldLayoutId xmlns:r="http://schemas.openxmlformats.org/officeDocument/2006/relationships" id="2147483649" r:id="R6a5580a0e11f4743"/>
+    <p:sldLayoutId xmlns:r="http://schemas.openxmlformats.org/officeDocument/2006/relationships" id="2147483649" r:id="R05ee29b702bb4ebf"/>
   </p:sldLayoutIdLst>
   <p:txStyles>
     <p:titleStyle>
@@ -1457,7 +1457,7 @@
           <p:cNvPr id="1" name="">
             <a:extLst xmlns:a="http://schemas.openxmlformats.org/drawingml/2006/main">
               <a:ext uri="{FF2B5EF4-FFF2-40B4-BE49-F238E27FC236}">
-                <a16:creationId xmlns:a16="http://schemas.microsoft.com/office/drawing/2014/main" id="{24BD6496-B2FB-4C5C-ADE9-E2F7704D4D6D}"/>
+                <a16:creationId xmlns:a16="http://schemas.microsoft.com/office/drawing/2014/main" id="{02B23C04-168B-499A-9B09-B879A4FDAEE8}"/>
               </a:ext>
             </a:extLst>
           </p:cNvPr>
@@ -1492,7 +1492,7 @@
           <p:cNvPr id="2" name="">
             <a:extLst xmlns:a="http://schemas.openxmlformats.org/drawingml/2006/main">
               <a:ext uri="{FF2B5EF4-FFF2-40B4-BE49-F238E27FC236}">
-                <a16:creationId xmlns:a16="http://schemas.microsoft.com/office/drawing/2014/main" id="{C4249AF8-DF9D-491C-B95C-8D8DDC017EBE}"/>
+                <a16:creationId xmlns:a16="http://schemas.microsoft.com/office/drawing/2014/main" id="{BD362294-5333-422B-9C70-02D26285997F}"/>
               </a:ext>
             </a:extLst>
           </p:cNvPr>
@@ -1527,7 +1527,7 @@
           <p:cNvPr id="3" name="">
             <a:extLst xmlns:a="http://schemas.openxmlformats.org/drawingml/2006/main">
               <a:ext uri="{FF2B5EF4-FFF2-40B4-BE49-F238E27FC236}">
-                <a16:creationId xmlns:a16="http://schemas.microsoft.com/office/drawing/2014/main" id="{07C4E2D1-158B-4771-8A96-C2D590AAA3F9}"/>
+                <a16:creationId xmlns:a16="http://schemas.microsoft.com/office/drawing/2014/main" id="{43379D92-AC04-4C8D-9BCF-38B02D1023DA}"/>
               </a:ext>
             </a:extLst>
           </p:cNvPr>
@@ -1591,7 +1591,7 @@
           <p:cNvPr id="4" name="">
             <a:extLst xmlns:a="http://schemas.openxmlformats.org/drawingml/2006/main">
               <a:ext uri="{FF2B5EF4-FFF2-40B4-BE49-F238E27FC236}">
-                <a16:creationId xmlns:a16="http://schemas.microsoft.com/office/drawing/2014/main" id="{78449027-FED6-40CC-BA6C-4A12B5B0C96A}"/>
+                <a16:creationId xmlns:a16="http://schemas.microsoft.com/office/drawing/2014/main" id="{2C2028F4-1FD1-411A-AE65-8B4D258BAB04}"/>
               </a:ext>
             </a:extLst>
           </p:cNvPr>
@@ -1655,7 +1655,7 @@
           <p:cNvPr id="5" name="">
             <a:extLst xmlns:a="http://schemas.openxmlformats.org/drawingml/2006/main">
               <a:ext uri="{FF2B5EF4-FFF2-40B4-BE49-F238E27FC236}">
-                <a16:creationId xmlns:a16="http://schemas.microsoft.com/office/drawing/2014/main" id="{4D8AF43D-F264-4EFE-B1DE-A96FBA0B3077}"/>
+                <a16:creationId xmlns:a16="http://schemas.microsoft.com/office/drawing/2014/main" id="{950EED38-D173-47D7-8CEA-BDEB6EC5A8FC}"/>
               </a:ext>
             </a:extLst>
           </p:cNvPr>
@@ -1690,7 +1690,7 @@
           <p:cNvPr id="6" name="">
             <a:extLst xmlns:a="http://schemas.openxmlformats.org/drawingml/2006/main">
               <a:ext uri="{FF2B5EF4-FFF2-40B4-BE49-F238E27FC236}">
-                <a16:creationId xmlns:a16="http://schemas.microsoft.com/office/drawing/2014/main" id="{0972CD58-E46E-4CC0-B718-061DB85D1959}"/>
+                <a16:creationId xmlns:a16="http://schemas.microsoft.com/office/drawing/2014/main" id="{58193EF1-8D28-4585-B10D-F8C1983BEFF5}"/>
               </a:ext>
             </a:extLst>
           </p:cNvPr>
@@ -1754,7 +1754,7 @@
           <p:cNvPr id="7" name="">
             <a:extLst xmlns:a="http://schemas.openxmlformats.org/drawingml/2006/main">
               <a:ext uri="{FF2B5EF4-FFF2-40B4-BE49-F238E27FC236}">
-                <a16:creationId xmlns:a16="http://schemas.microsoft.com/office/drawing/2014/main" id="{A9DA74A6-011E-42B7-8105-72D6ADC54886}"/>
+                <a16:creationId xmlns:a16="http://schemas.microsoft.com/office/drawing/2014/main" id="{95ED5853-904C-4284-AAC4-9390D39DBE72}"/>
               </a:ext>
             </a:extLst>
           </p:cNvPr>
@@ -1818,7 +1818,7 @@
           <p:cNvPr id="8" name="">
             <a:extLst xmlns:a="http://schemas.openxmlformats.org/drawingml/2006/main">
               <a:ext uri="{FF2B5EF4-FFF2-40B4-BE49-F238E27FC236}">
-                <a16:creationId xmlns:a16="http://schemas.microsoft.com/office/drawing/2014/main" id="{8804B4B7-BA03-4402-AE69-95137F1D970A}"/>
+                <a16:creationId xmlns:a16="http://schemas.microsoft.com/office/drawing/2014/main" id="{A2E9B6BE-AF3C-44A5-A473-7730C4B60CB5}"/>
               </a:ext>
             </a:extLst>
           </p:cNvPr>
@@ -1853,7 +1853,7 @@
           <p:cNvPr id="9" name="">
             <a:extLst xmlns:a="http://schemas.openxmlformats.org/drawingml/2006/main">
               <a:ext uri="{FF2B5EF4-FFF2-40B4-BE49-F238E27FC236}">
-                <a16:creationId xmlns:a16="http://schemas.microsoft.com/office/drawing/2014/main" id="{B8ED059E-588C-483D-BF1D-753D89A34270}"/>
+                <a16:creationId xmlns:a16="http://schemas.microsoft.com/office/drawing/2014/main" id="{C4BE8E97-0368-4316-824A-01615170FBBD}"/>
               </a:ext>
             </a:extLst>
           </p:cNvPr>
@@ -1917,7 +1917,7 @@
           <p:cNvPr id="10" name="">
             <a:extLst xmlns:a="http://schemas.openxmlformats.org/drawingml/2006/main">
               <a:ext uri="{FF2B5EF4-FFF2-40B4-BE49-F238E27FC236}">
-                <a16:creationId xmlns:a16="http://schemas.microsoft.com/office/drawing/2014/main" id="{392583F6-E8DB-4CBE-AE6C-0B2210715432}"/>
+                <a16:creationId xmlns:a16="http://schemas.microsoft.com/office/drawing/2014/main" id="{D9CA1FD4-2122-4305-AC9C-8F784A7936A7}"/>
               </a:ext>
             </a:extLst>
           </p:cNvPr>
@@ -1981,7 +1981,7 @@
           <p:cNvPr id="11" name="">
             <a:extLst xmlns:a="http://schemas.openxmlformats.org/drawingml/2006/main">
               <a:ext uri="{FF2B5EF4-FFF2-40B4-BE49-F238E27FC236}">
-                <a16:creationId xmlns:a16="http://schemas.microsoft.com/office/drawing/2014/main" id="{80DAAA57-CF19-48FB-88B7-A88123D1FFB5}"/>
+                <a16:creationId xmlns:a16="http://schemas.microsoft.com/office/drawing/2014/main" id="{C8A4F612-14A3-4C11-94DC-149DDE523914}"/>
               </a:ext>
             </a:extLst>
           </p:cNvPr>
@@ -2045,7 +2045,7 @@
           <p:cNvPr id="12" name="">
             <a:extLst xmlns:a="http://schemas.openxmlformats.org/drawingml/2006/main">
               <a:ext uri="{FF2B5EF4-FFF2-40B4-BE49-F238E27FC236}">
-                <a16:creationId xmlns:a16="http://schemas.microsoft.com/office/drawing/2014/main" id="{DA763DA0-2A6F-47B9-8522-A65D2243FB84}"/>
+                <a16:creationId xmlns:a16="http://schemas.microsoft.com/office/drawing/2014/main" id="{55247746-EE96-4780-A334-043A85BD1C3D}"/>
               </a:ext>
             </a:extLst>
           </p:cNvPr>
@@ -2080,7 +2080,7 @@
           <p:cNvPr id="13" name="">
             <a:extLst xmlns:a="http://schemas.openxmlformats.org/drawingml/2006/main">
               <a:ext uri="{FF2B5EF4-FFF2-40B4-BE49-F238E27FC236}">
-                <a16:creationId xmlns:a16="http://schemas.microsoft.com/office/drawing/2014/main" id="{114AFE0F-551D-4CFA-9EF3-301F9E5D6F86}"/>
+                <a16:creationId xmlns:a16="http://schemas.microsoft.com/office/drawing/2014/main" id="{3AB2C282-EF43-4239-9623-83FC0A7464DA}"/>
               </a:ext>
             </a:extLst>
           </p:cNvPr>
@@ -2144,7 +2144,7 @@
           <p:cNvPr id="14" name="">
             <a:extLst xmlns:a="http://schemas.openxmlformats.org/drawingml/2006/main">
               <a:ext uri="{FF2B5EF4-FFF2-40B4-BE49-F238E27FC236}">
-                <a16:creationId xmlns:a16="http://schemas.microsoft.com/office/drawing/2014/main" id="{5FBFD0C2-BBA1-4F52-A937-29A109798D18}"/>
+                <a16:creationId xmlns:a16="http://schemas.microsoft.com/office/drawing/2014/main" id="{11A58D5E-16F7-48C7-93B8-65170F2F7442}"/>
               </a:ext>
             </a:extLst>
           </p:cNvPr>
@@ -2208,7 +2208,7 @@
           <p:cNvPr id="15" name="">
             <a:extLst xmlns:a="http://schemas.openxmlformats.org/drawingml/2006/main">
               <a:ext uri="{FF2B5EF4-FFF2-40B4-BE49-F238E27FC236}">
-                <a16:creationId xmlns:a16="http://schemas.microsoft.com/office/drawing/2014/main" id="{C4AB8A1A-1C24-44FA-9696-8E560D700A91}"/>
+                <a16:creationId xmlns:a16="http://schemas.microsoft.com/office/drawing/2014/main" id="{B43CCDBF-6904-42AD-A14D-176A1E64DF4F}"/>
               </a:ext>
             </a:extLst>
           </p:cNvPr>
@@ -2272,7 +2272,7 @@
           <p:cNvPr id="16" name="">
             <a:extLst xmlns:a="http://schemas.openxmlformats.org/drawingml/2006/main">
               <a:ext uri="{FF2B5EF4-FFF2-40B4-BE49-F238E27FC236}">
-                <a16:creationId xmlns:a16="http://schemas.microsoft.com/office/drawing/2014/main" id="{7566BE01-51F7-439B-95F7-910257131160}"/>
+                <a16:creationId xmlns:a16="http://schemas.microsoft.com/office/drawing/2014/main" id="{B384C2CF-D238-4833-BFC0-078F939CC35E}"/>
               </a:ext>
             </a:extLst>
           </p:cNvPr>
@@ -2307,7 +2307,7 @@
           <p:cNvPr id="17" name="">
             <a:extLst xmlns:a="http://schemas.openxmlformats.org/drawingml/2006/main">
               <a:ext uri="{FF2B5EF4-FFF2-40B4-BE49-F238E27FC236}">
-                <a16:creationId xmlns:a16="http://schemas.microsoft.com/office/drawing/2014/main" id="{F5708F3A-6FE5-4FED-82A1-EDC075642BE2}"/>
+                <a16:creationId xmlns:a16="http://schemas.microsoft.com/office/drawing/2014/main" id="{42E3E716-0EDE-49A3-A6EC-CDA5F60D807B}"/>
               </a:ext>
             </a:extLst>
           </p:cNvPr>
@@ -2371,7 +2371,7 @@
           <p:cNvPr id="18" name="">
             <a:extLst xmlns:a="http://schemas.openxmlformats.org/drawingml/2006/main">
               <a:ext uri="{FF2B5EF4-FFF2-40B4-BE49-F238E27FC236}">
-                <a16:creationId xmlns:a16="http://schemas.microsoft.com/office/drawing/2014/main" id="{5DDF29A5-07F4-4DF0-A82C-DD6CB0CE758B}"/>
+                <a16:creationId xmlns:a16="http://schemas.microsoft.com/office/drawing/2014/main" id="{5A5118A8-B96F-41D0-9D1E-8A058CB373CF}"/>
               </a:ext>
             </a:extLst>
           </p:cNvPr>
@@ -2435,7 +2435,7 @@
           <p:cNvPr id="19" name="">
             <a:extLst xmlns:a="http://schemas.openxmlformats.org/drawingml/2006/main">
               <a:ext uri="{FF2B5EF4-FFF2-40B4-BE49-F238E27FC236}">
-                <a16:creationId xmlns:a16="http://schemas.microsoft.com/office/drawing/2014/main" id="{ADC6E8DA-9336-427E-A58B-9D9FAA100F1B}"/>
+                <a16:creationId xmlns:a16="http://schemas.microsoft.com/office/drawing/2014/main" id="{9193D93D-C1CC-45EA-AB27-5F6E59DA3ACB}"/>
               </a:ext>
             </a:extLst>
           </p:cNvPr>
@@ -2499,7 +2499,7 @@
           <p:cNvPr id="20" name="">
             <a:extLst xmlns:a="http://schemas.openxmlformats.org/drawingml/2006/main">
               <a:ext uri="{FF2B5EF4-FFF2-40B4-BE49-F238E27FC236}">
-                <a16:creationId xmlns:a16="http://schemas.microsoft.com/office/drawing/2014/main" id="{E7252D9F-5786-4EE1-B88C-0C450B029C59}"/>
+                <a16:creationId xmlns:a16="http://schemas.microsoft.com/office/drawing/2014/main" id="{66C17CAC-9C42-4E45-A4FD-FD3DB46A8CB1}"/>
               </a:ext>
             </a:extLst>
           </p:cNvPr>
@@ -2655,7 +2655,7 @@
           <p:cNvPr id="21" name="">
             <a:extLst xmlns:a="http://schemas.openxmlformats.org/drawingml/2006/main">
               <a:ext uri="{FF2B5EF4-FFF2-40B4-BE49-F238E27FC236}">
-                <a16:creationId xmlns:a16="http://schemas.microsoft.com/office/drawing/2014/main" id="{AF522A38-3971-4F95-B8F8-13966A36487D}"/>
+                <a16:creationId xmlns:a16="http://schemas.microsoft.com/office/drawing/2014/main" id="{59414F48-D8C9-477D-8642-61ECCB493621}"/>
               </a:ext>
             </a:extLst>
           </p:cNvPr>
@@ -2719,7 +2719,7 @@
           <p:cNvPr id="22" name="">
             <a:extLst xmlns:a="http://schemas.openxmlformats.org/drawingml/2006/main">
               <a:ext uri="{FF2B5EF4-FFF2-40B4-BE49-F238E27FC236}">
-                <a16:creationId xmlns:a16="http://schemas.microsoft.com/office/drawing/2014/main" id="{F1495999-D7A3-4257-8D03-A95A231FFFE6}"/>
+                <a16:creationId xmlns:a16="http://schemas.microsoft.com/office/drawing/2014/main" id="{49E082B9-15C7-45EA-8631-1F47D7A0AC87}"/>
               </a:ext>
             </a:extLst>
           </p:cNvPr>
@@ -2781,7 +2781,7 @@
     </p:spTree>
     <p:extLst>
       <p:ext uri="{BB962C8B-B14F-4D97-AF65-F5344CB8AC3E}">
-        <p14:creationId xmlns:p14="http://schemas.microsoft.com/office/powerpoint/2010/main" val="1881312866"/>
+        <p14:creationId xmlns:p14="http://schemas.microsoft.com/office/powerpoint/2010/main" val="860239449"/>
       </p:ext>
     </p:extLst>
   </p:cSld>
@@ -2805,7 +2805,7 @@
           <p:cNvPr id="1" name="">
             <a:extLst xmlns:a="http://schemas.openxmlformats.org/drawingml/2006/main">
               <a:ext uri="{FF2B5EF4-FFF2-40B4-BE49-F238E27FC236}">
-                <a16:creationId xmlns:a16="http://schemas.microsoft.com/office/drawing/2014/main" id="{47DEF0C5-9777-4EDB-A19F-8E85046FFB3C}"/>
+                <a16:creationId xmlns:a16="http://schemas.microsoft.com/office/drawing/2014/main" id="{0E79C62D-4AB6-4B88-9DFD-3086A5B358E5}"/>
               </a:ext>
             </a:extLst>
           </p:cNvPr>
@@ -2840,7 +2840,7 @@
           <p:cNvPr id="2" name="">
             <a:extLst xmlns:a="http://schemas.openxmlformats.org/drawingml/2006/main">
               <a:ext uri="{FF2B5EF4-FFF2-40B4-BE49-F238E27FC236}">
-                <a16:creationId xmlns:a16="http://schemas.microsoft.com/office/drawing/2014/main" id="{A04F95EA-52E7-420D-92B3-8646685731EE}"/>
+                <a16:creationId xmlns:a16="http://schemas.microsoft.com/office/drawing/2014/main" id="{42E52D5A-BAF5-4E60-9381-4DCBA9CBCC66}"/>
               </a:ext>
             </a:extLst>
           </p:cNvPr>
@@ -2875,7 +2875,7 @@
           <p:cNvPr id="3" name="">
             <a:extLst xmlns:a="http://schemas.openxmlformats.org/drawingml/2006/main">
               <a:ext uri="{FF2B5EF4-FFF2-40B4-BE49-F238E27FC236}">
-                <a16:creationId xmlns:a16="http://schemas.microsoft.com/office/drawing/2014/main" id="{FF3EA0EC-63F7-4C8A-8F62-D10E79197E0C}"/>
+                <a16:creationId xmlns:a16="http://schemas.microsoft.com/office/drawing/2014/main" id="{51831EB8-D6D6-4570-9E20-EA515341DEED}"/>
               </a:ext>
             </a:extLst>
           </p:cNvPr>
@@ -2939,7 +2939,7 @@
           <p:cNvPr id="4" name="">
             <a:extLst xmlns:a="http://schemas.openxmlformats.org/drawingml/2006/main">
               <a:ext uri="{FF2B5EF4-FFF2-40B4-BE49-F238E27FC236}">
-                <a16:creationId xmlns:a16="http://schemas.microsoft.com/office/drawing/2014/main" id="{E12D44B8-26B8-404E-8B71-890467DD6843}"/>
+                <a16:creationId xmlns:a16="http://schemas.microsoft.com/office/drawing/2014/main" id="{5034AF73-D32A-4A42-A604-6D4261B9FFC4}"/>
               </a:ext>
             </a:extLst>
           </p:cNvPr>
@@ -3003,7 +3003,7 @@
           <p:cNvPr id="5" name="">
             <a:extLst xmlns:a="http://schemas.openxmlformats.org/drawingml/2006/main">
               <a:ext uri="{FF2B5EF4-FFF2-40B4-BE49-F238E27FC236}">
-                <a16:creationId xmlns:a16="http://schemas.microsoft.com/office/drawing/2014/main" id="{500E357E-68A4-4B1B-B75D-D5F4293B3CE1}"/>
+                <a16:creationId xmlns:a16="http://schemas.microsoft.com/office/drawing/2014/main" id="{2A09DB82-D53E-4B57-886C-6CA3C9D48DC9}"/>
               </a:ext>
             </a:extLst>
           </p:cNvPr>
@@ -3067,7 +3067,7 @@
           <p:cNvPr id="6" name="">
             <a:extLst xmlns:a="http://schemas.openxmlformats.org/drawingml/2006/main">
               <a:ext uri="{FF2B5EF4-FFF2-40B4-BE49-F238E27FC236}">
-                <a16:creationId xmlns:a16="http://schemas.microsoft.com/office/drawing/2014/main" id="{694CF6CF-2DD6-4A9F-9FD2-A753828A01A6}"/>
+                <a16:creationId xmlns:a16="http://schemas.microsoft.com/office/drawing/2014/main" id="{D8445569-57C0-4971-A722-BA39964E0C0E}"/>
               </a:ext>
             </a:extLst>
           </p:cNvPr>
@@ -3131,7 +3131,7 @@
           <p:cNvPr id="7" name="">
             <a:extLst xmlns:a="http://schemas.openxmlformats.org/drawingml/2006/main">
               <a:ext uri="{FF2B5EF4-FFF2-40B4-BE49-F238E27FC236}">
-                <a16:creationId xmlns:a16="http://schemas.microsoft.com/office/drawing/2014/main" id="{079B29C3-C599-4C7D-B5A2-B3F0F7694BE1}"/>
+                <a16:creationId xmlns:a16="http://schemas.microsoft.com/office/drawing/2014/main" id="{EB64DEE7-30A6-460F-9D8E-D2094FDACF9A}"/>
               </a:ext>
             </a:extLst>
           </p:cNvPr>
@@ -3164,7 +3164,7 @@
           <p:cNvPr id="8" name="">
             <a:extLst xmlns:a="http://schemas.openxmlformats.org/drawingml/2006/main">
               <a:ext uri="{FF2B5EF4-FFF2-40B4-BE49-F238E27FC236}">
-                <a16:creationId xmlns:a16="http://schemas.microsoft.com/office/drawing/2014/main" id="{423C4637-C9B0-4B16-83B2-920996CA388C}"/>
+                <a16:creationId xmlns:a16="http://schemas.microsoft.com/office/drawing/2014/main" id="{84EDB8C2-AEDF-4E71-AABF-FAD85CEFBC86}"/>
               </a:ext>
             </a:extLst>
           </p:cNvPr>
@@ -3228,7 +3228,7 @@
           <p:cNvPr id="9" name="">
             <a:extLst xmlns:a="http://schemas.openxmlformats.org/drawingml/2006/main">
               <a:ext uri="{FF2B5EF4-FFF2-40B4-BE49-F238E27FC236}">
-                <a16:creationId xmlns:a16="http://schemas.microsoft.com/office/drawing/2014/main" id="{E4C177C8-0FDE-455F-9B5D-332DA59ED7C7}"/>
+                <a16:creationId xmlns:a16="http://schemas.microsoft.com/office/drawing/2014/main" id="{9C681E64-94E2-4768-A947-C80C8AD0942B}"/>
               </a:ext>
             </a:extLst>
           </p:cNvPr>
@@ -3292,7 +3292,7 @@
           <p:cNvPr id="10" name="">
             <a:extLst xmlns:a="http://schemas.openxmlformats.org/drawingml/2006/main">
               <a:ext uri="{FF2B5EF4-FFF2-40B4-BE49-F238E27FC236}">
-                <a16:creationId xmlns:a16="http://schemas.microsoft.com/office/drawing/2014/main" id="{50B3468B-7072-4D9E-88D8-09DC198A0067}"/>
+                <a16:creationId xmlns:a16="http://schemas.microsoft.com/office/drawing/2014/main" id="{FB6CC27C-39DD-4100-AAE0-D5E7A1B10869}"/>
               </a:ext>
             </a:extLst>
           </p:cNvPr>
@@ -3325,7 +3325,7 @@
           <p:cNvPr id="11" name="">
             <a:extLst xmlns:a="http://schemas.openxmlformats.org/drawingml/2006/main">
               <a:ext uri="{FF2B5EF4-FFF2-40B4-BE49-F238E27FC236}">
-                <a16:creationId xmlns:a16="http://schemas.microsoft.com/office/drawing/2014/main" id="{CBD64003-DBC0-4FA4-A9B2-2A13533CDE5F}"/>
+                <a16:creationId xmlns:a16="http://schemas.microsoft.com/office/drawing/2014/main" id="{E28554D9-276F-489C-8AC6-56392DE78F54}"/>
               </a:ext>
             </a:extLst>
           </p:cNvPr>
@@ -3389,7 +3389,7 @@
           <p:cNvPr id="12" name="">
             <a:extLst xmlns:a="http://schemas.openxmlformats.org/drawingml/2006/main">
               <a:ext uri="{FF2B5EF4-FFF2-40B4-BE49-F238E27FC236}">
-                <a16:creationId xmlns:a16="http://schemas.microsoft.com/office/drawing/2014/main" id="{BCB7895C-5E40-45E8-9904-454DAB41B5BA}"/>
+                <a16:creationId xmlns:a16="http://schemas.microsoft.com/office/drawing/2014/main" id="{F77D02B4-264C-440D-9F2A-B65CE4836343}"/>
               </a:ext>
             </a:extLst>
           </p:cNvPr>
@@ -3443,7 +3443,7 @@
                 <a:ea typeface="Aptos"/>
                 <a:cs typeface="Aptos"/>
               </a:rPr>
-              <a:t>Real Sagents, physics verifier, RLVR scoring, resumable HITL, mesh model, AMD Gemma path.</a:t>
+              <a:t>Real Sagents/Horde failover, physical DECT NR+ proof, physics verifier, RLVR scoring, resumable HITL, and AMD Gemma path.</a:t>
             </a:r>
           </a:p>
         </p:txBody>
@@ -3453,7 +3453,7 @@
           <p:cNvPr id="13" name="">
             <a:extLst xmlns:a="http://schemas.openxmlformats.org/drawingml/2006/main">
               <a:ext uri="{FF2B5EF4-FFF2-40B4-BE49-F238E27FC236}">
-                <a16:creationId xmlns:a16="http://schemas.microsoft.com/office/drawing/2014/main" id="{F2298C40-8E3A-4BAE-94CB-6E412BA377DF}"/>
+                <a16:creationId xmlns:a16="http://schemas.microsoft.com/office/drawing/2014/main" id="{177F280A-466B-4633-A4EE-38EB9B7D0623}"/>
               </a:ext>
             </a:extLst>
           </p:cNvPr>
@@ -3486,7 +3486,7 @@
           <p:cNvPr id="14" name="">
             <a:extLst xmlns:a="http://schemas.openxmlformats.org/drawingml/2006/main">
               <a:ext uri="{FF2B5EF4-FFF2-40B4-BE49-F238E27FC236}">
-                <a16:creationId xmlns:a16="http://schemas.microsoft.com/office/drawing/2014/main" id="{865F23E2-D6AE-4E2A-935B-5E01F0E38FD3}"/>
+                <a16:creationId xmlns:a16="http://schemas.microsoft.com/office/drawing/2014/main" id="{59A17A1A-521E-4573-A384-FE5714E4FD5A}"/>
               </a:ext>
             </a:extLst>
           </p:cNvPr>
@@ -3550,7 +3550,7 @@
           <p:cNvPr id="15" name="">
             <a:extLst xmlns:a="http://schemas.openxmlformats.org/drawingml/2006/main">
               <a:ext uri="{FF2B5EF4-FFF2-40B4-BE49-F238E27FC236}">
-                <a16:creationId xmlns:a16="http://schemas.microsoft.com/office/drawing/2014/main" id="{18799F74-1D7D-4B76-8B9C-52F49CD7F38B}"/>
+                <a16:creationId xmlns:a16="http://schemas.microsoft.com/office/drawing/2014/main" id="{29A998F9-305D-499D-80A5-D02D20E1A560}"/>
               </a:ext>
             </a:extLst>
           </p:cNvPr>
@@ -3604,7 +3604,7 @@
                 <a:ea typeface="Aptos"/>
                 <a:cs typeface="Aptos"/>
               </a:rPr>
-              <a:t>Docker app, local Gemma E2B, five-agent loop, producer approval, and evidence packets.</a:t>
+              <a:t>Docker app, local Gemma E2B, five-agent loop, producer approval, and validated software plus hardware evidence packets.</a:t>
             </a:r>
           </a:p>
         </p:txBody>
@@ -3614,7 +3614,7 @@
           <p:cNvPr id="16" name="">
             <a:extLst xmlns:a="http://schemas.openxmlformats.org/drawingml/2006/main">
               <a:ext uri="{FF2B5EF4-FFF2-40B4-BE49-F238E27FC236}">
-                <a16:creationId xmlns:a16="http://schemas.microsoft.com/office/drawing/2014/main" id="{03087293-8BBC-4359-8D8C-73C8E83B7A3B}"/>
+                <a16:creationId xmlns:a16="http://schemas.microsoft.com/office/drawing/2014/main" id="{FC3B4E8B-3419-4FAC-892D-026C0FD804DF}"/>
               </a:ext>
             </a:extLst>
           </p:cNvPr>
@@ -3678,7 +3678,7 @@
           <p:cNvPr id="17" name="">
             <a:extLst xmlns:a="http://schemas.openxmlformats.org/drawingml/2006/main">
               <a:ext uri="{FF2B5EF4-FFF2-40B4-BE49-F238E27FC236}">
-                <a16:creationId xmlns:a16="http://schemas.microsoft.com/office/drawing/2014/main" id="{3BE8DF8A-7BB2-4CF1-9615-94B18F9373AA}"/>
+                <a16:creationId xmlns:a16="http://schemas.microsoft.com/office/drawing/2014/main" id="{3E86BFF8-EFE4-4894-927D-66204807310B}"/>
               </a:ext>
             </a:extLst>
           </p:cNvPr>
@@ -3742,7 +3742,7 @@
           <p:cNvPr id="18" name="">
             <a:extLst xmlns:a="http://schemas.openxmlformats.org/drawingml/2006/main">
               <a:ext uri="{FF2B5EF4-FFF2-40B4-BE49-F238E27FC236}">
-                <a16:creationId xmlns:a16="http://schemas.microsoft.com/office/drawing/2014/main" id="{F8727D72-22F7-4926-BB01-DCFDF1FFC7FC}"/>
+                <a16:creationId xmlns:a16="http://schemas.microsoft.com/office/drawing/2014/main" id="{B33279C7-3A75-4755-A3C9-5A420706B57D}"/>
               </a:ext>
             </a:extLst>
           </p:cNvPr>
@@ -3804,7 +3804,7 @@
     </p:spTree>
     <p:extLst>
       <p:ext uri="{BB962C8B-B14F-4D97-AF65-F5344CB8AC3E}">
-        <p14:creationId xmlns:p14="http://schemas.microsoft.com/office/powerpoint/2010/main" val="2011880339"/>
+        <p14:creationId xmlns:p14="http://schemas.microsoft.com/office/powerpoint/2010/main" val="1548881226"/>
       </p:ext>
     </p:extLst>
   </p:cSld>
@@ -3828,7 +3828,7 @@
           <p:cNvPr id="1" name="">
             <a:extLst xmlns:a="http://schemas.openxmlformats.org/drawingml/2006/main">
               <a:ext uri="{FF2B5EF4-FFF2-40B4-BE49-F238E27FC236}">
-                <a16:creationId xmlns:a16="http://schemas.microsoft.com/office/drawing/2014/main" id="{93A2A204-4D4D-4CBD-8EC8-FA708DE4EB48}"/>
+                <a16:creationId xmlns:a16="http://schemas.microsoft.com/office/drawing/2014/main" id="{B824BA34-37C1-470D-92EC-8FE5C86E873C}"/>
               </a:ext>
             </a:extLst>
           </p:cNvPr>
@@ -3863,7 +3863,7 @@
           <p:cNvPr id="2" name="">
             <a:extLst xmlns:a="http://schemas.openxmlformats.org/drawingml/2006/main">
               <a:ext uri="{FF2B5EF4-FFF2-40B4-BE49-F238E27FC236}">
-                <a16:creationId xmlns:a16="http://schemas.microsoft.com/office/drawing/2014/main" id="{5704AFA5-926F-42D0-82DC-C06C10E42074}"/>
+                <a16:creationId xmlns:a16="http://schemas.microsoft.com/office/drawing/2014/main" id="{6AC74423-12F7-4327-9DC0-B9BF68BBA344}"/>
               </a:ext>
             </a:extLst>
           </p:cNvPr>
@@ -3898,7 +3898,7 @@
           <p:cNvPr id="3" name="">
             <a:extLst xmlns:a="http://schemas.openxmlformats.org/drawingml/2006/main">
               <a:ext uri="{FF2B5EF4-FFF2-40B4-BE49-F238E27FC236}">
-                <a16:creationId xmlns:a16="http://schemas.microsoft.com/office/drawing/2014/main" id="{D91AEF6B-14A9-4167-91B8-17EDE89C7823}"/>
+                <a16:creationId xmlns:a16="http://schemas.microsoft.com/office/drawing/2014/main" id="{3EB0CFDE-4BDC-4C1D-A77B-AECB7172B22B}"/>
               </a:ext>
             </a:extLst>
           </p:cNvPr>
@@ -3962,7 +3962,7 @@
           <p:cNvPr id="4" name="">
             <a:extLst xmlns:a="http://schemas.openxmlformats.org/drawingml/2006/main">
               <a:ext uri="{FF2B5EF4-FFF2-40B4-BE49-F238E27FC236}">
-                <a16:creationId xmlns:a16="http://schemas.microsoft.com/office/drawing/2014/main" id="{2D4C5446-B025-4E7B-84F7-E3BAED11D477}"/>
+                <a16:creationId xmlns:a16="http://schemas.microsoft.com/office/drawing/2014/main" id="{75C6C2B7-79E8-4B46-AC96-6C33776B91C0}"/>
               </a:ext>
             </a:extLst>
           </p:cNvPr>
@@ -4026,7 +4026,7 @@
           <p:cNvPr id="5" name="">
             <a:extLst xmlns:a="http://schemas.openxmlformats.org/drawingml/2006/main">
               <a:ext uri="{FF2B5EF4-FFF2-40B4-BE49-F238E27FC236}">
-                <a16:creationId xmlns:a16="http://schemas.microsoft.com/office/drawing/2014/main" id="{8C1D8F2B-336A-4D12-A2B4-29CC7450B0C2}"/>
+                <a16:creationId xmlns:a16="http://schemas.microsoft.com/office/drawing/2014/main" id="{93FB6378-BD3C-485B-8D26-8E8B000ED84F}"/>
               </a:ext>
             </a:extLst>
           </p:cNvPr>
@@ -4090,7 +4090,7 @@
           <p:cNvPr id="6" name="">
             <a:extLst xmlns:a="http://schemas.openxmlformats.org/drawingml/2006/main">
               <a:ext uri="{FF2B5EF4-FFF2-40B4-BE49-F238E27FC236}">
-                <a16:creationId xmlns:a16="http://schemas.microsoft.com/office/drawing/2014/main" id="{4F738B84-BF9D-4F48-A2C9-7051671A56AF}"/>
+                <a16:creationId xmlns:a16="http://schemas.microsoft.com/office/drawing/2014/main" id="{80760C10-EED2-4EF1-BD10-783A49527F69}"/>
               </a:ext>
             </a:extLst>
           </p:cNvPr>
@@ -4154,7 +4154,7 @@
           <p:cNvPr id="7" name="">
             <a:extLst xmlns:a="http://schemas.openxmlformats.org/drawingml/2006/main">
               <a:ext uri="{FF2B5EF4-FFF2-40B4-BE49-F238E27FC236}">
-                <a16:creationId xmlns:a16="http://schemas.microsoft.com/office/drawing/2014/main" id="{2901D38A-CE71-42DA-A93D-F789D6C0443F}"/>
+                <a16:creationId xmlns:a16="http://schemas.microsoft.com/office/drawing/2014/main" id="{05A90D9E-2D09-4A95-B9B1-C621A0AB82B7}"/>
               </a:ext>
             </a:extLst>
           </p:cNvPr>
@@ -4187,7 +4187,7 @@
           <p:cNvPr id="8" name="">
             <a:extLst xmlns:a="http://schemas.openxmlformats.org/drawingml/2006/main">
               <a:ext uri="{FF2B5EF4-FFF2-40B4-BE49-F238E27FC236}">
-                <a16:creationId xmlns:a16="http://schemas.microsoft.com/office/drawing/2014/main" id="{A13804ED-C3D0-49FC-84C8-A390FA0CD0BE}"/>
+                <a16:creationId xmlns:a16="http://schemas.microsoft.com/office/drawing/2014/main" id="{392198F5-E2FF-45EB-97EE-2F432A80CD1A}"/>
               </a:ext>
             </a:extLst>
           </p:cNvPr>
@@ -4251,7 +4251,7 @@
           <p:cNvPr id="9" name="">
             <a:extLst xmlns:a="http://schemas.openxmlformats.org/drawingml/2006/main">
               <a:ext uri="{FF2B5EF4-FFF2-40B4-BE49-F238E27FC236}">
-                <a16:creationId xmlns:a16="http://schemas.microsoft.com/office/drawing/2014/main" id="{8302219D-D251-4B5C-81B0-5F03BA955102}"/>
+                <a16:creationId xmlns:a16="http://schemas.microsoft.com/office/drawing/2014/main" id="{49F56574-BA59-4849-A790-8E17CC7CEE3A}"/>
               </a:ext>
             </a:extLst>
           </p:cNvPr>
@@ -4315,7 +4315,7 @@
           <p:cNvPr id="10" name="">
             <a:extLst xmlns:a="http://schemas.openxmlformats.org/drawingml/2006/main">
               <a:ext uri="{FF2B5EF4-FFF2-40B4-BE49-F238E27FC236}">
-                <a16:creationId xmlns:a16="http://schemas.microsoft.com/office/drawing/2014/main" id="{C8175700-24B3-483D-9C97-7AEE747E7987}"/>
+                <a16:creationId xmlns:a16="http://schemas.microsoft.com/office/drawing/2014/main" id="{DE93DE26-C42A-461C-80AE-0B9EABBF1855}"/>
               </a:ext>
             </a:extLst>
           </p:cNvPr>
@@ -4348,7 +4348,7 @@
           <p:cNvPr id="11" name="">
             <a:extLst xmlns:a="http://schemas.openxmlformats.org/drawingml/2006/main">
               <a:ext uri="{FF2B5EF4-FFF2-40B4-BE49-F238E27FC236}">
-                <a16:creationId xmlns:a16="http://schemas.microsoft.com/office/drawing/2014/main" id="{BB81B3DB-D7B0-4D10-AEC5-BE534D97ED67}"/>
+                <a16:creationId xmlns:a16="http://schemas.microsoft.com/office/drawing/2014/main" id="{871D8B09-CAB4-45F6-BF0B-7057EB296058}"/>
               </a:ext>
             </a:extLst>
           </p:cNvPr>
@@ -4412,7 +4412,7 @@
           <p:cNvPr id="12" name="">
             <a:extLst xmlns:a="http://schemas.openxmlformats.org/drawingml/2006/main">
               <a:ext uri="{FF2B5EF4-FFF2-40B4-BE49-F238E27FC236}">
-                <a16:creationId xmlns:a16="http://schemas.microsoft.com/office/drawing/2014/main" id="{F1DE2C82-5F3F-4438-9E6E-EEB4E5DFC7B3}"/>
+                <a16:creationId xmlns:a16="http://schemas.microsoft.com/office/drawing/2014/main" id="{BDBD3BF4-7F77-4333-A00D-921994C65EE4}"/>
               </a:ext>
             </a:extLst>
           </p:cNvPr>
@@ -4476,7 +4476,7 @@
           <p:cNvPr id="13" name="">
             <a:extLst xmlns:a="http://schemas.openxmlformats.org/drawingml/2006/main">
               <a:ext uri="{FF2B5EF4-FFF2-40B4-BE49-F238E27FC236}">
-                <a16:creationId xmlns:a16="http://schemas.microsoft.com/office/drawing/2014/main" id="{33A1F405-6C2D-4171-9BEB-776C57080545}"/>
+                <a16:creationId xmlns:a16="http://schemas.microsoft.com/office/drawing/2014/main" id="{D069A888-38EA-4153-B910-AD3B3A9AF977}"/>
               </a:ext>
             </a:extLst>
           </p:cNvPr>
@@ -4509,7 +4509,7 @@
           <p:cNvPr id="14" name="">
             <a:extLst xmlns:a="http://schemas.openxmlformats.org/drawingml/2006/main">
               <a:ext uri="{FF2B5EF4-FFF2-40B4-BE49-F238E27FC236}">
-                <a16:creationId xmlns:a16="http://schemas.microsoft.com/office/drawing/2014/main" id="{3A0D0651-332C-446A-BF67-858D8FCC799B}"/>
+                <a16:creationId xmlns:a16="http://schemas.microsoft.com/office/drawing/2014/main" id="{A58D91A6-D45A-48C1-847B-CCCF0C169E91}"/>
               </a:ext>
             </a:extLst>
           </p:cNvPr>
@@ -4573,7 +4573,7 @@
           <p:cNvPr id="15" name="">
             <a:extLst xmlns:a="http://schemas.openxmlformats.org/drawingml/2006/main">
               <a:ext uri="{FF2B5EF4-FFF2-40B4-BE49-F238E27FC236}">
-                <a16:creationId xmlns:a16="http://schemas.microsoft.com/office/drawing/2014/main" id="{7081D0BF-5F88-4D80-A18E-89E491514DBA}"/>
+                <a16:creationId xmlns:a16="http://schemas.microsoft.com/office/drawing/2014/main" id="{DA9CCEBF-583A-4789-ABA5-85C5B73D8D8B}"/>
               </a:ext>
             </a:extLst>
           </p:cNvPr>
@@ -4637,7 +4637,7 @@
           <p:cNvPr id="16" name="">
             <a:extLst xmlns:a="http://schemas.openxmlformats.org/drawingml/2006/main">
               <a:ext uri="{FF2B5EF4-FFF2-40B4-BE49-F238E27FC236}">
-                <a16:creationId xmlns:a16="http://schemas.microsoft.com/office/drawing/2014/main" id="{752D3BBB-8359-413F-98EF-51631B034346}"/>
+                <a16:creationId xmlns:a16="http://schemas.microsoft.com/office/drawing/2014/main" id="{B6275766-1940-4568-9153-69B6E94750A3}"/>
               </a:ext>
             </a:extLst>
           </p:cNvPr>
@@ -4701,7 +4701,7 @@
           <p:cNvPr id="17" name="">
             <a:extLst xmlns:a="http://schemas.openxmlformats.org/drawingml/2006/main">
               <a:ext uri="{FF2B5EF4-FFF2-40B4-BE49-F238E27FC236}">
-                <a16:creationId xmlns:a16="http://schemas.microsoft.com/office/drawing/2014/main" id="{EDAE304D-3BDB-486E-8873-88E0E20A312D}"/>
+                <a16:creationId xmlns:a16="http://schemas.microsoft.com/office/drawing/2014/main" id="{3484E6CA-2937-4938-8745-31C01D521188}"/>
               </a:ext>
             </a:extLst>
           </p:cNvPr>
@@ -4763,7 +4763,7 @@
     </p:spTree>
     <p:extLst>
       <p:ext uri="{BB962C8B-B14F-4D97-AF65-F5344CB8AC3E}">
-        <p14:creationId xmlns:p14="http://schemas.microsoft.com/office/powerpoint/2010/main" val="1517068359"/>
+        <p14:creationId xmlns:p14="http://schemas.microsoft.com/office/powerpoint/2010/main" val="897188182"/>
       </p:ext>
     </p:extLst>
   </p:cSld>
@@ -4787,7 +4787,7 @@
           <p:cNvPr id="1" name="">
             <a:extLst xmlns:a="http://schemas.openxmlformats.org/drawingml/2006/main">
               <a:ext uri="{FF2B5EF4-FFF2-40B4-BE49-F238E27FC236}">
-                <a16:creationId xmlns:a16="http://schemas.microsoft.com/office/drawing/2014/main" id="{BD19B0E2-4DE5-43EF-9FE4-A92AE37A3438}"/>
+                <a16:creationId xmlns:a16="http://schemas.microsoft.com/office/drawing/2014/main" id="{603FD5DB-E09E-4F39-9DEC-3BDC9A02B400}"/>
               </a:ext>
             </a:extLst>
           </p:cNvPr>
@@ -4822,7 +4822,7 @@
           <p:cNvPr id="2" name="">
             <a:extLst xmlns:a="http://schemas.openxmlformats.org/drawingml/2006/main">
               <a:ext uri="{FF2B5EF4-FFF2-40B4-BE49-F238E27FC236}">
-                <a16:creationId xmlns:a16="http://schemas.microsoft.com/office/drawing/2014/main" id="{A18A1298-446E-483F-9C73-A5A4832893EB}"/>
+                <a16:creationId xmlns:a16="http://schemas.microsoft.com/office/drawing/2014/main" id="{1FF482FD-A220-4899-A026-D3B3A973194F}"/>
               </a:ext>
             </a:extLst>
           </p:cNvPr>
@@ -4857,7 +4857,7 @@
           <p:cNvPr id="3" name="">
             <a:extLst xmlns:a="http://schemas.openxmlformats.org/drawingml/2006/main">
               <a:ext uri="{FF2B5EF4-FFF2-40B4-BE49-F238E27FC236}">
-                <a16:creationId xmlns:a16="http://schemas.microsoft.com/office/drawing/2014/main" id="{B734211C-2A27-43D0-B050-D0CF7AEE274E}"/>
+                <a16:creationId xmlns:a16="http://schemas.microsoft.com/office/drawing/2014/main" id="{4A1CDC33-A1E6-4935-9C53-21A6077DF829}"/>
               </a:ext>
             </a:extLst>
           </p:cNvPr>
@@ -4921,7 +4921,7 @@
           <p:cNvPr id="4" name="">
             <a:extLst xmlns:a="http://schemas.openxmlformats.org/drawingml/2006/main">
               <a:ext uri="{FF2B5EF4-FFF2-40B4-BE49-F238E27FC236}">
-                <a16:creationId xmlns:a16="http://schemas.microsoft.com/office/drawing/2014/main" id="{6A9DAD3C-9901-4C0B-8277-801AE241CB01}"/>
+                <a16:creationId xmlns:a16="http://schemas.microsoft.com/office/drawing/2014/main" id="{5168B6B5-45C5-4BD6-AC05-5B3ACE3041FA}"/>
               </a:ext>
             </a:extLst>
           </p:cNvPr>
@@ -4985,7 +4985,7 @@
           <p:cNvPr id="5" name="">
             <a:extLst xmlns:a="http://schemas.openxmlformats.org/drawingml/2006/main">
               <a:ext uri="{FF2B5EF4-FFF2-40B4-BE49-F238E27FC236}">
-                <a16:creationId xmlns:a16="http://schemas.microsoft.com/office/drawing/2014/main" id="{013F0C4B-B657-48B0-AD2B-5355C5B359DF}"/>
+                <a16:creationId xmlns:a16="http://schemas.microsoft.com/office/drawing/2014/main" id="{D576BECE-509C-494E-8E6A-7D257F1DDC8F}"/>
               </a:ext>
             </a:extLst>
           </p:cNvPr>
@@ -5049,7 +5049,7 @@
           <p:cNvPr id="6" name="">
             <a:extLst xmlns:a="http://schemas.openxmlformats.org/drawingml/2006/main">
               <a:ext uri="{FF2B5EF4-FFF2-40B4-BE49-F238E27FC236}">
-                <a16:creationId xmlns:a16="http://schemas.microsoft.com/office/drawing/2014/main" id="{B4999F5E-ED3E-4324-9D83-16EDB9C939CD}"/>
+                <a16:creationId xmlns:a16="http://schemas.microsoft.com/office/drawing/2014/main" id="{CCE76841-D8AE-443C-99A3-90847E8D1B43}"/>
               </a:ext>
             </a:extLst>
           </p:cNvPr>
@@ -5113,7 +5113,7 @@
           <p:cNvPr id="7" name="">
             <a:extLst xmlns:a="http://schemas.openxmlformats.org/drawingml/2006/main">
               <a:ext uri="{FF2B5EF4-FFF2-40B4-BE49-F238E27FC236}">
-                <a16:creationId xmlns:a16="http://schemas.microsoft.com/office/drawing/2014/main" id="{621C5141-E256-4555-9EC8-E9495202A152}"/>
+                <a16:creationId xmlns:a16="http://schemas.microsoft.com/office/drawing/2014/main" id="{56CC1CA6-1852-4544-9765-6D09933C780A}"/>
               </a:ext>
             </a:extLst>
           </p:cNvPr>
@@ -5146,7 +5146,7 @@
           <p:cNvPr id="8" name="">
             <a:extLst xmlns:a="http://schemas.openxmlformats.org/drawingml/2006/main">
               <a:ext uri="{FF2B5EF4-FFF2-40B4-BE49-F238E27FC236}">
-                <a16:creationId xmlns:a16="http://schemas.microsoft.com/office/drawing/2014/main" id="{BF10B47C-6D82-4C45-AEB7-38D396B3C4EF}"/>
+                <a16:creationId xmlns:a16="http://schemas.microsoft.com/office/drawing/2014/main" id="{56AC5122-3D87-42A7-9603-BC096D4E594A}"/>
               </a:ext>
             </a:extLst>
           </p:cNvPr>
@@ -5210,7 +5210,7 @@
           <p:cNvPr id="9" name="">
             <a:extLst xmlns:a="http://schemas.openxmlformats.org/drawingml/2006/main">
               <a:ext uri="{FF2B5EF4-FFF2-40B4-BE49-F238E27FC236}">
-                <a16:creationId xmlns:a16="http://schemas.microsoft.com/office/drawing/2014/main" id="{15569BD4-221A-40C5-8390-0E4BCCE0C1F7}"/>
+                <a16:creationId xmlns:a16="http://schemas.microsoft.com/office/drawing/2014/main" id="{B02F5887-DCE2-4C08-870D-F2F0A77DE536}"/>
               </a:ext>
             </a:extLst>
           </p:cNvPr>
@@ -5274,7 +5274,7 @@
           <p:cNvPr id="10" name="">
             <a:extLst xmlns:a="http://schemas.openxmlformats.org/drawingml/2006/main">
               <a:ext uri="{FF2B5EF4-FFF2-40B4-BE49-F238E27FC236}">
-                <a16:creationId xmlns:a16="http://schemas.microsoft.com/office/drawing/2014/main" id="{7B583500-4581-4B11-8E40-B9FD5DCE0B7F}"/>
+                <a16:creationId xmlns:a16="http://schemas.microsoft.com/office/drawing/2014/main" id="{D20B6359-53DB-44C5-9BE9-2D88483ED3E1}"/>
               </a:ext>
             </a:extLst>
           </p:cNvPr>
@@ -5338,7 +5338,7 @@
           <p:cNvPr id="11" name="">
             <a:extLst xmlns:a="http://schemas.openxmlformats.org/drawingml/2006/main">
               <a:ext uri="{FF2B5EF4-FFF2-40B4-BE49-F238E27FC236}">
-                <a16:creationId xmlns:a16="http://schemas.microsoft.com/office/drawing/2014/main" id="{6F0C6D40-A878-4129-A53F-993BD2164C0A}"/>
+                <a16:creationId xmlns:a16="http://schemas.microsoft.com/office/drawing/2014/main" id="{A1189062-1241-43E8-A3EE-2618421B777E}"/>
               </a:ext>
             </a:extLst>
           </p:cNvPr>
@@ -5371,7 +5371,7 @@
           <p:cNvPr id="12" name="">
             <a:extLst xmlns:a="http://schemas.openxmlformats.org/drawingml/2006/main">
               <a:ext uri="{FF2B5EF4-FFF2-40B4-BE49-F238E27FC236}">
-                <a16:creationId xmlns:a16="http://schemas.microsoft.com/office/drawing/2014/main" id="{7C0F9D5D-D554-4B2C-9217-EBEC37271C01}"/>
+                <a16:creationId xmlns:a16="http://schemas.microsoft.com/office/drawing/2014/main" id="{758DC3F3-918D-4816-8298-4073F7F1E883}"/>
               </a:ext>
             </a:extLst>
           </p:cNvPr>
@@ -5435,7 +5435,7 @@
           <p:cNvPr id="13" name="">
             <a:extLst xmlns:a="http://schemas.openxmlformats.org/drawingml/2006/main">
               <a:ext uri="{FF2B5EF4-FFF2-40B4-BE49-F238E27FC236}">
-                <a16:creationId xmlns:a16="http://schemas.microsoft.com/office/drawing/2014/main" id="{43F7E004-D654-4E2D-B83A-F3C462FE4152}"/>
+                <a16:creationId xmlns:a16="http://schemas.microsoft.com/office/drawing/2014/main" id="{DF2CC726-37D7-41EE-97F3-364DCF7A4EE6}"/>
               </a:ext>
             </a:extLst>
           </p:cNvPr>
@@ -5499,7 +5499,7 @@
           <p:cNvPr id="14" name="">
             <a:extLst xmlns:a="http://schemas.openxmlformats.org/drawingml/2006/main">
               <a:ext uri="{FF2B5EF4-FFF2-40B4-BE49-F238E27FC236}">
-                <a16:creationId xmlns:a16="http://schemas.microsoft.com/office/drawing/2014/main" id="{8A92EA54-58F0-44B8-AA18-5CF27D7ABFD0}"/>
+                <a16:creationId xmlns:a16="http://schemas.microsoft.com/office/drawing/2014/main" id="{ECF789A2-0105-4EAB-9CBA-47E10BEF0F10}"/>
               </a:ext>
             </a:extLst>
           </p:cNvPr>
@@ -5563,7 +5563,7 @@
           <p:cNvPr id="15" name="">
             <a:extLst xmlns:a="http://schemas.openxmlformats.org/drawingml/2006/main">
               <a:ext uri="{FF2B5EF4-FFF2-40B4-BE49-F238E27FC236}">
-                <a16:creationId xmlns:a16="http://schemas.microsoft.com/office/drawing/2014/main" id="{DB205B4D-6169-486C-B1C5-295E1129BD7F}"/>
+                <a16:creationId xmlns:a16="http://schemas.microsoft.com/office/drawing/2014/main" id="{B7426D1C-64FC-47B3-975E-6F88AC819455}"/>
               </a:ext>
             </a:extLst>
           </p:cNvPr>
@@ -5596,7 +5596,7 @@
           <p:cNvPr id="16" name="">
             <a:extLst xmlns:a="http://schemas.openxmlformats.org/drawingml/2006/main">
               <a:ext uri="{FF2B5EF4-FFF2-40B4-BE49-F238E27FC236}">
-                <a16:creationId xmlns:a16="http://schemas.microsoft.com/office/drawing/2014/main" id="{38D36E0E-779A-4B36-9CB1-F8E97539F325}"/>
+                <a16:creationId xmlns:a16="http://schemas.microsoft.com/office/drawing/2014/main" id="{C835B5B9-0A77-4393-8473-4E9E993D5B34}"/>
               </a:ext>
             </a:extLst>
           </p:cNvPr>
@@ -5660,7 +5660,7 @@
           <p:cNvPr id="17" name="">
             <a:extLst xmlns:a="http://schemas.openxmlformats.org/drawingml/2006/main">
               <a:ext uri="{FF2B5EF4-FFF2-40B4-BE49-F238E27FC236}">
-                <a16:creationId xmlns:a16="http://schemas.microsoft.com/office/drawing/2014/main" id="{EE67A029-5014-4DF1-9B17-B9D04446BD1B}"/>
+                <a16:creationId xmlns:a16="http://schemas.microsoft.com/office/drawing/2014/main" id="{04E269CA-6734-4C5D-991F-89C629D6722C}"/>
               </a:ext>
             </a:extLst>
           </p:cNvPr>
@@ -5724,7 +5724,7 @@
           <p:cNvPr id="18" name="">
             <a:extLst xmlns:a="http://schemas.openxmlformats.org/drawingml/2006/main">
               <a:ext uri="{FF2B5EF4-FFF2-40B4-BE49-F238E27FC236}">
-                <a16:creationId xmlns:a16="http://schemas.microsoft.com/office/drawing/2014/main" id="{B1A36A4C-B5E0-4198-949F-4076AA4A51D6}"/>
+                <a16:creationId xmlns:a16="http://schemas.microsoft.com/office/drawing/2014/main" id="{250773C4-B1A6-44BF-82F6-E59FA245F808}"/>
               </a:ext>
             </a:extLst>
           </p:cNvPr>
@@ -5788,7 +5788,7 @@
           <p:cNvPr id="19" name="">
             <a:extLst xmlns:a="http://schemas.openxmlformats.org/drawingml/2006/main">
               <a:ext uri="{FF2B5EF4-FFF2-40B4-BE49-F238E27FC236}">
-                <a16:creationId xmlns:a16="http://schemas.microsoft.com/office/drawing/2014/main" id="{3C5D6C47-82C5-4768-9BE1-0871682BB4A8}"/>
+                <a16:creationId xmlns:a16="http://schemas.microsoft.com/office/drawing/2014/main" id="{E2C35C22-4101-4E32-95E7-F52E0BB16E0D}"/>
               </a:ext>
             </a:extLst>
           </p:cNvPr>
@@ -5821,7 +5821,7 @@
           <p:cNvPr id="20" name="">
             <a:extLst xmlns:a="http://schemas.openxmlformats.org/drawingml/2006/main">
               <a:ext uri="{FF2B5EF4-FFF2-40B4-BE49-F238E27FC236}">
-                <a16:creationId xmlns:a16="http://schemas.microsoft.com/office/drawing/2014/main" id="{4FC63DB1-336A-4927-A3EE-D8649700CF79}"/>
+                <a16:creationId xmlns:a16="http://schemas.microsoft.com/office/drawing/2014/main" id="{49B94595-65AA-425D-B3DB-F93B63FD8C43}"/>
               </a:ext>
             </a:extLst>
           </p:cNvPr>
@@ -5885,7 +5885,7 @@
           <p:cNvPr id="21" name="">
             <a:extLst xmlns:a="http://schemas.openxmlformats.org/drawingml/2006/main">
               <a:ext uri="{FF2B5EF4-FFF2-40B4-BE49-F238E27FC236}">
-                <a16:creationId xmlns:a16="http://schemas.microsoft.com/office/drawing/2014/main" id="{BA1EF492-CCD5-4EC6-916F-CC24CF42E990}"/>
+                <a16:creationId xmlns:a16="http://schemas.microsoft.com/office/drawing/2014/main" id="{7835A133-AC0D-4086-98DE-626FB185B5AF}"/>
               </a:ext>
             </a:extLst>
           </p:cNvPr>
@@ -5949,7 +5949,7 @@
           <p:cNvPr id="22" name="">
             <a:extLst xmlns:a="http://schemas.openxmlformats.org/drawingml/2006/main">
               <a:ext uri="{FF2B5EF4-FFF2-40B4-BE49-F238E27FC236}">
-                <a16:creationId xmlns:a16="http://schemas.microsoft.com/office/drawing/2014/main" id="{068BC411-DFC2-4519-AF5B-8DE31E333109}"/>
+                <a16:creationId xmlns:a16="http://schemas.microsoft.com/office/drawing/2014/main" id="{70C4210B-2257-470C-8D66-E0AAD176DB93}"/>
               </a:ext>
             </a:extLst>
           </p:cNvPr>
@@ -5982,7 +5982,7 @@
           <p:cNvPr id="23" name="">
             <a:extLst xmlns:a="http://schemas.openxmlformats.org/drawingml/2006/main">
               <a:ext uri="{FF2B5EF4-FFF2-40B4-BE49-F238E27FC236}">
-                <a16:creationId xmlns:a16="http://schemas.microsoft.com/office/drawing/2014/main" id="{F8412D12-1134-43FC-B1DA-0FD55448DE02}"/>
+                <a16:creationId xmlns:a16="http://schemas.microsoft.com/office/drawing/2014/main" id="{AAD0EDE8-4F08-4AC3-96B8-2F027738AB31}"/>
               </a:ext>
             </a:extLst>
           </p:cNvPr>
@@ -6046,7 +6046,7 @@
           <p:cNvPr id="24" name="">
             <a:extLst xmlns:a="http://schemas.openxmlformats.org/drawingml/2006/main">
               <a:ext uri="{FF2B5EF4-FFF2-40B4-BE49-F238E27FC236}">
-                <a16:creationId xmlns:a16="http://schemas.microsoft.com/office/drawing/2014/main" id="{37617875-1F18-4151-B5C5-B1FD40F9FDD9}"/>
+                <a16:creationId xmlns:a16="http://schemas.microsoft.com/office/drawing/2014/main" id="{93D8061D-2948-44E9-BAB7-2D3F3F227081}"/>
               </a:ext>
             </a:extLst>
           </p:cNvPr>
@@ -6110,7 +6110,7 @@
           <p:cNvPr id="25" name="">
             <a:extLst xmlns:a="http://schemas.openxmlformats.org/drawingml/2006/main">
               <a:ext uri="{FF2B5EF4-FFF2-40B4-BE49-F238E27FC236}">
-                <a16:creationId xmlns:a16="http://schemas.microsoft.com/office/drawing/2014/main" id="{F6BB822E-CC2C-4BDC-B6AD-1E1E7E3111E7}"/>
+                <a16:creationId xmlns:a16="http://schemas.microsoft.com/office/drawing/2014/main" id="{37FE00A9-1458-464A-9576-38C4B0D812DC}"/>
               </a:ext>
             </a:extLst>
           </p:cNvPr>
@@ -6174,7 +6174,7 @@
           <p:cNvPr id="26" name="">
             <a:extLst xmlns:a="http://schemas.openxmlformats.org/drawingml/2006/main">
               <a:ext uri="{FF2B5EF4-FFF2-40B4-BE49-F238E27FC236}">
-                <a16:creationId xmlns:a16="http://schemas.microsoft.com/office/drawing/2014/main" id="{F21D0AC7-EE46-4008-9490-7C5ABE4B02DB}"/>
+                <a16:creationId xmlns:a16="http://schemas.microsoft.com/office/drawing/2014/main" id="{9E3E255F-CD55-4C4B-90C9-CC3FCFCA0D04}"/>
               </a:ext>
             </a:extLst>
           </p:cNvPr>
@@ -6236,7 +6236,7 @@
     </p:spTree>
     <p:extLst>
       <p:ext uri="{BB962C8B-B14F-4D97-AF65-F5344CB8AC3E}">
-        <p14:creationId xmlns:p14="http://schemas.microsoft.com/office/powerpoint/2010/main" val="1551004395"/>
+        <p14:creationId xmlns:p14="http://schemas.microsoft.com/office/powerpoint/2010/main" val="1786097367"/>
       </p:ext>
     </p:extLst>
   </p:cSld>
@@ -6260,7 +6260,7 @@
           <p:cNvPr id="1" name="">
             <a:extLst xmlns:a="http://schemas.openxmlformats.org/drawingml/2006/main">
               <a:ext uri="{FF2B5EF4-FFF2-40B4-BE49-F238E27FC236}">
-                <a16:creationId xmlns:a16="http://schemas.microsoft.com/office/drawing/2014/main" id="{B84A1E0F-A0EF-4EBB-A5A8-D3FAE22AE6FA}"/>
+                <a16:creationId xmlns:a16="http://schemas.microsoft.com/office/drawing/2014/main" id="{FCF8E545-6C4E-4BBD-9F6F-728A5BDDADE2}"/>
               </a:ext>
             </a:extLst>
           </p:cNvPr>
@@ -6295,7 +6295,7 @@
           <p:cNvPr id="2" name="">
             <a:extLst xmlns:a="http://schemas.openxmlformats.org/drawingml/2006/main">
               <a:ext uri="{FF2B5EF4-FFF2-40B4-BE49-F238E27FC236}">
-                <a16:creationId xmlns:a16="http://schemas.microsoft.com/office/drawing/2014/main" id="{16B2044C-7187-4B1F-A5A3-2A5E5DD70B01}"/>
+                <a16:creationId xmlns:a16="http://schemas.microsoft.com/office/drawing/2014/main" id="{3E3A6E69-B082-486A-AB22-49E165C174E9}"/>
               </a:ext>
             </a:extLst>
           </p:cNvPr>
@@ -6330,7 +6330,7 @@
           <p:cNvPr id="3" name="">
             <a:extLst xmlns:a="http://schemas.openxmlformats.org/drawingml/2006/main">
               <a:ext uri="{FF2B5EF4-FFF2-40B4-BE49-F238E27FC236}">
-                <a16:creationId xmlns:a16="http://schemas.microsoft.com/office/drawing/2014/main" id="{32F39198-2FDD-4FEB-B8E4-313917C71C91}"/>
+                <a16:creationId xmlns:a16="http://schemas.microsoft.com/office/drawing/2014/main" id="{E234C039-1F19-4DA4-BD2A-044290E24172}"/>
               </a:ext>
             </a:extLst>
           </p:cNvPr>
@@ -6394,7 +6394,7 @@
           <p:cNvPr id="4" name="">
             <a:extLst xmlns:a="http://schemas.openxmlformats.org/drawingml/2006/main">
               <a:ext uri="{FF2B5EF4-FFF2-40B4-BE49-F238E27FC236}">
-                <a16:creationId xmlns:a16="http://schemas.microsoft.com/office/drawing/2014/main" id="{BD4576CA-0733-4130-B175-EB4CF8BFC411}"/>
+                <a16:creationId xmlns:a16="http://schemas.microsoft.com/office/drawing/2014/main" id="{BBC66D80-B521-4428-8EB7-D5AE9BD73688}"/>
               </a:ext>
             </a:extLst>
           </p:cNvPr>
@@ -6458,7 +6458,7 @@
           <p:cNvPr id="5" name="">
             <a:extLst xmlns:a="http://schemas.openxmlformats.org/drawingml/2006/main">
               <a:ext uri="{FF2B5EF4-FFF2-40B4-BE49-F238E27FC236}">
-                <a16:creationId xmlns:a16="http://schemas.microsoft.com/office/drawing/2014/main" id="{77DC2302-232F-46AC-B7E5-B0A24546D93D}"/>
+                <a16:creationId xmlns:a16="http://schemas.microsoft.com/office/drawing/2014/main" id="{1D46D31F-BBA6-4CAC-ABEA-E38C3D0EA5A0}"/>
               </a:ext>
             </a:extLst>
           </p:cNvPr>
@@ -6522,7 +6522,7 @@
           <p:cNvPr id="6" name="">
             <a:extLst xmlns:a="http://schemas.openxmlformats.org/drawingml/2006/main">
               <a:ext uri="{FF2B5EF4-FFF2-40B4-BE49-F238E27FC236}">
-                <a16:creationId xmlns:a16="http://schemas.microsoft.com/office/drawing/2014/main" id="{1201A519-EAB1-4E8A-A397-6C2A2A307F9B}"/>
+                <a16:creationId xmlns:a16="http://schemas.microsoft.com/office/drawing/2014/main" id="{391FFE52-20AB-4B80-8B64-407F14EEDFCA}"/>
               </a:ext>
             </a:extLst>
           </p:cNvPr>
@@ -6586,7 +6586,7 @@
           <p:cNvPr id="7" name="">
             <a:extLst xmlns:a="http://schemas.openxmlformats.org/drawingml/2006/main">
               <a:ext uri="{FF2B5EF4-FFF2-40B4-BE49-F238E27FC236}">
-                <a16:creationId xmlns:a16="http://schemas.microsoft.com/office/drawing/2014/main" id="{7E7BA54C-CE9D-405F-91D6-FA543749421B}"/>
+                <a16:creationId xmlns:a16="http://schemas.microsoft.com/office/drawing/2014/main" id="{5C99053C-59F9-4AC6-84DA-ECA6D256EED9}"/>
               </a:ext>
             </a:extLst>
           </p:cNvPr>
@@ -6619,7 +6619,7 @@
           <p:cNvPr id="8" name="">
             <a:extLst xmlns:a="http://schemas.openxmlformats.org/drawingml/2006/main">
               <a:ext uri="{FF2B5EF4-FFF2-40B4-BE49-F238E27FC236}">
-                <a16:creationId xmlns:a16="http://schemas.microsoft.com/office/drawing/2014/main" id="{81B4F7C9-BE4B-47DD-87B9-1026D8B05C2D}"/>
+                <a16:creationId xmlns:a16="http://schemas.microsoft.com/office/drawing/2014/main" id="{6D8E75BA-8849-459C-9D2C-585A0958A43C}"/>
               </a:ext>
             </a:extLst>
           </p:cNvPr>
@@ -6683,7 +6683,7 @@
           <p:cNvPr id="9" name="">
             <a:extLst xmlns:a="http://schemas.openxmlformats.org/drawingml/2006/main">
               <a:ext uri="{FF2B5EF4-FFF2-40B4-BE49-F238E27FC236}">
-                <a16:creationId xmlns:a16="http://schemas.microsoft.com/office/drawing/2014/main" id="{8EA1FAAE-99DD-450A-A33D-A7668D5FBC30}"/>
+                <a16:creationId xmlns:a16="http://schemas.microsoft.com/office/drawing/2014/main" id="{869693A5-1D64-4EC3-A16B-C6509F811778}"/>
               </a:ext>
             </a:extLst>
           </p:cNvPr>
@@ -6747,7 +6747,7 @@
           <p:cNvPr id="10" name="">
             <a:extLst xmlns:a="http://schemas.openxmlformats.org/drawingml/2006/main">
               <a:ext uri="{FF2B5EF4-FFF2-40B4-BE49-F238E27FC236}">
-                <a16:creationId xmlns:a16="http://schemas.microsoft.com/office/drawing/2014/main" id="{E1FEAA79-C900-4FAA-ADA9-502DB52BD1C8}"/>
+                <a16:creationId xmlns:a16="http://schemas.microsoft.com/office/drawing/2014/main" id="{04C936EC-985A-4A59-8E9A-34086060187E}"/>
               </a:ext>
             </a:extLst>
           </p:cNvPr>
@@ -6811,7 +6811,7 @@
           <p:cNvPr id="11" name="">
             <a:extLst xmlns:a="http://schemas.openxmlformats.org/drawingml/2006/main">
               <a:ext uri="{FF2B5EF4-FFF2-40B4-BE49-F238E27FC236}">
-                <a16:creationId xmlns:a16="http://schemas.microsoft.com/office/drawing/2014/main" id="{D50F4D77-25B5-4981-85B6-303B750877A2}"/>
+                <a16:creationId xmlns:a16="http://schemas.microsoft.com/office/drawing/2014/main" id="{5C77E912-BD0F-4150-91AB-2756D4538E8E}"/>
               </a:ext>
             </a:extLst>
           </p:cNvPr>
@@ -6844,7 +6844,7 @@
           <p:cNvPr id="12" name="">
             <a:extLst xmlns:a="http://schemas.openxmlformats.org/drawingml/2006/main">
               <a:ext uri="{FF2B5EF4-FFF2-40B4-BE49-F238E27FC236}">
-                <a16:creationId xmlns:a16="http://schemas.microsoft.com/office/drawing/2014/main" id="{1B081FDC-7DE8-4C38-A78D-F090644AA727}"/>
+                <a16:creationId xmlns:a16="http://schemas.microsoft.com/office/drawing/2014/main" id="{FA8FE8BF-CC13-405F-A802-125971637CCB}"/>
               </a:ext>
             </a:extLst>
           </p:cNvPr>
@@ -6908,7 +6908,7 @@
           <p:cNvPr id="13" name="">
             <a:extLst xmlns:a="http://schemas.openxmlformats.org/drawingml/2006/main">
               <a:ext uri="{FF2B5EF4-FFF2-40B4-BE49-F238E27FC236}">
-                <a16:creationId xmlns:a16="http://schemas.microsoft.com/office/drawing/2014/main" id="{D1B54F09-CCAC-472E-AD14-A574927CFB8E}"/>
+                <a16:creationId xmlns:a16="http://schemas.microsoft.com/office/drawing/2014/main" id="{479FE342-C441-4510-A257-A0C1ED298334}"/>
               </a:ext>
             </a:extLst>
           </p:cNvPr>
@@ -6972,7 +6972,7 @@
           <p:cNvPr id="14" name="">
             <a:extLst xmlns:a="http://schemas.openxmlformats.org/drawingml/2006/main">
               <a:ext uri="{FF2B5EF4-FFF2-40B4-BE49-F238E27FC236}">
-                <a16:creationId xmlns:a16="http://schemas.microsoft.com/office/drawing/2014/main" id="{2EDDF161-C803-4563-9A56-01CEA21586F7}"/>
+                <a16:creationId xmlns:a16="http://schemas.microsoft.com/office/drawing/2014/main" id="{44D4E852-61CB-49E4-B4E4-9C78AF1880F2}"/>
               </a:ext>
             </a:extLst>
           </p:cNvPr>
@@ -7036,7 +7036,7 @@
           <p:cNvPr id="15" name="">
             <a:extLst xmlns:a="http://schemas.openxmlformats.org/drawingml/2006/main">
               <a:ext uri="{FF2B5EF4-FFF2-40B4-BE49-F238E27FC236}">
-                <a16:creationId xmlns:a16="http://schemas.microsoft.com/office/drawing/2014/main" id="{0636609C-60E2-4966-8FE4-06A52DE82C7C}"/>
+                <a16:creationId xmlns:a16="http://schemas.microsoft.com/office/drawing/2014/main" id="{4CF4BD3E-FB91-4206-80D0-CAE38A7DA784}"/>
               </a:ext>
             </a:extLst>
           </p:cNvPr>
@@ -7069,7 +7069,7 @@
           <p:cNvPr id="16" name="">
             <a:extLst xmlns:a="http://schemas.openxmlformats.org/drawingml/2006/main">
               <a:ext uri="{FF2B5EF4-FFF2-40B4-BE49-F238E27FC236}">
-                <a16:creationId xmlns:a16="http://schemas.microsoft.com/office/drawing/2014/main" id="{1C0D2557-3599-419D-9166-80BD09E5D75D}"/>
+                <a16:creationId xmlns:a16="http://schemas.microsoft.com/office/drawing/2014/main" id="{0BCAAC7E-C942-4574-9437-C7DDCDF12789}"/>
               </a:ext>
             </a:extLst>
           </p:cNvPr>
@@ -7133,7 +7133,7 @@
           <p:cNvPr id="17" name="">
             <a:extLst xmlns:a="http://schemas.openxmlformats.org/drawingml/2006/main">
               <a:ext uri="{FF2B5EF4-FFF2-40B4-BE49-F238E27FC236}">
-                <a16:creationId xmlns:a16="http://schemas.microsoft.com/office/drawing/2014/main" id="{828FA002-01E5-4B77-ADDC-C42019353D75}"/>
+                <a16:creationId xmlns:a16="http://schemas.microsoft.com/office/drawing/2014/main" id="{9BFDAEE1-51FF-41AC-902B-76EE2247A800}"/>
               </a:ext>
             </a:extLst>
           </p:cNvPr>
@@ -7197,7 +7197,7 @@
           <p:cNvPr id="18" name="">
             <a:extLst xmlns:a="http://schemas.openxmlformats.org/drawingml/2006/main">
               <a:ext uri="{FF2B5EF4-FFF2-40B4-BE49-F238E27FC236}">
-                <a16:creationId xmlns:a16="http://schemas.microsoft.com/office/drawing/2014/main" id="{D0B39E5B-E1FD-4788-AB34-F55C15C73DF3}"/>
+                <a16:creationId xmlns:a16="http://schemas.microsoft.com/office/drawing/2014/main" id="{C55F1F5C-4696-4714-9585-9133AB6DE051}"/>
               </a:ext>
             </a:extLst>
           </p:cNvPr>
@@ -7261,7 +7261,7 @@
           <p:cNvPr id="19" name="">
             <a:extLst xmlns:a="http://schemas.openxmlformats.org/drawingml/2006/main">
               <a:ext uri="{FF2B5EF4-FFF2-40B4-BE49-F238E27FC236}">
-                <a16:creationId xmlns:a16="http://schemas.microsoft.com/office/drawing/2014/main" id="{EEFB2214-4F23-4789-AF00-42E2DF40B00D}"/>
+                <a16:creationId xmlns:a16="http://schemas.microsoft.com/office/drawing/2014/main" id="{C5E5E08C-B3AD-49C2-90B4-736B33E99614}"/>
               </a:ext>
             </a:extLst>
           </p:cNvPr>
@@ -7294,7 +7294,7 @@
           <p:cNvPr id="20" name="">
             <a:extLst xmlns:a="http://schemas.openxmlformats.org/drawingml/2006/main">
               <a:ext uri="{FF2B5EF4-FFF2-40B4-BE49-F238E27FC236}">
-                <a16:creationId xmlns:a16="http://schemas.microsoft.com/office/drawing/2014/main" id="{5FFCB9E5-B29E-418B-BD66-ECCF5B65CEBF}"/>
+                <a16:creationId xmlns:a16="http://schemas.microsoft.com/office/drawing/2014/main" id="{190C22A9-1DCC-4AAB-9E72-AA03723997CF}"/>
               </a:ext>
             </a:extLst>
           </p:cNvPr>
@@ -7358,7 +7358,7 @@
           <p:cNvPr id="21" name="">
             <a:extLst xmlns:a="http://schemas.openxmlformats.org/drawingml/2006/main">
               <a:ext uri="{FF2B5EF4-FFF2-40B4-BE49-F238E27FC236}">
-                <a16:creationId xmlns:a16="http://schemas.microsoft.com/office/drawing/2014/main" id="{966F7A5A-AE49-49B1-AAEF-973568676F83}"/>
+                <a16:creationId xmlns:a16="http://schemas.microsoft.com/office/drawing/2014/main" id="{6A1F05A4-EA27-4F6D-9D52-1741A586A064}"/>
               </a:ext>
             </a:extLst>
           </p:cNvPr>
@@ -7422,7 +7422,7 @@
           <p:cNvPr id="22" name="">
             <a:extLst xmlns:a="http://schemas.openxmlformats.org/drawingml/2006/main">
               <a:ext uri="{FF2B5EF4-FFF2-40B4-BE49-F238E27FC236}">
-                <a16:creationId xmlns:a16="http://schemas.microsoft.com/office/drawing/2014/main" id="{AE1CFF33-26F6-4DE5-A7B2-258E0B435184}"/>
+                <a16:creationId xmlns:a16="http://schemas.microsoft.com/office/drawing/2014/main" id="{FC7C74D5-4FD4-4578-B1CB-5B51162EFC47}"/>
               </a:ext>
             </a:extLst>
           </p:cNvPr>
@@ -7455,7 +7455,7 @@
           <p:cNvPr id="23" name="">
             <a:extLst xmlns:a="http://schemas.openxmlformats.org/drawingml/2006/main">
               <a:ext uri="{FF2B5EF4-FFF2-40B4-BE49-F238E27FC236}">
-                <a16:creationId xmlns:a16="http://schemas.microsoft.com/office/drawing/2014/main" id="{E02C7C85-364A-4505-A39B-CC96B57CFABC}"/>
+                <a16:creationId xmlns:a16="http://schemas.microsoft.com/office/drawing/2014/main" id="{4B180E31-8F90-409F-B28E-4A54ACE436D2}"/>
               </a:ext>
             </a:extLst>
           </p:cNvPr>
@@ -7519,7 +7519,7 @@
           <p:cNvPr id="24" name="">
             <a:extLst xmlns:a="http://schemas.openxmlformats.org/drawingml/2006/main">
               <a:ext uri="{FF2B5EF4-FFF2-40B4-BE49-F238E27FC236}">
-                <a16:creationId xmlns:a16="http://schemas.microsoft.com/office/drawing/2014/main" id="{4075A442-034D-49F4-94DD-13CE916C61BE}"/>
+                <a16:creationId xmlns:a16="http://schemas.microsoft.com/office/drawing/2014/main" id="{2456BD63-4E73-4590-AC95-E21004611226}"/>
               </a:ext>
             </a:extLst>
           </p:cNvPr>
@@ -7583,7 +7583,7 @@
           <p:cNvPr id="25" name="">
             <a:extLst xmlns:a="http://schemas.openxmlformats.org/drawingml/2006/main">
               <a:ext uri="{FF2B5EF4-FFF2-40B4-BE49-F238E27FC236}">
-                <a16:creationId xmlns:a16="http://schemas.microsoft.com/office/drawing/2014/main" id="{B2212A53-B74C-4F22-A304-C632A9DAD6F8}"/>
+                <a16:creationId xmlns:a16="http://schemas.microsoft.com/office/drawing/2014/main" id="{2C7EA490-4FF6-42A2-9325-D81C993E4ECC}"/>
               </a:ext>
             </a:extLst>
           </p:cNvPr>
@@ -7647,7 +7647,7 @@
           <p:cNvPr id="26" name="">
             <a:extLst xmlns:a="http://schemas.openxmlformats.org/drawingml/2006/main">
               <a:ext uri="{FF2B5EF4-FFF2-40B4-BE49-F238E27FC236}">
-                <a16:creationId xmlns:a16="http://schemas.microsoft.com/office/drawing/2014/main" id="{10B04277-EE1C-41D3-B5E0-03E9787EC7E0}"/>
+                <a16:creationId xmlns:a16="http://schemas.microsoft.com/office/drawing/2014/main" id="{A7DDB755-6377-4ADD-B865-7719543B40F3}"/>
               </a:ext>
             </a:extLst>
           </p:cNvPr>
@@ -7709,7 +7709,7 @@
     </p:spTree>
     <p:extLst>
       <p:ext uri="{BB962C8B-B14F-4D97-AF65-F5344CB8AC3E}">
-        <p14:creationId xmlns:p14="http://schemas.microsoft.com/office/powerpoint/2010/main" val="451957049"/>
+        <p14:creationId xmlns:p14="http://schemas.microsoft.com/office/powerpoint/2010/main" val="1092044091"/>
       </p:ext>
     </p:extLst>
   </p:cSld>
@@ -7733,7 +7733,7 @@
           <p:cNvPr id="1" name="">
             <a:extLst xmlns:a="http://schemas.openxmlformats.org/drawingml/2006/main">
               <a:ext uri="{FF2B5EF4-FFF2-40B4-BE49-F238E27FC236}">
-                <a16:creationId xmlns:a16="http://schemas.microsoft.com/office/drawing/2014/main" id="{A8F6A767-8711-4ECB-BCEC-A3307247EA42}"/>
+                <a16:creationId xmlns:a16="http://schemas.microsoft.com/office/drawing/2014/main" id="{BF61FEDB-6FCF-4BDF-B60E-0C1FD2231E0F}"/>
               </a:ext>
             </a:extLst>
           </p:cNvPr>
@@ -7768,7 +7768,7 @@
           <p:cNvPr id="2" name="">
             <a:extLst xmlns:a="http://schemas.openxmlformats.org/drawingml/2006/main">
               <a:ext uri="{FF2B5EF4-FFF2-40B4-BE49-F238E27FC236}">
-                <a16:creationId xmlns:a16="http://schemas.microsoft.com/office/drawing/2014/main" id="{19D6499F-605F-47DB-8A5B-0CAB8761C982}"/>
+                <a16:creationId xmlns:a16="http://schemas.microsoft.com/office/drawing/2014/main" id="{C19A5AC0-D77B-4074-BDE2-2C9B58C14489}"/>
               </a:ext>
             </a:extLst>
           </p:cNvPr>
@@ -7803,7 +7803,7 @@
           <p:cNvPr id="3" name="">
             <a:extLst xmlns:a="http://schemas.openxmlformats.org/drawingml/2006/main">
               <a:ext uri="{FF2B5EF4-FFF2-40B4-BE49-F238E27FC236}">
-                <a16:creationId xmlns:a16="http://schemas.microsoft.com/office/drawing/2014/main" id="{DC69DEF2-0E09-40DD-AC9E-06383E42C2D4}"/>
+                <a16:creationId xmlns:a16="http://schemas.microsoft.com/office/drawing/2014/main" id="{EF74A8F6-BB68-4648-90BC-B1C1BD511F6E}"/>
               </a:ext>
             </a:extLst>
           </p:cNvPr>
@@ -7867,7 +7867,7 @@
           <p:cNvPr id="4" name="">
             <a:extLst xmlns:a="http://schemas.openxmlformats.org/drawingml/2006/main">
               <a:ext uri="{FF2B5EF4-FFF2-40B4-BE49-F238E27FC236}">
-                <a16:creationId xmlns:a16="http://schemas.microsoft.com/office/drawing/2014/main" id="{4F75B6E5-30C2-4275-A2A3-4D0C37FD2009}"/>
+                <a16:creationId xmlns:a16="http://schemas.microsoft.com/office/drawing/2014/main" id="{99D0EFB7-9CEA-4DFD-8B29-C74DECC8DCBE}"/>
               </a:ext>
             </a:extLst>
           </p:cNvPr>
@@ -7931,7 +7931,7 @@
           <p:cNvPr id="5" name="">
             <a:extLst xmlns:a="http://schemas.openxmlformats.org/drawingml/2006/main">
               <a:ext uri="{FF2B5EF4-FFF2-40B4-BE49-F238E27FC236}">
-                <a16:creationId xmlns:a16="http://schemas.microsoft.com/office/drawing/2014/main" id="{A688F5DF-E2A4-4447-B13A-2FB1922000D7}"/>
+                <a16:creationId xmlns:a16="http://schemas.microsoft.com/office/drawing/2014/main" id="{2A353138-CAB7-4857-8373-C073874E7E37}"/>
               </a:ext>
             </a:extLst>
           </p:cNvPr>
@@ -7995,7 +7995,7 @@
           <p:cNvPr id="6" name="">
             <a:extLst xmlns:a="http://schemas.openxmlformats.org/drawingml/2006/main">
               <a:ext uri="{FF2B5EF4-FFF2-40B4-BE49-F238E27FC236}">
-                <a16:creationId xmlns:a16="http://schemas.microsoft.com/office/drawing/2014/main" id="{CBB7DF24-FD62-453A-8605-512A43165CDD}"/>
+                <a16:creationId xmlns:a16="http://schemas.microsoft.com/office/drawing/2014/main" id="{19D0A010-BF87-4EC9-8C99-DE9D8A650F1A}"/>
               </a:ext>
             </a:extLst>
           </p:cNvPr>
@@ -8059,7 +8059,7 @@
           <p:cNvPr id="7" name="">
             <a:extLst xmlns:a="http://schemas.openxmlformats.org/drawingml/2006/main">
               <a:ext uri="{FF2B5EF4-FFF2-40B4-BE49-F238E27FC236}">
-                <a16:creationId xmlns:a16="http://schemas.microsoft.com/office/drawing/2014/main" id="{583C8424-7653-48F0-AFF0-9E494EC52A25}"/>
+                <a16:creationId xmlns:a16="http://schemas.microsoft.com/office/drawing/2014/main" id="{19F4EDBB-2169-41AB-B586-CAFC79C66D09}"/>
               </a:ext>
             </a:extLst>
           </p:cNvPr>
@@ -8094,7 +8094,7 @@
           <p:cNvPr id="8" name="">
             <a:extLst xmlns:a="http://schemas.openxmlformats.org/drawingml/2006/main">
               <a:ext uri="{FF2B5EF4-FFF2-40B4-BE49-F238E27FC236}">
-                <a16:creationId xmlns:a16="http://schemas.microsoft.com/office/drawing/2014/main" id="{948F4D01-059C-48F4-B891-798C333CFDEB}"/>
+                <a16:creationId xmlns:a16="http://schemas.microsoft.com/office/drawing/2014/main" id="{738BB8C6-8E9A-47B7-A449-ADF65E6679D9}"/>
               </a:ext>
             </a:extLst>
           </p:cNvPr>
@@ -8158,7 +8158,7 @@
           <p:cNvPr id="9" name="">
             <a:extLst xmlns:a="http://schemas.openxmlformats.org/drawingml/2006/main">
               <a:ext uri="{FF2B5EF4-FFF2-40B4-BE49-F238E27FC236}">
-                <a16:creationId xmlns:a16="http://schemas.microsoft.com/office/drawing/2014/main" id="{D391CB9F-64AE-4273-868C-CDA90E3543B8}"/>
+                <a16:creationId xmlns:a16="http://schemas.microsoft.com/office/drawing/2014/main" id="{F3FB3394-A498-4699-BCC5-85804E32CB86}"/>
               </a:ext>
             </a:extLst>
           </p:cNvPr>
@@ -8212,7 +8212,7 @@
                 <a:ea typeface="Aptos"/>
                 <a:cs typeface="Aptos"/>
               </a:rPr>
-              <a:t>131</a:t>
+              <a:t>145</a:t>
             </a:r>
           </a:p>
         </p:txBody>
@@ -8222,7 +8222,7 @@
           <p:cNvPr id="10" name="">
             <a:extLst xmlns:a="http://schemas.openxmlformats.org/drawingml/2006/main">
               <a:ext uri="{FF2B5EF4-FFF2-40B4-BE49-F238E27FC236}">
-                <a16:creationId xmlns:a16="http://schemas.microsoft.com/office/drawing/2014/main" id="{F49DE55B-5CDB-4982-9F45-2749154E310C}"/>
+                <a16:creationId xmlns:a16="http://schemas.microsoft.com/office/drawing/2014/main" id="{20C66A73-ACE5-4575-839F-1E55A4DF904A}"/>
               </a:ext>
             </a:extLst>
           </p:cNvPr>
@@ -8286,7 +8286,7 @@
           <p:cNvPr id="11" name="">
             <a:extLst xmlns:a="http://schemas.openxmlformats.org/drawingml/2006/main">
               <a:ext uri="{FF2B5EF4-FFF2-40B4-BE49-F238E27FC236}">
-                <a16:creationId xmlns:a16="http://schemas.microsoft.com/office/drawing/2014/main" id="{DA035F68-74EC-4264-9CAE-14A23D1DAD38}"/>
+                <a16:creationId xmlns:a16="http://schemas.microsoft.com/office/drawing/2014/main" id="{FDBAFBA1-7E9D-42FF-B5F1-7F191E1053C5}"/>
               </a:ext>
             </a:extLst>
           </p:cNvPr>
@@ -8321,7 +8321,7 @@
           <p:cNvPr id="12" name="">
             <a:extLst xmlns:a="http://schemas.openxmlformats.org/drawingml/2006/main">
               <a:ext uri="{FF2B5EF4-FFF2-40B4-BE49-F238E27FC236}">
-                <a16:creationId xmlns:a16="http://schemas.microsoft.com/office/drawing/2014/main" id="{09BEBA3D-87AF-4B2C-8635-17788CB662BF}"/>
+                <a16:creationId xmlns:a16="http://schemas.microsoft.com/office/drawing/2014/main" id="{DAF39F11-0EDD-457C-9186-848ECAD5EE6E}"/>
               </a:ext>
             </a:extLst>
           </p:cNvPr>
@@ -8385,7 +8385,7 @@
           <p:cNvPr id="13" name="">
             <a:extLst xmlns:a="http://schemas.openxmlformats.org/drawingml/2006/main">
               <a:ext uri="{FF2B5EF4-FFF2-40B4-BE49-F238E27FC236}">
-                <a16:creationId xmlns:a16="http://schemas.microsoft.com/office/drawing/2014/main" id="{98127E37-7E8F-422B-9C48-FE95C2767D4C}"/>
+                <a16:creationId xmlns:a16="http://schemas.microsoft.com/office/drawing/2014/main" id="{0C684A74-4B80-4CA8-81C0-CBDB1E421766}"/>
               </a:ext>
             </a:extLst>
           </p:cNvPr>
@@ -8439,7 +8439,7 @@
                 <a:ea typeface="Aptos"/>
                 <a:cs typeface="Aptos"/>
               </a:rPr>
-              <a:t>75</a:t>
+              <a:t>93</a:t>
             </a:r>
           </a:p>
         </p:txBody>
@@ -8449,7 +8449,7 @@
           <p:cNvPr id="14" name="">
             <a:extLst xmlns:a="http://schemas.openxmlformats.org/drawingml/2006/main">
               <a:ext uri="{FF2B5EF4-FFF2-40B4-BE49-F238E27FC236}">
-                <a16:creationId xmlns:a16="http://schemas.microsoft.com/office/drawing/2014/main" id="{B5D27572-262F-4C36-9821-33C29816AAF0}"/>
+                <a16:creationId xmlns:a16="http://schemas.microsoft.com/office/drawing/2014/main" id="{10F95449-E610-498C-A643-D1684885FABB}"/>
               </a:ext>
             </a:extLst>
           </p:cNvPr>
@@ -8513,7 +8513,7 @@
           <p:cNvPr id="15" name="">
             <a:extLst xmlns:a="http://schemas.openxmlformats.org/drawingml/2006/main">
               <a:ext uri="{FF2B5EF4-FFF2-40B4-BE49-F238E27FC236}">
-                <a16:creationId xmlns:a16="http://schemas.microsoft.com/office/drawing/2014/main" id="{84236CDF-E3F1-425A-AC71-930AE1CB5932}"/>
+                <a16:creationId xmlns:a16="http://schemas.microsoft.com/office/drawing/2014/main" id="{FDED96C1-592D-40D6-BA9D-024DD6E02E4D}"/>
               </a:ext>
             </a:extLst>
           </p:cNvPr>
@@ -8548,7 +8548,7 @@
           <p:cNvPr id="16" name="">
             <a:extLst xmlns:a="http://schemas.openxmlformats.org/drawingml/2006/main">
               <a:ext uri="{FF2B5EF4-FFF2-40B4-BE49-F238E27FC236}">
-                <a16:creationId xmlns:a16="http://schemas.microsoft.com/office/drawing/2014/main" id="{940536B8-B1E8-41E5-AE6A-EB5969E5B712}"/>
+                <a16:creationId xmlns:a16="http://schemas.microsoft.com/office/drawing/2014/main" id="{FD73AB87-ED7B-44B5-824D-430F2F0E6566}"/>
               </a:ext>
             </a:extLst>
           </p:cNvPr>
@@ -8612,7 +8612,7 @@
           <p:cNvPr id="17" name="">
             <a:extLst xmlns:a="http://schemas.openxmlformats.org/drawingml/2006/main">
               <a:ext uri="{FF2B5EF4-FFF2-40B4-BE49-F238E27FC236}">
-                <a16:creationId xmlns:a16="http://schemas.microsoft.com/office/drawing/2014/main" id="{643442FA-7C3D-46B8-A65F-EF3CD98A5309}"/>
+                <a16:creationId xmlns:a16="http://schemas.microsoft.com/office/drawing/2014/main" id="{2A1E2D6F-5947-4F9E-B39A-93A7A049F7A5}"/>
               </a:ext>
             </a:extLst>
           </p:cNvPr>
@@ -8676,7 +8676,7 @@
           <p:cNvPr id="18" name="">
             <a:extLst xmlns:a="http://schemas.openxmlformats.org/drawingml/2006/main">
               <a:ext uri="{FF2B5EF4-FFF2-40B4-BE49-F238E27FC236}">
-                <a16:creationId xmlns:a16="http://schemas.microsoft.com/office/drawing/2014/main" id="{810A17E6-5357-4BB5-A7F2-CEC8ABFBA18E}"/>
+                <a16:creationId xmlns:a16="http://schemas.microsoft.com/office/drawing/2014/main" id="{2E247800-5A69-4F00-8DAA-327DDFF13AE4}"/>
               </a:ext>
             </a:extLst>
           </p:cNvPr>
@@ -8740,7 +8740,7 @@
           <p:cNvPr id="19" name="">
             <a:extLst xmlns:a="http://schemas.openxmlformats.org/drawingml/2006/main">
               <a:ext uri="{FF2B5EF4-FFF2-40B4-BE49-F238E27FC236}">
-                <a16:creationId xmlns:a16="http://schemas.microsoft.com/office/drawing/2014/main" id="{00C7B2F9-99D5-4CA8-A513-FB49C273C634}"/>
+                <a16:creationId xmlns:a16="http://schemas.microsoft.com/office/drawing/2014/main" id="{2045127A-4450-4054-8F0C-D563D581EE56}"/>
               </a:ext>
             </a:extLst>
           </p:cNvPr>
@@ -8775,7 +8775,7 @@
           <p:cNvPr id="20" name="">
             <a:extLst xmlns:a="http://schemas.openxmlformats.org/drawingml/2006/main">
               <a:ext uri="{FF2B5EF4-FFF2-40B4-BE49-F238E27FC236}">
-                <a16:creationId xmlns:a16="http://schemas.microsoft.com/office/drawing/2014/main" id="{22EE9B66-43DF-45BD-97D1-A8A2C6394C87}"/>
+                <a16:creationId xmlns:a16="http://schemas.microsoft.com/office/drawing/2014/main" id="{BBC8F7CB-CA9E-4EDB-A914-4146C2CB43C6}"/>
               </a:ext>
             </a:extLst>
           </p:cNvPr>
@@ -8839,7 +8839,7 @@
           <p:cNvPr id="21" name="">
             <a:extLst xmlns:a="http://schemas.openxmlformats.org/drawingml/2006/main">
               <a:ext uri="{FF2B5EF4-FFF2-40B4-BE49-F238E27FC236}">
-                <a16:creationId xmlns:a16="http://schemas.microsoft.com/office/drawing/2014/main" id="{9C2979B8-EEB6-4A10-8F61-6766CA86D5FC}"/>
+                <a16:creationId xmlns:a16="http://schemas.microsoft.com/office/drawing/2014/main" id="{09A09BFE-5EDA-41E0-A653-79868824FC75}"/>
               </a:ext>
             </a:extLst>
           </p:cNvPr>
@@ -8903,7 +8903,7 @@
           <p:cNvPr id="22" name="">
             <a:extLst xmlns:a="http://schemas.openxmlformats.org/drawingml/2006/main">
               <a:ext uri="{FF2B5EF4-FFF2-40B4-BE49-F238E27FC236}">
-                <a16:creationId xmlns:a16="http://schemas.microsoft.com/office/drawing/2014/main" id="{20184F56-97E4-414D-8FD3-53CE6484844F}"/>
+                <a16:creationId xmlns:a16="http://schemas.microsoft.com/office/drawing/2014/main" id="{D2F97CA4-B07C-44F7-BBC1-FF6DEEDE8B81}"/>
               </a:ext>
             </a:extLst>
           </p:cNvPr>
@@ -8967,7 +8967,7 @@
           <p:cNvPr id="23" name="">
             <a:extLst xmlns:a="http://schemas.openxmlformats.org/drawingml/2006/main">
               <a:ext uri="{FF2B5EF4-FFF2-40B4-BE49-F238E27FC236}">
-                <a16:creationId xmlns:a16="http://schemas.microsoft.com/office/drawing/2014/main" id="{FF20E23B-1949-4C41-9474-DF74A716EEC6}"/>
+                <a16:creationId xmlns:a16="http://schemas.microsoft.com/office/drawing/2014/main" id="{C3B628FD-B778-44C8-9DB4-55608D3BD48D}"/>
               </a:ext>
             </a:extLst>
           </p:cNvPr>
@@ -9000,7 +9000,7 @@
           <p:cNvPr id="24" name="">
             <a:extLst xmlns:a="http://schemas.openxmlformats.org/drawingml/2006/main">
               <a:ext uri="{FF2B5EF4-FFF2-40B4-BE49-F238E27FC236}">
-                <a16:creationId xmlns:a16="http://schemas.microsoft.com/office/drawing/2014/main" id="{C1B547EC-F023-469F-A768-04C5E31AC274}"/>
+                <a16:creationId xmlns:a16="http://schemas.microsoft.com/office/drawing/2014/main" id="{F1B0231B-2AF8-44FF-A27A-FB9993BA8BA0}"/>
               </a:ext>
             </a:extLst>
           </p:cNvPr>
@@ -9064,7 +9064,7 @@
           <p:cNvPr id="25" name="">
             <a:extLst xmlns:a="http://schemas.openxmlformats.org/drawingml/2006/main">
               <a:ext uri="{FF2B5EF4-FFF2-40B4-BE49-F238E27FC236}">
-                <a16:creationId xmlns:a16="http://schemas.microsoft.com/office/drawing/2014/main" id="{C29C4285-6029-4C80-8554-D7787175BC3A}"/>
+                <a16:creationId xmlns:a16="http://schemas.microsoft.com/office/drawing/2014/main" id="{2CC6F490-5741-4F85-A696-9B91FC532B0F}"/>
               </a:ext>
             </a:extLst>
           </p:cNvPr>
@@ -9128,7 +9128,7 @@
           <p:cNvPr id="26" name="">
             <a:extLst xmlns:a="http://schemas.openxmlformats.org/drawingml/2006/main">
               <a:ext uri="{FF2B5EF4-FFF2-40B4-BE49-F238E27FC236}">
-                <a16:creationId xmlns:a16="http://schemas.microsoft.com/office/drawing/2014/main" id="{90A3353C-89C9-46B9-83BB-792DECF0F689}"/>
+                <a16:creationId xmlns:a16="http://schemas.microsoft.com/office/drawing/2014/main" id="{7C92AEB1-2D0E-42C8-ACB8-1237733CE6EE}"/>
               </a:ext>
             </a:extLst>
           </p:cNvPr>
@@ -9192,7 +9192,7 @@
           <p:cNvPr id="27" name="">
             <a:extLst xmlns:a="http://schemas.openxmlformats.org/drawingml/2006/main">
               <a:ext uri="{FF2B5EF4-FFF2-40B4-BE49-F238E27FC236}">
-                <a16:creationId xmlns:a16="http://schemas.microsoft.com/office/drawing/2014/main" id="{96880364-4BE1-46AF-BEA4-EA4143B1B39B}"/>
+                <a16:creationId xmlns:a16="http://schemas.microsoft.com/office/drawing/2014/main" id="{3C55C314-4E1D-481B-92B0-840CC99AD704}"/>
               </a:ext>
             </a:extLst>
           </p:cNvPr>
@@ -9254,7 +9254,7 @@
     </p:spTree>
     <p:extLst>
       <p:ext uri="{BB962C8B-B14F-4D97-AF65-F5344CB8AC3E}">
-        <p14:creationId xmlns:p14="http://schemas.microsoft.com/office/powerpoint/2010/main" val="1716266816"/>
+        <p14:creationId xmlns:p14="http://schemas.microsoft.com/office/powerpoint/2010/main" val="482818159"/>
       </p:ext>
     </p:extLst>
   </p:cSld>
@@ -9278,7 +9278,7 @@
           <p:cNvPr id="1" name="">
             <a:extLst xmlns:a="http://schemas.openxmlformats.org/drawingml/2006/main">
               <a:ext uri="{FF2B5EF4-FFF2-40B4-BE49-F238E27FC236}">
-                <a16:creationId xmlns:a16="http://schemas.microsoft.com/office/drawing/2014/main" id="{975CFCA0-9E84-4311-A1EA-2C4D64102D43}"/>
+                <a16:creationId xmlns:a16="http://schemas.microsoft.com/office/drawing/2014/main" id="{EA744B6E-9362-40BE-A064-910407B12C63}"/>
               </a:ext>
             </a:extLst>
           </p:cNvPr>
@@ -9313,7 +9313,7 @@
           <p:cNvPr id="2" name="">
             <a:extLst xmlns:a="http://schemas.openxmlformats.org/drawingml/2006/main">
               <a:ext uri="{FF2B5EF4-FFF2-40B4-BE49-F238E27FC236}">
-                <a16:creationId xmlns:a16="http://schemas.microsoft.com/office/drawing/2014/main" id="{9A9FAF44-C478-4B2B-8AF9-66497FCC670F}"/>
+                <a16:creationId xmlns:a16="http://schemas.microsoft.com/office/drawing/2014/main" id="{3881E75B-217C-4F11-9AAE-6201D846A013}"/>
               </a:ext>
             </a:extLst>
           </p:cNvPr>
@@ -9348,7 +9348,7 @@
           <p:cNvPr id="3" name="">
             <a:extLst xmlns:a="http://schemas.openxmlformats.org/drawingml/2006/main">
               <a:ext uri="{FF2B5EF4-FFF2-40B4-BE49-F238E27FC236}">
-                <a16:creationId xmlns:a16="http://schemas.microsoft.com/office/drawing/2014/main" id="{5F347DF0-C842-4C1A-9599-2BE7C172E4D9}"/>
+                <a16:creationId xmlns:a16="http://schemas.microsoft.com/office/drawing/2014/main" id="{C70C2FA9-A4F9-4120-8BD6-09EAC80A1E30}"/>
               </a:ext>
             </a:extLst>
           </p:cNvPr>
@@ -9412,7 +9412,7 @@
           <p:cNvPr id="4" name="">
             <a:extLst xmlns:a="http://schemas.openxmlformats.org/drawingml/2006/main">
               <a:ext uri="{FF2B5EF4-FFF2-40B4-BE49-F238E27FC236}">
-                <a16:creationId xmlns:a16="http://schemas.microsoft.com/office/drawing/2014/main" id="{C2545BFB-106B-40BB-A519-44C21D98611B}"/>
+                <a16:creationId xmlns:a16="http://schemas.microsoft.com/office/drawing/2014/main" id="{9E33910F-28A1-48DF-BB69-620FE1DE1641}"/>
               </a:ext>
             </a:extLst>
           </p:cNvPr>
@@ -9476,7 +9476,7 @@
           <p:cNvPr id="5" name="">
             <a:extLst xmlns:a="http://schemas.openxmlformats.org/drawingml/2006/main">
               <a:ext uri="{FF2B5EF4-FFF2-40B4-BE49-F238E27FC236}">
-                <a16:creationId xmlns:a16="http://schemas.microsoft.com/office/drawing/2014/main" id="{BE5C23FA-E9CD-440B-96C0-89A79E942A2C}"/>
+                <a16:creationId xmlns:a16="http://schemas.microsoft.com/office/drawing/2014/main" id="{C863DEA3-37AA-4BC3-BBA3-675C5D0CAC08}"/>
               </a:ext>
             </a:extLst>
           </p:cNvPr>
@@ -9540,7 +9540,7 @@
           <p:cNvPr id="6" name="">
             <a:extLst xmlns:a="http://schemas.openxmlformats.org/drawingml/2006/main">
               <a:ext uri="{FF2B5EF4-FFF2-40B4-BE49-F238E27FC236}">
-                <a16:creationId xmlns:a16="http://schemas.microsoft.com/office/drawing/2014/main" id="{300C345A-E59E-4010-9271-D9B6C99D5C00}"/>
+                <a16:creationId xmlns:a16="http://schemas.microsoft.com/office/drawing/2014/main" id="{8D5326C4-4060-46FD-B5EF-6DAACEEA5F8D}"/>
               </a:ext>
             </a:extLst>
           </p:cNvPr>
@@ -9604,7 +9604,7 @@
           <p:cNvPr id="7" name="">
             <a:extLst xmlns:a="http://schemas.openxmlformats.org/drawingml/2006/main">
               <a:ext uri="{FF2B5EF4-FFF2-40B4-BE49-F238E27FC236}">
-                <a16:creationId xmlns:a16="http://schemas.microsoft.com/office/drawing/2014/main" id="{4CA4EA53-97E2-43DE-8A53-37319502E7EE}"/>
+                <a16:creationId xmlns:a16="http://schemas.microsoft.com/office/drawing/2014/main" id="{14C499E5-8A84-49B0-BE86-55DEA043EC0B}"/>
               </a:ext>
             </a:extLst>
           </p:cNvPr>
@@ -9637,7 +9637,7 @@
           <p:cNvPr id="8" name="">
             <a:extLst xmlns:a="http://schemas.openxmlformats.org/drawingml/2006/main">
               <a:ext uri="{FF2B5EF4-FFF2-40B4-BE49-F238E27FC236}">
-                <a16:creationId xmlns:a16="http://schemas.microsoft.com/office/drawing/2014/main" id="{41A8247F-2D69-423D-8324-2F84113A63A8}"/>
+                <a16:creationId xmlns:a16="http://schemas.microsoft.com/office/drawing/2014/main" id="{84D8A799-E08A-40EA-91EE-4B24C37B030D}"/>
               </a:ext>
             </a:extLst>
           </p:cNvPr>
@@ -9701,7 +9701,7 @@
           <p:cNvPr id="9" name="">
             <a:extLst xmlns:a="http://schemas.openxmlformats.org/drawingml/2006/main">
               <a:ext uri="{FF2B5EF4-FFF2-40B4-BE49-F238E27FC236}">
-                <a16:creationId xmlns:a16="http://schemas.microsoft.com/office/drawing/2014/main" id="{086ECE59-D559-422E-9694-782450783171}"/>
+                <a16:creationId xmlns:a16="http://schemas.microsoft.com/office/drawing/2014/main" id="{D27D7D0C-1B30-46E9-9F61-EC1DA9ADBECD}"/>
               </a:ext>
             </a:extLst>
           </p:cNvPr>
@@ -9765,7 +9765,7 @@
           <p:cNvPr id="10" name="">
             <a:extLst xmlns:a="http://schemas.openxmlformats.org/drawingml/2006/main">
               <a:ext uri="{FF2B5EF4-FFF2-40B4-BE49-F238E27FC236}">
-                <a16:creationId xmlns:a16="http://schemas.microsoft.com/office/drawing/2014/main" id="{FE7FD4E7-1457-4920-AE98-2FFFAEB98FBB}"/>
+                <a16:creationId xmlns:a16="http://schemas.microsoft.com/office/drawing/2014/main" id="{E9671535-48BF-4B0F-825D-5F4176DC84D1}"/>
               </a:ext>
             </a:extLst>
           </p:cNvPr>
@@ -9798,7 +9798,7 @@
           <p:cNvPr id="11" name="">
             <a:extLst xmlns:a="http://schemas.openxmlformats.org/drawingml/2006/main">
               <a:ext uri="{FF2B5EF4-FFF2-40B4-BE49-F238E27FC236}">
-                <a16:creationId xmlns:a16="http://schemas.microsoft.com/office/drawing/2014/main" id="{43910DBA-EB00-4AB1-81C1-B7732E9D371E}"/>
+                <a16:creationId xmlns:a16="http://schemas.microsoft.com/office/drawing/2014/main" id="{EB6B4101-37B3-4DAF-A051-DA0C66C17566}"/>
               </a:ext>
             </a:extLst>
           </p:cNvPr>
@@ -9862,7 +9862,7 @@
           <p:cNvPr id="12" name="">
             <a:extLst xmlns:a="http://schemas.openxmlformats.org/drawingml/2006/main">
               <a:ext uri="{FF2B5EF4-FFF2-40B4-BE49-F238E27FC236}">
-                <a16:creationId xmlns:a16="http://schemas.microsoft.com/office/drawing/2014/main" id="{27857BF5-BB8D-4E68-AF7F-C453F9FCAB3C}"/>
+                <a16:creationId xmlns:a16="http://schemas.microsoft.com/office/drawing/2014/main" id="{004700DD-3F00-47C3-A350-8C1F0340D6DC}"/>
               </a:ext>
             </a:extLst>
           </p:cNvPr>
@@ -9926,7 +9926,7 @@
           <p:cNvPr id="13" name="">
             <a:extLst xmlns:a="http://schemas.openxmlformats.org/drawingml/2006/main">
               <a:ext uri="{FF2B5EF4-FFF2-40B4-BE49-F238E27FC236}">
-                <a16:creationId xmlns:a16="http://schemas.microsoft.com/office/drawing/2014/main" id="{1E0138BC-66F9-4503-887D-81D5D6A4A397}"/>
+                <a16:creationId xmlns:a16="http://schemas.microsoft.com/office/drawing/2014/main" id="{1B99BD07-FD11-4A98-8D09-60B4EFC73277}"/>
               </a:ext>
             </a:extLst>
           </p:cNvPr>
@@ -9959,7 +9959,7 @@
           <p:cNvPr id="14" name="">
             <a:extLst xmlns:a="http://schemas.openxmlformats.org/drawingml/2006/main">
               <a:ext uri="{FF2B5EF4-FFF2-40B4-BE49-F238E27FC236}">
-                <a16:creationId xmlns:a16="http://schemas.microsoft.com/office/drawing/2014/main" id="{F72340A8-17B5-4E70-9A6C-0B90FD7711BE}"/>
+                <a16:creationId xmlns:a16="http://schemas.microsoft.com/office/drawing/2014/main" id="{9382A52E-F12F-4EC2-B508-48D8145C0871}"/>
               </a:ext>
             </a:extLst>
           </p:cNvPr>
@@ -10023,7 +10023,7 @@
           <p:cNvPr id="15" name="">
             <a:extLst xmlns:a="http://schemas.openxmlformats.org/drawingml/2006/main">
               <a:ext uri="{FF2B5EF4-FFF2-40B4-BE49-F238E27FC236}">
-                <a16:creationId xmlns:a16="http://schemas.microsoft.com/office/drawing/2014/main" id="{6A23BC01-2C5E-4A72-B23B-698F42E49506}"/>
+                <a16:creationId xmlns:a16="http://schemas.microsoft.com/office/drawing/2014/main" id="{883C4CBE-9010-4B23-8927-531479F66E7D}"/>
               </a:ext>
             </a:extLst>
           </p:cNvPr>
@@ -10087,7 +10087,7 @@
           <p:cNvPr id="16" name="">
             <a:extLst xmlns:a="http://schemas.openxmlformats.org/drawingml/2006/main">
               <a:ext uri="{FF2B5EF4-FFF2-40B4-BE49-F238E27FC236}">
-                <a16:creationId xmlns:a16="http://schemas.microsoft.com/office/drawing/2014/main" id="{C7DF3F11-B670-466B-8F33-69734446A921}"/>
+                <a16:creationId xmlns:a16="http://schemas.microsoft.com/office/drawing/2014/main" id="{1C189A6C-3FF3-49E2-8336-0F41D060BD09}"/>
               </a:ext>
             </a:extLst>
           </p:cNvPr>
@@ -10151,7 +10151,7 @@
           <p:cNvPr id="17" name="">
             <a:extLst xmlns:a="http://schemas.openxmlformats.org/drawingml/2006/main">
               <a:ext uri="{FF2B5EF4-FFF2-40B4-BE49-F238E27FC236}">
-                <a16:creationId xmlns:a16="http://schemas.microsoft.com/office/drawing/2014/main" id="{501CE341-BF0E-4C69-9AD9-252CDE006033}"/>
+                <a16:creationId xmlns:a16="http://schemas.microsoft.com/office/drawing/2014/main" id="{9684AB02-0B0C-4602-B7ED-B922E1CD1CB2}"/>
               </a:ext>
             </a:extLst>
           </p:cNvPr>
@@ -10213,7 +10213,7 @@
     </p:spTree>
     <p:extLst>
       <p:ext uri="{BB962C8B-B14F-4D97-AF65-F5344CB8AC3E}">
-        <p14:creationId xmlns:p14="http://schemas.microsoft.com/office/powerpoint/2010/main" val="1162429555"/>
+        <p14:creationId xmlns:p14="http://schemas.microsoft.com/office/powerpoint/2010/main" val="195917996"/>
       </p:ext>
     </p:extLst>
   </p:cSld>
@@ -10237,7 +10237,7 @@
           <p:cNvPr id="1" name="">
             <a:extLst xmlns:a="http://schemas.openxmlformats.org/drawingml/2006/main">
               <a:ext uri="{FF2B5EF4-FFF2-40B4-BE49-F238E27FC236}">
-                <a16:creationId xmlns:a16="http://schemas.microsoft.com/office/drawing/2014/main" id="{12734C82-BA57-4A92-9570-1B93E8A59E63}"/>
+                <a16:creationId xmlns:a16="http://schemas.microsoft.com/office/drawing/2014/main" id="{755C4EDB-9714-4A89-9F2D-BEC35D3C3543}"/>
               </a:ext>
             </a:extLst>
           </p:cNvPr>
@@ -10272,7 +10272,7 @@
           <p:cNvPr id="2" name="">
             <a:extLst xmlns:a="http://schemas.openxmlformats.org/drawingml/2006/main">
               <a:ext uri="{FF2B5EF4-FFF2-40B4-BE49-F238E27FC236}">
-                <a16:creationId xmlns:a16="http://schemas.microsoft.com/office/drawing/2014/main" id="{211E2A9D-049B-4D78-8964-843BF51E4DD1}"/>
+                <a16:creationId xmlns:a16="http://schemas.microsoft.com/office/drawing/2014/main" id="{DB370297-B29F-4BF7-950A-5A310ECB0C0D}"/>
               </a:ext>
             </a:extLst>
           </p:cNvPr>
@@ -10307,7 +10307,7 @@
           <p:cNvPr id="3" name="">
             <a:extLst xmlns:a="http://schemas.openxmlformats.org/drawingml/2006/main">
               <a:ext uri="{FF2B5EF4-FFF2-40B4-BE49-F238E27FC236}">
-                <a16:creationId xmlns:a16="http://schemas.microsoft.com/office/drawing/2014/main" id="{9B80D1F3-4155-4F98-A71D-90FBCC888A7D}"/>
+                <a16:creationId xmlns:a16="http://schemas.microsoft.com/office/drawing/2014/main" id="{D54F0A9F-F964-4BB7-A6F1-8FA38487D649}"/>
               </a:ext>
             </a:extLst>
           </p:cNvPr>
@@ -10371,7 +10371,7 @@
           <p:cNvPr id="4" name="">
             <a:extLst xmlns:a="http://schemas.openxmlformats.org/drawingml/2006/main">
               <a:ext uri="{FF2B5EF4-FFF2-40B4-BE49-F238E27FC236}">
-                <a16:creationId xmlns:a16="http://schemas.microsoft.com/office/drawing/2014/main" id="{7B1A90BF-1A91-4663-90DA-1B1A4975B9FA}"/>
+                <a16:creationId xmlns:a16="http://schemas.microsoft.com/office/drawing/2014/main" id="{914484C0-528C-4F57-8259-FA910EB8875E}"/>
               </a:ext>
             </a:extLst>
           </p:cNvPr>
@@ -10435,7 +10435,7 @@
           <p:cNvPr id="5" name="">
             <a:extLst xmlns:a="http://schemas.openxmlformats.org/drawingml/2006/main">
               <a:ext uri="{FF2B5EF4-FFF2-40B4-BE49-F238E27FC236}">
-                <a16:creationId xmlns:a16="http://schemas.microsoft.com/office/drawing/2014/main" id="{2A819E19-C301-4D95-BCCA-3509308EC9BC}"/>
+                <a16:creationId xmlns:a16="http://schemas.microsoft.com/office/drawing/2014/main" id="{97B380CA-BD3D-46B4-9693-B5ADF7F5F516}"/>
               </a:ext>
             </a:extLst>
           </p:cNvPr>
@@ -10489,7 +10489,7 @@
                 <a:ea typeface="Aptos Display"/>
                 <a:cs typeface="Aptos Display"/>
               </a:rPr>
-              <a:t>The mesh keeps agents alive when an edge node fails</a:t>
+              <a:t>Real failover and real field radio have executable proof</a:t>
             </a:r>
           </a:p>
         </p:txBody>
@@ -10499,7 +10499,7 @@
           <p:cNvPr id="6" name="">
             <a:extLst xmlns:a="http://schemas.openxmlformats.org/drawingml/2006/main">
               <a:ext uri="{FF2B5EF4-FFF2-40B4-BE49-F238E27FC236}">
-                <a16:creationId xmlns:a16="http://schemas.microsoft.com/office/drawing/2014/main" id="{6438445E-F385-44A2-8909-D1C1B1E3D871}"/>
+                <a16:creationId xmlns:a16="http://schemas.microsoft.com/office/drawing/2014/main" id="{30F2BA4E-3F3B-40F7-8C04-01F44DF048E7}"/>
               </a:ext>
             </a:extLst>
           </p:cNvPr>
@@ -10553,7 +10553,7 @@
                 <a:ea typeface="Aptos"/>
                 <a:cs typeface="Aptos"/>
               </a:rPr>
-              <a:t>Local deterministic mesh behavior demonstrates the Horde/Sagents migration story without requiring a real cluster.</a:t>
+              <a:t>Horde preserves managed agent state across owner loss; two physical nRF9151 DKs prove the DECT NR+ link.</a:t>
             </a:r>
           </a:p>
         </p:txBody>
@@ -10563,19 +10563,19 @@
           <p:cNvPr id="7" name="">
             <a:extLst xmlns:a="http://schemas.openxmlformats.org/drawingml/2006/main">
               <a:ext uri="{FF2B5EF4-FFF2-40B4-BE49-F238E27FC236}">
-                <a16:creationId xmlns:a16="http://schemas.microsoft.com/office/drawing/2014/main" id="{A478E31F-2E9C-43A6-84E6-F8175DF1A9DD}"/>
-              </a:ext>
-            </a:extLst>
-          </p:cNvPr>
-          <p:cNvSpPr>
-            <a:spLocks xmlns:a="http://schemas.openxmlformats.org/drawingml/2006/main" noGrp="1"/>
-          </p:cNvSpPr>
-          <p:nvPr/>
-        </p:nvSpPr>
-        <p:spPr>
-          <a:xfrm xmlns:a="http://schemas.openxmlformats.org/drawingml/2006/main">
-            <a:off x="1143000" y="2286000"/>
-            <a:ext cx="2190750" cy="1066800"/>
+                <a16:creationId xmlns:a16="http://schemas.microsoft.com/office/drawing/2014/main" id="{1F53FE6B-948B-42D4-B491-F0DEB1D225D8}"/>
+              </a:ext>
+            </a:extLst>
+          </p:cNvPr>
+          <p:cNvSpPr>
+            <a:spLocks xmlns:a="http://schemas.openxmlformats.org/drawingml/2006/main" noGrp="1"/>
+          </p:cNvSpPr>
+          <p:nvPr/>
+        </p:nvSpPr>
+        <p:spPr>
+          <a:xfrm xmlns:a="http://schemas.openxmlformats.org/drawingml/2006/main">
+            <a:off x="990600" y="2286000"/>
+            <a:ext cx="2571750" cy="1162050"/>
           </a:xfrm>
           <a:prstGeom xmlns:a="http://schemas.openxmlformats.org/drawingml/2006/main" prst="rect">
             <a:avLst/>
@@ -10596,19 +10596,19 @@
           <p:cNvPr id="8" name="">
             <a:extLst xmlns:a="http://schemas.openxmlformats.org/drawingml/2006/main">
               <a:ext uri="{FF2B5EF4-FFF2-40B4-BE49-F238E27FC236}">
-                <a16:creationId xmlns:a16="http://schemas.microsoft.com/office/drawing/2014/main" id="{E1845A25-9B70-4F0C-AB71-DC22A3D68864}"/>
-              </a:ext>
-            </a:extLst>
-          </p:cNvPr>
-          <p:cNvSpPr>
-            <a:spLocks xmlns:a="http://schemas.openxmlformats.org/drawingml/2006/main" noGrp="1"/>
-          </p:cNvSpPr>
-          <p:nvPr/>
-        </p:nvSpPr>
-        <p:spPr>
-          <a:xfrm xmlns:a="http://schemas.openxmlformats.org/drawingml/2006/main">
-            <a:off x="1314450" y="2419350"/>
-            <a:ext cx="1847850" cy="285750"/>
+                <a16:creationId xmlns:a16="http://schemas.microsoft.com/office/drawing/2014/main" id="{1333FAAD-0BD8-41EE-ABEC-D2A6A2977CF0}"/>
+              </a:ext>
+            </a:extLst>
+          </p:cNvPr>
+          <p:cNvSpPr>
+            <a:spLocks xmlns:a="http://schemas.openxmlformats.org/drawingml/2006/main" noGrp="1"/>
+          </p:cNvSpPr>
+          <p:nvPr/>
+        </p:nvSpPr>
+        <p:spPr>
+          <a:xfrm xmlns:a="http://schemas.openxmlformats.org/drawingml/2006/main">
+            <a:off x="1162050" y="2419350"/>
+            <a:ext cx="2228850" cy="285750"/>
           </a:xfrm>
           <a:prstGeom xmlns:a="http://schemas.openxmlformats.org/drawingml/2006/main" prst="rect">
             <a:avLst/>
@@ -10650,7 +10650,7 @@
                 <a:ea typeface="Aptos"/>
                 <a:cs typeface="Aptos"/>
               </a:rPr>
-              <a:t>Edge tank A</a:t>
+              <a:t>proteinloop_web@web</a:t>
             </a:r>
           </a:p>
         </p:txBody>
@@ -10660,19 +10660,19 @@
           <p:cNvPr id="9" name="">
             <a:extLst xmlns:a="http://schemas.openxmlformats.org/drawingml/2006/main">
               <a:ext uri="{FF2B5EF4-FFF2-40B4-BE49-F238E27FC236}">
-                <a16:creationId xmlns:a16="http://schemas.microsoft.com/office/drawing/2014/main" id="{1544BDAD-52D6-4E9E-A479-23A66834C229}"/>
-              </a:ext>
-            </a:extLst>
-          </p:cNvPr>
-          <p:cNvSpPr>
-            <a:spLocks xmlns:a="http://schemas.openxmlformats.org/drawingml/2006/main" noGrp="1"/>
-          </p:cNvSpPr>
-          <p:nvPr/>
-        </p:nvSpPr>
-        <p:spPr>
-          <a:xfrm xmlns:a="http://schemas.openxmlformats.org/drawingml/2006/main">
-            <a:off x="1314450" y="2762250"/>
-            <a:ext cx="1847850" cy="419100"/>
+                <a16:creationId xmlns:a16="http://schemas.microsoft.com/office/drawing/2014/main" id="{760C11E5-10A7-4BAB-8029-C3388431D6FC}"/>
+              </a:ext>
+            </a:extLst>
+          </p:cNvPr>
+          <p:cNvSpPr>
+            <a:spLocks xmlns:a="http://schemas.openxmlformats.org/drawingml/2006/main" noGrp="1"/>
+          </p:cNvSpPr>
+          <p:nvPr/>
+        </p:nvSpPr>
+        <p:spPr>
+          <a:xfrm xmlns:a="http://schemas.openxmlformats.org/drawingml/2006/main">
+            <a:off x="1162050" y="2762250"/>
+            <a:ext cx="2228850" cy="514350"/>
           </a:xfrm>
           <a:prstGeom xmlns:a="http://schemas.openxmlformats.org/drawingml/2006/main" prst="rect">
             <a:avLst/>
@@ -10714,7 +10714,7 @@
                 <a:ea typeface="Aptos"/>
                 <a:cs typeface="Aptos"/>
               </a:rPr>
-              <a:t>fish + hydroponia agents</a:t>
+              <a:t>Initial owner persists the completed Gemma probe.</a:t>
             </a:r>
           </a:p>
         </p:txBody>
@@ -10724,18 +10724,18 @@
           <p:cNvPr id="10" name="">
             <a:extLst xmlns:a="http://schemas.openxmlformats.org/drawingml/2006/main">
               <a:ext uri="{FF2B5EF4-FFF2-40B4-BE49-F238E27FC236}">
-                <a16:creationId xmlns:a16="http://schemas.microsoft.com/office/drawing/2014/main" id="{DE1A7792-3F5C-4949-9B79-CC26D53E04A0}"/>
-              </a:ext>
-            </a:extLst>
-          </p:cNvPr>
-          <p:cNvSpPr>
-            <a:spLocks xmlns:a="http://schemas.openxmlformats.org/drawingml/2006/main" noGrp="1"/>
-          </p:cNvSpPr>
-          <p:nvPr/>
-        </p:nvSpPr>
-        <p:spPr>
-          <a:xfrm xmlns:a="http://schemas.openxmlformats.org/drawingml/2006/main">
-            <a:off x="3619500" y="2705100"/>
+                <a16:creationId xmlns:a16="http://schemas.microsoft.com/office/drawing/2014/main" id="{EB060C9C-7C66-4054-A19B-FEFDDCD83894}"/>
+              </a:ext>
+            </a:extLst>
+          </p:cNvPr>
+          <p:cNvSpPr>
+            <a:spLocks xmlns:a="http://schemas.openxmlformats.org/drawingml/2006/main" noGrp="1"/>
+          </p:cNvSpPr>
+          <p:nvPr/>
+        </p:nvSpPr>
+        <p:spPr>
+          <a:xfrm xmlns:a="http://schemas.openxmlformats.org/drawingml/2006/main">
+            <a:off x="3733800" y="2724150"/>
             <a:ext cx="457200" cy="266700"/>
           </a:xfrm>
           <a:prstGeom xmlns:a="http://schemas.openxmlformats.org/drawingml/2006/main" prst="rect">
@@ -10778,7 +10778,7 @@
                 <a:ea typeface="Aptos"/>
                 <a:cs typeface="Aptos"/>
               </a:rPr>
-              <a:t>fail</a:t>
+              <a:t>stop</a:t>
             </a:r>
           </a:p>
         </p:txBody>
@@ -10788,29 +10788,29 @@
           <p:cNvPr id="11" name="">
             <a:extLst xmlns:a="http://schemas.openxmlformats.org/drawingml/2006/main">
               <a:ext uri="{FF2B5EF4-FFF2-40B4-BE49-F238E27FC236}">
-                <a16:creationId xmlns:a16="http://schemas.microsoft.com/office/drawing/2014/main" id="{5DEB1789-373B-4849-9CDE-5AB28382B8D8}"/>
-              </a:ext>
-            </a:extLst>
-          </p:cNvPr>
-          <p:cNvSpPr>
-            <a:spLocks xmlns:a="http://schemas.openxmlformats.org/drawingml/2006/main" noGrp="1"/>
-          </p:cNvSpPr>
-          <p:nvPr/>
-        </p:nvSpPr>
-        <p:spPr>
-          <a:xfrm xmlns:a="http://schemas.openxmlformats.org/drawingml/2006/main">
-            <a:off x="4476750" y="2286000"/>
-            <a:ext cx="2190750" cy="1066800"/>
-          </a:xfrm>
-          <a:prstGeom xmlns:a="http://schemas.openxmlformats.org/drawingml/2006/main" prst="rect">
-            <a:avLst/>
-          </a:prstGeom>
-          <a:solidFill xmlns:a="http://schemas.openxmlformats.org/drawingml/2006/main">
-            <a:srgbClr val="DCFCE7"/>
+                <a16:creationId xmlns:a16="http://schemas.microsoft.com/office/drawing/2014/main" id="{638216F9-57EA-4414-A70D-C003D0718896}"/>
+              </a:ext>
+            </a:extLst>
+          </p:cNvPr>
+          <p:cNvSpPr>
+            <a:spLocks xmlns:a="http://schemas.openxmlformats.org/drawingml/2006/main" noGrp="1"/>
+          </p:cNvSpPr>
+          <p:nvPr/>
+        </p:nvSpPr>
+        <p:spPr>
+          <a:xfrm xmlns:a="http://schemas.openxmlformats.org/drawingml/2006/main">
+            <a:off x="4457700" y="2286000"/>
+            <a:ext cx="2571750" cy="1162050"/>
+          </a:xfrm>
+          <a:prstGeom xmlns:a="http://schemas.openxmlformats.org/drawingml/2006/main" prst="rect">
+            <a:avLst/>
+          </a:prstGeom>
+          <a:solidFill xmlns:a="http://schemas.openxmlformats.org/drawingml/2006/main">
+            <a:srgbClr val="CCFBF1"/>
           </a:solidFill>
           <a:ln xmlns:a="http://schemas.openxmlformats.org/drawingml/2006/main" w="19050">
             <a:solidFill>
-              <a:srgbClr val="15803D"/>
+              <a:srgbClr val="0F766E"/>
             </a:solidFill>
             <a:prstDash val="solid"/>
           </a:ln>
@@ -10821,19 +10821,19 @@
           <p:cNvPr id="12" name="">
             <a:extLst xmlns:a="http://schemas.openxmlformats.org/drawingml/2006/main">
               <a:ext uri="{FF2B5EF4-FFF2-40B4-BE49-F238E27FC236}">
-                <a16:creationId xmlns:a16="http://schemas.microsoft.com/office/drawing/2014/main" id="{935A1360-DDD3-45CE-A8C6-D9DE06D6042F}"/>
-              </a:ext>
-            </a:extLst>
-          </p:cNvPr>
-          <p:cNvSpPr>
-            <a:spLocks xmlns:a="http://schemas.openxmlformats.org/drawingml/2006/main" noGrp="1"/>
-          </p:cNvSpPr>
-          <p:nvPr/>
-        </p:nvSpPr>
-        <p:spPr>
-          <a:xfrm xmlns:a="http://schemas.openxmlformats.org/drawingml/2006/main">
-            <a:off x="4648200" y="2419350"/>
-            <a:ext cx="1847850" cy="285750"/>
+                <a16:creationId xmlns:a16="http://schemas.microsoft.com/office/drawing/2014/main" id="{407026F0-2A17-44E5-B764-EBCD2C598EF8}"/>
+              </a:ext>
+            </a:extLst>
+          </p:cNvPr>
+          <p:cNvSpPr>
+            <a:spLocks xmlns:a="http://schemas.openxmlformats.org/drawingml/2006/main" noGrp="1"/>
+          </p:cNvSpPr>
+          <p:nvPr/>
+        </p:nvSpPr>
+        <p:spPr>
+          <a:xfrm xmlns:a="http://schemas.openxmlformats.org/drawingml/2006/main">
+            <a:off x="4629150" y="2419350"/>
+            <a:ext cx="2228850" cy="285750"/>
           </a:xfrm>
           <a:prstGeom xmlns:a="http://schemas.openxmlformats.org/drawingml/2006/main" prst="rect">
             <a:avLst/>
@@ -10875,7 +10875,7 @@
                 <a:ea typeface="Aptos"/>
                 <a:cs typeface="Aptos"/>
               </a:rPr>
-              <a:t>Edge tank B</a:t>
+              <a:t>Horde 0.10.0</a:t>
             </a:r>
           </a:p>
         </p:txBody>
@@ -10885,19 +10885,19 @@
           <p:cNvPr id="13" name="">
             <a:extLst xmlns:a="http://schemas.openxmlformats.org/drawingml/2006/main">
               <a:ext uri="{FF2B5EF4-FFF2-40B4-BE49-F238E27FC236}">
-                <a16:creationId xmlns:a16="http://schemas.microsoft.com/office/drawing/2014/main" id="{DC0D994A-66D5-4599-BB17-3A856B3AA16D}"/>
-              </a:ext>
-            </a:extLst>
-          </p:cNvPr>
-          <p:cNvSpPr>
-            <a:spLocks xmlns:a="http://schemas.openxmlformats.org/drawingml/2006/main" noGrp="1"/>
-          </p:cNvSpPr>
-          <p:nvPr/>
-        </p:nvSpPr>
-        <p:spPr>
-          <a:xfrm xmlns:a="http://schemas.openxmlformats.org/drawingml/2006/main">
-            <a:off x="4648200" y="2762250"/>
-            <a:ext cx="1847850" cy="419100"/>
+                <a16:creationId xmlns:a16="http://schemas.microsoft.com/office/drawing/2014/main" id="{7429254F-68A2-4D81-81EC-F56777A31F90}"/>
+              </a:ext>
+            </a:extLst>
+          </p:cNvPr>
+          <p:cNvSpPr>
+            <a:spLocks xmlns:a="http://schemas.openxmlformats.org/drawingml/2006/main" noGrp="1"/>
+          </p:cNvSpPr>
+          <p:nvPr/>
+        </p:nvSpPr>
+        <p:spPr>
+          <a:xfrm xmlns:a="http://schemas.openxmlformats.org/drawingml/2006/main">
+            <a:off x="4629150" y="2762250"/>
+            <a:ext cx="2228850" cy="514350"/>
           </a:xfrm>
           <a:prstGeom xmlns:a="http://schemas.openxmlformats.org/drawingml/2006/main" prst="rect">
             <a:avLst/>
@@ -10939,7 +10939,7 @@
                 <a:ea typeface="Aptos"/>
                 <a:cs typeface="Aptos"/>
               </a:rPr>
-              <a:t>healthy backup node</a:t>
+              <a:t>Participation membership transfers managed ownership.</a:t>
             </a:r>
           </a:p>
         </p:txBody>
@@ -10949,18 +10949,18 @@
           <p:cNvPr id="14" name="">
             <a:extLst xmlns:a="http://schemas.openxmlformats.org/drawingml/2006/main">
               <a:ext uri="{FF2B5EF4-FFF2-40B4-BE49-F238E27FC236}">
-                <a16:creationId xmlns:a16="http://schemas.microsoft.com/office/drawing/2014/main" id="{201A01DF-A93B-412E-95B0-4028E367BDCB}"/>
-              </a:ext>
-            </a:extLst>
-          </p:cNvPr>
-          <p:cNvSpPr>
-            <a:spLocks xmlns:a="http://schemas.openxmlformats.org/drawingml/2006/main" noGrp="1"/>
-          </p:cNvSpPr>
-          <p:nvPr/>
-        </p:nvSpPr>
-        <p:spPr>
-          <a:xfrm xmlns:a="http://schemas.openxmlformats.org/drawingml/2006/main">
-            <a:off x="6953250" y="2705100"/>
+                <a16:creationId xmlns:a16="http://schemas.microsoft.com/office/drawing/2014/main" id="{94308913-D74F-4616-B2E8-6ED32406EC26}"/>
+              </a:ext>
+            </a:extLst>
+          </p:cNvPr>
+          <p:cNvSpPr>
+            <a:spLocks xmlns:a="http://schemas.openxmlformats.org/drawingml/2006/main" noGrp="1"/>
+          </p:cNvSpPr>
+          <p:nvPr/>
+        </p:nvSpPr>
+        <p:spPr>
+          <a:xfrm xmlns:a="http://schemas.openxmlformats.org/drawingml/2006/main">
+            <a:off x="7200900" y="2724150"/>
             <a:ext cx="457200" cy="266700"/>
           </a:xfrm>
           <a:prstGeom xmlns:a="http://schemas.openxmlformats.org/drawingml/2006/main" prst="rect">
@@ -11013,29 +11013,29 @@
           <p:cNvPr id="15" name="">
             <a:extLst xmlns:a="http://schemas.openxmlformats.org/drawingml/2006/main">
               <a:ext uri="{FF2B5EF4-FFF2-40B4-BE49-F238E27FC236}">
-                <a16:creationId xmlns:a16="http://schemas.microsoft.com/office/drawing/2014/main" id="{5BAC612B-6837-4EFF-946E-AC7A6998C35E}"/>
-              </a:ext>
-            </a:extLst>
-          </p:cNvPr>
-          <p:cNvSpPr>
-            <a:spLocks xmlns:a="http://schemas.openxmlformats.org/drawingml/2006/main" noGrp="1"/>
-          </p:cNvSpPr>
-          <p:nvPr/>
-        </p:nvSpPr>
-        <p:spPr>
-          <a:xfrm xmlns:a="http://schemas.openxmlformats.org/drawingml/2006/main">
-            <a:off x="7810500" y="2286000"/>
-            <a:ext cx="2190750" cy="1066800"/>
-          </a:xfrm>
-          <a:prstGeom xmlns:a="http://schemas.openxmlformats.org/drawingml/2006/main" prst="rect">
-            <a:avLst/>
-          </a:prstGeom>
-          <a:solidFill xmlns:a="http://schemas.openxmlformats.org/drawingml/2006/main">
-            <a:srgbClr val="E0F2FE"/>
+                <a16:creationId xmlns:a16="http://schemas.microsoft.com/office/drawing/2014/main" id="{536057C2-2B8C-4F32-BB74-AD2EAB0D83F9}"/>
+              </a:ext>
+            </a:extLst>
+          </p:cNvPr>
+          <p:cNvSpPr>
+            <a:spLocks xmlns:a="http://schemas.openxmlformats.org/drawingml/2006/main" noGrp="1"/>
+          </p:cNvSpPr>
+          <p:nvPr/>
+        </p:nvSpPr>
+        <p:spPr>
+          <a:xfrm xmlns:a="http://schemas.openxmlformats.org/drawingml/2006/main">
+            <a:off x="7924800" y="2286000"/>
+            <a:ext cx="2857500" cy="1162050"/>
+          </a:xfrm>
+          <a:prstGeom xmlns:a="http://schemas.openxmlformats.org/drawingml/2006/main" prst="rect">
+            <a:avLst/>
+          </a:prstGeom>
+          <a:solidFill xmlns:a="http://schemas.openxmlformats.org/drawingml/2006/main">
+            <a:srgbClr val="DCFCE7"/>
           </a:solidFill>
           <a:ln xmlns:a="http://schemas.openxmlformats.org/drawingml/2006/main" w="19050">
             <a:solidFill>
-              <a:srgbClr val="0369A1"/>
+              <a:srgbClr val="15803D"/>
             </a:solidFill>
             <a:prstDash val="solid"/>
           </a:ln>
@@ -11046,19 +11046,19 @@
           <p:cNvPr id="16" name="">
             <a:extLst xmlns:a="http://schemas.openxmlformats.org/drawingml/2006/main">
               <a:ext uri="{FF2B5EF4-FFF2-40B4-BE49-F238E27FC236}">
-                <a16:creationId xmlns:a16="http://schemas.microsoft.com/office/drawing/2014/main" id="{BCD1EEE7-9389-421A-9F7F-9C596495776B}"/>
-              </a:ext>
-            </a:extLst>
-          </p:cNvPr>
-          <p:cNvSpPr>
-            <a:spLocks xmlns:a="http://schemas.openxmlformats.org/drawingml/2006/main" noGrp="1"/>
-          </p:cNvSpPr>
-          <p:nvPr/>
-        </p:nvSpPr>
-        <p:spPr>
-          <a:xfrm xmlns:a="http://schemas.openxmlformats.org/drawingml/2006/main">
-            <a:off x="7981950" y="2419350"/>
-            <a:ext cx="1847850" cy="285750"/>
+                <a16:creationId xmlns:a16="http://schemas.microsoft.com/office/drawing/2014/main" id="{29641F51-C013-46C9-BF38-0F7E6C96FD92}"/>
+              </a:ext>
+            </a:extLst>
+          </p:cNvPr>
+          <p:cNvSpPr>
+            <a:spLocks xmlns:a="http://schemas.openxmlformats.org/drawingml/2006/main" noGrp="1"/>
+          </p:cNvSpPr>
+          <p:nvPr/>
+        </p:nvSpPr>
+        <p:spPr>
+          <a:xfrm xmlns:a="http://schemas.openxmlformats.org/drawingml/2006/main">
+            <a:off x="8096250" y="2419350"/>
+            <a:ext cx="2514600" cy="285750"/>
           </a:xfrm>
           <a:prstGeom xmlns:a="http://schemas.openxmlformats.org/drawingml/2006/main" prst="rect">
             <a:avLst/>
@@ -11100,7 +11100,7 @@
                 <a:ea typeface="Aptos"/>
                 <a:cs typeface="Aptos"/>
               </a:rPr>
-              <a:t>Cloud loop</a:t>
+              <a:t>proteinloop_peer@peer</a:t>
             </a:r>
           </a:p>
         </p:txBody>
@@ -11110,19 +11110,19 @@
           <p:cNvPr id="17" name="">
             <a:extLst xmlns:a="http://schemas.openxmlformats.org/drawingml/2006/main">
               <a:ext uri="{FF2B5EF4-FFF2-40B4-BE49-F238E27FC236}">
-                <a16:creationId xmlns:a16="http://schemas.microsoft.com/office/drawing/2014/main" id="{3F7C49D4-0FA9-42A9-A121-582755FE8F0B}"/>
-              </a:ext>
-            </a:extLst>
-          </p:cNvPr>
-          <p:cNvSpPr>
-            <a:spLocks xmlns:a="http://schemas.openxmlformats.org/drawingml/2006/main" noGrp="1"/>
-          </p:cNvSpPr>
-          <p:nvPr/>
-        </p:nvSpPr>
-        <p:spPr>
-          <a:xfrm xmlns:a="http://schemas.openxmlformats.org/drawingml/2006/main">
-            <a:off x="7981950" y="2762250"/>
-            <a:ext cx="1847850" cy="419100"/>
+                <a16:creationId xmlns:a16="http://schemas.microsoft.com/office/drawing/2014/main" id="{97CE3513-6FD2-4E87-9CC8-9360DF42EC54}"/>
+              </a:ext>
+            </a:extLst>
+          </p:cNvPr>
+          <p:cNvSpPr>
+            <a:spLocks xmlns:a="http://schemas.openxmlformats.org/drawingml/2006/main" noGrp="1"/>
+          </p:cNvSpPr>
+          <p:nvPr/>
+        </p:nvSpPr>
+        <p:spPr>
+          <a:xfrm xmlns:a="http://schemas.openxmlformats.org/drawingml/2006/main">
+            <a:off x="8096250" y="2762250"/>
+            <a:ext cx="2514600" cy="514350"/>
           </a:xfrm>
           <a:prstGeom xmlns:a="http://schemas.openxmlformats.org/drawingml/2006/main" prst="rect">
             <a:avLst/>
@@ -11164,7 +11164,7 @@
                 <a:ea typeface="Aptos"/>
                 <a:cs typeface="Aptos"/>
               </a:rPr>
-              <a:t>supervisor remains online</a:t>
+              <a:t>Survivor restores the same Sagents AgentServer state.</a:t>
             </a:r>
           </a:p>
         </p:txBody>
@@ -11174,19 +11174,19 @@
           <p:cNvPr id="18" name="">
             <a:extLst xmlns:a="http://schemas.openxmlformats.org/drawingml/2006/main">
               <a:ext uri="{FF2B5EF4-FFF2-40B4-BE49-F238E27FC236}">
-                <a16:creationId xmlns:a16="http://schemas.microsoft.com/office/drawing/2014/main" id="{F155EC94-3DC4-4B67-ADDA-EA4797417D40}"/>
-              </a:ext>
-            </a:extLst>
-          </p:cNvPr>
-          <p:cNvSpPr>
-            <a:spLocks xmlns:a="http://schemas.openxmlformats.org/drawingml/2006/main" noGrp="1"/>
-          </p:cNvSpPr>
-          <p:nvPr/>
-        </p:nvSpPr>
-        <p:spPr>
-          <a:xfrm xmlns:a="http://schemas.openxmlformats.org/drawingml/2006/main">
-            <a:off x="2247900" y="4095750"/>
-            <a:ext cx="7429500" cy="933450"/>
+                <a16:creationId xmlns:a16="http://schemas.microsoft.com/office/drawing/2014/main" id="{0ADDCD0A-9C31-4528-AA64-443A38C381E4}"/>
+              </a:ext>
+            </a:extLst>
+          </p:cNvPr>
+          <p:cNvSpPr>
+            <a:spLocks xmlns:a="http://schemas.openxmlformats.org/drawingml/2006/main" noGrp="1"/>
+          </p:cNvSpPr>
+          <p:nvPr/>
+        </p:nvSpPr>
+        <p:spPr>
+          <a:xfrm xmlns:a="http://schemas.openxmlformats.org/drawingml/2006/main">
+            <a:off x="990600" y="4038600"/>
+            <a:ext cx="4953000" cy="1104900"/>
           </a:xfrm>
           <a:prstGeom xmlns:a="http://schemas.openxmlformats.org/drawingml/2006/main" prst="rect">
             <a:avLst/>
@@ -11207,19 +11207,19 @@
           <p:cNvPr id="19" name="">
             <a:extLst xmlns:a="http://schemas.openxmlformats.org/drawingml/2006/main">
               <a:ext uri="{FF2B5EF4-FFF2-40B4-BE49-F238E27FC236}">
-                <a16:creationId xmlns:a16="http://schemas.microsoft.com/office/drawing/2014/main" id="{5A6AC410-6F8F-4EFD-87F1-A16E01208498}"/>
-              </a:ext>
-            </a:extLst>
-          </p:cNvPr>
-          <p:cNvSpPr>
-            <a:spLocks xmlns:a="http://schemas.openxmlformats.org/drawingml/2006/main" noGrp="1"/>
-          </p:cNvSpPr>
-          <p:nvPr/>
-        </p:nvSpPr>
-        <p:spPr>
-          <a:xfrm xmlns:a="http://schemas.openxmlformats.org/drawingml/2006/main">
-            <a:off x="2419350" y="4229100"/>
-            <a:ext cx="7086600" cy="285750"/>
+                <a16:creationId xmlns:a16="http://schemas.microsoft.com/office/drawing/2014/main" id="{D93E6615-C02E-40BC-9A4C-3515088890C7}"/>
+              </a:ext>
+            </a:extLst>
+          </p:cNvPr>
+          <p:cNvSpPr>
+            <a:spLocks xmlns:a="http://schemas.openxmlformats.org/drawingml/2006/main" noGrp="1"/>
+          </p:cNvSpPr>
+          <p:nvPr/>
+        </p:nvSpPr>
+        <p:spPr>
+          <a:xfrm xmlns:a="http://schemas.openxmlformats.org/drawingml/2006/main">
+            <a:off x="1162050" y="4171950"/>
+            <a:ext cx="4610100" cy="285750"/>
           </a:xfrm>
           <a:prstGeom xmlns:a="http://schemas.openxmlformats.org/drawingml/2006/main" prst="rect">
             <a:avLst/>
@@ -11261,7 +11261,7 @@
                 <a:ea typeface="Aptos"/>
                 <a:cs typeface="Aptos"/>
               </a:rPr>
-              <a:t>State preservation</a:t>
+              <a:t>Horde proof</a:t>
             </a:r>
           </a:p>
         </p:txBody>
@@ -11271,19 +11271,19 @@
           <p:cNvPr id="20" name="">
             <a:extLst xmlns:a="http://schemas.openxmlformats.org/drawingml/2006/main">
               <a:ext uri="{FF2B5EF4-FFF2-40B4-BE49-F238E27FC236}">
-                <a16:creationId xmlns:a16="http://schemas.microsoft.com/office/drawing/2014/main" id="{36BA5A64-1CE8-4945-972B-8FDA632B7140}"/>
-              </a:ext>
-            </a:extLst>
-          </p:cNvPr>
-          <p:cNvSpPr>
-            <a:spLocks xmlns:a="http://schemas.openxmlformats.org/drawingml/2006/main" noGrp="1"/>
-          </p:cNvSpPr>
-          <p:nvPr/>
-        </p:nvSpPr>
-        <p:spPr>
-          <a:xfrm xmlns:a="http://schemas.openxmlformats.org/drawingml/2006/main">
-            <a:off x="2419350" y="4572000"/>
-            <a:ext cx="7086600" cy="285750"/>
+                <a16:creationId xmlns:a16="http://schemas.microsoft.com/office/drawing/2014/main" id="{6EB98470-97FC-4D5C-B5C5-180D2CD9B524}"/>
+              </a:ext>
+            </a:extLst>
+          </p:cNvPr>
+          <p:cNvSpPr>
+            <a:spLocks xmlns:a="http://schemas.openxmlformats.org/drawingml/2006/main" noGrp="1"/>
+          </p:cNvSpPr>
+          <p:nvPr/>
+        </p:nvSpPr>
+        <p:spPr>
+          <a:xfrm xmlns:a="http://schemas.openxmlformats.org/drawingml/2006/main">
+            <a:off x="1162050" y="4514850"/>
+            <a:ext cx="4610100" cy="457200"/>
           </a:xfrm>
           <a:prstGeom xmlns:a="http://schemas.openxmlformats.org/drawingml/2006/main" prst="rect">
             <a:avLst/>
@@ -11325,7 +11325,7 @@
                 <a:ea typeface="Aptos"/>
                 <a:cs typeface="Aptos"/>
               </a:rPr>
-              <a:t>Agent identities and state tokens survive migration; dashboard shows node state, placement, migration count, and events.</a:t>
+              <a:t>Identity, state token, and fingerprint stay unchanged; restore_count increases on the peer and both nodes rejoin.</a:t>
             </a:r>
           </a:p>
         </p:txBody>
@@ -11335,7 +11335,168 @@
           <p:cNvPr id="21" name="">
             <a:extLst xmlns:a="http://schemas.openxmlformats.org/drawingml/2006/main">
               <a:ext uri="{FF2B5EF4-FFF2-40B4-BE49-F238E27FC236}">
-                <a16:creationId xmlns:a16="http://schemas.microsoft.com/office/drawing/2014/main" id="{88925E3B-811D-462B-8263-D9D4E1E3B356}"/>
+                <a16:creationId xmlns:a16="http://schemas.microsoft.com/office/drawing/2014/main" id="{E54B728C-7204-490D-BCE0-E7CBFA694B04}"/>
+              </a:ext>
+            </a:extLst>
+          </p:cNvPr>
+          <p:cNvSpPr>
+            <a:spLocks xmlns:a="http://schemas.openxmlformats.org/drawingml/2006/main" noGrp="1"/>
+          </p:cNvSpPr>
+          <p:nvPr/>
+        </p:nvSpPr>
+        <p:spPr>
+          <a:xfrm xmlns:a="http://schemas.openxmlformats.org/drawingml/2006/main">
+            <a:off x="6248400" y="4038600"/>
+            <a:ext cx="4953000" cy="1104900"/>
+          </a:xfrm>
+          <a:prstGeom xmlns:a="http://schemas.openxmlformats.org/drawingml/2006/main" prst="rect">
+            <a:avLst/>
+          </a:prstGeom>
+          <a:solidFill xmlns:a="http://schemas.openxmlformats.org/drawingml/2006/main">
+            <a:srgbClr val="DCFCE7"/>
+          </a:solidFill>
+          <a:ln xmlns:a="http://schemas.openxmlformats.org/drawingml/2006/main" w="19050">
+            <a:solidFill>
+              <a:srgbClr val="15803D"/>
+            </a:solidFill>
+            <a:prstDash val="solid"/>
+          </a:ln>
+        </p:spPr>
+      </p:sp>
+      <p:sp>
+        <p:nvSpPr>
+          <p:cNvPr id="22" name="">
+            <a:extLst xmlns:a="http://schemas.openxmlformats.org/drawingml/2006/main">
+              <a:ext uri="{FF2B5EF4-FFF2-40B4-BE49-F238E27FC236}">
+                <a16:creationId xmlns:a16="http://schemas.microsoft.com/office/drawing/2014/main" id="{0E01740F-3957-4FD9-B234-F8826BFF6279}"/>
+              </a:ext>
+            </a:extLst>
+          </p:cNvPr>
+          <p:cNvSpPr>
+            <a:spLocks xmlns:a="http://schemas.openxmlformats.org/drawingml/2006/main" noGrp="1"/>
+          </p:cNvSpPr>
+          <p:nvPr/>
+        </p:nvSpPr>
+        <p:spPr>
+          <a:xfrm xmlns:a="http://schemas.openxmlformats.org/drawingml/2006/main">
+            <a:off x="6419850" y="4171950"/>
+            <a:ext cx="4610100" cy="285750"/>
+          </a:xfrm>
+          <a:prstGeom xmlns:a="http://schemas.openxmlformats.org/drawingml/2006/main" prst="rect">
+            <a:avLst/>
+          </a:prstGeom>
+          <a:solidFill xmlns:a="http://schemas.openxmlformats.org/drawingml/2006/main">
+            <a:srgbClr val="000000">
+              <a:alpha val="0"/>
+            </a:srgbClr>
+          </a:solidFill>
+          <a:ln xmlns:a="http://schemas.openxmlformats.org/drawingml/2006/main" w="0">
+            <a:solidFill>
+              <a:srgbClr val="000000">
+                <a:alpha val="0"/>
+              </a:srgbClr>
+            </a:solidFill>
+            <a:prstDash val="solid"/>
+          </a:ln>
+        </p:spPr>
+        <p:txBody>
+          <a:bodyPr xmlns:a="http://schemas.openxmlformats.org/drawingml/2006/main" lIns="0" tIns="0" rIns="0" bIns="0" anchor="t"/>
+          <a:lstStyle xmlns:a="http://schemas.openxmlformats.org/drawingml/2006/main"/>
+          <a:p xmlns:a="http://schemas.openxmlformats.org/drawingml/2006/main">
+            <a:pPr algn="l">
+              <a:defRPr sz="1350" b="1">
+                <a:solidFill>
+                  <a:srgbClr val="0F172A"/>
+                </a:solidFill>
+                <a:latin typeface="Aptos"/>
+                <a:ea typeface="Aptos"/>
+                <a:cs typeface="Aptos"/>
+              </a:defRPr>
+            </a:pPr>
+            <a:r>
+              <a:rPr sz="1350" b="1">
+                <a:solidFill>
+                  <a:srgbClr val="0F172A"/>
+                </a:solidFill>
+                <a:latin typeface="Aptos"/>
+                <a:ea typeface="Aptos"/>
+                <a:cs typeface="Aptos"/>
+              </a:rPr>
+              <a:t>Physical DECT NR+ proof</a:t>
+            </a:r>
+          </a:p>
+        </p:txBody>
+      </p:sp>
+      <p:sp>
+        <p:nvSpPr>
+          <p:cNvPr id="23" name="">
+            <a:extLst xmlns:a="http://schemas.openxmlformats.org/drawingml/2006/main">
+              <a:ext uri="{FF2B5EF4-FFF2-40B4-BE49-F238E27FC236}">
+                <a16:creationId xmlns:a16="http://schemas.microsoft.com/office/drawing/2014/main" id="{0C4BC3CF-8D99-4139-9472-053497ADC588}"/>
+              </a:ext>
+            </a:extLst>
+          </p:cNvPr>
+          <p:cNvSpPr>
+            <a:spLocks xmlns:a="http://schemas.openxmlformats.org/drawingml/2006/main" noGrp="1"/>
+          </p:cNvSpPr>
+          <p:nvPr/>
+        </p:nvSpPr>
+        <p:spPr>
+          <a:xfrm xmlns:a="http://schemas.openxmlformats.org/drawingml/2006/main">
+            <a:off x="6419850" y="4514850"/>
+            <a:ext cx="4610100" cy="457200"/>
+          </a:xfrm>
+          <a:prstGeom xmlns:a="http://schemas.openxmlformats.org/drawingml/2006/main" prst="rect">
+            <a:avLst/>
+          </a:prstGeom>
+          <a:solidFill xmlns:a="http://schemas.openxmlformats.org/drawingml/2006/main">
+            <a:srgbClr val="000000">
+              <a:alpha val="0"/>
+            </a:srgbClr>
+          </a:solidFill>
+          <a:ln xmlns:a="http://schemas.openxmlformats.org/drawingml/2006/main" w="0">
+            <a:solidFill>
+              <a:srgbClr val="000000">
+                <a:alpha val="0"/>
+              </a:srgbClr>
+            </a:solidFill>
+            <a:prstDash val="solid"/>
+          </a:ln>
+        </p:spPr>
+        <p:txBody>
+          <a:bodyPr xmlns:a="http://schemas.openxmlformats.org/drawingml/2006/main" lIns="0" tIns="0" rIns="0" bIns="0" anchor="t"/>
+          <a:lstStyle xmlns:a="http://schemas.openxmlformats.org/drawingml/2006/main"/>
+          <a:p xmlns:a="http://schemas.openxmlformats.org/drawingml/2006/main">
+            <a:pPr algn="l">
+              <a:defRPr sz="900" b="0">
+                <a:solidFill>
+                  <a:srgbClr val="334155"/>
+                </a:solidFill>
+                <a:latin typeface="Aptos"/>
+                <a:ea typeface="Aptos"/>
+                <a:cs typeface="Aptos"/>
+              </a:defRPr>
+            </a:pPr>
+            <a:r>
+              <a:rPr sz="900" b="0">
+                <a:solidFill>
+                  <a:srgbClr val="334155"/>
+                </a:solidFill>
+                <a:latin typeface="Aptos"/>
+                <a:ea typeface="Aptos"/>
+                <a:cs typeface="Aptos"/>
+              </a:rPr>
+              <a:t>FT 1051223739 and PT 1051239227 show matching sequences in both directions. Read-only capture; no flash/reset; simulated: false.</a:t>
+            </a:r>
+          </a:p>
+        </p:txBody>
+      </p:sp>
+      <p:sp>
+        <p:nvSpPr>
+          <p:cNvPr id="24" name="">
+            <a:extLst xmlns:a="http://schemas.openxmlformats.org/drawingml/2006/main">
+              <a:ext uri="{FF2B5EF4-FFF2-40B4-BE49-F238E27FC236}">
+                <a16:creationId xmlns:a16="http://schemas.microsoft.com/office/drawing/2014/main" id="{B9986920-10E1-4A1E-B310-864045807CBC}"/>
               </a:ext>
             </a:extLst>
           </p:cNvPr>
@@ -11396,10 +11557,10 @@
       </p:sp>
       <p:sp>
         <p:nvSpPr>
-          <p:cNvPr id="22" name="">
-            <a:extLst xmlns:a="http://schemas.openxmlformats.org/drawingml/2006/main">
-              <a:ext uri="{FF2B5EF4-FFF2-40B4-BE49-F238E27FC236}">
-                <a16:creationId xmlns:a16="http://schemas.microsoft.com/office/drawing/2014/main" id="{A165019A-08AD-4D4D-B607-40DEB240E903}"/>
+          <p:cNvPr id="25" name="">
+            <a:extLst xmlns:a="http://schemas.openxmlformats.org/drawingml/2006/main">
+              <a:ext uri="{FF2B5EF4-FFF2-40B4-BE49-F238E27FC236}">
+                <a16:creationId xmlns:a16="http://schemas.microsoft.com/office/drawing/2014/main" id="{E5E7170F-3D6F-42BF-ABF0-4D8FC054134C}"/>
               </a:ext>
             </a:extLst>
           </p:cNvPr>
@@ -11461,7 +11622,7 @@
     </p:spTree>
     <p:extLst>
       <p:ext uri="{BB962C8B-B14F-4D97-AF65-F5344CB8AC3E}">
-        <p14:creationId xmlns:p14="http://schemas.microsoft.com/office/powerpoint/2010/main" val="1217616342"/>
+        <p14:creationId xmlns:p14="http://schemas.microsoft.com/office/powerpoint/2010/main" val="894989379"/>
       </p:ext>
     </p:extLst>
   </p:cSld>
@@ -11485,7 +11646,7 @@
           <p:cNvPr id="1" name="">
             <a:extLst xmlns:a="http://schemas.openxmlformats.org/drawingml/2006/main">
               <a:ext uri="{FF2B5EF4-FFF2-40B4-BE49-F238E27FC236}">
-                <a16:creationId xmlns:a16="http://schemas.microsoft.com/office/drawing/2014/main" id="{8D6F9B3A-95B3-4403-8A83-09397486FB13}"/>
+                <a16:creationId xmlns:a16="http://schemas.microsoft.com/office/drawing/2014/main" id="{F5AB9C48-3707-4ABA-91D0-928563A1AA84}"/>
               </a:ext>
             </a:extLst>
           </p:cNvPr>
@@ -11520,7 +11681,7 @@
           <p:cNvPr id="2" name="">
             <a:extLst xmlns:a="http://schemas.openxmlformats.org/drawingml/2006/main">
               <a:ext uri="{FF2B5EF4-FFF2-40B4-BE49-F238E27FC236}">
-                <a16:creationId xmlns:a16="http://schemas.microsoft.com/office/drawing/2014/main" id="{DDF3C9BE-0EAC-42A7-B895-89E455D457ED}"/>
+                <a16:creationId xmlns:a16="http://schemas.microsoft.com/office/drawing/2014/main" id="{FF3CFDEE-6721-475D-9B21-DEB927C66EAC}"/>
               </a:ext>
             </a:extLst>
           </p:cNvPr>
@@ -11555,7 +11716,7 @@
           <p:cNvPr id="3" name="">
             <a:extLst xmlns:a="http://schemas.openxmlformats.org/drawingml/2006/main">
               <a:ext uri="{FF2B5EF4-FFF2-40B4-BE49-F238E27FC236}">
-                <a16:creationId xmlns:a16="http://schemas.microsoft.com/office/drawing/2014/main" id="{B69DDFDF-577A-415C-A63F-F4EC6F225BF2}"/>
+                <a16:creationId xmlns:a16="http://schemas.microsoft.com/office/drawing/2014/main" id="{5A216F91-30FF-48FB-BCB8-0C9E0326860B}"/>
               </a:ext>
             </a:extLst>
           </p:cNvPr>
@@ -11619,7 +11780,7 @@
           <p:cNvPr id="4" name="">
             <a:extLst xmlns:a="http://schemas.openxmlformats.org/drawingml/2006/main">
               <a:ext uri="{FF2B5EF4-FFF2-40B4-BE49-F238E27FC236}">
-                <a16:creationId xmlns:a16="http://schemas.microsoft.com/office/drawing/2014/main" id="{2788CF8E-A10B-43AD-BB88-17F158771E3B}"/>
+                <a16:creationId xmlns:a16="http://schemas.microsoft.com/office/drawing/2014/main" id="{BE2E5382-E92B-4ACF-B588-7D3CEAF6CFCB}"/>
               </a:ext>
             </a:extLst>
           </p:cNvPr>
@@ -11683,7 +11844,7 @@
           <p:cNvPr id="5" name="">
             <a:extLst xmlns:a="http://schemas.openxmlformats.org/drawingml/2006/main">
               <a:ext uri="{FF2B5EF4-FFF2-40B4-BE49-F238E27FC236}">
-                <a16:creationId xmlns:a16="http://schemas.microsoft.com/office/drawing/2014/main" id="{0F4E2AE2-1893-4260-A3AC-1507B9915DEA}"/>
+                <a16:creationId xmlns:a16="http://schemas.microsoft.com/office/drawing/2014/main" id="{56556A74-50E9-47CC-89B6-790594C3431E}"/>
               </a:ext>
             </a:extLst>
           </p:cNvPr>
@@ -11747,7 +11908,7 @@
           <p:cNvPr id="6" name="">
             <a:extLst xmlns:a="http://schemas.openxmlformats.org/drawingml/2006/main">
               <a:ext uri="{FF2B5EF4-FFF2-40B4-BE49-F238E27FC236}">
-                <a16:creationId xmlns:a16="http://schemas.microsoft.com/office/drawing/2014/main" id="{6854B780-0503-4FFD-926B-372813D327AA}"/>
+                <a16:creationId xmlns:a16="http://schemas.microsoft.com/office/drawing/2014/main" id="{3A7B6E0A-66A3-4C41-A87D-9345D320D843}"/>
               </a:ext>
             </a:extLst>
           </p:cNvPr>
@@ -11811,7 +11972,7 @@
           <p:cNvPr id="7" name="">
             <a:extLst xmlns:a="http://schemas.openxmlformats.org/drawingml/2006/main">
               <a:ext uri="{FF2B5EF4-FFF2-40B4-BE49-F238E27FC236}">
-                <a16:creationId xmlns:a16="http://schemas.microsoft.com/office/drawing/2014/main" id="{EB05B9FB-1674-4A96-ADB5-A5CEEF747AEB}"/>
+                <a16:creationId xmlns:a16="http://schemas.microsoft.com/office/drawing/2014/main" id="{BC8116F3-0C38-41B3-BA11-C4294171ADF2}"/>
               </a:ext>
             </a:extLst>
           </p:cNvPr>
@@ -11844,7 +12005,7 @@
           <p:cNvPr id="8" name="">
             <a:extLst xmlns:a="http://schemas.openxmlformats.org/drawingml/2006/main">
               <a:ext uri="{FF2B5EF4-FFF2-40B4-BE49-F238E27FC236}">
-                <a16:creationId xmlns:a16="http://schemas.microsoft.com/office/drawing/2014/main" id="{D19C04AC-1657-496D-89A7-DE90FD2DDB02}"/>
+                <a16:creationId xmlns:a16="http://schemas.microsoft.com/office/drawing/2014/main" id="{30C9D99B-A16E-49FB-85FF-E8A6D4621BF2}"/>
               </a:ext>
             </a:extLst>
           </p:cNvPr>
@@ -11908,7 +12069,7 @@
           <p:cNvPr id="9" name="">
             <a:extLst xmlns:a="http://schemas.openxmlformats.org/drawingml/2006/main">
               <a:ext uri="{FF2B5EF4-FFF2-40B4-BE49-F238E27FC236}">
-                <a16:creationId xmlns:a16="http://schemas.microsoft.com/office/drawing/2014/main" id="{1494A035-F27C-4EA8-A722-CC8F38DF82B8}"/>
+                <a16:creationId xmlns:a16="http://schemas.microsoft.com/office/drawing/2014/main" id="{7B581F83-3718-44D7-BD16-BC4B9AC22F58}"/>
               </a:ext>
             </a:extLst>
           </p:cNvPr>
@@ -11972,7 +12133,7 @@
           <p:cNvPr id="10" name="">
             <a:extLst xmlns:a="http://schemas.openxmlformats.org/drawingml/2006/main">
               <a:ext uri="{FF2B5EF4-FFF2-40B4-BE49-F238E27FC236}">
-                <a16:creationId xmlns:a16="http://schemas.microsoft.com/office/drawing/2014/main" id="{1AD970BA-BA2B-48A7-A9CC-D321379A5CBA}"/>
+                <a16:creationId xmlns:a16="http://schemas.microsoft.com/office/drawing/2014/main" id="{00CB59BF-E26F-4576-8CC5-342A22C5BE07}"/>
               </a:ext>
             </a:extLst>
           </p:cNvPr>
@@ -12005,7 +12166,7 @@
           <p:cNvPr id="11" name="">
             <a:extLst xmlns:a="http://schemas.openxmlformats.org/drawingml/2006/main">
               <a:ext uri="{FF2B5EF4-FFF2-40B4-BE49-F238E27FC236}">
-                <a16:creationId xmlns:a16="http://schemas.microsoft.com/office/drawing/2014/main" id="{8A21249A-AF4E-4450-97F4-D34FCAFF79E1}"/>
+                <a16:creationId xmlns:a16="http://schemas.microsoft.com/office/drawing/2014/main" id="{FA16A7A0-5CBB-4604-A76B-F6B9971CA29D}"/>
               </a:ext>
             </a:extLst>
           </p:cNvPr>
@@ -12069,7 +12230,7 @@
           <p:cNvPr id="12" name="">
             <a:extLst xmlns:a="http://schemas.openxmlformats.org/drawingml/2006/main">
               <a:ext uri="{FF2B5EF4-FFF2-40B4-BE49-F238E27FC236}">
-                <a16:creationId xmlns:a16="http://schemas.microsoft.com/office/drawing/2014/main" id="{DF67E499-500E-468E-8511-1225D439561B}"/>
+                <a16:creationId xmlns:a16="http://schemas.microsoft.com/office/drawing/2014/main" id="{3D67D7DA-EDDC-4128-97F1-6C8A7250CBF1}"/>
               </a:ext>
             </a:extLst>
           </p:cNvPr>
@@ -12133,7 +12294,7 @@
           <p:cNvPr id="13" name="">
             <a:extLst xmlns:a="http://schemas.openxmlformats.org/drawingml/2006/main">
               <a:ext uri="{FF2B5EF4-FFF2-40B4-BE49-F238E27FC236}">
-                <a16:creationId xmlns:a16="http://schemas.microsoft.com/office/drawing/2014/main" id="{66A42672-B23F-42C9-BD7C-67BA3A5BD43D}"/>
+                <a16:creationId xmlns:a16="http://schemas.microsoft.com/office/drawing/2014/main" id="{14990FAE-25B3-48CA-8C2E-5837FCA1B264}"/>
               </a:ext>
             </a:extLst>
           </p:cNvPr>
@@ -12166,7 +12327,7 @@
           <p:cNvPr id="14" name="">
             <a:extLst xmlns:a="http://schemas.openxmlformats.org/drawingml/2006/main">
               <a:ext uri="{FF2B5EF4-FFF2-40B4-BE49-F238E27FC236}">
-                <a16:creationId xmlns:a16="http://schemas.microsoft.com/office/drawing/2014/main" id="{17F84962-2C50-4630-9C8F-FE304AB79F08}"/>
+                <a16:creationId xmlns:a16="http://schemas.microsoft.com/office/drawing/2014/main" id="{5ED000CE-4E56-4CFA-974D-244120448596}"/>
               </a:ext>
             </a:extLst>
           </p:cNvPr>
@@ -12230,7 +12391,7 @@
           <p:cNvPr id="15" name="">
             <a:extLst xmlns:a="http://schemas.openxmlformats.org/drawingml/2006/main">
               <a:ext uri="{FF2B5EF4-FFF2-40B4-BE49-F238E27FC236}">
-                <a16:creationId xmlns:a16="http://schemas.microsoft.com/office/drawing/2014/main" id="{69F480E6-FADF-4059-A6C5-C933A2FFA56B}"/>
+                <a16:creationId xmlns:a16="http://schemas.microsoft.com/office/drawing/2014/main" id="{1EF90A72-4F5D-492D-9734-7E168F09BC17}"/>
               </a:ext>
             </a:extLst>
           </p:cNvPr>
@@ -12294,7 +12455,7 @@
           <p:cNvPr id="16" name="">
             <a:extLst xmlns:a="http://schemas.openxmlformats.org/drawingml/2006/main">
               <a:ext uri="{FF2B5EF4-FFF2-40B4-BE49-F238E27FC236}">
-                <a16:creationId xmlns:a16="http://schemas.microsoft.com/office/drawing/2014/main" id="{307BA486-BB35-4AB8-8216-1180E6B81B5F}"/>
+                <a16:creationId xmlns:a16="http://schemas.microsoft.com/office/drawing/2014/main" id="{42326A9D-014C-4A01-8FEA-43310B910BA0}"/>
               </a:ext>
             </a:extLst>
           </p:cNvPr>
@@ -12358,7 +12519,7 @@
           <p:cNvPr id="17" name="">
             <a:extLst xmlns:a="http://schemas.openxmlformats.org/drawingml/2006/main">
               <a:ext uri="{FF2B5EF4-FFF2-40B4-BE49-F238E27FC236}">
-                <a16:creationId xmlns:a16="http://schemas.microsoft.com/office/drawing/2014/main" id="{AFDCAB50-0561-4075-9E79-16FD37C649F7}"/>
+                <a16:creationId xmlns:a16="http://schemas.microsoft.com/office/drawing/2014/main" id="{FC847C5D-B557-4ABC-8BCE-12B266D36FDE}"/>
               </a:ext>
             </a:extLst>
           </p:cNvPr>
@@ -12420,7 +12581,7 @@
     </p:spTree>
     <p:extLst>
       <p:ext uri="{BB962C8B-B14F-4D97-AF65-F5344CB8AC3E}">
-        <p14:creationId xmlns:p14="http://schemas.microsoft.com/office/powerpoint/2010/main" val="1575960991"/>
+        <p14:creationId xmlns:p14="http://schemas.microsoft.com/office/powerpoint/2010/main" val="1299017446"/>
       </p:ext>
     </p:extLst>
   </p:cSld>
@@ -12444,7 +12605,7 @@
           <p:cNvPr id="1" name="">
             <a:extLst xmlns:a="http://schemas.openxmlformats.org/drawingml/2006/main">
               <a:ext uri="{FF2B5EF4-FFF2-40B4-BE49-F238E27FC236}">
-                <a16:creationId xmlns:a16="http://schemas.microsoft.com/office/drawing/2014/main" id="{E1830D12-13A8-4CE6-9BC6-E5812B2BC2E1}"/>
+                <a16:creationId xmlns:a16="http://schemas.microsoft.com/office/drawing/2014/main" id="{3FCCEBB8-0774-4B6C-8596-302046377472}"/>
               </a:ext>
             </a:extLst>
           </p:cNvPr>
@@ -12479,7 +12640,7 @@
           <p:cNvPr id="2" name="">
             <a:extLst xmlns:a="http://schemas.openxmlformats.org/drawingml/2006/main">
               <a:ext uri="{FF2B5EF4-FFF2-40B4-BE49-F238E27FC236}">
-                <a16:creationId xmlns:a16="http://schemas.microsoft.com/office/drawing/2014/main" id="{89B97856-A5CD-454B-8340-D598B9020F6C}"/>
+                <a16:creationId xmlns:a16="http://schemas.microsoft.com/office/drawing/2014/main" id="{AA8149D3-884B-4C50-B41A-E9211D4207FE}"/>
               </a:ext>
             </a:extLst>
           </p:cNvPr>
@@ -12514,7 +12675,7 @@
           <p:cNvPr id="3" name="">
             <a:extLst xmlns:a="http://schemas.openxmlformats.org/drawingml/2006/main">
               <a:ext uri="{FF2B5EF4-FFF2-40B4-BE49-F238E27FC236}">
-                <a16:creationId xmlns:a16="http://schemas.microsoft.com/office/drawing/2014/main" id="{3A5F680B-AAB6-44B6-8249-8D63932DD00F}"/>
+                <a16:creationId xmlns:a16="http://schemas.microsoft.com/office/drawing/2014/main" id="{D0B746C9-0D79-4D6A-9939-23E12B7D05FE}"/>
               </a:ext>
             </a:extLst>
           </p:cNvPr>
@@ -12578,7 +12739,7 @@
           <p:cNvPr id="4" name="">
             <a:extLst xmlns:a="http://schemas.openxmlformats.org/drawingml/2006/main">
               <a:ext uri="{FF2B5EF4-FFF2-40B4-BE49-F238E27FC236}">
-                <a16:creationId xmlns:a16="http://schemas.microsoft.com/office/drawing/2014/main" id="{B5C39897-2C4E-46C1-9FD7-7C9FB2A222A9}"/>
+                <a16:creationId xmlns:a16="http://schemas.microsoft.com/office/drawing/2014/main" id="{CE1E4234-F25E-4C74-8E5C-52E2B7C2748D}"/>
               </a:ext>
             </a:extLst>
           </p:cNvPr>
@@ -12642,7 +12803,7 @@
           <p:cNvPr id="5" name="">
             <a:extLst xmlns:a="http://schemas.openxmlformats.org/drawingml/2006/main">
               <a:ext uri="{FF2B5EF4-FFF2-40B4-BE49-F238E27FC236}">
-                <a16:creationId xmlns:a16="http://schemas.microsoft.com/office/drawing/2014/main" id="{4D1DCACD-AC40-417A-8922-8DC32DEC5635}"/>
+                <a16:creationId xmlns:a16="http://schemas.microsoft.com/office/drawing/2014/main" id="{0DB004C7-1CE1-4123-A8F6-C0F66815DADC}"/>
               </a:ext>
             </a:extLst>
           </p:cNvPr>
@@ -12706,7 +12867,7 @@
           <p:cNvPr id="6" name="">
             <a:extLst xmlns:a="http://schemas.openxmlformats.org/drawingml/2006/main">
               <a:ext uri="{FF2B5EF4-FFF2-40B4-BE49-F238E27FC236}">
-                <a16:creationId xmlns:a16="http://schemas.microsoft.com/office/drawing/2014/main" id="{A9FF5E37-D72F-4898-A2ED-83963AB78FD6}"/>
+                <a16:creationId xmlns:a16="http://schemas.microsoft.com/office/drawing/2014/main" id="{0B1E51EA-A0E3-4BB0-9B57-C5CD371EEC67}"/>
               </a:ext>
             </a:extLst>
           </p:cNvPr>
@@ -12770,7 +12931,7 @@
           <p:cNvPr id="7" name="">
             <a:extLst xmlns:a="http://schemas.openxmlformats.org/drawingml/2006/main">
               <a:ext uri="{FF2B5EF4-FFF2-40B4-BE49-F238E27FC236}">
-                <a16:creationId xmlns:a16="http://schemas.microsoft.com/office/drawing/2014/main" id="{DEC782A2-B6F7-427B-9310-4A627B02DE23}"/>
+                <a16:creationId xmlns:a16="http://schemas.microsoft.com/office/drawing/2014/main" id="{0EE0156C-EDB2-45F1-85D7-D2CFB153AFF3}"/>
               </a:ext>
             </a:extLst>
           </p:cNvPr>
@@ -12803,7 +12964,7 @@
           <p:cNvPr id="8" name="">
             <a:extLst xmlns:a="http://schemas.openxmlformats.org/drawingml/2006/main">
               <a:ext uri="{FF2B5EF4-FFF2-40B4-BE49-F238E27FC236}">
-                <a16:creationId xmlns:a16="http://schemas.microsoft.com/office/drawing/2014/main" id="{0B1CCF46-BD28-4AFC-97B4-BB21C8DD8EA8}"/>
+                <a16:creationId xmlns:a16="http://schemas.microsoft.com/office/drawing/2014/main" id="{C85F6F62-487B-4D15-8A11-FFCE5290CE8B}"/>
               </a:ext>
             </a:extLst>
           </p:cNvPr>
@@ -12867,7 +13028,7 @@
           <p:cNvPr id="9" name="">
             <a:extLst xmlns:a="http://schemas.openxmlformats.org/drawingml/2006/main">
               <a:ext uri="{FF2B5EF4-FFF2-40B4-BE49-F238E27FC236}">
-                <a16:creationId xmlns:a16="http://schemas.microsoft.com/office/drawing/2014/main" id="{5158D5B1-CEDF-48AB-B52E-CBDB3DBE7D4B}"/>
+                <a16:creationId xmlns:a16="http://schemas.microsoft.com/office/drawing/2014/main" id="{B80DDE88-4D5F-4156-960E-31CBCF4BD206}"/>
               </a:ext>
             </a:extLst>
           </p:cNvPr>
@@ -12931,7 +13092,7 @@
           <p:cNvPr id="10" name="">
             <a:extLst xmlns:a="http://schemas.openxmlformats.org/drawingml/2006/main">
               <a:ext uri="{FF2B5EF4-FFF2-40B4-BE49-F238E27FC236}">
-                <a16:creationId xmlns:a16="http://schemas.microsoft.com/office/drawing/2014/main" id="{6906E812-A3DC-4EA1-B435-F5ACF4C0B7F7}"/>
+                <a16:creationId xmlns:a16="http://schemas.microsoft.com/office/drawing/2014/main" id="{641DC02F-77B7-4925-A8C1-D84C5CAC852A}"/>
               </a:ext>
             </a:extLst>
           </p:cNvPr>
@@ -12995,7 +13156,7 @@
           <p:cNvPr id="11" name="">
             <a:extLst xmlns:a="http://schemas.openxmlformats.org/drawingml/2006/main">
               <a:ext uri="{FF2B5EF4-FFF2-40B4-BE49-F238E27FC236}">
-                <a16:creationId xmlns:a16="http://schemas.microsoft.com/office/drawing/2014/main" id="{01B73A02-7FF9-4DDD-A569-5C60C9BDB8C6}"/>
+                <a16:creationId xmlns:a16="http://schemas.microsoft.com/office/drawing/2014/main" id="{078BBAFB-6080-4896-95C4-A3D9D5B56CC9}"/>
               </a:ext>
             </a:extLst>
           </p:cNvPr>
@@ -13028,7 +13189,7 @@
           <p:cNvPr id="12" name="">
             <a:extLst xmlns:a="http://schemas.openxmlformats.org/drawingml/2006/main">
               <a:ext uri="{FF2B5EF4-FFF2-40B4-BE49-F238E27FC236}">
-                <a16:creationId xmlns:a16="http://schemas.microsoft.com/office/drawing/2014/main" id="{268DB2AE-48ED-4F1F-9F12-0ABC6AF7F39D}"/>
+                <a16:creationId xmlns:a16="http://schemas.microsoft.com/office/drawing/2014/main" id="{C879206C-EBD3-42D0-B33E-1DC17E087C22}"/>
               </a:ext>
             </a:extLst>
           </p:cNvPr>
@@ -13092,7 +13253,7 @@
           <p:cNvPr id="13" name="">
             <a:extLst xmlns:a="http://schemas.openxmlformats.org/drawingml/2006/main">
               <a:ext uri="{FF2B5EF4-FFF2-40B4-BE49-F238E27FC236}">
-                <a16:creationId xmlns:a16="http://schemas.microsoft.com/office/drawing/2014/main" id="{D8DA8C88-2A4E-4CC6-ACBA-E79B0B8ED601}"/>
+                <a16:creationId xmlns:a16="http://schemas.microsoft.com/office/drawing/2014/main" id="{3C0CDAEE-C272-4626-979A-71EDA524F048}"/>
               </a:ext>
             </a:extLst>
           </p:cNvPr>
@@ -13156,7 +13317,7 @@
           <p:cNvPr id="14" name="">
             <a:extLst xmlns:a="http://schemas.openxmlformats.org/drawingml/2006/main">
               <a:ext uri="{FF2B5EF4-FFF2-40B4-BE49-F238E27FC236}">
-                <a16:creationId xmlns:a16="http://schemas.microsoft.com/office/drawing/2014/main" id="{F6A0B8AF-82D6-4495-B1D5-490259B8DA3D}"/>
+                <a16:creationId xmlns:a16="http://schemas.microsoft.com/office/drawing/2014/main" id="{EA18C95C-BAA1-443A-B6FB-F8023E8050DE}"/>
               </a:ext>
             </a:extLst>
           </p:cNvPr>
@@ -13220,7 +13381,7 @@
           <p:cNvPr id="15" name="">
             <a:extLst xmlns:a="http://schemas.openxmlformats.org/drawingml/2006/main">
               <a:ext uri="{FF2B5EF4-FFF2-40B4-BE49-F238E27FC236}">
-                <a16:creationId xmlns:a16="http://schemas.microsoft.com/office/drawing/2014/main" id="{34A48475-FB99-4905-893C-1A5A79D17F46}"/>
+                <a16:creationId xmlns:a16="http://schemas.microsoft.com/office/drawing/2014/main" id="{C9FD19DD-BE45-43A2-882F-A4FFF9EB56CD}"/>
               </a:ext>
             </a:extLst>
           </p:cNvPr>
@@ -13253,7 +13414,7 @@
           <p:cNvPr id="16" name="">
             <a:extLst xmlns:a="http://schemas.openxmlformats.org/drawingml/2006/main">
               <a:ext uri="{FF2B5EF4-FFF2-40B4-BE49-F238E27FC236}">
-                <a16:creationId xmlns:a16="http://schemas.microsoft.com/office/drawing/2014/main" id="{229EB372-C2D3-49C7-882F-54AE46C6C1F2}"/>
+                <a16:creationId xmlns:a16="http://schemas.microsoft.com/office/drawing/2014/main" id="{2B5F6829-7676-494C-9C75-B9DCD1801F75}"/>
               </a:ext>
             </a:extLst>
           </p:cNvPr>
@@ -13317,7 +13478,7 @@
           <p:cNvPr id="17" name="">
             <a:extLst xmlns:a="http://schemas.openxmlformats.org/drawingml/2006/main">
               <a:ext uri="{FF2B5EF4-FFF2-40B4-BE49-F238E27FC236}">
-                <a16:creationId xmlns:a16="http://schemas.microsoft.com/office/drawing/2014/main" id="{04D995B1-2815-4CFA-9245-F3D10AF56534}"/>
+                <a16:creationId xmlns:a16="http://schemas.microsoft.com/office/drawing/2014/main" id="{A63760F5-5016-4C38-9C15-EC5823584193}"/>
               </a:ext>
             </a:extLst>
           </p:cNvPr>
@@ -13381,7 +13542,7 @@
           <p:cNvPr id="18" name="">
             <a:extLst xmlns:a="http://schemas.openxmlformats.org/drawingml/2006/main">
               <a:ext uri="{FF2B5EF4-FFF2-40B4-BE49-F238E27FC236}">
-                <a16:creationId xmlns:a16="http://schemas.microsoft.com/office/drawing/2014/main" id="{2EC9B8F7-0EAF-47FC-A7C3-2E2F195D908F}"/>
+                <a16:creationId xmlns:a16="http://schemas.microsoft.com/office/drawing/2014/main" id="{274C8AC0-5C0A-41AD-82A0-CCE202996F05}"/>
               </a:ext>
             </a:extLst>
           </p:cNvPr>
@@ -13414,7 +13575,7 @@
           <p:cNvPr id="19" name="">
             <a:extLst xmlns:a="http://schemas.openxmlformats.org/drawingml/2006/main">
               <a:ext uri="{FF2B5EF4-FFF2-40B4-BE49-F238E27FC236}">
-                <a16:creationId xmlns:a16="http://schemas.microsoft.com/office/drawing/2014/main" id="{E9D338E2-0655-49F4-80C6-74020E3D7F4D}"/>
+                <a16:creationId xmlns:a16="http://schemas.microsoft.com/office/drawing/2014/main" id="{0F878021-E91C-4105-AEE5-528E2A43F60C}"/>
               </a:ext>
             </a:extLst>
           </p:cNvPr>
@@ -13478,7 +13639,7 @@
           <p:cNvPr id="20" name="">
             <a:extLst xmlns:a="http://schemas.openxmlformats.org/drawingml/2006/main">
               <a:ext uri="{FF2B5EF4-FFF2-40B4-BE49-F238E27FC236}">
-                <a16:creationId xmlns:a16="http://schemas.microsoft.com/office/drawing/2014/main" id="{B2C15674-A2D6-4F92-B397-AA62D7960F6F}"/>
+                <a16:creationId xmlns:a16="http://schemas.microsoft.com/office/drawing/2014/main" id="{74C8E110-524D-486B-B082-273A152AAB59}"/>
               </a:ext>
             </a:extLst>
           </p:cNvPr>
@@ -13542,7 +13703,7 @@
           <p:cNvPr id="21" name="">
             <a:extLst xmlns:a="http://schemas.openxmlformats.org/drawingml/2006/main">
               <a:ext uri="{FF2B5EF4-FFF2-40B4-BE49-F238E27FC236}">
-                <a16:creationId xmlns:a16="http://schemas.microsoft.com/office/drawing/2014/main" id="{557ACF10-674B-4BBA-AFFF-91542822A1FF}"/>
+                <a16:creationId xmlns:a16="http://schemas.microsoft.com/office/drawing/2014/main" id="{4E790B6C-8B17-41DC-B914-9A65FFD7CB56}"/>
               </a:ext>
             </a:extLst>
           </p:cNvPr>
@@ -13606,7 +13767,7 @@
           <p:cNvPr id="22" name="">
             <a:extLst xmlns:a="http://schemas.openxmlformats.org/drawingml/2006/main">
               <a:ext uri="{FF2B5EF4-FFF2-40B4-BE49-F238E27FC236}">
-                <a16:creationId xmlns:a16="http://schemas.microsoft.com/office/drawing/2014/main" id="{9E77EAE9-6429-495A-9E60-86740A4F2F45}"/>
+                <a16:creationId xmlns:a16="http://schemas.microsoft.com/office/drawing/2014/main" id="{25405B3A-5646-40D0-BC98-32AC431DD123}"/>
               </a:ext>
             </a:extLst>
           </p:cNvPr>
@@ -13668,7 +13829,7 @@
     </p:spTree>
     <p:extLst>
       <p:ext uri="{BB962C8B-B14F-4D97-AF65-F5344CB8AC3E}">
-        <p14:creationId xmlns:p14="http://schemas.microsoft.com/office/powerpoint/2010/main" val="1618042089"/>
+        <p14:creationId xmlns:p14="http://schemas.microsoft.com/office/powerpoint/2010/main" val="883688344"/>
       </p:ext>
     </p:extLst>
   </p:cSld>

</xml_diff>

<commit_message>
feat: integrate DECT evidence and local Gemma
</commit_message>
<xml_diff>
--- a/submission/proteinloop-hackathon-deck.pptx
+++ b/submission/proteinloop-hackathon-deck.pptx
@@ -2,22 +2,22 @@
 <file path=ppt/presentation.xml><?xml version="1.0" encoding="utf-8"?>
 <p:presentation xmlns:p="http://schemas.openxmlformats.org/presentationml/2006/main">
   <p:sldMasterIdLst>
-    <p:sldMasterId xmlns:r="http://schemas.openxmlformats.org/officeDocument/2006/relationships" id="2147483648" r:id="Rb49b9e36dea84cef"/>
+    <p:sldMasterId xmlns:r="http://schemas.openxmlformats.org/officeDocument/2006/relationships" id="2147483648" r:id="R88b63d29237e40fd"/>
   </p:sldMasterIdLst>
   <p:notesMasterIdLst>
-    <p:notesMasterId xmlns:r="http://schemas.openxmlformats.org/officeDocument/2006/relationships" r:id="R846e12746a004354"/>
+    <p:notesMasterId xmlns:r="http://schemas.openxmlformats.org/officeDocument/2006/relationships" r:id="R6d91cd40159543b9"/>
   </p:notesMasterIdLst>
   <p:sldIdLst>
-    <p:sldId xmlns:r="http://schemas.openxmlformats.org/officeDocument/2006/relationships" id="256" r:id="R5ce8ba05787b4089"/>
-    <p:sldId xmlns:r="http://schemas.openxmlformats.org/officeDocument/2006/relationships" id="257" r:id="R50fee8c593bc4f1b"/>
-    <p:sldId xmlns:r="http://schemas.openxmlformats.org/officeDocument/2006/relationships" id="258" r:id="R72b9f041c9c74b82"/>
-    <p:sldId xmlns:r="http://schemas.openxmlformats.org/officeDocument/2006/relationships" id="259" r:id="R711059c9d11a46d4"/>
-    <p:sldId xmlns:r="http://schemas.openxmlformats.org/officeDocument/2006/relationships" id="260" r:id="R006dde05754a4bc7"/>
-    <p:sldId xmlns:r="http://schemas.openxmlformats.org/officeDocument/2006/relationships" id="261" r:id="R330203f7e32443ac"/>
-    <p:sldId xmlns:r="http://schemas.openxmlformats.org/officeDocument/2006/relationships" id="262" r:id="R918bf42168b547a0"/>
-    <p:sldId xmlns:r="http://schemas.openxmlformats.org/officeDocument/2006/relationships" id="263" r:id="Rabb324c8be9c4f4a"/>
-    <p:sldId xmlns:r="http://schemas.openxmlformats.org/officeDocument/2006/relationships" id="264" r:id="R0dd0360107ec4011"/>
-    <p:sldId xmlns:r="http://schemas.openxmlformats.org/officeDocument/2006/relationships" id="265" r:id="Rd85d606df2d04d8a"/>
+    <p:sldId xmlns:r="http://schemas.openxmlformats.org/officeDocument/2006/relationships" id="256" r:id="Rc28cc2d0fc5e49cd"/>
+    <p:sldId xmlns:r="http://schemas.openxmlformats.org/officeDocument/2006/relationships" id="257" r:id="Rdb9afc10dc7a45a5"/>
+    <p:sldId xmlns:r="http://schemas.openxmlformats.org/officeDocument/2006/relationships" id="258" r:id="Rc5a66e95cf2a44e2"/>
+    <p:sldId xmlns:r="http://schemas.openxmlformats.org/officeDocument/2006/relationships" id="259" r:id="R48b19b12069240c5"/>
+    <p:sldId xmlns:r="http://schemas.openxmlformats.org/officeDocument/2006/relationships" id="260" r:id="R360a2fff4e234b07"/>
+    <p:sldId xmlns:r="http://schemas.openxmlformats.org/officeDocument/2006/relationships" id="261" r:id="R83df63821acb4509"/>
+    <p:sldId xmlns:r="http://schemas.openxmlformats.org/officeDocument/2006/relationships" id="262" r:id="R51083432c8974847"/>
+    <p:sldId xmlns:r="http://schemas.openxmlformats.org/officeDocument/2006/relationships" id="263" r:id="Re94e55f727ee446c"/>
+    <p:sldId xmlns:r="http://schemas.openxmlformats.org/officeDocument/2006/relationships" id="264" r:id="R91e9509f180d4d16"/>
+    <p:sldId xmlns:r="http://schemas.openxmlformats.org/officeDocument/2006/relationships" id="265" r:id="R0c577d8493d24a7b"/>
   </p:sldIdLst>
   <p:sldSz cx="12192000" cy="6858000"/>
   <p:notesSz cx="6858000" cy="9144000"/>
@@ -1158,7 +1158,7 @@
   </p:cSld>
   <p:clrMap bg1="lt1" tx1="dk1" bg2="lt2" tx2="dk2" accent1="accent1" accent2="accent2" accent3="accent3" accent4="accent4" accent5="accent5" accent6="accent6" hlink="hlink" folHlink="folHlink"/>
   <p:sldLayoutIdLst>
-    <p:sldLayoutId xmlns:r="http://schemas.openxmlformats.org/officeDocument/2006/relationships" id="2147483649" r:id="R05ee29b702bb4ebf"/>
+    <p:sldLayoutId xmlns:r="http://schemas.openxmlformats.org/officeDocument/2006/relationships" id="2147483649" r:id="Rb7953813de1e4f8f"/>
   </p:sldLayoutIdLst>
   <p:txStyles>
     <p:titleStyle>
@@ -1457,7 +1457,7 @@
           <p:cNvPr id="1" name="">
             <a:extLst xmlns:a="http://schemas.openxmlformats.org/drawingml/2006/main">
               <a:ext uri="{FF2B5EF4-FFF2-40B4-BE49-F238E27FC236}">
-                <a16:creationId xmlns:a16="http://schemas.microsoft.com/office/drawing/2014/main" id="{02B23C04-168B-499A-9B09-B879A4FDAEE8}"/>
+                <a16:creationId xmlns:a16="http://schemas.microsoft.com/office/drawing/2014/main" id="{DC96CD6C-720F-47AF-9C08-E0182934DFBE}"/>
               </a:ext>
             </a:extLst>
           </p:cNvPr>
@@ -1492,7 +1492,7 @@
           <p:cNvPr id="2" name="">
             <a:extLst xmlns:a="http://schemas.openxmlformats.org/drawingml/2006/main">
               <a:ext uri="{FF2B5EF4-FFF2-40B4-BE49-F238E27FC236}">
-                <a16:creationId xmlns:a16="http://schemas.microsoft.com/office/drawing/2014/main" id="{BD362294-5333-422B-9C70-02D26285997F}"/>
+                <a16:creationId xmlns:a16="http://schemas.microsoft.com/office/drawing/2014/main" id="{BBBA268C-9511-4C38-8F23-980248B12F66}"/>
               </a:ext>
             </a:extLst>
           </p:cNvPr>
@@ -1527,7 +1527,7 @@
           <p:cNvPr id="3" name="">
             <a:extLst xmlns:a="http://schemas.openxmlformats.org/drawingml/2006/main">
               <a:ext uri="{FF2B5EF4-FFF2-40B4-BE49-F238E27FC236}">
-                <a16:creationId xmlns:a16="http://schemas.microsoft.com/office/drawing/2014/main" id="{43379D92-AC04-4C8D-9BCF-38B02D1023DA}"/>
+                <a16:creationId xmlns:a16="http://schemas.microsoft.com/office/drawing/2014/main" id="{7C6663F5-775F-4042-BF1B-9B178064CE98}"/>
               </a:ext>
             </a:extLst>
           </p:cNvPr>
@@ -1591,7 +1591,7 @@
           <p:cNvPr id="4" name="">
             <a:extLst xmlns:a="http://schemas.openxmlformats.org/drawingml/2006/main">
               <a:ext uri="{FF2B5EF4-FFF2-40B4-BE49-F238E27FC236}">
-                <a16:creationId xmlns:a16="http://schemas.microsoft.com/office/drawing/2014/main" id="{2C2028F4-1FD1-411A-AE65-8B4D258BAB04}"/>
+                <a16:creationId xmlns:a16="http://schemas.microsoft.com/office/drawing/2014/main" id="{9FEB754A-4F79-472D-B8B6-DA2588B650E6}"/>
               </a:ext>
             </a:extLst>
           </p:cNvPr>
@@ -1655,7 +1655,7 @@
           <p:cNvPr id="5" name="">
             <a:extLst xmlns:a="http://schemas.openxmlformats.org/drawingml/2006/main">
               <a:ext uri="{FF2B5EF4-FFF2-40B4-BE49-F238E27FC236}">
-                <a16:creationId xmlns:a16="http://schemas.microsoft.com/office/drawing/2014/main" id="{950EED38-D173-47D7-8CEA-BDEB6EC5A8FC}"/>
+                <a16:creationId xmlns:a16="http://schemas.microsoft.com/office/drawing/2014/main" id="{3252D5D1-0AC3-45B0-9448-800BE6B6C7A3}"/>
               </a:ext>
             </a:extLst>
           </p:cNvPr>
@@ -1690,7 +1690,7 @@
           <p:cNvPr id="6" name="">
             <a:extLst xmlns:a="http://schemas.openxmlformats.org/drawingml/2006/main">
               <a:ext uri="{FF2B5EF4-FFF2-40B4-BE49-F238E27FC236}">
-                <a16:creationId xmlns:a16="http://schemas.microsoft.com/office/drawing/2014/main" id="{58193EF1-8D28-4585-B10D-F8C1983BEFF5}"/>
+                <a16:creationId xmlns:a16="http://schemas.microsoft.com/office/drawing/2014/main" id="{77C3FDFF-498B-434A-8FDE-8DFCE29E0EC4}"/>
               </a:ext>
             </a:extLst>
           </p:cNvPr>
@@ -1754,7 +1754,7 @@
           <p:cNvPr id="7" name="">
             <a:extLst xmlns:a="http://schemas.openxmlformats.org/drawingml/2006/main">
               <a:ext uri="{FF2B5EF4-FFF2-40B4-BE49-F238E27FC236}">
-                <a16:creationId xmlns:a16="http://schemas.microsoft.com/office/drawing/2014/main" id="{95ED5853-904C-4284-AAC4-9390D39DBE72}"/>
+                <a16:creationId xmlns:a16="http://schemas.microsoft.com/office/drawing/2014/main" id="{6F7D48CA-66E3-4548-AA08-BFFC15C50DC7}"/>
               </a:ext>
             </a:extLst>
           </p:cNvPr>
@@ -1818,7 +1818,7 @@
           <p:cNvPr id="8" name="">
             <a:extLst xmlns:a="http://schemas.openxmlformats.org/drawingml/2006/main">
               <a:ext uri="{FF2B5EF4-FFF2-40B4-BE49-F238E27FC236}">
-                <a16:creationId xmlns:a16="http://schemas.microsoft.com/office/drawing/2014/main" id="{A2E9B6BE-AF3C-44A5-A473-7730C4B60CB5}"/>
+                <a16:creationId xmlns:a16="http://schemas.microsoft.com/office/drawing/2014/main" id="{317BE6CE-A2B0-4B6C-8A7D-E1A9A8FC9562}"/>
               </a:ext>
             </a:extLst>
           </p:cNvPr>
@@ -1853,7 +1853,7 @@
           <p:cNvPr id="9" name="">
             <a:extLst xmlns:a="http://schemas.openxmlformats.org/drawingml/2006/main">
               <a:ext uri="{FF2B5EF4-FFF2-40B4-BE49-F238E27FC236}">
-                <a16:creationId xmlns:a16="http://schemas.microsoft.com/office/drawing/2014/main" id="{C4BE8E97-0368-4316-824A-01615170FBBD}"/>
+                <a16:creationId xmlns:a16="http://schemas.microsoft.com/office/drawing/2014/main" id="{35531000-493A-4C68-930E-99A6EDC86E01}"/>
               </a:ext>
             </a:extLst>
           </p:cNvPr>
@@ -1917,7 +1917,7 @@
           <p:cNvPr id="10" name="">
             <a:extLst xmlns:a="http://schemas.openxmlformats.org/drawingml/2006/main">
               <a:ext uri="{FF2B5EF4-FFF2-40B4-BE49-F238E27FC236}">
-                <a16:creationId xmlns:a16="http://schemas.microsoft.com/office/drawing/2014/main" id="{D9CA1FD4-2122-4305-AC9C-8F784A7936A7}"/>
+                <a16:creationId xmlns:a16="http://schemas.microsoft.com/office/drawing/2014/main" id="{14F13060-C28C-44A4-87CE-3EECDDCEEA7D}"/>
               </a:ext>
             </a:extLst>
           </p:cNvPr>
@@ -1981,7 +1981,7 @@
           <p:cNvPr id="11" name="">
             <a:extLst xmlns:a="http://schemas.openxmlformats.org/drawingml/2006/main">
               <a:ext uri="{FF2B5EF4-FFF2-40B4-BE49-F238E27FC236}">
-                <a16:creationId xmlns:a16="http://schemas.microsoft.com/office/drawing/2014/main" id="{C8A4F612-14A3-4C11-94DC-149DDE523914}"/>
+                <a16:creationId xmlns:a16="http://schemas.microsoft.com/office/drawing/2014/main" id="{DB6D8BE2-776D-499A-868E-8FDB3DD5B947}"/>
               </a:ext>
             </a:extLst>
           </p:cNvPr>
@@ -2045,7 +2045,7 @@
           <p:cNvPr id="12" name="">
             <a:extLst xmlns:a="http://schemas.openxmlformats.org/drawingml/2006/main">
               <a:ext uri="{FF2B5EF4-FFF2-40B4-BE49-F238E27FC236}">
-                <a16:creationId xmlns:a16="http://schemas.microsoft.com/office/drawing/2014/main" id="{55247746-EE96-4780-A334-043A85BD1C3D}"/>
+                <a16:creationId xmlns:a16="http://schemas.microsoft.com/office/drawing/2014/main" id="{08C2A290-50DE-49FF-B4B5-2F731299123B}"/>
               </a:ext>
             </a:extLst>
           </p:cNvPr>
@@ -2080,7 +2080,7 @@
           <p:cNvPr id="13" name="">
             <a:extLst xmlns:a="http://schemas.openxmlformats.org/drawingml/2006/main">
               <a:ext uri="{FF2B5EF4-FFF2-40B4-BE49-F238E27FC236}">
-                <a16:creationId xmlns:a16="http://schemas.microsoft.com/office/drawing/2014/main" id="{3AB2C282-EF43-4239-9623-83FC0A7464DA}"/>
+                <a16:creationId xmlns:a16="http://schemas.microsoft.com/office/drawing/2014/main" id="{17C222D9-D00B-435D-8EBD-F4EA5148341B}"/>
               </a:ext>
             </a:extLst>
           </p:cNvPr>
@@ -2144,7 +2144,7 @@
           <p:cNvPr id="14" name="">
             <a:extLst xmlns:a="http://schemas.openxmlformats.org/drawingml/2006/main">
               <a:ext uri="{FF2B5EF4-FFF2-40B4-BE49-F238E27FC236}">
-                <a16:creationId xmlns:a16="http://schemas.microsoft.com/office/drawing/2014/main" id="{11A58D5E-16F7-48C7-93B8-65170F2F7442}"/>
+                <a16:creationId xmlns:a16="http://schemas.microsoft.com/office/drawing/2014/main" id="{75A636D4-9352-4A25-B243-ED097770A33B}"/>
               </a:ext>
             </a:extLst>
           </p:cNvPr>
@@ -2208,7 +2208,7 @@
           <p:cNvPr id="15" name="">
             <a:extLst xmlns:a="http://schemas.openxmlformats.org/drawingml/2006/main">
               <a:ext uri="{FF2B5EF4-FFF2-40B4-BE49-F238E27FC236}">
-                <a16:creationId xmlns:a16="http://schemas.microsoft.com/office/drawing/2014/main" id="{B43CCDBF-6904-42AD-A14D-176A1E64DF4F}"/>
+                <a16:creationId xmlns:a16="http://schemas.microsoft.com/office/drawing/2014/main" id="{2A0549FA-3696-46C1-8D2C-3E811155F7D2}"/>
               </a:ext>
             </a:extLst>
           </p:cNvPr>
@@ -2272,7 +2272,7 @@
           <p:cNvPr id="16" name="">
             <a:extLst xmlns:a="http://schemas.openxmlformats.org/drawingml/2006/main">
               <a:ext uri="{FF2B5EF4-FFF2-40B4-BE49-F238E27FC236}">
-                <a16:creationId xmlns:a16="http://schemas.microsoft.com/office/drawing/2014/main" id="{B384C2CF-D238-4833-BFC0-078F939CC35E}"/>
+                <a16:creationId xmlns:a16="http://schemas.microsoft.com/office/drawing/2014/main" id="{54137A5B-D44C-468E-850E-EDD0DA4FE1A7}"/>
               </a:ext>
             </a:extLst>
           </p:cNvPr>
@@ -2307,7 +2307,7 @@
           <p:cNvPr id="17" name="">
             <a:extLst xmlns:a="http://schemas.openxmlformats.org/drawingml/2006/main">
               <a:ext uri="{FF2B5EF4-FFF2-40B4-BE49-F238E27FC236}">
-                <a16:creationId xmlns:a16="http://schemas.microsoft.com/office/drawing/2014/main" id="{42E3E716-0EDE-49A3-A6EC-CDA5F60D807B}"/>
+                <a16:creationId xmlns:a16="http://schemas.microsoft.com/office/drawing/2014/main" id="{73650957-0541-45E2-8713-195D50C2E0B7}"/>
               </a:ext>
             </a:extLst>
           </p:cNvPr>
@@ -2361,7 +2361,7 @@
                 <a:ea typeface="Aptos"/>
                 <a:cs typeface="Aptos"/>
               </a:rPr>
-              <a:t>platform path</a:t>
+              <a:t>model proof</a:t>
             </a:r>
           </a:p>
         </p:txBody>
@@ -2371,7 +2371,7 @@
           <p:cNvPr id="18" name="">
             <a:extLst xmlns:a="http://schemas.openxmlformats.org/drawingml/2006/main">
               <a:ext uri="{FF2B5EF4-FFF2-40B4-BE49-F238E27FC236}">
-                <a16:creationId xmlns:a16="http://schemas.microsoft.com/office/drawing/2014/main" id="{5A5118A8-B96F-41D0-9D1E-8A058CB373CF}"/>
+                <a16:creationId xmlns:a16="http://schemas.microsoft.com/office/drawing/2014/main" id="{DE76E455-A3A3-4C68-9B58-8B42372728A1}"/>
               </a:ext>
             </a:extLst>
           </p:cNvPr>
@@ -2425,7 +2425,7 @@
                 <a:ea typeface="Aptos"/>
                 <a:cs typeface="Aptos"/>
               </a:rPr>
-              <a:t>ROCm</a:t>
+              <a:t>E2B</a:t>
             </a:r>
           </a:p>
         </p:txBody>
@@ -2435,7 +2435,7 @@
           <p:cNvPr id="19" name="">
             <a:extLst xmlns:a="http://schemas.openxmlformats.org/drawingml/2006/main">
               <a:ext uri="{FF2B5EF4-FFF2-40B4-BE49-F238E27FC236}">
-                <a16:creationId xmlns:a16="http://schemas.microsoft.com/office/drawing/2014/main" id="{9193D93D-C1CC-45EA-AB27-5F6E59DA3ACB}"/>
+                <a16:creationId xmlns:a16="http://schemas.microsoft.com/office/drawing/2014/main" id="{0CBD05EC-982F-469C-BC02-F588BBBFEC38}"/>
               </a:ext>
             </a:extLst>
           </p:cNvPr>
@@ -2489,7 +2489,7 @@
                 <a:ea typeface="Aptos"/>
                 <a:cs typeface="Aptos"/>
               </a:rPr>
-              <a:t>Gemma via vLLM</a:t>
+              <a:t>llama.cpp + Metal</a:t>
             </a:r>
           </a:p>
         </p:txBody>
@@ -2499,7 +2499,7 @@
           <p:cNvPr id="20" name="">
             <a:extLst xmlns:a="http://schemas.openxmlformats.org/drawingml/2006/main">
               <a:ext uri="{FF2B5EF4-FFF2-40B4-BE49-F238E27FC236}">
-                <a16:creationId xmlns:a16="http://schemas.microsoft.com/office/drawing/2014/main" id="{66C17CAC-9C42-4E45-A4FD-FD3DB46A8CB1}"/>
+                <a16:creationId xmlns:a16="http://schemas.microsoft.com/office/drawing/2014/main" id="{A5915A1E-36A7-49D8-8D15-DC89F7368FD1}"/>
               </a:ext>
             </a:extLst>
           </p:cNvPr>
@@ -2655,7 +2655,7 @@
           <p:cNvPr id="21" name="">
             <a:extLst xmlns:a="http://schemas.openxmlformats.org/drawingml/2006/main">
               <a:ext uri="{FF2B5EF4-FFF2-40B4-BE49-F238E27FC236}">
-                <a16:creationId xmlns:a16="http://schemas.microsoft.com/office/drawing/2014/main" id="{59414F48-D8C9-477D-8642-61ECCB493621}"/>
+                <a16:creationId xmlns:a16="http://schemas.microsoft.com/office/drawing/2014/main" id="{D100C90E-52DF-4514-90A0-B512F486A819}"/>
               </a:ext>
             </a:extLst>
           </p:cNvPr>
@@ -2719,7 +2719,7 @@
           <p:cNvPr id="22" name="">
             <a:extLst xmlns:a="http://schemas.openxmlformats.org/drawingml/2006/main">
               <a:ext uri="{FF2B5EF4-FFF2-40B4-BE49-F238E27FC236}">
-                <a16:creationId xmlns:a16="http://schemas.microsoft.com/office/drawing/2014/main" id="{49E082B9-15C7-45EA-8631-1F47D7A0AC87}"/>
+                <a16:creationId xmlns:a16="http://schemas.microsoft.com/office/drawing/2014/main" id="{89E83783-611E-4E76-BB85-C67FB56FE81F}"/>
               </a:ext>
             </a:extLst>
           </p:cNvPr>
@@ -2781,7 +2781,7 @@
     </p:spTree>
     <p:extLst>
       <p:ext uri="{BB962C8B-B14F-4D97-AF65-F5344CB8AC3E}">
-        <p14:creationId xmlns:p14="http://schemas.microsoft.com/office/powerpoint/2010/main" val="860239449"/>
+        <p14:creationId xmlns:p14="http://schemas.microsoft.com/office/powerpoint/2010/main" val="1600259929"/>
       </p:ext>
     </p:extLst>
   </p:cSld>
@@ -2805,7 +2805,7 @@
           <p:cNvPr id="1" name="">
             <a:extLst xmlns:a="http://schemas.openxmlformats.org/drawingml/2006/main">
               <a:ext uri="{FF2B5EF4-FFF2-40B4-BE49-F238E27FC236}">
-                <a16:creationId xmlns:a16="http://schemas.microsoft.com/office/drawing/2014/main" id="{0E79C62D-4AB6-4B88-9DFD-3086A5B358E5}"/>
+                <a16:creationId xmlns:a16="http://schemas.microsoft.com/office/drawing/2014/main" id="{22A17DFF-9314-45BC-9077-C07356B55438}"/>
               </a:ext>
             </a:extLst>
           </p:cNvPr>
@@ -2840,7 +2840,7 @@
           <p:cNvPr id="2" name="">
             <a:extLst xmlns:a="http://schemas.openxmlformats.org/drawingml/2006/main">
               <a:ext uri="{FF2B5EF4-FFF2-40B4-BE49-F238E27FC236}">
-                <a16:creationId xmlns:a16="http://schemas.microsoft.com/office/drawing/2014/main" id="{42E52D5A-BAF5-4E60-9381-4DCBA9CBCC66}"/>
+                <a16:creationId xmlns:a16="http://schemas.microsoft.com/office/drawing/2014/main" id="{51EF8907-834E-420A-BE44-B9329B990411}"/>
               </a:ext>
             </a:extLst>
           </p:cNvPr>
@@ -2875,7 +2875,7 @@
           <p:cNvPr id="3" name="">
             <a:extLst xmlns:a="http://schemas.openxmlformats.org/drawingml/2006/main">
               <a:ext uri="{FF2B5EF4-FFF2-40B4-BE49-F238E27FC236}">
-                <a16:creationId xmlns:a16="http://schemas.microsoft.com/office/drawing/2014/main" id="{51831EB8-D6D6-4570-9E20-EA515341DEED}"/>
+                <a16:creationId xmlns:a16="http://schemas.microsoft.com/office/drawing/2014/main" id="{8F4F0FBF-2AB8-4581-991A-0DEFCD30EF7E}"/>
               </a:ext>
             </a:extLst>
           </p:cNvPr>
@@ -2939,7 +2939,7 @@
           <p:cNvPr id="4" name="">
             <a:extLst xmlns:a="http://schemas.openxmlformats.org/drawingml/2006/main">
               <a:ext uri="{FF2B5EF4-FFF2-40B4-BE49-F238E27FC236}">
-                <a16:creationId xmlns:a16="http://schemas.microsoft.com/office/drawing/2014/main" id="{5034AF73-D32A-4A42-A604-6D4261B9FFC4}"/>
+                <a16:creationId xmlns:a16="http://schemas.microsoft.com/office/drawing/2014/main" id="{5A0148CF-B64A-41E5-AFC4-008F4C8B4A65}"/>
               </a:ext>
             </a:extLst>
           </p:cNvPr>
@@ -3003,7 +3003,7 @@
           <p:cNvPr id="5" name="">
             <a:extLst xmlns:a="http://schemas.openxmlformats.org/drawingml/2006/main">
               <a:ext uri="{FF2B5EF4-FFF2-40B4-BE49-F238E27FC236}">
-                <a16:creationId xmlns:a16="http://schemas.microsoft.com/office/drawing/2014/main" id="{2A09DB82-D53E-4B57-886C-6CA3C9D48DC9}"/>
+                <a16:creationId xmlns:a16="http://schemas.microsoft.com/office/drawing/2014/main" id="{98A4DBD2-9F82-43A1-BE59-A71B3F67A439}"/>
               </a:ext>
             </a:extLst>
           </p:cNvPr>
@@ -3067,7 +3067,7 @@
           <p:cNvPr id="6" name="">
             <a:extLst xmlns:a="http://schemas.openxmlformats.org/drawingml/2006/main">
               <a:ext uri="{FF2B5EF4-FFF2-40B4-BE49-F238E27FC236}">
-                <a16:creationId xmlns:a16="http://schemas.microsoft.com/office/drawing/2014/main" id="{D8445569-57C0-4971-A722-BA39964E0C0E}"/>
+                <a16:creationId xmlns:a16="http://schemas.microsoft.com/office/drawing/2014/main" id="{17C3A50F-C155-4D90-ADBC-8F1D13C5879A}"/>
               </a:ext>
             </a:extLst>
           </p:cNvPr>
@@ -3131,7 +3131,7 @@
           <p:cNvPr id="7" name="">
             <a:extLst xmlns:a="http://schemas.openxmlformats.org/drawingml/2006/main">
               <a:ext uri="{FF2B5EF4-FFF2-40B4-BE49-F238E27FC236}">
-                <a16:creationId xmlns:a16="http://schemas.microsoft.com/office/drawing/2014/main" id="{EB64DEE7-30A6-460F-9D8E-D2094FDACF9A}"/>
+                <a16:creationId xmlns:a16="http://schemas.microsoft.com/office/drawing/2014/main" id="{F38A33E6-9AE4-434A-A86D-101CE02983FA}"/>
               </a:ext>
             </a:extLst>
           </p:cNvPr>
@@ -3164,7 +3164,7 @@
           <p:cNvPr id="8" name="">
             <a:extLst xmlns:a="http://schemas.openxmlformats.org/drawingml/2006/main">
               <a:ext uri="{FF2B5EF4-FFF2-40B4-BE49-F238E27FC236}">
-                <a16:creationId xmlns:a16="http://schemas.microsoft.com/office/drawing/2014/main" id="{84EDB8C2-AEDF-4E71-AABF-FAD85CEFBC86}"/>
+                <a16:creationId xmlns:a16="http://schemas.microsoft.com/office/drawing/2014/main" id="{2EA72D39-49BD-4BCE-AC0D-C5FB17CDDD57}"/>
               </a:ext>
             </a:extLst>
           </p:cNvPr>
@@ -3228,7 +3228,7 @@
           <p:cNvPr id="9" name="">
             <a:extLst xmlns:a="http://schemas.openxmlformats.org/drawingml/2006/main">
               <a:ext uri="{FF2B5EF4-FFF2-40B4-BE49-F238E27FC236}">
-                <a16:creationId xmlns:a16="http://schemas.microsoft.com/office/drawing/2014/main" id="{9C681E64-94E2-4768-A947-C80C8AD0942B}"/>
+                <a16:creationId xmlns:a16="http://schemas.microsoft.com/office/drawing/2014/main" id="{374FB243-56C7-429C-9729-3E9A294B178D}"/>
               </a:ext>
             </a:extLst>
           </p:cNvPr>
@@ -3292,7 +3292,7 @@
           <p:cNvPr id="10" name="">
             <a:extLst xmlns:a="http://schemas.openxmlformats.org/drawingml/2006/main">
               <a:ext uri="{FF2B5EF4-FFF2-40B4-BE49-F238E27FC236}">
-                <a16:creationId xmlns:a16="http://schemas.microsoft.com/office/drawing/2014/main" id="{FB6CC27C-39DD-4100-AAE0-D5E7A1B10869}"/>
+                <a16:creationId xmlns:a16="http://schemas.microsoft.com/office/drawing/2014/main" id="{F7015112-C562-4FF9-AC90-DA2FA71AFA24}"/>
               </a:ext>
             </a:extLst>
           </p:cNvPr>
@@ -3325,7 +3325,7 @@
           <p:cNvPr id="11" name="">
             <a:extLst xmlns:a="http://schemas.openxmlformats.org/drawingml/2006/main">
               <a:ext uri="{FF2B5EF4-FFF2-40B4-BE49-F238E27FC236}">
-                <a16:creationId xmlns:a16="http://schemas.microsoft.com/office/drawing/2014/main" id="{E28554D9-276F-489C-8AC6-56392DE78F54}"/>
+                <a16:creationId xmlns:a16="http://schemas.microsoft.com/office/drawing/2014/main" id="{9A656E6B-4E7B-479C-A212-CE8C966E7644}"/>
               </a:ext>
             </a:extLst>
           </p:cNvPr>
@@ -3389,7 +3389,7 @@
           <p:cNvPr id="12" name="">
             <a:extLst xmlns:a="http://schemas.openxmlformats.org/drawingml/2006/main">
               <a:ext uri="{FF2B5EF4-FFF2-40B4-BE49-F238E27FC236}">
-                <a16:creationId xmlns:a16="http://schemas.microsoft.com/office/drawing/2014/main" id="{F77D02B4-264C-440D-9F2A-B65CE4836343}"/>
+                <a16:creationId xmlns:a16="http://schemas.microsoft.com/office/drawing/2014/main" id="{D4CE7FA7-2AA3-4CAD-BB49-ED53813289CE}"/>
               </a:ext>
             </a:extLst>
           </p:cNvPr>
@@ -3443,7 +3443,7 @@
                 <a:ea typeface="Aptos"/>
                 <a:cs typeface="Aptos"/>
               </a:rPr>
-              <a:t>Real Sagents/Horde failover, physical DECT NR+ proof, physics verifier, RLVR scoring, resumable HITL, and AMD Gemma path.</a:t>
+              <a:t>Real Sagents/Horde failover, physical DECT NR+ proof, physics verifier, RLVR scoring, resumable HITL, and offline Gemma 4.</a:t>
             </a:r>
           </a:p>
         </p:txBody>
@@ -3453,7 +3453,7 @@
           <p:cNvPr id="13" name="">
             <a:extLst xmlns:a="http://schemas.openxmlformats.org/drawingml/2006/main">
               <a:ext uri="{FF2B5EF4-FFF2-40B4-BE49-F238E27FC236}">
-                <a16:creationId xmlns:a16="http://schemas.microsoft.com/office/drawing/2014/main" id="{177F280A-466B-4633-A4EE-38EB9B7D0623}"/>
+                <a16:creationId xmlns:a16="http://schemas.microsoft.com/office/drawing/2014/main" id="{DA2F17CD-ADC7-4832-87C1-A1E4ADAEBBBB}"/>
               </a:ext>
             </a:extLst>
           </p:cNvPr>
@@ -3486,7 +3486,7 @@
           <p:cNvPr id="14" name="">
             <a:extLst xmlns:a="http://schemas.openxmlformats.org/drawingml/2006/main">
               <a:ext uri="{FF2B5EF4-FFF2-40B4-BE49-F238E27FC236}">
-                <a16:creationId xmlns:a16="http://schemas.microsoft.com/office/drawing/2014/main" id="{59A17A1A-521E-4573-A384-FE5714E4FD5A}"/>
+                <a16:creationId xmlns:a16="http://schemas.microsoft.com/office/drawing/2014/main" id="{662F220D-B7BE-4F8C-AD3D-29F26EA0BC1B}"/>
               </a:ext>
             </a:extLst>
           </p:cNvPr>
@@ -3550,7 +3550,7 @@
           <p:cNvPr id="15" name="">
             <a:extLst xmlns:a="http://schemas.openxmlformats.org/drawingml/2006/main">
               <a:ext uri="{FF2B5EF4-FFF2-40B4-BE49-F238E27FC236}">
-                <a16:creationId xmlns:a16="http://schemas.microsoft.com/office/drawing/2014/main" id="{29A998F9-305D-499D-80A5-D02D20E1A560}"/>
+                <a16:creationId xmlns:a16="http://schemas.microsoft.com/office/drawing/2014/main" id="{FCAF10EC-8507-499D-B5AD-1246577EFD23}"/>
               </a:ext>
             </a:extLst>
           </p:cNvPr>
@@ -3614,7 +3614,7 @@
           <p:cNvPr id="16" name="">
             <a:extLst xmlns:a="http://schemas.openxmlformats.org/drawingml/2006/main">
               <a:ext uri="{FF2B5EF4-FFF2-40B4-BE49-F238E27FC236}">
-                <a16:creationId xmlns:a16="http://schemas.microsoft.com/office/drawing/2014/main" id="{FC3B4E8B-3419-4FAC-892D-026C0FD804DF}"/>
+                <a16:creationId xmlns:a16="http://schemas.microsoft.com/office/drawing/2014/main" id="{A1FF4B96-3C12-411F-9C9D-69661DB81059}"/>
               </a:ext>
             </a:extLst>
           </p:cNvPr>
@@ -3668,7 +3668,7 @@
                 <a:ea typeface="Aptos"/>
                 <a:cs typeface="Aptos"/>
               </a:rPr>
-              <a:t>Ask: Best Unicorn + Best AMD-Hosted Gemma</a:t>
+              <a:t>Ask: Best Unicorn</a:t>
             </a:r>
           </a:p>
         </p:txBody>
@@ -3678,7 +3678,7 @@
           <p:cNvPr id="17" name="">
             <a:extLst xmlns:a="http://schemas.openxmlformats.org/drawingml/2006/main">
               <a:ext uri="{FF2B5EF4-FFF2-40B4-BE49-F238E27FC236}">
-                <a16:creationId xmlns:a16="http://schemas.microsoft.com/office/drawing/2014/main" id="{3E86BFF8-EFE4-4894-927D-66204807310B}"/>
+                <a16:creationId xmlns:a16="http://schemas.microsoft.com/office/drawing/2014/main" id="{C8684689-495A-4C7A-AE46-FFFA3A965485}"/>
               </a:ext>
             </a:extLst>
           </p:cNvPr>
@@ -3742,7 +3742,7 @@
           <p:cNvPr id="18" name="">
             <a:extLst xmlns:a="http://schemas.openxmlformats.org/drawingml/2006/main">
               <a:ext uri="{FF2B5EF4-FFF2-40B4-BE49-F238E27FC236}">
-                <a16:creationId xmlns:a16="http://schemas.microsoft.com/office/drawing/2014/main" id="{B33279C7-3A75-4755-A3C9-5A420706B57D}"/>
+                <a16:creationId xmlns:a16="http://schemas.microsoft.com/office/drawing/2014/main" id="{535EF5A2-164C-4369-885E-920AD7C43C27}"/>
               </a:ext>
             </a:extLst>
           </p:cNvPr>
@@ -3804,7 +3804,7 @@
     </p:spTree>
     <p:extLst>
       <p:ext uri="{BB962C8B-B14F-4D97-AF65-F5344CB8AC3E}">
-        <p14:creationId xmlns:p14="http://schemas.microsoft.com/office/powerpoint/2010/main" val="1548881226"/>
+        <p14:creationId xmlns:p14="http://schemas.microsoft.com/office/powerpoint/2010/main" val="1066750752"/>
       </p:ext>
     </p:extLst>
   </p:cSld>
@@ -3828,7 +3828,7 @@
           <p:cNvPr id="1" name="">
             <a:extLst xmlns:a="http://schemas.openxmlformats.org/drawingml/2006/main">
               <a:ext uri="{FF2B5EF4-FFF2-40B4-BE49-F238E27FC236}">
-                <a16:creationId xmlns:a16="http://schemas.microsoft.com/office/drawing/2014/main" id="{B824BA34-37C1-470D-92EC-8FE5C86E873C}"/>
+                <a16:creationId xmlns:a16="http://schemas.microsoft.com/office/drawing/2014/main" id="{9460F5F3-69B2-4B08-A870-D851B281D665}"/>
               </a:ext>
             </a:extLst>
           </p:cNvPr>
@@ -3863,7 +3863,7 @@
           <p:cNvPr id="2" name="">
             <a:extLst xmlns:a="http://schemas.openxmlformats.org/drawingml/2006/main">
               <a:ext uri="{FF2B5EF4-FFF2-40B4-BE49-F238E27FC236}">
-                <a16:creationId xmlns:a16="http://schemas.microsoft.com/office/drawing/2014/main" id="{6AC74423-12F7-4327-9DC0-B9BF68BBA344}"/>
+                <a16:creationId xmlns:a16="http://schemas.microsoft.com/office/drawing/2014/main" id="{0597E432-165E-43F5-A3FB-8EB7013A07F4}"/>
               </a:ext>
             </a:extLst>
           </p:cNvPr>
@@ -3898,7 +3898,7 @@
           <p:cNvPr id="3" name="">
             <a:extLst xmlns:a="http://schemas.openxmlformats.org/drawingml/2006/main">
               <a:ext uri="{FF2B5EF4-FFF2-40B4-BE49-F238E27FC236}">
-                <a16:creationId xmlns:a16="http://schemas.microsoft.com/office/drawing/2014/main" id="{3EB0CFDE-4BDC-4C1D-A77B-AECB7172B22B}"/>
+                <a16:creationId xmlns:a16="http://schemas.microsoft.com/office/drawing/2014/main" id="{EDBDA22F-9B28-467F-80A0-6D23DEADB195}"/>
               </a:ext>
             </a:extLst>
           </p:cNvPr>
@@ -3962,7 +3962,7 @@
           <p:cNvPr id="4" name="">
             <a:extLst xmlns:a="http://schemas.openxmlformats.org/drawingml/2006/main">
               <a:ext uri="{FF2B5EF4-FFF2-40B4-BE49-F238E27FC236}">
-                <a16:creationId xmlns:a16="http://schemas.microsoft.com/office/drawing/2014/main" id="{75C6C2B7-79E8-4B46-AC96-6C33776B91C0}"/>
+                <a16:creationId xmlns:a16="http://schemas.microsoft.com/office/drawing/2014/main" id="{AAA0064B-6071-4F2E-9B71-F831C4B72599}"/>
               </a:ext>
             </a:extLst>
           </p:cNvPr>
@@ -4026,7 +4026,7 @@
           <p:cNvPr id="5" name="">
             <a:extLst xmlns:a="http://schemas.openxmlformats.org/drawingml/2006/main">
               <a:ext uri="{FF2B5EF4-FFF2-40B4-BE49-F238E27FC236}">
-                <a16:creationId xmlns:a16="http://schemas.microsoft.com/office/drawing/2014/main" id="{93FB6378-BD3C-485B-8D26-8E8B000ED84F}"/>
+                <a16:creationId xmlns:a16="http://schemas.microsoft.com/office/drawing/2014/main" id="{383FAC56-0C10-43B0-837D-7F8822B40D9B}"/>
               </a:ext>
             </a:extLst>
           </p:cNvPr>
@@ -4090,7 +4090,7 @@
           <p:cNvPr id="6" name="">
             <a:extLst xmlns:a="http://schemas.openxmlformats.org/drawingml/2006/main">
               <a:ext uri="{FF2B5EF4-FFF2-40B4-BE49-F238E27FC236}">
-                <a16:creationId xmlns:a16="http://schemas.microsoft.com/office/drawing/2014/main" id="{80760C10-EED2-4EF1-BD10-783A49527F69}"/>
+                <a16:creationId xmlns:a16="http://schemas.microsoft.com/office/drawing/2014/main" id="{818BBE22-7236-4014-ADFB-D6A054EC117F}"/>
               </a:ext>
             </a:extLst>
           </p:cNvPr>
@@ -4154,7 +4154,7 @@
           <p:cNvPr id="7" name="">
             <a:extLst xmlns:a="http://schemas.openxmlformats.org/drawingml/2006/main">
               <a:ext uri="{FF2B5EF4-FFF2-40B4-BE49-F238E27FC236}">
-                <a16:creationId xmlns:a16="http://schemas.microsoft.com/office/drawing/2014/main" id="{05A90D9E-2D09-4A95-B9B1-C621A0AB82B7}"/>
+                <a16:creationId xmlns:a16="http://schemas.microsoft.com/office/drawing/2014/main" id="{C85F0A32-49B8-4971-827A-0BBD8F189C28}"/>
               </a:ext>
             </a:extLst>
           </p:cNvPr>
@@ -4187,7 +4187,7 @@
           <p:cNvPr id="8" name="">
             <a:extLst xmlns:a="http://schemas.openxmlformats.org/drawingml/2006/main">
               <a:ext uri="{FF2B5EF4-FFF2-40B4-BE49-F238E27FC236}">
-                <a16:creationId xmlns:a16="http://schemas.microsoft.com/office/drawing/2014/main" id="{392198F5-E2FF-45EB-97EE-2F432A80CD1A}"/>
+                <a16:creationId xmlns:a16="http://schemas.microsoft.com/office/drawing/2014/main" id="{CD284E1B-8591-4721-9CCF-F7BC80976290}"/>
               </a:ext>
             </a:extLst>
           </p:cNvPr>
@@ -4251,7 +4251,7 @@
           <p:cNvPr id="9" name="">
             <a:extLst xmlns:a="http://schemas.openxmlformats.org/drawingml/2006/main">
               <a:ext uri="{FF2B5EF4-FFF2-40B4-BE49-F238E27FC236}">
-                <a16:creationId xmlns:a16="http://schemas.microsoft.com/office/drawing/2014/main" id="{49F56574-BA59-4849-A790-8E17CC7CEE3A}"/>
+                <a16:creationId xmlns:a16="http://schemas.microsoft.com/office/drawing/2014/main" id="{E7797DF6-8208-41CF-B5F3-3478C524C013}"/>
               </a:ext>
             </a:extLst>
           </p:cNvPr>
@@ -4315,7 +4315,7 @@
           <p:cNvPr id="10" name="">
             <a:extLst xmlns:a="http://schemas.openxmlformats.org/drawingml/2006/main">
               <a:ext uri="{FF2B5EF4-FFF2-40B4-BE49-F238E27FC236}">
-                <a16:creationId xmlns:a16="http://schemas.microsoft.com/office/drawing/2014/main" id="{DE93DE26-C42A-461C-80AE-0B9EABBF1855}"/>
+                <a16:creationId xmlns:a16="http://schemas.microsoft.com/office/drawing/2014/main" id="{B1800D4B-FFD8-46B9-9D78-7F3864107040}"/>
               </a:ext>
             </a:extLst>
           </p:cNvPr>
@@ -4348,7 +4348,7 @@
           <p:cNvPr id="11" name="">
             <a:extLst xmlns:a="http://schemas.openxmlformats.org/drawingml/2006/main">
               <a:ext uri="{FF2B5EF4-FFF2-40B4-BE49-F238E27FC236}">
-                <a16:creationId xmlns:a16="http://schemas.microsoft.com/office/drawing/2014/main" id="{871D8B09-CAB4-45F6-BF0B-7057EB296058}"/>
+                <a16:creationId xmlns:a16="http://schemas.microsoft.com/office/drawing/2014/main" id="{0B7B967B-1777-4F90-B94F-79B38CA8192C}"/>
               </a:ext>
             </a:extLst>
           </p:cNvPr>
@@ -4412,7 +4412,7 @@
           <p:cNvPr id="12" name="">
             <a:extLst xmlns:a="http://schemas.openxmlformats.org/drawingml/2006/main">
               <a:ext uri="{FF2B5EF4-FFF2-40B4-BE49-F238E27FC236}">
-                <a16:creationId xmlns:a16="http://schemas.microsoft.com/office/drawing/2014/main" id="{BDBD3BF4-7F77-4333-A00D-921994C65EE4}"/>
+                <a16:creationId xmlns:a16="http://schemas.microsoft.com/office/drawing/2014/main" id="{0FB9F361-26F9-4C27-93FA-0C70DA40B609}"/>
               </a:ext>
             </a:extLst>
           </p:cNvPr>
@@ -4476,7 +4476,7 @@
           <p:cNvPr id="13" name="">
             <a:extLst xmlns:a="http://schemas.openxmlformats.org/drawingml/2006/main">
               <a:ext uri="{FF2B5EF4-FFF2-40B4-BE49-F238E27FC236}">
-                <a16:creationId xmlns:a16="http://schemas.microsoft.com/office/drawing/2014/main" id="{D069A888-38EA-4153-B910-AD3B3A9AF977}"/>
+                <a16:creationId xmlns:a16="http://schemas.microsoft.com/office/drawing/2014/main" id="{AE185080-A7DA-40C5-AB96-A472CFB7317B}"/>
               </a:ext>
             </a:extLst>
           </p:cNvPr>
@@ -4509,7 +4509,7 @@
           <p:cNvPr id="14" name="">
             <a:extLst xmlns:a="http://schemas.openxmlformats.org/drawingml/2006/main">
               <a:ext uri="{FF2B5EF4-FFF2-40B4-BE49-F238E27FC236}">
-                <a16:creationId xmlns:a16="http://schemas.microsoft.com/office/drawing/2014/main" id="{A58D91A6-D45A-48C1-847B-CCCF0C169E91}"/>
+                <a16:creationId xmlns:a16="http://schemas.microsoft.com/office/drawing/2014/main" id="{E8F0C111-2803-4ECD-835C-7F45A0F6B74D}"/>
               </a:ext>
             </a:extLst>
           </p:cNvPr>
@@ -4573,7 +4573,7 @@
           <p:cNvPr id="15" name="">
             <a:extLst xmlns:a="http://schemas.openxmlformats.org/drawingml/2006/main">
               <a:ext uri="{FF2B5EF4-FFF2-40B4-BE49-F238E27FC236}">
-                <a16:creationId xmlns:a16="http://schemas.microsoft.com/office/drawing/2014/main" id="{DA9CCEBF-583A-4789-ABA5-85C5B73D8D8B}"/>
+                <a16:creationId xmlns:a16="http://schemas.microsoft.com/office/drawing/2014/main" id="{8AC2D6F9-1ADD-4A08-8038-AB14E0217883}"/>
               </a:ext>
             </a:extLst>
           </p:cNvPr>
@@ -4637,7 +4637,7 @@
           <p:cNvPr id="16" name="">
             <a:extLst xmlns:a="http://schemas.openxmlformats.org/drawingml/2006/main">
               <a:ext uri="{FF2B5EF4-FFF2-40B4-BE49-F238E27FC236}">
-                <a16:creationId xmlns:a16="http://schemas.microsoft.com/office/drawing/2014/main" id="{B6275766-1940-4568-9153-69B6E94750A3}"/>
+                <a16:creationId xmlns:a16="http://schemas.microsoft.com/office/drawing/2014/main" id="{B478FC38-AD26-4A3E-84AD-D9C5C1A5B484}"/>
               </a:ext>
             </a:extLst>
           </p:cNvPr>
@@ -4701,7 +4701,7 @@
           <p:cNvPr id="17" name="">
             <a:extLst xmlns:a="http://schemas.openxmlformats.org/drawingml/2006/main">
               <a:ext uri="{FF2B5EF4-FFF2-40B4-BE49-F238E27FC236}">
-                <a16:creationId xmlns:a16="http://schemas.microsoft.com/office/drawing/2014/main" id="{3484E6CA-2937-4938-8745-31C01D521188}"/>
+                <a16:creationId xmlns:a16="http://schemas.microsoft.com/office/drawing/2014/main" id="{B4F6EDA4-8F4F-4C65-876B-C216BF95745E}"/>
               </a:ext>
             </a:extLst>
           </p:cNvPr>
@@ -4763,7 +4763,7 @@
     </p:spTree>
     <p:extLst>
       <p:ext uri="{BB962C8B-B14F-4D97-AF65-F5344CB8AC3E}">
-        <p14:creationId xmlns:p14="http://schemas.microsoft.com/office/powerpoint/2010/main" val="897188182"/>
+        <p14:creationId xmlns:p14="http://schemas.microsoft.com/office/powerpoint/2010/main" val="333908311"/>
       </p:ext>
     </p:extLst>
   </p:cSld>
@@ -4787,7 +4787,7 @@
           <p:cNvPr id="1" name="">
             <a:extLst xmlns:a="http://schemas.openxmlformats.org/drawingml/2006/main">
               <a:ext uri="{FF2B5EF4-FFF2-40B4-BE49-F238E27FC236}">
-                <a16:creationId xmlns:a16="http://schemas.microsoft.com/office/drawing/2014/main" id="{603FD5DB-E09E-4F39-9DEC-3BDC9A02B400}"/>
+                <a16:creationId xmlns:a16="http://schemas.microsoft.com/office/drawing/2014/main" id="{8C5C764C-62D9-4DD8-9749-9F02CC14FEED}"/>
               </a:ext>
             </a:extLst>
           </p:cNvPr>
@@ -4822,7 +4822,7 @@
           <p:cNvPr id="2" name="">
             <a:extLst xmlns:a="http://schemas.openxmlformats.org/drawingml/2006/main">
               <a:ext uri="{FF2B5EF4-FFF2-40B4-BE49-F238E27FC236}">
-                <a16:creationId xmlns:a16="http://schemas.microsoft.com/office/drawing/2014/main" id="{1FF482FD-A220-4899-A026-D3B3A973194F}"/>
+                <a16:creationId xmlns:a16="http://schemas.microsoft.com/office/drawing/2014/main" id="{6F3642EA-D0D1-480A-A07E-E9515C5F86C1}"/>
               </a:ext>
             </a:extLst>
           </p:cNvPr>
@@ -4857,7 +4857,7 @@
           <p:cNvPr id="3" name="">
             <a:extLst xmlns:a="http://schemas.openxmlformats.org/drawingml/2006/main">
               <a:ext uri="{FF2B5EF4-FFF2-40B4-BE49-F238E27FC236}">
-                <a16:creationId xmlns:a16="http://schemas.microsoft.com/office/drawing/2014/main" id="{4A1CDC33-A1E6-4935-9C53-21A6077DF829}"/>
+                <a16:creationId xmlns:a16="http://schemas.microsoft.com/office/drawing/2014/main" id="{16DD1E59-746C-45D9-98CF-EB7307F5ADAA}"/>
               </a:ext>
             </a:extLst>
           </p:cNvPr>
@@ -4921,7 +4921,7 @@
           <p:cNvPr id="4" name="">
             <a:extLst xmlns:a="http://schemas.openxmlformats.org/drawingml/2006/main">
               <a:ext uri="{FF2B5EF4-FFF2-40B4-BE49-F238E27FC236}">
-                <a16:creationId xmlns:a16="http://schemas.microsoft.com/office/drawing/2014/main" id="{5168B6B5-45C5-4BD6-AC05-5B3ACE3041FA}"/>
+                <a16:creationId xmlns:a16="http://schemas.microsoft.com/office/drawing/2014/main" id="{229CBA7E-4A0A-42FD-9919-AACEF58A0637}"/>
               </a:ext>
             </a:extLst>
           </p:cNvPr>
@@ -4985,7 +4985,7 @@
           <p:cNvPr id="5" name="">
             <a:extLst xmlns:a="http://schemas.openxmlformats.org/drawingml/2006/main">
               <a:ext uri="{FF2B5EF4-FFF2-40B4-BE49-F238E27FC236}">
-                <a16:creationId xmlns:a16="http://schemas.microsoft.com/office/drawing/2014/main" id="{D576BECE-509C-494E-8E6A-7D257F1DDC8F}"/>
+                <a16:creationId xmlns:a16="http://schemas.microsoft.com/office/drawing/2014/main" id="{433EC3A9-CAC3-4205-9F35-BD200C0D7C26}"/>
               </a:ext>
             </a:extLst>
           </p:cNvPr>
@@ -5049,7 +5049,7 @@
           <p:cNvPr id="6" name="">
             <a:extLst xmlns:a="http://schemas.openxmlformats.org/drawingml/2006/main">
               <a:ext uri="{FF2B5EF4-FFF2-40B4-BE49-F238E27FC236}">
-                <a16:creationId xmlns:a16="http://schemas.microsoft.com/office/drawing/2014/main" id="{CCE76841-D8AE-443C-99A3-90847E8D1B43}"/>
+                <a16:creationId xmlns:a16="http://schemas.microsoft.com/office/drawing/2014/main" id="{0B5EFE6A-7C76-471B-9D6C-6EAAC4C6131D}"/>
               </a:ext>
             </a:extLst>
           </p:cNvPr>
@@ -5113,7 +5113,7 @@
           <p:cNvPr id="7" name="">
             <a:extLst xmlns:a="http://schemas.openxmlformats.org/drawingml/2006/main">
               <a:ext uri="{FF2B5EF4-FFF2-40B4-BE49-F238E27FC236}">
-                <a16:creationId xmlns:a16="http://schemas.microsoft.com/office/drawing/2014/main" id="{56CC1CA6-1852-4544-9765-6D09933C780A}"/>
+                <a16:creationId xmlns:a16="http://schemas.microsoft.com/office/drawing/2014/main" id="{234059AE-77FC-4540-BAA4-23F0D95EF86C}"/>
               </a:ext>
             </a:extLst>
           </p:cNvPr>
@@ -5146,7 +5146,7 @@
           <p:cNvPr id="8" name="">
             <a:extLst xmlns:a="http://schemas.openxmlformats.org/drawingml/2006/main">
               <a:ext uri="{FF2B5EF4-FFF2-40B4-BE49-F238E27FC236}">
-                <a16:creationId xmlns:a16="http://schemas.microsoft.com/office/drawing/2014/main" id="{56AC5122-3D87-42A7-9603-BC096D4E594A}"/>
+                <a16:creationId xmlns:a16="http://schemas.microsoft.com/office/drawing/2014/main" id="{51F94C2E-9A08-4E1E-960E-5826C85310CE}"/>
               </a:ext>
             </a:extLst>
           </p:cNvPr>
@@ -5210,7 +5210,7 @@
           <p:cNvPr id="9" name="">
             <a:extLst xmlns:a="http://schemas.openxmlformats.org/drawingml/2006/main">
               <a:ext uri="{FF2B5EF4-FFF2-40B4-BE49-F238E27FC236}">
-                <a16:creationId xmlns:a16="http://schemas.microsoft.com/office/drawing/2014/main" id="{B02F5887-DCE2-4C08-870D-F2F0A77DE536}"/>
+                <a16:creationId xmlns:a16="http://schemas.microsoft.com/office/drawing/2014/main" id="{1A632BCB-0EC5-440B-A6E2-52C5AF307BA0}"/>
               </a:ext>
             </a:extLst>
           </p:cNvPr>
@@ -5274,7 +5274,7 @@
           <p:cNvPr id="10" name="">
             <a:extLst xmlns:a="http://schemas.openxmlformats.org/drawingml/2006/main">
               <a:ext uri="{FF2B5EF4-FFF2-40B4-BE49-F238E27FC236}">
-                <a16:creationId xmlns:a16="http://schemas.microsoft.com/office/drawing/2014/main" id="{D20B6359-53DB-44C5-9BE9-2D88483ED3E1}"/>
+                <a16:creationId xmlns:a16="http://schemas.microsoft.com/office/drawing/2014/main" id="{0307FBC3-1AA3-4A39-B79D-82AD96A31754}"/>
               </a:ext>
             </a:extLst>
           </p:cNvPr>
@@ -5338,7 +5338,7 @@
           <p:cNvPr id="11" name="">
             <a:extLst xmlns:a="http://schemas.openxmlformats.org/drawingml/2006/main">
               <a:ext uri="{FF2B5EF4-FFF2-40B4-BE49-F238E27FC236}">
-                <a16:creationId xmlns:a16="http://schemas.microsoft.com/office/drawing/2014/main" id="{A1189062-1241-43E8-A3EE-2618421B777E}"/>
+                <a16:creationId xmlns:a16="http://schemas.microsoft.com/office/drawing/2014/main" id="{3F79CBF6-AE37-4726-BD5E-208D49579B22}"/>
               </a:ext>
             </a:extLst>
           </p:cNvPr>
@@ -5371,7 +5371,7 @@
           <p:cNvPr id="12" name="">
             <a:extLst xmlns:a="http://schemas.openxmlformats.org/drawingml/2006/main">
               <a:ext uri="{FF2B5EF4-FFF2-40B4-BE49-F238E27FC236}">
-                <a16:creationId xmlns:a16="http://schemas.microsoft.com/office/drawing/2014/main" id="{758DC3F3-918D-4816-8298-4073F7F1E883}"/>
+                <a16:creationId xmlns:a16="http://schemas.microsoft.com/office/drawing/2014/main" id="{30E855A0-F205-4CAE-A883-ABC18411A74B}"/>
               </a:ext>
             </a:extLst>
           </p:cNvPr>
@@ -5435,7 +5435,7 @@
           <p:cNvPr id="13" name="">
             <a:extLst xmlns:a="http://schemas.openxmlformats.org/drawingml/2006/main">
               <a:ext uri="{FF2B5EF4-FFF2-40B4-BE49-F238E27FC236}">
-                <a16:creationId xmlns:a16="http://schemas.microsoft.com/office/drawing/2014/main" id="{DF2CC726-37D7-41EE-97F3-364DCF7A4EE6}"/>
+                <a16:creationId xmlns:a16="http://schemas.microsoft.com/office/drawing/2014/main" id="{FFBECFDC-6A1A-488A-901B-D448D923F980}"/>
               </a:ext>
             </a:extLst>
           </p:cNvPr>
@@ -5499,7 +5499,7 @@
           <p:cNvPr id="14" name="">
             <a:extLst xmlns:a="http://schemas.openxmlformats.org/drawingml/2006/main">
               <a:ext uri="{FF2B5EF4-FFF2-40B4-BE49-F238E27FC236}">
-                <a16:creationId xmlns:a16="http://schemas.microsoft.com/office/drawing/2014/main" id="{ECF789A2-0105-4EAB-9CBA-47E10BEF0F10}"/>
+                <a16:creationId xmlns:a16="http://schemas.microsoft.com/office/drawing/2014/main" id="{973AB47D-BA07-4208-9EA1-F4D00C7E26A3}"/>
               </a:ext>
             </a:extLst>
           </p:cNvPr>
@@ -5563,7 +5563,7 @@
           <p:cNvPr id="15" name="">
             <a:extLst xmlns:a="http://schemas.openxmlformats.org/drawingml/2006/main">
               <a:ext uri="{FF2B5EF4-FFF2-40B4-BE49-F238E27FC236}">
-                <a16:creationId xmlns:a16="http://schemas.microsoft.com/office/drawing/2014/main" id="{B7426D1C-64FC-47B3-975E-6F88AC819455}"/>
+                <a16:creationId xmlns:a16="http://schemas.microsoft.com/office/drawing/2014/main" id="{35C0C05C-2EA8-4A64-9059-E234DF5357EF}"/>
               </a:ext>
             </a:extLst>
           </p:cNvPr>
@@ -5596,7 +5596,7 @@
           <p:cNvPr id="16" name="">
             <a:extLst xmlns:a="http://schemas.openxmlformats.org/drawingml/2006/main">
               <a:ext uri="{FF2B5EF4-FFF2-40B4-BE49-F238E27FC236}">
-                <a16:creationId xmlns:a16="http://schemas.microsoft.com/office/drawing/2014/main" id="{C835B5B9-0A77-4393-8473-4E9E993D5B34}"/>
+                <a16:creationId xmlns:a16="http://schemas.microsoft.com/office/drawing/2014/main" id="{AF89E0EB-D9D3-4663-A03B-00F1DAD625FE}"/>
               </a:ext>
             </a:extLst>
           </p:cNvPr>
@@ -5660,7 +5660,7 @@
           <p:cNvPr id="17" name="">
             <a:extLst xmlns:a="http://schemas.openxmlformats.org/drawingml/2006/main">
               <a:ext uri="{FF2B5EF4-FFF2-40B4-BE49-F238E27FC236}">
-                <a16:creationId xmlns:a16="http://schemas.microsoft.com/office/drawing/2014/main" id="{04E269CA-6734-4C5D-991F-89C629D6722C}"/>
+                <a16:creationId xmlns:a16="http://schemas.microsoft.com/office/drawing/2014/main" id="{2C18E65E-0A29-4B5E-8C35-BF51FDF1548B}"/>
               </a:ext>
             </a:extLst>
           </p:cNvPr>
@@ -5724,7 +5724,7 @@
           <p:cNvPr id="18" name="">
             <a:extLst xmlns:a="http://schemas.openxmlformats.org/drawingml/2006/main">
               <a:ext uri="{FF2B5EF4-FFF2-40B4-BE49-F238E27FC236}">
-                <a16:creationId xmlns:a16="http://schemas.microsoft.com/office/drawing/2014/main" id="{250773C4-B1A6-44BF-82F6-E59FA245F808}"/>
+                <a16:creationId xmlns:a16="http://schemas.microsoft.com/office/drawing/2014/main" id="{F4C2512F-8943-459B-91B2-96B9A51BA42F}"/>
               </a:ext>
             </a:extLst>
           </p:cNvPr>
@@ -5788,7 +5788,7 @@
           <p:cNvPr id="19" name="">
             <a:extLst xmlns:a="http://schemas.openxmlformats.org/drawingml/2006/main">
               <a:ext uri="{FF2B5EF4-FFF2-40B4-BE49-F238E27FC236}">
-                <a16:creationId xmlns:a16="http://schemas.microsoft.com/office/drawing/2014/main" id="{E2C35C22-4101-4E32-95E7-F52E0BB16E0D}"/>
+                <a16:creationId xmlns:a16="http://schemas.microsoft.com/office/drawing/2014/main" id="{B367648A-E025-4DED-8176-7DF56EDB5A9C}"/>
               </a:ext>
             </a:extLst>
           </p:cNvPr>
@@ -5821,7 +5821,7 @@
           <p:cNvPr id="20" name="">
             <a:extLst xmlns:a="http://schemas.openxmlformats.org/drawingml/2006/main">
               <a:ext uri="{FF2B5EF4-FFF2-40B4-BE49-F238E27FC236}">
-                <a16:creationId xmlns:a16="http://schemas.microsoft.com/office/drawing/2014/main" id="{49B94595-65AA-425D-B3DB-F93B63FD8C43}"/>
+                <a16:creationId xmlns:a16="http://schemas.microsoft.com/office/drawing/2014/main" id="{7CB34E1D-C0CB-4F05-8DE8-CDD183D3083F}"/>
               </a:ext>
             </a:extLst>
           </p:cNvPr>
@@ -5885,7 +5885,7 @@
           <p:cNvPr id="21" name="">
             <a:extLst xmlns:a="http://schemas.openxmlformats.org/drawingml/2006/main">
               <a:ext uri="{FF2B5EF4-FFF2-40B4-BE49-F238E27FC236}">
-                <a16:creationId xmlns:a16="http://schemas.microsoft.com/office/drawing/2014/main" id="{7835A133-AC0D-4086-98DE-626FB185B5AF}"/>
+                <a16:creationId xmlns:a16="http://schemas.microsoft.com/office/drawing/2014/main" id="{3B88EFD5-2E6A-4647-940C-924F5ECCA335}"/>
               </a:ext>
             </a:extLst>
           </p:cNvPr>
@@ -5949,7 +5949,7 @@
           <p:cNvPr id="22" name="">
             <a:extLst xmlns:a="http://schemas.openxmlformats.org/drawingml/2006/main">
               <a:ext uri="{FF2B5EF4-FFF2-40B4-BE49-F238E27FC236}">
-                <a16:creationId xmlns:a16="http://schemas.microsoft.com/office/drawing/2014/main" id="{70C4210B-2257-470C-8D66-E0AAD176DB93}"/>
+                <a16:creationId xmlns:a16="http://schemas.microsoft.com/office/drawing/2014/main" id="{A6736CCE-1716-4BBA-9062-3A5EEF405F4E}"/>
               </a:ext>
             </a:extLst>
           </p:cNvPr>
@@ -5982,7 +5982,7 @@
           <p:cNvPr id="23" name="">
             <a:extLst xmlns:a="http://schemas.openxmlformats.org/drawingml/2006/main">
               <a:ext uri="{FF2B5EF4-FFF2-40B4-BE49-F238E27FC236}">
-                <a16:creationId xmlns:a16="http://schemas.microsoft.com/office/drawing/2014/main" id="{AAD0EDE8-4F08-4AC3-96B8-2F027738AB31}"/>
+                <a16:creationId xmlns:a16="http://schemas.microsoft.com/office/drawing/2014/main" id="{BE052C3F-9B07-49CC-BA95-2B59338AB53B}"/>
               </a:ext>
             </a:extLst>
           </p:cNvPr>
@@ -6046,7 +6046,7 @@
           <p:cNvPr id="24" name="">
             <a:extLst xmlns:a="http://schemas.openxmlformats.org/drawingml/2006/main">
               <a:ext uri="{FF2B5EF4-FFF2-40B4-BE49-F238E27FC236}">
-                <a16:creationId xmlns:a16="http://schemas.microsoft.com/office/drawing/2014/main" id="{93D8061D-2948-44E9-BAB7-2D3F3F227081}"/>
+                <a16:creationId xmlns:a16="http://schemas.microsoft.com/office/drawing/2014/main" id="{D630BBB2-8442-4579-AED2-025C5BA8696E}"/>
               </a:ext>
             </a:extLst>
           </p:cNvPr>
@@ -6110,7 +6110,7 @@
           <p:cNvPr id="25" name="">
             <a:extLst xmlns:a="http://schemas.openxmlformats.org/drawingml/2006/main">
               <a:ext uri="{FF2B5EF4-FFF2-40B4-BE49-F238E27FC236}">
-                <a16:creationId xmlns:a16="http://schemas.microsoft.com/office/drawing/2014/main" id="{37FE00A9-1458-464A-9576-38C4B0D812DC}"/>
+                <a16:creationId xmlns:a16="http://schemas.microsoft.com/office/drawing/2014/main" id="{387A81F9-284B-4B86-B592-E5F719210196}"/>
               </a:ext>
             </a:extLst>
           </p:cNvPr>
@@ -6174,7 +6174,7 @@
           <p:cNvPr id="26" name="">
             <a:extLst xmlns:a="http://schemas.openxmlformats.org/drawingml/2006/main">
               <a:ext uri="{FF2B5EF4-FFF2-40B4-BE49-F238E27FC236}">
-                <a16:creationId xmlns:a16="http://schemas.microsoft.com/office/drawing/2014/main" id="{9E3E255F-CD55-4C4B-90C9-CC3FCFCA0D04}"/>
+                <a16:creationId xmlns:a16="http://schemas.microsoft.com/office/drawing/2014/main" id="{4AA3284F-B1BA-4874-A860-BF7661695809}"/>
               </a:ext>
             </a:extLst>
           </p:cNvPr>
@@ -6236,7 +6236,7 @@
     </p:spTree>
     <p:extLst>
       <p:ext uri="{BB962C8B-B14F-4D97-AF65-F5344CB8AC3E}">
-        <p14:creationId xmlns:p14="http://schemas.microsoft.com/office/powerpoint/2010/main" val="1786097367"/>
+        <p14:creationId xmlns:p14="http://schemas.microsoft.com/office/powerpoint/2010/main" val="964038635"/>
       </p:ext>
     </p:extLst>
   </p:cSld>
@@ -6260,7 +6260,7 @@
           <p:cNvPr id="1" name="">
             <a:extLst xmlns:a="http://schemas.openxmlformats.org/drawingml/2006/main">
               <a:ext uri="{FF2B5EF4-FFF2-40B4-BE49-F238E27FC236}">
-                <a16:creationId xmlns:a16="http://schemas.microsoft.com/office/drawing/2014/main" id="{FCF8E545-6C4E-4BBD-9F6F-728A5BDDADE2}"/>
+                <a16:creationId xmlns:a16="http://schemas.microsoft.com/office/drawing/2014/main" id="{D8B3D23F-7CA1-4853-B2B4-007EED270B64}"/>
               </a:ext>
             </a:extLst>
           </p:cNvPr>
@@ -6295,7 +6295,7 @@
           <p:cNvPr id="2" name="">
             <a:extLst xmlns:a="http://schemas.openxmlformats.org/drawingml/2006/main">
               <a:ext uri="{FF2B5EF4-FFF2-40B4-BE49-F238E27FC236}">
-                <a16:creationId xmlns:a16="http://schemas.microsoft.com/office/drawing/2014/main" id="{3E3A6E69-B082-486A-AB22-49E165C174E9}"/>
+                <a16:creationId xmlns:a16="http://schemas.microsoft.com/office/drawing/2014/main" id="{D459BD3D-AC50-4FC6-A21D-7CE18073ECCF}"/>
               </a:ext>
             </a:extLst>
           </p:cNvPr>
@@ -6330,7 +6330,7 @@
           <p:cNvPr id="3" name="">
             <a:extLst xmlns:a="http://schemas.openxmlformats.org/drawingml/2006/main">
               <a:ext uri="{FF2B5EF4-FFF2-40B4-BE49-F238E27FC236}">
-                <a16:creationId xmlns:a16="http://schemas.microsoft.com/office/drawing/2014/main" id="{E234C039-1F19-4DA4-BD2A-044290E24172}"/>
+                <a16:creationId xmlns:a16="http://schemas.microsoft.com/office/drawing/2014/main" id="{6258E937-2317-4388-B27B-8A8BF4A5D3BD}"/>
               </a:ext>
             </a:extLst>
           </p:cNvPr>
@@ -6394,7 +6394,7 @@
           <p:cNvPr id="4" name="">
             <a:extLst xmlns:a="http://schemas.openxmlformats.org/drawingml/2006/main">
               <a:ext uri="{FF2B5EF4-FFF2-40B4-BE49-F238E27FC236}">
-                <a16:creationId xmlns:a16="http://schemas.microsoft.com/office/drawing/2014/main" id="{BBC66D80-B521-4428-8EB7-D5AE9BD73688}"/>
+                <a16:creationId xmlns:a16="http://schemas.microsoft.com/office/drawing/2014/main" id="{AEF28783-16F1-4DB4-AE82-8B33BBAD0C42}"/>
               </a:ext>
             </a:extLst>
           </p:cNvPr>
@@ -6458,7 +6458,7 @@
           <p:cNvPr id="5" name="">
             <a:extLst xmlns:a="http://schemas.openxmlformats.org/drawingml/2006/main">
               <a:ext uri="{FF2B5EF4-FFF2-40B4-BE49-F238E27FC236}">
-                <a16:creationId xmlns:a16="http://schemas.microsoft.com/office/drawing/2014/main" id="{1D46D31F-BBA6-4CAC-ABEA-E38C3D0EA5A0}"/>
+                <a16:creationId xmlns:a16="http://schemas.microsoft.com/office/drawing/2014/main" id="{858D48FE-E293-41CB-B05B-FE538C35D0F2}"/>
               </a:ext>
             </a:extLst>
           </p:cNvPr>
@@ -6522,7 +6522,7 @@
           <p:cNvPr id="6" name="">
             <a:extLst xmlns:a="http://schemas.openxmlformats.org/drawingml/2006/main">
               <a:ext uri="{FF2B5EF4-FFF2-40B4-BE49-F238E27FC236}">
-                <a16:creationId xmlns:a16="http://schemas.microsoft.com/office/drawing/2014/main" id="{391FFE52-20AB-4B80-8B64-407F14EEDFCA}"/>
+                <a16:creationId xmlns:a16="http://schemas.microsoft.com/office/drawing/2014/main" id="{6806073A-4BB1-4F78-B6B9-E33D88594E8D}"/>
               </a:ext>
             </a:extLst>
           </p:cNvPr>
@@ -6586,7 +6586,7 @@
           <p:cNvPr id="7" name="">
             <a:extLst xmlns:a="http://schemas.openxmlformats.org/drawingml/2006/main">
               <a:ext uri="{FF2B5EF4-FFF2-40B4-BE49-F238E27FC236}">
-                <a16:creationId xmlns:a16="http://schemas.microsoft.com/office/drawing/2014/main" id="{5C99053C-59F9-4AC6-84DA-ECA6D256EED9}"/>
+                <a16:creationId xmlns:a16="http://schemas.microsoft.com/office/drawing/2014/main" id="{D89C0317-A0AF-4862-87AC-3CEE155939E0}"/>
               </a:ext>
             </a:extLst>
           </p:cNvPr>
@@ -6619,7 +6619,7 @@
           <p:cNvPr id="8" name="">
             <a:extLst xmlns:a="http://schemas.openxmlformats.org/drawingml/2006/main">
               <a:ext uri="{FF2B5EF4-FFF2-40B4-BE49-F238E27FC236}">
-                <a16:creationId xmlns:a16="http://schemas.microsoft.com/office/drawing/2014/main" id="{6D8E75BA-8849-459C-9D2C-585A0958A43C}"/>
+                <a16:creationId xmlns:a16="http://schemas.microsoft.com/office/drawing/2014/main" id="{AA584DDA-C0E6-4CC0-9405-2F1CF8BEF059}"/>
               </a:ext>
             </a:extLst>
           </p:cNvPr>
@@ -6683,7 +6683,7 @@
           <p:cNvPr id="9" name="">
             <a:extLst xmlns:a="http://schemas.openxmlformats.org/drawingml/2006/main">
               <a:ext uri="{FF2B5EF4-FFF2-40B4-BE49-F238E27FC236}">
-                <a16:creationId xmlns:a16="http://schemas.microsoft.com/office/drawing/2014/main" id="{869693A5-1D64-4EC3-A16B-C6509F811778}"/>
+                <a16:creationId xmlns:a16="http://schemas.microsoft.com/office/drawing/2014/main" id="{A2F85E56-B734-400D-A029-271309BA9EDE}"/>
               </a:ext>
             </a:extLst>
           </p:cNvPr>
@@ -6747,7 +6747,7 @@
           <p:cNvPr id="10" name="">
             <a:extLst xmlns:a="http://schemas.openxmlformats.org/drawingml/2006/main">
               <a:ext uri="{FF2B5EF4-FFF2-40B4-BE49-F238E27FC236}">
-                <a16:creationId xmlns:a16="http://schemas.microsoft.com/office/drawing/2014/main" id="{04C936EC-985A-4A59-8E9A-34086060187E}"/>
+                <a16:creationId xmlns:a16="http://schemas.microsoft.com/office/drawing/2014/main" id="{62922963-0C97-42E9-946E-7D33ED6771B9}"/>
               </a:ext>
             </a:extLst>
           </p:cNvPr>
@@ -6811,7 +6811,7 @@
           <p:cNvPr id="11" name="">
             <a:extLst xmlns:a="http://schemas.openxmlformats.org/drawingml/2006/main">
               <a:ext uri="{FF2B5EF4-FFF2-40B4-BE49-F238E27FC236}">
-                <a16:creationId xmlns:a16="http://schemas.microsoft.com/office/drawing/2014/main" id="{5C77E912-BD0F-4150-91AB-2756D4538E8E}"/>
+                <a16:creationId xmlns:a16="http://schemas.microsoft.com/office/drawing/2014/main" id="{9AF5A4DB-A77D-46BF-8C73-DE39C526CC83}"/>
               </a:ext>
             </a:extLst>
           </p:cNvPr>
@@ -6844,7 +6844,7 @@
           <p:cNvPr id="12" name="">
             <a:extLst xmlns:a="http://schemas.openxmlformats.org/drawingml/2006/main">
               <a:ext uri="{FF2B5EF4-FFF2-40B4-BE49-F238E27FC236}">
-                <a16:creationId xmlns:a16="http://schemas.microsoft.com/office/drawing/2014/main" id="{FA8FE8BF-CC13-405F-A802-125971637CCB}"/>
+                <a16:creationId xmlns:a16="http://schemas.microsoft.com/office/drawing/2014/main" id="{830005E5-DD80-4E4D-AEC1-A648760CC8A8}"/>
               </a:ext>
             </a:extLst>
           </p:cNvPr>
@@ -6908,7 +6908,7 @@
           <p:cNvPr id="13" name="">
             <a:extLst xmlns:a="http://schemas.openxmlformats.org/drawingml/2006/main">
               <a:ext uri="{FF2B5EF4-FFF2-40B4-BE49-F238E27FC236}">
-                <a16:creationId xmlns:a16="http://schemas.microsoft.com/office/drawing/2014/main" id="{479FE342-C441-4510-A257-A0C1ED298334}"/>
+                <a16:creationId xmlns:a16="http://schemas.microsoft.com/office/drawing/2014/main" id="{E871F3EC-C599-4D16-97BA-C8DB0373E68C}"/>
               </a:ext>
             </a:extLst>
           </p:cNvPr>
@@ -6972,7 +6972,7 @@
           <p:cNvPr id="14" name="">
             <a:extLst xmlns:a="http://schemas.openxmlformats.org/drawingml/2006/main">
               <a:ext uri="{FF2B5EF4-FFF2-40B4-BE49-F238E27FC236}">
-                <a16:creationId xmlns:a16="http://schemas.microsoft.com/office/drawing/2014/main" id="{44D4E852-61CB-49E4-B4E4-9C78AF1880F2}"/>
+                <a16:creationId xmlns:a16="http://schemas.microsoft.com/office/drawing/2014/main" id="{7725CFBC-BA95-4860-92B6-34201EDCF80C}"/>
               </a:ext>
             </a:extLst>
           </p:cNvPr>
@@ -7036,7 +7036,7 @@
           <p:cNvPr id="15" name="">
             <a:extLst xmlns:a="http://schemas.openxmlformats.org/drawingml/2006/main">
               <a:ext uri="{FF2B5EF4-FFF2-40B4-BE49-F238E27FC236}">
-                <a16:creationId xmlns:a16="http://schemas.microsoft.com/office/drawing/2014/main" id="{4CF4BD3E-FB91-4206-80D0-CAE38A7DA784}"/>
+                <a16:creationId xmlns:a16="http://schemas.microsoft.com/office/drawing/2014/main" id="{265C9F3E-89CF-4976-BC4A-13C24A4029BB}"/>
               </a:ext>
             </a:extLst>
           </p:cNvPr>
@@ -7069,7 +7069,7 @@
           <p:cNvPr id="16" name="">
             <a:extLst xmlns:a="http://schemas.openxmlformats.org/drawingml/2006/main">
               <a:ext uri="{FF2B5EF4-FFF2-40B4-BE49-F238E27FC236}">
-                <a16:creationId xmlns:a16="http://schemas.microsoft.com/office/drawing/2014/main" id="{0BCAAC7E-C942-4574-9437-C7DDCDF12789}"/>
+                <a16:creationId xmlns:a16="http://schemas.microsoft.com/office/drawing/2014/main" id="{4AF62595-0081-486C-AE47-6FDAED8A5A2C}"/>
               </a:ext>
             </a:extLst>
           </p:cNvPr>
@@ -7133,7 +7133,7 @@
           <p:cNvPr id="17" name="">
             <a:extLst xmlns:a="http://schemas.openxmlformats.org/drawingml/2006/main">
               <a:ext uri="{FF2B5EF4-FFF2-40B4-BE49-F238E27FC236}">
-                <a16:creationId xmlns:a16="http://schemas.microsoft.com/office/drawing/2014/main" id="{9BFDAEE1-51FF-41AC-902B-76EE2247A800}"/>
+                <a16:creationId xmlns:a16="http://schemas.microsoft.com/office/drawing/2014/main" id="{7CF3B934-CECF-4D7D-BC10-149DE0E7892D}"/>
               </a:ext>
             </a:extLst>
           </p:cNvPr>
@@ -7197,7 +7197,7 @@
           <p:cNvPr id="18" name="">
             <a:extLst xmlns:a="http://schemas.openxmlformats.org/drawingml/2006/main">
               <a:ext uri="{FF2B5EF4-FFF2-40B4-BE49-F238E27FC236}">
-                <a16:creationId xmlns:a16="http://schemas.microsoft.com/office/drawing/2014/main" id="{C55F1F5C-4696-4714-9585-9133AB6DE051}"/>
+                <a16:creationId xmlns:a16="http://schemas.microsoft.com/office/drawing/2014/main" id="{22CF7A61-4F8C-4B36-843D-1A72B53E5174}"/>
               </a:ext>
             </a:extLst>
           </p:cNvPr>
@@ -7261,7 +7261,7 @@
           <p:cNvPr id="19" name="">
             <a:extLst xmlns:a="http://schemas.openxmlformats.org/drawingml/2006/main">
               <a:ext uri="{FF2B5EF4-FFF2-40B4-BE49-F238E27FC236}">
-                <a16:creationId xmlns:a16="http://schemas.microsoft.com/office/drawing/2014/main" id="{C5E5E08C-B3AD-49C2-90B4-736B33E99614}"/>
+                <a16:creationId xmlns:a16="http://schemas.microsoft.com/office/drawing/2014/main" id="{3427DD97-CADB-4CBE-942D-5AE32A3A8C6A}"/>
               </a:ext>
             </a:extLst>
           </p:cNvPr>
@@ -7294,7 +7294,7 @@
           <p:cNvPr id="20" name="">
             <a:extLst xmlns:a="http://schemas.openxmlformats.org/drawingml/2006/main">
               <a:ext uri="{FF2B5EF4-FFF2-40B4-BE49-F238E27FC236}">
-                <a16:creationId xmlns:a16="http://schemas.microsoft.com/office/drawing/2014/main" id="{190C22A9-1DCC-4AAB-9E72-AA03723997CF}"/>
+                <a16:creationId xmlns:a16="http://schemas.microsoft.com/office/drawing/2014/main" id="{118C3F16-15CA-4C01-942F-7B9B351FFD61}"/>
               </a:ext>
             </a:extLst>
           </p:cNvPr>
@@ -7358,7 +7358,7 @@
           <p:cNvPr id="21" name="">
             <a:extLst xmlns:a="http://schemas.openxmlformats.org/drawingml/2006/main">
               <a:ext uri="{FF2B5EF4-FFF2-40B4-BE49-F238E27FC236}">
-                <a16:creationId xmlns:a16="http://schemas.microsoft.com/office/drawing/2014/main" id="{6A1F05A4-EA27-4F6D-9D52-1741A586A064}"/>
+                <a16:creationId xmlns:a16="http://schemas.microsoft.com/office/drawing/2014/main" id="{9E9FB93D-66F7-4649-A935-6A357D1CCF16}"/>
               </a:ext>
             </a:extLst>
           </p:cNvPr>
@@ -7422,7 +7422,7 @@
           <p:cNvPr id="22" name="">
             <a:extLst xmlns:a="http://schemas.openxmlformats.org/drawingml/2006/main">
               <a:ext uri="{FF2B5EF4-FFF2-40B4-BE49-F238E27FC236}">
-                <a16:creationId xmlns:a16="http://schemas.microsoft.com/office/drawing/2014/main" id="{FC7C74D5-4FD4-4578-B1CB-5B51162EFC47}"/>
+                <a16:creationId xmlns:a16="http://schemas.microsoft.com/office/drawing/2014/main" id="{6E16B10F-E194-474E-95DD-061F2092464B}"/>
               </a:ext>
             </a:extLst>
           </p:cNvPr>
@@ -7455,7 +7455,7 @@
           <p:cNvPr id="23" name="">
             <a:extLst xmlns:a="http://schemas.openxmlformats.org/drawingml/2006/main">
               <a:ext uri="{FF2B5EF4-FFF2-40B4-BE49-F238E27FC236}">
-                <a16:creationId xmlns:a16="http://schemas.microsoft.com/office/drawing/2014/main" id="{4B180E31-8F90-409F-B28E-4A54ACE436D2}"/>
+                <a16:creationId xmlns:a16="http://schemas.microsoft.com/office/drawing/2014/main" id="{D64D19FB-29F2-4645-A8AA-D1219FC7762A}"/>
               </a:ext>
             </a:extLst>
           </p:cNvPr>
@@ -7519,7 +7519,7 @@
           <p:cNvPr id="24" name="">
             <a:extLst xmlns:a="http://schemas.openxmlformats.org/drawingml/2006/main">
               <a:ext uri="{FF2B5EF4-FFF2-40B4-BE49-F238E27FC236}">
-                <a16:creationId xmlns:a16="http://schemas.microsoft.com/office/drawing/2014/main" id="{2456BD63-4E73-4590-AC95-E21004611226}"/>
+                <a16:creationId xmlns:a16="http://schemas.microsoft.com/office/drawing/2014/main" id="{9BD60EF1-FD0F-405D-B16C-356D29DCEBCB}"/>
               </a:ext>
             </a:extLst>
           </p:cNvPr>
@@ -7583,7 +7583,7 @@
           <p:cNvPr id="25" name="">
             <a:extLst xmlns:a="http://schemas.openxmlformats.org/drawingml/2006/main">
               <a:ext uri="{FF2B5EF4-FFF2-40B4-BE49-F238E27FC236}">
-                <a16:creationId xmlns:a16="http://schemas.microsoft.com/office/drawing/2014/main" id="{2C7EA490-4FF6-42A2-9325-D81C993E4ECC}"/>
+                <a16:creationId xmlns:a16="http://schemas.microsoft.com/office/drawing/2014/main" id="{B71CCB84-57D7-4054-AA83-3A0E962BC329}"/>
               </a:ext>
             </a:extLst>
           </p:cNvPr>
@@ -7647,7 +7647,7 @@
           <p:cNvPr id="26" name="">
             <a:extLst xmlns:a="http://schemas.openxmlformats.org/drawingml/2006/main">
               <a:ext uri="{FF2B5EF4-FFF2-40B4-BE49-F238E27FC236}">
-                <a16:creationId xmlns:a16="http://schemas.microsoft.com/office/drawing/2014/main" id="{A7DDB755-6377-4ADD-B865-7719543B40F3}"/>
+                <a16:creationId xmlns:a16="http://schemas.microsoft.com/office/drawing/2014/main" id="{5C3A2452-8236-4417-9E3D-B6B9324B1C27}"/>
               </a:ext>
             </a:extLst>
           </p:cNvPr>
@@ -7709,7 +7709,7 @@
     </p:spTree>
     <p:extLst>
       <p:ext uri="{BB962C8B-B14F-4D97-AF65-F5344CB8AC3E}">
-        <p14:creationId xmlns:p14="http://schemas.microsoft.com/office/powerpoint/2010/main" val="1092044091"/>
+        <p14:creationId xmlns:p14="http://schemas.microsoft.com/office/powerpoint/2010/main" val="2122032808"/>
       </p:ext>
     </p:extLst>
   </p:cSld>
@@ -7733,7 +7733,7 @@
           <p:cNvPr id="1" name="">
             <a:extLst xmlns:a="http://schemas.openxmlformats.org/drawingml/2006/main">
               <a:ext uri="{FF2B5EF4-FFF2-40B4-BE49-F238E27FC236}">
-                <a16:creationId xmlns:a16="http://schemas.microsoft.com/office/drawing/2014/main" id="{BF61FEDB-6FCF-4BDF-B60E-0C1FD2231E0F}"/>
+                <a16:creationId xmlns:a16="http://schemas.microsoft.com/office/drawing/2014/main" id="{070D2D39-1E25-4B43-B188-B2687702E65B}"/>
               </a:ext>
             </a:extLst>
           </p:cNvPr>
@@ -7768,7 +7768,7 @@
           <p:cNvPr id="2" name="">
             <a:extLst xmlns:a="http://schemas.openxmlformats.org/drawingml/2006/main">
               <a:ext uri="{FF2B5EF4-FFF2-40B4-BE49-F238E27FC236}">
-                <a16:creationId xmlns:a16="http://schemas.microsoft.com/office/drawing/2014/main" id="{C19A5AC0-D77B-4074-BDE2-2C9B58C14489}"/>
+                <a16:creationId xmlns:a16="http://schemas.microsoft.com/office/drawing/2014/main" id="{4B174FD8-5E52-4577-989B-E2324D6E873C}"/>
               </a:ext>
             </a:extLst>
           </p:cNvPr>
@@ -7803,7 +7803,7 @@
           <p:cNvPr id="3" name="">
             <a:extLst xmlns:a="http://schemas.openxmlformats.org/drawingml/2006/main">
               <a:ext uri="{FF2B5EF4-FFF2-40B4-BE49-F238E27FC236}">
-                <a16:creationId xmlns:a16="http://schemas.microsoft.com/office/drawing/2014/main" id="{EF74A8F6-BB68-4648-90BC-B1C1BD511F6E}"/>
+                <a16:creationId xmlns:a16="http://schemas.microsoft.com/office/drawing/2014/main" id="{8958D8D0-60DF-4972-B9B5-3BC7F0803048}"/>
               </a:ext>
             </a:extLst>
           </p:cNvPr>
@@ -7867,7 +7867,7 @@
           <p:cNvPr id="4" name="">
             <a:extLst xmlns:a="http://schemas.openxmlformats.org/drawingml/2006/main">
               <a:ext uri="{FF2B5EF4-FFF2-40B4-BE49-F238E27FC236}">
-                <a16:creationId xmlns:a16="http://schemas.microsoft.com/office/drawing/2014/main" id="{99D0EFB7-9CEA-4DFD-8B29-C74DECC8DCBE}"/>
+                <a16:creationId xmlns:a16="http://schemas.microsoft.com/office/drawing/2014/main" id="{91A074B0-88B1-4675-AD65-2C9EE03D6DFE}"/>
               </a:ext>
             </a:extLst>
           </p:cNvPr>
@@ -7931,7 +7931,7 @@
           <p:cNvPr id="5" name="">
             <a:extLst xmlns:a="http://schemas.openxmlformats.org/drawingml/2006/main">
               <a:ext uri="{FF2B5EF4-FFF2-40B4-BE49-F238E27FC236}">
-                <a16:creationId xmlns:a16="http://schemas.microsoft.com/office/drawing/2014/main" id="{2A353138-CAB7-4857-8373-C073874E7E37}"/>
+                <a16:creationId xmlns:a16="http://schemas.microsoft.com/office/drawing/2014/main" id="{50809326-28D7-4347-B8F1-3670B89D48BB}"/>
               </a:ext>
             </a:extLst>
           </p:cNvPr>
@@ -7995,7 +7995,7 @@
           <p:cNvPr id="6" name="">
             <a:extLst xmlns:a="http://schemas.openxmlformats.org/drawingml/2006/main">
               <a:ext uri="{FF2B5EF4-FFF2-40B4-BE49-F238E27FC236}">
-                <a16:creationId xmlns:a16="http://schemas.microsoft.com/office/drawing/2014/main" id="{19D0A010-BF87-4EC9-8C99-DE9D8A650F1A}"/>
+                <a16:creationId xmlns:a16="http://schemas.microsoft.com/office/drawing/2014/main" id="{27D0F717-AA77-460A-A098-FF067534C45A}"/>
               </a:ext>
             </a:extLst>
           </p:cNvPr>
@@ -8059,7 +8059,7 @@
           <p:cNvPr id="7" name="">
             <a:extLst xmlns:a="http://schemas.openxmlformats.org/drawingml/2006/main">
               <a:ext uri="{FF2B5EF4-FFF2-40B4-BE49-F238E27FC236}">
-                <a16:creationId xmlns:a16="http://schemas.microsoft.com/office/drawing/2014/main" id="{19F4EDBB-2169-41AB-B586-CAFC79C66D09}"/>
+                <a16:creationId xmlns:a16="http://schemas.microsoft.com/office/drawing/2014/main" id="{8C19E0F2-8FB8-4CDB-9887-C8DD2477ECA8}"/>
               </a:ext>
             </a:extLst>
           </p:cNvPr>
@@ -8094,7 +8094,7 @@
           <p:cNvPr id="8" name="">
             <a:extLst xmlns:a="http://schemas.openxmlformats.org/drawingml/2006/main">
               <a:ext uri="{FF2B5EF4-FFF2-40B4-BE49-F238E27FC236}">
-                <a16:creationId xmlns:a16="http://schemas.microsoft.com/office/drawing/2014/main" id="{738BB8C6-8E9A-47B7-A449-ADF65E6679D9}"/>
+                <a16:creationId xmlns:a16="http://schemas.microsoft.com/office/drawing/2014/main" id="{5EC1B59C-BC04-4028-8490-8F23B59805F1}"/>
               </a:ext>
             </a:extLst>
           </p:cNvPr>
@@ -8158,7 +8158,7 @@
           <p:cNvPr id="9" name="">
             <a:extLst xmlns:a="http://schemas.openxmlformats.org/drawingml/2006/main">
               <a:ext uri="{FF2B5EF4-FFF2-40B4-BE49-F238E27FC236}">
-                <a16:creationId xmlns:a16="http://schemas.microsoft.com/office/drawing/2014/main" id="{F3FB3394-A498-4699-BCC5-85804E32CB86}"/>
+                <a16:creationId xmlns:a16="http://schemas.microsoft.com/office/drawing/2014/main" id="{A6066AFD-5E46-4414-85CB-4A5F54C0FF70}"/>
               </a:ext>
             </a:extLst>
           </p:cNvPr>
@@ -8212,7 +8212,7 @@
                 <a:ea typeface="Aptos"/>
                 <a:cs typeface="Aptos"/>
               </a:rPr>
-              <a:t>145</a:t>
+              <a:t>155</a:t>
             </a:r>
           </a:p>
         </p:txBody>
@@ -8222,7 +8222,7 @@
           <p:cNvPr id="10" name="">
             <a:extLst xmlns:a="http://schemas.openxmlformats.org/drawingml/2006/main">
               <a:ext uri="{FF2B5EF4-FFF2-40B4-BE49-F238E27FC236}">
-                <a16:creationId xmlns:a16="http://schemas.microsoft.com/office/drawing/2014/main" id="{20C66A73-ACE5-4575-839F-1E55A4DF904A}"/>
+                <a16:creationId xmlns:a16="http://schemas.microsoft.com/office/drawing/2014/main" id="{DABC5F6E-2613-410F-B7E5-0AEBB8C71333}"/>
               </a:ext>
             </a:extLst>
           </p:cNvPr>
@@ -8286,7 +8286,7 @@
           <p:cNvPr id="11" name="">
             <a:extLst xmlns:a="http://schemas.openxmlformats.org/drawingml/2006/main">
               <a:ext uri="{FF2B5EF4-FFF2-40B4-BE49-F238E27FC236}">
-                <a16:creationId xmlns:a16="http://schemas.microsoft.com/office/drawing/2014/main" id="{FDBAFBA1-7E9D-42FF-B5F1-7F191E1053C5}"/>
+                <a16:creationId xmlns:a16="http://schemas.microsoft.com/office/drawing/2014/main" id="{FC827982-2CDD-4D65-9E7B-89B6B93643F3}"/>
               </a:ext>
             </a:extLst>
           </p:cNvPr>
@@ -8321,7 +8321,7 @@
           <p:cNvPr id="12" name="">
             <a:extLst xmlns:a="http://schemas.openxmlformats.org/drawingml/2006/main">
               <a:ext uri="{FF2B5EF4-FFF2-40B4-BE49-F238E27FC236}">
-                <a16:creationId xmlns:a16="http://schemas.microsoft.com/office/drawing/2014/main" id="{DAF39F11-0EDD-457C-9186-848ECAD5EE6E}"/>
+                <a16:creationId xmlns:a16="http://schemas.microsoft.com/office/drawing/2014/main" id="{AA6773F7-ACC7-4BFD-9E8A-B9E9C564EB4B}"/>
               </a:ext>
             </a:extLst>
           </p:cNvPr>
@@ -8385,7 +8385,7 @@
           <p:cNvPr id="13" name="">
             <a:extLst xmlns:a="http://schemas.openxmlformats.org/drawingml/2006/main">
               <a:ext uri="{FF2B5EF4-FFF2-40B4-BE49-F238E27FC236}">
-                <a16:creationId xmlns:a16="http://schemas.microsoft.com/office/drawing/2014/main" id="{0C684A74-4B80-4CA8-81C0-CBDB1E421766}"/>
+                <a16:creationId xmlns:a16="http://schemas.microsoft.com/office/drawing/2014/main" id="{BE22F96C-6FB3-4156-8434-4D93E3038D50}"/>
               </a:ext>
             </a:extLst>
           </p:cNvPr>
@@ -8439,7 +8439,7 @@
                 <a:ea typeface="Aptos"/>
                 <a:cs typeface="Aptos"/>
               </a:rPr>
-              <a:t>93</a:t>
+              <a:t>101</a:t>
             </a:r>
           </a:p>
         </p:txBody>
@@ -8449,7 +8449,7 @@
           <p:cNvPr id="14" name="">
             <a:extLst xmlns:a="http://schemas.openxmlformats.org/drawingml/2006/main">
               <a:ext uri="{FF2B5EF4-FFF2-40B4-BE49-F238E27FC236}">
-                <a16:creationId xmlns:a16="http://schemas.microsoft.com/office/drawing/2014/main" id="{10F95449-E610-498C-A643-D1684885FABB}"/>
+                <a16:creationId xmlns:a16="http://schemas.microsoft.com/office/drawing/2014/main" id="{DFF0F936-F571-4AA4-9D62-0F2EA7C269A9}"/>
               </a:ext>
             </a:extLst>
           </p:cNvPr>
@@ -8513,7 +8513,7 @@
           <p:cNvPr id="15" name="">
             <a:extLst xmlns:a="http://schemas.openxmlformats.org/drawingml/2006/main">
               <a:ext uri="{FF2B5EF4-FFF2-40B4-BE49-F238E27FC236}">
-                <a16:creationId xmlns:a16="http://schemas.microsoft.com/office/drawing/2014/main" id="{FDED96C1-592D-40D6-BA9D-024DD6E02E4D}"/>
+                <a16:creationId xmlns:a16="http://schemas.microsoft.com/office/drawing/2014/main" id="{11DAB77B-223C-442D-B90A-C03A6EC9742F}"/>
               </a:ext>
             </a:extLst>
           </p:cNvPr>
@@ -8548,7 +8548,7 @@
           <p:cNvPr id="16" name="">
             <a:extLst xmlns:a="http://schemas.openxmlformats.org/drawingml/2006/main">
               <a:ext uri="{FF2B5EF4-FFF2-40B4-BE49-F238E27FC236}">
-                <a16:creationId xmlns:a16="http://schemas.microsoft.com/office/drawing/2014/main" id="{FD73AB87-ED7B-44B5-824D-430F2F0E6566}"/>
+                <a16:creationId xmlns:a16="http://schemas.microsoft.com/office/drawing/2014/main" id="{9AE365F3-DB3C-4BFF-9104-0C2C1A51B891}"/>
               </a:ext>
             </a:extLst>
           </p:cNvPr>
@@ -8612,7 +8612,7 @@
           <p:cNvPr id="17" name="">
             <a:extLst xmlns:a="http://schemas.openxmlformats.org/drawingml/2006/main">
               <a:ext uri="{FF2B5EF4-FFF2-40B4-BE49-F238E27FC236}">
-                <a16:creationId xmlns:a16="http://schemas.microsoft.com/office/drawing/2014/main" id="{2A1E2D6F-5947-4F9E-B39A-93A7A049F7A5}"/>
+                <a16:creationId xmlns:a16="http://schemas.microsoft.com/office/drawing/2014/main" id="{DECB4937-387F-4F1B-8FA1-5EAA62B7536C}"/>
               </a:ext>
             </a:extLst>
           </p:cNvPr>
@@ -8676,7 +8676,7 @@
           <p:cNvPr id="18" name="">
             <a:extLst xmlns:a="http://schemas.openxmlformats.org/drawingml/2006/main">
               <a:ext uri="{FF2B5EF4-FFF2-40B4-BE49-F238E27FC236}">
-                <a16:creationId xmlns:a16="http://schemas.microsoft.com/office/drawing/2014/main" id="{2E247800-5A69-4F00-8DAA-327DDFF13AE4}"/>
+                <a16:creationId xmlns:a16="http://schemas.microsoft.com/office/drawing/2014/main" id="{A678CB4F-3497-4DB7-86F4-F05F54D1620E}"/>
               </a:ext>
             </a:extLst>
           </p:cNvPr>
@@ -8740,7 +8740,7 @@
           <p:cNvPr id="19" name="">
             <a:extLst xmlns:a="http://schemas.openxmlformats.org/drawingml/2006/main">
               <a:ext uri="{FF2B5EF4-FFF2-40B4-BE49-F238E27FC236}">
-                <a16:creationId xmlns:a16="http://schemas.microsoft.com/office/drawing/2014/main" id="{2045127A-4450-4054-8F0C-D563D581EE56}"/>
+                <a16:creationId xmlns:a16="http://schemas.microsoft.com/office/drawing/2014/main" id="{2D9E4BE9-1E60-41F6-9091-18404C6C5573}"/>
               </a:ext>
             </a:extLst>
           </p:cNvPr>
@@ -8775,7 +8775,7 @@
           <p:cNvPr id="20" name="">
             <a:extLst xmlns:a="http://schemas.openxmlformats.org/drawingml/2006/main">
               <a:ext uri="{FF2B5EF4-FFF2-40B4-BE49-F238E27FC236}">
-                <a16:creationId xmlns:a16="http://schemas.microsoft.com/office/drawing/2014/main" id="{BBC8F7CB-CA9E-4EDB-A914-4146C2CB43C6}"/>
+                <a16:creationId xmlns:a16="http://schemas.microsoft.com/office/drawing/2014/main" id="{A22C70AD-98BD-449F-9EEF-A99B562D2D31}"/>
               </a:ext>
             </a:extLst>
           </p:cNvPr>
@@ -8839,7 +8839,7 @@
           <p:cNvPr id="21" name="">
             <a:extLst xmlns:a="http://schemas.openxmlformats.org/drawingml/2006/main">
               <a:ext uri="{FF2B5EF4-FFF2-40B4-BE49-F238E27FC236}">
-                <a16:creationId xmlns:a16="http://schemas.microsoft.com/office/drawing/2014/main" id="{09A09BFE-5EDA-41E0-A653-79868824FC75}"/>
+                <a16:creationId xmlns:a16="http://schemas.microsoft.com/office/drawing/2014/main" id="{0061C3AB-B396-45D6-A848-086C2B9BD89C}"/>
               </a:ext>
             </a:extLst>
           </p:cNvPr>
@@ -8903,7 +8903,7 @@
           <p:cNvPr id="22" name="">
             <a:extLst xmlns:a="http://schemas.openxmlformats.org/drawingml/2006/main">
               <a:ext uri="{FF2B5EF4-FFF2-40B4-BE49-F238E27FC236}">
-                <a16:creationId xmlns:a16="http://schemas.microsoft.com/office/drawing/2014/main" id="{D2F97CA4-B07C-44F7-BBC1-FF6DEEDE8B81}"/>
+                <a16:creationId xmlns:a16="http://schemas.microsoft.com/office/drawing/2014/main" id="{43627D71-DFBE-4404-91D1-FFC5E4A1D7BA}"/>
               </a:ext>
             </a:extLst>
           </p:cNvPr>
@@ -8967,7 +8967,7 @@
           <p:cNvPr id="23" name="">
             <a:extLst xmlns:a="http://schemas.openxmlformats.org/drawingml/2006/main">
               <a:ext uri="{FF2B5EF4-FFF2-40B4-BE49-F238E27FC236}">
-                <a16:creationId xmlns:a16="http://schemas.microsoft.com/office/drawing/2014/main" id="{C3B628FD-B778-44C8-9DB4-55608D3BD48D}"/>
+                <a16:creationId xmlns:a16="http://schemas.microsoft.com/office/drawing/2014/main" id="{740B9EFD-66B4-45A2-8C38-DF1BA6FA2740}"/>
               </a:ext>
             </a:extLst>
           </p:cNvPr>
@@ -9000,7 +9000,7 @@
           <p:cNvPr id="24" name="">
             <a:extLst xmlns:a="http://schemas.openxmlformats.org/drawingml/2006/main">
               <a:ext uri="{FF2B5EF4-FFF2-40B4-BE49-F238E27FC236}">
-                <a16:creationId xmlns:a16="http://schemas.microsoft.com/office/drawing/2014/main" id="{F1B0231B-2AF8-44FF-A27A-FB9993BA8BA0}"/>
+                <a16:creationId xmlns:a16="http://schemas.microsoft.com/office/drawing/2014/main" id="{6CB911AA-122A-4129-93B4-D7CA52FDD4E0}"/>
               </a:ext>
             </a:extLst>
           </p:cNvPr>
@@ -9064,7 +9064,7 @@
           <p:cNvPr id="25" name="">
             <a:extLst xmlns:a="http://schemas.openxmlformats.org/drawingml/2006/main">
               <a:ext uri="{FF2B5EF4-FFF2-40B4-BE49-F238E27FC236}">
-                <a16:creationId xmlns:a16="http://schemas.microsoft.com/office/drawing/2014/main" id="{2CC6F490-5741-4F85-A696-9B91FC532B0F}"/>
+                <a16:creationId xmlns:a16="http://schemas.microsoft.com/office/drawing/2014/main" id="{2E6A90EE-A656-40A7-9651-31721A5D9BC6}"/>
               </a:ext>
             </a:extLst>
           </p:cNvPr>
@@ -9128,7 +9128,7 @@
           <p:cNvPr id="26" name="">
             <a:extLst xmlns:a="http://schemas.openxmlformats.org/drawingml/2006/main">
               <a:ext uri="{FF2B5EF4-FFF2-40B4-BE49-F238E27FC236}">
-                <a16:creationId xmlns:a16="http://schemas.microsoft.com/office/drawing/2014/main" id="{7C92AEB1-2D0E-42C8-ACB8-1237733CE6EE}"/>
+                <a16:creationId xmlns:a16="http://schemas.microsoft.com/office/drawing/2014/main" id="{A421260F-1615-4E97-ACE4-ECC96BDB92BA}"/>
               </a:ext>
             </a:extLst>
           </p:cNvPr>
@@ -9192,7 +9192,7 @@
           <p:cNvPr id="27" name="">
             <a:extLst xmlns:a="http://schemas.openxmlformats.org/drawingml/2006/main">
               <a:ext uri="{FF2B5EF4-FFF2-40B4-BE49-F238E27FC236}">
-                <a16:creationId xmlns:a16="http://schemas.microsoft.com/office/drawing/2014/main" id="{3C55C314-4E1D-481B-92B0-840CC99AD704}"/>
+                <a16:creationId xmlns:a16="http://schemas.microsoft.com/office/drawing/2014/main" id="{2CFC33A4-993F-4091-AF9A-C97EDE0E64EA}"/>
               </a:ext>
             </a:extLst>
           </p:cNvPr>
@@ -9254,7 +9254,7 @@
     </p:spTree>
     <p:extLst>
       <p:ext uri="{BB962C8B-B14F-4D97-AF65-F5344CB8AC3E}">
-        <p14:creationId xmlns:p14="http://schemas.microsoft.com/office/powerpoint/2010/main" val="482818159"/>
+        <p14:creationId xmlns:p14="http://schemas.microsoft.com/office/powerpoint/2010/main" val="1419229734"/>
       </p:ext>
     </p:extLst>
   </p:cSld>
@@ -9278,7 +9278,7 @@
           <p:cNvPr id="1" name="">
             <a:extLst xmlns:a="http://schemas.openxmlformats.org/drawingml/2006/main">
               <a:ext uri="{FF2B5EF4-FFF2-40B4-BE49-F238E27FC236}">
-                <a16:creationId xmlns:a16="http://schemas.microsoft.com/office/drawing/2014/main" id="{EA744B6E-9362-40BE-A064-910407B12C63}"/>
+                <a16:creationId xmlns:a16="http://schemas.microsoft.com/office/drawing/2014/main" id="{C9C8F08B-D1B5-4741-BF20-18E76EA062C7}"/>
               </a:ext>
             </a:extLst>
           </p:cNvPr>
@@ -9313,7 +9313,7 @@
           <p:cNvPr id="2" name="">
             <a:extLst xmlns:a="http://schemas.openxmlformats.org/drawingml/2006/main">
               <a:ext uri="{FF2B5EF4-FFF2-40B4-BE49-F238E27FC236}">
-                <a16:creationId xmlns:a16="http://schemas.microsoft.com/office/drawing/2014/main" id="{3881E75B-217C-4F11-9AAE-6201D846A013}"/>
+                <a16:creationId xmlns:a16="http://schemas.microsoft.com/office/drawing/2014/main" id="{6D3178DC-CD52-4C7C-808C-D6F6D40F8C12}"/>
               </a:ext>
             </a:extLst>
           </p:cNvPr>
@@ -9348,7 +9348,7 @@
           <p:cNvPr id="3" name="">
             <a:extLst xmlns:a="http://schemas.openxmlformats.org/drawingml/2006/main">
               <a:ext uri="{FF2B5EF4-FFF2-40B4-BE49-F238E27FC236}">
-                <a16:creationId xmlns:a16="http://schemas.microsoft.com/office/drawing/2014/main" id="{C70C2FA9-A4F9-4120-8BD6-09EAC80A1E30}"/>
+                <a16:creationId xmlns:a16="http://schemas.microsoft.com/office/drawing/2014/main" id="{B7881E6C-7AA9-4D54-BF9B-7FFCA2F136DA}"/>
               </a:ext>
             </a:extLst>
           </p:cNvPr>
@@ -9412,7 +9412,7 @@
           <p:cNvPr id="4" name="">
             <a:extLst xmlns:a="http://schemas.openxmlformats.org/drawingml/2006/main">
               <a:ext uri="{FF2B5EF4-FFF2-40B4-BE49-F238E27FC236}">
-                <a16:creationId xmlns:a16="http://schemas.microsoft.com/office/drawing/2014/main" id="{9E33910F-28A1-48DF-BB69-620FE1DE1641}"/>
+                <a16:creationId xmlns:a16="http://schemas.microsoft.com/office/drawing/2014/main" id="{939D4CCB-A8E9-43E0-85B9-81EFFB97F4C2}"/>
               </a:ext>
             </a:extLst>
           </p:cNvPr>
@@ -9476,7 +9476,7 @@
           <p:cNvPr id="5" name="">
             <a:extLst xmlns:a="http://schemas.openxmlformats.org/drawingml/2006/main">
               <a:ext uri="{FF2B5EF4-FFF2-40B4-BE49-F238E27FC236}">
-                <a16:creationId xmlns:a16="http://schemas.microsoft.com/office/drawing/2014/main" id="{C863DEA3-37AA-4BC3-BBA3-675C5D0CAC08}"/>
+                <a16:creationId xmlns:a16="http://schemas.microsoft.com/office/drawing/2014/main" id="{2AC87297-D512-4BCE-BD80-91F2DD63A0AD}"/>
               </a:ext>
             </a:extLst>
           </p:cNvPr>
@@ -9540,7 +9540,7 @@
           <p:cNvPr id="6" name="">
             <a:extLst xmlns:a="http://schemas.openxmlformats.org/drawingml/2006/main">
               <a:ext uri="{FF2B5EF4-FFF2-40B4-BE49-F238E27FC236}">
-                <a16:creationId xmlns:a16="http://schemas.microsoft.com/office/drawing/2014/main" id="{8D5326C4-4060-46FD-B5EF-6DAACEEA5F8D}"/>
+                <a16:creationId xmlns:a16="http://schemas.microsoft.com/office/drawing/2014/main" id="{6EC3EBB0-1DC2-4FDF-8B6C-51D54F244F42}"/>
               </a:ext>
             </a:extLst>
           </p:cNvPr>
@@ -9604,7 +9604,7 @@
           <p:cNvPr id="7" name="">
             <a:extLst xmlns:a="http://schemas.openxmlformats.org/drawingml/2006/main">
               <a:ext uri="{FF2B5EF4-FFF2-40B4-BE49-F238E27FC236}">
-                <a16:creationId xmlns:a16="http://schemas.microsoft.com/office/drawing/2014/main" id="{14C499E5-8A84-49B0-BE86-55DEA043EC0B}"/>
+                <a16:creationId xmlns:a16="http://schemas.microsoft.com/office/drawing/2014/main" id="{816995C4-F490-48D3-B454-92F34EF45220}"/>
               </a:ext>
             </a:extLst>
           </p:cNvPr>
@@ -9637,7 +9637,7 @@
           <p:cNvPr id="8" name="">
             <a:extLst xmlns:a="http://schemas.openxmlformats.org/drawingml/2006/main">
               <a:ext uri="{FF2B5EF4-FFF2-40B4-BE49-F238E27FC236}">
-                <a16:creationId xmlns:a16="http://schemas.microsoft.com/office/drawing/2014/main" id="{84D8A799-E08A-40EA-91EE-4B24C37B030D}"/>
+                <a16:creationId xmlns:a16="http://schemas.microsoft.com/office/drawing/2014/main" id="{A8B20B8E-1EBB-48B6-B502-6CD5CB0605EB}"/>
               </a:ext>
             </a:extLst>
           </p:cNvPr>
@@ -9701,7 +9701,7 @@
           <p:cNvPr id="9" name="">
             <a:extLst xmlns:a="http://schemas.openxmlformats.org/drawingml/2006/main">
               <a:ext uri="{FF2B5EF4-FFF2-40B4-BE49-F238E27FC236}">
-                <a16:creationId xmlns:a16="http://schemas.microsoft.com/office/drawing/2014/main" id="{D27D7D0C-1B30-46E9-9F61-EC1DA9ADBECD}"/>
+                <a16:creationId xmlns:a16="http://schemas.microsoft.com/office/drawing/2014/main" id="{D17D9D4D-838B-448D-95D4-012D46ACF8B9}"/>
               </a:ext>
             </a:extLst>
           </p:cNvPr>
@@ -9765,7 +9765,7 @@
           <p:cNvPr id="10" name="">
             <a:extLst xmlns:a="http://schemas.openxmlformats.org/drawingml/2006/main">
               <a:ext uri="{FF2B5EF4-FFF2-40B4-BE49-F238E27FC236}">
-                <a16:creationId xmlns:a16="http://schemas.microsoft.com/office/drawing/2014/main" id="{E9671535-48BF-4B0F-825D-5F4176DC84D1}"/>
+                <a16:creationId xmlns:a16="http://schemas.microsoft.com/office/drawing/2014/main" id="{03A050FB-5481-4289-BB84-201214888F77}"/>
               </a:ext>
             </a:extLst>
           </p:cNvPr>
@@ -9798,7 +9798,7 @@
           <p:cNvPr id="11" name="">
             <a:extLst xmlns:a="http://schemas.openxmlformats.org/drawingml/2006/main">
               <a:ext uri="{FF2B5EF4-FFF2-40B4-BE49-F238E27FC236}">
-                <a16:creationId xmlns:a16="http://schemas.microsoft.com/office/drawing/2014/main" id="{EB6B4101-37B3-4DAF-A051-DA0C66C17566}"/>
+                <a16:creationId xmlns:a16="http://schemas.microsoft.com/office/drawing/2014/main" id="{17B8F864-D0E9-4DE5-9258-1124C4A7A173}"/>
               </a:ext>
             </a:extLst>
           </p:cNvPr>
@@ -9862,7 +9862,7 @@
           <p:cNvPr id="12" name="">
             <a:extLst xmlns:a="http://schemas.openxmlformats.org/drawingml/2006/main">
               <a:ext uri="{FF2B5EF4-FFF2-40B4-BE49-F238E27FC236}">
-                <a16:creationId xmlns:a16="http://schemas.microsoft.com/office/drawing/2014/main" id="{004700DD-3F00-47C3-A350-8C1F0340D6DC}"/>
+                <a16:creationId xmlns:a16="http://schemas.microsoft.com/office/drawing/2014/main" id="{400C46EC-6060-4F2C-857C-9887C8AF3C47}"/>
               </a:ext>
             </a:extLst>
           </p:cNvPr>
@@ -9926,7 +9926,7 @@
           <p:cNvPr id="13" name="">
             <a:extLst xmlns:a="http://schemas.openxmlformats.org/drawingml/2006/main">
               <a:ext uri="{FF2B5EF4-FFF2-40B4-BE49-F238E27FC236}">
-                <a16:creationId xmlns:a16="http://schemas.microsoft.com/office/drawing/2014/main" id="{1B99BD07-FD11-4A98-8D09-60B4EFC73277}"/>
+                <a16:creationId xmlns:a16="http://schemas.microsoft.com/office/drawing/2014/main" id="{DE2E15E3-1C34-4285-B1F6-9071B303FD88}"/>
               </a:ext>
             </a:extLst>
           </p:cNvPr>
@@ -9959,7 +9959,7 @@
           <p:cNvPr id="14" name="">
             <a:extLst xmlns:a="http://schemas.openxmlformats.org/drawingml/2006/main">
               <a:ext uri="{FF2B5EF4-FFF2-40B4-BE49-F238E27FC236}">
-                <a16:creationId xmlns:a16="http://schemas.microsoft.com/office/drawing/2014/main" id="{9382A52E-F12F-4EC2-B508-48D8145C0871}"/>
+                <a16:creationId xmlns:a16="http://schemas.microsoft.com/office/drawing/2014/main" id="{F9C9C5F3-B81C-44A5-8BC7-4D3A21991C77}"/>
               </a:ext>
             </a:extLst>
           </p:cNvPr>
@@ -10023,7 +10023,7 @@
           <p:cNvPr id="15" name="">
             <a:extLst xmlns:a="http://schemas.openxmlformats.org/drawingml/2006/main">
               <a:ext uri="{FF2B5EF4-FFF2-40B4-BE49-F238E27FC236}">
-                <a16:creationId xmlns:a16="http://schemas.microsoft.com/office/drawing/2014/main" id="{883C4CBE-9010-4B23-8927-531479F66E7D}"/>
+                <a16:creationId xmlns:a16="http://schemas.microsoft.com/office/drawing/2014/main" id="{8F19967D-2752-41BD-B179-AB65936B3E17}"/>
               </a:ext>
             </a:extLst>
           </p:cNvPr>
@@ -10087,7 +10087,7 @@
           <p:cNvPr id="16" name="">
             <a:extLst xmlns:a="http://schemas.openxmlformats.org/drawingml/2006/main">
               <a:ext uri="{FF2B5EF4-FFF2-40B4-BE49-F238E27FC236}">
-                <a16:creationId xmlns:a16="http://schemas.microsoft.com/office/drawing/2014/main" id="{1C189A6C-3FF3-49E2-8336-0F41D060BD09}"/>
+                <a16:creationId xmlns:a16="http://schemas.microsoft.com/office/drawing/2014/main" id="{39A61BA1-F98A-4492-B16B-4EC36641E2D4}"/>
               </a:ext>
             </a:extLst>
           </p:cNvPr>
@@ -10151,7 +10151,7 @@
           <p:cNvPr id="17" name="">
             <a:extLst xmlns:a="http://schemas.openxmlformats.org/drawingml/2006/main">
               <a:ext uri="{FF2B5EF4-FFF2-40B4-BE49-F238E27FC236}">
-                <a16:creationId xmlns:a16="http://schemas.microsoft.com/office/drawing/2014/main" id="{9684AB02-0B0C-4602-B7ED-B922E1CD1CB2}"/>
+                <a16:creationId xmlns:a16="http://schemas.microsoft.com/office/drawing/2014/main" id="{DD0F86E0-39DB-4B0B-92B1-137C34E4D472}"/>
               </a:ext>
             </a:extLst>
           </p:cNvPr>
@@ -10213,7 +10213,7 @@
     </p:spTree>
     <p:extLst>
       <p:ext uri="{BB962C8B-B14F-4D97-AF65-F5344CB8AC3E}">
-        <p14:creationId xmlns:p14="http://schemas.microsoft.com/office/powerpoint/2010/main" val="195917996"/>
+        <p14:creationId xmlns:p14="http://schemas.microsoft.com/office/powerpoint/2010/main" val="300073077"/>
       </p:ext>
     </p:extLst>
   </p:cSld>
@@ -10237,7 +10237,7 @@
           <p:cNvPr id="1" name="">
             <a:extLst xmlns:a="http://schemas.openxmlformats.org/drawingml/2006/main">
               <a:ext uri="{FF2B5EF4-FFF2-40B4-BE49-F238E27FC236}">
-                <a16:creationId xmlns:a16="http://schemas.microsoft.com/office/drawing/2014/main" id="{755C4EDB-9714-4A89-9F2D-BEC35D3C3543}"/>
+                <a16:creationId xmlns:a16="http://schemas.microsoft.com/office/drawing/2014/main" id="{CDDE13C3-E7A0-46DD-8A63-EA0EEB2A95A4}"/>
               </a:ext>
             </a:extLst>
           </p:cNvPr>
@@ -10272,7 +10272,7 @@
           <p:cNvPr id="2" name="">
             <a:extLst xmlns:a="http://schemas.openxmlformats.org/drawingml/2006/main">
               <a:ext uri="{FF2B5EF4-FFF2-40B4-BE49-F238E27FC236}">
-                <a16:creationId xmlns:a16="http://schemas.microsoft.com/office/drawing/2014/main" id="{DB370297-B29F-4BF7-950A-5A310ECB0C0D}"/>
+                <a16:creationId xmlns:a16="http://schemas.microsoft.com/office/drawing/2014/main" id="{08A08557-8CA2-4BD6-8B2B-42AF09CCD322}"/>
               </a:ext>
             </a:extLst>
           </p:cNvPr>
@@ -10307,7 +10307,7 @@
           <p:cNvPr id="3" name="">
             <a:extLst xmlns:a="http://schemas.openxmlformats.org/drawingml/2006/main">
               <a:ext uri="{FF2B5EF4-FFF2-40B4-BE49-F238E27FC236}">
-                <a16:creationId xmlns:a16="http://schemas.microsoft.com/office/drawing/2014/main" id="{D54F0A9F-F964-4BB7-A6F1-8FA38487D649}"/>
+                <a16:creationId xmlns:a16="http://schemas.microsoft.com/office/drawing/2014/main" id="{E85A6108-F672-4525-B8A4-10067D616EE5}"/>
               </a:ext>
             </a:extLst>
           </p:cNvPr>
@@ -10371,7 +10371,7 @@
           <p:cNvPr id="4" name="">
             <a:extLst xmlns:a="http://schemas.openxmlformats.org/drawingml/2006/main">
               <a:ext uri="{FF2B5EF4-FFF2-40B4-BE49-F238E27FC236}">
-                <a16:creationId xmlns:a16="http://schemas.microsoft.com/office/drawing/2014/main" id="{914484C0-528C-4F57-8259-FA910EB8875E}"/>
+                <a16:creationId xmlns:a16="http://schemas.microsoft.com/office/drawing/2014/main" id="{2BD9CC9E-27A1-4D4A-8AB8-FC8D3969BB0B}"/>
               </a:ext>
             </a:extLst>
           </p:cNvPr>
@@ -10435,7 +10435,7 @@
           <p:cNvPr id="5" name="">
             <a:extLst xmlns:a="http://schemas.openxmlformats.org/drawingml/2006/main">
               <a:ext uri="{FF2B5EF4-FFF2-40B4-BE49-F238E27FC236}">
-                <a16:creationId xmlns:a16="http://schemas.microsoft.com/office/drawing/2014/main" id="{97B380CA-BD3D-46B4-9693-B5ADF7F5F516}"/>
+                <a16:creationId xmlns:a16="http://schemas.microsoft.com/office/drawing/2014/main" id="{4FC97D41-981A-431D-AD3F-2266E5670C7C}"/>
               </a:ext>
             </a:extLst>
           </p:cNvPr>
@@ -10499,7 +10499,7 @@
           <p:cNvPr id="6" name="">
             <a:extLst xmlns:a="http://schemas.openxmlformats.org/drawingml/2006/main">
               <a:ext uri="{FF2B5EF4-FFF2-40B4-BE49-F238E27FC236}">
-                <a16:creationId xmlns:a16="http://schemas.microsoft.com/office/drawing/2014/main" id="{30F2BA4E-3F3B-40F7-8C04-01F44DF048E7}"/>
+                <a16:creationId xmlns:a16="http://schemas.microsoft.com/office/drawing/2014/main" id="{26D2D3AB-7392-4C5D-9FC4-81FD078BDDB6}"/>
               </a:ext>
             </a:extLst>
           </p:cNvPr>
@@ -10563,7 +10563,7 @@
           <p:cNvPr id="7" name="">
             <a:extLst xmlns:a="http://schemas.openxmlformats.org/drawingml/2006/main">
               <a:ext uri="{FF2B5EF4-FFF2-40B4-BE49-F238E27FC236}">
-                <a16:creationId xmlns:a16="http://schemas.microsoft.com/office/drawing/2014/main" id="{1F53FE6B-948B-42D4-B491-F0DEB1D225D8}"/>
+                <a16:creationId xmlns:a16="http://schemas.microsoft.com/office/drawing/2014/main" id="{B26BB2E5-A94C-4619-9657-91550CF6A6A9}"/>
               </a:ext>
             </a:extLst>
           </p:cNvPr>
@@ -10596,7 +10596,7 @@
           <p:cNvPr id="8" name="">
             <a:extLst xmlns:a="http://schemas.openxmlformats.org/drawingml/2006/main">
               <a:ext uri="{FF2B5EF4-FFF2-40B4-BE49-F238E27FC236}">
-                <a16:creationId xmlns:a16="http://schemas.microsoft.com/office/drawing/2014/main" id="{1333FAAD-0BD8-41EE-ABEC-D2A6A2977CF0}"/>
+                <a16:creationId xmlns:a16="http://schemas.microsoft.com/office/drawing/2014/main" id="{44F177E3-5567-4416-AB60-2592FF9B8F80}"/>
               </a:ext>
             </a:extLst>
           </p:cNvPr>
@@ -10660,7 +10660,7 @@
           <p:cNvPr id="9" name="">
             <a:extLst xmlns:a="http://schemas.openxmlformats.org/drawingml/2006/main">
               <a:ext uri="{FF2B5EF4-FFF2-40B4-BE49-F238E27FC236}">
-                <a16:creationId xmlns:a16="http://schemas.microsoft.com/office/drawing/2014/main" id="{760C11E5-10A7-4BAB-8029-C3388431D6FC}"/>
+                <a16:creationId xmlns:a16="http://schemas.microsoft.com/office/drawing/2014/main" id="{6FC2818F-74BB-41A0-BEB3-826188E45279}"/>
               </a:ext>
             </a:extLst>
           </p:cNvPr>
@@ -10724,7 +10724,7 @@
           <p:cNvPr id="10" name="">
             <a:extLst xmlns:a="http://schemas.openxmlformats.org/drawingml/2006/main">
               <a:ext uri="{FF2B5EF4-FFF2-40B4-BE49-F238E27FC236}">
-                <a16:creationId xmlns:a16="http://schemas.microsoft.com/office/drawing/2014/main" id="{EB060C9C-7C66-4054-A19B-FEFDDCD83894}"/>
+                <a16:creationId xmlns:a16="http://schemas.microsoft.com/office/drawing/2014/main" id="{B7DCB3E6-8AFE-4B35-866A-B45A155F1F33}"/>
               </a:ext>
             </a:extLst>
           </p:cNvPr>
@@ -10788,7 +10788,7 @@
           <p:cNvPr id="11" name="">
             <a:extLst xmlns:a="http://schemas.openxmlformats.org/drawingml/2006/main">
               <a:ext uri="{FF2B5EF4-FFF2-40B4-BE49-F238E27FC236}">
-                <a16:creationId xmlns:a16="http://schemas.microsoft.com/office/drawing/2014/main" id="{638216F9-57EA-4414-A70D-C003D0718896}"/>
+                <a16:creationId xmlns:a16="http://schemas.microsoft.com/office/drawing/2014/main" id="{44413A7A-753E-4BDE-BD5F-FD5A50908CA9}"/>
               </a:ext>
             </a:extLst>
           </p:cNvPr>
@@ -10821,7 +10821,7 @@
           <p:cNvPr id="12" name="">
             <a:extLst xmlns:a="http://schemas.openxmlformats.org/drawingml/2006/main">
               <a:ext uri="{FF2B5EF4-FFF2-40B4-BE49-F238E27FC236}">
-                <a16:creationId xmlns:a16="http://schemas.microsoft.com/office/drawing/2014/main" id="{407026F0-2A17-44E5-B764-EBCD2C598EF8}"/>
+                <a16:creationId xmlns:a16="http://schemas.microsoft.com/office/drawing/2014/main" id="{1CB9F0BA-3365-4EC3-8BFD-09A124E76140}"/>
               </a:ext>
             </a:extLst>
           </p:cNvPr>
@@ -10885,7 +10885,7 @@
           <p:cNvPr id="13" name="">
             <a:extLst xmlns:a="http://schemas.openxmlformats.org/drawingml/2006/main">
               <a:ext uri="{FF2B5EF4-FFF2-40B4-BE49-F238E27FC236}">
-                <a16:creationId xmlns:a16="http://schemas.microsoft.com/office/drawing/2014/main" id="{7429254F-68A2-4D81-81EC-F56777A31F90}"/>
+                <a16:creationId xmlns:a16="http://schemas.microsoft.com/office/drawing/2014/main" id="{5C5C99F2-03FB-42E0-ADD5-EE0AE789A940}"/>
               </a:ext>
             </a:extLst>
           </p:cNvPr>
@@ -10949,7 +10949,7 @@
           <p:cNvPr id="14" name="">
             <a:extLst xmlns:a="http://schemas.openxmlformats.org/drawingml/2006/main">
               <a:ext uri="{FF2B5EF4-FFF2-40B4-BE49-F238E27FC236}">
-                <a16:creationId xmlns:a16="http://schemas.microsoft.com/office/drawing/2014/main" id="{94308913-D74F-4616-B2E8-6ED32406EC26}"/>
+                <a16:creationId xmlns:a16="http://schemas.microsoft.com/office/drawing/2014/main" id="{2F79C328-81E9-454C-B80F-8AE847A31146}"/>
               </a:ext>
             </a:extLst>
           </p:cNvPr>
@@ -11013,7 +11013,7 @@
           <p:cNvPr id="15" name="">
             <a:extLst xmlns:a="http://schemas.openxmlformats.org/drawingml/2006/main">
               <a:ext uri="{FF2B5EF4-FFF2-40B4-BE49-F238E27FC236}">
-                <a16:creationId xmlns:a16="http://schemas.microsoft.com/office/drawing/2014/main" id="{536057C2-2B8C-4F32-BB74-AD2EAB0D83F9}"/>
+                <a16:creationId xmlns:a16="http://schemas.microsoft.com/office/drawing/2014/main" id="{0D55853F-C249-4EC1-BFEB-5FBFBC0FE19A}"/>
               </a:ext>
             </a:extLst>
           </p:cNvPr>
@@ -11046,7 +11046,7 @@
           <p:cNvPr id="16" name="">
             <a:extLst xmlns:a="http://schemas.openxmlformats.org/drawingml/2006/main">
               <a:ext uri="{FF2B5EF4-FFF2-40B4-BE49-F238E27FC236}">
-                <a16:creationId xmlns:a16="http://schemas.microsoft.com/office/drawing/2014/main" id="{29641F51-C013-46C9-BF38-0F7E6C96FD92}"/>
+                <a16:creationId xmlns:a16="http://schemas.microsoft.com/office/drawing/2014/main" id="{604BE56B-7B27-4F6C-B4A3-E727839D720D}"/>
               </a:ext>
             </a:extLst>
           </p:cNvPr>
@@ -11110,7 +11110,7 @@
           <p:cNvPr id="17" name="">
             <a:extLst xmlns:a="http://schemas.openxmlformats.org/drawingml/2006/main">
               <a:ext uri="{FF2B5EF4-FFF2-40B4-BE49-F238E27FC236}">
-                <a16:creationId xmlns:a16="http://schemas.microsoft.com/office/drawing/2014/main" id="{97CE3513-6FD2-4E87-9CC8-9360DF42EC54}"/>
+                <a16:creationId xmlns:a16="http://schemas.microsoft.com/office/drawing/2014/main" id="{AFF17C80-F39C-4655-8EF4-9319E4AD3503}"/>
               </a:ext>
             </a:extLst>
           </p:cNvPr>
@@ -11174,7 +11174,7 @@
           <p:cNvPr id="18" name="">
             <a:extLst xmlns:a="http://schemas.openxmlformats.org/drawingml/2006/main">
               <a:ext uri="{FF2B5EF4-FFF2-40B4-BE49-F238E27FC236}">
-                <a16:creationId xmlns:a16="http://schemas.microsoft.com/office/drawing/2014/main" id="{0ADDCD0A-9C31-4528-AA64-443A38C381E4}"/>
+                <a16:creationId xmlns:a16="http://schemas.microsoft.com/office/drawing/2014/main" id="{7E369C73-EEEA-4A2E-8FC3-110D0E323407}"/>
               </a:ext>
             </a:extLst>
           </p:cNvPr>
@@ -11207,7 +11207,7 @@
           <p:cNvPr id="19" name="">
             <a:extLst xmlns:a="http://schemas.openxmlformats.org/drawingml/2006/main">
               <a:ext uri="{FF2B5EF4-FFF2-40B4-BE49-F238E27FC236}">
-                <a16:creationId xmlns:a16="http://schemas.microsoft.com/office/drawing/2014/main" id="{D93E6615-C02E-40BC-9A4C-3515088890C7}"/>
+                <a16:creationId xmlns:a16="http://schemas.microsoft.com/office/drawing/2014/main" id="{EA1673E7-DD8B-4B56-ABF5-4D7519CB63E1}"/>
               </a:ext>
             </a:extLst>
           </p:cNvPr>
@@ -11271,7 +11271,7 @@
           <p:cNvPr id="20" name="">
             <a:extLst xmlns:a="http://schemas.openxmlformats.org/drawingml/2006/main">
               <a:ext uri="{FF2B5EF4-FFF2-40B4-BE49-F238E27FC236}">
-                <a16:creationId xmlns:a16="http://schemas.microsoft.com/office/drawing/2014/main" id="{6EB98470-97FC-4D5C-B5C5-180D2CD9B524}"/>
+                <a16:creationId xmlns:a16="http://schemas.microsoft.com/office/drawing/2014/main" id="{E25ECF3F-30DC-4090-A568-A41DC9F7F958}"/>
               </a:ext>
             </a:extLst>
           </p:cNvPr>
@@ -11335,7 +11335,7 @@
           <p:cNvPr id="21" name="">
             <a:extLst xmlns:a="http://schemas.openxmlformats.org/drawingml/2006/main">
               <a:ext uri="{FF2B5EF4-FFF2-40B4-BE49-F238E27FC236}">
-                <a16:creationId xmlns:a16="http://schemas.microsoft.com/office/drawing/2014/main" id="{E54B728C-7204-490D-BCE0-E7CBFA694B04}"/>
+                <a16:creationId xmlns:a16="http://schemas.microsoft.com/office/drawing/2014/main" id="{7AA9352F-47D0-4813-9D9B-850F58C85D1D}"/>
               </a:ext>
             </a:extLst>
           </p:cNvPr>
@@ -11368,7 +11368,7 @@
           <p:cNvPr id="22" name="">
             <a:extLst xmlns:a="http://schemas.openxmlformats.org/drawingml/2006/main">
               <a:ext uri="{FF2B5EF4-FFF2-40B4-BE49-F238E27FC236}">
-                <a16:creationId xmlns:a16="http://schemas.microsoft.com/office/drawing/2014/main" id="{0E01740F-3957-4FD9-B234-F8826BFF6279}"/>
+                <a16:creationId xmlns:a16="http://schemas.microsoft.com/office/drawing/2014/main" id="{BCE1A745-FE09-4B18-AA3A-8DA914680AC8}"/>
               </a:ext>
             </a:extLst>
           </p:cNvPr>
@@ -11432,7 +11432,7 @@
           <p:cNvPr id="23" name="">
             <a:extLst xmlns:a="http://schemas.openxmlformats.org/drawingml/2006/main">
               <a:ext uri="{FF2B5EF4-FFF2-40B4-BE49-F238E27FC236}">
-                <a16:creationId xmlns:a16="http://schemas.microsoft.com/office/drawing/2014/main" id="{0C4BC3CF-8D99-4139-9472-053497ADC588}"/>
+                <a16:creationId xmlns:a16="http://schemas.microsoft.com/office/drawing/2014/main" id="{A856E6AC-FE34-46A3-AA4A-70608FA3AF23}"/>
               </a:ext>
             </a:extLst>
           </p:cNvPr>
@@ -11496,7 +11496,7 @@
           <p:cNvPr id="24" name="">
             <a:extLst xmlns:a="http://schemas.openxmlformats.org/drawingml/2006/main">
               <a:ext uri="{FF2B5EF4-FFF2-40B4-BE49-F238E27FC236}">
-                <a16:creationId xmlns:a16="http://schemas.microsoft.com/office/drawing/2014/main" id="{B9986920-10E1-4A1E-B310-864045807CBC}"/>
+                <a16:creationId xmlns:a16="http://schemas.microsoft.com/office/drawing/2014/main" id="{E7052181-5099-44DA-92B8-3AFD046EDE67}"/>
               </a:ext>
             </a:extLst>
           </p:cNvPr>
@@ -11560,7 +11560,7 @@
           <p:cNvPr id="25" name="">
             <a:extLst xmlns:a="http://schemas.openxmlformats.org/drawingml/2006/main">
               <a:ext uri="{FF2B5EF4-FFF2-40B4-BE49-F238E27FC236}">
-                <a16:creationId xmlns:a16="http://schemas.microsoft.com/office/drawing/2014/main" id="{E5E7170F-3D6F-42BF-ABF0-4D8FC054134C}"/>
+                <a16:creationId xmlns:a16="http://schemas.microsoft.com/office/drawing/2014/main" id="{A9731041-9279-450C-BD57-0163D269BE5E}"/>
               </a:ext>
             </a:extLst>
           </p:cNvPr>
@@ -11622,7 +11622,7 @@
     </p:spTree>
     <p:extLst>
       <p:ext uri="{BB962C8B-B14F-4D97-AF65-F5344CB8AC3E}">
-        <p14:creationId xmlns:p14="http://schemas.microsoft.com/office/powerpoint/2010/main" val="894989379"/>
+        <p14:creationId xmlns:p14="http://schemas.microsoft.com/office/powerpoint/2010/main" val="2039218808"/>
       </p:ext>
     </p:extLst>
   </p:cSld>
@@ -11646,7 +11646,7 @@
           <p:cNvPr id="1" name="">
             <a:extLst xmlns:a="http://schemas.openxmlformats.org/drawingml/2006/main">
               <a:ext uri="{FF2B5EF4-FFF2-40B4-BE49-F238E27FC236}">
-                <a16:creationId xmlns:a16="http://schemas.microsoft.com/office/drawing/2014/main" id="{F5AB9C48-3707-4ABA-91D0-928563A1AA84}"/>
+                <a16:creationId xmlns:a16="http://schemas.microsoft.com/office/drawing/2014/main" id="{F0878EF8-AA62-45CC-A567-0BF2B3E39642}"/>
               </a:ext>
             </a:extLst>
           </p:cNvPr>
@@ -11681,7 +11681,7 @@
           <p:cNvPr id="2" name="">
             <a:extLst xmlns:a="http://schemas.openxmlformats.org/drawingml/2006/main">
               <a:ext uri="{FF2B5EF4-FFF2-40B4-BE49-F238E27FC236}">
-                <a16:creationId xmlns:a16="http://schemas.microsoft.com/office/drawing/2014/main" id="{FF3CFDEE-6721-475D-9B21-DEB927C66EAC}"/>
+                <a16:creationId xmlns:a16="http://schemas.microsoft.com/office/drawing/2014/main" id="{B5C46E19-393C-4396-BD4A-BC0A23EFF78A}"/>
               </a:ext>
             </a:extLst>
           </p:cNvPr>
@@ -11716,7 +11716,7 @@
           <p:cNvPr id="3" name="">
             <a:extLst xmlns:a="http://schemas.openxmlformats.org/drawingml/2006/main">
               <a:ext uri="{FF2B5EF4-FFF2-40B4-BE49-F238E27FC236}">
-                <a16:creationId xmlns:a16="http://schemas.microsoft.com/office/drawing/2014/main" id="{5A216F91-30FF-48FB-BCB8-0C9E0326860B}"/>
+                <a16:creationId xmlns:a16="http://schemas.microsoft.com/office/drawing/2014/main" id="{D0F546B3-1E6B-4F09-AA81-AA5ABB7F6480}"/>
               </a:ext>
             </a:extLst>
           </p:cNvPr>
@@ -11780,7 +11780,7 @@
           <p:cNvPr id="4" name="">
             <a:extLst xmlns:a="http://schemas.openxmlformats.org/drawingml/2006/main">
               <a:ext uri="{FF2B5EF4-FFF2-40B4-BE49-F238E27FC236}">
-                <a16:creationId xmlns:a16="http://schemas.microsoft.com/office/drawing/2014/main" id="{BE2E5382-E92B-4ACF-B588-7D3CEAF6CFCB}"/>
+                <a16:creationId xmlns:a16="http://schemas.microsoft.com/office/drawing/2014/main" id="{3AB0886F-C976-4715-A51A-C4A18972123A}"/>
               </a:ext>
             </a:extLst>
           </p:cNvPr>
@@ -11844,7 +11844,7 @@
           <p:cNvPr id="5" name="">
             <a:extLst xmlns:a="http://schemas.openxmlformats.org/drawingml/2006/main">
               <a:ext uri="{FF2B5EF4-FFF2-40B4-BE49-F238E27FC236}">
-                <a16:creationId xmlns:a16="http://schemas.microsoft.com/office/drawing/2014/main" id="{56556A74-50E9-47CC-89B6-790594C3431E}"/>
+                <a16:creationId xmlns:a16="http://schemas.microsoft.com/office/drawing/2014/main" id="{2C2963A9-61DD-4F86-B3D9-62EFCBC750E5}"/>
               </a:ext>
             </a:extLst>
           </p:cNvPr>
@@ -11908,7 +11908,7 @@
           <p:cNvPr id="6" name="">
             <a:extLst xmlns:a="http://schemas.openxmlformats.org/drawingml/2006/main">
               <a:ext uri="{FF2B5EF4-FFF2-40B4-BE49-F238E27FC236}">
-                <a16:creationId xmlns:a16="http://schemas.microsoft.com/office/drawing/2014/main" id="{3A7B6E0A-66A3-4C41-A87D-9345D320D843}"/>
+                <a16:creationId xmlns:a16="http://schemas.microsoft.com/office/drawing/2014/main" id="{27578331-7E2A-4EA3-B62B-29BBDA5B55F0}"/>
               </a:ext>
             </a:extLst>
           </p:cNvPr>
@@ -11972,7 +11972,7 @@
           <p:cNvPr id="7" name="">
             <a:extLst xmlns:a="http://schemas.openxmlformats.org/drawingml/2006/main">
               <a:ext uri="{FF2B5EF4-FFF2-40B4-BE49-F238E27FC236}">
-                <a16:creationId xmlns:a16="http://schemas.microsoft.com/office/drawing/2014/main" id="{BC8116F3-0C38-41B3-BA11-C4294171ADF2}"/>
+                <a16:creationId xmlns:a16="http://schemas.microsoft.com/office/drawing/2014/main" id="{986246AF-B26A-4517-9F2D-DA9F6C47D7CF}"/>
               </a:ext>
             </a:extLst>
           </p:cNvPr>
@@ -12005,7 +12005,7 @@
           <p:cNvPr id="8" name="">
             <a:extLst xmlns:a="http://schemas.openxmlformats.org/drawingml/2006/main">
               <a:ext uri="{FF2B5EF4-FFF2-40B4-BE49-F238E27FC236}">
-                <a16:creationId xmlns:a16="http://schemas.microsoft.com/office/drawing/2014/main" id="{30C9D99B-A16E-49FB-85FF-E8A6D4621BF2}"/>
+                <a16:creationId xmlns:a16="http://schemas.microsoft.com/office/drawing/2014/main" id="{AF4CBB4D-9781-47DF-BDD9-17D080CFE2E6}"/>
               </a:ext>
             </a:extLst>
           </p:cNvPr>
@@ -12069,7 +12069,7 @@
           <p:cNvPr id="9" name="">
             <a:extLst xmlns:a="http://schemas.openxmlformats.org/drawingml/2006/main">
               <a:ext uri="{FF2B5EF4-FFF2-40B4-BE49-F238E27FC236}">
-                <a16:creationId xmlns:a16="http://schemas.microsoft.com/office/drawing/2014/main" id="{7B581F83-3718-44D7-BD16-BC4B9AC22F58}"/>
+                <a16:creationId xmlns:a16="http://schemas.microsoft.com/office/drawing/2014/main" id="{EEA0322A-27F6-4DD0-AB15-38443FE67B70}"/>
               </a:ext>
             </a:extLst>
           </p:cNvPr>
@@ -12133,7 +12133,7 @@
           <p:cNvPr id="10" name="">
             <a:extLst xmlns:a="http://schemas.openxmlformats.org/drawingml/2006/main">
               <a:ext uri="{FF2B5EF4-FFF2-40B4-BE49-F238E27FC236}">
-                <a16:creationId xmlns:a16="http://schemas.microsoft.com/office/drawing/2014/main" id="{00CB59BF-E26F-4576-8CC5-342A22C5BE07}"/>
+                <a16:creationId xmlns:a16="http://schemas.microsoft.com/office/drawing/2014/main" id="{183FD1C0-5D1E-4502-AF2A-7D80DA6E3238}"/>
               </a:ext>
             </a:extLst>
           </p:cNvPr>
@@ -12166,7 +12166,7 @@
           <p:cNvPr id="11" name="">
             <a:extLst xmlns:a="http://schemas.openxmlformats.org/drawingml/2006/main">
               <a:ext uri="{FF2B5EF4-FFF2-40B4-BE49-F238E27FC236}">
-                <a16:creationId xmlns:a16="http://schemas.microsoft.com/office/drawing/2014/main" id="{FA16A7A0-5CBB-4604-A76B-F6B9971CA29D}"/>
+                <a16:creationId xmlns:a16="http://schemas.microsoft.com/office/drawing/2014/main" id="{98784A18-68C1-40F8-80DE-52493F4CE597}"/>
               </a:ext>
             </a:extLst>
           </p:cNvPr>
@@ -12230,7 +12230,7 @@
           <p:cNvPr id="12" name="">
             <a:extLst xmlns:a="http://schemas.openxmlformats.org/drawingml/2006/main">
               <a:ext uri="{FF2B5EF4-FFF2-40B4-BE49-F238E27FC236}">
-                <a16:creationId xmlns:a16="http://schemas.microsoft.com/office/drawing/2014/main" id="{3D67D7DA-EDDC-4128-97F1-6C8A7250CBF1}"/>
+                <a16:creationId xmlns:a16="http://schemas.microsoft.com/office/drawing/2014/main" id="{F4EE9B89-D297-4585-AB84-DDF56B751048}"/>
               </a:ext>
             </a:extLst>
           </p:cNvPr>
@@ -12294,7 +12294,7 @@
           <p:cNvPr id="13" name="">
             <a:extLst xmlns:a="http://schemas.openxmlformats.org/drawingml/2006/main">
               <a:ext uri="{FF2B5EF4-FFF2-40B4-BE49-F238E27FC236}">
-                <a16:creationId xmlns:a16="http://schemas.microsoft.com/office/drawing/2014/main" id="{14990FAE-25B3-48CA-8C2E-5837FCA1B264}"/>
+                <a16:creationId xmlns:a16="http://schemas.microsoft.com/office/drawing/2014/main" id="{912C3C09-16E4-4E48-A729-EDDCEE5A1D64}"/>
               </a:ext>
             </a:extLst>
           </p:cNvPr>
@@ -12327,7 +12327,7 @@
           <p:cNvPr id="14" name="">
             <a:extLst xmlns:a="http://schemas.openxmlformats.org/drawingml/2006/main">
               <a:ext uri="{FF2B5EF4-FFF2-40B4-BE49-F238E27FC236}">
-                <a16:creationId xmlns:a16="http://schemas.microsoft.com/office/drawing/2014/main" id="{5ED000CE-4E56-4CFA-974D-244120448596}"/>
+                <a16:creationId xmlns:a16="http://schemas.microsoft.com/office/drawing/2014/main" id="{09B6CC81-3EA7-49A4-A7EA-F5E2BF55399D}"/>
               </a:ext>
             </a:extLst>
           </p:cNvPr>
@@ -12391,7 +12391,7 @@
           <p:cNvPr id="15" name="">
             <a:extLst xmlns:a="http://schemas.openxmlformats.org/drawingml/2006/main">
               <a:ext uri="{FF2B5EF4-FFF2-40B4-BE49-F238E27FC236}">
-                <a16:creationId xmlns:a16="http://schemas.microsoft.com/office/drawing/2014/main" id="{1EF90A72-4F5D-492D-9734-7E168F09BC17}"/>
+                <a16:creationId xmlns:a16="http://schemas.microsoft.com/office/drawing/2014/main" id="{94F1E77D-4DEC-4695-A12B-F9C19FAB12A9}"/>
               </a:ext>
             </a:extLst>
           </p:cNvPr>
@@ -12455,7 +12455,7 @@
           <p:cNvPr id="16" name="">
             <a:extLst xmlns:a="http://schemas.openxmlformats.org/drawingml/2006/main">
               <a:ext uri="{FF2B5EF4-FFF2-40B4-BE49-F238E27FC236}">
-                <a16:creationId xmlns:a16="http://schemas.microsoft.com/office/drawing/2014/main" id="{42326A9D-014C-4A01-8FEA-43310B910BA0}"/>
+                <a16:creationId xmlns:a16="http://schemas.microsoft.com/office/drawing/2014/main" id="{52E6CE42-5756-425E-8A89-304A2D639ECF}"/>
               </a:ext>
             </a:extLst>
           </p:cNvPr>
@@ -12519,7 +12519,7 @@
           <p:cNvPr id="17" name="">
             <a:extLst xmlns:a="http://schemas.openxmlformats.org/drawingml/2006/main">
               <a:ext uri="{FF2B5EF4-FFF2-40B4-BE49-F238E27FC236}">
-                <a16:creationId xmlns:a16="http://schemas.microsoft.com/office/drawing/2014/main" id="{FC847C5D-B557-4ABC-8BCE-12B266D36FDE}"/>
+                <a16:creationId xmlns:a16="http://schemas.microsoft.com/office/drawing/2014/main" id="{21DB1493-AD00-4FC2-85A7-247A135E904A}"/>
               </a:ext>
             </a:extLst>
           </p:cNvPr>
@@ -12581,7 +12581,7 @@
     </p:spTree>
     <p:extLst>
       <p:ext uri="{BB962C8B-B14F-4D97-AF65-F5344CB8AC3E}">
-        <p14:creationId xmlns:p14="http://schemas.microsoft.com/office/powerpoint/2010/main" val="1299017446"/>
+        <p14:creationId xmlns:p14="http://schemas.microsoft.com/office/powerpoint/2010/main" val="75885785"/>
       </p:ext>
     </p:extLst>
   </p:cSld>
@@ -12605,7 +12605,7 @@
           <p:cNvPr id="1" name="">
             <a:extLst xmlns:a="http://schemas.openxmlformats.org/drawingml/2006/main">
               <a:ext uri="{FF2B5EF4-FFF2-40B4-BE49-F238E27FC236}">
-                <a16:creationId xmlns:a16="http://schemas.microsoft.com/office/drawing/2014/main" id="{3FCCEBB8-0774-4B6C-8596-302046377472}"/>
+                <a16:creationId xmlns:a16="http://schemas.microsoft.com/office/drawing/2014/main" id="{046D7BFB-80FB-42F9-96B3-6848C6686BA9}"/>
               </a:ext>
             </a:extLst>
           </p:cNvPr>
@@ -12640,7 +12640,7 @@
           <p:cNvPr id="2" name="">
             <a:extLst xmlns:a="http://schemas.openxmlformats.org/drawingml/2006/main">
               <a:ext uri="{FF2B5EF4-FFF2-40B4-BE49-F238E27FC236}">
-                <a16:creationId xmlns:a16="http://schemas.microsoft.com/office/drawing/2014/main" id="{AA8149D3-884B-4C50-B41A-E9211D4207FE}"/>
+                <a16:creationId xmlns:a16="http://schemas.microsoft.com/office/drawing/2014/main" id="{0DBB30E6-6F3A-45ED-BE25-D695F19C4D2A}"/>
               </a:ext>
             </a:extLst>
           </p:cNvPr>
@@ -12675,7 +12675,7 @@
           <p:cNvPr id="3" name="">
             <a:extLst xmlns:a="http://schemas.openxmlformats.org/drawingml/2006/main">
               <a:ext uri="{FF2B5EF4-FFF2-40B4-BE49-F238E27FC236}">
-                <a16:creationId xmlns:a16="http://schemas.microsoft.com/office/drawing/2014/main" id="{D0B746C9-0D79-4D6A-9939-23E12B7D05FE}"/>
+                <a16:creationId xmlns:a16="http://schemas.microsoft.com/office/drawing/2014/main" id="{A8E105AB-5F82-4F61-AC1B-8204C70549E9}"/>
               </a:ext>
             </a:extLst>
           </p:cNvPr>
@@ -12739,7 +12739,7 @@
           <p:cNvPr id="4" name="">
             <a:extLst xmlns:a="http://schemas.openxmlformats.org/drawingml/2006/main">
               <a:ext uri="{FF2B5EF4-FFF2-40B4-BE49-F238E27FC236}">
-                <a16:creationId xmlns:a16="http://schemas.microsoft.com/office/drawing/2014/main" id="{CE1E4234-F25E-4C74-8E5C-52E2B7C2748D}"/>
+                <a16:creationId xmlns:a16="http://schemas.microsoft.com/office/drawing/2014/main" id="{BCBA867A-8C5D-4EA3-9874-C507C3C98F4F}"/>
               </a:ext>
             </a:extLst>
           </p:cNvPr>
@@ -12793,7 +12793,7 @@
                 <a:ea typeface="Aptos"/>
                 <a:cs typeface="Aptos"/>
               </a:rPr>
-              <a:t>AMD Gemma</a:t>
+              <a:t>Gemma runtime</a:t>
             </a:r>
           </a:p>
         </p:txBody>
@@ -12803,7 +12803,7 @@
           <p:cNvPr id="5" name="">
             <a:extLst xmlns:a="http://schemas.openxmlformats.org/drawingml/2006/main">
               <a:ext uri="{FF2B5EF4-FFF2-40B4-BE49-F238E27FC236}">
-                <a16:creationId xmlns:a16="http://schemas.microsoft.com/office/drawing/2014/main" id="{0DB004C7-1CE1-4123-A8F6-C0F66815DADC}"/>
+                <a16:creationId xmlns:a16="http://schemas.microsoft.com/office/drawing/2014/main" id="{5CDE95F3-80F9-4FCC-84CF-EA4E5AC128C1}"/>
               </a:ext>
             </a:extLst>
           </p:cNvPr>
@@ -12857,7 +12857,7 @@
                 <a:ea typeface="Aptos Display"/>
                 <a:cs typeface="Aptos Display"/>
               </a:rPr>
-              <a:t>Gemma already powers the real Sagents runtime</a:t>
+              <a:t>Local Gemma 4 already powers the real Sagents runtime</a:t>
             </a:r>
           </a:p>
         </p:txBody>
@@ -12867,7 +12867,7 @@
           <p:cNvPr id="6" name="">
             <a:extLst xmlns:a="http://schemas.openxmlformats.org/drawingml/2006/main">
               <a:ext uri="{FF2B5EF4-FFF2-40B4-BE49-F238E27FC236}">
-                <a16:creationId xmlns:a16="http://schemas.microsoft.com/office/drawing/2014/main" id="{0B1E51EA-A0E3-4BB0-9B57-C5CD371EEC67}"/>
+                <a16:creationId xmlns:a16="http://schemas.microsoft.com/office/drawing/2014/main" id="{A7F2DF8D-18A2-4981-A9CF-B0ED56F94B4E}"/>
               </a:ext>
             </a:extLst>
           </p:cNvPr>
@@ -12921,7 +12921,7 @@
                 <a:ea typeface="Aptos"/>
                 <a:cs typeface="Aptos"/>
               </a:rPr>
-              <a:t>Local E2B proves the loop offline; AMD-hosted Gemma uses the same GEMMA_ENDPOINT contract.</a:t>
+              <a:t>E2B proves the loop offline through the same portable GEMMA_ENDPOINT contract.</a:t>
             </a:r>
           </a:p>
         </p:txBody>
@@ -12931,7 +12931,7 @@
           <p:cNvPr id="7" name="">
             <a:extLst xmlns:a="http://schemas.openxmlformats.org/drawingml/2006/main">
               <a:ext uri="{FF2B5EF4-FFF2-40B4-BE49-F238E27FC236}">
-                <a16:creationId xmlns:a16="http://schemas.microsoft.com/office/drawing/2014/main" id="{0EE0156C-EDB2-45F1-85D7-D2CFB153AFF3}"/>
+                <a16:creationId xmlns:a16="http://schemas.microsoft.com/office/drawing/2014/main" id="{7A7241C6-607C-487C-B1DA-D4C6BB3BCBB2}"/>
               </a:ext>
             </a:extLst>
           </p:cNvPr>
@@ -12964,7 +12964,7 @@
           <p:cNvPr id="8" name="">
             <a:extLst xmlns:a="http://schemas.openxmlformats.org/drawingml/2006/main">
               <a:ext uri="{FF2B5EF4-FFF2-40B4-BE49-F238E27FC236}">
-                <a16:creationId xmlns:a16="http://schemas.microsoft.com/office/drawing/2014/main" id="{C85F6F62-487B-4D15-8A11-FFCE5290CE8B}"/>
+                <a16:creationId xmlns:a16="http://schemas.microsoft.com/office/drawing/2014/main" id="{437685EE-B502-46F8-91CD-395193B0EF33}"/>
               </a:ext>
             </a:extLst>
           </p:cNvPr>
@@ -13028,7 +13028,7 @@
           <p:cNvPr id="9" name="">
             <a:extLst xmlns:a="http://schemas.openxmlformats.org/drawingml/2006/main">
               <a:ext uri="{FF2B5EF4-FFF2-40B4-BE49-F238E27FC236}">
-                <a16:creationId xmlns:a16="http://schemas.microsoft.com/office/drawing/2014/main" id="{B80DDE88-4D5F-4156-960E-31CBCF4BD206}"/>
+                <a16:creationId xmlns:a16="http://schemas.microsoft.com/office/drawing/2014/main" id="{F75ADE5A-617A-45F3-AD31-6AF7C5BC7417}"/>
               </a:ext>
             </a:extLst>
           </p:cNvPr>
@@ -13092,7 +13092,7 @@
           <p:cNvPr id="10" name="">
             <a:extLst xmlns:a="http://schemas.openxmlformats.org/drawingml/2006/main">
               <a:ext uri="{FF2B5EF4-FFF2-40B4-BE49-F238E27FC236}">
-                <a16:creationId xmlns:a16="http://schemas.microsoft.com/office/drawing/2014/main" id="{641DC02F-77B7-4925-A8C1-D84C5CAC852A}"/>
+                <a16:creationId xmlns:a16="http://schemas.microsoft.com/office/drawing/2014/main" id="{A6E8786C-BA38-49D9-A722-304B627E50E3}"/>
               </a:ext>
             </a:extLst>
           </p:cNvPr>
@@ -13156,7 +13156,7 @@
           <p:cNvPr id="11" name="">
             <a:extLst xmlns:a="http://schemas.openxmlformats.org/drawingml/2006/main">
               <a:ext uri="{FF2B5EF4-FFF2-40B4-BE49-F238E27FC236}">
-                <a16:creationId xmlns:a16="http://schemas.microsoft.com/office/drawing/2014/main" id="{078BBAFB-6080-4896-95C4-A3D9D5B56CC9}"/>
+                <a16:creationId xmlns:a16="http://schemas.microsoft.com/office/drawing/2014/main" id="{E3B021AB-A79C-4D49-B91C-85E445129D0D}"/>
               </a:ext>
             </a:extLst>
           </p:cNvPr>
@@ -13189,7 +13189,7 @@
           <p:cNvPr id="12" name="">
             <a:extLst xmlns:a="http://schemas.openxmlformats.org/drawingml/2006/main">
               <a:ext uri="{FF2B5EF4-FFF2-40B4-BE49-F238E27FC236}">
-                <a16:creationId xmlns:a16="http://schemas.microsoft.com/office/drawing/2014/main" id="{C879206C-EBD3-42D0-B33E-1DC17E087C22}"/>
+                <a16:creationId xmlns:a16="http://schemas.microsoft.com/office/drawing/2014/main" id="{4D6ED711-8C74-42DB-BA86-5F1ED1E01C61}"/>
               </a:ext>
             </a:extLst>
           </p:cNvPr>
@@ -13253,7 +13253,7 @@
           <p:cNvPr id="13" name="">
             <a:extLst xmlns:a="http://schemas.openxmlformats.org/drawingml/2006/main">
               <a:ext uri="{FF2B5EF4-FFF2-40B4-BE49-F238E27FC236}">
-                <a16:creationId xmlns:a16="http://schemas.microsoft.com/office/drawing/2014/main" id="{3C0CDAEE-C272-4626-979A-71EDA524F048}"/>
+                <a16:creationId xmlns:a16="http://schemas.microsoft.com/office/drawing/2014/main" id="{165100C8-2DDF-4571-8624-D60F9F42139E}"/>
               </a:ext>
             </a:extLst>
           </p:cNvPr>
@@ -13317,7 +13317,7 @@
           <p:cNvPr id="14" name="">
             <a:extLst xmlns:a="http://schemas.openxmlformats.org/drawingml/2006/main">
               <a:ext uri="{FF2B5EF4-FFF2-40B4-BE49-F238E27FC236}">
-                <a16:creationId xmlns:a16="http://schemas.microsoft.com/office/drawing/2014/main" id="{EA18C95C-BAA1-443A-B6FB-F8023E8050DE}"/>
+                <a16:creationId xmlns:a16="http://schemas.microsoft.com/office/drawing/2014/main" id="{BEC11C53-1106-4949-887F-32C6D43F0972}"/>
               </a:ext>
             </a:extLst>
           </p:cNvPr>
@@ -13381,7 +13381,7 @@
           <p:cNvPr id="15" name="">
             <a:extLst xmlns:a="http://schemas.openxmlformats.org/drawingml/2006/main">
               <a:ext uri="{FF2B5EF4-FFF2-40B4-BE49-F238E27FC236}">
-                <a16:creationId xmlns:a16="http://schemas.microsoft.com/office/drawing/2014/main" id="{C9FD19DD-BE45-43A2-882F-A4FFF9EB56CD}"/>
+                <a16:creationId xmlns:a16="http://schemas.microsoft.com/office/drawing/2014/main" id="{6D5FF5FD-3365-4F53-A36C-3CBA9234C5A5}"/>
               </a:ext>
             </a:extLst>
           </p:cNvPr>
@@ -13414,7 +13414,7 @@
           <p:cNvPr id="16" name="">
             <a:extLst xmlns:a="http://schemas.openxmlformats.org/drawingml/2006/main">
               <a:ext uri="{FF2B5EF4-FFF2-40B4-BE49-F238E27FC236}">
-                <a16:creationId xmlns:a16="http://schemas.microsoft.com/office/drawing/2014/main" id="{2B5F6829-7676-494C-9C75-B9DCD1801F75}"/>
+                <a16:creationId xmlns:a16="http://schemas.microsoft.com/office/drawing/2014/main" id="{2FC7D785-2E25-4662-9894-39345D2BF331}"/>
               </a:ext>
             </a:extLst>
           </p:cNvPr>
@@ -13468,7 +13468,7 @@
                 <a:ea typeface="Aptos"/>
                 <a:cs typeface="Aptos"/>
               </a:rPr>
-              <a:t>vLLM on ROCm</a:t>
+              <a:t>llama.cpp + Metal</a:t>
             </a:r>
           </a:p>
         </p:txBody>
@@ -13478,7 +13478,7 @@
           <p:cNvPr id="17" name="">
             <a:extLst xmlns:a="http://schemas.openxmlformats.org/drawingml/2006/main">
               <a:ext uri="{FF2B5EF4-FFF2-40B4-BE49-F238E27FC236}">
-                <a16:creationId xmlns:a16="http://schemas.microsoft.com/office/drawing/2014/main" id="{A63760F5-5016-4C38-9C15-EC5823584193}"/>
+                <a16:creationId xmlns:a16="http://schemas.microsoft.com/office/drawing/2014/main" id="{EB510CE1-4B6C-4126-80EA-8B00A2E4A355}"/>
               </a:ext>
             </a:extLst>
           </p:cNvPr>
@@ -13532,7 +13532,7 @@
                 <a:ea typeface="Aptos"/>
                 <a:cs typeface="Aptos"/>
               </a:rPr>
-              <a:t>docker-compose.gemma-rocm.yml uses vllm/vllm-openai-rocm:gemma4.</a:t>
+              <a:t>The smallest Gemma 4 instruction model runs locally and offline after installation.</a:t>
             </a:r>
           </a:p>
         </p:txBody>
@@ -13542,7 +13542,7 @@
           <p:cNvPr id="18" name="">
             <a:extLst xmlns:a="http://schemas.openxmlformats.org/drawingml/2006/main">
               <a:ext uri="{FF2B5EF4-FFF2-40B4-BE49-F238E27FC236}">
-                <a16:creationId xmlns:a16="http://schemas.microsoft.com/office/drawing/2014/main" id="{274C8AC0-5C0A-41AD-82A0-CCE202996F05}"/>
+                <a16:creationId xmlns:a16="http://schemas.microsoft.com/office/drawing/2014/main" id="{021F581B-A192-486F-94A1-BE595DEC20D5}"/>
               </a:ext>
             </a:extLst>
           </p:cNvPr>
@@ -13575,7 +13575,7 @@
           <p:cNvPr id="19" name="">
             <a:extLst xmlns:a="http://schemas.openxmlformats.org/drawingml/2006/main">
               <a:ext uri="{FF2B5EF4-FFF2-40B4-BE49-F238E27FC236}">
-                <a16:creationId xmlns:a16="http://schemas.microsoft.com/office/drawing/2014/main" id="{0F878021-E91C-4105-AEE5-528E2A43F60C}"/>
+                <a16:creationId xmlns:a16="http://schemas.microsoft.com/office/drawing/2014/main" id="{1F7CDE97-6308-4817-9797-9B64DB8EDF92}"/>
               </a:ext>
             </a:extLst>
           </p:cNvPr>
@@ -13639,7 +13639,7 @@
           <p:cNvPr id="20" name="">
             <a:extLst xmlns:a="http://schemas.openxmlformats.org/drawingml/2006/main">
               <a:ext uri="{FF2B5EF4-FFF2-40B4-BE49-F238E27FC236}">
-                <a16:creationId xmlns:a16="http://schemas.microsoft.com/office/drawing/2014/main" id="{74C8E110-524D-486B-B082-273A152AAB59}"/>
+                <a16:creationId xmlns:a16="http://schemas.microsoft.com/office/drawing/2014/main" id="{49D31D65-5B60-49DF-9728-E0CDFF751BE4}"/>
               </a:ext>
             </a:extLst>
           </p:cNvPr>
@@ -13693,7 +13693,7 @@
                 <a:ea typeface="Aptos"/>
                 <a:cs typeface="Aptos"/>
               </a:rPr>
-              <a:t>Even AMD-hosted Gemma proposals cannot mutate state without passing simulator safety rules.</a:t>
+              <a:t>Local Gemma proposals cannot mutate state without passing deterministic simulator safety rules.</a:t>
             </a:r>
           </a:p>
         </p:txBody>
@@ -13703,7 +13703,7 @@
           <p:cNvPr id="21" name="">
             <a:extLst xmlns:a="http://schemas.openxmlformats.org/drawingml/2006/main">
               <a:ext uri="{FF2B5EF4-FFF2-40B4-BE49-F238E27FC236}">
-                <a16:creationId xmlns:a16="http://schemas.microsoft.com/office/drawing/2014/main" id="{4E790B6C-8B17-41DC-B914-9A65FFD7CB56}"/>
+                <a16:creationId xmlns:a16="http://schemas.microsoft.com/office/drawing/2014/main" id="{C1C0756F-988C-4B28-9D7F-B40AE3AF4F67}"/>
               </a:ext>
             </a:extLst>
           </p:cNvPr>
@@ -13767,7 +13767,7 @@
           <p:cNvPr id="22" name="">
             <a:extLst xmlns:a="http://schemas.openxmlformats.org/drawingml/2006/main">
               <a:ext uri="{FF2B5EF4-FFF2-40B4-BE49-F238E27FC236}">
-                <a16:creationId xmlns:a16="http://schemas.microsoft.com/office/drawing/2014/main" id="{25405B3A-5646-40D0-BC98-32AC431DD123}"/>
+                <a16:creationId xmlns:a16="http://schemas.microsoft.com/office/drawing/2014/main" id="{53EAC4CD-3D22-47DC-BE3A-7DEC64806F37}"/>
               </a:ext>
             </a:extLst>
           </p:cNvPr>
@@ -13829,7 +13829,7 @@
     </p:spTree>
     <p:extLst>
       <p:ext uri="{BB962C8B-B14F-4D97-AF65-F5344CB8AC3E}">
-        <p14:creationId xmlns:p14="http://schemas.microsoft.com/office/powerpoint/2010/main" val="883688344"/>
+        <p14:creationId xmlns:p14="http://schemas.microsoft.com/office/powerpoint/2010/main" val="726148268"/>
       </p:ext>
     </p:extLst>
   </p:cSld>

</xml_diff>

<commit_message>
feat: add visual plain-language system
</commit_message>
<xml_diff>
--- a/submission/proteinloop-hackathon-deck.pptx
+++ b/submission/proteinloop-hackathon-deck.pptx
@@ -2,22 +2,22 @@
 <file path=ppt/presentation.xml><?xml version="1.0" encoding="utf-8"?>
 <p:presentation xmlns:p="http://schemas.openxmlformats.org/presentationml/2006/main">
   <p:sldMasterIdLst>
-    <p:sldMasterId xmlns:r="http://schemas.openxmlformats.org/officeDocument/2006/relationships" id="2147483648" r:id="R88b63d29237e40fd"/>
+    <p:sldMasterId xmlns:r="http://schemas.openxmlformats.org/officeDocument/2006/relationships" id="2147483648" r:id="Rc9fc7047e45946d0"/>
   </p:sldMasterIdLst>
   <p:notesMasterIdLst>
-    <p:notesMasterId xmlns:r="http://schemas.openxmlformats.org/officeDocument/2006/relationships" r:id="R6d91cd40159543b9"/>
+    <p:notesMasterId xmlns:r="http://schemas.openxmlformats.org/officeDocument/2006/relationships" r:id="R874207f965f6429e"/>
   </p:notesMasterIdLst>
   <p:sldIdLst>
-    <p:sldId xmlns:r="http://schemas.openxmlformats.org/officeDocument/2006/relationships" id="256" r:id="Rc28cc2d0fc5e49cd"/>
-    <p:sldId xmlns:r="http://schemas.openxmlformats.org/officeDocument/2006/relationships" id="257" r:id="Rdb9afc10dc7a45a5"/>
-    <p:sldId xmlns:r="http://schemas.openxmlformats.org/officeDocument/2006/relationships" id="258" r:id="Rc5a66e95cf2a44e2"/>
-    <p:sldId xmlns:r="http://schemas.openxmlformats.org/officeDocument/2006/relationships" id="259" r:id="R48b19b12069240c5"/>
-    <p:sldId xmlns:r="http://schemas.openxmlformats.org/officeDocument/2006/relationships" id="260" r:id="R360a2fff4e234b07"/>
-    <p:sldId xmlns:r="http://schemas.openxmlformats.org/officeDocument/2006/relationships" id="261" r:id="R83df63821acb4509"/>
-    <p:sldId xmlns:r="http://schemas.openxmlformats.org/officeDocument/2006/relationships" id="262" r:id="R51083432c8974847"/>
-    <p:sldId xmlns:r="http://schemas.openxmlformats.org/officeDocument/2006/relationships" id="263" r:id="Re94e55f727ee446c"/>
-    <p:sldId xmlns:r="http://schemas.openxmlformats.org/officeDocument/2006/relationships" id="264" r:id="R91e9509f180d4d16"/>
-    <p:sldId xmlns:r="http://schemas.openxmlformats.org/officeDocument/2006/relationships" id="265" r:id="R0c577d8493d24a7b"/>
+    <p:sldId xmlns:r="http://schemas.openxmlformats.org/officeDocument/2006/relationships" id="256" r:id="R310a1f9e2b804836"/>
+    <p:sldId xmlns:r="http://schemas.openxmlformats.org/officeDocument/2006/relationships" id="257" r:id="R233fa6ce48a64064"/>
+    <p:sldId xmlns:r="http://schemas.openxmlformats.org/officeDocument/2006/relationships" id="258" r:id="R2a133b9104564784"/>
+    <p:sldId xmlns:r="http://schemas.openxmlformats.org/officeDocument/2006/relationships" id="259" r:id="R9f2138e6e1a74247"/>
+    <p:sldId xmlns:r="http://schemas.openxmlformats.org/officeDocument/2006/relationships" id="260" r:id="R55ff30d40c9a480b"/>
+    <p:sldId xmlns:r="http://schemas.openxmlformats.org/officeDocument/2006/relationships" id="261" r:id="R47ff83a10ec244c6"/>
+    <p:sldId xmlns:r="http://schemas.openxmlformats.org/officeDocument/2006/relationships" id="262" r:id="R6c6c4472a7f34fcd"/>
+    <p:sldId xmlns:r="http://schemas.openxmlformats.org/officeDocument/2006/relationships" id="263" r:id="Rab10ac3e4b544c49"/>
+    <p:sldId xmlns:r="http://schemas.openxmlformats.org/officeDocument/2006/relationships" id="264" r:id="Rd828d9d3f00941dd"/>
+    <p:sldId xmlns:r="http://schemas.openxmlformats.org/officeDocument/2006/relationships" id="265" r:id="R9e127670f09243df"/>
   </p:sldIdLst>
   <p:sldSz cx="12192000" cy="6858000"/>
   <p:notesSz cx="6858000" cy="9144000"/>
@@ -1158,7 +1158,7 @@
   </p:cSld>
   <p:clrMap bg1="lt1" tx1="dk1" bg2="lt2" tx2="dk2" accent1="accent1" accent2="accent2" accent3="accent3" accent4="accent4" accent5="accent5" accent6="accent6" hlink="hlink" folHlink="folHlink"/>
   <p:sldLayoutIdLst>
-    <p:sldLayoutId xmlns:r="http://schemas.openxmlformats.org/officeDocument/2006/relationships" id="2147483649" r:id="Rb7953813de1e4f8f"/>
+    <p:sldLayoutId xmlns:r="http://schemas.openxmlformats.org/officeDocument/2006/relationships" id="2147483649" r:id="Rae5f7c5d88824bde"/>
   </p:sldLayoutIdLst>
   <p:txStyles>
     <p:titleStyle>
@@ -1457,7 +1457,7 @@
           <p:cNvPr id="1" name="">
             <a:extLst xmlns:a="http://schemas.openxmlformats.org/drawingml/2006/main">
               <a:ext uri="{FF2B5EF4-FFF2-40B4-BE49-F238E27FC236}">
-                <a16:creationId xmlns:a16="http://schemas.microsoft.com/office/drawing/2014/main" id="{DC96CD6C-720F-47AF-9C08-E0182934DFBE}"/>
+                <a16:creationId xmlns:a16="http://schemas.microsoft.com/office/drawing/2014/main" id="{A359D533-7441-4A78-98A7-6F5D4087CACD}"/>
               </a:ext>
             </a:extLst>
           </p:cNvPr>
@@ -1492,7 +1492,7 @@
           <p:cNvPr id="2" name="">
             <a:extLst xmlns:a="http://schemas.openxmlformats.org/drawingml/2006/main">
               <a:ext uri="{FF2B5EF4-FFF2-40B4-BE49-F238E27FC236}">
-                <a16:creationId xmlns:a16="http://schemas.microsoft.com/office/drawing/2014/main" id="{BBBA268C-9511-4C38-8F23-980248B12F66}"/>
+                <a16:creationId xmlns:a16="http://schemas.microsoft.com/office/drawing/2014/main" id="{93811AEB-CC35-4264-B5E9-7825991064CC}"/>
               </a:ext>
             </a:extLst>
           </p:cNvPr>
@@ -1527,7 +1527,7 @@
           <p:cNvPr id="3" name="">
             <a:extLst xmlns:a="http://schemas.openxmlformats.org/drawingml/2006/main">
               <a:ext uri="{FF2B5EF4-FFF2-40B4-BE49-F238E27FC236}">
-                <a16:creationId xmlns:a16="http://schemas.microsoft.com/office/drawing/2014/main" id="{7C6663F5-775F-4042-BF1B-9B178064CE98}"/>
+                <a16:creationId xmlns:a16="http://schemas.microsoft.com/office/drawing/2014/main" id="{991DAF5A-28F8-4A39-9438-909156EF65C2}"/>
               </a:ext>
             </a:extLst>
           </p:cNvPr>
@@ -1591,7 +1591,7 @@
           <p:cNvPr id="4" name="">
             <a:extLst xmlns:a="http://schemas.openxmlformats.org/drawingml/2006/main">
               <a:ext uri="{FF2B5EF4-FFF2-40B4-BE49-F238E27FC236}">
-                <a16:creationId xmlns:a16="http://schemas.microsoft.com/office/drawing/2014/main" id="{9FEB754A-4F79-472D-B8B6-DA2588B650E6}"/>
+                <a16:creationId xmlns:a16="http://schemas.microsoft.com/office/drawing/2014/main" id="{18E5F365-2032-44AC-A37A-730318C461D4}"/>
               </a:ext>
             </a:extLst>
           </p:cNvPr>
@@ -1655,7 +1655,7 @@
           <p:cNvPr id="5" name="">
             <a:extLst xmlns:a="http://schemas.openxmlformats.org/drawingml/2006/main">
               <a:ext uri="{FF2B5EF4-FFF2-40B4-BE49-F238E27FC236}">
-                <a16:creationId xmlns:a16="http://schemas.microsoft.com/office/drawing/2014/main" id="{3252D5D1-0AC3-45B0-9448-800BE6B6C7A3}"/>
+                <a16:creationId xmlns:a16="http://schemas.microsoft.com/office/drawing/2014/main" id="{6B102BFA-4919-4B4F-94D3-B110D2635B64}"/>
               </a:ext>
             </a:extLst>
           </p:cNvPr>
@@ -1690,7 +1690,7 @@
           <p:cNvPr id="6" name="">
             <a:extLst xmlns:a="http://schemas.openxmlformats.org/drawingml/2006/main">
               <a:ext uri="{FF2B5EF4-FFF2-40B4-BE49-F238E27FC236}">
-                <a16:creationId xmlns:a16="http://schemas.microsoft.com/office/drawing/2014/main" id="{77C3FDFF-498B-434A-8FDE-8DFCE29E0EC4}"/>
+                <a16:creationId xmlns:a16="http://schemas.microsoft.com/office/drawing/2014/main" id="{9F0717A1-8095-40D6-9829-B09340789432}"/>
               </a:ext>
             </a:extLst>
           </p:cNvPr>
@@ -1754,7 +1754,7 @@
           <p:cNvPr id="7" name="">
             <a:extLst xmlns:a="http://schemas.openxmlformats.org/drawingml/2006/main">
               <a:ext uri="{FF2B5EF4-FFF2-40B4-BE49-F238E27FC236}">
-                <a16:creationId xmlns:a16="http://schemas.microsoft.com/office/drawing/2014/main" id="{6F7D48CA-66E3-4548-AA08-BFFC15C50DC7}"/>
+                <a16:creationId xmlns:a16="http://schemas.microsoft.com/office/drawing/2014/main" id="{E3549F6B-4E41-4958-A744-D37C5942B195}"/>
               </a:ext>
             </a:extLst>
           </p:cNvPr>
@@ -1818,7 +1818,7 @@
           <p:cNvPr id="8" name="">
             <a:extLst xmlns:a="http://schemas.openxmlformats.org/drawingml/2006/main">
               <a:ext uri="{FF2B5EF4-FFF2-40B4-BE49-F238E27FC236}">
-                <a16:creationId xmlns:a16="http://schemas.microsoft.com/office/drawing/2014/main" id="{317BE6CE-A2B0-4B6C-8A7D-E1A9A8FC9562}"/>
+                <a16:creationId xmlns:a16="http://schemas.microsoft.com/office/drawing/2014/main" id="{55EC3395-134D-4316-BCD3-2ABDDAEC7DFD}"/>
               </a:ext>
             </a:extLst>
           </p:cNvPr>
@@ -1853,7 +1853,7 @@
           <p:cNvPr id="9" name="">
             <a:extLst xmlns:a="http://schemas.openxmlformats.org/drawingml/2006/main">
               <a:ext uri="{FF2B5EF4-FFF2-40B4-BE49-F238E27FC236}">
-                <a16:creationId xmlns:a16="http://schemas.microsoft.com/office/drawing/2014/main" id="{35531000-493A-4C68-930E-99A6EDC86E01}"/>
+                <a16:creationId xmlns:a16="http://schemas.microsoft.com/office/drawing/2014/main" id="{1431C9BE-4912-4051-82AC-FF141EF6D2D7}"/>
               </a:ext>
             </a:extLst>
           </p:cNvPr>
@@ -1917,7 +1917,7 @@
           <p:cNvPr id="10" name="">
             <a:extLst xmlns:a="http://schemas.openxmlformats.org/drawingml/2006/main">
               <a:ext uri="{FF2B5EF4-FFF2-40B4-BE49-F238E27FC236}">
-                <a16:creationId xmlns:a16="http://schemas.microsoft.com/office/drawing/2014/main" id="{14F13060-C28C-44A4-87CE-3EECDDCEEA7D}"/>
+                <a16:creationId xmlns:a16="http://schemas.microsoft.com/office/drawing/2014/main" id="{0E2D3E1B-B356-49E9-B26A-F2AE4A781914}"/>
               </a:ext>
             </a:extLst>
           </p:cNvPr>
@@ -1981,7 +1981,7 @@
           <p:cNvPr id="11" name="">
             <a:extLst xmlns:a="http://schemas.openxmlformats.org/drawingml/2006/main">
               <a:ext uri="{FF2B5EF4-FFF2-40B4-BE49-F238E27FC236}">
-                <a16:creationId xmlns:a16="http://schemas.microsoft.com/office/drawing/2014/main" id="{DB6D8BE2-776D-499A-868E-8FDB3DD5B947}"/>
+                <a16:creationId xmlns:a16="http://schemas.microsoft.com/office/drawing/2014/main" id="{2C74C0AA-E279-4F4C-99AB-864AD79BB79A}"/>
               </a:ext>
             </a:extLst>
           </p:cNvPr>
@@ -2045,7 +2045,7 @@
           <p:cNvPr id="12" name="">
             <a:extLst xmlns:a="http://schemas.openxmlformats.org/drawingml/2006/main">
               <a:ext uri="{FF2B5EF4-FFF2-40B4-BE49-F238E27FC236}">
-                <a16:creationId xmlns:a16="http://schemas.microsoft.com/office/drawing/2014/main" id="{08C2A290-50DE-49FF-B4B5-2F731299123B}"/>
+                <a16:creationId xmlns:a16="http://schemas.microsoft.com/office/drawing/2014/main" id="{DBD89452-0A60-467B-839D-3065CDDABD1A}"/>
               </a:ext>
             </a:extLst>
           </p:cNvPr>
@@ -2080,7 +2080,7 @@
           <p:cNvPr id="13" name="">
             <a:extLst xmlns:a="http://schemas.openxmlformats.org/drawingml/2006/main">
               <a:ext uri="{FF2B5EF4-FFF2-40B4-BE49-F238E27FC236}">
-                <a16:creationId xmlns:a16="http://schemas.microsoft.com/office/drawing/2014/main" id="{17C222D9-D00B-435D-8EBD-F4EA5148341B}"/>
+                <a16:creationId xmlns:a16="http://schemas.microsoft.com/office/drawing/2014/main" id="{BBE68F2F-7E65-4455-A52B-283AF2058A51}"/>
               </a:ext>
             </a:extLst>
           </p:cNvPr>
@@ -2144,7 +2144,7 @@
           <p:cNvPr id="14" name="">
             <a:extLst xmlns:a="http://schemas.openxmlformats.org/drawingml/2006/main">
               <a:ext uri="{FF2B5EF4-FFF2-40B4-BE49-F238E27FC236}">
-                <a16:creationId xmlns:a16="http://schemas.microsoft.com/office/drawing/2014/main" id="{75A636D4-9352-4A25-B243-ED097770A33B}"/>
+                <a16:creationId xmlns:a16="http://schemas.microsoft.com/office/drawing/2014/main" id="{226BE245-F394-4FF9-9D89-2A2F93A756A9}"/>
               </a:ext>
             </a:extLst>
           </p:cNvPr>
@@ -2208,7 +2208,7 @@
           <p:cNvPr id="15" name="">
             <a:extLst xmlns:a="http://schemas.openxmlformats.org/drawingml/2006/main">
               <a:ext uri="{FF2B5EF4-FFF2-40B4-BE49-F238E27FC236}">
-                <a16:creationId xmlns:a16="http://schemas.microsoft.com/office/drawing/2014/main" id="{2A0549FA-3696-46C1-8D2C-3E811155F7D2}"/>
+                <a16:creationId xmlns:a16="http://schemas.microsoft.com/office/drawing/2014/main" id="{D8AFC1CF-C475-4624-AF30-360620F820E1}"/>
               </a:ext>
             </a:extLst>
           </p:cNvPr>
@@ -2272,7 +2272,7 @@
           <p:cNvPr id="16" name="">
             <a:extLst xmlns:a="http://schemas.openxmlformats.org/drawingml/2006/main">
               <a:ext uri="{FF2B5EF4-FFF2-40B4-BE49-F238E27FC236}">
-                <a16:creationId xmlns:a16="http://schemas.microsoft.com/office/drawing/2014/main" id="{54137A5B-D44C-468E-850E-EDD0DA4FE1A7}"/>
+                <a16:creationId xmlns:a16="http://schemas.microsoft.com/office/drawing/2014/main" id="{EC677A79-55FE-4AE7-B11C-C663EE06E496}"/>
               </a:ext>
             </a:extLst>
           </p:cNvPr>
@@ -2307,7 +2307,7 @@
           <p:cNvPr id="17" name="">
             <a:extLst xmlns:a="http://schemas.openxmlformats.org/drawingml/2006/main">
               <a:ext uri="{FF2B5EF4-FFF2-40B4-BE49-F238E27FC236}">
-                <a16:creationId xmlns:a16="http://schemas.microsoft.com/office/drawing/2014/main" id="{73650957-0541-45E2-8713-195D50C2E0B7}"/>
+                <a16:creationId xmlns:a16="http://schemas.microsoft.com/office/drawing/2014/main" id="{EDEB4759-1D28-44EE-91D7-79E6F6199225}"/>
               </a:ext>
             </a:extLst>
           </p:cNvPr>
@@ -2371,7 +2371,7 @@
           <p:cNvPr id="18" name="">
             <a:extLst xmlns:a="http://schemas.openxmlformats.org/drawingml/2006/main">
               <a:ext uri="{FF2B5EF4-FFF2-40B4-BE49-F238E27FC236}">
-                <a16:creationId xmlns:a16="http://schemas.microsoft.com/office/drawing/2014/main" id="{DE76E455-A3A3-4C68-9B58-8B42372728A1}"/>
+                <a16:creationId xmlns:a16="http://schemas.microsoft.com/office/drawing/2014/main" id="{CCCBFB01-5F29-4D12-9FC2-68C486658610}"/>
               </a:ext>
             </a:extLst>
           </p:cNvPr>
@@ -2435,7 +2435,7 @@
           <p:cNvPr id="19" name="">
             <a:extLst xmlns:a="http://schemas.openxmlformats.org/drawingml/2006/main">
               <a:ext uri="{FF2B5EF4-FFF2-40B4-BE49-F238E27FC236}">
-                <a16:creationId xmlns:a16="http://schemas.microsoft.com/office/drawing/2014/main" id="{0CBD05EC-982F-469C-BC02-F588BBBFEC38}"/>
+                <a16:creationId xmlns:a16="http://schemas.microsoft.com/office/drawing/2014/main" id="{2B5EEE2A-618B-4C09-A608-75786A71383D}"/>
               </a:ext>
             </a:extLst>
           </p:cNvPr>
@@ -2499,7 +2499,7 @@
           <p:cNvPr id="20" name="">
             <a:extLst xmlns:a="http://schemas.openxmlformats.org/drawingml/2006/main">
               <a:ext uri="{FF2B5EF4-FFF2-40B4-BE49-F238E27FC236}">
-                <a16:creationId xmlns:a16="http://schemas.microsoft.com/office/drawing/2014/main" id="{A5915A1E-36A7-49D8-8D15-DC89F7368FD1}"/>
+                <a16:creationId xmlns:a16="http://schemas.microsoft.com/office/drawing/2014/main" id="{F4E1B5E9-1537-4C9B-AE92-8175E51BCCC1}"/>
               </a:ext>
             </a:extLst>
           </p:cNvPr>
@@ -2655,7 +2655,7 @@
           <p:cNvPr id="21" name="">
             <a:extLst xmlns:a="http://schemas.openxmlformats.org/drawingml/2006/main">
               <a:ext uri="{FF2B5EF4-FFF2-40B4-BE49-F238E27FC236}">
-                <a16:creationId xmlns:a16="http://schemas.microsoft.com/office/drawing/2014/main" id="{D100C90E-52DF-4514-90A0-B512F486A819}"/>
+                <a16:creationId xmlns:a16="http://schemas.microsoft.com/office/drawing/2014/main" id="{11C81967-4188-4AF0-B2AD-7D8785257FEC}"/>
               </a:ext>
             </a:extLst>
           </p:cNvPr>
@@ -2719,7 +2719,7 @@
           <p:cNvPr id="22" name="">
             <a:extLst xmlns:a="http://schemas.openxmlformats.org/drawingml/2006/main">
               <a:ext uri="{FF2B5EF4-FFF2-40B4-BE49-F238E27FC236}">
-                <a16:creationId xmlns:a16="http://schemas.microsoft.com/office/drawing/2014/main" id="{89E83783-611E-4E76-BB85-C67FB56FE81F}"/>
+                <a16:creationId xmlns:a16="http://schemas.microsoft.com/office/drawing/2014/main" id="{38D7900E-18B3-426E-B76E-8D89CD18E82A}"/>
               </a:ext>
             </a:extLst>
           </p:cNvPr>
@@ -2781,7 +2781,7 @@
     </p:spTree>
     <p:extLst>
       <p:ext uri="{BB962C8B-B14F-4D97-AF65-F5344CB8AC3E}">
-        <p14:creationId xmlns:p14="http://schemas.microsoft.com/office/powerpoint/2010/main" val="1600259929"/>
+        <p14:creationId xmlns:p14="http://schemas.microsoft.com/office/powerpoint/2010/main" val="1590110437"/>
       </p:ext>
     </p:extLst>
   </p:cSld>
@@ -2805,7 +2805,7 @@
           <p:cNvPr id="1" name="">
             <a:extLst xmlns:a="http://schemas.openxmlformats.org/drawingml/2006/main">
               <a:ext uri="{FF2B5EF4-FFF2-40B4-BE49-F238E27FC236}">
-                <a16:creationId xmlns:a16="http://schemas.microsoft.com/office/drawing/2014/main" id="{22A17DFF-9314-45BC-9077-C07356B55438}"/>
+                <a16:creationId xmlns:a16="http://schemas.microsoft.com/office/drawing/2014/main" id="{A1B82152-7582-4EDA-AC7F-300C9A64D8EE}"/>
               </a:ext>
             </a:extLst>
           </p:cNvPr>
@@ -2840,7 +2840,7 @@
           <p:cNvPr id="2" name="">
             <a:extLst xmlns:a="http://schemas.openxmlformats.org/drawingml/2006/main">
               <a:ext uri="{FF2B5EF4-FFF2-40B4-BE49-F238E27FC236}">
-                <a16:creationId xmlns:a16="http://schemas.microsoft.com/office/drawing/2014/main" id="{51EF8907-834E-420A-BE44-B9329B990411}"/>
+                <a16:creationId xmlns:a16="http://schemas.microsoft.com/office/drawing/2014/main" id="{2128502B-48A6-4464-9967-B24039517A1C}"/>
               </a:ext>
             </a:extLst>
           </p:cNvPr>
@@ -2875,7 +2875,7 @@
           <p:cNvPr id="3" name="">
             <a:extLst xmlns:a="http://schemas.openxmlformats.org/drawingml/2006/main">
               <a:ext uri="{FF2B5EF4-FFF2-40B4-BE49-F238E27FC236}">
-                <a16:creationId xmlns:a16="http://schemas.microsoft.com/office/drawing/2014/main" id="{8F4F0FBF-2AB8-4581-991A-0DEFCD30EF7E}"/>
+                <a16:creationId xmlns:a16="http://schemas.microsoft.com/office/drawing/2014/main" id="{4E7F2AC2-C7F7-4676-930F-F55EF577A967}"/>
               </a:ext>
             </a:extLst>
           </p:cNvPr>
@@ -2939,7 +2939,7 @@
           <p:cNvPr id="4" name="">
             <a:extLst xmlns:a="http://schemas.openxmlformats.org/drawingml/2006/main">
               <a:ext uri="{FF2B5EF4-FFF2-40B4-BE49-F238E27FC236}">
-                <a16:creationId xmlns:a16="http://schemas.microsoft.com/office/drawing/2014/main" id="{5A0148CF-B64A-41E5-AFC4-008F4C8B4A65}"/>
+                <a16:creationId xmlns:a16="http://schemas.microsoft.com/office/drawing/2014/main" id="{A4D5C305-153C-47A7-89E9-9A201F8196EF}"/>
               </a:ext>
             </a:extLst>
           </p:cNvPr>
@@ -3003,7 +3003,7 @@
           <p:cNvPr id="5" name="">
             <a:extLst xmlns:a="http://schemas.openxmlformats.org/drawingml/2006/main">
               <a:ext uri="{FF2B5EF4-FFF2-40B4-BE49-F238E27FC236}">
-                <a16:creationId xmlns:a16="http://schemas.microsoft.com/office/drawing/2014/main" id="{98A4DBD2-9F82-43A1-BE59-A71B3F67A439}"/>
+                <a16:creationId xmlns:a16="http://schemas.microsoft.com/office/drawing/2014/main" id="{B34EB85A-76A7-4A04-9D54-B60C40434978}"/>
               </a:ext>
             </a:extLst>
           </p:cNvPr>
@@ -3067,7 +3067,7 @@
           <p:cNvPr id="6" name="">
             <a:extLst xmlns:a="http://schemas.openxmlformats.org/drawingml/2006/main">
               <a:ext uri="{FF2B5EF4-FFF2-40B4-BE49-F238E27FC236}">
-                <a16:creationId xmlns:a16="http://schemas.microsoft.com/office/drawing/2014/main" id="{17C3A50F-C155-4D90-ADBC-8F1D13C5879A}"/>
+                <a16:creationId xmlns:a16="http://schemas.microsoft.com/office/drawing/2014/main" id="{F90FF1DE-2961-45EA-9EA1-732C7E41DCEC}"/>
               </a:ext>
             </a:extLst>
           </p:cNvPr>
@@ -3131,7 +3131,7 @@
           <p:cNvPr id="7" name="">
             <a:extLst xmlns:a="http://schemas.openxmlformats.org/drawingml/2006/main">
               <a:ext uri="{FF2B5EF4-FFF2-40B4-BE49-F238E27FC236}">
-                <a16:creationId xmlns:a16="http://schemas.microsoft.com/office/drawing/2014/main" id="{F38A33E6-9AE4-434A-A86D-101CE02983FA}"/>
+                <a16:creationId xmlns:a16="http://schemas.microsoft.com/office/drawing/2014/main" id="{408DBA06-A8BC-4EED-A21A-DE8CC50422D4}"/>
               </a:ext>
             </a:extLst>
           </p:cNvPr>
@@ -3164,7 +3164,7 @@
           <p:cNvPr id="8" name="">
             <a:extLst xmlns:a="http://schemas.openxmlformats.org/drawingml/2006/main">
               <a:ext uri="{FF2B5EF4-FFF2-40B4-BE49-F238E27FC236}">
-                <a16:creationId xmlns:a16="http://schemas.microsoft.com/office/drawing/2014/main" id="{2EA72D39-49BD-4BCE-AC0D-C5FB17CDDD57}"/>
+                <a16:creationId xmlns:a16="http://schemas.microsoft.com/office/drawing/2014/main" id="{6DAC0D2A-F4CD-4422-9FC0-D5041B17D591}"/>
               </a:ext>
             </a:extLst>
           </p:cNvPr>
@@ -3228,7 +3228,7 @@
           <p:cNvPr id="9" name="">
             <a:extLst xmlns:a="http://schemas.openxmlformats.org/drawingml/2006/main">
               <a:ext uri="{FF2B5EF4-FFF2-40B4-BE49-F238E27FC236}">
-                <a16:creationId xmlns:a16="http://schemas.microsoft.com/office/drawing/2014/main" id="{374FB243-56C7-429C-9729-3E9A294B178D}"/>
+                <a16:creationId xmlns:a16="http://schemas.microsoft.com/office/drawing/2014/main" id="{957BEE5D-E811-4CF1-B49D-1613EB392C2F}"/>
               </a:ext>
             </a:extLst>
           </p:cNvPr>
@@ -3292,7 +3292,7 @@
           <p:cNvPr id="10" name="">
             <a:extLst xmlns:a="http://schemas.openxmlformats.org/drawingml/2006/main">
               <a:ext uri="{FF2B5EF4-FFF2-40B4-BE49-F238E27FC236}">
-                <a16:creationId xmlns:a16="http://schemas.microsoft.com/office/drawing/2014/main" id="{F7015112-C562-4FF9-AC90-DA2FA71AFA24}"/>
+                <a16:creationId xmlns:a16="http://schemas.microsoft.com/office/drawing/2014/main" id="{191DBC6D-B67D-481C-B77D-7B9D4D499BD8}"/>
               </a:ext>
             </a:extLst>
           </p:cNvPr>
@@ -3325,7 +3325,7 @@
           <p:cNvPr id="11" name="">
             <a:extLst xmlns:a="http://schemas.openxmlformats.org/drawingml/2006/main">
               <a:ext uri="{FF2B5EF4-FFF2-40B4-BE49-F238E27FC236}">
-                <a16:creationId xmlns:a16="http://schemas.microsoft.com/office/drawing/2014/main" id="{9A656E6B-4E7B-479C-A212-CE8C966E7644}"/>
+                <a16:creationId xmlns:a16="http://schemas.microsoft.com/office/drawing/2014/main" id="{A2728832-6772-4921-89D3-47DBBE29A958}"/>
               </a:ext>
             </a:extLst>
           </p:cNvPr>
@@ -3389,7 +3389,7 @@
           <p:cNvPr id="12" name="">
             <a:extLst xmlns:a="http://schemas.openxmlformats.org/drawingml/2006/main">
               <a:ext uri="{FF2B5EF4-FFF2-40B4-BE49-F238E27FC236}">
-                <a16:creationId xmlns:a16="http://schemas.microsoft.com/office/drawing/2014/main" id="{D4CE7FA7-2AA3-4CAD-BB49-ED53813289CE}"/>
+                <a16:creationId xmlns:a16="http://schemas.microsoft.com/office/drawing/2014/main" id="{70B9FE37-C588-4AAC-8468-E4C49651CDB2}"/>
               </a:ext>
             </a:extLst>
           </p:cNvPr>
@@ -3453,7 +3453,7 @@
           <p:cNvPr id="13" name="">
             <a:extLst xmlns:a="http://schemas.openxmlformats.org/drawingml/2006/main">
               <a:ext uri="{FF2B5EF4-FFF2-40B4-BE49-F238E27FC236}">
-                <a16:creationId xmlns:a16="http://schemas.microsoft.com/office/drawing/2014/main" id="{DA2F17CD-ADC7-4832-87C1-A1E4ADAEBBBB}"/>
+                <a16:creationId xmlns:a16="http://schemas.microsoft.com/office/drawing/2014/main" id="{69170CBA-28E6-4B64-BBD6-BD0B8F960A39}"/>
               </a:ext>
             </a:extLst>
           </p:cNvPr>
@@ -3486,7 +3486,7 @@
           <p:cNvPr id="14" name="">
             <a:extLst xmlns:a="http://schemas.openxmlformats.org/drawingml/2006/main">
               <a:ext uri="{FF2B5EF4-FFF2-40B4-BE49-F238E27FC236}">
-                <a16:creationId xmlns:a16="http://schemas.microsoft.com/office/drawing/2014/main" id="{662F220D-B7BE-4F8C-AD3D-29F26EA0BC1B}"/>
+                <a16:creationId xmlns:a16="http://schemas.microsoft.com/office/drawing/2014/main" id="{64720E4E-F8CA-4387-B58F-6E71DAF5C677}"/>
               </a:ext>
             </a:extLst>
           </p:cNvPr>
@@ -3550,7 +3550,7 @@
           <p:cNvPr id="15" name="">
             <a:extLst xmlns:a="http://schemas.openxmlformats.org/drawingml/2006/main">
               <a:ext uri="{FF2B5EF4-FFF2-40B4-BE49-F238E27FC236}">
-                <a16:creationId xmlns:a16="http://schemas.microsoft.com/office/drawing/2014/main" id="{FCAF10EC-8507-499D-B5AD-1246577EFD23}"/>
+                <a16:creationId xmlns:a16="http://schemas.microsoft.com/office/drawing/2014/main" id="{4618CA3E-7820-485D-A36E-D4709F3DC45E}"/>
               </a:ext>
             </a:extLst>
           </p:cNvPr>
@@ -3614,7 +3614,7 @@
           <p:cNvPr id="16" name="">
             <a:extLst xmlns:a="http://schemas.openxmlformats.org/drawingml/2006/main">
               <a:ext uri="{FF2B5EF4-FFF2-40B4-BE49-F238E27FC236}">
-                <a16:creationId xmlns:a16="http://schemas.microsoft.com/office/drawing/2014/main" id="{A1FF4B96-3C12-411F-9C9D-69661DB81059}"/>
+                <a16:creationId xmlns:a16="http://schemas.microsoft.com/office/drawing/2014/main" id="{7E938136-9788-4F3D-BAA9-9A91AEFFD497}"/>
               </a:ext>
             </a:extLst>
           </p:cNvPr>
@@ -3678,7 +3678,7 @@
           <p:cNvPr id="17" name="">
             <a:extLst xmlns:a="http://schemas.openxmlformats.org/drawingml/2006/main">
               <a:ext uri="{FF2B5EF4-FFF2-40B4-BE49-F238E27FC236}">
-                <a16:creationId xmlns:a16="http://schemas.microsoft.com/office/drawing/2014/main" id="{C8684689-495A-4C7A-AE46-FFFA3A965485}"/>
+                <a16:creationId xmlns:a16="http://schemas.microsoft.com/office/drawing/2014/main" id="{96AE1296-FA3B-4285-9EC2-B477412C72D9}"/>
               </a:ext>
             </a:extLst>
           </p:cNvPr>
@@ -3742,7 +3742,7 @@
           <p:cNvPr id="18" name="">
             <a:extLst xmlns:a="http://schemas.openxmlformats.org/drawingml/2006/main">
               <a:ext uri="{FF2B5EF4-FFF2-40B4-BE49-F238E27FC236}">
-                <a16:creationId xmlns:a16="http://schemas.microsoft.com/office/drawing/2014/main" id="{535EF5A2-164C-4369-885E-920AD7C43C27}"/>
+                <a16:creationId xmlns:a16="http://schemas.microsoft.com/office/drawing/2014/main" id="{539EBE5E-DEBB-44A0-A034-B6F73EF4CEEB}"/>
               </a:ext>
             </a:extLst>
           </p:cNvPr>
@@ -3804,7 +3804,7 @@
     </p:spTree>
     <p:extLst>
       <p:ext uri="{BB962C8B-B14F-4D97-AF65-F5344CB8AC3E}">
-        <p14:creationId xmlns:p14="http://schemas.microsoft.com/office/powerpoint/2010/main" val="1066750752"/>
+        <p14:creationId xmlns:p14="http://schemas.microsoft.com/office/powerpoint/2010/main" val="1667900142"/>
       </p:ext>
     </p:extLst>
   </p:cSld>
@@ -3828,7 +3828,7 @@
           <p:cNvPr id="1" name="">
             <a:extLst xmlns:a="http://schemas.openxmlformats.org/drawingml/2006/main">
               <a:ext uri="{FF2B5EF4-FFF2-40B4-BE49-F238E27FC236}">
-                <a16:creationId xmlns:a16="http://schemas.microsoft.com/office/drawing/2014/main" id="{9460F5F3-69B2-4B08-A870-D851B281D665}"/>
+                <a16:creationId xmlns:a16="http://schemas.microsoft.com/office/drawing/2014/main" id="{9F69CF4B-1142-4A01-BF08-E57825310E30}"/>
               </a:ext>
             </a:extLst>
           </p:cNvPr>
@@ -3863,7 +3863,7 @@
           <p:cNvPr id="2" name="">
             <a:extLst xmlns:a="http://schemas.openxmlformats.org/drawingml/2006/main">
               <a:ext uri="{FF2B5EF4-FFF2-40B4-BE49-F238E27FC236}">
-                <a16:creationId xmlns:a16="http://schemas.microsoft.com/office/drawing/2014/main" id="{0597E432-165E-43F5-A3FB-8EB7013A07F4}"/>
+                <a16:creationId xmlns:a16="http://schemas.microsoft.com/office/drawing/2014/main" id="{40BFC971-33BC-4F2B-8BFF-468EAAE47007}"/>
               </a:ext>
             </a:extLst>
           </p:cNvPr>
@@ -3898,7 +3898,7 @@
           <p:cNvPr id="3" name="">
             <a:extLst xmlns:a="http://schemas.openxmlformats.org/drawingml/2006/main">
               <a:ext uri="{FF2B5EF4-FFF2-40B4-BE49-F238E27FC236}">
-                <a16:creationId xmlns:a16="http://schemas.microsoft.com/office/drawing/2014/main" id="{EDBDA22F-9B28-467F-80A0-6D23DEADB195}"/>
+                <a16:creationId xmlns:a16="http://schemas.microsoft.com/office/drawing/2014/main" id="{BB64ADCF-E751-4A15-8811-553C2558BCA7}"/>
               </a:ext>
             </a:extLst>
           </p:cNvPr>
@@ -3962,7 +3962,7 @@
           <p:cNvPr id="4" name="">
             <a:extLst xmlns:a="http://schemas.openxmlformats.org/drawingml/2006/main">
               <a:ext uri="{FF2B5EF4-FFF2-40B4-BE49-F238E27FC236}">
-                <a16:creationId xmlns:a16="http://schemas.microsoft.com/office/drawing/2014/main" id="{AAA0064B-6071-4F2E-9B71-F831C4B72599}"/>
+                <a16:creationId xmlns:a16="http://schemas.microsoft.com/office/drawing/2014/main" id="{CC5AFCAA-DB47-425D-846F-6498C9371B55}"/>
               </a:ext>
             </a:extLst>
           </p:cNvPr>
@@ -4026,7 +4026,7 @@
           <p:cNvPr id="5" name="">
             <a:extLst xmlns:a="http://schemas.openxmlformats.org/drawingml/2006/main">
               <a:ext uri="{FF2B5EF4-FFF2-40B4-BE49-F238E27FC236}">
-                <a16:creationId xmlns:a16="http://schemas.microsoft.com/office/drawing/2014/main" id="{383FAC56-0C10-43B0-837D-7F8822B40D9B}"/>
+                <a16:creationId xmlns:a16="http://schemas.microsoft.com/office/drawing/2014/main" id="{EF180630-FC39-4A00-9317-A287AE6D15CD}"/>
               </a:ext>
             </a:extLst>
           </p:cNvPr>
@@ -4090,7 +4090,7 @@
           <p:cNvPr id="6" name="">
             <a:extLst xmlns:a="http://schemas.openxmlformats.org/drawingml/2006/main">
               <a:ext uri="{FF2B5EF4-FFF2-40B4-BE49-F238E27FC236}">
-                <a16:creationId xmlns:a16="http://schemas.microsoft.com/office/drawing/2014/main" id="{818BBE22-7236-4014-ADFB-D6A054EC117F}"/>
+                <a16:creationId xmlns:a16="http://schemas.microsoft.com/office/drawing/2014/main" id="{CF1078EF-4C53-49C5-8B01-1FC6512430EC}"/>
               </a:ext>
             </a:extLst>
           </p:cNvPr>
@@ -4154,7 +4154,7 @@
           <p:cNvPr id="7" name="">
             <a:extLst xmlns:a="http://schemas.openxmlformats.org/drawingml/2006/main">
               <a:ext uri="{FF2B5EF4-FFF2-40B4-BE49-F238E27FC236}">
-                <a16:creationId xmlns:a16="http://schemas.microsoft.com/office/drawing/2014/main" id="{C85F0A32-49B8-4971-827A-0BBD8F189C28}"/>
+                <a16:creationId xmlns:a16="http://schemas.microsoft.com/office/drawing/2014/main" id="{6A661449-2938-4649-84C8-8CF10A3670C2}"/>
               </a:ext>
             </a:extLst>
           </p:cNvPr>
@@ -4187,7 +4187,7 @@
           <p:cNvPr id="8" name="">
             <a:extLst xmlns:a="http://schemas.openxmlformats.org/drawingml/2006/main">
               <a:ext uri="{FF2B5EF4-FFF2-40B4-BE49-F238E27FC236}">
-                <a16:creationId xmlns:a16="http://schemas.microsoft.com/office/drawing/2014/main" id="{CD284E1B-8591-4721-9CCF-F7BC80976290}"/>
+                <a16:creationId xmlns:a16="http://schemas.microsoft.com/office/drawing/2014/main" id="{E1CE1D2F-A5A8-4C02-BEAA-F805419CCEFC}"/>
               </a:ext>
             </a:extLst>
           </p:cNvPr>
@@ -4251,7 +4251,7 @@
           <p:cNvPr id="9" name="">
             <a:extLst xmlns:a="http://schemas.openxmlformats.org/drawingml/2006/main">
               <a:ext uri="{FF2B5EF4-FFF2-40B4-BE49-F238E27FC236}">
-                <a16:creationId xmlns:a16="http://schemas.microsoft.com/office/drawing/2014/main" id="{E7797DF6-8208-41CF-B5F3-3478C524C013}"/>
+                <a16:creationId xmlns:a16="http://schemas.microsoft.com/office/drawing/2014/main" id="{60E20FB3-1A79-4B8F-BBE7-0F04AF61D77B}"/>
               </a:ext>
             </a:extLst>
           </p:cNvPr>
@@ -4315,7 +4315,7 @@
           <p:cNvPr id="10" name="">
             <a:extLst xmlns:a="http://schemas.openxmlformats.org/drawingml/2006/main">
               <a:ext uri="{FF2B5EF4-FFF2-40B4-BE49-F238E27FC236}">
-                <a16:creationId xmlns:a16="http://schemas.microsoft.com/office/drawing/2014/main" id="{B1800D4B-FFD8-46B9-9D78-7F3864107040}"/>
+                <a16:creationId xmlns:a16="http://schemas.microsoft.com/office/drawing/2014/main" id="{4C4D24AA-5654-4EB9-91C3-263370BF4CB0}"/>
               </a:ext>
             </a:extLst>
           </p:cNvPr>
@@ -4348,7 +4348,7 @@
           <p:cNvPr id="11" name="">
             <a:extLst xmlns:a="http://schemas.openxmlformats.org/drawingml/2006/main">
               <a:ext uri="{FF2B5EF4-FFF2-40B4-BE49-F238E27FC236}">
-                <a16:creationId xmlns:a16="http://schemas.microsoft.com/office/drawing/2014/main" id="{0B7B967B-1777-4F90-B94F-79B38CA8192C}"/>
+                <a16:creationId xmlns:a16="http://schemas.microsoft.com/office/drawing/2014/main" id="{2D85DAB1-6D96-486B-A646-62FC2DE7A745}"/>
               </a:ext>
             </a:extLst>
           </p:cNvPr>
@@ -4412,7 +4412,7 @@
           <p:cNvPr id="12" name="">
             <a:extLst xmlns:a="http://schemas.openxmlformats.org/drawingml/2006/main">
               <a:ext uri="{FF2B5EF4-FFF2-40B4-BE49-F238E27FC236}">
-                <a16:creationId xmlns:a16="http://schemas.microsoft.com/office/drawing/2014/main" id="{0FB9F361-26F9-4C27-93FA-0C70DA40B609}"/>
+                <a16:creationId xmlns:a16="http://schemas.microsoft.com/office/drawing/2014/main" id="{FF063BFB-E810-4A5B-88E8-82DC8CED59A0}"/>
               </a:ext>
             </a:extLst>
           </p:cNvPr>
@@ -4476,7 +4476,7 @@
           <p:cNvPr id="13" name="">
             <a:extLst xmlns:a="http://schemas.openxmlformats.org/drawingml/2006/main">
               <a:ext uri="{FF2B5EF4-FFF2-40B4-BE49-F238E27FC236}">
-                <a16:creationId xmlns:a16="http://schemas.microsoft.com/office/drawing/2014/main" id="{AE185080-A7DA-40C5-AB96-A472CFB7317B}"/>
+                <a16:creationId xmlns:a16="http://schemas.microsoft.com/office/drawing/2014/main" id="{E977F085-946B-44F4-A030-3E8D4020625F}"/>
               </a:ext>
             </a:extLst>
           </p:cNvPr>
@@ -4509,7 +4509,7 @@
           <p:cNvPr id="14" name="">
             <a:extLst xmlns:a="http://schemas.openxmlformats.org/drawingml/2006/main">
               <a:ext uri="{FF2B5EF4-FFF2-40B4-BE49-F238E27FC236}">
-                <a16:creationId xmlns:a16="http://schemas.microsoft.com/office/drawing/2014/main" id="{E8F0C111-2803-4ECD-835C-7F45A0F6B74D}"/>
+                <a16:creationId xmlns:a16="http://schemas.microsoft.com/office/drawing/2014/main" id="{703C1E56-62C4-424E-BBF3-15C8E44505AF}"/>
               </a:ext>
             </a:extLst>
           </p:cNvPr>
@@ -4573,7 +4573,7 @@
           <p:cNvPr id="15" name="">
             <a:extLst xmlns:a="http://schemas.openxmlformats.org/drawingml/2006/main">
               <a:ext uri="{FF2B5EF4-FFF2-40B4-BE49-F238E27FC236}">
-                <a16:creationId xmlns:a16="http://schemas.microsoft.com/office/drawing/2014/main" id="{8AC2D6F9-1ADD-4A08-8038-AB14E0217883}"/>
+                <a16:creationId xmlns:a16="http://schemas.microsoft.com/office/drawing/2014/main" id="{526DB75E-E85B-442B-BFC6-E24FDA002DC3}"/>
               </a:ext>
             </a:extLst>
           </p:cNvPr>
@@ -4627,7 +4627,7 @@
                 <a:ea typeface="Aptos"/>
                 <a:cs typeface="Aptos"/>
               </a:rPr>
-              <a:t>A closed protein cycle controlled by a verifier-gated agentic loop and Spanish producer approvals.</a:t>
+              <a:t>A closed protein cycle controlled by a verifier-gated agentic loop and clear producer approvals.</a:t>
             </a:r>
           </a:p>
         </p:txBody>
@@ -4637,7 +4637,7 @@
           <p:cNvPr id="16" name="">
             <a:extLst xmlns:a="http://schemas.openxmlformats.org/drawingml/2006/main">
               <a:ext uri="{FF2B5EF4-FFF2-40B4-BE49-F238E27FC236}">
-                <a16:creationId xmlns:a16="http://schemas.microsoft.com/office/drawing/2014/main" id="{B478FC38-AD26-4A3E-84AD-D9C5C1A5B484}"/>
+                <a16:creationId xmlns:a16="http://schemas.microsoft.com/office/drawing/2014/main" id="{94464458-D9F2-4E53-ACC3-F5D61BD7C027}"/>
               </a:ext>
             </a:extLst>
           </p:cNvPr>
@@ -4701,7 +4701,7 @@
           <p:cNvPr id="17" name="">
             <a:extLst xmlns:a="http://schemas.openxmlformats.org/drawingml/2006/main">
               <a:ext uri="{FF2B5EF4-FFF2-40B4-BE49-F238E27FC236}">
-                <a16:creationId xmlns:a16="http://schemas.microsoft.com/office/drawing/2014/main" id="{B4F6EDA4-8F4F-4C65-876B-C216BF95745E}"/>
+                <a16:creationId xmlns:a16="http://schemas.microsoft.com/office/drawing/2014/main" id="{A5B7B02C-D8E2-428E-A50D-B5A5210E2843}"/>
               </a:ext>
             </a:extLst>
           </p:cNvPr>
@@ -4763,7 +4763,7 @@
     </p:spTree>
     <p:extLst>
       <p:ext uri="{BB962C8B-B14F-4D97-AF65-F5344CB8AC3E}">
-        <p14:creationId xmlns:p14="http://schemas.microsoft.com/office/powerpoint/2010/main" val="333908311"/>
+        <p14:creationId xmlns:p14="http://schemas.microsoft.com/office/powerpoint/2010/main" val="1902378686"/>
       </p:ext>
     </p:extLst>
   </p:cSld>
@@ -4787,7 +4787,7 @@
           <p:cNvPr id="1" name="">
             <a:extLst xmlns:a="http://schemas.openxmlformats.org/drawingml/2006/main">
               <a:ext uri="{FF2B5EF4-FFF2-40B4-BE49-F238E27FC236}">
-                <a16:creationId xmlns:a16="http://schemas.microsoft.com/office/drawing/2014/main" id="{8C5C764C-62D9-4DD8-9749-9F02CC14FEED}"/>
+                <a16:creationId xmlns:a16="http://schemas.microsoft.com/office/drawing/2014/main" id="{684D52FB-942C-4C00-9FC7-D5551993AEF4}"/>
               </a:ext>
             </a:extLst>
           </p:cNvPr>
@@ -4822,7 +4822,7 @@
           <p:cNvPr id="2" name="">
             <a:extLst xmlns:a="http://schemas.openxmlformats.org/drawingml/2006/main">
               <a:ext uri="{FF2B5EF4-FFF2-40B4-BE49-F238E27FC236}">
-                <a16:creationId xmlns:a16="http://schemas.microsoft.com/office/drawing/2014/main" id="{6F3642EA-D0D1-480A-A07E-E9515C5F86C1}"/>
+                <a16:creationId xmlns:a16="http://schemas.microsoft.com/office/drawing/2014/main" id="{47F77D71-243D-490F-8995-4D4430B79693}"/>
               </a:ext>
             </a:extLst>
           </p:cNvPr>
@@ -4857,7 +4857,7 @@
           <p:cNvPr id="3" name="">
             <a:extLst xmlns:a="http://schemas.openxmlformats.org/drawingml/2006/main">
               <a:ext uri="{FF2B5EF4-FFF2-40B4-BE49-F238E27FC236}">
-                <a16:creationId xmlns:a16="http://schemas.microsoft.com/office/drawing/2014/main" id="{16DD1E59-746C-45D9-98CF-EB7307F5ADAA}"/>
+                <a16:creationId xmlns:a16="http://schemas.microsoft.com/office/drawing/2014/main" id="{CD9193A8-CFD4-488D-8BAC-F94C3CBE58CF}"/>
               </a:ext>
             </a:extLst>
           </p:cNvPr>
@@ -4921,7 +4921,7 @@
           <p:cNvPr id="4" name="">
             <a:extLst xmlns:a="http://schemas.openxmlformats.org/drawingml/2006/main">
               <a:ext uri="{FF2B5EF4-FFF2-40B4-BE49-F238E27FC236}">
-                <a16:creationId xmlns:a16="http://schemas.microsoft.com/office/drawing/2014/main" id="{229CBA7E-4A0A-42FD-9919-AACEF58A0637}"/>
+                <a16:creationId xmlns:a16="http://schemas.microsoft.com/office/drawing/2014/main" id="{6B590705-ED6D-436F-98FC-FCC552DD65B6}"/>
               </a:ext>
             </a:extLst>
           </p:cNvPr>
@@ -4985,7 +4985,7 @@
           <p:cNvPr id="5" name="">
             <a:extLst xmlns:a="http://schemas.openxmlformats.org/drawingml/2006/main">
               <a:ext uri="{FF2B5EF4-FFF2-40B4-BE49-F238E27FC236}">
-                <a16:creationId xmlns:a16="http://schemas.microsoft.com/office/drawing/2014/main" id="{433EC3A9-CAC3-4205-9F35-BD200C0D7C26}"/>
+                <a16:creationId xmlns:a16="http://schemas.microsoft.com/office/drawing/2014/main" id="{0F9FF02E-D6FE-4F46-AE90-6A2E17F6B1E0}"/>
               </a:ext>
             </a:extLst>
           </p:cNvPr>
@@ -5049,7 +5049,7 @@
           <p:cNvPr id="6" name="">
             <a:extLst xmlns:a="http://schemas.openxmlformats.org/drawingml/2006/main">
               <a:ext uri="{FF2B5EF4-FFF2-40B4-BE49-F238E27FC236}">
-                <a16:creationId xmlns:a16="http://schemas.microsoft.com/office/drawing/2014/main" id="{0B5EFE6A-7C76-471B-9D6C-6EAAC4C6131D}"/>
+                <a16:creationId xmlns:a16="http://schemas.microsoft.com/office/drawing/2014/main" id="{7FD12B3D-034A-4BCF-A2BD-D348B37E9543}"/>
               </a:ext>
             </a:extLst>
           </p:cNvPr>
@@ -5113,7 +5113,7 @@
           <p:cNvPr id="7" name="">
             <a:extLst xmlns:a="http://schemas.openxmlformats.org/drawingml/2006/main">
               <a:ext uri="{FF2B5EF4-FFF2-40B4-BE49-F238E27FC236}">
-                <a16:creationId xmlns:a16="http://schemas.microsoft.com/office/drawing/2014/main" id="{234059AE-77FC-4540-BAA4-23F0D95EF86C}"/>
+                <a16:creationId xmlns:a16="http://schemas.microsoft.com/office/drawing/2014/main" id="{473B9C85-4B1A-41E1-8B26-35B252B7CD18}"/>
               </a:ext>
             </a:extLst>
           </p:cNvPr>
@@ -5146,7 +5146,7 @@
           <p:cNvPr id="8" name="">
             <a:extLst xmlns:a="http://schemas.openxmlformats.org/drawingml/2006/main">
               <a:ext uri="{FF2B5EF4-FFF2-40B4-BE49-F238E27FC236}">
-                <a16:creationId xmlns:a16="http://schemas.microsoft.com/office/drawing/2014/main" id="{51F94C2E-9A08-4E1E-960E-5826C85310CE}"/>
+                <a16:creationId xmlns:a16="http://schemas.microsoft.com/office/drawing/2014/main" id="{900FF943-B582-4F3D-A486-267AC822B7C3}"/>
               </a:ext>
             </a:extLst>
           </p:cNvPr>
@@ -5210,7 +5210,7 @@
           <p:cNvPr id="9" name="">
             <a:extLst xmlns:a="http://schemas.openxmlformats.org/drawingml/2006/main">
               <a:ext uri="{FF2B5EF4-FFF2-40B4-BE49-F238E27FC236}">
-                <a16:creationId xmlns:a16="http://schemas.microsoft.com/office/drawing/2014/main" id="{1A632BCB-0EC5-440B-A6E2-52C5AF307BA0}"/>
+                <a16:creationId xmlns:a16="http://schemas.microsoft.com/office/drawing/2014/main" id="{33298D00-488A-4956-8023-9E1FF556A6CB}"/>
               </a:ext>
             </a:extLst>
           </p:cNvPr>
@@ -5274,7 +5274,7 @@
           <p:cNvPr id="10" name="">
             <a:extLst xmlns:a="http://schemas.openxmlformats.org/drawingml/2006/main">
               <a:ext uri="{FF2B5EF4-FFF2-40B4-BE49-F238E27FC236}">
-                <a16:creationId xmlns:a16="http://schemas.microsoft.com/office/drawing/2014/main" id="{0307FBC3-1AA3-4A39-B79D-82AD96A31754}"/>
+                <a16:creationId xmlns:a16="http://schemas.microsoft.com/office/drawing/2014/main" id="{521D8BD0-5BE2-4197-BC21-F636EA264331}"/>
               </a:ext>
             </a:extLst>
           </p:cNvPr>
@@ -5338,7 +5338,7 @@
           <p:cNvPr id="11" name="">
             <a:extLst xmlns:a="http://schemas.openxmlformats.org/drawingml/2006/main">
               <a:ext uri="{FF2B5EF4-FFF2-40B4-BE49-F238E27FC236}">
-                <a16:creationId xmlns:a16="http://schemas.microsoft.com/office/drawing/2014/main" id="{3F79CBF6-AE37-4726-BD5E-208D49579B22}"/>
+                <a16:creationId xmlns:a16="http://schemas.microsoft.com/office/drawing/2014/main" id="{DB4FE347-0EBD-4A19-B9DD-EEDED7F9F691}"/>
               </a:ext>
             </a:extLst>
           </p:cNvPr>
@@ -5371,7 +5371,7 @@
           <p:cNvPr id="12" name="">
             <a:extLst xmlns:a="http://schemas.openxmlformats.org/drawingml/2006/main">
               <a:ext uri="{FF2B5EF4-FFF2-40B4-BE49-F238E27FC236}">
-                <a16:creationId xmlns:a16="http://schemas.microsoft.com/office/drawing/2014/main" id="{30E855A0-F205-4CAE-A883-ABC18411A74B}"/>
+                <a16:creationId xmlns:a16="http://schemas.microsoft.com/office/drawing/2014/main" id="{521AEF52-C15E-4F51-81EE-0596C181D3B5}"/>
               </a:ext>
             </a:extLst>
           </p:cNvPr>
@@ -5435,7 +5435,7 @@
           <p:cNvPr id="13" name="">
             <a:extLst xmlns:a="http://schemas.openxmlformats.org/drawingml/2006/main">
               <a:ext uri="{FF2B5EF4-FFF2-40B4-BE49-F238E27FC236}">
-                <a16:creationId xmlns:a16="http://schemas.microsoft.com/office/drawing/2014/main" id="{FFBECFDC-6A1A-488A-901B-D448D923F980}"/>
+                <a16:creationId xmlns:a16="http://schemas.microsoft.com/office/drawing/2014/main" id="{05C774D4-0103-41A6-ACE2-310D838E95C3}"/>
               </a:ext>
             </a:extLst>
           </p:cNvPr>
@@ -5499,7 +5499,7 @@
           <p:cNvPr id="14" name="">
             <a:extLst xmlns:a="http://schemas.openxmlformats.org/drawingml/2006/main">
               <a:ext uri="{FF2B5EF4-FFF2-40B4-BE49-F238E27FC236}">
-                <a16:creationId xmlns:a16="http://schemas.microsoft.com/office/drawing/2014/main" id="{973AB47D-BA07-4208-9EA1-F4D00C7E26A3}"/>
+                <a16:creationId xmlns:a16="http://schemas.microsoft.com/office/drawing/2014/main" id="{8BA3A7D6-EE61-49D5-AB61-00339182C847}"/>
               </a:ext>
             </a:extLst>
           </p:cNvPr>
@@ -5563,7 +5563,7 @@
           <p:cNvPr id="15" name="">
             <a:extLst xmlns:a="http://schemas.openxmlformats.org/drawingml/2006/main">
               <a:ext uri="{FF2B5EF4-FFF2-40B4-BE49-F238E27FC236}">
-                <a16:creationId xmlns:a16="http://schemas.microsoft.com/office/drawing/2014/main" id="{35C0C05C-2EA8-4A64-9059-E234DF5357EF}"/>
+                <a16:creationId xmlns:a16="http://schemas.microsoft.com/office/drawing/2014/main" id="{3471FD29-A3DC-4521-ABBF-BE828F1A752D}"/>
               </a:ext>
             </a:extLst>
           </p:cNvPr>
@@ -5596,7 +5596,7 @@
           <p:cNvPr id="16" name="">
             <a:extLst xmlns:a="http://schemas.openxmlformats.org/drawingml/2006/main">
               <a:ext uri="{FF2B5EF4-FFF2-40B4-BE49-F238E27FC236}">
-                <a16:creationId xmlns:a16="http://schemas.microsoft.com/office/drawing/2014/main" id="{AF89E0EB-D9D3-4663-A03B-00F1DAD625FE}"/>
+                <a16:creationId xmlns:a16="http://schemas.microsoft.com/office/drawing/2014/main" id="{F05DA2A2-68C1-433A-9F80-92114F9934BE}"/>
               </a:ext>
             </a:extLst>
           </p:cNvPr>
@@ -5660,7 +5660,7 @@
           <p:cNvPr id="17" name="">
             <a:extLst xmlns:a="http://schemas.openxmlformats.org/drawingml/2006/main">
               <a:ext uri="{FF2B5EF4-FFF2-40B4-BE49-F238E27FC236}">
-                <a16:creationId xmlns:a16="http://schemas.microsoft.com/office/drawing/2014/main" id="{2C18E65E-0A29-4B5E-8C35-BF51FDF1548B}"/>
+                <a16:creationId xmlns:a16="http://schemas.microsoft.com/office/drawing/2014/main" id="{BBB37C22-7542-4CBA-B4C1-5F00A100A2EB}"/>
               </a:ext>
             </a:extLst>
           </p:cNvPr>
@@ -5724,7 +5724,7 @@
           <p:cNvPr id="18" name="">
             <a:extLst xmlns:a="http://schemas.openxmlformats.org/drawingml/2006/main">
               <a:ext uri="{FF2B5EF4-FFF2-40B4-BE49-F238E27FC236}">
-                <a16:creationId xmlns:a16="http://schemas.microsoft.com/office/drawing/2014/main" id="{F4C2512F-8943-459B-91B2-96B9A51BA42F}"/>
+                <a16:creationId xmlns:a16="http://schemas.microsoft.com/office/drawing/2014/main" id="{0534E370-EA41-40BA-81F7-A8C000618827}"/>
               </a:ext>
             </a:extLst>
           </p:cNvPr>
@@ -5788,7 +5788,7 @@
           <p:cNvPr id="19" name="">
             <a:extLst xmlns:a="http://schemas.openxmlformats.org/drawingml/2006/main">
               <a:ext uri="{FF2B5EF4-FFF2-40B4-BE49-F238E27FC236}">
-                <a16:creationId xmlns:a16="http://schemas.microsoft.com/office/drawing/2014/main" id="{B367648A-E025-4DED-8176-7DF56EDB5A9C}"/>
+                <a16:creationId xmlns:a16="http://schemas.microsoft.com/office/drawing/2014/main" id="{8C8093F9-E2C4-42BC-A8D4-1F6811F66F11}"/>
               </a:ext>
             </a:extLst>
           </p:cNvPr>
@@ -5821,7 +5821,7 @@
           <p:cNvPr id="20" name="">
             <a:extLst xmlns:a="http://schemas.openxmlformats.org/drawingml/2006/main">
               <a:ext uri="{FF2B5EF4-FFF2-40B4-BE49-F238E27FC236}">
-                <a16:creationId xmlns:a16="http://schemas.microsoft.com/office/drawing/2014/main" id="{7CB34E1D-C0CB-4F05-8DE8-CDD183D3083F}"/>
+                <a16:creationId xmlns:a16="http://schemas.microsoft.com/office/drawing/2014/main" id="{1D964805-D7BF-4062-8EF5-38F53E84B5F8}"/>
               </a:ext>
             </a:extLst>
           </p:cNvPr>
@@ -5885,7 +5885,7 @@
           <p:cNvPr id="21" name="">
             <a:extLst xmlns:a="http://schemas.openxmlformats.org/drawingml/2006/main">
               <a:ext uri="{FF2B5EF4-FFF2-40B4-BE49-F238E27FC236}">
-                <a16:creationId xmlns:a16="http://schemas.microsoft.com/office/drawing/2014/main" id="{3B88EFD5-2E6A-4647-940C-924F5ECCA335}"/>
+                <a16:creationId xmlns:a16="http://schemas.microsoft.com/office/drawing/2014/main" id="{640B0E92-835F-42E1-A555-2A788664E134}"/>
               </a:ext>
             </a:extLst>
           </p:cNvPr>
@@ -5949,7 +5949,7 @@
           <p:cNvPr id="22" name="">
             <a:extLst xmlns:a="http://schemas.openxmlformats.org/drawingml/2006/main">
               <a:ext uri="{FF2B5EF4-FFF2-40B4-BE49-F238E27FC236}">
-                <a16:creationId xmlns:a16="http://schemas.microsoft.com/office/drawing/2014/main" id="{A6736CCE-1716-4BBA-9062-3A5EEF405F4E}"/>
+                <a16:creationId xmlns:a16="http://schemas.microsoft.com/office/drawing/2014/main" id="{FA0E19AF-386D-450D-912D-0E62F6F00144}"/>
               </a:ext>
             </a:extLst>
           </p:cNvPr>
@@ -5982,7 +5982,7 @@
           <p:cNvPr id="23" name="">
             <a:extLst xmlns:a="http://schemas.openxmlformats.org/drawingml/2006/main">
               <a:ext uri="{FF2B5EF4-FFF2-40B4-BE49-F238E27FC236}">
-                <a16:creationId xmlns:a16="http://schemas.microsoft.com/office/drawing/2014/main" id="{BE052C3F-9B07-49CC-BA95-2B59338AB53B}"/>
+                <a16:creationId xmlns:a16="http://schemas.microsoft.com/office/drawing/2014/main" id="{3234A427-746E-46E8-9C1F-3132ED81D185}"/>
               </a:ext>
             </a:extLst>
           </p:cNvPr>
@@ -6046,7 +6046,7 @@
           <p:cNvPr id="24" name="">
             <a:extLst xmlns:a="http://schemas.openxmlformats.org/drawingml/2006/main">
               <a:ext uri="{FF2B5EF4-FFF2-40B4-BE49-F238E27FC236}">
-                <a16:creationId xmlns:a16="http://schemas.microsoft.com/office/drawing/2014/main" id="{D630BBB2-8442-4579-AED2-025C5BA8696E}"/>
+                <a16:creationId xmlns:a16="http://schemas.microsoft.com/office/drawing/2014/main" id="{48876379-48FB-4382-85C7-FE0AD95964C6}"/>
               </a:ext>
             </a:extLst>
           </p:cNvPr>
@@ -6110,7 +6110,7 @@
           <p:cNvPr id="25" name="">
             <a:extLst xmlns:a="http://schemas.openxmlformats.org/drawingml/2006/main">
               <a:ext uri="{FF2B5EF4-FFF2-40B4-BE49-F238E27FC236}">
-                <a16:creationId xmlns:a16="http://schemas.microsoft.com/office/drawing/2014/main" id="{387A81F9-284B-4B86-B592-E5F719210196}"/>
+                <a16:creationId xmlns:a16="http://schemas.microsoft.com/office/drawing/2014/main" id="{2756C30C-9CF8-4E67-8D98-DC944C57F4BC}"/>
               </a:ext>
             </a:extLst>
           </p:cNvPr>
@@ -6174,7 +6174,7 @@
           <p:cNvPr id="26" name="">
             <a:extLst xmlns:a="http://schemas.openxmlformats.org/drawingml/2006/main">
               <a:ext uri="{FF2B5EF4-FFF2-40B4-BE49-F238E27FC236}">
-                <a16:creationId xmlns:a16="http://schemas.microsoft.com/office/drawing/2014/main" id="{4AA3284F-B1BA-4874-A860-BF7661695809}"/>
+                <a16:creationId xmlns:a16="http://schemas.microsoft.com/office/drawing/2014/main" id="{A35A990E-5347-4B63-933A-639CFEF9B6FB}"/>
               </a:ext>
             </a:extLst>
           </p:cNvPr>
@@ -6236,7 +6236,7 @@
     </p:spTree>
     <p:extLst>
       <p:ext uri="{BB962C8B-B14F-4D97-AF65-F5344CB8AC3E}">
-        <p14:creationId xmlns:p14="http://schemas.microsoft.com/office/powerpoint/2010/main" val="964038635"/>
+        <p14:creationId xmlns:p14="http://schemas.microsoft.com/office/powerpoint/2010/main" val="1582187491"/>
       </p:ext>
     </p:extLst>
   </p:cSld>
@@ -6260,7 +6260,7 @@
           <p:cNvPr id="1" name="">
             <a:extLst xmlns:a="http://schemas.openxmlformats.org/drawingml/2006/main">
               <a:ext uri="{FF2B5EF4-FFF2-40B4-BE49-F238E27FC236}">
-                <a16:creationId xmlns:a16="http://schemas.microsoft.com/office/drawing/2014/main" id="{D8B3D23F-7CA1-4853-B2B4-007EED270B64}"/>
+                <a16:creationId xmlns:a16="http://schemas.microsoft.com/office/drawing/2014/main" id="{828D8A2A-522E-48B3-89D3-11142EF672E8}"/>
               </a:ext>
             </a:extLst>
           </p:cNvPr>
@@ -6295,7 +6295,7 @@
           <p:cNvPr id="2" name="">
             <a:extLst xmlns:a="http://schemas.openxmlformats.org/drawingml/2006/main">
               <a:ext uri="{FF2B5EF4-FFF2-40B4-BE49-F238E27FC236}">
-                <a16:creationId xmlns:a16="http://schemas.microsoft.com/office/drawing/2014/main" id="{D459BD3D-AC50-4FC6-A21D-7CE18073ECCF}"/>
+                <a16:creationId xmlns:a16="http://schemas.microsoft.com/office/drawing/2014/main" id="{49CD6A5D-368E-4910-A3B4-26662B796A38}"/>
               </a:ext>
             </a:extLst>
           </p:cNvPr>
@@ -6330,7 +6330,7 @@
           <p:cNvPr id="3" name="">
             <a:extLst xmlns:a="http://schemas.openxmlformats.org/drawingml/2006/main">
               <a:ext uri="{FF2B5EF4-FFF2-40B4-BE49-F238E27FC236}">
-                <a16:creationId xmlns:a16="http://schemas.microsoft.com/office/drawing/2014/main" id="{6258E937-2317-4388-B27B-8A8BF4A5D3BD}"/>
+                <a16:creationId xmlns:a16="http://schemas.microsoft.com/office/drawing/2014/main" id="{71FD0A63-8D15-45DB-8223-0DD433EDCCE5}"/>
               </a:ext>
             </a:extLst>
           </p:cNvPr>
@@ -6394,7 +6394,7 @@
           <p:cNvPr id="4" name="">
             <a:extLst xmlns:a="http://schemas.openxmlformats.org/drawingml/2006/main">
               <a:ext uri="{FF2B5EF4-FFF2-40B4-BE49-F238E27FC236}">
-                <a16:creationId xmlns:a16="http://schemas.microsoft.com/office/drawing/2014/main" id="{AEF28783-16F1-4DB4-AE82-8B33BBAD0C42}"/>
+                <a16:creationId xmlns:a16="http://schemas.microsoft.com/office/drawing/2014/main" id="{965017D3-B2D5-49C3-851F-1FC49AFB0E00}"/>
               </a:ext>
             </a:extLst>
           </p:cNvPr>
@@ -6458,7 +6458,7 @@
           <p:cNvPr id="5" name="">
             <a:extLst xmlns:a="http://schemas.openxmlformats.org/drawingml/2006/main">
               <a:ext uri="{FF2B5EF4-FFF2-40B4-BE49-F238E27FC236}">
-                <a16:creationId xmlns:a16="http://schemas.microsoft.com/office/drawing/2014/main" id="{858D48FE-E293-41CB-B05B-FE538C35D0F2}"/>
+                <a16:creationId xmlns:a16="http://schemas.microsoft.com/office/drawing/2014/main" id="{9B935E87-346B-48AD-90D1-E75B4C3084C7}"/>
               </a:ext>
             </a:extLst>
           </p:cNvPr>
@@ -6522,7 +6522,7 @@
           <p:cNvPr id="6" name="">
             <a:extLst xmlns:a="http://schemas.openxmlformats.org/drawingml/2006/main">
               <a:ext uri="{FF2B5EF4-FFF2-40B4-BE49-F238E27FC236}">
-                <a16:creationId xmlns:a16="http://schemas.microsoft.com/office/drawing/2014/main" id="{6806073A-4BB1-4F78-B6B9-E33D88594E8D}"/>
+                <a16:creationId xmlns:a16="http://schemas.microsoft.com/office/drawing/2014/main" id="{F8E34559-E55B-4DD4-83DE-2A86BB2BD022}"/>
               </a:ext>
             </a:extLst>
           </p:cNvPr>
@@ -6586,7 +6586,7 @@
           <p:cNvPr id="7" name="">
             <a:extLst xmlns:a="http://schemas.openxmlformats.org/drawingml/2006/main">
               <a:ext uri="{FF2B5EF4-FFF2-40B4-BE49-F238E27FC236}">
-                <a16:creationId xmlns:a16="http://schemas.microsoft.com/office/drawing/2014/main" id="{D89C0317-A0AF-4862-87AC-3CEE155939E0}"/>
+                <a16:creationId xmlns:a16="http://schemas.microsoft.com/office/drawing/2014/main" id="{6F2FFBD2-FAC8-457D-A3B9-4CFBF847AF26}"/>
               </a:ext>
             </a:extLst>
           </p:cNvPr>
@@ -6619,7 +6619,7 @@
           <p:cNvPr id="8" name="">
             <a:extLst xmlns:a="http://schemas.openxmlformats.org/drawingml/2006/main">
               <a:ext uri="{FF2B5EF4-FFF2-40B4-BE49-F238E27FC236}">
-                <a16:creationId xmlns:a16="http://schemas.microsoft.com/office/drawing/2014/main" id="{AA584DDA-C0E6-4CC0-9405-2F1CF8BEF059}"/>
+                <a16:creationId xmlns:a16="http://schemas.microsoft.com/office/drawing/2014/main" id="{E2DFE079-D382-4D0B-8F12-5A7377D93FF4}"/>
               </a:ext>
             </a:extLst>
           </p:cNvPr>
@@ -6683,7 +6683,7 @@
           <p:cNvPr id="9" name="">
             <a:extLst xmlns:a="http://schemas.openxmlformats.org/drawingml/2006/main">
               <a:ext uri="{FF2B5EF4-FFF2-40B4-BE49-F238E27FC236}">
-                <a16:creationId xmlns:a16="http://schemas.microsoft.com/office/drawing/2014/main" id="{A2F85E56-B734-400D-A029-271309BA9EDE}"/>
+                <a16:creationId xmlns:a16="http://schemas.microsoft.com/office/drawing/2014/main" id="{1E6EF5FC-F731-48FE-B4D5-2C40877363D2}"/>
               </a:ext>
             </a:extLst>
           </p:cNvPr>
@@ -6747,7 +6747,7 @@
           <p:cNvPr id="10" name="">
             <a:extLst xmlns:a="http://schemas.openxmlformats.org/drawingml/2006/main">
               <a:ext uri="{FF2B5EF4-FFF2-40B4-BE49-F238E27FC236}">
-                <a16:creationId xmlns:a16="http://schemas.microsoft.com/office/drawing/2014/main" id="{62922963-0C97-42E9-946E-7D33ED6771B9}"/>
+                <a16:creationId xmlns:a16="http://schemas.microsoft.com/office/drawing/2014/main" id="{57C6C4C7-BE03-4129-AD15-77444FF627FA}"/>
               </a:ext>
             </a:extLst>
           </p:cNvPr>
@@ -6811,7 +6811,7 @@
           <p:cNvPr id="11" name="">
             <a:extLst xmlns:a="http://schemas.openxmlformats.org/drawingml/2006/main">
               <a:ext uri="{FF2B5EF4-FFF2-40B4-BE49-F238E27FC236}">
-                <a16:creationId xmlns:a16="http://schemas.microsoft.com/office/drawing/2014/main" id="{9AF5A4DB-A77D-46BF-8C73-DE39C526CC83}"/>
+                <a16:creationId xmlns:a16="http://schemas.microsoft.com/office/drawing/2014/main" id="{E2E9BAC9-1B5E-4322-9657-C1AD2FCDC833}"/>
               </a:ext>
             </a:extLst>
           </p:cNvPr>
@@ -6844,7 +6844,7 @@
           <p:cNvPr id="12" name="">
             <a:extLst xmlns:a="http://schemas.openxmlformats.org/drawingml/2006/main">
               <a:ext uri="{FF2B5EF4-FFF2-40B4-BE49-F238E27FC236}">
-                <a16:creationId xmlns:a16="http://schemas.microsoft.com/office/drawing/2014/main" id="{830005E5-DD80-4E4D-AEC1-A648760CC8A8}"/>
+                <a16:creationId xmlns:a16="http://schemas.microsoft.com/office/drawing/2014/main" id="{CDFCAE96-1370-477A-994C-A0D5355CC5A2}"/>
               </a:ext>
             </a:extLst>
           </p:cNvPr>
@@ -6908,7 +6908,7 @@
           <p:cNvPr id="13" name="">
             <a:extLst xmlns:a="http://schemas.openxmlformats.org/drawingml/2006/main">
               <a:ext uri="{FF2B5EF4-FFF2-40B4-BE49-F238E27FC236}">
-                <a16:creationId xmlns:a16="http://schemas.microsoft.com/office/drawing/2014/main" id="{E871F3EC-C599-4D16-97BA-C8DB0373E68C}"/>
+                <a16:creationId xmlns:a16="http://schemas.microsoft.com/office/drawing/2014/main" id="{14BC5C2C-3B48-4AD9-A014-3421B567E8C2}"/>
               </a:ext>
             </a:extLst>
           </p:cNvPr>
@@ -6972,7 +6972,7 @@
           <p:cNvPr id="14" name="">
             <a:extLst xmlns:a="http://schemas.openxmlformats.org/drawingml/2006/main">
               <a:ext uri="{FF2B5EF4-FFF2-40B4-BE49-F238E27FC236}">
-                <a16:creationId xmlns:a16="http://schemas.microsoft.com/office/drawing/2014/main" id="{7725CFBC-BA95-4860-92B6-34201EDCF80C}"/>
+                <a16:creationId xmlns:a16="http://schemas.microsoft.com/office/drawing/2014/main" id="{87353F8F-72AF-4C1A-BF3D-357AF52C807F}"/>
               </a:ext>
             </a:extLst>
           </p:cNvPr>
@@ -7036,7 +7036,7 @@
           <p:cNvPr id="15" name="">
             <a:extLst xmlns:a="http://schemas.openxmlformats.org/drawingml/2006/main">
               <a:ext uri="{FF2B5EF4-FFF2-40B4-BE49-F238E27FC236}">
-                <a16:creationId xmlns:a16="http://schemas.microsoft.com/office/drawing/2014/main" id="{265C9F3E-89CF-4976-BC4A-13C24A4029BB}"/>
+                <a16:creationId xmlns:a16="http://schemas.microsoft.com/office/drawing/2014/main" id="{BBEF07C0-C3A7-44EB-B745-E87EE5EE572E}"/>
               </a:ext>
             </a:extLst>
           </p:cNvPr>
@@ -7069,7 +7069,7 @@
           <p:cNvPr id="16" name="">
             <a:extLst xmlns:a="http://schemas.openxmlformats.org/drawingml/2006/main">
               <a:ext uri="{FF2B5EF4-FFF2-40B4-BE49-F238E27FC236}">
-                <a16:creationId xmlns:a16="http://schemas.microsoft.com/office/drawing/2014/main" id="{4AF62595-0081-486C-AE47-6FDAED8A5A2C}"/>
+                <a16:creationId xmlns:a16="http://schemas.microsoft.com/office/drawing/2014/main" id="{0CDE3530-E41F-4745-8250-57EB22FE54FA}"/>
               </a:ext>
             </a:extLst>
           </p:cNvPr>
@@ -7133,7 +7133,7 @@
           <p:cNvPr id="17" name="">
             <a:extLst xmlns:a="http://schemas.openxmlformats.org/drawingml/2006/main">
               <a:ext uri="{FF2B5EF4-FFF2-40B4-BE49-F238E27FC236}">
-                <a16:creationId xmlns:a16="http://schemas.microsoft.com/office/drawing/2014/main" id="{7CF3B934-CECF-4D7D-BC10-149DE0E7892D}"/>
+                <a16:creationId xmlns:a16="http://schemas.microsoft.com/office/drawing/2014/main" id="{DC2B4AAE-1321-47A1-B66B-0A66E9F70F56}"/>
               </a:ext>
             </a:extLst>
           </p:cNvPr>
@@ -7197,7 +7197,7 @@
           <p:cNvPr id="18" name="">
             <a:extLst xmlns:a="http://schemas.openxmlformats.org/drawingml/2006/main">
               <a:ext uri="{FF2B5EF4-FFF2-40B4-BE49-F238E27FC236}">
-                <a16:creationId xmlns:a16="http://schemas.microsoft.com/office/drawing/2014/main" id="{22CF7A61-4F8C-4B36-843D-1A72B53E5174}"/>
+                <a16:creationId xmlns:a16="http://schemas.microsoft.com/office/drawing/2014/main" id="{3DC1F49D-C2DF-4F67-8232-A662E6BDFA2A}"/>
               </a:ext>
             </a:extLst>
           </p:cNvPr>
@@ -7261,7 +7261,7 @@
           <p:cNvPr id="19" name="">
             <a:extLst xmlns:a="http://schemas.openxmlformats.org/drawingml/2006/main">
               <a:ext uri="{FF2B5EF4-FFF2-40B4-BE49-F238E27FC236}">
-                <a16:creationId xmlns:a16="http://schemas.microsoft.com/office/drawing/2014/main" id="{3427DD97-CADB-4CBE-942D-5AE32A3A8C6A}"/>
+                <a16:creationId xmlns:a16="http://schemas.microsoft.com/office/drawing/2014/main" id="{74C29266-7416-4C4D-932E-0274847023D0}"/>
               </a:ext>
             </a:extLst>
           </p:cNvPr>
@@ -7294,7 +7294,7 @@
           <p:cNvPr id="20" name="">
             <a:extLst xmlns:a="http://schemas.openxmlformats.org/drawingml/2006/main">
               <a:ext uri="{FF2B5EF4-FFF2-40B4-BE49-F238E27FC236}">
-                <a16:creationId xmlns:a16="http://schemas.microsoft.com/office/drawing/2014/main" id="{118C3F16-15CA-4C01-942F-7B9B351FFD61}"/>
+                <a16:creationId xmlns:a16="http://schemas.microsoft.com/office/drawing/2014/main" id="{E2BC3438-DF2C-4FA0-B450-E63C8F722501}"/>
               </a:ext>
             </a:extLst>
           </p:cNvPr>
@@ -7358,7 +7358,7 @@
           <p:cNvPr id="21" name="">
             <a:extLst xmlns:a="http://schemas.openxmlformats.org/drawingml/2006/main">
               <a:ext uri="{FF2B5EF4-FFF2-40B4-BE49-F238E27FC236}">
-                <a16:creationId xmlns:a16="http://schemas.microsoft.com/office/drawing/2014/main" id="{9E9FB93D-66F7-4649-A935-6A357D1CCF16}"/>
+                <a16:creationId xmlns:a16="http://schemas.microsoft.com/office/drawing/2014/main" id="{9049EFD0-D970-47D1-AC0E-798889EC1DE6}"/>
               </a:ext>
             </a:extLst>
           </p:cNvPr>
@@ -7422,7 +7422,7 @@
           <p:cNvPr id="22" name="">
             <a:extLst xmlns:a="http://schemas.openxmlformats.org/drawingml/2006/main">
               <a:ext uri="{FF2B5EF4-FFF2-40B4-BE49-F238E27FC236}">
-                <a16:creationId xmlns:a16="http://schemas.microsoft.com/office/drawing/2014/main" id="{6E16B10F-E194-474E-95DD-061F2092464B}"/>
+                <a16:creationId xmlns:a16="http://schemas.microsoft.com/office/drawing/2014/main" id="{5424264F-2D54-4542-80F7-E526C095B339}"/>
               </a:ext>
             </a:extLst>
           </p:cNvPr>
@@ -7455,7 +7455,7 @@
           <p:cNvPr id="23" name="">
             <a:extLst xmlns:a="http://schemas.openxmlformats.org/drawingml/2006/main">
               <a:ext uri="{FF2B5EF4-FFF2-40B4-BE49-F238E27FC236}">
-                <a16:creationId xmlns:a16="http://schemas.microsoft.com/office/drawing/2014/main" id="{D64D19FB-29F2-4645-A8AA-D1219FC7762A}"/>
+                <a16:creationId xmlns:a16="http://schemas.microsoft.com/office/drawing/2014/main" id="{27F1C35F-14CC-4B53-9ACE-57D31290F7DA}"/>
               </a:ext>
             </a:extLst>
           </p:cNvPr>
@@ -7519,7 +7519,7 @@
           <p:cNvPr id="24" name="">
             <a:extLst xmlns:a="http://schemas.openxmlformats.org/drawingml/2006/main">
               <a:ext uri="{FF2B5EF4-FFF2-40B4-BE49-F238E27FC236}">
-                <a16:creationId xmlns:a16="http://schemas.microsoft.com/office/drawing/2014/main" id="{9BD60EF1-FD0F-405D-B16C-356D29DCEBCB}"/>
+                <a16:creationId xmlns:a16="http://schemas.microsoft.com/office/drawing/2014/main" id="{C8D92A32-9571-4AA3-B20D-F435B39D9025}"/>
               </a:ext>
             </a:extLst>
           </p:cNvPr>
@@ -7583,7 +7583,7 @@
           <p:cNvPr id="25" name="">
             <a:extLst xmlns:a="http://schemas.openxmlformats.org/drawingml/2006/main">
               <a:ext uri="{FF2B5EF4-FFF2-40B4-BE49-F238E27FC236}">
-                <a16:creationId xmlns:a16="http://schemas.microsoft.com/office/drawing/2014/main" id="{B71CCB84-57D7-4054-AA83-3A0E962BC329}"/>
+                <a16:creationId xmlns:a16="http://schemas.microsoft.com/office/drawing/2014/main" id="{0F9FB350-8586-4689-8603-6672D438B51B}"/>
               </a:ext>
             </a:extLst>
           </p:cNvPr>
@@ -7647,7 +7647,7 @@
           <p:cNvPr id="26" name="">
             <a:extLst xmlns:a="http://schemas.openxmlformats.org/drawingml/2006/main">
               <a:ext uri="{FF2B5EF4-FFF2-40B4-BE49-F238E27FC236}">
-                <a16:creationId xmlns:a16="http://schemas.microsoft.com/office/drawing/2014/main" id="{5C3A2452-8236-4417-9E3D-B6B9324B1C27}"/>
+                <a16:creationId xmlns:a16="http://schemas.microsoft.com/office/drawing/2014/main" id="{2C4E600C-4818-45FA-830C-6FCA689BFDE5}"/>
               </a:ext>
             </a:extLst>
           </p:cNvPr>
@@ -7709,7 +7709,7 @@
     </p:spTree>
     <p:extLst>
       <p:ext uri="{BB962C8B-B14F-4D97-AF65-F5344CB8AC3E}">
-        <p14:creationId xmlns:p14="http://schemas.microsoft.com/office/powerpoint/2010/main" val="2122032808"/>
+        <p14:creationId xmlns:p14="http://schemas.microsoft.com/office/powerpoint/2010/main" val="1473759217"/>
       </p:ext>
     </p:extLst>
   </p:cSld>
@@ -7733,7 +7733,7 @@
           <p:cNvPr id="1" name="">
             <a:extLst xmlns:a="http://schemas.openxmlformats.org/drawingml/2006/main">
               <a:ext uri="{FF2B5EF4-FFF2-40B4-BE49-F238E27FC236}">
-                <a16:creationId xmlns:a16="http://schemas.microsoft.com/office/drawing/2014/main" id="{070D2D39-1E25-4B43-B188-B2687702E65B}"/>
+                <a16:creationId xmlns:a16="http://schemas.microsoft.com/office/drawing/2014/main" id="{42D6205F-F975-4A8C-82C1-7668F1C3A913}"/>
               </a:ext>
             </a:extLst>
           </p:cNvPr>
@@ -7768,7 +7768,7 @@
           <p:cNvPr id="2" name="">
             <a:extLst xmlns:a="http://schemas.openxmlformats.org/drawingml/2006/main">
               <a:ext uri="{FF2B5EF4-FFF2-40B4-BE49-F238E27FC236}">
-                <a16:creationId xmlns:a16="http://schemas.microsoft.com/office/drawing/2014/main" id="{4B174FD8-5E52-4577-989B-E2324D6E873C}"/>
+                <a16:creationId xmlns:a16="http://schemas.microsoft.com/office/drawing/2014/main" id="{EC874679-4F6B-41B3-BF1C-43209EC69BDE}"/>
               </a:ext>
             </a:extLst>
           </p:cNvPr>
@@ -7803,7 +7803,7 @@
           <p:cNvPr id="3" name="">
             <a:extLst xmlns:a="http://schemas.openxmlformats.org/drawingml/2006/main">
               <a:ext uri="{FF2B5EF4-FFF2-40B4-BE49-F238E27FC236}">
-                <a16:creationId xmlns:a16="http://schemas.microsoft.com/office/drawing/2014/main" id="{8958D8D0-60DF-4972-B9B5-3BC7F0803048}"/>
+                <a16:creationId xmlns:a16="http://schemas.microsoft.com/office/drawing/2014/main" id="{DCC75074-A0C1-4739-B654-C113F0018F4C}"/>
               </a:ext>
             </a:extLst>
           </p:cNvPr>
@@ -7867,7 +7867,7 @@
           <p:cNvPr id="4" name="">
             <a:extLst xmlns:a="http://schemas.openxmlformats.org/drawingml/2006/main">
               <a:ext uri="{FF2B5EF4-FFF2-40B4-BE49-F238E27FC236}">
-                <a16:creationId xmlns:a16="http://schemas.microsoft.com/office/drawing/2014/main" id="{91A074B0-88B1-4675-AD65-2C9EE03D6DFE}"/>
+                <a16:creationId xmlns:a16="http://schemas.microsoft.com/office/drawing/2014/main" id="{F264C247-7772-48CD-8D12-2B14A9997785}"/>
               </a:ext>
             </a:extLst>
           </p:cNvPr>
@@ -7931,7 +7931,7 @@
           <p:cNvPr id="5" name="">
             <a:extLst xmlns:a="http://schemas.openxmlformats.org/drawingml/2006/main">
               <a:ext uri="{FF2B5EF4-FFF2-40B4-BE49-F238E27FC236}">
-                <a16:creationId xmlns:a16="http://schemas.microsoft.com/office/drawing/2014/main" id="{50809326-28D7-4347-B8F1-3670B89D48BB}"/>
+                <a16:creationId xmlns:a16="http://schemas.microsoft.com/office/drawing/2014/main" id="{BC4CA3D6-7698-4B1D-A8AB-7E05488F4CC4}"/>
               </a:ext>
             </a:extLst>
           </p:cNvPr>
@@ -7995,7 +7995,7 @@
           <p:cNvPr id="6" name="">
             <a:extLst xmlns:a="http://schemas.openxmlformats.org/drawingml/2006/main">
               <a:ext uri="{FF2B5EF4-FFF2-40B4-BE49-F238E27FC236}">
-                <a16:creationId xmlns:a16="http://schemas.microsoft.com/office/drawing/2014/main" id="{27D0F717-AA77-460A-A098-FF067534C45A}"/>
+                <a16:creationId xmlns:a16="http://schemas.microsoft.com/office/drawing/2014/main" id="{D7DA85BD-D70A-4DF8-AFE7-5AD3328C8B50}"/>
               </a:ext>
             </a:extLst>
           </p:cNvPr>
@@ -8059,7 +8059,7 @@
           <p:cNvPr id="7" name="">
             <a:extLst xmlns:a="http://schemas.openxmlformats.org/drawingml/2006/main">
               <a:ext uri="{FF2B5EF4-FFF2-40B4-BE49-F238E27FC236}">
-                <a16:creationId xmlns:a16="http://schemas.microsoft.com/office/drawing/2014/main" id="{8C19E0F2-8FB8-4CDB-9887-C8DD2477ECA8}"/>
+                <a16:creationId xmlns:a16="http://schemas.microsoft.com/office/drawing/2014/main" id="{43C8EB4E-09A3-4F4B-A164-3A79EFA651AB}"/>
               </a:ext>
             </a:extLst>
           </p:cNvPr>
@@ -8094,7 +8094,7 @@
           <p:cNvPr id="8" name="">
             <a:extLst xmlns:a="http://schemas.openxmlformats.org/drawingml/2006/main">
               <a:ext uri="{FF2B5EF4-FFF2-40B4-BE49-F238E27FC236}">
-                <a16:creationId xmlns:a16="http://schemas.microsoft.com/office/drawing/2014/main" id="{5EC1B59C-BC04-4028-8490-8F23B59805F1}"/>
+                <a16:creationId xmlns:a16="http://schemas.microsoft.com/office/drawing/2014/main" id="{282C52DD-F31E-4B35-94C9-00870FD2B7B3}"/>
               </a:ext>
             </a:extLst>
           </p:cNvPr>
@@ -8158,7 +8158,7 @@
           <p:cNvPr id="9" name="">
             <a:extLst xmlns:a="http://schemas.openxmlformats.org/drawingml/2006/main">
               <a:ext uri="{FF2B5EF4-FFF2-40B4-BE49-F238E27FC236}">
-                <a16:creationId xmlns:a16="http://schemas.microsoft.com/office/drawing/2014/main" id="{A6066AFD-5E46-4414-85CB-4A5F54C0FF70}"/>
+                <a16:creationId xmlns:a16="http://schemas.microsoft.com/office/drawing/2014/main" id="{B477A4A4-B38A-4721-8524-D955C81C6240}"/>
               </a:ext>
             </a:extLst>
           </p:cNvPr>
@@ -8222,7 +8222,7 @@
           <p:cNvPr id="10" name="">
             <a:extLst xmlns:a="http://schemas.openxmlformats.org/drawingml/2006/main">
               <a:ext uri="{FF2B5EF4-FFF2-40B4-BE49-F238E27FC236}">
-                <a16:creationId xmlns:a16="http://schemas.microsoft.com/office/drawing/2014/main" id="{DABC5F6E-2613-410F-B7E5-0AEBB8C71333}"/>
+                <a16:creationId xmlns:a16="http://schemas.microsoft.com/office/drawing/2014/main" id="{720848BE-863F-4B40-A142-DA727FD1512C}"/>
               </a:ext>
             </a:extLst>
           </p:cNvPr>
@@ -8286,7 +8286,7 @@
           <p:cNvPr id="11" name="">
             <a:extLst xmlns:a="http://schemas.openxmlformats.org/drawingml/2006/main">
               <a:ext uri="{FF2B5EF4-FFF2-40B4-BE49-F238E27FC236}">
-                <a16:creationId xmlns:a16="http://schemas.microsoft.com/office/drawing/2014/main" id="{FC827982-2CDD-4D65-9E7B-89B6B93643F3}"/>
+                <a16:creationId xmlns:a16="http://schemas.microsoft.com/office/drawing/2014/main" id="{D4229512-2F36-43A8-8E18-184095D48604}"/>
               </a:ext>
             </a:extLst>
           </p:cNvPr>
@@ -8321,7 +8321,7 @@
           <p:cNvPr id="12" name="">
             <a:extLst xmlns:a="http://schemas.openxmlformats.org/drawingml/2006/main">
               <a:ext uri="{FF2B5EF4-FFF2-40B4-BE49-F238E27FC236}">
-                <a16:creationId xmlns:a16="http://schemas.microsoft.com/office/drawing/2014/main" id="{AA6773F7-ACC7-4BFD-9E8A-B9E9C564EB4B}"/>
+                <a16:creationId xmlns:a16="http://schemas.microsoft.com/office/drawing/2014/main" id="{9AC4C389-3969-4CB0-BFEB-8B403289F85B}"/>
               </a:ext>
             </a:extLst>
           </p:cNvPr>
@@ -8385,7 +8385,7 @@
           <p:cNvPr id="13" name="">
             <a:extLst xmlns:a="http://schemas.openxmlformats.org/drawingml/2006/main">
               <a:ext uri="{FF2B5EF4-FFF2-40B4-BE49-F238E27FC236}">
-                <a16:creationId xmlns:a16="http://schemas.microsoft.com/office/drawing/2014/main" id="{BE22F96C-6FB3-4156-8434-4D93E3038D50}"/>
+                <a16:creationId xmlns:a16="http://schemas.microsoft.com/office/drawing/2014/main" id="{0F1E5D86-3725-42B0-9526-92E5E1864377}"/>
               </a:ext>
             </a:extLst>
           </p:cNvPr>
@@ -8449,7 +8449,7 @@
           <p:cNvPr id="14" name="">
             <a:extLst xmlns:a="http://schemas.openxmlformats.org/drawingml/2006/main">
               <a:ext uri="{FF2B5EF4-FFF2-40B4-BE49-F238E27FC236}">
-                <a16:creationId xmlns:a16="http://schemas.microsoft.com/office/drawing/2014/main" id="{DFF0F936-F571-4AA4-9D62-0F2EA7C269A9}"/>
+                <a16:creationId xmlns:a16="http://schemas.microsoft.com/office/drawing/2014/main" id="{15ED420C-A0FE-450A-9B1D-0BCB8F9022CF}"/>
               </a:ext>
             </a:extLst>
           </p:cNvPr>
@@ -8513,7 +8513,7 @@
           <p:cNvPr id="15" name="">
             <a:extLst xmlns:a="http://schemas.openxmlformats.org/drawingml/2006/main">
               <a:ext uri="{FF2B5EF4-FFF2-40B4-BE49-F238E27FC236}">
-                <a16:creationId xmlns:a16="http://schemas.microsoft.com/office/drawing/2014/main" id="{11DAB77B-223C-442D-B90A-C03A6EC9742F}"/>
+                <a16:creationId xmlns:a16="http://schemas.microsoft.com/office/drawing/2014/main" id="{E67A25F3-F00E-4D48-AAB5-38CE1577FD69}"/>
               </a:ext>
             </a:extLst>
           </p:cNvPr>
@@ -8548,7 +8548,7 @@
           <p:cNvPr id="16" name="">
             <a:extLst xmlns:a="http://schemas.openxmlformats.org/drawingml/2006/main">
               <a:ext uri="{FF2B5EF4-FFF2-40B4-BE49-F238E27FC236}">
-                <a16:creationId xmlns:a16="http://schemas.microsoft.com/office/drawing/2014/main" id="{9AE365F3-DB3C-4BFF-9104-0C2C1A51B891}"/>
+                <a16:creationId xmlns:a16="http://schemas.microsoft.com/office/drawing/2014/main" id="{DB69B9DC-E5C2-4A8A-A5CC-3E8A838E5BFC}"/>
               </a:ext>
             </a:extLst>
           </p:cNvPr>
@@ -8612,7 +8612,7 @@
           <p:cNvPr id="17" name="">
             <a:extLst xmlns:a="http://schemas.openxmlformats.org/drawingml/2006/main">
               <a:ext uri="{FF2B5EF4-FFF2-40B4-BE49-F238E27FC236}">
-                <a16:creationId xmlns:a16="http://schemas.microsoft.com/office/drawing/2014/main" id="{DECB4937-387F-4F1B-8FA1-5EAA62B7536C}"/>
+                <a16:creationId xmlns:a16="http://schemas.microsoft.com/office/drawing/2014/main" id="{C76C75AF-3FDC-4AA4-BE5F-CF82D190D510}"/>
               </a:ext>
             </a:extLst>
           </p:cNvPr>
@@ -8676,7 +8676,7 @@
           <p:cNvPr id="18" name="">
             <a:extLst xmlns:a="http://schemas.openxmlformats.org/drawingml/2006/main">
               <a:ext uri="{FF2B5EF4-FFF2-40B4-BE49-F238E27FC236}">
-                <a16:creationId xmlns:a16="http://schemas.microsoft.com/office/drawing/2014/main" id="{A678CB4F-3497-4DB7-86F4-F05F54D1620E}"/>
+                <a16:creationId xmlns:a16="http://schemas.microsoft.com/office/drawing/2014/main" id="{9934AA3A-4C16-4F06-9379-3308B77FC59B}"/>
               </a:ext>
             </a:extLst>
           </p:cNvPr>
@@ -8740,7 +8740,7 @@
           <p:cNvPr id="19" name="">
             <a:extLst xmlns:a="http://schemas.openxmlformats.org/drawingml/2006/main">
               <a:ext uri="{FF2B5EF4-FFF2-40B4-BE49-F238E27FC236}">
-                <a16:creationId xmlns:a16="http://schemas.microsoft.com/office/drawing/2014/main" id="{2D9E4BE9-1E60-41F6-9091-18404C6C5573}"/>
+                <a16:creationId xmlns:a16="http://schemas.microsoft.com/office/drawing/2014/main" id="{64729AB1-082E-4A3E-A668-C6D852D7B45E}"/>
               </a:ext>
             </a:extLst>
           </p:cNvPr>
@@ -8775,7 +8775,7 @@
           <p:cNvPr id="20" name="">
             <a:extLst xmlns:a="http://schemas.openxmlformats.org/drawingml/2006/main">
               <a:ext uri="{FF2B5EF4-FFF2-40B4-BE49-F238E27FC236}">
-                <a16:creationId xmlns:a16="http://schemas.microsoft.com/office/drawing/2014/main" id="{A22C70AD-98BD-449F-9EEF-A99B562D2D31}"/>
+                <a16:creationId xmlns:a16="http://schemas.microsoft.com/office/drawing/2014/main" id="{09C427F3-BCA0-4B50-B151-6FF3FD40F1C3}"/>
               </a:ext>
             </a:extLst>
           </p:cNvPr>
@@ -8839,7 +8839,7 @@
           <p:cNvPr id="21" name="">
             <a:extLst xmlns:a="http://schemas.openxmlformats.org/drawingml/2006/main">
               <a:ext uri="{FF2B5EF4-FFF2-40B4-BE49-F238E27FC236}">
-                <a16:creationId xmlns:a16="http://schemas.microsoft.com/office/drawing/2014/main" id="{0061C3AB-B396-45D6-A848-086C2B9BD89C}"/>
+                <a16:creationId xmlns:a16="http://schemas.microsoft.com/office/drawing/2014/main" id="{F91A1491-5C94-4034-8F68-219306E7170F}"/>
               </a:ext>
             </a:extLst>
           </p:cNvPr>
@@ -8903,7 +8903,7 @@
           <p:cNvPr id="22" name="">
             <a:extLst xmlns:a="http://schemas.openxmlformats.org/drawingml/2006/main">
               <a:ext uri="{FF2B5EF4-FFF2-40B4-BE49-F238E27FC236}">
-                <a16:creationId xmlns:a16="http://schemas.microsoft.com/office/drawing/2014/main" id="{43627D71-DFBE-4404-91D1-FFC5E4A1D7BA}"/>
+                <a16:creationId xmlns:a16="http://schemas.microsoft.com/office/drawing/2014/main" id="{DFA4EEF5-E7E5-441E-AAD2-486EAE048059}"/>
               </a:ext>
             </a:extLst>
           </p:cNvPr>
@@ -8967,7 +8967,7 @@
           <p:cNvPr id="23" name="">
             <a:extLst xmlns:a="http://schemas.openxmlformats.org/drawingml/2006/main">
               <a:ext uri="{FF2B5EF4-FFF2-40B4-BE49-F238E27FC236}">
-                <a16:creationId xmlns:a16="http://schemas.microsoft.com/office/drawing/2014/main" id="{740B9EFD-66B4-45A2-8C38-DF1BA6FA2740}"/>
+                <a16:creationId xmlns:a16="http://schemas.microsoft.com/office/drawing/2014/main" id="{C0892917-6914-449C-AFCA-6C38AE0EBDCA}"/>
               </a:ext>
             </a:extLst>
           </p:cNvPr>
@@ -9000,7 +9000,7 @@
           <p:cNvPr id="24" name="">
             <a:extLst xmlns:a="http://schemas.openxmlformats.org/drawingml/2006/main">
               <a:ext uri="{FF2B5EF4-FFF2-40B4-BE49-F238E27FC236}">
-                <a16:creationId xmlns:a16="http://schemas.microsoft.com/office/drawing/2014/main" id="{6CB911AA-122A-4129-93B4-D7CA52FDD4E0}"/>
+                <a16:creationId xmlns:a16="http://schemas.microsoft.com/office/drawing/2014/main" id="{DB0DD052-7F84-428B-993D-1CDD7054E938}"/>
               </a:ext>
             </a:extLst>
           </p:cNvPr>
@@ -9064,7 +9064,7 @@
           <p:cNvPr id="25" name="">
             <a:extLst xmlns:a="http://schemas.openxmlformats.org/drawingml/2006/main">
               <a:ext uri="{FF2B5EF4-FFF2-40B4-BE49-F238E27FC236}">
-                <a16:creationId xmlns:a16="http://schemas.microsoft.com/office/drawing/2014/main" id="{2E6A90EE-A656-40A7-9651-31721A5D9BC6}"/>
+                <a16:creationId xmlns:a16="http://schemas.microsoft.com/office/drawing/2014/main" id="{4DCDE5D7-13FE-400A-937C-94C210E9F476}"/>
               </a:ext>
             </a:extLst>
           </p:cNvPr>
@@ -9128,7 +9128,7 @@
           <p:cNvPr id="26" name="">
             <a:extLst xmlns:a="http://schemas.openxmlformats.org/drawingml/2006/main">
               <a:ext uri="{FF2B5EF4-FFF2-40B4-BE49-F238E27FC236}">
-                <a16:creationId xmlns:a16="http://schemas.microsoft.com/office/drawing/2014/main" id="{A421260F-1615-4E97-ACE4-ECC96BDB92BA}"/>
+                <a16:creationId xmlns:a16="http://schemas.microsoft.com/office/drawing/2014/main" id="{1EB5C058-E5A6-4199-AFC3-2586F92D62A7}"/>
               </a:ext>
             </a:extLst>
           </p:cNvPr>
@@ -9192,7 +9192,7 @@
           <p:cNvPr id="27" name="">
             <a:extLst xmlns:a="http://schemas.openxmlformats.org/drawingml/2006/main">
               <a:ext uri="{FF2B5EF4-FFF2-40B4-BE49-F238E27FC236}">
-                <a16:creationId xmlns:a16="http://schemas.microsoft.com/office/drawing/2014/main" id="{2CFC33A4-993F-4091-AF9A-C97EDE0E64EA}"/>
+                <a16:creationId xmlns:a16="http://schemas.microsoft.com/office/drawing/2014/main" id="{D50718F3-D65A-488D-A08F-FFEEB9A6522A}"/>
               </a:ext>
             </a:extLst>
           </p:cNvPr>
@@ -9254,7 +9254,7 @@
     </p:spTree>
     <p:extLst>
       <p:ext uri="{BB962C8B-B14F-4D97-AF65-F5344CB8AC3E}">
-        <p14:creationId xmlns:p14="http://schemas.microsoft.com/office/powerpoint/2010/main" val="1419229734"/>
+        <p14:creationId xmlns:p14="http://schemas.microsoft.com/office/powerpoint/2010/main" val="1574348199"/>
       </p:ext>
     </p:extLst>
   </p:cSld>
@@ -9278,7 +9278,7 @@
           <p:cNvPr id="1" name="">
             <a:extLst xmlns:a="http://schemas.openxmlformats.org/drawingml/2006/main">
               <a:ext uri="{FF2B5EF4-FFF2-40B4-BE49-F238E27FC236}">
-                <a16:creationId xmlns:a16="http://schemas.microsoft.com/office/drawing/2014/main" id="{C9C8F08B-D1B5-4741-BF20-18E76EA062C7}"/>
+                <a16:creationId xmlns:a16="http://schemas.microsoft.com/office/drawing/2014/main" id="{415BDA6D-A94E-447C-9DD9-F32DCE96AF7D}"/>
               </a:ext>
             </a:extLst>
           </p:cNvPr>
@@ -9313,7 +9313,7 @@
           <p:cNvPr id="2" name="">
             <a:extLst xmlns:a="http://schemas.openxmlformats.org/drawingml/2006/main">
               <a:ext uri="{FF2B5EF4-FFF2-40B4-BE49-F238E27FC236}">
-                <a16:creationId xmlns:a16="http://schemas.microsoft.com/office/drawing/2014/main" id="{6D3178DC-CD52-4C7C-808C-D6F6D40F8C12}"/>
+                <a16:creationId xmlns:a16="http://schemas.microsoft.com/office/drawing/2014/main" id="{90B5FDF0-A07D-4EC2-B966-219EE73A364B}"/>
               </a:ext>
             </a:extLst>
           </p:cNvPr>
@@ -9348,7 +9348,7 @@
           <p:cNvPr id="3" name="">
             <a:extLst xmlns:a="http://schemas.openxmlformats.org/drawingml/2006/main">
               <a:ext uri="{FF2B5EF4-FFF2-40B4-BE49-F238E27FC236}">
-                <a16:creationId xmlns:a16="http://schemas.microsoft.com/office/drawing/2014/main" id="{B7881E6C-7AA9-4D54-BF9B-7FFCA2F136DA}"/>
+                <a16:creationId xmlns:a16="http://schemas.microsoft.com/office/drawing/2014/main" id="{3088DC1E-F817-405A-9CE1-297F48EC7F7D}"/>
               </a:ext>
             </a:extLst>
           </p:cNvPr>
@@ -9412,7 +9412,7 @@
           <p:cNvPr id="4" name="">
             <a:extLst xmlns:a="http://schemas.openxmlformats.org/drawingml/2006/main">
               <a:ext uri="{FF2B5EF4-FFF2-40B4-BE49-F238E27FC236}">
-                <a16:creationId xmlns:a16="http://schemas.microsoft.com/office/drawing/2014/main" id="{939D4CCB-A8E9-43E0-85B9-81EFFB97F4C2}"/>
+                <a16:creationId xmlns:a16="http://schemas.microsoft.com/office/drawing/2014/main" id="{4409F2A7-28DD-4977-823D-686C4E9632E5}"/>
               </a:ext>
             </a:extLst>
           </p:cNvPr>
@@ -9476,7 +9476,7 @@
           <p:cNvPr id="5" name="">
             <a:extLst xmlns:a="http://schemas.openxmlformats.org/drawingml/2006/main">
               <a:ext uri="{FF2B5EF4-FFF2-40B4-BE49-F238E27FC236}">
-                <a16:creationId xmlns:a16="http://schemas.microsoft.com/office/drawing/2014/main" id="{2AC87297-D512-4BCE-BD80-91F2DD63A0AD}"/>
+                <a16:creationId xmlns:a16="http://schemas.microsoft.com/office/drawing/2014/main" id="{505003AA-4D72-4C3B-933F-EAD6C1F90187}"/>
               </a:ext>
             </a:extLst>
           </p:cNvPr>
@@ -9540,7 +9540,7 @@
           <p:cNvPr id="6" name="">
             <a:extLst xmlns:a="http://schemas.openxmlformats.org/drawingml/2006/main">
               <a:ext uri="{FF2B5EF4-FFF2-40B4-BE49-F238E27FC236}">
-                <a16:creationId xmlns:a16="http://schemas.microsoft.com/office/drawing/2014/main" id="{6EC3EBB0-1DC2-4FDF-8B6C-51D54F244F42}"/>
+                <a16:creationId xmlns:a16="http://schemas.microsoft.com/office/drawing/2014/main" id="{8D9E2F11-F82D-4095-BC19-13AD16C8E048}"/>
               </a:ext>
             </a:extLst>
           </p:cNvPr>
@@ -9604,7 +9604,7 @@
           <p:cNvPr id="7" name="">
             <a:extLst xmlns:a="http://schemas.openxmlformats.org/drawingml/2006/main">
               <a:ext uri="{FF2B5EF4-FFF2-40B4-BE49-F238E27FC236}">
-                <a16:creationId xmlns:a16="http://schemas.microsoft.com/office/drawing/2014/main" id="{816995C4-F490-48D3-B454-92F34EF45220}"/>
+                <a16:creationId xmlns:a16="http://schemas.microsoft.com/office/drawing/2014/main" id="{91C704BD-925B-4C58-A551-74E8CE4F55C0}"/>
               </a:ext>
             </a:extLst>
           </p:cNvPr>
@@ -9637,7 +9637,7 @@
           <p:cNvPr id="8" name="">
             <a:extLst xmlns:a="http://schemas.openxmlformats.org/drawingml/2006/main">
               <a:ext uri="{FF2B5EF4-FFF2-40B4-BE49-F238E27FC236}">
-                <a16:creationId xmlns:a16="http://schemas.microsoft.com/office/drawing/2014/main" id="{A8B20B8E-1EBB-48B6-B502-6CD5CB0605EB}"/>
+                <a16:creationId xmlns:a16="http://schemas.microsoft.com/office/drawing/2014/main" id="{CA2E688D-AE44-435C-A506-6FBCF82D9F87}"/>
               </a:ext>
             </a:extLst>
           </p:cNvPr>
@@ -9701,7 +9701,7 @@
           <p:cNvPr id="9" name="">
             <a:extLst xmlns:a="http://schemas.openxmlformats.org/drawingml/2006/main">
               <a:ext uri="{FF2B5EF4-FFF2-40B4-BE49-F238E27FC236}">
-                <a16:creationId xmlns:a16="http://schemas.microsoft.com/office/drawing/2014/main" id="{D17D9D4D-838B-448D-95D4-012D46ACF8B9}"/>
+                <a16:creationId xmlns:a16="http://schemas.microsoft.com/office/drawing/2014/main" id="{A6DE88A5-96A7-404D-8997-686F199944D4}"/>
               </a:ext>
             </a:extLst>
           </p:cNvPr>
@@ -9765,7 +9765,7 @@
           <p:cNvPr id="10" name="">
             <a:extLst xmlns:a="http://schemas.openxmlformats.org/drawingml/2006/main">
               <a:ext uri="{FF2B5EF4-FFF2-40B4-BE49-F238E27FC236}">
-                <a16:creationId xmlns:a16="http://schemas.microsoft.com/office/drawing/2014/main" id="{03A050FB-5481-4289-BB84-201214888F77}"/>
+                <a16:creationId xmlns:a16="http://schemas.microsoft.com/office/drawing/2014/main" id="{A71EEC70-3CB9-4618-B4D9-72B892445A04}"/>
               </a:ext>
             </a:extLst>
           </p:cNvPr>
@@ -9798,7 +9798,7 @@
           <p:cNvPr id="11" name="">
             <a:extLst xmlns:a="http://schemas.openxmlformats.org/drawingml/2006/main">
               <a:ext uri="{FF2B5EF4-FFF2-40B4-BE49-F238E27FC236}">
-                <a16:creationId xmlns:a16="http://schemas.microsoft.com/office/drawing/2014/main" id="{17B8F864-D0E9-4DE5-9258-1124C4A7A173}"/>
+                <a16:creationId xmlns:a16="http://schemas.microsoft.com/office/drawing/2014/main" id="{F3BA5736-189D-4E63-8BD4-263116DF3FAF}"/>
               </a:ext>
             </a:extLst>
           </p:cNvPr>
@@ -9862,7 +9862,7 @@
           <p:cNvPr id="12" name="">
             <a:extLst xmlns:a="http://schemas.openxmlformats.org/drawingml/2006/main">
               <a:ext uri="{FF2B5EF4-FFF2-40B4-BE49-F238E27FC236}">
-                <a16:creationId xmlns:a16="http://schemas.microsoft.com/office/drawing/2014/main" id="{400C46EC-6060-4F2C-857C-9887C8AF3C47}"/>
+                <a16:creationId xmlns:a16="http://schemas.microsoft.com/office/drawing/2014/main" id="{9AE4894E-E8B6-4780-BE2F-B0BC1C401C61}"/>
               </a:ext>
             </a:extLst>
           </p:cNvPr>
@@ -9926,7 +9926,7 @@
           <p:cNvPr id="13" name="">
             <a:extLst xmlns:a="http://schemas.openxmlformats.org/drawingml/2006/main">
               <a:ext uri="{FF2B5EF4-FFF2-40B4-BE49-F238E27FC236}">
-                <a16:creationId xmlns:a16="http://schemas.microsoft.com/office/drawing/2014/main" id="{DE2E15E3-1C34-4285-B1F6-9071B303FD88}"/>
+                <a16:creationId xmlns:a16="http://schemas.microsoft.com/office/drawing/2014/main" id="{21C5406D-3DCE-475A-844C-9C85500896A4}"/>
               </a:ext>
             </a:extLst>
           </p:cNvPr>
@@ -9959,7 +9959,7 @@
           <p:cNvPr id="14" name="">
             <a:extLst xmlns:a="http://schemas.openxmlformats.org/drawingml/2006/main">
               <a:ext uri="{FF2B5EF4-FFF2-40B4-BE49-F238E27FC236}">
-                <a16:creationId xmlns:a16="http://schemas.microsoft.com/office/drawing/2014/main" id="{F9C9C5F3-B81C-44A5-8BC7-4D3A21991C77}"/>
+                <a16:creationId xmlns:a16="http://schemas.microsoft.com/office/drawing/2014/main" id="{1D690D41-49F5-4D26-A2B0-EBEA2BF25970}"/>
               </a:ext>
             </a:extLst>
           </p:cNvPr>
@@ -10023,7 +10023,7 @@
           <p:cNvPr id="15" name="">
             <a:extLst xmlns:a="http://schemas.openxmlformats.org/drawingml/2006/main">
               <a:ext uri="{FF2B5EF4-FFF2-40B4-BE49-F238E27FC236}">
-                <a16:creationId xmlns:a16="http://schemas.microsoft.com/office/drawing/2014/main" id="{8F19967D-2752-41BD-B179-AB65936B3E17}"/>
+                <a16:creationId xmlns:a16="http://schemas.microsoft.com/office/drawing/2014/main" id="{E7991EB2-F94E-42FE-B111-D225AA4B54AF}"/>
               </a:ext>
             </a:extLst>
           </p:cNvPr>
@@ -10087,7 +10087,7 @@
           <p:cNvPr id="16" name="">
             <a:extLst xmlns:a="http://schemas.openxmlformats.org/drawingml/2006/main">
               <a:ext uri="{FF2B5EF4-FFF2-40B4-BE49-F238E27FC236}">
-                <a16:creationId xmlns:a16="http://schemas.microsoft.com/office/drawing/2014/main" id="{39A61BA1-F98A-4492-B16B-4EC36641E2D4}"/>
+                <a16:creationId xmlns:a16="http://schemas.microsoft.com/office/drawing/2014/main" id="{06CEC9DC-532C-4D75-B618-4D01C238471D}"/>
               </a:ext>
             </a:extLst>
           </p:cNvPr>
@@ -10151,7 +10151,7 @@
           <p:cNvPr id="17" name="">
             <a:extLst xmlns:a="http://schemas.openxmlformats.org/drawingml/2006/main">
               <a:ext uri="{FF2B5EF4-FFF2-40B4-BE49-F238E27FC236}">
-                <a16:creationId xmlns:a16="http://schemas.microsoft.com/office/drawing/2014/main" id="{DD0F86E0-39DB-4B0B-92B1-137C34E4D472}"/>
+                <a16:creationId xmlns:a16="http://schemas.microsoft.com/office/drawing/2014/main" id="{26671E49-6BE7-43E6-9493-11290FDB496E}"/>
               </a:ext>
             </a:extLst>
           </p:cNvPr>
@@ -10213,7 +10213,7 @@
     </p:spTree>
     <p:extLst>
       <p:ext uri="{BB962C8B-B14F-4D97-AF65-F5344CB8AC3E}">
-        <p14:creationId xmlns:p14="http://schemas.microsoft.com/office/powerpoint/2010/main" val="300073077"/>
+        <p14:creationId xmlns:p14="http://schemas.microsoft.com/office/powerpoint/2010/main" val="95733791"/>
       </p:ext>
     </p:extLst>
   </p:cSld>
@@ -10237,7 +10237,7 @@
           <p:cNvPr id="1" name="">
             <a:extLst xmlns:a="http://schemas.openxmlformats.org/drawingml/2006/main">
               <a:ext uri="{FF2B5EF4-FFF2-40B4-BE49-F238E27FC236}">
-                <a16:creationId xmlns:a16="http://schemas.microsoft.com/office/drawing/2014/main" id="{CDDE13C3-E7A0-46DD-8A63-EA0EEB2A95A4}"/>
+                <a16:creationId xmlns:a16="http://schemas.microsoft.com/office/drawing/2014/main" id="{F179A96B-BDCC-486E-B3EC-94033F9B2681}"/>
               </a:ext>
             </a:extLst>
           </p:cNvPr>
@@ -10272,7 +10272,7 @@
           <p:cNvPr id="2" name="">
             <a:extLst xmlns:a="http://schemas.openxmlformats.org/drawingml/2006/main">
               <a:ext uri="{FF2B5EF4-FFF2-40B4-BE49-F238E27FC236}">
-                <a16:creationId xmlns:a16="http://schemas.microsoft.com/office/drawing/2014/main" id="{08A08557-8CA2-4BD6-8B2B-42AF09CCD322}"/>
+                <a16:creationId xmlns:a16="http://schemas.microsoft.com/office/drawing/2014/main" id="{C08CFD60-7EDB-4929-8CFE-3A9AF8BF7DEF}"/>
               </a:ext>
             </a:extLst>
           </p:cNvPr>
@@ -10307,7 +10307,7 @@
           <p:cNvPr id="3" name="">
             <a:extLst xmlns:a="http://schemas.openxmlformats.org/drawingml/2006/main">
               <a:ext uri="{FF2B5EF4-FFF2-40B4-BE49-F238E27FC236}">
-                <a16:creationId xmlns:a16="http://schemas.microsoft.com/office/drawing/2014/main" id="{E85A6108-F672-4525-B8A4-10067D616EE5}"/>
+                <a16:creationId xmlns:a16="http://schemas.microsoft.com/office/drawing/2014/main" id="{085D67BD-C3DC-4FF3-880B-0B5BEF1A0D73}"/>
               </a:ext>
             </a:extLst>
           </p:cNvPr>
@@ -10371,7 +10371,7 @@
           <p:cNvPr id="4" name="">
             <a:extLst xmlns:a="http://schemas.openxmlformats.org/drawingml/2006/main">
               <a:ext uri="{FF2B5EF4-FFF2-40B4-BE49-F238E27FC236}">
-                <a16:creationId xmlns:a16="http://schemas.microsoft.com/office/drawing/2014/main" id="{2BD9CC9E-27A1-4D4A-8AB8-FC8D3969BB0B}"/>
+                <a16:creationId xmlns:a16="http://schemas.microsoft.com/office/drawing/2014/main" id="{6BB96327-B6DE-473B-80FE-3665EB32D9C1}"/>
               </a:ext>
             </a:extLst>
           </p:cNvPr>
@@ -10435,7 +10435,7 @@
           <p:cNvPr id="5" name="">
             <a:extLst xmlns:a="http://schemas.openxmlformats.org/drawingml/2006/main">
               <a:ext uri="{FF2B5EF4-FFF2-40B4-BE49-F238E27FC236}">
-                <a16:creationId xmlns:a16="http://schemas.microsoft.com/office/drawing/2014/main" id="{4FC97D41-981A-431D-AD3F-2266E5670C7C}"/>
+                <a16:creationId xmlns:a16="http://schemas.microsoft.com/office/drawing/2014/main" id="{D57DC076-8BDB-47A5-9F75-36A658C4AF33}"/>
               </a:ext>
             </a:extLst>
           </p:cNvPr>
@@ -10499,7 +10499,7 @@
           <p:cNvPr id="6" name="">
             <a:extLst xmlns:a="http://schemas.openxmlformats.org/drawingml/2006/main">
               <a:ext uri="{FF2B5EF4-FFF2-40B4-BE49-F238E27FC236}">
-                <a16:creationId xmlns:a16="http://schemas.microsoft.com/office/drawing/2014/main" id="{26D2D3AB-7392-4C5D-9FC4-81FD078BDDB6}"/>
+                <a16:creationId xmlns:a16="http://schemas.microsoft.com/office/drawing/2014/main" id="{8F6A02D4-AC8C-4099-B88B-12F46BE40BAA}"/>
               </a:ext>
             </a:extLst>
           </p:cNvPr>
@@ -10563,7 +10563,7 @@
           <p:cNvPr id="7" name="">
             <a:extLst xmlns:a="http://schemas.openxmlformats.org/drawingml/2006/main">
               <a:ext uri="{FF2B5EF4-FFF2-40B4-BE49-F238E27FC236}">
-                <a16:creationId xmlns:a16="http://schemas.microsoft.com/office/drawing/2014/main" id="{B26BB2E5-A94C-4619-9657-91550CF6A6A9}"/>
+                <a16:creationId xmlns:a16="http://schemas.microsoft.com/office/drawing/2014/main" id="{4EDE4A83-9906-4CA5-BDAB-E63ADE359A57}"/>
               </a:ext>
             </a:extLst>
           </p:cNvPr>
@@ -10596,7 +10596,7 @@
           <p:cNvPr id="8" name="">
             <a:extLst xmlns:a="http://schemas.openxmlformats.org/drawingml/2006/main">
               <a:ext uri="{FF2B5EF4-FFF2-40B4-BE49-F238E27FC236}">
-                <a16:creationId xmlns:a16="http://schemas.microsoft.com/office/drawing/2014/main" id="{44F177E3-5567-4416-AB60-2592FF9B8F80}"/>
+                <a16:creationId xmlns:a16="http://schemas.microsoft.com/office/drawing/2014/main" id="{04978B3A-D203-42E9-BED7-4E8C6C868DFF}"/>
               </a:ext>
             </a:extLst>
           </p:cNvPr>
@@ -10660,7 +10660,7 @@
           <p:cNvPr id="9" name="">
             <a:extLst xmlns:a="http://schemas.openxmlformats.org/drawingml/2006/main">
               <a:ext uri="{FF2B5EF4-FFF2-40B4-BE49-F238E27FC236}">
-                <a16:creationId xmlns:a16="http://schemas.microsoft.com/office/drawing/2014/main" id="{6FC2818F-74BB-41A0-BEB3-826188E45279}"/>
+                <a16:creationId xmlns:a16="http://schemas.microsoft.com/office/drawing/2014/main" id="{757CD545-C45E-48DD-A245-25A933747760}"/>
               </a:ext>
             </a:extLst>
           </p:cNvPr>
@@ -10724,7 +10724,7 @@
           <p:cNvPr id="10" name="">
             <a:extLst xmlns:a="http://schemas.openxmlformats.org/drawingml/2006/main">
               <a:ext uri="{FF2B5EF4-FFF2-40B4-BE49-F238E27FC236}">
-                <a16:creationId xmlns:a16="http://schemas.microsoft.com/office/drawing/2014/main" id="{B7DCB3E6-8AFE-4B35-866A-B45A155F1F33}"/>
+                <a16:creationId xmlns:a16="http://schemas.microsoft.com/office/drawing/2014/main" id="{19F41146-FF16-491F-AC74-57C769983998}"/>
               </a:ext>
             </a:extLst>
           </p:cNvPr>
@@ -10788,7 +10788,7 @@
           <p:cNvPr id="11" name="">
             <a:extLst xmlns:a="http://schemas.openxmlformats.org/drawingml/2006/main">
               <a:ext uri="{FF2B5EF4-FFF2-40B4-BE49-F238E27FC236}">
-                <a16:creationId xmlns:a16="http://schemas.microsoft.com/office/drawing/2014/main" id="{44413A7A-753E-4BDE-BD5F-FD5A50908CA9}"/>
+                <a16:creationId xmlns:a16="http://schemas.microsoft.com/office/drawing/2014/main" id="{776AC6A3-6DBD-4C43-871E-25E43DABF368}"/>
               </a:ext>
             </a:extLst>
           </p:cNvPr>
@@ -10821,7 +10821,7 @@
           <p:cNvPr id="12" name="">
             <a:extLst xmlns:a="http://schemas.openxmlformats.org/drawingml/2006/main">
               <a:ext uri="{FF2B5EF4-FFF2-40B4-BE49-F238E27FC236}">
-                <a16:creationId xmlns:a16="http://schemas.microsoft.com/office/drawing/2014/main" id="{1CB9F0BA-3365-4EC3-8BFD-09A124E76140}"/>
+                <a16:creationId xmlns:a16="http://schemas.microsoft.com/office/drawing/2014/main" id="{8FE9BA65-833C-4C7E-8884-90FAA9B2A305}"/>
               </a:ext>
             </a:extLst>
           </p:cNvPr>
@@ -10885,7 +10885,7 @@
           <p:cNvPr id="13" name="">
             <a:extLst xmlns:a="http://schemas.openxmlformats.org/drawingml/2006/main">
               <a:ext uri="{FF2B5EF4-FFF2-40B4-BE49-F238E27FC236}">
-                <a16:creationId xmlns:a16="http://schemas.microsoft.com/office/drawing/2014/main" id="{5C5C99F2-03FB-42E0-ADD5-EE0AE789A940}"/>
+                <a16:creationId xmlns:a16="http://schemas.microsoft.com/office/drawing/2014/main" id="{07A4FE27-C1AD-4BC9-9A40-8BB06EDDA5F4}"/>
               </a:ext>
             </a:extLst>
           </p:cNvPr>
@@ -10949,7 +10949,7 @@
           <p:cNvPr id="14" name="">
             <a:extLst xmlns:a="http://schemas.openxmlformats.org/drawingml/2006/main">
               <a:ext uri="{FF2B5EF4-FFF2-40B4-BE49-F238E27FC236}">
-                <a16:creationId xmlns:a16="http://schemas.microsoft.com/office/drawing/2014/main" id="{2F79C328-81E9-454C-B80F-8AE847A31146}"/>
+                <a16:creationId xmlns:a16="http://schemas.microsoft.com/office/drawing/2014/main" id="{5D3847C5-9061-408E-9834-96BFEDCA8987}"/>
               </a:ext>
             </a:extLst>
           </p:cNvPr>
@@ -11013,7 +11013,7 @@
           <p:cNvPr id="15" name="">
             <a:extLst xmlns:a="http://schemas.openxmlformats.org/drawingml/2006/main">
               <a:ext uri="{FF2B5EF4-FFF2-40B4-BE49-F238E27FC236}">
-                <a16:creationId xmlns:a16="http://schemas.microsoft.com/office/drawing/2014/main" id="{0D55853F-C249-4EC1-BFEB-5FBFBC0FE19A}"/>
+                <a16:creationId xmlns:a16="http://schemas.microsoft.com/office/drawing/2014/main" id="{66125BE1-DA56-4C42-AAB1-E891FFABA771}"/>
               </a:ext>
             </a:extLst>
           </p:cNvPr>
@@ -11046,7 +11046,7 @@
           <p:cNvPr id="16" name="">
             <a:extLst xmlns:a="http://schemas.openxmlformats.org/drawingml/2006/main">
               <a:ext uri="{FF2B5EF4-FFF2-40B4-BE49-F238E27FC236}">
-                <a16:creationId xmlns:a16="http://schemas.microsoft.com/office/drawing/2014/main" id="{604BE56B-7B27-4F6C-B4A3-E727839D720D}"/>
+                <a16:creationId xmlns:a16="http://schemas.microsoft.com/office/drawing/2014/main" id="{23C71904-0557-4143-B98B-071913F4F1B7}"/>
               </a:ext>
             </a:extLst>
           </p:cNvPr>
@@ -11110,7 +11110,7 @@
           <p:cNvPr id="17" name="">
             <a:extLst xmlns:a="http://schemas.openxmlformats.org/drawingml/2006/main">
               <a:ext uri="{FF2B5EF4-FFF2-40B4-BE49-F238E27FC236}">
-                <a16:creationId xmlns:a16="http://schemas.microsoft.com/office/drawing/2014/main" id="{AFF17C80-F39C-4655-8EF4-9319E4AD3503}"/>
+                <a16:creationId xmlns:a16="http://schemas.microsoft.com/office/drawing/2014/main" id="{1C064701-64FE-49C2-AD7C-D43AC8F92E51}"/>
               </a:ext>
             </a:extLst>
           </p:cNvPr>
@@ -11174,7 +11174,7 @@
           <p:cNvPr id="18" name="">
             <a:extLst xmlns:a="http://schemas.openxmlformats.org/drawingml/2006/main">
               <a:ext uri="{FF2B5EF4-FFF2-40B4-BE49-F238E27FC236}">
-                <a16:creationId xmlns:a16="http://schemas.microsoft.com/office/drawing/2014/main" id="{7E369C73-EEEA-4A2E-8FC3-110D0E323407}"/>
+                <a16:creationId xmlns:a16="http://schemas.microsoft.com/office/drawing/2014/main" id="{48D5E342-5407-49DF-8899-732E2C064818}"/>
               </a:ext>
             </a:extLst>
           </p:cNvPr>
@@ -11207,7 +11207,7 @@
           <p:cNvPr id="19" name="">
             <a:extLst xmlns:a="http://schemas.openxmlformats.org/drawingml/2006/main">
               <a:ext uri="{FF2B5EF4-FFF2-40B4-BE49-F238E27FC236}">
-                <a16:creationId xmlns:a16="http://schemas.microsoft.com/office/drawing/2014/main" id="{EA1673E7-DD8B-4B56-ABF5-4D7519CB63E1}"/>
+                <a16:creationId xmlns:a16="http://schemas.microsoft.com/office/drawing/2014/main" id="{183984DA-0AB1-4399-9FBE-6FE7CF18C3CC}"/>
               </a:ext>
             </a:extLst>
           </p:cNvPr>
@@ -11271,7 +11271,7 @@
           <p:cNvPr id="20" name="">
             <a:extLst xmlns:a="http://schemas.openxmlformats.org/drawingml/2006/main">
               <a:ext uri="{FF2B5EF4-FFF2-40B4-BE49-F238E27FC236}">
-                <a16:creationId xmlns:a16="http://schemas.microsoft.com/office/drawing/2014/main" id="{E25ECF3F-30DC-4090-A568-A41DC9F7F958}"/>
+                <a16:creationId xmlns:a16="http://schemas.microsoft.com/office/drawing/2014/main" id="{56BAD3CA-88B1-4E38-A668-4056CED15E59}"/>
               </a:ext>
             </a:extLst>
           </p:cNvPr>
@@ -11335,7 +11335,7 @@
           <p:cNvPr id="21" name="">
             <a:extLst xmlns:a="http://schemas.openxmlformats.org/drawingml/2006/main">
               <a:ext uri="{FF2B5EF4-FFF2-40B4-BE49-F238E27FC236}">
-                <a16:creationId xmlns:a16="http://schemas.microsoft.com/office/drawing/2014/main" id="{7AA9352F-47D0-4813-9D9B-850F58C85D1D}"/>
+                <a16:creationId xmlns:a16="http://schemas.microsoft.com/office/drawing/2014/main" id="{EE4F1E4A-3AA8-4445-A4E6-71A861FC36D8}"/>
               </a:ext>
             </a:extLst>
           </p:cNvPr>
@@ -11368,7 +11368,7 @@
           <p:cNvPr id="22" name="">
             <a:extLst xmlns:a="http://schemas.openxmlformats.org/drawingml/2006/main">
               <a:ext uri="{FF2B5EF4-FFF2-40B4-BE49-F238E27FC236}">
-                <a16:creationId xmlns:a16="http://schemas.microsoft.com/office/drawing/2014/main" id="{BCE1A745-FE09-4B18-AA3A-8DA914680AC8}"/>
+                <a16:creationId xmlns:a16="http://schemas.microsoft.com/office/drawing/2014/main" id="{5F136D76-3522-49D7-8E3E-782CDE3CB4E1}"/>
               </a:ext>
             </a:extLst>
           </p:cNvPr>
@@ -11432,7 +11432,7 @@
           <p:cNvPr id="23" name="">
             <a:extLst xmlns:a="http://schemas.openxmlformats.org/drawingml/2006/main">
               <a:ext uri="{FF2B5EF4-FFF2-40B4-BE49-F238E27FC236}">
-                <a16:creationId xmlns:a16="http://schemas.microsoft.com/office/drawing/2014/main" id="{A856E6AC-FE34-46A3-AA4A-70608FA3AF23}"/>
+                <a16:creationId xmlns:a16="http://schemas.microsoft.com/office/drawing/2014/main" id="{BEB46DB2-B71B-4D80-A8EC-74C711B25446}"/>
               </a:ext>
             </a:extLst>
           </p:cNvPr>
@@ -11496,7 +11496,7 @@
           <p:cNvPr id="24" name="">
             <a:extLst xmlns:a="http://schemas.openxmlformats.org/drawingml/2006/main">
               <a:ext uri="{FF2B5EF4-FFF2-40B4-BE49-F238E27FC236}">
-                <a16:creationId xmlns:a16="http://schemas.microsoft.com/office/drawing/2014/main" id="{E7052181-5099-44DA-92B8-3AFD046EDE67}"/>
+                <a16:creationId xmlns:a16="http://schemas.microsoft.com/office/drawing/2014/main" id="{166F1206-A653-4540-81D4-BF95A76DA245}"/>
               </a:ext>
             </a:extLst>
           </p:cNvPr>
@@ -11560,7 +11560,7 @@
           <p:cNvPr id="25" name="">
             <a:extLst xmlns:a="http://schemas.openxmlformats.org/drawingml/2006/main">
               <a:ext uri="{FF2B5EF4-FFF2-40B4-BE49-F238E27FC236}">
-                <a16:creationId xmlns:a16="http://schemas.microsoft.com/office/drawing/2014/main" id="{A9731041-9279-450C-BD57-0163D269BE5E}"/>
+                <a16:creationId xmlns:a16="http://schemas.microsoft.com/office/drawing/2014/main" id="{6BAA09A6-CB67-40A3-BAE5-21F837E6EDD0}"/>
               </a:ext>
             </a:extLst>
           </p:cNvPr>
@@ -11622,7 +11622,7 @@
     </p:spTree>
     <p:extLst>
       <p:ext uri="{BB962C8B-B14F-4D97-AF65-F5344CB8AC3E}">
-        <p14:creationId xmlns:p14="http://schemas.microsoft.com/office/powerpoint/2010/main" val="2039218808"/>
+        <p14:creationId xmlns:p14="http://schemas.microsoft.com/office/powerpoint/2010/main" val="1953682263"/>
       </p:ext>
     </p:extLst>
   </p:cSld>
@@ -11646,7 +11646,7 @@
           <p:cNvPr id="1" name="">
             <a:extLst xmlns:a="http://schemas.openxmlformats.org/drawingml/2006/main">
               <a:ext uri="{FF2B5EF4-FFF2-40B4-BE49-F238E27FC236}">
-                <a16:creationId xmlns:a16="http://schemas.microsoft.com/office/drawing/2014/main" id="{F0878EF8-AA62-45CC-A567-0BF2B3E39642}"/>
+                <a16:creationId xmlns:a16="http://schemas.microsoft.com/office/drawing/2014/main" id="{5DFA35DF-749D-47D6-851E-5F03EF5E87A5}"/>
               </a:ext>
             </a:extLst>
           </p:cNvPr>
@@ -11681,7 +11681,7 @@
           <p:cNvPr id="2" name="">
             <a:extLst xmlns:a="http://schemas.openxmlformats.org/drawingml/2006/main">
               <a:ext uri="{FF2B5EF4-FFF2-40B4-BE49-F238E27FC236}">
-                <a16:creationId xmlns:a16="http://schemas.microsoft.com/office/drawing/2014/main" id="{B5C46E19-393C-4396-BD4A-BC0A23EFF78A}"/>
+                <a16:creationId xmlns:a16="http://schemas.microsoft.com/office/drawing/2014/main" id="{0DF7D3BF-79D2-4CC1-8C72-1B23E8FDE1F7}"/>
               </a:ext>
             </a:extLst>
           </p:cNvPr>
@@ -11716,7 +11716,7 @@
           <p:cNvPr id="3" name="">
             <a:extLst xmlns:a="http://schemas.openxmlformats.org/drawingml/2006/main">
               <a:ext uri="{FF2B5EF4-FFF2-40B4-BE49-F238E27FC236}">
-                <a16:creationId xmlns:a16="http://schemas.microsoft.com/office/drawing/2014/main" id="{D0F546B3-1E6B-4F09-AA81-AA5ABB7F6480}"/>
+                <a16:creationId xmlns:a16="http://schemas.microsoft.com/office/drawing/2014/main" id="{F3AFA2DE-1053-480F-9D3A-D445322B4FA9}"/>
               </a:ext>
             </a:extLst>
           </p:cNvPr>
@@ -11780,7 +11780,7 @@
           <p:cNvPr id="4" name="">
             <a:extLst xmlns:a="http://schemas.openxmlformats.org/drawingml/2006/main">
               <a:ext uri="{FF2B5EF4-FFF2-40B4-BE49-F238E27FC236}">
-                <a16:creationId xmlns:a16="http://schemas.microsoft.com/office/drawing/2014/main" id="{3AB0886F-C976-4715-A51A-C4A18972123A}"/>
+                <a16:creationId xmlns:a16="http://schemas.microsoft.com/office/drawing/2014/main" id="{936DE08D-AA96-41F4-AEEA-3670553F0773}"/>
               </a:ext>
             </a:extLst>
           </p:cNvPr>
@@ -11844,7 +11844,7 @@
           <p:cNvPr id="5" name="">
             <a:extLst xmlns:a="http://schemas.openxmlformats.org/drawingml/2006/main">
               <a:ext uri="{FF2B5EF4-FFF2-40B4-BE49-F238E27FC236}">
-                <a16:creationId xmlns:a16="http://schemas.microsoft.com/office/drawing/2014/main" id="{2C2963A9-61DD-4F86-B3D9-62EFCBC750E5}"/>
+                <a16:creationId xmlns:a16="http://schemas.microsoft.com/office/drawing/2014/main" id="{EDB19CB0-7F33-49D5-84CA-20914CD5D2AF}"/>
               </a:ext>
             </a:extLst>
           </p:cNvPr>
@@ -11898,7 +11898,7 @@
                 <a:ea typeface="Aptos Display"/>
                 <a:cs typeface="Aptos Display"/>
               </a:rPr>
-              <a:t>Spanish HITL is control flow, not decoration</a:t>
+              <a:t>Human approval is control flow, not decoration</a:t>
             </a:r>
           </a:p>
         </p:txBody>
@@ -11908,7 +11908,7 @@
           <p:cNvPr id="6" name="">
             <a:extLst xmlns:a="http://schemas.openxmlformats.org/drawingml/2006/main">
               <a:ext uri="{FF2B5EF4-FFF2-40B4-BE49-F238E27FC236}">
-                <a16:creationId xmlns:a16="http://schemas.microsoft.com/office/drawing/2014/main" id="{27578331-7E2A-4EA3-B62B-29BBDA5B55F0}"/>
+                <a16:creationId xmlns:a16="http://schemas.microsoft.com/office/drawing/2014/main" id="{0E50CF7F-DB1F-4925-888F-51033485FB0A}"/>
               </a:ext>
             </a:extLst>
           </p:cNvPr>
@@ -11972,7 +11972,7 @@
           <p:cNvPr id="7" name="">
             <a:extLst xmlns:a="http://schemas.openxmlformats.org/drawingml/2006/main">
               <a:ext uri="{FF2B5EF4-FFF2-40B4-BE49-F238E27FC236}">
-                <a16:creationId xmlns:a16="http://schemas.microsoft.com/office/drawing/2014/main" id="{986246AF-B26A-4517-9F2D-DA9F6C47D7CF}"/>
+                <a16:creationId xmlns:a16="http://schemas.microsoft.com/office/drawing/2014/main" id="{A465675F-7287-4E8B-A746-D9383BFC5459}"/>
               </a:ext>
             </a:extLst>
           </p:cNvPr>
@@ -12005,7 +12005,7 @@
           <p:cNvPr id="8" name="">
             <a:extLst xmlns:a="http://schemas.openxmlformats.org/drawingml/2006/main">
               <a:ext uri="{FF2B5EF4-FFF2-40B4-BE49-F238E27FC236}">
-                <a16:creationId xmlns:a16="http://schemas.microsoft.com/office/drawing/2014/main" id="{AF4CBB4D-9781-47DF-BDD9-17D080CFE2E6}"/>
+                <a16:creationId xmlns:a16="http://schemas.microsoft.com/office/drawing/2014/main" id="{0569FB53-CF94-490C-885F-5906F29008BF}"/>
               </a:ext>
             </a:extLst>
           </p:cNvPr>
@@ -12069,7 +12069,7 @@
           <p:cNvPr id="9" name="">
             <a:extLst xmlns:a="http://schemas.openxmlformats.org/drawingml/2006/main">
               <a:ext uri="{FF2B5EF4-FFF2-40B4-BE49-F238E27FC236}">
-                <a16:creationId xmlns:a16="http://schemas.microsoft.com/office/drawing/2014/main" id="{EEA0322A-27F6-4DD0-AB15-38443FE67B70}"/>
+                <a16:creationId xmlns:a16="http://schemas.microsoft.com/office/drawing/2014/main" id="{73CBABDB-94A6-4C39-B692-9CBEB92662DB}"/>
               </a:ext>
             </a:extLst>
           </p:cNvPr>
@@ -12133,7 +12133,7 @@
           <p:cNvPr id="10" name="">
             <a:extLst xmlns:a="http://schemas.openxmlformats.org/drawingml/2006/main">
               <a:ext uri="{FF2B5EF4-FFF2-40B4-BE49-F238E27FC236}">
-                <a16:creationId xmlns:a16="http://schemas.microsoft.com/office/drawing/2014/main" id="{183FD1C0-5D1E-4502-AF2A-7D80DA6E3238}"/>
+                <a16:creationId xmlns:a16="http://schemas.microsoft.com/office/drawing/2014/main" id="{B5F6A3C5-EB26-49F9-A886-5759B591EEE4}"/>
               </a:ext>
             </a:extLst>
           </p:cNvPr>
@@ -12166,7 +12166,7 @@
           <p:cNvPr id="11" name="">
             <a:extLst xmlns:a="http://schemas.openxmlformats.org/drawingml/2006/main">
               <a:ext uri="{FF2B5EF4-FFF2-40B4-BE49-F238E27FC236}">
-                <a16:creationId xmlns:a16="http://schemas.microsoft.com/office/drawing/2014/main" id="{98784A18-68C1-40F8-80DE-52493F4CE597}"/>
+                <a16:creationId xmlns:a16="http://schemas.microsoft.com/office/drawing/2014/main" id="{98016595-3DB6-4607-8601-8572D627AA2D}"/>
               </a:ext>
             </a:extLst>
           </p:cNvPr>
@@ -12220,7 +12220,7 @@
                 <a:ea typeface="Aptos"/>
                 <a:cs typeface="Aptos"/>
               </a:rPr>
-              <a:t>Edit / Reject</a:t>
+              <a:t>Half / Reject</a:t>
             </a:r>
           </a:p>
         </p:txBody>
@@ -12230,7 +12230,7 @@
           <p:cNvPr id="12" name="">
             <a:extLst xmlns:a="http://schemas.openxmlformats.org/drawingml/2006/main">
               <a:ext uri="{FF2B5EF4-FFF2-40B4-BE49-F238E27FC236}">
-                <a16:creationId xmlns:a16="http://schemas.microsoft.com/office/drawing/2014/main" id="{F4EE9B89-D297-4585-AB84-DDF56B751048}"/>
+                <a16:creationId xmlns:a16="http://schemas.microsoft.com/office/drawing/2014/main" id="{7C347A4C-15B5-449A-B383-9D2E0F0A982A}"/>
               </a:ext>
             </a:extLst>
           </p:cNvPr>
@@ -12284,7 +12284,7 @@
                 <a:ea typeface="Aptos"/>
                 <a:cs typeface="Aptos"/>
               </a:rPr>
-              <a:t>Solo mitad is re-verified; rejection resumes with zero simulator mutation.</a:t>
+              <a:t>Apply half is re-verified; rejection resumes with zero simulator mutation.</a:t>
             </a:r>
           </a:p>
         </p:txBody>
@@ -12294,7 +12294,7 @@
           <p:cNvPr id="13" name="">
             <a:extLst xmlns:a="http://schemas.openxmlformats.org/drawingml/2006/main">
               <a:ext uri="{FF2B5EF4-FFF2-40B4-BE49-F238E27FC236}">
-                <a16:creationId xmlns:a16="http://schemas.microsoft.com/office/drawing/2014/main" id="{912C3C09-16E4-4E48-A729-EDDCEE5A1D64}"/>
+                <a16:creationId xmlns:a16="http://schemas.microsoft.com/office/drawing/2014/main" id="{F5E31171-A3A7-4FB9-BDAF-45FDDBB97680}"/>
               </a:ext>
             </a:extLst>
           </p:cNvPr>
@@ -12327,7 +12327,7 @@
           <p:cNvPr id="14" name="">
             <a:extLst xmlns:a="http://schemas.openxmlformats.org/drawingml/2006/main">
               <a:ext uri="{FF2B5EF4-FFF2-40B4-BE49-F238E27FC236}">
-                <a16:creationId xmlns:a16="http://schemas.microsoft.com/office/drawing/2014/main" id="{09B6CC81-3EA7-49A4-A7EA-F5E2BF55399D}"/>
+                <a16:creationId xmlns:a16="http://schemas.microsoft.com/office/drawing/2014/main" id="{83C50839-F516-4F79-A778-9E44C25C339A}"/>
               </a:ext>
             </a:extLst>
           </p:cNvPr>
@@ -12391,7 +12391,7 @@
           <p:cNvPr id="15" name="">
             <a:extLst xmlns:a="http://schemas.openxmlformats.org/drawingml/2006/main">
               <a:ext uri="{FF2B5EF4-FFF2-40B4-BE49-F238E27FC236}">
-                <a16:creationId xmlns:a16="http://schemas.microsoft.com/office/drawing/2014/main" id="{94F1E77D-4DEC-4695-A12B-F9C19FAB12A9}"/>
+                <a16:creationId xmlns:a16="http://schemas.microsoft.com/office/drawing/2014/main" id="{2A3302C8-0AB9-4414-9F24-6F8998132420}"/>
               </a:ext>
             </a:extLst>
           </p:cNvPr>
@@ -12445,7 +12445,7 @@
                 <a:ea typeface="Aptos"/>
                 <a:cs typeface="Aptos"/>
               </a:rPr>
-              <a:t>Respaldo offline gives deterministic Spanish emergency instructions without model or cloud access.</a:t>
+              <a:t>Deterministic English emergency instructions remain available without model or cloud access.</a:t>
             </a:r>
           </a:p>
         </p:txBody>
@@ -12455,7 +12455,7 @@
           <p:cNvPr id="16" name="">
             <a:extLst xmlns:a="http://schemas.openxmlformats.org/drawingml/2006/main">
               <a:ext uri="{FF2B5EF4-FFF2-40B4-BE49-F238E27FC236}">
-                <a16:creationId xmlns:a16="http://schemas.microsoft.com/office/drawing/2014/main" id="{52E6CE42-5756-425E-8A89-304A2D639ECF}"/>
+                <a16:creationId xmlns:a16="http://schemas.microsoft.com/office/drawing/2014/main" id="{DA3FF9FC-EB42-477C-AD70-8D53DC9B65FC}"/>
               </a:ext>
             </a:extLst>
           </p:cNvPr>
@@ -12519,7 +12519,7 @@
           <p:cNvPr id="17" name="">
             <a:extLst xmlns:a="http://schemas.openxmlformats.org/drawingml/2006/main">
               <a:ext uri="{FF2B5EF4-FFF2-40B4-BE49-F238E27FC236}">
-                <a16:creationId xmlns:a16="http://schemas.microsoft.com/office/drawing/2014/main" id="{21DB1493-AD00-4FC2-85A7-247A135E904A}"/>
+                <a16:creationId xmlns:a16="http://schemas.microsoft.com/office/drawing/2014/main" id="{E1641FAB-9F4C-4D84-BC01-EB0CBA55FFCB}"/>
               </a:ext>
             </a:extLst>
           </p:cNvPr>
@@ -12581,7 +12581,7 @@
     </p:spTree>
     <p:extLst>
       <p:ext uri="{BB962C8B-B14F-4D97-AF65-F5344CB8AC3E}">
-        <p14:creationId xmlns:p14="http://schemas.microsoft.com/office/powerpoint/2010/main" val="75885785"/>
+        <p14:creationId xmlns:p14="http://schemas.microsoft.com/office/powerpoint/2010/main" val="1999292940"/>
       </p:ext>
     </p:extLst>
   </p:cSld>
@@ -12605,7 +12605,7 @@
           <p:cNvPr id="1" name="">
             <a:extLst xmlns:a="http://schemas.openxmlformats.org/drawingml/2006/main">
               <a:ext uri="{FF2B5EF4-FFF2-40B4-BE49-F238E27FC236}">
-                <a16:creationId xmlns:a16="http://schemas.microsoft.com/office/drawing/2014/main" id="{046D7BFB-80FB-42F9-96B3-6848C6686BA9}"/>
+                <a16:creationId xmlns:a16="http://schemas.microsoft.com/office/drawing/2014/main" id="{D4978F08-2B8E-4626-8FB0-306A6360BAF7}"/>
               </a:ext>
             </a:extLst>
           </p:cNvPr>
@@ -12640,7 +12640,7 @@
           <p:cNvPr id="2" name="">
             <a:extLst xmlns:a="http://schemas.openxmlformats.org/drawingml/2006/main">
               <a:ext uri="{FF2B5EF4-FFF2-40B4-BE49-F238E27FC236}">
-                <a16:creationId xmlns:a16="http://schemas.microsoft.com/office/drawing/2014/main" id="{0DBB30E6-6F3A-45ED-BE25-D695F19C4D2A}"/>
+                <a16:creationId xmlns:a16="http://schemas.microsoft.com/office/drawing/2014/main" id="{AE7A9087-7F58-4AC3-A38A-D7895D8F1697}"/>
               </a:ext>
             </a:extLst>
           </p:cNvPr>
@@ -12675,7 +12675,7 @@
           <p:cNvPr id="3" name="">
             <a:extLst xmlns:a="http://schemas.openxmlformats.org/drawingml/2006/main">
               <a:ext uri="{FF2B5EF4-FFF2-40B4-BE49-F238E27FC236}">
-                <a16:creationId xmlns:a16="http://schemas.microsoft.com/office/drawing/2014/main" id="{A8E105AB-5F82-4F61-AC1B-8204C70549E9}"/>
+                <a16:creationId xmlns:a16="http://schemas.microsoft.com/office/drawing/2014/main" id="{7179E605-7301-47B9-8B0E-060A642A0997}"/>
               </a:ext>
             </a:extLst>
           </p:cNvPr>
@@ -12739,7 +12739,7 @@
           <p:cNvPr id="4" name="">
             <a:extLst xmlns:a="http://schemas.openxmlformats.org/drawingml/2006/main">
               <a:ext uri="{FF2B5EF4-FFF2-40B4-BE49-F238E27FC236}">
-                <a16:creationId xmlns:a16="http://schemas.microsoft.com/office/drawing/2014/main" id="{BCBA867A-8C5D-4EA3-9874-C507C3C98F4F}"/>
+                <a16:creationId xmlns:a16="http://schemas.microsoft.com/office/drawing/2014/main" id="{4BDD0072-BEC1-43B8-ADBA-A904346C566E}"/>
               </a:ext>
             </a:extLst>
           </p:cNvPr>
@@ -12803,7 +12803,7 @@
           <p:cNvPr id="5" name="">
             <a:extLst xmlns:a="http://schemas.openxmlformats.org/drawingml/2006/main">
               <a:ext uri="{FF2B5EF4-FFF2-40B4-BE49-F238E27FC236}">
-                <a16:creationId xmlns:a16="http://schemas.microsoft.com/office/drawing/2014/main" id="{5CDE95F3-80F9-4FCC-84CF-EA4E5AC128C1}"/>
+                <a16:creationId xmlns:a16="http://schemas.microsoft.com/office/drawing/2014/main" id="{E1D5D772-A63E-4E37-B71F-0686BE0A25A2}"/>
               </a:ext>
             </a:extLst>
           </p:cNvPr>
@@ -12867,7 +12867,7 @@
           <p:cNvPr id="6" name="">
             <a:extLst xmlns:a="http://schemas.openxmlformats.org/drawingml/2006/main">
               <a:ext uri="{FF2B5EF4-FFF2-40B4-BE49-F238E27FC236}">
-                <a16:creationId xmlns:a16="http://schemas.microsoft.com/office/drawing/2014/main" id="{A7F2DF8D-18A2-4981-A9CF-B0ED56F94B4E}"/>
+                <a16:creationId xmlns:a16="http://schemas.microsoft.com/office/drawing/2014/main" id="{8F52B721-BC78-4DF5-9D48-5BFC171D4341}"/>
               </a:ext>
             </a:extLst>
           </p:cNvPr>
@@ -12931,7 +12931,7 @@
           <p:cNvPr id="7" name="">
             <a:extLst xmlns:a="http://schemas.openxmlformats.org/drawingml/2006/main">
               <a:ext uri="{FF2B5EF4-FFF2-40B4-BE49-F238E27FC236}">
-                <a16:creationId xmlns:a16="http://schemas.microsoft.com/office/drawing/2014/main" id="{7A7241C6-607C-487C-B1DA-D4C6BB3BCBB2}"/>
+                <a16:creationId xmlns:a16="http://schemas.microsoft.com/office/drawing/2014/main" id="{F0859855-8A6A-427F-9890-59B76D0595FD}"/>
               </a:ext>
             </a:extLst>
           </p:cNvPr>
@@ -12964,7 +12964,7 @@
           <p:cNvPr id="8" name="">
             <a:extLst xmlns:a="http://schemas.openxmlformats.org/drawingml/2006/main">
               <a:ext uri="{FF2B5EF4-FFF2-40B4-BE49-F238E27FC236}">
-                <a16:creationId xmlns:a16="http://schemas.microsoft.com/office/drawing/2014/main" id="{437685EE-B502-46F8-91CD-395193B0EF33}"/>
+                <a16:creationId xmlns:a16="http://schemas.microsoft.com/office/drawing/2014/main" id="{27F0C1DF-4ABC-4615-A5DA-E8C2135A0FC8}"/>
               </a:ext>
             </a:extLst>
           </p:cNvPr>
@@ -13028,7 +13028,7 @@
           <p:cNvPr id="9" name="">
             <a:extLst xmlns:a="http://schemas.openxmlformats.org/drawingml/2006/main">
               <a:ext uri="{FF2B5EF4-FFF2-40B4-BE49-F238E27FC236}">
-                <a16:creationId xmlns:a16="http://schemas.microsoft.com/office/drawing/2014/main" id="{F75ADE5A-617A-45F3-AD31-6AF7C5BC7417}"/>
+                <a16:creationId xmlns:a16="http://schemas.microsoft.com/office/drawing/2014/main" id="{9CEDC509-91AD-40D0-9C84-3F24630024A2}"/>
               </a:ext>
             </a:extLst>
           </p:cNvPr>
@@ -13092,7 +13092,7 @@
           <p:cNvPr id="10" name="">
             <a:extLst xmlns:a="http://schemas.openxmlformats.org/drawingml/2006/main">
               <a:ext uri="{FF2B5EF4-FFF2-40B4-BE49-F238E27FC236}">
-                <a16:creationId xmlns:a16="http://schemas.microsoft.com/office/drawing/2014/main" id="{A6E8786C-BA38-49D9-A722-304B627E50E3}"/>
+                <a16:creationId xmlns:a16="http://schemas.microsoft.com/office/drawing/2014/main" id="{C527AE92-010B-492F-8D45-3147D4F410AE}"/>
               </a:ext>
             </a:extLst>
           </p:cNvPr>
@@ -13156,7 +13156,7 @@
           <p:cNvPr id="11" name="">
             <a:extLst xmlns:a="http://schemas.openxmlformats.org/drawingml/2006/main">
               <a:ext uri="{FF2B5EF4-FFF2-40B4-BE49-F238E27FC236}">
-                <a16:creationId xmlns:a16="http://schemas.microsoft.com/office/drawing/2014/main" id="{E3B021AB-A79C-4D49-B91C-85E445129D0D}"/>
+                <a16:creationId xmlns:a16="http://schemas.microsoft.com/office/drawing/2014/main" id="{D4C87985-F663-4D3F-94A0-25AAD4A08B71}"/>
               </a:ext>
             </a:extLst>
           </p:cNvPr>
@@ -13189,7 +13189,7 @@
           <p:cNvPr id="12" name="">
             <a:extLst xmlns:a="http://schemas.openxmlformats.org/drawingml/2006/main">
               <a:ext uri="{FF2B5EF4-FFF2-40B4-BE49-F238E27FC236}">
-                <a16:creationId xmlns:a16="http://schemas.microsoft.com/office/drawing/2014/main" id="{4D6ED711-8C74-42DB-BA86-5F1ED1E01C61}"/>
+                <a16:creationId xmlns:a16="http://schemas.microsoft.com/office/drawing/2014/main" id="{9211F71A-5C86-46D2-935A-88060CEFFD91}"/>
               </a:ext>
             </a:extLst>
           </p:cNvPr>
@@ -13253,7 +13253,7 @@
           <p:cNvPr id="13" name="">
             <a:extLst xmlns:a="http://schemas.openxmlformats.org/drawingml/2006/main">
               <a:ext uri="{FF2B5EF4-FFF2-40B4-BE49-F238E27FC236}">
-                <a16:creationId xmlns:a16="http://schemas.microsoft.com/office/drawing/2014/main" id="{165100C8-2DDF-4571-8624-D60F9F42139E}"/>
+                <a16:creationId xmlns:a16="http://schemas.microsoft.com/office/drawing/2014/main" id="{5AB2E40C-3F56-4885-B13A-6E9C50669625}"/>
               </a:ext>
             </a:extLst>
           </p:cNvPr>
@@ -13317,7 +13317,7 @@
           <p:cNvPr id="14" name="">
             <a:extLst xmlns:a="http://schemas.openxmlformats.org/drawingml/2006/main">
               <a:ext uri="{FF2B5EF4-FFF2-40B4-BE49-F238E27FC236}">
-                <a16:creationId xmlns:a16="http://schemas.microsoft.com/office/drawing/2014/main" id="{BEC11C53-1106-4949-887F-32C6D43F0972}"/>
+                <a16:creationId xmlns:a16="http://schemas.microsoft.com/office/drawing/2014/main" id="{0CD8567F-7A83-4197-8273-01524C96D54A}"/>
               </a:ext>
             </a:extLst>
           </p:cNvPr>
@@ -13381,7 +13381,7 @@
           <p:cNvPr id="15" name="">
             <a:extLst xmlns:a="http://schemas.openxmlformats.org/drawingml/2006/main">
               <a:ext uri="{FF2B5EF4-FFF2-40B4-BE49-F238E27FC236}">
-                <a16:creationId xmlns:a16="http://schemas.microsoft.com/office/drawing/2014/main" id="{6D5FF5FD-3365-4F53-A36C-3CBA9234C5A5}"/>
+                <a16:creationId xmlns:a16="http://schemas.microsoft.com/office/drawing/2014/main" id="{2180B138-027C-41D4-B6A4-8E7EDDBEDB79}"/>
               </a:ext>
             </a:extLst>
           </p:cNvPr>
@@ -13414,7 +13414,7 @@
           <p:cNvPr id="16" name="">
             <a:extLst xmlns:a="http://schemas.openxmlformats.org/drawingml/2006/main">
               <a:ext uri="{FF2B5EF4-FFF2-40B4-BE49-F238E27FC236}">
-                <a16:creationId xmlns:a16="http://schemas.microsoft.com/office/drawing/2014/main" id="{2FC7D785-2E25-4662-9894-39345D2BF331}"/>
+                <a16:creationId xmlns:a16="http://schemas.microsoft.com/office/drawing/2014/main" id="{7013A147-25D2-46E0-A0AE-8C602EA6F325}"/>
               </a:ext>
             </a:extLst>
           </p:cNvPr>
@@ -13478,7 +13478,7 @@
           <p:cNvPr id="17" name="">
             <a:extLst xmlns:a="http://schemas.openxmlformats.org/drawingml/2006/main">
               <a:ext uri="{FF2B5EF4-FFF2-40B4-BE49-F238E27FC236}">
-                <a16:creationId xmlns:a16="http://schemas.microsoft.com/office/drawing/2014/main" id="{EB510CE1-4B6C-4126-80EA-8B00A2E4A355}"/>
+                <a16:creationId xmlns:a16="http://schemas.microsoft.com/office/drawing/2014/main" id="{3E6C3BBC-61DD-42E9-8848-80E7D68CDC3E}"/>
               </a:ext>
             </a:extLst>
           </p:cNvPr>
@@ -13542,7 +13542,7 @@
           <p:cNvPr id="18" name="">
             <a:extLst xmlns:a="http://schemas.openxmlformats.org/drawingml/2006/main">
               <a:ext uri="{FF2B5EF4-FFF2-40B4-BE49-F238E27FC236}">
-                <a16:creationId xmlns:a16="http://schemas.microsoft.com/office/drawing/2014/main" id="{021F581B-A192-486F-94A1-BE595DEC20D5}"/>
+                <a16:creationId xmlns:a16="http://schemas.microsoft.com/office/drawing/2014/main" id="{17FC702C-6FD2-43C0-86AD-3942648340E5}"/>
               </a:ext>
             </a:extLst>
           </p:cNvPr>
@@ -13575,7 +13575,7 @@
           <p:cNvPr id="19" name="">
             <a:extLst xmlns:a="http://schemas.openxmlformats.org/drawingml/2006/main">
               <a:ext uri="{FF2B5EF4-FFF2-40B4-BE49-F238E27FC236}">
-                <a16:creationId xmlns:a16="http://schemas.microsoft.com/office/drawing/2014/main" id="{1F7CDE97-6308-4817-9797-9B64DB8EDF92}"/>
+                <a16:creationId xmlns:a16="http://schemas.microsoft.com/office/drawing/2014/main" id="{257A9E3D-B74D-4BE6-A96E-E9C60F16EC9F}"/>
               </a:ext>
             </a:extLst>
           </p:cNvPr>
@@ -13639,7 +13639,7 @@
           <p:cNvPr id="20" name="">
             <a:extLst xmlns:a="http://schemas.openxmlformats.org/drawingml/2006/main">
               <a:ext uri="{FF2B5EF4-FFF2-40B4-BE49-F238E27FC236}">
-                <a16:creationId xmlns:a16="http://schemas.microsoft.com/office/drawing/2014/main" id="{49D31D65-5B60-49DF-9728-E0CDFF751BE4}"/>
+                <a16:creationId xmlns:a16="http://schemas.microsoft.com/office/drawing/2014/main" id="{A62BE532-3A7D-412A-AE04-F1B2F49D18DC}"/>
               </a:ext>
             </a:extLst>
           </p:cNvPr>
@@ -13703,7 +13703,7 @@
           <p:cNvPr id="21" name="">
             <a:extLst xmlns:a="http://schemas.openxmlformats.org/drawingml/2006/main">
               <a:ext uri="{FF2B5EF4-FFF2-40B4-BE49-F238E27FC236}">
-                <a16:creationId xmlns:a16="http://schemas.microsoft.com/office/drawing/2014/main" id="{C1C0756F-988C-4B28-9D7F-B40AE3AF4F67}"/>
+                <a16:creationId xmlns:a16="http://schemas.microsoft.com/office/drawing/2014/main" id="{3E13D5C5-FD2B-4563-A3CE-ACB8C001A919}"/>
               </a:ext>
             </a:extLst>
           </p:cNvPr>
@@ -13767,7 +13767,7 @@
           <p:cNvPr id="22" name="">
             <a:extLst xmlns:a="http://schemas.openxmlformats.org/drawingml/2006/main">
               <a:ext uri="{FF2B5EF4-FFF2-40B4-BE49-F238E27FC236}">
-                <a16:creationId xmlns:a16="http://schemas.microsoft.com/office/drawing/2014/main" id="{53EAC4CD-3D22-47DC-BE3A-7DEC64806F37}"/>
+                <a16:creationId xmlns:a16="http://schemas.microsoft.com/office/drawing/2014/main" id="{3EE34BD4-4B4A-4DAF-8A78-8F69C9332293}"/>
               </a:ext>
             </a:extLst>
           </p:cNvPr>
@@ -13829,7 +13829,7 @@
     </p:spTree>
     <p:extLst>
       <p:ext uri="{BB962C8B-B14F-4D97-AF65-F5344CB8AC3E}">
-        <p14:creationId xmlns:p14="http://schemas.microsoft.com/office/powerpoint/2010/main" val="726148268"/>
+        <p14:creationId xmlns:p14="http://schemas.microsoft.com/office/powerpoint/2010/main" val="1675609024"/>
       </p:ext>
     </p:extLst>
   </p:cSld>

</xml_diff>

<commit_message>
feat: add executable judge experience
</commit_message>
<xml_diff>
--- a/submission/proteinloop-hackathon-deck.pptx
+++ b/submission/proteinloop-hackathon-deck.pptx
@@ -2,22 +2,22 @@
 <file path=ppt/presentation.xml><?xml version="1.0" encoding="utf-8"?>
 <p:presentation xmlns:p="http://schemas.openxmlformats.org/presentationml/2006/main">
   <p:sldMasterIdLst>
-    <p:sldMasterId xmlns:r="http://schemas.openxmlformats.org/officeDocument/2006/relationships" id="2147483648" r:id="Rc9fc7047e45946d0"/>
+    <p:sldMasterId xmlns:r="http://schemas.openxmlformats.org/officeDocument/2006/relationships" id="2147483648" r:id="R896ee810c5c243f8"/>
   </p:sldMasterIdLst>
   <p:notesMasterIdLst>
-    <p:notesMasterId xmlns:r="http://schemas.openxmlformats.org/officeDocument/2006/relationships" r:id="R874207f965f6429e"/>
+    <p:notesMasterId xmlns:r="http://schemas.openxmlformats.org/officeDocument/2006/relationships" r:id="Rc989136c751c43ea"/>
   </p:notesMasterIdLst>
   <p:sldIdLst>
-    <p:sldId xmlns:r="http://schemas.openxmlformats.org/officeDocument/2006/relationships" id="256" r:id="R310a1f9e2b804836"/>
-    <p:sldId xmlns:r="http://schemas.openxmlformats.org/officeDocument/2006/relationships" id="257" r:id="R233fa6ce48a64064"/>
-    <p:sldId xmlns:r="http://schemas.openxmlformats.org/officeDocument/2006/relationships" id="258" r:id="R2a133b9104564784"/>
-    <p:sldId xmlns:r="http://schemas.openxmlformats.org/officeDocument/2006/relationships" id="259" r:id="R9f2138e6e1a74247"/>
-    <p:sldId xmlns:r="http://schemas.openxmlformats.org/officeDocument/2006/relationships" id="260" r:id="R55ff30d40c9a480b"/>
-    <p:sldId xmlns:r="http://schemas.openxmlformats.org/officeDocument/2006/relationships" id="261" r:id="R47ff83a10ec244c6"/>
-    <p:sldId xmlns:r="http://schemas.openxmlformats.org/officeDocument/2006/relationships" id="262" r:id="R6c6c4472a7f34fcd"/>
-    <p:sldId xmlns:r="http://schemas.openxmlformats.org/officeDocument/2006/relationships" id="263" r:id="Rab10ac3e4b544c49"/>
-    <p:sldId xmlns:r="http://schemas.openxmlformats.org/officeDocument/2006/relationships" id="264" r:id="Rd828d9d3f00941dd"/>
-    <p:sldId xmlns:r="http://schemas.openxmlformats.org/officeDocument/2006/relationships" id="265" r:id="R9e127670f09243df"/>
+    <p:sldId xmlns:r="http://schemas.openxmlformats.org/officeDocument/2006/relationships" id="256" r:id="Rb94e47f575a04c3d"/>
+    <p:sldId xmlns:r="http://schemas.openxmlformats.org/officeDocument/2006/relationships" id="257" r:id="R74d8c850b89640be"/>
+    <p:sldId xmlns:r="http://schemas.openxmlformats.org/officeDocument/2006/relationships" id="258" r:id="Rd87b2610492b445f"/>
+    <p:sldId xmlns:r="http://schemas.openxmlformats.org/officeDocument/2006/relationships" id="259" r:id="Re3a0cb5a87af4e0a"/>
+    <p:sldId xmlns:r="http://schemas.openxmlformats.org/officeDocument/2006/relationships" id="260" r:id="Rae2c60e044104709"/>
+    <p:sldId xmlns:r="http://schemas.openxmlformats.org/officeDocument/2006/relationships" id="261" r:id="Rf63530e4d0ad4780"/>
+    <p:sldId xmlns:r="http://schemas.openxmlformats.org/officeDocument/2006/relationships" id="262" r:id="R12ce53cc39404bfa"/>
+    <p:sldId xmlns:r="http://schemas.openxmlformats.org/officeDocument/2006/relationships" id="263" r:id="R187cd8d85c994681"/>
+    <p:sldId xmlns:r="http://schemas.openxmlformats.org/officeDocument/2006/relationships" id="264" r:id="R52b4c845d5834938"/>
+    <p:sldId xmlns:r="http://schemas.openxmlformats.org/officeDocument/2006/relationships" id="265" r:id="R45f3de5f1ccf41f3"/>
   </p:sldIdLst>
   <p:sldSz cx="12192000" cy="6858000"/>
   <p:notesSz cx="6858000" cy="9144000"/>
@@ -1158,7 +1158,7 @@
   </p:cSld>
   <p:clrMap bg1="lt1" tx1="dk1" bg2="lt2" tx2="dk2" accent1="accent1" accent2="accent2" accent3="accent3" accent4="accent4" accent5="accent5" accent6="accent6" hlink="hlink" folHlink="folHlink"/>
   <p:sldLayoutIdLst>
-    <p:sldLayoutId xmlns:r="http://schemas.openxmlformats.org/officeDocument/2006/relationships" id="2147483649" r:id="Rae5f7c5d88824bde"/>
+    <p:sldLayoutId xmlns:r="http://schemas.openxmlformats.org/officeDocument/2006/relationships" id="2147483649" r:id="Rf3713d7dec0741a6"/>
   </p:sldLayoutIdLst>
   <p:txStyles>
     <p:titleStyle>
@@ -1457,7 +1457,7 @@
           <p:cNvPr id="1" name="">
             <a:extLst xmlns:a="http://schemas.openxmlformats.org/drawingml/2006/main">
               <a:ext uri="{FF2B5EF4-FFF2-40B4-BE49-F238E27FC236}">
-                <a16:creationId xmlns:a16="http://schemas.microsoft.com/office/drawing/2014/main" id="{A359D533-7441-4A78-98A7-6F5D4087CACD}"/>
+                <a16:creationId xmlns:a16="http://schemas.microsoft.com/office/drawing/2014/main" id="{57D09D46-0B9E-4243-99C4-F7E45319708B}"/>
               </a:ext>
             </a:extLst>
           </p:cNvPr>
@@ -1492,7 +1492,7 @@
           <p:cNvPr id="2" name="">
             <a:extLst xmlns:a="http://schemas.openxmlformats.org/drawingml/2006/main">
               <a:ext uri="{FF2B5EF4-FFF2-40B4-BE49-F238E27FC236}">
-                <a16:creationId xmlns:a16="http://schemas.microsoft.com/office/drawing/2014/main" id="{93811AEB-CC35-4264-B5E9-7825991064CC}"/>
+                <a16:creationId xmlns:a16="http://schemas.microsoft.com/office/drawing/2014/main" id="{7DC1ED6E-EA51-49B3-BDF6-4F73A8C5CFB0}"/>
               </a:ext>
             </a:extLst>
           </p:cNvPr>
@@ -1527,7 +1527,7 @@
           <p:cNvPr id="3" name="">
             <a:extLst xmlns:a="http://schemas.openxmlformats.org/drawingml/2006/main">
               <a:ext uri="{FF2B5EF4-FFF2-40B4-BE49-F238E27FC236}">
-                <a16:creationId xmlns:a16="http://schemas.microsoft.com/office/drawing/2014/main" id="{991DAF5A-28F8-4A39-9438-909156EF65C2}"/>
+                <a16:creationId xmlns:a16="http://schemas.microsoft.com/office/drawing/2014/main" id="{F55DFDFD-60BE-4A7C-9CA7-B6780A00BD19}"/>
               </a:ext>
             </a:extLst>
           </p:cNvPr>
@@ -1591,7 +1591,7 @@
           <p:cNvPr id="4" name="">
             <a:extLst xmlns:a="http://schemas.openxmlformats.org/drawingml/2006/main">
               <a:ext uri="{FF2B5EF4-FFF2-40B4-BE49-F238E27FC236}">
-                <a16:creationId xmlns:a16="http://schemas.microsoft.com/office/drawing/2014/main" id="{18E5F365-2032-44AC-A37A-730318C461D4}"/>
+                <a16:creationId xmlns:a16="http://schemas.microsoft.com/office/drawing/2014/main" id="{44A7514E-F826-482F-B9B1-6A7F96A8DDDC}"/>
               </a:ext>
             </a:extLst>
           </p:cNvPr>
@@ -1655,7 +1655,7 @@
           <p:cNvPr id="5" name="">
             <a:extLst xmlns:a="http://schemas.openxmlformats.org/drawingml/2006/main">
               <a:ext uri="{FF2B5EF4-FFF2-40B4-BE49-F238E27FC236}">
-                <a16:creationId xmlns:a16="http://schemas.microsoft.com/office/drawing/2014/main" id="{6B102BFA-4919-4B4F-94D3-B110D2635B64}"/>
+                <a16:creationId xmlns:a16="http://schemas.microsoft.com/office/drawing/2014/main" id="{CCEFC1EE-CE8D-4354-8470-CB46326711DD}"/>
               </a:ext>
             </a:extLst>
           </p:cNvPr>
@@ -1690,7 +1690,7 @@
           <p:cNvPr id="6" name="">
             <a:extLst xmlns:a="http://schemas.openxmlformats.org/drawingml/2006/main">
               <a:ext uri="{FF2B5EF4-FFF2-40B4-BE49-F238E27FC236}">
-                <a16:creationId xmlns:a16="http://schemas.microsoft.com/office/drawing/2014/main" id="{9F0717A1-8095-40D6-9829-B09340789432}"/>
+                <a16:creationId xmlns:a16="http://schemas.microsoft.com/office/drawing/2014/main" id="{24368380-BA4F-42FC-BAAC-09BF59432CE0}"/>
               </a:ext>
             </a:extLst>
           </p:cNvPr>
@@ -1754,7 +1754,7 @@
           <p:cNvPr id="7" name="">
             <a:extLst xmlns:a="http://schemas.openxmlformats.org/drawingml/2006/main">
               <a:ext uri="{FF2B5EF4-FFF2-40B4-BE49-F238E27FC236}">
-                <a16:creationId xmlns:a16="http://schemas.microsoft.com/office/drawing/2014/main" id="{E3549F6B-4E41-4958-A744-D37C5942B195}"/>
+                <a16:creationId xmlns:a16="http://schemas.microsoft.com/office/drawing/2014/main" id="{F725166A-0F11-42B4-B6D1-028FD4935B25}"/>
               </a:ext>
             </a:extLst>
           </p:cNvPr>
@@ -1818,7 +1818,7 @@
           <p:cNvPr id="8" name="">
             <a:extLst xmlns:a="http://schemas.openxmlformats.org/drawingml/2006/main">
               <a:ext uri="{FF2B5EF4-FFF2-40B4-BE49-F238E27FC236}">
-                <a16:creationId xmlns:a16="http://schemas.microsoft.com/office/drawing/2014/main" id="{55EC3395-134D-4316-BCD3-2ABDDAEC7DFD}"/>
+                <a16:creationId xmlns:a16="http://schemas.microsoft.com/office/drawing/2014/main" id="{B46CBC13-81DB-40D3-9CFE-C22BDD1E309D}"/>
               </a:ext>
             </a:extLst>
           </p:cNvPr>
@@ -1853,7 +1853,7 @@
           <p:cNvPr id="9" name="">
             <a:extLst xmlns:a="http://schemas.openxmlformats.org/drawingml/2006/main">
               <a:ext uri="{FF2B5EF4-FFF2-40B4-BE49-F238E27FC236}">
-                <a16:creationId xmlns:a16="http://schemas.microsoft.com/office/drawing/2014/main" id="{1431C9BE-4912-4051-82AC-FF141EF6D2D7}"/>
+                <a16:creationId xmlns:a16="http://schemas.microsoft.com/office/drawing/2014/main" id="{147CFF2E-6C2E-4F82-95F1-5E377846735B}"/>
               </a:ext>
             </a:extLst>
           </p:cNvPr>
@@ -1917,7 +1917,7 @@
           <p:cNvPr id="10" name="">
             <a:extLst xmlns:a="http://schemas.openxmlformats.org/drawingml/2006/main">
               <a:ext uri="{FF2B5EF4-FFF2-40B4-BE49-F238E27FC236}">
-                <a16:creationId xmlns:a16="http://schemas.microsoft.com/office/drawing/2014/main" id="{0E2D3E1B-B356-49E9-B26A-F2AE4A781914}"/>
+                <a16:creationId xmlns:a16="http://schemas.microsoft.com/office/drawing/2014/main" id="{4D5310F0-7060-4B61-BA7D-CAED20C2486D}"/>
               </a:ext>
             </a:extLst>
           </p:cNvPr>
@@ -1981,7 +1981,7 @@
           <p:cNvPr id="11" name="">
             <a:extLst xmlns:a="http://schemas.openxmlformats.org/drawingml/2006/main">
               <a:ext uri="{FF2B5EF4-FFF2-40B4-BE49-F238E27FC236}">
-                <a16:creationId xmlns:a16="http://schemas.microsoft.com/office/drawing/2014/main" id="{2C74C0AA-E279-4F4C-99AB-864AD79BB79A}"/>
+                <a16:creationId xmlns:a16="http://schemas.microsoft.com/office/drawing/2014/main" id="{4FE3E1F4-35A3-4B63-BADC-03D3796710A0}"/>
               </a:ext>
             </a:extLst>
           </p:cNvPr>
@@ -2045,7 +2045,7 @@
           <p:cNvPr id="12" name="">
             <a:extLst xmlns:a="http://schemas.openxmlformats.org/drawingml/2006/main">
               <a:ext uri="{FF2B5EF4-FFF2-40B4-BE49-F238E27FC236}">
-                <a16:creationId xmlns:a16="http://schemas.microsoft.com/office/drawing/2014/main" id="{DBD89452-0A60-467B-839D-3065CDDABD1A}"/>
+                <a16:creationId xmlns:a16="http://schemas.microsoft.com/office/drawing/2014/main" id="{20E5D1B2-7149-47D5-BA79-235F82544D84}"/>
               </a:ext>
             </a:extLst>
           </p:cNvPr>
@@ -2080,7 +2080,7 @@
           <p:cNvPr id="13" name="">
             <a:extLst xmlns:a="http://schemas.openxmlformats.org/drawingml/2006/main">
               <a:ext uri="{FF2B5EF4-FFF2-40B4-BE49-F238E27FC236}">
-                <a16:creationId xmlns:a16="http://schemas.microsoft.com/office/drawing/2014/main" id="{BBE68F2F-7E65-4455-A52B-283AF2058A51}"/>
+                <a16:creationId xmlns:a16="http://schemas.microsoft.com/office/drawing/2014/main" id="{6E45875C-AA40-4978-993F-C22A3B9445CE}"/>
               </a:ext>
             </a:extLst>
           </p:cNvPr>
@@ -2144,7 +2144,7 @@
           <p:cNvPr id="14" name="">
             <a:extLst xmlns:a="http://schemas.openxmlformats.org/drawingml/2006/main">
               <a:ext uri="{FF2B5EF4-FFF2-40B4-BE49-F238E27FC236}">
-                <a16:creationId xmlns:a16="http://schemas.microsoft.com/office/drawing/2014/main" id="{226BE245-F394-4FF9-9D89-2A2F93A756A9}"/>
+                <a16:creationId xmlns:a16="http://schemas.microsoft.com/office/drawing/2014/main" id="{74392B62-F536-4E6E-97A4-6BA319C29303}"/>
               </a:ext>
             </a:extLst>
           </p:cNvPr>
@@ -2208,7 +2208,7 @@
           <p:cNvPr id="15" name="">
             <a:extLst xmlns:a="http://schemas.openxmlformats.org/drawingml/2006/main">
               <a:ext uri="{FF2B5EF4-FFF2-40B4-BE49-F238E27FC236}">
-                <a16:creationId xmlns:a16="http://schemas.microsoft.com/office/drawing/2014/main" id="{D8AFC1CF-C475-4624-AF30-360620F820E1}"/>
+                <a16:creationId xmlns:a16="http://schemas.microsoft.com/office/drawing/2014/main" id="{EC4333BD-1323-4D2E-9CF9-D2182C61D981}"/>
               </a:ext>
             </a:extLst>
           </p:cNvPr>
@@ -2272,7 +2272,7 @@
           <p:cNvPr id="16" name="">
             <a:extLst xmlns:a="http://schemas.openxmlformats.org/drawingml/2006/main">
               <a:ext uri="{FF2B5EF4-FFF2-40B4-BE49-F238E27FC236}">
-                <a16:creationId xmlns:a16="http://schemas.microsoft.com/office/drawing/2014/main" id="{EC677A79-55FE-4AE7-B11C-C663EE06E496}"/>
+                <a16:creationId xmlns:a16="http://schemas.microsoft.com/office/drawing/2014/main" id="{92021084-656F-4313-A3AD-D8F26252826B}"/>
               </a:ext>
             </a:extLst>
           </p:cNvPr>
@@ -2307,7 +2307,7 @@
           <p:cNvPr id="17" name="">
             <a:extLst xmlns:a="http://schemas.openxmlformats.org/drawingml/2006/main">
               <a:ext uri="{FF2B5EF4-FFF2-40B4-BE49-F238E27FC236}">
-                <a16:creationId xmlns:a16="http://schemas.microsoft.com/office/drawing/2014/main" id="{EDEB4759-1D28-44EE-91D7-79E6F6199225}"/>
+                <a16:creationId xmlns:a16="http://schemas.microsoft.com/office/drawing/2014/main" id="{7A72307C-8132-4FA8-B081-E0EF3CECF22A}"/>
               </a:ext>
             </a:extLst>
           </p:cNvPr>
@@ -2371,7 +2371,7 @@
           <p:cNvPr id="18" name="">
             <a:extLst xmlns:a="http://schemas.openxmlformats.org/drawingml/2006/main">
               <a:ext uri="{FF2B5EF4-FFF2-40B4-BE49-F238E27FC236}">
-                <a16:creationId xmlns:a16="http://schemas.microsoft.com/office/drawing/2014/main" id="{CCCBFB01-5F29-4D12-9FC2-68C486658610}"/>
+                <a16:creationId xmlns:a16="http://schemas.microsoft.com/office/drawing/2014/main" id="{FADF4821-C547-496C-86D2-1ADC293DADD2}"/>
               </a:ext>
             </a:extLst>
           </p:cNvPr>
@@ -2435,7 +2435,7 @@
           <p:cNvPr id="19" name="">
             <a:extLst xmlns:a="http://schemas.openxmlformats.org/drawingml/2006/main">
               <a:ext uri="{FF2B5EF4-FFF2-40B4-BE49-F238E27FC236}">
-                <a16:creationId xmlns:a16="http://schemas.microsoft.com/office/drawing/2014/main" id="{2B5EEE2A-618B-4C09-A608-75786A71383D}"/>
+                <a16:creationId xmlns:a16="http://schemas.microsoft.com/office/drawing/2014/main" id="{E0FCAEB3-CA22-43F3-B806-B150A946E50A}"/>
               </a:ext>
             </a:extLst>
           </p:cNvPr>
@@ -2499,7 +2499,7 @@
           <p:cNvPr id="20" name="">
             <a:extLst xmlns:a="http://schemas.openxmlformats.org/drawingml/2006/main">
               <a:ext uri="{FF2B5EF4-FFF2-40B4-BE49-F238E27FC236}">
-                <a16:creationId xmlns:a16="http://schemas.microsoft.com/office/drawing/2014/main" id="{F4E1B5E9-1537-4C9B-AE92-8175E51BCCC1}"/>
+                <a16:creationId xmlns:a16="http://schemas.microsoft.com/office/drawing/2014/main" id="{FB7AD0EA-1555-4769-BEC0-32053DCF8DA1}"/>
               </a:ext>
             </a:extLst>
           </p:cNvPr>
@@ -2655,7 +2655,7 @@
           <p:cNvPr id="21" name="">
             <a:extLst xmlns:a="http://schemas.openxmlformats.org/drawingml/2006/main">
               <a:ext uri="{FF2B5EF4-FFF2-40B4-BE49-F238E27FC236}">
-                <a16:creationId xmlns:a16="http://schemas.microsoft.com/office/drawing/2014/main" id="{11C81967-4188-4AF0-B2AD-7D8785257FEC}"/>
+                <a16:creationId xmlns:a16="http://schemas.microsoft.com/office/drawing/2014/main" id="{F68923E0-7D65-48A1-B494-4BD6229AFCCE}"/>
               </a:ext>
             </a:extLst>
           </p:cNvPr>
@@ -2719,7 +2719,7 @@
           <p:cNvPr id="22" name="">
             <a:extLst xmlns:a="http://schemas.openxmlformats.org/drawingml/2006/main">
               <a:ext uri="{FF2B5EF4-FFF2-40B4-BE49-F238E27FC236}">
-                <a16:creationId xmlns:a16="http://schemas.microsoft.com/office/drawing/2014/main" id="{38D7900E-18B3-426E-B76E-8D89CD18E82A}"/>
+                <a16:creationId xmlns:a16="http://schemas.microsoft.com/office/drawing/2014/main" id="{9A2E809E-DBE0-4F34-9A80-94C8967E26BC}"/>
               </a:ext>
             </a:extLst>
           </p:cNvPr>
@@ -2781,7 +2781,7 @@
     </p:spTree>
     <p:extLst>
       <p:ext uri="{BB962C8B-B14F-4D97-AF65-F5344CB8AC3E}">
-        <p14:creationId xmlns:p14="http://schemas.microsoft.com/office/powerpoint/2010/main" val="1590110437"/>
+        <p14:creationId xmlns:p14="http://schemas.microsoft.com/office/powerpoint/2010/main" val="671481967"/>
       </p:ext>
     </p:extLst>
   </p:cSld>
@@ -2805,7 +2805,7 @@
           <p:cNvPr id="1" name="">
             <a:extLst xmlns:a="http://schemas.openxmlformats.org/drawingml/2006/main">
               <a:ext uri="{FF2B5EF4-FFF2-40B4-BE49-F238E27FC236}">
-                <a16:creationId xmlns:a16="http://schemas.microsoft.com/office/drawing/2014/main" id="{A1B82152-7582-4EDA-AC7F-300C9A64D8EE}"/>
+                <a16:creationId xmlns:a16="http://schemas.microsoft.com/office/drawing/2014/main" id="{850F4B17-CD49-4C89-A5D9-7F1BB0EA3446}"/>
               </a:ext>
             </a:extLst>
           </p:cNvPr>
@@ -2840,7 +2840,7 @@
           <p:cNvPr id="2" name="">
             <a:extLst xmlns:a="http://schemas.openxmlformats.org/drawingml/2006/main">
               <a:ext uri="{FF2B5EF4-FFF2-40B4-BE49-F238E27FC236}">
-                <a16:creationId xmlns:a16="http://schemas.microsoft.com/office/drawing/2014/main" id="{2128502B-48A6-4464-9967-B24039517A1C}"/>
+                <a16:creationId xmlns:a16="http://schemas.microsoft.com/office/drawing/2014/main" id="{A742BDDD-4BD5-4113-BF88-FF78467409B1}"/>
               </a:ext>
             </a:extLst>
           </p:cNvPr>
@@ -2875,7 +2875,7 @@
           <p:cNvPr id="3" name="">
             <a:extLst xmlns:a="http://schemas.openxmlformats.org/drawingml/2006/main">
               <a:ext uri="{FF2B5EF4-FFF2-40B4-BE49-F238E27FC236}">
-                <a16:creationId xmlns:a16="http://schemas.microsoft.com/office/drawing/2014/main" id="{4E7F2AC2-C7F7-4676-930F-F55EF577A967}"/>
+                <a16:creationId xmlns:a16="http://schemas.microsoft.com/office/drawing/2014/main" id="{03EF8E79-9533-41B0-842E-3859180DF01E}"/>
               </a:ext>
             </a:extLst>
           </p:cNvPr>
@@ -2939,7 +2939,7 @@
           <p:cNvPr id="4" name="">
             <a:extLst xmlns:a="http://schemas.openxmlformats.org/drawingml/2006/main">
               <a:ext uri="{FF2B5EF4-FFF2-40B4-BE49-F238E27FC236}">
-                <a16:creationId xmlns:a16="http://schemas.microsoft.com/office/drawing/2014/main" id="{A4D5C305-153C-47A7-89E9-9A201F8196EF}"/>
+                <a16:creationId xmlns:a16="http://schemas.microsoft.com/office/drawing/2014/main" id="{13457F3D-5C07-43C3-A208-198F09D03822}"/>
               </a:ext>
             </a:extLst>
           </p:cNvPr>
@@ -3003,7 +3003,7 @@
           <p:cNvPr id="5" name="">
             <a:extLst xmlns:a="http://schemas.openxmlformats.org/drawingml/2006/main">
               <a:ext uri="{FF2B5EF4-FFF2-40B4-BE49-F238E27FC236}">
-                <a16:creationId xmlns:a16="http://schemas.microsoft.com/office/drawing/2014/main" id="{B34EB85A-76A7-4A04-9D54-B60C40434978}"/>
+                <a16:creationId xmlns:a16="http://schemas.microsoft.com/office/drawing/2014/main" id="{265573CB-9E5B-411F-A179-6AB79A792174}"/>
               </a:ext>
             </a:extLst>
           </p:cNvPr>
@@ -3067,7 +3067,7 @@
           <p:cNvPr id="6" name="">
             <a:extLst xmlns:a="http://schemas.openxmlformats.org/drawingml/2006/main">
               <a:ext uri="{FF2B5EF4-FFF2-40B4-BE49-F238E27FC236}">
-                <a16:creationId xmlns:a16="http://schemas.microsoft.com/office/drawing/2014/main" id="{F90FF1DE-2961-45EA-9EA1-732C7E41DCEC}"/>
+                <a16:creationId xmlns:a16="http://schemas.microsoft.com/office/drawing/2014/main" id="{906D2196-DD1C-42EB-885C-813216A30EBD}"/>
               </a:ext>
             </a:extLst>
           </p:cNvPr>
@@ -3131,7 +3131,7 @@
           <p:cNvPr id="7" name="">
             <a:extLst xmlns:a="http://schemas.openxmlformats.org/drawingml/2006/main">
               <a:ext uri="{FF2B5EF4-FFF2-40B4-BE49-F238E27FC236}">
-                <a16:creationId xmlns:a16="http://schemas.microsoft.com/office/drawing/2014/main" id="{408DBA06-A8BC-4EED-A21A-DE8CC50422D4}"/>
+                <a16:creationId xmlns:a16="http://schemas.microsoft.com/office/drawing/2014/main" id="{9CFAEA53-117D-4B4D-A096-50756B7A45B9}"/>
               </a:ext>
             </a:extLst>
           </p:cNvPr>
@@ -3164,7 +3164,7 @@
           <p:cNvPr id="8" name="">
             <a:extLst xmlns:a="http://schemas.openxmlformats.org/drawingml/2006/main">
               <a:ext uri="{FF2B5EF4-FFF2-40B4-BE49-F238E27FC236}">
-                <a16:creationId xmlns:a16="http://schemas.microsoft.com/office/drawing/2014/main" id="{6DAC0D2A-F4CD-4422-9FC0-D5041B17D591}"/>
+                <a16:creationId xmlns:a16="http://schemas.microsoft.com/office/drawing/2014/main" id="{A36861D6-947B-4A7D-91C4-80EE92F60A0E}"/>
               </a:ext>
             </a:extLst>
           </p:cNvPr>
@@ -3228,7 +3228,7 @@
           <p:cNvPr id="9" name="">
             <a:extLst xmlns:a="http://schemas.openxmlformats.org/drawingml/2006/main">
               <a:ext uri="{FF2B5EF4-FFF2-40B4-BE49-F238E27FC236}">
-                <a16:creationId xmlns:a16="http://schemas.microsoft.com/office/drawing/2014/main" id="{957BEE5D-E811-4CF1-B49D-1613EB392C2F}"/>
+                <a16:creationId xmlns:a16="http://schemas.microsoft.com/office/drawing/2014/main" id="{3FB82E01-D2F5-476A-86BE-A06A76BBDB45}"/>
               </a:ext>
             </a:extLst>
           </p:cNvPr>
@@ -3292,7 +3292,7 @@
           <p:cNvPr id="10" name="">
             <a:extLst xmlns:a="http://schemas.openxmlformats.org/drawingml/2006/main">
               <a:ext uri="{FF2B5EF4-FFF2-40B4-BE49-F238E27FC236}">
-                <a16:creationId xmlns:a16="http://schemas.microsoft.com/office/drawing/2014/main" id="{191DBC6D-B67D-481C-B77D-7B9D4D499BD8}"/>
+                <a16:creationId xmlns:a16="http://schemas.microsoft.com/office/drawing/2014/main" id="{14CB26CE-C061-4B53-AE48-EC871685599C}"/>
               </a:ext>
             </a:extLst>
           </p:cNvPr>
@@ -3325,7 +3325,7 @@
           <p:cNvPr id="11" name="">
             <a:extLst xmlns:a="http://schemas.openxmlformats.org/drawingml/2006/main">
               <a:ext uri="{FF2B5EF4-FFF2-40B4-BE49-F238E27FC236}">
-                <a16:creationId xmlns:a16="http://schemas.microsoft.com/office/drawing/2014/main" id="{A2728832-6772-4921-89D3-47DBBE29A958}"/>
+                <a16:creationId xmlns:a16="http://schemas.microsoft.com/office/drawing/2014/main" id="{E7EC7D87-AF82-4E1F-8229-8EFA069B4ECE}"/>
               </a:ext>
             </a:extLst>
           </p:cNvPr>
@@ -3389,7 +3389,7 @@
           <p:cNvPr id="12" name="">
             <a:extLst xmlns:a="http://schemas.openxmlformats.org/drawingml/2006/main">
               <a:ext uri="{FF2B5EF4-FFF2-40B4-BE49-F238E27FC236}">
-                <a16:creationId xmlns:a16="http://schemas.microsoft.com/office/drawing/2014/main" id="{70B9FE37-C588-4AAC-8468-E4C49651CDB2}"/>
+                <a16:creationId xmlns:a16="http://schemas.microsoft.com/office/drawing/2014/main" id="{EE7E6B52-F9D5-4629-92C7-FD07BFC488F2}"/>
               </a:ext>
             </a:extLst>
           </p:cNvPr>
@@ -3453,7 +3453,7 @@
           <p:cNvPr id="13" name="">
             <a:extLst xmlns:a="http://schemas.openxmlformats.org/drawingml/2006/main">
               <a:ext uri="{FF2B5EF4-FFF2-40B4-BE49-F238E27FC236}">
-                <a16:creationId xmlns:a16="http://schemas.microsoft.com/office/drawing/2014/main" id="{69170CBA-28E6-4B64-BBD6-BD0B8F960A39}"/>
+                <a16:creationId xmlns:a16="http://schemas.microsoft.com/office/drawing/2014/main" id="{1906E168-93EC-45B5-88C9-F6057175EC01}"/>
               </a:ext>
             </a:extLst>
           </p:cNvPr>
@@ -3486,7 +3486,7 @@
           <p:cNvPr id="14" name="">
             <a:extLst xmlns:a="http://schemas.openxmlformats.org/drawingml/2006/main">
               <a:ext uri="{FF2B5EF4-FFF2-40B4-BE49-F238E27FC236}">
-                <a16:creationId xmlns:a16="http://schemas.microsoft.com/office/drawing/2014/main" id="{64720E4E-F8CA-4387-B58F-6E71DAF5C677}"/>
+                <a16:creationId xmlns:a16="http://schemas.microsoft.com/office/drawing/2014/main" id="{47BFAE8E-CA89-4427-A5D9-6B32A4CF7FD9}"/>
               </a:ext>
             </a:extLst>
           </p:cNvPr>
@@ -3550,7 +3550,7 @@
           <p:cNvPr id="15" name="">
             <a:extLst xmlns:a="http://schemas.openxmlformats.org/drawingml/2006/main">
               <a:ext uri="{FF2B5EF4-FFF2-40B4-BE49-F238E27FC236}">
-                <a16:creationId xmlns:a16="http://schemas.microsoft.com/office/drawing/2014/main" id="{4618CA3E-7820-485D-A36E-D4709F3DC45E}"/>
+                <a16:creationId xmlns:a16="http://schemas.microsoft.com/office/drawing/2014/main" id="{981D0578-4E23-4074-BA84-F2EF53345F12}"/>
               </a:ext>
             </a:extLst>
           </p:cNvPr>
@@ -3614,7 +3614,7 @@
           <p:cNvPr id="16" name="">
             <a:extLst xmlns:a="http://schemas.openxmlformats.org/drawingml/2006/main">
               <a:ext uri="{FF2B5EF4-FFF2-40B4-BE49-F238E27FC236}">
-                <a16:creationId xmlns:a16="http://schemas.microsoft.com/office/drawing/2014/main" id="{7E938136-9788-4F3D-BAA9-9A91AEFFD497}"/>
+                <a16:creationId xmlns:a16="http://schemas.microsoft.com/office/drawing/2014/main" id="{56ECC787-3159-4801-B0CA-614BF993D18F}"/>
               </a:ext>
             </a:extLst>
           </p:cNvPr>
@@ -3678,7 +3678,7 @@
           <p:cNvPr id="17" name="">
             <a:extLst xmlns:a="http://schemas.openxmlformats.org/drawingml/2006/main">
               <a:ext uri="{FF2B5EF4-FFF2-40B4-BE49-F238E27FC236}">
-                <a16:creationId xmlns:a16="http://schemas.microsoft.com/office/drawing/2014/main" id="{96AE1296-FA3B-4285-9EC2-B477412C72D9}"/>
+                <a16:creationId xmlns:a16="http://schemas.microsoft.com/office/drawing/2014/main" id="{2F5B6825-6901-4AF1-807C-F2B3E741D154}"/>
               </a:ext>
             </a:extLst>
           </p:cNvPr>
@@ -3742,7 +3742,7 @@
           <p:cNvPr id="18" name="">
             <a:extLst xmlns:a="http://schemas.openxmlformats.org/drawingml/2006/main">
               <a:ext uri="{FF2B5EF4-FFF2-40B4-BE49-F238E27FC236}">
-                <a16:creationId xmlns:a16="http://schemas.microsoft.com/office/drawing/2014/main" id="{539EBE5E-DEBB-44A0-A034-B6F73EF4CEEB}"/>
+                <a16:creationId xmlns:a16="http://schemas.microsoft.com/office/drawing/2014/main" id="{021443F2-E7F7-41CF-BDF3-F15C86ABAE87}"/>
               </a:ext>
             </a:extLst>
           </p:cNvPr>
@@ -3804,7 +3804,7 @@
     </p:spTree>
     <p:extLst>
       <p:ext uri="{BB962C8B-B14F-4D97-AF65-F5344CB8AC3E}">
-        <p14:creationId xmlns:p14="http://schemas.microsoft.com/office/powerpoint/2010/main" val="1667900142"/>
+        <p14:creationId xmlns:p14="http://schemas.microsoft.com/office/powerpoint/2010/main" val="1928399479"/>
       </p:ext>
     </p:extLst>
   </p:cSld>
@@ -3828,7 +3828,7 @@
           <p:cNvPr id="1" name="">
             <a:extLst xmlns:a="http://schemas.openxmlformats.org/drawingml/2006/main">
               <a:ext uri="{FF2B5EF4-FFF2-40B4-BE49-F238E27FC236}">
-                <a16:creationId xmlns:a16="http://schemas.microsoft.com/office/drawing/2014/main" id="{9F69CF4B-1142-4A01-BF08-E57825310E30}"/>
+                <a16:creationId xmlns:a16="http://schemas.microsoft.com/office/drawing/2014/main" id="{B18126B4-C6BA-4C8C-9FFD-7B72B831D2C7}"/>
               </a:ext>
             </a:extLst>
           </p:cNvPr>
@@ -3863,7 +3863,7 @@
           <p:cNvPr id="2" name="">
             <a:extLst xmlns:a="http://schemas.openxmlformats.org/drawingml/2006/main">
               <a:ext uri="{FF2B5EF4-FFF2-40B4-BE49-F238E27FC236}">
-                <a16:creationId xmlns:a16="http://schemas.microsoft.com/office/drawing/2014/main" id="{40BFC971-33BC-4F2B-8BFF-468EAAE47007}"/>
+                <a16:creationId xmlns:a16="http://schemas.microsoft.com/office/drawing/2014/main" id="{959A74E6-0154-4C23-9167-099A212B8D66}"/>
               </a:ext>
             </a:extLst>
           </p:cNvPr>
@@ -3898,7 +3898,7 @@
           <p:cNvPr id="3" name="">
             <a:extLst xmlns:a="http://schemas.openxmlformats.org/drawingml/2006/main">
               <a:ext uri="{FF2B5EF4-FFF2-40B4-BE49-F238E27FC236}">
-                <a16:creationId xmlns:a16="http://schemas.microsoft.com/office/drawing/2014/main" id="{BB64ADCF-E751-4A15-8811-553C2558BCA7}"/>
+                <a16:creationId xmlns:a16="http://schemas.microsoft.com/office/drawing/2014/main" id="{A612AA9B-0224-4814-9786-5F75112A681B}"/>
               </a:ext>
             </a:extLst>
           </p:cNvPr>
@@ -3962,7 +3962,7 @@
           <p:cNvPr id="4" name="">
             <a:extLst xmlns:a="http://schemas.openxmlformats.org/drawingml/2006/main">
               <a:ext uri="{FF2B5EF4-FFF2-40B4-BE49-F238E27FC236}">
-                <a16:creationId xmlns:a16="http://schemas.microsoft.com/office/drawing/2014/main" id="{CC5AFCAA-DB47-425D-846F-6498C9371B55}"/>
+                <a16:creationId xmlns:a16="http://schemas.microsoft.com/office/drawing/2014/main" id="{1339F461-85E2-4627-A95D-A0EA7C71D064}"/>
               </a:ext>
             </a:extLst>
           </p:cNvPr>
@@ -4026,7 +4026,7 @@
           <p:cNvPr id="5" name="">
             <a:extLst xmlns:a="http://schemas.openxmlformats.org/drawingml/2006/main">
               <a:ext uri="{FF2B5EF4-FFF2-40B4-BE49-F238E27FC236}">
-                <a16:creationId xmlns:a16="http://schemas.microsoft.com/office/drawing/2014/main" id="{EF180630-FC39-4A00-9317-A287AE6D15CD}"/>
+                <a16:creationId xmlns:a16="http://schemas.microsoft.com/office/drawing/2014/main" id="{D2C5607A-1473-4FE6-B95B-7B0B070541B8}"/>
               </a:ext>
             </a:extLst>
           </p:cNvPr>
@@ -4080,7 +4080,7 @@
                 <a:ea typeface="Aptos Display"/>
                 <a:cs typeface="Aptos Display"/>
               </a:rPr>
-              <a:t>Aquaponics is incomplete when protein is the real need</a:t>
+              <a:t>Aquaponics links fish and plants. ProteinLoop protects every output.</a:t>
             </a:r>
           </a:p>
         </p:txBody>
@@ -4090,7 +4090,7 @@
           <p:cNvPr id="6" name="">
             <a:extLst xmlns:a="http://schemas.openxmlformats.org/drawingml/2006/main">
               <a:ext uri="{FF2B5EF4-FFF2-40B4-BE49-F238E27FC236}">
-                <a16:creationId xmlns:a16="http://schemas.microsoft.com/office/drawing/2014/main" id="{CF1078EF-4C53-49C5-8B01-1FC6512430EC}"/>
+                <a16:creationId xmlns:a16="http://schemas.microsoft.com/office/drawing/2014/main" id="{59A24D53-7C87-4B63-8814-0E007E1D2747}"/>
               </a:ext>
             </a:extLst>
           </p:cNvPr>
@@ -4144,7 +4144,7 @@
                 <a:ea typeface="Aptos"/>
                 <a:cs typeface="Aptos"/>
               </a:rPr>
-              <a:t>Vegetables are useful, but rural families need resilient daily protein and a system they can operate safely.</a:t>
+              <a:t>The operational gap is making animal biomass, cross-species tradeoffs, and verified recovery immediately visible.</a:t>
             </a:r>
           </a:p>
         </p:txBody>
@@ -4154,7 +4154,7 @@
           <p:cNvPr id="7" name="">
             <a:extLst xmlns:a="http://schemas.openxmlformats.org/drawingml/2006/main">
               <a:ext uri="{FF2B5EF4-FFF2-40B4-BE49-F238E27FC236}">
-                <a16:creationId xmlns:a16="http://schemas.microsoft.com/office/drawing/2014/main" id="{6A661449-2938-4649-84C8-8CF10A3670C2}"/>
+                <a16:creationId xmlns:a16="http://schemas.microsoft.com/office/drawing/2014/main" id="{82366F36-1220-4E1C-99FA-B35FE5DECA7A}"/>
               </a:ext>
             </a:extLst>
           </p:cNvPr>
@@ -4187,7 +4187,7 @@
           <p:cNvPr id="8" name="">
             <a:extLst xmlns:a="http://schemas.openxmlformats.org/drawingml/2006/main">
               <a:ext uri="{FF2B5EF4-FFF2-40B4-BE49-F238E27FC236}">
-                <a16:creationId xmlns:a16="http://schemas.microsoft.com/office/drawing/2014/main" id="{E1CE1D2F-A5A8-4C02-BEAA-F805419CCEFC}"/>
+                <a16:creationId xmlns:a16="http://schemas.microsoft.com/office/drawing/2014/main" id="{72013DAE-275F-40A7-B5F8-2F26F128EC04}"/>
               </a:ext>
             </a:extLst>
           </p:cNvPr>
@@ -4241,7 +4241,7 @@
                 <a:ea typeface="Aptos"/>
                 <a:cs typeface="Aptos"/>
               </a:rPr>
-              <a:t>Current aquaponics</a:t>
+              <a:t>Aquaponics baseline</a:t>
             </a:r>
           </a:p>
         </p:txBody>
@@ -4251,7 +4251,7 @@
           <p:cNvPr id="9" name="">
             <a:extLst xmlns:a="http://schemas.openxmlformats.org/drawingml/2006/main">
               <a:ext uri="{FF2B5EF4-FFF2-40B4-BE49-F238E27FC236}">
-                <a16:creationId xmlns:a16="http://schemas.microsoft.com/office/drawing/2014/main" id="{60E20FB3-1A79-4B8F-BBE7-0F04AF61D77B}"/>
+                <a16:creationId xmlns:a16="http://schemas.microsoft.com/office/drawing/2014/main" id="{91815B99-B42F-4FD8-9BBF-44C41CE814CD}"/>
               </a:ext>
             </a:extLst>
           </p:cNvPr>
@@ -4305,7 +4305,7 @@
                 <a:ea typeface="Aptos"/>
                 <a:cs typeface="Aptos"/>
               </a:rPr>
-              <a:t>Often optimized around greens and water loops. Protein production is secondary and fragile.</a:t>
+              <a:t>Aquatic animals and plants share one water loop. A chemistry failure can threaten both.</a:t>
             </a:r>
           </a:p>
         </p:txBody>
@@ -4315,7 +4315,7 @@
           <p:cNvPr id="10" name="">
             <a:extLst xmlns:a="http://schemas.openxmlformats.org/drawingml/2006/main">
               <a:ext uri="{FF2B5EF4-FFF2-40B4-BE49-F238E27FC236}">
-                <a16:creationId xmlns:a16="http://schemas.microsoft.com/office/drawing/2014/main" id="{4C4D24AA-5654-4EB9-91C3-263370BF4CB0}"/>
+                <a16:creationId xmlns:a16="http://schemas.microsoft.com/office/drawing/2014/main" id="{27125CBD-6272-4BDC-8C2D-0273A232E69F}"/>
               </a:ext>
             </a:extLst>
           </p:cNvPr>
@@ -4348,7 +4348,7 @@
           <p:cNvPr id="11" name="">
             <a:extLst xmlns:a="http://schemas.openxmlformats.org/drawingml/2006/main">
               <a:ext uri="{FF2B5EF4-FFF2-40B4-BE49-F238E27FC236}">
-                <a16:creationId xmlns:a16="http://schemas.microsoft.com/office/drawing/2014/main" id="{2D85DAB1-6D96-486B-A646-62FC2DE7A745}"/>
+                <a16:creationId xmlns:a16="http://schemas.microsoft.com/office/drawing/2014/main" id="{974E1A06-0EC1-4470-BD84-056CDFC8D699}"/>
               </a:ext>
             </a:extLst>
           </p:cNvPr>
@@ -4412,7 +4412,7 @@
           <p:cNvPr id="12" name="">
             <a:extLst xmlns:a="http://schemas.openxmlformats.org/drawingml/2006/main">
               <a:ext uri="{FF2B5EF4-FFF2-40B4-BE49-F238E27FC236}">
-                <a16:creationId xmlns:a16="http://schemas.microsoft.com/office/drawing/2014/main" id="{FF063BFB-E810-4A5B-88E8-82DC8CED59A0}"/>
+                <a16:creationId xmlns:a16="http://schemas.microsoft.com/office/drawing/2014/main" id="{BA4031C8-080D-4E3F-A9A0-DC18C8A218D4}"/>
               </a:ext>
             </a:extLst>
           </p:cNvPr>
@@ -4476,7 +4476,7 @@
           <p:cNvPr id="13" name="">
             <a:extLst xmlns:a="http://schemas.openxmlformats.org/drawingml/2006/main">
               <a:ext uri="{FF2B5EF4-FFF2-40B4-BE49-F238E27FC236}">
-                <a16:creationId xmlns:a16="http://schemas.microsoft.com/office/drawing/2014/main" id="{E977F085-946B-44F4-A030-3E8D4020625F}"/>
+                <a16:creationId xmlns:a16="http://schemas.microsoft.com/office/drawing/2014/main" id="{A9B4C0F7-D156-4672-BDAD-EBE5706415DB}"/>
               </a:ext>
             </a:extLst>
           </p:cNvPr>
@@ -4509,7 +4509,7 @@
           <p:cNvPr id="14" name="">
             <a:extLst xmlns:a="http://schemas.openxmlformats.org/drawingml/2006/main">
               <a:ext uri="{FF2B5EF4-FFF2-40B4-BE49-F238E27FC236}">
-                <a16:creationId xmlns:a16="http://schemas.microsoft.com/office/drawing/2014/main" id="{703C1E56-62C4-424E-BBF3-15C8E44505AF}"/>
+                <a16:creationId xmlns:a16="http://schemas.microsoft.com/office/drawing/2014/main" id="{784CC26C-AFAA-4B50-BF0A-04574204AC5C}"/>
               </a:ext>
             </a:extLst>
           </p:cNvPr>
@@ -4573,7 +4573,7 @@
           <p:cNvPr id="15" name="">
             <a:extLst xmlns:a="http://schemas.openxmlformats.org/drawingml/2006/main">
               <a:ext uri="{FF2B5EF4-FFF2-40B4-BE49-F238E27FC236}">
-                <a16:creationId xmlns:a16="http://schemas.microsoft.com/office/drawing/2014/main" id="{526DB75E-E85B-442B-BFC6-E24FDA002DC3}"/>
+                <a16:creationId xmlns:a16="http://schemas.microsoft.com/office/drawing/2014/main" id="{4E651764-335A-44F9-A62D-15139104B910}"/>
               </a:ext>
             </a:extLst>
           </p:cNvPr>
@@ -4637,7 +4637,7 @@
           <p:cNvPr id="16" name="">
             <a:extLst xmlns:a="http://schemas.openxmlformats.org/drawingml/2006/main">
               <a:ext uri="{FF2B5EF4-FFF2-40B4-BE49-F238E27FC236}">
-                <a16:creationId xmlns:a16="http://schemas.microsoft.com/office/drawing/2014/main" id="{94464458-D9F2-4E53-ACC3-F5D61BD7C027}"/>
+                <a16:creationId xmlns:a16="http://schemas.microsoft.com/office/drawing/2014/main" id="{53CAA8A4-5CEE-45B8-BA7B-46DEF2AED2A1}"/>
               </a:ext>
             </a:extLst>
           </p:cNvPr>
@@ -4701,7 +4701,7 @@
           <p:cNvPr id="17" name="">
             <a:extLst xmlns:a="http://schemas.openxmlformats.org/drawingml/2006/main">
               <a:ext uri="{FF2B5EF4-FFF2-40B4-BE49-F238E27FC236}">
-                <a16:creationId xmlns:a16="http://schemas.microsoft.com/office/drawing/2014/main" id="{A5B7B02C-D8E2-428E-A50D-B5A5210E2843}"/>
+                <a16:creationId xmlns:a16="http://schemas.microsoft.com/office/drawing/2014/main" id="{A1F6D6C0-849D-4628-A802-F04E0CC4DF4E}"/>
               </a:ext>
             </a:extLst>
           </p:cNvPr>
@@ -4763,7 +4763,7 @@
     </p:spTree>
     <p:extLst>
       <p:ext uri="{BB962C8B-B14F-4D97-AF65-F5344CB8AC3E}">
-        <p14:creationId xmlns:p14="http://schemas.microsoft.com/office/powerpoint/2010/main" val="1902378686"/>
+        <p14:creationId xmlns:p14="http://schemas.microsoft.com/office/powerpoint/2010/main" val="706125872"/>
       </p:ext>
     </p:extLst>
   </p:cSld>
@@ -4787,7 +4787,7 @@
           <p:cNvPr id="1" name="">
             <a:extLst xmlns:a="http://schemas.openxmlformats.org/drawingml/2006/main">
               <a:ext uri="{FF2B5EF4-FFF2-40B4-BE49-F238E27FC236}">
-                <a16:creationId xmlns:a16="http://schemas.microsoft.com/office/drawing/2014/main" id="{684D52FB-942C-4C00-9FC7-D5551993AEF4}"/>
+                <a16:creationId xmlns:a16="http://schemas.microsoft.com/office/drawing/2014/main" id="{B0B86CB0-3C05-4EBB-AAAE-46CE067FE5B5}"/>
               </a:ext>
             </a:extLst>
           </p:cNvPr>
@@ -4822,7 +4822,7 @@
           <p:cNvPr id="2" name="">
             <a:extLst xmlns:a="http://schemas.openxmlformats.org/drawingml/2006/main">
               <a:ext uri="{FF2B5EF4-FFF2-40B4-BE49-F238E27FC236}">
-                <a16:creationId xmlns:a16="http://schemas.microsoft.com/office/drawing/2014/main" id="{47F77D71-243D-490F-8995-4D4430B79693}"/>
+                <a16:creationId xmlns:a16="http://schemas.microsoft.com/office/drawing/2014/main" id="{98C86D4D-2B74-4AFA-B377-7BA4F2A020ED}"/>
               </a:ext>
             </a:extLst>
           </p:cNvPr>
@@ -4857,7 +4857,7 @@
           <p:cNvPr id="3" name="">
             <a:extLst xmlns:a="http://schemas.openxmlformats.org/drawingml/2006/main">
               <a:ext uri="{FF2B5EF4-FFF2-40B4-BE49-F238E27FC236}">
-                <a16:creationId xmlns:a16="http://schemas.microsoft.com/office/drawing/2014/main" id="{CD9193A8-CFD4-488D-8BAC-F94C3CBE58CF}"/>
+                <a16:creationId xmlns:a16="http://schemas.microsoft.com/office/drawing/2014/main" id="{20F5013D-9836-4AD6-8A2A-E24F96996188}"/>
               </a:ext>
             </a:extLst>
           </p:cNvPr>
@@ -4921,7 +4921,7 @@
           <p:cNvPr id="4" name="">
             <a:extLst xmlns:a="http://schemas.openxmlformats.org/drawingml/2006/main">
               <a:ext uri="{FF2B5EF4-FFF2-40B4-BE49-F238E27FC236}">
-                <a16:creationId xmlns:a16="http://schemas.microsoft.com/office/drawing/2014/main" id="{6B590705-ED6D-436F-98FC-FCC552DD65B6}"/>
+                <a16:creationId xmlns:a16="http://schemas.microsoft.com/office/drawing/2014/main" id="{96DB5A11-FB43-47C1-B4AD-83BD3DFA6E60}"/>
               </a:ext>
             </a:extLst>
           </p:cNvPr>
@@ -4985,7 +4985,7 @@
           <p:cNvPr id="5" name="">
             <a:extLst xmlns:a="http://schemas.openxmlformats.org/drawingml/2006/main">
               <a:ext uri="{FF2B5EF4-FFF2-40B4-BE49-F238E27FC236}">
-                <a16:creationId xmlns:a16="http://schemas.microsoft.com/office/drawing/2014/main" id="{0F9FF02E-D6FE-4F46-AE90-6A2E17F6B1E0}"/>
+                <a16:creationId xmlns:a16="http://schemas.microsoft.com/office/drawing/2014/main" id="{30E841B9-C077-4510-80E4-12DF149D7C87}"/>
               </a:ext>
             </a:extLst>
           </p:cNvPr>
@@ -5049,7 +5049,7 @@
           <p:cNvPr id="6" name="">
             <a:extLst xmlns:a="http://schemas.openxmlformats.org/drawingml/2006/main">
               <a:ext uri="{FF2B5EF4-FFF2-40B4-BE49-F238E27FC236}">
-                <a16:creationId xmlns:a16="http://schemas.microsoft.com/office/drawing/2014/main" id="{7FD12B3D-034A-4BCF-A2BD-D348B37E9543}"/>
+                <a16:creationId xmlns:a16="http://schemas.microsoft.com/office/drawing/2014/main" id="{1239B93D-8206-4ED4-B826-945ED578E5F1}"/>
               </a:ext>
             </a:extLst>
           </p:cNvPr>
@@ -5113,7 +5113,7 @@
           <p:cNvPr id="7" name="">
             <a:extLst xmlns:a="http://schemas.openxmlformats.org/drawingml/2006/main">
               <a:ext uri="{FF2B5EF4-FFF2-40B4-BE49-F238E27FC236}">
-                <a16:creationId xmlns:a16="http://schemas.microsoft.com/office/drawing/2014/main" id="{473B9C85-4B1A-41E1-8B26-35B252B7CD18}"/>
+                <a16:creationId xmlns:a16="http://schemas.microsoft.com/office/drawing/2014/main" id="{3CFB1CDD-883A-4DFB-9965-C0F6CD925A6A}"/>
               </a:ext>
             </a:extLst>
           </p:cNvPr>
@@ -5146,7 +5146,7 @@
           <p:cNvPr id="8" name="">
             <a:extLst xmlns:a="http://schemas.openxmlformats.org/drawingml/2006/main">
               <a:ext uri="{FF2B5EF4-FFF2-40B4-BE49-F238E27FC236}">
-                <a16:creationId xmlns:a16="http://schemas.microsoft.com/office/drawing/2014/main" id="{900FF943-B582-4F3D-A486-267AC822B7C3}"/>
+                <a16:creationId xmlns:a16="http://schemas.microsoft.com/office/drawing/2014/main" id="{4EDB83C7-6FF2-4671-8DE7-3DD85D096CB3}"/>
               </a:ext>
             </a:extLst>
           </p:cNvPr>
@@ -5210,7 +5210,7 @@
           <p:cNvPr id="9" name="">
             <a:extLst xmlns:a="http://schemas.openxmlformats.org/drawingml/2006/main">
               <a:ext uri="{FF2B5EF4-FFF2-40B4-BE49-F238E27FC236}">
-                <a16:creationId xmlns:a16="http://schemas.microsoft.com/office/drawing/2014/main" id="{33298D00-488A-4956-8023-9E1FF556A6CB}"/>
+                <a16:creationId xmlns:a16="http://schemas.microsoft.com/office/drawing/2014/main" id="{F4B4AC52-82B1-478E-90D8-B27231118E5D}"/>
               </a:ext>
             </a:extLst>
           </p:cNvPr>
@@ -5274,7 +5274,7 @@
           <p:cNvPr id="10" name="">
             <a:extLst xmlns:a="http://schemas.openxmlformats.org/drawingml/2006/main">
               <a:ext uri="{FF2B5EF4-FFF2-40B4-BE49-F238E27FC236}">
-                <a16:creationId xmlns:a16="http://schemas.microsoft.com/office/drawing/2014/main" id="{521D8BD0-5BE2-4197-BC21-F636EA264331}"/>
+                <a16:creationId xmlns:a16="http://schemas.microsoft.com/office/drawing/2014/main" id="{8103C4A8-8B2E-4CD8-9B65-9379DCF18834}"/>
               </a:ext>
             </a:extLst>
           </p:cNvPr>
@@ -5338,7 +5338,7 @@
           <p:cNvPr id="11" name="">
             <a:extLst xmlns:a="http://schemas.openxmlformats.org/drawingml/2006/main">
               <a:ext uri="{FF2B5EF4-FFF2-40B4-BE49-F238E27FC236}">
-                <a16:creationId xmlns:a16="http://schemas.microsoft.com/office/drawing/2014/main" id="{DB4FE347-0EBD-4A19-B9DD-EEDED7F9F691}"/>
+                <a16:creationId xmlns:a16="http://schemas.microsoft.com/office/drawing/2014/main" id="{457A95D1-FB9F-431C-8D3B-5AC9118171F7}"/>
               </a:ext>
             </a:extLst>
           </p:cNvPr>
@@ -5371,7 +5371,7 @@
           <p:cNvPr id="12" name="">
             <a:extLst xmlns:a="http://schemas.openxmlformats.org/drawingml/2006/main">
               <a:ext uri="{FF2B5EF4-FFF2-40B4-BE49-F238E27FC236}">
-                <a16:creationId xmlns:a16="http://schemas.microsoft.com/office/drawing/2014/main" id="{521AEF52-C15E-4F51-81EE-0596C181D3B5}"/>
+                <a16:creationId xmlns:a16="http://schemas.microsoft.com/office/drawing/2014/main" id="{EC8C835F-922F-40D2-A10E-812D4D33D7DC}"/>
               </a:ext>
             </a:extLst>
           </p:cNvPr>
@@ -5435,7 +5435,7 @@
           <p:cNvPr id="13" name="">
             <a:extLst xmlns:a="http://schemas.openxmlformats.org/drawingml/2006/main">
               <a:ext uri="{FF2B5EF4-FFF2-40B4-BE49-F238E27FC236}">
-                <a16:creationId xmlns:a16="http://schemas.microsoft.com/office/drawing/2014/main" id="{05C774D4-0103-41A6-ACE2-310D838E95C3}"/>
+                <a16:creationId xmlns:a16="http://schemas.microsoft.com/office/drawing/2014/main" id="{C0079DF4-ABE9-4891-ABDC-FFB70FA9B5F8}"/>
               </a:ext>
             </a:extLst>
           </p:cNvPr>
@@ -5499,7 +5499,7 @@
           <p:cNvPr id="14" name="">
             <a:extLst xmlns:a="http://schemas.openxmlformats.org/drawingml/2006/main">
               <a:ext uri="{FF2B5EF4-FFF2-40B4-BE49-F238E27FC236}">
-                <a16:creationId xmlns:a16="http://schemas.microsoft.com/office/drawing/2014/main" id="{8BA3A7D6-EE61-49D5-AB61-00339182C847}"/>
+                <a16:creationId xmlns:a16="http://schemas.microsoft.com/office/drawing/2014/main" id="{DB36F4F9-8994-414D-A97A-AFEB1603991A}"/>
               </a:ext>
             </a:extLst>
           </p:cNvPr>
@@ -5563,7 +5563,7 @@
           <p:cNvPr id="15" name="">
             <a:extLst xmlns:a="http://schemas.openxmlformats.org/drawingml/2006/main">
               <a:ext uri="{FF2B5EF4-FFF2-40B4-BE49-F238E27FC236}">
-                <a16:creationId xmlns:a16="http://schemas.microsoft.com/office/drawing/2014/main" id="{3471FD29-A3DC-4521-ABBF-BE828F1A752D}"/>
+                <a16:creationId xmlns:a16="http://schemas.microsoft.com/office/drawing/2014/main" id="{C8861518-F60D-4B5E-999E-438F5F0A36D5}"/>
               </a:ext>
             </a:extLst>
           </p:cNvPr>
@@ -5596,7 +5596,7 @@
           <p:cNvPr id="16" name="">
             <a:extLst xmlns:a="http://schemas.openxmlformats.org/drawingml/2006/main">
               <a:ext uri="{FF2B5EF4-FFF2-40B4-BE49-F238E27FC236}">
-                <a16:creationId xmlns:a16="http://schemas.microsoft.com/office/drawing/2014/main" id="{F05DA2A2-68C1-433A-9F80-92114F9934BE}"/>
+                <a16:creationId xmlns:a16="http://schemas.microsoft.com/office/drawing/2014/main" id="{5E1A051E-9838-48A9-9B5B-FAE8AB348D81}"/>
               </a:ext>
             </a:extLst>
           </p:cNvPr>
@@ -5660,7 +5660,7 @@
           <p:cNvPr id="17" name="">
             <a:extLst xmlns:a="http://schemas.openxmlformats.org/drawingml/2006/main">
               <a:ext uri="{FF2B5EF4-FFF2-40B4-BE49-F238E27FC236}">
-                <a16:creationId xmlns:a16="http://schemas.microsoft.com/office/drawing/2014/main" id="{BBB37C22-7542-4CBA-B4C1-5F00A100A2EB}"/>
+                <a16:creationId xmlns:a16="http://schemas.microsoft.com/office/drawing/2014/main" id="{AD9E8758-E139-4208-BD47-DD452EF91288}"/>
               </a:ext>
             </a:extLst>
           </p:cNvPr>
@@ -5724,7 +5724,7 @@
           <p:cNvPr id="18" name="">
             <a:extLst xmlns:a="http://schemas.openxmlformats.org/drawingml/2006/main">
               <a:ext uri="{FF2B5EF4-FFF2-40B4-BE49-F238E27FC236}">
-                <a16:creationId xmlns:a16="http://schemas.microsoft.com/office/drawing/2014/main" id="{0534E370-EA41-40BA-81F7-A8C000618827}"/>
+                <a16:creationId xmlns:a16="http://schemas.microsoft.com/office/drawing/2014/main" id="{EB0330E4-4C95-4C2C-8A37-2C780890D247}"/>
               </a:ext>
             </a:extLst>
           </p:cNvPr>
@@ -5788,7 +5788,7 @@
           <p:cNvPr id="19" name="">
             <a:extLst xmlns:a="http://schemas.openxmlformats.org/drawingml/2006/main">
               <a:ext uri="{FF2B5EF4-FFF2-40B4-BE49-F238E27FC236}">
-                <a16:creationId xmlns:a16="http://schemas.microsoft.com/office/drawing/2014/main" id="{8C8093F9-E2C4-42BC-A8D4-1F6811F66F11}"/>
+                <a16:creationId xmlns:a16="http://schemas.microsoft.com/office/drawing/2014/main" id="{CC86E89D-A75E-4101-951C-82DD738083D2}"/>
               </a:ext>
             </a:extLst>
           </p:cNvPr>
@@ -5821,7 +5821,7 @@
           <p:cNvPr id="20" name="">
             <a:extLst xmlns:a="http://schemas.openxmlformats.org/drawingml/2006/main">
               <a:ext uri="{FF2B5EF4-FFF2-40B4-BE49-F238E27FC236}">
-                <a16:creationId xmlns:a16="http://schemas.microsoft.com/office/drawing/2014/main" id="{1D964805-D7BF-4062-8EF5-38F53E84B5F8}"/>
+                <a16:creationId xmlns:a16="http://schemas.microsoft.com/office/drawing/2014/main" id="{24F3C6E9-716E-4716-833B-1102353FA7C2}"/>
               </a:ext>
             </a:extLst>
           </p:cNvPr>
@@ -5885,7 +5885,7 @@
           <p:cNvPr id="21" name="">
             <a:extLst xmlns:a="http://schemas.openxmlformats.org/drawingml/2006/main">
               <a:ext uri="{FF2B5EF4-FFF2-40B4-BE49-F238E27FC236}">
-                <a16:creationId xmlns:a16="http://schemas.microsoft.com/office/drawing/2014/main" id="{640B0E92-835F-42E1-A555-2A788664E134}"/>
+                <a16:creationId xmlns:a16="http://schemas.microsoft.com/office/drawing/2014/main" id="{DF3EA840-3B8A-4788-9997-87CBA56426CB}"/>
               </a:ext>
             </a:extLst>
           </p:cNvPr>
@@ -5949,7 +5949,7 @@
           <p:cNvPr id="22" name="">
             <a:extLst xmlns:a="http://schemas.openxmlformats.org/drawingml/2006/main">
               <a:ext uri="{FF2B5EF4-FFF2-40B4-BE49-F238E27FC236}">
-                <a16:creationId xmlns:a16="http://schemas.microsoft.com/office/drawing/2014/main" id="{FA0E19AF-386D-450D-912D-0E62F6F00144}"/>
+                <a16:creationId xmlns:a16="http://schemas.microsoft.com/office/drawing/2014/main" id="{C7A692CE-84BE-4BAC-AA04-224CC106A52E}"/>
               </a:ext>
             </a:extLst>
           </p:cNvPr>
@@ -5982,7 +5982,7 @@
           <p:cNvPr id="23" name="">
             <a:extLst xmlns:a="http://schemas.openxmlformats.org/drawingml/2006/main">
               <a:ext uri="{FF2B5EF4-FFF2-40B4-BE49-F238E27FC236}">
-                <a16:creationId xmlns:a16="http://schemas.microsoft.com/office/drawing/2014/main" id="{3234A427-746E-46E8-9C1F-3132ED81D185}"/>
+                <a16:creationId xmlns:a16="http://schemas.microsoft.com/office/drawing/2014/main" id="{1EA3A54E-C797-43D9-A765-904189FFB944}"/>
               </a:ext>
             </a:extLst>
           </p:cNvPr>
@@ -6046,7 +6046,7 @@
           <p:cNvPr id="24" name="">
             <a:extLst xmlns:a="http://schemas.openxmlformats.org/drawingml/2006/main">
               <a:ext uri="{FF2B5EF4-FFF2-40B4-BE49-F238E27FC236}">
-                <a16:creationId xmlns:a16="http://schemas.microsoft.com/office/drawing/2014/main" id="{48876379-48FB-4382-85C7-FE0AD95964C6}"/>
+                <a16:creationId xmlns:a16="http://schemas.microsoft.com/office/drawing/2014/main" id="{610C9658-57AB-46B6-93D2-DA9C79EACD5A}"/>
               </a:ext>
             </a:extLst>
           </p:cNvPr>
@@ -6110,7 +6110,7 @@
           <p:cNvPr id="25" name="">
             <a:extLst xmlns:a="http://schemas.openxmlformats.org/drawingml/2006/main">
               <a:ext uri="{FF2B5EF4-FFF2-40B4-BE49-F238E27FC236}">
-                <a16:creationId xmlns:a16="http://schemas.microsoft.com/office/drawing/2014/main" id="{2756C30C-9CF8-4E67-8D98-DC944C57F4BC}"/>
+                <a16:creationId xmlns:a16="http://schemas.microsoft.com/office/drawing/2014/main" id="{A2D78A40-70D2-4B86-A9AF-EE34DE8FA7AD}"/>
               </a:ext>
             </a:extLst>
           </p:cNvPr>
@@ -6174,7 +6174,7 @@
           <p:cNvPr id="26" name="">
             <a:extLst xmlns:a="http://schemas.openxmlformats.org/drawingml/2006/main">
               <a:ext uri="{FF2B5EF4-FFF2-40B4-BE49-F238E27FC236}">
-                <a16:creationId xmlns:a16="http://schemas.microsoft.com/office/drawing/2014/main" id="{A35A990E-5347-4B63-933A-639CFEF9B6FB}"/>
+                <a16:creationId xmlns:a16="http://schemas.microsoft.com/office/drawing/2014/main" id="{11FB3507-9CD8-4A43-B25E-AE169D89F180}"/>
               </a:ext>
             </a:extLst>
           </p:cNvPr>
@@ -6236,7 +6236,7 @@
     </p:spTree>
     <p:extLst>
       <p:ext uri="{BB962C8B-B14F-4D97-AF65-F5344CB8AC3E}">
-        <p14:creationId xmlns:p14="http://schemas.microsoft.com/office/powerpoint/2010/main" val="1582187491"/>
+        <p14:creationId xmlns:p14="http://schemas.microsoft.com/office/powerpoint/2010/main" val="1910141926"/>
       </p:ext>
     </p:extLst>
   </p:cSld>
@@ -6260,7 +6260,7 @@
           <p:cNvPr id="1" name="">
             <a:extLst xmlns:a="http://schemas.openxmlformats.org/drawingml/2006/main">
               <a:ext uri="{FF2B5EF4-FFF2-40B4-BE49-F238E27FC236}">
-                <a16:creationId xmlns:a16="http://schemas.microsoft.com/office/drawing/2014/main" id="{828D8A2A-522E-48B3-89D3-11142EF672E8}"/>
+                <a16:creationId xmlns:a16="http://schemas.microsoft.com/office/drawing/2014/main" id="{6577F2C9-92A0-46E9-BBF0-F420626DACE5}"/>
               </a:ext>
             </a:extLst>
           </p:cNvPr>
@@ -6295,7 +6295,7 @@
           <p:cNvPr id="2" name="">
             <a:extLst xmlns:a="http://schemas.openxmlformats.org/drawingml/2006/main">
               <a:ext uri="{FF2B5EF4-FFF2-40B4-BE49-F238E27FC236}">
-                <a16:creationId xmlns:a16="http://schemas.microsoft.com/office/drawing/2014/main" id="{49CD6A5D-368E-4910-A3B4-26662B796A38}"/>
+                <a16:creationId xmlns:a16="http://schemas.microsoft.com/office/drawing/2014/main" id="{CBC40A47-DFFC-4487-A52D-713DA60865D9}"/>
               </a:ext>
             </a:extLst>
           </p:cNvPr>
@@ -6330,7 +6330,7 @@
           <p:cNvPr id="3" name="">
             <a:extLst xmlns:a="http://schemas.openxmlformats.org/drawingml/2006/main">
               <a:ext uri="{FF2B5EF4-FFF2-40B4-BE49-F238E27FC236}">
-                <a16:creationId xmlns:a16="http://schemas.microsoft.com/office/drawing/2014/main" id="{71FD0A63-8D15-45DB-8223-0DD433EDCCE5}"/>
+                <a16:creationId xmlns:a16="http://schemas.microsoft.com/office/drawing/2014/main" id="{DD27CDC6-8FAE-44EA-B863-3B25F633FFA9}"/>
               </a:ext>
             </a:extLst>
           </p:cNvPr>
@@ -6394,7 +6394,7 @@
           <p:cNvPr id="4" name="">
             <a:extLst xmlns:a="http://schemas.openxmlformats.org/drawingml/2006/main">
               <a:ext uri="{FF2B5EF4-FFF2-40B4-BE49-F238E27FC236}">
-                <a16:creationId xmlns:a16="http://schemas.microsoft.com/office/drawing/2014/main" id="{965017D3-B2D5-49C3-851F-1FC49AFB0E00}"/>
+                <a16:creationId xmlns:a16="http://schemas.microsoft.com/office/drawing/2014/main" id="{E63F26FF-DA4D-4099-A819-9F7FE9939379}"/>
               </a:ext>
             </a:extLst>
           </p:cNvPr>
@@ -6458,7 +6458,7 @@
           <p:cNvPr id="5" name="">
             <a:extLst xmlns:a="http://schemas.openxmlformats.org/drawingml/2006/main">
               <a:ext uri="{FF2B5EF4-FFF2-40B4-BE49-F238E27FC236}">
-                <a16:creationId xmlns:a16="http://schemas.microsoft.com/office/drawing/2014/main" id="{9B935E87-346B-48AD-90D1-E75B4C3084C7}"/>
+                <a16:creationId xmlns:a16="http://schemas.microsoft.com/office/drawing/2014/main" id="{7DABDD03-82D8-4A5F-B2C1-660BC4693EB8}"/>
               </a:ext>
             </a:extLst>
           </p:cNvPr>
@@ -6522,7 +6522,7 @@
           <p:cNvPr id="6" name="">
             <a:extLst xmlns:a="http://schemas.openxmlformats.org/drawingml/2006/main">
               <a:ext uri="{FF2B5EF4-FFF2-40B4-BE49-F238E27FC236}">
-                <a16:creationId xmlns:a16="http://schemas.microsoft.com/office/drawing/2014/main" id="{F8E34559-E55B-4DD4-83DE-2A86BB2BD022}"/>
+                <a16:creationId xmlns:a16="http://schemas.microsoft.com/office/drawing/2014/main" id="{154C4713-B6D0-4A78-B20F-4FF96A3AA5DC}"/>
               </a:ext>
             </a:extLst>
           </p:cNvPr>
@@ -6586,7 +6586,7 @@
           <p:cNvPr id="7" name="">
             <a:extLst xmlns:a="http://schemas.openxmlformats.org/drawingml/2006/main">
               <a:ext uri="{FF2B5EF4-FFF2-40B4-BE49-F238E27FC236}">
-                <a16:creationId xmlns:a16="http://schemas.microsoft.com/office/drawing/2014/main" id="{6F2FFBD2-FAC8-457D-A3B9-4CFBF847AF26}"/>
+                <a16:creationId xmlns:a16="http://schemas.microsoft.com/office/drawing/2014/main" id="{2305C42C-1ECB-4041-A89B-C1A87EA03AF0}"/>
               </a:ext>
             </a:extLst>
           </p:cNvPr>
@@ -6619,7 +6619,7 @@
           <p:cNvPr id="8" name="">
             <a:extLst xmlns:a="http://schemas.openxmlformats.org/drawingml/2006/main">
               <a:ext uri="{FF2B5EF4-FFF2-40B4-BE49-F238E27FC236}">
-                <a16:creationId xmlns:a16="http://schemas.microsoft.com/office/drawing/2014/main" id="{E2DFE079-D382-4D0B-8F12-5A7377D93FF4}"/>
+                <a16:creationId xmlns:a16="http://schemas.microsoft.com/office/drawing/2014/main" id="{2413E95B-7941-4412-B112-D26D488ED1BA}"/>
               </a:ext>
             </a:extLst>
           </p:cNvPr>
@@ -6683,7 +6683,7 @@
           <p:cNvPr id="9" name="">
             <a:extLst xmlns:a="http://schemas.openxmlformats.org/drawingml/2006/main">
               <a:ext uri="{FF2B5EF4-FFF2-40B4-BE49-F238E27FC236}">
-                <a16:creationId xmlns:a16="http://schemas.microsoft.com/office/drawing/2014/main" id="{1E6EF5FC-F731-48FE-B4D5-2C40877363D2}"/>
+                <a16:creationId xmlns:a16="http://schemas.microsoft.com/office/drawing/2014/main" id="{B3BCF77E-88C0-4758-956C-E203DDF764B5}"/>
               </a:ext>
             </a:extLst>
           </p:cNvPr>
@@ -6747,7 +6747,7 @@
           <p:cNvPr id="10" name="">
             <a:extLst xmlns:a="http://schemas.openxmlformats.org/drawingml/2006/main">
               <a:ext uri="{FF2B5EF4-FFF2-40B4-BE49-F238E27FC236}">
-                <a16:creationId xmlns:a16="http://schemas.microsoft.com/office/drawing/2014/main" id="{57C6C4C7-BE03-4129-AD15-77444FF627FA}"/>
+                <a16:creationId xmlns:a16="http://schemas.microsoft.com/office/drawing/2014/main" id="{DC204356-D0AF-46CB-88E0-1BC7868FC97E}"/>
               </a:ext>
             </a:extLst>
           </p:cNvPr>
@@ -6811,7 +6811,7 @@
           <p:cNvPr id="11" name="">
             <a:extLst xmlns:a="http://schemas.openxmlformats.org/drawingml/2006/main">
               <a:ext uri="{FF2B5EF4-FFF2-40B4-BE49-F238E27FC236}">
-                <a16:creationId xmlns:a16="http://schemas.microsoft.com/office/drawing/2014/main" id="{E2E9BAC9-1B5E-4322-9657-C1AD2FCDC833}"/>
+                <a16:creationId xmlns:a16="http://schemas.microsoft.com/office/drawing/2014/main" id="{36C4A67F-BD42-454C-86B6-39F3824AE13B}"/>
               </a:ext>
             </a:extLst>
           </p:cNvPr>
@@ -6844,7 +6844,7 @@
           <p:cNvPr id="12" name="">
             <a:extLst xmlns:a="http://schemas.openxmlformats.org/drawingml/2006/main">
               <a:ext uri="{FF2B5EF4-FFF2-40B4-BE49-F238E27FC236}">
-                <a16:creationId xmlns:a16="http://schemas.microsoft.com/office/drawing/2014/main" id="{CDFCAE96-1370-477A-994C-A0D5355CC5A2}"/>
+                <a16:creationId xmlns:a16="http://schemas.microsoft.com/office/drawing/2014/main" id="{E75EFE26-9432-4F0F-9460-C9EBA51C123E}"/>
               </a:ext>
             </a:extLst>
           </p:cNvPr>
@@ -6908,7 +6908,7 @@
           <p:cNvPr id="13" name="">
             <a:extLst xmlns:a="http://schemas.openxmlformats.org/drawingml/2006/main">
               <a:ext uri="{FF2B5EF4-FFF2-40B4-BE49-F238E27FC236}">
-                <a16:creationId xmlns:a16="http://schemas.microsoft.com/office/drawing/2014/main" id="{14BC5C2C-3B48-4AD9-A014-3421B567E8C2}"/>
+                <a16:creationId xmlns:a16="http://schemas.microsoft.com/office/drawing/2014/main" id="{8C94D59C-4CF5-4BC6-BFFC-16C489820780}"/>
               </a:ext>
             </a:extLst>
           </p:cNvPr>
@@ -6972,7 +6972,7 @@
           <p:cNvPr id="14" name="">
             <a:extLst xmlns:a="http://schemas.openxmlformats.org/drawingml/2006/main">
               <a:ext uri="{FF2B5EF4-FFF2-40B4-BE49-F238E27FC236}">
-                <a16:creationId xmlns:a16="http://schemas.microsoft.com/office/drawing/2014/main" id="{87353F8F-72AF-4C1A-BF3D-357AF52C807F}"/>
+                <a16:creationId xmlns:a16="http://schemas.microsoft.com/office/drawing/2014/main" id="{9E9A023E-5FCC-49D8-8CD4-A54A64DB7B78}"/>
               </a:ext>
             </a:extLst>
           </p:cNvPr>
@@ -7036,7 +7036,7 @@
           <p:cNvPr id="15" name="">
             <a:extLst xmlns:a="http://schemas.openxmlformats.org/drawingml/2006/main">
               <a:ext uri="{FF2B5EF4-FFF2-40B4-BE49-F238E27FC236}">
-                <a16:creationId xmlns:a16="http://schemas.microsoft.com/office/drawing/2014/main" id="{BBEF07C0-C3A7-44EB-B745-E87EE5EE572E}"/>
+                <a16:creationId xmlns:a16="http://schemas.microsoft.com/office/drawing/2014/main" id="{C4487952-FB42-4532-B8E4-5C914B8254B7}"/>
               </a:ext>
             </a:extLst>
           </p:cNvPr>
@@ -7069,7 +7069,7 @@
           <p:cNvPr id="16" name="">
             <a:extLst xmlns:a="http://schemas.openxmlformats.org/drawingml/2006/main">
               <a:ext uri="{FF2B5EF4-FFF2-40B4-BE49-F238E27FC236}">
-                <a16:creationId xmlns:a16="http://schemas.microsoft.com/office/drawing/2014/main" id="{0CDE3530-E41F-4745-8250-57EB22FE54FA}"/>
+                <a16:creationId xmlns:a16="http://schemas.microsoft.com/office/drawing/2014/main" id="{67126A79-E1DF-4E9B-B377-FD6AF0992640}"/>
               </a:ext>
             </a:extLst>
           </p:cNvPr>
@@ -7133,7 +7133,7 @@
           <p:cNvPr id="17" name="">
             <a:extLst xmlns:a="http://schemas.openxmlformats.org/drawingml/2006/main">
               <a:ext uri="{FF2B5EF4-FFF2-40B4-BE49-F238E27FC236}">
-                <a16:creationId xmlns:a16="http://schemas.microsoft.com/office/drawing/2014/main" id="{DC2B4AAE-1321-47A1-B66B-0A66E9F70F56}"/>
+                <a16:creationId xmlns:a16="http://schemas.microsoft.com/office/drawing/2014/main" id="{116D9FA6-EBD3-42CE-8523-58D344A30D4F}"/>
               </a:ext>
             </a:extLst>
           </p:cNvPr>
@@ -7197,7 +7197,7 @@
           <p:cNvPr id="18" name="">
             <a:extLst xmlns:a="http://schemas.openxmlformats.org/drawingml/2006/main">
               <a:ext uri="{FF2B5EF4-FFF2-40B4-BE49-F238E27FC236}">
-                <a16:creationId xmlns:a16="http://schemas.microsoft.com/office/drawing/2014/main" id="{3DC1F49D-C2DF-4F67-8232-A662E6BDFA2A}"/>
+                <a16:creationId xmlns:a16="http://schemas.microsoft.com/office/drawing/2014/main" id="{12227AB4-887A-440F-9469-C6E61570EEDC}"/>
               </a:ext>
             </a:extLst>
           </p:cNvPr>
@@ -7261,7 +7261,7 @@
           <p:cNvPr id="19" name="">
             <a:extLst xmlns:a="http://schemas.openxmlformats.org/drawingml/2006/main">
               <a:ext uri="{FF2B5EF4-FFF2-40B4-BE49-F238E27FC236}">
-                <a16:creationId xmlns:a16="http://schemas.microsoft.com/office/drawing/2014/main" id="{74C29266-7416-4C4D-932E-0274847023D0}"/>
+                <a16:creationId xmlns:a16="http://schemas.microsoft.com/office/drawing/2014/main" id="{B9505027-880C-4924-AD45-337A4FA87973}"/>
               </a:ext>
             </a:extLst>
           </p:cNvPr>
@@ -7294,7 +7294,7 @@
           <p:cNvPr id="20" name="">
             <a:extLst xmlns:a="http://schemas.openxmlformats.org/drawingml/2006/main">
               <a:ext uri="{FF2B5EF4-FFF2-40B4-BE49-F238E27FC236}">
-                <a16:creationId xmlns:a16="http://schemas.microsoft.com/office/drawing/2014/main" id="{E2BC3438-DF2C-4FA0-B450-E63C8F722501}"/>
+                <a16:creationId xmlns:a16="http://schemas.microsoft.com/office/drawing/2014/main" id="{08C55C13-0BE1-451D-B0EA-6B4405976093}"/>
               </a:ext>
             </a:extLst>
           </p:cNvPr>
@@ -7358,7 +7358,7 @@
           <p:cNvPr id="21" name="">
             <a:extLst xmlns:a="http://schemas.openxmlformats.org/drawingml/2006/main">
               <a:ext uri="{FF2B5EF4-FFF2-40B4-BE49-F238E27FC236}">
-                <a16:creationId xmlns:a16="http://schemas.microsoft.com/office/drawing/2014/main" id="{9049EFD0-D970-47D1-AC0E-798889EC1DE6}"/>
+                <a16:creationId xmlns:a16="http://schemas.microsoft.com/office/drawing/2014/main" id="{1FFAE396-B015-4CA7-9CCD-10B16BF53338}"/>
               </a:ext>
             </a:extLst>
           </p:cNvPr>
@@ -7422,7 +7422,7 @@
           <p:cNvPr id="22" name="">
             <a:extLst xmlns:a="http://schemas.openxmlformats.org/drawingml/2006/main">
               <a:ext uri="{FF2B5EF4-FFF2-40B4-BE49-F238E27FC236}">
-                <a16:creationId xmlns:a16="http://schemas.microsoft.com/office/drawing/2014/main" id="{5424264F-2D54-4542-80F7-E526C095B339}"/>
+                <a16:creationId xmlns:a16="http://schemas.microsoft.com/office/drawing/2014/main" id="{5DFDD4EC-CFBD-4C44-A486-63E9FC02281A}"/>
               </a:ext>
             </a:extLst>
           </p:cNvPr>
@@ -7455,7 +7455,7 @@
           <p:cNvPr id="23" name="">
             <a:extLst xmlns:a="http://schemas.openxmlformats.org/drawingml/2006/main">
               <a:ext uri="{FF2B5EF4-FFF2-40B4-BE49-F238E27FC236}">
-                <a16:creationId xmlns:a16="http://schemas.microsoft.com/office/drawing/2014/main" id="{27F1C35F-14CC-4B53-9ACE-57D31290F7DA}"/>
+                <a16:creationId xmlns:a16="http://schemas.microsoft.com/office/drawing/2014/main" id="{CC282610-30E9-4E82-BE32-105C35490AD3}"/>
               </a:ext>
             </a:extLst>
           </p:cNvPr>
@@ -7519,7 +7519,7 @@
           <p:cNvPr id="24" name="">
             <a:extLst xmlns:a="http://schemas.openxmlformats.org/drawingml/2006/main">
               <a:ext uri="{FF2B5EF4-FFF2-40B4-BE49-F238E27FC236}">
-                <a16:creationId xmlns:a16="http://schemas.microsoft.com/office/drawing/2014/main" id="{C8D92A32-9571-4AA3-B20D-F435B39D9025}"/>
+                <a16:creationId xmlns:a16="http://schemas.microsoft.com/office/drawing/2014/main" id="{0A14F0F6-2014-4C6E-8792-08D4499FAD76}"/>
               </a:ext>
             </a:extLst>
           </p:cNvPr>
@@ -7583,7 +7583,7 @@
           <p:cNvPr id="25" name="">
             <a:extLst xmlns:a="http://schemas.openxmlformats.org/drawingml/2006/main">
               <a:ext uri="{FF2B5EF4-FFF2-40B4-BE49-F238E27FC236}">
-                <a16:creationId xmlns:a16="http://schemas.microsoft.com/office/drawing/2014/main" id="{0F9FB350-8586-4689-8603-6672D438B51B}"/>
+                <a16:creationId xmlns:a16="http://schemas.microsoft.com/office/drawing/2014/main" id="{82FF1DC7-C807-4213-B618-D1EE21CBDBAD}"/>
               </a:ext>
             </a:extLst>
           </p:cNvPr>
@@ -7647,7 +7647,7 @@
           <p:cNvPr id="26" name="">
             <a:extLst xmlns:a="http://schemas.openxmlformats.org/drawingml/2006/main">
               <a:ext uri="{FF2B5EF4-FFF2-40B4-BE49-F238E27FC236}">
-                <a16:creationId xmlns:a16="http://schemas.microsoft.com/office/drawing/2014/main" id="{2C4E600C-4818-45FA-830C-6FCA689BFDE5}"/>
+                <a16:creationId xmlns:a16="http://schemas.microsoft.com/office/drawing/2014/main" id="{7326D8F9-7C04-4700-814B-843572C530C7}"/>
               </a:ext>
             </a:extLst>
           </p:cNvPr>
@@ -7709,7 +7709,7 @@
     </p:spTree>
     <p:extLst>
       <p:ext uri="{BB962C8B-B14F-4D97-AF65-F5344CB8AC3E}">
-        <p14:creationId xmlns:p14="http://schemas.microsoft.com/office/powerpoint/2010/main" val="1473759217"/>
+        <p14:creationId xmlns:p14="http://schemas.microsoft.com/office/powerpoint/2010/main" val="1272261919"/>
       </p:ext>
     </p:extLst>
   </p:cSld>
@@ -7733,7 +7733,7 @@
           <p:cNvPr id="1" name="">
             <a:extLst xmlns:a="http://schemas.openxmlformats.org/drawingml/2006/main">
               <a:ext uri="{FF2B5EF4-FFF2-40B4-BE49-F238E27FC236}">
-                <a16:creationId xmlns:a16="http://schemas.microsoft.com/office/drawing/2014/main" id="{42D6205F-F975-4A8C-82C1-7668F1C3A913}"/>
+                <a16:creationId xmlns:a16="http://schemas.microsoft.com/office/drawing/2014/main" id="{373F1338-87CA-4F4F-A569-E7A1F5B0A36D}"/>
               </a:ext>
             </a:extLst>
           </p:cNvPr>
@@ -7768,7 +7768,7 @@
           <p:cNvPr id="2" name="">
             <a:extLst xmlns:a="http://schemas.openxmlformats.org/drawingml/2006/main">
               <a:ext uri="{FF2B5EF4-FFF2-40B4-BE49-F238E27FC236}">
-                <a16:creationId xmlns:a16="http://schemas.microsoft.com/office/drawing/2014/main" id="{EC874679-4F6B-41B3-BF1C-43209EC69BDE}"/>
+                <a16:creationId xmlns:a16="http://schemas.microsoft.com/office/drawing/2014/main" id="{9245BDD9-AC9F-4FFD-A067-9617511BCF48}"/>
               </a:ext>
             </a:extLst>
           </p:cNvPr>
@@ -7803,7 +7803,7 @@
           <p:cNvPr id="3" name="">
             <a:extLst xmlns:a="http://schemas.openxmlformats.org/drawingml/2006/main">
               <a:ext uri="{FF2B5EF4-FFF2-40B4-BE49-F238E27FC236}">
-                <a16:creationId xmlns:a16="http://schemas.microsoft.com/office/drawing/2014/main" id="{DCC75074-A0C1-4739-B654-C113F0018F4C}"/>
+                <a16:creationId xmlns:a16="http://schemas.microsoft.com/office/drawing/2014/main" id="{E0AD91A3-D5A6-4004-A9A7-29416B87779F}"/>
               </a:ext>
             </a:extLst>
           </p:cNvPr>
@@ -7867,7 +7867,7 @@
           <p:cNvPr id="4" name="">
             <a:extLst xmlns:a="http://schemas.openxmlformats.org/drawingml/2006/main">
               <a:ext uri="{FF2B5EF4-FFF2-40B4-BE49-F238E27FC236}">
-                <a16:creationId xmlns:a16="http://schemas.microsoft.com/office/drawing/2014/main" id="{F264C247-7772-48CD-8D12-2B14A9997785}"/>
+                <a16:creationId xmlns:a16="http://schemas.microsoft.com/office/drawing/2014/main" id="{B9810AD5-E237-4BFE-BD17-D269C541FA23}"/>
               </a:ext>
             </a:extLst>
           </p:cNvPr>
@@ -7931,7 +7931,7 @@
           <p:cNvPr id="5" name="">
             <a:extLst xmlns:a="http://schemas.openxmlformats.org/drawingml/2006/main">
               <a:ext uri="{FF2B5EF4-FFF2-40B4-BE49-F238E27FC236}">
-                <a16:creationId xmlns:a16="http://schemas.microsoft.com/office/drawing/2014/main" id="{BC4CA3D6-7698-4B1D-A8AB-7E05488F4CC4}"/>
+                <a16:creationId xmlns:a16="http://schemas.microsoft.com/office/drawing/2014/main" id="{A21B2B7B-D5FE-4363-9FF1-A5313DD91733}"/>
               </a:ext>
             </a:extLst>
           </p:cNvPr>
@@ -7995,7 +7995,7 @@
           <p:cNvPr id="6" name="">
             <a:extLst xmlns:a="http://schemas.openxmlformats.org/drawingml/2006/main">
               <a:ext uri="{FF2B5EF4-FFF2-40B4-BE49-F238E27FC236}">
-                <a16:creationId xmlns:a16="http://schemas.microsoft.com/office/drawing/2014/main" id="{D7DA85BD-D70A-4DF8-AFE7-5AD3328C8B50}"/>
+                <a16:creationId xmlns:a16="http://schemas.microsoft.com/office/drawing/2014/main" id="{F30E102A-4673-47F9-9B56-8C1E9472C064}"/>
               </a:ext>
             </a:extLst>
           </p:cNvPr>
@@ -8059,7 +8059,7 @@
           <p:cNvPr id="7" name="">
             <a:extLst xmlns:a="http://schemas.openxmlformats.org/drawingml/2006/main">
               <a:ext uri="{FF2B5EF4-FFF2-40B4-BE49-F238E27FC236}">
-                <a16:creationId xmlns:a16="http://schemas.microsoft.com/office/drawing/2014/main" id="{43C8EB4E-09A3-4F4B-A164-3A79EFA651AB}"/>
+                <a16:creationId xmlns:a16="http://schemas.microsoft.com/office/drawing/2014/main" id="{67D09788-4608-45D0-BE2E-6A41C3F166D6}"/>
               </a:ext>
             </a:extLst>
           </p:cNvPr>
@@ -8094,7 +8094,7 @@
           <p:cNvPr id="8" name="">
             <a:extLst xmlns:a="http://schemas.openxmlformats.org/drawingml/2006/main">
               <a:ext uri="{FF2B5EF4-FFF2-40B4-BE49-F238E27FC236}">
-                <a16:creationId xmlns:a16="http://schemas.microsoft.com/office/drawing/2014/main" id="{282C52DD-F31E-4B35-94C9-00870FD2B7B3}"/>
+                <a16:creationId xmlns:a16="http://schemas.microsoft.com/office/drawing/2014/main" id="{E0877B8E-05A7-499B-92DE-017BC8A01831}"/>
               </a:ext>
             </a:extLst>
           </p:cNvPr>
@@ -8158,7 +8158,7 @@
           <p:cNvPr id="9" name="">
             <a:extLst xmlns:a="http://schemas.openxmlformats.org/drawingml/2006/main">
               <a:ext uri="{FF2B5EF4-FFF2-40B4-BE49-F238E27FC236}">
-                <a16:creationId xmlns:a16="http://schemas.microsoft.com/office/drawing/2014/main" id="{B477A4A4-B38A-4721-8524-D955C81C6240}"/>
+                <a16:creationId xmlns:a16="http://schemas.microsoft.com/office/drawing/2014/main" id="{14B50EB3-80F9-40EF-88A0-753AE7C1FC54}"/>
               </a:ext>
             </a:extLst>
           </p:cNvPr>
@@ -8212,7 +8212,7 @@
                 <a:ea typeface="Aptos"/>
                 <a:cs typeface="Aptos"/>
               </a:rPr>
-              <a:t>155</a:t>
+              <a:t>156</a:t>
             </a:r>
           </a:p>
         </p:txBody>
@@ -8222,7 +8222,7 @@
           <p:cNvPr id="10" name="">
             <a:extLst xmlns:a="http://schemas.openxmlformats.org/drawingml/2006/main">
               <a:ext uri="{FF2B5EF4-FFF2-40B4-BE49-F238E27FC236}">
-                <a16:creationId xmlns:a16="http://schemas.microsoft.com/office/drawing/2014/main" id="{720848BE-863F-4B40-A142-DA727FD1512C}"/>
+                <a16:creationId xmlns:a16="http://schemas.microsoft.com/office/drawing/2014/main" id="{D7EA03D4-3253-4768-BCD4-9ADB3238D8ED}"/>
               </a:ext>
             </a:extLst>
           </p:cNvPr>
@@ -8286,7 +8286,7 @@
           <p:cNvPr id="11" name="">
             <a:extLst xmlns:a="http://schemas.openxmlformats.org/drawingml/2006/main">
               <a:ext uri="{FF2B5EF4-FFF2-40B4-BE49-F238E27FC236}">
-                <a16:creationId xmlns:a16="http://schemas.microsoft.com/office/drawing/2014/main" id="{D4229512-2F36-43A8-8E18-184095D48604}"/>
+                <a16:creationId xmlns:a16="http://schemas.microsoft.com/office/drawing/2014/main" id="{44F71A29-403B-4F69-A96E-47B845B9BF07}"/>
               </a:ext>
             </a:extLst>
           </p:cNvPr>
@@ -8321,7 +8321,7 @@
           <p:cNvPr id="12" name="">
             <a:extLst xmlns:a="http://schemas.openxmlformats.org/drawingml/2006/main">
               <a:ext uri="{FF2B5EF4-FFF2-40B4-BE49-F238E27FC236}">
-                <a16:creationId xmlns:a16="http://schemas.microsoft.com/office/drawing/2014/main" id="{9AC4C389-3969-4CB0-BFEB-8B403289F85B}"/>
+                <a16:creationId xmlns:a16="http://schemas.microsoft.com/office/drawing/2014/main" id="{35FA8740-AF1B-4315-95F5-B6248A2DE08F}"/>
               </a:ext>
             </a:extLst>
           </p:cNvPr>
@@ -8385,7 +8385,7 @@
           <p:cNvPr id="13" name="">
             <a:extLst xmlns:a="http://schemas.openxmlformats.org/drawingml/2006/main">
               <a:ext uri="{FF2B5EF4-FFF2-40B4-BE49-F238E27FC236}">
-                <a16:creationId xmlns:a16="http://schemas.microsoft.com/office/drawing/2014/main" id="{0F1E5D86-3725-42B0-9526-92E5E1864377}"/>
+                <a16:creationId xmlns:a16="http://schemas.microsoft.com/office/drawing/2014/main" id="{FC783133-D03A-40FF-AB8F-E1355B708710}"/>
               </a:ext>
             </a:extLst>
           </p:cNvPr>
@@ -8439,7 +8439,7 @@
                 <a:ea typeface="Aptos"/>
                 <a:cs typeface="Aptos"/>
               </a:rPr>
-              <a:t>101</a:t>
+              <a:t>119</a:t>
             </a:r>
           </a:p>
         </p:txBody>
@@ -8449,7 +8449,7 @@
           <p:cNvPr id="14" name="">
             <a:extLst xmlns:a="http://schemas.openxmlformats.org/drawingml/2006/main">
               <a:ext uri="{FF2B5EF4-FFF2-40B4-BE49-F238E27FC236}">
-                <a16:creationId xmlns:a16="http://schemas.microsoft.com/office/drawing/2014/main" id="{15ED420C-A0FE-450A-9B1D-0BCB8F9022CF}"/>
+                <a16:creationId xmlns:a16="http://schemas.microsoft.com/office/drawing/2014/main" id="{7A0E7828-7DB9-44B5-AE84-7A2B30669609}"/>
               </a:ext>
             </a:extLst>
           </p:cNvPr>
@@ -8513,7 +8513,7 @@
           <p:cNvPr id="15" name="">
             <a:extLst xmlns:a="http://schemas.openxmlformats.org/drawingml/2006/main">
               <a:ext uri="{FF2B5EF4-FFF2-40B4-BE49-F238E27FC236}">
-                <a16:creationId xmlns:a16="http://schemas.microsoft.com/office/drawing/2014/main" id="{E67A25F3-F00E-4D48-AAB5-38CE1577FD69}"/>
+                <a16:creationId xmlns:a16="http://schemas.microsoft.com/office/drawing/2014/main" id="{FFA071B6-751E-41A4-AC62-80B8C7B4D8EA}"/>
               </a:ext>
             </a:extLst>
           </p:cNvPr>
@@ -8548,7 +8548,7 @@
           <p:cNvPr id="16" name="">
             <a:extLst xmlns:a="http://schemas.openxmlformats.org/drawingml/2006/main">
               <a:ext uri="{FF2B5EF4-FFF2-40B4-BE49-F238E27FC236}">
-                <a16:creationId xmlns:a16="http://schemas.microsoft.com/office/drawing/2014/main" id="{DB69B9DC-E5C2-4A8A-A5CC-3E8A838E5BFC}"/>
+                <a16:creationId xmlns:a16="http://schemas.microsoft.com/office/drawing/2014/main" id="{4F36CF5D-031A-42D0-9389-0BF4D52E8B0E}"/>
               </a:ext>
             </a:extLst>
           </p:cNvPr>
@@ -8612,7 +8612,7 @@
           <p:cNvPr id="17" name="">
             <a:extLst xmlns:a="http://schemas.openxmlformats.org/drawingml/2006/main">
               <a:ext uri="{FF2B5EF4-FFF2-40B4-BE49-F238E27FC236}">
-                <a16:creationId xmlns:a16="http://schemas.microsoft.com/office/drawing/2014/main" id="{C76C75AF-3FDC-4AA4-BE5F-CF82D190D510}"/>
+                <a16:creationId xmlns:a16="http://schemas.microsoft.com/office/drawing/2014/main" id="{EB47A79E-2F95-4BC3-ACED-013A7270B9D1}"/>
               </a:ext>
             </a:extLst>
           </p:cNvPr>
@@ -8676,7 +8676,7 @@
           <p:cNvPr id="18" name="">
             <a:extLst xmlns:a="http://schemas.openxmlformats.org/drawingml/2006/main">
               <a:ext uri="{FF2B5EF4-FFF2-40B4-BE49-F238E27FC236}">
-                <a16:creationId xmlns:a16="http://schemas.microsoft.com/office/drawing/2014/main" id="{9934AA3A-4C16-4F06-9379-3308B77FC59B}"/>
+                <a16:creationId xmlns:a16="http://schemas.microsoft.com/office/drawing/2014/main" id="{EFA03F68-3983-4B6E-9ACB-6DC4A2CCC154}"/>
               </a:ext>
             </a:extLst>
           </p:cNvPr>
@@ -8740,7 +8740,7 @@
           <p:cNvPr id="19" name="">
             <a:extLst xmlns:a="http://schemas.openxmlformats.org/drawingml/2006/main">
               <a:ext uri="{FF2B5EF4-FFF2-40B4-BE49-F238E27FC236}">
-                <a16:creationId xmlns:a16="http://schemas.microsoft.com/office/drawing/2014/main" id="{64729AB1-082E-4A3E-A668-C6D852D7B45E}"/>
+                <a16:creationId xmlns:a16="http://schemas.microsoft.com/office/drawing/2014/main" id="{CF221F27-0680-4C91-AA76-CFAA872332AD}"/>
               </a:ext>
             </a:extLst>
           </p:cNvPr>
@@ -8775,7 +8775,7 @@
           <p:cNvPr id="20" name="">
             <a:extLst xmlns:a="http://schemas.openxmlformats.org/drawingml/2006/main">
               <a:ext uri="{FF2B5EF4-FFF2-40B4-BE49-F238E27FC236}">
-                <a16:creationId xmlns:a16="http://schemas.microsoft.com/office/drawing/2014/main" id="{09C427F3-BCA0-4B50-B151-6FF3FD40F1C3}"/>
+                <a16:creationId xmlns:a16="http://schemas.microsoft.com/office/drawing/2014/main" id="{545F1E51-6FCA-4223-A566-353E6E865A3D}"/>
               </a:ext>
             </a:extLst>
           </p:cNvPr>
@@ -8839,7 +8839,7 @@
           <p:cNvPr id="21" name="">
             <a:extLst xmlns:a="http://schemas.openxmlformats.org/drawingml/2006/main">
               <a:ext uri="{FF2B5EF4-FFF2-40B4-BE49-F238E27FC236}">
-                <a16:creationId xmlns:a16="http://schemas.microsoft.com/office/drawing/2014/main" id="{F91A1491-5C94-4034-8F68-219306E7170F}"/>
+                <a16:creationId xmlns:a16="http://schemas.microsoft.com/office/drawing/2014/main" id="{63AF29F4-536A-41D9-81D1-E2F0970C1BFE}"/>
               </a:ext>
             </a:extLst>
           </p:cNvPr>
@@ -8903,7 +8903,7 @@
           <p:cNvPr id="22" name="">
             <a:extLst xmlns:a="http://schemas.openxmlformats.org/drawingml/2006/main">
               <a:ext uri="{FF2B5EF4-FFF2-40B4-BE49-F238E27FC236}">
-                <a16:creationId xmlns:a16="http://schemas.microsoft.com/office/drawing/2014/main" id="{DFA4EEF5-E7E5-441E-AAD2-486EAE048059}"/>
+                <a16:creationId xmlns:a16="http://schemas.microsoft.com/office/drawing/2014/main" id="{C4C2C680-6574-45B3-B474-30E16784205B}"/>
               </a:ext>
             </a:extLst>
           </p:cNvPr>
@@ -8967,7 +8967,7 @@
           <p:cNvPr id="23" name="">
             <a:extLst xmlns:a="http://schemas.openxmlformats.org/drawingml/2006/main">
               <a:ext uri="{FF2B5EF4-FFF2-40B4-BE49-F238E27FC236}">
-                <a16:creationId xmlns:a16="http://schemas.microsoft.com/office/drawing/2014/main" id="{C0892917-6914-449C-AFCA-6C38AE0EBDCA}"/>
+                <a16:creationId xmlns:a16="http://schemas.microsoft.com/office/drawing/2014/main" id="{C4D5EB64-44A4-4918-B7C4-D7BCB5FBE4CA}"/>
               </a:ext>
             </a:extLst>
           </p:cNvPr>
@@ -9000,7 +9000,7 @@
           <p:cNvPr id="24" name="">
             <a:extLst xmlns:a="http://schemas.openxmlformats.org/drawingml/2006/main">
               <a:ext uri="{FF2B5EF4-FFF2-40B4-BE49-F238E27FC236}">
-                <a16:creationId xmlns:a16="http://schemas.microsoft.com/office/drawing/2014/main" id="{DB0DD052-7F84-428B-993D-1CDD7054E938}"/>
+                <a16:creationId xmlns:a16="http://schemas.microsoft.com/office/drawing/2014/main" id="{DA50053F-3C1B-492A-B257-6B349A38064B}"/>
               </a:ext>
             </a:extLst>
           </p:cNvPr>
@@ -9064,7 +9064,7 @@
           <p:cNvPr id="25" name="">
             <a:extLst xmlns:a="http://schemas.openxmlformats.org/drawingml/2006/main">
               <a:ext uri="{FF2B5EF4-FFF2-40B4-BE49-F238E27FC236}">
-                <a16:creationId xmlns:a16="http://schemas.microsoft.com/office/drawing/2014/main" id="{4DCDE5D7-13FE-400A-937C-94C210E9F476}"/>
+                <a16:creationId xmlns:a16="http://schemas.microsoft.com/office/drawing/2014/main" id="{744CC53B-43E1-4606-86C6-085EBC1F1285}"/>
               </a:ext>
             </a:extLst>
           </p:cNvPr>
@@ -9118,7 +9118,7 @@
                 <a:ea typeface="Aptos"/>
                 <a:cs typeface="Aptos"/>
               </a:rPr>
-              <a:t>Run demo cascade -&gt; inspect RLVR evidence -&gt; run four real Sagents/Gemma agents -&gt; verify close_cycle.</a:t>
+              <a:t>Run one-click verifier proof -&gt; see unsafe rejection and safe recovery -&gt; run the separate live Gemma mission -&gt; inspect close_cycle.</a:t>
             </a:r>
           </a:p>
         </p:txBody>
@@ -9128,7 +9128,7 @@
           <p:cNvPr id="26" name="">
             <a:extLst xmlns:a="http://schemas.openxmlformats.org/drawingml/2006/main">
               <a:ext uri="{FF2B5EF4-FFF2-40B4-BE49-F238E27FC236}">
-                <a16:creationId xmlns:a16="http://schemas.microsoft.com/office/drawing/2014/main" id="{1EB5C058-E5A6-4199-AFC3-2586F92D62A7}"/>
+                <a16:creationId xmlns:a16="http://schemas.microsoft.com/office/drawing/2014/main" id="{367B0DB9-C8DB-474F-9969-409DCB33AA2E}"/>
               </a:ext>
             </a:extLst>
           </p:cNvPr>
@@ -9192,7 +9192,7 @@
           <p:cNvPr id="27" name="">
             <a:extLst xmlns:a="http://schemas.openxmlformats.org/drawingml/2006/main">
               <a:ext uri="{FF2B5EF4-FFF2-40B4-BE49-F238E27FC236}">
-                <a16:creationId xmlns:a16="http://schemas.microsoft.com/office/drawing/2014/main" id="{D50718F3-D65A-488D-A08F-FFEEB9A6522A}"/>
+                <a16:creationId xmlns:a16="http://schemas.microsoft.com/office/drawing/2014/main" id="{EC9AE982-DD76-4FCE-A023-391994D73C2D}"/>
               </a:ext>
             </a:extLst>
           </p:cNvPr>
@@ -9254,7 +9254,7 @@
     </p:spTree>
     <p:extLst>
       <p:ext uri="{BB962C8B-B14F-4D97-AF65-F5344CB8AC3E}">
-        <p14:creationId xmlns:p14="http://schemas.microsoft.com/office/powerpoint/2010/main" val="1574348199"/>
+        <p14:creationId xmlns:p14="http://schemas.microsoft.com/office/powerpoint/2010/main" val="189076322"/>
       </p:ext>
     </p:extLst>
   </p:cSld>
@@ -9278,7 +9278,7 @@
           <p:cNvPr id="1" name="">
             <a:extLst xmlns:a="http://schemas.openxmlformats.org/drawingml/2006/main">
               <a:ext uri="{FF2B5EF4-FFF2-40B4-BE49-F238E27FC236}">
-                <a16:creationId xmlns:a16="http://schemas.microsoft.com/office/drawing/2014/main" id="{415BDA6D-A94E-447C-9DD9-F32DCE96AF7D}"/>
+                <a16:creationId xmlns:a16="http://schemas.microsoft.com/office/drawing/2014/main" id="{2B4BFF89-99D6-4FD8-AE3E-66D9A061C339}"/>
               </a:ext>
             </a:extLst>
           </p:cNvPr>
@@ -9313,7 +9313,7 @@
           <p:cNvPr id="2" name="">
             <a:extLst xmlns:a="http://schemas.openxmlformats.org/drawingml/2006/main">
               <a:ext uri="{FF2B5EF4-FFF2-40B4-BE49-F238E27FC236}">
-                <a16:creationId xmlns:a16="http://schemas.microsoft.com/office/drawing/2014/main" id="{90B5FDF0-A07D-4EC2-B966-219EE73A364B}"/>
+                <a16:creationId xmlns:a16="http://schemas.microsoft.com/office/drawing/2014/main" id="{F8194145-7422-43DE-9F92-969C68D22F97}"/>
               </a:ext>
             </a:extLst>
           </p:cNvPr>
@@ -9348,7 +9348,7 @@
           <p:cNvPr id="3" name="">
             <a:extLst xmlns:a="http://schemas.openxmlformats.org/drawingml/2006/main">
               <a:ext uri="{FF2B5EF4-FFF2-40B4-BE49-F238E27FC236}">
-                <a16:creationId xmlns:a16="http://schemas.microsoft.com/office/drawing/2014/main" id="{3088DC1E-F817-405A-9CE1-297F48EC7F7D}"/>
+                <a16:creationId xmlns:a16="http://schemas.microsoft.com/office/drawing/2014/main" id="{5B5296D8-CA08-436A-A3D9-D2EABB8332CC}"/>
               </a:ext>
             </a:extLst>
           </p:cNvPr>
@@ -9412,7 +9412,7 @@
           <p:cNvPr id="4" name="">
             <a:extLst xmlns:a="http://schemas.openxmlformats.org/drawingml/2006/main">
               <a:ext uri="{FF2B5EF4-FFF2-40B4-BE49-F238E27FC236}">
-                <a16:creationId xmlns:a16="http://schemas.microsoft.com/office/drawing/2014/main" id="{4409F2A7-28DD-4977-823D-686C4E9632E5}"/>
+                <a16:creationId xmlns:a16="http://schemas.microsoft.com/office/drawing/2014/main" id="{30BFEE4C-A416-4969-B7D5-120AC9703BB5}"/>
               </a:ext>
             </a:extLst>
           </p:cNvPr>
@@ -9476,7 +9476,7 @@
           <p:cNvPr id="5" name="">
             <a:extLst xmlns:a="http://schemas.openxmlformats.org/drawingml/2006/main">
               <a:ext uri="{FF2B5EF4-FFF2-40B4-BE49-F238E27FC236}">
-                <a16:creationId xmlns:a16="http://schemas.microsoft.com/office/drawing/2014/main" id="{505003AA-4D72-4C3B-933F-EAD6C1F90187}"/>
+                <a16:creationId xmlns:a16="http://schemas.microsoft.com/office/drawing/2014/main" id="{A4F08D33-5012-4E81-89C2-D68562F59C4C}"/>
               </a:ext>
             </a:extLst>
           </p:cNvPr>
@@ -9540,7 +9540,7 @@
           <p:cNvPr id="6" name="">
             <a:extLst xmlns:a="http://schemas.openxmlformats.org/drawingml/2006/main">
               <a:ext uri="{FF2B5EF4-FFF2-40B4-BE49-F238E27FC236}">
-                <a16:creationId xmlns:a16="http://schemas.microsoft.com/office/drawing/2014/main" id="{8D9E2F11-F82D-4095-BC19-13AD16C8E048}"/>
+                <a16:creationId xmlns:a16="http://schemas.microsoft.com/office/drawing/2014/main" id="{1855076D-2EDE-428B-92A3-02ECCD62384B}"/>
               </a:ext>
             </a:extLst>
           </p:cNvPr>
@@ -9604,7 +9604,7 @@
           <p:cNvPr id="7" name="">
             <a:extLst xmlns:a="http://schemas.openxmlformats.org/drawingml/2006/main">
               <a:ext uri="{FF2B5EF4-FFF2-40B4-BE49-F238E27FC236}">
-                <a16:creationId xmlns:a16="http://schemas.microsoft.com/office/drawing/2014/main" id="{91C704BD-925B-4C58-A551-74E8CE4F55C0}"/>
+                <a16:creationId xmlns:a16="http://schemas.microsoft.com/office/drawing/2014/main" id="{4C6225B3-D1D1-4F34-A521-F4D6E51DA80B}"/>
               </a:ext>
             </a:extLst>
           </p:cNvPr>
@@ -9637,7 +9637,7 @@
           <p:cNvPr id="8" name="">
             <a:extLst xmlns:a="http://schemas.openxmlformats.org/drawingml/2006/main">
               <a:ext uri="{FF2B5EF4-FFF2-40B4-BE49-F238E27FC236}">
-                <a16:creationId xmlns:a16="http://schemas.microsoft.com/office/drawing/2014/main" id="{CA2E688D-AE44-435C-A506-6FBCF82D9F87}"/>
+                <a16:creationId xmlns:a16="http://schemas.microsoft.com/office/drawing/2014/main" id="{D3557520-9F80-4AD2-9B9C-F01CA5D66832}"/>
               </a:ext>
             </a:extLst>
           </p:cNvPr>
@@ -9701,7 +9701,7 @@
           <p:cNvPr id="9" name="">
             <a:extLst xmlns:a="http://schemas.openxmlformats.org/drawingml/2006/main">
               <a:ext uri="{FF2B5EF4-FFF2-40B4-BE49-F238E27FC236}">
-                <a16:creationId xmlns:a16="http://schemas.microsoft.com/office/drawing/2014/main" id="{A6DE88A5-96A7-404D-8997-686F199944D4}"/>
+                <a16:creationId xmlns:a16="http://schemas.microsoft.com/office/drawing/2014/main" id="{488FEF38-3B11-4900-AD50-F7DE6259F831}"/>
               </a:ext>
             </a:extLst>
           </p:cNvPr>
@@ -9765,7 +9765,7 @@
           <p:cNvPr id="10" name="">
             <a:extLst xmlns:a="http://schemas.openxmlformats.org/drawingml/2006/main">
               <a:ext uri="{FF2B5EF4-FFF2-40B4-BE49-F238E27FC236}">
-                <a16:creationId xmlns:a16="http://schemas.microsoft.com/office/drawing/2014/main" id="{A71EEC70-3CB9-4618-B4D9-72B892445A04}"/>
+                <a16:creationId xmlns:a16="http://schemas.microsoft.com/office/drawing/2014/main" id="{65166435-7DF3-41E7-94F0-ED1167EBA1F7}"/>
               </a:ext>
             </a:extLst>
           </p:cNvPr>
@@ -9798,7 +9798,7 @@
           <p:cNvPr id="11" name="">
             <a:extLst xmlns:a="http://schemas.openxmlformats.org/drawingml/2006/main">
               <a:ext uri="{FF2B5EF4-FFF2-40B4-BE49-F238E27FC236}">
-                <a16:creationId xmlns:a16="http://schemas.microsoft.com/office/drawing/2014/main" id="{F3BA5736-189D-4E63-8BD4-263116DF3FAF}"/>
+                <a16:creationId xmlns:a16="http://schemas.microsoft.com/office/drawing/2014/main" id="{9535867E-CD4E-4640-BAF7-12F8DF21E7FC}"/>
               </a:ext>
             </a:extLst>
           </p:cNvPr>
@@ -9862,7 +9862,7 @@
           <p:cNvPr id="12" name="">
             <a:extLst xmlns:a="http://schemas.openxmlformats.org/drawingml/2006/main">
               <a:ext uri="{FF2B5EF4-FFF2-40B4-BE49-F238E27FC236}">
-                <a16:creationId xmlns:a16="http://schemas.microsoft.com/office/drawing/2014/main" id="{9AE4894E-E8B6-4780-BE2F-B0BC1C401C61}"/>
+                <a16:creationId xmlns:a16="http://schemas.microsoft.com/office/drawing/2014/main" id="{05ECA4F3-21DF-405C-A916-67EE8FE2CCD9}"/>
               </a:ext>
             </a:extLst>
           </p:cNvPr>
@@ -9926,7 +9926,7 @@
           <p:cNvPr id="13" name="">
             <a:extLst xmlns:a="http://schemas.openxmlformats.org/drawingml/2006/main">
               <a:ext uri="{FF2B5EF4-FFF2-40B4-BE49-F238E27FC236}">
-                <a16:creationId xmlns:a16="http://schemas.microsoft.com/office/drawing/2014/main" id="{21C5406D-3DCE-475A-844C-9C85500896A4}"/>
+                <a16:creationId xmlns:a16="http://schemas.microsoft.com/office/drawing/2014/main" id="{73297F5C-AAF5-4732-9E11-4015CD7713D6}"/>
               </a:ext>
             </a:extLst>
           </p:cNvPr>
@@ -9959,7 +9959,7 @@
           <p:cNvPr id="14" name="">
             <a:extLst xmlns:a="http://schemas.openxmlformats.org/drawingml/2006/main">
               <a:ext uri="{FF2B5EF4-FFF2-40B4-BE49-F238E27FC236}">
-                <a16:creationId xmlns:a16="http://schemas.microsoft.com/office/drawing/2014/main" id="{1D690D41-49F5-4D26-A2B0-EBEA2BF25970}"/>
+                <a16:creationId xmlns:a16="http://schemas.microsoft.com/office/drawing/2014/main" id="{CDD87169-D21B-472B-9293-AF00B28A7A82}"/>
               </a:ext>
             </a:extLst>
           </p:cNvPr>
@@ -10023,7 +10023,7 @@
           <p:cNvPr id="15" name="">
             <a:extLst xmlns:a="http://schemas.openxmlformats.org/drawingml/2006/main">
               <a:ext uri="{FF2B5EF4-FFF2-40B4-BE49-F238E27FC236}">
-                <a16:creationId xmlns:a16="http://schemas.microsoft.com/office/drawing/2014/main" id="{E7991EB2-F94E-42FE-B111-D225AA4B54AF}"/>
+                <a16:creationId xmlns:a16="http://schemas.microsoft.com/office/drawing/2014/main" id="{E48D2B57-28CF-420D-98C7-C1F91D3E2866}"/>
               </a:ext>
             </a:extLst>
           </p:cNvPr>
@@ -10087,7 +10087,7 @@
           <p:cNvPr id="16" name="">
             <a:extLst xmlns:a="http://schemas.openxmlformats.org/drawingml/2006/main">
               <a:ext uri="{FF2B5EF4-FFF2-40B4-BE49-F238E27FC236}">
-                <a16:creationId xmlns:a16="http://schemas.microsoft.com/office/drawing/2014/main" id="{06CEC9DC-532C-4D75-B618-4D01C238471D}"/>
+                <a16:creationId xmlns:a16="http://schemas.microsoft.com/office/drawing/2014/main" id="{32E5EE30-CD20-4E03-82B6-8F781C90D406}"/>
               </a:ext>
             </a:extLst>
           </p:cNvPr>
@@ -10151,7 +10151,7 @@
           <p:cNvPr id="17" name="">
             <a:extLst xmlns:a="http://schemas.openxmlformats.org/drawingml/2006/main">
               <a:ext uri="{FF2B5EF4-FFF2-40B4-BE49-F238E27FC236}">
-                <a16:creationId xmlns:a16="http://schemas.microsoft.com/office/drawing/2014/main" id="{26671E49-6BE7-43E6-9493-11290FDB496E}"/>
+                <a16:creationId xmlns:a16="http://schemas.microsoft.com/office/drawing/2014/main" id="{56316BEE-54A2-469E-A6C4-01FEAB977932}"/>
               </a:ext>
             </a:extLst>
           </p:cNvPr>
@@ -10213,7 +10213,7 @@
     </p:spTree>
     <p:extLst>
       <p:ext uri="{BB962C8B-B14F-4D97-AF65-F5344CB8AC3E}">
-        <p14:creationId xmlns:p14="http://schemas.microsoft.com/office/powerpoint/2010/main" val="95733791"/>
+        <p14:creationId xmlns:p14="http://schemas.microsoft.com/office/powerpoint/2010/main" val="600645062"/>
       </p:ext>
     </p:extLst>
   </p:cSld>
@@ -10237,7 +10237,7 @@
           <p:cNvPr id="1" name="">
             <a:extLst xmlns:a="http://schemas.openxmlformats.org/drawingml/2006/main">
               <a:ext uri="{FF2B5EF4-FFF2-40B4-BE49-F238E27FC236}">
-                <a16:creationId xmlns:a16="http://schemas.microsoft.com/office/drawing/2014/main" id="{F179A96B-BDCC-486E-B3EC-94033F9B2681}"/>
+                <a16:creationId xmlns:a16="http://schemas.microsoft.com/office/drawing/2014/main" id="{82CE67E9-3448-416C-AF77-3B0FED9DDFA7}"/>
               </a:ext>
             </a:extLst>
           </p:cNvPr>
@@ -10272,7 +10272,7 @@
           <p:cNvPr id="2" name="">
             <a:extLst xmlns:a="http://schemas.openxmlformats.org/drawingml/2006/main">
               <a:ext uri="{FF2B5EF4-FFF2-40B4-BE49-F238E27FC236}">
-                <a16:creationId xmlns:a16="http://schemas.microsoft.com/office/drawing/2014/main" id="{C08CFD60-7EDB-4929-8CFE-3A9AF8BF7DEF}"/>
+                <a16:creationId xmlns:a16="http://schemas.microsoft.com/office/drawing/2014/main" id="{482DC5A5-C5DC-4412-BE55-593067EA8E41}"/>
               </a:ext>
             </a:extLst>
           </p:cNvPr>
@@ -10307,7 +10307,7 @@
           <p:cNvPr id="3" name="">
             <a:extLst xmlns:a="http://schemas.openxmlformats.org/drawingml/2006/main">
               <a:ext uri="{FF2B5EF4-FFF2-40B4-BE49-F238E27FC236}">
-                <a16:creationId xmlns:a16="http://schemas.microsoft.com/office/drawing/2014/main" id="{085D67BD-C3DC-4FF3-880B-0B5BEF1A0D73}"/>
+                <a16:creationId xmlns:a16="http://schemas.microsoft.com/office/drawing/2014/main" id="{F16DAA12-84DE-4205-BBD3-57BE34FD3A57}"/>
               </a:ext>
             </a:extLst>
           </p:cNvPr>
@@ -10371,7 +10371,7 @@
           <p:cNvPr id="4" name="">
             <a:extLst xmlns:a="http://schemas.openxmlformats.org/drawingml/2006/main">
               <a:ext uri="{FF2B5EF4-FFF2-40B4-BE49-F238E27FC236}">
-                <a16:creationId xmlns:a16="http://schemas.microsoft.com/office/drawing/2014/main" id="{6BB96327-B6DE-473B-80FE-3665EB32D9C1}"/>
+                <a16:creationId xmlns:a16="http://schemas.microsoft.com/office/drawing/2014/main" id="{01D51899-E077-4507-B785-F4B36A50A80B}"/>
               </a:ext>
             </a:extLst>
           </p:cNvPr>
@@ -10435,7 +10435,7 @@
           <p:cNvPr id="5" name="">
             <a:extLst xmlns:a="http://schemas.openxmlformats.org/drawingml/2006/main">
               <a:ext uri="{FF2B5EF4-FFF2-40B4-BE49-F238E27FC236}">
-                <a16:creationId xmlns:a16="http://schemas.microsoft.com/office/drawing/2014/main" id="{D57DC076-8BDB-47A5-9F75-36A658C4AF33}"/>
+                <a16:creationId xmlns:a16="http://schemas.microsoft.com/office/drawing/2014/main" id="{CCFABCB3-C561-41F0-91AC-6EAF93124084}"/>
               </a:ext>
             </a:extLst>
           </p:cNvPr>
@@ -10499,7 +10499,7 @@
           <p:cNvPr id="6" name="">
             <a:extLst xmlns:a="http://schemas.openxmlformats.org/drawingml/2006/main">
               <a:ext uri="{FF2B5EF4-FFF2-40B4-BE49-F238E27FC236}">
-                <a16:creationId xmlns:a16="http://schemas.microsoft.com/office/drawing/2014/main" id="{8F6A02D4-AC8C-4099-B88B-12F46BE40BAA}"/>
+                <a16:creationId xmlns:a16="http://schemas.microsoft.com/office/drawing/2014/main" id="{821B3F3F-5E8F-4B1B-AC16-F4C82455F95B}"/>
               </a:ext>
             </a:extLst>
           </p:cNvPr>
@@ -10563,7 +10563,7 @@
           <p:cNvPr id="7" name="">
             <a:extLst xmlns:a="http://schemas.openxmlformats.org/drawingml/2006/main">
               <a:ext uri="{FF2B5EF4-FFF2-40B4-BE49-F238E27FC236}">
-                <a16:creationId xmlns:a16="http://schemas.microsoft.com/office/drawing/2014/main" id="{4EDE4A83-9906-4CA5-BDAB-E63ADE359A57}"/>
+                <a16:creationId xmlns:a16="http://schemas.microsoft.com/office/drawing/2014/main" id="{8CB6FE4F-3F6A-45D0-83A3-E40FA79D0A9E}"/>
               </a:ext>
             </a:extLst>
           </p:cNvPr>
@@ -10596,7 +10596,7 @@
           <p:cNvPr id="8" name="">
             <a:extLst xmlns:a="http://schemas.openxmlformats.org/drawingml/2006/main">
               <a:ext uri="{FF2B5EF4-FFF2-40B4-BE49-F238E27FC236}">
-                <a16:creationId xmlns:a16="http://schemas.microsoft.com/office/drawing/2014/main" id="{04978B3A-D203-42E9-BED7-4E8C6C868DFF}"/>
+                <a16:creationId xmlns:a16="http://schemas.microsoft.com/office/drawing/2014/main" id="{85219CDA-0A0A-4FF8-9FA7-E4F91663A56F}"/>
               </a:ext>
             </a:extLst>
           </p:cNvPr>
@@ -10660,7 +10660,7 @@
           <p:cNvPr id="9" name="">
             <a:extLst xmlns:a="http://schemas.openxmlformats.org/drawingml/2006/main">
               <a:ext uri="{FF2B5EF4-FFF2-40B4-BE49-F238E27FC236}">
-                <a16:creationId xmlns:a16="http://schemas.microsoft.com/office/drawing/2014/main" id="{757CD545-C45E-48DD-A245-25A933747760}"/>
+                <a16:creationId xmlns:a16="http://schemas.microsoft.com/office/drawing/2014/main" id="{52B12A31-2C08-406A-96BF-F6C7CF9027F8}"/>
               </a:ext>
             </a:extLst>
           </p:cNvPr>
@@ -10724,7 +10724,7 @@
           <p:cNvPr id="10" name="">
             <a:extLst xmlns:a="http://schemas.openxmlformats.org/drawingml/2006/main">
               <a:ext uri="{FF2B5EF4-FFF2-40B4-BE49-F238E27FC236}">
-                <a16:creationId xmlns:a16="http://schemas.microsoft.com/office/drawing/2014/main" id="{19F41146-FF16-491F-AC74-57C769983998}"/>
+                <a16:creationId xmlns:a16="http://schemas.microsoft.com/office/drawing/2014/main" id="{4A6C6087-12A4-4A84-807B-C94AE3658EEE}"/>
               </a:ext>
             </a:extLst>
           </p:cNvPr>
@@ -10788,7 +10788,7 @@
           <p:cNvPr id="11" name="">
             <a:extLst xmlns:a="http://schemas.openxmlformats.org/drawingml/2006/main">
               <a:ext uri="{FF2B5EF4-FFF2-40B4-BE49-F238E27FC236}">
-                <a16:creationId xmlns:a16="http://schemas.microsoft.com/office/drawing/2014/main" id="{776AC6A3-6DBD-4C43-871E-25E43DABF368}"/>
+                <a16:creationId xmlns:a16="http://schemas.microsoft.com/office/drawing/2014/main" id="{6D8D4E01-A952-426B-9FBB-A56F5EC7B519}"/>
               </a:ext>
             </a:extLst>
           </p:cNvPr>
@@ -10821,7 +10821,7 @@
           <p:cNvPr id="12" name="">
             <a:extLst xmlns:a="http://schemas.openxmlformats.org/drawingml/2006/main">
               <a:ext uri="{FF2B5EF4-FFF2-40B4-BE49-F238E27FC236}">
-                <a16:creationId xmlns:a16="http://schemas.microsoft.com/office/drawing/2014/main" id="{8FE9BA65-833C-4C7E-8884-90FAA9B2A305}"/>
+                <a16:creationId xmlns:a16="http://schemas.microsoft.com/office/drawing/2014/main" id="{7373A08B-6B28-489E-9A34-C97DD79C4AF4}"/>
               </a:ext>
             </a:extLst>
           </p:cNvPr>
@@ -10885,7 +10885,7 @@
           <p:cNvPr id="13" name="">
             <a:extLst xmlns:a="http://schemas.openxmlformats.org/drawingml/2006/main">
               <a:ext uri="{FF2B5EF4-FFF2-40B4-BE49-F238E27FC236}">
-                <a16:creationId xmlns:a16="http://schemas.microsoft.com/office/drawing/2014/main" id="{07A4FE27-C1AD-4BC9-9A40-8BB06EDDA5F4}"/>
+                <a16:creationId xmlns:a16="http://schemas.microsoft.com/office/drawing/2014/main" id="{F631329E-5F6A-471A-B010-895FAA93D752}"/>
               </a:ext>
             </a:extLst>
           </p:cNvPr>
@@ -10949,7 +10949,7 @@
           <p:cNvPr id="14" name="">
             <a:extLst xmlns:a="http://schemas.openxmlformats.org/drawingml/2006/main">
               <a:ext uri="{FF2B5EF4-FFF2-40B4-BE49-F238E27FC236}">
-                <a16:creationId xmlns:a16="http://schemas.microsoft.com/office/drawing/2014/main" id="{5D3847C5-9061-408E-9834-96BFEDCA8987}"/>
+                <a16:creationId xmlns:a16="http://schemas.microsoft.com/office/drawing/2014/main" id="{D444F21E-8775-4DB4-B98F-40BCC15A00CF}"/>
               </a:ext>
             </a:extLst>
           </p:cNvPr>
@@ -11013,7 +11013,7 @@
           <p:cNvPr id="15" name="">
             <a:extLst xmlns:a="http://schemas.openxmlformats.org/drawingml/2006/main">
               <a:ext uri="{FF2B5EF4-FFF2-40B4-BE49-F238E27FC236}">
-                <a16:creationId xmlns:a16="http://schemas.microsoft.com/office/drawing/2014/main" id="{66125BE1-DA56-4C42-AAB1-E891FFABA771}"/>
+                <a16:creationId xmlns:a16="http://schemas.microsoft.com/office/drawing/2014/main" id="{E66783CF-5A8C-4E9E-AEFC-42DB066C1236}"/>
               </a:ext>
             </a:extLst>
           </p:cNvPr>
@@ -11046,7 +11046,7 @@
           <p:cNvPr id="16" name="">
             <a:extLst xmlns:a="http://schemas.openxmlformats.org/drawingml/2006/main">
               <a:ext uri="{FF2B5EF4-FFF2-40B4-BE49-F238E27FC236}">
-                <a16:creationId xmlns:a16="http://schemas.microsoft.com/office/drawing/2014/main" id="{23C71904-0557-4143-B98B-071913F4F1B7}"/>
+                <a16:creationId xmlns:a16="http://schemas.microsoft.com/office/drawing/2014/main" id="{CCF6079B-827F-462A-BA35-AEF6AFFE380C}"/>
               </a:ext>
             </a:extLst>
           </p:cNvPr>
@@ -11110,7 +11110,7 @@
           <p:cNvPr id="17" name="">
             <a:extLst xmlns:a="http://schemas.openxmlformats.org/drawingml/2006/main">
               <a:ext uri="{FF2B5EF4-FFF2-40B4-BE49-F238E27FC236}">
-                <a16:creationId xmlns:a16="http://schemas.microsoft.com/office/drawing/2014/main" id="{1C064701-64FE-49C2-AD7C-D43AC8F92E51}"/>
+                <a16:creationId xmlns:a16="http://schemas.microsoft.com/office/drawing/2014/main" id="{AEAB97EF-5205-4487-A034-71A45E707A2F}"/>
               </a:ext>
             </a:extLst>
           </p:cNvPr>
@@ -11174,7 +11174,7 @@
           <p:cNvPr id="18" name="">
             <a:extLst xmlns:a="http://schemas.openxmlformats.org/drawingml/2006/main">
               <a:ext uri="{FF2B5EF4-FFF2-40B4-BE49-F238E27FC236}">
-                <a16:creationId xmlns:a16="http://schemas.microsoft.com/office/drawing/2014/main" id="{48D5E342-5407-49DF-8899-732E2C064818}"/>
+                <a16:creationId xmlns:a16="http://schemas.microsoft.com/office/drawing/2014/main" id="{A41B2C62-1E8A-4BB7-8752-5DFD166B594C}"/>
               </a:ext>
             </a:extLst>
           </p:cNvPr>
@@ -11207,7 +11207,7 @@
           <p:cNvPr id="19" name="">
             <a:extLst xmlns:a="http://schemas.openxmlformats.org/drawingml/2006/main">
               <a:ext uri="{FF2B5EF4-FFF2-40B4-BE49-F238E27FC236}">
-                <a16:creationId xmlns:a16="http://schemas.microsoft.com/office/drawing/2014/main" id="{183984DA-0AB1-4399-9FBE-6FE7CF18C3CC}"/>
+                <a16:creationId xmlns:a16="http://schemas.microsoft.com/office/drawing/2014/main" id="{2F369840-E67D-4840-9FB4-01FE719F206E}"/>
               </a:ext>
             </a:extLst>
           </p:cNvPr>
@@ -11271,7 +11271,7 @@
           <p:cNvPr id="20" name="">
             <a:extLst xmlns:a="http://schemas.openxmlformats.org/drawingml/2006/main">
               <a:ext uri="{FF2B5EF4-FFF2-40B4-BE49-F238E27FC236}">
-                <a16:creationId xmlns:a16="http://schemas.microsoft.com/office/drawing/2014/main" id="{56BAD3CA-88B1-4E38-A668-4056CED15E59}"/>
+                <a16:creationId xmlns:a16="http://schemas.microsoft.com/office/drawing/2014/main" id="{835080F9-47BF-4ACC-983F-FB238AD02A71}"/>
               </a:ext>
             </a:extLst>
           </p:cNvPr>
@@ -11335,7 +11335,7 @@
           <p:cNvPr id="21" name="">
             <a:extLst xmlns:a="http://schemas.openxmlformats.org/drawingml/2006/main">
               <a:ext uri="{FF2B5EF4-FFF2-40B4-BE49-F238E27FC236}">
-                <a16:creationId xmlns:a16="http://schemas.microsoft.com/office/drawing/2014/main" id="{EE4F1E4A-3AA8-4445-A4E6-71A861FC36D8}"/>
+                <a16:creationId xmlns:a16="http://schemas.microsoft.com/office/drawing/2014/main" id="{A006B807-DE26-407C-9597-62585045E427}"/>
               </a:ext>
             </a:extLst>
           </p:cNvPr>
@@ -11368,7 +11368,7 @@
           <p:cNvPr id="22" name="">
             <a:extLst xmlns:a="http://schemas.openxmlformats.org/drawingml/2006/main">
               <a:ext uri="{FF2B5EF4-FFF2-40B4-BE49-F238E27FC236}">
-                <a16:creationId xmlns:a16="http://schemas.microsoft.com/office/drawing/2014/main" id="{5F136D76-3522-49D7-8E3E-782CDE3CB4E1}"/>
+                <a16:creationId xmlns:a16="http://schemas.microsoft.com/office/drawing/2014/main" id="{F408F05F-07DE-4AAC-94C1-774B1BEC360E}"/>
               </a:ext>
             </a:extLst>
           </p:cNvPr>
@@ -11432,7 +11432,7 @@
           <p:cNvPr id="23" name="">
             <a:extLst xmlns:a="http://schemas.openxmlformats.org/drawingml/2006/main">
               <a:ext uri="{FF2B5EF4-FFF2-40B4-BE49-F238E27FC236}">
-                <a16:creationId xmlns:a16="http://schemas.microsoft.com/office/drawing/2014/main" id="{BEB46DB2-B71B-4D80-A8EC-74C711B25446}"/>
+                <a16:creationId xmlns:a16="http://schemas.microsoft.com/office/drawing/2014/main" id="{46D19ACC-DFC4-4646-A94D-D7EBBF6C452E}"/>
               </a:ext>
             </a:extLst>
           </p:cNvPr>
@@ -11496,7 +11496,7 @@
           <p:cNvPr id="24" name="">
             <a:extLst xmlns:a="http://schemas.openxmlformats.org/drawingml/2006/main">
               <a:ext uri="{FF2B5EF4-FFF2-40B4-BE49-F238E27FC236}">
-                <a16:creationId xmlns:a16="http://schemas.microsoft.com/office/drawing/2014/main" id="{166F1206-A653-4540-81D4-BF95A76DA245}"/>
+                <a16:creationId xmlns:a16="http://schemas.microsoft.com/office/drawing/2014/main" id="{2F998196-2A50-4FEC-BFDC-329545580A97}"/>
               </a:ext>
             </a:extLst>
           </p:cNvPr>
@@ -11560,7 +11560,7 @@
           <p:cNvPr id="25" name="">
             <a:extLst xmlns:a="http://schemas.openxmlformats.org/drawingml/2006/main">
               <a:ext uri="{FF2B5EF4-FFF2-40B4-BE49-F238E27FC236}">
-                <a16:creationId xmlns:a16="http://schemas.microsoft.com/office/drawing/2014/main" id="{6BAA09A6-CB67-40A3-BAE5-21F837E6EDD0}"/>
+                <a16:creationId xmlns:a16="http://schemas.microsoft.com/office/drawing/2014/main" id="{D75795DD-D81C-49FC-9676-4D7895AC2FC6}"/>
               </a:ext>
             </a:extLst>
           </p:cNvPr>
@@ -11622,7 +11622,7 @@
     </p:spTree>
     <p:extLst>
       <p:ext uri="{BB962C8B-B14F-4D97-AF65-F5344CB8AC3E}">
-        <p14:creationId xmlns:p14="http://schemas.microsoft.com/office/powerpoint/2010/main" val="1953682263"/>
+        <p14:creationId xmlns:p14="http://schemas.microsoft.com/office/powerpoint/2010/main" val="634122266"/>
       </p:ext>
     </p:extLst>
   </p:cSld>
@@ -11646,7 +11646,7 @@
           <p:cNvPr id="1" name="">
             <a:extLst xmlns:a="http://schemas.openxmlformats.org/drawingml/2006/main">
               <a:ext uri="{FF2B5EF4-FFF2-40B4-BE49-F238E27FC236}">
-                <a16:creationId xmlns:a16="http://schemas.microsoft.com/office/drawing/2014/main" id="{5DFA35DF-749D-47D6-851E-5F03EF5E87A5}"/>
+                <a16:creationId xmlns:a16="http://schemas.microsoft.com/office/drawing/2014/main" id="{D079E3D4-54CE-48A3-A5F6-3F8693990864}"/>
               </a:ext>
             </a:extLst>
           </p:cNvPr>
@@ -11681,7 +11681,7 @@
           <p:cNvPr id="2" name="">
             <a:extLst xmlns:a="http://schemas.openxmlformats.org/drawingml/2006/main">
               <a:ext uri="{FF2B5EF4-FFF2-40B4-BE49-F238E27FC236}">
-                <a16:creationId xmlns:a16="http://schemas.microsoft.com/office/drawing/2014/main" id="{0DF7D3BF-79D2-4CC1-8C72-1B23E8FDE1F7}"/>
+                <a16:creationId xmlns:a16="http://schemas.microsoft.com/office/drawing/2014/main" id="{54A2797E-7B67-4AEA-B9CC-E6F56B2B90A5}"/>
               </a:ext>
             </a:extLst>
           </p:cNvPr>
@@ -11716,7 +11716,7 @@
           <p:cNvPr id="3" name="">
             <a:extLst xmlns:a="http://schemas.openxmlformats.org/drawingml/2006/main">
               <a:ext uri="{FF2B5EF4-FFF2-40B4-BE49-F238E27FC236}">
-                <a16:creationId xmlns:a16="http://schemas.microsoft.com/office/drawing/2014/main" id="{F3AFA2DE-1053-480F-9D3A-D445322B4FA9}"/>
+                <a16:creationId xmlns:a16="http://schemas.microsoft.com/office/drawing/2014/main" id="{D8668E27-AE05-4B66-B74C-EB3E742CF33C}"/>
               </a:ext>
             </a:extLst>
           </p:cNvPr>
@@ -11780,7 +11780,7 @@
           <p:cNvPr id="4" name="">
             <a:extLst xmlns:a="http://schemas.openxmlformats.org/drawingml/2006/main">
               <a:ext uri="{FF2B5EF4-FFF2-40B4-BE49-F238E27FC236}">
-                <a16:creationId xmlns:a16="http://schemas.microsoft.com/office/drawing/2014/main" id="{936DE08D-AA96-41F4-AEEA-3670553F0773}"/>
+                <a16:creationId xmlns:a16="http://schemas.microsoft.com/office/drawing/2014/main" id="{73EC6378-1852-49A8-BEE2-3E43F9E81CE5}"/>
               </a:ext>
             </a:extLst>
           </p:cNvPr>
@@ -11844,7 +11844,7 @@
           <p:cNvPr id="5" name="">
             <a:extLst xmlns:a="http://schemas.openxmlformats.org/drawingml/2006/main">
               <a:ext uri="{FF2B5EF4-FFF2-40B4-BE49-F238E27FC236}">
-                <a16:creationId xmlns:a16="http://schemas.microsoft.com/office/drawing/2014/main" id="{EDB19CB0-7F33-49D5-84CA-20914CD5D2AF}"/>
+                <a16:creationId xmlns:a16="http://schemas.microsoft.com/office/drawing/2014/main" id="{DE855D9F-CEE8-44A8-A1F6-29B017599EAD}"/>
               </a:ext>
             </a:extLst>
           </p:cNvPr>
@@ -11908,7 +11908,7 @@
           <p:cNvPr id="6" name="">
             <a:extLst xmlns:a="http://schemas.openxmlformats.org/drawingml/2006/main">
               <a:ext uri="{FF2B5EF4-FFF2-40B4-BE49-F238E27FC236}">
-                <a16:creationId xmlns:a16="http://schemas.microsoft.com/office/drawing/2014/main" id="{0E50CF7F-DB1F-4925-888F-51033485FB0A}"/>
+                <a16:creationId xmlns:a16="http://schemas.microsoft.com/office/drawing/2014/main" id="{D74752FA-F73E-4FD1-848A-1A3949C49FAE}"/>
               </a:ext>
             </a:extLst>
           </p:cNvPr>
@@ -11972,7 +11972,7 @@
           <p:cNvPr id="7" name="">
             <a:extLst xmlns:a="http://schemas.openxmlformats.org/drawingml/2006/main">
               <a:ext uri="{FF2B5EF4-FFF2-40B4-BE49-F238E27FC236}">
-                <a16:creationId xmlns:a16="http://schemas.microsoft.com/office/drawing/2014/main" id="{A465675F-7287-4E8B-A746-D9383BFC5459}"/>
+                <a16:creationId xmlns:a16="http://schemas.microsoft.com/office/drawing/2014/main" id="{A65CF34F-1ACC-4946-9B23-9732FA5ECE91}"/>
               </a:ext>
             </a:extLst>
           </p:cNvPr>
@@ -12005,7 +12005,7 @@
           <p:cNvPr id="8" name="">
             <a:extLst xmlns:a="http://schemas.openxmlformats.org/drawingml/2006/main">
               <a:ext uri="{FF2B5EF4-FFF2-40B4-BE49-F238E27FC236}">
-                <a16:creationId xmlns:a16="http://schemas.microsoft.com/office/drawing/2014/main" id="{0569FB53-CF94-490C-885F-5906F29008BF}"/>
+                <a16:creationId xmlns:a16="http://schemas.microsoft.com/office/drawing/2014/main" id="{E0519B6D-135E-4A5D-BEB8-5E003B9BEFB3}"/>
               </a:ext>
             </a:extLst>
           </p:cNvPr>
@@ -12069,7 +12069,7 @@
           <p:cNvPr id="9" name="">
             <a:extLst xmlns:a="http://schemas.openxmlformats.org/drawingml/2006/main">
               <a:ext uri="{FF2B5EF4-FFF2-40B4-BE49-F238E27FC236}">
-                <a16:creationId xmlns:a16="http://schemas.microsoft.com/office/drawing/2014/main" id="{73CBABDB-94A6-4C39-B692-9CBEB92662DB}"/>
+                <a16:creationId xmlns:a16="http://schemas.microsoft.com/office/drawing/2014/main" id="{D2159217-EDAA-4F97-93EC-A265F44EB446}"/>
               </a:ext>
             </a:extLst>
           </p:cNvPr>
@@ -12133,7 +12133,7 @@
           <p:cNvPr id="10" name="">
             <a:extLst xmlns:a="http://schemas.openxmlformats.org/drawingml/2006/main">
               <a:ext uri="{FF2B5EF4-FFF2-40B4-BE49-F238E27FC236}">
-                <a16:creationId xmlns:a16="http://schemas.microsoft.com/office/drawing/2014/main" id="{B5F6A3C5-EB26-49F9-A886-5759B591EEE4}"/>
+                <a16:creationId xmlns:a16="http://schemas.microsoft.com/office/drawing/2014/main" id="{0293AC2D-6F0F-4CA2-A641-155468DC23B8}"/>
               </a:ext>
             </a:extLst>
           </p:cNvPr>
@@ -12166,7 +12166,7 @@
           <p:cNvPr id="11" name="">
             <a:extLst xmlns:a="http://schemas.openxmlformats.org/drawingml/2006/main">
               <a:ext uri="{FF2B5EF4-FFF2-40B4-BE49-F238E27FC236}">
-                <a16:creationId xmlns:a16="http://schemas.microsoft.com/office/drawing/2014/main" id="{98016595-3DB6-4607-8601-8572D627AA2D}"/>
+                <a16:creationId xmlns:a16="http://schemas.microsoft.com/office/drawing/2014/main" id="{0F595E83-B9F7-4728-90F8-1BCE046EF76C}"/>
               </a:ext>
             </a:extLst>
           </p:cNvPr>
@@ -12230,7 +12230,7 @@
           <p:cNvPr id="12" name="">
             <a:extLst xmlns:a="http://schemas.openxmlformats.org/drawingml/2006/main">
               <a:ext uri="{FF2B5EF4-FFF2-40B4-BE49-F238E27FC236}">
-                <a16:creationId xmlns:a16="http://schemas.microsoft.com/office/drawing/2014/main" id="{7C347A4C-15B5-449A-B383-9D2E0F0A982A}"/>
+                <a16:creationId xmlns:a16="http://schemas.microsoft.com/office/drawing/2014/main" id="{90D18344-FD28-44F8-929D-70D0BD7F4B61}"/>
               </a:ext>
             </a:extLst>
           </p:cNvPr>
@@ -12294,7 +12294,7 @@
           <p:cNvPr id="13" name="">
             <a:extLst xmlns:a="http://schemas.openxmlformats.org/drawingml/2006/main">
               <a:ext uri="{FF2B5EF4-FFF2-40B4-BE49-F238E27FC236}">
-                <a16:creationId xmlns:a16="http://schemas.microsoft.com/office/drawing/2014/main" id="{F5E31171-A3A7-4FB9-BDAF-45FDDBB97680}"/>
+                <a16:creationId xmlns:a16="http://schemas.microsoft.com/office/drawing/2014/main" id="{0539FEFE-95D6-4434-B92F-B43539B0B62E}"/>
               </a:ext>
             </a:extLst>
           </p:cNvPr>
@@ -12327,7 +12327,7 @@
           <p:cNvPr id="14" name="">
             <a:extLst xmlns:a="http://schemas.openxmlformats.org/drawingml/2006/main">
               <a:ext uri="{FF2B5EF4-FFF2-40B4-BE49-F238E27FC236}">
-                <a16:creationId xmlns:a16="http://schemas.microsoft.com/office/drawing/2014/main" id="{83C50839-F516-4F79-A778-9E44C25C339A}"/>
+                <a16:creationId xmlns:a16="http://schemas.microsoft.com/office/drawing/2014/main" id="{F8E83596-721F-469F-B6D9-E335224D0E20}"/>
               </a:ext>
             </a:extLst>
           </p:cNvPr>
@@ -12391,7 +12391,7 @@
           <p:cNvPr id="15" name="">
             <a:extLst xmlns:a="http://schemas.openxmlformats.org/drawingml/2006/main">
               <a:ext uri="{FF2B5EF4-FFF2-40B4-BE49-F238E27FC236}">
-                <a16:creationId xmlns:a16="http://schemas.microsoft.com/office/drawing/2014/main" id="{2A3302C8-0AB9-4414-9F24-6F8998132420}"/>
+                <a16:creationId xmlns:a16="http://schemas.microsoft.com/office/drawing/2014/main" id="{2CEB2275-C2BB-4756-AD32-699DA2985CF1}"/>
               </a:ext>
             </a:extLst>
           </p:cNvPr>
@@ -12455,7 +12455,7 @@
           <p:cNvPr id="16" name="">
             <a:extLst xmlns:a="http://schemas.openxmlformats.org/drawingml/2006/main">
               <a:ext uri="{FF2B5EF4-FFF2-40B4-BE49-F238E27FC236}">
-                <a16:creationId xmlns:a16="http://schemas.microsoft.com/office/drawing/2014/main" id="{DA3FF9FC-EB42-477C-AD70-8D53DC9B65FC}"/>
+                <a16:creationId xmlns:a16="http://schemas.microsoft.com/office/drawing/2014/main" id="{14279AFD-5A66-4007-AD07-A7DD86659871}"/>
               </a:ext>
             </a:extLst>
           </p:cNvPr>
@@ -12519,7 +12519,7 @@
           <p:cNvPr id="17" name="">
             <a:extLst xmlns:a="http://schemas.openxmlformats.org/drawingml/2006/main">
               <a:ext uri="{FF2B5EF4-FFF2-40B4-BE49-F238E27FC236}">
-                <a16:creationId xmlns:a16="http://schemas.microsoft.com/office/drawing/2014/main" id="{E1641FAB-9F4C-4D84-BC01-EB0CBA55FFCB}"/>
+                <a16:creationId xmlns:a16="http://schemas.microsoft.com/office/drawing/2014/main" id="{2DC07A1A-1B26-4DAF-9912-FD37A8647BAE}"/>
               </a:ext>
             </a:extLst>
           </p:cNvPr>
@@ -12581,7 +12581,7 @@
     </p:spTree>
     <p:extLst>
       <p:ext uri="{BB962C8B-B14F-4D97-AF65-F5344CB8AC3E}">
-        <p14:creationId xmlns:p14="http://schemas.microsoft.com/office/powerpoint/2010/main" val="1999292940"/>
+        <p14:creationId xmlns:p14="http://schemas.microsoft.com/office/powerpoint/2010/main" val="904924263"/>
       </p:ext>
     </p:extLst>
   </p:cSld>
@@ -12605,7 +12605,7 @@
           <p:cNvPr id="1" name="">
             <a:extLst xmlns:a="http://schemas.openxmlformats.org/drawingml/2006/main">
               <a:ext uri="{FF2B5EF4-FFF2-40B4-BE49-F238E27FC236}">
-                <a16:creationId xmlns:a16="http://schemas.microsoft.com/office/drawing/2014/main" id="{D4978F08-2B8E-4626-8FB0-306A6360BAF7}"/>
+                <a16:creationId xmlns:a16="http://schemas.microsoft.com/office/drawing/2014/main" id="{B1E18092-D764-4547-9037-EEBC0F6A6AB1}"/>
               </a:ext>
             </a:extLst>
           </p:cNvPr>
@@ -12640,7 +12640,7 @@
           <p:cNvPr id="2" name="">
             <a:extLst xmlns:a="http://schemas.openxmlformats.org/drawingml/2006/main">
               <a:ext uri="{FF2B5EF4-FFF2-40B4-BE49-F238E27FC236}">
-                <a16:creationId xmlns:a16="http://schemas.microsoft.com/office/drawing/2014/main" id="{AE7A9087-7F58-4AC3-A38A-D7895D8F1697}"/>
+                <a16:creationId xmlns:a16="http://schemas.microsoft.com/office/drawing/2014/main" id="{283FD013-4B4D-4FC1-8A9A-27E50EA9C5EB}"/>
               </a:ext>
             </a:extLst>
           </p:cNvPr>
@@ -12675,7 +12675,7 @@
           <p:cNvPr id="3" name="">
             <a:extLst xmlns:a="http://schemas.openxmlformats.org/drawingml/2006/main">
               <a:ext uri="{FF2B5EF4-FFF2-40B4-BE49-F238E27FC236}">
-                <a16:creationId xmlns:a16="http://schemas.microsoft.com/office/drawing/2014/main" id="{7179E605-7301-47B9-8B0E-060A642A0997}"/>
+                <a16:creationId xmlns:a16="http://schemas.microsoft.com/office/drawing/2014/main" id="{4E43FCF6-05BD-4F82-BD2E-E53824BABE7E}"/>
               </a:ext>
             </a:extLst>
           </p:cNvPr>
@@ -12739,7 +12739,7 @@
           <p:cNvPr id="4" name="">
             <a:extLst xmlns:a="http://schemas.openxmlformats.org/drawingml/2006/main">
               <a:ext uri="{FF2B5EF4-FFF2-40B4-BE49-F238E27FC236}">
-                <a16:creationId xmlns:a16="http://schemas.microsoft.com/office/drawing/2014/main" id="{4BDD0072-BEC1-43B8-ADBA-A904346C566E}"/>
+                <a16:creationId xmlns:a16="http://schemas.microsoft.com/office/drawing/2014/main" id="{8CFC3359-D77F-44E3-A990-4BF4612BA61B}"/>
               </a:ext>
             </a:extLst>
           </p:cNvPr>
@@ -12803,7 +12803,7 @@
           <p:cNvPr id="5" name="">
             <a:extLst xmlns:a="http://schemas.openxmlformats.org/drawingml/2006/main">
               <a:ext uri="{FF2B5EF4-FFF2-40B4-BE49-F238E27FC236}">
-                <a16:creationId xmlns:a16="http://schemas.microsoft.com/office/drawing/2014/main" id="{E1D5D772-A63E-4E37-B71F-0686BE0A25A2}"/>
+                <a16:creationId xmlns:a16="http://schemas.microsoft.com/office/drawing/2014/main" id="{66A3480E-A91C-4157-8F57-125DCE069541}"/>
               </a:ext>
             </a:extLst>
           </p:cNvPr>
@@ -12867,7 +12867,7 @@
           <p:cNvPr id="6" name="">
             <a:extLst xmlns:a="http://schemas.openxmlformats.org/drawingml/2006/main">
               <a:ext uri="{FF2B5EF4-FFF2-40B4-BE49-F238E27FC236}">
-                <a16:creationId xmlns:a16="http://schemas.microsoft.com/office/drawing/2014/main" id="{8F52B721-BC78-4DF5-9D48-5BFC171D4341}"/>
+                <a16:creationId xmlns:a16="http://schemas.microsoft.com/office/drawing/2014/main" id="{1CFA3573-77A5-49C0-9794-EA4858FD15EA}"/>
               </a:ext>
             </a:extLst>
           </p:cNvPr>
@@ -12931,7 +12931,7 @@
           <p:cNvPr id="7" name="">
             <a:extLst xmlns:a="http://schemas.openxmlformats.org/drawingml/2006/main">
               <a:ext uri="{FF2B5EF4-FFF2-40B4-BE49-F238E27FC236}">
-                <a16:creationId xmlns:a16="http://schemas.microsoft.com/office/drawing/2014/main" id="{F0859855-8A6A-427F-9890-59B76D0595FD}"/>
+                <a16:creationId xmlns:a16="http://schemas.microsoft.com/office/drawing/2014/main" id="{A1635FE6-9466-4CC1-B495-AF2D1CAB5243}"/>
               </a:ext>
             </a:extLst>
           </p:cNvPr>
@@ -12964,7 +12964,7 @@
           <p:cNvPr id="8" name="">
             <a:extLst xmlns:a="http://schemas.openxmlformats.org/drawingml/2006/main">
               <a:ext uri="{FF2B5EF4-FFF2-40B4-BE49-F238E27FC236}">
-                <a16:creationId xmlns:a16="http://schemas.microsoft.com/office/drawing/2014/main" id="{27F0C1DF-4ABC-4615-A5DA-E8C2135A0FC8}"/>
+                <a16:creationId xmlns:a16="http://schemas.microsoft.com/office/drawing/2014/main" id="{4AB98E3E-A13F-469C-B4F1-0FA20D2B5EC9}"/>
               </a:ext>
             </a:extLst>
           </p:cNvPr>
@@ -13028,7 +13028,7 @@
           <p:cNvPr id="9" name="">
             <a:extLst xmlns:a="http://schemas.openxmlformats.org/drawingml/2006/main">
               <a:ext uri="{FF2B5EF4-FFF2-40B4-BE49-F238E27FC236}">
-                <a16:creationId xmlns:a16="http://schemas.microsoft.com/office/drawing/2014/main" id="{9CEDC509-91AD-40D0-9C84-3F24630024A2}"/>
+                <a16:creationId xmlns:a16="http://schemas.microsoft.com/office/drawing/2014/main" id="{8A811FB8-E597-4EF3-BAF8-7393A8CC88D4}"/>
               </a:ext>
             </a:extLst>
           </p:cNvPr>
@@ -13092,7 +13092,7 @@
           <p:cNvPr id="10" name="">
             <a:extLst xmlns:a="http://schemas.openxmlformats.org/drawingml/2006/main">
               <a:ext uri="{FF2B5EF4-FFF2-40B4-BE49-F238E27FC236}">
-                <a16:creationId xmlns:a16="http://schemas.microsoft.com/office/drawing/2014/main" id="{C527AE92-010B-492F-8D45-3147D4F410AE}"/>
+                <a16:creationId xmlns:a16="http://schemas.microsoft.com/office/drawing/2014/main" id="{67A8C97D-990F-4348-AEF3-A6593542195B}"/>
               </a:ext>
             </a:extLst>
           </p:cNvPr>
@@ -13156,7 +13156,7 @@
           <p:cNvPr id="11" name="">
             <a:extLst xmlns:a="http://schemas.openxmlformats.org/drawingml/2006/main">
               <a:ext uri="{FF2B5EF4-FFF2-40B4-BE49-F238E27FC236}">
-                <a16:creationId xmlns:a16="http://schemas.microsoft.com/office/drawing/2014/main" id="{D4C87985-F663-4D3F-94A0-25AAD4A08B71}"/>
+                <a16:creationId xmlns:a16="http://schemas.microsoft.com/office/drawing/2014/main" id="{7E07AC7D-EFEC-4987-8057-7E16119AD1B4}"/>
               </a:ext>
             </a:extLst>
           </p:cNvPr>
@@ -13189,7 +13189,7 @@
           <p:cNvPr id="12" name="">
             <a:extLst xmlns:a="http://schemas.openxmlformats.org/drawingml/2006/main">
               <a:ext uri="{FF2B5EF4-FFF2-40B4-BE49-F238E27FC236}">
-                <a16:creationId xmlns:a16="http://schemas.microsoft.com/office/drawing/2014/main" id="{9211F71A-5C86-46D2-935A-88060CEFFD91}"/>
+                <a16:creationId xmlns:a16="http://schemas.microsoft.com/office/drawing/2014/main" id="{48B15D7B-09BE-44C0-BA41-5D35AFC0D6CF}"/>
               </a:ext>
             </a:extLst>
           </p:cNvPr>
@@ -13253,7 +13253,7 @@
           <p:cNvPr id="13" name="">
             <a:extLst xmlns:a="http://schemas.openxmlformats.org/drawingml/2006/main">
               <a:ext uri="{FF2B5EF4-FFF2-40B4-BE49-F238E27FC236}">
-                <a16:creationId xmlns:a16="http://schemas.microsoft.com/office/drawing/2014/main" id="{5AB2E40C-3F56-4885-B13A-6E9C50669625}"/>
+                <a16:creationId xmlns:a16="http://schemas.microsoft.com/office/drawing/2014/main" id="{06880A99-52E9-4A65-9F9F-3B2A7D13BF76}"/>
               </a:ext>
             </a:extLst>
           </p:cNvPr>
@@ -13317,7 +13317,7 @@
           <p:cNvPr id="14" name="">
             <a:extLst xmlns:a="http://schemas.openxmlformats.org/drawingml/2006/main">
               <a:ext uri="{FF2B5EF4-FFF2-40B4-BE49-F238E27FC236}">
-                <a16:creationId xmlns:a16="http://schemas.microsoft.com/office/drawing/2014/main" id="{0CD8567F-7A83-4197-8273-01524C96D54A}"/>
+                <a16:creationId xmlns:a16="http://schemas.microsoft.com/office/drawing/2014/main" id="{5C10FC47-F5CB-495E-9E17-56717AB1EE80}"/>
               </a:ext>
             </a:extLst>
           </p:cNvPr>
@@ -13381,7 +13381,7 @@
           <p:cNvPr id="15" name="">
             <a:extLst xmlns:a="http://schemas.openxmlformats.org/drawingml/2006/main">
               <a:ext uri="{FF2B5EF4-FFF2-40B4-BE49-F238E27FC236}">
-                <a16:creationId xmlns:a16="http://schemas.microsoft.com/office/drawing/2014/main" id="{2180B138-027C-41D4-B6A4-8E7EDDBEDB79}"/>
+                <a16:creationId xmlns:a16="http://schemas.microsoft.com/office/drawing/2014/main" id="{C2E265B3-5430-490E-8D98-27D4B9AA6514}"/>
               </a:ext>
             </a:extLst>
           </p:cNvPr>
@@ -13414,7 +13414,7 @@
           <p:cNvPr id="16" name="">
             <a:extLst xmlns:a="http://schemas.openxmlformats.org/drawingml/2006/main">
               <a:ext uri="{FF2B5EF4-FFF2-40B4-BE49-F238E27FC236}">
-                <a16:creationId xmlns:a16="http://schemas.microsoft.com/office/drawing/2014/main" id="{7013A147-25D2-46E0-A0AE-8C602EA6F325}"/>
+                <a16:creationId xmlns:a16="http://schemas.microsoft.com/office/drawing/2014/main" id="{2206CE81-FDF2-46F6-9ED6-ECCC6E19D652}"/>
               </a:ext>
             </a:extLst>
           </p:cNvPr>
@@ -13478,7 +13478,7 @@
           <p:cNvPr id="17" name="">
             <a:extLst xmlns:a="http://schemas.openxmlformats.org/drawingml/2006/main">
               <a:ext uri="{FF2B5EF4-FFF2-40B4-BE49-F238E27FC236}">
-                <a16:creationId xmlns:a16="http://schemas.microsoft.com/office/drawing/2014/main" id="{3E6C3BBC-61DD-42E9-8848-80E7D68CDC3E}"/>
+                <a16:creationId xmlns:a16="http://schemas.microsoft.com/office/drawing/2014/main" id="{66682C59-638A-4E09-833B-E9B625D10E41}"/>
               </a:ext>
             </a:extLst>
           </p:cNvPr>
@@ -13542,7 +13542,7 @@
           <p:cNvPr id="18" name="">
             <a:extLst xmlns:a="http://schemas.openxmlformats.org/drawingml/2006/main">
               <a:ext uri="{FF2B5EF4-FFF2-40B4-BE49-F238E27FC236}">
-                <a16:creationId xmlns:a16="http://schemas.microsoft.com/office/drawing/2014/main" id="{17FC702C-6FD2-43C0-86AD-3942648340E5}"/>
+                <a16:creationId xmlns:a16="http://schemas.microsoft.com/office/drawing/2014/main" id="{F68A4B03-7F92-4830-A187-3BB97910F27A}"/>
               </a:ext>
             </a:extLst>
           </p:cNvPr>
@@ -13575,7 +13575,7 @@
           <p:cNvPr id="19" name="">
             <a:extLst xmlns:a="http://schemas.openxmlformats.org/drawingml/2006/main">
               <a:ext uri="{FF2B5EF4-FFF2-40B4-BE49-F238E27FC236}">
-                <a16:creationId xmlns:a16="http://schemas.microsoft.com/office/drawing/2014/main" id="{257A9E3D-B74D-4BE6-A96E-E9C60F16EC9F}"/>
+                <a16:creationId xmlns:a16="http://schemas.microsoft.com/office/drawing/2014/main" id="{ADBC181F-F0FA-4885-A685-B8675123CA55}"/>
               </a:ext>
             </a:extLst>
           </p:cNvPr>
@@ -13639,7 +13639,7 @@
           <p:cNvPr id="20" name="">
             <a:extLst xmlns:a="http://schemas.openxmlformats.org/drawingml/2006/main">
               <a:ext uri="{FF2B5EF4-FFF2-40B4-BE49-F238E27FC236}">
-                <a16:creationId xmlns:a16="http://schemas.microsoft.com/office/drawing/2014/main" id="{A62BE532-3A7D-412A-AE04-F1B2F49D18DC}"/>
+                <a16:creationId xmlns:a16="http://schemas.microsoft.com/office/drawing/2014/main" id="{2FE7D7F7-DAF9-4369-8C56-69941232E569}"/>
               </a:ext>
             </a:extLst>
           </p:cNvPr>
@@ -13703,7 +13703,7 @@
           <p:cNvPr id="21" name="">
             <a:extLst xmlns:a="http://schemas.openxmlformats.org/drawingml/2006/main">
               <a:ext uri="{FF2B5EF4-FFF2-40B4-BE49-F238E27FC236}">
-                <a16:creationId xmlns:a16="http://schemas.microsoft.com/office/drawing/2014/main" id="{3E13D5C5-FD2B-4563-A3CE-ACB8C001A919}"/>
+                <a16:creationId xmlns:a16="http://schemas.microsoft.com/office/drawing/2014/main" id="{33C35ACF-BD9A-42F6-B519-33A9DBD31CB6}"/>
               </a:ext>
             </a:extLst>
           </p:cNvPr>
@@ -13767,7 +13767,7 @@
           <p:cNvPr id="22" name="">
             <a:extLst xmlns:a="http://schemas.openxmlformats.org/drawingml/2006/main">
               <a:ext uri="{FF2B5EF4-FFF2-40B4-BE49-F238E27FC236}">
-                <a16:creationId xmlns:a16="http://schemas.microsoft.com/office/drawing/2014/main" id="{3EE34BD4-4B4A-4DAF-8A78-8F69C9332293}"/>
+                <a16:creationId xmlns:a16="http://schemas.microsoft.com/office/drawing/2014/main" id="{CD17102A-7916-4A0A-97B3-00E1C7181724}"/>
               </a:ext>
             </a:extLst>
           </p:cNvPr>
@@ -13829,7 +13829,7 @@
     </p:spTree>
     <p:extLst>
       <p:ext uri="{BB962C8B-B14F-4D97-AF65-F5344CB8AC3E}">
-        <p14:creationId xmlns:p14="http://schemas.microsoft.com/office/powerpoint/2010/main" val="1675609024"/>
+        <p14:creationId xmlns:p14="http://schemas.microsoft.com/office/powerpoint/2010/main" val="2096555736"/>
       </p:ext>
     </p:extLst>
   </p:cSld>

</xml_diff>

<commit_message>
feat: explain off-grid field continuity
</commit_message>
<xml_diff>
--- a/submission/proteinloop-hackathon-deck.pptx
+++ b/submission/proteinloop-hackathon-deck.pptx
@@ -2,22 +2,22 @@
 <file path=ppt/presentation.xml><?xml version="1.0" encoding="utf-8"?>
 <p:presentation xmlns:p="http://schemas.openxmlformats.org/presentationml/2006/main">
   <p:sldMasterIdLst>
-    <p:sldMasterId xmlns:r="http://schemas.openxmlformats.org/officeDocument/2006/relationships" id="2147483648" r:id="R896ee810c5c243f8"/>
+    <p:sldMasterId xmlns:r="http://schemas.openxmlformats.org/officeDocument/2006/relationships" id="2147483648" r:id="R98f1f919712c42f9"/>
   </p:sldMasterIdLst>
   <p:notesMasterIdLst>
-    <p:notesMasterId xmlns:r="http://schemas.openxmlformats.org/officeDocument/2006/relationships" r:id="Rc989136c751c43ea"/>
+    <p:notesMasterId xmlns:r="http://schemas.openxmlformats.org/officeDocument/2006/relationships" r:id="R5d6b16586f2b4fae"/>
   </p:notesMasterIdLst>
   <p:sldIdLst>
-    <p:sldId xmlns:r="http://schemas.openxmlformats.org/officeDocument/2006/relationships" id="256" r:id="Rb94e47f575a04c3d"/>
-    <p:sldId xmlns:r="http://schemas.openxmlformats.org/officeDocument/2006/relationships" id="257" r:id="R74d8c850b89640be"/>
-    <p:sldId xmlns:r="http://schemas.openxmlformats.org/officeDocument/2006/relationships" id="258" r:id="Rd87b2610492b445f"/>
-    <p:sldId xmlns:r="http://schemas.openxmlformats.org/officeDocument/2006/relationships" id="259" r:id="Re3a0cb5a87af4e0a"/>
-    <p:sldId xmlns:r="http://schemas.openxmlformats.org/officeDocument/2006/relationships" id="260" r:id="Rae2c60e044104709"/>
-    <p:sldId xmlns:r="http://schemas.openxmlformats.org/officeDocument/2006/relationships" id="261" r:id="Rf63530e4d0ad4780"/>
-    <p:sldId xmlns:r="http://schemas.openxmlformats.org/officeDocument/2006/relationships" id="262" r:id="R12ce53cc39404bfa"/>
-    <p:sldId xmlns:r="http://schemas.openxmlformats.org/officeDocument/2006/relationships" id="263" r:id="R187cd8d85c994681"/>
-    <p:sldId xmlns:r="http://schemas.openxmlformats.org/officeDocument/2006/relationships" id="264" r:id="R52b4c845d5834938"/>
-    <p:sldId xmlns:r="http://schemas.openxmlformats.org/officeDocument/2006/relationships" id="265" r:id="R45f3de5f1ccf41f3"/>
+    <p:sldId xmlns:r="http://schemas.openxmlformats.org/officeDocument/2006/relationships" id="256" r:id="Rf81549b35379400b"/>
+    <p:sldId xmlns:r="http://schemas.openxmlformats.org/officeDocument/2006/relationships" id="257" r:id="R0c276de5635b41b5"/>
+    <p:sldId xmlns:r="http://schemas.openxmlformats.org/officeDocument/2006/relationships" id="258" r:id="Re9dd8b8e57d94111"/>
+    <p:sldId xmlns:r="http://schemas.openxmlformats.org/officeDocument/2006/relationships" id="259" r:id="R968268323b4c4ad6"/>
+    <p:sldId xmlns:r="http://schemas.openxmlformats.org/officeDocument/2006/relationships" id="260" r:id="R2e471bef25b74bcf"/>
+    <p:sldId xmlns:r="http://schemas.openxmlformats.org/officeDocument/2006/relationships" id="261" r:id="R606f8f4eca884cc8"/>
+    <p:sldId xmlns:r="http://schemas.openxmlformats.org/officeDocument/2006/relationships" id="262" r:id="Rad966d13c69d4473"/>
+    <p:sldId xmlns:r="http://schemas.openxmlformats.org/officeDocument/2006/relationships" id="263" r:id="Rd9817204d310458d"/>
+    <p:sldId xmlns:r="http://schemas.openxmlformats.org/officeDocument/2006/relationships" id="264" r:id="R72d89ec2ff9749f7"/>
+    <p:sldId xmlns:r="http://schemas.openxmlformats.org/officeDocument/2006/relationships" id="265" r:id="Rb0f26de0b34e4f05"/>
   </p:sldIdLst>
   <p:sldSz cx="12192000" cy="6858000"/>
   <p:notesSz cx="6858000" cy="9144000"/>
@@ -1158,7 +1158,7 @@
   </p:cSld>
   <p:clrMap bg1="lt1" tx1="dk1" bg2="lt2" tx2="dk2" accent1="accent1" accent2="accent2" accent3="accent3" accent4="accent4" accent5="accent5" accent6="accent6" hlink="hlink" folHlink="folHlink"/>
   <p:sldLayoutIdLst>
-    <p:sldLayoutId xmlns:r="http://schemas.openxmlformats.org/officeDocument/2006/relationships" id="2147483649" r:id="Rf3713d7dec0741a6"/>
+    <p:sldLayoutId xmlns:r="http://schemas.openxmlformats.org/officeDocument/2006/relationships" id="2147483649" r:id="Rbf2491285e16493a"/>
   </p:sldLayoutIdLst>
   <p:txStyles>
     <p:titleStyle>
@@ -1457,7 +1457,7 @@
           <p:cNvPr id="1" name="">
             <a:extLst xmlns:a="http://schemas.openxmlformats.org/drawingml/2006/main">
               <a:ext uri="{FF2B5EF4-FFF2-40B4-BE49-F238E27FC236}">
-                <a16:creationId xmlns:a16="http://schemas.microsoft.com/office/drawing/2014/main" id="{57D09D46-0B9E-4243-99C4-F7E45319708B}"/>
+                <a16:creationId xmlns:a16="http://schemas.microsoft.com/office/drawing/2014/main" id="{5A99E4D0-7AF8-42CA-A787-7FD97292BF5A}"/>
               </a:ext>
             </a:extLst>
           </p:cNvPr>
@@ -1492,7 +1492,7 @@
           <p:cNvPr id="2" name="">
             <a:extLst xmlns:a="http://schemas.openxmlformats.org/drawingml/2006/main">
               <a:ext uri="{FF2B5EF4-FFF2-40B4-BE49-F238E27FC236}">
-                <a16:creationId xmlns:a16="http://schemas.microsoft.com/office/drawing/2014/main" id="{7DC1ED6E-EA51-49B3-BDF6-4F73A8C5CFB0}"/>
+                <a16:creationId xmlns:a16="http://schemas.microsoft.com/office/drawing/2014/main" id="{957A21FA-9D9F-4E39-A8EA-F20FD3607FDD}"/>
               </a:ext>
             </a:extLst>
           </p:cNvPr>
@@ -1527,7 +1527,7 @@
           <p:cNvPr id="3" name="">
             <a:extLst xmlns:a="http://schemas.openxmlformats.org/drawingml/2006/main">
               <a:ext uri="{FF2B5EF4-FFF2-40B4-BE49-F238E27FC236}">
-                <a16:creationId xmlns:a16="http://schemas.microsoft.com/office/drawing/2014/main" id="{F55DFDFD-60BE-4A7C-9CA7-B6780A00BD19}"/>
+                <a16:creationId xmlns:a16="http://schemas.microsoft.com/office/drawing/2014/main" id="{034DC44D-AC61-4173-954A-EA3D545D5339}"/>
               </a:ext>
             </a:extLst>
           </p:cNvPr>
@@ -1591,7 +1591,7 @@
           <p:cNvPr id="4" name="">
             <a:extLst xmlns:a="http://schemas.openxmlformats.org/drawingml/2006/main">
               <a:ext uri="{FF2B5EF4-FFF2-40B4-BE49-F238E27FC236}">
-                <a16:creationId xmlns:a16="http://schemas.microsoft.com/office/drawing/2014/main" id="{44A7514E-F826-482F-B9B1-6A7F96A8DDDC}"/>
+                <a16:creationId xmlns:a16="http://schemas.microsoft.com/office/drawing/2014/main" id="{DCB3C3DC-9622-4ED5-A8C9-D390B9DC3D2F}"/>
               </a:ext>
             </a:extLst>
           </p:cNvPr>
@@ -1655,7 +1655,7 @@
           <p:cNvPr id="5" name="">
             <a:extLst xmlns:a="http://schemas.openxmlformats.org/drawingml/2006/main">
               <a:ext uri="{FF2B5EF4-FFF2-40B4-BE49-F238E27FC236}">
-                <a16:creationId xmlns:a16="http://schemas.microsoft.com/office/drawing/2014/main" id="{CCEFC1EE-CE8D-4354-8470-CB46326711DD}"/>
+                <a16:creationId xmlns:a16="http://schemas.microsoft.com/office/drawing/2014/main" id="{1B6FFAB3-6864-4FA9-BFFB-C23C2019A807}"/>
               </a:ext>
             </a:extLst>
           </p:cNvPr>
@@ -1690,7 +1690,7 @@
           <p:cNvPr id="6" name="">
             <a:extLst xmlns:a="http://schemas.openxmlformats.org/drawingml/2006/main">
               <a:ext uri="{FF2B5EF4-FFF2-40B4-BE49-F238E27FC236}">
-                <a16:creationId xmlns:a16="http://schemas.microsoft.com/office/drawing/2014/main" id="{24368380-BA4F-42FC-BAAC-09BF59432CE0}"/>
+                <a16:creationId xmlns:a16="http://schemas.microsoft.com/office/drawing/2014/main" id="{D7E9172F-6B0B-483B-80F2-805DB7E855CB}"/>
               </a:ext>
             </a:extLst>
           </p:cNvPr>
@@ -1754,7 +1754,7 @@
           <p:cNvPr id="7" name="">
             <a:extLst xmlns:a="http://schemas.openxmlformats.org/drawingml/2006/main">
               <a:ext uri="{FF2B5EF4-FFF2-40B4-BE49-F238E27FC236}">
-                <a16:creationId xmlns:a16="http://schemas.microsoft.com/office/drawing/2014/main" id="{F725166A-0F11-42B4-B6D1-028FD4935B25}"/>
+                <a16:creationId xmlns:a16="http://schemas.microsoft.com/office/drawing/2014/main" id="{E735EF7C-018D-48BC-9276-BFDDD948A17C}"/>
               </a:ext>
             </a:extLst>
           </p:cNvPr>
@@ -1818,7 +1818,7 @@
           <p:cNvPr id="8" name="">
             <a:extLst xmlns:a="http://schemas.openxmlformats.org/drawingml/2006/main">
               <a:ext uri="{FF2B5EF4-FFF2-40B4-BE49-F238E27FC236}">
-                <a16:creationId xmlns:a16="http://schemas.microsoft.com/office/drawing/2014/main" id="{B46CBC13-81DB-40D3-9CFE-C22BDD1E309D}"/>
+                <a16:creationId xmlns:a16="http://schemas.microsoft.com/office/drawing/2014/main" id="{C0EA1038-7525-45D1-BBD3-4586984B9FB3}"/>
               </a:ext>
             </a:extLst>
           </p:cNvPr>
@@ -1853,7 +1853,7 @@
           <p:cNvPr id="9" name="">
             <a:extLst xmlns:a="http://schemas.openxmlformats.org/drawingml/2006/main">
               <a:ext uri="{FF2B5EF4-FFF2-40B4-BE49-F238E27FC236}">
-                <a16:creationId xmlns:a16="http://schemas.microsoft.com/office/drawing/2014/main" id="{147CFF2E-6C2E-4F82-95F1-5E377846735B}"/>
+                <a16:creationId xmlns:a16="http://schemas.microsoft.com/office/drawing/2014/main" id="{E8F641CE-C9E7-4250-AEC5-9B289F150BF5}"/>
               </a:ext>
             </a:extLst>
           </p:cNvPr>
@@ -1917,7 +1917,7 @@
           <p:cNvPr id="10" name="">
             <a:extLst xmlns:a="http://schemas.openxmlformats.org/drawingml/2006/main">
               <a:ext uri="{FF2B5EF4-FFF2-40B4-BE49-F238E27FC236}">
-                <a16:creationId xmlns:a16="http://schemas.microsoft.com/office/drawing/2014/main" id="{4D5310F0-7060-4B61-BA7D-CAED20C2486D}"/>
+                <a16:creationId xmlns:a16="http://schemas.microsoft.com/office/drawing/2014/main" id="{5B630906-B504-45F0-8993-72448500DD1D}"/>
               </a:ext>
             </a:extLst>
           </p:cNvPr>
@@ -1981,7 +1981,7 @@
           <p:cNvPr id="11" name="">
             <a:extLst xmlns:a="http://schemas.openxmlformats.org/drawingml/2006/main">
               <a:ext uri="{FF2B5EF4-FFF2-40B4-BE49-F238E27FC236}">
-                <a16:creationId xmlns:a16="http://schemas.microsoft.com/office/drawing/2014/main" id="{4FE3E1F4-35A3-4B63-BADC-03D3796710A0}"/>
+                <a16:creationId xmlns:a16="http://schemas.microsoft.com/office/drawing/2014/main" id="{EA5FD788-B5C8-4929-87A0-F1566A9C5C0F}"/>
               </a:ext>
             </a:extLst>
           </p:cNvPr>
@@ -2045,7 +2045,7 @@
           <p:cNvPr id="12" name="">
             <a:extLst xmlns:a="http://schemas.openxmlformats.org/drawingml/2006/main">
               <a:ext uri="{FF2B5EF4-FFF2-40B4-BE49-F238E27FC236}">
-                <a16:creationId xmlns:a16="http://schemas.microsoft.com/office/drawing/2014/main" id="{20E5D1B2-7149-47D5-BA79-235F82544D84}"/>
+                <a16:creationId xmlns:a16="http://schemas.microsoft.com/office/drawing/2014/main" id="{7023C592-B12D-458C-BE4C-710880B33C4A}"/>
               </a:ext>
             </a:extLst>
           </p:cNvPr>
@@ -2080,7 +2080,7 @@
           <p:cNvPr id="13" name="">
             <a:extLst xmlns:a="http://schemas.openxmlformats.org/drawingml/2006/main">
               <a:ext uri="{FF2B5EF4-FFF2-40B4-BE49-F238E27FC236}">
-                <a16:creationId xmlns:a16="http://schemas.microsoft.com/office/drawing/2014/main" id="{6E45875C-AA40-4978-993F-C22A3B9445CE}"/>
+                <a16:creationId xmlns:a16="http://schemas.microsoft.com/office/drawing/2014/main" id="{6DB29429-620D-4C7A-A33C-0C89E0646F48}"/>
               </a:ext>
             </a:extLst>
           </p:cNvPr>
@@ -2144,7 +2144,7 @@
           <p:cNvPr id="14" name="">
             <a:extLst xmlns:a="http://schemas.openxmlformats.org/drawingml/2006/main">
               <a:ext uri="{FF2B5EF4-FFF2-40B4-BE49-F238E27FC236}">
-                <a16:creationId xmlns:a16="http://schemas.microsoft.com/office/drawing/2014/main" id="{74392B62-F536-4E6E-97A4-6BA319C29303}"/>
+                <a16:creationId xmlns:a16="http://schemas.microsoft.com/office/drawing/2014/main" id="{E13DE85A-0865-4785-81B0-B1743A787651}"/>
               </a:ext>
             </a:extLst>
           </p:cNvPr>
@@ -2208,7 +2208,7 @@
           <p:cNvPr id="15" name="">
             <a:extLst xmlns:a="http://schemas.openxmlformats.org/drawingml/2006/main">
               <a:ext uri="{FF2B5EF4-FFF2-40B4-BE49-F238E27FC236}">
-                <a16:creationId xmlns:a16="http://schemas.microsoft.com/office/drawing/2014/main" id="{EC4333BD-1323-4D2E-9CF9-D2182C61D981}"/>
+                <a16:creationId xmlns:a16="http://schemas.microsoft.com/office/drawing/2014/main" id="{2F6688A9-0E7E-4D36-B708-F22297B2D9FC}"/>
               </a:ext>
             </a:extLst>
           </p:cNvPr>
@@ -2272,7 +2272,7 @@
           <p:cNvPr id="16" name="">
             <a:extLst xmlns:a="http://schemas.openxmlformats.org/drawingml/2006/main">
               <a:ext uri="{FF2B5EF4-FFF2-40B4-BE49-F238E27FC236}">
-                <a16:creationId xmlns:a16="http://schemas.microsoft.com/office/drawing/2014/main" id="{92021084-656F-4313-A3AD-D8F26252826B}"/>
+                <a16:creationId xmlns:a16="http://schemas.microsoft.com/office/drawing/2014/main" id="{0ED77FB6-66D2-4F85-8A0D-8A5924EA5C57}"/>
               </a:ext>
             </a:extLst>
           </p:cNvPr>
@@ -2307,7 +2307,7 @@
           <p:cNvPr id="17" name="">
             <a:extLst xmlns:a="http://schemas.openxmlformats.org/drawingml/2006/main">
               <a:ext uri="{FF2B5EF4-FFF2-40B4-BE49-F238E27FC236}">
-                <a16:creationId xmlns:a16="http://schemas.microsoft.com/office/drawing/2014/main" id="{7A72307C-8132-4FA8-B081-E0EF3CECF22A}"/>
+                <a16:creationId xmlns:a16="http://schemas.microsoft.com/office/drawing/2014/main" id="{F936987D-414B-4658-8FE0-5114A889EBB4}"/>
               </a:ext>
             </a:extLst>
           </p:cNvPr>
@@ -2371,7 +2371,7 @@
           <p:cNvPr id="18" name="">
             <a:extLst xmlns:a="http://schemas.openxmlformats.org/drawingml/2006/main">
               <a:ext uri="{FF2B5EF4-FFF2-40B4-BE49-F238E27FC236}">
-                <a16:creationId xmlns:a16="http://schemas.microsoft.com/office/drawing/2014/main" id="{FADF4821-C547-496C-86D2-1ADC293DADD2}"/>
+                <a16:creationId xmlns:a16="http://schemas.microsoft.com/office/drawing/2014/main" id="{FA65987C-A073-4274-ACED-A1BB8BB50097}"/>
               </a:ext>
             </a:extLst>
           </p:cNvPr>
@@ -2435,7 +2435,7 @@
           <p:cNvPr id="19" name="">
             <a:extLst xmlns:a="http://schemas.openxmlformats.org/drawingml/2006/main">
               <a:ext uri="{FF2B5EF4-FFF2-40B4-BE49-F238E27FC236}">
-                <a16:creationId xmlns:a16="http://schemas.microsoft.com/office/drawing/2014/main" id="{E0FCAEB3-CA22-43F3-B806-B150A946E50A}"/>
+                <a16:creationId xmlns:a16="http://schemas.microsoft.com/office/drawing/2014/main" id="{A12C15E4-1F87-4589-BC3C-4EF6C31333B3}"/>
               </a:ext>
             </a:extLst>
           </p:cNvPr>
@@ -2499,7 +2499,7 @@
           <p:cNvPr id="20" name="">
             <a:extLst xmlns:a="http://schemas.openxmlformats.org/drawingml/2006/main">
               <a:ext uri="{FF2B5EF4-FFF2-40B4-BE49-F238E27FC236}">
-                <a16:creationId xmlns:a16="http://schemas.microsoft.com/office/drawing/2014/main" id="{FB7AD0EA-1555-4769-BEC0-32053DCF8DA1}"/>
+                <a16:creationId xmlns:a16="http://schemas.microsoft.com/office/drawing/2014/main" id="{4AC4B596-7EA2-4FF3-9532-7ED6CF214233}"/>
               </a:ext>
             </a:extLst>
           </p:cNvPr>
@@ -2655,7 +2655,7 @@
           <p:cNvPr id="21" name="">
             <a:extLst xmlns:a="http://schemas.openxmlformats.org/drawingml/2006/main">
               <a:ext uri="{FF2B5EF4-FFF2-40B4-BE49-F238E27FC236}">
-                <a16:creationId xmlns:a16="http://schemas.microsoft.com/office/drawing/2014/main" id="{F68923E0-7D65-48A1-B494-4BD6229AFCCE}"/>
+                <a16:creationId xmlns:a16="http://schemas.microsoft.com/office/drawing/2014/main" id="{6BFF9D84-3B53-433F-A036-94B76CA29A79}"/>
               </a:ext>
             </a:extLst>
           </p:cNvPr>
@@ -2719,7 +2719,7 @@
           <p:cNvPr id="22" name="">
             <a:extLst xmlns:a="http://schemas.openxmlformats.org/drawingml/2006/main">
               <a:ext uri="{FF2B5EF4-FFF2-40B4-BE49-F238E27FC236}">
-                <a16:creationId xmlns:a16="http://schemas.microsoft.com/office/drawing/2014/main" id="{9A2E809E-DBE0-4F34-9A80-94C8967E26BC}"/>
+                <a16:creationId xmlns:a16="http://schemas.microsoft.com/office/drawing/2014/main" id="{439B5598-4221-4E38-9CEF-1DF63FB403C1}"/>
               </a:ext>
             </a:extLst>
           </p:cNvPr>
@@ -2781,7 +2781,7 @@
     </p:spTree>
     <p:extLst>
       <p:ext uri="{BB962C8B-B14F-4D97-AF65-F5344CB8AC3E}">
-        <p14:creationId xmlns:p14="http://schemas.microsoft.com/office/powerpoint/2010/main" val="671481967"/>
+        <p14:creationId xmlns:p14="http://schemas.microsoft.com/office/powerpoint/2010/main" val="2107187446"/>
       </p:ext>
     </p:extLst>
   </p:cSld>
@@ -2805,7 +2805,7 @@
           <p:cNvPr id="1" name="">
             <a:extLst xmlns:a="http://schemas.openxmlformats.org/drawingml/2006/main">
               <a:ext uri="{FF2B5EF4-FFF2-40B4-BE49-F238E27FC236}">
-                <a16:creationId xmlns:a16="http://schemas.microsoft.com/office/drawing/2014/main" id="{850F4B17-CD49-4C89-A5D9-7F1BB0EA3446}"/>
+                <a16:creationId xmlns:a16="http://schemas.microsoft.com/office/drawing/2014/main" id="{348EB53D-4B37-479F-A477-F1C3A14653B9}"/>
               </a:ext>
             </a:extLst>
           </p:cNvPr>
@@ -2840,7 +2840,7 @@
           <p:cNvPr id="2" name="">
             <a:extLst xmlns:a="http://schemas.openxmlformats.org/drawingml/2006/main">
               <a:ext uri="{FF2B5EF4-FFF2-40B4-BE49-F238E27FC236}">
-                <a16:creationId xmlns:a16="http://schemas.microsoft.com/office/drawing/2014/main" id="{A742BDDD-4BD5-4113-BF88-FF78467409B1}"/>
+                <a16:creationId xmlns:a16="http://schemas.microsoft.com/office/drawing/2014/main" id="{1DAC4F58-0E08-4CF3-AB02-46EE2D420E34}"/>
               </a:ext>
             </a:extLst>
           </p:cNvPr>
@@ -2875,7 +2875,7 @@
           <p:cNvPr id="3" name="">
             <a:extLst xmlns:a="http://schemas.openxmlformats.org/drawingml/2006/main">
               <a:ext uri="{FF2B5EF4-FFF2-40B4-BE49-F238E27FC236}">
-                <a16:creationId xmlns:a16="http://schemas.microsoft.com/office/drawing/2014/main" id="{03EF8E79-9533-41B0-842E-3859180DF01E}"/>
+                <a16:creationId xmlns:a16="http://schemas.microsoft.com/office/drawing/2014/main" id="{A3A9D4CC-976D-4419-B9B0-A994C6E74993}"/>
               </a:ext>
             </a:extLst>
           </p:cNvPr>
@@ -2939,7 +2939,7 @@
           <p:cNvPr id="4" name="">
             <a:extLst xmlns:a="http://schemas.openxmlformats.org/drawingml/2006/main">
               <a:ext uri="{FF2B5EF4-FFF2-40B4-BE49-F238E27FC236}">
-                <a16:creationId xmlns:a16="http://schemas.microsoft.com/office/drawing/2014/main" id="{13457F3D-5C07-43C3-A208-198F09D03822}"/>
+                <a16:creationId xmlns:a16="http://schemas.microsoft.com/office/drawing/2014/main" id="{BBA13743-1DEB-4235-BC42-2BEA519DA002}"/>
               </a:ext>
             </a:extLst>
           </p:cNvPr>
@@ -3003,7 +3003,7 @@
           <p:cNvPr id="5" name="">
             <a:extLst xmlns:a="http://schemas.openxmlformats.org/drawingml/2006/main">
               <a:ext uri="{FF2B5EF4-FFF2-40B4-BE49-F238E27FC236}">
-                <a16:creationId xmlns:a16="http://schemas.microsoft.com/office/drawing/2014/main" id="{265573CB-9E5B-411F-A179-6AB79A792174}"/>
+                <a16:creationId xmlns:a16="http://schemas.microsoft.com/office/drawing/2014/main" id="{541ECFCF-975C-4177-807A-F2A8B244B263}"/>
               </a:ext>
             </a:extLst>
           </p:cNvPr>
@@ -3067,7 +3067,7 @@
           <p:cNvPr id="6" name="">
             <a:extLst xmlns:a="http://schemas.openxmlformats.org/drawingml/2006/main">
               <a:ext uri="{FF2B5EF4-FFF2-40B4-BE49-F238E27FC236}">
-                <a16:creationId xmlns:a16="http://schemas.microsoft.com/office/drawing/2014/main" id="{906D2196-DD1C-42EB-885C-813216A30EBD}"/>
+                <a16:creationId xmlns:a16="http://schemas.microsoft.com/office/drawing/2014/main" id="{A2307B97-ED44-4883-A823-607706CAA542}"/>
               </a:ext>
             </a:extLst>
           </p:cNvPr>
@@ -3131,7 +3131,7 @@
           <p:cNvPr id="7" name="">
             <a:extLst xmlns:a="http://schemas.openxmlformats.org/drawingml/2006/main">
               <a:ext uri="{FF2B5EF4-FFF2-40B4-BE49-F238E27FC236}">
-                <a16:creationId xmlns:a16="http://schemas.microsoft.com/office/drawing/2014/main" id="{9CFAEA53-117D-4B4D-A096-50756B7A45B9}"/>
+                <a16:creationId xmlns:a16="http://schemas.microsoft.com/office/drawing/2014/main" id="{A4DEBC5E-AEC9-4274-8392-6DFF38CD220D}"/>
               </a:ext>
             </a:extLst>
           </p:cNvPr>
@@ -3164,7 +3164,7 @@
           <p:cNvPr id="8" name="">
             <a:extLst xmlns:a="http://schemas.openxmlformats.org/drawingml/2006/main">
               <a:ext uri="{FF2B5EF4-FFF2-40B4-BE49-F238E27FC236}">
-                <a16:creationId xmlns:a16="http://schemas.microsoft.com/office/drawing/2014/main" id="{A36861D6-947B-4A7D-91C4-80EE92F60A0E}"/>
+                <a16:creationId xmlns:a16="http://schemas.microsoft.com/office/drawing/2014/main" id="{BF9AEA9D-165B-4882-BFE2-0CCEBFF7527F}"/>
               </a:ext>
             </a:extLst>
           </p:cNvPr>
@@ -3228,7 +3228,7 @@
           <p:cNvPr id="9" name="">
             <a:extLst xmlns:a="http://schemas.openxmlformats.org/drawingml/2006/main">
               <a:ext uri="{FF2B5EF4-FFF2-40B4-BE49-F238E27FC236}">
-                <a16:creationId xmlns:a16="http://schemas.microsoft.com/office/drawing/2014/main" id="{3FB82E01-D2F5-476A-86BE-A06A76BBDB45}"/>
+                <a16:creationId xmlns:a16="http://schemas.microsoft.com/office/drawing/2014/main" id="{64D3D996-DFAC-4C65-99D9-2C0611B21205}"/>
               </a:ext>
             </a:extLst>
           </p:cNvPr>
@@ -3282,7 +3282,7 @@
                 <a:ea typeface="Aptos"/>
                 <a:cs typeface="Aptos"/>
               </a:rPr>
-              <a:t>Rural families and cooperatives that need low-cost, resilient protein production.</a:t>
+              <a:t>Rural families and cooperatives where farm Wi-Fi, cloud access, and grid electricity cannot be assumed.</a:t>
             </a:r>
           </a:p>
         </p:txBody>
@@ -3292,7 +3292,7 @@
           <p:cNvPr id="10" name="">
             <a:extLst xmlns:a="http://schemas.openxmlformats.org/drawingml/2006/main">
               <a:ext uri="{FF2B5EF4-FFF2-40B4-BE49-F238E27FC236}">
-                <a16:creationId xmlns:a16="http://schemas.microsoft.com/office/drawing/2014/main" id="{14CB26CE-C061-4B53-AE48-EC871685599C}"/>
+                <a16:creationId xmlns:a16="http://schemas.microsoft.com/office/drawing/2014/main" id="{C4BF2D9B-34CC-4E0D-9AC0-668D7C86D5A9}"/>
               </a:ext>
             </a:extLst>
           </p:cNvPr>
@@ -3325,7 +3325,7 @@
           <p:cNvPr id="11" name="">
             <a:extLst xmlns:a="http://schemas.openxmlformats.org/drawingml/2006/main">
               <a:ext uri="{FF2B5EF4-FFF2-40B4-BE49-F238E27FC236}">
-                <a16:creationId xmlns:a16="http://schemas.microsoft.com/office/drawing/2014/main" id="{E7EC7D87-AF82-4E1F-8229-8EFA069B4ECE}"/>
+                <a16:creationId xmlns:a16="http://schemas.microsoft.com/office/drawing/2014/main" id="{6692B4E5-0092-45FB-942B-318F6EB2C518}"/>
               </a:ext>
             </a:extLst>
           </p:cNvPr>
@@ -3389,7 +3389,7 @@
           <p:cNvPr id="12" name="">
             <a:extLst xmlns:a="http://schemas.openxmlformats.org/drawingml/2006/main">
               <a:ext uri="{FF2B5EF4-FFF2-40B4-BE49-F238E27FC236}">
-                <a16:creationId xmlns:a16="http://schemas.microsoft.com/office/drawing/2014/main" id="{EE7E6B52-F9D5-4629-92C7-FD07BFC488F2}"/>
+                <a16:creationId xmlns:a16="http://schemas.microsoft.com/office/drawing/2014/main" id="{D2397EBC-4EFF-4B9B-A701-5DF249D15055}"/>
               </a:ext>
             </a:extLst>
           </p:cNvPr>
@@ -3443,7 +3443,7 @@
                 <a:ea typeface="Aptos"/>
                 <a:cs typeface="Aptos"/>
               </a:rPr>
-              <a:t>Real Sagents/Horde failover, physical DECT NR+ proof, physics verifier, RLVR scoring, resumable HITL, and offline Gemma 4.</a:t>
+              <a:t>Private DECT NR+ field transport, self-hosted Gemma, physics verifier, RLVR, resumable HITL, and real Sagents/Horde failover.</a:t>
             </a:r>
           </a:p>
         </p:txBody>
@@ -3453,7 +3453,7 @@
           <p:cNvPr id="13" name="">
             <a:extLst xmlns:a="http://schemas.openxmlformats.org/drawingml/2006/main">
               <a:ext uri="{FF2B5EF4-FFF2-40B4-BE49-F238E27FC236}">
-                <a16:creationId xmlns:a16="http://schemas.microsoft.com/office/drawing/2014/main" id="{1906E168-93EC-45B5-88C9-F6057175EC01}"/>
+                <a16:creationId xmlns:a16="http://schemas.microsoft.com/office/drawing/2014/main" id="{3A634005-FE98-4B52-B221-7BC3AE0079CE}"/>
               </a:ext>
             </a:extLst>
           </p:cNvPr>
@@ -3486,7 +3486,7 @@
           <p:cNvPr id="14" name="">
             <a:extLst xmlns:a="http://schemas.openxmlformats.org/drawingml/2006/main">
               <a:ext uri="{FF2B5EF4-FFF2-40B4-BE49-F238E27FC236}">
-                <a16:creationId xmlns:a16="http://schemas.microsoft.com/office/drawing/2014/main" id="{47BFAE8E-CA89-4427-A5D9-6B32A4CF7FD9}"/>
+                <a16:creationId xmlns:a16="http://schemas.microsoft.com/office/drawing/2014/main" id="{D7185D18-E63F-474C-991A-15678D039E74}"/>
               </a:ext>
             </a:extLst>
           </p:cNvPr>
@@ -3550,7 +3550,7 @@
           <p:cNvPr id="15" name="">
             <a:extLst xmlns:a="http://schemas.openxmlformats.org/drawingml/2006/main">
               <a:ext uri="{FF2B5EF4-FFF2-40B4-BE49-F238E27FC236}">
-                <a16:creationId xmlns:a16="http://schemas.microsoft.com/office/drawing/2014/main" id="{981D0578-4E23-4074-BA84-F2EF53345F12}"/>
+                <a16:creationId xmlns:a16="http://schemas.microsoft.com/office/drawing/2014/main" id="{917727B0-CB66-4C0F-99B7-FB2615A29B68}"/>
               </a:ext>
             </a:extLst>
           </p:cNvPr>
@@ -3604,7 +3604,7 @@
                 <a:ea typeface="Aptos"/>
                 <a:cs typeface="Aptos"/>
               </a:rPr>
-              <a:t>Docker app, local Gemma E2B, five-agent loop, producer approval, and validated software plus hardware evidence packets.</a:t>
+              <a:t>Docker app, local Gemma E2B, five-agent loop, producer approval, and proven radio evidence with honest solar/sensor milestones.</a:t>
             </a:r>
           </a:p>
         </p:txBody>
@@ -3614,7 +3614,7 @@
           <p:cNvPr id="16" name="">
             <a:extLst xmlns:a="http://schemas.openxmlformats.org/drawingml/2006/main">
               <a:ext uri="{FF2B5EF4-FFF2-40B4-BE49-F238E27FC236}">
-                <a16:creationId xmlns:a16="http://schemas.microsoft.com/office/drawing/2014/main" id="{56ECC787-3159-4801-B0CA-614BF993D18F}"/>
+                <a16:creationId xmlns:a16="http://schemas.microsoft.com/office/drawing/2014/main" id="{67F3D63A-5D74-4BDC-A252-BB0B8D4C0AFD}"/>
               </a:ext>
             </a:extLst>
           </p:cNvPr>
@@ -3678,7 +3678,7 @@
           <p:cNvPr id="17" name="">
             <a:extLst xmlns:a="http://schemas.openxmlformats.org/drawingml/2006/main">
               <a:ext uri="{FF2B5EF4-FFF2-40B4-BE49-F238E27FC236}">
-                <a16:creationId xmlns:a16="http://schemas.microsoft.com/office/drawing/2014/main" id="{2F5B6825-6901-4AF1-807C-F2B3E741D154}"/>
+                <a16:creationId xmlns:a16="http://schemas.microsoft.com/office/drawing/2014/main" id="{18EEF3E1-2A79-4C72-8694-06E01F943A9B}"/>
               </a:ext>
             </a:extLst>
           </p:cNvPr>
@@ -3742,7 +3742,7 @@
           <p:cNvPr id="18" name="">
             <a:extLst xmlns:a="http://schemas.openxmlformats.org/drawingml/2006/main">
               <a:ext uri="{FF2B5EF4-FFF2-40B4-BE49-F238E27FC236}">
-                <a16:creationId xmlns:a16="http://schemas.microsoft.com/office/drawing/2014/main" id="{021443F2-E7F7-41CF-BDF3-F15C86ABAE87}"/>
+                <a16:creationId xmlns:a16="http://schemas.microsoft.com/office/drawing/2014/main" id="{496B9955-79A1-4116-AB53-7D1738A5505F}"/>
               </a:ext>
             </a:extLst>
           </p:cNvPr>
@@ -3804,7 +3804,7 @@
     </p:spTree>
     <p:extLst>
       <p:ext uri="{BB962C8B-B14F-4D97-AF65-F5344CB8AC3E}">
-        <p14:creationId xmlns:p14="http://schemas.microsoft.com/office/powerpoint/2010/main" val="1928399479"/>
+        <p14:creationId xmlns:p14="http://schemas.microsoft.com/office/powerpoint/2010/main" val="446718710"/>
       </p:ext>
     </p:extLst>
   </p:cSld>
@@ -3828,7 +3828,7 @@
           <p:cNvPr id="1" name="">
             <a:extLst xmlns:a="http://schemas.openxmlformats.org/drawingml/2006/main">
               <a:ext uri="{FF2B5EF4-FFF2-40B4-BE49-F238E27FC236}">
-                <a16:creationId xmlns:a16="http://schemas.microsoft.com/office/drawing/2014/main" id="{B18126B4-C6BA-4C8C-9FFD-7B72B831D2C7}"/>
+                <a16:creationId xmlns:a16="http://schemas.microsoft.com/office/drawing/2014/main" id="{BB5ADE9D-7D0E-4E0B-B959-59217D9E3FE0}"/>
               </a:ext>
             </a:extLst>
           </p:cNvPr>
@@ -3863,7 +3863,7 @@
           <p:cNvPr id="2" name="">
             <a:extLst xmlns:a="http://schemas.openxmlformats.org/drawingml/2006/main">
               <a:ext uri="{FF2B5EF4-FFF2-40B4-BE49-F238E27FC236}">
-                <a16:creationId xmlns:a16="http://schemas.microsoft.com/office/drawing/2014/main" id="{959A74E6-0154-4C23-9167-099A212B8D66}"/>
+                <a16:creationId xmlns:a16="http://schemas.microsoft.com/office/drawing/2014/main" id="{0760191B-B0ED-4443-83CC-8C48AE20C655}"/>
               </a:ext>
             </a:extLst>
           </p:cNvPr>
@@ -3898,7 +3898,7 @@
           <p:cNvPr id="3" name="">
             <a:extLst xmlns:a="http://schemas.openxmlformats.org/drawingml/2006/main">
               <a:ext uri="{FF2B5EF4-FFF2-40B4-BE49-F238E27FC236}">
-                <a16:creationId xmlns:a16="http://schemas.microsoft.com/office/drawing/2014/main" id="{A612AA9B-0224-4814-9786-5F75112A681B}"/>
+                <a16:creationId xmlns:a16="http://schemas.microsoft.com/office/drawing/2014/main" id="{2C9270E1-F541-4B87-81C5-E4E5CF08BEE5}"/>
               </a:ext>
             </a:extLst>
           </p:cNvPr>
@@ -3962,7 +3962,7 @@
           <p:cNvPr id="4" name="">
             <a:extLst xmlns:a="http://schemas.openxmlformats.org/drawingml/2006/main">
               <a:ext uri="{FF2B5EF4-FFF2-40B4-BE49-F238E27FC236}">
-                <a16:creationId xmlns:a16="http://schemas.microsoft.com/office/drawing/2014/main" id="{1339F461-85E2-4627-A95D-A0EA7C71D064}"/>
+                <a16:creationId xmlns:a16="http://schemas.microsoft.com/office/drawing/2014/main" id="{8B5EDE10-5D84-46E5-BF27-95111C73B55F}"/>
               </a:ext>
             </a:extLst>
           </p:cNvPr>
@@ -4026,7 +4026,7 @@
           <p:cNvPr id="5" name="">
             <a:extLst xmlns:a="http://schemas.openxmlformats.org/drawingml/2006/main">
               <a:ext uri="{FF2B5EF4-FFF2-40B4-BE49-F238E27FC236}">
-                <a16:creationId xmlns:a16="http://schemas.microsoft.com/office/drawing/2014/main" id="{D2C5607A-1473-4FE6-B95B-7B0B070541B8}"/>
+                <a16:creationId xmlns:a16="http://schemas.microsoft.com/office/drawing/2014/main" id="{E09B6843-B327-4216-9331-E3CE6221F7C7}"/>
               </a:ext>
             </a:extLst>
           </p:cNvPr>
@@ -4090,7 +4090,7 @@
           <p:cNvPr id="6" name="">
             <a:extLst xmlns:a="http://schemas.openxmlformats.org/drawingml/2006/main">
               <a:ext uri="{FF2B5EF4-FFF2-40B4-BE49-F238E27FC236}">
-                <a16:creationId xmlns:a16="http://schemas.microsoft.com/office/drawing/2014/main" id="{59A24D53-7C87-4B63-8814-0E007E1D2747}"/>
+                <a16:creationId xmlns:a16="http://schemas.microsoft.com/office/drawing/2014/main" id="{EB32D92D-BEE4-4932-8473-29EFE82F9D3D}"/>
               </a:ext>
             </a:extLst>
           </p:cNvPr>
@@ -4154,7 +4154,7 @@
           <p:cNvPr id="7" name="">
             <a:extLst xmlns:a="http://schemas.openxmlformats.org/drawingml/2006/main">
               <a:ext uri="{FF2B5EF4-FFF2-40B4-BE49-F238E27FC236}">
-                <a16:creationId xmlns:a16="http://schemas.microsoft.com/office/drawing/2014/main" id="{82366F36-1220-4E1C-99FA-B35FE5DECA7A}"/>
+                <a16:creationId xmlns:a16="http://schemas.microsoft.com/office/drawing/2014/main" id="{C867C521-5BE1-453E-8741-DD264245BAC9}"/>
               </a:ext>
             </a:extLst>
           </p:cNvPr>
@@ -4187,7 +4187,7 @@
           <p:cNvPr id="8" name="">
             <a:extLst xmlns:a="http://schemas.openxmlformats.org/drawingml/2006/main">
               <a:ext uri="{FF2B5EF4-FFF2-40B4-BE49-F238E27FC236}">
-                <a16:creationId xmlns:a16="http://schemas.microsoft.com/office/drawing/2014/main" id="{72013DAE-275F-40A7-B5F8-2F26F128EC04}"/>
+                <a16:creationId xmlns:a16="http://schemas.microsoft.com/office/drawing/2014/main" id="{8A7AAA79-7637-4046-A249-6A4E707A7811}"/>
               </a:ext>
             </a:extLst>
           </p:cNvPr>
@@ -4251,7 +4251,7 @@
           <p:cNvPr id="9" name="">
             <a:extLst xmlns:a="http://schemas.openxmlformats.org/drawingml/2006/main">
               <a:ext uri="{FF2B5EF4-FFF2-40B4-BE49-F238E27FC236}">
-                <a16:creationId xmlns:a16="http://schemas.microsoft.com/office/drawing/2014/main" id="{91815B99-B42F-4FD8-9BBF-44C41CE814CD}"/>
+                <a16:creationId xmlns:a16="http://schemas.microsoft.com/office/drawing/2014/main" id="{25EAABC7-9A88-4DBD-B61A-12545323617B}"/>
               </a:ext>
             </a:extLst>
           </p:cNvPr>
@@ -4315,7 +4315,7 @@
           <p:cNvPr id="10" name="">
             <a:extLst xmlns:a="http://schemas.openxmlformats.org/drawingml/2006/main">
               <a:ext uri="{FF2B5EF4-FFF2-40B4-BE49-F238E27FC236}">
-                <a16:creationId xmlns:a16="http://schemas.microsoft.com/office/drawing/2014/main" id="{27125CBD-6272-4BDC-8C2D-0273A232E69F}"/>
+                <a16:creationId xmlns:a16="http://schemas.microsoft.com/office/drawing/2014/main" id="{3E8FDB82-3F9D-4E74-8567-D9485A7FD868}"/>
               </a:ext>
             </a:extLst>
           </p:cNvPr>
@@ -4348,7 +4348,7 @@
           <p:cNvPr id="11" name="">
             <a:extLst xmlns:a="http://schemas.openxmlformats.org/drawingml/2006/main">
               <a:ext uri="{FF2B5EF4-FFF2-40B4-BE49-F238E27FC236}">
-                <a16:creationId xmlns:a16="http://schemas.microsoft.com/office/drawing/2014/main" id="{974E1A06-0EC1-4470-BD84-056CDFC8D699}"/>
+                <a16:creationId xmlns:a16="http://schemas.microsoft.com/office/drawing/2014/main" id="{253AD833-CA23-45F3-9882-1157F2CF096C}"/>
               </a:ext>
             </a:extLst>
           </p:cNvPr>
@@ -4412,7 +4412,7 @@
           <p:cNvPr id="12" name="">
             <a:extLst xmlns:a="http://schemas.openxmlformats.org/drawingml/2006/main">
               <a:ext uri="{FF2B5EF4-FFF2-40B4-BE49-F238E27FC236}">
-                <a16:creationId xmlns:a16="http://schemas.microsoft.com/office/drawing/2014/main" id="{BA4031C8-080D-4E3F-A9A0-DC18C8A218D4}"/>
+                <a16:creationId xmlns:a16="http://schemas.microsoft.com/office/drawing/2014/main" id="{DFDC01CD-D450-430D-A669-1CA8D115F802}"/>
               </a:ext>
             </a:extLst>
           </p:cNvPr>
@@ -4476,7 +4476,7 @@
           <p:cNvPr id="13" name="">
             <a:extLst xmlns:a="http://schemas.openxmlformats.org/drawingml/2006/main">
               <a:ext uri="{FF2B5EF4-FFF2-40B4-BE49-F238E27FC236}">
-                <a16:creationId xmlns:a16="http://schemas.microsoft.com/office/drawing/2014/main" id="{A9B4C0F7-D156-4672-BDAD-EBE5706415DB}"/>
+                <a16:creationId xmlns:a16="http://schemas.microsoft.com/office/drawing/2014/main" id="{FF1AC919-9EE3-4D9D-9211-5EACAFB7EEB1}"/>
               </a:ext>
             </a:extLst>
           </p:cNvPr>
@@ -4509,7 +4509,7 @@
           <p:cNvPr id="14" name="">
             <a:extLst xmlns:a="http://schemas.openxmlformats.org/drawingml/2006/main">
               <a:ext uri="{FF2B5EF4-FFF2-40B4-BE49-F238E27FC236}">
-                <a16:creationId xmlns:a16="http://schemas.microsoft.com/office/drawing/2014/main" id="{784CC26C-AFAA-4B50-BF0A-04574204AC5C}"/>
+                <a16:creationId xmlns:a16="http://schemas.microsoft.com/office/drawing/2014/main" id="{8B33C232-47B6-4018-BF94-0990D186A5B2}"/>
               </a:ext>
             </a:extLst>
           </p:cNvPr>
@@ -4573,7 +4573,7 @@
           <p:cNvPr id="15" name="">
             <a:extLst xmlns:a="http://schemas.openxmlformats.org/drawingml/2006/main">
               <a:ext uri="{FF2B5EF4-FFF2-40B4-BE49-F238E27FC236}">
-                <a16:creationId xmlns:a16="http://schemas.microsoft.com/office/drawing/2014/main" id="{4E651764-335A-44F9-A62D-15139104B910}"/>
+                <a16:creationId xmlns:a16="http://schemas.microsoft.com/office/drawing/2014/main" id="{5C4B3979-6804-469B-BADB-74E5E654CF37}"/>
               </a:ext>
             </a:extLst>
           </p:cNvPr>
@@ -4637,7 +4637,7 @@
           <p:cNvPr id="16" name="">
             <a:extLst xmlns:a="http://schemas.openxmlformats.org/drawingml/2006/main">
               <a:ext uri="{FF2B5EF4-FFF2-40B4-BE49-F238E27FC236}">
-                <a16:creationId xmlns:a16="http://schemas.microsoft.com/office/drawing/2014/main" id="{53CAA8A4-5CEE-45B8-BA7B-46DEF2AED2A1}"/>
+                <a16:creationId xmlns:a16="http://schemas.microsoft.com/office/drawing/2014/main" id="{4F9F2F46-5449-4FAD-A235-590B566E58A1}"/>
               </a:ext>
             </a:extLst>
           </p:cNvPr>
@@ -4701,7 +4701,7 @@
           <p:cNvPr id="17" name="">
             <a:extLst xmlns:a="http://schemas.openxmlformats.org/drawingml/2006/main">
               <a:ext uri="{FF2B5EF4-FFF2-40B4-BE49-F238E27FC236}">
-                <a16:creationId xmlns:a16="http://schemas.microsoft.com/office/drawing/2014/main" id="{A1F6D6C0-849D-4628-A802-F04E0CC4DF4E}"/>
+                <a16:creationId xmlns:a16="http://schemas.microsoft.com/office/drawing/2014/main" id="{54C126F9-042F-4890-84E1-97449F7814F3}"/>
               </a:ext>
             </a:extLst>
           </p:cNvPr>
@@ -4763,7 +4763,7 @@
     </p:spTree>
     <p:extLst>
       <p:ext uri="{BB962C8B-B14F-4D97-AF65-F5344CB8AC3E}">
-        <p14:creationId xmlns:p14="http://schemas.microsoft.com/office/powerpoint/2010/main" val="706125872"/>
+        <p14:creationId xmlns:p14="http://schemas.microsoft.com/office/powerpoint/2010/main" val="1258315649"/>
       </p:ext>
     </p:extLst>
   </p:cSld>
@@ -4787,7 +4787,7 @@
           <p:cNvPr id="1" name="">
             <a:extLst xmlns:a="http://schemas.openxmlformats.org/drawingml/2006/main">
               <a:ext uri="{FF2B5EF4-FFF2-40B4-BE49-F238E27FC236}">
-                <a16:creationId xmlns:a16="http://schemas.microsoft.com/office/drawing/2014/main" id="{B0B86CB0-3C05-4EBB-AAAE-46CE067FE5B5}"/>
+                <a16:creationId xmlns:a16="http://schemas.microsoft.com/office/drawing/2014/main" id="{6E186F2C-1D39-4C7A-A0EE-A1DCCC0CDE1B}"/>
               </a:ext>
             </a:extLst>
           </p:cNvPr>
@@ -4822,7 +4822,7 @@
           <p:cNvPr id="2" name="">
             <a:extLst xmlns:a="http://schemas.openxmlformats.org/drawingml/2006/main">
               <a:ext uri="{FF2B5EF4-FFF2-40B4-BE49-F238E27FC236}">
-                <a16:creationId xmlns:a16="http://schemas.microsoft.com/office/drawing/2014/main" id="{98C86D4D-2B74-4AFA-B377-7BA4F2A020ED}"/>
+                <a16:creationId xmlns:a16="http://schemas.microsoft.com/office/drawing/2014/main" id="{07FA5761-D184-4109-9554-EAAA5A9B6A7A}"/>
               </a:ext>
             </a:extLst>
           </p:cNvPr>
@@ -4857,7 +4857,7 @@
           <p:cNvPr id="3" name="">
             <a:extLst xmlns:a="http://schemas.openxmlformats.org/drawingml/2006/main">
               <a:ext uri="{FF2B5EF4-FFF2-40B4-BE49-F238E27FC236}">
-                <a16:creationId xmlns:a16="http://schemas.microsoft.com/office/drawing/2014/main" id="{20F5013D-9836-4AD6-8A2A-E24F96996188}"/>
+                <a16:creationId xmlns:a16="http://schemas.microsoft.com/office/drawing/2014/main" id="{4D7FCFE1-9CB4-4CD0-953D-01ADDA6F5F55}"/>
               </a:ext>
             </a:extLst>
           </p:cNvPr>
@@ -4921,7 +4921,7 @@
           <p:cNvPr id="4" name="">
             <a:extLst xmlns:a="http://schemas.openxmlformats.org/drawingml/2006/main">
               <a:ext uri="{FF2B5EF4-FFF2-40B4-BE49-F238E27FC236}">
-                <a16:creationId xmlns:a16="http://schemas.microsoft.com/office/drawing/2014/main" id="{96DB5A11-FB43-47C1-B4AD-83BD3DFA6E60}"/>
+                <a16:creationId xmlns:a16="http://schemas.microsoft.com/office/drawing/2014/main" id="{A2F8593C-8D67-484A-96D8-51DE9BBFAA65}"/>
               </a:ext>
             </a:extLst>
           </p:cNvPr>
@@ -4985,7 +4985,7 @@
           <p:cNvPr id="5" name="">
             <a:extLst xmlns:a="http://schemas.openxmlformats.org/drawingml/2006/main">
               <a:ext uri="{FF2B5EF4-FFF2-40B4-BE49-F238E27FC236}">
-                <a16:creationId xmlns:a16="http://schemas.microsoft.com/office/drawing/2014/main" id="{30E841B9-C077-4510-80E4-12DF149D7C87}"/>
+                <a16:creationId xmlns:a16="http://schemas.microsoft.com/office/drawing/2014/main" id="{A87871A4-AFFD-48AA-92E6-D4080D0DFC5E}"/>
               </a:ext>
             </a:extLst>
           </p:cNvPr>
@@ -5049,7 +5049,7 @@
           <p:cNvPr id="6" name="">
             <a:extLst xmlns:a="http://schemas.openxmlformats.org/drawingml/2006/main">
               <a:ext uri="{FF2B5EF4-FFF2-40B4-BE49-F238E27FC236}">
-                <a16:creationId xmlns:a16="http://schemas.microsoft.com/office/drawing/2014/main" id="{1239B93D-8206-4ED4-B826-945ED578E5F1}"/>
+                <a16:creationId xmlns:a16="http://schemas.microsoft.com/office/drawing/2014/main" id="{B33D1CC0-5FBB-40D8-8BC4-E4ED2EE35524}"/>
               </a:ext>
             </a:extLst>
           </p:cNvPr>
@@ -5113,7 +5113,7 @@
           <p:cNvPr id="7" name="">
             <a:extLst xmlns:a="http://schemas.openxmlformats.org/drawingml/2006/main">
               <a:ext uri="{FF2B5EF4-FFF2-40B4-BE49-F238E27FC236}">
-                <a16:creationId xmlns:a16="http://schemas.microsoft.com/office/drawing/2014/main" id="{3CFB1CDD-883A-4DFB-9965-C0F6CD925A6A}"/>
+                <a16:creationId xmlns:a16="http://schemas.microsoft.com/office/drawing/2014/main" id="{DFEBCF20-30C9-46BE-9F4A-7E1E1EBAEBFD}"/>
               </a:ext>
             </a:extLst>
           </p:cNvPr>
@@ -5146,7 +5146,7 @@
           <p:cNvPr id="8" name="">
             <a:extLst xmlns:a="http://schemas.openxmlformats.org/drawingml/2006/main">
               <a:ext uri="{FF2B5EF4-FFF2-40B4-BE49-F238E27FC236}">
-                <a16:creationId xmlns:a16="http://schemas.microsoft.com/office/drawing/2014/main" id="{4EDB83C7-6FF2-4671-8DE7-3DD85D096CB3}"/>
+                <a16:creationId xmlns:a16="http://schemas.microsoft.com/office/drawing/2014/main" id="{D419DB1F-DE09-454E-BA50-A6AB5FF1A546}"/>
               </a:ext>
             </a:extLst>
           </p:cNvPr>
@@ -5210,7 +5210,7 @@
           <p:cNvPr id="9" name="">
             <a:extLst xmlns:a="http://schemas.openxmlformats.org/drawingml/2006/main">
               <a:ext uri="{FF2B5EF4-FFF2-40B4-BE49-F238E27FC236}">
-                <a16:creationId xmlns:a16="http://schemas.microsoft.com/office/drawing/2014/main" id="{F4B4AC52-82B1-478E-90D8-B27231118E5D}"/>
+                <a16:creationId xmlns:a16="http://schemas.microsoft.com/office/drawing/2014/main" id="{E7E48685-3F43-471D-A1AF-484FF84A7EFE}"/>
               </a:ext>
             </a:extLst>
           </p:cNvPr>
@@ -5274,7 +5274,7 @@
           <p:cNvPr id="10" name="">
             <a:extLst xmlns:a="http://schemas.openxmlformats.org/drawingml/2006/main">
               <a:ext uri="{FF2B5EF4-FFF2-40B4-BE49-F238E27FC236}">
-                <a16:creationId xmlns:a16="http://schemas.microsoft.com/office/drawing/2014/main" id="{8103C4A8-8B2E-4CD8-9B65-9379DCF18834}"/>
+                <a16:creationId xmlns:a16="http://schemas.microsoft.com/office/drawing/2014/main" id="{6C52964F-28B5-44E0-8F2A-59FBE8F40D9E}"/>
               </a:ext>
             </a:extLst>
           </p:cNvPr>
@@ -5338,7 +5338,7 @@
           <p:cNvPr id="11" name="">
             <a:extLst xmlns:a="http://schemas.openxmlformats.org/drawingml/2006/main">
               <a:ext uri="{FF2B5EF4-FFF2-40B4-BE49-F238E27FC236}">
-                <a16:creationId xmlns:a16="http://schemas.microsoft.com/office/drawing/2014/main" id="{457A95D1-FB9F-431C-8D3B-5AC9118171F7}"/>
+                <a16:creationId xmlns:a16="http://schemas.microsoft.com/office/drawing/2014/main" id="{C2C6AE59-14AE-48A8-8BDB-42C435697512}"/>
               </a:ext>
             </a:extLst>
           </p:cNvPr>
@@ -5371,7 +5371,7 @@
           <p:cNvPr id="12" name="">
             <a:extLst xmlns:a="http://schemas.openxmlformats.org/drawingml/2006/main">
               <a:ext uri="{FF2B5EF4-FFF2-40B4-BE49-F238E27FC236}">
-                <a16:creationId xmlns:a16="http://schemas.microsoft.com/office/drawing/2014/main" id="{EC8C835F-922F-40D2-A10E-812D4D33D7DC}"/>
+                <a16:creationId xmlns:a16="http://schemas.microsoft.com/office/drawing/2014/main" id="{FDDB2898-691D-4944-AFC9-12E0AB19B547}"/>
               </a:ext>
             </a:extLst>
           </p:cNvPr>
@@ -5435,7 +5435,7 @@
           <p:cNvPr id="13" name="">
             <a:extLst xmlns:a="http://schemas.openxmlformats.org/drawingml/2006/main">
               <a:ext uri="{FF2B5EF4-FFF2-40B4-BE49-F238E27FC236}">
-                <a16:creationId xmlns:a16="http://schemas.microsoft.com/office/drawing/2014/main" id="{C0079DF4-ABE9-4891-ABDC-FFB70FA9B5F8}"/>
+                <a16:creationId xmlns:a16="http://schemas.microsoft.com/office/drawing/2014/main" id="{3D873F18-E011-4D9B-B19E-14F40772DCD3}"/>
               </a:ext>
             </a:extLst>
           </p:cNvPr>
@@ -5499,7 +5499,7 @@
           <p:cNvPr id="14" name="">
             <a:extLst xmlns:a="http://schemas.openxmlformats.org/drawingml/2006/main">
               <a:ext uri="{FF2B5EF4-FFF2-40B4-BE49-F238E27FC236}">
-                <a16:creationId xmlns:a16="http://schemas.microsoft.com/office/drawing/2014/main" id="{DB36F4F9-8994-414D-A97A-AFEB1603991A}"/>
+                <a16:creationId xmlns:a16="http://schemas.microsoft.com/office/drawing/2014/main" id="{EF05F564-3C69-4278-94BB-9D4BD8B90090}"/>
               </a:ext>
             </a:extLst>
           </p:cNvPr>
@@ -5563,7 +5563,7 @@
           <p:cNvPr id="15" name="">
             <a:extLst xmlns:a="http://schemas.openxmlformats.org/drawingml/2006/main">
               <a:ext uri="{FF2B5EF4-FFF2-40B4-BE49-F238E27FC236}">
-                <a16:creationId xmlns:a16="http://schemas.microsoft.com/office/drawing/2014/main" id="{C8861518-F60D-4B5E-999E-438F5F0A36D5}"/>
+                <a16:creationId xmlns:a16="http://schemas.microsoft.com/office/drawing/2014/main" id="{2328B6D6-C1EF-4BD7-BEE5-D869705B7D65}"/>
               </a:ext>
             </a:extLst>
           </p:cNvPr>
@@ -5596,7 +5596,7 @@
           <p:cNvPr id="16" name="">
             <a:extLst xmlns:a="http://schemas.openxmlformats.org/drawingml/2006/main">
               <a:ext uri="{FF2B5EF4-FFF2-40B4-BE49-F238E27FC236}">
-                <a16:creationId xmlns:a16="http://schemas.microsoft.com/office/drawing/2014/main" id="{5E1A051E-9838-48A9-9B5B-FAE8AB348D81}"/>
+                <a16:creationId xmlns:a16="http://schemas.microsoft.com/office/drawing/2014/main" id="{A23F47A1-9658-41D4-AF18-3AF1F887DD05}"/>
               </a:ext>
             </a:extLst>
           </p:cNvPr>
@@ -5660,7 +5660,7 @@
           <p:cNvPr id="17" name="">
             <a:extLst xmlns:a="http://schemas.openxmlformats.org/drawingml/2006/main">
               <a:ext uri="{FF2B5EF4-FFF2-40B4-BE49-F238E27FC236}">
-                <a16:creationId xmlns:a16="http://schemas.microsoft.com/office/drawing/2014/main" id="{AD9E8758-E139-4208-BD47-DD452EF91288}"/>
+                <a16:creationId xmlns:a16="http://schemas.microsoft.com/office/drawing/2014/main" id="{E6E2348F-8F5B-4EF0-8DDA-2649BAEA9476}"/>
               </a:ext>
             </a:extLst>
           </p:cNvPr>
@@ -5724,7 +5724,7 @@
           <p:cNvPr id="18" name="">
             <a:extLst xmlns:a="http://schemas.openxmlformats.org/drawingml/2006/main">
               <a:ext uri="{FF2B5EF4-FFF2-40B4-BE49-F238E27FC236}">
-                <a16:creationId xmlns:a16="http://schemas.microsoft.com/office/drawing/2014/main" id="{EB0330E4-4C95-4C2C-8A37-2C780890D247}"/>
+                <a16:creationId xmlns:a16="http://schemas.microsoft.com/office/drawing/2014/main" id="{F66791E0-C6B3-49B2-B549-B4F80EAE3B13}"/>
               </a:ext>
             </a:extLst>
           </p:cNvPr>
@@ -5788,7 +5788,7 @@
           <p:cNvPr id="19" name="">
             <a:extLst xmlns:a="http://schemas.openxmlformats.org/drawingml/2006/main">
               <a:ext uri="{FF2B5EF4-FFF2-40B4-BE49-F238E27FC236}">
-                <a16:creationId xmlns:a16="http://schemas.microsoft.com/office/drawing/2014/main" id="{CC86E89D-A75E-4101-951C-82DD738083D2}"/>
+                <a16:creationId xmlns:a16="http://schemas.microsoft.com/office/drawing/2014/main" id="{D71C2ACB-04C1-4716-B221-ADC0E409E34C}"/>
               </a:ext>
             </a:extLst>
           </p:cNvPr>
@@ -5821,7 +5821,7 @@
           <p:cNvPr id="20" name="">
             <a:extLst xmlns:a="http://schemas.openxmlformats.org/drawingml/2006/main">
               <a:ext uri="{FF2B5EF4-FFF2-40B4-BE49-F238E27FC236}">
-                <a16:creationId xmlns:a16="http://schemas.microsoft.com/office/drawing/2014/main" id="{24F3C6E9-716E-4716-833B-1102353FA7C2}"/>
+                <a16:creationId xmlns:a16="http://schemas.microsoft.com/office/drawing/2014/main" id="{BE74E843-5A44-4C6E-836F-EF32056E8166}"/>
               </a:ext>
             </a:extLst>
           </p:cNvPr>
@@ -5885,7 +5885,7 @@
           <p:cNvPr id="21" name="">
             <a:extLst xmlns:a="http://schemas.openxmlformats.org/drawingml/2006/main">
               <a:ext uri="{FF2B5EF4-FFF2-40B4-BE49-F238E27FC236}">
-                <a16:creationId xmlns:a16="http://schemas.microsoft.com/office/drawing/2014/main" id="{DF3EA840-3B8A-4788-9997-87CBA56426CB}"/>
+                <a16:creationId xmlns:a16="http://schemas.microsoft.com/office/drawing/2014/main" id="{B0AB89C7-27D6-4FC6-8496-5F7C577AE1F3}"/>
               </a:ext>
             </a:extLst>
           </p:cNvPr>
@@ -5949,7 +5949,7 @@
           <p:cNvPr id="22" name="">
             <a:extLst xmlns:a="http://schemas.openxmlformats.org/drawingml/2006/main">
               <a:ext uri="{FF2B5EF4-FFF2-40B4-BE49-F238E27FC236}">
-                <a16:creationId xmlns:a16="http://schemas.microsoft.com/office/drawing/2014/main" id="{C7A692CE-84BE-4BAC-AA04-224CC106A52E}"/>
+                <a16:creationId xmlns:a16="http://schemas.microsoft.com/office/drawing/2014/main" id="{C17F273A-E082-4603-8BFC-67C3B66F214F}"/>
               </a:ext>
             </a:extLst>
           </p:cNvPr>
@@ -5982,7 +5982,7 @@
           <p:cNvPr id="23" name="">
             <a:extLst xmlns:a="http://schemas.openxmlformats.org/drawingml/2006/main">
               <a:ext uri="{FF2B5EF4-FFF2-40B4-BE49-F238E27FC236}">
-                <a16:creationId xmlns:a16="http://schemas.microsoft.com/office/drawing/2014/main" id="{1EA3A54E-C797-43D9-A765-904189FFB944}"/>
+                <a16:creationId xmlns:a16="http://schemas.microsoft.com/office/drawing/2014/main" id="{EC06A0AA-B047-43B5-BC61-3FBC40983977}"/>
               </a:ext>
             </a:extLst>
           </p:cNvPr>
@@ -6046,7 +6046,7 @@
           <p:cNvPr id="24" name="">
             <a:extLst xmlns:a="http://schemas.openxmlformats.org/drawingml/2006/main">
               <a:ext uri="{FF2B5EF4-FFF2-40B4-BE49-F238E27FC236}">
-                <a16:creationId xmlns:a16="http://schemas.microsoft.com/office/drawing/2014/main" id="{610C9658-57AB-46B6-93D2-DA9C79EACD5A}"/>
+                <a16:creationId xmlns:a16="http://schemas.microsoft.com/office/drawing/2014/main" id="{FDED0E5C-8988-4A3D-94BA-9AFCA9621035}"/>
               </a:ext>
             </a:extLst>
           </p:cNvPr>
@@ -6110,7 +6110,7 @@
           <p:cNvPr id="25" name="">
             <a:extLst xmlns:a="http://schemas.openxmlformats.org/drawingml/2006/main">
               <a:ext uri="{FF2B5EF4-FFF2-40B4-BE49-F238E27FC236}">
-                <a16:creationId xmlns:a16="http://schemas.microsoft.com/office/drawing/2014/main" id="{A2D78A40-70D2-4B86-A9AF-EE34DE8FA7AD}"/>
+                <a16:creationId xmlns:a16="http://schemas.microsoft.com/office/drawing/2014/main" id="{9E07B5EE-BEE0-4DFE-A00F-86583A3A23D1}"/>
               </a:ext>
             </a:extLst>
           </p:cNvPr>
@@ -6174,7 +6174,7 @@
           <p:cNvPr id="26" name="">
             <a:extLst xmlns:a="http://schemas.openxmlformats.org/drawingml/2006/main">
               <a:ext uri="{FF2B5EF4-FFF2-40B4-BE49-F238E27FC236}">
-                <a16:creationId xmlns:a16="http://schemas.microsoft.com/office/drawing/2014/main" id="{11FB3507-9CD8-4A43-B25E-AE169D89F180}"/>
+                <a16:creationId xmlns:a16="http://schemas.microsoft.com/office/drawing/2014/main" id="{7B133643-0B1C-4889-A126-E706124B5236}"/>
               </a:ext>
             </a:extLst>
           </p:cNvPr>
@@ -6236,7 +6236,7 @@
     </p:spTree>
     <p:extLst>
       <p:ext uri="{BB962C8B-B14F-4D97-AF65-F5344CB8AC3E}">
-        <p14:creationId xmlns:p14="http://schemas.microsoft.com/office/powerpoint/2010/main" val="1910141926"/>
+        <p14:creationId xmlns:p14="http://schemas.microsoft.com/office/powerpoint/2010/main" val="1179864289"/>
       </p:ext>
     </p:extLst>
   </p:cSld>
@@ -6260,7 +6260,7 @@
           <p:cNvPr id="1" name="">
             <a:extLst xmlns:a="http://schemas.openxmlformats.org/drawingml/2006/main">
               <a:ext uri="{FF2B5EF4-FFF2-40B4-BE49-F238E27FC236}">
-                <a16:creationId xmlns:a16="http://schemas.microsoft.com/office/drawing/2014/main" id="{6577F2C9-92A0-46E9-BBF0-F420626DACE5}"/>
+                <a16:creationId xmlns:a16="http://schemas.microsoft.com/office/drawing/2014/main" id="{53D36E14-08CD-4B65-8EAE-693D0D4BA66D}"/>
               </a:ext>
             </a:extLst>
           </p:cNvPr>
@@ -6295,7 +6295,7 @@
           <p:cNvPr id="2" name="">
             <a:extLst xmlns:a="http://schemas.openxmlformats.org/drawingml/2006/main">
               <a:ext uri="{FF2B5EF4-FFF2-40B4-BE49-F238E27FC236}">
-                <a16:creationId xmlns:a16="http://schemas.microsoft.com/office/drawing/2014/main" id="{CBC40A47-DFFC-4487-A52D-713DA60865D9}"/>
+                <a16:creationId xmlns:a16="http://schemas.microsoft.com/office/drawing/2014/main" id="{90D66469-7700-49AA-B64B-19380F34D0A4}"/>
               </a:ext>
             </a:extLst>
           </p:cNvPr>
@@ -6330,7 +6330,7 @@
           <p:cNvPr id="3" name="">
             <a:extLst xmlns:a="http://schemas.openxmlformats.org/drawingml/2006/main">
               <a:ext uri="{FF2B5EF4-FFF2-40B4-BE49-F238E27FC236}">
-                <a16:creationId xmlns:a16="http://schemas.microsoft.com/office/drawing/2014/main" id="{DD27CDC6-8FAE-44EA-B863-3B25F633FFA9}"/>
+                <a16:creationId xmlns:a16="http://schemas.microsoft.com/office/drawing/2014/main" id="{283EAE39-FBE2-46F2-B668-0A07E054720D}"/>
               </a:ext>
             </a:extLst>
           </p:cNvPr>
@@ -6394,7 +6394,7 @@
           <p:cNvPr id="4" name="">
             <a:extLst xmlns:a="http://schemas.openxmlformats.org/drawingml/2006/main">
               <a:ext uri="{FF2B5EF4-FFF2-40B4-BE49-F238E27FC236}">
-                <a16:creationId xmlns:a16="http://schemas.microsoft.com/office/drawing/2014/main" id="{E63F26FF-DA4D-4099-A819-9F7FE9939379}"/>
+                <a16:creationId xmlns:a16="http://schemas.microsoft.com/office/drawing/2014/main" id="{96D369F1-2243-469E-8E0B-3FDBC33739DA}"/>
               </a:ext>
             </a:extLst>
           </p:cNvPr>
@@ -6458,7 +6458,7 @@
           <p:cNvPr id="5" name="">
             <a:extLst xmlns:a="http://schemas.openxmlformats.org/drawingml/2006/main">
               <a:ext uri="{FF2B5EF4-FFF2-40B4-BE49-F238E27FC236}">
-                <a16:creationId xmlns:a16="http://schemas.microsoft.com/office/drawing/2014/main" id="{7DABDD03-82D8-4A5F-B2C1-660BC4693EB8}"/>
+                <a16:creationId xmlns:a16="http://schemas.microsoft.com/office/drawing/2014/main" id="{54468C1A-1020-4AB3-BED0-0FD6FF123F8C}"/>
               </a:ext>
             </a:extLst>
           </p:cNvPr>
@@ -6522,7 +6522,7 @@
           <p:cNvPr id="6" name="">
             <a:extLst xmlns:a="http://schemas.openxmlformats.org/drawingml/2006/main">
               <a:ext uri="{FF2B5EF4-FFF2-40B4-BE49-F238E27FC236}">
-                <a16:creationId xmlns:a16="http://schemas.microsoft.com/office/drawing/2014/main" id="{154C4713-B6D0-4A78-B20F-4FF96A3AA5DC}"/>
+                <a16:creationId xmlns:a16="http://schemas.microsoft.com/office/drawing/2014/main" id="{B4351BB2-B1D6-467C-A3B5-6D85C6518189}"/>
               </a:ext>
             </a:extLst>
           </p:cNvPr>
@@ -6586,7 +6586,7 @@
           <p:cNvPr id="7" name="">
             <a:extLst xmlns:a="http://schemas.openxmlformats.org/drawingml/2006/main">
               <a:ext uri="{FF2B5EF4-FFF2-40B4-BE49-F238E27FC236}">
-                <a16:creationId xmlns:a16="http://schemas.microsoft.com/office/drawing/2014/main" id="{2305C42C-1ECB-4041-A89B-C1A87EA03AF0}"/>
+                <a16:creationId xmlns:a16="http://schemas.microsoft.com/office/drawing/2014/main" id="{A3398F08-CEC7-43E4-8D2F-AF9FB60A1F43}"/>
               </a:ext>
             </a:extLst>
           </p:cNvPr>
@@ -6619,7 +6619,7 @@
           <p:cNvPr id="8" name="">
             <a:extLst xmlns:a="http://schemas.openxmlformats.org/drawingml/2006/main">
               <a:ext uri="{FF2B5EF4-FFF2-40B4-BE49-F238E27FC236}">
-                <a16:creationId xmlns:a16="http://schemas.microsoft.com/office/drawing/2014/main" id="{2413E95B-7941-4412-B112-D26D488ED1BA}"/>
+                <a16:creationId xmlns:a16="http://schemas.microsoft.com/office/drawing/2014/main" id="{E8C306F8-AE4F-48C6-8C75-9AD4AB40183C}"/>
               </a:ext>
             </a:extLst>
           </p:cNvPr>
@@ -6683,7 +6683,7 @@
           <p:cNvPr id="9" name="">
             <a:extLst xmlns:a="http://schemas.openxmlformats.org/drawingml/2006/main">
               <a:ext uri="{FF2B5EF4-FFF2-40B4-BE49-F238E27FC236}">
-                <a16:creationId xmlns:a16="http://schemas.microsoft.com/office/drawing/2014/main" id="{B3BCF77E-88C0-4758-956C-E203DDF764B5}"/>
+                <a16:creationId xmlns:a16="http://schemas.microsoft.com/office/drawing/2014/main" id="{D1AA245B-2AC1-4EDA-8598-B27E1FC36ADD}"/>
               </a:ext>
             </a:extLst>
           </p:cNvPr>
@@ -6747,7 +6747,7 @@
           <p:cNvPr id="10" name="">
             <a:extLst xmlns:a="http://schemas.openxmlformats.org/drawingml/2006/main">
               <a:ext uri="{FF2B5EF4-FFF2-40B4-BE49-F238E27FC236}">
-                <a16:creationId xmlns:a16="http://schemas.microsoft.com/office/drawing/2014/main" id="{DC204356-D0AF-46CB-88E0-1BC7868FC97E}"/>
+                <a16:creationId xmlns:a16="http://schemas.microsoft.com/office/drawing/2014/main" id="{F6DB869D-4050-4BEB-9335-5860F508E417}"/>
               </a:ext>
             </a:extLst>
           </p:cNvPr>
@@ -6811,7 +6811,7 @@
           <p:cNvPr id="11" name="">
             <a:extLst xmlns:a="http://schemas.openxmlformats.org/drawingml/2006/main">
               <a:ext uri="{FF2B5EF4-FFF2-40B4-BE49-F238E27FC236}">
-                <a16:creationId xmlns:a16="http://schemas.microsoft.com/office/drawing/2014/main" id="{36C4A67F-BD42-454C-86B6-39F3824AE13B}"/>
+                <a16:creationId xmlns:a16="http://schemas.microsoft.com/office/drawing/2014/main" id="{12A3BD12-20E4-42D7-A32E-BECCB6C7D150}"/>
               </a:ext>
             </a:extLst>
           </p:cNvPr>
@@ -6844,7 +6844,7 @@
           <p:cNvPr id="12" name="">
             <a:extLst xmlns:a="http://schemas.openxmlformats.org/drawingml/2006/main">
               <a:ext uri="{FF2B5EF4-FFF2-40B4-BE49-F238E27FC236}">
-                <a16:creationId xmlns:a16="http://schemas.microsoft.com/office/drawing/2014/main" id="{E75EFE26-9432-4F0F-9460-C9EBA51C123E}"/>
+                <a16:creationId xmlns:a16="http://schemas.microsoft.com/office/drawing/2014/main" id="{E6390743-532D-42D4-A2A0-EF1056809748}"/>
               </a:ext>
             </a:extLst>
           </p:cNvPr>
@@ -6908,7 +6908,7 @@
           <p:cNvPr id="13" name="">
             <a:extLst xmlns:a="http://schemas.openxmlformats.org/drawingml/2006/main">
               <a:ext uri="{FF2B5EF4-FFF2-40B4-BE49-F238E27FC236}">
-                <a16:creationId xmlns:a16="http://schemas.microsoft.com/office/drawing/2014/main" id="{8C94D59C-4CF5-4BC6-BFFC-16C489820780}"/>
+                <a16:creationId xmlns:a16="http://schemas.microsoft.com/office/drawing/2014/main" id="{DB2E974C-F63D-410D-B0F5-699CB1197CB4}"/>
               </a:ext>
             </a:extLst>
           </p:cNvPr>
@@ -6972,7 +6972,7 @@
           <p:cNvPr id="14" name="">
             <a:extLst xmlns:a="http://schemas.openxmlformats.org/drawingml/2006/main">
               <a:ext uri="{FF2B5EF4-FFF2-40B4-BE49-F238E27FC236}">
-                <a16:creationId xmlns:a16="http://schemas.microsoft.com/office/drawing/2014/main" id="{9E9A023E-5FCC-49D8-8CD4-A54A64DB7B78}"/>
+                <a16:creationId xmlns:a16="http://schemas.microsoft.com/office/drawing/2014/main" id="{225E1A15-71E9-4C94-AF7B-E2D5DF72E719}"/>
               </a:ext>
             </a:extLst>
           </p:cNvPr>
@@ -7036,7 +7036,7 @@
           <p:cNvPr id="15" name="">
             <a:extLst xmlns:a="http://schemas.openxmlformats.org/drawingml/2006/main">
               <a:ext uri="{FF2B5EF4-FFF2-40B4-BE49-F238E27FC236}">
-                <a16:creationId xmlns:a16="http://schemas.microsoft.com/office/drawing/2014/main" id="{C4487952-FB42-4532-B8E4-5C914B8254B7}"/>
+                <a16:creationId xmlns:a16="http://schemas.microsoft.com/office/drawing/2014/main" id="{6E41D6EF-93A3-4018-AAB0-EF54E62AE688}"/>
               </a:ext>
             </a:extLst>
           </p:cNvPr>
@@ -7069,7 +7069,7 @@
           <p:cNvPr id="16" name="">
             <a:extLst xmlns:a="http://schemas.openxmlformats.org/drawingml/2006/main">
               <a:ext uri="{FF2B5EF4-FFF2-40B4-BE49-F238E27FC236}">
-                <a16:creationId xmlns:a16="http://schemas.microsoft.com/office/drawing/2014/main" id="{67126A79-E1DF-4E9B-B377-FD6AF0992640}"/>
+                <a16:creationId xmlns:a16="http://schemas.microsoft.com/office/drawing/2014/main" id="{DA9E2D09-8411-41C4-A34B-724561EABF05}"/>
               </a:ext>
             </a:extLst>
           </p:cNvPr>
@@ -7133,7 +7133,7 @@
           <p:cNvPr id="17" name="">
             <a:extLst xmlns:a="http://schemas.openxmlformats.org/drawingml/2006/main">
               <a:ext uri="{FF2B5EF4-FFF2-40B4-BE49-F238E27FC236}">
-                <a16:creationId xmlns:a16="http://schemas.microsoft.com/office/drawing/2014/main" id="{116D9FA6-EBD3-42CE-8523-58D344A30D4F}"/>
+                <a16:creationId xmlns:a16="http://schemas.microsoft.com/office/drawing/2014/main" id="{78406D52-DDB0-4B23-BCB8-6618CB5702E3}"/>
               </a:ext>
             </a:extLst>
           </p:cNvPr>
@@ -7197,7 +7197,7 @@
           <p:cNvPr id="18" name="">
             <a:extLst xmlns:a="http://schemas.openxmlformats.org/drawingml/2006/main">
               <a:ext uri="{FF2B5EF4-FFF2-40B4-BE49-F238E27FC236}">
-                <a16:creationId xmlns:a16="http://schemas.microsoft.com/office/drawing/2014/main" id="{12227AB4-887A-440F-9469-C6E61570EEDC}"/>
+                <a16:creationId xmlns:a16="http://schemas.microsoft.com/office/drawing/2014/main" id="{477C2672-79AE-4A13-8BFF-BCABA1F98805}"/>
               </a:ext>
             </a:extLst>
           </p:cNvPr>
@@ -7261,7 +7261,7 @@
           <p:cNvPr id="19" name="">
             <a:extLst xmlns:a="http://schemas.openxmlformats.org/drawingml/2006/main">
               <a:ext uri="{FF2B5EF4-FFF2-40B4-BE49-F238E27FC236}">
-                <a16:creationId xmlns:a16="http://schemas.microsoft.com/office/drawing/2014/main" id="{B9505027-880C-4924-AD45-337A4FA87973}"/>
+                <a16:creationId xmlns:a16="http://schemas.microsoft.com/office/drawing/2014/main" id="{78CE9BFC-4F73-4568-A1E7-1AB29342AD08}"/>
               </a:ext>
             </a:extLst>
           </p:cNvPr>
@@ -7294,7 +7294,7 @@
           <p:cNvPr id="20" name="">
             <a:extLst xmlns:a="http://schemas.openxmlformats.org/drawingml/2006/main">
               <a:ext uri="{FF2B5EF4-FFF2-40B4-BE49-F238E27FC236}">
-                <a16:creationId xmlns:a16="http://schemas.microsoft.com/office/drawing/2014/main" id="{08C55C13-0BE1-451D-B0EA-6B4405976093}"/>
+                <a16:creationId xmlns:a16="http://schemas.microsoft.com/office/drawing/2014/main" id="{DBFFBC98-9AEC-4BEA-9EB0-F6E8231BDAF6}"/>
               </a:ext>
             </a:extLst>
           </p:cNvPr>
@@ -7358,7 +7358,7 @@
           <p:cNvPr id="21" name="">
             <a:extLst xmlns:a="http://schemas.openxmlformats.org/drawingml/2006/main">
               <a:ext uri="{FF2B5EF4-FFF2-40B4-BE49-F238E27FC236}">
-                <a16:creationId xmlns:a16="http://schemas.microsoft.com/office/drawing/2014/main" id="{1FFAE396-B015-4CA7-9CCD-10B16BF53338}"/>
+                <a16:creationId xmlns:a16="http://schemas.microsoft.com/office/drawing/2014/main" id="{38E694FE-C342-4785-B6FB-2AC315DC0282}"/>
               </a:ext>
             </a:extLst>
           </p:cNvPr>
@@ -7422,7 +7422,7 @@
           <p:cNvPr id="22" name="">
             <a:extLst xmlns:a="http://schemas.openxmlformats.org/drawingml/2006/main">
               <a:ext uri="{FF2B5EF4-FFF2-40B4-BE49-F238E27FC236}">
-                <a16:creationId xmlns:a16="http://schemas.microsoft.com/office/drawing/2014/main" id="{5DFDD4EC-CFBD-4C44-A486-63E9FC02281A}"/>
+                <a16:creationId xmlns:a16="http://schemas.microsoft.com/office/drawing/2014/main" id="{E3D4008F-4657-4264-AEB3-B487892BB76B}"/>
               </a:ext>
             </a:extLst>
           </p:cNvPr>
@@ -7455,7 +7455,7 @@
           <p:cNvPr id="23" name="">
             <a:extLst xmlns:a="http://schemas.openxmlformats.org/drawingml/2006/main">
               <a:ext uri="{FF2B5EF4-FFF2-40B4-BE49-F238E27FC236}">
-                <a16:creationId xmlns:a16="http://schemas.microsoft.com/office/drawing/2014/main" id="{CC282610-30E9-4E82-BE32-105C35490AD3}"/>
+                <a16:creationId xmlns:a16="http://schemas.microsoft.com/office/drawing/2014/main" id="{76B18E4F-8500-4E9C-8D0E-27E2BA6D9E89}"/>
               </a:ext>
             </a:extLst>
           </p:cNvPr>
@@ -7519,7 +7519,7 @@
           <p:cNvPr id="24" name="">
             <a:extLst xmlns:a="http://schemas.openxmlformats.org/drawingml/2006/main">
               <a:ext uri="{FF2B5EF4-FFF2-40B4-BE49-F238E27FC236}">
-                <a16:creationId xmlns:a16="http://schemas.microsoft.com/office/drawing/2014/main" id="{0A14F0F6-2014-4C6E-8792-08D4499FAD76}"/>
+                <a16:creationId xmlns:a16="http://schemas.microsoft.com/office/drawing/2014/main" id="{3DDE3F03-4EF4-405E-8F10-4B2B72053A6A}"/>
               </a:ext>
             </a:extLst>
           </p:cNvPr>
@@ -7583,7 +7583,7 @@
           <p:cNvPr id="25" name="">
             <a:extLst xmlns:a="http://schemas.openxmlformats.org/drawingml/2006/main">
               <a:ext uri="{FF2B5EF4-FFF2-40B4-BE49-F238E27FC236}">
-                <a16:creationId xmlns:a16="http://schemas.microsoft.com/office/drawing/2014/main" id="{82FF1DC7-C807-4213-B618-D1EE21CBDBAD}"/>
+                <a16:creationId xmlns:a16="http://schemas.microsoft.com/office/drawing/2014/main" id="{AC169951-A6BB-4CC3-8368-C4B46C2C63F5}"/>
               </a:ext>
             </a:extLst>
           </p:cNvPr>
@@ -7647,7 +7647,7 @@
           <p:cNvPr id="26" name="">
             <a:extLst xmlns:a="http://schemas.openxmlformats.org/drawingml/2006/main">
               <a:ext uri="{FF2B5EF4-FFF2-40B4-BE49-F238E27FC236}">
-                <a16:creationId xmlns:a16="http://schemas.microsoft.com/office/drawing/2014/main" id="{7326D8F9-7C04-4700-814B-843572C530C7}"/>
+                <a16:creationId xmlns:a16="http://schemas.microsoft.com/office/drawing/2014/main" id="{8076E127-E076-4664-A1C7-20795AACED49}"/>
               </a:ext>
             </a:extLst>
           </p:cNvPr>
@@ -7709,7 +7709,7 @@
     </p:spTree>
     <p:extLst>
       <p:ext uri="{BB962C8B-B14F-4D97-AF65-F5344CB8AC3E}">
-        <p14:creationId xmlns:p14="http://schemas.microsoft.com/office/powerpoint/2010/main" val="1272261919"/>
+        <p14:creationId xmlns:p14="http://schemas.microsoft.com/office/powerpoint/2010/main" val="1596411556"/>
       </p:ext>
     </p:extLst>
   </p:cSld>
@@ -7733,7 +7733,7 @@
           <p:cNvPr id="1" name="">
             <a:extLst xmlns:a="http://schemas.openxmlformats.org/drawingml/2006/main">
               <a:ext uri="{FF2B5EF4-FFF2-40B4-BE49-F238E27FC236}">
-                <a16:creationId xmlns:a16="http://schemas.microsoft.com/office/drawing/2014/main" id="{373F1338-87CA-4F4F-A569-E7A1F5B0A36D}"/>
+                <a16:creationId xmlns:a16="http://schemas.microsoft.com/office/drawing/2014/main" id="{56719910-2A97-4341-B1BC-690DA8C31186}"/>
               </a:ext>
             </a:extLst>
           </p:cNvPr>
@@ -7768,7 +7768,7 @@
           <p:cNvPr id="2" name="">
             <a:extLst xmlns:a="http://schemas.openxmlformats.org/drawingml/2006/main">
               <a:ext uri="{FF2B5EF4-FFF2-40B4-BE49-F238E27FC236}">
-                <a16:creationId xmlns:a16="http://schemas.microsoft.com/office/drawing/2014/main" id="{9245BDD9-AC9F-4FFD-A067-9617511BCF48}"/>
+                <a16:creationId xmlns:a16="http://schemas.microsoft.com/office/drawing/2014/main" id="{F1A31DE4-0C8F-49EA-B5D4-071D6478AC57}"/>
               </a:ext>
             </a:extLst>
           </p:cNvPr>
@@ -7803,7 +7803,7 @@
           <p:cNvPr id="3" name="">
             <a:extLst xmlns:a="http://schemas.openxmlformats.org/drawingml/2006/main">
               <a:ext uri="{FF2B5EF4-FFF2-40B4-BE49-F238E27FC236}">
-                <a16:creationId xmlns:a16="http://schemas.microsoft.com/office/drawing/2014/main" id="{E0AD91A3-D5A6-4004-A9A7-29416B87779F}"/>
+                <a16:creationId xmlns:a16="http://schemas.microsoft.com/office/drawing/2014/main" id="{13E72ADF-90D6-4E3E-A56C-E453AFD4C29C}"/>
               </a:ext>
             </a:extLst>
           </p:cNvPr>
@@ -7867,7 +7867,7 @@
           <p:cNvPr id="4" name="">
             <a:extLst xmlns:a="http://schemas.openxmlformats.org/drawingml/2006/main">
               <a:ext uri="{FF2B5EF4-FFF2-40B4-BE49-F238E27FC236}">
-                <a16:creationId xmlns:a16="http://schemas.microsoft.com/office/drawing/2014/main" id="{B9810AD5-E237-4BFE-BD17-D269C541FA23}"/>
+                <a16:creationId xmlns:a16="http://schemas.microsoft.com/office/drawing/2014/main" id="{4ECD9C2D-B073-48A7-9D48-963189D5FF62}"/>
               </a:ext>
             </a:extLst>
           </p:cNvPr>
@@ -7931,7 +7931,7 @@
           <p:cNvPr id="5" name="">
             <a:extLst xmlns:a="http://schemas.openxmlformats.org/drawingml/2006/main">
               <a:ext uri="{FF2B5EF4-FFF2-40B4-BE49-F238E27FC236}">
-                <a16:creationId xmlns:a16="http://schemas.microsoft.com/office/drawing/2014/main" id="{A21B2B7B-D5FE-4363-9FF1-A5313DD91733}"/>
+                <a16:creationId xmlns:a16="http://schemas.microsoft.com/office/drawing/2014/main" id="{61B99BAC-69B6-4EA5-90C9-84DCFBBFA190}"/>
               </a:ext>
             </a:extLst>
           </p:cNvPr>
@@ -7995,7 +7995,7 @@
           <p:cNvPr id="6" name="">
             <a:extLst xmlns:a="http://schemas.openxmlformats.org/drawingml/2006/main">
               <a:ext uri="{FF2B5EF4-FFF2-40B4-BE49-F238E27FC236}">
-                <a16:creationId xmlns:a16="http://schemas.microsoft.com/office/drawing/2014/main" id="{F30E102A-4673-47F9-9B56-8C1E9472C064}"/>
+                <a16:creationId xmlns:a16="http://schemas.microsoft.com/office/drawing/2014/main" id="{2AA30F12-F367-4EAF-B620-505538E76684}"/>
               </a:ext>
             </a:extLst>
           </p:cNvPr>
@@ -8059,7 +8059,7 @@
           <p:cNvPr id="7" name="">
             <a:extLst xmlns:a="http://schemas.openxmlformats.org/drawingml/2006/main">
               <a:ext uri="{FF2B5EF4-FFF2-40B4-BE49-F238E27FC236}">
-                <a16:creationId xmlns:a16="http://schemas.microsoft.com/office/drawing/2014/main" id="{67D09788-4608-45D0-BE2E-6A41C3F166D6}"/>
+                <a16:creationId xmlns:a16="http://schemas.microsoft.com/office/drawing/2014/main" id="{9C344A24-25F3-437D-9ACD-A7A008EB96D7}"/>
               </a:ext>
             </a:extLst>
           </p:cNvPr>
@@ -8094,7 +8094,7 @@
           <p:cNvPr id="8" name="">
             <a:extLst xmlns:a="http://schemas.openxmlformats.org/drawingml/2006/main">
               <a:ext uri="{FF2B5EF4-FFF2-40B4-BE49-F238E27FC236}">
-                <a16:creationId xmlns:a16="http://schemas.microsoft.com/office/drawing/2014/main" id="{E0877B8E-05A7-499B-92DE-017BC8A01831}"/>
+                <a16:creationId xmlns:a16="http://schemas.microsoft.com/office/drawing/2014/main" id="{B3F60EF6-C605-453E-9234-211C4153FAE5}"/>
               </a:ext>
             </a:extLst>
           </p:cNvPr>
@@ -8158,7 +8158,7 @@
           <p:cNvPr id="9" name="">
             <a:extLst xmlns:a="http://schemas.openxmlformats.org/drawingml/2006/main">
               <a:ext uri="{FF2B5EF4-FFF2-40B4-BE49-F238E27FC236}">
-                <a16:creationId xmlns:a16="http://schemas.microsoft.com/office/drawing/2014/main" id="{14B50EB3-80F9-40EF-88A0-753AE7C1FC54}"/>
+                <a16:creationId xmlns:a16="http://schemas.microsoft.com/office/drawing/2014/main" id="{06F2EE0A-E974-41F6-AA17-1CEC8F3F7490}"/>
               </a:ext>
             </a:extLst>
           </p:cNvPr>
@@ -8212,7 +8212,7 @@
                 <a:ea typeface="Aptos"/>
                 <a:cs typeface="Aptos"/>
               </a:rPr>
-              <a:t>156</a:t>
+              <a:t>160</a:t>
             </a:r>
           </a:p>
         </p:txBody>
@@ -8222,7 +8222,7 @@
           <p:cNvPr id="10" name="">
             <a:extLst xmlns:a="http://schemas.openxmlformats.org/drawingml/2006/main">
               <a:ext uri="{FF2B5EF4-FFF2-40B4-BE49-F238E27FC236}">
-                <a16:creationId xmlns:a16="http://schemas.microsoft.com/office/drawing/2014/main" id="{D7EA03D4-3253-4768-BCD4-9ADB3238D8ED}"/>
+                <a16:creationId xmlns:a16="http://schemas.microsoft.com/office/drawing/2014/main" id="{2BAF7533-D7A8-44D5-9F1F-A605394A5694}"/>
               </a:ext>
             </a:extLst>
           </p:cNvPr>
@@ -8286,7 +8286,7 @@
           <p:cNvPr id="11" name="">
             <a:extLst xmlns:a="http://schemas.openxmlformats.org/drawingml/2006/main">
               <a:ext uri="{FF2B5EF4-FFF2-40B4-BE49-F238E27FC236}">
-                <a16:creationId xmlns:a16="http://schemas.microsoft.com/office/drawing/2014/main" id="{44F71A29-403B-4F69-A96E-47B845B9BF07}"/>
+                <a16:creationId xmlns:a16="http://schemas.microsoft.com/office/drawing/2014/main" id="{37BE5FDA-E9DB-4B6E-8FAD-EE006E784D13}"/>
               </a:ext>
             </a:extLst>
           </p:cNvPr>
@@ -8321,7 +8321,7 @@
           <p:cNvPr id="12" name="">
             <a:extLst xmlns:a="http://schemas.openxmlformats.org/drawingml/2006/main">
               <a:ext uri="{FF2B5EF4-FFF2-40B4-BE49-F238E27FC236}">
-                <a16:creationId xmlns:a16="http://schemas.microsoft.com/office/drawing/2014/main" id="{35FA8740-AF1B-4315-95F5-B6248A2DE08F}"/>
+                <a16:creationId xmlns:a16="http://schemas.microsoft.com/office/drawing/2014/main" id="{58331576-1E28-4E8F-A605-6826A5479EB5}"/>
               </a:ext>
             </a:extLst>
           </p:cNvPr>
@@ -8385,7 +8385,7 @@
           <p:cNvPr id="13" name="">
             <a:extLst xmlns:a="http://schemas.openxmlformats.org/drawingml/2006/main">
               <a:ext uri="{FF2B5EF4-FFF2-40B4-BE49-F238E27FC236}">
-                <a16:creationId xmlns:a16="http://schemas.microsoft.com/office/drawing/2014/main" id="{FC783133-D03A-40FF-AB8F-E1355B708710}"/>
+                <a16:creationId xmlns:a16="http://schemas.microsoft.com/office/drawing/2014/main" id="{D3F6E62A-C952-4BE4-A7F2-1D0DCBD7BA9C}"/>
               </a:ext>
             </a:extLst>
           </p:cNvPr>
@@ -8439,7 +8439,7 @@
                 <a:ea typeface="Aptos"/>
                 <a:cs typeface="Aptos"/>
               </a:rPr>
-              <a:t>119</a:t>
+              <a:t>120</a:t>
             </a:r>
           </a:p>
         </p:txBody>
@@ -8449,7 +8449,7 @@
           <p:cNvPr id="14" name="">
             <a:extLst xmlns:a="http://schemas.openxmlformats.org/drawingml/2006/main">
               <a:ext uri="{FF2B5EF4-FFF2-40B4-BE49-F238E27FC236}">
-                <a16:creationId xmlns:a16="http://schemas.microsoft.com/office/drawing/2014/main" id="{7A0E7828-7DB9-44B5-AE84-7A2B30669609}"/>
+                <a16:creationId xmlns:a16="http://schemas.microsoft.com/office/drawing/2014/main" id="{F8621A0A-3C7F-4BAC-96E5-317FCE335609}"/>
               </a:ext>
             </a:extLst>
           </p:cNvPr>
@@ -8513,7 +8513,7 @@
           <p:cNvPr id="15" name="">
             <a:extLst xmlns:a="http://schemas.openxmlformats.org/drawingml/2006/main">
               <a:ext uri="{FF2B5EF4-FFF2-40B4-BE49-F238E27FC236}">
-                <a16:creationId xmlns:a16="http://schemas.microsoft.com/office/drawing/2014/main" id="{FFA071B6-751E-41A4-AC62-80B8C7B4D8EA}"/>
+                <a16:creationId xmlns:a16="http://schemas.microsoft.com/office/drawing/2014/main" id="{A80E1FC9-823C-4FA7-93D4-2D26FFC08571}"/>
               </a:ext>
             </a:extLst>
           </p:cNvPr>
@@ -8548,7 +8548,7 @@
           <p:cNvPr id="16" name="">
             <a:extLst xmlns:a="http://schemas.openxmlformats.org/drawingml/2006/main">
               <a:ext uri="{FF2B5EF4-FFF2-40B4-BE49-F238E27FC236}">
-                <a16:creationId xmlns:a16="http://schemas.microsoft.com/office/drawing/2014/main" id="{4F36CF5D-031A-42D0-9389-0BF4D52E8B0E}"/>
+                <a16:creationId xmlns:a16="http://schemas.microsoft.com/office/drawing/2014/main" id="{45EEA2FA-55C5-4B82-8E98-66902FA8864C}"/>
               </a:ext>
             </a:extLst>
           </p:cNvPr>
@@ -8612,7 +8612,7 @@
           <p:cNvPr id="17" name="">
             <a:extLst xmlns:a="http://schemas.openxmlformats.org/drawingml/2006/main">
               <a:ext uri="{FF2B5EF4-FFF2-40B4-BE49-F238E27FC236}">
-                <a16:creationId xmlns:a16="http://schemas.microsoft.com/office/drawing/2014/main" id="{EB47A79E-2F95-4BC3-ACED-013A7270B9D1}"/>
+                <a16:creationId xmlns:a16="http://schemas.microsoft.com/office/drawing/2014/main" id="{66E328B8-E1EF-4AC5-9B85-78B1CB767FE0}"/>
               </a:ext>
             </a:extLst>
           </p:cNvPr>
@@ -8676,7 +8676,7 @@
           <p:cNvPr id="18" name="">
             <a:extLst xmlns:a="http://schemas.openxmlformats.org/drawingml/2006/main">
               <a:ext uri="{FF2B5EF4-FFF2-40B4-BE49-F238E27FC236}">
-                <a16:creationId xmlns:a16="http://schemas.microsoft.com/office/drawing/2014/main" id="{EFA03F68-3983-4B6E-9ACB-6DC4A2CCC154}"/>
+                <a16:creationId xmlns:a16="http://schemas.microsoft.com/office/drawing/2014/main" id="{EA6A8C2C-CB69-4C11-9A19-285D8604F0B7}"/>
               </a:ext>
             </a:extLst>
           </p:cNvPr>
@@ -8740,7 +8740,7 @@
           <p:cNvPr id="19" name="">
             <a:extLst xmlns:a="http://schemas.openxmlformats.org/drawingml/2006/main">
               <a:ext uri="{FF2B5EF4-FFF2-40B4-BE49-F238E27FC236}">
-                <a16:creationId xmlns:a16="http://schemas.microsoft.com/office/drawing/2014/main" id="{CF221F27-0680-4C91-AA76-CFAA872332AD}"/>
+                <a16:creationId xmlns:a16="http://schemas.microsoft.com/office/drawing/2014/main" id="{A6E0E011-117D-4135-A085-0C0A9170B8A3}"/>
               </a:ext>
             </a:extLst>
           </p:cNvPr>
@@ -8775,7 +8775,7 @@
           <p:cNvPr id="20" name="">
             <a:extLst xmlns:a="http://schemas.openxmlformats.org/drawingml/2006/main">
               <a:ext uri="{FF2B5EF4-FFF2-40B4-BE49-F238E27FC236}">
-                <a16:creationId xmlns:a16="http://schemas.microsoft.com/office/drawing/2014/main" id="{545F1E51-6FCA-4223-A566-353E6E865A3D}"/>
+                <a16:creationId xmlns:a16="http://schemas.microsoft.com/office/drawing/2014/main" id="{687FC3A5-DB85-46DF-A7F9-BCBFF1EB4AAF}"/>
               </a:ext>
             </a:extLst>
           </p:cNvPr>
@@ -8839,7 +8839,7 @@
           <p:cNvPr id="21" name="">
             <a:extLst xmlns:a="http://schemas.openxmlformats.org/drawingml/2006/main">
               <a:ext uri="{FF2B5EF4-FFF2-40B4-BE49-F238E27FC236}">
-                <a16:creationId xmlns:a16="http://schemas.microsoft.com/office/drawing/2014/main" id="{63AF29F4-536A-41D9-81D1-E2F0970C1BFE}"/>
+                <a16:creationId xmlns:a16="http://schemas.microsoft.com/office/drawing/2014/main" id="{545BE920-EDFB-42A3-ADC2-922D7681CA54}"/>
               </a:ext>
             </a:extLst>
           </p:cNvPr>
@@ -8903,7 +8903,7 @@
           <p:cNvPr id="22" name="">
             <a:extLst xmlns:a="http://schemas.openxmlformats.org/drawingml/2006/main">
               <a:ext uri="{FF2B5EF4-FFF2-40B4-BE49-F238E27FC236}">
-                <a16:creationId xmlns:a16="http://schemas.microsoft.com/office/drawing/2014/main" id="{C4C2C680-6574-45B3-B474-30E16784205B}"/>
+                <a16:creationId xmlns:a16="http://schemas.microsoft.com/office/drawing/2014/main" id="{1DFB2CAB-C8AA-4310-A28D-2DFC35032537}"/>
               </a:ext>
             </a:extLst>
           </p:cNvPr>
@@ -8967,7 +8967,7 @@
           <p:cNvPr id="23" name="">
             <a:extLst xmlns:a="http://schemas.openxmlformats.org/drawingml/2006/main">
               <a:ext uri="{FF2B5EF4-FFF2-40B4-BE49-F238E27FC236}">
-                <a16:creationId xmlns:a16="http://schemas.microsoft.com/office/drawing/2014/main" id="{C4D5EB64-44A4-4918-B7C4-D7BCB5FBE4CA}"/>
+                <a16:creationId xmlns:a16="http://schemas.microsoft.com/office/drawing/2014/main" id="{BC1511EB-0A09-4B44-95DF-21C59D05A7A4}"/>
               </a:ext>
             </a:extLst>
           </p:cNvPr>
@@ -9000,7 +9000,7 @@
           <p:cNvPr id="24" name="">
             <a:extLst xmlns:a="http://schemas.openxmlformats.org/drawingml/2006/main">
               <a:ext uri="{FF2B5EF4-FFF2-40B4-BE49-F238E27FC236}">
-                <a16:creationId xmlns:a16="http://schemas.microsoft.com/office/drawing/2014/main" id="{DA50053F-3C1B-492A-B257-6B349A38064B}"/>
+                <a16:creationId xmlns:a16="http://schemas.microsoft.com/office/drawing/2014/main" id="{DD122F4C-3455-4EF6-96ED-50E915B99417}"/>
               </a:ext>
             </a:extLst>
           </p:cNvPr>
@@ -9064,7 +9064,7 @@
           <p:cNvPr id="25" name="">
             <a:extLst xmlns:a="http://schemas.openxmlformats.org/drawingml/2006/main">
               <a:ext uri="{FF2B5EF4-FFF2-40B4-BE49-F238E27FC236}">
-                <a16:creationId xmlns:a16="http://schemas.microsoft.com/office/drawing/2014/main" id="{744CC53B-43E1-4606-86C6-085EBC1F1285}"/>
+                <a16:creationId xmlns:a16="http://schemas.microsoft.com/office/drawing/2014/main" id="{AE82CBA6-4B3C-439C-9C10-17390C889720}"/>
               </a:ext>
             </a:extLst>
           </p:cNvPr>
@@ -9128,7 +9128,7 @@
           <p:cNvPr id="26" name="">
             <a:extLst xmlns:a="http://schemas.openxmlformats.org/drawingml/2006/main">
               <a:ext uri="{FF2B5EF4-FFF2-40B4-BE49-F238E27FC236}">
-                <a16:creationId xmlns:a16="http://schemas.microsoft.com/office/drawing/2014/main" id="{367B0DB9-C8DB-474F-9969-409DCB33AA2E}"/>
+                <a16:creationId xmlns:a16="http://schemas.microsoft.com/office/drawing/2014/main" id="{DBF2C530-425B-418F-8800-AE9C839FF4CD}"/>
               </a:ext>
             </a:extLst>
           </p:cNvPr>
@@ -9192,7 +9192,7 @@
           <p:cNvPr id="27" name="">
             <a:extLst xmlns:a="http://schemas.openxmlformats.org/drawingml/2006/main">
               <a:ext uri="{FF2B5EF4-FFF2-40B4-BE49-F238E27FC236}">
-                <a16:creationId xmlns:a16="http://schemas.microsoft.com/office/drawing/2014/main" id="{EC9AE982-DD76-4FCE-A023-391994D73C2D}"/>
+                <a16:creationId xmlns:a16="http://schemas.microsoft.com/office/drawing/2014/main" id="{AB1FF683-306D-4DC3-8F9F-A7DC66415377}"/>
               </a:ext>
             </a:extLst>
           </p:cNvPr>
@@ -9254,7 +9254,7 @@
     </p:spTree>
     <p:extLst>
       <p:ext uri="{BB962C8B-B14F-4D97-AF65-F5344CB8AC3E}">
-        <p14:creationId xmlns:p14="http://schemas.microsoft.com/office/powerpoint/2010/main" val="189076322"/>
+        <p14:creationId xmlns:p14="http://schemas.microsoft.com/office/powerpoint/2010/main" val="1267871397"/>
       </p:ext>
     </p:extLst>
   </p:cSld>
@@ -9278,7 +9278,7 @@
           <p:cNvPr id="1" name="">
             <a:extLst xmlns:a="http://schemas.openxmlformats.org/drawingml/2006/main">
               <a:ext uri="{FF2B5EF4-FFF2-40B4-BE49-F238E27FC236}">
-                <a16:creationId xmlns:a16="http://schemas.microsoft.com/office/drawing/2014/main" id="{2B4BFF89-99D6-4FD8-AE3E-66D9A061C339}"/>
+                <a16:creationId xmlns:a16="http://schemas.microsoft.com/office/drawing/2014/main" id="{28EA78B0-BDAB-4033-AE74-2DB745EED555}"/>
               </a:ext>
             </a:extLst>
           </p:cNvPr>
@@ -9313,7 +9313,7 @@
           <p:cNvPr id="2" name="">
             <a:extLst xmlns:a="http://schemas.openxmlformats.org/drawingml/2006/main">
               <a:ext uri="{FF2B5EF4-FFF2-40B4-BE49-F238E27FC236}">
-                <a16:creationId xmlns:a16="http://schemas.microsoft.com/office/drawing/2014/main" id="{F8194145-7422-43DE-9F92-969C68D22F97}"/>
+                <a16:creationId xmlns:a16="http://schemas.microsoft.com/office/drawing/2014/main" id="{F892C0F6-D573-40A8-9237-B608C7B6D8F8}"/>
               </a:ext>
             </a:extLst>
           </p:cNvPr>
@@ -9348,7 +9348,7 @@
           <p:cNvPr id="3" name="">
             <a:extLst xmlns:a="http://schemas.openxmlformats.org/drawingml/2006/main">
               <a:ext uri="{FF2B5EF4-FFF2-40B4-BE49-F238E27FC236}">
-                <a16:creationId xmlns:a16="http://schemas.microsoft.com/office/drawing/2014/main" id="{5B5296D8-CA08-436A-A3D9-D2EABB8332CC}"/>
+                <a16:creationId xmlns:a16="http://schemas.microsoft.com/office/drawing/2014/main" id="{890563F2-C224-4D68-BD64-A1627C9B2D3A}"/>
               </a:ext>
             </a:extLst>
           </p:cNvPr>
@@ -9412,7 +9412,7 @@
           <p:cNvPr id="4" name="">
             <a:extLst xmlns:a="http://schemas.openxmlformats.org/drawingml/2006/main">
               <a:ext uri="{FF2B5EF4-FFF2-40B4-BE49-F238E27FC236}">
-                <a16:creationId xmlns:a16="http://schemas.microsoft.com/office/drawing/2014/main" id="{30BFEE4C-A416-4969-B7D5-120AC9703BB5}"/>
+                <a16:creationId xmlns:a16="http://schemas.microsoft.com/office/drawing/2014/main" id="{6EE9EBCC-BC0F-4ECD-A4DB-8A485CDF2B4E}"/>
               </a:ext>
             </a:extLst>
           </p:cNvPr>
@@ -9476,7 +9476,7 @@
           <p:cNvPr id="5" name="">
             <a:extLst xmlns:a="http://schemas.openxmlformats.org/drawingml/2006/main">
               <a:ext uri="{FF2B5EF4-FFF2-40B4-BE49-F238E27FC236}">
-                <a16:creationId xmlns:a16="http://schemas.microsoft.com/office/drawing/2014/main" id="{A4F08D33-5012-4E81-89C2-D68562F59C4C}"/>
+                <a16:creationId xmlns:a16="http://schemas.microsoft.com/office/drawing/2014/main" id="{3D49467D-444D-464A-8CCD-0CB133206261}"/>
               </a:ext>
             </a:extLst>
           </p:cNvPr>
@@ -9540,7 +9540,7 @@
           <p:cNvPr id="6" name="">
             <a:extLst xmlns:a="http://schemas.openxmlformats.org/drawingml/2006/main">
               <a:ext uri="{FF2B5EF4-FFF2-40B4-BE49-F238E27FC236}">
-                <a16:creationId xmlns:a16="http://schemas.microsoft.com/office/drawing/2014/main" id="{1855076D-2EDE-428B-92A3-02ECCD62384B}"/>
+                <a16:creationId xmlns:a16="http://schemas.microsoft.com/office/drawing/2014/main" id="{CE7A2592-E004-40FB-AE52-6FEE72DEBF1E}"/>
               </a:ext>
             </a:extLst>
           </p:cNvPr>
@@ -9604,7 +9604,7 @@
           <p:cNvPr id="7" name="">
             <a:extLst xmlns:a="http://schemas.openxmlformats.org/drawingml/2006/main">
               <a:ext uri="{FF2B5EF4-FFF2-40B4-BE49-F238E27FC236}">
-                <a16:creationId xmlns:a16="http://schemas.microsoft.com/office/drawing/2014/main" id="{4C6225B3-D1D1-4F34-A521-F4D6E51DA80B}"/>
+                <a16:creationId xmlns:a16="http://schemas.microsoft.com/office/drawing/2014/main" id="{86C35A13-4A96-476E-AA26-99B555DCDB35}"/>
               </a:ext>
             </a:extLst>
           </p:cNvPr>
@@ -9637,7 +9637,7 @@
           <p:cNvPr id="8" name="">
             <a:extLst xmlns:a="http://schemas.openxmlformats.org/drawingml/2006/main">
               <a:ext uri="{FF2B5EF4-FFF2-40B4-BE49-F238E27FC236}">
-                <a16:creationId xmlns:a16="http://schemas.microsoft.com/office/drawing/2014/main" id="{D3557520-9F80-4AD2-9B9C-F01CA5D66832}"/>
+                <a16:creationId xmlns:a16="http://schemas.microsoft.com/office/drawing/2014/main" id="{70E59CC1-417F-48A7-A199-F76C19E1CBF6}"/>
               </a:ext>
             </a:extLst>
           </p:cNvPr>
@@ -9701,7 +9701,7 @@
           <p:cNvPr id="9" name="">
             <a:extLst xmlns:a="http://schemas.openxmlformats.org/drawingml/2006/main">
               <a:ext uri="{FF2B5EF4-FFF2-40B4-BE49-F238E27FC236}">
-                <a16:creationId xmlns:a16="http://schemas.microsoft.com/office/drawing/2014/main" id="{488FEF38-3B11-4900-AD50-F7DE6259F831}"/>
+                <a16:creationId xmlns:a16="http://schemas.microsoft.com/office/drawing/2014/main" id="{4B23A732-9694-420A-A5E9-B0AB51B1B436}"/>
               </a:ext>
             </a:extLst>
           </p:cNvPr>
@@ -9765,7 +9765,7 @@
           <p:cNvPr id="10" name="">
             <a:extLst xmlns:a="http://schemas.openxmlformats.org/drawingml/2006/main">
               <a:ext uri="{FF2B5EF4-FFF2-40B4-BE49-F238E27FC236}">
-                <a16:creationId xmlns:a16="http://schemas.microsoft.com/office/drawing/2014/main" id="{65166435-7DF3-41E7-94F0-ED1167EBA1F7}"/>
+                <a16:creationId xmlns:a16="http://schemas.microsoft.com/office/drawing/2014/main" id="{CCBB89E6-CF74-4552-8F78-CBF863901E5A}"/>
               </a:ext>
             </a:extLst>
           </p:cNvPr>
@@ -9798,7 +9798,7 @@
           <p:cNvPr id="11" name="">
             <a:extLst xmlns:a="http://schemas.openxmlformats.org/drawingml/2006/main">
               <a:ext uri="{FF2B5EF4-FFF2-40B4-BE49-F238E27FC236}">
-                <a16:creationId xmlns:a16="http://schemas.microsoft.com/office/drawing/2014/main" id="{9535867E-CD4E-4640-BAF7-12F8DF21E7FC}"/>
+                <a16:creationId xmlns:a16="http://schemas.microsoft.com/office/drawing/2014/main" id="{BA3BDB90-21E8-424C-A9EF-443F0CFE3ACA}"/>
               </a:ext>
             </a:extLst>
           </p:cNvPr>
@@ -9862,7 +9862,7 @@
           <p:cNvPr id="12" name="">
             <a:extLst xmlns:a="http://schemas.openxmlformats.org/drawingml/2006/main">
               <a:ext uri="{FF2B5EF4-FFF2-40B4-BE49-F238E27FC236}">
-                <a16:creationId xmlns:a16="http://schemas.microsoft.com/office/drawing/2014/main" id="{05ECA4F3-21DF-405C-A916-67EE8FE2CCD9}"/>
+                <a16:creationId xmlns:a16="http://schemas.microsoft.com/office/drawing/2014/main" id="{47D1722A-FA7B-4FE3-AB06-8F43705F0324}"/>
               </a:ext>
             </a:extLst>
           </p:cNvPr>
@@ -9926,7 +9926,7 @@
           <p:cNvPr id="13" name="">
             <a:extLst xmlns:a="http://schemas.openxmlformats.org/drawingml/2006/main">
               <a:ext uri="{FF2B5EF4-FFF2-40B4-BE49-F238E27FC236}">
-                <a16:creationId xmlns:a16="http://schemas.microsoft.com/office/drawing/2014/main" id="{73297F5C-AAF5-4732-9E11-4015CD7713D6}"/>
+                <a16:creationId xmlns:a16="http://schemas.microsoft.com/office/drawing/2014/main" id="{405CA4E1-4279-4F43-B89A-9A9970020612}"/>
               </a:ext>
             </a:extLst>
           </p:cNvPr>
@@ -9959,7 +9959,7 @@
           <p:cNvPr id="14" name="">
             <a:extLst xmlns:a="http://schemas.openxmlformats.org/drawingml/2006/main">
               <a:ext uri="{FF2B5EF4-FFF2-40B4-BE49-F238E27FC236}">
-                <a16:creationId xmlns:a16="http://schemas.microsoft.com/office/drawing/2014/main" id="{CDD87169-D21B-472B-9293-AF00B28A7A82}"/>
+                <a16:creationId xmlns:a16="http://schemas.microsoft.com/office/drawing/2014/main" id="{B21552A1-E36E-46C0-9215-656C1E9F6C59}"/>
               </a:ext>
             </a:extLst>
           </p:cNvPr>
@@ -10023,7 +10023,7 @@
           <p:cNvPr id="15" name="">
             <a:extLst xmlns:a="http://schemas.openxmlformats.org/drawingml/2006/main">
               <a:ext uri="{FF2B5EF4-FFF2-40B4-BE49-F238E27FC236}">
-                <a16:creationId xmlns:a16="http://schemas.microsoft.com/office/drawing/2014/main" id="{E48D2B57-28CF-420D-98C7-C1F91D3E2866}"/>
+                <a16:creationId xmlns:a16="http://schemas.microsoft.com/office/drawing/2014/main" id="{4F7F7F54-D413-4A7E-8CA6-CD76E6093D1D}"/>
               </a:ext>
             </a:extLst>
           </p:cNvPr>
@@ -10087,7 +10087,7 @@
           <p:cNvPr id="16" name="">
             <a:extLst xmlns:a="http://schemas.openxmlformats.org/drawingml/2006/main">
               <a:ext uri="{FF2B5EF4-FFF2-40B4-BE49-F238E27FC236}">
-                <a16:creationId xmlns:a16="http://schemas.microsoft.com/office/drawing/2014/main" id="{32E5EE30-CD20-4E03-82B6-8F781C90D406}"/>
+                <a16:creationId xmlns:a16="http://schemas.microsoft.com/office/drawing/2014/main" id="{1ED0C382-37C3-4D00-8C29-21845D1C572F}"/>
               </a:ext>
             </a:extLst>
           </p:cNvPr>
@@ -10151,7 +10151,7 @@
           <p:cNvPr id="17" name="">
             <a:extLst xmlns:a="http://schemas.openxmlformats.org/drawingml/2006/main">
               <a:ext uri="{FF2B5EF4-FFF2-40B4-BE49-F238E27FC236}">
-                <a16:creationId xmlns:a16="http://schemas.microsoft.com/office/drawing/2014/main" id="{56316BEE-54A2-469E-A6C4-01FEAB977932}"/>
+                <a16:creationId xmlns:a16="http://schemas.microsoft.com/office/drawing/2014/main" id="{82BE725E-1E10-4B0B-BC9F-56308D76956B}"/>
               </a:ext>
             </a:extLst>
           </p:cNvPr>
@@ -10213,7 +10213,7 @@
     </p:spTree>
     <p:extLst>
       <p:ext uri="{BB962C8B-B14F-4D97-AF65-F5344CB8AC3E}">
-        <p14:creationId xmlns:p14="http://schemas.microsoft.com/office/powerpoint/2010/main" val="600645062"/>
+        <p14:creationId xmlns:p14="http://schemas.microsoft.com/office/powerpoint/2010/main" val="1812809456"/>
       </p:ext>
     </p:extLst>
   </p:cSld>
@@ -10237,7 +10237,7 @@
           <p:cNvPr id="1" name="">
             <a:extLst xmlns:a="http://schemas.openxmlformats.org/drawingml/2006/main">
               <a:ext uri="{FF2B5EF4-FFF2-40B4-BE49-F238E27FC236}">
-                <a16:creationId xmlns:a16="http://schemas.microsoft.com/office/drawing/2014/main" id="{82CE67E9-3448-416C-AF77-3B0FED9DDFA7}"/>
+                <a16:creationId xmlns:a16="http://schemas.microsoft.com/office/drawing/2014/main" id="{049283AC-F4FC-48E7-A31F-449EF4BF4E69}"/>
               </a:ext>
             </a:extLst>
           </p:cNvPr>
@@ -10272,7 +10272,7 @@
           <p:cNvPr id="2" name="">
             <a:extLst xmlns:a="http://schemas.openxmlformats.org/drawingml/2006/main">
               <a:ext uri="{FF2B5EF4-FFF2-40B4-BE49-F238E27FC236}">
-                <a16:creationId xmlns:a16="http://schemas.microsoft.com/office/drawing/2014/main" id="{482DC5A5-C5DC-4412-BE55-593067EA8E41}"/>
+                <a16:creationId xmlns:a16="http://schemas.microsoft.com/office/drawing/2014/main" id="{AD514649-41D7-4556-B6F9-3244FE382991}"/>
               </a:ext>
             </a:extLst>
           </p:cNvPr>
@@ -10307,7 +10307,7 @@
           <p:cNvPr id="3" name="">
             <a:extLst xmlns:a="http://schemas.openxmlformats.org/drawingml/2006/main">
               <a:ext uri="{FF2B5EF4-FFF2-40B4-BE49-F238E27FC236}">
-                <a16:creationId xmlns:a16="http://schemas.microsoft.com/office/drawing/2014/main" id="{F16DAA12-84DE-4205-BBD3-57BE34FD3A57}"/>
+                <a16:creationId xmlns:a16="http://schemas.microsoft.com/office/drawing/2014/main" id="{EEF8703E-EC27-4BA0-85A0-A79BAEF4502A}"/>
               </a:ext>
             </a:extLst>
           </p:cNvPr>
@@ -10371,7 +10371,7 @@
           <p:cNvPr id="4" name="">
             <a:extLst xmlns:a="http://schemas.openxmlformats.org/drawingml/2006/main">
               <a:ext uri="{FF2B5EF4-FFF2-40B4-BE49-F238E27FC236}">
-                <a16:creationId xmlns:a16="http://schemas.microsoft.com/office/drawing/2014/main" id="{01D51899-E077-4507-B785-F4B36A50A80B}"/>
+                <a16:creationId xmlns:a16="http://schemas.microsoft.com/office/drawing/2014/main" id="{667C3C2D-7CEF-488B-AFD1-12E7CBAFB5F2}"/>
               </a:ext>
             </a:extLst>
           </p:cNvPr>
@@ -10425,7 +10425,7 @@
                 <a:ea typeface="Aptos"/>
                 <a:cs typeface="Aptos"/>
               </a:rPr>
-              <a:t>Self-healing</a:t>
+              <a:t>Off-grid continuity</a:t>
             </a:r>
           </a:p>
         </p:txBody>
@@ -10435,7 +10435,7 @@
           <p:cNvPr id="5" name="">
             <a:extLst xmlns:a="http://schemas.openxmlformats.org/drawingml/2006/main">
               <a:ext uri="{FF2B5EF4-FFF2-40B4-BE49-F238E27FC236}">
-                <a16:creationId xmlns:a16="http://schemas.microsoft.com/office/drawing/2014/main" id="{CCFABCB3-C561-41F0-91AC-6EAF93124084}"/>
+                <a16:creationId xmlns:a16="http://schemas.microsoft.com/office/drawing/2014/main" id="{8107ED9B-B02D-4D81-81E0-F55666753C9B}"/>
               </a:ext>
             </a:extLst>
           </p:cNvPr>
@@ -10489,7 +10489,7 @@
                 <a:ea typeface="Aptos Display"/>
                 <a:cs typeface="Aptos Display"/>
               </a:rPr>
-              <a:t>Real failover and real field radio have executable proof</a:t>
+              <a:t>Private field radio keeps the food control loop local</a:t>
             </a:r>
           </a:p>
         </p:txBody>
@@ -10499,7 +10499,7 @@
           <p:cNvPr id="6" name="">
             <a:extLst xmlns:a="http://schemas.openxmlformats.org/drawingml/2006/main">
               <a:ext uri="{FF2B5EF4-FFF2-40B4-BE49-F238E27FC236}">
-                <a16:creationId xmlns:a16="http://schemas.microsoft.com/office/drawing/2014/main" id="{821B3F3F-5E8F-4B1B-AC16-F4C82455F95B}"/>
+                <a16:creationId xmlns:a16="http://schemas.microsoft.com/office/drawing/2014/main" id="{CCB66E91-B7EC-4CE3-BBDC-27222C170096}"/>
               </a:ext>
             </a:extLst>
           </p:cNvPr>
@@ -10553,7 +10553,7 @@
                 <a:ea typeface="Aptos"/>
                 <a:cs typeface="Aptos"/>
               </a:rPr>
-              <a:t>Horde preserves managed agent state across owner loss; two physical nRF9151 DKs prove the DECT NR+ link.</a:t>
+              <a:t>No Wi-Fi for the tank hop. No cloud for inference. Solar-plus-battery power is the next measured field proof.</a:t>
             </a:r>
           </a:p>
         </p:txBody>
@@ -10563,29 +10563,29 @@
           <p:cNvPr id="7" name="">
             <a:extLst xmlns:a="http://schemas.openxmlformats.org/drawingml/2006/main">
               <a:ext uri="{FF2B5EF4-FFF2-40B4-BE49-F238E27FC236}">
-                <a16:creationId xmlns:a16="http://schemas.microsoft.com/office/drawing/2014/main" id="{8CB6FE4F-3F6A-45D0-83A3-E40FA79D0A9E}"/>
-              </a:ext>
-            </a:extLst>
-          </p:cNvPr>
-          <p:cNvSpPr>
-            <a:spLocks xmlns:a="http://schemas.openxmlformats.org/drawingml/2006/main" noGrp="1"/>
-          </p:cNvSpPr>
-          <p:nvPr/>
-        </p:nvSpPr>
-        <p:spPr>
-          <a:xfrm xmlns:a="http://schemas.openxmlformats.org/drawingml/2006/main">
-            <a:off x="990600" y="2286000"/>
-            <a:ext cx="2571750" cy="1162050"/>
-          </a:xfrm>
-          <a:prstGeom xmlns:a="http://schemas.openxmlformats.org/drawingml/2006/main" prst="rect">
-            <a:avLst/>
-          </a:prstGeom>
-          <a:solidFill xmlns:a="http://schemas.openxmlformats.org/drawingml/2006/main">
-            <a:srgbClr val="FEE2E2"/>
+                <a16:creationId xmlns:a16="http://schemas.microsoft.com/office/drawing/2014/main" id="{1B12F2DE-46FF-4361-AE44-6EFF0E8E3FC9}"/>
+              </a:ext>
+            </a:extLst>
+          </p:cNvPr>
+          <p:cNvSpPr>
+            <a:spLocks xmlns:a="http://schemas.openxmlformats.org/drawingml/2006/main" noGrp="1"/>
+          </p:cNvSpPr>
+          <p:nvPr/>
+        </p:nvSpPr>
+        <p:spPr>
+          <a:xfrm xmlns:a="http://schemas.openxmlformats.org/drawingml/2006/main">
+            <a:off x="438150" y="2266950"/>
+            <a:ext cx="2000250" cy="1257300"/>
+          </a:xfrm>
+          <a:prstGeom xmlns:a="http://schemas.openxmlformats.org/drawingml/2006/main" prst="rect">
+            <a:avLst/>
+          </a:prstGeom>
+          <a:solidFill xmlns:a="http://schemas.openxmlformats.org/drawingml/2006/main">
+            <a:srgbClr val="E0F2FE"/>
           </a:solidFill>
           <a:ln xmlns:a="http://schemas.openxmlformats.org/drawingml/2006/main" w="19050">
             <a:solidFill>
-              <a:srgbClr val="B91C1C"/>
+              <a:srgbClr val="0369A1"/>
             </a:solidFill>
             <a:prstDash val="solid"/>
           </a:ln>
@@ -10596,19 +10596,19 @@
           <p:cNvPr id="8" name="">
             <a:extLst xmlns:a="http://schemas.openxmlformats.org/drawingml/2006/main">
               <a:ext uri="{FF2B5EF4-FFF2-40B4-BE49-F238E27FC236}">
-                <a16:creationId xmlns:a16="http://schemas.microsoft.com/office/drawing/2014/main" id="{85219CDA-0A0A-4FF8-9FA7-E4F91663A56F}"/>
-              </a:ext>
-            </a:extLst>
-          </p:cNvPr>
-          <p:cNvSpPr>
-            <a:spLocks xmlns:a="http://schemas.openxmlformats.org/drawingml/2006/main" noGrp="1"/>
-          </p:cNvSpPr>
-          <p:nvPr/>
-        </p:nvSpPr>
-        <p:spPr>
-          <a:xfrm xmlns:a="http://schemas.openxmlformats.org/drawingml/2006/main">
-            <a:off x="1162050" y="2419350"/>
-            <a:ext cx="2228850" cy="285750"/>
+                <a16:creationId xmlns:a16="http://schemas.microsoft.com/office/drawing/2014/main" id="{52479D8F-5FF9-4E99-8C33-A2C5F7792046}"/>
+              </a:ext>
+            </a:extLst>
+          </p:cNvPr>
+          <p:cNvSpPr>
+            <a:spLocks xmlns:a="http://schemas.openxmlformats.org/drawingml/2006/main" noGrp="1"/>
+          </p:cNvSpPr>
+          <p:nvPr/>
+        </p:nvSpPr>
+        <p:spPr>
+          <a:xfrm xmlns:a="http://schemas.openxmlformats.org/drawingml/2006/main">
+            <a:off x="609600" y="2400300"/>
+            <a:ext cx="1657350" cy="285750"/>
           </a:xfrm>
           <a:prstGeom xmlns:a="http://schemas.openxmlformats.org/drawingml/2006/main" prst="rect">
             <a:avLst/>
@@ -10650,7 +10650,7 @@
                 <a:ea typeface="Aptos"/>
                 <a:cs typeface="Aptos"/>
               </a:rPr>
-              <a:t>proteinloop_web@web</a:t>
+              <a:t>PT tank node</a:t>
             </a:r>
           </a:p>
         </p:txBody>
@@ -10660,19 +10660,19 @@
           <p:cNvPr id="9" name="">
             <a:extLst xmlns:a="http://schemas.openxmlformats.org/drawingml/2006/main">
               <a:ext uri="{FF2B5EF4-FFF2-40B4-BE49-F238E27FC236}">
-                <a16:creationId xmlns:a16="http://schemas.microsoft.com/office/drawing/2014/main" id="{52B12A31-2C08-406A-96BF-F6C7CF9027F8}"/>
-              </a:ext>
-            </a:extLst>
-          </p:cNvPr>
-          <p:cNvSpPr>
-            <a:spLocks xmlns:a="http://schemas.openxmlformats.org/drawingml/2006/main" noGrp="1"/>
-          </p:cNvSpPr>
-          <p:nvPr/>
-        </p:nvSpPr>
-        <p:spPr>
-          <a:xfrm xmlns:a="http://schemas.openxmlformats.org/drawingml/2006/main">
-            <a:off x="1162050" y="2762250"/>
-            <a:ext cx="2228850" cy="514350"/>
+                <a16:creationId xmlns:a16="http://schemas.microsoft.com/office/drawing/2014/main" id="{2B960434-1461-4AD4-B46A-C95B4058D76E}"/>
+              </a:ext>
+            </a:extLst>
+          </p:cNvPr>
+          <p:cNvSpPr>
+            <a:spLocks xmlns:a="http://schemas.openxmlformats.org/drawingml/2006/main" noGrp="1"/>
+          </p:cNvSpPr>
+          <p:nvPr/>
+        </p:nvSpPr>
+        <p:spPr>
+          <a:xfrm xmlns:a="http://schemas.openxmlformats.org/drawingml/2006/main">
+            <a:off x="609600" y="2743200"/>
+            <a:ext cx="1657350" cy="609600"/>
           </a:xfrm>
           <a:prstGeom xmlns:a="http://schemas.openxmlformats.org/drawingml/2006/main" prst="rect">
             <a:avLst/>
@@ -10714,7 +10714,7 @@
                 <a:ea typeface="Aptos"/>
                 <a:cs typeface="Aptos"/>
               </a:rPr>
-              <a:t>Initial owner persists the completed Gemma probe.</a:t>
+              <a:t>nRF9151 at the tank. Physical board proven; chemistry probes integrate next.</a:t>
             </a:r>
           </a:p>
         </p:txBody>
@@ -10724,18 +10724,18 @@
           <p:cNvPr id="10" name="">
             <a:extLst xmlns:a="http://schemas.openxmlformats.org/drawingml/2006/main">
               <a:ext uri="{FF2B5EF4-FFF2-40B4-BE49-F238E27FC236}">
-                <a16:creationId xmlns:a16="http://schemas.microsoft.com/office/drawing/2014/main" id="{4A6C6087-12A4-4A84-807B-C94AE3658EEE}"/>
-              </a:ext>
-            </a:extLst>
-          </p:cNvPr>
-          <p:cNvSpPr>
-            <a:spLocks xmlns:a="http://schemas.openxmlformats.org/drawingml/2006/main" noGrp="1"/>
-          </p:cNvSpPr>
-          <p:nvPr/>
-        </p:nvSpPr>
-        <p:spPr>
-          <a:xfrm xmlns:a="http://schemas.openxmlformats.org/drawingml/2006/main">
-            <a:off x="3733800" y="2724150"/>
+                <a16:creationId xmlns:a16="http://schemas.microsoft.com/office/drawing/2014/main" id="{82BF952A-8AE9-41A5-8F62-C57EC9855E75}"/>
+              </a:ext>
+            </a:extLst>
+          </p:cNvPr>
+          <p:cNvSpPr>
+            <a:spLocks xmlns:a="http://schemas.openxmlformats.org/drawingml/2006/main" noGrp="1"/>
+          </p:cNvSpPr>
+          <p:nvPr/>
+        </p:nvSpPr>
+        <p:spPr>
+          <a:xfrm xmlns:a="http://schemas.openxmlformats.org/drawingml/2006/main">
+            <a:off x="2533650" y="2724150"/>
             <a:ext cx="457200" cy="266700"/>
           </a:xfrm>
           <a:prstGeom xmlns:a="http://schemas.openxmlformats.org/drawingml/2006/main" prst="rect">
@@ -10778,7 +10778,7 @@
                 <a:ea typeface="Aptos"/>
                 <a:cs typeface="Aptos"/>
               </a:rPr>
-              <a:t>stop</a:t>
+              <a:t>-&gt;</a:t>
             </a:r>
           </a:p>
         </p:txBody>
@@ -10788,29 +10788,29 @@
           <p:cNvPr id="11" name="">
             <a:extLst xmlns:a="http://schemas.openxmlformats.org/drawingml/2006/main">
               <a:ext uri="{FF2B5EF4-FFF2-40B4-BE49-F238E27FC236}">
-                <a16:creationId xmlns:a16="http://schemas.microsoft.com/office/drawing/2014/main" id="{6D8D4E01-A952-426B-9FBB-A56F5EC7B519}"/>
-              </a:ext>
-            </a:extLst>
-          </p:cNvPr>
-          <p:cNvSpPr>
-            <a:spLocks xmlns:a="http://schemas.openxmlformats.org/drawingml/2006/main" noGrp="1"/>
-          </p:cNvSpPr>
-          <p:nvPr/>
-        </p:nvSpPr>
-        <p:spPr>
-          <a:xfrm xmlns:a="http://schemas.openxmlformats.org/drawingml/2006/main">
-            <a:off x="4457700" y="2286000"/>
-            <a:ext cx="2571750" cy="1162050"/>
-          </a:xfrm>
-          <a:prstGeom xmlns:a="http://schemas.openxmlformats.org/drawingml/2006/main" prst="rect">
-            <a:avLst/>
-          </a:prstGeom>
-          <a:solidFill xmlns:a="http://schemas.openxmlformats.org/drawingml/2006/main">
-            <a:srgbClr val="CCFBF1"/>
+                <a16:creationId xmlns:a16="http://schemas.microsoft.com/office/drawing/2014/main" id="{D5E08895-3C92-44B9-97E2-CC94BD5AE50F}"/>
+              </a:ext>
+            </a:extLst>
+          </p:cNvPr>
+          <p:cNvSpPr>
+            <a:spLocks xmlns:a="http://schemas.openxmlformats.org/drawingml/2006/main" noGrp="1"/>
+          </p:cNvSpPr>
+          <p:nvPr/>
+        </p:nvSpPr>
+        <p:spPr>
+          <a:xfrm xmlns:a="http://schemas.openxmlformats.org/drawingml/2006/main">
+            <a:off x="3086100" y="2266950"/>
+            <a:ext cx="2362200" cy="1257300"/>
+          </a:xfrm>
+          <a:prstGeom xmlns:a="http://schemas.openxmlformats.org/drawingml/2006/main" prst="rect">
+            <a:avLst/>
+          </a:prstGeom>
+          <a:solidFill xmlns:a="http://schemas.openxmlformats.org/drawingml/2006/main">
+            <a:srgbClr val="DCFCE7"/>
           </a:solidFill>
           <a:ln xmlns:a="http://schemas.openxmlformats.org/drawingml/2006/main" w="19050">
             <a:solidFill>
-              <a:srgbClr val="0F766E"/>
+              <a:srgbClr val="15803D"/>
             </a:solidFill>
             <a:prstDash val="solid"/>
           </a:ln>
@@ -10821,19 +10821,19 @@
           <p:cNvPr id="12" name="">
             <a:extLst xmlns:a="http://schemas.openxmlformats.org/drawingml/2006/main">
               <a:ext uri="{FF2B5EF4-FFF2-40B4-BE49-F238E27FC236}">
-                <a16:creationId xmlns:a16="http://schemas.microsoft.com/office/drawing/2014/main" id="{7373A08B-6B28-489E-9A34-C97DD79C4AF4}"/>
-              </a:ext>
-            </a:extLst>
-          </p:cNvPr>
-          <p:cNvSpPr>
-            <a:spLocks xmlns:a="http://schemas.openxmlformats.org/drawingml/2006/main" noGrp="1"/>
-          </p:cNvSpPr>
-          <p:nvPr/>
-        </p:nvSpPr>
-        <p:spPr>
-          <a:xfrm xmlns:a="http://schemas.openxmlformats.org/drawingml/2006/main">
-            <a:off x="4629150" y="2419350"/>
-            <a:ext cx="2228850" cy="285750"/>
+                <a16:creationId xmlns:a16="http://schemas.microsoft.com/office/drawing/2014/main" id="{774CDA4B-00A7-4EB8-969C-530ED4F0E169}"/>
+              </a:ext>
+            </a:extLst>
+          </p:cNvPr>
+          <p:cNvSpPr>
+            <a:spLocks xmlns:a="http://schemas.openxmlformats.org/drawingml/2006/main" noGrp="1"/>
+          </p:cNvSpPr>
+          <p:nvPr/>
+        </p:nvSpPr>
+        <p:spPr>
+          <a:xfrm xmlns:a="http://schemas.openxmlformats.org/drawingml/2006/main">
+            <a:off x="3257550" y="2400300"/>
+            <a:ext cx="2019300" cy="285750"/>
           </a:xfrm>
           <a:prstGeom xmlns:a="http://schemas.openxmlformats.org/drawingml/2006/main" prst="rect">
             <a:avLst/>
@@ -10875,7 +10875,7 @@
                 <a:ea typeface="Aptos"/>
                 <a:cs typeface="Aptos"/>
               </a:rPr>
-              <a:t>Horde 0.10.0</a:t>
+              <a:t>DECT NR+</a:t>
             </a:r>
           </a:p>
         </p:txBody>
@@ -10885,19 +10885,19 @@
           <p:cNvPr id="13" name="">
             <a:extLst xmlns:a="http://schemas.openxmlformats.org/drawingml/2006/main">
               <a:ext uri="{FF2B5EF4-FFF2-40B4-BE49-F238E27FC236}">
-                <a16:creationId xmlns:a16="http://schemas.microsoft.com/office/drawing/2014/main" id="{F631329E-5F6A-471A-B010-895FAA93D752}"/>
-              </a:ext>
-            </a:extLst>
-          </p:cNvPr>
-          <p:cNvSpPr>
-            <a:spLocks xmlns:a="http://schemas.openxmlformats.org/drawingml/2006/main" noGrp="1"/>
-          </p:cNvSpPr>
-          <p:nvPr/>
-        </p:nvSpPr>
-        <p:spPr>
-          <a:xfrm xmlns:a="http://schemas.openxmlformats.org/drawingml/2006/main">
-            <a:off x="4629150" y="2762250"/>
-            <a:ext cx="2228850" cy="514350"/>
+                <a16:creationId xmlns:a16="http://schemas.microsoft.com/office/drawing/2014/main" id="{E3A3A624-F165-45FA-AFC7-276C7E75820E}"/>
+              </a:ext>
+            </a:extLst>
+          </p:cNvPr>
+          <p:cNvSpPr>
+            <a:spLocks xmlns:a="http://schemas.openxmlformats.org/drawingml/2006/main" noGrp="1"/>
+          </p:cNvSpPr>
+          <p:nvPr/>
+        </p:nvSpPr>
+        <p:spPr>
+          <a:xfrm xmlns:a="http://schemas.openxmlformats.org/drawingml/2006/main">
+            <a:off x="3257550" y="2743200"/>
+            <a:ext cx="2019300" cy="609600"/>
           </a:xfrm>
           <a:prstGeom xmlns:a="http://schemas.openxmlformats.org/drawingml/2006/main" prst="rect">
             <a:avLst/>
@@ -10939,7 +10939,7 @@
                 <a:ea typeface="Aptos"/>
                 <a:cs typeface="Aptos"/>
               </a:rPr>
-              <a:t>Participation membership transfers managed ownership.</a:t>
+              <a:t>Private non-cellular 5G hop. No Wi-Fi, SIM, or cloud. Sequence 100 proven.</a:t>
             </a:r>
           </a:p>
         </p:txBody>
@@ -10949,18 +10949,18 @@
           <p:cNvPr id="14" name="">
             <a:extLst xmlns:a="http://schemas.openxmlformats.org/drawingml/2006/main">
               <a:ext uri="{FF2B5EF4-FFF2-40B4-BE49-F238E27FC236}">
-                <a16:creationId xmlns:a16="http://schemas.microsoft.com/office/drawing/2014/main" id="{D444F21E-8775-4DB4-B98F-40BCC15A00CF}"/>
-              </a:ext>
-            </a:extLst>
-          </p:cNvPr>
-          <p:cNvSpPr>
-            <a:spLocks xmlns:a="http://schemas.openxmlformats.org/drawingml/2006/main" noGrp="1"/>
-          </p:cNvSpPr>
-          <p:nvPr/>
-        </p:nvSpPr>
-        <p:spPr>
-          <a:xfrm xmlns:a="http://schemas.openxmlformats.org/drawingml/2006/main">
-            <a:off x="7200900" y="2724150"/>
+                <a16:creationId xmlns:a16="http://schemas.microsoft.com/office/drawing/2014/main" id="{8A5C5D32-AFC8-442C-9EEF-0DCCE4B4C051}"/>
+              </a:ext>
+            </a:extLst>
+          </p:cNvPr>
+          <p:cNvSpPr>
+            <a:spLocks xmlns:a="http://schemas.openxmlformats.org/drawingml/2006/main" noGrp="1"/>
+          </p:cNvSpPr>
+          <p:nvPr/>
+        </p:nvSpPr>
+        <p:spPr>
+          <a:xfrm xmlns:a="http://schemas.openxmlformats.org/drawingml/2006/main">
+            <a:off x="5543550" y="2724150"/>
             <a:ext cx="457200" cy="266700"/>
           </a:xfrm>
           <a:prstGeom xmlns:a="http://schemas.openxmlformats.org/drawingml/2006/main" prst="rect">
@@ -11013,29 +11013,29 @@
           <p:cNvPr id="15" name="">
             <a:extLst xmlns:a="http://schemas.openxmlformats.org/drawingml/2006/main">
               <a:ext uri="{FF2B5EF4-FFF2-40B4-BE49-F238E27FC236}">
-                <a16:creationId xmlns:a16="http://schemas.microsoft.com/office/drawing/2014/main" id="{E66783CF-5A8C-4E9E-AEFC-42DB066C1236}"/>
-              </a:ext>
-            </a:extLst>
-          </p:cNvPr>
-          <p:cNvSpPr>
-            <a:spLocks xmlns:a="http://schemas.openxmlformats.org/drawingml/2006/main" noGrp="1"/>
-          </p:cNvSpPr>
-          <p:nvPr/>
-        </p:nvSpPr>
-        <p:spPr>
-          <a:xfrm xmlns:a="http://schemas.openxmlformats.org/drawingml/2006/main">
-            <a:off x="7924800" y="2286000"/>
-            <a:ext cx="2857500" cy="1162050"/>
-          </a:xfrm>
-          <a:prstGeom xmlns:a="http://schemas.openxmlformats.org/drawingml/2006/main" prst="rect">
-            <a:avLst/>
-          </a:prstGeom>
-          <a:solidFill xmlns:a="http://schemas.openxmlformats.org/drawingml/2006/main">
-            <a:srgbClr val="DCFCE7"/>
+                <a16:creationId xmlns:a16="http://schemas.microsoft.com/office/drawing/2014/main" id="{6E3B9BA4-5010-4849-B6D2-D5BA0647E19E}"/>
+              </a:ext>
+            </a:extLst>
+          </p:cNvPr>
+          <p:cNvSpPr>
+            <a:spLocks xmlns:a="http://schemas.openxmlformats.org/drawingml/2006/main" noGrp="1"/>
+          </p:cNvSpPr>
+          <p:nvPr/>
+        </p:nvSpPr>
+        <p:spPr>
+          <a:xfrm xmlns:a="http://schemas.openxmlformats.org/drawingml/2006/main">
+            <a:off x="6096000" y="2266950"/>
+            <a:ext cx="2000250" cy="1257300"/>
+          </a:xfrm>
+          <a:prstGeom xmlns:a="http://schemas.openxmlformats.org/drawingml/2006/main" prst="rect">
+            <a:avLst/>
+          </a:prstGeom>
+          <a:solidFill xmlns:a="http://schemas.openxmlformats.org/drawingml/2006/main">
+            <a:srgbClr val="E0F2FE"/>
           </a:solidFill>
           <a:ln xmlns:a="http://schemas.openxmlformats.org/drawingml/2006/main" w="19050">
             <a:solidFill>
-              <a:srgbClr val="15803D"/>
+              <a:srgbClr val="0369A1"/>
             </a:solidFill>
             <a:prstDash val="solid"/>
           </a:ln>
@@ -11046,19 +11046,19 @@
           <p:cNvPr id="16" name="">
             <a:extLst xmlns:a="http://schemas.openxmlformats.org/drawingml/2006/main">
               <a:ext uri="{FF2B5EF4-FFF2-40B4-BE49-F238E27FC236}">
-                <a16:creationId xmlns:a16="http://schemas.microsoft.com/office/drawing/2014/main" id="{CCF6079B-827F-462A-BA35-AEF6AFFE380C}"/>
-              </a:ext>
-            </a:extLst>
-          </p:cNvPr>
-          <p:cNvSpPr>
-            <a:spLocks xmlns:a="http://schemas.openxmlformats.org/drawingml/2006/main" noGrp="1"/>
-          </p:cNvSpPr>
-          <p:nvPr/>
-        </p:nvSpPr>
-        <p:spPr>
-          <a:xfrm xmlns:a="http://schemas.openxmlformats.org/drawingml/2006/main">
-            <a:off x="8096250" y="2419350"/>
-            <a:ext cx="2514600" cy="285750"/>
+                <a16:creationId xmlns:a16="http://schemas.microsoft.com/office/drawing/2014/main" id="{DDD2A279-CD8E-445C-BCE0-D9A2D2E3478A}"/>
+              </a:ext>
+            </a:extLst>
+          </p:cNvPr>
+          <p:cNvSpPr>
+            <a:spLocks xmlns:a="http://schemas.openxmlformats.org/drawingml/2006/main" noGrp="1"/>
+          </p:cNvSpPr>
+          <p:nvPr/>
+        </p:nvSpPr>
+        <p:spPr>
+          <a:xfrm xmlns:a="http://schemas.openxmlformats.org/drawingml/2006/main">
+            <a:off x="6267450" y="2400300"/>
+            <a:ext cx="1657350" cy="285750"/>
           </a:xfrm>
           <a:prstGeom xmlns:a="http://schemas.openxmlformats.org/drawingml/2006/main" prst="rect">
             <a:avLst/>
@@ -11100,7 +11100,7 @@
                 <a:ea typeface="Aptos"/>
                 <a:cs typeface="Aptos"/>
               </a:rPr>
-              <a:t>proteinloop_peer@peer</a:t>
+              <a:t>FT gateway radio</a:t>
             </a:r>
           </a:p>
         </p:txBody>
@@ -11110,19 +11110,19 @@
           <p:cNvPr id="17" name="">
             <a:extLst xmlns:a="http://schemas.openxmlformats.org/drawingml/2006/main">
               <a:ext uri="{FF2B5EF4-FFF2-40B4-BE49-F238E27FC236}">
-                <a16:creationId xmlns:a16="http://schemas.microsoft.com/office/drawing/2014/main" id="{AEAB97EF-5205-4487-A034-71A45E707A2F}"/>
-              </a:ext>
-            </a:extLst>
-          </p:cNvPr>
-          <p:cNvSpPr>
-            <a:spLocks xmlns:a="http://schemas.openxmlformats.org/drawingml/2006/main" noGrp="1"/>
-          </p:cNvSpPr>
-          <p:nvPr/>
-        </p:nvSpPr>
-        <p:spPr>
-          <a:xfrm xmlns:a="http://schemas.openxmlformats.org/drawingml/2006/main">
-            <a:off x="8096250" y="2762250"/>
-            <a:ext cx="2514600" cy="514350"/>
+                <a16:creationId xmlns:a16="http://schemas.microsoft.com/office/drawing/2014/main" id="{03A1B4EE-54F1-499F-B7A3-C8C7E8865830}"/>
+              </a:ext>
+            </a:extLst>
+          </p:cNvPr>
+          <p:cNvSpPr>
+            <a:spLocks xmlns:a="http://schemas.openxmlformats.org/drawingml/2006/main" noGrp="1"/>
+          </p:cNvSpPr>
+          <p:nvPr/>
+        </p:nvSpPr>
+        <p:spPr>
+          <a:xfrm xmlns:a="http://schemas.openxmlformats.org/drawingml/2006/main">
+            <a:off x="6267450" y="2743200"/>
+            <a:ext cx="1657350" cy="609600"/>
           </a:xfrm>
           <a:prstGeom xmlns:a="http://schemas.openxmlformats.org/drawingml/2006/main" prst="rect">
             <a:avLst/>
@@ -11164,7 +11164,7 @@
                 <a:ea typeface="Aptos"/>
                 <a:cs typeface="Aptos"/>
               </a:rPr>
-              <a:t>Survivor restores the same Sagents AgentServer state.</a:t>
+              <a:t>nRF9151 receives the field packet and hands it to edge compute.</a:t>
             </a:r>
           </a:p>
         </p:txBody>
@@ -11174,25 +11174,89 @@
           <p:cNvPr id="18" name="">
             <a:extLst xmlns:a="http://schemas.openxmlformats.org/drawingml/2006/main">
               <a:ext uri="{FF2B5EF4-FFF2-40B4-BE49-F238E27FC236}">
-                <a16:creationId xmlns:a16="http://schemas.microsoft.com/office/drawing/2014/main" id="{A41B2C62-1E8A-4BB7-8752-5DFD166B594C}"/>
-              </a:ext>
-            </a:extLst>
-          </p:cNvPr>
-          <p:cNvSpPr>
-            <a:spLocks xmlns:a="http://schemas.openxmlformats.org/drawingml/2006/main" noGrp="1"/>
-          </p:cNvSpPr>
-          <p:nvPr/>
-        </p:nvSpPr>
-        <p:spPr>
-          <a:xfrm xmlns:a="http://schemas.openxmlformats.org/drawingml/2006/main">
-            <a:off x="990600" y="4038600"/>
-            <a:ext cx="4953000" cy="1104900"/>
-          </a:xfrm>
-          <a:prstGeom xmlns:a="http://schemas.openxmlformats.org/drawingml/2006/main" prst="rect">
-            <a:avLst/>
-          </a:prstGeom>
-          <a:solidFill xmlns:a="http://schemas.openxmlformats.org/drawingml/2006/main">
-            <a:srgbClr val="FFFFFF"/>
+                <a16:creationId xmlns:a16="http://schemas.microsoft.com/office/drawing/2014/main" id="{968548C5-FF76-48FE-8375-91FDB9ACF864}"/>
+              </a:ext>
+            </a:extLst>
+          </p:cNvPr>
+          <p:cNvSpPr>
+            <a:spLocks xmlns:a="http://schemas.openxmlformats.org/drawingml/2006/main" noGrp="1"/>
+          </p:cNvSpPr>
+          <p:nvPr/>
+        </p:nvSpPr>
+        <p:spPr>
+          <a:xfrm xmlns:a="http://schemas.openxmlformats.org/drawingml/2006/main">
+            <a:off x="8191500" y="2724150"/>
+            <a:ext cx="457200" cy="266700"/>
+          </a:xfrm>
+          <a:prstGeom xmlns:a="http://schemas.openxmlformats.org/drawingml/2006/main" prst="rect">
+            <a:avLst/>
+          </a:prstGeom>
+          <a:solidFill xmlns:a="http://schemas.openxmlformats.org/drawingml/2006/main">
+            <a:srgbClr val="000000">
+              <a:alpha val="0"/>
+            </a:srgbClr>
+          </a:solidFill>
+          <a:ln xmlns:a="http://schemas.openxmlformats.org/drawingml/2006/main" w="0">
+            <a:solidFill>
+              <a:srgbClr val="000000">
+                <a:alpha val="0"/>
+              </a:srgbClr>
+            </a:solidFill>
+            <a:prstDash val="solid"/>
+          </a:ln>
+        </p:spPr>
+        <p:txBody>
+          <a:bodyPr xmlns:a="http://schemas.openxmlformats.org/drawingml/2006/main" lIns="0" tIns="0" rIns="0" bIns="0" anchor="t"/>
+          <a:lstStyle xmlns:a="http://schemas.openxmlformats.org/drawingml/2006/main"/>
+          <a:p xmlns:a="http://schemas.openxmlformats.org/drawingml/2006/main">
+            <a:pPr algn="ctr">
+              <a:defRPr sz="1650" b="1">
+                <a:solidFill>
+                  <a:srgbClr val="0F766E"/>
+                </a:solidFill>
+                <a:latin typeface="Aptos"/>
+                <a:ea typeface="Aptos"/>
+                <a:cs typeface="Aptos"/>
+              </a:defRPr>
+            </a:pPr>
+            <a:r>
+              <a:rPr sz="1650" b="1">
+                <a:solidFill>
+                  <a:srgbClr val="0F766E"/>
+                </a:solidFill>
+                <a:latin typeface="Aptos"/>
+                <a:ea typeface="Aptos"/>
+                <a:cs typeface="Aptos"/>
+              </a:rPr>
+              <a:t>-&gt;</a:t>
+            </a:r>
+          </a:p>
+        </p:txBody>
+      </p:sp>
+      <p:sp>
+        <p:nvSpPr>
+          <p:cNvPr id="19" name="">
+            <a:extLst xmlns:a="http://schemas.openxmlformats.org/drawingml/2006/main">
+              <a:ext uri="{FF2B5EF4-FFF2-40B4-BE49-F238E27FC236}">
+                <a16:creationId xmlns:a16="http://schemas.microsoft.com/office/drawing/2014/main" id="{2E0DAE48-F4A6-499A-B44F-49E6EEDE5F8D}"/>
+              </a:ext>
+            </a:extLst>
+          </p:cNvPr>
+          <p:cNvSpPr>
+            <a:spLocks xmlns:a="http://schemas.openxmlformats.org/drawingml/2006/main" noGrp="1"/>
+          </p:cNvSpPr>
+          <p:nvPr/>
+        </p:nvSpPr>
+        <p:spPr>
+          <a:xfrm xmlns:a="http://schemas.openxmlformats.org/drawingml/2006/main">
+            <a:off x="8743950" y="2266950"/>
+            <a:ext cx="2952750" cy="1257300"/>
+          </a:xfrm>
+          <a:prstGeom xmlns:a="http://schemas.openxmlformats.org/drawingml/2006/main" prst="rect">
+            <a:avLst/>
+          </a:prstGeom>
+          <a:solidFill xmlns:a="http://schemas.openxmlformats.org/drawingml/2006/main">
+            <a:srgbClr val="CCFBF1"/>
           </a:solidFill>
           <a:ln xmlns:a="http://schemas.openxmlformats.org/drawingml/2006/main" w="19050">
             <a:solidFill>
@@ -11204,22 +11268,22 @@
       </p:sp>
       <p:sp>
         <p:nvSpPr>
-          <p:cNvPr id="19" name="">
-            <a:extLst xmlns:a="http://schemas.openxmlformats.org/drawingml/2006/main">
-              <a:ext uri="{FF2B5EF4-FFF2-40B4-BE49-F238E27FC236}">
-                <a16:creationId xmlns:a16="http://schemas.microsoft.com/office/drawing/2014/main" id="{2F369840-E67D-4840-9FB4-01FE719F206E}"/>
-              </a:ext>
-            </a:extLst>
-          </p:cNvPr>
-          <p:cNvSpPr>
-            <a:spLocks xmlns:a="http://schemas.openxmlformats.org/drawingml/2006/main" noGrp="1"/>
-          </p:cNvSpPr>
-          <p:nvPr/>
-        </p:nvSpPr>
-        <p:spPr>
-          <a:xfrm xmlns:a="http://schemas.openxmlformats.org/drawingml/2006/main">
-            <a:off x="1162050" y="4171950"/>
-            <a:ext cx="4610100" cy="285750"/>
+          <p:cNvPr id="20" name="">
+            <a:extLst xmlns:a="http://schemas.openxmlformats.org/drawingml/2006/main">
+              <a:ext uri="{FF2B5EF4-FFF2-40B4-BE49-F238E27FC236}">
+                <a16:creationId xmlns:a16="http://schemas.microsoft.com/office/drawing/2014/main" id="{DBB63914-1012-479C-A26E-CC7647AA113D}"/>
+              </a:ext>
+            </a:extLst>
+          </p:cNvPr>
+          <p:cNvSpPr>
+            <a:spLocks xmlns:a="http://schemas.openxmlformats.org/drawingml/2006/main" noGrp="1"/>
+          </p:cNvSpPr>
+          <p:nvPr/>
+        </p:nvSpPr>
+        <p:spPr>
+          <a:xfrm xmlns:a="http://schemas.openxmlformats.org/drawingml/2006/main">
+            <a:off x="8915400" y="2400300"/>
+            <a:ext cx="2609850" cy="285750"/>
           </a:xfrm>
           <a:prstGeom xmlns:a="http://schemas.openxmlformats.org/drawingml/2006/main" prst="rect">
             <a:avLst/>
@@ -11261,29 +11325,29 @@
                 <a:ea typeface="Aptos"/>
                 <a:cs typeface="Aptos"/>
               </a:rPr>
-              <a:t>Horde proof</a:t>
-            </a:r>
-          </a:p>
-        </p:txBody>
-      </p:sp>
-      <p:sp>
-        <p:nvSpPr>
-          <p:cNvPr id="20" name="">
-            <a:extLst xmlns:a="http://schemas.openxmlformats.org/drawingml/2006/main">
-              <a:ext uri="{FF2B5EF4-FFF2-40B4-BE49-F238E27FC236}">
-                <a16:creationId xmlns:a16="http://schemas.microsoft.com/office/drawing/2014/main" id="{835080F9-47BF-4ACC-983F-FB238AD02A71}"/>
-              </a:ext>
-            </a:extLst>
-          </p:cNvPr>
-          <p:cNvSpPr>
-            <a:spLocks xmlns:a="http://schemas.openxmlformats.org/drawingml/2006/main" noGrp="1"/>
-          </p:cNvSpPr>
-          <p:nvPr/>
-        </p:nvSpPr>
-        <p:spPr>
-          <a:xfrm xmlns:a="http://schemas.openxmlformats.org/drawingml/2006/main">
-            <a:off x="1162050" y="4514850"/>
-            <a:ext cx="4610100" cy="457200"/>
+              <a:t>Separate edge computer</a:t>
+            </a:r>
+          </a:p>
+        </p:txBody>
+      </p:sp>
+      <p:sp>
+        <p:nvSpPr>
+          <p:cNvPr id="21" name="">
+            <a:extLst xmlns:a="http://schemas.openxmlformats.org/drawingml/2006/main">
+              <a:ext uri="{FF2B5EF4-FFF2-40B4-BE49-F238E27FC236}">
+                <a16:creationId xmlns:a16="http://schemas.microsoft.com/office/drawing/2014/main" id="{7D0BE11E-A9A7-4162-9B72-6D6A8DB3A494}"/>
+              </a:ext>
+            </a:extLst>
+          </p:cNvPr>
+          <p:cNvSpPr>
+            <a:spLocks xmlns:a="http://schemas.openxmlformats.org/drawingml/2006/main" noGrp="1"/>
+          </p:cNvSpPr>
+          <p:nvPr/>
+        </p:nvSpPr>
+        <p:spPr>
+          <a:xfrm xmlns:a="http://schemas.openxmlformats.org/drawingml/2006/main">
+            <a:off x="8915400" y="2743200"/>
+            <a:ext cx="2609850" cy="609600"/>
           </a:xfrm>
           <a:prstGeom xmlns:a="http://schemas.openxmlformats.org/drawingml/2006/main" prst="rect">
             <a:avLst/>
@@ -11325,28 +11389,28 @@
                 <a:ea typeface="Aptos"/>
                 <a:cs typeface="Aptos"/>
               </a:rPr>
-              <a:t>Identity, state token, and fingerprint stay unchanged; restore_count increases on the peer and both nodes rejoin.</a:t>
-            </a:r>
-          </a:p>
-        </p:txBody>
-      </p:sp>
-      <p:sp>
-        <p:nvSpPr>
-          <p:cNvPr id="21" name="">
-            <a:extLst xmlns:a="http://schemas.openxmlformats.org/drawingml/2006/main">
-              <a:ext uri="{FF2B5EF4-FFF2-40B4-BE49-F238E27FC236}">
-                <a16:creationId xmlns:a16="http://schemas.microsoft.com/office/drawing/2014/main" id="{A006B807-DE26-407C-9597-62585045E427}"/>
-              </a:ext>
-            </a:extLst>
-          </p:cNvPr>
-          <p:cNvSpPr>
-            <a:spLocks xmlns:a="http://schemas.openxmlformats.org/drawingml/2006/main" noGrp="1"/>
-          </p:cNvSpPr>
-          <p:nvPr/>
-        </p:nvSpPr>
-        <p:spPr>
-          <a:xfrm xmlns:a="http://schemas.openxmlformats.org/drawingml/2006/main">
-            <a:off x="6248400" y="4038600"/>
+              <a:t>Self-hosted Gemma + deterministic verifier + producer workflow. The radios do not run the model.</a:t>
+            </a:r>
+          </a:p>
+        </p:txBody>
+      </p:sp>
+      <p:sp>
+        <p:nvSpPr>
+          <p:cNvPr id="22" name="">
+            <a:extLst xmlns:a="http://schemas.openxmlformats.org/drawingml/2006/main">
+              <a:ext uri="{FF2B5EF4-FFF2-40B4-BE49-F238E27FC236}">
+                <a16:creationId xmlns:a16="http://schemas.microsoft.com/office/drawing/2014/main" id="{74B54068-616F-452B-A77E-586602A53ED4}"/>
+              </a:ext>
+            </a:extLst>
+          </p:cNvPr>
+          <p:cNvSpPr>
+            <a:spLocks xmlns:a="http://schemas.openxmlformats.org/drawingml/2006/main" noGrp="1"/>
+          </p:cNvSpPr>
+          <p:nvPr/>
+        </p:nvSpPr>
+        <p:spPr>
+          <a:xfrm xmlns:a="http://schemas.openxmlformats.org/drawingml/2006/main">
+            <a:off x="857250" y="4114800"/>
             <a:ext cx="4953000" cy="1104900"/>
           </a:xfrm>
           <a:prstGeom xmlns:a="http://schemas.openxmlformats.org/drawingml/2006/main" prst="rect">
@@ -11365,21 +11429,21 @@
       </p:sp>
       <p:sp>
         <p:nvSpPr>
-          <p:cNvPr id="22" name="">
-            <a:extLst xmlns:a="http://schemas.openxmlformats.org/drawingml/2006/main">
-              <a:ext uri="{FF2B5EF4-FFF2-40B4-BE49-F238E27FC236}">
-                <a16:creationId xmlns:a16="http://schemas.microsoft.com/office/drawing/2014/main" id="{F408F05F-07DE-4AAC-94C1-774B1BEC360E}"/>
-              </a:ext>
-            </a:extLst>
-          </p:cNvPr>
-          <p:cNvSpPr>
-            <a:spLocks xmlns:a="http://schemas.openxmlformats.org/drawingml/2006/main" noGrp="1"/>
-          </p:cNvSpPr>
-          <p:nvPr/>
-        </p:nvSpPr>
-        <p:spPr>
-          <a:xfrm xmlns:a="http://schemas.openxmlformats.org/drawingml/2006/main">
-            <a:off x="6419850" y="4171950"/>
+          <p:cNvPr id="23" name="">
+            <a:extLst xmlns:a="http://schemas.openxmlformats.org/drawingml/2006/main">
+              <a:ext uri="{FF2B5EF4-FFF2-40B4-BE49-F238E27FC236}">
+                <a16:creationId xmlns:a16="http://schemas.microsoft.com/office/drawing/2014/main" id="{E0FF54B2-E7B3-4FCD-AA90-859D62D408CA}"/>
+              </a:ext>
+            </a:extLst>
+          </p:cNvPr>
+          <p:cNvSpPr>
+            <a:spLocks xmlns:a="http://schemas.openxmlformats.org/drawingml/2006/main" noGrp="1"/>
+          </p:cNvSpPr>
+          <p:nvPr/>
+        </p:nvSpPr>
+        <p:spPr>
+          <a:xfrm xmlns:a="http://schemas.openxmlformats.org/drawingml/2006/main">
+            <a:off x="1028700" y="4248150"/>
             <a:ext cx="4610100" cy="285750"/>
           </a:xfrm>
           <a:prstGeom xmlns:a="http://schemas.openxmlformats.org/drawingml/2006/main" prst="rect">
@@ -11422,28 +11486,28 @@
                 <a:ea typeface="Aptos"/>
                 <a:cs typeface="Aptos"/>
               </a:rPr>
-              <a:t>Physical DECT NR+ proof</a:t>
-            </a:r>
-          </a:p>
-        </p:txBody>
-      </p:sp>
-      <p:sp>
-        <p:nvSpPr>
-          <p:cNvPr id="23" name="">
-            <a:extLst xmlns:a="http://schemas.openxmlformats.org/drawingml/2006/main">
-              <a:ext uri="{FF2B5EF4-FFF2-40B4-BE49-F238E27FC236}">
-                <a16:creationId xmlns:a16="http://schemas.microsoft.com/office/drawing/2014/main" id="{46D19ACC-DFC4-4646-A94D-D7EBBF6C452E}"/>
-              </a:ext>
-            </a:extLst>
-          </p:cNvPr>
-          <p:cNvSpPr>
-            <a:spLocks xmlns:a="http://schemas.openxmlformats.org/drawingml/2006/main" noGrp="1"/>
-          </p:cNvSpPr>
-          <p:nvPr/>
-        </p:nvSpPr>
-        <p:spPr>
-          <a:xfrm xmlns:a="http://schemas.openxmlformats.org/drawingml/2006/main">
-            <a:off x="6419850" y="4514850"/>
+              <a:t>Proven now</a:t>
+            </a:r>
+          </a:p>
+        </p:txBody>
+      </p:sp>
+      <p:sp>
+        <p:nvSpPr>
+          <p:cNvPr id="24" name="">
+            <a:extLst xmlns:a="http://schemas.openxmlformats.org/drawingml/2006/main">
+              <a:ext uri="{FF2B5EF4-FFF2-40B4-BE49-F238E27FC236}">
+                <a16:creationId xmlns:a16="http://schemas.microsoft.com/office/drawing/2014/main" id="{34FA1EB5-E2C1-467B-98F4-23AC51B55294}"/>
+              </a:ext>
+            </a:extLst>
+          </p:cNvPr>
+          <p:cNvSpPr>
+            <a:spLocks xmlns:a="http://schemas.openxmlformats.org/drawingml/2006/main" noGrp="1"/>
+          </p:cNvSpPr>
+          <p:nvPr/>
+        </p:nvSpPr>
+        <p:spPr>
+          <a:xfrm xmlns:a="http://schemas.openxmlformats.org/drawingml/2006/main">
+            <a:off x="1028700" y="4591050"/>
             <a:ext cx="4610100" cy="457200"/>
           </a:xfrm>
           <a:prstGeom xmlns:a="http://schemas.openxmlformats.org/drawingml/2006/main" prst="rect">
@@ -11486,17 +11550,178 @@
                 <a:ea typeface="Aptos"/>
                 <a:cs typeface="Aptos"/>
               </a:rPr>
-              <a:t>FT 1051223739 and PT 1051239227 show matching sequences in both directions. Read-only capture; no flash/reset; simulated: false.</a:t>
-            </a:r>
-          </a:p>
-        </p:txBody>
-      </p:sp>
-      <p:sp>
-        <p:nvSpPr>
-          <p:cNvPr id="24" name="">
-            <a:extLst xmlns:a="http://schemas.openxmlformats.org/drawingml/2006/main">
-              <a:ext uri="{FF2B5EF4-FFF2-40B4-BE49-F238E27FC236}">
-                <a16:creationId xmlns:a16="http://schemas.microsoft.com/office/drawing/2014/main" id="{2F998196-2A50-4FEC-BFDC-329545580A97}"/>
+              <a:t>Two-board bidirectional radio, local Gemma 4 E2B, offline rules, verifier gating, and producer approval.</a:t>
+            </a:r>
+          </a:p>
+        </p:txBody>
+      </p:sp>
+      <p:sp>
+        <p:nvSpPr>
+          <p:cNvPr id="25" name="">
+            <a:extLst xmlns:a="http://schemas.openxmlformats.org/drawingml/2006/main">
+              <a:ext uri="{FF2B5EF4-FFF2-40B4-BE49-F238E27FC236}">
+                <a16:creationId xmlns:a16="http://schemas.microsoft.com/office/drawing/2014/main" id="{C5B41040-04F2-4FDE-8C76-E1EE605D4F72}"/>
+              </a:ext>
+            </a:extLst>
+          </p:cNvPr>
+          <p:cNvSpPr>
+            <a:spLocks xmlns:a="http://schemas.openxmlformats.org/drawingml/2006/main" noGrp="1"/>
+          </p:cNvSpPr>
+          <p:nvPr/>
+        </p:nvSpPr>
+        <p:spPr>
+          <a:xfrm xmlns:a="http://schemas.openxmlformats.org/drawingml/2006/main">
+            <a:off x="6381750" y="4114800"/>
+            <a:ext cx="4953000" cy="1104900"/>
+          </a:xfrm>
+          <a:prstGeom xmlns:a="http://schemas.openxmlformats.org/drawingml/2006/main" prst="rect">
+            <a:avLst/>
+          </a:prstGeom>
+          <a:solidFill xmlns:a="http://schemas.openxmlformats.org/drawingml/2006/main">
+            <a:srgbClr val="FEF3C7"/>
+          </a:solidFill>
+          <a:ln xmlns:a="http://schemas.openxmlformats.org/drawingml/2006/main" w="19050">
+            <a:solidFill>
+              <a:srgbClr val="B45309"/>
+            </a:solidFill>
+            <a:prstDash val="solid"/>
+          </a:ln>
+        </p:spPr>
+      </p:sp>
+      <p:sp>
+        <p:nvSpPr>
+          <p:cNvPr id="26" name="">
+            <a:extLst xmlns:a="http://schemas.openxmlformats.org/drawingml/2006/main">
+              <a:ext uri="{FF2B5EF4-FFF2-40B4-BE49-F238E27FC236}">
+                <a16:creationId xmlns:a16="http://schemas.microsoft.com/office/drawing/2014/main" id="{BFDC83D0-E66B-4B55-AD35-4EF933A1885E}"/>
+              </a:ext>
+            </a:extLst>
+          </p:cNvPr>
+          <p:cNvSpPr>
+            <a:spLocks xmlns:a="http://schemas.openxmlformats.org/drawingml/2006/main" noGrp="1"/>
+          </p:cNvSpPr>
+          <p:nvPr/>
+        </p:nvSpPr>
+        <p:spPr>
+          <a:xfrm xmlns:a="http://schemas.openxmlformats.org/drawingml/2006/main">
+            <a:off x="6553200" y="4248150"/>
+            <a:ext cx="4610100" cy="285750"/>
+          </a:xfrm>
+          <a:prstGeom xmlns:a="http://schemas.openxmlformats.org/drawingml/2006/main" prst="rect">
+            <a:avLst/>
+          </a:prstGeom>
+          <a:solidFill xmlns:a="http://schemas.openxmlformats.org/drawingml/2006/main">
+            <a:srgbClr val="000000">
+              <a:alpha val="0"/>
+            </a:srgbClr>
+          </a:solidFill>
+          <a:ln xmlns:a="http://schemas.openxmlformats.org/drawingml/2006/main" w="0">
+            <a:solidFill>
+              <a:srgbClr val="000000">
+                <a:alpha val="0"/>
+              </a:srgbClr>
+            </a:solidFill>
+            <a:prstDash val="solid"/>
+          </a:ln>
+        </p:spPr>
+        <p:txBody>
+          <a:bodyPr xmlns:a="http://schemas.openxmlformats.org/drawingml/2006/main" lIns="0" tIns="0" rIns="0" bIns="0" anchor="t"/>
+          <a:lstStyle xmlns:a="http://schemas.openxmlformats.org/drawingml/2006/main"/>
+          <a:p xmlns:a="http://schemas.openxmlformats.org/drawingml/2006/main">
+            <a:pPr algn="l">
+              <a:defRPr sz="1350" b="1">
+                <a:solidFill>
+                  <a:srgbClr val="0F172A"/>
+                </a:solidFill>
+                <a:latin typeface="Aptos"/>
+                <a:ea typeface="Aptos"/>
+                <a:cs typeface="Aptos"/>
+              </a:defRPr>
+            </a:pPr>
+            <a:r>
+              <a:rPr sz="1350" b="1">
+                <a:solidFill>
+                  <a:srgbClr val="0F172A"/>
+                </a:solidFill>
+                <a:latin typeface="Aptos"/>
+                <a:ea typeface="Aptos"/>
+                <a:cs typeface="Aptos"/>
+              </a:rPr>
+              <a:t>Next measured field proof</a:t>
+            </a:r>
+          </a:p>
+        </p:txBody>
+      </p:sp>
+      <p:sp>
+        <p:nvSpPr>
+          <p:cNvPr id="27" name="">
+            <a:extLst xmlns:a="http://schemas.openxmlformats.org/drawingml/2006/main">
+              <a:ext uri="{FF2B5EF4-FFF2-40B4-BE49-F238E27FC236}">
+                <a16:creationId xmlns:a16="http://schemas.microsoft.com/office/drawing/2014/main" id="{87BCBDFE-42B3-4E2A-97A2-53A1761B202F}"/>
+              </a:ext>
+            </a:extLst>
+          </p:cNvPr>
+          <p:cNvSpPr>
+            <a:spLocks xmlns:a="http://schemas.openxmlformats.org/drawingml/2006/main" noGrp="1"/>
+          </p:cNvSpPr>
+          <p:nvPr/>
+        </p:nvSpPr>
+        <p:spPr>
+          <a:xfrm xmlns:a="http://schemas.openxmlformats.org/drawingml/2006/main">
+            <a:off x="6553200" y="4591050"/>
+            <a:ext cx="4610100" cy="457200"/>
+          </a:xfrm>
+          <a:prstGeom xmlns:a="http://schemas.openxmlformats.org/drawingml/2006/main" prst="rect">
+            <a:avLst/>
+          </a:prstGeom>
+          <a:solidFill xmlns:a="http://schemas.openxmlformats.org/drawingml/2006/main">
+            <a:srgbClr val="000000">
+              <a:alpha val="0"/>
+            </a:srgbClr>
+          </a:solidFill>
+          <a:ln xmlns:a="http://schemas.openxmlformats.org/drawingml/2006/main" w="0">
+            <a:solidFill>
+              <a:srgbClr val="000000">
+                <a:alpha val="0"/>
+              </a:srgbClr>
+            </a:solidFill>
+            <a:prstDash val="solid"/>
+          </a:ln>
+        </p:spPr>
+        <p:txBody>
+          <a:bodyPr xmlns:a="http://schemas.openxmlformats.org/drawingml/2006/main" lIns="0" tIns="0" rIns="0" bIns="0" anchor="t"/>
+          <a:lstStyle xmlns:a="http://schemas.openxmlformats.org/drawingml/2006/main"/>
+          <a:p xmlns:a="http://schemas.openxmlformats.org/drawingml/2006/main">
+            <a:pPr algn="l">
+              <a:defRPr sz="900" b="0">
+                <a:solidFill>
+                  <a:srgbClr val="334155"/>
+                </a:solidFill>
+                <a:latin typeface="Aptos"/>
+                <a:ea typeface="Aptos"/>
+                <a:cs typeface="Aptos"/>
+              </a:defRPr>
+            </a:pPr>
+            <a:r>
+              <a:rPr sz="900" b="0">
+                <a:solidFill>
+                  <a:srgbClr val="334155"/>
+                </a:solidFill>
+                <a:latin typeface="Aptos"/>
+                <a:ea typeface="Aptos"/>
+                <a:cs typeface="Aptos"/>
+              </a:rPr>
+              <a:t>Physical water probes, solar energy budget, battery autonomy, range, and regional spectrum approval.</a:t>
+            </a:r>
+          </a:p>
+        </p:txBody>
+      </p:sp>
+      <p:sp>
+        <p:nvSpPr>
+          <p:cNvPr id="28" name="">
+            <a:extLst xmlns:a="http://schemas.openxmlformats.org/drawingml/2006/main">
+              <a:ext uri="{FF2B5EF4-FFF2-40B4-BE49-F238E27FC236}">
+                <a16:creationId xmlns:a16="http://schemas.microsoft.com/office/drawing/2014/main" id="{EF6490B2-E3A5-488D-A0AC-B750E424E95E}"/>
               </a:ext>
             </a:extLst>
           </p:cNvPr>
@@ -11557,10 +11782,10 @@
       </p:sp>
       <p:sp>
         <p:nvSpPr>
-          <p:cNvPr id="25" name="">
-            <a:extLst xmlns:a="http://schemas.openxmlformats.org/drawingml/2006/main">
-              <a:ext uri="{FF2B5EF4-FFF2-40B4-BE49-F238E27FC236}">
-                <a16:creationId xmlns:a16="http://schemas.microsoft.com/office/drawing/2014/main" id="{D75795DD-D81C-49FC-9676-4D7895AC2FC6}"/>
+          <p:cNvPr id="29" name="">
+            <a:extLst xmlns:a="http://schemas.openxmlformats.org/drawingml/2006/main">
+              <a:ext uri="{FF2B5EF4-FFF2-40B4-BE49-F238E27FC236}">
+                <a16:creationId xmlns:a16="http://schemas.microsoft.com/office/drawing/2014/main" id="{E205F970-B233-48D6-B6DE-FBEDC59D9AC8}"/>
               </a:ext>
             </a:extLst>
           </p:cNvPr>
@@ -11622,7 +11847,7 @@
     </p:spTree>
     <p:extLst>
       <p:ext uri="{BB962C8B-B14F-4D97-AF65-F5344CB8AC3E}">
-        <p14:creationId xmlns:p14="http://schemas.microsoft.com/office/powerpoint/2010/main" val="634122266"/>
+        <p14:creationId xmlns:p14="http://schemas.microsoft.com/office/powerpoint/2010/main" val="1919270827"/>
       </p:ext>
     </p:extLst>
   </p:cSld>
@@ -11646,7 +11871,7 @@
           <p:cNvPr id="1" name="">
             <a:extLst xmlns:a="http://schemas.openxmlformats.org/drawingml/2006/main">
               <a:ext uri="{FF2B5EF4-FFF2-40B4-BE49-F238E27FC236}">
-                <a16:creationId xmlns:a16="http://schemas.microsoft.com/office/drawing/2014/main" id="{D079E3D4-54CE-48A3-A5F6-3F8693990864}"/>
+                <a16:creationId xmlns:a16="http://schemas.microsoft.com/office/drawing/2014/main" id="{A41E26F2-A41B-407F-B9B3-5423A6B26512}"/>
               </a:ext>
             </a:extLst>
           </p:cNvPr>
@@ -11681,7 +11906,7 @@
           <p:cNvPr id="2" name="">
             <a:extLst xmlns:a="http://schemas.openxmlformats.org/drawingml/2006/main">
               <a:ext uri="{FF2B5EF4-FFF2-40B4-BE49-F238E27FC236}">
-                <a16:creationId xmlns:a16="http://schemas.microsoft.com/office/drawing/2014/main" id="{54A2797E-7B67-4AEA-B9CC-E6F56B2B90A5}"/>
+                <a16:creationId xmlns:a16="http://schemas.microsoft.com/office/drawing/2014/main" id="{2AFF3448-DB05-4168-A854-00BE51BA8DF1}"/>
               </a:ext>
             </a:extLst>
           </p:cNvPr>
@@ -11716,7 +11941,7 @@
           <p:cNvPr id="3" name="">
             <a:extLst xmlns:a="http://schemas.openxmlformats.org/drawingml/2006/main">
               <a:ext uri="{FF2B5EF4-FFF2-40B4-BE49-F238E27FC236}">
-                <a16:creationId xmlns:a16="http://schemas.microsoft.com/office/drawing/2014/main" id="{D8668E27-AE05-4B66-B74C-EB3E742CF33C}"/>
+                <a16:creationId xmlns:a16="http://schemas.microsoft.com/office/drawing/2014/main" id="{7BAAF073-A141-4046-BCFE-84137A814245}"/>
               </a:ext>
             </a:extLst>
           </p:cNvPr>
@@ -11780,7 +12005,7 @@
           <p:cNvPr id="4" name="">
             <a:extLst xmlns:a="http://schemas.openxmlformats.org/drawingml/2006/main">
               <a:ext uri="{FF2B5EF4-FFF2-40B4-BE49-F238E27FC236}">
-                <a16:creationId xmlns:a16="http://schemas.microsoft.com/office/drawing/2014/main" id="{73EC6378-1852-49A8-BEE2-3E43F9E81CE5}"/>
+                <a16:creationId xmlns:a16="http://schemas.microsoft.com/office/drawing/2014/main" id="{6478CDF2-A03E-4387-AD7F-3B9A2B199663}"/>
               </a:ext>
             </a:extLst>
           </p:cNvPr>
@@ -11844,7 +12069,7 @@
           <p:cNvPr id="5" name="">
             <a:extLst xmlns:a="http://schemas.openxmlformats.org/drawingml/2006/main">
               <a:ext uri="{FF2B5EF4-FFF2-40B4-BE49-F238E27FC236}">
-                <a16:creationId xmlns:a16="http://schemas.microsoft.com/office/drawing/2014/main" id="{DE855D9F-CEE8-44A8-A1F6-29B017599EAD}"/>
+                <a16:creationId xmlns:a16="http://schemas.microsoft.com/office/drawing/2014/main" id="{C7DF4545-02AF-4D8B-A8BC-2EB63CF5ADD3}"/>
               </a:ext>
             </a:extLst>
           </p:cNvPr>
@@ -11908,7 +12133,7 @@
           <p:cNvPr id="6" name="">
             <a:extLst xmlns:a="http://schemas.openxmlformats.org/drawingml/2006/main">
               <a:ext uri="{FF2B5EF4-FFF2-40B4-BE49-F238E27FC236}">
-                <a16:creationId xmlns:a16="http://schemas.microsoft.com/office/drawing/2014/main" id="{D74752FA-F73E-4FD1-848A-1A3949C49FAE}"/>
+                <a16:creationId xmlns:a16="http://schemas.microsoft.com/office/drawing/2014/main" id="{AE7EE0A3-4492-4238-9538-57FAC6B77F1D}"/>
               </a:ext>
             </a:extLst>
           </p:cNvPr>
@@ -11972,7 +12197,7 @@
           <p:cNvPr id="7" name="">
             <a:extLst xmlns:a="http://schemas.openxmlformats.org/drawingml/2006/main">
               <a:ext uri="{FF2B5EF4-FFF2-40B4-BE49-F238E27FC236}">
-                <a16:creationId xmlns:a16="http://schemas.microsoft.com/office/drawing/2014/main" id="{A65CF34F-1ACC-4946-9B23-9732FA5ECE91}"/>
+                <a16:creationId xmlns:a16="http://schemas.microsoft.com/office/drawing/2014/main" id="{FCA90F4D-7B4E-400A-9996-BEFCF25664C6}"/>
               </a:ext>
             </a:extLst>
           </p:cNvPr>
@@ -12005,7 +12230,7 @@
           <p:cNvPr id="8" name="">
             <a:extLst xmlns:a="http://schemas.openxmlformats.org/drawingml/2006/main">
               <a:ext uri="{FF2B5EF4-FFF2-40B4-BE49-F238E27FC236}">
-                <a16:creationId xmlns:a16="http://schemas.microsoft.com/office/drawing/2014/main" id="{E0519B6D-135E-4A5D-BEB8-5E003B9BEFB3}"/>
+                <a16:creationId xmlns:a16="http://schemas.microsoft.com/office/drawing/2014/main" id="{DDC99539-D27B-431D-9B02-4A15D2EE8C89}"/>
               </a:ext>
             </a:extLst>
           </p:cNvPr>
@@ -12069,7 +12294,7 @@
           <p:cNvPr id="9" name="">
             <a:extLst xmlns:a="http://schemas.openxmlformats.org/drawingml/2006/main">
               <a:ext uri="{FF2B5EF4-FFF2-40B4-BE49-F238E27FC236}">
-                <a16:creationId xmlns:a16="http://schemas.microsoft.com/office/drawing/2014/main" id="{D2159217-EDAA-4F97-93EC-A265F44EB446}"/>
+                <a16:creationId xmlns:a16="http://schemas.microsoft.com/office/drawing/2014/main" id="{E4DB69A7-FB12-4EC7-88D4-140E35616DD3}"/>
               </a:ext>
             </a:extLst>
           </p:cNvPr>
@@ -12133,7 +12358,7 @@
           <p:cNvPr id="10" name="">
             <a:extLst xmlns:a="http://schemas.openxmlformats.org/drawingml/2006/main">
               <a:ext uri="{FF2B5EF4-FFF2-40B4-BE49-F238E27FC236}">
-                <a16:creationId xmlns:a16="http://schemas.microsoft.com/office/drawing/2014/main" id="{0293AC2D-6F0F-4CA2-A641-155468DC23B8}"/>
+                <a16:creationId xmlns:a16="http://schemas.microsoft.com/office/drawing/2014/main" id="{2007464A-6C7A-4D7C-ACDD-70BC4A794425}"/>
               </a:ext>
             </a:extLst>
           </p:cNvPr>
@@ -12166,7 +12391,7 @@
           <p:cNvPr id="11" name="">
             <a:extLst xmlns:a="http://schemas.openxmlformats.org/drawingml/2006/main">
               <a:ext uri="{FF2B5EF4-FFF2-40B4-BE49-F238E27FC236}">
-                <a16:creationId xmlns:a16="http://schemas.microsoft.com/office/drawing/2014/main" id="{0F595E83-B9F7-4728-90F8-1BCE046EF76C}"/>
+                <a16:creationId xmlns:a16="http://schemas.microsoft.com/office/drawing/2014/main" id="{0839306C-DCED-4E1E-84DD-D8C6BE769F29}"/>
               </a:ext>
             </a:extLst>
           </p:cNvPr>
@@ -12230,7 +12455,7 @@
           <p:cNvPr id="12" name="">
             <a:extLst xmlns:a="http://schemas.openxmlformats.org/drawingml/2006/main">
               <a:ext uri="{FF2B5EF4-FFF2-40B4-BE49-F238E27FC236}">
-                <a16:creationId xmlns:a16="http://schemas.microsoft.com/office/drawing/2014/main" id="{90D18344-FD28-44F8-929D-70D0BD7F4B61}"/>
+                <a16:creationId xmlns:a16="http://schemas.microsoft.com/office/drawing/2014/main" id="{AD7F444B-A3A2-41B7-BA71-E1E4658BDFC0}"/>
               </a:ext>
             </a:extLst>
           </p:cNvPr>
@@ -12294,7 +12519,7 @@
           <p:cNvPr id="13" name="">
             <a:extLst xmlns:a="http://schemas.openxmlformats.org/drawingml/2006/main">
               <a:ext uri="{FF2B5EF4-FFF2-40B4-BE49-F238E27FC236}">
-                <a16:creationId xmlns:a16="http://schemas.microsoft.com/office/drawing/2014/main" id="{0539FEFE-95D6-4434-B92F-B43539B0B62E}"/>
+                <a16:creationId xmlns:a16="http://schemas.microsoft.com/office/drawing/2014/main" id="{29148609-0F2C-49B5-9805-EAD387A9C984}"/>
               </a:ext>
             </a:extLst>
           </p:cNvPr>
@@ -12327,7 +12552,7 @@
           <p:cNvPr id="14" name="">
             <a:extLst xmlns:a="http://schemas.openxmlformats.org/drawingml/2006/main">
               <a:ext uri="{FF2B5EF4-FFF2-40B4-BE49-F238E27FC236}">
-                <a16:creationId xmlns:a16="http://schemas.microsoft.com/office/drawing/2014/main" id="{F8E83596-721F-469F-B6D9-E335224D0E20}"/>
+                <a16:creationId xmlns:a16="http://schemas.microsoft.com/office/drawing/2014/main" id="{1F39CEAC-0ABC-441F-80E4-9E2C3162625B}"/>
               </a:ext>
             </a:extLst>
           </p:cNvPr>
@@ -12391,7 +12616,7 @@
           <p:cNvPr id="15" name="">
             <a:extLst xmlns:a="http://schemas.openxmlformats.org/drawingml/2006/main">
               <a:ext uri="{FF2B5EF4-FFF2-40B4-BE49-F238E27FC236}">
-                <a16:creationId xmlns:a16="http://schemas.microsoft.com/office/drawing/2014/main" id="{2CEB2275-C2BB-4756-AD32-699DA2985CF1}"/>
+                <a16:creationId xmlns:a16="http://schemas.microsoft.com/office/drawing/2014/main" id="{BD25B666-1EF1-426C-91B0-1DD18D94E1B6}"/>
               </a:ext>
             </a:extLst>
           </p:cNvPr>
@@ -12455,7 +12680,7 @@
           <p:cNvPr id="16" name="">
             <a:extLst xmlns:a="http://schemas.openxmlformats.org/drawingml/2006/main">
               <a:ext uri="{FF2B5EF4-FFF2-40B4-BE49-F238E27FC236}">
-                <a16:creationId xmlns:a16="http://schemas.microsoft.com/office/drawing/2014/main" id="{14279AFD-5A66-4007-AD07-A7DD86659871}"/>
+                <a16:creationId xmlns:a16="http://schemas.microsoft.com/office/drawing/2014/main" id="{67C924B0-76D0-4D4F-92DE-96A6DA3CC3C8}"/>
               </a:ext>
             </a:extLst>
           </p:cNvPr>
@@ -12519,7 +12744,7 @@
           <p:cNvPr id="17" name="">
             <a:extLst xmlns:a="http://schemas.openxmlformats.org/drawingml/2006/main">
               <a:ext uri="{FF2B5EF4-FFF2-40B4-BE49-F238E27FC236}">
-                <a16:creationId xmlns:a16="http://schemas.microsoft.com/office/drawing/2014/main" id="{2DC07A1A-1B26-4DAF-9912-FD37A8647BAE}"/>
+                <a16:creationId xmlns:a16="http://schemas.microsoft.com/office/drawing/2014/main" id="{47E8CA41-C5C0-42FB-8E14-2B9DD42A7BD7}"/>
               </a:ext>
             </a:extLst>
           </p:cNvPr>
@@ -12581,7 +12806,7 @@
     </p:spTree>
     <p:extLst>
       <p:ext uri="{BB962C8B-B14F-4D97-AF65-F5344CB8AC3E}">
-        <p14:creationId xmlns:p14="http://schemas.microsoft.com/office/powerpoint/2010/main" val="904924263"/>
+        <p14:creationId xmlns:p14="http://schemas.microsoft.com/office/powerpoint/2010/main" val="1491965324"/>
       </p:ext>
     </p:extLst>
   </p:cSld>
@@ -12605,7 +12830,7 @@
           <p:cNvPr id="1" name="">
             <a:extLst xmlns:a="http://schemas.openxmlformats.org/drawingml/2006/main">
               <a:ext uri="{FF2B5EF4-FFF2-40B4-BE49-F238E27FC236}">
-                <a16:creationId xmlns:a16="http://schemas.microsoft.com/office/drawing/2014/main" id="{B1E18092-D764-4547-9037-EEBC0F6A6AB1}"/>
+                <a16:creationId xmlns:a16="http://schemas.microsoft.com/office/drawing/2014/main" id="{184ED88F-CCC4-434D-80DC-1797FA5CDCF5}"/>
               </a:ext>
             </a:extLst>
           </p:cNvPr>
@@ -12640,7 +12865,7 @@
           <p:cNvPr id="2" name="">
             <a:extLst xmlns:a="http://schemas.openxmlformats.org/drawingml/2006/main">
               <a:ext uri="{FF2B5EF4-FFF2-40B4-BE49-F238E27FC236}">
-                <a16:creationId xmlns:a16="http://schemas.microsoft.com/office/drawing/2014/main" id="{283FD013-4B4D-4FC1-8A9A-27E50EA9C5EB}"/>
+                <a16:creationId xmlns:a16="http://schemas.microsoft.com/office/drawing/2014/main" id="{EB0B9326-59AB-4248-B212-89DF9C703C81}"/>
               </a:ext>
             </a:extLst>
           </p:cNvPr>
@@ -12675,7 +12900,7 @@
           <p:cNvPr id="3" name="">
             <a:extLst xmlns:a="http://schemas.openxmlformats.org/drawingml/2006/main">
               <a:ext uri="{FF2B5EF4-FFF2-40B4-BE49-F238E27FC236}">
-                <a16:creationId xmlns:a16="http://schemas.microsoft.com/office/drawing/2014/main" id="{4E43FCF6-05BD-4F82-BD2E-E53824BABE7E}"/>
+                <a16:creationId xmlns:a16="http://schemas.microsoft.com/office/drawing/2014/main" id="{50D40FDE-1493-4017-B263-7B7EAFF3C3F6}"/>
               </a:ext>
             </a:extLst>
           </p:cNvPr>
@@ -12739,7 +12964,7 @@
           <p:cNvPr id="4" name="">
             <a:extLst xmlns:a="http://schemas.openxmlformats.org/drawingml/2006/main">
               <a:ext uri="{FF2B5EF4-FFF2-40B4-BE49-F238E27FC236}">
-                <a16:creationId xmlns:a16="http://schemas.microsoft.com/office/drawing/2014/main" id="{8CFC3359-D77F-44E3-A990-4BF4612BA61B}"/>
+                <a16:creationId xmlns:a16="http://schemas.microsoft.com/office/drawing/2014/main" id="{7A9DD8DE-CA1B-4041-87A1-59B9EFA4F1D2}"/>
               </a:ext>
             </a:extLst>
           </p:cNvPr>
@@ -12803,7 +13028,7 @@
           <p:cNvPr id="5" name="">
             <a:extLst xmlns:a="http://schemas.openxmlformats.org/drawingml/2006/main">
               <a:ext uri="{FF2B5EF4-FFF2-40B4-BE49-F238E27FC236}">
-                <a16:creationId xmlns:a16="http://schemas.microsoft.com/office/drawing/2014/main" id="{66A3480E-A91C-4157-8F57-125DCE069541}"/>
+                <a16:creationId xmlns:a16="http://schemas.microsoft.com/office/drawing/2014/main" id="{A39A65FA-DEF6-4B64-A46C-A800FED85853}"/>
               </a:ext>
             </a:extLst>
           </p:cNvPr>
@@ -12857,7 +13082,7 @@
                 <a:ea typeface="Aptos Display"/>
                 <a:cs typeface="Aptos Display"/>
               </a:rPr>
-              <a:t>Local Gemma 4 already powers the real Sagents runtime</a:t>
+              <a:t>Self-hosted Gemma keeps reasoning on the farm</a:t>
             </a:r>
           </a:p>
         </p:txBody>
@@ -12867,7 +13092,7 @@
           <p:cNvPr id="6" name="">
             <a:extLst xmlns:a="http://schemas.openxmlformats.org/drawingml/2006/main">
               <a:ext uri="{FF2B5EF4-FFF2-40B4-BE49-F238E27FC236}">
-                <a16:creationId xmlns:a16="http://schemas.microsoft.com/office/drawing/2014/main" id="{1CFA3573-77A5-49C0-9794-EA4858FD15EA}"/>
+                <a16:creationId xmlns:a16="http://schemas.microsoft.com/office/drawing/2014/main" id="{1FCC88EA-2D23-4BFF-87FD-B7DE6379F14E}"/>
               </a:ext>
             </a:extLst>
           </p:cNvPr>
@@ -12921,7 +13146,7 @@
                 <a:ea typeface="Aptos"/>
                 <a:cs typeface="Aptos"/>
               </a:rPr>
-              <a:t>E2B proves the loop offline through the same portable GEMMA_ENDPOINT contract.</a:t>
+              <a:t>The radios move field data; a separate edge computer runs AI and deterministic safety without cloud access.</a:t>
             </a:r>
           </a:p>
         </p:txBody>
@@ -12931,7 +13156,7 @@
           <p:cNvPr id="7" name="">
             <a:extLst xmlns:a="http://schemas.openxmlformats.org/drawingml/2006/main">
               <a:ext uri="{FF2B5EF4-FFF2-40B4-BE49-F238E27FC236}">
-                <a16:creationId xmlns:a16="http://schemas.microsoft.com/office/drawing/2014/main" id="{A1635FE6-9466-4CC1-B495-AF2D1CAB5243}"/>
+                <a16:creationId xmlns:a16="http://schemas.microsoft.com/office/drawing/2014/main" id="{C56D4043-7273-4A76-9C80-C01813F439B6}"/>
               </a:ext>
             </a:extLst>
           </p:cNvPr>
@@ -12964,7 +13189,7 @@
           <p:cNvPr id="8" name="">
             <a:extLst xmlns:a="http://schemas.openxmlformats.org/drawingml/2006/main">
               <a:ext uri="{FF2B5EF4-FFF2-40B4-BE49-F238E27FC236}">
-                <a16:creationId xmlns:a16="http://schemas.microsoft.com/office/drawing/2014/main" id="{4AB98E3E-A13F-469C-B4F1-0FA20D2B5EC9}"/>
+                <a16:creationId xmlns:a16="http://schemas.microsoft.com/office/drawing/2014/main" id="{7A17890D-686F-4906-96E7-2B3A49D16C44}"/>
               </a:ext>
             </a:extLst>
           </p:cNvPr>
@@ -13028,7 +13253,7 @@
           <p:cNvPr id="9" name="">
             <a:extLst xmlns:a="http://schemas.openxmlformats.org/drawingml/2006/main">
               <a:ext uri="{FF2B5EF4-FFF2-40B4-BE49-F238E27FC236}">
-                <a16:creationId xmlns:a16="http://schemas.microsoft.com/office/drawing/2014/main" id="{8A811FB8-E597-4EF3-BAF8-7393A8CC88D4}"/>
+                <a16:creationId xmlns:a16="http://schemas.microsoft.com/office/drawing/2014/main" id="{144E4AB5-792D-44A8-9F59-8F994C475842}"/>
               </a:ext>
             </a:extLst>
           </p:cNvPr>
@@ -13092,7 +13317,7 @@
           <p:cNvPr id="10" name="">
             <a:extLst xmlns:a="http://schemas.openxmlformats.org/drawingml/2006/main">
               <a:ext uri="{FF2B5EF4-FFF2-40B4-BE49-F238E27FC236}">
-                <a16:creationId xmlns:a16="http://schemas.microsoft.com/office/drawing/2014/main" id="{67A8C97D-990F-4348-AEF3-A6593542195B}"/>
+                <a16:creationId xmlns:a16="http://schemas.microsoft.com/office/drawing/2014/main" id="{226FC984-B7C0-48EE-B3A8-E2B71803473C}"/>
               </a:ext>
             </a:extLst>
           </p:cNvPr>
@@ -13156,7 +13381,7 @@
           <p:cNvPr id="11" name="">
             <a:extLst xmlns:a="http://schemas.openxmlformats.org/drawingml/2006/main">
               <a:ext uri="{FF2B5EF4-FFF2-40B4-BE49-F238E27FC236}">
-                <a16:creationId xmlns:a16="http://schemas.microsoft.com/office/drawing/2014/main" id="{7E07AC7D-EFEC-4987-8057-7E16119AD1B4}"/>
+                <a16:creationId xmlns:a16="http://schemas.microsoft.com/office/drawing/2014/main" id="{04B02A8B-7E64-4154-AD59-62492BFC7EF5}"/>
               </a:ext>
             </a:extLst>
           </p:cNvPr>
@@ -13189,7 +13414,7 @@
           <p:cNvPr id="12" name="">
             <a:extLst xmlns:a="http://schemas.openxmlformats.org/drawingml/2006/main">
               <a:ext uri="{FF2B5EF4-FFF2-40B4-BE49-F238E27FC236}">
-                <a16:creationId xmlns:a16="http://schemas.microsoft.com/office/drawing/2014/main" id="{48B15D7B-09BE-44C0-BA41-5D35AFC0D6CF}"/>
+                <a16:creationId xmlns:a16="http://schemas.microsoft.com/office/drawing/2014/main" id="{A5FB8AF6-7B2F-47B3-A305-BC2E891A2C0E}"/>
               </a:ext>
             </a:extLst>
           </p:cNvPr>
@@ -13253,7 +13478,7 @@
           <p:cNvPr id="13" name="">
             <a:extLst xmlns:a="http://schemas.openxmlformats.org/drawingml/2006/main">
               <a:ext uri="{FF2B5EF4-FFF2-40B4-BE49-F238E27FC236}">
-                <a16:creationId xmlns:a16="http://schemas.microsoft.com/office/drawing/2014/main" id="{06880A99-52E9-4A65-9F9F-3B2A7D13BF76}"/>
+                <a16:creationId xmlns:a16="http://schemas.microsoft.com/office/drawing/2014/main" id="{812E7F64-76F9-42C0-81E5-BDD42C2C1D58}"/>
               </a:ext>
             </a:extLst>
           </p:cNvPr>
@@ -13317,7 +13542,7 @@
           <p:cNvPr id="14" name="">
             <a:extLst xmlns:a="http://schemas.openxmlformats.org/drawingml/2006/main">
               <a:ext uri="{FF2B5EF4-FFF2-40B4-BE49-F238E27FC236}">
-                <a16:creationId xmlns:a16="http://schemas.microsoft.com/office/drawing/2014/main" id="{5C10FC47-F5CB-495E-9E17-56717AB1EE80}"/>
+                <a16:creationId xmlns:a16="http://schemas.microsoft.com/office/drawing/2014/main" id="{B9648B2C-746A-4DA0-A4D4-FDE960D72ABB}"/>
               </a:ext>
             </a:extLst>
           </p:cNvPr>
@@ -13381,7 +13606,7 @@
           <p:cNvPr id="15" name="">
             <a:extLst xmlns:a="http://schemas.openxmlformats.org/drawingml/2006/main">
               <a:ext uri="{FF2B5EF4-FFF2-40B4-BE49-F238E27FC236}">
-                <a16:creationId xmlns:a16="http://schemas.microsoft.com/office/drawing/2014/main" id="{C2E265B3-5430-490E-8D98-27D4B9AA6514}"/>
+                <a16:creationId xmlns:a16="http://schemas.microsoft.com/office/drawing/2014/main" id="{3F58CE89-9BFD-4024-9BDE-7BDF99EA8869}"/>
               </a:ext>
             </a:extLst>
           </p:cNvPr>
@@ -13414,7 +13639,7 @@
           <p:cNvPr id="16" name="">
             <a:extLst xmlns:a="http://schemas.openxmlformats.org/drawingml/2006/main">
               <a:ext uri="{FF2B5EF4-FFF2-40B4-BE49-F238E27FC236}">
-                <a16:creationId xmlns:a16="http://schemas.microsoft.com/office/drawing/2014/main" id="{2206CE81-FDF2-46F6-9ED6-ECCC6E19D652}"/>
+                <a16:creationId xmlns:a16="http://schemas.microsoft.com/office/drawing/2014/main" id="{6F31BFC6-EA86-45A7-AA63-B1F77C89C34A}"/>
               </a:ext>
             </a:extLst>
           </p:cNvPr>
@@ -13468,7 +13693,7 @@
                 <a:ea typeface="Aptos"/>
                 <a:cs typeface="Aptos"/>
               </a:rPr>
-              <a:t>llama.cpp + Metal</a:t>
+              <a:t>Separate edge runtime</a:t>
             </a:r>
           </a:p>
         </p:txBody>
@@ -13478,7 +13703,7 @@
           <p:cNvPr id="17" name="">
             <a:extLst xmlns:a="http://schemas.openxmlformats.org/drawingml/2006/main">
               <a:ext uri="{FF2B5EF4-FFF2-40B4-BE49-F238E27FC236}">
-                <a16:creationId xmlns:a16="http://schemas.microsoft.com/office/drawing/2014/main" id="{66682C59-638A-4E09-833B-E9B625D10E41}"/>
+                <a16:creationId xmlns:a16="http://schemas.microsoft.com/office/drawing/2014/main" id="{C505430B-4122-4127-B90B-4BB1E5EEB755}"/>
               </a:ext>
             </a:extLst>
           </p:cNvPr>
@@ -13532,7 +13757,7 @@
                 <a:ea typeface="Aptos"/>
                 <a:cs typeface="Aptos"/>
               </a:rPr>
-              <a:t>The smallest Gemma 4 instruction model runs locally and offline after installation.</a:t>
+              <a:t>Gemma 4 E2B runs locally through llama.cpp + Metal. nRF9151 transports data; it does not run Gemma.</a:t>
             </a:r>
           </a:p>
         </p:txBody>
@@ -13542,7 +13767,7 @@
           <p:cNvPr id="18" name="">
             <a:extLst xmlns:a="http://schemas.openxmlformats.org/drawingml/2006/main">
               <a:ext uri="{FF2B5EF4-FFF2-40B4-BE49-F238E27FC236}">
-                <a16:creationId xmlns:a16="http://schemas.microsoft.com/office/drawing/2014/main" id="{F68A4B03-7F92-4830-A187-3BB97910F27A}"/>
+                <a16:creationId xmlns:a16="http://schemas.microsoft.com/office/drawing/2014/main" id="{6809F064-9766-46C9-AF00-7012C8EA00D8}"/>
               </a:ext>
             </a:extLst>
           </p:cNvPr>
@@ -13575,7 +13800,7 @@
           <p:cNvPr id="19" name="">
             <a:extLst xmlns:a="http://schemas.openxmlformats.org/drawingml/2006/main">
               <a:ext uri="{FF2B5EF4-FFF2-40B4-BE49-F238E27FC236}">
-                <a16:creationId xmlns:a16="http://schemas.microsoft.com/office/drawing/2014/main" id="{ADBC181F-F0FA-4885-A685-B8675123CA55}"/>
+                <a16:creationId xmlns:a16="http://schemas.microsoft.com/office/drawing/2014/main" id="{30CC9EB9-88C1-4915-A300-84B171E7E86E}"/>
               </a:ext>
             </a:extLst>
           </p:cNvPr>
@@ -13639,7 +13864,7 @@
           <p:cNvPr id="20" name="">
             <a:extLst xmlns:a="http://schemas.openxmlformats.org/drawingml/2006/main">
               <a:ext uri="{FF2B5EF4-FFF2-40B4-BE49-F238E27FC236}">
-                <a16:creationId xmlns:a16="http://schemas.microsoft.com/office/drawing/2014/main" id="{2FE7D7F7-DAF9-4369-8C56-69941232E569}"/>
+                <a16:creationId xmlns:a16="http://schemas.microsoft.com/office/drawing/2014/main" id="{96344A3E-40B3-4D8C-A381-5CBA77D2504D}"/>
               </a:ext>
             </a:extLst>
           </p:cNvPr>
@@ -13693,7 +13918,7 @@
                 <a:ea typeface="Aptos"/>
                 <a:cs typeface="Aptos"/>
               </a:rPr>
-              <a:t>Local Gemma proposals cannot mutate state without passing deterministic simulator safety rules.</a:t>
+              <a:t>Local Gemma proposals cannot mutate state without deterministic safety. Solar autonomy is a planned power proof, not a current claim.</a:t>
             </a:r>
           </a:p>
         </p:txBody>
@@ -13703,7 +13928,7 @@
           <p:cNvPr id="21" name="">
             <a:extLst xmlns:a="http://schemas.openxmlformats.org/drawingml/2006/main">
               <a:ext uri="{FF2B5EF4-FFF2-40B4-BE49-F238E27FC236}">
-                <a16:creationId xmlns:a16="http://schemas.microsoft.com/office/drawing/2014/main" id="{33C35ACF-BD9A-42F6-B519-33A9DBD31CB6}"/>
+                <a16:creationId xmlns:a16="http://schemas.microsoft.com/office/drawing/2014/main" id="{2D9F15FB-1C35-4AA0-990F-BCA3DF51177D}"/>
               </a:ext>
             </a:extLst>
           </p:cNvPr>
@@ -13767,7 +13992,7 @@
           <p:cNvPr id="22" name="">
             <a:extLst xmlns:a="http://schemas.openxmlformats.org/drawingml/2006/main">
               <a:ext uri="{FF2B5EF4-FFF2-40B4-BE49-F238E27FC236}">
-                <a16:creationId xmlns:a16="http://schemas.microsoft.com/office/drawing/2014/main" id="{CD17102A-7916-4A0A-97B3-00E1C7181724}"/>
+                <a16:creationId xmlns:a16="http://schemas.microsoft.com/office/drawing/2014/main" id="{8D643F94-7F75-40D9-BE1A-FB2F4BB6B68A}"/>
               </a:ext>
             </a:extLst>
           </p:cNvPr>
@@ -13829,7 +14054,7 @@
     </p:spTree>
     <p:extLst>
       <p:ext uri="{BB962C8B-B14F-4D97-AF65-F5344CB8AC3E}">
-        <p14:creationId xmlns:p14="http://schemas.microsoft.com/office/powerpoint/2010/main" val="2096555736"/>
+        <p14:creationId xmlns:p14="http://schemas.microsoft.com/office/powerpoint/2010/main" val="956987174"/>
       </p:ext>
     </p:extLst>
   </p:cSld>

</xml_diff>

<commit_message>
feat: show live agent activity
</commit_message>
<xml_diff>
--- a/submission/proteinloop-hackathon-deck.pptx
+++ b/submission/proteinloop-hackathon-deck.pptx
@@ -2,22 +2,22 @@
 <file path=ppt/presentation.xml><?xml version="1.0" encoding="utf-8"?>
 <p:presentation xmlns:p="http://schemas.openxmlformats.org/presentationml/2006/main">
   <p:sldMasterIdLst>
-    <p:sldMasterId xmlns:r="http://schemas.openxmlformats.org/officeDocument/2006/relationships" id="2147483648" r:id="R98f1f919712c42f9"/>
+    <p:sldMasterId xmlns:r="http://schemas.openxmlformats.org/officeDocument/2006/relationships" id="2147483648" r:id="R91ccda9784b34016"/>
   </p:sldMasterIdLst>
   <p:notesMasterIdLst>
-    <p:notesMasterId xmlns:r="http://schemas.openxmlformats.org/officeDocument/2006/relationships" r:id="R5d6b16586f2b4fae"/>
+    <p:notesMasterId xmlns:r="http://schemas.openxmlformats.org/officeDocument/2006/relationships" r:id="R521f499f918d42ec"/>
   </p:notesMasterIdLst>
   <p:sldIdLst>
-    <p:sldId xmlns:r="http://schemas.openxmlformats.org/officeDocument/2006/relationships" id="256" r:id="Rf81549b35379400b"/>
-    <p:sldId xmlns:r="http://schemas.openxmlformats.org/officeDocument/2006/relationships" id="257" r:id="R0c276de5635b41b5"/>
-    <p:sldId xmlns:r="http://schemas.openxmlformats.org/officeDocument/2006/relationships" id="258" r:id="Re9dd8b8e57d94111"/>
-    <p:sldId xmlns:r="http://schemas.openxmlformats.org/officeDocument/2006/relationships" id="259" r:id="R968268323b4c4ad6"/>
-    <p:sldId xmlns:r="http://schemas.openxmlformats.org/officeDocument/2006/relationships" id="260" r:id="R2e471bef25b74bcf"/>
-    <p:sldId xmlns:r="http://schemas.openxmlformats.org/officeDocument/2006/relationships" id="261" r:id="R606f8f4eca884cc8"/>
-    <p:sldId xmlns:r="http://schemas.openxmlformats.org/officeDocument/2006/relationships" id="262" r:id="Rad966d13c69d4473"/>
-    <p:sldId xmlns:r="http://schemas.openxmlformats.org/officeDocument/2006/relationships" id="263" r:id="Rd9817204d310458d"/>
-    <p:sldId xmlns:r="http://schemas.openxmlformats.org/officeDocument/2006/relationships" id="264" r:id="R72d89ec2ff9749f7"/>
-    <p:sldId xmlns:r="http://schemas.openxmlformats.org/officeDocument/2006/relationships" id="265" r:id="Rb0f26de0b34e4f05"/>
+    <p:sldId xmlns:r="http://schemas.openxmlformats.org/officeDocument/2006/relationships" id="256" r:id="R2d5a30f24505496e"/>
+    <p:sldId xmlns:r="http://schemas.openxmlformats.org/officeDocument/2006/relationships" id="257" r:id="R62d4cee324f44e06"/>
+    <p:sldId xmlns:r="http://schemas.openxmlformats.org/officeDocument/2006/relationships" id="258" r:id="R944f1826d8654272"/>
+    <p:sldId xmlns:r="http://schemas.openxmlformats.org/officeDocument/2006/relationships" id="259" r:id="R8308e117b7b74642"/>
+    <p:sldId xmlns:r="http://schemas.openxmlformats.org/officeDocument/2006/relationships" id="260" r:id="Ra06c9ab110294bc8"/>
+    <p:sldId xmlns:r="http://schemas.openxmlformats.org/officeDocument/2006/relationships" id="261" r:id="Rd11b3b291ea04cfb"/>
+    <p:sldId xmlns:r="http://schemas.openxmlformats.org/officeDocument/2006/relationships" id="262" r:id="Rddfc869470614112"/>
+    <p:sldId xmlns:r="http://schemas.openxmlformats.org/officeDocument/2006/relationships" id="263" r:id="R59e6a83106834c2c"/>
+    <p:sldId xmlns:r="http://schemas.openxmlformats.org/officeDocument/2006/relationships" id="264" r:id="R92c0a5d3033045cb"/>
+    <p:sldId xmlns:r="http://schemas.openxmlformats.org/officeDocument/2006/relationships" id="265" r:id="Rc008e44c0a264e0f"/>
   </p:sldIdLst>
   <p:sldSz cx="12192000" cy="6858000"/>
   <p:notesSz cx="6858000" cy="9144000"/>
@@ -1158,7 +1158,7 @@
   </p:cSld>
   <p:clrMap bg1="lt1" tx1="dk1" bg2="lt2" tx2="dk2" accent1="accent1" accent2="accent2" accent3="accent3" accent4="accent4" accent5="accent5" accent6="accent6" hlink="hlink" folHlink="folHlink"/>
   <p:sldLayoutIdLst>
-    <p:sldLayoutId xmlns:r="http://schemas.openxmlformats.org/officeDocument/2006/relationships" id="2147483649" r:id="Rbf2491285e16493a"/>
+    <p:sldLayoutId xmlns:r="http://schemas.openxmlformats.org/officeDocument/2006/relationships" id="2147483649" r:id="Rb1e56053a168429d"/>
   </p:sldLayoutIdLst>
   <p:txStyles>
     <p:titleStyle>
@@ -1457,7 +1457,7 @@
           <p:cNvPr id="1" name="">
             <a:extLst xmlns:a="http://schemas.openxmlformats.org/drawingml/2006/main">
               <a:ext uri="{FF2B5EF4-FFF2-40B4-BE49-F238E27FC236}">
-                <a16:creationId xmlns:a16="http://schemas.microsoft.com/office/drawing/2014/main" id="{5A99E4D0-7AF8-42CA-A787-7FD97292BF5A}"/>
+                <a16:creationId xmlns:a16="http://schemas.microsoft.com/office/drawing/2014/main" id="{5891BB0B-D7C5-4B8E-9EC0-C5C8D97C9262}"/>
               </a:ext>
             </a:extLst>
           </p:cNvPr>
@@ -1492,7 +1492,7 @@
           <p:cNvPr id="2" name="">
             <a:extLst xmlns:a="http://schemas.openxmlformats.org/drawingml/2006/main">
               <a:ext uri="{FF2B5EF4-FFF2-40B4-BE49-F238E27FC236}">
-                <a16:creationId xmlns:a16="http://schemas.microsoft.com/office/drawing/2014/main" id="{957A21FA-9D9F-4E39-A8EA-F20FD3607FDD}"/>
+                <a16:creationId xmlns:a16="http://schemas.microsoft.com/office/drawing/2014/main" id="{23C99B3D-C99A-483F-B230-97C5123210A5}"/>
               </a:ext>
             </a:extLst>
           </p:cNvPr>
@@ -1527,7 +1527,7 @@
           <p:cNvPr id="3" name="">
             <a:extLst xmlns:a="http://schemas.openxmlformats.org/drawingml/2006/main">
               <a:ext uri="{FF2B5EF4-FFF2-40B4-BE49-F238E27FC236}">
-                <a16:creationId xmlns:a16="http://schemas.microsoft.com/office/drawing/2014/main" id="{034DC44D-AC61-4173-954A-EA3D545D5339}"/>
+                <a16:creationId xmlns:a16="http://schemas.microsoft.com/office/drawing/2014/main" id="{DD40F4E5-658B-4927-B9D4-970803357602}"/>
               </a:ext>
             </a:extLst>
           </p:cNvPr>
@@ -1591,7 +1591,7 @@
           <p:cNvPr id="4" name="">
             <a:extLst xmlns:a="http://schemas.openxmlformats.org/drawingml/2006/main">
               <a:ext uri="{FF2B5EF4-FFF2-40B4-BE49-F238E27FC236}">
-                <a16:creationId xmlns:a16="http://schemas.microsoft.com/office/drawing/2014/main" id="{DCB3C3DC-9622-4ED5-A8C9-D390B9DC3D2F}"/>
+                <a16:creationId xmlns:a16="http://schemas.microsoft.com/office/drawing/2014/main" id="{025803DB-2DE8-4481-9778-4B0B0A9826C4}"/>
               </a:ext>
             </a:extLst>
           </p:cNvPr>
@@ -1655,7 +1655,7 @@
           <p:cNvPr id="5" name="">
             <a:extLst xmlns:a="http://schemas.openxmlformats.org/drawingml/2006/main">
               <a:ext uri="{FF2B5EF4-FFF2-40B4-BE49-F238E27FC236}">
-                <a16:creationId xmlns:a16="http://schemas.microsoft.com/office/drawing/2014/main" id="{1B6FFAB3-6864-4FA9-BFFB-C23C2019A807}"/>
+                <a16:creationId xmlns:a16="http://schemas.microsoft.com/office/drawing/2014/main" id="{E61BD61C-6FEB-4383-819B-BB6C0D921970}"/>
               </a:ext>
             </a:extLst>
           </p:cNvPr>
@@ -1690,7 +1690,7 @@
           <p:cNvPr id="6" name="">
             <a:extLst xmlns:a="http://schemas.openxmlformats.org/drawingml/2006/main">
               <a:ext uri="{FF2B5EF4-FFF2-40B4-BE49-F238E27FC236}">
-                <a16:creationId xmlns:a16="http://schemas.microsoft.com/office/drawing/2014/main" id="{D7E9172F-6B0B-483B-80F2-805DB7E855CB}"/>
+                <a16:creationId xmlns:a16="http://schemas.microsoft.com/office/drawing/2014/main" id="{21B410A8-4E68-46E8-BEC7-FB5BA26E9A37}"/>
               </a:ext>
             </a:extLst>
           </p:cNvPr>
@@ -1754,7 +1754,7 @@
           <p:cNvPr id="7" name="">
             <a:extLst xmlns:a="http://schemas.openxmlformats.org/drawingml/2006/main">
               <a:ext uri="{FF2B5EF4-FFF2-40B4-BE49-F238E27FC236}">
-                <a16:creationId xmlns:a16="http://schemas.microsoft.com/office/drawing/2014/main" id="{E735EF7C-018D-48BC-9276-BFDDD948A17C}"/>
+                <a16:creationId xmlns:a16="http://schemas.microsoft.com/office/drawing/2014/main" id="{725B5D3D-CF9E-491D-B1CE-5AF5BA6D9DBB}"/>
               </a:ext>
             </a:extLst>
           </p:cNvPr>
@@ -1818,7 +1818,7 @@
           <p:cNvPr id="8" name="">
             <a:extLst xmlns:a="http://schemas.openxmlformats.org/drawingml/2006/main">
               <a:ext uri="{FF2B5EF4-FFF2-40B4-BE49-F238E27FC236}">
-                <a16:creationId xmlns:a16="http://schemas.microsoft.com/office/drawing/2014/main" id="{C0EA1038-7525-45D1-BBD3-4586984B9FB3}"/>
+                <a16:creationId xmlns:a16="http://schemas.microsoft.com/office/drawing/2014/main" id="{F4AC6A7A-72B3-46AB-BD3F-8BFB2EBDD1CF}"/>
               </a:ext>
             </a:extLst>
           </p:cNvPr>
@@ -1853,7 +1853,7 @@
           <p:cNvPr id="9" name="">
             <a:extLst xmlns:a="http://schemas.openxmlformats.org/drawingml/2006/main">
               <a:ext uri="{FF2B5EF4-FFF2-40B4-BE49-F238E27FC236}">
-                <a16:creationId xmlns:a16="http://schemas.microsoft.com/office/drawing/2014/main" id="{E8F641CE-C9E7-4250-AEC5-9B289F150BF5}"/>
+                <a16:creationId xmlns:a16="http://schemas.microsoft.com/office/drawing/2014/main" id="{616FC0D0-033A-4D52-B697-B2F9C84C1770}"/>
               </a:ext>
             </a:extLst>
           </p:cNvPr>
@@ -1917,7 +1917,7 @@
           <p:cNvPr id="10" name="">
             <a:extLst xmlns:a="http://schemas.openxmlformats.org/drawingml/2006/main">
               <a:ext uri="{FF2B5EF4-FFF2-40B4-BE49-F238E27FC236}">
-                <a16:creationId xmlns:a16="http://schemas.microsoft.com/office/drawing/2014/main" id="{5B630906-B504-45F0-8993-72448500DD1D}"/>
+                <a16:creationId xmlns:a16="http://schemas.microsoft.com/office/drawing/2014/main" id="{6C43619F-2866-4ACB-A40D-A59CA397571C}"/>
               </a:ext>
             </a:extLst>
           </p:cNvPr>
@@ -1981,7 +1981,7 @@
           <p:cNvPr id="11" name="">
             <a:extLst xmlns:a="http://schemas.openxmlformats.org/drawingml/2006/main">
               <a:ext uri="{FF2B5EF4-FFF2-40B4-BE49-F238E27FC236}">
-                <a16:creationId xmlns:a16="http://schemas.microsoft.com/office/drawing/2014/main" id="{EA5FD788-B5C8-4929-87A0-F1566A9C5C0F}"/>
+                <a16:creationId xmlns:a16="http://schemas.microsoft.com/office/drawing/2014/main" id="{BA2A2CF8-3238-4C2F-A459-58CDA666F29F}"/>
               </a:ext>
             </a:extLst>
           </p:cNvPr>
@@ -2045,7 +2045,7 @@
           <p:cNvPr id="12" name="">
             <a:extLst xmlns:a="http://schemas.openxmlformats.org/drawingml/2006/main">
               <a:ext uri="{FF2B5EF4-FFF2-40B4-BE49-F238E27FC236}">
-                <a16:creationId xmlns:a16="http://schemas.microsoft.com/office/drawing/2014/main" id="{7023C592-B12D-458C-BE4C-710880B33C4A}"/>
+                <a16:creationId xmlns:a16="http://schemas.microsoft.com/office/drawing/2014/main" id="{A90E7D75-D971-4A48-A328-2D68320F6A74}"/>
               </a:ext>
             </a:extLst>
           </p:cNvPr>
@@ -2080,7 +2080,7 @@
           <p:cNvPr id="13" name="">
             <a:extLst xmlns:a="http://schemas.openxmlformats.org/drawingml/2006/main">
               <a:ext uri="{FF2B5EF4-FFF2-40B4-BE49-F238E27FC236}">
-                <a16:creationId xmlns:a16="http://schemas.microsoft.com/office/drawing/2014/main" id="{6DB29429-620D-4C7A-A33C-0C89E0646F48}"/>
+                <a16:creationId xmlns:a16="http://schemas.microsoft.com/office/drawing/2014/main" id="{BDFF9739-000B-45A4-B144-2D8EEBD05B0F}"/>
               </a:ext>
             </a:extLst>
           </p:cNvPr>
@@ -2144,7 +2144,7 @@
           <p:cNvPr id="14" name="">
             <a:extLst xmlns:a="http://schemas.openxmlformats.org/drawingml/2006/main">
               <a:ext uri="{FF2B5EF4-FFF2-40B4-BE49-F238E27FC236}">
-                <a16:creationId xmlns:a16="http://schemas.microsoft.com/office/drawing/2014/main" id="{E13DE85A-0865-4785-81B0-B1743A787651}"/>
+                <a16:creationId xmlns:a16="http://schemas.microsoft.com/office/drawing/2014/main" id="{BF7F095F-E756-4729-AFC5-7460F8A2E992}"/>
               </a:ext>
             </a:extLst>
           </p:cNvPr>
@@ -2208,7 +2208,7 @@
           <p:cNvPr id="15" name="">
             <a:extLst xmlns:a="http://schemas.openxmlformats.org/drawingml/2006/main">
               <a:ext uri="{FF2B5EF4-FFF2-40B4-BE49-F238E27FC236}">
-                <a16:creationId xmlns:a16="http://schemas.microsoft.com/office/drawing/2014/main" id="{2F6688A9-0E7E-4D36-B708-F22297B2D9FC}"/>
+                <a16:creationId xmlns:a16="http://schemas.microsoft.com/office/drawing/2014/main" id="{A311CEC6-443E-4CA5-80C8-62EA4B708324}"/>
               </a:ext>
             </a:extLst>
           </p:cNvPr>
@@ -2272,7 +2272,7 @@
           <p:cNvPr id="16" name="">
             <a:extLst xmlns:a="http://schemas.openxmlformats.org/drawingml/2006/main">
               <a:ext uri="{FF2B5EF4-FFF2-40B4-BE49-F238E27FC236}">
-                <a16:creationId xmlns:a16="http://schemas.microsoft.com/office/drawing/2014/main" id="{0ED77FB6-66D2-4F85-8A0D-8A5924EA5C57}"/>
+                <a16:creationId xmlns:a16="http://schemas.microsoft.com/office/drawing/2014/main" id="{2FAC804E-6449-4365-A6F1-0390A324B413}"/>
               </a:ext>
             </a:extLst>
           </p:cNvPr>
@@ -2307,7 +2307,7 @@
           <p:cNvPr id="17" name="">
             <a:extLst xmlns:a="http://schemas.openxmlformats.org/drawingml/2006/main">
               <a:ext uri="{FF2B5EF4-FFF2-40B4-BE49-F238E27FC236}">
-                <a16:creationId xmlns:a16="http://schemas.microsoft.com/office/drawing/2014/main" id="{F936987D-414B-4658-8FE0-5114A889EBB4}"/>
+                <a16:creationId xmlns:a16="http://schemas.microsoft.com/office/drawing/2014/main" id="{04E28969-AA0A-4F9B-8B92-5A16BB0A6095}"/>
               </a:ext>
             </a:extLst>
           </p:cNvPr>
@@ -2371,7 +2371,7 @@
           <p:cNvPr id="18" name="">
             <a:extLst xmlns:a="http://schemas.openxmlformats.org/drawingml/2006/main">
               <a:ext uri="{FF2B5EF4-FFF2-40B4-BE49-F238E27FC236}">
-                <a16:creationId xmlns:a16="http://schemas.microsoft.com/office/drawing/2014/main" id="{FA65987C-A073-4274-ACED-A1BB8BB50097}"/>
+                <a16:creationId xmlns:a16="http://schemas.microsoft.com/office/drawing/2014/main" id="{20739BDF-D9E7-4D26-A9F9-18D689EBE19B}"/>
               </a:ext>
             </a:extLst>
           </p:cNvPr>
@@ -2435,7 +2435,7 @@
           <p:cNvPr id="19" name="">
             <a:extLst xmlns:a="http://schemas.openxmlformats.org/drawingml/2006/main">
               <a:ext uri="{FF2B5EF4-FFF2-40B4-BE49-F238E27FC236}">
-                <a16:creationId xmlns:a16="http://schemas.microsoft.com/office/drawing/2014/main" id="{A12C15E4-1F87-4589-BC3C-4EF6C31333B3}"/>
+                <a16:creationId xmlns:a16="http://schemas.microsoft.com/office/drawing/2014/main" id="{01906687-04D0-4CB4-AFBA-BDC61CC5FAE6}"/>
               </a:ext>
             </a:extLst>
           </p:cNvPr>
@@ -2499,7 +2499,7 @@
           <p:cNvPr id="20" name="">
             <a:extLst xmlns:a="http://schemas.openxmlformats.org/drawingml/2006/main">
               <a:ext uri="{FF2B5EF4-FFF2-40B4-BE49-F238E27FC236}">
-                <a16:creationId xmlns:a16="http://schemas.microsoft.com/office/drawing/2014/main" id="{4AC4B596-7EA2-4FF3-9532-7ED6CF214233}"/>
+                <a16:creationId xmlns:a16="http://schemas.microsoft.com/office/drawing/2014/main" id="{5CCF3279-136D-4355-8D49-FA38E6FA3EE7}"/>
               </a:ext>
             </a:extLst>
           </p:cNvPr>
@@ -2655,7 +2655,7 @@
           <p:cNvPr id="21" name="">
             <a:extLst xmlns:a="http://schemas.openxmlformats.org/drawingml/2006/main">
               <a:ext uri="{FF2B5EF4-FFF2-40B4-BE49-F238E27FC236}">
-                <a16:creationId xmlns:a16="http://schemas.microsoft.com/office/drawing/2014/main" id="{6BFF9D84-3B53-433F-A036-94B76CA29A79}"/>
+                <a16:creationId xmlns:a16="http://schemas.microsoft.com/office/drawing/2014/main" id="{B599B230-0484-4250-895C-FDABEBCE2FF9}"/>
               </a:ext>
             </a:extLst>
           </p:cNvPr>
@@ -2719,7 +2719,7 @@
           <p:cNvPr id="22" name="">
             <a:extLst xmlns:a="http://schemas.openxmlformats.org/drawingml/2006/main">
               <a:ext uri="{FF2B5EF4-FFF2-40B4-BE49-F238E27FC236}">
-                <a16:creationId xmlns:a16="http://schemas.microsoft.com/office/drawing/2014/main" id="{439B5598-4221-4E38-9CEF-1DF63FB403C1}"/>
+                <a16:creationId xmlns:a16="http://schemas.microsoft.com/office/drawing/2014/main" id="{25D5E766-CB83-4856-B4EB-4F9E44803112}"/>
               </a:ext>
             </a:extLst>
           </p:cNvPr>
@@ -2781,7 +2781,7 @@
     </p:spTree>
     <p:extLst>
       <p:ext uri="{BB962C8B-B14F-4D97-AF65-F5344CB8AC3E}">
-        <p14:creationId xmlns:p14="http://schemas.microsoft.com/office/powerpoint/2010/main" val="2107187446"/>
+        <p14:creationId xmlns:p14="http://schemas.microsoft.com/office/powerpoint/2010/main" val="1260778574"/>
       </p:ext>
     </p:extLst>
   </p:cSld>
@@ -2805,7 +2805,7 @@
           <p:cNvPr id="1" name="">
             <a:extLst xmlns:a="http://schemas.openxmlformats.org/drawingml/2006/main">
               <a:ext uri="{FF2B5EF4-FFF2-40B4-BE49-F238E27FC236}">
-                <a16:creationId xmlns:a16="http://schemas.microsoft.com/office/drawing/2014/main" id="{348EB53D-4B37-479F-A477-F1C3A14653B9}"/>
+                <a16:creationId xmlns:a16="http://schemas.microsoft.com/office/drawing/2014/main" id="{04727C4F-203A-49FB-A118-20356E4F2C83}"/>
               </a:ext>
             </a:extLst>
           </p:cNvPr>
@@ -2840,7 +2840,7 @@
           <p:cNvPr id="2" name="">
             <a:extLst xmlns:a="http://schemas.openxmlformats.org/drawingml/2006/main">
               <a:ext uri="{FF2B5EF4-FFF2-40B4-BE49-F238E27FC236}">
-                <a16:creationId xmlns:a16="http://schemas.microsoft.com/office/drawing/2014/main" id="{1DAC4F58-0E08-4CF3-AB02-46EE2D420E34}"/>
+                <a16:creationId xmlns:a16="http://schemas.microsoft.com/office/drawing/2014/main" id="{D8DD2FB7-8D5B-4C21-A32D-73F1D245E195}"/>
               </a:ext>
             </a:extLst>
           </p:cNvPr>
@@ -2875,7 +2875,7 @@
           <p:cNvPr id="3" name="">
             <a:extLst xmlns:a="http://schemas.openxmlformats.org/drawingml/2006/main">
               <a:ext uri="{FF2B5EF4-FFF2-40B4-BE49-F238E27FC236}">
-                <a16:creationId xmlns:a16="http://schemas.microsoft.com/office/drawing/2014/main" id="{A3A9D4CC-976D-4419-B9B0-A994C6E74993}"/>
+                <a16:creationId xmlns:a16="http://schemas.microsoft.com/office/drawing/2014/main" id="{4033E743-DB82-463C-9353-E6CDDE8914B1}"/>
               </a:ext>
             </a:extLst>
           </p:cNvPr>
@@ -2939,7 +2939,7 @@
           <p:cNvPr id="4" name="">
             <a:extLst xmlns:a="http://schemas.openxmlformats.org/drawingml/2006/main">
               <a:ext uri="{FF2B5EF4-FFF2-40B4-BE49-F238E27FC236}">
-                <a16:creationId xmlns:a16="http://schemas.microsoft.com/office/drawing/2014/main" id="{BBA13743-1DEB-4235-BC42-2BEA519DA002}"/>
+                <a16:creationId xmlns:a16="http://schemas.microsoft.com/office/drawing/2014/main" id="{EA5967A8-2656-4195-9DB1-1236810ED711}"/>
               </a:ext>
             </a:extLst>
           </p:cNvPr>
@@ -3003,7 +3003,7 @@
           <p:cNvPr id="5" name="">
             <a:extLst xmlns:a="http://schemas.openxmlformats.org/drawingml/2006/main">
               <a:ext uri="{FF2B5EF4-FFF2-40B4-BE49-F238E27FC236}">
-                <a16:creationId xmlns:a16="http://schemas.microsoft.com/office/drawing/2014/main" id="{541ECFCF-975C-4177-807A-F2A8B244B263}"/>
+                <a16:creationId xmlns:a16="http://schemas.microsoft.com/office/drawing/2014/main" id="{3E762D85-D03B-4A1E-8A22-BF05FFE112DD}"/>
               </a:ext>
             </a:extLst>
           </p:cNvPr>
@@ -3067,7 +3067,7 @@
           <p:cNvPr id="6" name="">
             <a:extLst xmlns:a="http://schemas.openxmlformats.org/drawingml/2006/main">
               <a:ext uri="{FF2B5EF4-FFF2-40B4-BE49-F238E27FC236}">
-                <a16:creationId xmlns:a16="http://schemas.microsoft.com/office/drawing/2014/main" id="{A2307B97-ED44-4883-A823-607706CAA542}"/>
+                <a16:creationId xmlns:a16="http://schemas.microsoft.com/office/drawing/2014/main" id="{105BEC43-68C0-4644-89B3-0C4160A2BCA9}"/>
               </a:ext>
             </a:extLst>
           </p:cNvPr>
@@ -3131,7 +3131,7 @@
           <p:cNvPr id="7" name="">
             <a:extLst xmlns:a="http://schemas.openxmlformats.org/drawingml/2006/main">
               <a:ext uri="{FF2B5EF4-FFF2-40B4-BE49-F238E27FC236}">
-                <a16:creationId xmlns:a16="http://schemas.microsoft.com/office/drawing/2014/main" id="{A4DEBC5E-AEC9-4274-8392-6DFF38CD220D}"/>
+                <a16:creationId xmlns:a16="http://schemas.microsoft.com/office/drawing/2014/main" id="{F340019F-7A15-4D1C-97C3-D4EE30BA6630}"/>
               </a:ext>
             </a:extLst>
           </p:cNvPr>
@@ -3164,7 +3164,7 @@
           <p:cNvPr id="8" name="">
             <a:extLst xmlns:a="http://schemas.openxmlformats.org/drawingml/2006/main">
               <a:ext uri="{FF2B5EF4-FFF2-40B4-BE49-F238E27FC236}">
-                <a16:creationId xmlns:a16="http://schemas.microsoft.com/office/drawing/2014/main" id="{BF9AEA9D-165B-4882-BFE2-0CCEBFF7527F}"/>
+                <a16:creationId xmlns:a16="http://schemas.microsoft.com/office/drawing/2014/main" id="{5630000F-403B-4DEC-AE28-00C0D4F5BC65}"/>
               </a:ext>
             </a:extLst>
           </p:cNvPr>
@@ -3228,7 +3228,7 @@
           <p:cNvPr id="9" name="">
             <a:extLst xmlns:a="http://schemas.openxmlformats.org/drawingml/2006/main">
               <a:ext uri="{FF2B5EF4-FFF2-40B4-BE49-F238E27FC236}">
-                <a16:creationId xmlns:a16="http://schemas.microsoft.com/office/drawing/2014/main" id="{64D3D996-DFAC-4C65-99D9-2C0611B21205}"/>
+                <a16:creationId xmlns:a16="http://schemas.microsoft.com/office/drawing/2014/main" id="{F25B74C7-825F-4054-8D8B-D66804471C2F}"/>
               </a:ext>
             </a:extLst>
           </p:cNvPr>
@@ -3292,7 +3292,7 @@
           <p:cNvPr id="10" name="">
             <a:extLst xmlns:a="http://schemas.openxmlformats.org/drawingml/2006/main">
               <a:ext uri="{FF2B5EF4-FFF2-40B4-BE49-F238E27FC236}">
-                <a16:creationId xmlns:a16="http://schemas.microsoft.com/office/drawing/2014/main" id="{C4BF2D9B-34CC-4E0D-9AC0-668D7C86D5A9}"/>
+                <a16:creationId xmlns:a16="http://schemas.microsoft.com/office/drawing/2014/main" id="{302692EE-CD09-49D7-99F1-4C1151B08CE7}"/>
               </a:ext>
             </a:extLst>
           </p:cNvPr>
@@ -3325,7 +3325,7 @@
           <p:cNvPr id="11" name="">
             <a:extLst xmlns:a="http://schemas.openxmlformats.org/drawingml/2006/main">
               <a:ext uri="{FF2B5EF4-FFF2-40B4-BE49-F238E27FC236}">
-                <a16:creationId xmlns:a16="http://schemas.microsoft.com/office/drawing/2014/main" id="{6692B4E5-0092-45FB-942B-318F6EB2C518}"/>
+                <a16:creationId xmlns:a16="http://schemas.microsoft.com/office/drawing/2014/main" id="{70903236-71D3-4A24-8B0E-8F0BEB44F6EE}"/>
               </a:ext>
             </a:extLst>
           </p:cNvPr>
@@ -3389,7 +3389,7 @@
           <p:cNvPr id="12" name="">
             <a:extLst xmlns:a="http://schemas.openxmlformats.org/drawingml/2006/main">
               <a:ext uri="{FF2B5EF4-FFF2-40B4-BE49-F238E27FC236}">
-                <a16:creationId xmlns:a16="http://schemas.microsoft.com/office/drawing/2014/main" id="{D2397EBC-4EFF-4B9B-A701-5DF249D15055}"/>
+                <a16:creationId xmlns:a16="http://schemas.microsoft.com/office/drawing/2014/main" id="{5BFF1B6C-D828-4763-8161-CA203479E021}"/>
               </a:ext>
             </a:extLst>
           </p:cNvPr>
@@ -3453,7 +3453,7 @@
           <p:cNvPr id="13" name="">
             <a:extLst xmlns:a="http://schemas.openxmlformats.org/drawingml/2006/main">
               <a:ext uri="{FF2B5EF4-FFF2-40B4-BE49-F238E27FC236}">
-                <a16:creationId xmlns:a16="http://schemas.microsoft.com/office/drawing/2014/main" id="{3A634005-FE98-4B52-B221-7BC3AE0079CE}"/>
+                <a16:creationId xmlns:a16="http://schemas.microsoft.com/office/drawing/2014/main" id="{29BCFC1D-5753-472E-B886-769C71452C1D}"/>
               </a:ext>
             </a:extLst>
           </p:cNvPr>
@@ -3486,7 +3486,7 @@
           <p:cNvPr id="14" name="">
             <a:extLst xmlns:a="http://schemas.openxmlformats.org/drawingml/2006/main">
               <a:ext uri="{FF2B5EF4-FFF2-40B4-BE49-F238E27FC236}">
-                <a16:creationId xmlns:a16="http://schemas.microsoft.com/office/drawing/2014/main" id="{D7185D18-E63F-474C-991A-15678D039E74}"/>
+                <a16:creationId xmlns:a16="http://schemas.microsoft.com/office/drawing/2014/main" id="{5F1BF421-BD19-4EF9-95A4-227E52E9607D}"/>
               </a:ext>
             </a:extLst>
           </p:cNvPr>
@@ -3550,7 +3550,7 @@
           <p:cNvPr id="15" name="">
             <a:extLst xmlns:a="http://schemas.openxmlformats.org/drawingml/2006/main">
               <a:ext uri="{FF2B5EF4-FFF2-40B4-BE49-F238E27FC236}">
-                <a16:creationId xmlns:a16="http://schemas.microsoft.com/office/drawing/2014/main" id="{917727B0-CB66-4C0F-99B7-FB2615A29B68}"/>
+                <a16:creationId xmlns:a16="http://schemas.microsoft.com/office/drawing/2014/main" id="{3D29AB5F-66BC-48BB-B0BD-E1B75500C493}"/>
               </a:ext>
             </a:extLst>
           </p:cNvPr>
@@ -3604,7 +3604,7 @@
                 <a:ea typeface="Aptos"/>
                 <a:cs typeface="Aptos"/>
               </a:rPr>
-              <a:t>Docker app, local Gemma E2B, five-agent loop, producer approval, and proven radio evidence with honest solar/sensor milestones.</a:t>
+              <a:t>Docker app, live five-agent activity, local Gemma E2B, producer approval, and proven radio evidence with honest solar/sensor milestones.</a:t>
             </a:r>
           </a:p>
         </p:txBody>
@@ -3614,7 +3614,7 @@
           <p:cNvPr id="16" name="">
             <a:extLst xmlns:a="http://schemas.openxmlformats.org/drawingml/2006/main">
               <a:ext uri="{FF2B5EF4-FFF2-40B4-BE49-F238E27FC236}">
-                <a16:creationId xmlns:a16="http://schemas.microsoft.com/office/drawing/2014/main" id="{67F3D63A-5D74-4BDC-A252-BB0B8D4C0AFD}"/>
+                <a16:creationId xmlns:a16="http://schemas.microsoft.com/office/drawing/2014/main" id="{F2BAFFEC-4D4F-459B-AA0B-3662E23F56D3}"/>
               </a:ext>
             </a:extLst>
           </p:cNvPr>
@@ -3678,7 +3678,7 @@
           <p:cNvPr id="17" name="">
             <a:extLst xmlns:a="http://schemas.openxmlformats.org/drawingml/2006/main">
               <a:ext uri="{FF2B5EF4-FFF2-40B4-BE49-F238E27FC236}">
-                <a16:creationId xmlns:a16="http://schemas.microsoft.com/office/drawing/2014/main" id="{18EEF3E1-2A79-4C72-8694-06E01F943A9B}"/>
+                <a16:creationId xmlns:a16="http://schemas.microsoft.com/office/drawing/2014/main" id="{E5C66A5B-EE71-4EF1-8F3C-E5BCE1EC3720}"/>
               </a:ext>
             </a:extLst>
           </p:cNvPr>
@@ -3742,7 +3742,7 @@
           <p:cNvPr id="18" name="">
             <a:extLst xmlns:a="http://schemas.openxmlformats.org/drawingml/2006/main">
               <a:ext uri="{FF2B5EF4-FFF2-40B4-BE49-F238E27FC236}">
-                <a16:creationId xmlns:a16="http://schemas.microsoft.com/office/drawing/2014/main" id="{496B9955-79A1-4116-AB53-7D1738A5505F}"/>
+                <a16:creationId xmlns:a16="http://schemas.microsoft.com/office/drawing/2014/main" id="{D122545A-D3AD-422F-B37C-270DA9F89260}"/>
               </a:ext>
             </a:extLst>
           </p:cNvPr>
@@ -3804,7 +3804,7 @@
     </p:spTree>
     <p:extLst>
       <p:ext uri="{BB962C8B-B14F-4D97-AF65-F5344CB8AC3E}">
-        <p14:creationId xmlns:p14="http://schemas.microsoft.com/office/powerpoint/2010/main" val="446718710"/>
+        <p14:creationId xmlns:p14="http://schemas.microsoft.com/office/powerpoint/2010/main" val="143757977"/>
       </p:ext>
     </p:extLst>
   </p:cSld>
@@ -3828,7 +3828,7 @@
           <p:cNvPr id="1" name="">
             <a:extLst xmlns:a="http://schemas.openxmlformats.org/drawingml/2006/main">
               <a:ext uri="{FF2B5EF4-FFF2-40B4-BE49-F238E27FC236}">
-                <a16:creationId xmlns:a16="http://schemas.microsoft.com/office/drawing/2014/main" id="{BB5ADE9D-7D0E-4E0B-B959-59217D9E3FE0}"/>
+                <a16:creationId xmlns:a16="http://schemas.microsoft.com/office/drawing/2014/main" id="{7E2245F4-3B59-4646-83B0-480D2DEDCC1D}"/>
               </a:ext>
             </a:extLst>
           </p:cNvPr>
@@ -3863,7 +3863,7 @@
           <p:cNvPr id="2" name="">
             <a:extLst xmlns:a="http://schemas.openxmlformats.org/drawingml/2006/main">
               <a:ext uri="{FF2B5EF4-FFF2-40B4-BE49-F238E27FC236}">
-                <a16:creationId xmlns:a16="http://schemas.microsoft.com/office/drawing/2014/main" id="{0760191B-B0ED-4443-83CC-8C48AE20C655}"/>
+                <a16:creationId xmlns:a16="http://schemas.microsoft.com/office/drawing/2014/main" id="{C96DFB73-B790-423A-863A-2F3A1F91B52D}"/>
               </a:ext>
             </a:extLst>
           </p:cNvPr>
@@ -3898,7 +3898,7 @@
           <p:cNvPr id="3" name="">
             <a:extLst xmlns:a="http://schemas.openxmlformats.org/drawingml/2006/main">
               <a:ext uri="{FF2B5EF4-FFF2-40B4-BE49-F238E27FC236}">
-                <a16:creationId xmlns:a16="http://schemas.microsoft.com/office/drawing/2014/main" id="{2C9270E1-F541-4B87-81C5-E4E5CF08BEE5}"/>
+                <a16:creationId xmlns:a16="http://schemas.microsoft.com/office/drawing/2014/main" id="{D2BAF779-EBC4-4C60-8985-B27318722ABB}"/>
               </a:ext>
             </a:extLst>
           </p:cNvPr>
@@ -3962,7 +3962,7 @@
           <p:cNvPr id="4" name="">
             <a:extLst xmlns:a="http://schemas.openxmlformats.org/drawingml/2006/main">
               <a:ext uri="{FF2B5EF4-FFF2-40B4-BE49-F238E27FC236}">
-                <a16:creationId xmlns:a16="http://schemas.microsoft.com/office/drawing/2014/main" id="{8B5EDE10-5D84-46E5-BF27-95111C73B55F}"/>
+                <a16:creationId xmlns:a16="http://schemas.microsoft.com/office/drawing/2014/main" id="{799B9BA3-E2B9-4FD3-B2D2-55E50F533502}"/>
               </a:ext>
             </a:extLst>
           </p:cNvPr>
@@ -4026,7 +4026,7 @@
           <p:cNvPr id="5" name="">
             <a:extLst xmlns:a="http://schemas.openxmlformats.org/drawingml/2006/main">
               <a:ext uri="{FF2B5EF4-FFF2-40B4-BE49-F238E27FC236}">
-                <a16:creationId xmlns:a16="http://schemas.microsoft.com/office/drawing/2014/main" id="{E09B6843-B327-4216-9331-E3CE6221F7C7}"/>
+                <a16:creationId xmlns:a16="http://schemas.microsoft.com/office/drawing/2014/main" id="{4CF95735-5AD1-4129-8CFA-312F82610BB1}"/>
               </a:ext>
             </a:extLst>
           </p:cNvPr>
@@ -4090,7 +4090,7 @@
           <p:cNvPr id="6" name="">
             <a:extLst xmlns:a="http://schemas.openxmlformats.org/drawingml/2006/main">
               <a:ext uri="{FF2B5EF4-FFF2-40B4-BE49-F238E27FC236}">
-                <a16:creationId xmlns:a16="http://schemas.microsoft.com/office/drawing/2014/main" id="{EB32D92D-BEE4-4932-8473-29EFE82F9D3D}"/>
+                <a16:creationId xmlns:a16="http://schemas.microsoft.com/office/drawing/2014/main" id="{C6F3C1F0-368B-4CA8-85CE-CA7109B974E2}"/>
               </a:ext>
             </a:extLst>
           </p:cNvPr>
@@ -4154,7 +4154,7 @@
           <p:cNvPr id="7" name="">
             <a:extLst xmlns:a="http://schemas.openxmlformats.org/drawingml/2006/main">
               <a:ext uri="{FF2B5EF4-FFF2-40B4-BE49-F238E27FC236}">
-                <a16:creationId xmlns:a16="http://schemas.microsoft.com/office/drawing/2014/main" id="{C867C521-5BE1-453E-8741-DD264245BAC9}"/>
+                <a16:creationId xmlns:a16="http://schemas.microsoft.com/office/drawing/2014/main" id="{120C5CDF-2458-4C14-88FA-98F3C6880392}"/>
               </a:ext>
             </a:extLst>
           </p:cNvPr>
@@ -4187,7 +4187,7 @@
           <p:cNvPr id="8" name="">
             <a:extLst xmlns:a="http://schemas.openxmlformats.org/drawingml/2006/main">
               <a:ext uri="{FF2B5EF4-FFF2-40B4-BE49-F238E27FC236}">
-                <a16:creationId xmlns:a16="http://schemas.microsoft.com/office/drawing/2014/main" id="{8A7AAA79-7637-4046-A249-6A4E707A7811}"/>
+                <a16:creationId xmlns:a16="http://schemas.microsoft.com/office/drawing/2014/main" id="{C7423CE2-F789-44D0-9173-62EA80746187}"/>
               </a:ext>
             </a:extLst>
           </p:cNvPr>
@@ -4251,7 +4251,7 @@
           <p:cNvPr id="9" name="">
             <a:extLst xmlns:a="http://schemas.openxmlformats.org/drawingml/2006/main">
               <a:ext uri="{FF2B5EF4-FFF2-40B4-BE49-F238E27FC236}">
-                <a16:creationId xmlns:a16="http://schemas.microsoft.com/office/drawing/2014/main" id="{25EAABC7-9A88-4DBD-B61A-12545323617B}"/>
+                <a16:creationId xmlns:a16="http://schemas.microsoft.com/office/drawing/2014/main" id="{7EF64DC2-77F5-49B3-9560-F28B1029E2AF}"/>
               </a:ext>
             </a:extLst>
           </p:cNvPr>
@@ -4315,7 +4315,7 @@
           <p:cNvPr id="10" name="">
             <a:extLst xmlns:a="http://schemas.openxmlformats.org/drawingml/2006/main">
               <a:ext uri="{FF2B5EF4-FFF2-40B4-BE49-F238E27FC236}">
-                <a16:creationId xmlns:a16="http://schemas.microsoft.com/office/drawing/2014/main" id="{3E8FDB82-3F9D-4E74-8567-D9485A7FD868}"/>
+                <a16:creationId xmlns:a16="http://schemas.microsoft.com/office/drawing/2014/main" id="{88CD65D8-B113-4BC3-A75C-5E70312C6A75}"/>
               </a:ext>
             </a:extLst>
           </p:cNvPr>
@@ -4348,7 +4348,7 @@
           <p:cNvPr id="11" name="">
             <a:extLst xmlns:a="http://schemas.openxmlformats.org/drawingml/2006/main">
               <a:ext uri="{FF2B5EF4-FFF2-40B4-BE49-F238E27FC236}">
-                <a16:creationId xmlns:a16="http://schemas.microsoft.com/office/drawing/2014/main" id="{253AD833-CA23-45F3-9882-1157F2CF096C}"/>
+                <a16:creationId xmlns:a16="http://schemas.microsoft.com/office/drawing/2014/main" id="{0F91CE8B-05CD-4D77-BEAF-250A2256DD4E}"/>
               </a:ext>
             </a:extLst>
           </p:cNvPr>
@@ -4412,7 +4412,7 @@
           <p:cNvPr id="12" name="">
             <a:extLst xmlns:a="http://schemas.openxmlformats.org/drawingml/2006/main">
               <a:ext uri="{FF2B5EF4-FFF2-40B4-BE49-F238E27FC236}">
-                <a16:creationId xmlns:a16="http://schemas.microsoft.com/office/drawing/2014/main" id="{DFDC01CD-D450-430D-A669-1CA8D115F802}"/>
+                <a16:creationId xmlns:a16="http://schemas.microsoft.com/office/drawing/2014/main" id="{DEB993EB-EE96-4EFD-AB05-E8CAF6600951}"/>
               </a:ext>
             </a:extLst>
           </p:cNvPr>
@@ -4476,7 +4476,7 @@
           <p:cNvPr id="13" name="">
             <a:extLst xmlns:a="http://schemas.openxmlformats.org/drawingml/2006/main">
               <a:ext uri="{FF2B5EF4-FFF2-40B4-BE49-F238E27FC236}">
-                <a16:creationId xmlns:a16="http://schemas.microsoft.com/office/drawing/2014/main" id="{FF1AC919-9EE3-4D9D-9211-5EACAFB7EEB1}"/>
+                <a16:creationId xmlns:a16="http://schemas.microsoft.com/office/drawing/2014/main" id="{28C21600-36D9-4C9D-AD67-F3A02AB44444}"/>
               </a:ext>
             </a:extLst>
           </p:cNvPr>
@@ -4509,7 +4509,7 @@
           <p:cNvPr id="14" name="">
             <a:extLst xmlns:a="http://schemas.openxmlformats.org/drawingml/2006/main">
               <a:ext uri="{FF2B5EF4-FFF2-40B4-BE49-F238E27FC236}">
-                <a16:creationId xmlns:a16="http://schemas.microsoft.com/office/drawing/2014/main" id="{8B33C232-47B6-4018-BF94-0990D186A5B2}"/>
+                <a16:creationId xmlns:a16="http://schemas.microsoft.com/office/drawing/2014/main" id="{164F8587-0E86-4117-A86E-9DC6EBE46AF8}"/>
               </a:ext>
             </a:extLst>
           </p:cNvPr>
@@ -4573,7 +4573,7 @@
           <p:cNvPr id="15" name="">
             <a:extLst xmlns:a="http://schemas.openxmlformats.org/drawingml/2006/main">
               <a:ext uri="{FF2B5EF4-FFF2-40B4-BE49-F238E27FC236}">
-                <a16:creationId xmlns:a16="http://schemas.microsoft.com/office/drawing/2014/main" id="{5C4B3979-6804-469B-BADB-74E5E654CF37}"/>
+                <a16:creationId xmlns:a16="http://schemas.microsoft.com/office/drawing/2014/main" id="{FFC66AF3-084F-4097-8663-AFD9F43228A7}"/>
               </a:ext>
             </a:extLst>
           </p:cNvPr>
@@ -4637,7 +4637,7 @@
           <p:cNvPr id="16" name="">
             <a:extLst xmlns:a="http://schemas.openxmlformats.org/drawingml/2006/main">
               <a:ext uri="{FF2B5EF4-FFF2-40B4-BE49-F238E27FC236}">
-                <a16:creationId xmlns:a16="http://schemas.microsoft.com/office/drawing/2014/main" id="{4F9F2F46-5449-4FAD-A235-590B566E58A1}"/>
+                <a16:creationId xmlns:a16="http://schemas.microsoft.com/office/drawing/2014/main" id="{C0C9B0C7-C66E-431F-951A-AE53D29814A5}"/>
               </a:ext>
             </a:extLst>
           </p:cNvPr>
@@ -4701,7 +4701,7 @@
           <p:cNvPr id="17" name="">
             <a:extLst xmlns:a="http://schemas.openxmlformats.org/drawingml/2006/main">
               <a:ext uri="{FF2B5EF4-FFF2-40B4-BE49-F238E27FC236}">
-                <a16:creationId xmlns:a16="http://schemas.microsoft.com/office/drawing/2014/main" id="{54C126F9-042F-4890-84E1-97449F7814F3}"/>
+                <a16:creationId xmlns:a16="http://schemas.microsoft.com/office/drawing/2014/main" id="{54285DCD-ABB6-48C1-BEAF-F1D363BFA3C4}"/>
               </a:ext>
             </a:extLst>
           </p:cNvPr>
@@ -4763,7 +4763,7 @@
     </p:spTree>
     <p:extLst>
       <p:ext uri="{BB962C8B-B14F-4D97-AF65-F5344CB8AC3E}">
-        <p14:creationId xmlns:p14="http://schemas.microsoft.com/office/powerpoint/2010/main" val="1258315649"/>
+        <p14:creationId xmlns:p14="http://schemas.microsoft.com/office/powerpoint/2010/main" val="148738773"/>
       </p:ext>
     </p:extLst>
   </p:cSld>
@@ -4787,7 +4787,7 @@
           <p:cNvPr id="1" name="">
             <a:extLst xmlns:a="http://schemas.openxmlformats.org/drawingml/2006/main">
               <a:ext uri="{FF2B5EF4-FFF2-40B4-BE49-F238E27FC236}">
-                <a16:creationId xmlns:a16="http://schemas.microsoft.com/office/drawing/2014/main" id="{6E186F2C-1D39-4C7A-A0EE-A1DCCC0CDE1B}"/>
+                <a16:creationId xmlns:a16="http://schemas.microsoft.com/office/drawing/2014/main" id="{A54333C0-FCB7-4D6B-BF27-F793FC833D27}"/>
               </a:ext>
             </a:extLst>
           </p:cNvPr>
@@ -4822,7 +4822,7 @@
           <p:cNvPr id="2" name="">
             <a:extLst xmlns:a="http://schemas.openxmlformats.org/drawingml/2006/main">
               <a:ext uri="{FF2B5EF4-FFF2-40B4-BE49-F238E27FC236}">
-                <a16:creationId xmlns:a16="http://schemas.microsoft.com/office/drawing/2014/main" id="{07FA5761-D184-4109-9554-EAAA5A9B6A7A}"/>
+                <a16:creationId xmlns:a16="http://schemas.microsoft.com/office/drawing/2014/main" id="{CDB2D8FF-D220-4B52-893E-5DE54012D1AC}"/>
               </a:ext>
             </a:extLst>
           </p:cNvPr>
@@ -4857,7 +4857,7 @@
           <p:cNvPr id="3" name="">
             <a:extLst xmlns:a="http://schemas.openxmlformats.org/drawingml/2006/main">
               <a:ext uri="{FF2B5EF4-FFF2-40B4-BE49-F238E27FC236}">
-                <a16:creationId xmlns:a16="http://schemas.microsoft.com/office/drawing/2014/main" id="{4D7FCFE1-9CB4-4CD0-953D-01ADDA6F5F55}"/>
+                <a16:creationId xmlns:a16="http://schemas.microsoft.com/office/drawing/2014/main" id="{E7C9EFF9-D3E4-4E3C-8FF2-09FA9FD607F2}"/>
               </a:ext>
             </a:extLst>
           </p:cNvPr>
@@ -4921,7 +4921,7 @@
           <p:cNvPr id="4" name="">
             <a:extLst xmlns:a="http://schemas.openxmlformats.org/drawingml/2006/main">
               <a:ext uri="{FF2B5EF4-FFF2-40B4-BE49-F238E27FC236}">
-                <a16:creationId xmlns:a16="http://schemas.microsoft.com/office/drawing/2014/main" id="{A2F8593C-8D67-484A-96D8-51DE9BBFAA65}"/>
+                <a16:creationId xmlns:a16="http://schemas.microsoft.com/office/drawing/2014/main" id="{D19006EB-FB0F-4864-B3DA-1B7C557BE06B}"/>
               </a:ext>
             </a:extLst>
           </p:cNvPr>
@@ -4985,7 +4985,7 @@
           <p:cNvPr id="5" name="">
             <a:extLst xmlns:a="http://schemas.openxmlformats.org/drawingml/2006/main">
               <a:ext uri="{FF2B5EF4-FFF2-40B4-BE49-F238E27FC236}">
-                <a16:creationId xmlns:a16="http://schemas.microsoft.com/office/drawing/2014/main" id="{A87871A4-AFFD-48AA-92E6-D4080D0DFC5E}"/>
+                <a16:creationId xmlns:a16="http://schemas.microsoft.com/office/drawing/2014/main" id="{38D5E0A1-3242-4BEA-BAAF-8E350B88721E}"/>
               </a:ext>
             </a:extLst>
           </p:cNvPr>
@@ -5049,7 +5049,7 @@
           <p:cNvPr id="6" name="">
             <a:extLst xmlns:a="http://schemas.openxmlformats.org/drawingml/2006/main">
               <a:ext uri="{FF2B5EF4-FFF2-40B4-BE49-F238E27FC236}">
-                <a16:creationId xmlns:a16="http://schemas.microsoft.com/office/drawing/2014/main" id="{B33D1CC0-5FBB-40D8-8BC4-E4ED2EE35524}"/>
+                <a16:creationId xmlns:a16="http://schemas.microsoft.com/office/drawing/2014/main" id="{FE5CCE1B-FC4B-4A9E-A32E-0BC62DE0271F}"/>
               </a:ext>
             </a:extLst>
           </p:cNvPr>
@@ -5113,7 +5113,7 @@
           <p:cNvPr id="7" name="">
             <a:extLst xmlns:a="http://schemas.openxmlformats.org/drawingml/2006/main">
               <a:ext uri="{FF2B5EF4-FFF2-40B4-BE49-F238E27FC236}">
-                <a16:creationId xmlns:a16="http://schemas.microsoft.com/office/drawing/2014/main" id="{DFEBCF20-30C9-46BE-9F4A-7E1E1EBAEBFD}"/>
+                <a16:creationId xmlns:a16="http://schemas.microsoft.com/office/drawing/2014/main" id="{10D77194-2347-4920-B0CE-F94BF822979F}"/>
               </a:ext>
             </a:extLst>
           </p:cNvPr>
@@ -5146,7 +5146,7 @@
           <p:cNvPr id="8" name="">
             <a:extLst xmlns:a="http://schemas.openxmlformats.org/drawingml/2006/main">
               <a:ext uri="{FF2B5EF4-FFF2-40B4-BE49-F238E27FC236}">
-                <a16:creationId xmlns:a16="http://schemas.microsoft.com/office/drawing/2014/main" id="{D419DB1F-DE09-454E-BA50-A6AB5FF1A546}"/>
+                <a16:creationId xmlns:a16="http://schemas.microsoft.com/office/drawing/2014/main" id="{071A6677-176A-43DD-9AA0-87DEEEAD7599}"/>
               </a:ext>
             </a:extLst>
           </p:cNvPr>
@@ -5210,7 +5210,7 @@
           <p:cNvPr id="9" name="">
             <a:extLst xmlns:a="http://schemas.openxmlformats.org/drawingml/2006/main">
               <a:ext uri="{FF2B5EF4-FFF2-40B4-BE49-F238E27FC236}">
-                <a16:creationId xmlns:a16="http://schemas.microsoft.com/office/drawing/2014/main" id="{E7E48685-3F43-471D-A1AF-484FF84A7EFE}"/>
+                <a16:creationId xmlns:a16="http://schemas.microsoft.com/office/drawing/2014/main" id="{7864BD91-9752-4CF3-BE3A-4B1E83AE039F}"/>
               </a:ext>
             </a:extLst>
           </p:cNvPr>
@@ -5274,7 +5274,7 @@
           <p:cNvPr id="10" name="">
             <a:extLst xmlns:a="http://schemas.openxmlformats.org/drawingml/2006/main">
               <a:ext uri="{FF2B5EF4-FFF2-40B4-BE49-F238E27FC236}">
-                <a16:creationId xmlns:a16="http://schemas.microsoft.com/office/drawing/2014/main" id="{6C52964F-28B5-44E0-8F2A-59FBE8F40D9E}"/>
+                <a16:creationId xmlns:a16="http://schemas.microsoft.com/office/drawing/2014/main" id="{14B82712-CF2C-4624-AAB0-5E0A691CEF94}"/>
               </a:ext>
             </a:extLst>
           </p:cNvPr>
@@ -5338,7 +5338,7 @@
           <p:cNvPr id="11" name="">
             <a:extLst xmlns:a="http://schemas.openxmlformats.org/drawingml/2006/main">
               <a:ext uri="{FF2B5EF4-FFF2-40B4-BE49-F238E27FC236}">
-                <a16:creationId xmlns:a16="http://schemas.microsoft.com/office/drawing/2014/main" id="{C2C6AE59-14AE-48A8-8BDB-42C435697512}"/>
+                <a16:creationId xmlns:a16="http://schemas.microsoft.com/office/drawing/2014/main" id="{AA866C81-4AD8-46FC-B81E-1BF36DEE7A02}"/>
               </a:ext>
             </a:extLst>
           </p:cNvPr>
@@ -5371,7 +5371,7 @@
           <p:cNvPr id="12" name="">
             <a:extLst xmlns:a="http://schemas.openxmlformats.org/drawingml/2006/main">
               <a:ext uri="{FF2B5EF4-FFF2-40B4-BE49-F238E27FC236}">
-                <a16:creationId xmlns:a16="http://schemas.microsoft.com/office/drawing/2014/main" id="{FDDB2898-691D-4944-AFC9-12E0AB19B547}"/>
+                <a16:creationId xmlns:a16="http://schemas.microsoft.com/office/drawing/2014/main" id="{B82E7E6A-C75B-4578-826A-43227BB7B926}"/>
               </a:ext>
             </a:extLst>
           </p:cNvPr>
@@ -5435,7 +5435,7 @@
           <p:cNvPr id="13" name="">
             <a:extLst xmlns:a="http://schemas.openxmlformats.org/drawingml/2006/main">
               <a:ext uri="{FF2B5EF4-FFF2-40B4-BE49-F238E27FC236}">
-                <a16:creationId xmlns:a16="http://schemas.microsoft.com/office/drawing/2014/main" id="{3D873F18-E011-4D9B-B19E-14F40772DCD3}"/>
+                <a16:creationId xmlns:a16="http://schemas.microsoft.com/office/drawing/2014/main" id="{A8C59986-0137-4C61-98A9-ADE11A763EA3}"/>
               </a:ext>
             </a:extLst>
           </p:cNvPr>
@@ -5499,7 +5499,7 @@
           <p:cNvPr id="14" name="">
             <a:extLst xmlns:a="http://schemas.openxmlformats.org/drawingml/2006/main">
               <a:ext uri="{FF2B5EF4-FFF2-40B4-BE49-F238E27FC236}">
-                <a16:creationId xmlns:a16="http://schemas.microsoft.com/office/drawing/2014/main" id="{EF05F564-3C69-4278-94BB-9D4BD8B90090}"/>
+                <a16:creationId xmlns:a16="http://schemas.microsoft.com/office/drawing/2014/main" id="{64CB9113-59EB-48AC-A306-40034A6EB65A}"/>
               </a:ext>
             </a:extLst>
           </p:cNvPr>
@@ -5563,7 +5563,7 @@
           <p:cNvPr id="15" name="">
             <a:extLst xmlns:a="http://schemas.openxmlformats.org/drawingml/2006/main">
               <a:ext uri="{FF2B5EF4-FFF2-40B4-BE49-F238E27FC236}">
-                <a16:creationId xmlns:a16="http://schemas.microsoft.com/office/drawing/2014/main" id="{2328B6D6-C1EF-4BD7-BEE5-D869705B7D65}"/>
+                <a16:creationId xmlns:a16="http://schemas.microsoft.com/office/drawing/2014/main" id="{8AE7A923-E46C-4723-9228-F5F1CE4CCFB2}"/>
               </a:ext>
             </a:extLst>
           </p:cNvPr>
@@ -5596,7 +5596,7 @@
           <p:cNvPr id="16" name="">
             <a:extLst xmlns:a="http://schemas.openxmlformats.org/drawingml/2006/main">
               <a:ext uri="{FF2B5EF4-FFF2-40B4-BE49-F238E27FC236}">
-                <a16:creationId xmlns:a16="http://schemas.microsoft.com/office/drawing/2014/main" id="{A23F47A1-9658-41D4-AF18-3AF1F887DD05}"/>
+                <a16:creationId xmlns:a16="http://schemas.microsoft.com/office/drawing/2014/main" id="{41BBF93E-E912-48E9-9A7B-7E7BB4BE75E0}"/>
               </a:ext>
             </a:extLst>
           </p:cNvPr>
@@ -5660,7 +5660,7 @@
           <p:cNvPr id="17" name="">
             <a:extLst xmlns:a="http://schemas.openxmlformats.org/drawingml/2006/main">
               <a:ext uri="{FF2B5EF4-FFF2-40B4-BE49-F238E27FC236}">
-                <a16:creationId xmlns:a16="http://schemas.microsoft.com/office/drawing/2014/main" id="{E6E2348F-8F5B-4EF0-8DDA-2649BAEA9476}"/>
+                <a16:creationId xmlns:a16="http://schemas.microsoft.com/office/drawing/2014/main" id="{69627329-948B-403A-84A3-AF81D5836626}"/>
               </a:ext>
             </a:extLst>
           </p:cNvPr>
@@ -5724,7 +5724,7 @@
           <p:cNvPr id="18" name="">
             <a:extLst xmlns:a="http://schemas.openxmlformats.org/drawingml/2006/main">
               <a:ext uri="{FF2B5EF4-FFF2-40B4-BE49-F238E27FC236}">
-                <a16:creationId xmlns:a16="http://schemas.microsoft.com/office/drawing/2014/main" id="{F66791E0-C6B3-49B2-B549-B4F80EAE3B13}"/>
+                <a16:creationId xmlns:a16="http://schemas.microsoft.com/office/drawing/2014/main" id="{91CAAB98-E950-430A-8FD3-085085C21618}"/>
               </a:ext>
             </a:extLst>
           </p:cNvPr>
@@ -5788,7 +5788,7 @@
           <p:cNvPr id="19" name="">
             <a:extLst xmlns:a="http://schemas.openxmlformats.org/drawingml/2006/main">
               <a:ext uri="{FF2B5EF4-FFF2-40B4-BE49-F238E27FC236}">
-                <a16:creationId xmlns:a16="http://schemas.microsoft.com/office/drawing/2014/main" id="{D71C2ACB-04C1-4716-B221-ADC0E409E34C}"/>
+                <a16:creationId xmlns:a16="http://schemas.microsoft.com/office/drawing/2014/main" id="{82C821DC-CFA4-468C-9D11-A5BC5E58B644}"/>
               </a:ext>
             </a:extLst>
           </p:cNvPr>
@@ -5821,7 +5821,7 @@
           <p:cNvPr id="20" name="">
             <a:extLst xmlns:a="http://schemas.openxmlformats.org/drawingml/2006/main">
               <a:ext uri="{FF2B5EF4-FFF2-40B4-BE49-F238E27FC236}">
-                <a16:creationId xmlns:a16="http://schemas.microsoft.com/office/drawing/2014/main" id="{BE74E843-5A44-4C6E-836F-EF32056E8166}"/>
+                <a16:creationId xmlns:a16="http://schemas.microsoft.com/office/drawing/2014/main" id="{C44AC7F6-060B-40C0-BD28-DA031DFC7D45}"/>
               </a:ext>
             </a:extLst>
           </p:cNvPr>
@@ -5885,7 +5885,7 @@
           <p:cNvPr id="21" name="">
             <a:extLst xmlns:a="http://schemas.openxmlformats.org/drawingml/2006/main">
               <a:ext uri="{FF2B5EF4-FFF2-40B4-BE49-F238E27FC236}">
-                <a16:creationId xmlns:a16="http://schemas.microsoft.com/office/drawing/2014/main" id="{B0AB89C7-27D6-4FC6-8496-5F7C577AE1F3}"/>
+                <a16:creationId xmlns:a16="http://schemas.microsoft.com/office/drawing/2014/main" id="{FC981389-1344-4D2E-A7E2-85F94002D4AC}"/>
               </a:ext>
             </a:extLst>
           </p:cNvPr>
@@ -5949,7 +5949,7 @@
           <p:cNvPr id="22" name="">
             <a:extLst xmlns:a="http://schemas.openxmlformats.org/drawingml/2006/main">
               <a:ext uri="{FF2B5EF4-FFF2-40B4-BE49-F238E27FC236}">
-                <a16:creationId xmlns:a16="http://schemas.microsoft.com/office/drawing/2014/main" id="{C17F273A-E082-4603-8BFC-67C3B66F214F}"/>
+                <a16:creationId xmlns:a16="http://schemas.microsoft.com/office/drawing/2014/main" id="{34667695-E80B-4B19-A772-96903F013936}"/>
               </a:ext>
             </a:extLst>
           </p:cNvPr>
@@ -5982,7 +5982,7 @@
           <p:cNvPr id="23" name="">
             <a:extLst xmlns:a="http://schemas.openxmlformats.org/drawingml/2006/main">
               <a:ext uri="{FF2B5EF4-FFF2-40B4-BE49-F238E27FC236}">
-                <a16:creationId xmlns:a16="http://schemas.microsoft.com/office/drawing/2014/main" id="{EC06A0AA-B047-43B5-BC61-3FBC40983977}"/>
+                <a16:creationId xmlns:a16="http://schemas.microsoft.com/office/drawing/2014/main" id="{C3A72CA4-83A7-43DB-87EE-4A16C29D85D2}"/>
               </a:ext>
             </a:extLst>
           </p:cNvPr>
@@ -6036,7 +6036,7 @@
                 <a:ea typeface="Aptos"/>
                 <a:cs typeface="Aptos"/>
               </a:rPr>
-              <a:t>Agent supervisor</a:t>
+              <a:t>Visible agent supervisor</a:t>
             </a:r>
           </a:p>
         </p:txBody>
@@ -6046,7 +6046,7 @@
           <p:cNvPr id="24" name="">
             <a:extLst xmlns:a="http://schemas.openxmlformats.org/drawingml/2006/main">
               <a:ext uri="{FF2B5EF4-FFF2-40B4-BE49-F238E27FC236}">
-                <a16:creationId xmlns:a16="http://schemas.microsoft.com/office/drawing/2014/main" id="{FDED0E5C-8988-4A3D-94BA-9AFCA9621035}"/>
+                <a16:creationId xmlns:a16="http://schemas.microsoft.com/office/drawing/2014/main" id="{2FC23963-9E46-4816-866A-BB74E760FA51}"/>
               </a:ext>
             </a:extLst>
           </p:cNvPr>
@@ -6100,7 +6100,7 @@
                 <a:ea typeface="Aptos"/>
                 <a:cs typeface="Aptos"/>
               </a:rPr>
-              <a:t>Balances feed, oxygen, water exchange, harvest, and risk across subsystem agents.</a:t>
+              <a:t>Live structured events show four briefs becoming one verifier-gated intervention.</a:t>
             </a:r>
           </a:p>
         </p:txBody>
@@ -6110,7 +6110,7 @@
           <p:cNvPr id="25" name="">
             <a:extLst xmlns:a="http://schemas.openxmlformats.org/drawingml/2006/main">
               <a:ext uri="{FF2B5EF4-FFF2-40B4-BE49-F238E27FC236}">
-                <a16:creationId xmlns:a16="http://schemas.microsoft.com/office/drawing/2014/main" id="{9E07B5EE-BEE0-4DFE-A00F-86583A3A23D1}"/>
+                <a16:creationId xmlns:a16="http://schemas.microsoft.com/office/drawing/2014/main" id="{54764875-DAA1-45D7-9B6D-DCAD34A3FA44}"/>
               </a:ext>
             </a:extLst>
           </p:cNvPr>
@@ -6174,7 +6174,7 @@
           <p:cNvPr id="26" name="">
             <a:extLst xmlns:a="http://schemas.openxmlformats.org/drawingml/2006/main">
               <a:ext uri="{FF2B5EF4-FFF2-40B4-BE49-F238E27FC236}">
-                <a16:creationId xmlns:a16="http://schemas.microsoft.com/office/drawing/2014/main" id="{7B133643-0B1C-4889-A126-E706124B5236}"/>
+                <a16:creationId xmlns:a16="http://schemas.microsoft.com/office/drawing/2014/main" id="{051CAE03-DC48-411A-B1C5-3F5CC07EC672}"/>
               </a:ext>
             </a:extLst>
           </p:cNvPr>
@@ -6236,7 +6236,7 @@
     </p:spTree>
     <p:extLst>
       <p:ext uri="{BB962C8B-B14F-4D97-AF65-F5344CB8AC3E}">
-        <p14:creationId xmlns:p14="http://schemas.microsoft.com/office/powerpoint/2010/main" val="1179864289"/>
+        <p14:creationId xmlns:p14="http://schemas.microsoft.com/office/powerpoint/2010/main" val="869420255"/>
       </p:ext>
     </p:extLst>
   </p:cSld>
@@ -6260,7 +6260,7 @@
           <p:cNvPr id="1" name="">
             <a:extLst xmlns:a="http://schemas.openxmlformats.org/drawingml/2006/main">
               <a:ext uri="{FF2B5EF4-FFF2-40B4-BE49-F238E27FC236}">
-                <a16:creationId xmlns:a16="http://schemas.microsoft.com/office/drawing/2014/main" id="{53D36E14-08CD-4B65-8EAE-693D0D4BA66D}"/>
+                <a16:creationId xmlns:a16="http://schemas.microsoft.com/office/drawing/2014/main" id="{DFD189C5-D86C-4F21-88F3-A0FE28BE7A0F}"/>
               </a:ext>
             </a:extLst>
           </p:cNvPr>
@@ -6295,7 +6295,7 @@
           <p:cNvPr id="2" name="">
             <a:extLst xmlns:a="http://schemas.openxmlformats.org/drawingml/2006/main">
               <a:ext uri="{FF2B5EF4-FFF2-40B4-BE49-F238E27FC236}">
-                <a16:creationId xmlns:a16="http://schemas.microsoft.com/office/drawing/2014/main" id="{90D66469-7700-49AA-B64B-19380F34D0A4}"/>
+                <a16:creationId xmlns:a16="http://schemas.microsoft.com/office/drawing/2014/main" id="{F0DB7FB9-2B06-40FF-93FA-8E54927E4A95}"/>
               </a:ext>
             </a:extLst>
           </p:cNvPr>
@@ -6330,7 +6330,7 @@
           <p:cNvPr id="3" name="">
             <a:extLst xmlns:a="http://schemas.openxmlformats.org/drawingml/2006/main">
               <a:ext uri="{FF2B5EF4-FFF2-40B4-BE49-F238E27FC236}">
-                <a16:creationId xmlns:a16="http://schemas.microsoft.com/office/drawing/2014/main" id="{283EAE39-FBE2-46F2-B668-0A07E054720D}"/>
+                <a16:creationId xmlns:a16="http://schemas.microsoft.com/office/drawing/2014/main" id="{A49198DC-9EA1-43DF-A3C7-81814A5AC59B}"/>
               </a:ext>
             </a:extLst>
           </p:cNvPr>
@@ -6394,7 +6394,7 @@
           <p:cNvPr id="4" name="">
             <a:extLst xmlns:a="http://schemas.openxmlformats.org/drawingml/2006/main">
               <a:ext uri="{FF2B5EF4-FFF2-40B4-BE49-F238E27FC236}">
-                <a16:creationId xmlns:a16="http://schemas.microsoft.com/office/drawing/2014/main" id="{96D369F1-2243-469E-8E0B-3FDBC33739DA}"/>
+                <a16:creationId xmlns:a16="http://schemas.microsoft.com/office/drawing/2014/main" id="{D989DD90-4935-4527-AA77-5A5D43AB679D}"/>
               </a:ext>
             </a:extLst>
           </p:cNvPr>
@@ -6458,7 +6458,7 @@
           <p:cNvPr id="5" name="">
             <a:extLst xmlns:a="http://schemas.openxmlformats.org/drawingml/2006/main">
               <a:ext uri="{FF2B5EF4-FFF2-40B4-BE49-F238E27FC236}">
-                <a16:creationId xmlns:a16="http://schemas.microsoft.com/office/drawing/2014/main" id="{54468C1A-1020-4AB3-BED0-0FD6FF123F8C}"/>
+                <a16:creationId xmlns:a16="http://schemas.microsoft.com/office/drawing/2014/main" id="{AFD7A268-0A6E-43F7-959C-6EB42FB7AECB}"/>
               </a:ext>
             </a:extLst>
           </p:cNvPr>
@@ -6522,7 +6522,7 @@
           <p:cNvPr id="6" name="">
             <a:extLst xmlns:a="http://schemas.openxmlformats.org/drawingml/2006/main">
               <a:ext uri="{FF2B5EF4-FFF2-40B4-BE49-F238E27FC236}">
-                <a16:creationId xmlns:a16="http://schemas.microsoft.com/office/drawing/2014/main" id="{B4351BB2-B1D6-467C-A3B5-6D85C6518189}"/>
+                <a16:creationId xmlns:a16="http://schemas.microsoft.com/office/drawing/2014/main" id="{DAABEFC0-FC54-42F8-8E2D-99CF9FD1100E}"/>
               </a:ext>
             </a:extLst>
           </p:cNvPr>
@@ -6586,7 +6586,7 @@
           <p:cNvPr id="7" name="">
             <a:extLst xmlns:a="http://schemas.openxmlformats.org/drawingml/2006/main">
               <a:ext uri="{FF2B5EF4-FFF2-40B4-BE49-F238E27FC236}">
-                <a16:creationId xmlns:a16="http://schemas.microsoft.com/office/drawing/2014/main" id="{A3398F08-CEC7-43E4-8D2F-AF9FB60A1F43}"/>
+                <a16:creationId xmlns:a16="http://schemas.microsoft.com/office/drawing/2014/main" id="{890B5F8F-4B40-436B-8C55-F6F571609F82}"/>
               </a:ext>
             </a:extLst>
           </p:cNvPr>
@@ -6619,7 +6619,7 @@
           <p:cNvPr id="8" name="">
             <a:extLst xmlns:a="http://schemas.openxmlformats.org/drawingml/2006/main">
               <a:ext uri="{FF2B5EF4-FFF2-40B4-BE49-F238E27FC236}">
-                <a16:creationId xmlns:a16="http://schemas.microsoft.com/office/drawing/2014/main" id="{E8C306F8-AE4F-48C6-8C75-9AD4AB40183C}"/>
+                <a16:creationId xmlns:a16="http://schemas.microsoft.com/office/drawing/2014/main" id="{EF33087E-7EA7-4EBE-9181-DA0EE76D8A00}"/>
               </a:ext>
             </a:extLst>
           </p:cNvPr>
@@ -6683,7 +6683,7 @@
           <p:cNvPr id="9" name="">
             <a:extLst xmlns:a="http://schemas.openxmlformats.org/drawingml/2006/main">
               <a:ext uri="{FF2B5EF4-FFF2-40B4-BE49-F238E27FC236}">
-                <a16:creationId xmlns:a16="http://schemas.microsoft.com/office/drawing/2014/main" id="{D1AA245B-2AC1-4EDA-8598-B27E1FC36ADD}"/>
+                <a16:creationId xmlns:a16="http://schemas.microsoft.com/office/drawing/2014/main" id="{C766BC5B-FB41-43C1-99FD-9A17D7A9FDCA}"/>
               </a:ext>
             </a:extLst>
           </p:cNvPr>
@@ -6737,7 +6737,7 @@
                 <a:ea typeface="Aptos"/>
                 <a:cs typeface="Aptos"/>
               </a:rPr>
-              <a:t>Four Gemma subagents report to a Sagents supervisor.</a:t>
+              <a:t>Four Gemma specialists stream structured progress to the live operator view.</a:t>
             </a:r>
           </a:p>
         </p:txBody>
@@ -6747,7 +6747,7 @@
           <p:cNvPr id="10" name="">
             <a:extLst xmlns:a="http://schemas.openxmlformats.org/drawingml/2006/main">
               <a:ext uri="{FF2B5EF4-FFF2-40B4-BE49-F238E27FC236}">
-                <a16:creationId xmlns:a16="http://schemas.microsoft.com/office/drawing/2014/main" id="{F6DB869D-4050-4BEB-9335-5860F508E417}"/>
+                <a16:creationId xmlns:a16="http://schemas.microsoft.com/office/drawing/2014/main" id="{3FD22189-3A9D-41FB-B250-34FAF91DB666}"/>
               </a:ext>
             </a:extLst>
           </p:cNvPr>
@@ -6811,7 +6811,7 @@
           <p:cNvPr id="11" name="">
             <a:extLst xmlns:a="http://schemas.openxmlformats.org/drawingml/2006/main">
               <a:ext uri="{FF2B5EF4-FFF2-40B4-BE49-F238E27FC236}">
-                <a16:creationId xmlns:a16="http://schemas.microsoft.com/office/drawing/2014/main" id="{12A3BD12-20E4-42D7-A32E-BECCB6C7D150}"/>
+                <a16:creationId xmlns:a16="http://schemas.microsoft.com/office/drawing/2014/main" id="{34016B2B-91D5-4032-BFD9-1C4CA5833607}"/>
               </a:ext>
             </a:extLst>
           </p:cNvPr>
@@ -6844,7 +6844,7 @@
           <p:cNvPr id="12" name="">
             <a:extLst xmlns:a="http://schemas.openxmlformats.org/drawingml/2006/main">
               <a:ext uri="{FF2B5EF4-FFF2-40B4-BE49-F238E27FC236}">
-                <a16:creationId xmlns:a16="http://schemas.microsoft.com/office/drawing/2014/main" id="{E6390743-532D-42D4-A2A0-EF1056809748}"/>
+                <a16:creationId xmlns:a16="http://schemas.microsoft.com/office/drawing/2014/main" id="{91A3A839-BD78-4963-861C-2C9E78BE2F74}"/>
               </a:ext>
             </a:extLst>
           </p:cNvPr>
@@ -6908,7 +6908,7 @@
           <p:cNvPr id="13" name="">
             <a:extLst xmlns:a="http://schemas.openxmlformats.org/drawingml/2006/main">
               <a:ext uri="{FF2B5EF4-FFF2-40B4-BE49-F238E27FC236}">
-                <a16:creationId xmlns:a16="http://schemas.microsoft.com/office/drawing/2014/main" id="{DB2E974C-F63D-410D-B0F5-699CB1197CB4}"/>
+                <a16:creationId xmlns:a16="http://schemas.microsoft.com/office/drawing/2014/main" id="{7D7854DA-7ED6-49DE-A833-988943492792}"/>
               </a:ext>
             </a:extLst>
           </p:cNvPr>
@@ -6972,7 +6972,7 @@
           <p:cNvPr id="14" name="">
             <a:extLst xmlns:a="http://schemas.openxmlformats.org/drawingml/2006/main">
               <a:ext uri="{FF2B5EF4-FFF2-40B4-BE49-F238E27FC236}">
-                <a16:creationId xmlns:a16="http://schemas.microsoft.com/office/drawing/2014/main" id="{225E1A15-71E9-4C94-AF7B-E2D5DF72E719}"/>
+                <a16:creationId xmlns:a16="http://schemas.microsoft.com/office/drawing/2014/main" id="{8CB085FB-592A-4684-A378-404BC8EAD08E}"/>
               </a:ext>
             </a:extLst>
           </p:cNvPr>
@@ -7036,7 +7036,7 @@
           <p:cNvPr id="15" name="">
             <a:extLst xmlns:a="http://schemas.openxmlformats.org/drawingml/2006/main">
               <a:ext uri="{FF2B5EF4-FFF2-40B4-BE49-F238E27FC236}">
-                <a16:creationId xmlns:a16="http://schemas.microsoft.com/office/drawing/2014/main" id="{6E41D6EF-93A3-4018-AAB0-EF54E62AE688}"/>
+                <a16:creationId xmlns:a16="http://schemas.microsoft.com/office/drawing/2014/main" id="{1722A276-14CA-49B4-BF35-D3EE3ACE9C87}"/>
               </a:ext>
             </a:extLst>
           </p:cNvPr>
@@ -7069,7 +7069,7 @@
           <p:cNvPr id="16" name="">
             <a:extLst xmlns:a="http://schemas.openxmlformats.org/drawingml/2006/main">
               <a:ext uri="{FF2B5EF4-FFF2-40B4-BE49-F238E27FC236}">
-                <a16:creationId xmlns:a16="http://schemas.microsoft.com/office/drawing/2014/main" id="{DA9E2D09-8411-41C4-A34B-724561EABF05}"/>
+                <a16:creationId xmlns:a16="http://schemas.microsoft.com/office/drawing/2014/main" id="{0B9B9918-1E1B-4BC0-BF5D-29115C4FAE4E}"/>
               </a:ext>
             </a:extLst>
           </p:cNvPr>
@@ -7133,7 +7133,7 @@
           <p:cNvPr id="17" name="">
             <a:extLst xmlns:a="http://schemas.openxmlformats.org/drawingml/2006/main">
               <a:ext uri="{FF2B5EF4-FFF2-40B4-BE49-F238E27FC236}">
-                <a16:creationId xmlns:a16="http://schemas.microsoft.com/office/drawing/2014/main" id="{78406D52-DDB0-4B23-BCB8-6618CB5702E3}"/>
+                <a16:creationId xmlns:a16="http://schemas.microsoft.com/office/drawing/2014/main" id="{7602BBBA-B87E-42DE-A5D5-0DD6899B6928}"/>
               </a:ext>
             </a:extLst>
           </p:cNvPr>
@@ -7197,7 +7197,7 @@
           <p:cNvPr id="18" name="">
             <a:extLst xmlns:a="http://schemas.openxmlformats.org/drawingml/2006/main">
               <a:ext uri="{FF2B5EF4-FFF2-40B4-BE49-F238E27FC236}">
-                <a16:creationId xmlns:a16="http://schemas.microsoft.com/office/drawing/2014/main" id="{477C2672-79AE-4A13-8BFF-BCABA1F98805}"/>
+                <a16:creationId xmlns:a16="http://schemas.microsoft.com/office/drawing/2014/main" id="{0F637D1B-4111-4D32-BF56-59EC5EB6F084}"/>
               </a:ext>
             </a:extLst>
           </p:cNvPr>
@@ -7261,7 +7261,7 @@
           <p:cNvPr id="19" name="">
             <a:extLst xmlns:a="http://schemas.openxmlformats.org/drawingml/2006/main">
               <a:ext uri="{FF2B5EF4-FFF2-40B4-BE49-F238E27FC236}">
-                <a16:creationId xmlns:a16="http://schemas.microsoft.com/office/drawing/2014/main" id="{78CE9BFC-4F73-4568-A1E7-1AB29342AD08}"/>
+                <a16:creationId xmlns:a16="http://schemas.microsoft.com/office/drawing/2014/main" id="{A00B7D60-1060-4A09-ACE8-3BEC5BC3B7D8}"/>
               </a:ext>
             </a:extLst>
           </p:cNvPr>
@@ -7294,7 +7294,7 @@
           <p:cNvPr id="20" name="">
             <a:extLst xmlns:a="http://schemas.openxmlformats.org/drawingml/2006/main">
               <a:ext uri="{FF2B5EF4-FFF2-40B4-BE49-F238E27FC236}">
-                <a16:creationId xmlns:a16="http://schemas.microsoft.com/office/drawing/2014/main" id="{DBFFBC98-9AEC-4BEA-9EB0-F6E8231BDAF6}"/>
+                <a16:creationId xmlns:a16="http://schemas.microsoft.com/office/drawing/2014/main" id="{3591CBE6-3EC7-4CFB-AED8-9E76DBFF39F4}"/>
               </a:ext>
             </a:extLst>
           </p:cNvPr>
@@ -7358,7 +7358,7 @@
           <p:cNvPr id="21" name="">
             <a:extLst xmlns:a="http://schemas.openxmlformats.org/drawingml/2006/main">
               <a:ext uri="{FF2B5EF4-FFF2-40B4-BE49-F238E27FC236}">
-                <a16:creationId xmlns:a16="http://schemas.microsoft.com/office/drawing/2014/main" id="{38E694FE-C342-4785-B6FB-2AC315DC0282}"/>
+                <a16:creationId xmlns:a16="http://schemas.microsoft.com/office/drawing/2014/main" id="{1DC1A7D3-B89E-4273-88CB-EE0B98DAB59B}"/>
               </a:ext>
             </a:extLst>
           </p:cNvPr>
@@ -7422,7 +7422,7 @@
           <p:cNvPr id="22" name="">
             <a:extLst xmlns:a="http://schemas.openxmlformats.org/drawingml/2006/main">
               <a:ext uri="{FF2B5EF4-FFF2-40B4-BE49-F238E27FC236}">
-                <a16:creationId xmlns:a16="http://schemas.microsoft.com/office/drawing/2014/main" id="{E3D4008F-4657-4264-AEB3-B487892BB76B}"/>
+                <a16:creationId xmlns:a16="http://schemas.microsoft.com/office/drawing/2014/main" id="{4F519005-15C1-45DE-A48E-635F346B6E90}"/>
               </a:ext>
             </a:extLst>
           </p:cNvPr>
@@ -7455,7 +7455,7 @@
           <p:cNvPr id="23" name="">
             <a:extLst xmlns:a="http://schemas.openxmlformats.org/drawingml/2006/main">
               <a:ext uri="{FF2B5EF4-FFF2-40B4-BE49-F238E27FC236}">
-                <a16:creationId xmlns:a16="http://schemas.microsoft.com/office/drawing/2014/main" id="{76B18E4F-8500-4E9C-8D0E-27E2BA6D9E89}"/>
+                <a16:creationId xmlns:a16="http://schemas.microsoft.com/office/drawing/2014/main" id="{DB1B33C6-3D19-4860-9DD6-65E3ACBFE615}"/>
               </a:ext>
             </a:extLst>
           </p:cNvPr>
@@ -7519,7 +7519,7 @@
           <p:cNvPr id="24" name="">
             <a:extLst xmlns:a="http://schemas.openxmlformats.org/drawingml/2006/main">
               <a:ext uri="{FF2B5EF4-FFF2-40B4-BE49-F238E27FC236}">
-                <a16:creationId xmlns:a16="http://schemas.microsoft.com/office/drawing/2014/main" id="{3DDE3F03-4EF4-405E-8F10-4B2B72053A6A}"/>
+                <a16:creationId xmlns:a16="http://schemas.microsoft.com/office/drawing/2014/main" id="{F557F63B-2D3C-4348-9A89-376CD64C36E6}"/>
               </a:ext>
             </a:extLst>
           </p:cNvPr>
@@ -7583,7 +7583,7 @@
           <p:cNvPr id="25" name="">
             <a:extLst xmlns:a="http://schemas.openxmlformats.org/drawingml/2006/main">
               <a:ext uri="{FF2B5EF4-FFF2-40B4-BE49-F238E27FC236}">
-                <a16:creationId xmlns:a16="http://schemas.microsoft.com/office/drawing/2014/main" id="{AC169951-A6BB-4CC3-8368-C4B46C2C63F5}"/>
+                <a16:creationId xmlns:a16="http://schemas.microsoft.com/office/drawing/2014/main" id="{428A30BA-DB5B-4435-93BC-35682701BDE6}"/>
               </a:ext>
             </a:extLst>
           </p:cNvPr>
@@ -7647,7 +7647,7 @@
           <p:cNvPr id="26" name="">
             <a:extLst xmlns:a="http://schemas.openxmlformats.org/drawingml/2006/main">
               <a:ext uri="{FF2B5EF4-FFF2-40B4-BE49-F238E27FC236}">
-                <a16:creationId xmlns:a16="http://schemas.microsoft.com/office/drawing/2014/main" id="{8076E127-E076-4664-A1C7-20795AACED49}"/>
+                <a16:creationId xmlns:a16="http://schemas.microsoft.com/office/drawing/2014/main" id="{AE4D3662-DDCF-4727-8B13-4546C83D3DDC}"/>
               </a:ext>
             </a:extLst>
           </p:cNvPr>
@@ -7709,7 +7709,7 @@
     </p:spTree>
     <p:extLst>
       <p:ext uri="{BB962C8B-B14F-4D97-AF65-F5344CB8AC3E}">
-        <p14:creationId xmlns:p14="http://schemas.microsoft.com/office/powerpoint/2010/main" val="1596411556"/>
+        <p14:creationId xmlns:p14="http://schemas.microsoft.com/office/powerpoint/2010/main" val="526403912"/>
       </p:ext>
     </p:extLst>
   </p:cSld>
@@ -7733,7 +7733,7 @@
           <p:cNvPr id="1" name="">
             <a:extLst xmlns:a="http://schemas.openxmlformats.org/drawingml/2006/main">
               <a:ext uri="{FF2B5EF4-FFF2-40B4-BE49-F238E27FC236}">
-                <a16:creationId xmlns:a16="http://schemas.microsoft.com/office/drawing/2014/main" id="{56719910-2A97-4341-B1BC-690DA8C31186}"/>
+                <a16:creationId xmlns:a16="http://schemas.microsoft.com/office/drawing/2014/main" id="{14093961-C594-45EB-BB6C-114A851C2715}"/>
               </a:ext>
             </a:extLst>
           </p:cNvPr>
@@ -7768,7 +7768,7 @@
           <p:cNvPr id="2" name="">
             <a:extLst xmlns:a="http://schemas.openxmlformats.org/drawingml/2006/main">
               <a:ext uri="{FF2B5EF4-FFF2-40B4-BE49-F238E27FC236}">
-                <a16:creationId xmlns:a16="http://schemas.microsoft.com/office/drawing/2014/main" id="{F1A31DE4-0C8F-49EA-B5D4-071D6478AC57}"/>
+                <a16:creationId xmlns:a16="http://schemas.microsoft.com/office/drawing/2014/main" id="{2AD3728D-D5D7-4F68-BF5A-83999CF8B776}"/>
               </a:ext>
             </a:extLst>
           </p:cNvPr>
@@ -7803,7 +7803,7 @@
           <p:cNvPr id="3" name="">
             <a:extLst xmlns:a="http://schemas.openxmlformats.org/drawingml/2006/main">
               <a:ext uri="{FF2B5EF4-FFF2-40B4-BE49-F238E27FC236}">
-                <a16:creationId xmlns:a16="http://schemas.microsoft.com/office/drawing/2014/main" id="{13E72ADF-90D6-4E3E-A56C-E453AFD4C29C}"/>
+                <a16:creationId xmlns:a16="http://schemas.microsoft.com/office/drawing/2014/main" id="{995A0FCA-4AF2-4231-A47D-C54818A438A3}"/>
               </a:ext>
             </a:extLst>
           </p:cNvPr>
@@ -7867,7 +7867,7 @@
           <p:cNvPr id="4" name="">
             <a:extLst xmlns:a="http://schemas.openxmlformats.org/drawingml/2006/main">
               <a:ext uri="{FF2B5EF4-FFF2-40B4-BE49-F238E27FC236}">
-                <a16:creationId xmlns:a16="http://schemas.microsoft.com/office/drawing/2014/main" id="{4ECD9C2D-B073-48A7-9D48-963189D5FF62}"/>
+                <a16:creationId xmlns:a16="http://schemas.microsoft.com/office/drawing/2014/main" id="{61EE2377-2CD6-4FB6-B0E7-9AFEE3AD7AD2}"/>
               </a:ext>
             </a:extLst>
           </p:cNvPr>
@@ -7931,7 +7931,7 @@
           <p:cNvPr id="5" name="">
             <a:extLst xmlns:a="http://schemas.openxmlformats.org/drawingml/2006/main">
               <a:ext uri="{FF2B5EF4-FFF2-40B4-BE49-F238E27FC236}">
-                <a16:creationId xmlns:a16="http://schemas.microsoft.com/office/drawing/2014/main" id="{61B99BAC-69B6-4EA5-90C9-84DCFBBFA190}"/>
+                <a16:creationId xmlns:a16="http://schemas.microsoft.com/office/drawing/2014/main" id="{6EEFFFBD-6E77-4D28-9FB6-9F0B59233C19}"/>
               </a:ext>
             </a:extLst>
           </p:cNvPr>
@@ -7995,7 +7995,7 @@
           <p:cNvPr id="6" name="">
             <a:extLst xmlns:a="http://schemas.openxmlformats.org/drawingml/2006/main">
               <a:ext uri="{FF2B5EF4-FFF2-40B4-BE49-F238E27FC236}">
-                <a16:creationId xmlns:a16="http://schemas.microsoft.com/office/drawing/2014/main" id="{2AA30F12-F367-4EAF-B620-505538E76684}"/>
+                <a16:creationId xmlns:a16="http://schemas.microsoft.com/office/drawing/2014/main" id="{D725B99B-546A-4BD2-AE5E-1EEE19FD2C6D}"/>
               </a:ext>
             </a:extLst>
           </p:cNvPr>
@@ -8059,7 +8059,7 @@
           <p:cNvPr id="7" name="">
             <a:extLst xmlns:a="http://schemas.openxmlformats.org/drawingml/2006/main">
               <a:ext uri="{FF2B5EF4-FFF2-40B4-BE49-F238E27FC236}">
-                <a16:creationId xmlns:a16="http://schemas.microsoft.com/office/drawing/2014/main" id="{9C344A24-25F3-437D-9ACD-A7A008EB96D7}"/>
+                <a16:creationId xmlns:a16="http://schemas.microsoft.com/office/drawing/2014/main" id="{C091B7A3-DB38-4D3C-B43F-3FCD7251E49C}"/>
               </a:ext>
             </a:extLst>
           </p:cNvPr>
@@ -8094,7 +8094,7 @@
           <p:cNvPr id="8" name="">
             <a:extLst xmlns:a="http://schemas.openxmlformats.org/drawingml/2006/main">
               <a:ext uri="{FF2B5EF4-FFF2-40B4-BE49-F238E27FC236}">
-                <a16:creationId xmlns:a16="http://schemas.microsoft.com/office/drawing/2014/main" id="{B3F60EF6-C605-453E-9234-211C4153FAE5}"/>
+                <a16:creationId xmlns:a16="http://schemas.microsoft.com/office/drawing/2014/main" id="{88745CE2-008E-438A-804F-FA07A1ADEB60}"/>
               </a:ext>
             </a:extLst>
           </p:cNvPr>
@@ -8158,7 +8158,7 @@
           <p:cNvPr id="9" name="">
             <a:extLst xmlns:a="http://schemas.openxmlformats.org/drawingml/2006/main">
               <a:ext uri="{FF2B5EF4-FFF2-40B4-BE49-F238E27FC236}">
-                <a16:creationId xmlns:a16="http://schemas.microsoft.com/office/drawing/2014/main" id="{06F2EE0A-E974-41F6-AA17-1CEC8F3F7490}"/>
+                <a16:creationId xmlns:a16="http://schemas.microsoft.com/office/drawing/2014/main" id="{8CE48853-349E-4A9B-AD24-446473190AC1}"/>
               </a:ext>
             </a:extLst>
           </p:cNvPr>
@@ -8212,7 +8212,7 @@
                 <a:ea typeface="Aptos"/>
                 <a:cs typeface="Aptos"/>
               </a:rPr>
-              <a:t>160</a:t>
+              <a:t>163</a:t>
             </a:r>
           </a:p>
         </p:txBody>
@@ -8222,7 +8222,7 @@
           <p:cNvPr id="10" name="">
             <a:extLst xmlns:a="http://schemas.openxmlformats.org/drawingml/2006/main">
               <a:ext uri="{FF2B5EF4-FFF2-40B4-BE49-F238E27FC236}">
-                <a16:creationId xmlns:a16="http://schemas.microsoft.com/office/drawing/2014/main" id="{2BAF7533-D7A8-44D5-9F1F-A605394A5694}"/>
+                <a16:creationId xmlns:a16="http://schemas.microsoft.com/office/drawing/2014/main" id="{EA93DCD6-64C7-47AF-B3C0-64521D65BD05}"/>
               </a:ext>
             </a:extLst>
           </p:cNvPr>
@@ -8286,7 +8286,7 @@
           <p:cNvPr id="11" name="">
             <a:extLst xmlns:a="http://schemas.openxmlformats.org/drawingml/2006/main">
               <a:ext uri="{FF2B5EF4-FFF2-40B4-BE49-F238E27FC236}">
-                <a16:creationId xmlns:a16="http://schemas.microsoft.com/office/drawing/2014/main" id="{37BE5FDA-E9DB-4B6E-8FAD-EE006E784D13}"/>
+                <a16:creationId xmlns:a16="http://schemas.microsoft.com/office/drawing/2014/main" id="{0B58765D-61CF-4901-BDBB-982BF7F09D4A}"/>
               </a:ext>
             </a:extLst>
           </p:cNvPr>
@@ -8321,7 +8321,7 @@
           <p:cNvPr id="12" name="">
             <a:extLst xmlns:a="http://schemas.openxmlformats.org/drawingml/2006/main">
               <a:ext uri="{FF2B5EF4-FFF2-40B4-BE49-F238E27FC236}">
-                <a16:creationId xmlns:a16="http://schemas.microsoft.com/office/drawing/2014/main" id="{58331576-1E28-4E8F-A605-6826A5479EB5}"/>
+                <a16:creationId xmlns:a16="http://schemas.microsoft.com/office/drawing/2014/main" id="{0C506529-55F8-45D5-928F-44431C7C118E}"/>
               </a:ext>
             </a:extLst>
           </p:cNvPr>
@@ -8385,7 +8385,7 @@
           <p:cNvPr id="13" name="">
             <a:extLst xmlns:a="http://schemas.openxmlformats.org/drawingml/2006/main">
               <a:ext uri="{FF2B5EF4-FFF2-40B4-BE49-F238E27FC236}">
-                <a16:creationId xmlns:a16="http://schemas.microsoft.com/office/drawing/2014/main" id="{D3F6E62A-C952-4BE4-A7F2-1D0DCBD7BA9C}"/>
+                <a16:creationId xmlns:a16="http://schemas.microsoft.com/office/drawing/2014/main" id="{FAF68C83-5A14-4F16-AA66-3166A24E1B73}"/>
               </a:ext>
             </a:extLst>
           </p:cNvPr>
@@ -8439,7 +8439,7 @@
                 <a:ea typeface="Aptos"/>
                 <a:cs typeface="Aptos"/>
               </a:rPr>
-              <a:t>120</a:t>
+              <a:t>122</a:t>
             </a:r>
           </a:p>
         </p:txBody>
@@ -8449,7 +8449,7 @@
           <p:cNvPr id="14" name="">
             <a:extLst xmlns:a="http://schemas.openxmlformats.org/drawingml/2006/main">
               <a:ext uri="{FF2B5EF4-FFF2-40B4-BE49-F238E27FC236}">
-                <a16:creationId xmlns:a16="http://schemas.microsoft.com/office/drawing/2014/main" id="{F8621A0A-3C7F-4BAC-96E5-317FCE335609}"/>
+                <a16:creationId xmlns:a16="http://schemas.microsoft.com/office/drawing/2014/main" id="{11369167-2BF7-4934-9AD1-E0A2063BBC0A}"/>
               </a:ext>
             </a:extLst>
           </p:cNvPr>
@@ -8513,7 +8513,7 @@
           <p:cNvPr id="15" name="">
             <a:extLst xmlns:a="http://schemas.openxmlformats.org/drawingml/2006/main">
               <a:ext uri="{FF2B5EF4-FFF2-40B4-BE49-F238E27FC236}">
-                <a16:creationId xmlns:a16="http://schemas.microsoft.com/office/drawing/2014/main" id="{A80E1FC9-823C-4FA7-93D4-2D26FFC08571}"/>
+                <a16:creationId xmlns:a16="http://schemas.microsoft.com/office/drawing/2014/main" id="{D90ABDC2-E2A6-45DD-BB80-45D7A239B87A}"/>
               </a:ext>
             </a:extLst>
           </p:cNvPr>
@@ -8548,7 +8548,7 @@
           <p:cNvPr id="16" name="">
             <a:extLst xmlns:a="http://schemas.openxmlformats.org/drawingml/2006/main">
               <a:ext uri="{FF2B5EF4-FFF2-40B4-BE49-F238E27FC236}">
-                <a16:creationId xmlns:a16="http://schemas.microsoft.com/office/drawing/2014/main" id="{45EEA2FA-55C5-4B82-8E98-66902FA8864C}"/>
+                <a16:creationId xmlns:a16="http://schemas.microsoft.com/office/drawing/2014/main" id="{845A1470-1A9E-4353-9B46-0CC9FF5FC203}"/>
               </a:ext>
             </a:extLst>
           </p:cNvPr>
@@ -8612,7 +8612,7 @@
           <p:cNvPr id="17" name="">
             <a:extLst xmlns:a="http://schemas.openxmlformats.org/drawingml/2006/main">
               <a:ext uri="{FF2B5EF4-FFF2-40B4-BE49-F238E27FC236}">
-                <a16:creationId xmlns:a16="http://schemas.microsoft.com/office/drawing/2014/main" id="{66E328B8-E1EF-4AC5-9B85-78B1CB767FE0}"/>
+                <a16:creationId xmlns:a16="http://schemas.microsoft.com/office/drawing/2014/main" id="{662BC869-B455-4D0F-BDDB-D4E6023E150E}"/>
               </a:ext>
             </a:extLst>
           </p:cNvPr>
@@ -8676,7 +8676,7 @@
           <p:cNvPr id="18" name="">
             <a:extLst xmlns:a="http://schemas.openxmlformats.org/drawingml/2006/main">
               <a:ext uri="{FF2B5EF4-FFF2-40B4-BE49-F238E27FC236}">
-                <a16:creationId xmlns:a16="http://schemas.microsoft.com/office/drawing/2014/main" id="{EA6A8C2C-CB69-4C11-9A19-285D8604F0B7}"/>
+                <a16:creationId xmlns:a16="http://schemas.microsoft.com/office/drawing/2014/main" id="{116C0814-F633-47F5-9568-33219D1A3EE0}"/>
               </a:ext>
             </a:extLst>
           </p:cNvPr>
@@ -8740,7 +8740,7 @@
           <p:cNvPr id="19" name="">
             <a:extLst xmlns:a="http://schemas.openxmlformats.org/drawingml/2006/main">
               <a:ext uri="{FF2B5EF4-FFF2-40B4-BE49-F238E27FC236}">
-                <a16:creationId xmlns:a16="http://schemas.microsoft.com/office/drawing/2014/main" id="{A6E0E011-117D-4135-A085-0C0A9170B8A3}"/>
+                <a16:creationId xmlns:a16="http://schemas.microsoft.com/office/drawing/2014/main" id="{369E8A76-A21C-42D3-9B69-E72B942B59C4}"/>
               </a:ext>
             </a:extLst>
           </p:cNvPr>
@@ -8775,7 +8775,7 @@
           <p:cNvPr id="20" name="">
             <a:extLst xmlns:a="http://schemas.openxmlformats.org/drawingml/2006/main">
               <a:ext uri="{FF2B5EF4-FFF2-40B4-BE49-F238E27FC236}">
-                <a16:creationId xmlns:a16="http://schemas.microsoft.com/office/drawing/2014/main" id="{687FC3A5-DB85-46DF-A7F9-BCBFF1EB4AAF}"/>
+                <a16:creationId xmlns:a16="http://schemas.microsoft.com/office/drawing/2014/main" id="{8753A042-FBE9-4C18-A762-A86A292EBB26}"/>
               </a:ext>
             </a:extLst>
           </p:cNvPr>
@@ -8839,7 +8839,7 @@
           <p:cNvPr id="21" name="">
             <a:extLst xmlns:a="http://schemas.openxmlformats.org/drawingml/2006/main">
               <a:ext uri="{FF2B5EF4-FFF2-40B4-BE49-F238E27FC236}">
-                <a16:creationId xmlns:a16="http://schemas.microsoft.com/office/drawing/2014/main" id="{545BE920-EDFB-42A3-ADC2-922D7681CA54}"/>
+                <a16:creationId xmlns:a16="http://schemas.microsoft.com/office/drawing/2014/main" id="{4774AE09-7C83-4398-A660-BAA6064D9716}"/>
               </a:ext>
             </a:extLst>
           </p:cNvPr>
@@ -8903,7 +8903,7 @@
           <p:cNvPr id="22" name="">
             <a:extLst xmlns:a="http://schemas.openxmlformats.org/drawingml/2006/main">
               <a:ext uri="{FF2B5EF4-FFF2-40B4-BE49-F238E27FC236}">
-                <a16:creationId xmlns:a16="http://schemas.microsoft.com/office/drawing/2014/main" id="{1DFB2CAB-C8AA-4310-A28D-2DFC35032537}"/>
+                <a16:creationId xmlns:a16="http://schemas.microsoft.com/office/drawing/2014/main" id="{163997B8-B93B-4D86-AE73-101026966A2B}"/>
               </a:ext>
             </a:extLst>
           </p:cNvPr>
@@ -8967,7 +8967,7 @@
           <p:cNvPr id="23" name="">
             <a:extLst xmlns:a="http://schemas.openxmlformats.org/drawingml/2006/main">
               <a:ext uri="{FF2B5EF4-FFF2-40B4-BE49-F238E27FC236}">
-                <a16:creationId xmlns:a16="http://schemas.microsoft.com/office/drawing/2014/main" id="{BC1511EB-0A09-4B44-95DF-21C59D05A7A4}"/>
+                <a16:creationId xmlns:a16="http://schemas.microsoft.com/office/drawing/2014/main" id="{0561B586-E37B-41B9-855A-26973E7CBE21}"/>
               </a:ext>
             </a:extLst>
           </p:cNvPr>
@@ -9000,7 +9000,7 @@
           <p:cNvPr id="24" name="">
             <a:extLst xmlns:a="http://schemas.openxmlformats.org/drawingml/2006/main">
               <a:ext uri="{FF2B5EF4-FFF2-40B4-BE49-F238E27FC236}">
-                <a16:creationId xmlns:a16="http://schemas.microsoft.com/office/drawing/2014/main" id="{DD122F4C-3455-4EF6-96ED-50E915B99417}"/>
+                <a16:creationId xmlns:a16="http://schemas.microsoft.com/office/drawing/2014/main" id="{9B402650-E6B6-4874-8408-9D85F08B994A}"/>
               </a:ext>
             </a:extLst>
           </p:cNvPr>
@@ -9064,7 +9064,7 @@
           <p:cNvPr id="25" name="">
             <a:extLst xmlns:a="http://schemas.openxmlformats.org/drawingml/2006/main">
               <a:ext uri="{FF2B5EF4-FFF2-40B4-BE49-F238E27FC236}">
-                <a16:creationId xmlns:a16="http://schemas.microsoft.com/office/drawing/2014/main" id="{AE82CBA6-4B3C-439C-9C10-17390C889720}"/>
+                <a16:creationId xmlns:a16="http://schemas.microsoft.com/office/drawing/2014/main" id="{C0ED6847-55E3-4240-8A4C-83F99A7EFBA8}"/>
               </a:ext>
             </a:extLst>
           </p:cNvPr>
@@ -9128,7 +9128,7 @@
           <p:cNvPr id="26" name="">
             <a:extLst xmlns:a="http://schemas.openxmlformats.org/drawingml/2006/main">
               <a:ext uri="{FF2B5EF4-FFF2-40B4-BE49-F238E27FC236}">
-                <a16:creationId xmlns:a16="http://schemas.microsoft.com/office/drawing/2014/main" id="{DBF2C530-425B-418F-8800-AE9C839FF4CD}"/>
+                <a16:creationId xmlns:a16="http://schemas.microsoft.com/office/drawing/2014/main" id="{E7321871-4684-4D23-A7C6-2702B3D3A5DC}"/>
               </a:ext>
             </a:extLst>
           </p:cNvPr>
@@ -9192,7 +9192,7 @@
           <p:cNvPr id="27" name="">
             <a:extLst xmlns:a="http://schemas.openxmlformats.org/drawingml/2006/main">
               <a:ext uri="{FF2B5EF4-FFF2-40B4-BE49-F238E27FC236}">
-                <a16:creationId xmlns:a16="http://schemas.microsoft.com/office/drawing/2014/main" id="{AB1FF683-306D-4DC3-8F9F-A7DC66415377}"/>
+                <a16:creationId xmlns:a16="http://schemas.microsoft.com/office/drawing/2014/main" id="{76DB8976-36BD-492F-9B20-BDFE00EF312D}"/>
               </a:ext>
             </a:extLst>
           </p:cNvPr>
@@ -9254,7 +9254,7 @@
     </p:spTree>
     <p:extLst>
       <p:ext uri="{BB962C8B-B14F-4D97-AF65-F5344CB8AC3E}">
-        <p14:creationId xmlns:p14="http://schemas.microsoft.com/office/powerpoint/2010/main" val="1267871397"/>
+        <p14:creationId xmlns:p14="http://schemas.microsoft.com/office/powerpoint/2010/main" val="823658042"/>
       </p:ext>
     </p:extLst>
   </p:cSld>
@@ -9278,7 +9278,7 @@
           <p:cNvPr id="1" name="">
             <a:extLst xmlns:a="http://schemas.openxmlformats.org/drawingml/2006/main">
               <a:ext uri="{FF2B5EF4-FFF2-40B4-BE49-F238E27FC236}">
-                <a16:creationId xmlns:a16="http://schemas.microsoft.com/office/drawing/2014/main" id="{28EA78B0-BDAB-4033-AE74-2DB745EED555}"/>
+                <a16:creationId xmlns:a16="http://schemas.microsoft.com/office/drawing/2014/main" id="{402A8A9A-52E6-4978-A2BC-6DDE3ED54A5C}"/>
               </a:ext>
             </a:extLst>
           </p:cNvPr>
@@ -9313,7 +9313,7 @@
           <p:cNvPr id="2" name="">
             <a:extLst xmlns:a="http://schemas.openxmlformats.org/drawingml/2006/main">
               <a:ext uri="{FF2B5EF4-FFF2-40B4-BE49-F238E27FC236}">
-                <a16:creationId xmlns:a16="http://schemas.microsoft.com/office/drawing/2014/main" id="{F892C0F6-D573-40A8-9237-B608C7B6D8F8}"/>
+                <a16:creationId xmlns:a16="http://schemas.microsoft.com/office/drawing/2014/main" id="{8738D994-DF81-41F8-AAC7-D5378ED87CEB}"/>
               </a:ext>
             </a:extLst>
           </p:cNvPr>
@@ -9348,7 +9348,7 @@
           <p:cNvPr id="3" name="">
             <a:extLst xmlns:a="http://schemas.openxmlformats.org/drawingml/2006/main">
               <a:ext uri="{FF2B5EF4-FFF2-40B4-BE49-F238E27FC236}">
-                <a16:creationId xmlns:a16="http://schemas.microsoft.com/office/drawing/2014/main" id="{890563F2-C224-4D68-BD64-A1627C9B2D3A}"/>
+                <a16:creationId xmlns:a16="http://schemas.microsoft.com/office/drawing/2014/main" id="{47959B74-9D7B-4C91-A16F-BE15BD782AF7}"/>
               </a:ext>
             </a:extLst>
           </p:cNvPr>
@@ -9412,7 +9412,7 @@
           <p:cNvPr id="4" name="">
             <a:extLst xmlns:a="http://schemas.openxmlformats.org/drawingml/2006/main">
               <a:ext uri="{FF2B5EF4-FFF2-40B4-BE49-F238E27FC236}">
-                <a16:creationId xmlns:a16="http://schemas.microsoft.com/office/drawing/2014/main" id="{6EE9EBCC-BC0F-4ECD-A4DB-8A485CDF2B4E}"/>
+                <a16:creationId xmlns:a16="http://schemas.microsoft.com/office/drawing/2014/main" id="{D7DAB57F-D9BD-422F-8C94-D5EE36CB5BC7}"/>
               </a:ext>
             </a:extLst>
           </p:cNvPr>
@@ -9476,7 +9476,7 @@
           <p:cNvPr id="5" name="">
             <a:extLst xmlns:a="http://schemas.openxmlformats.org/drawingml/2006/main">
               <a:ext uri="{FF2B5EF4-FFF2-40B4-BE49-F238E27FC236}">
-                <a16:creationId xmlns:a16="http://schemas.microsoft.com/office/drawing/2014/main" id="{3D49467D-444D-464A-8CCD-0CB133206261}"/>
+                <a16:creationId xmlns:a16="http://schemas.microsoft.com/office/drawing/2014/main" id="{C94F747E-8035-4022-AEB9-9DE0E46A5FB3}"/>
               </a:ext>
             </a:extLst>
           </p:cNvPr>
@@ -9540,7 +9540,7 @@
           <p:cNvPr id="6" name="">
             <a:extLst xmlns:a="http://schemas.openxmlformats.org/drawingml/2006/main">
               <a:ext uri="{FF2B5EF4-FFF2-40B4-BE49-F238E27FC236}">
-                <a16:creationId xmlns:a16="http://schemas.microsoft.com/office/drawing/2014/main" id="{CE7A2592-E004-40FB-AE52-6FEE72DEBF1E}"/>
+                <a16:creationId xmlns:a16="http://schemas.microsoft.com/office/drawing/2014/main" id="{29FC3D5D-46D1-4101-87D1-67AF98C9D44E}"/>
               </a:ext>
             </a:extLst>
           </p:cNvPr>
@@ -9604,7 +9604,7 @@
           <p:cNvPr id="7" name="">
             <a:extLst xmlns:a="http://schemas.openxmlformats.org/drawingml/2006/main">
               <a:ext uri="{FF2B5EF4-FFF2-40B4-BE49-F238E27FC236}">
-                <a16:creationId xmlns:a16="http://schemas.microsoft.com/office/drawing/2014/main" id="{86C35A13-4A96-476E-AA26-99B555DCDB35}"/>
+                <a16:creationId xmlns:a16="http://schemas.microsoft.com/office/drawing/2014/main" id="{58E9FF18-5E02-44D3-9DFE-1D224A4F5A1B}"/>
               </a:ext>
             </a:extLst>
           </p:cNvPr>
@@ -9637,7 +9637,7 @@
           <p:cNvPr id="8" name="">
             <a:extLst xmlns:a="http://schemas.openxmlformats.org/drawingml/2006/main">
               <a:ext uri="{FF2B5EF4-FFF2-40B4-BE49-F238E27FC236}">
-                <a16:creationId xmlns:a16="http://schemas.microsoft.com/office/drawing/2014/main" id="{70E59CC1-417F-48A7-A199-F76C19E1CBF6}"/>
+                <a16:creationId xmlns:a16="http://schemas.microsoft.com/office/drawing/2014/main" id="{C56ECA95-803D-4A90-8443-9949FC8B9ED2}"/>
               </a:ext>
             </a:extLst>
           </p:cNvPr>
@@ -9701,7 +9701,7 @@
           <p:cNvPr id="9" name="">
             <a:extLst xmlns:a="http://schemas.openxmlformats.org/drawingml/2006/main">
               <a:ext uri="{FF2B5EF4-FFF2-40B4-BE49-F238E27FC236}">
-                <a16:creationId xmlns:a16="http://schemas.microsoft.com/office/drawing/2014/main" id="{4B23A732-9694-420A-A5E9-B0AB51B1B436}"/>
+                <a16:creationId xmlns:a16="http://schemas.microsoft.com/office/drawing/2014/main" id="{259085BA-2BAE-4AE2-9C00-2C0DC7FD2068}"/>
               </a:ext>
             </a:extLst>
           </p:cNvPr>
@@ -9765,7 +9765,7 @@
           <p:cNvPr id="10" name="">
             <a:extLst xmlns:a="http://schemas.openxmlformats.org/drawingml/2006/main">
               <a:ext uri="{FF2B5EF4-FFF2-40B4-BE49-F238E27FC236}">
-                <a16:creationId xmlns:a16="http://schemas.microsoft.com/office/drawing/2014/main" id="{CCBB89E6-CF74-4552-8F78-CBF863901E5A}"/>
+                <a16:creationId xmlns:a16="http://schemas.microsoft.com/office/drawing/2014/main" id="{488A7E47-E16C-421D-87F0-71DB0D846B78}"/>
               </a:ext>
             </a:extLst>
           </p:cNvPr>
@@ -9798,7 +9798,7 @@
           <p:cNvPr id="11" name="">
             <a:extLst xmlns:a="http://schemas.openxmlformats.org/drawingml/2006/main">
               <a:ext uri="{FF2B5EF4-FFF2-40B4-BE49-F238E27FC236}">
-                <a16:creationId xmlns:a16="http://schemas.microsoft.com/office/drawing/2014/main" id="{BA3BDB90-21E8-424C-A9EF-443F0CFE3ACA}"/>
+                <a16:creationId xmlns:a16="http://schemas.microsoft.com/office/drawing/2014/main" id="{B123067B-17DD-4844-9B97-F3B263BCBED8}"/>
               </a:ext>
             </a:extLst>
           </p:cNvPr>
@@ -9862,7 +9862,7 @@
           <p:cNvPr id="12" name="">
             <a:extLst xmlns:a="http://schemas.openxmlformats.org/drawingml/2006/main">
               <a:ext uri="{FF2B5EF4-FFF2-40B4-BE49-F238E27FC236}">
-                <a16:creationId xmlns:a16="http://schemas.microsoft.com/office/drawing/2014/main" id="{47D1722A-FA7B-4FE3-AB06-8F43705F0324}"/>
+                <a16:creationId xmlns:a16="http://schemas.microsoft.com/office/drawing/2014/main" id="{894E3D64-5998-4568-BCE6-FAB395691EC1}"/>
               </a:ext>
             </a:extLst>
           </p:cNvPr>
@@ -9926,7 +9926,7 @@
           <p:cNvPr id="13" name="">
             <a:extLst xmlns:a="http://schemas.openxmlformats.org/drawingml/2006/main">
               <a:ext uri="{FF2B5EF4-FFF2-40B4-BE49-F238E27FC236}">
-                <a16:creationId xmlns:a16="http://schemas.microsoft.com/office/drawing/2014/main" id="{405CA4E1-4279-4F43-B89A-9A9970020612}"/>
+                <a16:creationId xmlns:a16="http://schemas.microsoft.com/office/drawing/2014/main" id="{41603D80-C3BE-42C6-90DE-F4B3F1BEBF0C}"/>
               </a:ext>
             </a:extLst>
           </p:cNvPr>
@@ -9959,7 +9959,7 @@
           <p:cNvPr id="14" name="">
             <a:extLst xmlns:a="http://schemas.openxmlformats.org/drawingml/2006/main">
               <a:ext uri="{FF2B5EF4-FFF2-40B4-BE49-F238E27FC236}">
-                <a16:creationId xmlns:a16="http://schemas.microsoft.com/office/drawing/2014/main" id="{B21552A1-E36E-46C0-9215-656C1E9F6C59}"/>
+                <a16:creationId xmlns:a16="http://schemas.microsoft.com/office/drawing/2014/main" id="{DE64A20F-B620-451D-BF07-A62B320C3180}"/>
               </a:ext>
             </a:extLst>
           </p:cNvPr>
@@ -10023,7 +10023,7 @@
           <p:cNvPr id="15" name="">
             <a:extLst xmlns:a="http://schemas.openxmlformats.org/drawingml/2006/main">
               <a:ext uri="{FF2B5EF4-FFF2-40B4-BE49-F238E27FC236}">
-                <a16:creationId xmlns:a16="http://schemas.microsoft.com/office/drawing/2014/main" id="{4F7F7F54-D413-4A7E-8CA6-CD76E6093D1D}"/>
+                <a16:creationId xmlns:a16="http://schemas.microsoft.com/office/drawing/2014/main" id="{3DB66EDE-D04B-4B23-9AA5-0B340A042EED}"/>
               </a:ext>
             </a:extLst>
           </p:cNvPr>
@@ -10087,7 +10087,7 @@
           <p:cNvPr id="16" name="">
             <a:extLst xmlns:a="http://schemas.openxmlformats.org/drawingml/2006/main">
               <a:ext uri="{FF2B5EF4-FFF2-40B4-BE49-F238E27FC236}">
-                <a16:creationId xmlns:a16="http://schemas.microsoft.com/office/drawing/2014/main" id="{1ED0C382-37C3-4D00-8C29-21845D1C572F}"/>
+                <a16:creationId xmlns:a16="http://schemas.microsoft.com/office/drawing/2014/main" id="{8F854EFE-D876-41E9-8E26-164AA5F77271}"/>
               </a:ext>
             </a:extLst>
           </p:cNvPr>
@@ -10151,7 +10151,7 @@
           <p:cNvPr id="17" name="">
             <a:extLst xmlns:a="http://schemas.openxmlformats.org/drawingml/2006/main">
               <a:ext uri="{FF2B5EF4-FFF2-40B4-BE49-F238E27FC236}">
-                <a16:creationId xmlns:a16="http://schemas.microsoft.com/office/drawing/2014/main" id="{82BE725E-1E10-4B0B-BC9F-56308D76956B}"/>
+                <a16:creationId xmlns:a16="http://schemas.microsoft.com/office/drawing/2014/main" id="{AF65A2B3-E988-4D9A-9AC8-CACC4FFA895F}"/>
               </a:ext>
             </a:extLst>
           </p:cNvPr>
@@ -10213,7 +10213,7 @@
     </p:spTree>
     <p:extLst>
       <p:ext uri="{BB962C8B-B14F-4D97-AF65-F5344CB8AC3E}">
-        <p14:creationId xmlns:p14="http://schemas.microsoft.com/office/powerpoint/2010/main" val="1812809456"/>
+        <p14:creationId xmlns:p14="http://schemas.microsoft.com/office/powerpoint/2010/main" val="232879943"/>
       </p:ext>
     </p:extLst>
   </p:cSld>
@@ -10237,7 +10237,7 @@
           <p:cNvPr id="1" name="">
             <a:extLst xmlns:a="http://schemas.openxmlformats.org/drawingml/2006/main">
               <a:ext uri="{FF2B5EF4-FFF2-40B4-BE49-F238E27FC236}">
-                <a16:creationId xmlns:a16="http://schemas.microsoft.com/office/drawing/2014/main" id="{049283AC-F4FC-48E7-A31F-449EF4BF4E69}"/>
+                <a16:creationId xmlns:a16="http://schemas.microsoft.com/office/drawing/2014/main" id="{E5EA1057-0350-44F8-AB01-74F1A44174BA}"/>
               </a:ext>
             </a:extLst>
           </p:cNvPr>
@@ -10272,7 +10272,7 @@
           <p:cNvPr id="2" name="">
             <a:extLst xmlns:a="http://schemas.openxmlformats.org/drawingml/2006/main">
               <a:ext uri="{FF2B5EF4-FFF2-40B4-BE49-F238E27FC236}">
-                <a16:creationId xmlns:a16="http://schemas.microsoft.com/office/drawing/2014/main" id="{AD514649-41D7-4556-B6F9-3244FE382991}"/>
+                <a16:creationId xmlns:a16="http://schemas.microsoft.com/office/drawing/2014/main" id="{85F555F5-EFD3-48DC-99D5-03A337FE9F56}"/>
               </a:ext>
             </a:extLst>
           </p:cNvPr>
@@ -10307,7 +10307,7 @@
           <p:cNvPr id="3" name="">
             <a:extLst xmlns:a="http://schemas.openxmlformats.org/drawingml/2006/main">
               <a:ext uri="{FF2B5EF4-FFF2-40B4-BE49-F238E27FC236}">
-                <a16:creationId xmlns:a16="http://schemas.microsoft.com/office/drawing/2014/main" id="{EEF8703E-EC27-4BA0-85A0-A79BAEF4502A}"/>
+                <a16:creationId xmlns:a16="http://schemas.microsoft.com/office/drawing/2014/main" id="{C52B6734-49E8-42D5-B8DF-3238DCD8C45D}"/>
               </a:ext>
             </a:extLst>
           </p:cNvPr>
@@ -10371,7 +10371,7 @@
           <p:cNvPr id="4" name="">
             <a:extLst xmlns:a="http://schemas.openxmlformats.org/drawingml/2006/main">
               <a:ext uri="{FF2B5EF4-FFF2-40B4-BE49-F238E27FC236}">
-                <a16:creationId xmlns:a16="http://schemas.microsoft.com/office/drawing/2014/main" id="{667C3C2D-7CEF-488B-AFD1-12E7CBAFB5F2}"/>
+                <a16:creationId xmlns:a16="http://schemas.microsoft.com/office/drawing/2014/main" id="{6F87E53E-006C-4EB2-81A3-F1F3DC489281}"/>
               </a:ext>
             </a:extLst>
           </p:cNvPr>
@@ -10435,7 +10435,7 @@
           <p:cNvPr id="5" name="">
             <a:extLst xmlns:a="http://schemas.openxmlformats.org/drawingml/2006/main">
               <a:ext uri="{FF2B5EF4-FFF2-40B4-BE49-F238E27FC236}">
-                <a16:creationId xmlns:a16="http://schemas.microsoft.com/office/drawing/2014/main" id="{8107ED9B-B02D-4D81-81E0-F55666753C9B}"/>
+                <a16:creationId xmlns:a16="http://schemas.microsoft.com/office/drawing/2014/main" id="{4608629C-C68C-4539-BB85-3D5001118D62}"/>
               </a:ext>
             </a:extLst>
           </p:cNvPr>
@@ -10499,7 +10499,7 @@
           <p:cNvPr id="6" name="">
             <a:extLst xmlns:a="http://schemas.openxmlformats.org/drawingml/2006/main">
               <a:ext uri="{FF2B5EF4-FFF2-40B4-BE49-F238E27FC236}">
-                <a16:creationId xmlns:a16="http://schemas.microsoft.com/office/drawing/2014/main" id="{CCB66E91-B7EC-4CE3-BBDC-27222C170096}"/>
+                <a16:creationId xmlns:a16="http://schemas.microsoft.com/office/drawing/2014/main" id="{13EC2FA6-6092-4456-9E77-3526CF6CEC1E}"/>
               </a:ext>
             </a:extLst>
           </p:cNvPr>
@@ -10563,7 +10563,7 @@
           <p:cNvPr id="7" name="">
             <a:extLst xmlns:a="http://schemas.openxmlformats.org/drawingml/2006/main">
               <a:ext uri="{FF2B5EF4-FFF2-40B4-BE49-F238E27FC236}">
-                <a16:creationId xmlns:a16="http://schemas.microsoft.com/office/drawing/2014/main" id="{1B12F2DE-46FF-4361-AE44-6EFF0E8E3FC9}"/>
+                <a16:creationId xmlns:a16="http://schemas.microsoft.com/office/drawing/2014/main" id="{0F417317-253E-425A-8A2D-9AE37FCF0317}"/>
               </a:ext>
             </a:extLst>
           </p:cNvPr>
@@ -10596,7 +10596,7 @@
           <p:cNvPr id="8" name="">
             <a:extLst xmlns:a="http://schemas.openxmlformats.org/drawingml/2006/main">
               <a:ext uri="{FF2B5EF4-FFF2-40B4-BE49-F238E27FC236}">
-                <a16:creationId xmlns:a16="http://schemas.microsoft.com/office/drawing/2014/main" id="{52479D8F-5FF9-4E99-8C33-A2C5F7792046}"/>
+                <a16:creationId xmlns:a16="http://schemas.microsoft.com/office/drawing/2014/main" id="{DB9C2C8F-995A-4F4C-8FB4-C656C16B0B11}"/>
               </a:ext>
             </a:extLst>
           </p:cNvPr>
@@ -10660,7 +10660,7 @@
           <p:cNvPr id="9" name="">
             <a:extLst xmlns:a="http://schemas.openxmlformats.org/drawingml/2006/main">
               <a:ext uri="{FF2B5EF4-FFF2-40B4-BE49-F238E27FC236}">
-                <a16:creationId xmlns:a16="http://schemas.microsoft.com/office/drawing/2014/main" id="{2B960434-1461-4AD4-B46A-C95B4058D76E}"/>
+                <a16:creationId xmlns:a16="http://schemas.microsoft.com/office/drawing/2014/main" id="{EFFB0543-D2AF-4B8A-918A-EE238648A46B}"/>
               </a:ext>
             </a:extLst>
           </p:cNvPr>
@@ -10724,7 +10724,7 @@
           <p:cNvPr id="10" name="">
             <a:extLst xmlns:a="http://schemas.openxmlformats.org/drawingml/2006/main">
               <a:ext uri="{FF2B5EF4-FFF2-40B4-BE49-F238E27FC236}">
-                <a16:creationId xmlns:a16="http://schemas.microsoft.com/office/drawing/2014/main" id="{82BF952A-8AE9-41A5-8F62-C57EC9855E75}"/>
+                <a16:creationId xmlns:a16="http://schemas.microsoft.com/office/drawing/2014/main" id="{DAABD42C-9952-46D9-97D5-43C97C5B0451}"/>
               </a:ext>
             </a:extLst>
           </p:cNvPr>
@@ -10788,7 +10788,7 @@
           <p:cNvPr id="11" name="">
             <a:extLst xmlns:a="http://schemas.openxmlformats.org/drawingml/2006/main">
               <a:ext uri="{FF2B5EF4-FFF2-40B4-BE49-F238E27FC236}">
-                <a16:creationId xmlns:a16="http://schemas.microsoft.com/office/drawing/2014/main" id="{D5E08895-3C92-44B9-97E2-CC94BD5AE50F}"/>
+                <a16:creationId xmlns:a16="http://schemas.microsoft.com/office/drawing/2014/main" id="{D433DCCF-DBE1-4772-A52A-A253F326BE4A}"/>
               </a:ext>
             </a:extLst>
           </p:cNvPr>
@@ -10821,7 +10821,7 @@
           <p:cNvPr id="12" name="">
             <a:extLst xmlns:a="http://schemas.openxmlformats.org/drawingml/2006/main">
               <a:ext uri="{FF2B5EF4-FFF2-40B4-BE49-F238E27FC236}">
-                <a16:creationId xmlns:a16="http://schemas.microsoft.com/office/drawing/2014/main" id="{774CDA4B-00A7-4EB8-969C-530ED4F0E169}"/>
+                <a16:creationId xmlns:a16="http://schemas.microsoft.com/office/drawing/2014/main" id="{3729B1CF-A7F5-4D46-8279-B69A25CB8C3E}"/>
               </a:ext>
             </a:extLst>
           </p:cNvPr>
@@ -10885,7 +10885,7 @@
           <p:cNvPr id="13" name="">
             <a:extLst xmlns:a="http://schemas.openxmlformats.org/drawingml/2006/main">
               <a:ext uri="{FF2B5EF4-FFF2-40B4-BE49-F238E27FC236}">
-                <a16:creationId xmlns:a16="http://schemas.microsoft.com/office/drawing/2014/main" id="{E3A3A624-F165-45FA-AFC7-276C7E75820E}"/>
+                <a16:creationId xmlns:a16="http://schemas.microsoft.com/office/drawing/2014/main" id="{8B8900DC-2FE0-49FD-ACB7-7139C7E02C98}"/>
               </a:ext>
             </a:extLst>
           </p:cNvPr>
@@ -10949,7 +10949,7 @@
           <p:cNvPr id="14" name="">
             <a:extLst xmlns:a="http://schemas.openxmlformats.org/drawingml/2006/main">
               <a:ext uri="{FF2B5EF4-FFF2-40B4-BE49-F238E27FC236}">
-                <a16:creationId xmlns:a16="http://schemas.microsoft.com/office/drawing/2014/main" id="{8A5C5D32-AFC8-442C-9EEF-0DCCE4B4C051}"/>
+                <a16:creationId xmlns:a16="http://schemas.microsoft.com/office/drawing/2014/main" id="{00014A04-160A-4BFA-9F56-D94148ADF584}"/>
               </a:ext>
             </a:extLst>
           </p:cNvPr>
@@ -11013,7 +11013,7 @@
           <p:cNvPr id="15" name="">
             <a:extLst xmlns:a="http://schemas.openxmlformats.org/drawingml/2006/main">
               <a:ext uri="{FF2B5EF4-FFF2-40B4-BE49-F238E27FC236}">
-                <a16:creationId xmlns:a16="http://schemas.microsoft.com/office/drawing/2014/main" id="{6E3B9BA4-5010-4849-B6D2-D5BA0647E19E}"/>
+                <a16:creationId xmlns:a16="http://schemas.microsoft.com/office/drawing/2014/main" id="{95950909-5FFD-4337-83D0-21FCFE353958}"/>
               </a:ext>
             </a:extLst>
           </p:cNvPr>
@@ -11046,7 +11046,7 @@
           <p:cNvPr id="16" name="">
             <a:extLst xmlns:a="http://schemas.openxmlformats.org/drawingml/2006/main">
               <a:ext uri="{FF2B5EF4-FFF2-40B4-BE49-F238E27FC236}">
-                <a16:creationId xmlns:a16="http://schemas.microsoft.com/office/drawing/2014/main" id="{DDD2A279-CD8E-445C-BCE0-D9A2D2E3478A}"/>
+                <a16:creationId xmlns:a16="http://schemas.microsoft.com/office/drawing/2014/main" id="{A5A1810A-7961-4560-A6A8-2D785C61CE06}"/>
               </a:ext>
             </a:extLst>
           </p:cNvPr>
@@ -11110,7 +11110,7 @@
           <p:cNvPr id="17" name="">
             <a:extLst xmlns:a="http://schemas.openxmlformats.org/drawingml/2006/main">
               <a:ext uri="{FF2B5EF4-FFF2-40B4-BE49-F238E27FC236}">
-                <a16:creationId xmlns:a16="http://schemas.microsoft.com/office/drawing/2014/main" id="{03A1B4EE-54F1-499F-B7A3-C8C7E8865830}"/>
+                <a16:creationId xmlns:a16="http://schemas.microsoft.com/office/drawing/2014/main" id="{660C8BF0-48AB-4C8A-9162-4E6C3DA95F12}"/>
               </a:ext>
             </a:extLst>
           </p:cNvPr>
@@ -11174,7 +11174,7 @@
           <p:cNvPr id="18" name="">
             <a:extLst xmlns:a="http://schemas.openxmlformats.org/drawingml/2006/main">
               <a:ext uri="{FF2B5EF4-FFF2-40B4-BE49-F238E27FC236}">
-                <a16:creationId xmlns:a16="http://schemas.microsoft.com/office/drawing/2014/main" id="{968548C5-FF76-48FE-8375-91FDB9ACF864}"/>
+                <a16:creationId xmlns:a16="http://schemas.microsoft.com/office/drawing/2014/main" id="{3B40B91E-10BE-4555-AA33-623C32EF231E}"/>
               </a:ext>
             </a:extLst>
           </p:cNvPr>
@@ -11238,7 +11238,7 @@
           <p:cNvPr id="19" name="">
             <a:extLst xmlns:a="http://schemas.openxmlformats.org/drawingml/2006/main">
               <a:ext uri="{FF2B5EF4-FFF2-40B4-BE49-F238E27FC236}">
-                <a16:creationId xmlns:a16="http://schemas.microsoft.com/office/drawing/2014/main" id="{2E0DAE48-F4A6-499A-B44F-49E6EEDE5F8D}"/>
+                <a16:creationId xmlns:a16="http://schemas.microsoft.com/office/drawing/2014/main" id="{C693A5CA-17E9-4439-825D-62B211D53D17}"/>
               </a:ext>
             </a:extLst>
           </p:cNvPr>
@@ -11271,7 +11271,7 @@
           <p:cNvPr id="20" name="">
             <a:extLst xmlns:a="http://schemas.openxmlformats.org/drawingml/2006/main">
               <a:ext uri="{FF2B5EF4-FFF2-40B4-BE49-F238E27FC236}">
-                <a16:creationId xmlns:a16="http://schemas.microsoft.com/office/drawing/2014/main" id="{DBB63914-1012-479C-A26E-CC7647AA113D}"/>
+                <a16:creationId xmlns:a16="http://schemas.microsoft.com/office/drawing/2014/main" id="{F8C21733-8153-414F-9C54-205FB67FAED5}"/>
               </a:ext>
             </a:extLst>
           </p:cNvPr>
@@ -11335,7 +11335,7 @@
           <p:cNvPr id="21" name="">
             <a:extLst xmlns:a="http://schemas.openxmlformats.org/drawingml/2006/main">
               <a:ext uri="{FF2B5EF4-FFF2-40B4-BE49-F238E27FC236}">
-                <a16:creationId xmlns:a16="http://schemas.microsoft.com/office/drawing/2014/main" id="{7D0BE11E-A9A7-4162-9B72-6D6A8DB3A494}"/>
+                <a16:creationId xmlns:a16="http://schemas.microsoft.com/office/drawing/2014/main" id="{09E752D5-F73B-4C3C-B8F3-3672F622B3E8}"/>
               </a:ext>
             </a:extLst>
           </p:cNvPr>
@@ -11399,7 +11399,7 @@
           <p:cNvPr id="22" name="">
             <a:extLst xmlns:a="http://schemas.openxmlformats.org/drawingml/2006/main">
               <a:ext uri="{FF2B5EF4-FFF2-40B4-BE49-F238E27FC236}">
-                <a16:creationId xmlns:a16="http://schemas.microsoft.com/office/drawing/2014/main" id="{74B54068-616F-452B-A77E-586602A53ED4}"/>
+                <a16:creationId xmlns:a16="http://schemas.microsoft.com/office/drawing/2014/main" id="{7C4FAF5B-944F-486A-BA34-8E6A9FFE1A3B}"/>
               </a:ext>
             </a:extLst>
           </p:cNvPr>
@@ -11432,7 +11432,7 @@
           <p:cNvPr id="23" name="">
             <a:extLst xmlns:a="http://schemas.openxmlformats.org/drawingml/2006/main">
               <a:ext uri="{FF2B5EF4-FFF2-40B4-BE49-F238E27FC236}">
-                <a16:creationId xmlns:a16="http://schemas.microsoft.com/office/drawing/2014/main" id="{E0FF54B2-E7B3-4FCD-AA90-859D62D408CA}"/>
+                <a16:creationId xmlns:a16="http://schemas.microsoft.com/office/drawing/2014/main" id="{2F2525F2-722C-4EA0-857E-77C7A7DFD12F}"/>
               </a:ext>
             </a:extLst>
           </p:cNvPr>
@@ -11496,7 +11496,7 @@
           <p:cNvPr id="24" name="">
             <a:extLst xmlns:a="http://schemas.openxmlformats.org/drawingml/2006/main">
               <a:ext uri="{FF2B5EF4-FFF2-40B4-BE49-F238E27FC236}">
-                <a16:creationId xmlns:a16="http://schemas.microsoft.com/office/drawing/2014/main" id="{34FA1EB5-E2C1-467B-98F4-23AC51B55294}"/>
+                <a16:creationId xmlns:a16="http://schemas.microsoft.com/office/drawing/2014/main" id="{730F8A8B-0622-4758-825C-D2BC4F42A6D7}"/>
               </a:ext>
             </a:extLst>
           </p:cNvPr>
@@ -11560,7 +11560,7 @@
           <p:cNvPr id="25" name="">
             <a:extLst xmlns:a="http://schemas.openxmlformats.org/drawingml/2006/main">
               <a:ext uri="{FF2B5EF4-FFF2-40B4-BE49-F238E27FC236}">
-                <a16:creationId xmlns:a16="http://schemas.microsoft.com/office/drawing/2014/main" id="{C5B41040-04F2-4FDE-8C76-E1EE605D4F72}"/>
+                <a16:creationId xmlns:a16="http://schemas.microsoft.com/office/drawing/2014/main" id="{71DC55DC-81C3-48CB-A1BA-36E592C7E748}"/>
               </a:ext>
             </a:extLst>
           </p:cNvPr>
@@ -11593,7 +11593,7 @@
           <p:cNvPr id="26" name="">
             <a:extLst xmlns:a="http://schemas.openxmlformats.org/drawingml/2006/main">
               <a:ext uri="{FF2B5EF4-FFF2-40B4-BE49-F238E27FC236}">
-                <a16:creationId xmlns:a16="http://schemas.microsoft.com/office/drawing/2014/main" id="{BFDC83D0-E66B-4B55-AD35-4EF933A1885E}"/>
+                <a16:creationId xmlns:a16="http://schemas.microsoft.com/office/drawing/2014/main" id="{91D808C1-8F0D-432D-8340-7B6C71FB839B}"/>
               </a:ext>
             </a:extLst>
           </p:cNvPr>
@@ -11657,7 +11657,7 @@
           <p:cNvPr id="27" name="">
             <a:extLst xmlns:a="http://schemas.openxmlformats.org/drawingml/2006/main">
               <a:ext uri="{FF2B5EF4-FFF2-40B4-BE49-F238E27FC236}">
-                <a16:creationId xmlns:a16="http://schemas.microsoft.com/office/drawing/2014/main" id="{87BCBDFE-42B3-4E2A-97A2-53A1761B202F}"/>
+                <a16:creationId xmlns:a16="http://schemas.microsoft.com/office/drawing/2014/main" id="{1FC3A77A-49FE-4669-A190-3FACCECB3D71}"/>
               </a:ext>
             </a:extLst>
           </p:cNvPr>
@@ -11721,7 +11721,7 @@
           <p:cNvPr id="28" name="">
             <a:extLst xmlns:a="http://schemas.openxmlformats.org/drawingml/2006/main">
               <a:ext uri="{FF2B5EF4-FFF2-40B4-BE49-F238E27FC236}">
-                <a16:creationId xmlns:a16="http://schemas.microsoft.com/office/drawing/2014/main" id="{EF6490B2-E3A5-488D-A0AC-B750E424E95E}"/>
+                <a16:creationId xmlns:a16="http://schemas.microsoft.com/office/drawing/2014/main" id="{5139B53F-430D-4C0A-8396-9F706C0C7173}"/>
               </a:ext>
             </a:extLst>
           </p:cNvPr>
@@ -11785,7 +11785,7 @@
           <p:cNvPr id="29" name="">
             <a:extLst xmlns:a="http://schemas.openxmlformats.org/drawingml/2006/main">
               <a:ext uri="{FF2B5EF4-FFF2-40B4-BE49-F238E27FC236}">
-                <a16:creationId xmlns:a16="http://schemas.microsoft.com/office/drawing/2014/main" id="{E205F970-B233-48D6-B6DE-FBEDC59D9AC8}"/>
+                <a16:creationId xmlns:a16="http://schemas.microsoft.com/office/drawing/2014/main" id="{9FE89C0E-58B5-4284-8191-5F7691CE6E1D}"/>
               </a:ext>
             </a:extLst>
           </p:cNvPr>
@@ -11847,7 +11847,7 @@
     </p:spTree>
     <p:extLst>
       <p:ext uri="{BB962C8B-B14F-4D97-AF65-F5344CB8AC3E}">
-        <p14:creationId xmlns:p14="http://schemas.microsoft.com/office/powerpoint/2010/main" val="1919270827"/>
+        <p14:creationId xmlns:p14="http://schemas.microsoft.com/office/powerpoint/2010/main" val="1485142984"/>
       </p:ext>
     </p:extLst>
   </p:cSld>
@@ -11871,7 +11871,7 @@
           <p:cNvPr id="1" name="">
             <a:extLst xmlns:a="http://schemas.openxmlformats.org/drawingml/2006/main">
               <a:ext uri="{FF2B5EF4-FFF2-40B4-BE49-F238E27FC236}">
-                <a16:creationId xmlns:a16="http://schemas.microsoft.com/office/drawing/2014/main" id="{A41E26F2-A41B-407F-B9B3-5423A6B26512}"/>
+                <a16:creationId xmlns:a16="http://schemas.microsoft.com/office/drawing/2014/main" id="{4A9B8290-B600-4BF7-AA5E-14E01FD0EE12}"/>
               </a:ext>
             </a:extLst>
           </p:cNvPr>
@@ -11906,7 +11906,7 @@
           <p:cNvPr id="2" name="">
             <a:extLst xmlns:a="http://schemas.openxmlformats.org/drawingml/2006/main">
               <a:ext uri="{FF2B5EF4-FFF2-40B4-BE49-F238E27FC236}">
-                <a16:creationId xmlns:a16="http://schemas.microsoft.com/office/drawing/2014/main" id="{2AFF3448-DB05-4168-A854-00BE51BA8DF1}"/>
+                <a16:creationId xmlns:a16="http://schemas.microsoft.com/office/drawing/2014/main" id="{BC7B33CD-ACE9-413E-B52F-55B431563051}"/>
               </a:ext>
             </a:extLst>
           </p:cNvPr>
@@ -11941,7 +11941,7 @@
           <p:cNvPr id="3" name="">
             <a:extLst xmlns:a="http://schemas.openxmlformats.org/drawingml/2006/main">
               <a:ext uri="{FF2B5EF4-FFF2-40B4-BE49-F238E27FC236}">
-                <a16:creationId xmlns:a16="http://schemas.microsoft.com/office/drawing/2014/main" id="{7BAAF073-A141-4046-BCFE-84137A814245}"/>
+                <a16:creationId xmlns:a16="http://schemas.microsoft.com/office/drawing/2014/main" id="{44C52C37-5F80-430D-93C1-567879729D0D}"/>
               </a:ext>
             </a:extLst>
           </p:cNvPr>
@@ -12005,7 +12005,7 @@
           <p:cNvPr id="4" name="">
             <a:extLst xmlns:a="http://schemas.openxmlformats.org/drawingml/2006/main">
               <a:ext uri="{FF2B5EF4-FFF2-40B4-BE49-F238E27FC236}">
-                <a16:creationId xmlns:a16="http://schemas.microsoft.com/office/drawing/2014/main" id="{6478CDF2-A03E-4387-AD7F-3B9A2B199663}"/>
+                <a16:creationId xmlns:a16="http://schemas.microsoft.com/office/drawing/2014/main" id="{CA38FB3A-F2DA-4812-8F2E-F26D807158CC}"/>
               </a:ext>
             </a:extLst>
           </p:cNvPr>
@@ -12069,7 +12069,7 @@
           <p:cNvPr id="5" name="">
             <a:extLst xmlns:a="http://schemas.openxmlformats.org/drawingml/2006/main">
               <a:ext uri="{FF2B5EF4-FFF2-40B4-BE49-F238E27FC236}">
-                <a16:creationId xmlns:a16="http://schemas.microsoft.com/office/drawing/2014/main" id="{C7DF4545-02AF-4D8B-A8BC-2EB63CF5ADD3}"/>
+                <a16:creationId xmlns:a16="http://schemas.microsoft.com/office/drawing/2014/main" id="{864365ED-FFD1-4F3C-AD5A-5BAA5CAFC0AA}"/>
               </a:ext>
             </a:extLst>
           </p:cNvPr>
@@ -12133,7 +12133,7 @@
           <p:cNvPr id="6" name="">
             <a:extLst xmlns:a="http://schemas.openxmlformats.org/drawingml/2006/main">
               <a:ext uri="{FF2B5EF4-FFF2-40B4-BE49-F238E27FC236}">
-                <a16:creationId xmlns:a16="http://schemas.microsoft.com/office/drawing/2014/main" id="{AE7EE0A3-4492-4238-9538-57FAC6B77F1D}"/>
+                <a16:creationId xmlns:a16="http://schemas.microsoft.com/office/drawing/2014/main" id="{9B705C80-2594-4998-9959-865348DD11F1}"/>
               </a:ext>
             </a:extLst>
           </p:cNvPr>
@@ -12197,7 +12197,7 @@
           <p:cNvPr id="7" name="">
             <a:extLst xmlns:a="http://schemas.openxmlformats.org/drawingml/2006/main">
               <a:ext uri="{FF2B5EF4-FFF2-40B4-BE49-F238E27FC236}">
-                <a16:creationId xmlns:a16="http://schemas.microsoft.com/office/drawing/2014/main" id="{FCA90F4D-7B4E-400A-9996-BEFCF25664C6}"/>
+                <a16:creationId xmlns:a16="http://schemas.microsoft.com/office/drawing/2014/main" id="{7BB43688-4BD3-4A87-B511-15514FF089D6}"/>
               </a:ext>
             </a:extLst>
           </p:cNvPr>
@@ -12230,7 +12230,7 @@
           <p:cNvPr id="8" name="">
             <a:extLst xmlns:a="http://schemas.openxmlformats.org/drawingml/2006/main">
               <a:ext uri="{FF2B5EF4-FFF2-40B4-BE49-F238E27FC236}">
-                <a16:creationId xmlns:a16="http://schemas.microsoft.com/office/drawing/2014/main" id="{DDC99539-D27B-431D-9B02-4A15D2EE8C89}"/>
+                <a16:creationId xmlns:a16="http://schemas.microsoft.com/office/drawing/2014/main" id="{8346492E-8C55-41F7-A6C7-520CA69DB8AA}"/>
               </a:ext>
             </a:extLst>
           </p:cNvPr>
@@ -12294,7 +12294,7 @@
           <p:cNvPr id="9" name="">
             <a:extLst xmlns:a="http://schemas.openxmlformats.org/drawingml/2006/main">
               <a:ext uri="{FF2B5EF4-FFF2-40B4-BE49-F238E27FC236}">
-                <a16:creationId xmlns:a16="http://schemas.microsoft.com/office/drawing/2014/main" id="{E4DB69A7-FB12-4EC7-88D4-140E35616DD3}"/>
+                <a16:creationId xmlns:a16="http://schemas.microsoft.com/office/drawing/2014/main" id="{E455B86F-2E0E-4C8E-9CC8-B0C03277762B}"/>
               </a:ext>
             </a:extLst>
           </p:cNvPr>
@@ -12358,7 +12358,7 @@
           <p:cNvPr id="10" name="">
             <a:extLst xmlns:a="http://schemas.openxmlformats.org/drawingml/2006/main">
               <a:ext uri="{FF2B5EF4-FFF2-40B4-BE49-F238E27FC236}">
-                <a16:creationId xmlns:a16="http://schemas.microsoft.com/office/drawing/2014/main" id="{2007464A-6C7A-4D7C-ACDD-70BC4A794425}"/>
+                <a16:creationId xmlns:a16="http://schemas.microsoft.com/office/drawing/2014/main" id="{85254383-6ED9-4E44-82AF-C66661DAC712}"/>
               </a:ext>
             </a:extLst>
           </p:cNvPr>
@@ -12391,7 +12391,7 @@
           <p:cNvPr id="11" name="">
             <a:extLst xmlns:a="http://schemas.openxmlformats.org/drawingml/2006/main">
               <a:ext uri="{FF2B5EF4-FFF2-40B4-BE49-F238E27FC236}">
-                <a16:creationId xmlns:a16="http://schemas.microsoft.com/office/drawing/2014/main" id="{0839306C-DCED-4E1E-84DD-D8C6BE769F29}"/>
+                <a16:creationId xmlns:a16="http://schemas.microsoft.com/office/drawing/2014/main" id="{93157F1E-1E26-455D-88AA-A8F4A6949CD8}"/>
               </a:ext>
             </a:extLst>
           </p:cNvPr>
@@ -12455,7 +12455,7 @@
           <p:cNvPr id="12" name="">
             <a:extLst xmlns:a="http://schemas.openxmlformats.org/drawingml/2006/main">
               <a:ext uri="{FF2B5EF4-FFF2-40B4-BE49-F238E27FC236}">
-                <a16:creationId xmlns:a16="http://schemas.microsoft.com/office/drawing/2014/main" id="{AD7F444B-A3A2-41B7-BA71-E1E4658BDFC0}"/>
+                <a16:creationId xmlns:a16="http://schemas.microsoft.com/office/drawing/2014/main" id="{CAB2A93D-A2A9-4E39-A355-50B41B74B888}"/>
               </a:ext>
             </a:extLst>
           </p:cNvPr>
@@ -12519,7 +12519,7 @@
           <p:cNvPr id="13" name="">
             <a:extLst xmlns:a="http://schemas.openxmlformats.org/drawingml/2006/main">
               <a:ext uri="{FF2B5EF4-FFF2-40B4-BE49-F238E27FC236}">
-                <a16:creationId xmlns:a16="http://schemas.microsoft.com/office/drawing/2014/main" id="{29148609-0F2C-49B5-9805-EAD387A9C984}"/>
+                <a16:creationId xmlns:a16="http://schemas.microsoft.com/office/drawing/2014/main" id="{7161EC57-D498-4C7C-B784-D8E7461F96A9}"/>
               </a:ext>
             </a:extLst>
           </p:cNvPr>
@@ -12552,7 +12552,7 @@
           <p:cNvPr id="14" name="">
             <a:extLst xmlns:a="http://schemas.openxmlformats.org/drawingml/2006/main">
               <a:ext uri="{FF2B5EF4-FFF2-40B4-BE49-F238E27FC236}">
-                <a16:creationId xmlns:a16="http://schemas.microsoft.com/office/drawing/2014/main" id="{1F39CEAC-0ABC-441F-80E4-9E2C3162625B}"/>
+                <a16:creationId xmlns:a16="http://schemas.microsoft.com/office/drawing/2014/main" id="{FE4B3869-C598-4628-83DE-ED902FC47DC3}"/>
               </a:ext>
             </a:extLst>
           </p:cNvPr>
@@ -12616,7 +12616,7 @@
           <p:cNvPr id="15" name="">
             <a:extLst xmlns:a="http://schemas.openxmlformats.org/drawingml/2006/main">
               <a:ext uri="{FF2B5EF4-FFF2-40B4-BE49-F238E27FC236}">
-                <a16:creationId xmlns:a16="http://schemas.microsoft.com/office/drawing/2014/main" id="{BD25B666-1EF1-426C-91B0-1DD18D94E1B6}"/>
+                <a16:creationId xmlns:a16="http://schemas.microsoft.com/office/drawing/2014/main" id="{6DE9B221-19D4-4831-A16B-1CB2DDAFA9B8}"/>
               </a:ext>
             </a:extLst>
           </p:cNvPr>
@@ -12680,7 +12680,7 @@
           <p:cNvPr id="16" name="">
             <a:extLst xmlns:a="http://schemas.openxmlformats.org/drawingml/2006/main">
               <a:ext uri="{FF2B5EF4-FFF2-40B4-BE49-F238E27FC236}">
-                <a16:creationId xmlns:a16="http://schemas.microsoft.com/office/drawing/2014/main" id="{67C924B0-76D0-4D4F-92DE-96A6DA3CC3C8}"/>
+                <a16:creationId xmlns:a16="http://schemas.microsoft.com/office/drawing/2014/main" id="{C6C73D8A-E378-4732-BFEA-5EDBD1B65A78}"/>
               </a:ext>
             </a:extLst>
           </p:cNvPr>
@@ -12744,7 +12744,7 @@
           <p:cNvPr id="17" name="">
             <a:extLst xmlns:a="http://schemas.openxmlformats.org/drawingml/2006/main">
               <a:ext uri="{FF2B5EF4-FFF2-40B4-BE49-F238E27FC236}">
-                <a16:creationId xmlns:a16="http://schemas.microsoft.com/office/drawing/2014/main" id="{47E8CA41-C5C0-42FB-8E14-2B9DD42A7BD7}"/>
+                <a16:creationId xmlns:a16="http://schemas.microsoft.com/office/drawing/2014/main" id="{5DF2D14F-E3FC-4374-AE20-EBD91B578A3A}"/>
               </a:ext>
             </a:extLst>
           </p:cNvPr>
@@ -12806,7 +12806,7 @@
     </p:spTree>
     <p:extLst>
       <p:ext uri="{BB962C8B-B14F-4D97-AF65-F5344CB8AC3E}">
-        <p14:creationId xmlns:p14="http://schemas.microsoft.com/office/powerpoint/2010/main" val="1491965324"/>
+        <p14:creationId xmlns:p14="http://schemas.microsoft.com/office/powerpoint/2010/main" val="1691441250"/>
       </p:ext>
     </p:extLst>
   </p:cSld>
@@ -12830,7 +12830,7 @@
           <p:cNvPr id="1" name="">
             <a:extLst xmlns:a="http://schemas.openxmlformats.org/drawingml/2006/main">
               <a:ext uri="{FF2B5EF4-FFF2-40B4-BE49-F238E27FC236}">
-                <a16:creationId xmlns:a16="http://schemas.microsoft.com/office/drawing/2014/main" id="{184ED88F-CCC4-434D-80DC-1797FA5CDCF5}"/>
+                <a16:creationId xmlns:a16="http://schemas.microsoft.com/office/drawing/2014/main" id="{E67103D3-721C-4BEF-9CDF-7CBF4D599BC0}"/>
               </a:ext>
             </a:extLst>
           </p:cNvPr>
@@ -12865,7 +12865,7 @@
           <p:cNvPr id="2" name="">
             <a:extLst xmlns:a="http://schemas.openxmlformats.org/drawingml/2006/main">
               <a:ext uri="{FF2B5EF4-FFF2-40B4-BE49-F238E27FC236}">
-                <a16:creationId xmlns:a16="http://schemas.microsoft.com/office/drawing/2014/main" id="{EB0B9326-59AB-4248-B212-89DF9C703C81}"/>
+                <a16:creationId xmlns:a16="http://schemas.microsoft.com/office/drawing/2014/main" id="{8AD16A65-05FF-402B-9121-41EC9E0EBC78}"/>
               </a:ext>
             </a:extLst>
           </p:cNvPr>
@@ -12900,7 +12900,7 @@
           <p:cNvPr id="3" name="">
             <a:extLst xmlns:a="http://schemas.openxmlformats.org/drawingml/2006/main">
               <a:ext uri="{FF2B5EF4-FFF2-40B4-BE49-F238E27FC236}">
-                <a16:creationId xmlns:a16="http://schemas.microsoft.com/office/drawing/2014/main" id="{50D40FDE-1493-4017-B263-7B7EAFF3C3F6}"/>
+                <a16:creationId xmlns:a16="http://schemas.microsoft.com/office/drawing/2014/main" id="{FE432829-B41D-4983-8B29-B02CE873CBCB}"/>
               </a:ext>
             </a:extLst>
           </p:cNvPr>
@@ -12964,7 +12964,7 @@
           <p:cNvPr id="4" name="">
             <a:extLst xmlns:a="http://schemas.openxmlformats.org/drawingml/2006/main">
               <a:ext uri="{FF2B5EF4-FFF2-40B4-BE49-F238E27FC236}">
-                <a16:creationId xmlns:a16="http://schemas.microsoft.com/office/drawing/2014/main" id="{7A9DD8DE-CA1B-4041-87A1-59B9EFA4F1D2}"/>
+                <a16:creationId xmlns:a16="http://schemas.microsoft.com/office/drawing/2014/main" id="{8A1DBB83-9FBE-4997-BD04-5678A2E13A96}"/>
               </a:ext>
             </a:extLst>
           </p:cNvPr>
@@ -13028,7 +13028,7 @@
           <p:cNvPr id="5" name="">
             <a:extLst xmlns:a="http://schemas.openxmlformats.org/drawingml/2006/main">
               <a:ext uri="{FF2B5EF4-FFF2-40B4-BE49-F238E27FC236}">
-                <a16:creationId xmlns:a16="http://schemas.microsoft.com/office/drawing/2014/main" id="{A39A65FA-DEF6-4B64-A46C-A800FED85853}"/>
+                <a16:creationId xmlns:a16="http://schemas.microsoft.com/office/drawing/2014/main" id="{A28F0640-F00D-4D28-814A-5CFED7F1F447}"/>
               </a:ext>
             </a:extLst>
           </p:cNvPr>
@@ -13092,7 +13092,7 @@
           <p:cNvPr id="6" name="">
             <a:extLst xmlns:a="http://schemas.openxmlformats.org/drawingml/2006/main">
               <a:ext uri="{FF2B5EF4-FFF2-40B4-BE49-F238E27FC236}">
-                <a16:creationId xmlns:a16="http://schemas.microsoft.com/office/drawing/2014/main" id="{1FCC88EA-2D23-4BFF-87FD-B7DE6379F14E}"/>
+                <a16:creationId xmlns:a16="http://schemas.microsoft.com/office/drawing/2014/main" id="{61A5F509-81F1-4495-88E1-C8376E1DD289}"/>
               </a:ext>
             </a:extLst>
           </p:cNvPr>
@@ -13156,7 +13156,7 @@
           <p:cNvPr id="7" name="">
             <a:extLst xmlns:a="http://schemas.openxmlformats.org/drawingml/2006/main">
               <a:ext uri="{FF2B5EF4-FFF2-40B4-BE49-F238E27FC236}">
-                <a16:creationId xmlns:a16="http://schemas.microsoft.com/office/drawing/2014/main" id="{C56D4043-7273-4A76-9C80-C01813F439B6}"/>
+                <a16:creationId xmlns:a16="http://schemas.microsoft.com/office/drawing/2014/main" id="{A611C06D-E9D2-459F-B597-FB88360499EF}"/>
               </a:ext>
             </a:extLst>
           </p:cNvPr>
@@ -13189,7 +13189,7 @@
           <p:cNvPr id="8" name="">
             <a:extLst xmlns:a="http://schemas.openxmlformats.org/drawingml/2006/main">
               <a:ext uri="{FF2B5EF4-FFF2-40B4-BE49-F238E27FC236}">
-                <a16:creationId xmlns:a16="http://schemas.microsoft.com/office/drawing/2014/main" id="{7A17890D-686F-4906-96E7-2B3A49D16C44}"/>
+                <a16:creationId xmlns:a16="http://schemas.microsoft.com/office/drawing/2014/main" id="{5DCCF79C-3B5E-417E-9ED8-7D9C54C31900}"/>
               </a:ext>
             </a:extLst>
           </p:cNvPr>
@@ -13253,7 +13253,7 @@
           <p:cNvPr id="9" name="">
             <a:extLst xmlns:a="http://schemas.openxmlformats.org/drawingml/2006/main">
               <a:ext uri="{FF2B5EF4-FFF2-40B4-BE49-F238E27FC236}">
-                <a16:creationId xmlns:a16="http://schemas.microsoft.com/office/drawing/2014/main" id="{144E4AB5-792D-44A8-9F59-8F994C475842}"/>
+                <a16:creationId xmlns:a16="http://schemas.microsoft.com/office/drawing/2014/main" id="{32FC8A71-01DA-48C0-9817-43BD81C6BDCD}"/>
               </a:ext>
             </a:extLst>
           </p:cNvPr>
@@ -13317,7 +13317,7 @@
           <p:cNvPr id="10" name="">
             <a:extLst xmlns:a="http://schemas.openxmlformats.org/drawingml/2006/main">
               <a:ext uri="{FF2B5EF4-FFF2-40B4-BE49-F238E27FC236}">
-                <a16:creationId xmlns:a16="http://schemas.microsoft.com/office/drawing/2014/main" id="{226FC984-B7C0-48EE-B3A8-E2B71803473C}"/>
+                <a16:creationId xmlns:a16="http://schemas.microsoft.com/office/drawing/2014/main" id="{550E9844-713D-4269-B492-D13E52204892}"/>
               </a:ext>
             </a:extLst>
           </p:cNvPr>
@@ -13381,7 +13381,7 @@
           <p:cNvPr id="11" name="">
             <a:extLst xmlns:a="http://schemas.openxmlformats.org/drawingml/2006/main">
               <a:ext uri="{FF2B5EF4-FFF2-40B4-BE49-F238E27FC236}">
-                <a16:creationId xmlns:a16="http://schemas.microsoft.com/office/drawing/2014/main" id="{04B02A8B-7E64-4154-AD59-62492BFC7EF5}"/>
+                <a16:creationId xmlns:a16="http://schemas.microsoft.com/office/drawing/2014/main" id="{D33C84C6-506C-4EB6-9D97-B2FEF86C840D}"/>
               </a:ext>
             </a:extLst>
           </p:cNvPr>
@@ -13414,7 +13414,7 @@
           <p:cNvPr id="12" name="">
             <a:extLst xmlns:a="http://schemas.openxmlformats.org/drawingml/2006/main">
               <a:ext uri="{FF2B5EF4-FFF2-40B4-BE49-F238E27FC236}">
-                <a16:creationId xmlns:a16="http://schemas.microsoft.com/office/drawing/2014/main" id="{A5FB8AF6-7B2F-47B3-A305-BC2E891A2C0E}"/>
+                <a16:creationId xmlns:a16="http://schemas.microsoft.com/office/drawing/2014/main" id="{1C4B5C23-41C3-4938-8B12-4C9C1EB77070}"/>
               </a:ext>
             </a:extLst>
           </p:cNvPr>
@@ -13478,7 +13478,7 @@
           <p:cNvPr id="13" name="">
             <a:extLst xmlns:a="http://schemas.openxmlformats.org/drawingml/2006/main">
               <a:ext uri="{FF2B5EF4-FFF2-40B4-BE49-F238E27FC236}">
-                <a16:creationId xmlns:a16="http://schemas.microsoft.com/office/drawing/2014/main" id="{812E7F64-76F9-42C0-81E5-BDD42C2C1D58}"/>
+                <a16:creationId xmlns:a16="http://schemas.microsoft.com/office/drawing/2014/main" id="{B97198E3-5FE8-433F-9104-E1A672819807}"/>
               </a:ext>
             </a:extLst>
           </p:cNvPr>
@@ -13542,7 +13542,7 @@
           <p:cNvPr id="14" name="">
             <a:extLst xmlns:a="http://schemas.openxmlformats.org/drawingml/2006/main">
               <a:ext uri="{FF2B5EF4-FFF2-40B4-BE49-F238E27FC236}">
-                <a16:creationId xmlns:a16="http://schemas.microsoft.com/office/drawing/2014/main" id="{B9648B2C-746A-4DA0-A4D4-FDE960D72ABB}"/>
+                <a16:creationId xmlns:a16="http://schemas.microsoft.com/office/drawing/2014/main" id="{E7C097BC-C85F-403C-9B35-2D8D7E147195}"/>
               </a:ext>
             </a:extLst>
           </p:cNvPr>
@@ -13606,7 +13606,7 @@
           <p:cNvPr id="15" name="">
             <a:extLst xmlns:a="http://schemas.openxmlformats.org/drawingml/2006/main">
               <a:ext uri="{FF2B5EF4-FFF2-40B4-BE49-F238E27FC236}">
-                <a16:creationId xmlns:a16="http://schemas.microsoft.com/office/drawing/2014/main" id="{3F58CE89-9BFD-4024-9BDE-7BDF99EA8869}"/>
+                <a16:creationId xmlns:a16="http://schemas.microsoft.com/office/drawing/2014/main" id="{AA754287-7B5E-4857-AE41-3B572F6420CC}"/>
               </a:ext>
             </a:extLst>
           </p:cNvPr>
@@ -13639,7 +13639,7 @@
           <p:cNvPr id="16" name="">
             <a:extLst xmlns:a="http://schemas.openxmlformats.org/drawingml/2006/main">
               <a:ext uri="{FF2B5EF4-FFF2-40B4-BE49-F238E27FC236}">
-                <a16:creationId xmlns:a16="http://schemas.microsoft.com/office/drawing/2014/main" id="{6F31BFC6-EA86-45A7-AA63-B1F77C89C34A}"/>
+                <a16:creationId xmlns:a16="http://schemas.microsoft.com/office/drawing/2014/main" id="{95F47A42-9A8A-4D36-A126-5453541701DB}"/>
               </a:ext>
             </a:extLst>
           </p:cNvPr>
@@ -13703,7 +13703,7 @@
           <p:cNvPr id="17" name="">
             <a:extLst xmlns:a="http://schemas.openxmlformats.org/drawingml/2006/main">
               <a:ext uri="{FF2B5EF4-FFF2-40B4-BE49-F238E27FC236}">
-                <a16:creationId xmlns:a16="http://schemas.microsoft.com/office/drawing/2014/main" id="{C505430B-4122-4127-B90B-4BB1E5EEB755}"/>
+                <a16:creationId xmlns:a16="http://schemas.microsoft.com/office/drawing/2014/main" id="{7DC28E0F-9853-46AE-B8DC-2DD534190AB6}"/>
               </a:ext>
             </a:extLst>
           </p:cNvPr>
@@ -13767,7 +13767,7 @@
           <p:cNvPr id="18" name="">
             <a:extLst xmlns:a="http://schemas.openxmlformats.org/drawingml/2006/main">
               <a:ext uri="{FF2B5EF4-FFF2-40B4-BE49-F238E27FC236}">
-                <a16:creationId xmlns:a16="http://schemas.microsoft.com/office/drawing/2014/main" id="{6809F064-9766-46C9-AF00-7012C8EA00D8}"/>
+                <a16:creationId xmlns:a16="http://schemas.microsoft.com/office/drawing/2014/main" id="{4C2ED0C4-DE8C-4320-91D7-736DF7D1C497}"/>
               </a:ext>
             </a:extLst>
           </p:cNvPr>
@@ -13800,7 +13800,7 @@
           <p:cNvPr id="19" name="">
             <a:extLst xmlns:a="http://schemas.openxmlformats.org/drawingml/2006/main">
               <a:ext uri="{FF2B5EF4-FFF2-40B4-BE49-F238E27FC236}">
-                <a16:creationId xmlns:a16="http://schemas.microsoft.com/office/drawing/2014/main" id="{30CC9EB9-88C1-4915-A300-84B171E7E86E}"/>
+                <a16:creationId xmlns:a16="http://schemas.microsoft.com/office/drawing/2014/main" id="{0F62E1B3-A29A-4010-B3E9-330DB03A24FC}"/>
               </a:ext>
             </a:extLst>
           </p:cNvPr>
@@ -13864,7 +13864,7 @@
           <p:cNvPr id="20" name="">
             <a:extLst xmlns:a="http://schemas.openxmlformats.org/drawingml/2006/main">
               <a:ext uri="{FF2B5EF4-FFF2-40B4-BE49-F238E27FC236}">
-                <a16:creationId xmlns:a16="http://schemas.microsoft.com/office/drawing/2014/main" id="{96344A3E-40B3-4D8C-A381-5CBA77D2504D}"/>
+                <a16:creationId xmlns:a16="http://schemas.microsoft.com/office/drawing/2014/main" id="{EE0D57D7-174F-4812-B62B-F3342ECE891C}"/>
               </a:ext>
             </a:extLst>
           </p:cNvPr>
@@ -13928,7 +13928,7 @@
           <p:cNvPr id="21" name="">
             <a:extLst xmlns:a="http://schemas.openxmlformats.org/drawingml/2006/main">
               <a:ext uri="{FF2B5EF4-FFF2-40B4-BE49-F238E27FC236}">
-                <a16:creationId xmlns:a16="http://schemas.microsoft.com/office/drawing/2014/main" id="{2D9F15FB-1C35-4AA0-990F-BCA3DF51177D}"/>
+                <a16:creationId xmlns:a16="http://schemas.microsoft.com/office/drawing/2014/main" id="{B89FC34C-5F9F-4C9F-9C66-722560D61BF1}"/>
               </a:ext>
             </a:extLst>
           </p:cNvPr>
@@ -13992,7 +13992,7 @@
           <p:cNvPr id="22" name="">
             <a:extLst xmlns:a="http://schemas.openxmlformats.org/drawingml/2006/main">
               <a:ext uri="{FF2B5EF4-FFF2-40B4-BE49-F238E27FC236}">
-                <a16:creationId xmlns:a16="http://schemas.microsoft.com/office/drawing/2014/main" id="{8D643F94-7F75-40D9-BE1A-FB2F4BB6B68A}"/>
+                <a16:creationId xmlns:a16="http://schemas.microsoft.com/office/drawing/2014/main" id="{70F9B68F-B688-42C6-87E6-512B5A524B3E}"/>
               </a:ext>
             </a:extLst>
           </p:cNvPr>
@@ -14054,7 +14054,7 @@
     </p:spTree>
     <p:extLst>
       <p:ext uri="{BB962C8B-B14F-4D97-AF65-F5344CB8AC3E}">
-        <p14:creationId xmlns:p14="http://schemas.microsoft.com/office/powerpoint/2010/main" val="956987174"/>
+        <p14:creationId xmlns:p14="http://schemas.microsoft.com/office/powerpoint/2010/main" val="550959672"/>
       </p:ext>
     </p:extLst>
   </p:cSld>

</xml_diff>

<commit_message>
align submission pitch with public CPU Gemma
</commit_message>
<xml_diff>
--- a/submission/proteinloop-hackathon-deck.pptx
+++ b/submission/proteinloop-hackathon-deck.pptx
@@ -2,22 +2,22 @@
 <file path=ppt/presentation.xml><?xml version="1.0" encoding="utf-8"?>
 <p:presentation xmlns:p="http://schemas.openxmlformats.org/presentationml/2006/main">
   <p:sldMasterIdLst>
-    <p:sldMasterId xmlns:r="http://schemas.openxmlformats.org/officeDocument/2006/relationships" id="2147483648" r:id="R91ccda9784b34016"/>
+    <p:sldMasterId xmlns:r="http://schemas.openxmlformats.org/officeDocument/2006/relationships" id="2147483648" r:id="Rf46c56cdeb0047e1"/>
   </p:sldMasterIdLst>
   <p:notesMasterIdLst>
-    <p:notesMasterId xmlns:r="http://schemas.openxmlformats.org/officeDocument/2006/relationships" r:id="R521f499f918d42ec"/>
+    <p:notesMasterId xmlns:r="http://schemas.openxmlformats.org/officeDocument/2006/relationships" r:id="Rb32b52f05dbb4684"/>
   </p:notesMasterIdLst>
   <p:sldIdLst>
-    <p:sldId xmlns:r="http://schemas.openxmlformats.org/officeDocument/2006/relationships" id="256" r:id="R2d5a30f24505496e"/>
-    <p:sldId xmlns:r="http://schemas.openxmlformats.org/officeDocument/2006/relationships" id="257" r:id="R62d4cee324f44e06"/>
-    <p:sldId xmlns:r="http://schemas.openxmlformats.org/officeDocument/2006/relationships" id="258" r:id="R944f1826d8654272"/>
-    <p:sldId xmlns:r="http://schemas.openxmlformats.org/officeDocument/2006/relationships" id="259" r:id="R8308e117b7b74642"/>
-    <p:sldId xmlns:r="http://schemas.openxmlformats.org/officeDocument/2006/relationships" id="260" r:id="Ra06c9ab110294bc8"/>
-    <p:sldId xmlns:r="http://schemas.openxmlformats.org/officeDocument/2006/relationships" id="261" r:id="Rd11b3b291ea04cfb"/>
-    <p:sldId xmlns:r="http://schemas.openxmlformats.org/officeDocument/2006/relationships" id="262" r:id="Rddfc869470614112"/>
-    <p:sldId xmlns:r="http://schemas.openxmlformats.org/officeDocument/2006/relationships" id="263" r:id="R59e6a83106834c2c"/>
-    <p:sldId xmlns:r="http://schemas.openxmlformats.org/officeDocument/2006/relationships" id="264" r:id="R92c0a5d3033045cb"/>
-    <p:sldId xmlns:r="http://schemas.openxmlformats.org/officeDocument/2006/relationships" id="265" r:id="Rc008e44c0a264e0f"/>
+    <p:sldId xmlns:r="http://schemas.openxmlformats.org/officeDocument/2006/relationships" id="256" r:id="R206ed949006843b7"/>
+    <p:sldId xmlns:r="http://schemas.openxmlformats.org/officeDocument/2006/relationships" id="257" r:id="R1c246d7cd8f04784"/>
+    <p:sldId xmlns:r="http://schemas.openxmlformats.org/officeDocument/2006/relationships" id="258" r:id="R3dc3b72111764bf3"/>
+    <p:sldId xmlns:r="http://schemas.openxmlformats.org/officeDocument/2006/relationships" id="259" r:id="R90d4acdf47f749a5"/>
+    <p:sldId xmlns:r="http://schemas.openxmlformats.org/officeDocument/2006/relationships" id="260" r:id="R800e1d82c0cc4a78"/>
+    <p:sldId xmlns:r="http://schemas.openxmlformats.org/officeDocument/2006/relationships" id="261" r:id="R7200cc71a0684410"/>
+    <p:sldId xmlns:r="http://schemas.openxmlformats.org/officeDocument/2006/relationships" id="262" r:id="R158ad52eef6144e3"/>
+    <p:sldId xmlns:r="http://schemas.openxmlformats.org/officeDocument/2006/relationships" id="263" r:id="R930e595ae19046a7"/>
+    <p:sldId xmlns:r="http://schemas.openxmlformats.org/officeDocument/2006/relationships" id="264" r:id="R0116b80385454604"/>
+    <p:sldId xmlns:r="http://schemas.openxmlformats.org/officeDocument/2006/relationships" id="265" r:id="R764014dedced4563"/>
   </p:sldIdLst>
   <p:sldSz cx="12192000" cy="6858000"/>
   <p:notesSz cx="6858000" cy="9144000"/>
@@ -1158,7 +1158,7 @@
   </p:cSld>
   <p:clrMap bg1="lt1" tx1="dk1" bg2="lt2" tx2="dk2" accent1="accent1" accent2="accent2" accent3="accent3" accent4="accent4" accent5="accent5" accent6="accent6" hlink="hlink" folHlink="folHlink"/>
   <p:sldLayoutIdLst>
-    <p:sldLayoutId xmlns:r="http://schemas.openxmlformats.org/officeDocument/2006/relationships" id="2147483649" r:id="Rb1e56053a168429d"/>
+    <p:sldLayoutId xmlns:r="http://schemas.openxmlformats.org/officeDocument/2006/relationships" id="2147483649" r:id="Re268994dd8eb4927"/>
   </p:sldLayoutIdLst>
   <p:txStyles>
     <p:titleStyle>
@@ -1457,7 +1457,7 @@
           <p:cNvPr id="1" name="">
             <a:extLst xmlns:a="http://schemas.openxmlformats.org/drawingml/2006/main">
               <a:ext uri="{FF2B5EF4-FFF2-40B4-BE49-F238E27FC236}">
-                <a16:creationId xmlns:a16="http://schemas.microsoft.com/office/drawing/2014/main" id="{5891BB0B-D7C5-4B8E-9EC0-C5C8D97C9262}"/>
+                <a16:creationId xmlns:a16="http://schemas.microsoft.com/office/drawing/2014/main" id="{54793884-3573-4D28-8783-B68DA499278E}"/>
               </a:ext>
             </a:extLst>
           </p:cNvPr>
@@ -1492,7 +1492,7 @@
           <p:cNvPr id="2" name="">
             <a:extLst xmlns:a="http://schemas.openxmlformats.org/drawingml/2006/main">
               <a:ext uri="{FF2B5EF4-FFF2-40B4-BE49-F238E27FC236}">
-                <a16:creationId xmlns:a16="http://schemas.microsoft.com/office/drawing/2014/main" id="{23C99B3D-C99A-483F-B230-97C5123210A5}"/>
+                <a16:creationId xmlns:a16="http://schemas.microsoft.com/office/drawing/2014/main" id="{DF835694-7508-438E-BA84-1EB315EB1956}"/>
               </a:ext>
             </a:extLst>
           </p:cNvPr>
@@ -1527,7 +1527,7 @@
           <p:cNvPr id="3" name="">
             <a:extLst xmlns:a="http://schemas.openxmlformats.org/drawingml/2006/main">
               <a:ext uri="{FF2B5EF4-FFF2-40B4-BE49-F238E27FC236}">
-                <a16:creationId xmlns:a16="http://schemas.microsoft.com/office/drawing/2014/main" id="{DD40F4E5-658B-4927-B9D4-970803357602}"/>
+                <a16:creationId xmlns:a16="http://schemas.microsoft.com/office/drawing/2014/main" id="{12AE41D7-DB2D-4995-AFA0-62AC0DD1DDCF}"/>
               </a:ext>
             </a:extLst>
           </p:cNvPr>
@@ -1591,7 +1591,7 @@
           <p:cNvPr id="4" name="">
             <a:extLst xmlns:a="http://schemas.openxmlformats.org/drawingml/2006/main">
               <a:ext uri="{FF2B5EF4-FFF2-40B4-BE49-F238E27FC236}">
-                <a16:creationId xmlns:a16="http://schemas.microsoft.com/office/drawing/2014/main" id="{025803DB-2DE8-4481-9778-4B0B0A9826C4}"/>
+                <a16:creationId xmlns:a16="http://schemas.microsoft.com/office/drawing/2014/main" id="{93986A57-7108-47A9-9015-D515BF16E500}"/>
               </a:ext>
             </a:extLst>
           </p:cNvPr>
@@ -1655,7 +1655,7 @@
           <p:cNvPr id="5" name="">
             <a:extLst xmlns:a="http://schemas.openxmlformats.org/drawingml/2006/main">
               <a:ext uri="{FF2B5EF4-FFF2-40B4-BE49-F238E27FC236}">
-                <a16:creationId xmlns:a16="http://schemas.microsoft.com/office/drawing/2014/main" id="{E61BD61C-6FEB-4383-819B-BB6C0D921970}"/>
+                <a16:creationId xmlns:a16="http://schemas.microsoft.com/office/drawing/2014/main" id="{8A5A347A-BF98-447C-8881-051CCCA0814F}"/>
               </a:ext>
             </a:extLst>
           </p:cNvPr>
@@ -1690,7 +1690,7 @@
           <p:cNvPr id="6" name="">
             <a:extLst xmlns:a="http://schemas.openxmlformats.org/drawingml/2006/main">
               <a:ext uri="{FF2B5EF4-FFF2-40B4-BE49-F238E27FC236}">
-                <a16:creationId xmlns:a16="http://schemas.microsoft.com/office/drawing/2014/main" id="{21B410A8-4E68-46E8-BEC7-FB5BA26E9A37}"/>
+                <a16:creationId xmlns:a16="http://schemas.microsoft.com/office/drawing/2014/main" id="{FABE88E8-9013-41B2-8D2B-00996C520C4F}"/>
               </a:ext>
             </a:extLst>
           </p:cNvPr>
@@ -1754,7 +1754,7 @@
           <p:cNvPr id="7" name="">
             <a:extLst xmlns:a="http://schemas.openxmlformats.org/drawingml/2006/main">
               <a:ext uri="{FF2B5EF4-FFF2-40B4-BE49-F238E27FC236}">
-                <a16:creationId xmlns:a16="http://schemas.microsoft.com/office/drawing/2014/main" id="{725B5D3D-CF9E-491D-B1CE-5AF5BA6D9DBB}"/>
+                <a16:creationId xmlns:a16="http://schemas.microsoft.com/office/drawing/2014/main" id="{5E3308D0-56CF-4170-85CA-06F3B9801D88}"/>
               </a:ext>
             </a:extLst>
           </p:cNvPr>
@@ -1818,7 +1818,7 @@
           <p:cNvPr id="8" name="">
             <a:extLst xmlns:a="http://schemas.openxmlformats.org/drawingml/2006/main">
               <a:ext uri="{FF2B5EF4-FFF2-40B4-BE49-F238E27FC236}">
-                <a16:creationId xmlns:a16="http://schemas.microsoft.com/office/drawing/2014/main" id="{F4AC6A7A-72B3-46AB-BD3F-8BFB2EBDD1CF}"/>
+                <a16:creationId xmlns:a16="http://schemas.microsoft.com/office/drawing/2014/main" id="{9BD7524D-B5A8-4483-B60F-0758EAF8879B}"/>
               </a:ext>
             </a:extLst>
           </p:cNvPr>
@@ -1853,7 +1853,7 @@
           <p:cNvPr id="9" name="">
             <a:extLst xmlns:a="http://schemas.openxmlformats.org/drawingml/2006/main">
               <a:ext uri="{FF2B5EF4-FFF2-40B4-BE49-F238E27FC236}">
-                <a16:creationId xmlns:a16="http://schemas.microsoft.com/office/drawing/2014/main" id="{616FC0D0-033A-4D52-B697-B2F9C84C1770}"/>
+                <a16:creationId xmlns:a16="http://schemas.microsoft.com/office/drawing/2014/main" id="{ABFD6C9B-0836-4CBF-9F80-1A021B837388}"/>
               </a:ext>
             </a:extLst>
           </p:cNvPr>
@@ -1917,7 +1917,7 @@
           <p:cNvPr id="10" name="">
             <a:extLst xmlns:a="http://schemas.openxmlformats.org/drawingml/2006/main">
               <a:ext uri="{FF2B5EF4-FFF2-40B4-BE49-F238E27FC236}">
-                <a16:creationId xmlns:a16="http://schemas.microsoft.com/office/drawing/2014/main" id="{6C43619F-2866-4ACB-A40D-A59CA397571C}"/>
+                <a16:creationId xmlns:a16="http://schemas.microsoft.com/office/drawing/2014/main" id="{45F0AB8E-1648-4DA9-9C20-C9C2369AF936}"/>
               </a:ext>
             </a:extLst>
           </p:cNvPr>
@@ -1981,7 +1981,7 @@
           <p:cNvPr id="11" name="">
             <a:extLst xmlns:a="http://schemas.openxmlformats.org/drawingml/2006/main">
               <a:ext uri="{FF2B5EF4-FFF2-40B4-BE49-F238E27FC236}">
-                <a16:creationId xmlns:a16="http://schemas.microsoft.com/office/drawing/2014/main" id="{BA2A2CF8-3238-4C2F-A459-58CDA666F29F}"/>
+                <a16:creationId xmlns:a16="http://schemas.microsoft.com/office/drawing/2014/main" id="{85B20D6E-1789-464F-8BD3-458070536BF2}"/>
               </a:ext>
             </a:extLst>
           </p:cNvPr>
@@ -2045,7 +2045,7 @@
           <p:cNvPr id="12" name="">
             <a:extLst xmlns:a="http://schemas.openxmlformats.org/drawingml/2006/main">
               <a:ext uri="{FF2B5EF4-FFF2-40B4-BE49-F238E27FC236}">
-                <a16:creationId xmlns:a16="http://schemas.microsoft.com/office/drawing/2014/main" id="{A90E7D75-D971-4A48-A328-2D68320F6A74}"/>
+                <a16:creationId xmlns:a16="http://schemas.microsoft.com/office/drawing/2014/main" id="{233191E6-CA33-4F99-BF17-49CD00B752DC}"/>
               </a:ext>
             </a:extLst>
           </p:cNvPr>
@@ -2080,7 +2080,7 @@
           <p:cNvPr id="13" name="">
             <a:extLst xmlns:a="http://schemas.openxmlformats.org/drawingml/2006/main">
               <a:ext uri="{FF2B5EF4-FFF2-40B4-BE49-F238E27FC236}">
-                <a16:creationId xmlns:a16="http://schemas.microsoft.com/office/drawing/2014/main" id="{BDFF9739-000B-45A4-B144-2D8EEBD05B0F}"/>
+                <a16:creationId xmlns:a16="http://schemas.microsoft.com/office/drawing/2014/main" id="{4B90FE65-2DFA-4D5F-8B42-C77183DE8C3D}"/>
               </a:ext>
             </a:extLst>
           </p:cNvPr>
@@ -2144,7 +2144,7 @@
           <p:cNvPr id="14" name="">
             <a:extLst xmlns:a="http://schemas.openxmlformats.org/drawingml/2006/main">
               <a:ext uri="{FF2B5EF4-FFF2-40B4-BE49-F238E27FC236}">
-                <a16:creationId xmlns:a16="http://schemas.microsoft.com/office/drawing/2014/main" id="{BF7F095F-E756-4729-AFC5-7460F8A2E992}"/>
+                <a16:creationId xmlns:a16="http://schemas.microsoft.com/office/drawing/2014/main" id="{9D24FDF9-87E3-47FA-BF03-8F4F8D6CB68C}"/>
               </a:ext>
             </a:extLst>
           </p:cNvPr>
@@ -2208,7 +2208,7 @@
           <p:cNvPr id="15" name="">
             <a:extLst xmlns:a="http://schemas.openxmlformats.org/drawingml/2006/main">
               <a:ext uri="{FF2B5EF4-FFF2-40B4-BE49-F238E27FC236}">
-                <a16:creationId xmlns:a16="http://schemas.microsoft.com/office/drawing/2014/main" id="{A311CEC6-443E-4CA5-80C8-62EA4B708324}"/>
+                <a16:creationId xmlns:a16="http://schemas.microsoft.com/office/drawing/2014/main" id="{602BE7ED-2C1A-4020-A155-B69D247BE1C6}"/>
               </a:ext>
             </a:extLst>
           </p:cNvPr>
@@ -2272,7 +2272,7 @@
           <p:cNvPr id="16" name="">
             <a:extLst xmlns:a="http://schemas.openxmlformats.org/drawingml/2006/main">
               <a:ext uri="{FF2B5EF4-FFF2-40B4-BE49-F238E27FC236}">
-                <a16:creationId xmlns:a16="http://schemas.microsoft.com/office/drawing/2014/main" id="{2FAC804E-6449-4365-A6F1-0390A324B413}"/>
+                <a16:creationId xmlns:a16="http://schemas.microsoft.com/office/drawing/2014/main" id="{5E7E1179-131A-4B63-8209-48865413DF1D}"/>
               </a:ext>
             </a:extLst>
           </p:cNvPr>
@@ -2307,7 +2307,7 @@
           <p:cNvPr id="17" name="">
             <a:extLst xmlns:a="http://schemas.openxmlformats.org/drawingml/2006/main">
               <a:ext uri="{FF2B5EF4-FFF2-40B4-BE49-F238E27FC236}">
-                <a16:creationId xmlns:a16="http://schemas.microsoft.com/office/drawing/2014/main" id="{04E28969-AA0A-4F9B-8B92-5A16BB0A6095}"/>
+                <a16:creationId xmlns:a16="http://schemas.microsoft.com/office/drawing/2014/main" id="{282B54F9-A9B7-4C7C-A8A9-94803271DCF3}"/>
               </a:ext>
             </a:extLst>
           </p:cNvPr>
@@ -2371,7 +2371,7 @@
           <p:cNvPr id="18" name="">
             <a:extLst xmlns:a="http://schemas.openxmlformats.org/drawingml/2006/main">
               <a:ext uri="{FF2B5EF4-FFF2-40B4-BE49-F238E27FC236}">
-                <a16:creationId xmlns:a16="http://schemas.microsoft.com/office/drawing/2014/main" id="{20739BDF-D9E7-4D26-A9F9-18D689EBE19B}"/>
+                <a16:creationId xmlns:a16="http://schemas.microsoft.com/office/drawing/2014/main" id="{9AFEFBA0-11B6-4075-99F6-064A8ACEF564}"/>
               </a:ext>
             </a:extLst>
           </p:cNvPr>
@@ -2435,7 +2435,7 @@
           <p:cNvPr id="19" name="">
             <a:extLst xmlns:a="http://schemas.openxmlformats.org/drawingml/2006/main">
               <a:ext uri="{FF2B5EF4-FFF2-40B4-BE49-F238E27FC236}">
-                <a16:creationId xmlns:a16="http://schemas.microsoft.com/office/drawing/2014/main" id="{01906687-04D0-4CB4-AFBA-BDC61CC5FAE6}"/>
+                <a16:creationId xmlns:a16="http://schemas.microsoft.com/office/drawing/2014/main" id="{E79491C7-350A-426C-A021-54AA15AEAD8B}"/>
               </a:ext>
             </a:extLst>
           </p:cNvPr>
@@ -2489,7 +2489,7 @@
                 <a:ea typeface="Aptos"/>
                 <a:cs typeface="Aptos"/>
               </a:rPr>
-              <a:t>llama.cpp + Metal</a:t>
+              <a:t>CPU + Metal evidence</a:t>
             </a:r>
           </a:p>
         </p:txBody>
@@ -2499,7 +2499,7 @@
           <p:cNvPr id="20" name="">
             <a:extLst xmlns:a="http://schemas.openxmlformats.org/drawingml/2006/main">
               <a:ext uri="{FF2B5EF4-FFF2-40B4-BE49-F238E27FC236}">
-                <a16:creationId xmlns:a16="http://schemas.microsoft.com/office/drawing/2014/main" id="{5CCF3279-136D-4355-8D49-FA38E6FA3EE7}"/>
+                <a16:creationId xmlns:a16="http://schemas.microsoft.com/office/drawing/2014/main" id="{57D5430F-98AD-45F2-BDAA-9C67DEF8DBC0}"/>
               </a:ext>
             </a:extLst>
           </p:cNvPr>
@@ -2655,7 +2655,7 @@
           <p:cNvPr id="21" name="">
             <a:extLst xmlns:a="http://schemas.openxmlformats.org/drawingml/2006/main">
               <a:ext uri="{FF2B5EF4-FFF2-40B4-BE49-F238E27FC236}">
-                <a16:creationId xmlns:a16="http://schemas.microsoft.com/office/drawing/2014/main" id="{B599B230-0484-4250-895C-FDABEBCE2FF9}"/>
+                <a16:creationId xmlns:a16="http://schemas.microsoft.com/office/drawing/2014/main" id="{6C6BD329-1270-4E17-B2A6-8502522069CD}"/>
               </a:ext>
             </a:extLst>
           </p:cNvPr>
@@ -2719,7 +2719,7 @@
           <p:cNvPr id="22" name="">
             <a:extLst xmlns:a="http://schemas.openxmlformats.org/drawingml/2006/main">
               <a:ext uri="{FF2B5EF4-FFF2-40B4-BE49-F238E27FC236}">
-                <a16:creationId xmlns:a16="http://schemas.microsoft.com/office/drawing/2014/main" id="{25D5E766-CB83-4856-B4EB-4F9E44803112}"/>
+                <a16:creationId xmlns:a16="http://schemas.microsoft.com/office/drawing/2014/main" id="{9E8FB1C2-5737-4712-ABB4-AD0CD8FF3E5F}"/>
               </a:ext>
             </a:extLst>
           </p:cNvPr>
@@ -2781,7 +2781,7 @@
     </p:spTree>
     <p:extLst>
       <p:ext uri="{BB962C8B-B14F-4D97-AF65-F5344CB8AC3E}">
-        <p14:creationId xmlns:p14="http://schemas.microsoft.com/office/powerpoint/2010/main" val="1260778574"/>
+        <p14:creationId xmlns:p14="http://schemas.microsoft.com/office/powerpoint/2010/main" val="553394919"/>
       </p:ext>
     </p:extLst>
   </p:cSld>
@@ -2805,7 +2805,7 @@
           <p:cNvPr id="1" name="">
             <a:extLst xmlns:a="http://schemas.openxmlformats.org/drawingml/2006/main">
               <a:ext uri="{FF2B5EF4-FFF2-40B4-BE49-F238E27FC236}">
-                <a16:creationId xmlns:a16="http://schemas.microsoft.com/office/drawing/2014/main" id="{04727C4F-203A-49FB-A118-20356E4F2C83}"/>
+                <a16:creationId xmlns:a16="http://schemas.microsoft.com/office/drawing/2014/main" id="{B701B2B2-28BA-49F7-BD42-1BB7E49F9BCA}"/>
               </a:ext>
             </a:extLst>
           </p:cNvPr>
@@ -2840,7 +2840,7 @@
           <p:cNvPr id="2" name="">
             <a:extLst xmlns:a="http://schemas.openxmlformats.org/drawingml/2006/main">
               <a:ext uri="{FF2B5EF4-FFF2-40B4-BE49-F238E27FC236}">
-                <a16:creationId xmlns:a16="http://schemas.microsoft.com/office/drawing/2014/main" id="{D8DD2FB7-8D5B-4C21-A32D-73F1D245E195}"/>
+                <a16:creationId xmlns:a16="http://schemas.microsoft.com/office/drawing/2014/main" id="{7E429A8C-2466-4D17-9F5F-BCC39ED1827C}"/>
               </a:ext>
             </a:extLst>
           </p:cNvPr>
@@ -2875,7 +2875,7 @@
           <p:cNvPr id="3" name="">
             <a:extLst xmlns:a="http://schemas.openxmlformats.org/drawingml/2006/main">
               <a:ext uri="{FF2B5EF4-FFF2-40B4-BE49-F238E27FC236}">
-                <a16:creationId xmlns:a16="http://schemas.microsoft.com/office/drawing/2014/main" id="{4033E743-DB82-463C-9353-E6CDDE8914B1}"/>
+                <a16:creationId xmlns:a16="http://schemas.microsoft.com/office/drawing/2014/main" id="{A08648A1-E67E-480C-B0BF-1B822B165EB8}"/>
               </a:ext>
             </a:extLst>
           </p:cNvPr>
@@ -2939,7 +2939,7 @@
           <p:cNvPr id="4" name="">
             <a:extLst xmlns:a="http://schemas.openxmlformats.org/drawingml/2006/main">
               <a:ext uri="{FF2B5EF4-FFF2-40B4-BE49-F238E27FC236}">
-                <a16:creationId xmlns:a16="http://schemas.microsoft.com/office/drawing/2014/main" id="{EA5967A8-2656-4195-9DB1-1236810ED711}"/>
+                <a16:creationId xmlns:a16="http://schemas.microsoft.com/office/drawing/2014/main" id="{3DF12EBF-44BD-4579-A4A6-54AF87B21E7D}"/>
               </a:ext>
             </a:extLst>
           </p:cNvPr>
@@ -3003,7 +3003,7 @@
           <p:cNvPr id="5" name="">
             <a:extLst xmlns:a="http://schemas.openxmlformats.org/drawingml/2006/main">
               <a:ext uri="{FF2B5EF4-FFF2-40B4-BE49-F238E27FC236}">
-                <a16:creationId xmlns:a16="http://schemas.microsoft.com/office/drawing/2014/main" id="{3E762D85-D03B-4A1E-8A22-BF05FFE112DD}"/>
+                <a16:creationId xmlns:a16="http://schemas.microsoft.com/office/drawing/2014/main" id="{61254453-173D-42F6-A4B0-6079A2B9A94F}"/>
               </a:ext>
             </a:extLst>
           </p:cNvPr>
@@ -3067,7 +3067,7 @@
           <p:cNvPr id="6" name="">
             <a:extLst xmlns:a="http://schemas.openxmlformats.org/drawingml/2006/main">
               <a:ext uri="{FF2B5EF4-FFF2-40B4-BE49-F238E27FC236}">
-                <a16:creationId xmlns:a16="http://schemas.microsoft.com/office/drawing/2014/main" id="{105BEC43-68C0-4644-89B3-0C4160A2BCA9}"/>
+                <a16:creationId xmlns:a16="http://schemas.microsoft.com/office/drawing/2014/main" id="{ECC1A538-84CE-47B6-A58C-E8DB5ACDABCC}"/>
               </a:ext>
             </a:extLst>
           </p:cNvPr>
@@ -3131,7 +3131,7 @@
           <p:cNvPr id="7" name="">
             <a:extLst xmlns:a="http://schemas.openxmlformats.org/drawingml/2006/main">
               <a:ext uri="{FF2B5EF4-FFF2-40B4-BE49-F238E27FC236}">
-                <a16:creationId xmlns:a16="http://schemas.microsoft.com/office/drawing/2014/main" id="{F340019F-7A15-4D1C-97C3-D4EE30BA6630}"/>
+                <a16:creationId xmlns:a16="http://schemas.microsoft.com/office/drawing/2014/main" id="{552A0B3F-B969-4DCC-BEDA-2A4D30EEF98D}"/>
               </a:ext>
             </a:extLst>
           </p:cNvPr>
@@ -3164,7 +3164,7 @@
           <p:cNvPr id="8" name="">
             <a:extLst xmlns:a="http://schemas.openxmlformats.org/drawingml/2006/main">
               <a:ext uri="{FF2B5EF4-FFF2-40B4-BE49-F238E27FC236}">
-                <a16:creationId xmlns:a16="http://schemas.microsoft.com/office/drawing/2014/main" id="{5630000F-403B-4DEC-AE28-00C0D4F5BC65}"/>
+                <a16:creationId xmlns:a16="http://schemas.microsoft.com/office/drawing/2014/main" id="{1D12685B-F4D8-4DE4-B293-1011D0D9A259}"/>
               </a:ext>
             </a:extLst>
           </p:cNvPr>
@@ -3228,7 +3228,7 @@
           <p:cNvPr id="9" name="">
             <a:extLst xmlns:a="http://schemas.openxmlformats.org/drawingml/2006/main">
               <a:ext uri="{FF2B5EF4-FFF2-40B4-BE49-F238E27FC236}">
-                <a16:creationId xmlns:a16="http://schemas.microsoft.com/office/drawing/2014/main" id="{F25B74C7-825F-4054-8D8B-D66804471C2F}"/>
+                <a16:creationId xmlns:a16="http://schemas.microsoft.com/office/drawing/2014/main" id="{6492FDDC-CCFE-40AD-9C37-985C9A4D4F1B}"/>
               </a:ext>
             </a:extLst>
           </p:cNvPr>
@@ -3292,7 +3292,7 @@
           <p:cNvPr id="10" name="">
             <a:extLst xmlns:a="http://schemas.openxmlformats.org/drawingml/2006/main">
               <a:ext uri="{FF2B5EF4-FFF2-40B4-BE49-F238E27FC236}">
-                <a16:creationId xmlns:a16="http://schemas.microsoft.com/office/drawing/2014/main" id="{302692EE-CD09-49D7-99F1-4C1151B08CE7}"/>
+                <a16:creationId xmlns:a16="http://schemas.microsoft.com/office/drawing/2014/main" id="{52DC4107-8CAD-4D60-BFE6-03C39E90FC75}"/>
               </a:ext>
             </a:extLst>
           </p:cNvPr>
@@ -3325,7 +3325,7 @@
           <p:cNvPr id="11" name="">
             <a:extLst xmlns:a="http://schemas.openxmlformats.org/drawingml/2006/main">
               <a:ext uri="{FF2B5EF4-FFF2-40B4-BE49-F238E27FC236}">
-                <a16:creationId xmlns:a16="http://schemas.microsoft.com/office/drawing/2014/main" id="{70903236-71D3-4A24-8B0E-8F0BEB44F6EE}"/>
+                <a16:creationId xmlns:a16="http://schemas.microsoft.com/office/drawing/2014/main" id="{2E040DA0-5014-4D04-AB9F-4F6CAAE73B41}"/>
               </a:ext>
             </a:extLst>
           </p:cNvPr>
@@ -3389,7 +3389,7 @@
           <p:cNvPr id="12" name="">
             <a:extLst xmlns:a="http://schemas.openxmlformats.org/drawingml/2006/main">
               <a:ext uri="{FF2B5EF4-FFF2-40B4-BE49-F238E27FC236}">
-                <a16:creationId xmlns:a16="http://schemas.microsoft.com/office/drawing/2014/main" id="{5BFF1B6C-D828-4763-8161-CA203479E021}"/>
+                <a16:creationId xmlns:a16="http://schemas.microsoft.com/office/drawing/2014/main" id="{A332027B-0CDB-40EA-96C9-83A8C8CEFB1C}"/>
               </a:ext>
             </a:extLst>
           </p:cNvPr>
@@ -3453,7 +3453,7 @@
           <p:cNvPr id="13" name="">
             <a:extLst xmlns:a="http://schemas.openxmlformats.org/drawingml/2006/main">
               <a:ext uri="{FF2B5EF4-FFF2-40B4-BE49-F238E27FC236}">
-                <a16:creationId xmlns:a16="http://schemas.microsoft.com/office/drawing/2014/main" id="{29BCFC1D-5753-472E-B886-769C71452C1D}"/>
+                <a16:creationId xmlns:a16="http://schemas.microsoft.com/office/drawing/2014/main" id="{C332F087-F98F-4B8F-9204-5574956C84BC}"/>
               </a:ext>
             </a:extLst>
           </p:cNvPr>
@@ -3486,7 +3486,7 @@
           <p:cNvPr id="14" name="">
             <a:extLst xmlns:a="http://schemas.openxmlformats.org/drawingml/2006/main">
               <a:ext uri="{FF2B5EF4-FFF2-40B4-BE49-F238E27FC236}">
-                <a16:creationId xmlns:a16="http://schemas.microsoft.com/office/drawing/2014/main" id="{5F1BF421-BD19-4EF9-95A4-227E52E9607D}"/>
+                <a16:creationId xmlns:a16="http://schemas.microsoft.com/office/drawing/2014/main" id="{C8AB2EFE-DB02-4031-B546-5AC1BA8FB24B}"/>
               </a:ext>
             </a:extLst>
           </p:cNvPr>
@@ -3550,7 +3550,7 @@
           <p:cNvPr id="15" name="">
             <a:extLst xmlns:a="http://schemas.openxmlformats.org/drawingml/2006/main">
               <a:ext uri="{FF2B5EF4-FFF2-40B4-BE49-F238E27FC236}">
-                <a16:creationId xmlns:a16="http://schemas.microsoft.com/office/drawing/2014/main" id="{3D29AB5F-66BC-48BB-B0BD-E1B75500C493}"/>
+                <a16:creationId xmlns:a16="http://schemas.microsoft.com/office/drawing/2014/main" id="{196B6059-02BF-487A-8E99-41EA3D6A6F93}"/>
               </a:ext>
             </a:extLst>
           </p:cNvPr>
@@ -3604,7 +3604,7 @@
                 <a:ea typeface="Aptos"/>
                 <a:cs typeface="Aptos"/>
               </a:rPr>
-              <a:t>Docker app, live five-agent activity, local Gemma E2B, producer approval, and proven radio evidence with honest solar/sensor milestones.</a:t>
+              <a:t>Docker app, live five-agent activity, public CPU Gemma E2B, producer approval, and proven radio evidence with honest solar/sensor milestones.</a:t>
             </a:r>
           </a:p>
         </p:txBody>
@@ -3614,7 +3614,7 @@
           <p:cNvPr id="16" name="">
             <a:extLst xmlns:a="http://schemas.openxmlformats.org/drawingml/2006/main">
               <a:ext uri="{FF2B5EF4-FFF2-40B4-BE49-F238E27FC236}">
-                <a16:creationId xmlns:a16="http://schemas.microsoft.com/office/drawing/2014/main" id="{F2BAFFEC-4D4F-459B-AA0B-3662E23F56D3}"/>
+                <a16:creationId xmlns:a16="http://schemas.microsoft.com/office/drawing/2014/main" id="{9C3F7723-06A0-451B-87C3-703A19C7355C}"/>
               </a:ext>
             </a:extLst>
           </p:cNvPr>
@@ -3678,7 +3678,7 @@
           <p:cNvPr id="17" name="">
             <a:extLst xmlns:a="http://schemas.openxmlformats.org/drawingml/2006/main">
               <a:ext uri="{FF2B5EF4-FFF2-40B4-BE49-F238E27FC236}">
-                <a16:creationId xmlns:a16="http://schemas.microsoft.com/office/drawing/2014/main" id="{E5C66A5B-EE71-4EF1-8F3C-E5BCE1EC3720}"/>
+                <a16:creationId xmlns:a16="http://schemas.microsoft.com/office/drawing/2014/main" id="{8D3A6DCC-3347-4896-B229-B05F00C2092C}"/>
               </a:ext>
             </a:extLst>
           </p:cNvPr>
@@ -3742,7 +3742,7 @@
           <p:cNvPr id="18" name="">
             <a:extLst xmlns:a="http://schemas.openxmlformats.org/drawingml/2006/main">
               <a:ext uri="{FF2B5EF4-FFF2-40B4-BE49-F238E27FC236}">
-                <a16:creationId xmlns:a16="http://schemas.microsoft.com/office/drawing/2014/main" id="{D122545A-D3AD-422F-B37C-270DA9F89260}"/>
+                <a16:creationId xmlns:a16="http://schemas.microsoft.com/office/drawing/2014/main" id="{04CABBFD-B069-4BCF-B403-E90B05734BFB}"/>
               </a:ext>
             </a:extLst>
           </p:cNvPr>
@@ -3804,7 +3804,7 @@
     </p:spTree>
     <p:extLst>
       <p:ext uri="{BB962C8B-B14F-4D97-AF65-F5344CB8AC3E}">
-        <p14:creationId xmlns:p14="http://schemas.microsoft.com/office/powerpoint/2010/main" val="143757977"/>
+        <p14:creationId xmlns:p14="http://schemas.microsoft.com/office/powerpoint/2010/main" val="900904334"/>
       </p:ext>
     </p:extLst>
   </p:cSld>
@@ -3828,7 +3828,7 @@
           <p:cNvPr id="1" name="">
             <a:extLst xmlns:a="http://schemas.openxmlformats.org/drawingml/2006/main">
               <a:ext uri="{FF2B5EF4-FFF2-40B4-BE49-F238E27FC236}">
-                <a16:creationId xmlns:a16="http://schemas.microsoft.com/office/drawing/2014/main" id="{7E2245F4-3B59-4646-83B0-480D2DEDCC1D}"/>
+                <a16:creationId xmlns:a16="http://schemas.microsoft.com/office/drawing/2014/main" id="{B1F546A0-2894-4E8C-899D-D8A78A4B475C}"/>
               </a:ext>
             </a:extLst>
           </p:cNvPr>
@@ -3863,7 +3863,7 @@
           <p:cNvPr id="2" name="">
             <a:extLst xmlns:a="http://schemas.openxmlformats.org/drawingml/2006/main">
               <a:ext uri="{FF2B5EF4-FFF2-40B4-BE49-F238E27FC236}">
-                <a16:creationId xmlns:a16="http://schemas.microsoft.com/office/drawing/2014/main" id="{C96DFB73-B790-423A-863A-2F3A1F91B52D}"/>
+                <a16:creationId xmlns:a16="http://schemas.microsoft.com/office/drawing/2014/main" id="{1E9E0606-C827-4E46-A386-3E10F8CF942E}"/>
               </a:ext>
             </a:extLst>
           </p:cNvPr>
@@ -3898,7 +3898,7 @@
           <p:cNvPr id="3" name="">
             <a:extLst xmlns:a="http://schemas.openxmlformats.org/drawingml/2006/main">
               <a:ext uri="{FF2B5EF4-FFF2-40B4-BE49-F238E27FC236}">
-                <a16:creationId xmlns:a16="http://schemas.microsoft.com/office/drawing/2014/main" id="{D2BAF779-EBC4-4C60-8985-B27318722ABB}"/>
+                <a16:creationId xmlns:a16="http://schemas.microsoft.com/office/drawing/2014/main" id="{A1009981-0CE7-4C5D-B125-3CE94EF4F895}"/>
               </a:ext>
             </a:extLst>
           </p:cNvPr>
@@ -3962,7 +3962,7 @@
           <p:cNvPr id="4" name="">
             <a:extLst xmlns:a="http://schemas.openxmlformats.org/drawingml/2006/main">
               <a:ext uri="{FF2B5EF4-FFF2-40B4-BE49-F238E27FC236}">
-                <a16:creationId xmlns:a16="http://schemas.microsoft.com/office/drawing/2014/main" id="{799B9BA3-E2B9-4FD3-B2D2-55E50F533502}"/>
+                <a16:creationId xmlns:a16="http://schemas.microsoft.com/office/drawing/2014/main" id="{C78DEF2B-215A-4070-8E18-08E82C101EF2}"/>
               </a:ext>
             </a:extLst>
           </p:cNvPr>
@@ -4026,7 +4026,7 @@
           <p:cNvPr id="5" name="">
             <a:extLst xmlns:a="http://schemas.openxmlformats.org/drawingml/2006/main">
               <a:ext uri="{FF2B5EF4-FFF2-40B4-BE49-F238E27FC236}">
-                <a16:creationId xmlns:a16="http://schemas.microsoft.com/office/drawing/2014/main" id="{4CF95735-5AD1-4129-8CFA-312F82610BB1}"/>
+                <a16:creationId xmlns:a16="http://schemas.microsoft.com/office/drawing/2014/main" id="{5899842D-5918-4296-8DE4-E166B7EBC7EF}"/>
               </a:ext>
             </a:extLst>
           </p:cNvPr>
@@ -4090,7 +4090,7 @@
           <p:cNvPr id="6" name="">
             <a:extLst xmlns:a="http://schemas.openxmlformats.org/drawingml/2006/main">
               <a:ext uri="{FF2B5EF4-FFF2-40B4-BE49-F238E27FC236}">
-                <a16:creationId xmlns:a16="http://schemas.microsoft.com/office/drawing/2014/main" id="{C6F3C1F0-368B-4CA8-85CE-CA7109B974E2}"/>
+                <a16:creationId xmlns:a16="http://schemas.microsoft.com/office/drawing/2014/main" id="{0D773A0F-8059-466C-A159-882353E965C5}"/>
               </a:ext>
             </a:extLst>
           </p:cNvPr>
@@ -4154,7 +4154,7 @@
           <p:cNvPr id="7" name="">
             <a:extLst xmlns:a="http://schemas.openxmlformats.org/drawingml/2006/main">
               <a:ext uri="{FF2B5EF4-FFF2-40B4-BE49-F238E27FC236}">
-                <a16:creationId xmlns:a16="http://schemas.microsoft.com/office/drawing/2014/main" id="{120C5CDF-2458-4C14-88FA-98F3C6880392}"/>
+                <a16:creationId xmlns:a16="http://schemas.microsoft.com/office/drawing/2014/main" id="{230D1C70-14BB-42D3-9501-3FCC845C67A3}"/>
               </a:ext>
             </a:extLst>
           </p:cNvPr>
@@ -4187,7 +4187,7 @@
           <p:cNvPr id="8" name="">
             <a:extLst xmlns:a="http://schemas.openxmlformats.org/drawingml/2006/main">
               <a:ext uri="{FF2B5EF4-FFF2-40B4-BE49-F238E27FC236}">
-                <a16:creationId xmlns:a16="http://schemas.microsoft.com/office/drawing/2014/main" id="{C7423CE2-F789-44D0-9173-62EA80746187}"/>
+                <a16:creationId xmlns:a16="http://schemas.microsoft.com/office/drawing/2014/main" id="{22D24BAA-C955-4064-8542-85FFA8CBB737}"/>
               </a:ext>
             </a:extLst>
           </p:cNvPr>
@@ -4251,7 +4251,7 @@
           <p:cNvPr id="9" name="">
             <a:extLst xmlns:a="http://schemas.openxmlformats.org/drawingml/2006/main">
               <a:ext uri="{FF2B5EF4-FFF2-40B4-BE49-F238E27FC236}">
-                <a16:creationId xmlns:a16="http://schemas.microsoft.com/office/drawing/2014/main" id="{7EF64DC2-77F5-49B3-9560-F28B1029E2AF}"/>
+                <a16:creationId xmlns:a16="http://schemas.microsoft.com/office/drawing/2014/main" id="{8A779E05-1821-469E-9D31-E2CDA2FFCA45}"/>
               </a:ext>
             </a:extLst>
           </p:cNvPr>
@@ -4315,7 +4315,7 @@
           <p:cNvPr id="10" name="">
             <a:extLst xmlns:a="http://schemas.openxmlformats.org/drawingml/2006/main">
               <a:ext uri="{FF2B5EF4-FFF2-40B4-BE49-F238E27FC236}">
-                <a16:creationId xmlns:a16="http://schemas.microsoft.com/office/drawing/2014/main" id="{88CD65D8-B113-4BC3-A75C-5E70312C6A75}"/>
+                <a16:creationId xmlns:a16="http://schemas.microsoft.com/office/drawing/2014/main" id="{6E7319B8-5859-430C-AA9F-25667035E921}"/>
               </a:ext>
             </a:extLst>
           </p:cNvPr>
@@ -4348,7 +4348,7 @@
           <p:cNvPr id="11" name="">
             <a:extLst xmlns:a="http://schemas.openxmlformats.org/drawingml/2006/main">
               <a:ext uri="{FF2B5EF4-FFF2-40B4-BE49-F238E27FC236}">
-                <a16:creationId xmlns:a16="http://schemas.microsoft.com/office/drawing/2014/main" id="{0F91CE8B-05CD-4D77-BEAF-250A2256DD4E}"/>
+                <a16:creationId xmlns:a16="http://schemas.microsoft.com/office/drawing/2014/main" id="{0D9C39C4-5C39-410E-9A15-87A289CB30EA}"/>
               </a:ext>
             </a:extLst>
           </p:cNvPr>
@@ -4412,7 +4412,7 @@
           <p:cNvPr id="12" name="">
             <a:extLst xmlns:a="http://schemas.openxmlformats.org/drawingml/2006/main">
               <a:ext uri="{FF2B5EF4-FFF2-40B4-BE49-F238E27FC236}">
-                <a16:creationId xmlns:a16="http://schemas.microsoft.com/office/drawing/2014/main" id="{DEB993EB-EE96-4EFD-AB05-E8CAF6600951}"/>
+                <a16:creationId xmlns:a16="http://schemas.microsoft.com/office/drawing/2014/main" id="{CE093AA6-8AC8-4B38-B991-AD9DBED64ED0}"/>
               </a:ext>
             </a:extLst>
           </p:cNvPr>
@@ -4476,7 +4476,7 @@
           <p:cNvPr id="13" name="">
             <a:extLst xmlns:a="http://schemas.openxmlformats.org/drawingml/2006/main">
               <a:ext uri="{FF2B5EF4-FFF2-40B4-BE49-F238E27FC236}">
-                <a16:creationId xmlns:a16="http://schemas.microsoft.com/office/drawing/2014/main" id="{28C21600-36D9-4C9D-AD67-F3A02AB44444}"/>
+                <a16:creationId xmlns:a16="http://schemas.microsoft.com/office/drawing/2014/main" id="{F9885FCA-D467-43B9-856E-90375693695A}"/>
               </a:ext>
             </a:extLst>
           </p:cNvPr>
@@ -4509,7 +4509,7 @@
           <p:cNvPr id="14" name="">
             <a:extLst xmlns:a="http://schemas.openxmlformats.org/drawingml/2006/main">
               <a:ext uri="{FF2B5EF4-FFF2-40B4-BE49-F238E27FC236}">
-                <a16:creationId xmlns:a16="http://schemas.microsoft.com/office/drawing/2014/main" id="{164F8587-0E86-4117-A86E-9DC6EBE46AF8}"/>
+                <a16:creationId xmlns:a16="http://schemas.microsoft.com/office/drawing/2014/main" id="{4D7575C3-2EE8-4416-8886-F28DA7B4E3BD}"/>
               </a:ext>
             </a:extLst>
           </p:cNvPr>
@@ -4573,7 +4573,7 @@
           <p:cNvPr id="15" name="">
             <a:extLst xmlns:a="http://schemas.openxmlformats.org/drawingml/2006/main">
               <a:ext uri="{FF2B5EF4-FFF2-40B4-BE49-F238E27FC236}">
-                <a16:creationId xmlns:a16="http://schemas.microsoft.com/office/drawing/2014/main" id="{FFC66AF3-084F-4097-8663-AFD9F43228A7}"/>
+                <a16:creationId xmlns:a16="http://schemas.microsoft.com/office/drawing/2014/main" id="{9017C038-0A04-4413-B3AA-D196810BC41C}"/>
               </a:ext>
             </a:extLst>
           </p:cNvPr>
@@ -4637,7 +4637,7 @@
           <p:cNvPr id="16" name="">
             <a:extLst xmlns:a="http://schemas.openxmlformats.org/drawingml/2006/main">
               <a:ext uri="{FF2B5EF4-FFF2-40B4-BE49-F238E27FC236}">
-                <a16:creationId xmlns:a16="http://schemas.microsoft.com/office/drawing/2014/main" id="{C0C9B0C7-C66E-431F-951A-AE53D29814A5}"/>
+                <a16:creationId xmlns:a16="http://schemas.microsoft.com/office/drawing/2014/main" id="{5DD81480-4F8A-4284-B0CF-63EF43011A61}"/>
               </a:ext>
             </a:extLst>
           </p:cNvPr>
@@ -4701,7 +4701,7 @@
           <p:cNvPr id="17" name="">
             <a:extLst xmlns:a="http://schemas.openxmlformats.org/drawingml/2006/main">
               <a:ext uri="{FF2B5EF4-FFF2-40B4-BE49-F238E27FC236}">
-                <a16:creationId xmlns:a16="http://schemas.microsoft.com/office/drawing/2014/main" id="{54285DCD-ABB6-48C1-BEAF-F1D363BFA3C4}"/>
+                <a16:creationId xmlns:a16="http://schemas.microsoft.com/office/drawing/2014/main" id="{94CB5371-0006-4A58-9C3A-F51758274A48}"/>
               </a:ext>
             </a:extLst>
           </p:cNvPr>
@@ -4763,7 +4763,7 @@
     </p:spTree>
     <p:extLst>
       <p:ext uri="{BB962C8B-B14F-4D97-AF65-F5344CB8AC3E}">
-        <p14:creationId xmlns:p14="http://schemas.microsoft.com/office/powerpoint/2010/main" val="148738773"/>
+        <p14:creationId xmlns:p14="http://schemas.microsoft.com/office/powerpoint/2010/main" val="1306096078"/>
       </p:ext>
     </p:extLst>
   </p:cSld>
@@ -4787,7 +4787,7 @@
           <p:cNvPr id="1" name="">
             <a:extLst xmlns:a="http://schemas.openxmlformats.org/drawingml/2006/main">
               <a:ext uri="{FF2B5EF4-FFF2-40B4-BE49-F238E27FC236}">
-                <a16:creationId xmlns:a16="http://schemas.microsoft.com/office/drawing/2014/main" id="{A54333C0-FCB7-4D6B-BF27-F793FC833D27}"/>
+                <a16:creationId xmlns:a16="http://schemas.microsoft.com/office/drawing/2014/main" id="{B78960AD-F948-4076-B3BA-4B0D4945F833}"/>
               </a:ext>
             </a:extLst>
           </p:cNvPr>
@@ -4822,7 +4822,7 @@
           <p:cNvPr id="2" name="">
             <a:extLst xmlns:a="http://schemas.openxmlformats.org/drawingml/2006/main">
               <a:ext uri="{FF2B5EF4-FFF2-40B4-BE49-F238E27FC236}">
-                <a16:creationId xmlns:a16="http://schemas.microsoft.com/office/drawing/2014/main" id="{CDB2D8FF-D220-4B52-893E-5DE54012D1AC}"/>
+                <a16:creationId xmlns:a16="http://schemas.microsoft.com/office/drawing/2014/main" id="{492D7103-02A4-4358-8501-7FF85A25B3EF}"/>
               </a:ext>
             </a:extLst>
           </p:cNvPr>
@@ -4857,7 +4857,7 @@
           <p:cNvPr id="3" name="">
             <a:extLst xmlns:a="http://schemas.openxmlformats.org/drawingml/2006/main">
               <a:ext uri="{FF2B5EF4-FFF2-40B4-BE49-F238E27FC236}">
-                <a16:creationId xmlns:a16="http://schemas.microsoft.com/office/drawing/2014/main" id="{E7C9EFF9-D3E4-4E3C-8FF2-09FA9FD607F2}"/>
+                <a16:creationId xmlns:a16="http://schemas.microsoft.com/office/drawing/2014/main" id="{7A8B03EB-B248-432D-A8B2-B2A493166231}"/>
               </a:ext>
             </a:extLst>
           </p:cNvPr>
@@ -4921,7 +4921,7 @@
           <p:cNvPr id="4" name="">
             <a:extLst xmlns:a="http://schemas.openxmlformats.org/drawingml/2006/main">
               <a:ext uri="{FF2B5EF4-FFF2-40B4-BE49-F238E27FC236}">
-                <a16:creationId xmlns:a16="http://schemas.microsoft.com/office/drawing/2014/main" id="{D19006EB-FB0F-4864-B3DA-1B7C557BE06B}"/>
+                <a16:creationId xmlns:a16="http://schemas.microsoft.com/office/drawing/2014/main" id="{986A1162-D319-488A-AE2B-05B1E6411B62}"/>
               </a:ext>
             </a:extLst>
           </p:cNvPr>
@@ -4985,7 +4985,7 @@
           <p:cNvPr id="5" name="">
             <a:extLst xmlns:a="http://schemas.openxmlformats.org/drawingml/2006/main">
               <a:ext uri="{FF2B5EF4-FFF2-40B4-BE49-F238E27FC236}">
-                <a16:creationId xmlns:a16="http://schemas.microsoft.com/office/drawing/2014/main" id="{38D5E0A1-3242-4BEA-BAAF-8E350B88721E}"/>
+                <a16:creationId xmlns:a16="http://schemas.microsoft.com/office/drawing/2014/main" id="{B59C0639-F8D1-4D12-8231-10880C90103D}"/>
               </a:ext>
             </a:extLst>
           </p:cNvPr>
@@ -5049,7 +5049,7 @@
           <p:cNvPr id="6" name="">
             <a:extLst xmlns:a="http://schemas.openxmlformats.org/drawingml/2006/main">
               <a:ext uri="{FF2B5EF4-FFF2-40B4-BE49-F238E27FC236}">
-                <a16:creationId xmlns:a16="http://schemas.microsoft.com/office/drawing/2014/main" id="{FE5CCE1B-FC4B-4A9E-A32E-0BC62DE0271F}"/>
+                <a16:creationId xmlns:a16="http://schemas.microsoft.com/office/drawing/2014/main" id="{BB77667E-5FCB-4D87-AACE-351DD790E207}"/>
               </a:ext>
             </a:extLst>
           </p:cNvPr>
@@ -5113,7 +5113,7 @@
           <p:cNvPr id="7" name="">
             <a:extLst xmlns:a="http://schemas.openxmlformats.org/drawingml/2006/main">
               <a:ext uri="{FF2B5EF4-FFF2-40B4-BE49-F238E27FC236}">
-                <a16:creationId xmlns:a16="http://schemas.microsoft.com/office/drawing/2014/main" id="{10D77194-2347-4920-B0CE-F94BF822979F}"/>
+                <a16:creationId xmlns:a16="http://schemas.microsoft.com/office/drawing/2014/main" id="{C1D62A8F-FA04-4380-87B8-D7B092CCA07E}"/>
               </a:ext>
             </a:extLst>
           </p:cNvPr>
@@ -5146,7 +5146,7 @@
           <p:cNvPr id="8" name="">
             <a:extLst xmlns:a="http://schemas.openxmlformats.org/drawingml/2006/main">
               <a:ext uri="{FF2B5EF4-FFF2-40B4-BE49-F238E27FC236}">
-                <a16:creationId xmlns:a16="http://schemas.microsoft.com/office/drawing/2014/main" id="{071A6677-176A-43DD-9AA0-87DEEEAD7599}"/>
+                <a16:creationId xmlns:a16="http://schemas.microsoft.com/office/drawing/2014/main" id="{1137A151-70DA-42D7-9CC2-4BC609C8974E}"/>
               </a:ext>
             </a:extLst>
           </p:cNvPr>
@@ -5210,7 +5210,7 @@
           <p:cNvPr id="9" name="">
             <a:extLst xmlns:a="http://schemas.openxmlformats.org/drawingml/2006/main">
               <a:ext uri="{FF2B5EF4-FFF2-40B4-BE49-F238E27FC236}">
-                <a16:creationId xmlns:a16="http://schemas.microsoft.com/office/drawing/2014/main" id="{7864BD91-9752-4CF3-BE3A-4B1E83AE039F}"/>
+                <a16:creationId xmlns:a16="http://schemas.microsoft.com/office/drawing/2014/main" id="{A63CE4C9-DA54-4BAA-97A7-8A353487D645}"/>
               </a:ext>
             </a:extLst>
           </p:cNvPr>
@@ -5274,7 +5274,7 @@
           <p:cNvPr id="10" name="">
             <a:extLst xmlns:a="http://schemas.openxmlformats.org/drawingml/2006/main">
               <a:ext uri="{FF2B5EF4-FFF2-40B4-BE49-F238E27FC236}">
-                <a16:creationId xmlns:a16="http://schemas.microsoft.com/office/drawing/2014/main" id="{14B82712-CF2C-4624-AAB0-5E0A691CEF94}"/>
+                <a16:creationId xmlns:a16="http://schemas.microsoft.com/office/drawing/2014/main" id="{2467EBC7-1539-457C-BA6B-5A6D08741F58}"/>
               </a:ext>
             </a:extLst>
           </p:cNvPr>
@@ -5338,7 +5338,7 @@
           <p:cNvPr id="11" name="">
             <a:extLst xmlns:a="http://schemas.openxmlformats.org/drawingml/2006/main">
               <a:ext uri="{FF2B5EF4-FFF2-40B4-BE49-F238E27FC236}">
-                <a16:creationId xmlns:a16="http://schemas.microsoft.com/office/drawing/2014/main" id="{AA866C81-4AD8-46FC-B81E-1BF36DEE7A02}"/>
+                <a16:creationId xmlns:a16="http://schemas.microsoft.com/office/drawing/2014/main" id="{D7BE6469-5406-41F9-8B73-E56C342F81CF}"/>
               </a:ext>
             </a:extLst>
           </p:cNvPr>
@@ -5371,7 +5371,7 @@
           <p:cNvPr id="12" name="">
             <a:extLst xmlns:a="http://schemas.openxmlformats.org/drawingml/2006/main">
               <a:ext uri="{FF2B5EF4-FFF2-40B4-BE49-F238E27FC236}">
-                <a16:creationId xmlns:a16="http://schemas.microsoft.com/office/drawing/2014/main" id="{B82E7E6A-C75B-4578-826A-43227BB7B926}"/>
+                <a16:creationId xmlns:a16="http://schemas.microsoft.com/office/drawing/2014/main" id="{A5C8C874-C219-48BD-B945-EA3A6968097E}"/>
               </a:ext>
             </a:extLst>
           </p:cNvPr>
@@ -5435,7 +5435,7 @@
           <p:cNvPr id="13" name="">
             <a:extLst xmlns:a="http://schemas.openxmlformats.org/drawingml/2006/main">
               <a:ext uri="{FF2B5EF4-FFF2-40B4-BE49-F238E27FC236}">
-                <a16:creationId xmlns:a16="http://schemas.microsoft.com/office/drawing/2014/main" id="{A8C59986-0137-4C61-98A9-ADE11A763EA3}"/>
+                <a16:creationId xmlns:a16="http://schemas.microsoft.com/office/drawing/2014/main" id="{E2C1CF42-A783-48ED-AA9A-7EA71462629D}"/>
               </a:ext>
             </a:extLst>
           </p:cNvPr>
@@ -5499,7 +5499,7 @@
           <p:cNvPr id="14" name="">
             <a:extLst xmlns:a="http://schemas.openxmlformats.org/drawingml/2006/main">
               <a:ext uri="{FF2B5EF4-FFF2-40B4-BE49-F238E27FC236}">
-                <a16:creationId xmlns:a16="http://schemas.microsoft.com/office/drawing/2014/main" id="{64CB9113-59EB-48AC-A306-40034A6EB65A}"/>
+                <a16:creationId xmlns:a16="http://schemas.microsoft.com/office/drawing/2014/main" id="{99676108-C70B-4E44-9732-C552537F72A2}"/>
               </a:ext>
             </a:extLst>
           </p:cNvPr>
@@ -5563,7 +5563,7 @@
           <p:cNvPr id="15" name="">
             <a:extLst xmlns:a="http://schemas.openxmlformats.org/drawingml/2006/main">
               <a:ext uri="{FF2B5EF4-FFF2-40B4-BE49-F238E27FC236}">
-                <a16:creationId xmlns:a16="http://schemas.microsoft.com/office/drawing/2014/main" id="{8AE7A923-E46C-4723-9228-F5F1CE4CCFB2}"/>
+                <a16:creationId xmlns:a16="http://schemas.microsoft.com/office/drawing/2014/main" id="{091E3F14-0CB6-4CED-BC2A-F4AC0AE47D58}"/>
               </a:ext>
             </a:extLst>
           </p:cNvPr>
@@ -5596,7 +5596,7 @@
           <p:cNvPr id="16" name="">
             <a:extLst xmlns:a="http://schemas.openxmlformats.org/drawingml/2006/main">
               <a:ext uri="{FF2B5EF4-FFF2-40B4-BE49-F238E27FC236}">
-                <a16:creationId xmlns:a16="http://schemas.microsoft.com/office/drawing/2014/main" id="{41BBF93E-E912-48E9-9A7B-7E7BB4BE75E0}"/>
+                <a16:creationId xmlns:a16="http://schemas.microsoft.com/office/drawing/2014/main" id="{1FD61853-2DB6-4297-A84E-A5FA752D2B57}"/>
               </a:ext>
             </a:extLst>
           </p:cNvPr>
@@ -5660,7 +5660,7 @@
           <p:cNvPr id="17" name="">
             <a:extLst xmlns:a="http://schemas.openxmlformats.org/drawingml/2006/main">
               <a:ext uri="{FF2B5EF4-FFF2-40B4-BE49-F238E27FC236}">
-                <a16:creationId xmlns:a16="http://schemas.microsoft.com/office/drawing/2014/main" id="{69627329-948B-403A-84A3-AF81D5836626}"/>
+                <a16:creationId xmlns:a16="http://schemas.microsoft.com/office/drawing/2014/main" id="{70C88A4F-DC26-49C9-A956-D8F81FF045AA}"/>
               </a:ext>
             </a:extLst>
           </p:cNvPr>
@@ -5724,7 +5724,7 @@
           <p:cNvPr id="18" name="">
             <a:extLst xmlns:a="http://schemas.openxmlformats.org/drawingml/2006/main">
               <a:ext uri="{FF2B5EF4-FFF2-40B4-BE49-F238E27FC236}">
-                <a16:creationId xmlns:a16="http://schemas.microsoft.com/office/drawing/2014/main" id="{91CAAB98-E950-430A-8FD3-085085C21618}"/>
+                <a16:creationId xmlns:a16="http://schemas.microsoft.com/office/drawing/2014/main" id="{8587D0A2-C074-4B46-90E1-07A61A0EE100}"/>
               </a:ext>
             </a:extLst>
           </p:cNvPr>
@@ -5788,7 +5788,7 @@
           <p:cNvPr id="19" name="">
             <a:extLst xmlns:a="http://schemas.openxmlformats.org/drawingml/2006/main">
               <a:ext uri="{FF2B5EF4-FFF2-40B4-BE49-F238E27FC236}">
-                <a16:creationId xmlns:a16="http://schemas.microsoft.com/office/drawing/2014/main" id="{82C821DC-CFA4-468C-9D11-A5BC5E58B644}"/>
+                <a16:creationId xmlns:a16="http://schemas.microsoft.com/office/drawing/2014/main" id="{4F31022D-4B96-4CFD-8FCA-D2305711E5D7}"/>
               </a:ext>
             </a:extLst>
           </p:cNvPr>
@@ -5821,7 +5821,7 @@
           <p:cNvPr id="20" name="">
             <a:extLst xmlns:a="http://schemas.openxmlformats.org/drawingml/2006/main">
               <a:ext uri="{FF2B5EF4-FFF2-40B4-BE49-F238E27FC236}">
-                <a16:creationId xmlns:a16="http://schemas.microsoft.com/office/drawing/2014/main" id="{C44AC7F6-060B-40C0-BD28-DA031DFC7D45}"/>
+                <a16:creationId xmlns:a16="http://schemas.microsoft.com/office/drawing/2014/main" id="{F6A6445B-F3EA-4362-B605-7DC037BD4BAE}"/>
               </a:ext>
             </a:extLst>
           </p:cNvPr>
@@ -5885,7 +5885,7 @@
           <p:cNvPr id="21" name="">
             <a:extLst xmlns:a="http://schemas.openxmlformats.org/drawingml/2006/main">
               <a:ext uri="{FF2B5EF4-FFF2-40B4-BE49-F238E27FC236}">
-                <a16:creationId xmlns:a16="http://schemas.microsoft.com/office/drawing/2014/main" id="{FC981389-1344-4D2E-A7E2-85F94002D4AC}"/>
+                <a16:creationId xmlns:a16="http://schemas.microsoft.com/office/drawing/2014/main" id="{40D14D5C-7159-4F0B-AD04-3AA39470787E}"/>
               </a:ext>
             </a:extLst>
           </p:cNvPr>
@@ -5949,7 +5949,7 @@
           <p:cNvPr id="22" name="">
             <a:extLst xmlns:a="http://schemas.openxmlformats.org/drawingml/2006/main">
               <a:ext uri="{FF2B5EF4-FFF2-40B4-BE49-F238E27FC236}">
-                <a16:creationId xmlns:a16="http://schemas.microsoft.com/office/drawing/2014/main" id="{34667695-E80B-4B19-A772-96903F013936}"/>
+                <a16:creationId xmlns:a16="http://schemas.microsoft.com/office/drawing/2014/main" id="{B90040ED-E191-4819-8DB2-5E49605BF974}"/>
               </a:ext>
             </a:extLst>
           </p:cNvPr>
@@ -5982,7 +5982,7 @@
           <p:cNvPr id="23" name="">
             <a:extLst xmlns:a="http://schemas.openxmlformats.org/drawingml/2006/main">
               <a:ext uri="{FF2B5EF4-FFF2-40B4-BE49-F238E27FC236}">
-                <a16:creationId xmlns:a16="http://schemas.microsoft.com/office/drawing/2014/main" id="{C3A72CA4-83A7-43DB-87EE-4A16C29D85D2}"/>
+                <a16:creationId xmlns:a16="http://schemas.microsoft.com/office/drawing/2014/main" id="{5C720F19-4F9B-45C9-800D-57F026EFFF8F}"/>
               </a:ext>
             </a:extLst>
           </p:cNvPr>
@@ -6046,7 +6046,7 @@
           <p:cNvPr id="24" name="">
             <a:extLst xmlns:a="http://schemas.openxmlformats.org/drawingml/2006/main">
               <a:ext uri="{FF2B5EF4-FFF2-40B4-BE49-F238E27FC236}">
-                <a16:creationId xmlns:a16="http://schemas.microsoft.com/office/drawing/2014/main" id="{2FC23963-9E46-4816-866A-BB74E760FA51}"/>
+                <a16:creationId xmlns:a16="http://schemas.microsoft.com/office/drawing/2014/main" id="{46803F9F-D7A4-4690-B72E-98541431252D}"/>
               </a:ext>
             </a:extLst>
           </p:cNvPr>
@@ -6110,7 +6110,7 @@
           <p:cNvPr id="25" name="">
             <a:extLst xmlns:a="http://schemas.openxmlformats.org/drawingml/2006/main">
               <a:ext uri="{FF2B5EF4-FFF2-40B4-BE49-F238E27FC236}">
-                <a16:creationId xmlns:a16="http://schemas.microsoft.com/office/drawing/2014/main" id="{54764875-DAA1-45D7-9B6D-DCAD34A3FA44}"/>
+                <a16:creationId xmlns:a16="http://schemas.microsoft.com/office/drawing/2014/main" id="{F3154CC1-5F2A-47B9-AF5C-30A92F114D3F}"/>
               </a:ext>
             </a:extLst>
           </p:cNvPr>
@@ -6174,7 +6174,7 @@
           <p:cNvPr id="26" name="">
             <a:extLst xmlns:a="http://schemas.openxmlformats.org/drawingml/2006/main">
               <a:ext uri="{FF2B5EF4-FFF2-40B4-BE49-F238E27FC236}">
-                <a16:creationId xmlns:a16="http://schemas.microsoft.com/office/drawing/2014/main" id="{051CAE03-DC48-411A-B1C5-3F5CC07EC672}"/>
+                <a16:creationId xmlns:a16="http://schemas.microsoft.com/office/drawing/2014/main" id="{17891570-0DFF-4340-885A-74B23FA466B6}"/>
               </a:ext>
             </a:extLst>
           </p:cNvPr>
@@ -6236,7 +6236,7 @@
     </p:spTree>
     <p:extLst>
       <p:ext uri="{BB962C8B-B14F-4D97-AF65-F5344CB8AC3E}">
-        <p14:creationId xmlns:p14="http://schemas.microsoft.com/office/powerpoint/2010/main" val="869420255"/>
+        <p14:creationId xmlns:p14="http://schemas.microsoft.com/office/powerpoint/2010/main" val="401574389"/>
       </p:ext>
     </p:extLst>
   </p:cSld>
@@ -6260,7 +6260,7 @@
           <p:cNvPr id="1" name="">
             <a:extLst xmlns:a="http://schemas.openxmlformats.org/drawingml/2006/main">
               <a:ext uri="{FF2B5EF4-FFF2-40B4-BE49-F238E27FC236}">
-                <a16:creationId xmlns:a16="http://schemas.microsoft.com/office/drawing/2014/main" id="{DFD189C5-D86C-4F21-88F3-A0FE28BE7A0F}"/>
+                <a16:creationId xmlns:a16="http://schemas.microsoft.com/office/drawing/2014/main" id="{0B09024A-C023-45EA-8243-431FD7DF94F4}"/>
               </a:ext>
             </a:extLst>
           </p:cNvPr>
@@ -6295,7 +6295,7 @@
           <p:cNvPr id="2" name="">
             <a:extLst xmlns:a="http://schemas.openxmlformats.org/drawingml/2006/main">
               <a:ext uri="{FF2B5EF4-FFF2-40B4-BE49-F238E27FC236}">
-                <a16:creationId xmlns:a16="http://schemas.microsoft.com/office/drawing/2014/main" id="{F0DB7FB9-2B06-40FF-93FA-8E54927E4A95}"/>
+                <a16:creationId xmlns:a16="http://schemas.microsoft.com/office/drawing/2014/main" id="{FF40EC68-DB44-4200-BEF5-969CCC7B3634}"/>
               </a:ext>
             </a:extLst>
           </p:cNvPr>
@@ -6330,7 +6330,7 @@
           <p:cNvPr id="3" name="">
             <a:extLst xmlns:a="http://schemas.openxmlformats.org/drawingml/2006/main">
               <a:ext uri="{FF2B5EF4-FFF2-40B4-BE49-F238E27FC236}">
-                <a16:creationId xmlns:a16="http://schemas.microsoft.com/office/drawing/2014/main" id="{A49198DC-9EA1-43DF-A3C7-81814A5AC59B}"/>
+                <a16:creationId xmlns:a16="http://schemas.microsoft.com/office/drawing/2014/main" id="{95276F86-A6AB-4396-B031-7C4F9F83A418}"/>
               </a:ext>
             </a:extLst>
           </p:cNvPr>
@@ -6394,7 +6394,7 @@
           <p:cNvPr id="4" name="">
             <a:extLst xmlns:a="http://schemas.openxmlformats.org/drawingml/2006/main">
               <a:ext uri="{FF2B5EF4-FFF2-40B4-BE49-F238E27FC236}">
-                <a16:creationId xmlns:a16="http://schemas.microsoft.com/office/drawing/2014/main" id="{D989DD90-4935-4527-AA77-5A5D43AB679D}"/>
+                <a16:creationId xmlns:a16="http://schemas.microsoft.com/office/drawing/2014/main" id="{80BCCC84-3C34-44BE-AABB-E1B2CE47CDF5}"/>
               </a:ext>
             </a:extLst>
           </p:cNvPr>
@@ -6458,7 +6458,7 @@
           <p:cNvPr id="5" name="">
             <a:extLst xmlns:a="http://schemas.openxmlformats.org/drawingml/2006/main">
               <a:ext uri="{FF2B5EF4-FFF2-40B4-BE49-F238E27FC236}">
-                <a16:creationId xmlns:a16="http://schemas.microsoft.com/office/drawing/2014/main" id="{AFD7A268-0A6E-43F7-959C-6EB42FB7AECB}"/>
+                <a16:creationId xmlns:a16="http://schemas.microsoft.com/office/drawing/2014/main" id="{E18EF698-F33E-406B-8F47-1A51EF5AF682}"/>
               </a:ext>
             </a:extLst>
           </p:cNvPr>
@@ -6522,7 +6522,7 @@
           <p:cNvPr id="6" name="">
             <a:extLst xmlns:a="http://schemas.openxmlformats.org/drawingml/2006/main">
               <a:ext uri="{FF2B5EF4-FFF2-40B4-BE49-F238E27FC236}">
-                <a16:creationId xmlns:a16="http://schemas.microsoft.com/office/drawing/2014/main" id="{DAABEFC0-FC54-42F8-8E2D-99CF9FD1100E}"/>
+                <a16:creationId xmlns:a16="http://schemas.microsoft.com/office/drawing/2014/main" id="{53EB10D6-E05D-4268-9BC2-5FF396D81F01}"/>
               </a:ext>
             </a:extLst>
           </p:cNvPr>
@@ -6586,7 +6586,7 @@
           <p:cNvPr id="7" name="">
             <a:extLst xmlns:a="http://schemas.openxmlformats.org/drawingml/2006/main">
               <a:ext uri="{FF2B5EF4-FFF2-40B4-BE49-F238E27FC236}">
-                <a16:creationId xmlns:a16="http://schemas.microsoft.com/office/drawing/2014/main" id="{890B5F8F-4B40-436B-8C55-F6F571609F82}"/>
+                <a16:creationId xmlns:a16="http://schemas.microsoft.com/office/drawing/2014/main" id="{921D5207-996D-40D2-A8B5-F3BF1C4C2610}"/>
               </a:ext>
             </a:extLst>
           </p:cNvPr>
@@ -6619,7 +6619,7 @@
           <p:cNvPr id="8" name="">
             <a:extLst xmlns:a="http://schemas.openxmlformats.org/drawingml/2006/main">
               <a:ext uri="{FF2B5EF4-FFF2-40B4-BE49-F238E27FC236}">
-                <a16:creationId xmlns:a16="http://schemas.microsoft.com/office/drawing/2014/main" id="{EF33087E-7EA7-4EBE-9181-DA0EE76D8A00}"/>
+                <a16:creationId xmlns:a16="http://schemas.microsoft.com/office/drawing/2014/main" id="{5833EBA2-8477-41A1-934A-6C580EBB8470}"/>
               </a:ext>
             </a:extLst>
           </p:cNvPr>
@@ -6683,7 +6683,7 @@
           <p:cNvPr id="9" name="">
             <a:extLst xmlns:a="http://schemas.openxmlformats.org/drawingml/2006/main">
               <a:ext uri="{FF2B5EF4-FFF2-40B4-BE49-F238E27FC236}">
-                <a16:creationId xmlns:a16="http://schemas.microsoft.com/office/drawing/2014/main" id="{C766BC5B-FB41-43C1-99FD-9A17D7A9FDCA}"/>
+                <a16:creationId xmlns:a16="http://schemas.microsoft.com/office/drawing/2014/main" id="{9BFC257B-654C-4D2F-8874-4B56DBAC8B32}"/>
               </a:ext>
             </a:extLst>
           </p:cNvPr>
@@ -6747,7 +6747,7 @@
           <p:cNvPr id="10" name="">
             <a:extLst xmlns:a="http://schemas.openxmlformats.org/drawingml/2006/main">
               <a:ext uri="{FF2B5EF4-FFF2-40B4-BE49-F238E27FC236}">
-                <a16:creationId xmlns:a16="http://schemas.microsoft.com/office/drawing/2014/main" id="{3FD22189-3A9D-41FB-B250-34FAF91DB666}"/>
+                <a16:creationId xmlns:a16="http://schemas.microsoft.com/office/drawing/2014/main" id="{E215D3F3-E7FB-4DF2-9FDB-6D466D910E3A}"/>
               </a:ext>
             </a:extLst>
           </p:cNvPr>
@@ -6811,7 +6811,7 @@
           <p:cNvPr id="11" name="">
             <a:extLst xmlns:a="http://schemas.openxmlformats.org/drawingml/2006/main">
               <a:ext uri="{FF2B5EF4-FFF2-40B4-BE49-F238E27FC236}">
-                <a16:creationId xmlns:a16="http://schemas.microsoft.com/office/drawing/2014/main" id="{34016B2B-91D5-4032-BFD9-1C4CA5833607}"/>
+                <a16:creationId xmlns:a16="http://schemas.microsoft.com/office/drawing/2014/main" id="{57CFFB65-3918-4C6C-B599-9A03A0F0E2D5}"/>
               </a:ext>
             </a:extLst>
           </p:cNvPr>
@@ -6844,7 +6844,7 @@
           <p:cNvPr id="12" name="">
             <a:extLst xmlns:a="http://schemas.openxmlformats.org/drawingml/2006/main">
               <a:ext uri="{FF2B5EF4-FFF2-40B4-BE49-F238E27FC236}">
-                <a16:creationId xmlns:a16="http://schemas.microsoft.com/office/drawing/2014/main" id="{91A3A839-BD78-4963-861C-2C9E78BE2F74}"/>
+                <a16:creationId xmlns:a16="http://schemas.microsoft.com/office/drawing/2014/main" id="{2AB35F2A-0DDC-46F8-9EF2-2641B43E4474}"/>
               </a:ext>
             </a:extLst>
           </p:cNvPr>
@@ -6908,7 +6908,7 @@
           <p:cNvPr id="13" name="">
             <a:extLst xmlns:a="http://schemas.openxmlformats.org/drawingml/2006/main">
               <a:ext uri="{FF2B5EF4-FFF2-40B4-BE49-F238E27FC236}">
-                <a16:creationId xmlns:a16="http://schemas.microsoft.com/office/drawing/2014/main" id="{7D7854DA-7ED6-49DE-A833-988943492792}"/>
+                <a16:creationId xmlns:a16="http://schemas.microsoft.com/office/drawing/2014/main" id="{D58CCDE5-1B32-4406-9394-434C4C279543}"/>
               </a:ext>
             </a:extLst>
           </p:cNvPr>
@@ -6972,7 +6972,7 @@
           <p:cNvPr id="14" name="">
             <a:extLst xmlns:a="http://schemas.openxmlformats.org/drawingml/2006/main">
               <a:ext uri="{FF2B5EF4-FFF2-40B4-BE49-F238E27FC236}">
-                <a16:creationId xmlns:a16="http://schemas.microsoft.com/office/drawing/2014/main" id="{8CB085FB-592A-4684-A378-404BC8EAD08E}"/>
+                <a16:creationId xmlns:a16="http://schemas.microsoft.com/office/drawing/2014/main" id="{CC898308-53C5-478A-83EA-47D631CABA61}"/>
               </a:ext>
             </a:extLst>
           </p:cNvPr>
@@ -7036,7 +7036,7 @@
           <p:cNvPr id="15" name="">
             <a:extLst xmlns:a="http://schemas.openxmlformats.org/drawingml/2006/main">
               <a:ext uri="{FF2B5EF4-FFF2-40B4-BE49-F238E27FC236}">
-                <a16:creationId xmlns:a16="http://schemas.microsoft.com/office/drawing/2014/main" id="{1722A276-14CA-49B4-BF35-D3EE3ACE9C87}"/>
+                <a16:creationId xmlns:a16="http://schemas.microsoft.com/office/drawing/2014/main" id="{B4632EBA-DC15-44ED-96F9-F77B2985304D}"/>
               </a:ext>
             </a:extLst>
           </p:cNvPr>
@@ -7069,7 +7069,7 @@
           <p:cNvPr id="16" name="">
             <a:extLst xmlns:a="http://schemas.openxmlformats.org/drawingml/2006/main">
               <a:ext uri="{FF2B5EF4-FFF2-40B4-BE49-F238E27FC236}">
-                <a16:creationId xmlns:a16="http://schemas.microsoft.com/office/drawing/2014/main" id="{0B9B9918-1E1B-4BC0-BF5D-29115C4FAE4E}"/>
+                <a16:creationId xmlns:a16="http://schemas.microsoft.com/office/drawing/2014/main" id="{CC3025FF-2372-42B0-AF90-AE7286563EBB}"/>
               </a:ext>
             </a:extLst>
           </p:cNvPr>
@@ -7133,7 +7133,7 @@
           <p:cNvPr id="17" name="">
             <a:extLst xmlns:a="http://schemas.openxmlformats.org/drawingml/2006/main">
               <a:ext uri="{FF2B5EF4-FFF2-40B4-BE49-F238E27FC236}">
-                <a16:creationId xmlns:a16="http://schemas.microsoft.com/office/drawing/2014/main" id="{7602BBBA-B87E-42DE-A5D5-0DD6899B6928}"/>
+                <a16:creationId xmlns:a16="http://schemas.microsoft.com/office/drawing/2014/main" id="{47989221-8910-4065-AA6B-3F3291FDE1A1}"/>
               </a:ext>
             </a:extLst>
           </p:cNvPr>
@@ -7197,7 +7197,7 @@
           <p:cNvPr id="18" name="">
             <a:extLst xmlns:a="http://schemas.openxmlformats.org/drawingml/2006/main">
               <a:ext uri="{FF2B5EF4-FFF2-40B4-BE49-F238E27FC236}">
-                <a16:creationId xmlns:a16="http://schemas.microsoft.com/office/drawing/2014/main" id="{0F637D1B-4111-4D32-BF56-59EC5EB6F084}"/>
+                <a16:creationId xmlns:a16="http://schemas.microsoft.com/office/drawing/2014/main" id="{E7D3B959-5351-4686-8C2D-86C9584B3F58}"/>
               </a:ext>
             </a:extLst>
           </p:cNvPr>
@@ -7261,7 +7261,7 @@
           <p:cNvPr id="19" name="">
             <a:extLst xmlns:a="http://schemas.openxmlformats.org/drawingml/2006/main">
               <a:ext uri="{FF2B5EF4-FFF2-40B4-BE49-F238E27FC236}">
-                <a16:creationId xmlns:a16="http://schemas.microsoft.com/office/drawing/2014/main" id="{A00B7D60-1060-4A09-ACE8-3BEC5BC3B7D8}"/>
+                <a16:creationId xmlns:a16="http://schemas.microsoft.com/office/drawing/2014/main" id="{4895E9B9-D8D5-4270-B42E-A86D2F6C0AED}"/>
               </a:ext>
             </a:extLst>
           </p:cNvPr>
@@ -7294,7 +7294,7 @@
           <p:cNvPr id="20" name="">
             <a:extLst xmlns:a="http://schemas.openxmlformats.org/drawingml/2006/main">
               <a:ext uri="{FF2B5EF4-FFF2-40B4-BE49-F238E27FC236}">
-                <a16:creationId xmlns:a16="http://schemas.microsoft.com/office/drawing/2014/main" id="{3591CBE6-3EC7-4CFB-AED8-9E76DBFF39F4}"/>
+                <a16:creationId xmlns:a16="http://schemas.microsoft.com/office/drawing/2014/main" id="{854AAA5B-EBC9-46A7-B95E-E6BBDE0D937C}"/>
               </a:ext>
             </a:extLst>
           </p:cNvPr>
@@ -7358,7 +7358,7 @@
           <p:cNvPr id="21" name="">
             <a:extLst xmlns:a="http://schemas.openxmlformats.org/drawingml/2006/main">
               <a:ext uri="{FF2B5EF4-FFF2-40B4-BE49-F238E27FC236}">
-                <a16:creationId xmlns:a16="http://schemas.microsoft.com/office/drawing/2014/main" id="{1DC1A7D3-B89E-4273-88CB-EE0B98DAB59B}"/>
+                <a16:creationId xmlns:a16="http://schemas.microsoft.com/office/drawing/2014/main" id="{1F05BEF3-1EE3-49ED-842C-4CCCB7AADCB1}"/>
               </a:ext>
             </a:extLst>
           </p:cNvPr>
@@ -7422,7 +7422,7 @@
           <p:cNvPr id="22" name="">
             <a:extLst xmlns:a="http://schemas.openxmlformats.org/drawingml/2006/main">
               <a:ext uri="{FF2B5EF4-FFF2-40B4-BE49-F238E27FC236}">
-                <a16:creationId xmlns:a16="http://schemas.microsoft.com/office/drawing/2014/main" id="{4F519005-15C1-45DE-A48E-635F346B6E90}"/>
+                <a16:creationId xmlns:a16="http://schemas.microsoft.com/office/drawing/2014/main" id="{BB0A8DA3-DF72-4AD5-9533-A534103D40CD}"/>
               </a:ext>
             </a:extLst>
           </p:cNvPr>
@@ -7455,7 +7455,7 @@
           <p:cNvPr id="23" name="">
             <a:extLst xmlns:a="http://schemas.openxmlformats.org/drawingml/2006/main">
               <a:ext uri="{FF2B5EF4-FFF2-40B4-BE49-F238E27FC236}">
-                <a16:creationId xmlns:a16="http://schemas.microsoft.com/office/drawing/2014/main" id="{DB1B33C6-3D19-4860-9DD6-65E3ACBFE615}"/>
+                <a16:creationId xmlns:a16="http://schemas.microsoft.com/office/drawing/2014/main" id="{A98DBC1A-CF64-4627-83B4-1790AC8CA0C8}"/>
               </a:ext>
             </a:extLst>
           </p:cNvPr>
@@ -7519,7 +7519,7 @@
           <p:cNvPr id="24" name="">
             <a:extLst xmlns:a="http://schemas.openxmlformats.org/drawingml/2006/main">
               <a:ext uri="{FF2B5EF4-FFF2-40B4-BE49-F238E27FC236}">
-                <a16:creationId xmlns:a16="http://schemas.microsoft.com/office/drawing/2014/main" id="{F557F63B-2D3C-4348-9A89-376CD64C36E6}"/>
+                <a16:creationId xmlns:a16="http://schemas.microsoft.com/office/drawing/2014/main" id="{1EAD9F8F-A6EE-435E-AF87-C9404CD8066D}"/>
               </a:ext>
             </a:extLst>
           </p:cNvPr>
@@ -7583,7 +7583,7 @@
           <p:cNvPr id="25" name="">
             <a:extLst xmlns:a="http://schemas.openxmlformats.org/drawingml/2006/main">
               <a:ext uri="{FF2B5EF4-FFF2-40B4-BE49-F238E27FC236}">
-                <a16:creationId xmlns:a16="http://schemas.microsoft.com/office/drawing/2014/main" id="{428A30BA-DB5B-4435-93BC-35682701BDE6}"/>
+                <a16:creationId xmlns:a16="http://schemas.microsoft.com/office/drawing/2014/main" id="{F99A300D-EF9A-477B-AF55-FA2911A36DFA}"/>
               </a:ext>
             </a:extLst>
           </p:cNvPr>
@@ -7647,7 +7647,7 @@
           <p:cNvPr id="26" name="">
             <a:extLst xmlns:a="http://schemas.openxmlformats.org/drawingml/2006/main">
               <a:ext uri="{FF2B5EF4-FFF2-40B4-BE49-F238E27FC236}">
-                <a16:creationId xmlns:a16="http://schemas.microsoft.com/office/drawing/2014/main" id="{AE4D3662-DDCF-4727-8B13-4546C83D3DDC}"/>
+                <a16:creationId xmlns:a16="http://schemas.microsoft.com/office/drawing/2014/main" id="{F5589BA2-8536-433C-ADBC-3687A6F4B984}"/>
               </a:ext>
             </a:extLst>
           </p:cNvPr>
@@ -7709,7 +7709,7 @@
     </p:spTree>
     <p:extLst>
       <p:ext uri="{BB962C8B-B14F-4D97-AF65-F5344CB8AC3E}">
-        <p14:creationId xmlns:p14="http://schemas.microsoft.com/office/powerpoint/2010/main" val="526403912"/>
+        <p14:creationId xmlns:p14="http://schemas.microsoft.com/office/powerpoint/2010/main" val="1642815606"/>
       </p:ext>
     </p:extLst>
   </p:cSld>
@@ -7733,7 +7733,7 @@
           <p:cNvPr id="1" name="">
             <a:extLst xmlns:a="http://schemas.openxmlformats.org/drawingml/2006/main">
               <a:ext uri="{FF2B5EF4-FFF2-40B4-BE49-F238E27FC236}">
-                <a16:creationId xmlns:a16="http://schemas.microsoft.com/office/drawing/2014/main" id="{14093961-C594-45EB-BB6C-114A851C2715}"/>
+                <a16:creationId xmlns:a16="http://schemas.microsoft.com/office/drawing/2014/main" id="{F0965B15-4D2B-4016-B1D0-EF453362B202}"/>
               </a:ext>
             </a:extLst>
           </p:cNvPr>
@@ -7768,7 +7768,7 @@
           <p:cNvPr id="2" name="">
             <a:extLst xmlns:a="http://schemas.openxmlformats.org/drawingml/2006/main">
               <a:ext uri="{FF2B5EF4-FFF2-40B4-BE49-F238E27FC236}">
-                <a16:creationId xmlns:a16="http://schemas.microsoft.com/office/drawing/2014/main" id="{2AD3728D-D5D7-4F68-BF5A-83999CF8B776}"/>
+                <a16:creationId xmlns:a16="http://schemas.microsoft.com/office/drawing/2014/main" id="{E5625EED-FAB0-467A-B550-246274B708D4}"/>
               </a:ext>
             </a:extLst>
           </p:cNvPr>
@@ -7803,7 +7803,7 @@
           <p:cNvPr id="3" name="">
             <a:extLst xmlns:a="http://schemas.openxmlformats.org/drawingml/2006/main">
               <a:ext uri="{FF2B5EF4-FFF2-40B4-BE49-F238E27FC236}">
-                <a16:creationId xmlns:a16="http://schemas.microsoft.com/office/drawing/2014/main" id="{995A0FCA-4AF2-4231-A47D-C54818A438A3}"/>
+                <a16:creationId xmlns:a16="http://schemas.microsoft.com/office/drawing/2014/main" id="{44E1ECA7-B478-4278-AA3E-373405B5AA23}"/>
               </a:ext>
             </a:extLst>
           </p:cNvPr>
@@ -7867,7 +7867,7 @@
           <p:cNvPr id="4" name="">
             <a:extLst xmlns:a="http://schemas.openxmlformats.org/drawingml/2006/main">
               <a:ext uri="{FF2B5EF4-FFF2-40B4-BE49-F238E27FC236}">
-                <a16:creationId xmlns:a16="http://schemas.microsoft.com/office/drawing/2014/main" id="{61EE2377-2CD6-4FB6-B0E7-9AFEE3AD7AD2}"/>
+                <a16:creationId xmlns:a16="http://schemas.microsoft.com/office/drawing/2014/main" id="{72EF152A-F06B-4158-8CBF-06B246A210E6}"/>
               </a:ext>
             </a:extLst>
           </p:cNvPr>
@@ -7931,7 +7931,7 @@
           <p:cNvPr id="5" name="">
             <a:extLst xmlns:a="http://schemas.openxmlformats.org/drawingml/2006/main">
               <a:ext uri="{FF2B5EF4-FFF2-40B4-BE49-F238E27FC236}">
-                <a16:creationId xmlns:a16="http://schemas.microsoft.com/office/drawing/2014/main" id="{6EEFFFBD-6E77-4D28-9FB6-9F0B59233C19}"/>
+                <a16:creationId xmlns:a16="http://schemas.microsoft.com/office/drawing/2014/main" id="{06AFE92E-A4B6-4C37-9DF9-60042B74FE7D}"/>
               </a:ext>
             </a:extLst>
           </p:cNvPr>
@@ -7995,7 +7995,7 @@
           <p:cNvPr id="6" name="">
             <a:extLst xmlns:a="http://schemas.openxmlformats.org/drawingml/2006/main">
               <a:ext uri="{FF2B5EF4-FFF2-40B4-BE49-F238E27FC236}">
-                <a16:creationId xmlns:a16="http://schemas.microsoft.com/office/drawing/2014/main" id="{D725B99B-546A-4BD2-AE5E-1EEE19FD2C6D}"/>
+                <a16:creationId xmlns:a16="http://schemas.microsoft.com/office/drawing/2014/main" id="{0CBA90C6-AC1C-49C7-A4C7-E8F73E715BDD}"/>
               </a:ext>
             </a:extLst>
           </p:cNvPr>
@@ -8059,7 +8059,7 @@
           <p:cNvPr id="7" name="">
             <a:extLst xmlns:a="http://schemas.openxmlformats.org/drawingml/2006/main">
               <a:ext uri="{FF2B5EF4-FFF2-40B4-BE49-F238E27FC236}">
-                <a16:creationId xmlns:a16="http://schemas.microsoft.com/office/drawing/2014/main" id="{C091B7A3-DB38-4D3C-B43F-3FCD7251E49C}"/>
+                <a16:creationId xmlns:a16="http://schemas.microsoft.com/office/drawing/2014/main" id="{1462AD02-4575-4308-B9B4-F0195842AA70}"/>
               </a:ext>
             </a:extLst>
           </p:cNvPr>
@@ -8094,7 +8094,7 @@
           <p:cNvPr id="8" name="">
             <a:extLst xmlns:a="http://schemas.openxmlformats.org/drawingml/2006/main">
               <a:ext uri="{FF2B5EF4-FFF2-40B4-BE49-F238E27FC236}">
-                <a16:creationId xmlns:a16="http://schemas.microsoft.com/office/drawing/2014/main" id="{88745CE2-008E-438A-804F-FA07A1ADEB60}"/>
+                <a16:creationId xmlns:a16="http://schemas.microsoft.com/office/drawing/2014/main" id="{2113FCD4-38B3-4982-9A2D-F284CC194FD9}"/>
               </a:ext>
             </a:extLst>
           </p:cNvPr>
@@ -8158,7 +8158,7 @@
           <p:cNvPr id="9" name="">
             <a:extLst xmlns:a="http://schemas.openxmlformats.org/drawingml/2006/main">
               <a:ext uri="{FF2B5EF4-FFF2-40B4-BE49-F238E27FC236}">
-                <a16:creationId xmlns:a16="http://schemas.microsoft.com/office/drawing/2014/main" id="{8CE48853-349E-4A9B-AD24-446473190AC1}"/>
+                <a16:creationId xmlns:a16="http://schemas.microsoft.com/office/drawing/2014/main" id="{F8788704-E683-49EA-9E34-696330E994DA}"/>
               </a:ext>
             </a:extLst>
           </p:cNvPr>
@@ -8212,7 +8212,7 @@
                 <a:ea typeface="Aptos"/>
                 <a:cs typeface="Aptos"/>
               </a:rPr>
-              <a:t>163</a:t>
+              <a:t>179</a:t>
             </a:r>
           </a:p>
         </p:txBody>
@@ -8222,7 +8222,7 @@
           <p:cNvPr id="10" name="">
             <a:extLst xmlns:a="http://schemas.openxmlformats.org/drawingml/2006/main">
               <a:ext uri="{FF2B5EF4-FFF2-40B4-BE49-F238E27FC236}">
-                <a16:creationId xmlns:a16="http://schemas.microsoft.com/office/drawing/2014/main" id="{EA93DCD6-64C7-47AF-B3C0-64521D65BD05}"/>
+                <a16:creationId xmlns:a16="http://schemas.microsoft.com/office/drawing/2014/main" id="{A7A4FF83-210D-4039-8D26-0CC3ED3C64BD}"/>
               </a:ext>
             </a:extLst>
           </p:cNvPr>
@@ -8286,7 +8286,7 @@
           <p:cNvPr id="11" name="">
             <a:extLst xmlns:a="http://schemas.openxmlformats.org/drawingml/2006/main">
               <a:ext uri="{FF2B5EF4-FFF2-40B4-BE49-F238E27FC236}">
-                <a16:creationId xmlns:a16="http://schemas.microsoft.com/office/drawing/2014/main" id="{0B58765D-61CF-4901-BDBB-982BF7F09D4A}"/>
+                <a16:creationId xmlns:a16="http://schemas.microsoft.com/office/drawing/2014/main" id="{9BEEC4BE-17A5-4DB1-B669-181F083D3109}"/>
               </a:ext>
             </a:extLst>
           </p:cNvPr>
@@ -8321,7 +8321,7 @@
           <p:cNvPr id="12" name="">
             <a:extLst xmlns:a="http://schemas.openxmlformats.org/drawingml/2006/main">
               <a:ext uri="{FF2B5EF4-FFF2-40B4-BE49-F238E27FC236}">
-                <a16:creationId xmlns:a16="http://schemas.microsoft.com/office/drawing/2014/main" id="{0C506529-55F8-45D5-928F-44431C7C118E}"/>
+                <a16:creationId xmlns:a16="http://schemas.microsoft.com/office/drawing/2014/main" id="{6BA25511-23A7-4992-9898-C0B9B0012566}"/>
               </a:ext>
             </a:extLst>
           </p:cNvPr>
@@ -8385,7 +8385,7 @@
           <p:cNvPr id="13" name="">
             <a:extLst xmlns:a="http://schemas.openxmlformats.org/drawingml/2006/main">
               <a:ext uri="{FF2B5EF4-FFF2-40B4-BE49-F238E27FC236}">
-                <a16:creationId xmlns:a16="http://schemas.microsoft.com/office/drawing/2014/main" id="{FAF68C83-5A14-4F16-AA66-3166A24E1B73}"/>
+                <a16:creationId xmlns:a16="http://schemas.microsoft.com/office/drawing/2014/main" id="{C729C6D3-36BD-4809-ADE0-7EF38EACFB0A}"/>
               </a:ext>
             </a:extLst>
           </p:cNvPr>
@@ -8449,7 +8449,7 @@
           <p:cNvPr id="14" name="">
             <a:extLst xmlns:a="http://schemas.openxmlformats.org/drawingml/2006/main">
               <a:ext uri="{FF2B5EF4-FFF2-40B4-BE49-F238E27FC236}">
-                <a16:creationId xmlns:a16="http://schemas.microsoft.com/office/drawing/2014/main" id="{11369167-2BF7-4934-9AD1-E0A2063BBC0A}"/>
+                <a16:creationId xmlns:a16="http://schemas.microsoft.com/office/drawing/2014/main" id="{EE8E1894-6E17-4C1C-B1EB-070C950AC252}"/>
               </a:ext>
             </a:extLst>
           </p:cNvPr>
@@ -8513,7 +8513,7 @@
           <p:cNvPr id="15" name="">
             <a:extLst xmlns:a="http://schemas.openxmlformats.org/drawingml/2006/main">
               <a:ext uri="{FF2B5EF4-FFF2-40B4-BE49-F238E27FC236}">
-                <a16:creationId xmlns:a16="http://schemas.microsoft.com/office/drawing/2014/main" id="{D90ABDC2-E2A6-45DD-BB80-45D7A239B87A}"/>
+                <a16:creationId xmlns:a16="http://schemas.microsoft.com/office/drawing/2014/main" id="{082EA2CD-64CB-4FA8-887A-ABB59F8F1800}"/>
               </a:ext>
             </a:extLst>
           </p:cNvPr>
@@ -8548,7 +8548,7 @@
           <p:cNvPr id="16" name="">
             <a:extLst xmlns:a="http://schemas.openxmlformats.org/drawingml/2006/main">
               <a:ext uri="{FF2B5EF4-FFF2-40B4-BE49-F238E27FC236}">
-                <a16:creationId xmlns:a16="http://schemas.microsoft.com/office/drawing/2014/main" id="{845A1470-1A9E-4353-9B46-0CC9FF5FC203}"/>
+                <a16:creationId xmlns:a16="http://schemas.microsoft.com/office/drawing/2014/main" id="{BBC90C71-4267-4C66-8F20-0E0C1F319DC7}"/>
               </a:ext>
             </a:extLst>
           </p:cNvPr>
@@ -8612,7 +8612,7 @@
           <p:cNvPr id="17" name="">
             <a:extLst xmlns:a="http://schemas.openxmlformats.org/drawingml/2006/main">
               <a:ext uri="{FF2B5EF4-FFF2-40B4-BE49-F238E27FC236}">
-                <a16:creationId xmlns:a16="http://schemas.microsoft.com/office/drawing/2014/main" id="{662BC869-B455-4D0F-BDDB-D4E6023E150E}"/>
+                <a16:creationId xmlns:a16="http://schemas.microsoft.com/office/drawing/2014/main" id="{66045703-8F97-46A3-AD17-0DB767150E5C}"/>
               </a:ext>
             </a:extLst>
           </p:cNvPr>
@@ -8676,7 +8676,7 @@
           <p:cNvPr id="18" name="">
             <a:extLst xmlns:a="http://schemas.openxmlformats.org/drawingml/2006/main">
               <a:ext uri="{FF2B5EF4-FFF2-40B4-BE49-F238E27FC236}">
-                <a16:creationId xmlns:a16="http://schemas.microsoft.com/office/drawing/2014/main" id="{116C0814-F633-47F5-9568-33219D1A3EE0}"/>
+                <a16:creationId xmlns:a16="http://schemas.microsoft.com/office/drawing/2014/main" id="{4E3D1225-19DE-4BB9-948B-FDAD5BCF50CD}"/>
               </a:ext>
             </a:extLst>
           </p:cNvPr>
@@ -8740,7 +8740,7 @@
           <p:cNvPr id="19" name="">
             <a:extLst xmlns:a="http://schemas.openxmlformats.org/drawingml/2006/main">
               <a:ext uri="{FF2B5EF4-FFF2-40B4-BE49-F238E27FC236}">
-                <a16:creationId xmlns:a16="http://schemas.microsoft.com/office/drawing/2014/main" id="{369E8A76-A21C-42D3-9B69-E72B942B59C4}"/>
+                <a16:creationId xmlns:a16="http://schemas.microsoft.com/office/drawing/2014/main" id="{C40EB962-EE46-4413-A5C6-0A32ACB35B5F}"/>
               </a:ext>
             </a:extLst>
           </p:cNvPr>
@@ -8775,7 +8775,7 @@
           <p:cNvPr id="20" name="">
             <a:extLst xmlns:a="http://schemas.openxmlformats.org/drawingml/2006/main">
               <a:ext uri="{FF2B5EF4-FFF2-40B4-BE49-F238E27FC236}">
-                <a16:creationId xmlns:a16="http://schemas.microsoft.com/office/drawing/2014/main" id="{8753A042-FBE9-4C18-A762-A86A292EBB26}"/>
+                <a16:creationId xmlns:a16="http://schemas.microsoft.com/office/drawing/2014/main" id="{D86A5707-52AB-48BA-A99E-47DE46AECEB0}"/>
               </a:ext>
             </a:extLst>
           </p:cNvPr>
@@ -8839,7 +8839,7 @@
           <p:cNvPr id="21" name="">
             <a:extLst xmlns:a="http://schemas.openxmlformats.org/drawingml/2006/main">
               <a:ext uri="{FF2B5EF4-FFF2-40B4-BE49-F238E27FC236}">
-                <a16:creationId xmlns:a16="http://schemas.microsoft.com/office/drawing/2014/main" id="{4774AE09-7C83-4398-A660-BAA6064D9716}"/>
+                <a16:creationId xmlns:a16="http://schemas.microsoft.com/office/drawing/2014/main" id="{97DD7C0B-6CB3-45E4-AA38-29B1ABE673B1}"/>
               </a:ext>
             </a:extLst>
           </p:cNvPr>
@@ -8903,7 +8903,7 @@
           <p:cNvPr id="22" name="">
             <a:extLst xmlns:a="http://schemas.openxmlformats.org/drawingml/2006/main">
               <a:ext uri="{FF2B5EF4-FFF2-40B4-BE49-F238E27FC236}">
-                <a16:creationId xmlns:a16="http://schemas.microsoft.com/office/drawing/2014/main" id="{163997B8-B93B-4D86-AE73-101026966A2B}"/>
+                <a16:creationId xmlns:a16="http://schemas.microsoft.com/office/drawing/2014/main" id="{5C6B1164-ED57-4249-8C43-8ED193432CF4}"/>
               </a:ext>
             </a:extLst>
           </p:cNvPr>
@@ -8967,7 +8967,7 @@
           <p:cNvPr id="23" name="">
             <a:extLst xmlns:a="http://schemas.openxmlformats.org/drawingml/2006/main">
               <a:ext uri="{FF2B5EF4-FFF2-40B4-BE49-F238E27FC236}">
-                <a16:creationId xmlns:a16="http://schemas.microsoft.com/office/drawing/2014/main" id="{0561B586-E37B-41B9-855A-26973E7CBE21}"/>
+                <a16:creationId xmlns:a16="http://schemas.microsoft.com/office/drawing/2014/main" id="{8DD875CA-19A7-4074-8737-C49FCF5A603A}"/>
               </a:ext>
             </a:extLst>
           </p:cNvPr>
@@ -9000,7 +9000,7 @@
           <p:cNvPr id="24" name="">
             <a:extLst xmlns:a="http://schemas.openxmlformats.org/drawingml/2006/main">
               <a:ext uri="{FF2B5EF4-FFF2-40B4-BE49-F238E27FC236}">
-                <a16:creationId xmlns:a16="http://schemas.microsoft.com/office/drawing/2014/main" id="{9B402650-E6B6-4874-8408-9D85F08B994A}"/>
+                <a16:creationId xmlns:a16="http://schemas.microsoft.com/office/drawing/2014/main" id="{E97E09A5-9498-4D95-AB21-68C0567CBC5F}"/>
               </a:ext>
             </a:extLst>
           </p:cNvPr>
@@ -9064,7 +9064,7 @@
           <p:cNvPr id="25" name="">
             <a:extLst xmlns:a="http://schemas.openxmlformats.org/drawingml/2006/main">
               <a:ext uri="{FF2B5EF4-FFF2-40B4-BE49-F238E27FC236}">
-                <a16:creationId xmlns:a16="http://schemas.microsoft.com/office/drawing/2014/main" id="{C0ED6847-55E3-4240-8A4C-83F99A7EFBA8}"/>
+                <a16:creationId xmlns:a16="http://schemas.microsoft.com/office/drawing/2014/main" id="{E4A227C0-D788-4B08-9A70-946CC0D57550}"/>
               </a:ext>
             </a:extLst>
           </p:cNvPr>
@@ -9128,7 +9128,7 @@
           <p:cNvPr id="26" name="">
             <a:extLst xmlns:a="http://schemas.openxmlformats.org/drawingml/2006/main">
               <a:ext uri="{FF2B5EF4-FFF2-40B4-BE49-F238E27FC236}">
-                <a16:creationId xmlns:a16="http://schemas.microsoft.com/office/drawing/2014/main" id="{E7321871-4684-4D23-A7C6-2702B3D3A5DC}"/>
+                <a16:creationId xmlns:a16="http://schemas.microsoft.com/office/drawing/2014/main" id="{2CD755C8-5A2B-45A4-8B0A-6C188C5E6899}"/>
               </a:ext>
             </a:extLst>
           </p:cNvPr>
@@ -9192,7 +9192,7 @@
           <p:cNvPr id="27" name="">
             <a:extLst xmlns:a="http://schemas.openxmlformats.org/drawingml/2006/main">
               <a:ext uri="{FF2B5EF4-FFF2-40B4-BE49-F238E27FC236}">
-                <a16:creationId xmlns:a16="http://schemas.microsoft.com/office/drawing/2014/main" id="{76DB8976-36BD-492F-9B20-BDFE00EF312D}"/>
+                <a16:creationId xmlns:a16="http://schemas.microsoft.com/office/drawing/2014/main" id="{CAE14BB7-FCB4-4E4A-ABBB-18319A6C4B92}"/>
               </a:ext>
             </a:extLst>
           </p:cNvPr>
@@ -9254,7 +9254,7 @@
     </p:spTree>
     <p:extLst>
       <p:ext uri="{BB962C8B-B14F-4D97-AF65-F5344CB8AC3E}">
-        <p14:creationId xmlns:p14="http://schemas.microsoft.com/office/powerpoint/2010/main" val="823658042"/>
+        <p14:creationId xmlns:p14="http://schemas.microsoft.com/office/powerpoint/2010/main" val="1029013910"/>
       </p:ext>
     </p:extLst>
   </p:cSld>
@@ -9278,7 +9278,7 @@
           <p:cNvPr id="1" name="">
             <a:extLst xmlns:a="http://schemas.openxmlformats.org/drawingml/2006/main">
               <a:ext uri="{FF2B5EF4-FFF2-40B4-BE49-F238E27FC236}">
-                <a16:creationId xmlns:a16="http://schemas.microsoft.com/office/drawing/2014/main" id="{402A8A9A-52E6-4978-A2BC-6DDE3ED54A5C}"/>
+                <a16:creationId xmlns:a16="http://schemas.microsoft.com/office/drawing/2014/main" id="{4A216A36-DF91-4C73-BED4-838AA882A617}"/>
               </a:ext>
             </a:extLst>
           </p:cNvPr>
@@ -9313,7 +9313,7 @@
           <p:cNvPr id="2" name="">
             <a:extLst xmlns:a="http://schemas.openxmlformats.org/drawingml/2006/main">
               <a:ext uri="{FF2B5EF4-FFF2-40B4-BE49-F238E27FC236}">
-                <a16:creationId xmlns:a16="http://schemas.microsoft.com/office/drawing/2014/main" id="{8738D994-DF81-41F8-AAC7-D5378ED87CEB}"/>
+                <a16:creationId xmlns:a16="http://schemas.microsoft.com/office/drawing/2014/main" id="{0694E183-FCE0-4FD1-9AD4-F3D7F9500A13}"/>
               </a:ext>
             </a:extLst>
           </p:cNvPr>
@@ -9348,7 +9348,7 @@
           <p:cNvPr id="3" name="">
             <a:extLst xmlns:a="http://schemas.openxmlformats.org/drawingml/2006/main">
               <a:ext uri="{FF2B5EF4-FFF2-40B4-BE49-F238E27FC236}">
-                <a16:creationId xmlns:a16="http://schemas.microsoft.com/office/drawing/2014/main" id="{47959B74-9D7B-4C91-A16F-BE15BD782AF7}"/>
+                <a16:creationId xmlns:a16="http://schemas.microsoft.com/office/drawing/2014/main" id="{E5F72072-B9ED-4F65-9A70-63F4758E6459}"/>
               </a:ext>
             </a:extLst>
           </p:cNvPr>
@@ -9412,7 +9412,7 @@
           <p:cNvPr id="4" name="">
             <a:extLst xmlns:a="http://schemas.openxmlformats.org/drawingml/2006/main">
               <a:ext uri="{FF2B5EF4-FFF2-40B4-BE49-F238E27FC236}">
-                <a16:creationId xmlns:a16="http://schemas.microsoft.com/office/drawing/2014/main" id="{D7DAB57F-D9BD-422F-8C94-D5EE36CB5BC7}"/>
+                <a16:creationId xmlns:a16="http://schemas.microsoft.com/office/drawing/2014/main" id="{20E1EB50-2FC3-40D2-A282-B2278D07FD32}"/>
               </a:ext>
             </a:extLst>
           </p:cNvPr>
@@ -9476,7 +9476,7 @@
           <p:cNvPr id="5" name="">
             <a:extLst xmlns:a="http://schemas.openxmlformats.org/drawingml/2006/main">
               <a:ext uri="{FF2B5EF4-FFF2-40B4-BE49-F238E27FC236}">
-                <a16:creationId xmlns:a16="http://schemas.microsoft.com/office/drawing/2014/main" id="{C94F747E-8035-4022-AEB9-9DE0E46A5FB3}"/>
+                <a16:creationId xmlns:a16="http://schemas.microsoft.com/office/drawing/2014/main" id="{A83748C6-4126-447F-BC52-5FCDBC107A85}"/>
               </a:ext>
             </a:extLst>
           </p:cNvPr>
@@ -9540,7 +9540,7 @@
           <p:cNvPr id="6" name="">
             <a:extLst xmlns:a="http://schemas.openxmlformats.org/drawingml/2006/main">
               <a:ext uri="{FF2B5EF4-FFF2-40B4-BE49-F238E27FC236}">
-                <a16:creationId xmlns:a16="http://schemas.microsoft.com/office/drawing/2014/main" id="{29FC3D5D-46D1-4101-87D1-67AF98C9D44E}"/>
+                <a16:creationId xmlns:a16="http://schemas.microsoft.com/office/drawing/2014/main" id="{D4BD8902-503A-480E-B834-B7B6414F25B8}"/>
               </a:ext>
             </a:extLst>
           </p:cNvPr>
@@ -9604,7 +9604,7 @@
           <p:cNvPr id="7" name="">
             <a:extLst xmlns:a="http://schemas.openxmlformats.org/drawingml/2006/main">
               <a:ext uri="{FF2B5EF4-FFF2-40B4-BE49-F238E27FC236}">
-                <a16:creationId xmlns:a16="http://schemas.microsoft.com/office/drawing/2014/main" id="{58E9FF18-5E02-44D3-9DFE-1D224A4F5A1B}"/>
+                <a16:creationId xmlns:a16="http://schemas.microsoft.com/office/drawing/2014/main" id="{9EAB9B37-7C5E-4C86-8A71-AD316C92E89C}"/>
               </a:ext>
             </a:extLst>
           </p:cNvPr>
@@ -9637,7 +9637,7 @@
           <p:cNvPr id="8" name="">
             <a:extLst xmlns:a="http://schemas.openxmlformats.org/drawingml/2006/main">
               <a:ext uri="{FF2B5EF4-FFF2-40B4-BE49-F238E27FC236}">
-                <a16:creationId xmlns:a16="http://schemas.microsoft.com/office/drawing/2014/main" id="{C56ECA95-803D-4A90-8443-9949FC8B9ED2}"/>
+                <a16:creationId xmlns:a16="http://schemas.microsoft.com/office/drawing/2014/main" id="{06F4A6F8-1422-4F99-9982-20EFEE80EE50}"/>
               </a:ext>
             </a:extLst>
           </p:cNvPr>
@@ -9701,7 +9701,7 @@
           <p:cNvPr id="9" name="">
             <a:extLst xmlns:a="http://schemas.openxmlformats.org/drawingml/2006/main">
               <a:ext uri="{FF2B5EF4-FFF2-40B4-BE49-F238E27FC236}">
-                <a16:creationId xmlns:a16="http://schemas.microsoft.com/office/drawing/2014/main" id="{259085BA-2BAE-4AE2-9C00-2C0DC7FD2068}"/>
+                <a16:creationId xmlns:a16="http://schemas.microsoft.com/office/drawing/2014/main" id="{53616140-7492-4305-9CE6-C20B44FAFABC}"/>
               </a:ext>
             </a:extLst>
           </p:cNvPr>
@@ -9765,7 +9765,7 @@
           <p:cNvPr id="10" name="">
             <a:extLst xmlns:a="http://schemas.openxmlformats.org/drawingml/2006/main">
               <a:ext uri="{FF2B5EF4-FFF2-40B4-BE49-F238E27FC236}">
-                <a16:creationId xmlns:a16="http://schemas.microsoft.com/office/drawing/2014/main" id="{488A7E47-E16C-421D-87F0-71DB0D846B78}"/>
+                <a16:creationId xmlns:a16="http://schemas.microsoft.com/office/drawing/2014/main" id="{9EA70F2D-AC07-4284-B381-43C2AB8433A6}"/>
               </a:ext>
             </a:extLst>
           </p:cNvPr>
@@ -9798,7 +9798,7 @@
           <p:cNvPr id="11" name="">
             <a:extLst xmlns:a="http://schemas.openxmlformats.org/drawingml/2006/main">
               <a:ext uri="{FF2B5EF4-FFF2-40B4-BE49-F238E27FC236}">
-                <a16:creationId xmlns:a16="http://schemas.microsoft.com/office/drawing/2014/main" id="{B123067B-17DD-4844-9B97-F3B263BCBED8}"/>
+                <a16:creationId xmlns:a16="http://schemas.microsoft.com/office/drawing/2014/main" id="{9DD6991F-7D61-472F-896B-801F8672E09D}"/>
               </a:ext>
             </a:extLst>
           </p:cNvPr>
@@ -9862,7 +9862,7 @@
           <p:cNvPr id="12" name="">
             <a:extLst xmlns:a="http://schemas.openxmlformats.org/drawingml/2006/main">
               <a:ext uri="{FF2B5EF4-FFF2-40B4-BE49-F238E27FC236}">
-                <a16:creationId xmlns:a16="http://schemas.microsoft.com/office/drawing/2014/main" id="{894E3D64-5998-4568-BCE6-FAB395691EC1}"/>
+                <a16:creationId xmlns:a16="http://schemas.microsoft.com/office/drawing/2014/main" id="{CE561077-5FA9-483A-87DA-11279C18E6E3}"/>
               </a:ext>
             </a:extLst>
           </p:cNvPr>
@@ -9926,7 +9926,7 @@
           <p:cNvPr id="13" name="">
             <a:extLst xmlns:a="http://schemas.openxmlformats.org/drawingml/2006/main">
               <a:ext uri="{FF2B5EF4-FFF2-40B4-BE49-F238E27FC236}">
-                <a16:creationId xmlns:a16="http://schemas.microsoft.com/office/drawing/2014/main" id="{41603D80-C3BE-42C6-90DE-F4B3F1BEBF0C}"/>
+                <a16:creationId xmlns:a16="http://schemas.microsoft.com/office/drawing/2014/main" id="{5DE8C2D5-5DEC-4CDA-9DBC-BCA445D90ABD}"/>
               </a:ext>
             </a:extLst>
           </p:cNvPr>
@@ -9959,7 +9959,7 @@
           <p:cNvPr id="14" name="">
             <a:extLst xmlns:a="http://schemas.openxmlformats.org/drawingml/2006/main">
               <a:ext uri="{FF2B5EF4-FFF2-40B4-BE49-F238E27FC236}">
-                <a16:creationId xmlns:a16="http://schemas.microsoft.com/office/drawing/2014/main" id="{DE64A20F-B620-451D-BF07-A62B320C3180}"/>
+                <a16:creationId xmlns:a16="http://schemas.microsoft.com/office/drawing/2014/main" id="{A31D9BEB-4EFB-4F6E-B870-D2BED44F1CF2}"/>
               </a:ext>
             </a:extLst>
           </p:cNvPr>
@@ -10023,7 +10023,7 @@
           <p:cNvPr id="15" name="">
             <a:extLst xmlns:a="http://schemas.openxmlformats.org/drawingml/2006/main">
               <a:ext uri="{FF2B5EF4-FFF2-40B4-BE49-F238E27FC236}">
-                <a16:creationId xmlns:a16="http://schemas.microsoft.com/office/drawing/2014/main" id="{3DB66EDE-D04B-4B23-9AA5-0B340A042EED}"/>
+                <a16:creationId xmlns:a16="http://schemas.microsoft.com/office/drawing/2014/main" id="{0D61316A-A09A-457A-8458-8BEBEED71F51}"/>
               </a:ext>
             </a:extLst>
           </p:cNvPr>
@@ -10087,7 +10087,7 @@
           <p:cNvPr id="16" name="">
             <a:extLst xmlns:a="http://schemas.openxmlformats.org/drawingml/2006/main">
               <a:ext uri="{FF2B5EF4-FFF2-40B4-BE49-F238E27FC236}">
-                <a16:creationId xmlns:a16="http://schemas.microsoft.com/office/drawing/2014/main" id="{8F854EFE-D876-41E9-8E26-164AA5F77271}"/>
+                <a16:creationId xmlns:a16="http://schemas.microsoft.com/office/drawing/2014/main" id="{FBC23501-F224-4553-AB71-074256E174BE}"/>
               </a:ext>
             </a:extLst>
           </p:cNvPr>
@@ -10151,7 +10151,7 @@
           <p:cNvPr id="17" name="">
             <a:extLst xmlns:a="http://schemas.openxmlformats.org/drawingml/2006/main">
               <a:ext uri="{FF2B5EF4-FFF2-40B4-BE49-F238E27FC236}">
-                <a16:creationId xmlns:a16="http://schemas.microsoft.com/office/drawing/2014/main" id="{AF65A2B3-E988-4D9A-9AC8-CACC4FFA895F}"/>
+                <a16:creationId xmlns:a16="http://schemas.microsoft.com/office/drawing/2014/main" id="{53FDB296-DA8B-4343-BD66-F7614E11061A}"/>
               </a:ext>
             </a:extLst>
           </p:cNvPr>
@@ -10213,7 +10213,7 @@
     </p:spTree>
     <p:extLst>
       <p:ext uri="{BB962C8B-B14F-4D97-AF65-F5344CB8AC3E}">
-        <p14:creationId xmlns:p14="http://schemas.microsoft.com/office/powerpoint/2010/main" val="232879943"/>
+        <p14:creationId xmlns:p14="http://schemas.microsoft.com/office/powerpoint/2010/main" val="376526229"/>
       </p:ext>
     </p:extLst>
   </p:cSld>
@@ -10237,7 +10237,7 @@
           <p:cNvPr id="1" name="">
             <a:extLst xmlns:a="http://schemas.openxmlformats.org/drawingml/2006/main">
               <a:ext uri="{FF2B5EF4-FFF2-40B4-BE49-F238E27FC236}">
-                <a16:creationId xmlns:a16="http://schemas.microsoft.com/office/drawing/2014/main" id="{E5EA1057-0350-44F8-AB01-74F1A44174BA}"/>
+                <a16:creationId xmlns:a16="http://schemas.microsoft.com/office/drawing/2014/main" id="{C6AA34C8-F170-4085-AA04-465EC1B8342B}"/>
               </a:ext>
             </a:extLst>
           </p:cNvPr>
@@ -10272,7 +10272,7 @@
           <p:cNvPr id="2" name="">
             <a:extLst xmlns:a="http://schemas.openxmlformats.org/drawingml/2006/main">
               <a:ext uri="{FF2B5EF4-FFF2-40B4-BE49-F238E27FC236}">
-                <a16:creationId xmlns:a16="http://schemas.microsoft.com/office/drawing/2014/main" id="{85F555F5-EFD3-48DC-99D5-03A337FE9F56}"/>
+                <a16:creationId xmlns:a16="http://schemas.microsoft.com/office/drawing/2014/main" id="{B759ECAE-E9F7-4356-9A44-15D16A41B79E}"/>
               </a:ext>
             </a:extLst>
           </p:cNvPr>
@@ -10307,7 +10307,7 @@
           <p:cNvPr id="3" name="">
             <a:extLst xmlns:a="http://schemas.openxmlformats.org/drawingml/2006/main">
               <a:ext uri="{FF2B5EF4-FFF2-40B4-BE49-F238E27FC236}">
-                <a16:creationId xmlns:a16="http://schemas.microsoft.com/office/drawing/2014/main" id="{C52B6734-49E8-42D5-B8DF-3238DCD8C45D}"/>
+                <a16:creationId xmlns:a16="http://schemas.microsoft.com/office/drawing/2014/main" id="{50DC7DF7-DE68-4003-AD5D-16A200CE6C11}"/>
               </a:ext>
             </a:extLst>
           </p:cNvPr>
@@ -10371,7 +10371,7 @@
           <p:cNvPr id="4" name="">
             <a:extLst xmlns:a="http://schemas.openxmlformats.org/drawingml/2006/main">
               <a:ext uri="{FF2B5EF4-FFF2-40B4-BE49-F238E27FC236}">
-                <a16:creationId xmlns:a16="http://schemas.microsoft.com/office/drawing/2014/main" id="{6F87E53E-006C-4EB2-81A3-F1F3DC489281}"/>
+                <a16:creationId xmlns:a16="http://schemas.microsoft.com/office/drawing/2014/main" id="{42E35FDF-8FCB-4A2F-9891-CABD469CC496}"/>
               </a:ext>
             </a:extLst>
           </p:cNvPr>
@@ -10435,7 +10435,7 @@
           <p:cNvPr id="5" name="">
             <a:extLst xmlns:a="http://schemas.openxmlformats.org/drawingml/2006/main">
               <a:ext uri="{FF2B5EF4-FFF2-40B4-BE49-F238E27FC236}">
-                <a16:creationId xmlns:a16="http://schemas.microsoft.com/office/drawing/2014/main" id="{4608629C-C68C-4539-BB85-3D5001118D62}"/>
+                <a16:creationId xmlns:a16="http://schemas.microsoft.com/office/drawing/2014/main" id="{4CAC98E2-9CFF-42B3-8B7F-F6B384DDAE9A}"/>
               </a:ext>
             </a:extLst>
           </p:cNvPr>
@@ -10499,7 +10499,7 @@
           <p:cNvPr id="6" name="">
             <a:extLst xmlns:a="http://schemas.openxmlformats.org/drawingml/2006/main">
               <a:ext uri="{FF2B5EF4-FFF2-40B4-BE49-F238E27FC236}">
-                <a16:creationId xmlns:a16="http://schemas.microsoft.com/office/drawing/2014/main" id="{13EC2FA6-6092-4456-9E77-3526CF6CEC1E}"/>
+                <a16:creationId xmlns:a16="http://schemas.microsoft.com/office/drawing/2014/main" id="{6C58DF2D-8145-470D-A088-1DEF0060868F}"/>
               </a:ext>
             </a:extLst>
           </p:cNvPr>
@@ -10563,7 +10563,7 @@
           <p:cNvPr id="7" name="">
             <a:extLst xmlns:a="http://schemas.openxmlformats.org/drawingml/2006/main">
               <a:ext uri="{FF2B5EF4-FFF2-40B4-BE49-F238E27FC236}">
-                <a16:creationId xmlns:a16="http://schemas.microsoft.com/office/drawing/2014/main" id="{0F417317-253E-425A-8A2D-9AE37FCF0317}"/>
+                <a16:creationId xmlns:a16="http://schemas.microsoft.com/office/drawing/2014/main" id="{1CA1F2A6-0D86-4D90-AA7C-049715BFF67A}"/>
               </a:ext>
             </a:extLst>
           </p:cNvPr>
@@ -10596,7 +10596,7 @@
           <p:cNvPr id="8" name="">
             <a:extLst xmlns:a="http://schemas.openxmlformats.org/drawingml/2006/main">
               <a:ext uri="{FF2B5EF4-FFF2-40B4-BE49-F238E27FC236}">
-                <a16:creationId xmlns:a16="http://schemas.microsoft.com/office/drawing/2014/main" id="{DB9C2C8F-995A-4F4C-8FB4-C656C16B0B11}"/>
+                <a16:creationId xmlns:a16="http://schemas.microsoft.com/office/drawing/2014/main" id="{D06616E0-FABE-4336-B304-D01C527F0DE6}"/>
               </a:ext>
             </a:extLst>
           </p:cNvPr>
@@ -10660,7 +10660,7 @@
           <p:cNvPr id="9" name="">
             <a:extLst xmlns:a="http://schemas.openxmlformats.org/drawingml/2006/main">
               <a:ext uri="{FF2B5EF4-FFF2-40B4-BE49-F238E27FC236}">
-                <a16:creationId xmlns:a16="http://schemas.microsoft.com/office/drawing/2014/main" id="{EFFB0543-D2AF-4B8A-918A-EE238648A46B}"/>
+                <a16:creationId xmlns:a16="http://schemas.microsoft.com/office/drawing/2014/main" id="{9A6A2C92-1B0D-4B3E-98E8-6579369F44A5}"/>
               </a:ext>
             </a:extLst>
           </p:cNvPr>
@@ -10724,7 +10724,7 @@
           <p:cNvPr id="10" name="">
             <a:extLst xmlns:a="http://schemas.openxmlformats.org/drawingml/2006/main">
               <a:ext uri="{FF2B5EF4-FFF2-40B4-BE49-F238E27FC236}">
-                <a16:creationId xmlns:a16="http://schemas.microsoft.com/office/drawing/2014/main" id="{DAABD42C-9952-46D9-97D5-43C97C5B0451}"/>
+                <a16:creationId xmlns:a16="http://schemas.microsoft.com/office/drawing/2014/main" id="{551811A6-B623-444E-86E0-1856EAF8C5D0}"/>
               </a:ext>
             </a:extLst>
           </p:cNvPr>
@@ -10788,7 +10788,7 @@
           <p:cNvPr id="11" name="">
             <a:extLst xmlns:a="http://schemas.openxmlformats.org/drawingml/2006/main">
               <a:ext uri="{FF2B5EF4-FFF2-40B4-BE49-F238E27FC236}">
-                <a16:creationId xmlns:a16="http://schemas.microsoft.com/office/drawing/2014/main" id="{D433DCCF-DBE1-4772-A52A-A253F326BE4A}"/>
+                <a16:creationId xmlns:a16="http://schemas.microsoft.com/office/drawing/2014/main" id="{16E7E2DC-08AE-4ADC-9F41-EF26CBF6EDED}"/>
               </a:ext>
             </a:extLst>
           </p:cNvPr>
@@ -10821,7 +10821,7 @@
           <p:cNvPr id="12" name="">
             <a:extLst xmlns:a="http://schemas.openxmlformats.org/drawingml/2006/main">
               <a:ext uri="{FF2B5EF4-FFF2-40B4-BE49-F238E27FC236}">
-                <a16:creationId xmlns:a16="http://schemas.microsoft.com/office/drawing/2014/main" id="{3729B1CF-A7F5-4D46-8279-B69A25CB8C3E}"/>
+                <a16:creationId xmlns:a16="http://schemas.microsoft.com/office/drawing/2014/main" id="{43810EAC-7858-4936-8942-6A044CB61FCF}"/>
               </a:ext>
             </a:extLst>
           </p:cNvPr>
@@ -10885,7 +10885,7 @@
           <p:cNvPr id="13" name="">
             <a:extLst xmlns:a="http://schemas.openxmlformats.org/drawingml/2006/main">
               <a:ext uri="{FF2B5EF4-FFF2-40B4-BE49-F238E27FC236}">
-                <a16:creationId xmlns:a16="http://schemas.microsoft.com/office/drawing/2014/main" id="{8B8900DC-2FE0-49FD-ACB7-7139C7E02C98}"/>
+                <a16:creationId xmlns:a16="http://schemas.microsoft.com/office/drawing/2014/main" id="{97FAE454-23F6-4649-82D5-0A34190BD7B6}"/>
               </a:ext>
             </a:extLst>
           </p:cNvPr>
@@ -10949,7 +10949,7 @@
           <p:cNvPr id="14" name="">
             <a:extLst xmlns:a="http://schemas.openxmlformats.org/drawingml/2006/main">
               <a:ext uri="{FF2B5EF4-FFF2-40B4-BE49-F238E27FC236}">
-                <a16:creationId xmlns:a16="http://schemas.microsoft.com/office/drawing/2014/main" id="{00014A04-160A-4BFA-9F56-D94148ADF584}"/>
+                <a16:creationId xmlns:a16="http://schemas.microsoft.com/office/drawing/2014/main" id="{13B1D0FB-B9F5-4099-A423-2176C56FAA36}"/>
               </a:ext>
             </a:extLst>
           </p:cNvPr>
@@ -11013,7 +11013,7 @@
           <p:cNvPr id="15" name="">
             <a:extLst xmlns:a="http://schemas.openxmlformats.org/drawingml/2006/main">
               <a:ext uri="{FF2B5EF4-FFF2-40B4-BE49-F238E27FC236}">
-                <a16:creationId xmlns:a16="http://schemas.microsoft.com/office/drawing/2014/main" id="{95950909-5FFD-4337-83D0-21FCFE353958}"/>
+                <a16:creationId xmlns:a16="http://schemas.microsoft.com/office/drawing/2014/main" id="{B02DC726-67EF-4051-B179-196FAF3D64DF}"/>
               </a:ext>
             </a:extLst>
           </p:cNvPr>
@@ -11046,7 +11046,7 @@
           <p:cNvPr id="16" name="">
             <a:extLst xmlns:a="http://schemas.openxmlformats.org/drawingml/2006/main">
               <a:ext uri="{FF2B5EF4-FFF2-40B4-BE49-F238E27FC236}">
-                <a16:creationId xmlns:a16="http://schemas.microsoft.com/office/drawing/2014/main" id="{A5A1810A-7961-4560-A6A8-2D785C61CE06}"/>
+                <a16:creationId xmlns:a16="http://schemas.microsoft.com/office/drawing/2014/main" id="{170D628F-1E1A-4389-8DB9-EF2440B56E0C}"/>
               </a:ext>
             </a:extLst>
           </p:cNvPr>
@@ -11110,7 +11110,7 @@
           <p:cNvPr id="17" name="">
             <a:extLst xmlns:a="http://schemas.openxmlformats.org/drawingml/2006/main">
               <a:ext uri="{FF2B5EF4-FFF2-40B4-BE49-F238E27FC236}">
-                <a16:creationId xmlns:a16="http://schemas.microsoft.com/office/drawing/2014/main" id="{660C8BF0-48AB-4C8A-9162-4E6C3DA95F12}"/>
+                <a16:creationId xmlns:a16="http://schemas.microsoft.com/office/drawing/2014/main" id="{EBE2FD72-D5E6-4C60-978B-383860E59E7B}"/>
               </a:ext>
             </a:extLst>
           </p:cNvPr>
@@ -11174,7 +11174,7 @@
           <p:cNvPr id="18" name="">
             <a:extLst xmlns:a="http://schemas.openxmlformats.org/drawingml/2006/main">
               <a:ext uri="{FF2B5EF4-FFF2-40B4-BE49-F238E27FC236}">
-                <a16:creationId xmlns:a16="http://schemas.microsoft.com/office/drawing/2014/main" id="{3B40B91E-10BE-4555-AA33-623C32EF231E}"/>
+                <a16:creationId xmlns:a16="http://schemas.microsoft.com/office/drawing/2014/main" id="{5293AAD0-770A-4E02-BAAB-6A358384AA26}"/>
               </a:ext>
             </a:extLst>
           </p:cNvPr>
@@ -11238,7 +11238,7 @@
           <p:cNvPr id="19" name="">
             <a:extLst xmlns:a="http://schemas.openxmlformats.org/drawingml/2006/main">
               <a:ext uri="{FF2B5EF4-FFF2-40B4-BE49-F238E27FC236}">
-                <a16:creationId xmlns:a16="http://schemas.microsoft.com/office/drawing/2014/main" id="{C693A5CA-17E9-4439-825D-62B211D53D17}"/>
+                <a16:creationId xmlns:a16="http://schemas.microsoft.com/office/drawing/2014/main" id="{13F400B3-6702-4C66-9619-622558C8A45D}"/>
               </a:ext>
             </a:extLst>
           </p:cNvPr>
@@ -11271,7 +11271,7 @@
           <p:cNvPr id="20" name="">
             <a:extLst xmlns:a="http://schemas.openxmlformats.org/drawingml/2006/main">
               <a:ext uri="{FF2B5EF4-FFF2-40B4-BE49-F238E27FC236}">
-                <a16:creationId xmlns:a16="http://schemas.microsoft.com/office/drawing/2014/main" id="{F8C21733-8153-414F-9C54-205FB67FAED5}"/>
+                <a16:creationId xmlns:a16="http://schemas.microsoft.com/office/drawing/2014/main" id="{44EB3EBE-D4EF-44BD-9EC3-5A18D08BD8B5}"/>
               </a:ext>
             </a:extLst>
           </p:cNvPr>
@@ -11335,7 +11335,7 @@
           <p:cNvPr id="21" name="">
             <a:extLst xmlns:a="http://schemas.openxmlformats.org/drawingml/2006/main">
               <a:ext uri="{FF2B5EF4-FFF2-40B4-BE49-F238E27FC236}">
-                <a16:creationId xmlns:a16="http://schemas.microsoft.com/office/drawing/2014/main" id="{09E752D5-F73B-4C3C-B8F3-3672F622B3E8}"/>
+                <a16:creationId xmlns:a16="http://schemas.microsoft.com/office/drawing/2014/main" id="{842D9DD0-BE08-4F22-835A-27F074E368E6}"/>
               </a:ext>
             </a:extLst>
           </p:cNvPr>
@@ -11399,7 +11399,7 @@
           <p:cNvPr id="22" name="">
             <a:extLst xmlns:a="http://schemas.openxmlformats.org/drawingml/2006/main">
               <a:ext uri="{FF2B5EF4-FFF2-40B4-BE49-F238E27FC236}">
-                <a16:creationId xmlns:a16="http://schemas.microsoft.com/office/drawing/2014/main" id="{7C4FAF5B-944F-486A-BA34-8E6A9FFE1A3B}"/>
+                <a16:creationId xmlns:a16="http://schemas.microsoft.com/office/drawing/2014/main" id="{37EA7315-A351-45C9-B76C-669BBEFC79FA}"/>
               </a:ext>
             </a:extLst>
           </p:cNvPr>
@@ -11432,7 +11432,7 @@
           <p:cNvPr id="23" name="">
             <a:extLst xmlns:a="http://schemas.openxmlformats.org/drawingml/2006/main">
               <a:ext uri="{FF2B5EF4-FFF2-40B4-BE49-F238E27FC236}">
-                <a16:creationId xmlns:a16="http://schemas.microsoft.com/office/drawing/2014/main" id="{2F2525F2-722C-4EA0-857E-77C7A7DFD12F}"/>
+                <a16:creationId xmlns:a16="http://schemas.microsoft.com/office/drawing/2014/main" id="{F21D6D76-6C3B-4526-8FEB-C945A7D42EED}"/>
               </a:ext>
             </a:extLst>
           </p:cNvPr>
@@ -11496,7 +11496,7 @@
           <p:cNvPr id="24" name="">
             <a:extLst xmlns:a="http://schemas.openxmlformats.org/drawingml/2006/main">
               <a:ext uri="{FF2B5EF4-FFF2-40B4-BE49-F238E27FC236}">
-                <a16:creationId xmlns:a16="http://schemas.microsoft.com/office/drawing/2014/main" id="{730F8A8B-0622-4758-825C-D2BC4F42A6D7}"/>
+                <a16:creationId xmlns:a16="http://schemas.microsoft.com/office/drawing/2014/main" id="{A0901990-6D25-4413-80DB-DBDE57C1D3C7}"/>
               </a:ext>
             </a:extLst>
           </p:cNvPr>
@@ -11550,7 +11550,7 @@
                 <a:ea typeface="Aptos"/>
                 <a:cs typeface="Aptos"/>
               </a:rPr>
-              <a:t>Two-board bidirectional radio, local Gemma 4 E2B, offline rules, verifier gating, and producer approval.</a:t>
+              <a:t>Two-board bidirectional radio, public CPU and local Metal Gemma 4 E2B, offline rules, verifier gating, and producer approval.</a:t>
             </a:r>
           </a:p>
         </p:txBody>
@@ -11560,7 +11560,7 @@
           <p:cNvPr id="25" name="">
             <a:extLst xmlns:a="http://schemas.openxmlformats.org/drawingml/2006/main">
               <a:ext uri="{FF2B5EF4-FFF2-40B4-BE49-F238E27FC236}">
-                <a16:creationId xmlns:a16="http://schemas.microsoft.com/office/drawing/2014/main" id="{71DC55DC-81C3-48CB-A1BA-36E592C7E748}"/>
+                <a16:creationId xmlns:a16="http://schemas.microsoft.com/office/drawing/2014/main" id="{9247DD85-D655-40DF-80EA-33E59E33AD73}"/>
               </a:ext>
             </a:extLst>
           </p:cNvPr>
@@ -11593,7 +11593,7 @@
           <p:cNvPr id="26" name="">
             <a:extLst xmlns:a="http://schemas.openxmlformats.org/drawingml/2006/main">
               <a:ext uri="{FF2B5EF4-FFF2-40B4-BE49-F238E27FC236}">
-                <a16:creationId xmlns:a16="http://schemas.microsoft.com/office/drawing/2014/main" id="{91D808C1-8F0D-432D-8340-7B6C71FB839B}"/>
+                <a16:creationId xmlns:a16="http://schemas.microsoft.com/office/drawing/2014/main" id="{759B1218-999E-4507-9EE5-F4FAB83CE3BE}"/>
               </a:ext>
             </a:extLst>
           </p:cNvPr>
@@ -11657,7 +11657,7 @@
           <p:cNvPr id="27" name="">
             <a:extLst xmlns:a="http://schemas.openxmlformats.org/drawingml/2006/main">
               <a:ext uri="{FF2B5EF4-FFF2-40B4-BE49-F238E27FC236}">
-                <a16:creationId xmlns:a16="http://schemas.microsoft.com/office/drawing/2014/main" id="{1FC3A77A-49FE-4669-A190-3FACCECB3D71}"/>
+                <a16:creationId xmlns:a16="http://schemas.microsoft.com/office/drawing/2014/main" id="{91AD836C-8A0F-4579-B705-83F9FCD01AE5}"/>
               </a:ext>
             </a:extLst>
           </p:cNvPr>
@@ -11721,7 +11721,7 @@
           <p:cNvPr id="28" name="">
             <a:extLst xmlns:a="http://schemas.openxmlformats.org/drawingml/2006/main">
               <a:ext uri="{FF2B5EF4-FFF2-40B4-BE49-F238E27FC236}">
-                <a16:creationId xmlns:a16="http://schemas.microsoft.com/office/drawing/2014/main" id="{5139B53F-430D-4C0A-8396-9F706C0C7173}"/>
+                <a16:creationId xmlns:a16="http://schemas.microsoft.com/office/drawing/2014/main" id="{FA218EB1-F3AD-4260-A995-90A698E95B54}"/>
               </a:ext>
             </a:extLst>
           </p:cNvPr>
@@ -11785,7 +11785,7 @@
           <p:cNvPr id="29" name="">
             <a:extLst xmlns:a="http://schemas.openxmlformats.org/drawingml/2006/main">
               <a:ext uri="{FF2B5EF4-FFF2-40B4-BE49-F238E27FC236}">
-                <a16:creationId xmlns:a16="http://schemas.microsoft.com/office/drawing/2014/main" id="{9FE89C0E-58B5-4284-8191-5F7691CE6E1D}"/>
+                <a16:creationId xmlns:a16="http://schemas.microsoft.com/office/drawing/2014/main" id="{0095D189-FCF8-4C8F-8AFE-CCEB51FA2BB5}"/>
               </a:ext>
             </a:extLst>
           </p:cNvPr>
@@ -11847,7 +11847,7 @@
     </p:spTree>
     <p:extLst>
       <p:ext uri="{BB962C8B-B14F-4D97-AF65-F5344CB8AC3E}">
-        <p14:creationId xmlns:p14="http://schemas.microsoft.com/office/powerpoint/2010/main" val="1485142984"/>
+        <p14:creationId xmlns:p14="http://schemas.microsoft.com/office/powerpoint/2010/main" val="891938619"/>
       </p:ext>
     </p:extLst>
   </p:cSld>
@@ -11871,7 +11871,7 @@
           <p:cNvPr id="1" name="">
             <a:extLst xmlns:a="http://schemas.openxmlformats.org/drawingml/2006/main">
               <a:ext uri="{FF2B5EF4-FFF2-40B4-BE49-F238E27FC236}">
-                <a16:creationId xmlns:a16="http://schemas.microsoft.com/office/drawing/2014/main" id="{4A9B8290-B600-4BF7-AA5E-14E01FD0EE12}"/>
+                <a16:creationId xmlns:a16="http://schemas.microsoft.com/office/drawing/2014/main" id="{940DF86A-CE14-4DE6-A68F-D472D1398126}"/>
               </a:ext>
             </a:extLst>
           </p:cNvPr>
@@ -11906,7 +11906,7 @@
           <p:cNvPr id="2" name="">
             <a:extLst xmlns:a="http://schemas.openxmlformats.org/drawingml/2006/main">
               <a:ext uri="{FF2B5EF4-FFF2-40B4-BE49-F238E27FC236}">
-                <a16:creationId xmlns:a16="http://schemas.microsoft.com/office/drawing/2014/main" id="{BC7B33CD-ACE9-413E-B52F-55B431563051}"/>
+                <a16:creationId xmlns:a16="http://schemas.microsoft.com/office/drawing/2014/main" id="{A6422DC6-4CEC-4A59-BD59-200281E84D4D}"/>
               </a:ext>
             </a:extLst>
           </p:cNvPr>
@@ -11941,7 +11941,7 @@
           <p:cNvPr id="3" name="">
             <a:extLst xmlns:a="http://schemas.openxmlformats.org/drawingml/2006/main">
               <a:ext uri="{FF2B5EF4-FFF2-40B4-BE49-F238E27FC236}">
-                <a16:creationId xmlns:a16="http://schemas.microsoft.com/office/drawing/2014/main" id="{44C52C37-5F80-430D-93C1-567879729D0D}"/>
+                <a16:creationId xmlns:a16="http://schemas.microsoft.com/office/drawing/2014/main" id="{60EB89F9-B49E-4CC4-AC8E-438EDF32243B}"/>
               </a:ext>
             </a:extLst>
           </p:cNvPr>
@@ -12005,7 +12005,7 @@
           <p:cNvPr id="4" name="">
             <a:extLst xmlns:a="http://schemas.openxmlformats.org/drawingml/2006/main">
               <a:ext uri="{FF2B5EF4-FFF2-40B4-BE49-F238E27FC236}">
-                <a16:creationId xmlns:a16="http://schemas.microsoft.com/office/drawing/2014/main" id="{CA38FB3A-F2DA-4812-8F2E-F26D807158CC}"/>
+                <a16:creationId xmlns:a16="http://schemas.microsoft.com/office/drawing/2014/main" id="{8FF6663A-BCEC-4D85-A3DE-9F93CA00789E}"/>
               </a:ext>
             </a:extLst>
           </p:cNvPr>
@@ -12069,7 +12069,7 @@
           <p:cNvPr id="5" name="">
             <a:extLst xmlns:a="http://schemas.openxmlformats.org/drawingml/2006/main">
               <a:ext uri="{FF2B5EF4-FFF2-40B4-BE49-F238E27FC236}">
-                <a16:creationId xmlns:a16="http://schemas.microsoft.com/office/drawing/2014/main" id="{864365ED-FFD1-4F3C-AD5A-5BAA5CAFC0AA}"/>
+                <a16:creationId xmlns:a16="http://schemas.microsoft.com/office/drawing/2014/main" id="{6DE89C70-8446-4FBC-9E32-A8878B463EB7}"/>
               </a:ext>
             </a:extLst>
           </p:cNvPr>
@@ -12133,7 +12133,7 @@
           <p:cNvPr id="6" name="">
             <a:extLst xmlns:a="http://schemas.openxmlformats.org/drawingml/2006/main">
               <a:ext uri="{FF2B5EF4-FFF2-40B4-BE49-F238E27FC236}">
-                <a16:creationId xmlns:a16="http://schemas.microsoft.com/office/drawing/2014/main" id="{9B705C80-2594-4998-9959-865348DD11F1}"/>
+                <a16:creationId xmlns:a16="http://schemas.microsoft.com/office/drawing/2014/main" id="{F6B1FFA4-CDA9-472E-94CF-D2A72CC37629}"/>
               </a:ext>
             </a:extLst>
           </p:cNvPr>
@@ -12197,7 +12197,7 @@
           <p:cNvPr id="7" name="">
             <a:extLst xmlns:a="http://schemas.openxmlformats.org/drawingml/2006/main">
               <a:ext uri="{FF2B5EF4-FFF2-40B4-BE49-F238E27FC236}">
-                <a16:creationId xmlns:a16="http://schemas.microsoft.com/office/drawing/2014/main" id="{7BB43688-4BD3-4A87-B511-15514FF089D6}"/>
+                <a16:creationId xmlns:a16="http://schemas.microsoft.com/office/drawing/2014/main" id="{14B832FF-3B1E-4A70-96D3-0DF9D3FE3BE8}"/>
               </a:ext>
             </a:extLst>
           </p:cNvPr>
@@ -12230,7 +12230,7 @@
           <p:cNvPr id="8" name="">
             <a:extLst xmlns:a="http://schemas.openxmlformats.org/drawingml/2006/main">
               <a:ext uri="{FF2B5EF4-FFF2-40B4-BE49-F238E27FC236}">
-                <a16:creationId xmlns:a16="http://schemas.microsoft.com/office/drawing/2014/main" id="{8346492E-8C55-41F7-A6C7-520CA69DB8AA}"/>
+                <a16:creationId xmlns:a16="http://schemas.microsoft.com/office/drawing/2014/main" id="{EAAE528A-9922-4085-86BE-4AB108ACCF3A}"/>
               </a:ext>
             </a:extLst>
           </p:cNvPr>
@@ -12294,7 +12294,7 @@
           <p:cNvPr id="9" name="">
             <a:extLst xmlns:a="http://schemas.openxmlformats.org/drawingml/2006/main">
               <a:ext uri="{FF2B5EF4-FFF2-40B4-BE49-F238E27FC236}">
-                <a16:creationId xmlns:a16="http://schemas.microsoft.com/office/drawing/2014/main" id="{E455B86F-2E0E-4C8E-9CC8-B0C03277762B}"/>
+                <a16:creationId xmlns:a16="http://schemas.microsoft.com/office/drawing/2014/main" id="{6D2C75CD-040E-480A-8951-BE2DBB4AF257}"/>
               </a:ext>
             </a:extLst>
           </p:cNvPr>
@@ -12358,7 +12358,7 @@
           <p:cNvPr id="10" name="">
             <a:extLst xmlns:a="http://schemas.openxmlformats.org/drawingml/2006/main">
               <a:ext uri="{FF2B5EF4-FFF2-40B4-BE49-F238E27FC236}">
-                <a16:creationId xmlns:a16="http://schemas.microsoft.com/office/drawing/2014/main" id="{85254383-6ED9-4E44-82AF-C66661DAC712}"/>
+                <a16:creationId xmlns:a16="http://schemas.microsoft.com/office/drawing/2014/main" id="{EFE5CDA1-F96C-4EEF-891B-A4AF5C89C528}"/>
               </a:ext>
             </a:extLst>
           </p:cNvPr>
@@ -12391,7 +12391,7 @@
           <p:cNvPr id="11" name="">
             <a:extLst xmlns:a="http://schemas.openxmlformats.org/drawingml/2006/main">
               <a:ext uri="{FF2B5EF4-FFF2-40B4-BE49-F238E27FC236}">
-                <a16:creationId xmlns:a16="http://schemas.microsoft.com/office/drawing/2014/main" id="{93157F1E-1E26-455D-88AA-A8F4A6949CD8}"/>
+                <a16:creationId xmlns:a16="http://schemas.microsoft.com/office/drawing/2014/main" id="{1CD48FA1-3220-400D-AB57-28EE7D21C62E}"/>
               </a:ext>
             </a:extLst>
           </p:cNvPr>
@@ -12455,7 +12455,7 @@
           <p:cNvPr id="12" name="">
             <a:extLst xmlns:a="http://schemas.openxmlformats.org/drawingml/2006/main">
               <a:ext uri="{FF2B5EF4-FFF2-40B4-BE49-F238E27FC236}">
-                <a16:creationId xmlns:a16="http://schemas.microsoft.com/office/drawing/2014/main" id="{CAB2A93D-A2A9-4E39-A355-50B41B74B888}"/>
+                <a16:creationId xmlns:a16="http://schemas.microsoft.com/office/drawing/2014/main" id="{16221AFB-E197-46E9-8E28-6ED9C490CB6B}"/>
               </a:ext>
             </a:extLst>
           </p:cNvPr>
@@ -12519,7 +12519,7 @@
           <p:cNvPr id="13" name="">
             <a:extLst xmlns:a="http://schemas.openxmlformats.org/drawingml/2006/main">
               <a:ext uri="{FF2B5EF4-FFF2-40B4-BE49-F238E27FC236}">
-                <a16:creationId xmlns:a16="http://schemas.microsoft.com/office/drawing/2014/main" id="{7161EC57-D498-4C7C-B784-D8E7461F96A9}"/>
+                <a16:creationId xmlns:a16="http://schemas.microsoft.com/office/drawing/2014/main" id="{8DFA732B-237C-41F0-A8BF-76D59B7A48A3}"/>
               </a:ext>
             </a:extLst>
           </p:cNvPr>
@@ -12552,7 +12552,7 @@
           <p:cNvPr id="14" name="">
             <a:extLst xmlns:a="http://schemas.openxmlformats.org/drawingml/2006/main">
               <a:ext uri="{FF2B5EF4-FFF2-40B4-BE49-F238E27FC236}">
-                <a16:creationId xmlns:a16="http://schemas.microsoft.com/office/drawing/2014/main" id="{FE4B3869-C598-4628-83DE-ED902FC47DC3}"/>
+                <a16:creationId xmlns:a16="http://schemas.microsoft.com/office/drawing/2014/main" id="{2EC3BC35-D834-4EAD-ADBC-7900F2C084AB}"/>
               </a:ext>
             </a:extLst>
           </p:cNvPr>
@@ -12616,7 +12616,7 @@
           <p:cNvPr id="15" name="">
             <a:extLst xmlns:a="http://schemas.openxmlformats.org/drawingml/2006/main">
               <a:ext uri="{FF2B5EF4-FFF2-40B4-BE49-F238E27FC236}">
-                <a16:creationId xmlns:a16="http://schemas.microsoft.com/office/drawing/2014/main" id="{6DE9B221-19D4-4831-A16B-1CB2DDAFA9B8}"/>
+                <a16:creationId xmlns:a16="http://schemas.microsoft.com/office/drawing/2014/main" id="{56374312-F89E-446C-B897-559BA3851CAA}"/>
               </a:ext>
             </a:extLst>
           </p:cNvPr>
@@ -12680,7 +12680,7 @@
           <p:cNvPr id="16" name="">
             <a:extLst xmlns:a="http://schemas.openxmlformats.org/drawingml/2006/main">
               <a:ext uri="{FF2B5EF4-FFF2-40B4-BE49-F238E27FC236}">
-                <a16:creationId xmlns:a16="http://schemas.microsoft.com/office/drawing/2014/main" id="{C6C73D8A-E378-4732-BFEA-5EDBD1B65A78}"/>
+                <a16:creationId xmlns:a16="http://schemas.microsoft.com/office/drawing/2014/main" id="{9EBD78B0-C7F9-4DC2-AF8E-2FBBA5C9371D}"/>
               </a:ext>
             </a:extLst>
           </p:cNvPr>
@@ -12744,7 +12744,7 @@
           <p:cNvPr id="17" name="">
             <a:extLst xmlns:a="http://schemas.openxmlformats.org/drawingml/2006/main">
               <a:ext uri="{FF2B5EF4-FFF2-40B4-BE49-F238E27FC236}">
-                <a16:creationId xmlns:a16="http://schemas.microsoft.com/office/drawing/2014/main" id="{5DF2D14F-E3FC-4374-AE20-EBD91B578A3A}"/>
+                <a16:creationId xmlns:a16="http://schemas.microsoft.com/office/drawing/2014/main" id="{32EFFBD0-8110-4D18-9705-A66C54D8332E}"/>
               </a:ext>
             </a:extLst>
           </p:cNvPr>
@@ -12806,7 +12806,7 @@
     </p:spTree>
     <p:extLst>
       <p:ext uri="{BB962C8B-B14F-4D97-AF65-F5344CB8AC3E}">
-        <p14:creationId xmlns:p14="http://schemas.microsoft.com/office/powerpoint/2010/main" val="1691441250"/>
+        <p14:creationId xmlns:p14="http://schemas.microsoft.com/office/powerpoint/2010/main" val="20005188"/>
       </p:ext>
     </p:extLst>
   </p:cSld>
@@ -12830,7 +12830,7 @@
           <p:cNvPr id="1" name="">
             <a:extLst xmlns:a="http://schemas.openxmlformats.org/drawingml/2006/main">
               <a:ext uri="{FF2B5EF4-FFF2-40B4-BE49-F238E27FC236}">
-                <a16:creationId xmlns:a16="http://schemas.microsoft.com/office/drawing/2014/main" id="{E67103D3-721C-4BEF-9CDF-7CBF4D599BC0}"/>
+                <a16:creationId xmlns:a16="http://schemas.microsoft.com/office/drawing/2014/main" id="{C418A93C-14EC-4040-97A3-691707CA33F9}"/>
               </a:ext>
             </a:extLst>
           </p:cNvPr>
@@ -12865,7 +12865,7 @@
           <p:cNvPr id="2" name="">
             <a:extLst xmlns:a="http://schemas.openxmlformats.org/drawingml/2006/main">
               <a:ext uri="{FF2B5EF4-FFF2-40B4-BE49-F238E27FC236}">
-                <a16:creationId xmlns:a16="http://schemas.microsoft.com/office/drawing/2014/main" id="{8AD16A65-05FF-402B-9121-41EC9E0EBC78}"/>
+                <a16:creationId xmlns:a16="http://schemas.microsoft.com/office/drawing/2014/main" id="{A0A47ED9-77D0-4118-B9FD-D37FB10E63F6}"/>
               </a:ext>
             </a:extLst>
           </p:cNvPr>
@@ -12900,7 +12900,7 @@
           <p:cNvPr id="3" name="">
             <a:extLst xmlns:a="http://schemas.openxmlformats.org/drawingml/2006/main">
               <a:ext uri="{FF2B5EF4-FFF2-40B4-BE49-F238E27FC236}">
-                <a16:creationId xmlns:a16="http://schemas.microsoft.com/office/drawing/2014/main" id="{FE432829-B41D-4983-8B29-B02CE873CBCB}"/>
+                <a16:creationId xmlns:a16="http://schemas.microsoft.com/office/drawing/2014/main" id="{5712C359-8B6C-4DD2-B719-54025DEC19AA}"/>
               </a:ext>
             </a:extLst>
           </p:cNvPr>
@@ -12964,7 +12964,7 @@
           <p:cNvPr id="4" name="">
             <a:extLst xmlns:a="http://schemas.openxmlformats.org/drawingml/2006/main">
               <a:ext uri="{FF2B5EF4-FFF2-40B4-BE49-F238E27FC236}">
-                <a16:creationId xmlns:a16="http://schemas.microsoft.com/office/drawing/2014/main" id="{8A1DBB83-9FBE-4997-BD04-5678A2E13A96}"/>
+                <a16:creationId xmlns:a16="http://schemas.microsoft.com/office/drawing/2014/main" id="{34FA05F5-FA09-4742-B710-775A333990ED}"/>
               </a:ext>
             </a:extLst>
           </p:cNvPr>
@@ -13028,7 +13028,7 @@
           <p:cNvPr id="5" name="">
             <a:extLst xmlns:a="http://schemas.openxmlformats.org/drawingml/2006/main">
               <a:ext uri="{FF2B5EF4-FFF2-40B4-BE49-F238E27FC236}">
-                <a16:creationId xmlns:a16="http://schemas.microsoft.com/office/drawing/2014/main" id="{A28F0640-F00D-4D28-814A-5CFED7F1F447}"/>
+                <a16:creationId xmlns:a16="http://schemas.microsoft.com/office/drawing/2014/main" id="{3CCB330D-6FB3-4003-A758-3FD3EDEF0B3B}"/>
               </a:ext>
             </a:extLst>
           </p:cNvPr>
@@ -13092,7 +13092,7 @@
           <p:cNvPr id="6" name="">
             <a:extLst xmlns:a="http://schemas.openxmlformats.org/drawingml/2006/main">
               <a:ext uri="{FF2B5EF4-FFF2-40B4-BE49-F238E27FC236}">
-                <a16:creationId xmlns:a16="http://schemas.microsoft.com/office/drawing/2014/main" id="{61A5F509-81F1-4495-88E1-C8376E1DD289}"/>
+                <a16:creationId xmlns:a16="http://schemas.microsoft.com/office/drawing/2014/main" id="{E89FE201-9DBD-4E42-A0EF-C46FBCEFE5D2}"/>
               </a:ext>
             </a:extLst>
           </p:cNvPr>
@@ -13156,7 +13156,7 @@
           <p:cNvPr id="7" name="">
             <a:extLst xmlns:a="http://schemas.openxmlformats.org/drawingml/2006/main">
               <a:ext uri="{FF2B5EF4-FFF2-40B4-BE49-F238E27FC236}">
-                <a16:creationId xmlns:a16="http://schemas.microsoft.com/office/drawing/2014/main" id="{A611C06D-E9D2-459F-B597-FB88360499EF}"/>
+                <a16:creationId xmlns:a16="http://schemas.microsoft.com/office/drawing/2014/main" id="{0F808248-0583-4E6C-96D0-DD628CC4CFFA}"/>
               </a:ext>
             </a:extLst>
           </p:cNvPr>
@@ -13189,7 +13189,7 @@
           <p:cNvPr id="8" name="">
             <a:extLst xmlns:a="http://schemas.openxmlformats.org/drawingml/2006/main">
               <a:ext uri="{FF2B5EF4-FFF2-40B4-BE49-F238E27FC236}">
-                <a16:creationId xmlns:a16="http://schemas.microsoft.com/office/drawing/2014/main" id="{5DCCF79C-3B5E-417E-9ED8-7D9C54C31900}"/>
+                <a16:creationId xmlns:a16="http://schemas.microsoft.com/office/drawing/2014/main" id="{2671437F-652A-4EF7-80CB-0B34D889A994}"/>
               </a:ext>
             </a:extLst>
           </p:cNvPr>
@@ -13253,7 +13253,7 @@
           <p:cNvPr id="9" name="">
             <a:extLst xmlns:a="http://schemas.openxmlformats.org/drawingml/2006/main">
               <a:ext uri="{FF2B5EF4-FFF2-40B4-BE49-F238E27FC236}">
-                <a16:creationId xmlns:a16="http://schemas.microsoft.com/office/drawing/2014/main" id="{32FC8A71-01DA-48C0-9817-43BD81C6BDCD}"/>
+                <a16:creationId xmlns:a16="http://schemas.microsoft.com/office/drawing/2014/main" id="{A0A398F3-61C0-43B6-BA98-BE2F301365E5}"/>
               </a:ext>
             </a:extLst>
           </p:cNvPr>
@@ -13317,7 +13317,7 @@
           <p:cNvPr id="10" name="">
             <a:extLst xmlns:a="http://schemas.openxmlformats.org/drawingml/2006/main">
               <a:ext uri="{FF2B5EF4-FFF2-40B4-BE49-F238E27FC236}">
-                <a16:creationId xmlns:a16="http://schemas.microsoft.com/office/drawing/2014/main" id="{550E9844-713D-4269-B492-D13E52204892}"/>
+                <a16:creationId xmlns:a16="http://schemas.microsoft.com/office/drawing/2014/main" id="{9BCFC902-72BB-43FF-B1BC-47EDCB1E2C9B}"/>
               </a:ext>
             </a:extLst>
           </p:cNvPr>
@@ -13381,7 +13381,7 @@
           <p:cNvPr id="11" name="">
             <a:extLst xmlns:a="http://schemas.openxmlformats.org/drawingml/2006/main">
               <a:ext uri="{FF2B5EF4-FFF2-40B4-BE49-F238E27FC236}">
-                <a16:creationId xmlns:a16="http://schemas.microsoft.com/office/drawing/2014/main" id="{D33C84C6-506C-4EB6-9D97-B2FEF86C840D}"/>
+                <a16:creationId xmlns:a16="http://schemas.microsoft.com/office/drawing/2014/main" id="{9B61A33E-2602-4113-85D0-612757B74EEC}"/>
               </a:ext>
             </a:extLst>
           </p:cNvPr>
@@ -13414,7 +13414,7 @@
           <p:cNvPr id="12" name="">
             <a:extLst xmlns:a="http://schemas.openxmlformats.org/drawingml/2006/main">
               <a:ext uri="{FF2B5EF4-FFF2-40B4-BE49-F238E27FC236}">
-                <a16:creationId xmlns:a16="http://schemas.microsoft.com/office/drawing/2014/main" id="{1C4B5C23-41C3-4938-8B12-4C9C1EB77070}"/>
+                <a16:creationId xmlns:a16="http://schemas.microsoft.com/office/drawing/2014/main" id="{36C90C54-DC46-4B1B-A6B1-469E1405C698}"/>
               </a:ext>
             </a:extLst>
           </p:cNvPr>
@@ -13478,7 +13478,7 @@
           <p:cNvPr id="13" name="">
             <a:extLst xmlns:a="http://schemas.openxmlformats.org/drawingml/2006/main">
               <a:ext uri="{FF2B5EF4-FFF2-40B4-BE49-F238E27FC236}">
-                <a16:creationId xmlns:a16="http://schemas.microsoft.com/office/drawing/2014/main" id="{B97198E3-5FE8-433F-9104-E1A672819807}"/>
+                <a16:creationId xmlns:a16="http://schemas.microsoft.com/office/drawing/2014/main" id="{A31AB908-C1DA-4B30-9A1A-7C876AAA54DB}"/>
               </a:ext>
             </a:extLst>
           </p:cNvPr>
@@ -13542,7 +13542,7 @@
           <p:cNvPr id="14" name="">
             <a:extLst xmlns:a="http://schemas.openxmlformats.org/drawingml/2006/main">
               <a:ext uri="{FF2B5EF4-FFF2-40B4-BE49-F238E27FC236}">
-                <a16:creationId xmlns:a16="http://schemas.microsoft.com/office/drawing/2014/main" id="{E7C097BC-C85F-403C-9B35-2D8D7E147195}"/>
+                <a16:creationId xmlns:a16="http://schemas.microsoft.com/office/drawing/2014/main" id="{68E08836-D39D-465A-8623-94BE9CE683ED}"/>
               </a:ext>
             </a:extLst>
           </p:cNvPr>
@@ -13606,7 +13606,7 @@
           <p:cNvPr id="15" name="">
             <a:extLst xmlns:a="http://schemas.openxmlformats.org/drawingml/2006/main">
               <a:ext uri="{FF2B5EF4-FFF2-40B4-BE49-F238E27FC236}">
-                <a16:creationId xmlns:a16="http://schemas.microsoft.com/office/drawing/2014/main" id="{AA754287-7B5E-4857-AE41-3B572F6420CC}"/>
+                <a16:creationId xmlns:a16="http://schemas.microsoft.com/office/drawing/2014/main" id="{88837B35-218D-450A-A8AA-35105836D9BE}"/>
               </a:ext>
             </a:extLst>
           </p:cNvPr>
@@ -13639,7 +13639,7 @@
           <p:cNvPr id="16" name="">
             <a:extLst xmlns:a="http://schemas.openxmlformats.org/drawingml/2006/main">
               <a:ext uri="{FF2B5EF4-FFF2-40B4-BE49-F238E27FC236}">
-                <a16:creationId xmlns:a16="http://schemas.microsoft.com/office/drawing/2014/main" id="{95F47A42-9A8A-4D36-A126-5453541701DB}"/>
+                <a16:creationId xmlns:a16="http://schemas.microsoft.com/office/drawing/2014/main" id="{2AA98B97-BC75-4766-9210-D4D7AAD54FBC}"/>
               </a:ext>
             </a:extLst>
           </p:cNvPr>
@@ -13703,7 +13703,7 @@
           <p:cNvPr id="17" name="">
             <a:extLst xmlns:a="http://schemas.openxmlformats.org/drawingml/2006/main">
               <a:ext uri="{FF2B5EF4-FFF2-40B4-BE49-F238E27FC236}">
-                <a16:creationId xmlns:a16="http://schemas.microsoft.com/office/drawing/2014/main" id="{7DC28E0F-9853-46AE-B8DC-2DD534190AB6}"/>
+                <a16:creationId xmlns:a16="http://schemas.microsoft.com/office/drawing/2014/main" id="{C6E33878-00D1-49D5-9B4B-EA175A660D74}"/>
               </a:ext>
             </a:extLst>
           </p:cNvPr>
@@ -13757,7 +13757,7 @@
                 <a:ea typeface="Aptos"/>
                 <a:cs typeface="Aptos"/>
               </a:rPr>
-              <a:t>Gemma 4 E2B runs locally through llama.cpp + Metal. nRF9151 transports data; it does not run Gemma.</a:t>
+              <a:t>Gemma 4 E2B runs through llama.cpp on the public 8 GB CPU host, with separate local Metal proof. nRF9151 transports data; it does not run Gemma.</a:t>
             </a:r>
           </a:p>
         </p:txBody>
@@ -13767,7 +13767,7 @@
           <p:cNvPr id="18" name="">
             <a:extLst xmlns:a="http://schemas.openxmlformats.org/drawingml/2006/main">
               <a:ext uri="{FF2B5EF4-FFF2-40B4-BE49-F238E27FC236}">
-                <a16:creationId xmlns:a16="http://schemas.microsoft.com/office/drawing/2014/main" id="{4C2ED0C4-DE8C-4320-91D7-736DF7D1C497}"/>
+                <a16:creationId xmlns:a16="http://schemas.microsoft.com/office/drawing/2014/main" id="{F05EFEE5-B219-4413-B649-32A5D85C70CF}"/>
               </a:ext>
             </a:extLst>
           </p:cNvPr>
@@ -13800,7 +13800,7 @@
           <p:cNvPr id="19" name="">
             <a:extLst xmlns:a="http://schemas.openxmlformats.org/drawingml/2006/main">
               <a:ext uri="{FF2B5EF4-FFF2-40B4-BE49-F238E27FC236}">
-                <a16:creationId xmlns:a16="http://schemas.microsoft.com/office/drawing/2014/main" id="{0F62E1B3-A29A-4010-B3E9-330DB03A24FC}"/>
+                <a16:creationId xmlns:a16="http://schemas.microsoft.com/office/drawing/2014/main" id="{E4B8505F-2081-4695-9246-AFC85FA05A6A}"/>
               </a:ext>
             </a:extLst>
           </p:cNvPr>
@@ -13864,7 +13864,7 @@
           <p:cNvPr id="20" name="">
             <a:extLst xmlns:a="http://schemas.openxmlformats.org/drawingml/2006/main">
               <a:ext uri="{FF2B5EF4-FFF2-40B4-BE49-F238E27FC236}">
-                <a16:creationId xmlns:a16="http://schemas.microsoft.com/office/drawing/2014/main" id="{EE0D57D7-174F-4812-B62B-F3342ECE891C}"/>
+                <a16:creationId xmlns:a16="http://schemas.microsoft.com/office/drawing/2014/main" id="{F5C3C1FD-7489-4EFB-8B35-E28AA49596E1}"/>
               </a:ext>
             </a:extLst>
           </p:cNvPr>
@@ -13928,7 +13928,7 @@
           <p:cNvPr id="21" name="">
             <a:extLst xmlns:a="http://schemas.openxmlformats.org/drawingml/2006/main">
               <a:ext uri="{FF2B5EF4-FFF2-40B4-BE49-F238E27FC236}">
-                <a16:creationId xmlns:a16="http://schemas.microsoft.com/office/drawing/2014/main" id="{B89FC34C-5F9F-4C9F-9C66-722560D61BF1}"/>
+                <a16:creationId xmlns:a16="http://schemas.microsoft.com/office/drawing/2014/main" id="{4C0E4665-6D90-4B41-A944-30CD9803AA3E}"/>
               </a:ext>
             </a:extLst>
           </p:cNvPr>
@@ -13992,7 +13992,7 @@
           <p:cNvPr id="22" name="">
             <a:extLst xmlns:a="http://schemas.openxmlformats.org/drawingml/2006/main">
               <a:ext uri="{FF2B5EF4-FFF2-40B4-BE49-F238E27FC236}">
-                <a16:creationId xmlns:a16="http://schemas.microsoft.com/office/drawing/2014/main" id="{70F9B68F-B688-42C6-87E6-512B5A524B3E}"/>
+                <a16:creationId xmlns:a16="http://schemas.microsoft.com/office/drawing/2014/main" id="{B07BBF0B-6364-4D48-AFC5-7BAEE73CC682}"/>
               </a:ext>
             </a:extLst>
           </p:cNvPr>
@@ -14054,7 +14054,7 @@
     </p:spTree>
     <p:extLst>
       <p:ext uri="{BB962C8B-B14F-4D97-AF65-F5344CB8AC3E}">
-        <p14:creationId xmlns:p14="http://schemas.microsoft.com/office/powerpoint/2010/main" val="550959672"/>
+        <p14:creationId xmlns:p14="http://schemas.microsoft.com/office/powerpoint/2010/main" val="1930366349"/>
       </p:ext>
     </p:extLst>
   </p:cSld>

</xml_diff>

<commit_message>
Harden responsive tank evidence
</commit_message>
<xml_diff>
--- a/submission/proteinloop-hackathon-deck.pptx
+++ b/submission/proteinloop-hackathon-deck.pptx
@@ -2,22 +2,22 @@
 <file path=ppt/presentation.xml><?xml version="1.0" encoding="utf-8"?>
 <p:presentation xmlns:p="http://schemas.openxmlformats.org/presentationml/2006/main">
   <p:sldMasterIdLst>
-    <p:sldMasterId xmlns:r="http://schemas.openxmlformats.org/officeDocument/2006/relationships" id="2147483648" r:id="R25180a25a0254182"/>
+    <p:sldMasterId xmlns:r="http://schemas.openxmlformats.org/officeDocument/2006/relationships" id="2147483648" r:id="R27af26ace53e489b"/>
   </p:sldMasterIdLst>
   <p:notesMasterIdLst>
-    <p:notesMasterId xmlns:r="http://schemas.openxmlformats.org/officeDocument/2006/relationships" r:id="R359d04efe3db495f"/>
+    <p:notesMasterId xmlns:r="http://schemas.openxmlformats.org/officeDocument/2006/relationships" r:id="Rf9aeabcb19ec4dc7"/>
   </p:notesMasterIdLst>
   <p:sldIdLst>
-    <p:sldId xmlns:r="http://schemas.openxmlformats.org/officeDocument/2006/relationships" id="256" r:id="R3ccb1e1f880f4ac4"/>
-    <p:sldId xmlns:r="http://schemas.openxmlformats.org/officeDocument/2006/relationships" id="257" r:id="Rc07cd7dd823746b3"/>
-    <p:sldId xmlns:r="http://schemas.openxmlformats.org/officeDocument/2006/relationships" id="258" r:id="R0b56b6b828354bd4"/>
-    <p:sldId xmlns:r="http://schemas.openxmlformats.org/officeDocument/2006/relationships" id="259" r:id="R7704afadc47c4e0e"/>
-    <p:sldId xmlns:r="http://schemas.openxmlformats.org/officeDocument/2006/relationships" id="260" r:id="Rbe4ff6ac03774252"/>
-    <p:sldId xmlns:r="http://schemas.openxmlformats.org/officeDocument/2006/relationships" id="261" r:id="Rb5cfc58b22f14b3d"/>
-    <p:sldId xmlns:r="http://schemas.openxmlformats.org/officeDocument/2006/relationships" id="262" r:id="R135dbded9a2441f9"/>
-    <p:sldId xmlns:r="http://schemas.openxmlformats.org/officeDocument/2006/relationships" id="263" r:id="R0c8cba3972004f2c"/>
-    <p:sldId xmlns:r="http://schemas.openxmlformats.org/officeDocument/2006/relationships" id="264" r:id="R72b1da93f19e4692"/>
-    <p:sldId xmlns:r="http://schemas.openxmlformats.org/officeDocument/2006/relationships" id="265" r:id="R4fa91ff68ed94976"/>
+    <p:sldId xmlns:r="http://schemas.openxmlformats.org/officeDocument/2006/relationships" id="256" r:id="Rb7d77e09965d4068"/>
+    <p:sldId xmlns:r="http://schemas.openxmlformats.org/officeDocument/2006/relationships" id="257" r:id="R99e6dd9242154b63"/>
+    <p:sldId xmlns:r="http://schemas.openxmlformats.org/officeDocument/2006/relationships" id="258" r:id="R46f05fc96aa34a58"/>
+    <p:sldId xmlns:r="http://schemas.openxmlformats.org/officeDocument/2006/relationships" id="259" r:id="R02e2edf84f2c4f56"/>
+    <p:sldId xmlns:r="http://schemas.openxmlformats.org/officeDocument/2006/relationships" id="260" r:id="R8befc32ff2484760"/>
+    <p:sldId xmlns:r="http://schemas.openxmlformats.org/officeDocument/2006/relationships" id="261" r:id="R5f48dead392e42e5"/>
+    <p:sldId xmlns:r="http://schemas.openxmlformats.org/officeDocument/2006/relationships" id="262" r:id="R48d0fc19aca94e95"/>
+    <p:sldId xmlns:r="http://schemas.openxmlformats.org/officeDocument/2006/relationships" id="263" r:id="Rfdb7a691c5c84eb6"/>
+    <p:sldId xmlns:r="http://schemas.openxmlformats.org/officeDocument/2006/relationships" id="264" r:id="R82b87dbe32084ace"/>
+    <p:sldId xmlns:r="http://schemas.openxmlformats.org/officeDocument/2006/relationships" id="265" r:id="R69a99ead9b624bd5"/>
   </p:sldIdLst>
   <p:sldSz cx="12192000" cy="6858000"/>
   <p:notesSz cx="6858000" cy="9144000"/>
@@ -1158,7 +1158,7 @@
   </p:cSld>
   <p:clrMap bg1="lt1" tx1="dk1" bg2="lt2" tx2="dk2" accent1="accent1" accent2="accent2" accent3="accent3" accent4="accent4" accent5="accent5" accent6="accent6" hlink="hlink" folHlink="folHlink"/>
   <p:sldLayoutIdLst>
-    <p:sldLayoutId xmlns:r="http://schemas.openxmlformats.org/officeDocument/2006/relationships" id="2147483649" r:id="R6f0eff399d764e50"/>
+    <p:sldLayoutId xmlns:r="http://schemas.openxmlformats.org/officeDocument/2006/relationships" id="2147483649" r:id="R362c26f3c89a47bd"/>
   </p:sldLayoutIdLst>
   <p:txStyles>
     <p:titleStyle>
@@ -1461,7 +1461,7 @@
           <p:nvPr/>
         </p:nvPicPr>
         <p:blipFill>
-          <a:blip xmlns:r="http://schemas.openxmlformats.org/officeDocument/2006/relationships" xmlns:a="http://schemas.openxmlformats.org/drawingml/2006/main" r:embed="R87144997902543c6"/>
+          <a:blip xmlns:r="http://schemas.openxmlformats.org/officeDocument/2006/relationships" xmlns:a="http://schemas.openxmlformats.org/drawingml/2006/main" r:embed="Ra7cb2b8f63a749bc"/>
           <a:srcRect xmlns:a="http://schemas.openxmlformats.org/drawingml/2006/main" l="0" t="0" r="0" b="0"/>
           <a:stretch xmlns:a="http://schemas.openxmlformats.org/drawingml/2006/main">
             <a:fillRect l="0" t="0" r="0" b="0"/>
@@ -1480,7 +1480,7 @@
     </p:spTree>
     <p:extLst>
       <p:ext uri="{BB962C8B-B14F-4D97-AF65-F5344CB8AC3E}">
-        <p14:creationId xmlns:p14="http://schemas.microsoft.com/office/powerpoint/2010/main" val="125175983"/>
+        <p14:creationId xmlns:p14="http://schemas.microsoft.com/office/powerpoint/2010/main" val="8689119"/>
       </p:ext>
     </p:extLst>
   </p:cSld>
@@ -1504,7 +1504,7 @@
           <p:cNvPr id="1" name="">
             <a:extLst xmlns:a="http://schemas.openxmlformats.org/drawingml/2006/main">
               <a:ext uri="{FF2B5EF4-FFF2-40B4-BE49-F238E27FC236}">
-                <a16:creationId xmlns:a16="http://schemas.microsoft.com/office/drawing/2014/main" id="{1017A17B-4A8D-41BF-A541-ECA17889FA8A}"/>
+                <a16:creationId xmlns:a16="http://schemas.microsoft.com/office/drawing/2014/main" id="{D6E7FA5D-FA71-4D5C-B66B-1B308898AE9B}"/>
               </a:ext>
             </a:extLst>
           </p:cNvPr>
@@ -1539,7 +1539,7 @@
           <p:cNvPr id="2" name="">
             <a:extLst xmlns:a="http://schemas.openxmlformats.org/drawingml/2006/main">
               <a:ext uri="{FF2B5EF4-FFF2-40B4-BE49-F238E27FC236}">
-                <a16:creationId xmlns:a16="http://schemas.microsoft.com/office/drawing/2014/main" id="{249A4C98-204C-4F04-8C12-006EB29D5206}"/>
+                <a16:creationId xmlns:a16="http://schemas.microsoft.com/office/drawing/2014/main" id="{B39989DB-D835-454A-BFE0-C24EF8AEA62F}"/>
               </a:ext>
             </a:extLst>
           </p:cNvPr>
@@ -1574,7 +1574,7 @@
           <p:cNvPr id="3" name="">
             <a:extLst xmlns:a="http://schemas.openxmlformats.org/drawingml/2006/main">
               <a:ext uri="{FF2B5EF4-FFF2-40B4-BE49-F238E27FC236}">
-                <a16:creationId xmlns:a16="http://schemas.microsoft.com/office/drawing/2014/main" id="{B84D00E2-713F-48F8-B647-7FAEF2026DD7}"/>
+                <a16:creationId xmlns:a16="http://schemas.microsoft.com/office/drawing/2014/main" id="{F7DA41B0-589B-441F-B0E4-8F68CA73B595}"/>
               </a:ext>
             </a:extLst>
           </p:cNvPr>
@@ -1638,7 +1638,7 @@
           <p:cNvPr id="4" name="">
             <a:extLst xmlns:a="http://schemas.openxmlformats.org/drawingml/2006/main">
               <a:ext uri="{FF2B5EF4-FFF2-40B4-BE49-F238E27FC236}">
-                <a16:creationId xmlns:a16="http://schemas.microsoft.com/office/drawing/2014/main" id="{B19C924A-87FC-434A-8188-48C9D5DCA4C9}"/>
+                <a16:creationId xmlns:a16="http://schemas.microsoft.com/office/drawing/2014/main" id="{8D7C40A9-AF9E-4AB6-A293-EB6AEBAD0511}"/>
               </a:ext>
             </a:extLst>
           </p:cNvPr>
@@ -1702,7 +1702,7 @@
           <p:cNvPr id="5" name="">
             <a:extLst xmlns:a="http://schemas.openxmlformats.org/drawingml/2006/main">
               <a:ext uri="{FF2B5EF4-FFF2-40B4-BE49-F238E27FC236}">
-                <a16:creationId xmlns:a16="http://schemas.microsoft.com/office/drawing/2014/main" id="{DD81BA60-88CF-4560-93FF-B25E5FBCA1B9}"/>
+                <a16:creationId xmlns:a16="http://schemas.microsoft.com/office/drawing/2014/main" id="{9AFEC3AD-0692-40A9-8E93-DA6DB7DEF926}"/>
               </a:ext>
             </a:extLst>
           </p:cNvPr>
@@ -1766,7 +1766,7 @@
           <p:cNvPr id="6" name="">
             <a:extLst xmlns:a="http://schemas.openxmlformats.org/drawingml/2006/main">
               <a:ext uri="{FF2B5EF4-FFF2-40B4-BE49-F238E27FC236}">
-                <a16:creationId xmlns:a16="http://schemas.microsoft.com/office/drawing/2014/main" id="{5BA941C4-35E2-4F95-B8F0-F1B607EE4FBB}"/>
+                <a16:creationId xmlns:a16="http://schemas.microsoft.com/office/drawing/2014/main" id="{09B3DE23-CA7C-471C-990D-A9CCF0609E13}"/>
               </a:ext>
             </a:extLst>
           </p:cNvPr>
@@ -1801,7 +1801,7 @@
           <p:cNvPr id="7" name="">
             <a:extLst xmlns:a="http://schemas.openxmlformats.org/drawingml/2006/main">
               <a:ext uri="{FF2B5EF4-FFF2-40B4-BE49-F238E27FC236}">
-                <a16:creationId xmlns:a16="http://schemas.microsoft.com/office/drawing/2014/main" id="{3A995C30-9D14-43E3-A453-8C932729B8A4}"/>
+                <a16:creationId xmlns:a16="http://schemas.microsoft.com/office/drawing/2014/main" id="{D24111E2-0A6B-4CA2-910B-8EF6869580A2}"/>
               </a:ext>
             </a:extLst>
           </p:cNvPr>
@@ -1865,7 +1865,7 @@
           <p:cNvPr id="8" name="">
             <a:extLst xmlns:a="http://schemas.openxmlformats.org/drawingml/2006/main">
               <a:ext uri="{FF2B5EF4-FFF2-40B4-BE49-F238E27FC236}">
-                <a16:creationId xmlns:a16="http://schemas.microsoft.com/office/drawing/2014/main" id="{D9B4CEC2-9DAF-4E43-B3BE-A1BABD2255C3}"/>
+                <a16:creationId xmlns:a16="http://schemas.microsoft.com/office/drawing/2014/main" id="{7A1B679A-3262-4DE1-B14A-9774529381AD}"/>
               </a:ext>
             </a:extLst>
           </p:cNvPr>
@@ -1929,7 +1929,7 @@
           <p:cNvPr id="9" name="">
             <a:extLst xmlns:a="http://schemas.openxmlformats.org/drawingml/2006/main">
               <a:ext uri="{FF2B5EF4-FFF2-40B4-BE49-F238E27FC236}">
-                <a16:creationId xmlns:a16="http://schemas.microsoft.com/office/drawing/2014/main" id="{FBC86FE5-B2CD-4826-A18F-F8FA53D0BFA0}"/>
+                <a16:creationId xmlns:a16="http://schemas.microsoft.com/office/drawing/2014/main" id="{32E501AE-591D-4F67-BC47-3EC3A5E51E0F}"/>
               </a:ext>
             </a:extLst>
           </p:cNvPr>
@@ -1964,7 +1964,7 @@
           <p:cNvPr id="10" name="">
             <a:extLst xmlns:a="http://schemas.openxmlformats.org/drawingml/2006/main">
               <a:ext uri="{FF2B5EF4-FFF2-40B4-BE49-F238E27FC236}">
-                <a16:creationId xmlns:a16="http://schemas.microsoft.com/office/drawing/2014/main" id="{C95DF90B-DD19-4D06-81CD-5758DD05CFA7}"/>
+                <a16:creationId xmlns:a16="http://schemas.microsoft.com/office/drawing/2014/main" id="{31E819B7-194B-4752-9152-AE87F0CCE678}"/>
               </a:ext>
             </a:extLst>
           </p:cNvPr>
@@ -2028,7 +2028,7 @@
           <p:cNvPr id="11" name="">
             <a:extLst xmlns:a="http://schemas.openxmlformats.org/drawingml/2006/main">
               <a:ext uri="{FF2B5EF4-FFF2-40B4-BE49-F238E27FC236}">
-                <a16:creationId xmlns:a16="http://schemas.microsoft.com/office/drawing/2014/main" id="{E750AAE4-879C-4D2C-A73E-D41159B328E2}"/>
+                <a16:creationId xmlns:a16="http://schemas.microsoft.com/office/drawing/2014/main" id="{2C06AB2C-5A85-493E-A5A1-35CAAAAE60CE}"/>
               </a:ext>
             </a:extLst>
           </p:cNvPr>
@@ -2092,7 +2092,7 @@
           <p:cNvPr id="12" name="">
             <a:extLst xmlns:a="http://schemas.openxmlformats.org/drawingml/2006/main">
               <a:ext uri="{FF2B5EF4-FFF2-40B4-BE49-F238E27FC236}">
-                <a16:creationId xmlns:a16="http://schemas.microsoft.com/office/drawing/2014/main" id="{4472DD14-5355-4040-9733-2AD84F90A6DA}"/>
+                <a16:creationId xmlns:a16="http://schemas.microsoft.com/office/drawing/2014/main" id="{371630C4-6694-4158-9E92-AABF07EB35F8}"/>
               </a:ext>
             </a:extLst>
           </p:cNvPr>
@@ -2127,7 +2127,7 @@
           <p:cNvPr id="13" name="">
             <a:extLst xmlns:a="http://schemas.openxmlformats.org/drawingml/2006/main">
               <a:ext uri="{FF2B5EF4-FFF2-40B4-BE49-F238E27FC236}">
-                <a16:creationId xmlns:a16="http://schemas.microsoft.com/office/drawing/2014/main" id="{4DCC26C5-58D5-4051-9697-951CC1DCA5D9}"/>
+                <a16:creationId xmlns:a16="http://schemas.microsoft.com/office/drawing/2014/main" id="{53799F7B-D712-4A54-836B-6721C42D9DC3}"/>
               </a:ext>
             </a:extLst>
           </p:cNvPr>
@@ -2191,7 +2191,7 @@
           <p:cNvPr id="14" name="">
             <a:extLst xmlns:a="http://schemas.openxmlformats.org/drawingml/2006/main">
               <a:ext uri="{FF2B5EF4-FFF2-40B4-BE49-F238E27FC236}">
-                <a16:creationId xmlns:a16="http://schemas.microsoft.com/office/drawing/2014/main" id="{4097FAF2-F067-49EF-87CF-5086297E1229}"/>
+                <a16:creationId xmlns:a16="http://schemas.microsoft.com/office/drawing/2014/main" id="{39075629-6DEE-451B-ABBC-6754AA93B790}"/>
               </a:ext>
             </a:extLst>
           </p:cNvPr>
@@ -2255,7 +2255,7 @@
           <p:cNvPr id="15" name="">
             <a:extLst xmlns:a="http://schemas.openxmlformats.org/drawingml/2006/main">
               <a:ext uri="{FF2B5EF4-FFF2-40B4-BE49-F238E27FC236}">
-                <a16:creationId xmlns:a16="http://schemas.microsoft.com/office/drawing/2014/main" id="{412E679F-EDF6-44F4-A31F-0BD5163864F3}"/>
+                <a16:creationId xmlns:a16="http://schemas.microsoft.com/office/drawing/2014/main" id="{BB0FD61F-703E-4E98-BE30-4B4BEAD08343}"/>
               </a:ext>
             </a:extLst>
           </p:cNvPr>
@@ -2319,7 +2319,7 @@
           <p:cNvPr id="16" name="">
             <a:extLst xmlns:a="http://schemas.openxmlformats.org/drawingml/2006/main">
               <a:ext uri="{FF2B5EF4-FFF2-40B4-BE49-F238E27FC236}">
-                <a16:creationId xmlns:a16="http://schemas.microsoft.com/office/drawing/2014/main" id="{E77B525F-C485-41A6-8FB6-07913B8CF19B}"/>
+                <a16:creationId xmlns:a16="http://schemas.microsoft.com/office/drawing/2014/main" id="{D6106761-5361-4C29-8FBB-45096377779B}"/>
               </a:ext>
             </a:extLst>
           </p:cNvPr>
@@ -2358,7 +2358,7 @@
           <p:nvPr/>
         </p:nvPicPr>
         <p:blipFill>
-          <a:blip xmlns:r="http://schemas.openxmlformats.org/officeDocument/2006/relationships" xmlns:a="http://schemas.openxmlformats.org/drawingml/2006/main" r:embed="R4815b5e577e24e1b"/>
+          <a:blip xmlns:r="http://schemas.openxmlformats.org/officeDocument/2006/relationships" xmlns:a="http://schemas.openxmlformats.org/drawingml/2006/main" r:embed="R1b00fd3811344431"/>
           <a:srcRect xmlns:a="http://schemas.openxmlformats.org/drawingml/2006/main" l="20736" t="0" r="20736" b="0"/>
           <a:stretch xmlns:a="http://schemas.openxmlformats.org/drawingml/2006/main">
             <a:fillRect l="0" t="0" r="0" b="0"/>
@@ -2379,7 +2379,7 @@
           <p:cNvPr id="18" name="">
             <a:extLst xmlns:a="http://schemas.openxmlformats.org/drawingml/2006/main">
               <a:ext uri="{FF2B5EF4-FFF2-40B4-BE49-F238E27FC236}">
-                <a16:creationId xmlns:a16="http://schemas.microsoft.com/office/drawing/2014/main" id="{1506931E-B82E-45E3-AEBB-1370B2FEF61E}"/>
+                <a16:creationId xmlns:a16="http://schemas.microsoft.com/office/drawing/2014/main" id="{05E599E2-8F79-4702-9969-531B0B8AC882}"/>
               </a:ext>
             </a:extLst>
           </p:cNvPr>
@@ -2416,7 +2416,7 @@
           <p:cNvPr id="19" name="">
             <a:extLst xmlns:a="http://schemas.openxmlformats.org/drawingml/2006/main">
               <a:ext uri="{FF2B5EF4-FFF2-40B4-BE49-F238E27FC236}">
-                <a16:creationId xmlns:a16="http://schemas.microsoft.com/office/drawing/2014/main" id="{A2E855A4-5E62-440C-B69E-00DA9F6EE622}"/>
+                <a16:creationId xmlns:a16="http://schemas.microsoft.com/office/drawing/2014/main" id="{B85C4D47-45DC-40B0-A22C-629DE8829469}"/>
               </a:ext>
             </a:extLst>
           </p:cNvPr>
@@ -2478,7 +2478,7 @@
     </p:spTree>
     <p:extLst>
       <p:ext uri="{BB962C8B-B14F-4D97-AF65-F5344CB8AC3E}">
-        <p14:creationId xmlns:p14="http://schemas.microsoft.com/office/powerpoint/2010/main" val="951885563"/>
+        <p14:creationId xmlns:p14="http://schemas.microsoft.com/office/powerpoint/2010/main" val="1638779374"/>
       </p:ext>
     </p:extLst>
   </p:cSld>
@@ -2502,7 +2502,7 @@
           <p:cNvPr id="1" name="">
             <a:extLst xmlns:a="http://schemas.openxmlformats.org/drawingml/2006/main">
               <a:ext uri="{FF2B5EF4-FFF2-40B4-BE49-F238E27FC236}">
-                <a16:creationId xmlns:a16="http://schemas.microsoft.com/office/drawing/2014/main" id="{1B95DA8E-AB23-4A66-883D-89BD79B57506}"/>
+                <a16:creationId xmlns:a16="http://schemas.microsoft.com/office/drawing/2014/main" id="{AC9448A2-7DB7-4F54-AC97-80E2746FD5E0}"/>
               </a:ext>
             </a:extLst>
           </p:cNvPr>
@@ -2537,7 +2537,7 @@
           <p:cNvPr id="2" name="">
             <a:extLst xmlns:a="http://schemas.openxmlformats.org/drawingml/2006/main">
               <a:ext uri="{FF2B5EF4-FFF2-40B4-BE49-F238E27FC236}">
-                <a16:creationId xmlns:a16="http://schemas.microsoft.com/office/drawing/2014/main" id="{6D7DA024-ADAB-4246-8B2B-09045ECBC358}"/>
+                <a16:creationId xmlns:a16="http://schemas.microsoft.com/office/drawing/2014/main" id="{39BCC229-7C30-4BA6-A1F4-3083B996FCE2}"/>
               </a:ext>
             </a:extLst>
           </p:cNvPr>
@@ -2572,7 +2572,7 @@
           <p:cNvPr id="3" name="">
             <a:extLst xmlns:a="http://schemas.openxmlformats.org/drawingml/2006/main">
               <a:ext uri="{FF2B5EF4-FFF2-40B4-BE49-F238E27FC236}">
-                <a16:creationId xmlns:a16="http://schemas.microsoft.com/office/drawing/2014/main" id="{944E0BD1-067C-4BED-82CE-5C47AF8D0102}"/>
+                <a16:creationId xmlns:a16="http://schemas.microsoft.com/office/drawing/2014/main" id="{7680E172-0E54-44B2-942D-363B5969E9B3}"/>
               </a:ext>
             </a:extLst>
           </p:cNvPr>
@@ -2636,7 +2636,7 @@
           <p:cNvPr id="4" name="">
             <a:extLst xmlns:a="http://schemas.openxmlformats.org/drawingml/2006/main">
               <a:ext uri="{FF2B5EF4-FFF2-40B4-BE49-F238E27FC236}">
-                <a16:creationId xmlns:a16="http://schemas.microsoft.com/office/drawing/2014/main" id="{33CD74BC-52DB-4FCE-AB6D-C63F0AD5AC36}"/>
+                <a16:creationId xmlns:a16="http://schemas.microsoft.com/office/drawing/2014/main" id="{F60C1EE9-49FA-4B7D-8F9C-52C4332B923C}"/>
               </a:ext>
             </a:extLst>
           </p:cNvPr>
@@ -2700,7 +2700,7 @@
           <p:cNvPr id="5" name="">
             <a:extLst xmlns:a="http://schemas.openxmlformats.org/drawingml/2006/main">
               <a:ext uri="{FF2B5EF4-FFF2-40B4-BE49-F238E27FC236}">
-                <a16:creationId xmlns:a16="http://schemas.microsoft.com/office/drawing/2014/main" id="{4B2573AB-9751-4F4C-8441-AE16F6645623}"/>
+                <a16:creationId xmlns:a16="http://schemas.microsoft.com/office/drawing/2014/main" id="{25214729-1BFC-40AF-B9AD-71B205218514}"/>
               </a:ext>
             </a:extLst>
           </p:cNvPr>
@@ -2764,7 +2764,7 @@
           <p:cNvPr id="6" name="">
             <a:extLst xmlns:a="http://schemas.openxmlformats.org/drawingml/2006/main">
               <a:ext uri="{FF2B5EF4-FFF2-40B4-BE49-F238E27FC236}">
-                <a16:creationId xmlns:a16="http://schemas.microsoft.com/office/drawing/2014/main" id="{43B0562E-81FD-47A3-A306-1B219EB1F234}"/>
+                <a16:creationId xmlns:a16="http://schemas.microsoft.com/office/drawing/2014/main" id="{90D6FC35-11DF-44AB-8B26-443AC86C1820}"/>
               </a:ext>
             </a:extLst>
           </p:cNvPr>
@@ -2828,7 +2828,7 @@
           <p:cNvPr id="7" name="">
             <a:extLst xmlns:a="http://schemas.openxmlformats.org/drawingml/2006/main">
               <a:ext uri="{FF2B5EF4-FFF2-40B4-BE49-F238E27FC236}">
-                <a16:creationId xmlns:a16="http://schemas.microsoft.com/office/drawing/2014/main" id="{6468FF5B-BDA0-491C-84B7-84BF5826AD84}"/>
+                <a16:creationId xmlns:a16="http://schemas.microsoft.com/office/drawing/2014/main" id="{EF9056D4-29E9-4C0D-94A2-3F9230C63208}"/>
               </a:ext>
             </a:extLst>
           </p:cNvPr>
@@ -2892,7 +2892,7 @@
           <p:cNvPr id="8" name="">
             <a:extLst xmlns:a="http://schemas.openxmlformats.org/drawingml/2006/main">
               <a:ext uri="{FF2B5EF4-FFF2-40B4-BE49-F238E27FC236}">
-                <a16:creationId xmlns:a16="http://schemas.microsoft.com/office/drawing/2014/main" id="{CB613914-C189-494D-B8AA-A0B5D33DD9D5}"/>
+                <a16:creationId xmlns:a16="http://schemas.microsoft.com/office/drawing/2014/main" id="{34F9D0E0-965D-47E5-9FB6-798751311090}"/>
               </a:ext>
             </a:extLst>
           </p:cNvPr>
@@ -2925,7 +2925,7 @@
           <p:cNvPr id="9" name="">
             <a:extLst xmlns:a="http://schemas.openxmlformats.org/drawingml/2006/main">
               <a:ext uri="{FF2B5EF4-FFF2-40B4-BE49-F238E27FC236}">
-                <a16:creationId xmlns:a16="http://schemas.microsoft.com/office/drawing/2014/main" id="{27B4979A-DA5C-4485-A3E0-E0DCBC1C14FE}"/>
+                <a16:creationId xmlns:a16="http://schemas.microsoft.com/office/drawing/2014/main" id="{45BC6843-C2FD-4D17-AA15-3EFDE835FEB1}"/>
               </a:ext>
             </a:extLst>
           </p:cNvPr>
@@ -2989,7 +2989,7 @@
           <p:cNvPr id="10" name="">
             <a:extLst xmlns:a="http://schemas.openxmlformats.org/drawingml/2006/main">
               <a:ext uri="{FF2B5EF4-FFF2-40B4-BE49-F238E27FC236}">
-                <a16:creationId xmlns:a16="http://schemas.microsoft.com/office/drawing/2014/main" id="{696E2D44-4A08-4416-A8DC-4431758CEC92}"/>
+                <a16:creationId xmlns:a16="http://schemas.microsoft.com/office/drawing/2014/main" id="{D81BF05F-5A2F-4DF3-9EAA-E763A793354E}"/>
               </a:ext>
             </a:extLst>
           </p:cNvPr>
@@ -3053,7 +3053,7 @@
           <p:cNvPr id="11" name="">
             <a:extLst xmlns:a="http://schemas.openxmlformats.org/drawingml/2006/main">
               <a:ext uri="{FF2B5EF4-FFF2-40B4-BE49-F238E27FC236}">
-                <a16:creationId xmlns:a16="http://schemas.microsoft.com/office/drawing/2014/main" id="{188CE170-5266-4EBD-BCAD-06170460A7A5}"/>
+                <a16:creationId xmlns:a16="http://schemas.microsoft.com/office/drawing/2014/main" id="{41FB93D7-E0C2-4611-B109-BB9D64FB79F8}"/>
               </a:ext>
             </a:extLst>
           </p:cNvPr>
@@ -3088,7 +3088,7 @@
           <p:cNvPr id="12" name="">
             <a:extLst xmlns:a="http://schemas.openxmlformats.org/drawingml/2006/main">
               <a:ext uri="{FF2B5EF4-FFF2-40B4-BE49-F238E27FC236}">
-                <a16:creationId xmlns:a16="http://schemas.microsoft.com/office/drawing/2014/main" id="{C4C569B0-4FA9-4743-A39D-4E61892C7566}"/>
+                <a16:creationId xmlns:a16="http://schemas.microsoft.com/office/drawing/2014/main" id="{FDAFDBB2-B011-42BC-8BDB-54396363525D}"/>
               </a:ext>
             </a:extLst>
           </p:cNvPr>
@@ -3123,7 +3123,7 @@
           <p:cNvPr id="13" name="">
             <a:extLst xmlns:a="http://schemas.openxmlformats.org/drawingml/2006/main">
               <a:ext uri="{FF2B5EF4-FFF2-40B4-BE49-F238E27FC236}">
-                <a16:creationId xmlns:a16="http://schemas.microsoft.com/office/drawing/2014/main" id="{D7347F2E-6507-4592-AAB8-86E3BAB2C334}"/>
+                <a16:creationId xmlns:a16="http://schemas.microsoft.com/office/drawing/2014/main" id="{7456826E-579E-41EA-91DE-E162DAA94947}"/>
               </a:ext>
             </a:extLst>
           </p:cNvPr>
@@ -3187,7 +3187,7 @@
           <p:cNvPr id="14" name="">
             <a:extLst xmlns:a="http://schemas.openxmlformats.org/drawingml/2006/main">
               <a:ext uri="{FF2B5EF4-FFF2-40B4-BE49-F238E27FC236}">
-                <a16:creationId xmlns:a16="http://schemas.microsoft.com/office/drawing/2014/main" id="{CF912639-B123-4A69-B827-5B3626B6D6D1}"/>
+                <a16:creationId xmlns:a16="http://schemas.microsoft.com/office/drawing/2014/main" id="{C7D741DA-0D41-46B9-AF2C-5ECE6C166539}"/>
               </a:ext>
             </a:extLst>
           </p:cNvPr>
@@ -3251,7 +3251,7 @@
           <p:cNvPr id="15" name="">
             <a:extLst xmlns:a="http://schemas.openxmlformats.org/drawingml/2006/main">
               <a:ext uri="{FF2B5EF4-FFF2-40B4-BE49-F238E27FC236}">
-                <a16:creationId xmlns:a16="http://schemas.microsoft.com/office/drawing/2014/main" id="{A0B9EA43-0ECF-459A-8ECE-306D8E6FFDBC}"/>
+                <a16:creationId xmlns:a16="http://schemas.microsoft.com/office/drawing/2014/main" id="{7F39113F-5498-4499-9A77-0E32232D614D}"/>
               </a:ext>
             </a:extLst>
           </p:cNvPr>
@@ -3286,7 +3286,7 @@
           <p:cNvPr id="16" name="">
             <a:extLst xmlns:a="http://schemas.openxmlformats.org/drawingml/2006/main">
               <a:ext uri="{FF2B5EF4-FFF2-40B4-BE49-F238E27FC236}">
-                <a16:creationId xmlns:a16="http://schemas.microsoft.com/office/drawing/2014/main" id="{C704D95F-F1E5-4E67-853A-823A252CC27D}"/>
+                <a16:creationId xmlns:a16="http://schemas.microsoft.com/office/drawing/2014/main" id="{2921DC0E-8F93-47C9-8520-B079F25F9226}"/>
               </a:ext>
             </a:extLst>
           </p:cNvPr>
@@ -3350,7 +3350,7 @@
           <p:cNvPr id="17" name="">
             <a:extLst xmlns:a="http://schemas.openxmlformats.org/drawingml/2006/main">
               <a:ext uri="{FF2B5EF4-FFF2-40B4-BE49-F238E27FC236}">
-                <a16:creationId xmlns:a16="http://schemas.microsoft.com/office/drawing/2014/main" id="{63574049-9D5A-4782-B840-F62A0E7CB19A}"/>
+                <a16:creationId xmlns:a16="http://schemas.microsoft.com/office/drawing/2014/main" id="{0DF3E204-51E2-40DE-B3D2-755827647C1D}"/>
               </a:ext>
             </a:extLst>
           </p:cNvPr>
@@ -3414,7 +3414,7 @@
           <p:cNvPr id="18" name="">
             <a:extLst xmlns:a="http://schemas.openxmlformats.org/drawingml/2006/main">
               <a:ext uri="{FF2B5EF4-FFF2-40B4-BE49-F238E27FC236}">
-                <a16:creationId xmlns:a16="http://schemas.microsoft.com/office/drawing/2014/main" id="{5E29D1CE-C1C4-4DD2-A03B-D3E9EB90CE68}"/>
+                <a16:creationId xmlns:a16="http://schemas.microsoft.com/office/drawing/2014/main" id="{41322573-D67C-4390-9398-35D55B68AD88}"/>
               </a:ext>
             </a:extLst>
           </p:cNvPr>
@@ -3449,7 +3449,7 @@
           <p:cNvPr id="19" name="">
             <a:extLst xmlns:a="http://schemas.openxmlformats.org/drawingml/2006/main">
               <a:ext uri="{FF2B5EF4-FFF2-40B4-BE49-F238E27FC236}">
-                <a16:creationId xmlns:a16="http://schemas.microsoft.com/office/drawing/2014/main" id="{BA8CB49B-E976-4313-A341-015DFA5A7C05}"/>
+                <a16:creationId xmlns:a16="http://schemas.microsoft.com/office/drawing/2014/main" id="{EB2DED3A-042B-4772-B046-6AE40BB94BF8}"/>
               </a:ext>
             </a:extLst>
           </p:cNvPr>
@@ -3513,7 +3513,7 @@
           <p:cNvPr id="20" name="">
             <a:extLst xmlns:a="http://schemas.openxmlformats.org/drawingml/2006/main">
               <a:ext uri="{FF2B5EF4-FFF2-40B4-BE49-F238E27FC236}">
-                <a16:creationId xmlns:a16="http://schemas.microsoft.com/office/drawing/2014/main" id="{22A21351-2D67-495D-B165-0F7F3FB08A5C}"/>
+                <a16:creationId xmlns:a16="http://schemas.microsoft.com/office/drawing/2014/main" id="{5DE6D301-2CED-4365-8BF3-7A2C5047AD5E}"/>
               </a:ext>
             </a:extLst>
           </p:cNvPr>
@@ -3577,7 +3577,7 @@
           <p:cNvPr id="21" name="">
             <a:extLst xmlns:a="http://schemas.openxmlformats.org/drawingml/2006/main">
               <a:ext uri="{FF2B5EF4-FFF2-40B4-BE49-F238E27FC236}">
-                <a16:creationId xmlns:a16="http://schemas.microsoft.com/office/drawing/2014/main" id="{0C527032-84D5-43DD-B629-D4CAD163E8F5}"/>
+                <a16:creationId xmlns:a16="http://schemas.microsoft.com/office/drawing/2014/main" id="{DFD5F86A-0DA7-47FB-B6B9-069CDDDA665A}"/>
               </a:ext>
             </a:extLst>
           </p:cNvPr>
@@ -3639,7 +3639,7 @@
     </p:spTree>
     <p:extLst>
       <p:ext uri="{BB962C8B-B14F-4D97-AF65-F5344CB8AC3E}">
-        <p14:creationId xmlns:p14="http://schemas.microsoft.com/office/powerpoint/2010/main" val="104288589"/>
+        <p14:creationId xmlns:p14="http://schemas.microsoft.com/office/powerpoint/2010/main" val="1887695261"/>
       </p:ext>
     </p:extLst>
   </p:cSld>
@@ -3663,7 +3663,7 @@
           <p:cNvPr id="1" name="">
             <a:extLst xmlns:a="http://schemas.openxmlformats.org/drawingml/2006/main">
               <a:ext uri="{FF2B5EF4-FFF2-40B4-BE49-F238E27FC236}">
-                <a16:creationId xmlns:a16="http://schemas.microsoft.com/office/drawing/2014/main" id="{0B2B602A-7D4A-4C95-B9DA-D4ADC4C7A8E7}"/>
+                <a16:creationId xmlns:a16="http://schemas.microsoft.com/office/drawing/2014/main" id="{65BDC3EE-6C2D-458B-8A26-BFAAD75D73DA}"/>
               </a:ext>
             </a:extLst>
           </p:cNvPr>
@@ -3698,7 +3698,7 @@
           <p:cNvPr id="2" name="">
             <a:extLst xmlns:a="http://schemas.openxmlformats.org/drawingml/2006/main">
               <a:ext uri="{FF2B5EF4-FFF2-40B4-BE49-F238E27FC236}">
-                <a16:creationId xmlns:a16="http://schemas.microsoft.com/office/drawing/2014/main" id="{605E652F-75C5-4AF4-B31D-1D0CDCB62FE6}"/>
+                <a16:creationId xmlns:a16="http://schemas.microsoft.com/office/drawing/2014/main" id="{469CB850-FFEF-4C67-8124-828FEFC62F9C}"/>
               </a:ext>
             </a:extLst>
           </p:cNvPr>
@@ -3733,7 +3733,7 @@
           <p:cNvPr id="3" name="">
             <a:extLst xmlns:a="http://schemas.openxmlformats.org/drawingml/2006/main">
               <a:ext uri="{FF2B5EF4-FFF2-40B4-BE49-F238E27FC236}">
-                <a16:creationId xmlns:a16="http://schemas.microsoft.com/office/drawing/2014/main" id="{74F655E3-B205-4ECF-93B1-180BFDE9E0F3}"/>
+                <a16:creationId xmlns:a16="http://schemas.microsoft.com/office/drawing/2014/main" id="{59C8D6D6-ECA6-462C-A0EA-110CA50D36D2}"/>
               </a:ext>
             </a:extLst>
           </p:cNvPr>
@@ -3797,7 +3797,7 @@
           <p:cNvPr id="4" name="">
             <a:extLst xmlns:a="http://schemas.openxmlformats.org/drawingml/2006/main">
               <a:ext uri="{FF2B5EF4-FFF2-40B4-BE49-F238E27FC236}">
-                <a16:creationId xmlns:a16="http://schemas.microsoft.com/office/drawing/2014/main" id="{5CD4A556-EAEE-4A57-A6CF-4EBFFA39CB85}"/>
+                <a16:creationId xmlns:a16="http://schemas.microsoft.com/office/drawing/2014/main" id="{F5C7F0A2-70EB-47CD-B5FF-C2D93A2BF043}"/>
               </a:ext>
             </a:extLst>
           </p:cNvPr>
@@ -3861,7 +3861,7 @@
           <p:cNvPr id="5" name="">
             <a:extLst xmlns:a="http://schemas.openxmlformats.org/drawingml/2006/main">
               <a:ext uri="{FF2B5EF4-FFF2-40B4-BE49-F238E27FC236}">
-                <a16:creationId xmlns:a16="http://schemas.microsoft.com/office/drawing/2014/main" id="{931B01EA-42AC-4E73-8E35-0A00C3870EA5}"/>
+                <a16:creationId xmlns:a16="http://schemas.microsoft.com/office/drawing/2014/main" id="{AB9F510D-EBA7-4F5D-90B3-C33467706164}"/>
               </a:ext>
             </a:extLst>
           </p:cNvPr>
@@ -3925,7 +3925,7 @@
           <p:cNvPr id="6" name="">
             <a:extLst xmlns:a="http://schemas.openxmlformats.org/drawingml/2006/main">
               <a:ext uri="{FF2B5EF4-FFF2-40B4-BE49-F238E27FC236}">
-                <a16:creationId xmlns:a16="http://schemas.microsoft.com/office/drawing/2014/main" id="{7D42ABAD-5184-4048-8B52-F6171B4D5C1C}"/>
+                <a16:creationId xmlns:a16="http://schemas.microsoft.com/office/drawing/2014/main" id="{735AB043-8A4B-4577-8BE1-A75432F28D49}"/>
               </a:ext>
             </a:extLst>
           </p:cNvPr>
@@ -3989,7 +3989,7 @@
           <p:cNvPr id="7" name="">
             <a:extLst xmlns:a="http://schemas.openxmlformats.org/drawingml/2006/main">
               <a:ext uri="{FF2B5EF4-FFF2-40B4-BE49-F238E27FC236}">
-                <a16:creationId xmlns:a16="http://schemas.microsoft.com/office/drawing/2014/main" id="{7C3CE1EF-39A4-42A8-9EA1-00AF66515B30}"/>
+                <a16:creationId xmlns:a16="http://schemas.microsoft.com/office/drawing/2014/main" id="{CAF2841F-A3C8-473F-A96A-F7D13B90FA68}"/>
               </a:ext>
             </a:extLst>
           </p:cNvPr>
@@ -4026,7 +4026,7 @@
           <p:nvPr/>
         </p:nvPicPr>
         <p:blipFill>
-          <a:blip xmlns:r="http://schemas.openxmlformats.org/officeDocument/2006/relationships" xmlns:a="http://schemas.openxmlformats.org/drawingml/2006/main" r:embed="R01c9bd72b31d4a2d"/>
+          <a:blip xmlns:r="http://schemas.openxmlformats.org/officeDocument/2006/relationships" xmlns:a="http://schemas.openxmlformats.org/drawingml/2006/main" r:embed="Rd806507a958b47e5"/>
           <a:stretch xmlns:a="http://schemas.openxmlformats.org/drawingml/2006/main"/>
         </p:blipFill>
         <p:spPr>
@@ -4044,7 +4044,7 @@
           <p:cNvPr id="9" name="">
             <a:extLst xmlns:a="http://schemas.openxmlformats.org/drawingml/2006/main">
               <a:ext uri="{FF2B5EF4-FFF2-40B4-BE49-F238E27FC236}">
-                <a16:creationId xmlns:a16="http://schemas.microsoft.com/office/drawing/2014/main" id="{22B4BE51-7F0E-4816-8E55-E8358D185EEF}"/>
+                <a16:creationId xmlns:a16="http://schemas.microsoft.com/office/drawing/2014/main" id="{C72E3ECB-C409-4698-87E2-D9A012BFE528}"/>
               </a:ext>
             </a:extLst>
           </p:cNvPr>
@@ -4079,7 +4079,7 @@
           <p:cNvPr id="10" name="">
             <a:extLst xmlns:a="http://schemas.openxmlformats.org/drawingml/2006/main">
               <a:ext uri="{FF2B5EF4-FFF2-40B4-BE49-F238E27FC236}">
-                <a16:creationId xmlns:a16="http://schemas.microsoft.com/office/drawing/2014/main" id="{21F2B80C-9C41-4A64-A44A-E083AE6E8D43}"/>
+                <a16:creationId xmlns:a16="http://schemas.microsoft.com/office/drawing/2014/main" id="{D8F56DD3-216C-485C-8046-77DCC00A4C70}"/>
               </a:ext>
             </a:extLst>
           </p:cNvPr>
@@ -4143,7 +4143,7 @@
           <p:cNvPr id="11" name="">
             <a:extLst xmlns:a="http://schemas.openxmlformats.org/drawingml/2006/main">
               <a:ext uri="{FF2B5EF4-FFF2-40B4-BE49-F238E27FC236}">
-                <a16:creationId xmlns:a16="http://schemas.microsoft.com/office/drawing/2014/main" id="{E5D6D00C-1196-4DE7-9988-A4A992840724}"/>
+                <a16:creationId xmlns:a16="http://schemas.microsoft.com/office/drawing/2014/main" id="{D69B48AC-3F85-4439-818B-5118DEF0F767}"/>
               </a:ext>
             </a:extLst>
           </p:cNvPr>
@@ -4178,7 +4178,7 @@
           <p:cNvPr id="12" name="">
             <a:extLst xmlns:a="http://schemas.openxmlformats.org/drawingml/2006/main">
               <a:ext uri="{FF2B5EF4-FFF2-40B4-BE49-F238E27FC236}">
-                <a16:creationId xmlns:a16="http://schemas.microsoft.com/office/drawing/2014/main" id="{9712F17A-CE9A-4B86-B983-A2E353738ED6}"/>
+                <a16:creationId xmlns:a16="http://schemas.microsoft.com/office/drawing/2014/main" id="{084926E0-9F26-4559-8623-1E714E584043}"/>
               </a:ext>
             </a:extLst>
           </p:cNvPr>
@@ -4242,7 +4242,7 @@
           <p:cNvPr id="13" name="">
             <a:extLst xmlns:a="http://schemas.openxmlformats.org/drawingml/2006/main">
               <a:ext uri="{FF2B5EF4-FFF2-40B4-BE49-F238E27FC236}">
-                <a16:creationId xmlns:a16="http://schemas.microsoft.com/office/drawing/2014/main" id="{CE4835D2-02F5-48EF-BF1D-6CCDB335DC42}"/>
+                <a16:creationId xmlns:a16="http://schemas.microsoft.com/office/drawing/2014/main" id="{8A101AB7-5133-49BE-AF29-C8004337B826}"/>
               </a:ext>
             </a:extLst>
           </p:cNvPr>
@@ -4277,7 +4277,7 @@
           <p:cNvPr id="14" name="">
             <a:extLst xmlns:a="http://schemas.openxmlformats.org/drawingml/2006/main">
               <a:ext uri="{FF2B5EF4-FFF2-40B4-BE49-F238E27FC236}">
-                <a16:creationId xmlns:a16="http://schemas.microsoft.com/office/drawing/2014/main" id="{EEA860D4-4B4D-4E49-B6DF-347EA43FCAA2}"/>
+                <a16:creationId xmlns:a16="http://schemas.microsoft.com/office/drawing/2014/main" id="{12065CA5-913A-4E85-A445-3ECFB48ECDCD}"/>
               </a:ext>
             </a:extLst>
           </p:cNvPr>
@@ -4341,7 +4341,7 @@
           <p:cNvPr id="15" name="">
             <a:extLst xmlns:a="http://schemas.openxmlformats.org/drawingml/2006/main">
               <a:ext uri="{FF2B5EF4-FFF2-40B4-BE49-F238E27FC236}">
-                <a16:creationId xmlns:a16="http://schemas.microsoft.com/office/drawing/2014/main" id="{956170F7-6AA7-447A-AEE0-5ABEE223FB33}"/>
+                <a16:creationId xmlns:a16="http://schemas.microsoft.com/office/drawing/2014/main" id="{A78E0E75-0E46-4824-A2CD-85688D6EB7F0}"/>
               </a:ext>
             </a:extLst>
           </p:cNvPr>
@@ -4403,7 +4403,7 @@
     </p:spTree>
     <p:extLst>
       <p:ext uri="{BB962C8B-B14F-4D97-AF65-F5344CB8AC3E}">
-        <p14:creationId xmlns:p14="http://schemas.microsoft.com/office/powerpoint/2010/main" val="1309349533"/>
+        <p14:creationId xmlns:p14="http://schemas.microsoft.com/office/powerpoint/2010/main" val="1834480185"/>
       </p:ext>
     </p:extLst>
   </p:cSld>
@@ -4431,7 +4431,7 @@
           <p:nvPr/>
         </p:nvPicPr>
         <p:blipFill>
-          <a:blip xmlns:r="http://schemas.openxmlformats.org/officeDocument/2006/relationships" xmlns:a="http://schemas.openxmlformats.org/drawingml/2006/main" r:embed="Re3e45aedc7a94efe"/>
+          <a:blip xmlns:r="http://schemas.openxmlformats.org/officeDocument/2006/relationships" xmlns:a="http://schemas.openxmlformats.org/drawingml/2006/main" r:embed="R294947f430754887"/>
           <a:srcRect xmlns:a="http://schemas.openxmlformats.org/drawingml/2006/main" l="0" t="5284" r="0" b="5284"/>
           <a:stretch xmlns:a="http://schemas.openxmlformats.org/drawingml/2006/main">
             <a:fillRect l="0" t="0" r="0" b="0"/>
@@ -4452,7 +4452,7 @@
           <p:cNvPr id="2" name="">
             <a:extLst xmlns:a="http://schemas.openxmlformats.org/drawingml/2006/main">
               <a:ext uri="{FF2B5EF4-FFF2-40B4-BE49-F238E27FC236}">
-                <a16:creationId xmlns:a16="http://schemas.microsoft.com/office/drawing/2014/main" id="{C5A14B47-03D1-4C80-BD28-F411A84465FC}"/>
+                <a16:creationId xmlns:a16="http://schemas.microsoft.com/office/drawing/2014/main" id="{C74ABBDB-5A88-4362-8375-DFB3BDCBAA23}"/>
               </a:ext>
             </a:extLst>
           </p:cNvPr>
@@ -4489,7 +4489,7 @@
           <p:cNvPr id="3" name="">
             <a:extLst xmlns:a="http://schemas.openxmlformats.org/drawingml/2006/main">
               <a:ext uri="{FF2B5EF4-FFF2-40B4-BE49-F238E27FC236}">
-                <a16:creationId xmlns:a16="http://schemas.microsoft.com/office/drawing/2014/main" id="{31E0DB61-B84D-4E63-8E66-D40D3796F7DA}"/>
+                <a16:creationId xmlns:a16="http://schemas.microsoft.com/office/drawing/2014/main" id="{F9BD8886-A64C-466C-8A24-B091B002833B}"/>
               </a:ext>
             </a:extLst>
           </p:cNvPr>
@@ -4553,7 +4553,7 @@
           <p:cNvPr id="4" name="">
             <a:extLst xmlns:a="http://schemas.openxmlformats.org/drawingml/2006/main">
               <a:ext uri="{FF2B5EF4-FFF2-40B4-BE49-F238E27FC236}">
-                <a16:creationId xmlns:a16="http://schemas.microsoft.com/office/drawing/2014/main" id="{C766C78F-2CF2-4DBC-A6E8-41F5D622361D}"/>
+                <a16:creationId xmlns:a16="http://schemas.microsoft.com/office/drawing/2014/main" id="{90E6ACD1-A5FC-4BD1-917B-62C7FB937484}"/>
               </a:ext>
             </a:extLst>
           </p:cNvPr>
@@ -4617,7 +4617,7 @@
           <p:cNvPr id="5" name="">
             <a:extLst xmlns:a="http://schemas.openxmlformats.org/drawingml/2006/main">
               <a:ext uri="{FF2B5EF4-FFF2-40B4-BE49-F238E27FC236}">
-                <a16:creationId xmlns:a16="http://schemas.microsoft.com/office/drawing/2014/main" id="{A677764B-5418-4D2A-9296-A5368902B59C}"/>
+                <a16:creationId xmlns:a16="http://schemas.microsoft.com/office/drawing/2014/main" id="{CA44C7C9-B5D2-4642-9610-1B1E9DA4E7F4}"/>
               </a:ext>
             </a:extLst>
           </p:cNvPr>
@@ -4681,7 +4681,7 @@
           <p:cNvPr id="6" name="">
             <a:extLst xmlns:a="http://schemas.openxmlformats.org/drawingml/2006/main">
               <a:ext uri="{FF2B5EF4-FFF2-40B4-BE49-F238E27FC236}">
-                <a16:creationId xmlns:a16="http://schemas.microsoft.com/office/drawing/2014/main" id="{2A70EC38-5707-4FF9-8A45-4F2859BE499D}"/>
+                <a16:creationId xmlns:a16="http://schemas.microsoft.com/office/drawing/2014/main" id="{B580A19C-DAA4-4492-A9E0-0F102527C6AC}"/>
               </a:ext>
             </a:extLst>
           </p:cNvPr>
@@ -4745,7 +4745,7 @@
           <p:cNvPr id="7" name="">
             <a:extLst xmlns:a="http://schemas.openxmlformats.org/drawingml/2006/main">
               <a:ext uri="{FF2B5EF4-FFF2-40B4-BE49-F238E27FC236}">
-                <a16:creationId xmlns:a16="http://schemas.microsoft.com/office/drawing/2014/main" id="{6E8DAB5D-942E-42AC-8C77-83879C68B1BF}"/>
+                <a16:creationId xmlns:a16="http://schemas.microsoft.com/office/drawing/2014/main" id="{1EFDE143-5829-4206-A35D-B1C955024529}"/>
               </a:ext>
             </a:extLst>
           </p:cNvPr>
@@ -4809,7 +4809,7 @@
           <p:cNvPr id="8" name="">
             <a:extLst xmlns:a="http://schemas.openxmlformats.org/drawingml/2006/main">
               <a:ext uri="{FF2B5EF4-FFF2-40B4-BE49-F238E27FC236}">
-                <a16:creationId xmlns:a16="http://schemas.microsoft.com/office/drawing/2014/main" id="{8FBA1078-8E39-4D27-9A07-0BF1A41DE6A9}"/>
+                <a16:creationId xmlns:a16="http://schemas.microsoft.com/office/drawing/2014/main" id="{386CE0E6-5453-4976-83A3-D8F412B48EBD}"/>
               </a:ext>
             </a:extLst>
           </p:cNvPr>
@@ -4873,7 +4873,7 @@
           <p:cNvPr id="9" name="">
             <a:extLst xmlns:a="http://schemas.openxmlformats.org/drawingml/2006/main">
               <a:ext uri="{FF2B5EF4-FFF2-40B4-BE49-F238E27FC236}">
-                <a16:creationId xmlns:a16="http://schemas.microsoft.com/office/drawing/2014/main" id="{F379B6CC-8DC1-4D89-826D-588B0789852A}"/>
+                <a16:creationId xmlns:a16="http://schemas.microsoft.com/office/drawing/2014/main" id="{7AC8DAFD-DA9A-4AC5-9A14-23E182BD176B}"/>
               </a:ext>
             </a:extLst>
           </p:cNvPr>
@@ -4937,7 +4937,7 @@
           <p:cNvPr id="10" name="">
             <a:extLst xmlns:a="http://schemas.openxmlformats.org/drawingml/2006/main">
               <a:ext uri="{FF2B5EF4-FFF2-40B4-BE49-F238E27FC236}">
-                <a16:creationId xmlns:a16="http://schemas.microsoft.com/office/drawing/2014/main" id="{2985058B-5661-44E4-B4DA-6A8FD460F12F}"/>
+                <a16:creationId xmlns:a16="http://schemas.microsoft.com/office/drawing/2014/main" id="{1A7F0534-52E7-4806-8101-ACC6F1D1366F}"/>
               </a:ext>
             </a:extLst>
           </p:cNvPr>
@@ -5001,7 +5001,7 @@
           <p:cNvPr id="11" name="">
             <a:extLst xmlns:a="http://schemas.openxmlformats.org/drawingml/2006/main">
               <a:ext uri="{FF2B5EF4-FFF2-40B4-BE49-F238E27FC236}">
-                <a16:creationId xmlns:a16="http://schemas.microsoft.com/office/drawing/2014/main" id="{797177B5-CF8A-4AAD-9B0A-997F74A008B3}"/>
+                <a16:creationId xmlns:a16="http://schemas.microsoft.com/office/drawing/2014/main" id="{05465358-CC93-4C60-9E66-8987CB64E6B8}"/>
               </a:ext>
             </a:extLst>
           </p:cNvPr>
@@ -5065,7 +5065,7 @@
           <p:cNvPr id="12" name="">
             <a:extLst xmlns:a="http://schemas.openxmlformats.org/drawingml/2006/main">
               <a:ext uri="{FF2B5EF4-FFF2-40B4-BE49-F238E27FC236}">
-                <a16:creationId xmlns:a16="http://schemas.microsoft.com/office/drawing/2014/main" id="{C1E0FE22-154A-461F-BAAB-0D687E52BDEF}"/>
+                <a16:creationId xmlns:a16="http://schemas.microsoft.com/office/drawing/2014/main" id="{CDBD2F5B-8E5A-4130-9FA4-FDE519AA4E86}"/>
               </a:ext>
             </a:extLst>
           </p:cNvPr>
@@ -5129,7 +5129,7 @@
           <p:cNvPr id="13" name="">
             <a:extLst xmlns:a="http://schemas.openxmlformats.org/drawingml/2006/main">
               <a:ext uri="{FF2B5EF4-FFF2-40B4-BE49-F238E27FC236}">
-                <a16:creationId xmlns:a16="http://schemas.microsoft.com/office/drawing/2014/main" id="{C134F9DE-7849-4369-9876-482F62812176}"/>
+                <a16:creationId xmlns:a16="http://schemas.microsoft.com/office/drawing/2014/main" id="{F5EDB4D9-2C42-42E2-B1DC-F648A23C589A}"/>
               </a:ext>
             </a:extLst>
           </p:cNvPr>
@@ -5193,7 +5193,7 @@
           <p:cNvPr id="14" name="">
             <a:extLst xmlns:a="http://schemas.openxmlformats.org/drawingml/2006/main">
               <a:ext uri="{FF2B5EF4-FFF2-40B4-BE49-F238E27FC236}">
-                <a16:creationId xmlns:a16="http://schemas.microsoft.com/office/drawing/2014/main" id="{890577E0-59BD-4C40-879B-9C1D837EF1FF}"/>
+                <a16:creationId xmlns:a16="http://schemas.microsoft.com/office/drawing/2014/main" id="{B27DF8D8-13D0-4A8A-9311-36796638584C}"/>
               </a:ext>
             </a:extLst>
           </p:cNvPr>
@@ -5255,7 +5255,7 @@
     </p:spTree>
     <p:extLst>
       <p:ext uri="{BB962C8B-B14F-4D97-AF65-F5344CB8AC3E}">
-        <p14:creationId xmlns:p14="http://schemas.microsoft.com/office/powerpoint/2010/main" val="1481483552"/>
+        <p14:creationId xmlns:p14="http://schemas.microsoft.com/office/powerpoint/2010/main" val="1983369942"/>
       </p:ext>
     </p:extLst>
   </p:cSld>
@@ -5279,7 +5279,7 @@
           <p:cNvPr id="1" name="">
             <a:extLst xmlns:a="http://schemas.openxmlformats.org/drawingml/2006/main">
               <a:ext uri="{FF2B5EF4-FFF2-40B4-BE49-F238E27FC236}">
-                <a16:creationId xmlns:a16="http://schemas.microsoft.com/office/drawing/2014/main" id="{BACED97D-9C60-468F-9468-FEB7E9C24AF5}"/>
+                <a16:creationId xmlns:a16="http://schemas.microsoft.com/office/drawing/2014/main" id="{A362AD22-085C-407A-8A6E-CC4995F7AFDB}"/>
               </a:ext>
             </a:extLst>
           </p:cNvPr>
@@ -5314,7 +5314,7 @@
           <p:cNvPr id="2" name="">
             <a:extLst xmlns:a="http://schemas.openxmlformats.org/drawingml/2006/main">
               <a:ext uri="{FF2B5EF4-FFF2-40B4-BE49-F238E27FC236}">
-                <a16:creationId xmlns:a16="http://schemas.microsoft.com/office/drawing/2014/main" id="{6B9D4C5D-DA48-4EF0-A7B5-1CE46026DDE2}"/>
+                <a16:creationId xmlns:a16="http://schemas.microsoft.com/office/drawing/2014/main" id="{E99BCF4C-F9B4-40BC-8D23-B76BECD94A99}"/>
               </a:ext>
             </a:extLst>
           </p:cNvPr>
@@ -5349,7 +5349,7 @@
           <p:cNvPr id="3" name="">
             <a:extLst xmlns:a="http://schemas.openxmlformats.org/drawingml/2006/main">
               <a:ext uri="{FF2B5EF4-FFF2-40B4-BE49-F238E27FC236}">
-                <a16:creationId xmlns:a16="http://schemas.microsoft.com/office/drawing/2014/main" id="{7A8CCDFB-B320-4D76-9EE7-A1068584D6FE}"/>
+                <a16:creationId xmlns:a16="http://schemas.microsoft.com/office/drawing/2014/main" id="{57BD39AB-7136-4007-A91B-26FB9B49D991}"/>
               </a:ext>
             </a:extLst>
           </p:cNvPr>
@@ -5413,7 +5413,7 @@
           <p:cNvPr id="4" name="">
             <a:extLst xmlns:a="http://schemas.openxmlformats.org/drawingml/2006/main">
               <a:ext uri="{FF2B5EF4-FFF2-40B4-BE49-F238E27FC236}">
-                <a16:creationId xmlns:a16="http://schemas.microsoft.com/office/drawing/2014/main" id="{1A473DBF-3117-44D8-86EA-59F17DDAE675}"/>
+                <a16:creationId xmlns:a16="http://schemas.microsoft.com/office/drawing/2014/main" id="{2EDB24CB-7EB8-4AF9-95EB-3C47D88715F0}"/>
               </a:ext>
             </a:extLst>
           </p:cNvPr>
@@ -5477,7 +5477,7 @@
           <p:cNvPr id="5" name="">
             <a:extLst xmlns:a="http://schemas.openxmlformats.org/drawingml/2006/main">
               <a:ext uri="{FF2B5EF4-FFF2-40B4-BE49-F238E27FC236}">
-                <a16:creationId xmlns:a16="http://schemas.microsoft.com/office/drawing/2014/main" id="{DDB3FEF4-0945-4C51-AC23-E50EDF8EE80F}"/>
+                <a16:creationId xmlns:a16="http://schemas.microsoft.com/office/drawing/2014/main" id="{614626B9-A31A-44FC-9789-8F6EF7F6295F}"/>
               </a:ext>
             </a:extLst>
           </p:cNvPr>
@@ -5541,7 +5541,7 @@
           <p:cNvPr id="6" name="">
             <a:extLst xmlns:a="http://schemas.openxmlformats.org/drawingml/2006/main">
               <a:ext uri="{FF2B5EF4-FFF2-40B4-BE49-F238E27FC236}">
-                <a16:creationId xmlns:a16="http://schemas.microsoft.com/office/drawing/2014/main" id="{E7E0D5A5-160E-4CDB-8194-E08CE4E50BEC}"/>
+                <a16:creationId xmlns:a16="http://schemas.microsoft.com/office/drawing/2014/main" id="{4E30A6F7-4285-468E-9B18-2A232C7B590C}"/>
               </a:ext>
             </a:extLst>
           </p:cNvPr>
@@ -5605,7 +5605,7 @@
           <p:cNvPr id="7" name="">
             <a:extLst xmlns:a="http://schemas.openxmlformats.org/drawingml/2006/main">
               <a:ext uri="{FF2B5EF4-FFF2-40B4-BE49-F238E27FC236}">
-                <a16:creationId xmlns:a16="http://schemas.microsoft.com/office/drawing/2014/main" id="{77AEE9FC-8924-477B-97B0-C645B592E401}"/>
+                <a16:creationId xmlns:a16="http://schemas.microsoft.com/office/drawing/2014/main" id="{2BD90847-078E-40CB-B395-B301CA2944F3}"/>
               </a:ext>
             </a:extLst>
           </p:cNvPr>
@@ -5638,7 +5638,7 @@
           <p:cNvPr id="8" name="">
             <a:extLst xmlns:a="http://schemas.openxmlformats.org/drawingml/2006/main">
               <a:ext uri="{FF2B5EF4-FFF2-40B4-BE49-F238E27FC236}">
-                <a16:creationId xmlns:a16="http://schemas.microsoft.com/office/drawing/2014/main" id="{9F71BB6C-E0CF-4F1A-9792-764B0A32F084}"/>
+                <a16:creationId xmlns:a16="http://schemas.microsoft.com/office/drawing/2014/main" id="{170AD82A-D1B4-4CDE-B6BC-51EF5CE34FEA}"/>
               </a:ext>
             </a:extLst>
           </p:cNvPr>
@@ -5673,7 +5673,7 @@
           <p:cNvPr id="9" name="">
             <a:extLst xmlns:a="http://schemas.openxmlformats.org/drawingml/2006/main">
               <a:ext uri="{FF2B5EF4-FFF2-40B4-BE49-F238E27FC236}">
-                <a16:creationId xmlns:a16="http://schemas.microsoft.com/office/drawing/2014/main" id="{9D9F70B2-8F33-4A00-82E3-674903D7BB20}"/>
+                <a16:creationId xmlns:a16="http://schemas.microsoft.com/office/drawing/2014/main" id="{28E84F62-73B5-40D7-A8C6-040CDD56BB8D}"/>
               </a:ext>
             </a:extLst>
           </p:cNvPr>
@@ -5737,7 +5737,7 @@
           <p:cNvPr id="10" name="">
             <a:extLst xmlns:a="http://schemas.openxmlformats.org/drawingml/2006/main">
               <a:ext uri="{FF2B5EF4-FFF2-40B4-BE49-F238E27FC236}">
-                <a16:creationId xmlns:a16="http://schemas.microsoft.com/office/drawing/2014/main" id="{710B73F4-4A83-4123-88C3-6D7B299968D5}"/>
+                <a16:creationId xmlns:a16="http://schemas.microsoft.com/office/drawing/2014/main" id="{7F9293CC-640B-4084-A971-D8D46B612EF2}"/>
               </a:ext>
             </a:extLst>
           </p:cNvPr>
@@ -5801,7 +5801,7 @@
           <p:cNvPr id="11" name="">
             <a:extLst xmlns:a="http://schemas.openxmlformats.org/drawingml/2006/main">
               <a:ext uri="{FF2B5EF4-FFF2-40B4-BE49-F238E27FC236}">
-                <a16:creationId xmlns:a16="http://schemas.microsoft.com/office/drawing/2014/main" id="{C0FCD1B7-059C-45C5-B168-E967A8308A7A}"/>
+                <a16:creationId xmlns:a16="http://schemas.microsoft.com/office/drawing/2014/main" id="{1E2430EF-059E-4138-BAC1-AB7EC847F104}"/>
               </a:ext>
             </a:extLst>
           </p:cNvPr>
@@ -5865,7 +5865,7 @@
           <p:cNvPr id="12" name="">
             <a:extLst xmlns:a="http://schemas.openxmlformats.org/drawingml/2006/main">
               <a:ext uri="{FF2B5EF4-FFF2-40B4-BE49-F238E27FC236}">
-                <a16:creationId xmlns:a16="http://schemas.microsoft.com/office/drawing/2014/main" id="{9F6048F3-650E-4F26-9D79-BB7C4A699E2F}"/>
+                <a16:creationId xmlns:a16="http://schemas.microsoft.com/office/drawing/2014/main" id="{A86B9517-F879-463E-AEDF-E8B6BF2681FC}"/>
               </a:ext>
             </a:extLst>
           </p:cNvPr>
@@ -5900,7 +5900,7 @@
           <p:cNvPr id="13" name="">
             <a:extLst xmlns:a="http://schemas.openxmlformats.org/drawingml/2006/main">
               <a:ext uri="{FF2B5EF4-FFF2-40B4-BE49-F238E27FC236}">
-                <a16:creationId xmlns:a16="http://schemas.microsoft.com/office/drawing/2014/main" id="{0834273A-5E2B-42FD-BAE4-6A082F9289AF}"/>
+                <a16:creationId xmlns:a16="http://schemas.microsoft.com/office/drawing/2014/main" id="{6C8ABEA9-1982-41AF-95CB-1BE34E11AB59}"/>
               </a:ext>
             </a:extLst>
           </p:cNvPr>
@@ -5964,7 +5964,7 @@
           <p:cNvPr id="14" name="">
             <a:extLst xmlns:a="http://schemas.openxmlformats.org/drawingml/2006/main">
               <a:ext uri="{FF2B5EF4-FFF2-40B4-BE49-F238E27FC236}">
-                <a16:creationId xmlns:a16="http://schemas.microsoft.com/office/drawing/2014/main" id="{4C5BA3B2-746F-4364-B465-6D8DFE71DA65}"/>
+                <a16:creationId xmlns:a16="http://schemas.microsoft.com/office/drawing/2014/main" id="{1115E886-905F-4353-B2EB-A1438F66A7B8}"/>
               </a:ext>
             </a:extLst>
           </p:cNvPr>
@@ -5997,7 +5997,7 @@
           <p:cNvPr id="15" name="">
             <a:extLst xmlns:a="http://schemas.openxmlformats.org/drawingml/2006/main">
               <a:ext uri="{FF2B5EF4-FFF2-40B4-BE49-F238E27FC236}">
-                <a16:creationId xmlns:a16="http://schemas.microsoft.com/office/drawing/2014/main" id="{C2C5785D-BA78-4EA2-BCDA-637DAF060660}"/>
+                <a16:creationId xmlns:a16="http://schemas.microsoft.com/office/drawing/2014/main" id="{B2B89E14-2C8E-4044-A118-0F5B18FBFF9B}"/>
               </a:ext>
             </a:extLst>
           </p:cNvPr>
@@ -6032,7 +6032,7 @@
           <p:cNvPr id="16" name="">
             <a:extLst xmlns:a="http://schemas.openxmlformats.org/drawingml/2006/main">
               <a:ext uri="{FF2B5EF4-FFF2-40B4-BE49-F238E27FC236}">
-                <a16:creationId xmlns:a16="http://schemas.microsoft.com/office/drawing/2014/main" id="{9C5EF409-5368-40AC-87CA-DA2DA7922E26}"/>
+                <a16:creationId xmlns:a16="http://schemas.microsoft.com/office/drawing/2014/main" id="{F9A2D257-8684-4B81-8E05-03F6581E557C}"/>
               </a:ext>
             </a:extLst>
           </p:cNvPr>
@@ -6096,7 +6096,7 @@
           <p:cNvPr id="17" name="">
             <a:extLst xmlns:a="http://schemas.openxmlformats.org/drawingml/2006/main">
               <a:ext uri="{FF2B5EF4-FFF2-40B4-BE49-F238E27FC236}">
-                <a16:creationId xmlns:a16="http://schemas.microsoft.com/office/drawing/2014/main" id="{0F9059F1-646C-43D9-AD95-ADF9AACBD674}"/>
+                <a16:creationId xmlns:a16="http://schemas.microsoft.com/office/drawing/2014/main" id="{9BFC6887-229D-4D1A-AD16-C4DC84372DB6}"/>
               </a:ext>
             </a:extLst>
           </p:cNvPr>
@@ -6160,7 +6160,7 @@
           <p:cNvPr id="18" name="">
             <a:extLst xmlns:a="http://schemas.openxmlformats.org/drawingml/2006/main">
               <a:ext uri="{FF2B5EF4-FFF2-40B4-BE49-F238E27FC236}">
-                <a16:creationId xmlns:a16="http://schemas.microsoft.com/office/drawing/2014/main" id="{420CD658-392C-415D-ABAB-78B770D5DE2D}"/>
+                <a16:creationId xmlns:a16="http://schemas.microsoft.com/office/drawing/2014/main" id="{EC49D484-E618-42F5-A808-B314C9B326D5}"/>
               </a:ext>
             </a:extLst>
           </p:cNvPr>
@@ -6224,7 +6224,7 @@
           <p:cNvPr id="19" name="">
             <a:extLst xmlns:a="http://schemas.openxmlformats.org/drawingml/2006/main">
               <a:ext uri="{FF2B5EF4-FFF2-40B4-BE49-F238E27FC236}">
-                <a16:creationId xmlns:a16="http://schemas.microsoft.com/office/drawing/2014/main" id="{E3B01ABB-C4F6-409C-B049-FED8177079F5}"/>
+                <a16:creationId xmlns:a16="http://schemas.microsoft.com/office/drawing/2014/main" id="{63733F5A-ACE2-4168-9596-175BB1093B01}"/>
               </a:ext>
             </a:extLst>
           </p:cNvPr>
@@ -6259,7 +6259,7 @@
           <p:cNvPr id="20" name="">
             <a:extLst xmlns:a="http://schemas.openxmlformats.org/drawingml/2006/main">
               <a:ext uri="{FF2B5EF4-FFF2-40B4-BE49-F238E27FC236}">
-                <a16:creationId xmlns:a16="http://schemas.microsoft.com/office/drawing/2014/main" id="{0DE5D92C-E6C2-4115-97DB-63ADC0F2AD06}"/>
+                <a16:creationId xmlns:a16="http://schemas.microsoft.com/office/drawing/2014/main" id="{E01F7F7F-5D0C-4A33-91F0-A76793168ED4}"/>
               </a:ext>
             </a:extLst>
           </p:cNvPr>
@@ -6323,7 +6323,7 @@
           <p:cNvPr id="21" name="">
             <a:extLst xmlns:a="http://schemas.openxmlformats.org/drawingml/2006/main">
               <a:ext uri="{FF2B5EF4-FFF2-40B4-BE49-F238E27FC236}">
-                <a16:creationId xmlns:a16="http://schemas.microsoft.com/office/drawing/2014/main" id="{69567555-364C-435B-8841-28AEA07362AB}"/>
+                <a16:creationId xmlns:a16="http://schemas.microsoft.com/office/drawing/2014/main" id="{59ED7F09-97E2-4DB7-AF0F-E9270A431995}"/>
               </a:ext>
             </a:extLst>
           </p:cNvPr>
@@ -6356,7 +6356,7 @@
           <p:cNvPr id="22" name="">
             <a:extLst xmlns:a="http://schemas.openxmlformats.org/drawingml/2006/main">
               <a:ext uri="{FF2B5EF4-FFF2-40B4-BE49-F238E27FC236}">
-                <a16:creationId xmlns:a16="http://schemas.microsoft.com/office/drawing/2014/main" id="{F85B2523-6D70-44B0-9E71-CC9D5D33B198}"/>
+                <a16:creationId xmlns:a16="http://schemas.microsoft.com/office/drawing/2014/main" id="{DCE93AB9-0622-42FC-AF4F-86AE510DCB61}"/>
               </a:ext>
             </a:extLst>
           </p:cNvPr>
@@ -6391,7 +6391,7 @@
           <p:cNvPr id="23" name="">
             <a:extLst xmlns:a="http://schemas.openxmlformats.org/drawingml/2006/main">
               <a:ext uri="{FF2B5EF4-FFF2-40B4-BE49-F238E27FC236}">
-                <a16:creationId xmlns:a16="http://schemas.microsoft.com/office/drawing/2014/main" id="{421A7620-1B82-48FF-8395-9C42CFCF86A1}"/>
+                <a16:creationId xmlns:a16="http://schemas.microsoft.com/office/drawing/2014/main" id="{3513E38E-F584-4632-BE66-1333C4F23ECD}"/>
               </a:ext>
             </a:extLst>
           </p:cNvPr>
@@ -6455,7 +6455,7 @@
           <p:cNvPr id="24" name="">
             <a:extLst xmlns:a="http://schemas.openxmlformats.org/drawingml/2006/main">
               <a:ext uri="{FF2B5EF4-FFF2-40B4-BE49-F238E27FC236}">
-                <a16:creationId xmlns:a16="http://schemas.microsoft.com/office/drawing/2014/main" id="{2122D7B8-ED95-41F6-BE50-FC7A875EBF7F}"/>
+                <a16:creationId xmlns:a16="http://schemas.microsoft.com/office/drawing/2014/main" id="{EF0EB925-061F-4CFE-AF10-1565C7817C39}"/>
               </a:ext>
             </a:extLst>
           </p:cNvPr>
@@ -6519,7 +6519,7 @@
           <p:cNvPr id="25" name="">
             <a:extLst xmlns:a="http://schemas.openxmlformats.org/drawingml/2006/main">
               <a:ext uri="{FF2B5EF4-FFF2-40B4-BE49-F238E27FC236}">
-                <a16:creationId xmlns:a16="http://schemas.microsoft.com/office/drawing/2014/main" id="{EA41BA3F-8A60-480E-ACC4-4526F02EAB7D}"/>
+                <a16:creationId xmlns:a16="http://schemas.microsoft.com/office/drawing/2014/main" id="{814CCE94-F3E2-428C-A566-F68D1614DE42}"/>
               </a:ext>
             </a:extLst>
           </p:cNvPr>
@@ -6583,7 +6583,7 @@
           <p:cNvPr id="26" name="">
             <a:extLst xmlns:a="http://schemas.openxmlformats.org/drawingml/2006/main">
               <a:ext uri="{FF2B5EF4-FFF2-40B4-BE49-F238E27FC236}">
-                <a16:creationId xmlns:a16="http://schemas.microsoft.com/office/drawing/2014/main" id="{30F72CC3-1562-4AD4-B2C6-C6CF7FA3976C}"/>
+                <a16:creationId xmlns:a16="http://schemas.microsoft.com/office/drawing/2014/main" id="{E8D51D38-D204-45A9-A222-2C7542540B8F}"/>
               </a:ext>
             </a:extLst>
           </p:cNvPr>
@@ -6618,7 +6618,7 @@
           <p:cNvPr id="27" name="">
             <a:extLst xmlns:a="http://schemas.openxmlformats.org/drawingml/2006/main">
               <a:ext uri="{FF2B5EF4-FFF2-40B4-BE49-F238E27FC236}">
-                <a16:creationId xmlns:a16="http://schemas.microsoft.com/office/drawing/2014/main" id="{BBA22E42-1B3D-409D-BD4C-C30B4054D6BD}"/>
+                <a16:creationId xmlns:a16="http://schemas.microsoft.com/office/drawing/2014/main" id="{DE1B5458-C4A7-4FEA-8C43-52422C9EB8CB}"/>
               </a:ext>
             </a:extLst>
           </p:cNvPr>
@@ -6682,7 +6682,7 @@
           <p:cNvPr id="28" name="">
             <a:extLst xmlns:a="http://schemas.openxmlformats.org/drawingml/2006/main">
               <a:ext uri="{FF2B5EF4-FFF2-40B4-BE49-F238E27FC236}">
-                <a16:creationId xmlns:a16="http://schemas.microsoft.com/office/drawing/2014/main" id="{DBE51968-48E6-4272-9A76-EC9C766FA923}"/>
+                <a16:creationId xmlns:a16="http://schemas.microsoft.com/office/drawing/2014/main" id="{C701DDB6-7429-43AC-AC0E-540C0BCB1D53}"/>
               </a:ext>
             </a:extLst>
           </p:cNvPr>
@@ -6715,7 +6715,7 @@
           <p:cNvPr id="29" name="">
             <a:extLst xmlns:a="http://schemas.openxmlformats.org/drawingml/2006/main">
               <a:ext uri="{FF2B5EF4-FFF2-40B4-BE49-F238E27FC236}">
-                <a16:creationId xmlns:a16="http://schemas.microsoft.com/office/drawing/2014/main" id="{7368D8D4-109A-48E8-BDA8-563AB67CDA02}"/>
+                <a16:creationId xmlns:a16="http://schemas.microsoft.com/office/drawing/2014/main" id="{11604F0A-C855-4F29-9C38-BD5F6D6135FB}"/>
               </a:ext>
             </a:extLst>
           </p:cNvPr>
@@ -6750,7 +6750,7 @@
           <p:cNvPr id="30" name="">
             <a:extLst xmlns:a="http://schemas.openxmlformats.org/drawingml/2006/main">
               <a:ext uri="{FF2B5EF4-FFF2-40B4-BE49-F238E27FC236}">
-                <a16:creationId xmlns:a16="http://schemas.microsoft.com/office/drawing/2014/main" id="{0BBF3B85-4456-4E75-859D-04FAB8B6432E}"/>
+                <a16:creationId xmlns:a16="http://schemas.microsoft.com/office/drawing/2014/main" id="{0071A9FF-A8DF-4D32-82CF-89D7326EBF6E}"/>
               </a:ext>
             </a:extLst>
           </p:cNvPr>
@@ -6814,7 +6814,7 @@
           <p:cNvPr id="31" name="">
             <a:extLst xmlns:a="http://schemas.openxmlformats.org/drawingml/2006/main">
               <a:ext uri="{FF2B5EF4-FFF2-40B4-BE49-F238E27FC236}">
-                <a16:creationId xmlns:a16="http://schemas.microsoft.com/office/drawing/2014/main" id="{AD32D5E3-70BD-464F-B374-45BDAC2EED5C}"/>
+                <a16:creationId xmlns:a16="http://schemas.microsoft.com/office/drawing/2014/main" id="{A14F370B-80F6-4272-91DF-929A3F15C725}"/>
               </a:ext>
             </a:extLst>
           </p:cNvPr>
@@ -6878,7 +6878,7 @@
           <p:cNvPr id="32" name="">
             <a:extLst xmlns:a="http://schemas.openxmlformats.org/drawingml/2006/main">
               <a:ext uri="{FF2B5EF4-FFF2-40B4-BE49-F238E27FC236}">
-                <a16:creationId xmlns:a16="http://schemas.microsoft.com/office/drawing/2014/main" id="{BF56768D-8331-47B5-8CF8-F8A0E658F92B}"/>
+                <a16:creationId xmlns:a16="http://schemas.microsoft.com/office/drawing/2014/main" id="{DBCE230E-2116-40D8-ADD3-51E3B68F31F9}"/>
               </a:ext>
             </a:extLst>
           </p:cNvPr>
@@ -6942,7 +6942,7 @@
           <p:cNvPr id="33" name="">
             <a:extLst xmlns:a="http://schemas.openxmlformats.org/drawingml/2006/main">
               <a:ext uri="{FF2B5EF4-FFF2-40B4-BE49-F238E27FC236}">
-                <a16:creationId xmlns:a16="http://schemas.microsoft.com/office/drawing/2014/main" id="{3E9D7877-FB95-498D-B0EF-23CFCE2A1DA4}"/>
+                <a16:creationId xmlns:a16="http://schemas.microsoft.com/office/drawing/2014/main" id="{553AD032-C974-4657-9BC4-A11813EBED1A}"/>
               </a:ext>
             </a:extLst>
           </p:cNvPr>
@@ -6975,7 +6975,7 @@
           <p:cNvPr id="34" name="">
             <a:extLst xmlns:a="http://schemas.openxmlformats.org/drawingml/2006/main">
               <a:ext uri="{FF2B5EF4-FFF2-40B4-BE49-F238E27FC236}">
-                <a16:creationId xmlns:a16="http://schemas.microsoft.com/office/drawing/2014/main" id="{CE96A1F4-DAB9-4F8E-BFED-90BD46325248}"/>
+                <a16:creationId xmlns:a16="http://schemas.microsoft.com/office/drawing/2014/main" id="{FBF11E45-226E-46F7-90E4-05F8FA87E53C}"/>
               </a:ext>
             </a:extLst>
           </p:cNvPr>
@@ -7039,7 +7039,7 @@
           <p:cNvPr id="35" name="">
             <a:extLst xmlns:a="http://schemas.openxmlformats.org/drawingml/2006/main">
               <a:ext uri="{FF2B5EF4-FFF2-40B4-BE49-F238E27FC236}">
-                <a16:creationId xmlns:a16="http://schemas.microsoft.com/office/drawing/2014/main" id="{E3D86105-7A7B-4A35-AB83-E26B8066760E}"/>
+                <a16:creationId xmlns:a16="http://schemas.microsoft.com/office/drawing/2014/main" id="{D76F4E8C-3CC3-43CC-B31F-F1C747836A04}"/>
               </a:ext>
             </a:extLst>
           </p:cNvPr>
@@ -7103,7 +7103,7 @@
           <p:cNvPr id="36" name="">
             <a:extLst xmlns:a="http://schemas.openxmlformats.org/drawingml/2006/main">
               <a:ext uri="{FF2B5EF4-FFF2-40B4-BE49-F238E27FC236}">
-                <a16:creationId xmlns:a16="http://schemas.microsoft.com/office/drawing/2014/main" id="{472BED79-FC2B-4301-86D6-66ACCB743489}"/>
+                <a16:creationId xmlns:a16="http://schemas.microsoft.com/office/drawing/2014/main" id="{25EB7EAB-8CBD-4E56-BD40-3E9BFB32EBCA}"/>
               </a:ext>
             </a:extLst>
           </p:cNvPr>
@@ -7138,7 +7138,7 @@
           <p:cNvPr id="37" name="">
             <a:extLst xmlns:a="http://schemas.openxmlformats.org/drawingml/2006/main">
               <a:ext uri="{FF2B5EF4-FFF2-40B4-BE49-F238E27FC236}">
-                <a16:creationId xmlns:a16="http://schemas.microsoft.com/office/drawing/2014/main" id="{E4A5C5E8-EB00-478E-A6DC-FAA26329317C}"/>
+                <a16:creationId xmlns:a16="http://schemas.microsoft.com/office/drawing/2014/main" id="{6DAEE695-3750-4F25-8425-36A7033B234D}"/>
               </a:ext>
             </a:extLst>
           </p:cNvPr>
@@ -7202,7 +7202,7 @@
           <p:cNvPr id="38" name="">
             <a:extLst xmlns:a="http://schemas.openxmlformats.org/drawingml/2006/main">
               <a:ext uri="{FF2B5EF4-FFF2-40B4-BE49-F238E27FC236}">
-                <a16:creationId xmlns:a16="http://schemas.microsoft.com/office/drawing/2014/main" id="{B90841DC-C399-4AC2-8B74-6F23A3C4A5DA}"/>
+                <a16:creationId xmlns:a16="http://schemas.microsoft.com/office/drawing/2014/main" id="{0A42B2A1-2517-4CA5-978A-F42FD1AE6D48}"/>
               </a:ext>
             </a:extLst>
           </p:cNvPr>
@@ -7264,7 +7264,7 @@
     </p:spTree>
     <p:extLst>
       <p:ext uri="{BB962C8B-B14F-4D97-AF65-F5344CB8AC3E}">
-        <p14:creationId xmlns:p14="http://schemas.microsoft.com/office/powerpoint/2010/main" val="2001463233"/>
+        <p14:creationId xmlns:p14="http://schemas.microsoft.com/office/powerpoint/2010/main" val="2058950338"/>
       </p:ext>
     </p:extLst>
   </p:cSld>
@@ -7288,7 +7288,7 @@
           <p:cNvPr id="1" name="">
             <a:extLst xmlns:a="http://schemas.openxmlformats.org/drawingml/2006/main">
               <a:ext uri="{FF2B5EF4-FFF2-40B4-BE49-F238E27FC236}">
-                <a16:creationId xmlns:a16="http://schemas.microsoft.com/office/drawing/2014/main" id="{E4BEEA15-9E18-476D-B9DF-AE87EDF77C69}"/>
+                <a16:creationId xmlns:a16="http://schemas.microsoft.com/office/drawing/2014/main" id="{36A2CED7-125C-43AA-AE31-D9A1424104FC}"/>
               </a:ext>
             </a:extLst>
           </p:cNvPr>
@@ -7323,7 +7323,7 @@
           <p:cNvPr id="2" name="">
             <a:extLst xmlns:a="http://schemas.openxmlformats.org/drawingml/2006/main">
               <a:ext uri="{FF2B5EF4-FFF2-40B4-BE49-F238E27FC236}">
-                <a16:creationId xmlns:a16="http://schemas.microsoft.com/office/drawing/2014/main" id="{75ACD2D9-D607-4C26-B018-7FF4FDCC00BF}"/>
+                <a16:creationId xmlns:a16="http://schemas.microsoft.com/office/drawing/2014/main" id="{99AA1713-1CB3-4D92-8C08-069856027A63}"/>
               </a:ext>
             </a:extLst>
           </p:cNvPr>
@@ -7358,7 +7358,7 @@
           <p:cNvPr id="3" name="">
             <a:extLst xmlns:a="http://schemas.openxmlformats.org/drawingml/2006/main">
               <a:ext uri="{FF2B5EF4-FFF2-40B4-BE49-F238E27FC236}">
-                <a16:creationId xmlns:a16="http://schemas.microsoft.com/office/drawing/2014/main" id="{838D6D5D-5787-41AB-9BB9-61D99B6DA831}"/>
+                <a16:creationId xmlns:a16="http://schemas.microsoft.com/office/drawing/2014/main" id="{6F100519-AABC-4E1E-B690-BBD67DB0B196}"/>
               </a:ext>
             </a:extLst>
           </p:cNvPr>
@@ -7422,7 +7422,7 @@
           <p:cNvPr id="4" name="">
             <a:extLst xmlns:a="http://schemas.openxmlformats.org/drawingml/2006/main">
               <a:ext uri="{FF2B5EF4-FFF2-40B4-BE49-F238E27FC236}">
-                <a16:creationId xmlns:a16="http://schemas.microsoft.com/office/drawing/2014/main" id="{0E909062-1B52-46F0-93B4-293D19F56C97}"/>
+                <a16:creationId xmlns:a16="http://schemas.microsoft.com/office/drawing/2014/main" id="{09F2416E-F695-428E-A7A7-632D74A4D1ED}"/>
               </a:ext>
             </a:extLst>
           </p:cNvPr>
@@ -7486,7 +7486,7 @@
           <p:cNvPr id="5" name="">
             <a:extLst xmlns:a="http://schemas.openxmlformats.org/drawingml/2006/main">
               <a:ext uri="{FF2B5EF4-FFF2-40B4-BE49-F238E27FC236}">
-                <a16:creationId xmlns:a16="http://schemas.microsoft.com/office/drawing/2014/main" id="{F33228B0-9B8D-48A2-9FC3-ABC4CA424014}"/>
+                <a16:creationId xmlns:a16="http://schemas.microsoft.com/office/drawing/2014/main" id="{48E6F1F5-E904-40A6-BFC9-1057F751C390}"/>
               </a:ext>
             </a:extLst>
           </p:cNvPr>
@@ -7550,7 +7550,7 @@
           <p:cNvPr id="6" name="">
             <a:extLst xmlns:a="http://schemas.openxmlformats.org/drawingml/2006/main">
               <a:ext uri="{FF2B5EF4-FFF2-40B4-BE49-F238E27FC236}">
-                <a16:creationId xmlns:a16="http://schemas.microsoft.com/office/drawing/2014/main" id="{55EFFCB5-C43A-458F-BDC5-3639069FC363}"/>
+                <a16:creationId xmlns:a16="http://schemas.microsoft.com/office/drawing/2014/main" id="{FBAE0C0A-DE44-4D9C-A6B3-8766F549D864}"/>
               </a:ext>
             </a:extLst>
           </p:cNvPr>
@@ -7614,7 +7614,7 @@
           <p:cNvPr id="7" name="">
             <a:extLst xmlns:a="http://schemas.openxmlformats.org/drawingml/2006/main">
               <a:ext uri="{FF2B5EF4-FFF2-40B4-BE49-F238E27FC236}">
-                <a16:creationId xmlns:a16="http://schemas.microsoft.com/office/drawing/2014/main" id="{065CA7FC-B216-48AD-B274-57525A603935}"/>
+                <a16:creationId xmlns:a16="http://schemas.microsoft.com/office/drawing/2014/main" id="{5DF6C3EC-0E84-4004-9502-F5245F8F3B58}"/>
               </a:ext>
             </a:extLst>
           </p:cNvPr>
@@ -7678,7 +7678,7 @@
           <p:cNvPr id="8" name="">
             <a:extLst xmlns:a="http://schemas.openxmlformats.org/drawingml/2006/main">
               <a:ext uri="{FF2B5EF4-FFF2-40B4-BE49-F238E27FC236}">
-                <a16:creationId xmlns:a16="http://schemas.microsoft.com/office/drawing/2014/main" id="{DB08810C-F3F4-4E81-AD68-2AACD63E17B8}"/>
+                <a16:creationId xmlns:a16="http://schemas.microsoft.com/office/drawing/2014/main" id="{153A73B2-AB68-4AA6-AC4A-F53B11034D9C}"/>
               </a:ext>
             </a:extLst>
           </p:cNvPr>
@@ -7742,7 +7742,7 @@
           <p:cNvPr id="9" name="">
             <a:extLst xmlns:a="http://schemas.openxmlformats.org/drawingml/2006/main">
               <a:ext uri="{FF2B5EF4-FFF2-40B4-BE49-F238E27FC236}">
-                <a16:creationId xmlns:a16="http://schemas.microsoft.com/office/drawing/2014/main" id="{E21BC810-7FFA-44CB-904C-8E0ACD843B69}"/>
+                <a16:creationId xmlns:a16="http://schemas.microsoft.com/office/drawing/2014/main" id="{824A0F8B-3783-4CA4-98E4-A49C2FAA5F17}"/>
               </a:ext>
             </a:extLst>
           </p:cNvPr>
@@ -7806,7 +7806,7 @@
           <p:cNvPr id="10" name="">
             <a:extLst xmlns:a="http://schemas.openxmlformats.org/drawingml/2006/main">
               <a:ext uri="{FF2B5EF4-FFF2-40B4-BE49-F238E27FC236}">
-                <a16:creationId xmlns:a16="http://schemas.microsoft.com/office/drawing/2014/main" id="{C7CAA268-7F1B-4315-9AC4-109C1AAD355C}"/>
+                <a16:creationId xmlns:a16="http://schemas.microsoft.com/office/drawing/2014/main" id="{8099F762-CD18-47E2-840C-9531BF397FAC}"/>
               </a:ext>
             </a:extLst>
           </p:cNvPr>
@@ -7841,7 +7841,7 @@
           <p:cNvPr id="11" name="">
             <a:extLst xmlns:a="http://schemas.openxmlformats.org/drawingml/2006/main">
               <a:ext uri="{FF2B5EF4-FFF2-40B4-BE49-F238E27FC236}">
-                <a16:creationId xmlns:a16="http://schemas.microsoft.com/office/drawing/2014/main" id="{1ABB3119-E030-4E10-9A65-FF902255872E}"/>
+                <a16:creationId xmlns:a16="http://schemas.microsoft.com/office/drawing/2014/main" id="{8BBCDD43-C618-4C3F-A080-686CBF7E3BFD}"/>
               </a:ext>
             </a:extLst>
           </p:cNvPr>
@@ -7905,7 +7905,7 @@
           <p:cNvPr id="12" name="">
             <a:extLst xmlns:a="http://schemas.openxmlformats.org/drawingml/2006/main">
               <a:ext uri="{FF2B5EF4-FFF2-40B4-BE49-F238E27FC236}">
-                <a16:creationId xmlns:a16="http://schemas.microsoft.com/office/drawing/2014/main" id="{CFC84BDB-CDA8-45D9-B240-17FB8B27A887}"/>
+                <a16:creationId xmlns:a16="http://schemas.microsoft.com/office/drawing/2014/main" id="{B7B87592-C100-47E2-9999-0BB9754AFC21}"/>
               </a:ext>
             </a:extLst>
           </p:cNvPr>
@@ -7969,7 +7969,7 @@
           <p:cNvPr id="13" name="">
             <a:extLst xmlns:a="http://schemas.openxmlformats.org/drawingml/2006/main">
               <a:ext uri="{FF2B5EF4-FFF2-40B4-BE49-F238E27FC236}">
-                <a16:creationId xmlns:a16="http://schemas.microsoft.com/office/drawing/2014/main" id="{AEC31EA8-5182-401C-8614-BF031BC671DC}"/>
+                <a16:creationId xmlns:a16="http://schemas.microsoft.com/office/drawing/2014/main" id="{D15A1224-B699-4DC3-BECB-0C0375F9FBCB}"/>
               </a:ext>
             </a:extLst>
           </p:cNvPr>
@@ -8033,7 +8033,7 @@
           <p:cNvPr id="14" name="">
             <a:extLst xmlns:a="http://schemas.openxmlformats.org/drawingml/2006/main">
               <a:ext uri="{FF2B5EF4-FFF2-40B4-BE49-F238E27FC236}">
-                <a16:creationId xmlns:a16="http://schemas.microsoft.com/office/drawing/2014/main" id="{80507344-9DEA-40FB-99E7-1E85BD3BC128}"/>
+                <a16:creationId xmlns:a16="http://schemas.microsoft.com/office/drawing/2014/main" id="{249738D7-E03E-47E4-B3AD-CDD8A9D5A970}"/>
               </a:ext>
             </a:extLst>
           </p:cNvPr>
@@ -8068,7 +8068,7 @@
           <p:cNvPr id="15" name="">
             <a:extLst xmlns:a="http://schemas.openxmlformats.org/drawingml/2006/main">
               <a:ext uri="{FF2B5EF4-FFF2-40B4-BE49-F238E27FC236}">
-                <a16:creationId xmlns:a16="http://schemas.microsoft.com/office/drawing/2014/main" id="{AF8FA95F-2392-41B4-8A62-2C16DFF25B21}"/>
+                <a16:creationId xmlns:a16="http://schemas.microsoft.com/office/drawing/2014/main" id="{9C0D1C13-478A-442E-AB21-5EA78F0DBD7D}"/>
               </a:ext>
             </a:extLst>
           </p:cNvPr>
@@ -8132,7 +8132,7 @@
           <p:cNvPr id="16" name="">
             <a:extLst xmlns:a="http://schemas.openxmlformats.org/drawingml/2006/main">
               <a:ext uri="{FF2B5EF4-FFF2-40B4-BE49-F238E27FC236}">
-                <a16:creationId xmlns:a16="http://schemas.microsoft.com/office/drawing/2014/main" id="{23B16295-FC55-4381-AB2A-48FC1BA55B54}"/>
+                <a16:creationId xmlns:a16="http://schemas.microsoft.com/office/drawing/2014/main" id="{865FB1AC-F364-45B5-B1A6-123975E81206}"/>
               </a:ext>
             </a:extLst>
           </p:cNvPr>
@@ -8196,7 +8196,7 @@
           <p:cNvPr id="17" name="">
             <a:extLst xmlns:a="http://schemas.openxmlformats.org/drawingml/2006/main">
               <a:ext uri="{FF2B5EF4-FFF2-40B4-BE49-F238E27FC236}">
-                <a16:creationId xmlns:a16="http://schemas.microsoft.com/office/drawing/2014/main" id="{BE8E9CF9-DACB-4527-99AC-E89DED6D4C8A}"/>
+                <a16:creationId xmlns:a16="http://schemas.microsoft.com/office/drawing/2014/main" id="{DBF29384-A4DA-4B25-ABB9-C29E96127B4A}"/>
               </a:ext>
             </a:extLst>
           </p:cNvPr>
@@ -8260,7 +8260,7 @@
           <p:cNvPr id="18" name="">
             <a:extLst xmlns:a="http://schemas.openxmlformats.org/drawingml/2006/main">
               <a:ext uri="{FF2B5EF4-FFF2-40B4-BE49-F238E27FC236}">
-                <a16:creationId xmlns:a16="http://schemas.microsoft.com/office/drawing/2014/main" id="{3A9807B8-0D1B-4F79-A227-3753D9ED512C}"/>
+                <a16:creationId xmlns:a16="http://schemas.microsoft.com/office/drawing/2014/main" id="{8A9BB4D3-6CA9-46CE-AE62-772BA7F5AC29}"/>
               </a:ext>
             </a:extLst>
           </p:cNvPr>
@@ -8295,7 +8295,7 @@
           <p:cNvPr id="19" name="">
             <a:extLst xmlns:a="http://schemas.openxmlformats.org/drawingml/2006/main">
               <a:ext uri="{FF2B5EF4-FFF2-40B4-BE49-F238E27FC236}">
-                <a16:creationId xmlns:a16="http://schemas.microsoft.com/office/drawing/2014/main" id="{D4D660CF-A806-4548-8967-CE04409CED62}"/>
+                <a16:creationId xmlns:a16="http://schemas.microsoft.com/office/drawing/2014/main" id="{A0650004-81EA-413F-BAA5-5C1128970330}"/>
               </a:ext>
             </a:extLst>
           </p:cNvPr>
@@ -8359,7 +8359,7 @@
           <p:cNvPr id="20" name="">
             <a:extLst xmlns:a="http://schemas.openxmlformats.org/drawingml/2006/main">
               <a:ext uri="{FF2B5EF4-FFF2-40B4-BE49-F238E27FC236}">
-                <a16:creationId xmlns:a16="http://schemas.microsoft.com/office/drawing/2014/main" id="{7F1261E3-5EF9-435B-B7CD-AC152271E37B}"/>
+                <a16:creationId xmlns:a16="http://schemas.microsoft.com/office/drawing/2014/main" id="{261EC5E8-9ED7-4FBF-BE2A-4D1ED70C5208}"/>
               </a:ext>
             </a:extLst>
           </p:cNvPr>
@@ -8423,7 +8423,7 @@
           <p:cNvPr id="21" name="">
             <a:extLst xmlns:a="http://schemas.openxmlformats.org/drawingml/2006/main">
               <a:ext uri="{FF2B5EF4-FFF2-40B4-BE49-F238E27FC236}">
-                <a16:creationId xmlns:a16="http://schemas.microsoft.com/office/drawing/2014/main" id="{5719781A-C9D6-4356-8BB5-23254E2B7C6F}"/>
+                <a16:creationId xmlns:a16="http://schemas.microsoft.com/office/drawing/2014/main" id="{60DCC3B7-7BA2-4CFC-8DE8-EDB74177A308}"/>
               </a:ext>
             </a:extLst>
           </p:cNvPr>
@@ -8487,7 +8487,7 @@
           <p:cNvPr id="22" name="">
             <a:extLst xmlns:a="http://schemas.openxmlformats.org/drawingml/2006/main">
               <a:ext uri="{FF2B5EF4-FFF2-40B4-BE49-F238E27FC236}">
-                <a16:creationId xmlns:a16="http://schemas.microsoft.com/office/drawing/2014/main" id="{2B21DDBC-92BC-495E-A127-DB7EC456E955}"/>
+                <a16:creationId xmlns:a16="http://schemas.microsoft.com/office/drawing/2014/main" id="{2BF2AAFE-E736-4398-82C9-50B7D8AFC15E}"/>
               </a:ext>
             </a:extLst>
           </p:cNvPr>
@@ -8522,7 +8522,7 @@
           <p:cNvPr id="23" name="">
             <a:extLst xmlns:a="http://schemas.openxmlformats.org/drawingml/2006/main">
               <a:ext uri="{FF2B5EF4-FFF2-40B4-BE49-F238E27FC236}">
-                <a16:creationId xmlns:a16="http://schemas.microsoft.com/office/drawing/2014/main" id="{60BE823D-2F46-4C53-A5FC-9470979E8074}"/>
+                <a16:creationId xmlns:a16="http://schemas.microsoft.com/office/drawing/2014/main" id="{DC5C767E-C88D-4D35-ABB2-7F1B1B5FA3CC}"/>
               </a:ext>
             </a:extLst>
           </p:cNvPr>
@@ -8555,7 +8555,7 @@
           <p:cNvPr id="24" name="">
             <a:extLst xmlns:a="http://schemas.openxmlformats.org/drawingml/2006/main">
               <a:ext uri="{FF2B5EF4-FFF2-40B4-BE49-F238E27FC236}">
-                <a16:creationId xmlns:a16="http://schemas.microsoft.com/office/drawing/2014/main" id="{DAB10605-C8E5-4121-9CD2-5F4F19A3DC45}"/>
+                <a16:creationId xmlns:a16="http://schemas.microsoft.com/office/drawing/2014/main" id="{E1289C52-E6CB-4B4D-B9D0-7301A30E53F1}"/>
               </a:ext>
             </a:extLst>
           </p:cNvPr>
@@ -8619,7 +8619,7 @@
           <p:cNvPr id="25" name="">
             <a:extLst xmlns:a="http://schemas.openxmlformats.org/drawingml/2006/main">
               <a:ext uri="{FF2B5EF4-FFF2-40B4-BE49-F238E27FC236}">
-                <a16:creationId xmlns:a16="http://schemas.microsoft.com/office/drawing/2014/main" id="{AF5512F8-1007-4DF7-A49D-8DF080ECE322}"/>
+                <a16:creationId xmlns:a16="http://schemas.microsoft.com/office/drawing/2014/main" id="{8EF99FA9-A40D-45CD-AFD5-11382F33CA5F}"/>
               </a:ext>
             </a:extLst>
           </p:cNvPr>
@@ -8683,7 +8683,7 @@
           <p:cNvPr id="26" name="">
             <a:extLst xmlns:a="http://schemas.openxmlformats.org/drawingml/2006/main">
               <a:ext uri="{FF2B5EF4-FFF2-40B4-BE49-F238E27FC236}">
-                <a16:creationId xmlns:a16="http://schemas.microsoft.com/office/drawing/2014/main" id="{4BD039AA-9740-4926-8618-D7C5F3EB9DE4}"/>
+                <a16:creationId xmlns:a16="http://schemas.microsoft.com/office/drawing/2014/main" id="{34A31E06-E320-4A89-98B2-1C0B6AEB502A}"/>
               </a:ext>
             </a:extLst>
           </p:cNvPr>
@@ -8737,7 +8737,7 @@
                 <a:ea typeface="Aptos"/>
                 <a:cs typeface="Aptos"/>
               </a:rPr>
-              <a:t>Verified July 11, 2026: 182 Python and 131 Phoenix tests, zero failures.</a:t>
+              <a:t>Verified July 11, 2026: 184 Python and 132 Phoenix tests, zero failures.</a:t>
             </a:r>
           </a:p>
         </p:txBody>
@@ -8745,7 +8745,7 @@
     </p:spTree>
     <p:extLst>
       <p:ext uri="{BB962C8B-B14F-4D97-AF65-F5344CB8AC3E}">
-        <p14:creationId xmlns:p14="http://schemas.microsoft.com/office/powerpoint/2010/main" val="917204786"/>
+        <p14:creationId xmlns:p14="http://schemas.microsoft.com/office/powerpoint/2010/main" val="1908914169"/>
       </p:ext>
     </p:extLst>
   </p:cSld>
@@ -8769,7 +8769,7 @@
           <p:cNvPr id="1" name="">
             <a:extLst xmlns:a="http://schemas.openxmlformats.org/drawingml/2006/main">
               <a:ext uri="{FF2B5EF4-FFF2-40B4-BE49-F238E27FC236}">
-                <a16:creationId xmlns:a16="http://schemas.microsoft.com/office/drawing/2014/main" id="{CB48189E-B488-4C80-BF4B-EF52DAB5081B}"/>
+                <a16:creationId xmlns:a16="http://schemas.microsoft.com/office/drawing/2014/main" id="{65B1D0DD-6333-4E49-BF04-7C7B9E18DE41}"/>
               </a:ext>
             </a:extLst>
           </p:cNvPr>
@@ -8804,7 +8804,7 @@
           <p:cNvPr id="2" name="">
             <a:extLst xmlns:a="http://schemas.openxmlformats.org/drawingml/2006/main">
               <a:ext uri="{FF2B5EF4-FFF2-40B4-BE49-F238E27FC236}">
-                <a16:creationId xmlns:a16="http://schemas.microsoft.com/office/drawing/2014/main" id="{74170FAA-EC09-495E-B623-442B89B00A1D}"/>
+                <a16:creationId xmlns:a16="http://schemas.microsoft.com/office/drawing/2014/main" id="{B4711C6D-3A61-4307-B82E-E3BA53CEDC9A}"/>
               </a:ext>
             </a:extLst>
           </p:cNvPr>
@@ -8839,7 +8839,7 @@
           <p:cNvPr id="3" name="">
             <a:extLst xmlns:a="http://schemas.openxmlformats.org/drawingml/2006/main">
               <a:ext uri="{FF2B5EF4-FFF2-40B4-BE49-F238E27FC236}">
-                <a16:creationId xmlns:a16="http://schemas.microsoft.com/office/drawing/2014/main" id="{C6E796D7-5BB4-4898-914D-E7E8FE28E46B}"/>
+                <a16:creationId xmlns:a16="http://schemas.microsoft.com/office/drawing/2014/main" id="{915C3D01-D738-4AE8-BB61-ECD04A210B29}"/>
               </a:ext>
             </a:extLst>
           </p:cNvPr>
@@ -8903,7 +8903,7 @@
           <p:cNvPr id="4" name="">
             <a:extLst xmlns:a="http://schemas.openxmlformats.org/drawingml/2006/main">
               <a:ext uri="{FF2B5EF4-FFF2-40B4-BE49-F238E27FC236}">
-                <a16:creationId xmlns:a16="http://schemas.microsoft.com/office/drawing/2014/main" id="{30774634-B5D4-47C3-84B6-7108C492AFF0}"/>
+                <a16:creationId xmlns:a16="http://schemas.microsoft.com/office/drawing/2014/main" id="{A6BD9909-95A9-4223-A4A6-2126E7CCEA3E}"/>
               </a:ext>
             </a:extLst>
           </p:cNvPr>
@@ -8967,7 +8967,7 @@
           <p:cNvPr id="5" name="">
             <a:extLst xmlns:a="http://schemas.openxmlformats.org/drawingml/2006/main">
               <a:ext uri="{FF2B5EF4-FFF2-40B4-BE49-F238E27FC236}">
-                <a16:creationId xmlns:a16="http://schemas.microsoft.com/office/drawing/2014/main" id="{A6E969FA-CAA7-4D8B-AAD0-A67898177665}"/>
+                <a16:creationId xmlns:a16="http://schemas.microsoft.com/office/drawing/2014/main" id="{34EE3F62-F8FA-4244-9B3E-E699A82A49B3}"/>
               </a:ext>
             </a:extLst>
           </p:cNvPr>
@@ -9031,7 +9031,7 @@
           <p:cNvPr id="6" name="">
             <a:extLst xmlns:a="http://schemas.openxmlformats.org/drawingml/2006/main">
               <a:ext uri="{FF2B5EF4-FFF2-40B4-BE49-F238E27FC236}">
-                <a16:creationId xmlns:a16="http://schemas.microsoft.com/office/drawing/2014/main" id="{F159FF84-C244-44AF-A751-AA69909F5F42}"/>
+                <a16:creationId xmlns:a16="http://schemas.microsoft.com/office/drawing/2014/main" id="{71C08072-998B-4E17-8962-3E0969AC1BB4}"/>
               </a:ext>
             </a:extLst>
           </p:cNvPr>
@@ -9095,7 +9095,7 @@
           <p:cNvPr id="7" name="">
             <a:extLst xmlns:a="http://schemas.openxmlformats.org/drawingml/2006/main">
               <a:ext uri="{FF2B5EF4-FFF2-40B4-BE49-F238E27FC236}">
-                <a16:creationId xmlns:a16="http://schemas.microsoft.com/office/drawing/2014/main" id="{EBEDB741-A467-4021-A74D-9ED2A7AC9E88}"/>
+                <a16:creationId xmlns:a16="http://schemas.microsoft.com/office/drawing/2014/main" id="{56E2FE6B-EBEA-4D5F-879B-6F5C5E519B77}"/>
               </a:ext>
             </a:extLst>
           </p:cNvPr>
@@ -9128,7 +9128,7 @@
           <p:cNvPr id="8" name="">
             <a:extLst xmlns:a="http://schemas.openxmlformats.org/drawingml/2006/main">
               <a:ext uri="{FF2B5EF4-FFF2-40B4-BE49-F238E27FC236}">
-                <a16:creationId xmlns:a16="http://schemas.microsoft.com/office/drawing/2014/main" id="{1E4DD4E1-D13A-4C70-98C6-626689E9A517}"/>
+                <a16:creationId xmlns:a16="http://schemas.microsoft.com/office/drawing/2014/main" id="{BD1909FA-36B8-4023-BA06-25E3946CEC38}"/>
               </a:ext>
             </a:extLst>
           </p:cNvPr>
@@ -9192,7 +9192,7 @@
           <p:cNvPr id="9" name="">
             <a:extLst xmlns:a="http://schemas.openxmlformats.org/drawingml/2006/main">
               <a:ext uri="{FF2B5EF4-FFF2-40B4-BE49-F238E27FC236}">
-                <a16:creationId xmlns:a16="http://schemas.microsoft.com/office/drawing/2014/main" id="{636D16A4-09BE-4C33-961B-87B5E9C81049}"/>
+                <a16:creationId xmlns:a16="http://schemas.microsoft.com/office/drawing/2014/main" id="{6933DDBA-36B0-40BA-BA22-2186CEA48C67}"/>
               </a:ext>
             </a:extLst>
           </p:cNvPr>
@@ -9256,7 +9256,7 @@
           <p:cNvPr id="10" name="">
             <a:extLst xmlns:a="http://schemas.openxmlformats.org/drawingml/2006/main">
               <a:ext uri="{FF2B5EF4-FFF2-40B4-BE49-F238E27FC236}">
-                <a16:creationId xmlns:a16="http://schemas.microsoft.com/office/drawing/2014/main" id="{7C6AC8E1-4694-4949-9F23-6DDC1503B254}"/>
+                <a16:creationId xmlns:a16="http://schemas.microsoft.com/office/drawing/2014/main" id="{3D4D6A0F-DEE5-4C51-BC23-0148D592E5F9}"/>
               </a:ext>
             </a:extLst>
           </p:cNvPr>
@@ -9320,7 +9320,7 @@
           <p:cNvPr id="11" name="">
             <a:extLst xmlns:a="http://schemas.openxmlformats.org/drawingml/2006/main">
               <a:ext uri="{FF2B5EF4-FFF2-40B4-BE49-F238E27FC236}">
-                <a16:creationId xmlns:a16="http://schemas.microsoft.com/office/drawing/2014/main" id="{57424FF8-5809-46BC-81E4-2B6F6082896A}"/>
+                <a16:creationId xmlns:a16="http://schemas.microsoft.com/office/drawing/2014/main" id="{5512C86D-1ED2-4AFA-B5A6-A86582D8A099}"/>
               </a:ext>
             </a:extLst>
           </p:cNvPr>
@@ -9353,7 +9353,7 @@
           <p:cNvPr id="12" name="">
             <a:extLst xmlns:a="http://schemas.openxmlformats.org/drawingml/2006/main">
               <a:ext uri="{FF2B5EF4-FFF2-40B4-BE49-F238E27FC236}">
-                <a16:creationId xmlns:a16="http://schemas.microsoft.com/office/drawing/2014/main" id="{8A84F179-A39A-4B11-8F6D-1136ADC5E443}"/>
+                <a16:creationId xmlns:a16="http://schemas.microsoft.com/office/drawing/2014/main" id="{9D59F946-3D2C-4F23-9BB3-4FF76D803178}"/>
               </a:ext>
             </a:extLst>
           </p:cNvPr>
@@ -9417,7 +9417,7 @@
           <p:cNvPr id="13" name="">
             <a:extLst xmlns:a="http://schemas.openxmlformats.org/drawingml/2006/main">
               <a:ext uri="{FF2B5EF4-FFF2-40B4-BE49-F238E27FC236}">
-                <a16:creationId xmlns:a16="http://schemas.microsoft.com/office/drawing/2014/main" id="{F8B5D5A3-3ACD-4F42-9F44-7F429D8C20C3}"/>
+                <a16:creationId xmlns:a16="http://schemas.microsoft.com/office/drawing/2014/main" id="{A830E1CB-3DE3-4780-B502-E5992E2A43B9}"/>
               </a:ext>
             </a:extLst>
           </p:cNvPr>
@@ -9481,7 +9481,7 @@
           <p:cNvPr id="14" name="">
             <a:extLst xmlns:a="http://schemas.openxmlformats.org/drawingml/2006/main">
               <a:ext uri="{FF2B5EF4-FFF2-40B4-BE49-F238E27FC236}">
-                <a16:creationId xmlns:a16="http://schemas.microsoft.com/office/drawing/2014/main" id="{4CAA0BFC-26EF-4EF5-9503-254D817FCD28}"/>
+                <a16:creationId xmlns:a16="http://schemas.microsoft.com/office/drawing/2014/main" id="{25958EAD-BAEC-4EAA-B772-FA8A5AA90B22}"/>
               </a:ext>
             </a:extLst>
           </p:cNvPr>
@@ -9545,7 +9545,7 @@
           <p:cNvPr id="15" name="">
             <a:extLst xmlns:a="http://schemas.openxmlformats.org/drawingml/2006/main">
               <a:ext uri="{FF2B5EF4-FFF2-40B4-BE49-F238E27FC236}">
-                <a16:creationId xmlns:a16="http://schemas.microsoft.com/office/drawing/2014/main" id="{609B6D42-4265-41A5-9C23-C87C02A824FA}"/>
+                <a16:creationId xmlns:a16="http://schemas.microsoft.com/office/drawing/2014/main" id="{B6195254-E10E-42C4-B415-018FF8DCA510}"/>
               </a:ext>
             </a:extLst>
           </p:cNvPr>
@@ -9578,7 +9578,7 @@
           <p:cNvPr id="16" name="">
             <a:extLst xmlns:a="http://schemas.openxmlformats.org/drawingml/2006/main">
               <a:ext uri="{FF2B5EF4-FFF2-40B4-BE49-F238E27FC236}">
-                <a16:creationId xmlns:a16="http://schemas.microsoft.com/office/drawing/2014/main" id="{F1A64542-2349-46D4-9E4E-46B6B77D1F07}"/>
+                <a16:creationId xmlns:a16="http://schemas.microsoft.com/office/drawing/2014/main" id="{12F62A9D-7571-449F-9B9A-DE02FFD5CE7D}"/>
               </a:ext>
             </a:extLst>
           </p:cNvPr>
@@ -9642,7 +9642,7 @@
           <p:cNvPr id="17" name="">
             <a:extLst xmlns:a="http://schemas.openxmlformats.org/drawingml/2006/main">
               <a:ext uri="{FF2B5EF4-FFF2-40B4-BE49-F238E27FC236}">
-                <a16:creationId xmlns:a16="http://schemas.microsoft.com/office/drawing/2014/main" id="{838D1DA7-A20C-4F7E-919F-23B35A309E5E}"/>
+                <a16:creationId xmlns:a16="http://schemas.microsoft.com/office/drawing/2014/main" id="{7355FCE3-BEEB-41FD-9A12-E6C49C3B35D3}"/>
               </a:ext>
             </a:extLst>
           </p:cNvPr>
@@ -9706,7 +9706,7 @@
           <p:cNvPr id="18" name="">
             <a:extLst xmlns:a="http://schemas.openxmlformats.org/drawingml/2006/main">
               <a:ext uri="{FF2B5EF4-FFF2-40B4-BE49-F238E27FC236}">
-                <a16:creationId xmlns:a16="http://schemas.microsoft.com/office/drawing/2014/main" id="{D72CD289-86E9-4A09-9645-D9E7B300A4CD}"/>
+                <a16:creationId xmlns:a16="http://schemas.microsoft.com/office/drawing/2014/main" id="{537B06BD-1B66-4382-96A6-C50C80147E45}"/>
               </a:ext>
             </a:extLst>
           </p:cNvPr>
@@ -9770,7 +9770,7 @@
           <p:cNvPr id="19" name="">
             <a:extLst xmlns:a="http://schemas.openxmlformats.org/drawingml/2006/main">
               <a:ext uri="{FF2B5EF4-FFF2-40B4-BE49-F238E27FC236}">
-                <a16:creationId xmlns:a16="http://schemas.microsoft.com/office/drawing/2014/main" id="{B1E867E4-988F-4E7B-9AF3-20AECADE8F48}"/>
+                <a16:creationId xmlns:a16="http://schemas.microsoft.com/office/drawing/2014/main" id="{28E2DA42-FB94-4050-95CB-B91B79EBBDA0}"/>
               </a:ext>
             </a:extLst>
           </p:cNvPr>
@@ -9803,7 +9803,7 @@
           <p:cNvPr id="20" name="">
             <a:extLst xmlns:a="http://schemas.openxmlformats.org/drawingml/2006/main">
               <a:ext uri="{FF2B5EF4-FFF2-40B4-BE49-F238E27FC236}">
-                <a16:creationId xmlns:a16="http://schemas.microsoft.com/office/drawing/2014/main" id="{43DE84A7-78FF-49BD-A220-09655D4E6253}"/>
+                <a16:creationId xmlns:a16="http://schemas.microsoft.com/office/drawing/2014/main" id="{D9E0C676-100C-4BA9-9407-F38907EE8145}"/>
               </a:ext>
             </a:extLst>
           </p:cNvPr>
@@ -9867,7 +9867,7 @@
           <p:cNvPr id="21" name="">
             <a:extLst xmlns:a="http://schemas.openxmlformats.org/drawingml/2006/main">
               <a:ext uri="{FF2B5EF4-FFF2-40B4-BE49-F238E27FC236}">
-                <a16:creationId xmlns:a16="http://schemas.microsoft.com/office/drawing/2014/main" id="{577FA16B-6538-4703-9DB2-30BE7D88D090}"/>
+                <a16:creationId xmlns:a16="http://schemas.microsoft.com/office/drawing/2014/main" id="{700DA78C-2ED6-4FC5-981F-5F152E26AD5C}"/>
               </a:ext>
             </a:extLst>
           </p:cNvPr>
@@ -9931,7 +9931,7 @@
           <p:cNvPr id="22" name="">
             <a:extLst xmlns:a="http://schemas.openxmlformats.org/drawingml/2006/main">
               <a:ext uri="{FF2B5EF4-FFF2-40B4-BE49-F238E27FC236}">
-                <a16:creationId xmlns:a16="http://schemas.microsoft.com/office/drawing/2014/main" id="{6EBC9F2E-B952-43F7-8453-2DB511B30DF6}"/>
+                <a16:creationId xmlns:a16="http://schemas.microsoft.com/office/drawing/2014/main" id="{344C54E6-7B9C-47D3-BBDC-A1357B297C1A}"/>
               </a:ext>
             </a:extLst>
           </p:cNvPr>
@@ -9995,7 +9995,7 @@
           <p:cNvPr id="23" name="">
             <a:extLst xmlns:a="http://schemas.openxmlformats.org/drawingml/2006/main">
               <a:ext uri="{FF2B5EF4-FFF2-40B4-BE49-F238E27FC236}">
-                <a16:creationId xmlns:a16="http://schemas.microsoft.com/office/drawing/2014/main" id="{946F46A5-4209-4F14-A473-592DA84C3112}"/>
+                <a16:creationId xmlns:a16="http://schemas.microsoft.com/office/drawing/2014/main" id="{879E4856-B20E-43DF-BB9C-C8A72ABB8BBF}"/>
               </a:ext>
             </a:extLst>
           </p:cNvPr>
@@ -10028,7 +10028,7 @@
           <p:cNvPr id="24" name="">
             <a:extLst xmlns:a="http://schemas.openxmlformats.org/drawingml/2006/main">
               <a:ext uri="{FF2B5EF4-FFF2-40B4-BE49-F238E27FC236}">
-                <a16:creationId xmlns:a16="http://schemas.microsoft.com/office/drawing/2014/main" id="{66D1D8AF-3866-4099-B295-34D9D89433AD}"/>
+                <a16:creationId xmlns:a16="http://schemas.microsoft.com/office/drawing/2014/main" id="{C5DD66E7-8F1A-41F0-918B-9742851324A4}"/>
               </a:ext>
             </a:extLst>
           </p:cNvPr>
@@ -10092,7 +10092,7 @@
           <p:cNvPr id="25" name="">
             <a:extLst xmlns:a="http://schemas.openxmlformats.org/drawingml/2006/main">
               <a:ext uri="{FF2B5EF4-FFF2-40B4-BE49-F238E27FC236}">
-                <a16:creationId xmlns:a16="http://schemas.microsoft.com/office/drawing/2014/main" id="{2AB086D5-50DB-4ECB-BF8C-8E2C6A72E192}"/>
+                <a16:creationId xmlns:a16="http://schemas.microsoft.com/office/drawing/2014/main" id="{51CA35AF-69EB-4A04-9B6D-1E3661D85ACE}"/>
               </a:ext>
             </a:extLst>
           </p:cNvPr>
@@ -10156,7 +10156,7 @@
           <p:cNvPr id="26" name="">
             <a:extLst xmlns:a="http://schemas.openxmlformats.org/drawingml/2006/main">
               <a:ext uri="{FF2B5EF4-FFF2-40B4-BE49-F238E27FC236}">
-                <a16:creationId xmlns:a16="http://schemas.microsoft.com/office/drawing/2014/main" id="{B8EE0B5A-1894-4DEB-930B-71AB32DF352E}"/>
+                <a16:creationId xmlns:a16="http://schemas.microsoft.com/office/drawing/2014/main" id="{A87FC604-DBF3-47FB-972B-52C0AF124F10}"/>
               </a:ext>
             </a:extLst>
           </p:cNvPr>
@@ -10191,7 +10191,7 @@
           <p:cNvPr id="27" name="">
             <a:extLst xmlns:a="http://schemas.openxmlformats.org/drawingml/2006/main">
               <a:ext uri="{FF2B5EF4-FFF2-40B4-BE49-F238E27FC236}">
-                <a16:creationId xmlns:a16="http://schemas.microsoft.com/office/drawing/2014/main" id="{98526A20-DC9E-4AE5-98F1-32E81AD2F0C4}"/>
+                <a16:creationId xmlns:a16="http://schemas.microsoft.com/office/drawing/2014/main" id="{D9DEA58F-681B-4AD7-88BF-82B2B2C4F11C}"/>
               </a:ext>
             </a:extLst>
           </p:cNvPr>
@@ -10255,7 +10255,7 @@
           <p:cNvPr id="28" name="">
             <a:extLst xmlns:a="http://schemas.openxmlformats.org/drawingml/2006/main">
               <a:ext uri="{FF2B5EF4-FFF2-40B4-BE49-F238E27FC236}">
-                <a16:creationId xmlns:a16="http://schemas.microsoft.com/office/drawing/2014/main" id="{5A8D2DBB-FE6C-406C-B2C2-ACEEE2CDB50C}"/>
+                <a16:creationId xmlns:a16="http://schemas.microsoft.com/office/drawing/2014/main" id="{22FBB2C0-0D7F-4A19-B5B4-C56375F47638}"/>
               </a:ext>
             </a:extLst>
           </p:cNvPr>
@@ -10290,7 +10290,7 @@
           <p:cNvPr id="29" name="">
             <a:extLst xmlns:a="http://schemas.openxmlformats.org/drawingml/2006/main">
               <a:ext uri="{FF2B5EF4-FFF2-40B4-BE49-F238E27FC236}">
-                <a16:creationId xmlns:a16="http://schemas.microsoft.com/office/drawing/2014/main" id="{9D89A04D-26A2-4061-BFA6-D159D7BDD085}"/>
+                <a16:creationId xmlns:a16="http://schemas.microsoft.com/office/drawing/2014/main" id="{322071C7-0260-40C7-B5A2-AF210767CD2F}"/>
               </a:ext>
             </a:extLst>
           </p:cNvPr>
@@ -10354,7 +10354,7 @@
           <p:cNvPr id="30" name="">
             <a:extLst xmlns:a="http://schemas.openxmlformats.org/drawingml/2006/main">
               <a:ext uri="{FF2B5EF4-FFF2-40B4-BE49-F238E27FC236}">
-                <a16:creationId xmlns:a16="http://schemas.microsoft.com/office/drawing/2014/main" id="{A3CE6601-2DC5-4D62-9848-9CDCB02B2436}"/>
+                <a16:creationId xmlns:a16="http://schemas.microsoft.com/office/drawing/2014/main" id="{E6628D4C-F5DF-47D9-B516-FCBE7294D624}"/>
               </a:ext>
             </a:extLst>
           </p:cNvPr>
@@ -10389,7 +10389,7 @@
           <p:cNvPr id="31" name="">
             <a:extLst xmlns:a="http://schemas.openxmlformats.org/drawingml/2006/main">
               <a:ext uri="{FF2B5EF4-FFF2-40B4-BE49-F238E27FC236}">
-                <a16:creationId xmlns:a16="http://schemas.microsoft.com/office/drawing/2014/main" id="{BA97D36C-4773-44EE-B2DA-DACDDEE9484D}"/>
+                <a16:creationId xmlns:a16="http://schemas.microsoft.com/office/drawing/2014/main" id="{D1C3B358-9163-43FD-87B4-E23157BFF15B}"/>
               </a:ext>
             </a:extLst>
           </p:cNvPr>
@@ -10453,7 +10453,7 @@
           <p:cNvPr id="32" name="">
             <a:extLst xmlns:a="http://schemas.openxmlformats.org/drawingml/2006/main">
               <a:ext uri="{FF2B5EF4-FFF2-40B4-BE49-F238E27FC236}">
-                <a16:creationId xmlns:a16="http://schemas.microsoft.com/office/drawing/2014/main" id="{70D285DD-F1CD-4C10-BC24-DE7134C9780F}"/>
+                <a16:creationId xmlns:a16="http://schemas.microsoft.com/office/drawing/2014/main" id="{03DFA526-457B-48E9-968E-C2E27602D37C}"/>
               </a:ext>
             </a:extLst>
           </p:cNvPr>
@@ -10488,7 +10488,7 @@
           <p:cNvPr id="33" name="">
             <a:extLst xmlns:a="http://schemas.openxmlformats.org/drawingml/2006/main">
               <a:ext uri="{FF2B5EF4-FFF2-40B4-BE49-F238E27FC236}">
-                <a16:creationId xmlns:a16="http://schemas.microsoft.com/office/drawing/2014/main" id="{30E73E14-B2BD-4E26-A210-56BA0B5763CB}"/>
+                <a16:creationId xmlns:a16="http://schemas.microsoft.com/office/drawing/2014/main" id="{259211B8-2E0B-4911-BAF8-5498E97ECD43}"/>
               </a:ext>
             </a:extLst>
           </p:cNvPr>
@@ -10552,7 +10552,7 @@
           <p:cNvPr id="34" name="">
             <a:extLst xmlns:a="http://schemas.openxmlformats.org/drawingml/2006/main">
               <a:ext uri="{FF2B5EF4-FFF2-40B4-BE49-F238E27FC236}">
-                <a16:creationId xmlns:a16="http://schemas.microsoft.com/office/drawing/2014/main" id="{324B5488-EFF1-448F-8769-A7979405AC93}"/>
+                <a16:creationId xmlns:a16="http://schemas.microsoft.com/office/drawing/2014/main" id="{76159607-E99F-42C7-9572-532E599764F9}"/>
               </a:ext>
             </a:extLst>
           </p:cNvPr>
@@ -10587,7 +10587,7 @@
           <p:cNvPr id="35" name="">
             <a:extLst xmlns:a="http://schemas.openxmlformats.org/drawingml/2006/main">
               <a:ext uri="{FF2B5EF4-FFF2-40B4-BE49-F238E27FC236}">
-                <a16:creationId xmlns:a16="http://schemas.microsoft.com/office/drawing/2014/main" id="{3A14EF54-93B1-4A83-A230-4BA305B0A399}"/>
+                <a16:creationId xmlns:a16="http://schemas.microsoft.com/office/drawing/2014/main" id="{905857F3-D14D-462E-9C90-D0A6629DF280}"/>
               </a:ext>
             </a:extLst>
           </p:cNvPr>
@@ -10651,7 +10651,7 @@
           <p:cNvPr id="36" name="">
             <a:extLst xmlns:a="http://schemas.openxmlformats.org/drawingml/2006/main">
               <a:ext uri="{FF2B5EF4-FFF2-40B4-BE49-F238E27FC236}">
-                <a16:creationId xmlns:a16="http://schemas.microsoft.com/office/drawing/2014/main" id="{7B58B8D4-43C9-4E3D-B0F3-B27C756CE9BD}"/>
+                <a16:creationId xmlns:a16="http://schemas.microsoft.com/office/drawing/2014/main" id="{CA54F505-15DD-445D-A32A-E52DA918A3AF}"/>
               </a:ext>
             </a:extLst>
           </p:cNvPr>
@@ -10686,7 +10686,7 @@
           <p:cNvPr id="37" name="">
             <a:extLst xmlns:a="http://schemas.openxmlformats.org/drawingml/2006/main">
               <a:ext uri="{FF2B5EF4-FFF2-40B4-BE49-F238E27FC236}">
-                <a16:creationId xmlns:a16="http://schemas.microsoft.com/office/drawing/2014/main" id="{A8D80263-90B9-4D01-8A50-9B2B17CC147F}"/>
+                <a16:creationId xmlns:a16="http://schemas.microsoft.com/office/drawing/2014/main" id="{89419320-538E-4846-992F-240DBF38A450}"/>
               </a:ext>
             </a:extLst>
           </p:cNvPr>
@@ -10750,7 +10750,7 @@
           <p:cNvPr id="38" name="">
             <a:extLst xmlns:a="http://schemas.openxmlformats.org/drawingml/2006/main">
               <a:ext uri="{FF2B5EF4-FFF2-40B4-BE49-F238E27FC236}">
-                <a16:creationId xmlns:a16="http://schemas.microsoft.com/office/drawing/2014/main" id="{16875EC6-7F28-4316-8C8D-41921D4C08C0}"/>
+                <a16:creationId xmlns:a16="http://schemas.microsoft.com/office/drawing/2014/main" id="{ADE8AD24-0D7C-4411-A3FF-D8F5FC9AB014}"/>
               </a:ext>
             </a:extLst>
           </p:cNvPr>
@@ -10814,7 +10814,7 @@
           <p:cNvPr id="39" name="">
             <a:extLst xmlns:a="http://schemas.openxmlformats.org/drawingml/2006/main">
               <a:ext uri="{FF2B5EF4-FFF2-40B4-BE49-F238E27FC236}">
-                <a16:creationId xmlns:a16="http://schemas.microsoft.com/office/drawing/2014/main" id="{57C6EC95-0C0E-4B2F-9454-DED3E460FF0E}"/>
+                <a16:creationId xmlns:a16="http://schemas.microsoft.com/office/drawing/2014/main" id="{7251AAFB-0A08-4035-A7B1-03185CBD22D3}"/>
               </a:ext>
             </a:extLst>
           </p:cNvPr>
@@ -10878,7 +10878,7 @@
           <p:cNvPr id="40" name="">
             <a:extLst xmlns:a="http://schemas.openxmlformats.org/drawingml/2006/main">
               <a:ext uri="{FF2B5EF4-FFF2-40B4-BE49-F238E27FC236}">
-                <a16:creationId xmlns:a16="http://schemas.microsoft.com/office/drawing/2014/main" id="{098C2C44-FDE0-4C21-BFF2-69CB8C96D895}"/>
+                <a16:creationId xmlns:a16="http://schemas.microsoft.com/office/drawing/2014/main" id="{0E27B6DC-4051-4917-B5CA-D73124F8CD88}"/>
               </a:ext>
             </a:extLst>
           </p:cNvPr>
@@ -10942,7 +10942,7 @@
           <p:cNvPr id="41" name="">
             <a:extLst xmlns:a="http://schemas.openxmlformats.org/drawingml/2006/main">
               <a:ext uri="{FF2B5EF4-FFF2-40B4-BE49-F238E27FC236}">
-                <a16:creationId xmlns:a16="http://schemas.microsoft.com/office/drawing/2014/main" id="{452604B2-D6CF-4070-8772-0FA412E8E4A8}"/>
+                <a16:creationId xmlns:a16="http://schemas.microsoft.com/office/drawing/2014/main" id="{95A6F7EA-2C98-4CAB-89EF-19CDC261016D}"/>
               </a:ext>
             </a:extLst>
           </p:cNvPr>
@@ -11006,7 +11006,7 @@
           <p:cNvPr id="42" name="">
             <a:extLst xmlns:a="http://schemas.openxmlformats.org/drawingml/2006/main">
               <a:ext uri="{FF2B5EF4-FFF2-40B4-BE49-F238E27FC236}">
-                <a16:creationId xmlns:a16="http://schemas.microsoft.com/office/drawing/2014/main" id="{F99C68C6-11D7-4AA8-ADCE-F7A65100F31F}"/>
+                <a16:creationId xmlns:a16="http://schemas.microsoft.com/office/drawing/2014/main" id="{02632C84-EFFE-4B8F-A3DD-E450F8027401}"/>
               </a:ext>
             </a:extLst>
           </p:cNvPr>
@@ -11070,7 +11070,7 @@
           <p:cNvPr id="43" name="">
             <a:extLst xmlns:a="http://schemas.openxmlformats.org/drawingml/2006/main">
               <a:ext uri="{FF2B5EF4-FFF2-40B4-BE49-F238E27FC236}">
-                <a16:creationId xmlns:a16="http://schemas.microsoft.com/office/drawing/2014/main" id="{523A6B92-1357-49C6-A926-FD7D7788ADD6}"/>
+                <a16:creationId xmlns:a16="http://schemas.microsoft.com/office/drawing/2014/main" id="{6F578375-9616-45CA-B109-9454E504127E}"/>
               </a:ext>
             </a:extLst>
           </p:cNvPr>
@@ -11132,7 +11132,7 @@
     </p:spTree>
     <p:extLst>
       <p:ext uri="{BB962C8B-B14F-4D97-AF65-F5344CB8AC3E}">
-        <p14:creationId xmlns:p14="http://schemas.microsoft.com/office/powerpoint/2010/main" val="544482242"/>
+        <p14:creationId xmlns:p14="http://schemas.microsoft.com/office/powerpoint/2010/main" val="1669487313"/>
       </p:ext>
     </p:extLst>
   </p:cSld>
@@ -11156,7 +11156,7 @@
           <p:cNvPr id="1" name="">
             <a:extLst xmlns:a="http://schemas.openxmlformats.org/drawingml/2006/main">
               <a:ext uri="{FF2B5EF4-FFF2-40B4-BE49-F238E27FC236}">
-                <a16:creationId xmlns:a16="http://schemas.microsoft.com/office/drawing/2014/main" id="{BB8977A5-59DE-43E4-97BB-1AE1DEA6A8DE}"/>
+                <a16:creationId xmlns:a16="http://schemas.microsoft.com/office/drawing/2014/main" id="{05CED370-A455-4BFD-9C83-4AEF10D552C3}"/>
               </a:ext>
             </a:extLst>
           </p:cNvPr>
@@ -11191,7 +11191,7 @@
           <p:cNvPr id="2" name="">
             <a:extLst xmlns:a="http://schemas.openxmlformats.org/drawingml/2006/main">
               <a:ext uri="{FF2B5EF4-FFF2-40B4-BE49-F238E27FC236}">
-                <a16:creationId xmlns:a16="http://schemas.microsoft.com/office/drawing/2014/main" id="{ED8F83E4-969F-4541-9E9C-C582259AEF5F}"/>
+                <a16:creationId xmlns:a16="http://schemas.microsoft.com/office/drawing/2014/main" id="{A93AF2EB-5A8C-4338-AFBF-B1C84C13D0B4}"/>
               </a:ext>
             </a:extLst>
           </p:cNvPr>
@@ -11226,7 +11226,7 @@
           <p:cNvPr id="3" name="">
             <a:extLst xmlns:a="http://schemas.openxmlformats.org/drawingml/2006/main">
               <a:ext uri="{FF2B5EF4-FFF2-40B4-BE49-F238E27FC236}">
-                <a16:creationId xmlns:a16="http://schemas.microsoft.com/office/drawing/2014/main" id="{B850B27F-AAB7-4A6B-818A-DECBCC23502E}"/>
+                <a16:creationId xmlns:a16="http://schemas.microsoft.com/office/drawing/2014/main" id="{34B937C4-0CD0-410D-8035-E312B8A64D9E}"/>
               </a:ext>
             </a:extLst>
           </p:cNvPr>
@@ -11290,7 +11290,7 @@
           <p:cNvPr id="4" name="">
             <a:extLst xmlns:a="http://schemas.openxmlformats.org/drawingml/2006/main">
               <a:ext uri="{FF2B5EF4-FFF2-40B4-BE49-F238E27FC236}">
-                <a16:creationId xmlns:a16="http://schemas.microsoft.com/office/drawing/2014/main" id="{A258F728-3F1C-4C3C-BEBD-54C38FDFB047}"/>
+                <a16:creationId xmlns:a16="http://schemas.microsoft.com/office/drawing/2014/main" id="{B3988BF4-754A-4EEC-8D8D-583C4EDB7D23}"/>
               </a:ext>
             </a:extLst>
           </p:cNvPr>
@@ -11354,7 +11354,7 @@
           <p:cNvPr id="5" name="">
             <a:extLst xmlns:a="http://schemas.openxmlformats.org/drawingml/2006/main">
               <a:ext uri="{FF2B5EF4-FFF2-40B4-BE49-F238E27FC236}">
-                <a16:creationId xmlns:a16="http://schemas.microsoft.com/office/drawing/2014/main" id="{062E270B-67AC-4DEC-B7D9-42F29F40F4BC}"/>
+                <a16:creationId xmlns:a16="http://schemas.microsoft.com/office/drawing/2014/main" id="{6A9A600E-1F93-4FAC-AD6C-737A4072D953}"/>
               </a:ext>
             </a:extLst>
           </p:cNvPr>
@@ -11418,7 +11418,7 @@
           <p:cNvPr id="6" name="">
             <a:extLst xmlns:a="http://schemas.openxmlformats.org/drawingml/2006/main">
               <a:ext uri="{FF2B5EF4-FFF2-40B4-BE49-F238E27FC236}">
-                <a16:creationId xmlns:a16="http://schemas.microsoft.com/office/drawing/2014/main" id="{20347277-5DFE-47C7-AFAA-0BB4A3444A64}"/>
+                <a16:creationId xmlns:a16="http://schemas.microsoft.com/office/drawing/2014/main" id="{9F59EEB7-345A-4A0D-BFBA-B43EAC984D4C}"/>
               </a:ext>
             </a:extLst>
           </p:cNvPr>
@@ -11482,7 +11482,7 @@
           <p:cNvPr id="7" name="">
             <a:extLst xmlns:a="http://schemas.openxmlformats.org/drawingml/2006/main">
               <a:ext uri="{FF2B5EF4-FFF2-40B4-BE49-F238E27FC236}">
-                <a16:creationId xmlns:a16="http://schemas.microsoft.com/office/drawing/2014/main" id="{4BBBF1B8-8155-4FF9-AC27-6F35A474C3E8}"/>
+                <a16:creationId xmlns:a16="http://schemas.microsoft.com/office/drawing/2014/main" id="{7D678577-1BAF-41B1-A967-3F03509FF870}"/>
               </a:ext>
             </a:extLst>
           </p:cNvPr>
@@ -11569,7 +11569,7 @@
           <p:cNvPr id="8" name="">
             <a:extLst xmlns:a="http://schemas.openxmlformats.org/drawingml/2006/main">
               <a:ext uri="{FF2B5EF4-FFF2-40B4-BE49-F238E27FC236}">
-                <a16:creationId xmlns:a16="http://schemas.microsoft.com/office/drawing/2014/main" id="{3AACD0C2-E283-4509-8AE9-C794B1A64D07}"/>
+                <a16:creationId xmlns:a16="http://schemas.microsoft.com/office/drawing/2014/main" id="{9C6AF3BE-9814-4945-AA24-36EA68C3843C}"/>
               </a:ext>
             </a:extLst>
           </p:cNvPr>
@@ -11602,7 +11602,7 @@
           <p:cNvPr id="9" name="">
             <a:extLst xmlns:a="http://schemas.openxmlformats.org/drawingml/2006/main">
               <a:ext uri="{FF2B5EF4-FFF2-40B4-BE49-F238E27FC236}">
-                <a16:creationId xmlns:a16="http://schemas.microsoft.com/office/drawing/2014/main" id="{ECB98CC7-4D48-4BB5-953C-F94226EF2E1D}"/>
+                <a16:creationId xmlns:a16="http://schemas.microsoft.com/office/drawing/2014/main" id="{97A72636-1933-404F-9C48-3D9C41034D8E}"/>
               </a:ext>
             </a:extLst>
           </p:cNvPr>
@@ -11666,7 +11666,7 @@
           <p:cNvPr id="10" name="">
             <a:extLst xmlns:a="http://schemas.openxmlformats.org/drawingml/2006/main">
               <a:ext uri="{FF2B5EF4-FFF2-40B4-BE49-F238E27FC236}">
-                <a16:creationId xmlns:a16="http://schemas.microsoft.com/office/drawing/2014/main" id="{4812A293-B8F7-47A7-83BA-70540CADF708}"/>
+                <a16:creationId xmlns:a16="http://schemas.microsoft.com/office/drawing/2014/main" id="{9A7AB2AB-7D68-46FE-B20D-921F281DE25A}"/>
               </a:ext>
             </a:extLst>
           </p:cNvPr>
@@ -11730,7 +11730,7 @@
           <p:cNvPr id="11" name="">
             <a:extLst xmlns:a="http://schemas.openxmlformats.org/drawingml/2006/main">
               <a:ext uri="{FF2B5EF4-FFF2-40B4-BE49-F238E27FC236}">
-                <a16:creationId xmlns:a16="http://schemas.microsoft.com/office/drawing/2014/main" id="{AEC75A2E-07B3-4A08-96EB-5F4F553BBCBF}"/>
+                <a16:creationId xmlns:a16="http://schemas.microsoft.com/office/drawing/2014/main" id="{83E736FC-C41C-4B91-B813-630D7DBA75BB}"/>
               </a:ext>
             </a:extLst>
           </p:cNvPr>
@@ -11763,7 +11763,7 @@
           <p:cNvPr id="12" name="">
             <a:extLst xmlns:a="http://schemas.openxmlformats.org/drawingml/2006/main">
               <a:ext uri="{FF2B5EF4-FFF2-40B4-BE49-F238E27FC236}">
-                <a16:creationId xmlns:a16="http://schemas.microsoft.com/office/drawing/2014/main" id="{0DCA19B4-6EE6-41ED-A1AD-6839F48FF5D2}"/>
+                <a16:creationId xmlns:a16="http://schemas.microsoft.com/office/drawing/2014/main" id="{380E24B2-3281-4C45-9D9B-C28347F15C23}"/>
               </a:ext>
             </a:extLst>
           </p:cNvPr>
@@ -11827,7 +11827,7 @@
           <p:cNvPr id="13" name="">
             <a:extLst xmlns:a="http://schemas.openxmlformats.org/drawingml/2006/main">
               <a:ext uri="{FF2B5EF4-FFF2-40B4-BE49-F238E27FC236}">
-                <a16:creationId xmlns:a16="http://schemas.microsoft.com/office/drawing/2014/main" id="{53D2D45D-CF47-4BF8-B0FF-0DC4988B4E03}"/>
+                <a16:creationId xmlns:a16="http://schemas.microsoft.com/office/drawing/2014/main" id="{19813752-DAE4-4976-BD72-8CE5FAE059CD}"/>
               </a:ext>
             </a:extLst>
           </p:cNvPr>
@@ -11891,7 +11891,7 @@
           <p:cNvPr id="14" name="">
             <a:extLst xmlns:a="http://schemas.openxmlformats.org/drawingml/2006/main">
               <a:ext uri="{FF2B5EF4-FFF2-40B4-BE49-F238E27FC236}">
-                <a16:creationId xmlns:a16="http://schemas.microsoft.com/office/drawing/2014/main" id="{04754EC6-EBE1-4BD9-94B5-92D496AC72BC}"/>
+                <a16:creationId xmlns:a16="http://schemas.microsoft.com/office/drawing/2014/main" id="{A506E1A4-3694-44A4-95AF-F64A4E67A8B2}"/>
               </a:ext>
             </a:extLst>
           </p:cNvPr>
@@ -11924,7 +11924,7 @@
           <p:cNvPr id="15" name="">
             <a:extLst xmlns:a="http://schemas.openxmlformats.org/drawingml/2006/main">
               <a:ext uri="{FF2B5EF4-FFF2-40B4-BE49-F238E27FC236}">
-                <a16:creationId xmlns:a16="http://schemas.microsoft.com/office/drawing/2014/main" id="{79246D91-D5AE-480F-83CC-4E550E35A43F}"/>
+                <a16:creationId xmlns:a16="http://schemas.microsoft.com/office/drawing/2014/main" id="{636F4FA8-571E-4E0D-846C-C66DBACC8AC0}"/>
               </a:ext>
             </a:extLst>
           </p:cNvPr>
@@ -11988,7 +11988,7 @@
           <p:cNvPr id="16" name="">
             <a:extLst xmlns:a="http://schemas.openxmlformats.org/drawingml/2006/main">
               <a:ext uri="{FF2B5EF4-FFF2-40B4-BE49-F238E27FC236}">
-                <a16:creationId xmlns:a16="http://schemas.microsoft.com/office/drawing/2014/main" id="{B5346529-DD38-4291-8111-461DCED052C9}"/>
+                <a16:creationId xmlns:a16="http://schemas.microsoft.com/office/drawing/2014/main" id="{C8699538-25D1-4A83-9CEC-A3CBB79FB72E}"/>
               </a:ext>
             </a:extLst>
           </p:cNvPr>
@@ -12052,7 +12052,7 @@
           <p:cNvPr id="17" name="">
             <a:extLst xmlns:a="http://schemas.openxmlformats.org/drawingml/2006/main">
               <a:ext uri="{FF2B5EF4-FFF2-40B4-BE49-F238E27FC236}">
-                <a16:creationId xmlns:a16="http://schemas.microsoft.com/office/drawing/2014/main" id="{AA5E0B2D-37C9-498B-91B5-A6518B213EDD}"/>
+                <a16:creationId xmlns:a16="http://schemas.microsoft.com/office/drawing/2014/main" id="{7273A5FE-3238-43A4-BB8C-7C21A29B88AB}"/>
               </a:ext>
             </a:extLst>
           </p:cNvPr>
@@ -12087,7 +12087,7 @@
           <p:cNvPr id="18" name="">
             <a:extLst xmlns:a="http://schemas.openxmlformats.org/drawingml/2006/main">
               <a:ext uri="{FF2B5EF4-FFF2-40B4-BE49-F238E27FC236}">
-                <a16:creationId xmlns:a16="http://schemas.microsoft.com/office/drawing/2014/main" id="{14F5AED4-906D-4D34-A1ED-668F652C2D04}"/>
+                <a16:creationId xmlns:a16="http://schemas.microsoft.com/office/drawing/2014/main" id="{D7981AC3-4486-42F8-8745-C51878E43D9D}"/>
               </a:ext>
             </a:extLst>
           </p:cNvPr>
@@ -12122,7 +12122,7 @@
           <p:cNvPr id="19" name="">
             <a:extLst xmlns:a="http://schemas.openxmlformats.org/drawingml/2006/main">
               <a:ext uri="{FF2B5EF4-FFF2-40B4-BE49-F238E27FC236}">
-                <a16:creationId xmlns:a16="http://schemas.microsoft.com/office/drawing/2014/main" id="{4966D9C0-AB55-4D4D-AC76-FE0B1F73437D}"/>
+                <a16:creationId xmlns:a16="http://schemas.microsoft.com/office/drawing/2014/main" id="{AF1EB15F-3136-4AB3-AA91-43B77BF201C7}"/>
               </a:ext>
             </a:extLst>
           </p:cNvPr>
@@ -12184,7 +12184,7 @@
     </p:spTree>
     <p:extLst>
       <p:ext uri="{BB962C8B-B14F-4D97-AF65-F5344CB8AC3E}">
-        <p14:creationId xmlns:p14="http://schemas.microsoft.com/office/powerpoint/2010/main" val="1490622363"/>
+        <p14:creationId xmlns:p14="http://schemas.microsoft.com/office/powerpoint/2010/main" val="1723777257"/>
       </p:ext>
     </p:extLst>
   </p:cSld>
@@ -12208,7 +12208,7 @@
           <p:cNvPr id="1" name="">
             <a:extLst xmlns:a="http://schemas.openxmlformats.org/drawingml/2006/main">
               <a:ext uri="{FF2B5EF4-FFF2-40B4-BE49-F238E27FC236}">
-                <a16:creationId xmlns:a16="http://schemas.microsoft.com/office/drawing/2014/main" id="{21683932-7110-48CE-9F67-130EE40CA7BC}"/>
+                <a16:creationId xmlns:a16="http://schemas.microsoft.com/office/drawing/2014/main" id="{F2DF9D5D-6370-4468-AB19-6DE3909C4580}"/>
               </a:ext>
             </a:extLst>
           </p:cNvPr>
@@ -12243,7 +12243,7 @@
           <p:cNvPr id="2" name="">
             <a:extLst xmlns:a="http://schemas.openxmlformats.org/drawingml/2006/main">
               <a:ext uri="{FF2B5EF4-FFF2-40B4-BE49-F238E27FC236}">
-                <a16:creationId xmlns:a16="http://schemas.microsoft.com/office/drawing/2014/main" id="{8B3917D3-316B-4483-99E0-2660C0D3EA18}"/>
+                <a16:creationId xmlns:a16="http://schemas.microsoft.com/office/drawing/2014/main" id="{BCDFBBF8-EE1D-4D94-80C0-BD5E380633D3}"/>
               </a:ext>
             </a:extLst>
           </p:cNvPr>
@@ -12278,7 +12278,7 @@
           <p:cNvPr id="3" name="">
             <a:extLst xmlns:a="http://schemas.openxmlformats.org/drawingml/2006/main">
               <a:ext uri="{FF2B5EF4-FFF2-40B4-BE49-F238E27FC236}">
-                <a16:creationId xmlns:a16="http://schemas.microsoft.com/office/drawing/2014/main" id="{68FB5664-7BA9-45CE-8107-3B6A14DD009F}"/>
+                <a16:creationId xmlns:a16="http://schemas.microsoft.com/office/drawing/2014/main" id="{7BE3B624-F19D-4F24-A161-F4DB4C575E34}"/>
               </a:ext>
             </a:extLst>
           </p:cNvPr>
@@ -12342,7 +12342,7 @@
           <p:cNvPr id="4" name="">
             <a:extLst xmlns:a="http://schemas.openxmlformats.org/drawingml/2006/main">
               <a:ext uri="{FF2B5EF4-FFF2-40B4-BE49-F238E27FC236}">
-                <a16:creationId xmlns:a16="http://schemas.microsoft.com/office/drawing/2014/main" id="{41D333B0-BAEC-4430-B79F-F7E37AD64F7F}"/>
+                <a16:creationId xmlns:a16="http://schemas.microsoft.com/office/drawing/2014/main" id="{0BB629BC-C8A0-495E-BD5C-5CD7FDD0461F}"/>
               </a:ext>
             </a:extLst>
           </p:cNvPr>
@@ -12406,7 +12406,7 @@
           <p:cNvPr id="5" name="">
             <a:extLst xmlns:a="http://schemas.openxmlformats.org/drawingml/2006/main">
               <a:ext uri="{FF2B5EF4-FFF2-40B4-BE49-F238E27FC236}">
-                <a16:creationId xmlns:a16="http://schemas.microsoft.com/office/drawing/2014/main" id="{AD630CCF-D308-4361-A994-B53F3ECCD10C}"/>
+                <a16:creationId xmlns:a16="http://schemas.microsoft.com/office/drawing/2014/main" id="{A2374036-6339-44C6-B4DF-5A6982F5F3BA}"/>
               </a:ext>
             </a:extLst>
           </p:cNvPr>
@@ -12470,7 +12470,7 @@
           <p:cNvPr id="6" name="">
             <a:extLst xmlns:a="http://schemas.openxmlformats.org/drawingml/2006/main">
               <a:ext uri="{FF2B5EF4-FFF2-40B4-BE49-F238E27FC236}">
-                <a16:creationId xmlns:a16="http://schemas.microsoft.com/office/drawing/2014/main" id="{E13C2879-BAA2-443F-B666-A26432FC5487}"/>
+                <a16:creationId xmlns:a16="http://schemas.microsoft.com/office/drawing/2014/main" id="{BF37D56B-0833-47ED-BD32-D79AF75F5417}"/>
               </a:ext>
             </a:extLst>
           </p:cNvPr>
@@ -12534,7 +12534,7 @@
           <p:cNvPr id="7" name="">
             <a:extLst xmlns:a="http://schemas.openxmlformats.org/drawingml/2006/main">
               <a:ext uri="{FF2B5EF4-FFF2-40B4-BE49-F238E27FC236}">
-                <a16:creationId xmlns:a16="http://schemas.microsoft.com/office/drawing/2014/main" id="{CB9EEBDD-3225-4455-9098-25CB6A2CDA4A}"/>
+                <a16:creationId xmlns:a16="http://schemas.microsoft.com/office/drawing/2014/main" id="{299B50E4-C7C0-4DE0-BECF-1DC81FF2CF2F}"/>
               </a:ext>
             </a:extLst>
           </p:cNvPr>
@@ -12598,7 +12598,7 @@
           <p:cNvPr id="8" name="">
             <a:extLst xmlns:a="http://schemas.openxmlformats.org/drawingml/2006/main">
               <a:ext uri="{FF2B5EF4-FFF2-40B4-BE49-F238E27FC236}">
-                <a16:creationId xmlns:a16="http://schemas.microsoft.com/office/drawing/2014/main" id="{C925541B-F5C9-4649-8AA3-8B032EE80FA2}"/>
+                <a16:creationId xmlns:a16="http://schemas.microsoft.com/office/drawing/2014/main" id="{B033A521-5C46-4DE5-8876-6A3038444638}"/>
               </a:ext>
             </a:extLst>
           </p:cNvPr>
@@ -12631,7 +12631,7 @@
           <p:cNvPr id="9" name="">
             <a:extLst xmlns:a="http://schemas.openxmlformats.org/drawingml/2006/main">
               <a:ext uri="{FF2B5EF4-FFF2-40B4-BE49-F238E27FC236}">
-                <a16:creationId xmlns:a16="http://schemas.microsoft.com/office/drawing/2014/main" id="{40202348-A693-4F53-8EFF-BC9091461BD4}"/>
+                <a16:creationId xmlns:a16="http://schemas.microsoft.com/office/drawing/2014/main" id="{2B3AF423-C2A7-430B-8D63-8C17300783C5}"/>
               </a:ext>
             </a:extLst>
           </p:cNvPr>
@@ -12695,7 +12695,7 @@
           <p:cNvPr id="10" name="">
             <a:extLst xmlns:a="http://schemas.openxmlformats.org/drawingml/2006/main">
               <a:ext uri="{FF2B5EF4-FFF2-40B4-BE49-F238E27FC236}">
-                <a16:creationId xmlns:a16="http://schemas.microsoft.com/office/drawing/2014/main" id="{E8109650-C498-4D8D-8AF3-DE9AB5422F78}"/>
+                <a16:creationId xmlns:a16="http://schemas.microsoft.com/office/drawing/2014/main" id="{4130C58E-5726-4110-B9D5-137C5E653DCE}"/>
               </a:ext>
             </a:extLst>
           </p:cNvPr>
@@ -12828,7 +12828,7 @@
           <p:cNvPr id="11" name="">
             <a:extLst xmlns:a="http://schemas.openxmlformats.org/drawingml/2006/main">
               <a:ext uri="{FF2B5EF4-FFF2-40B4-BE49-F238E27FC236}">
-                <a16:creationId xmlns:a16="http://schemas.microsoft.com/office/drawing/2014/main" id="{2018E748-E20D-4E71-86FC-704CA5C3978A}"/>
+                <a16:creationId xmlns:a16="http://schemas.microsoft.com/office/drawing/2014/main" id="{68F51351-AED0-4997-9ED8-526287A47F2C}"/>
               </a:ext>
             </a:extLst>
           </p:cNvPr>
@@ -12861,7 +12861,7 @@
           <p:cNvPr id="12" name="">
             <a:extLst xmlns:a="http://schemas.openxmlformats.org/drawingml/2006/main">
               <a:ext uri="{FF2B5EF4-FFF2-40B4-BE49-F238E27FC236}">
-                <a16:creationId xmlns:a16="http://schemas.microsoft.com/office/drawing/2014/main" id="{998F9ADE-5A5B-4B3F-AE11-43F2BED09044}"/>
+                <a16:creationId xmlns:a16="http://schemas.microsoft.com/office/drawing/2014/main" id="{AEF5AFDD-00BC-481B-B943-4609AB4BF454}"/>
               </a:ext>
             </a:extLst>
           </p:cNvPr>
@@ -12925,7 +12925,7 @@
           <p:cNvPr id="13" name="">
             <a:extLst xmlns:a="http://schemas.openxmlformats.org/drawingml/2006/main">
               <a:ext uri="{FF2B5EF4-FFF2-40B4-BE49-F238E27FC236}">
-                <a16:creationId xmlns:a16="http://schemas.microsoft.com/office/drawing/2014/main" id="{15794148-65D6-4629-AB10-D9DB59951F4D}"/>
+                <a16:creationId xmlns:a16="http://schemas.microsoft.com/office/drawing/2014/main" id="{6563501D-D679-4629-9B4E-BD39FE612339}"/>
               </a:ext>
             </a:extLst>
           </p:cNvPr>
@@ -12989,7 +12989,7 @@
           <p:cNvPr id="14" name="">
             <a:extLst xmlns:a="http://schemas.openxmlformats.org/drawingml/2006/main">
               <a:ext uri="{FF2B5EF4-FFF2-40B4-BE49-F238E27FC236}">
-                <a16:creationId xmlns:a16="http://schemas.microsoft.com/office/drawing/2014/main" id="{BA871C3F-573E-4AB7-A6BE-F72F96821613}"/>
+                <a16:creationId xmlns:a16="http://schemas.microsoft.com/office/drawing/2014/main" id="{277B23B5-8C4D-4161-A055-2FEF61D7FDC0}"/>
               </a:ext>
             </a:extLst>
           </p:cNvPr>
@@ -13053,7 +13053,7 @@
           <p:cNvPr id="15" name="">
             <a:extLst xmlns:a="http://schemas.openxmlformats.org/drawingml/2006/main">
               <a:ext uri="{FF2B5EF4-FFF2-40B4-BE49-F238E27FC236}">
-                <a16:creationId xmlns:a16="http://schemas.microsoft.com/office/drawing/2014/main" id="{9140310D-A3D9-4AB7-AF1C-4B22AA9A44ED}"/>
+                <a16:creationId xmlns:a16="http://schemas.microsoft.com/office/drawing/2014/main" id="{75DFC321-E34F-4EAC-8375-21A1F1DB2CDB}"/>
               </a:ext>
             </a:extLst>
           </p:cNvPr>
@@ -13117,7 +13117,7 @@
           <p:cNvPr id="16" name="">
             <a:extLst xmlns:a="http://schemas.openxmlformats.org/drawingml/2006/main">
               <a:ext uri="{FF2B5EF4-FFF2-40B4-BE49-F238E27FC236}">
-                <a16:creationId xmlns:a16="http://schemas.microsoft.com/office/drawing/2014/main" id="{98412992-86D9-4CEA-82BF-5BD3E0BB64C0}"/>
+                <a16:creationId xmlns:a16="http://schemas.microsoft.com/office/drawing/2014/main" id="{9E6AAEB8-01BF-4D4D-9C9B-147CA6105DA2}"/>
               </a:ext>
             </a:extLst>
           </p:cNvPr>
@@ -13181,7 +13181,7 @@
           <p:cNvPr id="17" name="">
             <a:extLst xmlns:a="http://schemas.openxmlformats.org/drawingml/2006/main">
               <a:ext uri="{FF2B5EF4-FFF2-40B4-BE49-F238E27FC236}">
-                <a16:creationId xmlns:a16="http://schemas.microsoft.com/office/drawing/2014/main" id="{D8A25327-B8A3-4FE5-9A41-1AD41D58B5D6}"/>
+                <a16:creationId xmlns:a16="http://schemas.microsoft.com/office/drawing/2014/main" id="{3003F111-BF7F-4FD0-998A-CE896BB0756C}"/>
               </a:ext>
             </a:extLst>
           </p:cNvPr>
@@ -13214,7 +13214,7 @@
           <p:cNvPr id="18" name="">
             <a:extLst xmlns:a="http://schemas.openxmlformats.org/drawingml/2006/main">
               <a:ext uri="{FF2B5EF4-FFF2-40B4-BE49-F238E27FC236}">
-                <a16:creationId xmlns:a16="http://schemas.microsoft.com/office/drawing/2014/main" id="{FB749B22-0ACA-4F80-BA1B-0EB56DD23132}"/>
+                <a16:creationId xmlns:a16="http://schemas.microsoft.com/office/drawing/2014/main" id="{6AB5FF00-3998-4040-B429-633A696C7FF1}"/>
               </a:ext>
             </a:extLst>
           </p:cNvPr>
@@ -13278,7 +13278,7 @@
           <p:cNvPr id="19" name="">
             <a:extLst xmlns:a="http://schemas.openxmlformats.org/drawingml/2006/main">
               <a:ext uri="{FF2B5EF4-FFF2-40B4-BE49-F238E27FC236}">
-                <a16:creationId xmlns:a16="http://schemas.microsoft.com/office/drawing/2014/main" id="{73F66E4B-0A82-48C4-83CD-F9AEEDDA2CCA}"/>
+                <a16:creationId xmlns:a16="http://schemas.microsoft.com/office/drawing/2014/main" id="{8E70F227-7B34-4016-8EFB-37FDCBCF1F75}"/>
               </a:ext>
             </a:extLst>
           </p:cNvPr>
@@ -13411,7 +13411,7 @@
           <p:cNvPr id="20" name="">
             <a:extLst xmlns:a="http://schemas.openxmlformats.org/drawingml/2006/main">
               <a:ext uri="{FF2B5EF4-FFF2-40B4-BE49-F238E27FC236}">
-                <a16:creationId xmlns:a16="http://schemas.microsoft.com/office/drawing/2014/main" id="{37653960-6F81-46B9-B310-04D1BBAF899B}"/>
+                <a16:creationId xmlns:a16="http://schemas.microsoft.com/office/drawing/2014/main" id="{19DF0CB3-6132-4B24-862E-A0C112DF9FEF}"/>
               </a:ext>
             </a:extLst>
           </p:cNvPr>
@@ -13475,7 +13475,7 @@
           <p:cNvPr id="21" name="">
             <a:extLst xmlns:a="http://schemas.openxmlformats.org/drawingml/2006/main">
               <a:ext uri="{FF2B5EF4-FFF2-40B4-BE49-F238E27FC236}">
-                <a16:creationId xmlns:a16="http://schemas.microsoft.com/office/drawing/2014/main" id="{DFB039CC-32EE-4FB5-BBC3-56572408BAA3}"/>
+                <a16:creationId xmlns:a16="http://schemas.microsoft.com/office/drawing/2014/main" id="{B0950618-4D5B-47A2-A75D-11978493F30B}"/>
               </a:ext>
             </a:extLst>
           </p:cNvPr>
@@ -13537,7 +13537,7 @@
     </p:spTree>
     <p:extLst>
       <p:ext uri="{BB962C8B-B14F-4D97-AF65-F5344CB8AC3E}">
-        <p14:creationId xmlns:p14="http://schemas.microsoft.com/office/powerpoint/2010/main" val="510826189"/>
+        <p14:creationId xmlns:p14="http://schemas.microsoft.com/office/powerpoint/2010/main" val="1885607401"/>
       </p:ext>
     </p:extLst>
   </p:cSld>

</xml_diff>

<commit_message>
Publish measured AMD Gemma product evidence
</commit_message>
<xml_diff>
--- a/submission/proteinloop-hackathon-deck.pptx
+++ b/submission/proteinloop-hackathon-deck.pptx
@@ -2,22 +2,22 @@
 <file path=ppt/presentation.xml><?xml version="1.0" encoding="utf-8"?>
 <p:presentation xmlns:p="http://schemas.openxmlformats.org/presentationml/2006/main">
   <p:sldMasterIdLst>
-    <p:sldMasterId xmlns:r="http://schemas.openxmlformats.org/officeDocument/2006/relationships" id="2147483648" r:id="R27af26ace53e489b"/>
+    <p:sldMasterId xmlns:r="http://schemas.openxmlformats.org/officeDocument/2006/relationships" id="2147483648" r:id="R8dd0e0369d4844bd"/>
   </p:sldMasterIdLst>
   <p:notesMasterIdLst>
-    <p:notesMasterId xmlns:r="http://schemas.openxmlformats.org/officeDocument/2006/relationships" r:id="Rf9aeabcb19ec4dc7"/>
+    <p:notesMasterId xmlns:r="http://schemas.openxmlformats.org/officeDocument/2006/relationships" r:id="R5a741055d00144a0"/>
   </p:notesMasterIdLst>
   <p:sldIdLst>
-    <p:sldId xmlns:r="http://schemas.openxmlformats.org/officeDocument/2006/relationships" id="256" r:id="Rb7d77e09965d4068"/>
-    <p:sldId xmlns:r="http://schemas.openxmlformats.org/officeDocument/2006/relationships" id="257" r:id="R99e6dd9242154b63"/>
-    <p:sldId xmlns:r="http://schemas.openxmlformats.org/officeDocument/2006/relationships" id="258" r:id="R46f05fc96aa34a58"/>
-    <p:sldId xmlns:r="http://schemas.openxmlformats.org/officeDocument/2006/relationships" id="259" r:id="R02e2edf84f2c4f56"/>
-    <p:sldId xmlns:r="http://schemas.openxmlformats.org/officeDocument/2006/relationships" id="260" r:id="R8befc32ff2484760"/>
-    <p:sldId xmlns:r="http://schemas.openxmlformats.org/officeDocument/2006/relationships" id="261" r:id="R5f48dead392e42e5"/>
-    <p:sldId xmlns:r="http://schemas.openxmlformats.org/officeDocument/2006/relationships" id="262" r:id="R48d0fc19aca94e95"/>
-    <p:sldId xmlns:r="http://schemas.openxmlformats.org/officeDocument/2006/relationships" id="263" r:id="Rfdb7a691c5c84eb6"/>
-    <p:sldId xmlns:r="http://schemas.openxmlformats.org/officeDocument/2006/relationships" id="264" r:id="R82b87dbe32084ace"/>
-    <p:sldId xmlns:r="http://schemas.openxmlformats.org/officeDocument/2006/relationships" id="265" r:id="R69a99ead9b624bd5"/>
+    <p:sldId xmlns:r="http://schemas.openxmlformats.org/officeDocument/2006/relationships" id="256" r:id="Rc38fa13d936b420d"/>
+    <p:sldId xmlns:r="http://schemas.openxmlformats.org/officeDocument/2006/relationships" id="257" r:id="R4f0ccd1bcf774342"/>
+    <p:sldId xmlns:r="http://schemas.openxmlformats.org/officeDocument/2006/relationships" id="258" r:id="R03954e9136994f51"/>
+    <p:sldId xmlns:r="http://schemas.openxmlformats.org/officeDocument/2006/relationships" id="259" r:id="Re0028fe216f44706"/>
+    <p:sldId xmlns:r="http://schemas.openxmlformats.org/officeDocument/2006/relationships" id="260" r:id="Redf9ccc7ca954a36"/>
+    <p:sldId xmlns:r="http://schemas.openxmlformats.org/officeDocument/2006/relationships" id="261" r:id="R629fa57eff084c8c"/>
+    <p:sldId xmlns:r="http://schemas.openxmlformats.org/officeDocument/2006/relationships" id="262" r:id="R521b112677004a43"/>
+    <p:sldId xmlns:r="http://schemas.openxmlformats.org/officeDocument/2006/relationships" id="263" r:id="Re0e20465961e4e05"/>
+    <p:sldId xmlns:r="http://schemas.openxmlformats.org/officeDocument/2006/relationships" id="264" r:id="Re6ece8f2e51d49dd"/>
+    <p:sldId xmlns:r="http://schemas.openxmlformats.org/officeDocument/2006/relationships" id="265" r:id="R89ba160ecc9541c8"/>
   </p:sldIdLst>
   <p:sldSz cx="12192000" cy="6858000"/>
   <p:notesSz cx="6858000" cy="9144000"/>
@@ -1158,7 +1158,7 @@
   </p:cSld>
   <p:clrMap bg1="lt1" tx1="dk1" bg2="lt2" tx2="dk2" accent1="accent1" accent2="accent2" accent3="accent3" accent4="accent4" accent5="accent5" accent6="accent6" hlink="hlink" folHlink="folHlink"/>
   <p:sldLayoutIdLst>
-    <p:sldLayoutId xmlns:r="http://schemas.openxmlformats.org/officeDocument/2006/relationships" id="2147483649" r:id="R362c26f3c89a47bd"/>
+    <p:sldLayoutId xmlns:r="http://schemas.openxmlformats.org/officeDocument/2006/relationships" id="2147483649" r:id="R397fb345f3884a9e"/>
   </p:sldLayoutIdLst>
   <p:txStyles>
     <p:titleStyle>
@@ -1461,7 +1461,7 @@
           <p:nvPr/>
         </p:nvPicPr>
         <p:blipFill>
-          <a:blip xmlns:r="http://schemas.openxmlformats.org/officeDocument/2006/relationships" xmlns:a="http://schemas.openxmlformats.org/drawingml/2006/main" r:embed="Ra7cb2b8f63a749bc"/>
+          <a:blip xmlns:r="http://schemas.openxmlformats.org/officeDocument/2006/relationships" xmlns:a="http://schemas.openxmlformats.org/drawingml/2006/main" r:embed="R25ea035c4e754bce"/>
           <a:srcRect xmlns:a="http://schemas.openxmlformats.org/drawingml/2006/main" l="0" t="0" r="0" b="0"/>
           <a:stretch xmlns:a="http://schemas.openxmlformats.org/drawingml/2006/main">
             <a:fillRect l="0" t="0" r="0" b="0"/>
@@ -1480,7 +1480,7 @@
     </p:spTree>
     <p:extLst>
       <p:ext uri="{BB962C8B-B14F-4D97-AF65-F5344CB8AC3E}">
-        <p14:creationId xmlns:p14="http://schemas.microsoft.com/office/powerpoint/2010/main" val="8689119"/>
+        <p14:creationId xmlns:p14="http://schemas.microsoft.com/office/powerpoint/2010/main" val="620996482"/>
       </p:ext>
     </p:extLst>
   </p:cSld>
@@ -1504,7 +1504,7 @@
           <p:cNvPr id="1" name="">
             <a:extLst xmlns:a="http://schemas.openxmlformats.org/drawingml/2006/main">
               <a:ext uri="{FF2B5EF4-FFF2-40B4-BE49-F238E27FC236}">
-                <a16:creationId xmlns:a16="http://schemas.microsoft.com/office/drawing/2014/main" id="{D6E7FA5D-FA71-4D5C-B66B-1B308898AE9B}"/>
+                <a16:creationId xmlns:a16="http://schemas.microsoft.com/office/drawing/2014/main" id="{46EBCF83-C4EE-488C-8CFB-99ED86B9A173}"/>
               </a:ext>
             </a:extLst>
           </p:cNvPr>
@@ -1539,7 +1539,7 @@
           <p:cNvPr id="2" name="">
             <a:extLst xmlns:a="http://schemas.openxmlformats.org/drawingml/2006/main">
               <a:ext uri="{FF2B5EF4-FFF2-40B4-BE49-F238E27FC236}">
-                <a16:creationId xmlns:a16="http://schemas.microsoft.com/office/drawing/2014/main" id="{B39989DB-D835-454A-BFE0-C24EF8AEA62F}"/>
+                <a16:creationId xmlns:a16="http://schemas.microsoft.com/office/drawing/2014/main" id="{950988E6-82AF-44A9-AE9C-53B3430E33BE}"/>
               </a:ext>
             </a:extLst>
           </p:cNvPr>
@@ -1574,7 +1574,7 @@
           <p:cNvPr id="3" name="">
             <a:extLst xmlns:a="http://schemas.openxmlformats.org/drawingml/2006/main">
               <a:ext uri="{FF2B5EF4-FFF2-40B4-BE49-F238E27FC236}">
-                <a16:creationId xmlns:a16="http://schemas.microsoft.com/office/drawing/2014/main" id="{F7DA41B0-589B-441F-B0E4-8F68CA73B595}"/>
+                <a16:creationId xmlns:a16="http://schemas.microsoft.com/office/drawing/2014/main" id="{3722765B-4E91-4E02-8B58-7708E2014F67}"/>
               </a:ext>
             </a:extLst>
           </p:cNvPr>
@@ -1638,7 +1638,7 @@
           <p:cNvPr id="4" name="">
             <a:extLst xmlns:a="http://schemas.openxmlformats.org/drawingml/2006/main">
               <a:ext uri="{FF2B5EF4-FFF2-40B4-BE49-F238E27FC236}">
-                <a16:creationId xmlns:a16="http://schemas.microsoft.com/office/drawing/2014/main" id="{8D7C40A9-AF9E-4AB6-A293-EB6AEBAD0511}"/>
+                <a16:creationId xmlns:a16="http://schemas.microsoft.com/office/drawing/2014/main" id="{96D0C8B8-8531-4AD4-BECD-EC66C0522B1C}"/>
               </a:ext>
             </a:extLst>
           </p:cNvPr>
@@ -1702,7 +1702,7 @@
           <p:cNvPr id="5" name="">
             <a:extLst xmlns:a="http://schemas.openxmlformats.org/drawingml/2006/main">
               <a:ext uri="{FF2B5EF4-FFF2-40B4-BE49-F238E27FC236}">
-                <a16:creationId xmlns:a16="http://schemas.microsoft.com/office/drawing/2014/main" id="{9AFEC3AD-0692-40A9-8E93-DA6DB7DEF926}"/>
+                <a16:creationId xmlns:a16="http://schemas.microsoft.com/office/drawing/2014/main" id="{77615E93-D942-47F2-9A64-54BD30773AD3}"/>
               </a:ext>
             </a:extLst>
           </p:cNvPr>
@@ -1766,7 +1766,7 @@
           <p:cNvPr id="6" name="">
             <a:extLst xmlns:a="http://schemas.openxmlformats.org/drawingml/2006/main">
               <a:ext uri="{FF2B5EF4-FFF2-40B4-BE49-F238E27FC236}">
-                <a16:creationId xmlns:a16="http://schemas.microsoft.com/office/drawing/2014/main" id="{09B3DE23-CA7C-471C-990D-A9CCF0609E13}"/>
+                <a16:creationId xmlns:a16="http://schemas.microsoft.com/office/drawing/2014/main" id="{39ED0734-7F0E-4D7B-841C-B7D41CDC111C}"/>
               </a:ext>
             </a:extLst>
           </p:cNvPr>
@@ -1801,7 +1801,7 @@
           <p:cNvPr id="7" name="">
             <a:extLst xmlns:a="http://schemas.openxmlformats.org/drawingml/2006/main">
               <a:ext uri="{FF2B5EF4-FFF2-40B4-BE49-F238E27FC236}">
-                <a16:creationId xmlns:a16="http://schemas.microsoft.com/office/drawing/2014/main" id="{D24111E2-0A6B-4CA2-910B-8EF6869580A2}"/>
+                <a16:creationId xmlns:a16="http://schemas.microsoft.com/office/drawing/2014/main" id="{C43A2257-1E82-4134-817C-895F493600B0}"/>
               </a:ext>
             </a:extLst>
           </p:cNvPr>
@@ -1865,7 +1865,7 @@
           <p:cNvPr id="8" name="">
             <a:extLst xmlns:a="http://schemas.openxmlformats.org/drawingml/2006/main">
               <a:ext uri="{FF2B5EF4-FFF2-40B4-BE49-F238E27FC236}">
-                <a16:creationId xmlns:a16="http://schemas.microsoft.com/office/drawing/2014/main" id="{7A1B679A-3262-4DE1-B14A-9774529381AD}"/>
+                <a16:creationId xmlns:a16="http://schemas.microsoft.com/office/drawing/2014/main" id="{CDD41A3F-4FC3-4D3E-A08E-B8D8977E959B}"/>
               </a:ext>
             </a:extLst>
           </p:cNvPr>
@@ -1929,7 +1929,7 @@
           <p:cNvPr id="9" name="">
             <a:extLst xmlns:a="http://schemas.openxmlformats.org/drawingml/2006/main">
               <a:ext uri="{FF2B5EF4-FFF2-40B4-BE49-F238E27FC236}">
-                <a16:creationId xmlns:a16="http://schemas.microsoft.com/office/drawing/2014/main" id="{32E501AE-591D-4F67-BC47-3EC3A5E51E0F}"/>
+                <a16:creationId xmlns:a16="http://schemas.microsoft.com/office/drawing/2014/main" id="{67A83C62-C024-4549-964A-DDB78F80FC8A}"/>
               </a:ext>
             </a:extLst>
           </p:cNvPr>
@@ -1964,7 +1964,7 @@
           <p:cNvPr id="10" name="">
             <a:extLst xmlns:a="http://schemas.openxmlformats.org/drawingml/2006/main">
               <a:ext uri="{FF2B5EF4-FFF2-40B4-BE49-F238E27FC236}">
-                <a16:creationId xmlns:a16="http://schemas.microsoft.com/office/drawing/2014/main" id="{31E819B7-194B-4752-9152-AE87F0CCE678}"/>
+                <a16:creationId xmlns:a16="http://schemas.microsoft.com/office/drawing/2014/main" id="{86187832-53DD-4A98-A91C-F9DC2DC7893F}"/>
               </a:ext>
             </a:extLst>
           </p:cNvPr>
@@ -2028,7 +2028,7 @@
           <p:cNvPr id="11" name="">
             <a:extLst xmlns:a="http://schemas.openxmlformats.org/drawingml/2006/main">
               <a:ext uri="{FF2B5EF4-FFF2-40B4-BE49-F238E27FC236}">
-                <a16:creationId xmlns:a16="http://schemas.microsoft.com/office/drawing/2014/main" id="{2C06AB2C-5A85-493E-A5A1-35CAAAAE60CE}"/>
+                <a16:creationId xmlns:a16="http://schemas.microsoft.com/office/drawing/2014/main" id="{5316FA4C-6DB4-4DBB-8053-FE7207F2D54F}"/>
               </a:ext>
             </a:extLst>
           </p:cNvPr>
@@ -2092,7 +2092,7 @@
           <p:cNvPr id="12" name="">
             <a:extLst xmlns:a="http://schemas.openxmlformats.org/drawingml/2006/main">
               <a:ext uri="{FF2B5EF4-FFF2-40B4-BE49-F238E27FC236}">
-                <a16:creationId xmlns:a16="http://schemas.microsoft.com/office/drawing/2014/main" id="{371630C4-6694-4158-9E92-AABF07EB35F8}"/>
+                <a16:creationId xmlns:a16="http://schemas.microsoft.com/office/drawing/2014/main" id="{0E8C0AB7-0E35-4B10-94BD-79F028E1FFB2}"/>
               </a:ext>
             </a:extLst>
           </p:cNvPr>
@@ -2127,7 +2127,7 @@
           <p:cNvPr id="13" name="">
             <a:extLst xmlns:a="http://schemas.openxmlformats.org/drawingml/2006/main">
               <a:ext uri="{FF2B5EF4-FFF2-40B4-BE49-F238E27FC236}">
-                <a16:creationId xmlns:a16="http://schemas.microsoft.com/office/drawing/2014/main" id="{53799F7B-D712-4A54-836B-6721C42D9DC3}"/>
+                <a16:creationId xmlns:a16="http://schemas.microsoft.com/office/drawing/2014/main" id="{84282D44-D1B1-4D8E-85D7-056D2A7020D4}"/>
               </a:ext>
             </a:extLst>
           </p:cNvPr>
@@ -2191,7 +2191,7 @@
           <p:cNvPr id="14" name="">
             <a:extLst xmlns:a="http://schemas.openxmlformats.org/drawingml/2006/main">
               <a:ext uri="{FF2B5EF4-FFF2-40B4-BE49-F238E27FC236}">
-                <a16:creationId xmlns:a16="http://schemas.microsoft.com/office/drawing/2014/main" id="{39075629-6DEE-451B-ABBC-6754AA93B790}"/>
+                <a16:creationId xmlns:a16="http://schemas.microsoft.com/office/drawing/2014/main" id="{5DF25B7C-62E6-4EA0-941E-2C03279A27DC}"/>
               </a:ext>
             </a:extLst>
           </p:cNvPr>
@@ -2255,7 +2255,7 @@
           <p:cNvPr id="15" name="">
             <a:extLst xmlns:a="http://schemas.openxmlformats.org/drawingml/2006/main">
               <a:ext uri="{FF2B5EF4-FFF2-40B4-BE49-F238E27FC236}">
-                <a16:creationId xmlns:a16="http://schemas.microsoft.com/office/drawing/2014/main" id="{BB0FD61F-703E-4E98-BE30-4B4BEAD08343}"/>
+                <a16:creationId xmlns:a16="http://schemas.microsoft.com/office/drawing/2014/main" id="{A141CB4D-7360-4EA3-8203-CBB9408BF276}"/>
               </a:ext>
             </a:extLst>
           </p:cNvPr>
@@ -2319,7 +2319,7 @@
           <p:cNvPr id="16" name="">
             <a:extLst xmlns:a="http://schemas.openxmlformats.org/drawingml/2006/main">
               <a:ext uri="{FF2B5EF4-FFF2-40B4-BE49-F238E27FC236}">
-                <a16:creationId xmlns:a16="http://schemas.microsoft.com/office/drawing/2014/main" id="{D6106761-5361-4C29-8FBB-45096377779B}"/>
+                <a16:creationId xmlns:a16="http://schemas.microsoft.com/office/drawing/2014/main" id="{0C58F718-956A-4D1A-B5F2-519B1328DC4B}"/>
               </a:ext>
             </a:extLst>
           </p:cNvPr>
@@ -2358,7 +2358,7 @@
           <p:nvPr/>
         </p:nvPicPr>
         <p:blipFill>
-          <a:blip xmlns:r="http://schemas.openxmlformats.org/officeDocument/2006/relationships" xmlns:a="http://schemas.openxmlformats.org/drawingml/2006/main" r:embed="R1b00fd3811344431"/>
+          <a:blip xmlns:r="http://schemas.openxmlformats.org/officeDocument/2006/relationships" xmlns:a="http://schemas.openxmlformats.org/drawingml/2006/main" r:embed="Re7a4857b756941a4"/>
           <a:srcRect xmlns:a="http://schemas.openxmlformats.org/drawingml/2006/main" l="20736" t="0" r="20736" b="0"/>
           <a:stretch xmlns:a="http://schemas.openxmlformats.org/drawingml/2006/main">
             <a:fillRect l="0" t="0" r="0" b="0"/>
@@ -2379,7 +2379,7 @@
           <p:cNvPr id="18" name="">
             <a:extLst xmlns:a="http://schemas.openxmlformats.org/drawingml/2006/main">
               <a:ext uri="{FF2B5EF4-FFF2-40B4-BE49-F238E27FC236}">
-                <a16:creationId xmlns:a16="http://schemas.microsoft.com/office/drawing/2014/main" id="{05E599E2-8F79-4702-9969-531B0B8AC882}"/>
+                <a16:creationId xmlns:a16="http://schemas.microsoft.com/office/drawing/2014/main" id="{5C20E90A-6C28-421B-81DA-2643DCBB5D35}"/>
               </a:ext>
             </a:extLst>
           </p:cNvPr>
@@ -2416,7 +2416,7 @@
           <p:cNvPr id="19" name="">
             <a:extLst xmlns:a="http://schemas.openxmlformats.org/drawingml/2006/main">
               <a:ext uri="{FF2B5EF4-FFF2-40B4-BE49-F238E27FC236}">
-                <a16:creationId xmlns:a16="http://schemas.microsoft.com/office/drawing/2014/main" id="{B85C4D47-45DC-40B0-A22C-629DE8829469}"/>
+                <a16:creationId xmlns:a16="http://schemas.microsoft.com/office/drawing/2014/main" id="{C358E484-D9D4-4A46-B7B5-A0016E6030E9}"/>
               </a:ext>
             </a:extLst>
           </p:cNvPr>
@@ -2478,7 +2478,7 @@
     </p:spTree>
     <p:extLst>
       <p:ext uri="{BB962C8B-B14F-4D97-AF65-F5344CB8AC3E}">
-        <p14:creationId xmlns:p14="http://schemas.microsoft.com/office/powerpoint/2010/main" val="1638779374"/>
+        <p14:creationId xmlns:p14="http://schemas.microsoft.com/office/powerpoint/2010/main" val="1745942232"/>
       </p:ext>
     </p:extLst>
   </p:cSld>
@@ -2502,7 +2502,7 @@
           <p:cNvPr id="1" name="">
             <a:extLst xmlns:a="http://schemas.openxmlformats.org/drawingml/2006/main">
               <a:ext uri="{FF2B5EF4-FFF2-40B4-BE49-F238E27FC236}">
-                <a16:creationId xmlns:a16="http://schemas.microsoft.com/office/drawing/2014/main" id="{AC9448A2-7DB7-4F54-AC97-80E2746FD5E0}"/>
+                <a16:creationId xmlns:a16="http://schemas.microsoft.com/office/drawing/2014/main" id="{C734DCFC-BAEF-4F90-9197-45E2CC91FCD0}"/>
               </a:ext>
             </a:extLst>
           </p:cNvPr>
@@ -2537,7 +2537,7 @@
           <p:cNvPr id="2" name="">
             <a:extLst xmlns:a="http://schemas.openxmlformats.org/drawingml/2006/main">
               <a:ext uri="{FF2B5EF4-FFF2-40B4-BE49-F238E27FC236}">
-                <a16:creationId xmlns:a16="http://schemas.microsoft.com/office/drawing/2014/main" id="{39BCC229-7C30-4BA6-A1F4-3083B996FCE2}"/>
+                <a16:creationId xmlns:a16="http://schemas.microsoft.com/office/drawing/2014/main" id="{481C4319-EB9A-4DD9-A2FC-80DF0510A122}"/>
               </a:ext>
             </a:extLst>
           </p:cNvPr>
@@ -2572,7 +2572,7 @@
           <p:cNvPr id="3" name="">
             <a:extLst xmlns:a="http://schemas.openxmlformats.org/drawingml/2006/main">
               <a:ext uri="{FF2B5EF4-FFF2-40B4-BE49-F238E27FC236}">
-                <a16:creationId xmlns:a16="http://schemas.microsoft.com/office/drawing/2014/main" id="{7680E172-0E54-44B2-942D-363B5969E9B3}"/>
+                <a16:creationId xmlns:a16="http://schemas.microsoft.com/office/drawing/2014/main" id="{833A8088-237D-4324-8DB4-F4E89E3BC2C8}"/>
               </a:ext>
             </a:extLst>
           </p:cNvPr>
@@ -2636,7 +2636,7 @@
           <p:cNvPr id="4" name="">
             <a:extLst xmlns:a="http://schemas.openxmlformats.org/drawingml/2006/main">
               <a:ext uri="{FF2B5EF4-FFF2-40B4-BE49-F238E27FC236}">
-                <a16:creationId xmlns:a16="http://schemas.microsoft.com/office/drawing/2014/main" id="{F60C1EE9-49FA-4B7D-8F9C-52C4332B923C}"/>
+                <a16:creationId xmlns:a16="http://schemas.microsoft.com/office/drawing/2014/main" id="{F5ACF1A7-9B53-4B30-AA72-6C7F6B51B982}"/>
               </a:ext>
             </a:extLst>
           </p:cNvPr>
@@ -2700,7 +2700,7 @@
           <p:cNvPr id="5" name="">
             <a:extLst xmlns:a="http://schemas.openxmlformats.org/drawingml/2006/main">
               <a:ext uri="{FF2B5EF4-FFF2-40B4-BE49-F238E27FC236}">
-                <a16:creationId xmlns:a16="http://schemas.microsoft.com/office/drawing/2014/main" id="{25214729-1BFC-40AF-B9AD-71B205218514}"/>
+                <a16:creationId xmlns:a16="http://schemas.microsoft.com/office/drawing/2014/main" id="{11466233-4F24-410A-9CB3-9552C266028D}"/>
               </a:ext>
             </a:extLst>
           </p:cNvPr>
@@ -2764,7 +2764,7 @@
           <p:cNvPr id="6" name="">
             <a:extLst xmlns:a="http://schemas.openxmlformats.org/drawingml/2006/main">
               <a:ext uri="{FF2B5EF4-FFF2-40B4-BE49-F238E27FC236}">
-                <a16:creationId xmlns:a16="http://schemas.microsoft.com/office/drawing/2014/main" id="{90D6FC35-11DF-44AB-8B26-443AC86C1820}"/>
+                <a16:creationId xmlns:a16="http://schemas.microsoft.com/office/drawing/2014/main" id="{0A73D9BA-7DA5-4600-84FE-99143514754F}"/>
               </a:ext>
             </a:extLst>
           </p:cNvPr>
@@ -2828,7 +2828,7 @@
           <p:cNvPr id="7" name="">
             <a:extLst xmlns:a="http://schemas.openxmlformats.org/drawingml/2006/main">
               <a:ext uri="{FF2B5EF4-FFF2-40B4-BE49-F238E27FC236}">
-                <a16:creationId xmlns:a16="http://schemas.microsoft.com/office/drawing/2014/main" id="{EF9056D4-29E9-4C0D-94A2-3F9230C63208}"/>
+                <a16:creationId xmlns:a16="http://schemas.microsoft.com/office/drawing/2014/main" id="{087CB317-600A-4FBC-B19F-9819A9A6378E}"/>
               </a:ext>
             </a:extLst>
           </p:cNvPr>
@@ -2892,7 +2892,7 @@
           <p:cNvPr id="8" name="">
             <a:extLst xmlns:a="http://schemas.openxmlformats.org/drawingml/2006/main">
               <a:ext uri="{FF2B5EF4-FFF2-40B4-BE49-F238E27FC236}">
-                <a16:creationId xmlns:a16="http://schemas.microsoft.com/office/drawing/2014/main" id="{34F9D0E0-965D-47E5-9FB6-798751311090}"/>
+                <a16:creationId xmlns:a16="http://schemas.microsoft.com/office/drawing/2014/main" id="{3E3E7AAB-2820-4E34-9702-2CAB921EE6D2}"/>
               </a:ext>
             </a:extLst>
           </p:cNvPr>
@@ -2925,7 +2925,7 @@
           <p:cNvPr id="9" name="">
             <a:extLst xmlns:a="http://schemas.openxmlformats.org/drawingml/2006/main">
               <a:ext uri="{FF2B5EF4-FFF2-40B4-BE49-F238E27FC236}">
-                <a16:creationId xmlns:a16="http://schemas.microsoft.com/office/drawing/2014/main" id="{45BC6843-C2FD-4D17-AA15-3EFDE835FEB1}"/>
+                <a16:creationId xmlns:a16="http://schemas.microsoft.com/office/drawing/2014/main" id="{1A270BCD-D437-4780-BB55-8CFEACFA8751}"/>
               </a:ext>
             </a:extLst>
           </p:cNvPr>
@@ -2989,7 +2989,7 @@
           <p:cNvPr id="10" name="">
             <a:extLst xmlns:a="http://schemas.openxmlformats.org/drawingml/2006/main">
               <a:ext uri="{FF2B5EF4-FFF2-40B4-BE49-F238E27FC236}">
-                <a16:creationId xmlns:a16="http://schemas.microsoft.com/office/drawing/2014/main" id="{D81BF05F-5A2F-4DF3-9EAA-E763A793354E}"/>
+                <a16:creationId xmlns:a16="http://schemas.microsoft.com/office/drawing/2014/main" id="{B983E8D8-9236-4881-97AD-59B8F08C2B90}"/>
               </a:ext>
             </a:extLst>
           </p:cNvPr>
@@ -3053,7 +3053,7 @@
           <p:cNvPr id="11" name="">
             <a:extLst xmlns:a="http://schemas.openxmlformats.org/drawingml/2006/main">
               <a:ext uri="{FF2B5EF4-FFF2-40B4-BE49-F238E27FC236}">
-                <a16:creationId xmlns:a16="http://schemas.microsoft.com/office/drawing/2014/main" id="{41FB93D7-E0C2-4611-B109-BB9D64FB79F8}"/>
+                <a16:creationId xmlns:a16="http://schemas.microsoft.com/office/drawing/2014/main" id="{EF9C53E3-F200-4920-B8AB-6C643DC398BE}"/>
               </a:ext>
             </a:extLst>
           </p:cNvPr>
@@ -3088,7 +3088,7 @@
           <p:cNvPr id="12" name="">
             <a:extLst xmlns:a="http://schemas.openxmlformats.org/drawingml/2006/main">
               <a:ext uri="{FF2B5EF4-FFF2-40B4-BE49-F238E27FC236}">
-                <a16:creationId xmlns:a16="http://schemas.microsoft.com/office/drawing/2014/main" id="{FDAFDBB2-B011-42BC-8BDB-54396363525D}"/>
+                <a16:creationId xmlns:a16="http://schemas.microsoft.com/office/drawing/2014/main" id="{D87ABD90-6ED1-4678-9A6E-57795F1DD012}"/>
               </a:ext>
             </a:extLst>
           </p:cNvPr>
@@ -3123,7 +3123,7 @@
           <p:cNvPr id="13" name="">
             <a:extLst xmlns:a="http://schemas.openxmlformats.org/drawingml/2006/main">
               <a:ext uri="{FF2B5EF4-FFF2-40B4-BE49-F238E27FC236}">
-                <a16:creationId xmlns:a16="http://schemas.microsoft.com/office/drawing/2014/main" id="{7456826E-579E-41EA-91DE-E162DAA94947}"/>
+                <a16:creationId xmlns:a16="http://schemas.microsoft.com/office/drawing/2014/main" id="{5BB778E3-E716-4E00-A39F-9D0FF5AC1DC9}"/>
               </a:ext>
             </a:extLst>
           </p:cNvPr>
@@ -3187,7 +3187,7 @@
           <p:cNvPr id="14" name="">
             <a:extLst xmlns:a="http://schemas.openxmlformats.org/drawingml/2006/main">
               <a:ext uri="{FF2B5EF4-FFF2-40B4-BE49-F238E27FC236}">
-                <a16:creationId xmlns:a16="http://schemas.microsoft.com/office/drawing/2014/main" id="{C7D741DA-0D41-46B9-AF2C-5ECE6C166539}"/>
+                <a16:creationId xmlns:a16="http://schemas.microsoft.com/office/drawing/2014/main" id="{32EACF1D-1774-4990-B124-F23ACF496EC5}"/>
               </a:ext>
             </a:extLst>
           </p:cNvPr>
@@ -3251,7 +3251,7 @@
           <p:cNvPr id="15" name="">
             <a:extLst xmlns:a="http://schemas.openxmlformats.org/drawingml/2006/main">
               <a:ext uri="{FF2B5EF4-FFF2-40B4-BE49-F238E27FC236}">
-                <a16:creationId xmlns:a16="http://schemas.microsoft.com/office/drawing/2014/main" id="{7F39113F-5498-4499-9A77-0E32232D614D}"/>
+                <a16:creationId xmlns:a16="http://schemas.microsoft.com/office/drawing/2014/main" id="{B08B56FE-67B1-4567-A329-9240FD877D2E}"/>
               </a:ext>
             </a:extLst>
           </p:cNvPr>
@@ -3286,7 +3286,7 @@
           <p:cNvPr id="16" name="">
             <a:extLst xmlns:a="http://schemas.openxmlformats.org/drawingml/2006/main">
               <a:ext uri="{FF2B5EF4-FFF2-40B4-BE49-F238E27FC236}">
-                <a16:creationId xmlns:a16="http://schemas.microsoft.com/office/drawing/2014/main" id="{2921DC0E-8F93-47C9-8520-B079F25F9226}"/>
+                <a16:creationId xmlns:a16="http://schemas.microsoft.com/office/drawing/2014/main" id="{DE15FA99-3EA2-45E6-83BB-886E9CACDB60}"/>
               </a:ext>
             </a:extLst>
           </p:cNvPr>
@@ -3350,7 +3350,7 @@
           <p:cNvPr id="17" name="">
             <a:extLst xmlns:a="http://schemas.openxmlformats.org/drawingml/2006/main">
               <a:ext uri="{FF2B5EF4-FFF2-40B4-BE49-F238E27FC236}">
-                <a16:creationId xmlns:a16="http://schemas.microsoft.com/office/drawing/2014/main" id="{0DF3E204-51E2-40DE-B3D2-755827647C1D}"/>
+                <a16:creationId xmlns:a16="http://schemas.microsoft.com/office/drawing/2014/main" id="{4D6795D3-60DD-4D55-BE5D-3EE11AF5322A}"/>
               </a:ext>
             </a:extLst>
           </p:cNvPr>
@@ -3414,7 +3414,7 @@
           <p:cNvPr id="18" name="">
             <a:extLst xmlns:a="http://schemas.openxmlformats.org/drawingml/2006/main">
               <a:ext uri="{FF2B5EF4-FFF2-40B4-BE49-F238E27FC236}">
-                <a16:creationId xmlns:a16="http://schemas.microsoft.com/office/drawing/2014/main" id="{41322573-D67C-4390-9398-35D55B68AD88}"/>
+                <a16:creationId xmlns:a16="http://schemas.microsoft.com/office/drawing/2014/main" id="{337A7171-F3BA-464E-9BF2-CA991D13F591}"/>
               </a:ext>
             </a:extLst>
           </p:cNvPr>
@@ -3449,7 +3449,7 @@
           <p:cNvPr id="19" name="">
             <a:extLst xmlns:a="http://schemas.openxmlformats.org/drawingml/2006/main">
               <a:ext uri="{FF2B5EF4-FFF2-40B4-BE49-F238E27FC236}">
-                <a16:creationId xmlns:a16="http://schemas.microsoft.com/office/drawing/2014/main" id="{EB2DED3A-042B-4772-B046-6AE40BB94BF8}"/>
+                <a16:creationId xmlns:a16="http://schemas.microsoft.com/office/drawing/2014/main" id="{2A2F3D41-615D-4460-A370-A02A8EC23BDC}"/>
               </a:ext>
             </a:extLst>
           </p:cNvPr>
@@ -3513,7 +3513,7 @@
           <p:cNvPr id="20" name="">
             <a:extLst xmlns:a="http://schemas.openxmlformats.org/drawingml/2006/main">
               <a:ext uri="{FF2B5EF4-FFF2-40B4-BE49-F238E27FC236}">
-                <a16:creationId xmlns:a16="http://schemas.microsoft.com/office/drawing/2014/main" id="{5DE6D301-2CED-4365-8BF3-7A2C5047AD5E}"/>
+                <a16:creationId xmlns:a16="http://schemas.microsoft.com/office/drawing/2014/main" id="{62DE1662-8A85-4A55-8896-FE6EA4601AC7}"/>
               </a:ext>
             </a:extLst>
           </p:cNvPr>
@@ -3577,7 +3577,7 @@
           <p:cNvPr id="21" name="">
             <a:extLst xmlns:a="http://schemas.openxmlformats.org/drawingml/2006/main">
               <a:ext uri="{FF2B5EF4-FFF2-40B4-BE49-F238E27FC236}">
-                <a16:creationId xmlns:a16="http://schemas.microsoft.com/office/drawing/2014/main" id="{DFD5F86A-0DA7-47FB-B6B9-069CDDDA665A}"/>
+                <a16:creationId xmlns:a16="http://schemas.microsoft.com/office/drawing/2014/main" id="{7CECBD84-5BD9-40AF-AD27-A846FA33E64F}"/>
               </a:ext>
             </a:extLst>
           </p:cNvPr>
@@ -3639,7 +3639,7 @@
     </p:spTree>
     <p:extLst>
       <p:ext uri="{BB962C8B-B14F-4D97-AF65-F5344CB8AC3E}">
-        <p14:creationId xmlns:p14="http://schemas.microsoft.com/office/powerpoint/2010/main" val="1887695261"/>
+        <p14:creationId xmlns:p14="http://schemas.microsoft.com/office/powerpoint/2010/main" val="233184275"/>
       </p:ext>
     </p:extLst>
   </p:cSld>
@@ -3663,7 +3663,7 @@
           <p:cNvPr id="1" name="">
             <a:extLst xmlns:a="http://schemas.openxmlformats.org/drawingml/2006/main">
               <a:ext uri="{FF2B5EF4-FFF2-40B4-BE49-F238E27FC236}">
-                <a16:creationId xmlns:a16="http://schemas.microsoft.com/office/drawing/2014/main" id="{65BDC3EE-6C2D-458B-8A26-BFAAD75D73DA}"/>
+                <a16:creationId xmlns:a16="http://schemas.microsoft.com/office/drawing/2014/main" id="{CF5120C9-25B7-4E2F-8FB0-0302DA48D581}"/>
               </a:ext>
             </a:extLst>
           </p:cNvPr>
@@ -3698,7 +3698,7 @@
           <p:cNvPr id="2" name="">
             <a:extLst xmlns:a="http://schemas.openxmlformats.org/drawingml/2006/main">
               <a:ext uri="{FF2B5EF4-FFF2-40B4-BE49-F238E27FC236}">
-                <a16:creationId xmlns:a16="http://schemas.microsoft.com/office/drawing/2014/main" id="{469CB850-FFEF-4C67-8124-828FEFC62F9C}"/>
+                <a16:creationId xmlns:a16="http://schemas.microsoft.com/office/drawing/2014/main" id="{D00E959A-165D-4193-8E36-527F2B5DBF49}"/>
               </a:ext>
             </a:extLst>
           </p:cNvPr>
@@ -3733,7 +3733,7 @@
           <p:cNvPr id="3" name="">
             <a:extLst xmlns:a="http://schemas.openxmlformats.org/drawingml/2006/main">
               <a:ext uri="{FF2B5EF4-FFF2-40B4-BE49-F238E27FC236}">
-                <a16:creationId xmlns:a16="http://schemas.microsoft.com/office/drawing/2014/main" id="{59C8D6D6-ECA6-462C-A0EA-110CA50D36D2}"/>
+                <a16:creationId xmlns:a16="http://schemas.microsoft.com/office/drawing/2014/main" id="{64E2992D-EA0D-4757-93B2-D83FE1687FE3}"/>
               </a:ext>
             </a:extLst>
           </p:cNvPr>
@@ -3797,7 +3797,7 @@
           <p:cNvPr id="4" name="">
             <a:extLst xmlns:a="http://schemas.openxmlformats.org/drawingml/2006/main">
               <a:ext uri="{FF2B5EF4-FFF2-40B4-BE49-F238E27FC236}">
-                <a16:creationId xmlns:a16="http://schemas.microsoft.com/office/drawing/2014/main" id="{F5C7F0A2-70EB-47CD-B5FF-C2D93A2BF043}"/>
+                <a16:creationId xmlns:a16="http://schemas.microsoft.com/office/drawing/2014/main" id="{862CDC91-7BB6-4C1C-92E9-4A771DC2065B}"/>
               </a:ext>
             </a:extLst>
           </p:cNvPr>
@@ -3861,7 +3861,7 @@
           <p:cNvPr id="5" name="">
             <a:extLst xmlns:a="http://schemas.openxmlformats.org/drawingml/2006/main">
               <a:ext uri="{FF2B5EF4-FFF2-40B4-BE49-F238E27FC236}">
-                <a16:creationId xmlns:a16="http://schemas.microsoft.com/office/drawing/2014/main" id="{AB9F510D-EBA7-4F5D-90B3-C33467706164}"/>
+                <a16:creationId xmlns:a16="http://schemas.microsoft.com/office/drawing/2014/main" id="{16D862AB-E870-4149-AF02-66B29403FBC3}"/>
               </a:ext>
             </a:extLst>
           </p:cNvPr>
@@ -3925,7 +3925,7 @@
           <p:cNvPr id="6" name="">
             <a:extLst xmlns:a="http://schemas.openxmlformats.org/drawingml/2006/main">
               <a:ext uri="{FF2B5EF4-FFF2-40B4-BE49-F238E27FC236}">
-                <a16:creationId xmlns:a16="http://schemas.microsoft.com/office/drawing/2014/main" id="{735AB043-8A4B-4577-8BE1-A75432F28D49}"/>
+                <a16:creationId xmlns:a16="http://schemas.microsoft.com/office/drawing/2014/main" id="{41EE830C-2A21-4886-9740-C36FA11A5D0F}"/>
               </a:ext>
             </a:extLst>
           </p:cNvPr>
@@ -3989,7 +3989,7 @@
           <p:cNvPr id="7" name="">
             <a:extLst xmlns:a="http://schemas.openxmlformats.org/drawingml/2006/main">
               <a:ext uri="{FF2B5EF4-FFF2-40B4-BE49-F238E27FC236}">
-                <a16:creationId xmlns:a16="http://schemas.microsoft.com/office/drawing/2014/main" id="{CAF2841F-A3C8-473F-A96A-F7D13B90FA68}"/>
+                <a16:creationId xmlns:a16="http://schemas.microsoft.com/office/drawing/2014/main" id="{480EC114-635F-4B84-931E-42225247F494}"/>
               </a:ext>
             </a:extLst>
           </p:cNvPr>
@@ -4026,7 +4026,7 @@
           <p:nvPr/>
         </p:nvPicPr>
         <p:blipFill>
-          <a:blip xmlns:r="http://schemas.openxmlformats.org/officeDocument/2006/relationships" xmlns:a="http://schemas.openxmlformats.org/drawingml/2006/main" r:embed="Rd806507a958b47e5"/>
+          <a:blip xmlns:r="http://schemas.openxmlformats.org/officeDocument/2006/relationships" xmlns:a="http://schemas.openxmlformats.org/drawingml/2006/main" r:embed="R77677536fc794330"/>
           <a:stretch xmlns:a="http://schemas.openxmlformats.org/drawingml/2006/main"/>
         </p:blipFill>
         <p:spPr>
@@ -4044,7 +4044,7 @@
           <p:cNvPr id="9" name="">
             <a:extLst xmlns:a="http://schemas.openxmlformats.org/drawingml/2006/main">
               <a:ext uri="{FF2B5EF4-FFF2-40B4-BE49-F238E27FC236}">
-                <a16:creationId xmlns:a16="http://schemas.microsoft.com/office/drawing/2014/main" id="{C72E3ECB-C409-4698-87E2-D9A012BFE528}"/>
+                <a16:creationId xmlns:a16="http://schemas.microsoft.com/office/drawing/2014/main" id="{3DAD0DD0-E192-447F-AC8F-1355FD846881}"/>
               </a:ext>
             </a:extLst>
           </p:cNvPr>
@@ -4079,7 +4079,7 @@
           <p:cNvPr id="10" name="">
             <a:extLst xmlns:a="http://schemas.openxmlformats.org/drawingml/2006/main">
               <a:ext uri="{FF2B5EF4-FFF2-40B4-BE49-F238E27FC236}">
-                <a16:creationId xmlns:a16="http://schemas.microsoft.com/office/drawing/2014/main" id="{D8F56DD3-216C-485C-8046-77DCC00A4C70}"/>
+                <a16:creationId xmlns:a16="http://schemas.microsoft.com/office/drawing/2014/main" id="{89711C4F-F9E7-4E40-A50F-0873BECA2CF8}"/>
               </a:ext>
             </a:extLst>
           </p:cNvPr>
@@ -4143,7 +4143,7 @@
           <p:cNvPr id="11" name="">
             <a:extLst xmlns:a="http://schemas.openxmlformats.org/drawingml/2006/main">
               <a:ext uri="{FF2B5EF4-FFF2-40B4-BE49-F238E27FC236}">
-                <a16:creationId xmlns:a16="http://schemas.microsoft.com/office/drawing/2014/main" id="{D69B48AC-3F85-4439-818B-5118DEF0F767}"/>
+                <a16:creationId xmlns:a16="http://schemas.microsoft.com/office/drawing/2014/main" id="{536F569C-1C1A-478E-860C-797DE2CCF7A0}"/>
               </a:ext>
             </a:extLst>
           </p:cNvPr>
@@ -4178,7 +4178,7 @@
           <p:cNvPr id="12" name="">
             <a:extLst xmlns:a="http://schemas.openxmlformats.org/drawingml/2006/main">
               <a:ext uri="{FF2B5EF4-FFF2-40B4-BE49-F238E27FC236}">
-                <a16:creationId xmlns:a16="http://schemas.microsoft.com/office/drawing/2014/main" id="{084926E0-9F26-4559-8623-1E714E584043}"/>
+                <a16:creationId xmlns:a16="http://schemas.microsoft.com/office/drawing/2014/main" id="{8547F6BD-53CE-433A-9B18-4919237F56DE}"/>
               </a:ext>
             </a:extLst>
           </p:cNvPr>
@@ -4242,7 +4242,7 @@
           <p:cNvPr id="13" name="">
             <a:extLst xmlns:a="http://schemas.openxmlformats.org/drawingml/2006/main">
               <a:ext uri="{FF2B5EF4-FFF2-40B4-BE49-F238E27FC236}">
-                <a16:creationId xmlns:a16="http://schemas.microsoft.com/office/drawing/2014/main" id="{8A101AB7-5133-49BE-AF29-C8004337B826}"/>
+                <a16:creationId xmlns:a16="http://schemas.microsoft.com/office/drawing/2014/main" id="{51FD148D-CEF9-4A07-B27E-42AE7D81067C}"/>
               </a:ext>
             </a:extLst>
           </p:cNvPr>
@@ -4277,7 +4277,7 @@
           <p:cNvPr id="14" name="">
             <a:extLst xmlns:a="http://schemas.openxmlformats.org/drawingml/2006/main">
               <a:ext uri="{FF2B5EF4-FFF2-40B4-BE49-F238E27FC236}">
-                <a16:creationId xmlns:a16="http://schemas.microsoft.com/office/drawing/2014/main" id="{12065CA5-913A-4E85-A445-3ECFB48ECDCD}"/>
+                <a16:creationId xmlns:a16="http://schemas.microsoft.com/office/drawing/2014/main" id="{810F8AE3-B9FF-45C0-B7BA-3338CFA12386}"/>
               </a:ext>
             </a:extLst>
           </p:cNvPr>
@@ -4341,7 +4341,7 @@
           <p:cNvPr id="15" name="">
             <a:extLst xmlns:a="http://schemas.openxmlformats.org/drawingml/2006/main">
               <a:ext uri="{FF2B5EF4-FFF2-40B4-BE49-F238E27FC236}">
-                <a16:creationId xmlns:a16="http://schemas.microsoft.com/office/drawing/2014/main" id="{A78E0E75-0E46-4824-A2CD-85688D6EB7F0}"/>
+                <a16:creationId xmlns:a16="http://schemas.microsoft.com/office/drawing/2014/main" id="{8D5DB897-9FD0-43F2-88BE-31ED41C556A6}"/>
               </a:ext>
             </a:extLst>
           </p:cNvPr>
@@ -4403,7 +4403,7 @@
     </p:spTree>
     <p:extLst>
       <p:ext uri="{BB962C8B-B14F-4D97-AF65-F5344CB8AC3E}">
-        <p14:creationId xmlns:p14="http://schemas.microsoft.com/office/powerpoint/2010/main" val="1834480185"/>
+        <p14:creationId xmlns:p14="http://schemas.microsoft.com/office/powerpoint/2010/main" val="1803389830"/>
       </p:ext>
     </p:extLst>
   </p:cSld>
@@ -4431,7 +4431,7 @@
           <p:nvPr/>
         </p:nvPicPr>
         <p:blipFill>
-          <a:blip xmlns:r="http://schemas.openxmlformats.org/officeDocument/2006/relationships" xmlns:a="http://schemas.openxmlformats.org/drawingml/2006/main" r:embed="R294947f430754887"/>
+          <a:blip xmlns:r="http://schemas.openxmlformats.org/officeDocument/2006/relationships" xmlns:a="http://schemas.openxmlformats.org/drawingml/2006/main" r:embed="Rc77d563b98a84b9c"/>
           <a:srcRect xmlns:a="http://schemas.openxmlformats.org/drawingml/2006/main" l="0" t="5284" r="0" b="5284"/>
           <a:stretch xmlns:a="http://schemas.openxmlformats.org/drawingml/2006/main">
             <a:fillRect l="0" t="0" r="0" b="0"/>
@@ -4452,7 +4452,7 @@
           <p:cNvPr id="2" name="">
             <a:extLst xmlns:a="http://schemas.openxmlformats.org/drawingml/2006/main">
               <a:ext uri="{FF2B5EF4-FFF2-40B4-BE49-F238E27FC236}">
-                <a16:creationId xmlns:a16="http://schemas.microsoft.com/office/drawing/2014/main" id="{C74ABBDB-5A88-4362-8375-DFB3BDCBAA23}"/>
+                <a16:creationId xmlns:a16="http://schemas.microsoft.com/office/drawing/2014/main" id="{9BD119EF-F446-467D-98D7-34FF900D2339}"/>
               </a:ext>
             </a:extLst>
           </p:cNvPr>
@@ -4489,7 +4489,7 @@
           <p:cNvPr id="3" name="">
             <a:extLst xmlns:a="http://schemas.openxmlformats.org/drawingml/2006/main">
               <a:ext uri="{FF2B5EF4-FFF2-40B4-BE49-F238E27FC236}">
-                <a16:creationId xmlns:a16="http://schemas.microsoft.com/office/drawing/2014/main" id="{F9BD8886-A64C-466C-8A24-B091B002833B}"/>
+                <a16:creationId xmlns:a16="http://schemas.microsoft.com/office/drawing/2014/main" id="{43EF27DC-2EF8-4147-AFBA-BE256A14F71C}"/>
               </a:ext>
             </a:extLst>
           </p:cNvPr>
@@ -4553,7 +4553,7 @@
           <p:cNvPr id="4" name="">
             <a:extLst xmlns:a="http://schemas.openxmlformats.org/drawingml/2006/main">
               <a:ext uri="{FF2B5EF4-FFF2-40B4-BE49-F238E27FC236}">
-                <a16:creationId xmlns:a16="http://schemas.microsoft.com/office/drawing/2014/main" id="{90E6ACD1-A5FC-4BD1-917B-62C7FB937484}"/>
+                <a16:creationId xmlns:a16="http://schemas.microsoft.com/office/drawing/2014/main" id="{F6DB4368-0722-4453-8135-CA6D17FA156A}"/>
               </a:ext>
             </a:extLst>
           </p:cNvPr>
@@ -4617,7 +4617,7 @@
           <p:cNvPr id="5" name="">
             <a:extLst xmlns:a="http://schemas.openxmlformats.org/drawingml/2006/main">
               <a:ext uri="{FF2B5EF4-FFF2-40B4-BE49-F238E27FC236}">
-                <a16:creationId xmlns:a16="http://schemas.microsoft.com/office/drawing/2014/main" id="{CA44C7C9-B5D2-4642-9610-1B1E9DA4E7F4}"/>
+                <a16:creationId xmlns:a16="http://schemas.microsoft.com/office/drawing/2014/main" id="{24FD366C-3319-459F-B450-407E32BF2F46}"/>
               </a:ext>
             </a:extLst>
           </p:cNvPr>
@@ -4681,7 +4681,7 @@
           <p:cNvPr id="6" name="">
             <a:extLst xmlns:a="http://schemas.openxmlformats.org/drawingml/2006/main">
               <a:ext uri="{FF2B5EF4-FFF2-40B4-BE49-F238E27FC236}">
-                <a16:creationId xmlns:a16="http://schemas.microsoft.com/office/drawing/2014/main" id="{B580A19C-DAA4-4492-A9E0-0F102527C6AC}"/>
+                <a16:creationId xmlns:a16="http://schemas.microsoft.com/office/drawing/2014/main" id="{31C9EF9E-A938-4E15-B593-12F90ECD755A}"/>
               </a:ext>
             </a:extLst>
           </p:cNvPr>
@@ -4745,7 +4745,7 @@
           <p:cNvPr id="7" name="">
             <a:extLst xmlns:a="http://schemas.openxmlformats.org/drawingml/2006/main">
               <a:ext uri="{FF2B5EF4-FFF2-40B4-BE49-F238E27FC236}">
-                <a16:creationId xmlns:a16="http://schemas.microsoft.com/office/drawing/2014/main" id="{1EFDE143-5829-4206-A35D-B1C955024529}"/>
+                <a16:creationId xmlns:a16="http://schemas.microsoft.com/office/drawing/2014/main" id="{F0ED9227-687D-4923-8D42-51CF2F33419B}"/>
               </a:ext>
             </a:extLst>
           </p:cNvPr>
@@ -4809,7 +4809,7 @@
           <p:cNvPr id="8" name="">
             <a:extLst xmlns:a="http://schemas.openxmlformats.org/drawingml/2006/main">
               <a:ext uri="{FF2B5EF4-FFF2-40B4-BE49-F238E27FC236}">
-                <a16:creationId xmlns:a16="http://schemas.microsoft.com/office/drawing/2014/main" id="{386CE0E6-5453-4976-83A3-D8F412B48EBD}"/>
+                <a16:creationId xmlns:a16="http://schemas.microsoft.com/office/drawing/2014/main" id="{1ACB5366-2635-40A1-8BFB-BCAB545E1467}"/>
               </a:ext>
             </a:extLst>
           </p:cNvPr>
@@ -4873,7 +4873,7 @@
           <p:cNvPr id="9" name="">
             <a:extLst xmlns:a="http://schemas.openxmlformats.org/drawingml/2006/main">
               <a:ext uri="{FF2B5EF4-FFF2-40B4-BE49-F238E27FC236}">
-                <a16:creationId xmlns:a16="http://schemas.microsoft.com/office/drawing/2014/main" id="{7AC8DAFD-DA9A-4AC5-9A14-23E182BD176B}"/>
+                <a16:creationId xmlns:a16="http://schemas.microsoft.com/office/drawing/2014/main" id="{3E03DE82-E500-4021-9544-5D1D24E62439}"/>
               </a:ext>
             </a:extLst>
           </p:cNvPr>
@@ -4937,7 +4937,7 @@
           <p:cNvPr id="10" name="">
             <a:extLst xmlns:a="http://schemas.openxmlformats.org/drawingml/2006/main">
               <a:ext uri="{FF2B5EF4-FFF2-40B4-BE49-F238E27FC236}">
-                <a16:creationId xmlns:a16="http://schemas.microsoft.com/office/drawing/2014/main" id="{1A7F0534-52E7-4806-8101-ACC6F1D1366F}"/>
+                <a16:creationId xmlns:a16="http://schemas.microsoft.com/office/drawing/2014/main" id="{6476B071-CAC7-4F5E-B78D-FBE2FA80B8EF}"/>
               </a:ext>
             </a:extLst>
           </p:cNvPr>
@@ -5001,7 +5001,7 @@
           <p:cNvPr id="11" name="">
             <a:extLst xmlns:a="http://schemas.openxmlformats.org/drawingml/2006/main">
               <a:ext uri="{FF2B5EF4-FFF2-40B4-BE49-F238E27FC236}">
-                <a16:creationId xmlns:a16="http://schemas.microsoft.com/office/drawing/2014/main" id="{05465358-CC93-4C60-9E66-8987CB64E6B8}"/>
+                <a16:creationId xmlns:a16="http://schemas.microsoft.com/office/drawing/2014/main" id="{7C1B962B-C42C-4F05-99FD-77BDEA75A1E3}"/>
               </a:ext>
             </a:extLst>
           </p:cNvPr>
@@ -5065,7 +5065,7 @@
           <p:cNvPr id="12" name="">
             <a:extLst xmlns:a="http://schemas.openxmlformats.org/drawingml/2006/main">
               <a:ext uri="{FF2B5EF4-FFF2-40B4-BE49-F238E27FC236}">
-                <a16:creationId xmlns:a16="http://schemas.microsoft.com/office/drawing/2014/main" id="{CDBD2F5B-8E5A-4130-9FA4-FDE519AA4E86}"/>
+                <a16:creationId xmlns:a16="http://schemas.microsoft.com/office/drawing/2014/main" id="{922CE91A-8239-4100-B345-9A8332D293C9}"/>
               </a:ext>
             </a:extLst>
           </p:cNvPr>
@@ -5129,7 +5129,7 @@
           <p:cNvPr id="13" name="">
             <a:extLst xmlns:a="http://schemas.openxmlformats.org/drawingml/2006/main">
               <a:ext uri="{FF2B5EF4-FFF2-40B4-BE49-F238E27FC236}">
-                <a16:creationId xmlns:a16="http://schemas.microsoft.com/office/drawing/2014/main" id="{F5EDB4D9-2C42-42E2-B1DC-F648A23C589A}"/>
+                <a16:creationId xmlns:a16="http://schemas.microsoft.com/office/drawing/2014/main" id="{2BAAC1B1-57BB-4742-A32E-EC2F289F3572}"/>
               </a:ext>
             </a:extLst>
           </p:cNvPr>
@@ -5193,7 +5193,7 @@
           <p:cNvPr id="14" name="">
             <a:extLst xmlns:a="http://schemas.openxmlformats.org/drawingml/2006/main">
               <a:ext uri="{FF2B5EF4-FFF2-40B4-BE49-F238E27FC236}">
-                <a16:creationId xmlns:a16="http://schemas.microsoft.com/office/drawing/2014/main" id="{B27DF8D8-13D0-4A8A-9311-36796638584C}"/>
+                <a16:creationId xmlns:a16="http://schemas.microsoft.com/office/drawing/2014/main" id="{9F28048B-4C09-4FC7-8EBE-FEDCF60CE67D}"/>
               </a:ext>
             </a:extLst>
           </p:cNvPr>
@@ -5255,7 +5255,7 @@
     </p:spTree>
     <p:extLst>
       <p:ext uri="{BB962C8B-B14F-4D97-AF65-F5344CB8AC3E}">
-        <p14:creationId xmlns:p14="http://schemas.microsoft.com/office/powerpoint/2010/main" val="1983369942"/>
+        <p14:creationId xmlns:p14="http://schemas.microsoft.com/office/powerpoint/2010/main" val="1416640357"/>
       </p:ext>
     </p:extLst>
   </p:cSld>
@@ -5279,7 +5279,7 @@
           <p:cNvPr id="1" name="">
             <a:extLst xmlns:a="http://schemas.openxmlformats.org/drawingml/2006/main">
               <a:ext uri="{FF2B5EF4-FFF2-40B4-BE49-F238E27FC236}">
-                <a16:creationId xmlns:a16="http://schemas.microsoft.com/office/drawing/2014/main" id="{A362AD22-085C-407A-8A6E-CC4995F7AFDB}"/>
+                <a16:creationId xmlns:a16="http://schemas.microsoft.com/office/drawing/2014/main" id="{D0E5FC3A-CAA2-43C1-9793-E681E5C83489}"/>
               </a:ext>
             </a:extLst>
           </p:cNvPr>
@@ -5314,7 +5314,7 @@
           <p:cNvPr id="2" name="">
             <a:extLst xmlns:a="http://schemas.openxmlformats.org/drawingml/2006/main">
               <a:ext uri="{FF2B5EF4-FFF2-40B4-BE49-F238E27FC236}">
-                <a16:creationId xmlns:a16="http://schemas.microsoft.com/office/drawing/2014/main" id="{E99BCF4C-F9B4-40BC-8D23-B76BECD94A99}"/>
+                <a16:creationId xmlns:a16="http://schemas.microsoft.com/office/drawing/2014/main" id="{906F25DF-0531-4C8E-803A-3C4D585B62FF}"/>
               </a:ext>
             </a:extLst>
           </p:cNvPr>
@@ -5349,7 +5349,7 @@
           <p:cNvPr id="3" name="">
             <a:extLst xmlns:a="http://schemas.openxmlformats.org/drawingml/2006/main">
               <a:ext uri="{FF2B5EF4-FFF2-40B4-BE49-F238E27FC236}">
-                <a16:creationId xmlns:a16="http://schemas.microsoft.com/office/drawing/2014/main" id="{57BD39AB-7136-4007-A91B-26FB9B49D991}"/>
+                <a16:creationId xmlns:a16="http://schemas.microsoft.com/office/drawing/2014/main" id="{1D580E41-20CF-4ECB-AE3D-21463515A52B}"/>
               </a:ext>
             </a:extLst>
           </p:cNvPr>
@@ -5413,7 +5413,7 @@
           <p:cNvPr id="4" name="">
             <a:extLst xmlns:a="http://schemas.openxmlformats.org/drawingml/2006/main">
               <a:ext uri="{FF2B5EF4-FFF2-40B4-BE49-F238E27FC236}">
-                <a16:creationId xmlns:a16="http://schemas.microsoft.com/office/drawing/2014/main" id="{2EDB24CB-7EB8-4AF9-95EB-3C47D88715F0}"/>
+                <a16:creationId xmlns:a16="http://schemas.microsoft.com/office/drawing/2014/main" id="{A504675A-2381-4B16-BFB1-5B7196684568}"/>
               </a:ext>
             </a:extLst>
           </p:cNvPr>
@@ -5477,7 +5477,7 @@
           <p:cNvPr id="5" name="">
             <a:extLst xmlns:a="http://schemas.openxmlformats.org/drawingml/2006/main">
               <a:ext uri="{FF2B5EF4-FFF2-40B4-BE49-F238E27FC236}">
-                <a16:creationId xmlns:a16="http://schemas.microsoft.com/office/drawing/2014/main" id="{614626B9-A31A-44FC-9789-8F6EF7F6295F}"/>
+                <a16:creationId xmlns:a16="http://schemas.microsoft.com/office/drawing/2014/main" id="{B0FC8C45-1A5B-4418-BD2B-09BBBE7D213D}"/>
               </a:ext>
             </a:extLst>
           </p:cNvPr>
@@ -5541,7 +5541,7 @@
           <p:cNvPr id="6" name="">
             <a:extLst xmlns:a="http://schemas.openxmlformats.org/drawingml/2006/main">
               <a:ext uri="{FF2B5EF4-FFF2-40B4-BE49-F238E27FC236}">
-                <a16:creationId xmlns:a16="http://schemas.microsoft.com/office/drawing/2014/main" id="{4E30A6F7-4285-468E-9B18-2A232C7B590C}"/>
+                <a16:creationId xmlns:a16="http://schemas.microsoft.com/office/drawing/2014/main" id="{AB3ED952-CE13-4973-9011-2757A72E201A}"/>
               </a:ext>
             </a:extLst>
           </p:cNvPr>
@@ -5605,7 +5605,7 @@
           <p:cNvPr id="7" name="">
             <a:extLst xmlns:a="http://schemas.openxmlformats.org/drawingml/2006/main">
               <a:ext uri="{FF2B5EF4-FFF2-40B4-BE49-F238E27FC236}">
-                <a16:creationId xmlns:a16="http://schemas.microsoft.com/office/drawing/2014/main" id="{2BD90847-078E-40CB-B395-B301CA2944F3}"/>
+                <a16:creationId xmlns:a16="http://schemas.microsoft.com/office/drawing/2014/main" id="{D6674647-EA09-4CC8-A807-9652D52685F4}"/>
               </a:ext>
             </a:extLst>
           </p:cNvPr>
@@ -5638,7 +5638,7 @@
           <p:cNvPr id="8" name="">
             <a:extLst xmlns:a="http://schemas.openxmlformats.org/drawingml/2006/main">
               <a:ext uri="{FF2B5EF4-FFF2-40B4-BE49-F238E27FC236}">
-                <a16:creationId xmlns:a16="http://schemas.microsoft.com/office/drawing/2014/main" id="{170AD82A-D1B4-4CDE-B6BC-51EF5CE34FEA}"/>
+                <a16:creationId xmlns:a16="http://schemas.microsoft.com/office/drawing/2014/main" id="{5C4CF93F-3453-4F98-A175-3843333A4562}"/>
               </a:ext>
             </a:extLst>
           </p:cNvPr>
@@ -5673,7 +5673,7 @@
           <p:cNvPr id="9" name="">
             <a:extLst xmlns:a="http://schemas.openxmlformats.org/drawingml/2006/main">
               <a:ext uri="{FF2B5EF4-FFF2-40B4-BE49-F238E27FC236}">
-                <a16:creationId xmlns:a16="http://schemas.microsoft.com/office/drawing/2014/main" id="{28E84F62-73B5-40D7-A8C6-040CDD56BB8D}"/>
+                <a16:creationId xmlns:a16="http://schemas.microsoft.com/office/drawing/2014/main" id="{FEDC2345-A4F0-4761-8EF2-60571FA28010}"/>
               </a:ext>
             </a:extLst>
           </p:cNvPr>
@@ -5737,7 +5737,7 @@
           <p:cNvPr id="10" name="">
             <a:extLst xmlns:a="http://schemas.openxmlformats.org/drawingml/2006/main">
               <a:ext uri="{FF2B5EF4-FFF2-40B4-BE49-F238E27FC236}">
-                <a16:creationId xmlns:a16="http://schemas.microsoft.com/office/drawing/2014/main" id="{7F9293CC-640B-4084-A971-D8D46B612EF2}"/>
+                <a16:creationId xmlns:a16="http://schemas.microsoft.com/office/drawing/2014/main" id="{9B5557DA-B9FB-4091-B2E4-6E23DF97550E}"/>
               </a:ext>
             </a:extLst>
           </p:cNvPr>
@@ -5801,7 +5801,7 @@
           <p:cNvPr id="11" name="">
             <a:extLst xmlns:a="http://schemas.openxmlformats.org/drawingml/2006/main">
               <a:ext uri="{FF2B5EF4-FFF2-40B4-BE49-F238E27FC236}">
-                <a16:creationId xmlns:a16="http://schemas.microsoft.com/office/drawing/2014/main" id="{1E2430EF-059E-4138-BAC1-AB7EC847F104}"/>
+                <a16:creationId xmlns:a16="http://schemas.microsoft.com/office/drawing/2014/main" id="{69F78257-1305-4C89-920D-C8E6398C7D1A}"/>
               </a:ext>
             </a:extLst>
           </p:cNvPr>
@@ -5865,7 +5865,7 @@
           <p:cNvPr id="12" name="">
             <a:extLst xmlns:a="http://schemas.openxmlformats.org/drawingml/2006/main">
               <a:ext uri="{FF2B5EF4-FFF2-40B4-BE49-F238E27FC236}">
-                <a16:creationId xmlns:a16="http://schemas.microsoft.com/office/drawing/2014/main" id="{A86B9517-F879-463E-AEDF-E8B6BF2681FC}"/>
+                <a16:creationId xmlns:a16="http://schemas.microsoft.com/office/drawing/2014/main" id="{E9A97931-8F14-46D4-891B-B3EAF7A31C63}"/>
               </a:ext>
             </a:extLst>
           </p:cNvPr>
@@ -5900,7 +5900,7 @@
           <p:cNvPr id="13" name="">
             <a:extLst xmlns:a="http://schemas.openxmlformats.org/drawingml/2006/main">
               <a:ext uri="{FF2B5EF4-FFF2-40B4-BE49-F238E27FC236}">
-                <a16:creationId xmlns:a16="http://schemas.microsoft.com/office/drawing/2014/main" id="{6C8ABEA9-1982-41AF-95CB-1BE34E11AB59}"/>
+                <a16:creationId xmlns:a16="http://schemas.microsoft.com/office/drawing/2014/main" id="{A5204E9B-B080-4147-B1D3-272769D65CF2}"/>
               </a:ext>
             </a:extLst>
           </p:cNvPr>
@@ -5964,7 +5964,7 @@
           <p:cNvPr id="14" name="">
             <a:extLst xmlns:a="http://schemas.openxmlformats.org/drawingml/2006/main">
               <a:ext uri="{FF2B5EF4-FFF2-40B4-BE49-F238E27FC236}">
-                <a16:creationId xmlns:a16="http://schemas.microsoft.com/office/drawing/2014/main" id="{1115E886-905F-4353-B2EB-A1438F66A7B8}"/>
+                <a16:creationId xmlns:a16="http://schemas.microsoft.com/office/drawing/2014/main" id="{ED20FA06-8B02-4371-8745-5B439401C77C}"/>
               </a:ext>
             </a:extLst>
           </p:cNvPr>
@@ -5997,7 +5997,7 @@
           <p:cNvPr id="15" name="">
             <a:extLst xmlns:a="http://schemas.openxmlformats.org/drawingml/2006/main">
               <a:ext uri="{FF2B5EF4-FFF2-40B4-BE49-F238E27FC236}">
-                <a16:creationId xmlns:a16="http://schemas.microsoft.com/office/drawing/2014/main" id="{B2B89E14-2C8E-4044-A118-0F5B18FBFF9B}"/>
+                <a16:creationId xmlns:a16="http://schemas.microsoft.com/office/drawing/2014/main" id="{554E7B59-48B0-40CE-8818-7120DA742A24}"/>
               </a:ext>
             </a:extLst>
           </p:cNvPr>
@@ -6032,7 +6032,7 @@
           <p:cNvPr id="16" name="">
             <a:extLst xmlns:a="http://schemas.openxmlformats.org/drawingml/2006/main">
               <a:ext uri="{FF2B5EF4-FFF2-40B4-BE49-F238E27FC236}">
-                <a16:creationId xmlns:a16="http://schemas.microsoft.com/office/drawing/2014/main" id="{F9A2D257-8684-4B81-8E05-03F6581E557C}"/>
+                <a16:creationId xmlns:a16="http://schemas.microsoft.com/office/drawing/2014/main" id="{7BDA9B13-F52B-4B6A-A4D5-C16723337E48}"/>
               </a:ext>
             </a:extLst>
           </p:cNvPr>
@@ -6096,7 +6096,7 @@
           <p:cNvPr id="17" name="">
             <a:extLst xmlns:a="http://schemas.openxmlformats.org/drawingml/2006/main">
               <a:ext uri="{FF2B5EF4-FFF2-40B4-BE49-F238E27FC236}">
-                <a16:creationId xmlns:a16="http://schemas.microsoft.com/office/drawing/2014/main" id="{9BFC6887-229D-4D1A-AD16-C4DC84372DB6}"/>
+                <a16:creationId xmlns:a16="http://schemas.microsoft.com/office/drawing/2014/main" id="{C4B0F9A2-0A2A-4652-8B6B-74AC44C8A4A2}"/>
               </a:ext>
             </a:extLst>
           </p:cNvPr>
@@ -6160,7 +6160,7 @@
           <p:cNvPr id="18" name="">
             <a:extLst xmlns:a="http://schemas.openxmlformats.org/drawingml/2006/main">
               <a:ext uri="{FF2B5EF4-FFF2-40B4-BE49-F238E27FC236}">
-                <a16:creationId xmlns:a16="http://schemas.microsoft.com/office/drawing/2014/main" id="{EC49D484-E618-42F5-A808-B314C9B326D5}"/>
+                <a16:creationId xmlns:a16="http://schemas.microsoft.com/office/drawing/2014/main" id="{1AEF0B44-EB5E-40B7-86D9-211A2F2810B5}"/>
               </a:ext>
             </a:extLst>
           </p:cNvPr>
@@ -6224,7 +6224,7 @@
           <p:cNvPr id="19" name="">
             <a:extLst xmlns:a="http://schemas.openxmlformats.org/drawingml/2006/main">
               <a:ext uri="{FF2B5EF4-FFF2-40B4-BE49-F238E27FC236}">
-                <a16:creationId xmlns:a16="http://schemas.microsoft.com/office/drawing/2014/main" id="{63733F5A-ACE2-4168-9596-175BB1093B01}"/>
+                <a16:creationId xmlns:a16="http://schemas.microsoft.com/office/drawing/2014/main" id="{CCE50E9B-3E05-4150-8D25-56492493B0A4}"/>
               </a:ext>
             </a:extLst>
           </p:cNvPr>
@@ -6259,7 +6259,7 @@
           <p:cNvPr id="20" name="">
             <a:extLst xmlns:a="http://schemas.openxmlformats.org/drawingml/2006/main">
               <a:ext uri="{FF2B5EF4-FFF2-40B4-BE49-F238E27FC236}">
-                <a16:creationId xmlns:a16="http://schemas.microsoft.com/office/drawing/2014/main" id="{E01F7F7F-5D0C-4A33-91F0-A76793168ED4}"/>
+                <a16:creationId xmlns:a16="http://schemas.microsoft.com/office/drawing/2014/main" id="{E06DAFBF-A416-4F47-9909-D4C7AE7E0161}"/>
               </a:ext>
             </a:extLst>
           </p:cNvPr>
@@ -6323,7 +6323,7 @@
           <p:cNvPr id="21" name="">
             <a:extLst xmlns:a="http://schemas.openxmlformats.org/drawingml/2006/main">
               <a:ext uri="{FF2B5EF4-FFF2-40B4-BE49-F238E27FC236}">
-                <a16:creationId xmlns:a16="http://schemas.microsoft.com/office/drawing/2014/main" id="{59ED7F09-97E2-4DB7-AF0F-E9270A431995}"/>
+                <a16:creationId xmlns:a16="http://schemas.microsoft.com/office/drawing/2014/main" id="{654BFAA0-5593-40A6-8E06-ED457449E00A}"/>
               </a:ext>
             </a:extLst>
           </p:cNvPr>
@@ -6356,7 +6356,7 @@
           <p:cNvPr id="22" name="">
             <a:extLst xmlns:a="http://schemas.openxmlformats.org/drawingml/2006/main">
               <a:ext uri="{FF2B5EF4-FFF2-40B4-BE49-F238E27FC236}">
-                <a16:creationId xmlns:a16="http://schemas.microsoft.com/office/drawing/2014/main" id="{DCE93AB9-0622-42FC-AF4F-86AE510DCB61}"/>
+                <a16:creationId xmlns:a16="http://schemas.microsoft.com/office/drawing/2014/main" id="{9E9B1768-F88D-4A79-B0E2-2E78B5E6D7A1}"/>
               </a:ext>
             </a:extLst>
           </p:cNvPr>
@@ -6391,7 +6391,7 @@
           <p:cNvPr id="23" name="">
             <a:extLst xmlns:a="http://schemas.openxmlformats.org/drawingml/2006/main">
               <a:ext uri="{FF2B5EF4-FFF2-40B4-BE49-F238E27FC236}">
-                <a16:creationId xmlns:a16="http://schemas.microsoft.com/office/drawing/2014/main" id="{3513E38E-F584-4632-BE66-1333C4F23ECD}"/>
+                <a16:creationId xmlns:a16="http://schemas.microsoft.com/office/drawing/2014/main" id="{94D5783E-337A-48E5-8949-79142434F786}"/>
               </a:ext>
             </a:extLst>
           </p:cNvPr>
@@ -6455,7 +6455,7 @@
           <p:cNvPr id="24" name="">
             <a:extLst xmlns:a="http://schemas.openxmlformats.org/drawingml/2006/main">
               <a:ext uri="{FF2B5EF4-FFF2-40B4-BE49-F238E27FC236}">
-                <a16:creationId xmlns:a16="http://schemas.microsoft.com/office/drawing/2014/main" id="{EF0EB925-061F-4CFE-AF10-1565C7817C39}"/>
+                <a16:creationId xmlns:a16="http://schemas.microsoft.com/office/drawing/2014/main" id="{073524D3-32D5-4C0E-8B72-82A1038E2A3B}"/>
               </a:ext>
             </a:extLst>
           </p:cNvPr>
@@ -6519,7 +6519,7 @@
           <p:cNvPr id="25" name="">
             <a:extLst xmlns:a="http://schemas.openxmlformats.org/drawingml/2006/main">
               <a:ext uri="{FF2B5EF4-FFF2-40B4-BE49-F238E27FC236}">
-                <a16:creationId xmlns:a16="http://schemas.microsoft.com/office/drawing/2014/main" id="{814CCE94-F3E2-428C-A566-F68D1614DE42}"/>
+                <a16:creationId xmlns:a16="http://schemas.microsoft.com/office/drawing/2014/main" id="{AC56BD96-CC16-4E46-AE53-F67DA242AFAE}"/>
               </a:ext>
             </a:extLst>
           </p:cNvPr>
@@ -6583,7 +6583,7 @@
           <p:cNvPr id="26" name="">
             <a:extLst xmlns:a="http://schemas.openxmlformats.org/drawingml/2006/main">
               <a:ext uri="{FF2B5EF4-FFF2-40B4-BE49-F238E27FC236}">
-                <a16:creationId xmlns:a16="http://schemas.microsoft.com/office/drawing/2014/main" id="{E8D51D38-D204-45A9-A222-2C7542540B8F}"/>
+                <a16:creationId xmlns:a16="http://schemas.microsoft.com/office/drawing/2014/main" id="{97AF7A46-EE83-4240-B18F-D6691DE8085C}"/>
               </a:ext>
             </a:extLst>
           </p:cNvPr>
@@ -6618,7 +6618,7 @@
           <p:cNvPr id="27" name="">
             <a:extLst xmlns:a="http://schemas.openxmlformats.org/drawingml/2006/main">
               <a:ext uri="{FF2B5EF4-FFF2-40B4-BE49-F238E27FC236}">
-                <a16:creationId xmlns:a16="http://schemas.microsoft.com/office/drawing/2014/main" id="{DE1B5458-C4A7-4FEA-8C43-52422C9EB8CB}"/>
+                <a16:creationId xmlns:a16="http://schemas.microsoft.com/office/drawing/2014/main" id="{DD741AA2-78B4-45BE-8A08-483A257FB812}"/>
               </a:ext>
             </a:extLst>
           </p:cNvPr>
@@ -6682,7 +6682,7 @@
           <p:cNvPr id="28" name="">
             <a:extLst xmlns:a="http://schemas.openxmlformats.org/drawingml/2006/main">
               <a:ext uri="{FF2B5EF4-FFF2-40B4-BE49-F238E27FC236}">
-                <a16:creationId xmlns:a16="http://schemas.microsoft.com/office/drawing/2014/main" id="{C701DDB6-7429-43AC-AC0E-540C0BCB1D53}"/>
+                <a16:creationId xmlns:a16="http://schemas.microsoft.com/office/drawing/2014/main" id="{4A20C8FD-E226-4323-AB4E-06E5BEF5BD8A}"/>
               </a:ext>
             </a:extLst>
           </p:cNvPr>
@@ -6715,7 +6715,7 @@
           <p:cNvPr id="29" name="">
             <a:extLst xmlns:a="http://schemas.openxmlformats.org/drawingml/2006/main">
               <a:ext uri="{FF2B5EF4-FFF2-40B4-BE49-F238E27FC236}">
-                <a16:creationId xmlns:a16="http://schemas.microsoft.com/office/drawing/2014/main" id="{11604F0A-C855-4F29-9C38-BD5F6D6135FB}"/>
+                <a16:creationId xmlns:a16="http://schemas.microsoft.com/office/drawing/2014/main" id="{DD190EAB-5128-4078-9E22-87CAD82827EA}"/>
               </a:ext>
             </a:extLst>
           </p:cNvPr>
@@ -6750,7 +6750,7 @@
           <p:cNvPr id="30" name="">
             <a:extLst xmlns:a="http://schemas.openxmlformats.org/drawingml/2006/main">
               <a:ext uri="{FF2B5EF4-FFF2-40B4-BE49-F238E27FC236}">
-                <a16:creationId xmlns:a16="http://schemas.microsoft.com/office/drawing/2014/main" id="{0071A9FF-A8DF-4D32-82CF-89D7326EBF6E}"/>
+                <a16:creationId xmlns:a16="http://schemas.microsoft.com/office/drawing/2014/main" id="{71D75E03-1405-41C3-8E0F-23DCCF682EA5}"/>
               </a:ext>
             </a:extLst>
           </p:cNvPr>
@@ -6814,7 +6814,7 @@
           <p:cNvPr id="31" name="">
             <a:extLst xmlns:a="http://schemas.openxmlformats.org/drawingml/2006/main">
               <a:ext uri="{FF2B5EF4-FFF2-40B4-BE49-F238E27FC236}">
-                <a16:creationId xmlns:a16="http://schemas.microsoft.com/office/drawing/2014/main" id="{A14F370B-80F6-4272-91DF-929A3F15C725}"/>
+                <a16:creationId xmlns:a16="http://schemas.microsoft.com/office/drawing/2014/main" id="{778D90F8-FB55-49B4-987D-07E45C69D119}"/>
               </a:ext>
             </a:extLst>
           </p:cNvPr>
@@ -6878,7 +6878,7 @@
           <p:cNvPr id="32" name="">
             <a:extLst xmlns:a="http://schemas.openxmlformats.org/drawingml/2006/main">
               <a:ext uri="{FF2B5EF4-FFF2-40B4-BE49-F238E27FC236}">
-                <a16:creationId xmlns:a16="http://schemas.microsoft.com/office/drawing/2014/main" id="{DBCE230E-2116-40D8-ADD3-51E3B68F31F9}"/>
+                <a16:creationId xmlns:a16="http://schemas.microsoft.com/office/drawing/2014/main" id="{AA259A68-B121-4BA5-B431-1DB2700C98DB}"/>
               </a:ext>
             </a:extLst>
           </p:cNvPr>
@@ -6942,7 +6942,7 @@
           <p:cNvPr id="33" name="">
             <a:extLst xmlns:a="http://schemas.openxmlformats.org/drawingml/2006/main">
               <a:ext uri="{FF2B5EF4-FFF2-40B4-BE49-F238E27FC236}">
-                <a16:creationId xmlns:a16="http://schemas.microsoft.com/office/drawing/2014/main" id="{553AD032-C974-4657-9BC4-A11813EBED1A}"/>
+                <a16:creationId xmlns:a16="http://schemas.microsoft.com/office/drawing/2014/main" id="{00748DFE-06BE-4AB5-B8E9-05F31E5ABE66}"/>
               </a:ext>
             </a:extLst>
           </p:cNvPr>
@@ -6975,7 +6975,7 @@
           <p:cNvPr id="34" name="">
             <a:extLst xmlns:a="http://schemas.openxmlformats.org/drawingml/2006/main">
               <a:ext uri="{FF2B5EF4-FFF2-40B4-BE49-F238E27FC236}">
-                <a16:creationId xmlns:a16="http://schemas.microsoft.com/office/drawing/2014/main" id="{FBF11E45-226E-46F7-90E4-05F8FA87E53C}"/>
+                <a16:creationId xmlns:a16="http://schemas.microsoft.com/office/drawing/2014/main" id="{8552E50E-8739-4014-A4A5-3288016525DD}"/>
               </a:ext>
             </a:extLst>
           </p:cNvPr>
@@ -7039,7 +7039,7 @@
           <p:cNvPr id="35" name="">
             <a:extLst xmlns:a="http://schemas.openxmlformats.org/drawingml/2006/main">
               <a:ext uri="{FF2B5EF4-FFF2-40B4-BE49-F238E27FC236}">
-                <a16:creationId xmlns:a16="http://schemas.microsoft.com/office/drawing/2014/main" id="{D76F4E8C-3CC3-43CC-B31F-F1C747836A04}"/>
+                <a16:creationId xmlns:a16="http://schemas.microsoft.com/office/drawing/2014/main" id="{415BC898-511D-4253-9B97-3D726F572322}"/>
               </a:ext>
             </a:extLst>
           </p:cNvPr>
@@ -7103,7 +7103,7 @@
           <p:cNvPr id="36" name="">
             <a:extLst xmlns:a="http://schemas.openxmlformats.org/drawingml/2006/main">
               <a:ext uri="{FF2B5EF4-FFF2-40B4-BE49-F238E27FC236}">
-                <a16:creationId xmlns:a16="http://schemas.microsoft.com/office/drawing/2014/main" id="{25EB7EAB-8CBD-4E56-BD40-3E9BFB32EBCA}"/>
+                <a16:creationId xmlns:a16="http://schemas.microsoft.com/office/drawing/2014/main" id="{B58A254E-DBB9-4AD4-B195-35ADAC08A945}"/>
               </a:ext>
             </a:extLst>
           </p:cNvPr>
@@ -7138,7 +7138,7 @@
           <p:cNvPr id="37" name="">
             <a:extLst xmlns:a="http://schemas.openxmlformats.org/drawingml/2006/main">
               <a:ext uri="{FF2B5EF4-FFF2-40B4-BE49-F238E27FC236}">
-                <a16:creationId xmlns:a16="http://schemas.microsoft.com/office/drawing/2014/main" id="{6DAEE695-3750-4F25-8425-36A7033B234D}"/>
+                <a16:creationId xmlns:a16="http://schemas.microsoft.com/office/drawing/2014/main" id="{E0DCE9E1-C41B-44EC-A513-385EAB90EC0E}"/>
               </a:ext>
             </a:extLst>
           </p:cNvPr>
@@ -7202,7 +7202,7 @@
           <p:cNvPr id="38" name="">
             <a:extLst xmlns:a="http://schemas.openxmlformats.org/drawingml/2006/main">
               <a:ext uri="{FF2B5EF4-FFF2-40B4-BE49-F238E27FC236}">
-                <a16:creationId xmlns:a16="http://schemas.microsoft.com/office/drawing/2014/main" id="{0A42B2A1-2517-4CA5-978A-F42FD1AE6D48}"/>
+                <a16:creationId xmlns:a16="http://schemas.microsoft.com/office/drawing/2014/main" id="{6C20BA45-6034-4C7D-9942-DCCF8FDBA06B}"/>
               </a:ext>
             </a:extLst>
           </p:cNvPr>
@@ -7264,7 +7264,7 @@
     </p:spTree>
     <p:extLst>
       <p:ext uri="{BB962C8B-B14F-4D97-AF65-F5344CB8AC3E}">
-        <p14:creationId xmlns:p14="http://schemas.microsoft.com/office/powerpoint/2010/main" val="2058950338"/>
+        <p14:creationId xmlns:p14="http://schemas.microsoft.com/office/powerpoint/2010/main" val="880045590"/>
       </p:ext>
     </p:extLst>
   </p:cSld>
@@ -7288,7 +7288,7 @@
           <p:cNvPr id="1" name="">
             <a:extLst xmlns:a="http://schemas.openxmlformats.org/drawingml/2006/main">
               <a:ext uri="{FF2B5EF4-FFF2-40B4-BE49-F238E27FC236}">
-                <a16:creationId xmlns:a16="http://schemas.microsoft.com/office/drawing/2014/main" id="{36A2CED7-125C-43AA-AE31-D9A1424104FC}"/>
+                <a16:creationId xmlns:a16="http://schemas.microsoft.com/office/drawing/2014/main" id="{2BAA1E8F-09AE-48D1-B700-FD06F2B0E3F5}"/>
               </a:ext>
             </a:extLst>
           </p:cNvPr>
@@ -7323,7 +7323,7 @@
           <p:cNvPr id="2" name="">
             <a:extLst xmlns:a="http://schemas.openxmlformats.org/drawingml/2006/main">
               <a:ext uri="{FF2B5EF4-FFF2-40B4-BE49-F238E27FC236}">
-                <a16:creationId xmlns:a16="http://schemas.microsoft.com/office/drawing/2014/main" id="{99AA1713-1CB3-4D92-8C08-069856027A63}"/>
+                <a16:creationId xmlns:a16="http://schemas.microsoft.com/office/drawing/2014/main" id="{82845786-755A-4D89-8871-C1A9765C80E1}"/>
               </a:ext>
             </a:extLst>
           </p:cNvPr>
@@ -7358,7 +7358,7 @@
           <p:cNvPr id="3" name="">
             <a:extLst xmlns:a="http://schemas.openxmlformats.org/drawingml/2006/main">
               <a:ext uri="{FF2B5EF4-FFF2-40B4-BE49-F238E27FC236}">
-                <a16:creationId xmlns:a16="http://schemas.microsoft.com/office/drawing/2014/main" id="{6F100519-AABC-4E1E-B690-BBD67DB0B196}"/>
+                <a16:creationId xmlns:a16="http://schemas.microsoft.com/office/drawing/2014/main" id="{968A83E8-B058-47FD-B8FE-D5DD6E5FAF65}"/>
               </a:ext>
             </a:extLst>
           </p:cNvPr>
@@ -7422,7 +7422,7 @@
           <p:cNvPr id="4" name="">
             <a:extLst xmlns:a="http://schemas.openxmlformats.org/drawingml/2006/main">
               <a:ext uri="{FF2B5EF4-FFF2-40B4-BE49-F238E27FC236}">
-                <a16:creationId xmlns:a16="http://schemas.microsoft.com/office/drawing/2014/main" id="{09F2416E-F695-428E-A7A7-632D74A4D1ED}"/>
+                <a16:creationId xmlns:a16="http://schemas.microsoft.com/office/drawing/2014/main" id="{C8B0940B-721F-424E-8F9A-A095E2B7F72D}"/>
               </a:ext>
             </a:extLst>
           </p:cNvPr>
@@ -7486,7 +7486,7 @@
           <p:cNvPr id="5" name="">
             <a:extLst xmlns:a="http://schemas.openxmlformats.org/drawingml/2006/main">
               <a:ext uri="{FF2B5EF4-FFF2-40B4-BE49-F238E27FC236}">
-                <a16:creationId xmlns:a16="http://schemas.microsoft.com/office/drawing/2014/main" id="{48E6F1F5-E904-40A6-BFC9-1057F751C390}"/>
+                <a16:creationId xmlns:a16="http://schemas.microsoft.com/office/drawing/2014/main" id="{78963E26-7F9D-420F-83A7-66F7BA9D00E1}"/>
               </a:ext>
             </a:extLst>
           </p:cNvPr>
@@ -7550,7 +7550,7 @@
           <p:cNvPr id="6" name="">
             <a:extLst xmlns:a="http://schemas.openxmlformats.org/drawingml/2006/main">
               <a:ext uri="{FF2B5EF4-FFF2-40B4-BE49-F238E27FC236}">
-                <a16:creationId xmlns:a16="http://schemas.microsoft.com/office/drawing/2014/main" id="{FBAE0C0A-DE44-4D9C-A6B3-8766F549D864}"/>
+                <a16:creationId xmlns:a16="http://schemas.microsoft.com/office/drawing/2014/main" id="{68736D92-DDB8-4AD6-9412-406183428794}"/>
               </a:ext>
             </a:extLst>
           </p:cNvPr>
@@ -7614,7 +7614,7 @@
           <p:cNvPr id="7" name="">
             <a:extLst xmlns:a="http://schemas.openxmlformats.org/drawingml/2006/main">
               <a:ext uri="{FF2B5EF4-FFF2-40B4-BE49-F238E27FC236}">
-                <a16:creationId xmlns:a16="http://schemas.microsoft.com/office/drawing/2014/main" id="{5DF6C3EC-0E84-4004-9502-F5245F8F3B58}"/>
+                <a16:creationId xmlns:a16="http://schemas.microsoft.com/office/drawing/2014/main" id="{3EFEFE18-97FC-4430-ACB8-CCE0402BE399}"/>
               </a:ext>
             </a:extLst>
           </p:cNvPr>
@@ -7668,7 +7668,7 @@
                 <a:ea typeface="Aptos"/>
                 <a:cs typeface="Aptos"/>
               </a:rPr>
-              <a:t>180</a:t>
+              <a:t>199</a:t>
             </a:r>
           </a:p>
         </p:txBody>
@@ -7678,7 +7678,7 @@
           <p:cNvPr id="8" name="">
             <a:extLst xmlns:a="http://schemas.openxmlformats.org/drawingml/2006/main">
               <a:ext uri="{FF2B5EF4-FFF2-40B4-BE49-F238E27FC236}">
-                <a16:creationId xmlns:a16="http://schemas.microsoft.com/office/drawing/2014/main" id="{153A73B2-AB68-4AA6-AC4A-F53B11034D9C}"/>
+                <a16:creationId xmlns:a16="http://schemas.microsoft.com/office/drawing/2014/main" id="{E73E4F76-94B8-4B8C-AA0A-0FD0C94D3923}"/>
               </a:ext>
             </a:extLst>
           </p:cNvPr>
@@ -7742,7 +7742,7 @@
           <p:cNvPr id="9" name="">
             <a:extLst xmlns:a="http://schemas.openxmlformats.org/drawingml/2006/main">
               <a:ext uri="{FF2B5EF4-FFF2-40B4-BE49-F238E27FC236}">
-                <a16:creationId xmlns:a16="http://schemas.microsoft.com/office/drawing/2014/main" id="{824A0F8B-3783-4CA4-98E4-A49C2FAA5F17}"/>
+                <a16:creationId xmlns:a16="http://schemas.microsoft.com/office/drawing/2014/main" id="{E5CFE2AC-1494-45EE-99C8-9A66D79C7E91}"/>
               </a:ext>
             </a:extLst>
           </p:cNvPr>
@@ -7806,7 +7806,7 @@
           <p:cNvPr id="10" name="">
             <a:extLst xmlns:a="http://schemas.openxmlformats.org/drawingml/2006/main">
               <a:ext uri="{FF2B5EF4-FFF2-40B4-BE49-F238E27FC236}">
-                <a16:creationId xmlns:a16="http://schemas.microsoft.com/office/drawing/2014/main" id="{8099F762-CD18-47E2-840C-9531BF397FAC}"/>
+                <a16:creationId xmlns:a16="http://schemas.microsoft.com/office/drawing/2014/main" id="{5738EF40-88E3-4B5A-BC33-387C21E2ABEE}"/>
               </a:ext>
             </a:extLst>
           </p:cNvPr>
@@ -7841,7 +7841,7 @@
           <p:cNvPr id="11" name="">
             <a:extLst xmlns:a="http://schemas.openxmlformats.org/drawingml/2006/main">
               <a:ext uri="{FF2B5EF4-FFF2-40B4-BE49-F238E27FC236}">
-                <a16:creationId xmlns:a16="http://schemas.microsoft.com/office/drawing/2014/main" id="{8BBCDD43-C618-4C3F-A080-686CBF7E3BFD}"/>
+                <a16:creationId xmlns:a16="http://schemas.microsoft.com/office/drawing/2014/main" id="{89EDC35F-339A-45FB-8499-3964DCCB7937}"/>
               </a:ext>
             </a:extLst>
           </p:cNvPr>
@@ -7895,7 +7895,7 @@
                 <a:ea typeface="Aptos"/>
                 <a:cs typeface="Aptos"/>
               </a:rPr>
-              <a:t>129</a:t>
+              <a:t>140</a:t>
             </a:r>
           </a:p>
         </p:txBody>
@@ -7905,7 +7905,7 @@
           <p:cNvPr id="12" name="">
             <a:extLst xmlns:a="http://schemas.openxmlformats.org/drawingml/2006/main">
               <a:ext uri="{FF2B5EF4-FFF2-40B4-BE49-F238E27FC236}">
-                <a16:creationId xmlns:a16="http://schemas.microsoft.com/office/drawing/2014/main" id="{B7B87592-C100-47E2-9999-0BB9754AFC21}"/>
+                <a16:creationId xmlns:a16="http://schemas.microsoft.com/office/drawing/2014/main" id="{E0A59393-3AD1-413A-AC9A-C44AD9223B87}"/>
               </a:ext>
             </a:extLst>
           </p:cNvPr>
@@ -7969,7 +7969,7 @@
           <p:cNvPr id="13" name="">
             <a:extLst xmlns:a="http://schemas.openxmlformats.org/drawingml/2006/main">
               <a:ext uri="{FF2B5EF4-FFF2-40B4-BE49-F238E27FC236}">
-                <a16:creationId xmlns:a16="http://schemas.microsoft.com/office/drawing/2014/main" id="{D15A1224-B699-4DC3-BECB-0C0375F9FBCB}"/>
+                <a16:creationId xmlns:a16="http://schemas.microsoft.com/office/drawing/2014/main" id="{92CE1A1F-1039-48D2-BF8A-858AFBAEC206}"/>
               </a:ext>
             </a:extLst>
           </p:cNvPr>
@@ -8033,7 +8033,7 @@
           <p:cNvPr id="14" name="">
             <a:extLst xmlns:a="http://schemas.openxmlformats.org/drawingml/2006/main">
               <a:ext uri="{FF2B5EF4-FFF2-40B4-BE49-F238E27FC236}">
-                <a16:creationId xmlns:a16="http://schemas.microsoft.com/office/drawing/2014/main" id="{249738D7-E03E-47E4-B3AD-CDD8A9D5A970}"/>
+                <a16:creationId xmlns:a16="http://schemas.microsoft.com/office/drawing/2014/main" id="{E8AC555C-A3CF-4291-8619-58534161977D}"/>
               </a:ext>
             </a:extLst>
           </p:cNvPr>
@@ -8068,7 +8068,7 @@
           <p:cNvPr id="15" name="">
             <a:extLst xmlns:a="http://schemas.openxmlformats.org/drawingml/2006/main">
               <a:ext uri="{FF2B5EF4-FFF2-40B4-BE49-F238E27FC236}">
-                <a16:creationId xmlns:a16="http://schemas.microsoft.com/office/drawing/2014/main" id="{9C0D1C13-478A-442E-AB21-5EA78F0DBD7D}"/>
+                <a16:creationId xmlns:a16="http://schemas.microsoft.com/office/drawing/2014/main" id="{CB782C09-8D33-426D-848A-F1B88D380822}"/>
               </a:ext>
             </a:extLst>
           </p:cNvPr>
@@ -8132,7 +8132,7 @@
           <p:cNvPr id="16" name="">
             <a:extLst xmlns:a="http://schemas.openxmlformats.org/drawingml/2006/main">
               <a:ext uri="{FF2B5EF4-FFF2-40B4-BE49-F238E27FC236}">
-                <a16:creationId xmlns:a16="http://schemas.microsoft.com/office/drawing/2014/main" id="{865FB1AC-F364-45B5-B1A6-123975E81206}"/>
+                <a16:creationId xmlns:a16="http://schemas.microsoft.com/office/drawing/2014/main" id="{5D8019E6-BD73-494A-9E07-9612798E1D32}"/>
               </a:ext>
             </a:extLst>
           </p:cNvPr>
@@ -8196,7 +8196,7 @@
           <p:cNvPr id="17" name="">
             <a:extLst xmlns:a="http://schemas.openxmlformats.org/drawingml/2006/main">
               <a:ext uri="{FF2B5EF4-FFF2-40B4-BE49-F238E27FC236}">
-                <a16:creationId xmlns:a16="http://schemas.microsoft.com/office/drawing/2014/main" id="{DBF29384-A4DA-4B25-ABB9-C29E96127B4A}"/>
+                <a16:creationId xmlns:a16="http://schemas.microsoft.com/office/drawing/2014/main" id="{37508BAF-49CC-4943-BC34-E23792440DB5}"/>
               </a:ext>
             </a:extLst>
           </p:cNvPr>
@@ -8260,7 +8260,7 @@
           <p:cNvPr id="18" name="">
             <a:extLst xmlns:a="http://schemas.openxmlformats.org/drawingml/2006/main">
               <a:ext uri="{FF2B5EF4-FFF2-40B4-BE49-F238E27FC236}">
-                <a16:creationId xmlns:a16="http://schemas.microsoft.com/office/drawing/2014/main" id="{8A9BB4D3-6CA9-46CE-AE62-772BA7F5AC29}"/>
+                <a16:creationId xmlns:a16="http://schemas.microsoft.com/office/drawing/2014/main" id="{A52D9906-D38F-4A19-8518-F3DA63490665}"/>
               </a:ext>
             </a:extLst>
           </p:cNvPr>
@@ -8295,7 +8295,7 @@
           <p:cNvPr id="19" name="">
             <a:extLst xmlns:a="http://schemas.openxmlformats.org/drawingml/2006/main">
               <a:ext uri="{FF2B5EF4-FFF2-40B4-BE49-F238E27FC236}">
-                <a16:creationId xmlns:a16="http://schemas.microsoft.com/office/drawing/2014/main" id="{A0650004-81EA-413F-BAA5-5C1128970330}"/>
+                <a16:creationId xmlns:a16="http://schemas.microsoft.com/office/drawing/2014/main" id="{F9E2DB21-B9FE-4228-89A1-737A1214BF41}"/>
               </a:ext>
             </a:extLst>
           </p:cNvPr>
@@ -8359,7 +8359,7 @@
           <p:cNvPr id="20" name="">
             <a:extLst xmlns:a="http://schemas.openxmlformats.org/drawingml/2006/main">
               <a:ext uri="{FF2B5EF4-FFF2-40B4-BE49-F238E27FC236}">
-                <a16:creationId xmlns:a16="http://schemas.microsoft.com/office/drawing/2014/main" id="{261EC5E8-9ED7-4FBF-BE2A-4D1ED70C5208}"/>
+                <a16:creationId xmlns:a16="http://schemas.microsoft.com/office/drawing/2014/main" id="{F6711183-4EC9-4141-972A-8CC8F77F6777}"/>
               </a:ext>
             </a:extLst>
           </p:cNvPr>
@@ -8423,7 +8423,7 @@
           <p:cNvPr id="21" name="">
             <a:extLst xmlns:a="http://schemas.openxmlformats.org/drawingml/2006/main">
               <a:ext uri="{FF2B5EF4-FFF2-40B4-BE49-F238E27FC236}">
-                <a16:creationId xmlns:a16="http://schemas.microsoft.com/office/drawing/2014/main" id="{60DCC3B7-7BA2-4CFC-8DE8-EDB74177A308}"/>
+                <a16:creationId xmlns:a16="http://schemas.microsoft.com/office/drawing/2014/main" id="{DB8C8950-4D08-4F23-928B-389129A6DEBD}"/>
               </a:ext>
             </a:extLst>
           </p:cNvPr>
@@ -8487,7 +8487,7 @@
           <p:cNvPr id="22" name="">
             <a:extLst xmlns:a="http://schemas.openxmlformats.org/drawingml/2006/main">
               <a:ext uri="{FF2B5EF4-FFF2-40B4-BE49-F238E27FC236}">
-                <a16:creationId xmlns:a16="http://schemas.microsoft.com/office/drawing/2014/main" id="{2BF2AAFE-E736-4398-82C9-50B7D8AFC15E}"/>
+                <a16:creationId xmlns:a16="http://schemas.microsoft.com/office/drawing/2014/main" id="{332B71F5-ECC6-4DD7-864F-F67618DAB4CA}"/>
               </a:ext>
             </a:extLst>
           </p:cNvPr>
@@ -8522,7 +8522,7 @@
           <p:cNvPr id="23" name="">
             <a:extLst xmlns:a="http://schemas.openxmlformats.org/drawingml/2006/main">
               <a:ext uri="{FF2B5EF4-FFF2-40B4-BE49-F238E27FC236}">
-                <a16:creationId xmlns:a16="http://schemas.microsoft.com/office/drawing/2014/main" id="{DC5C767E-C88D-4D35-ABB2-7F1B1B5FA3CC}"/>
+                <a16:creationId xmlns:a16="http://schemas.microsoft.com/office/drawing/2014/main" id="{73A484DA-03E1-43EF-B27F-E5F8477601B3}"/>
               </a:ext>
             </a:extLst>
           </p:cNvPr>
@@ -8555,7 +8555,7 @@
           <p:cNvPr id="24" name="">
             <a:extLst xmlns:a="http://schemas.openxmlformats.org/drawingml/2006/main">
               <a:ext uri="{FF2B5EF4-FFF2-40B4-BE49-F238E27FC236}">
-                <a16:creationId xmlns:a16="http://schemas.microsoft.com/office/drawing/2014/main" id="{E1289C52-E6CB-4B4D-B9D0-7301A30E53F1}"/>
+                <a16:creationId xmlns:a16="http://schemas.microsoft.com/office/drawing/2014/main" id="{6BBCD5D8-0DD7-4AE7-BAEC-A2F14B280621}"/>
               </a:ext>
             </a:extLst>
           </p:cNvPr>
@@ -8619,7 +8619,7 @@
           <p:cNvPr id="25" name="">
             <a:extLst xmlns:a="http://schemas.openxmlformats.org/drawingml/2006/main">
               <a:ext uri="{FF2B5EF4-FFF2-40B4-BE49-F238E27FC236}">
-                <a16:creationId xmlns:a16="http://schemas.microsoft.com/office/drawing/2014/main" id="{8EF99FA9-A40D-45CD-AFD5-11382F33CA5F}"/>
+                <a16:creationId xmlns:a16="http://schemas.microsoft.com/office/drawing/2014/main" id="{D74E748D-0949-4DBA-844E-3B4FE7B641B3}"/>
               </a:ext>
             </a:extLst>
           </p:cNvPr>
@@ -8683,7 +8683,7 @@
           <p:cNvPr id="26" name="">
             <a:extLst xmlns:a="http://schemas.openxmlformats.org/drawingml/2006/main">
               <a:ext uri="{FF2B5EF4-FFF2-40B4-BE49-F238E27FC236}">
-                <a16:creationId xmlns:a16="http://schemas.microsoft.com/office/drawing/2014/main" id="{34A31E06-E320-4A89-98B2-1C0B6AEB502A}"/>
+                <a16:creationId xmlns:a16="http://schemas.microsoft.com/office/drawing/2014/main" id="{043BEF97-A895-44B6-BAB0-BD85597A7506}"/>
               </a:ext>
             </a:extLst>
           </p:cNvPr>
@@ -8737,7 +8737,7 @@
                 <a:ea typeface="Aptos"/>
                 <a:cs typeface="Aptos"/>
               </a:rPr>
-              <a:t>Verified July 11, 2026: 184 Python and 132 Phoenix tests, zero failures.</a:t>
+              <a:t>Verified July 11, 2026: 199 Python and 140 Phoenix tests, zero failures.</a:t>
             </a:r>
           </a:p>
         </p:txBody>
@@ -8745,7 +8745,7 @@
     </p:spTree>
     <p:extLst>
       <p:ext uri="{BB962C8B-B14F-4D97-AF65-F5344CB8AC3E}">
-        <p14:creationId xmlns:p14="http://schemas.microsoft.com/office/powerpoint/2010/main" val="1908914169"/>
+        <p14:creationId xmlns:p14="http://schemas.microsoft.com/office/powerpoint/2010/main" val="1578534267"/>
       </p:ext>
     </p:extLst>
   </p:cSld>
@@ -8769,7 +8769,7 @@
           <p:cNvPr id="1" name="">
             <a:extLst xmlns:a="http://schemas.openxmlformats.org/drawingml/2006/main">
               <a:ext uri="{FF2B5EF4-FFF2-40B4-BE49-F238E27FC236}">
-                <a16:creationId xmlns:a16="http://schemas.microsoft.com/office/drawing/2014/main" id="{65B1D0DD-6333-4E49-BF04-7C7B9E18DE41}"/>
+                <a16:creationId xmlns:a16="http://schemas.microsoft.com/office/drawing/2014/main" id="{6D6973C6-0991-4467-A063-00518F885B14}"/>
               </a:ext>
             </a:extLst>
           </p:cNvPr>
@@ -8804,7 +8804,7 @@
           <p:cNvPr id="2" name="">
             <a:extLst xmlns:a="http://schemas.openxmlformats.org/drawingml/2006/main">
               <a:ext uri="{FF2B5EF4-FFF2-40B4-BE49-F238E27FC236}">
-                <a16:creationId xmlns:a16="http://schemas.microsoft.com/office/drawing/2014/main" id="{B4711C6D-3A61-4307-B82E-E3BA53CEDC9A}"/>
+                <a16:creationId xmlns:a16="http://schemas.microsoft.com/office/drawing/2014/main" id="{897596D5-36E1-457C-8DB7-7D81357806F2}"/>
               </a:ext>
             </a:extLst>
           </p:cNvPr>
@@ -8839,7 +8839,7 @@
           <p:cNvPr id="3" name="">
             <a:extLst xmlns:a="http://schemas.openxmlformats.org/drawingml/2006/main">
               <a:ext uri="{FF2B5EF4-FFF2-40B4-BE49-F238E27FC236}">
-                <a16:creationId xmlns:a16="http://schemas.microsoft.com/office/drawing/2014/main" id="{915C3D01-D738-4AE8-BB61-ECD04A210B29}"/>
+                <a16:creationId xmlns:a16="http://schemas.microsoft.com/office/drawing/2014/main" id="{0943A770-E3CF-41FA-8E12-94193069F3BC}"/>
               </a:ext>
             </a:extLst>
           </p:cNvPr>
@@ -8903,7 +8903,7 @@
           <p:cNvPr id="4" name="">
             <a:extLst xmlns:a="http://schemas.openxmlformats.org/drawingml/2006/main">
               <a:ext uri="{FF2B5EF4-FFF2-40B4-BE49-F238E27FC236}">
-                <a16:creationId xmlns:a16="http://schemas.microsoft.com/office/drawing/2014/main" id="{A6BD9909-95A9-4223-A4A6-2126E7CCEA3E}"/>
+                <a16:creationId xmlns:a16="http://schemas.microsoft.com/office/drawing/2014/main" id="{651E93EC-52FB-48C4-B991-F963FC72C4A9}"/>
               </a:ext>
             </a:extLst>
           </p:cNvPr>
@@ -8967,7 +8967,7 @@
           <p:cNvPr id="5" name="">
             <a:extLst xmlns:a="http://schemas.openxmlformats.org/drawingml/2006/main">
               <a:ext uri="{FF2B5EF4-FFF2-40B4-BE49-F238E27FC236}">
-                <a16:creationId xmlns:a16="http://schemas.microsoft.com/office/drawing/2014/main" id="{34EE3F62-F8FA-4244-9B3E-E699A82A49B3}"/>
+                <a16:creationId xmlns:a16="http://schemas.microsoft.com/office/drawing/2014/main" id="{9FB705DE-CEAB-4A99-A3D7-A9CA4D88C536}"/>
               </a:ext>
             </a:extLst>
           </p:cNvPr>
@@ -9031,7 +9031,7 @@
           <p:cNvPr id="6" name="">
             <a:extLst xmlns:a="http://schemas.openxmlformats.org/drawingml/2006/main">
               <a:ext uri="{FF2B5EF4-FFF2-40B4-BE49-F238E27FC236}">
-                <a16:creationId xmlns:a16="http://schemas.microsoft.com/office/drawing/2014/main" id="{71C08072-998B-4E17-8962-3E0969AC1BB4}"/>
+                <a16:creationId xmlns:a16="http://schemas.microsoft.com/office/drawing/2014/main" id="{A6A823AE-6672-40EF-A2E7-EFEB96E09E4A}"/>
               </a:ext>
             </a:extLst>
           </p:cNvPr>
@@ -9095,7 +9095,7 @@
           <p:cNvPr id="7" name="">
             <a:extLst xmlns:a="http://schemas.openxmlformats.org/drawingml/2006/main">
               <a:ext uri="{FF2B5EF4-FFF2-40B4-BE49-F238E27FC236}">
-                <a16:creationId xmlns:a16="http://schemas.microsoft.com/office/drawing/2014/main" id="{56E2FE6B-EBEA-4D5F-879B-6F5C5E519B77}"/>
+                <a16:creationId xmlns:a16="http://schemas.microsoft.com/office/drawing/2014/main" id="{65A26139-A819-484D-B7C6-46F9A143A013}"/>
               </a:ext>
             </a:extLst>
           </p:cNvPr>
@@ -9128,7 +9128,7 @@
           <p:cNvPr id="8" name="">
             <a:extLst xmlns:a="http://schemas.openxmlformats.org/drawingml/2006/main">
               <a:ext uri="{FF2B5EF4-FFF2-40B4-BE49-F238E27FC236}">
-                <a16:creationId xmlns:a16="http://schemas.microsoft.com/office/drawing/2014/main" id="{BD1909FA-36B8-4023-BA06-25E3946CEC38}"/>
+                <a16:creationId xmlns:a16="http://schemas.microsoft.com/office/drawing/2014/main" id="{45F63BA9-0398-411E-B2EB-301CB41B8396}"/>
               </a:ext>
             </a:extLst>
           </p:cNvPr>
@@ -9192,7 +9192,7 @@
           <p:cNvPr id="9" name="">
             <a:extLst xmlns:a="http://schemas.openxmlformats.org/drawingml/2006/main">
               <a:ext uri="{FF2B5EF4-FFF2-40B4-BE49-F238E27FC236}">
-                <a16:creationId xmlns:a16="http://schemas.microsoft.com/office/drawing/2014/main" id="{6933DDBA-36B0-40BA-BA22-2186CEA48C67}"/>
+                <a16:creationId xmlns:a16="http://schemas.microsoft.com/office/drawing/2014/main" id="{EAD55EA7-4A66-4828-ACCB-DB600ED88466}"/>
               </a:ext>
             </a:extLst>
           </p:cNvPr>
@@ -9256,7 +9256,7 @@
           <p:cNvPr id="10" name="">
             <a:extLst xmlns:a="http://schemas.openxmlformats.org/drawingml/2006/main">
               <a:ext uri="{FF2B5EF4-FFF2-40B4-BE49-F238E27FC236}">
-                <a16:creationId xmlns:a16="http://schemas.microsoft.com/office/drawing/2014/main" id="{3D4D6A0F-DEE5-4C51-BC23-0148D592E5F9}"/>
+                <a16:creationId xmlns:a16="http://schemas.microsoft.com/office/drawing/2014/main" id="{4A60B0EF-B685-4718-91DF-1324275EEFAE}"/>
               </a:ext>
             </a:extLst>
           </p:cNvPr>
@@ -9320,7 +9320,7 @@
           <p:cNvPr id="11" name="">
             <a:extLst xmlns:a="http://schemas.openxmlformats.org/drawingml/2006/main">
               <a:ext uri="{FF2B5EF4-FFF2-40B4-BE49-F238E27FC236}">
-                <a16:creationId xmlns:a16="http://schemas.microsoft.com/office/drawing/2014/main" id="{5512C86D-1ED2-4AFA-B5A6-A86582D8A099}"/>
+                <a16:creationId xmlns:a16="http://schemas.microsoft.com/office/drawing/2014/main" id="{16970D6C-5AD8-496D-B7B4-8B471F2D3895}"/>
               </a:ext>
             </a:extLst>
           </p:cNvPr>
@@ -9353,7 +9353,7 @@
           <p:cNvPr id="12" name="">
             <a:extLst xmlns:a="http://schemas.openxmlformats.org/drawingml/2006/main">
               <a:ext uri="{FF2B5EF4-FFF2-40B4-BE49-F238E27FC236}">
-                <a16:creationId xmlns:a16="http://schemas.microsoft.com/office/drawing/2014/main" id="{9D59F946-3D2C-4F23-9BB3-4FF76D803178}"/>
+                <a16:creationId xmlns:a16="http://schemas.microsoft.com/office/drawing/2014/main" id="{F737ACFE-7F38-4FD6-9EC0-1A88DB40D4F9}"/>
               </a:ext>
             </a:extLst>
           </p:cNvPr>
@@ -9417,7 +9417,7 @@
           <p:cNvPr id="13" name="">
             <a:extLst xmlns:a="http://schemas.openxmlformats.org/drawingml/2006/main">
               <a:ext uri="{FF2B5EF4-FFF2-40B4-BE49-F238E27FC236}">
-                <a16:creationId xmlns:a16="http://schemas.microsoft.com/office/drawing/2014/main" id="{A830E1CB-3DE3-4780-B502-E5992E2A43B9}"/>
+                <a16:creationId xmlns:a16="http://schemas.microsoft.com/office/drawing/2014/main" id="{7E9EA2B0-DC0E-4696-ACB8-CE0C1CBA0E82}"/>
               </a:ext>
             </a:extLst>
           </p:cNvPr>
@@ -9481,7 +9481,7 @@
           <p:cNvPr id="14" name="">
             <a:extLst xmlns:a="http://schemas.openxmlformats.org/drawingml/2006/main">
               <a:ext uri="{FF2B5EF4-FFF2-40B4-BE49-F238E27FC236}">
-                <a16:creationId xmlns:a16="http://schemas.microsoft.com/office/drawing/2014/main" id="{25958EAD-BAEC-4EAA-B772-FA8A5AA90B22}"/>
+                <a16:creationId xmlns:a16="http://schemas.microsoft.com/office/drawing/2014/main" id="{DA4982CC-4BE3-4121-A360-12383360BC22}"/>
               </a:ext>
             </a:extLst>
           </p:cNvPr>
@@ -9545,7 +9545,7 @@
           <p:cNvPr id="15" name="">
             <a:extLst xmlns:a="http://schemas.openxmlformats.org/drawingml/2006/main">
               <a:ext uri="{FF2B5EF4-FFF2-40B4-BE49-F238E27FC236}">
-                <a16:creationId xmlns:a16="http://schemas.microsoft.com/office/drawing/2014/main" id="{B6195254-E10E-42C4-B415-018FF8DCA510}"/>
+                <a16:creationId xmlns:a16="http://schemas.microsoft.com/office/drawing/2014/main" id="{1686392F-C0CA-4F9E-B18F-ACA80D088AB8}"/>
               </a:ext>
             </a:extLst>
           </p:cNvPr>
@@ -9578,7 +9578,7 @@
           <p:cNvPr id="16" name="">
             <a:extLst xmlns:a="http://schemas.openxmlformats.org/drawingml/2006/main">
               <a:ext uri="{FF2B5EF4-FFF2-40B4-BE49-F238E27FC236}">
-                <a16:creationId xmlns:a16="http://schemas.microsoft.com/office/drawing/2014/main" id="{12F62A9D-7571-449F-9B9A-DE02FFD5CE7D}"/>
+                <a16:creationId xmlns:a16="http://schemas.microsoft.com/office/drawing/2014/main" id="{376B51B5-001A-45D6-B2D5-D5281E754505}"/>
               </a:ext>
             </a:extLst>
           </p:cNvPr>
@@ -9642,7 +9642,7 @@
           <p:cNvPr id="17" name="">
             <a:extLst xmlns:a="http://schemas.openxmlformats.org/drawingml/2006/main">
               <a:ext uri="{FF2B5EF4-FFF2-40B4-BE49-F238E27FC236}">
-                <a16:creationId xmlns:a16="http://schemas.microsoft.com/office/drawing/2014/main" id="{7355FCE3-BEEB-41FD-9A12-E6C49C3B35D3}"/>
+                <a16:creationId xmlns:a16="http://schemas.microsoft.com/office/drawing/2014/main" id="{F3EAFD67-D108-4583-944D-47C302294B21}"/>
               </a:ext>
             </a:extLst>
           </p:cNvPr>
@@ -9706,7 +9706,7 @@
           <p:cNvPr id="18" name="">
             <a:extLst xmlns:a="http://schemas.openxmlformats.org/drawingml/2006/main">
               <a:ext uri="{FF2B5EF4-FFF2-40B4-BE49-F238E27FC236}">
-                <a16:creationId xmlns:a16="http://schemas.microsoft.com/office/drawing/2014/main" id="{537B06BD-1B66-4382-96A6-C50C80147E45}"/>
+                <a16:creationId xmlns:a16="http://schemas.microsoft.com/office/drawing/2014/main" id="{FD51C439-E2F2-4A2A-BAE7-25F2C67B78A0}"/>
               </a:ext>
             </a:extLst>
           </p:cNvPr>
@@ -9770,7 +9770,7 @@
           <p:cNvPr id="19" name="">
             <a:extLst xmlns:a="http://schemas.openxmlformats.org/drawingml/2006/main">
               <a:ext uri="{FF2B5EF4-FFF2-40B4-BE49-F238E27FC236}">
-                <a16:creationId xmlns:a16="http://schemas.microsoft.com/office/drawing/2014/main" id="{28E2DA42-FB94-4050-95CB-B91B79EBBDA0}"/>
+                <a16:creationId xmlns:a16="http://schemas.microsoft.com/office/drawing/2014/main" id="{1F16A40F-5614-4062-AE28-0D6DC83192F0}"/>
               </a:ext>
             </a:extLst>
           </p:cNvPr>
@@ -9803,7 +9803,7 @@
           <p:cNvPr id="20" name="">
             <a:extLst xmlns:a="http://schemas.openxmlformats.org/drawingml/2006/main">
               <a:ext uri="{FF2B5EF4-FFF2-40B4-BE49-F238E27FC236}">
-                <a16:creationId xmlns:a16="http://schemas.microsoft.com/office/drawing/2014/main" id="{D9E0C676-100C-4BA9-9407-F38907EE8145}"/>
+                <a16:creationId xmlns:a16="http://schemas.microsoft.com/office/drawing/2014/main" id="{E23549D6-DB4F-4D55-85C2-4A98BFE67820}"/>
               </a:ext>
             </a:extLst>
           </p:cNvPr>
@@ -9867,7 +9867,7 @@
           <p:cNvPr id="21" name="">
             <a:extLst xmlns:a="http://schemas.openxmlformats.org/drawingml/2006/main">
               <a:ext uri="{FF2B5EF4-FFF2-40B4-BE49-F238E27FC236}">
-                <a16:creationId xmlns:a16="http://schemas.microsoft.com/office/drawing/2014/main" id="{700DA78C-2ED6-4FC5-981F-5F152E26AD5C}"/>
+                <a16:creationId xmlns:a16="http://schemas.microsoft.com/office/drawing/2014/main" id="{BA73C04B-EC72-4B27-9622-1FF62F60EFCE}"/>
               </a:ext>
             </a:extLst>
           </p:cNvPr>
@@ -9931,7 +9931,7 @@
           <p:cNvPr id="22" name="">
             <a:extLst xmlns:a="http://schemas.openxmlformats.org/drawingml/2006/main">
               <a:ext uri="{FF2B5EF4-FFF2-40B4-BE49-F238E27FC236}">
-                <a16:creationId xmlns:a16="http://schemas.microsoft.com/office/drawing/2014/main" id="{344C54E6-7B9C-47D3-BBDC-A1357B297C1A}"/>
+                <a16:creationId xmlns:a16="http://schemas.microsoft.com/office/drawing/2014/main" id="{AB692A3D-0DA0-4479-A89C-F42ABD3A9234}"/>
               </a:ext>
             </a:extLst>
           </p:cNvPr>
@@ -9995,7 +9995,7 @@
           <p:cNvPr id="23" name="">
             <a:extLst xmlns:a="http://schemas.openxmlformats.org/drawingml/2006/main">
               <a:ext uri="{FF2B5EF4-FFF2-40B4-BE49-F238E27FC236}">
-                <a16:creationId xmlns:a16="http://schemas.microsoft.com/office/drawing/2014/main" id="{879E4856-B20E-43DF-BB9C-C8A72ABB8BBF}"/>
+                <a16:creationId xmlns:a16="http://schemas.microsoft.com/office/drawing/2014/main" id="{A534ED78-A10D-4024-9C68-C41957590CB0}"/>
               </a:ext>
             </a:extLst>
           </p:cNvPr>
@@ -10028,7 +10028,7 @@
           <p:cNvPr id="24" name="">
             <a:extLst xmlns:a="http://schemas.openxmlformats.org/drawingml/2006/main">
               <a:ext uri="{FF2B5EF4-FFF2-40B4-BE49-F238E27FC236}">
-                <a16:creationId xmlns:a16="http://schemas.microsoft.com/office/drawing/2014/main" id="{C5DD66E7-8F1A-41F0-918B-9742851324A4}"/>
+                <a16:creationId xmlns:a16="http://schemas.microsoft.com/office/drawing/2014/main" id="{52B8A911-2E0B-46F7-A610-07904FECC614}"/>
               </a:ext>
             </a:extLst>
           </p:cNvPr>
@@ -10092,7 +10092,7 @@
           <p:cNvPr id="25" name="">
             <a:extLst xmlns:a="http://schemas.openxmlformats.org/drawingml/2006/main">
               <a:ext uri="{FF2B5EF4-FFF2-40B4-BE49-F238E27FC236}">
-                <a16:creationId xmlns:a16="http://schemas.microsoft.com/office/drawing/2014/main" id="{51CA35AF-69EB-4A04-9B6D-1E3661D85ACE}"/>
+                <a16:creationId xmlns:a16="http://schemas.microsoft.com/office/drawing/2014/main" id="{BA572584-94A6-41C1-8F0F-80255682DFD3}"/>
               </a:ext>
             </a:extLst>
           </p:cNvPr>
@@ -10156,7 +10156,7 @@
           <p:cNvPr id="26" name="">
             <a:extLst xmlns:a="http://schemas.openxmlformats.org/drawingml/2006/main">
               <a:ext uri="{FF2B5EF4-FFF2-40B4-BE49-F238E27FC236}">
-                <a16:creationId xmlns:a16="http://schemas.microsoft.com/office/drawing/2014/main" id="{A87FC604-DBF3-47FB-972B-52C0AF124F10}"/>
+                <a16:creationId xmlns:a16="http://schemas.microsoft.com/office/drawing/2014/main" id="{44F134CC-3987-45CA-B800-727379D80CA8}"/>
               </a:ext>
             </a:extLst>
           </p:cNvPr>
@@ -10191,7 +10191,7 @@
           <p:cNvPr id="27" name="">
             <a:extLst xmlns:a="http://schemas.openxmlformats.org/drawingml/2006/main">
               <a:ext uri="{FF2B5EF4-FFF2-40B4-BE49-F238E27FC236}">
-                <a16:creationId xmlns:a16="http://schemas.microsoft.com/office/drawing/2014/main" id="{D9DEA58F-681B-4AD7-88BF-82B2B2C4F11C}"/>
+                <a16:creationId xmlns:a16="http://schemas.microsoft.com/office/drawing/2014/main" id="{A4FBD082-7823-4009-884C-190986418EA4}"/>
               </a:ext>
             </a:extLst>
           </p:cNvPr>
@@ -10255,7 +10255,7 @@
           <p:cNvPr id="28" name="">
             <a:extLst xmlns:a="http://schemas.openxmlformats.org/drawingml/2006/main">
               <a:ext uri="{FF2B5EF4-FFF2-40B4-BE49-F238E27FC236}">
-                <a16:creationId xmlns:a16="http://schemas.microsoft.com/office/drawing/2014/main" id="{22FBB2C0-0D7F-4A19-B5B4-C56375F47638}"/>
+                <a16:creationId xmlns:a16="http://schemas.microsoft.com/office/drawing/2014/main" id="{5ADB098A-68A2-4A07-9D59-DC7F4A8721CF}"/>
               </a:ext>
             </a:extLst>
           </p:cNvPr>
@@ -10290,7 +10290,7 @@
           <p:cNvPr id="29" name="">
             <a:extLst xmlns:a="http://schemas.openxmlformats.org/drawingml/2006/main">
               <a:ext uri="{FF2B5EF4-FFF2-40B4-BE49-F238E27FC236}">
-                <a16:creationId xmlns:a16="http://schemas.microsoft.com/office/drawing/2014/main" id="{322071C7-0260-40C7-B5A2-AF210767CD2F}"/>
+                <a16:creationId xmlns:a16="http://schemas.microsoft.com/office/drawing/2014/main" id="{712E9FA7-7CF3-4F65-A4BD-022E8420D1D4}"/>
               </a:ext>
             </a:extLst>
           </p:cNvPr>
@@ -10354,7 +10354,7 @@
           <p:cNvPr id="30" name="">
             <a:extLst xmlns:a="http://schemas.openxmlformats.org/drawingml/2006/main">
               <a:ext uri="{FF2B5EF4-FFF2-40B4-BE49-F238E27FC236}">
-                <a16:creationId xmlns:a16="http://schemas.microsoft.com/office/drawing/2014/main" id="{E6628D4C-F5DF-47D9-B516-FCBE7294D624}"/>
+                <a16:creationId xmlns:a16="http://schemas.microsoft.com/office/drawing/2014/main" id="{B9876CBC-83F5-4D45-A43F-3980706422E6}"/>
               </a:ext>
             </a:extLst>
           </p:cNvPr>
@@ -10389,7 +10389,7 @@
           <p:cNvPr id="31" name="">
             <a:extLst xmlns:a="http://schemas.openxmlformats.org/drawingml/2006/main">
               <a:ext uri="{FF2B5EF4-FFF2-40B4-BE49-F238E27FC236}">
-                <a16:creationId xmlns:a16="http://schemas.microsoft.com/office/drawing/2014/main" id="{D1C3B358-9163-43FD-87B4-E23157BFF15B}"/>
+                <a16:creationId xmlns:a16="http://schemas.microsoft.com/office/drawing/2014/main" id="{822FB355-89FA-45BB-BF8E-F57C3EAEEE30}"/>
               </a:ext>
             </a:extLst>
           </p:cNvPr>
@@ -10453,7 +10453,7 @@
           <p:cNvPr id="32" name="">
             <a:extLst xmlns:a="http://schemas.openxmlformats.org/drawingml/2006/main">
               <a:ext uri="{FF2B5EF4-FFF2-40B4-BE49-F238E27FC236}">
-                <a16:creationId xmlns:a16="http://schemas.microsoft.com/office/drawing/2014/main" id="{03DFA526-457B-48E9-968E-C2E27602D37C}"/>
+                <a16:creationId xmlns:a16="http://schemas.microsoft.com/office/drawing/2014/main" id="{67903CFF-2909-4FF3-B5A2-6EB03BF11AFF}"/>
               </a:ext>
             </a:extLst>
           </p:cNvPr>
@@ -10488,7 +10488,7 @@
           <p:cNvPr id="33" name="">
             <a:extLst xmlns:a="http://schemas.openxmlformats.org/drawingml/2006/main">
               <a:ext uri="{FF2B5EF4-FFF2-40B4-BE49-F238E27FC236}">
-                <a16:creationId xmlns:a16="http://schemas.microsoft.com/office/drawing/2014/main" id="{259211B8-2E0B-4911-BAF8-5498E97ECD43}"/>
+                <a16:creationId xmlns:a16="http://schemas.microsoft.com/office/drawing/2014/main" id="{CA5D64BF-E8EA-4B7E-A2A1-3F92FD19CE25}"/>
               </a:ext>
             </a:extLst>
           </p:cNvPr>
@@ -10552,7 +10552,7 @@
           <p:cNvPr id="34" name="">
             <a:extLst xmlns:a="http://schemas.openxmlformats.org/drawingml/2006/main">
               <a:ext uri="{FF2B5EF4-FFF2-40B4-BE49-F238E27FC236}">
-                <a16:creationId xmlns:a16="http://schemas.microsoft.com/office/drawing/2014/main" id="{76159607-E99F-42C7-9572-532E599764F9}"/>
+                <a16:creationId xmlns:a16="http://schemas.microsoft.com/office/drawing/2014/main" id="{AD2997BA-798B-4BF9-8F0E-9FF77B2EE3D1}"/>
               </a:ext>
             </a:extLst>
           </p:cNvPr>
@@ -10587,7 +10587,7 @@
           <p:cNvPr id="35" name="">
             <a:extLst xmlns:a="http://schemas.openxmlformats.org/drawingml/2006/main">
               <a:ext uri="{FF2B5EF4-FFF2-40B4-BE49-F238E27FC236}">
-                <a16:creationId xmlns:a16="http://schemas.microsoft.com/office/drawing/2014/main" id="{905857F3-D14D-462E-9C90-D0A6629DF280}"/>
+                <a16:creationId xmlns:a16="http://schemas.microsoft.com/office/drawing/2014/main" id="{980F8DDE-37D2-4EBD-B79E-8EB705328327}"/>
               </a:ext>
             </a:extLst>
           </p:cNvPr>
@@ -10651,7 +10651,7 @@
           <p:cNvPr id="36" name="">
             <a:extLst xmlns:a="http://schemas.openxmlformats.org/drawingml/2006/main">
               <a:ext uri="{FF2B5EF4-FFF2-40B4-BE49-F238E27FC236}">
-                <a16:creationId xmlns:a16="http://schemas.microsoft.com/office/drawing/2014/main" id="{CA54F505-15DD-445D-A32A-E52DA918A3AF}"/>
+                <a16:creationId xmlns:a16="http://schemas.microsoft.com/office/drawing/2014/main" id="{543CC83D-8528-4BD5-B7D5-78AD133D0D48}"/>
               </a:ext>
             </a:extLst>
           </p:cNvPr>
@@ -10686,7 +10686,7 @@
           <p:cNvPr id="37" name="">
             <a:extLst xmlns:a="http://schemas.openxmlformats.org/drawingml/2006/main">
               <a:ext uri="{FF2B5EF4-FFF2-40B4-BE49-F238E27FC236}">
-                <a16:creationId xmlns:a16="http://schemas.microsoft.com/office/drawing/2014/main" id="{89419320-538E-4846-992F-240DBF38A450}"/>
+                <a16:creationId xmlns:a16="http://schemas.microsoft.com/office/drawing/2014/main" id="{663904F1-0F2F-4D45-95D5-005E5E5F3367}"/>
               </a:ext>
             </a:extLst>
           </p:cNvPr>
@@ -10750,7 +10750,7 @@
           <p:cNvPr id="38" name="">
             <a:extLst xmlns:a="http://schemas.openxmlformats.org/drawingml/2006/main">
               <a:ext uri="{FF2B5EF4-FFF2-40B4-BE49-F238E27FC236}">
-                <a16:creationId xmlns:a16="http://schemas.microsoft.com/office/drawing/2014/main" id="{ADE8AD24-0D7C-4411-A3FF-D8F5FC9AB014}"/>
+                <a16:creationId xmlns:a16="http://schemas.microsoft.com/office/drawing/2014/main" id="{5CBB0CE5-0865-4A7B-923C-326FC67D01F7}"/>
               </a:ext>
             </a:extLst>
           </p:cNvPr>
@@ -10814,7 +10814,7 @@
           <p:cNvPr id="39" name="">
             <a:extLst xmlns:a="http://schemas.openxmlformats.org/drawingml/2006/main">
               <a:ext uri="{FF2B5EF4-FFF2-40B4-BE49-F238E27FC236}">
-                <a16:creationId xmlns:a16="http://schemas.microsoft.com/office/drawing/2014/main" id="{7251AAFB-0A08-4035-A7B1-03185CBD22D3}"/>
+                <a16:creationId xmlns:a16="http://schemas.microsoft.com/office/drawing/2014/main" id="{F3B5172C-14C9-4E49-91DB-4A689816CE5E}"/>
               </a:ext>
             </a:extLst>
           </p:cNvPr>
@@ -10878,7 +10878,7 @@
           <p:cNvPr id="40" name="">
             <a:extLst xmlns:a="http://schemas.openxmlformats.org/drawingml/2006/main">
               <a:ext uri="{FF2B5EF4-FFF2-40B4-BE49-F238E27FC236}">
-                <a16:creationId xmlns:a16="http://schemas.microsoft.com/office/drawing/2014/main" id="{0E27B6DC-4051-4917-B5CA-D73124F8CD88}"/>
+                <a16:creationId xmlns:a16="http://schemas.microsoft.com/office/drawing/2014/main" id="{2AFEB6B3-6236-4274-9B31-75F9E83F629F}"/>
               </a:ext>
             </a:extLst>
           </p:cNvPr>
@@ -10942,7 +10942,7 @@
           <p:cNvPr id="41" name="">
             <a:extLst xmlns:a="http://schemas.openxmlformats.org/drawingml/2006/main">
               <a:ext uri="{FF2B5EF4-FFF2-40B4-BE49-F238E27FC236}">
-                <a16:creationId xmlns:a16="http://schemas.microsoft.com/office/drawing/2014/main" id="{95A6F7EA-2C98-4CAB-89EF-19CDC261016D}"/>
+                <a16:creationId xmlns:a16="http://schemas.microsoft.com/office/drawing/2014/main" id="{F1EC22F7-30B7-4F2D-BF75-601F3728CC48}"/>
               </a:ext>
             </a:extLst>
           </p:cNvPr>
@@ -11006,7 +11006,7 @@
           <p:cNvPr id="42" name="">
             <a:extLst xmlns:a="http://schemas.openxmlformats.org/drawingml/2006/main">
               <a:ext uri="{FF2B5EF4-FFF2-40B4-BE49-F238E27FC236}">
-                <a16:creationId xmlns:a16="http://schemas.microsoft.com/office/drawing/2014/main" id="{02632C84-EFFE-4B8F-A3DD-E450F8027401}"/>
+                <a16:creationId xmlns:a16="http://schemas.microsoft.com/office/drawing/2014/main" id="{1DB5DDA9-EFC5-4F5B-925B-FCF0FDA57FA8}"/>
               </a:ext>
             </a:extLst>
           </p:cNvPr>
@@ -11070,7 +11070,7 @@
           <p:cNvPr id="43" name="">
             <a:extLst xmlns:a="http://schemas.openxmlformats.org/drawingml/2006/main">
               <a:ext uri="{FF2B5EF4-FFF2-40B4-BE49-F238E27FC236}">
-                <a16:creationId xmlns:a16="http://schemas.microsoft.com/office/drawing/2014/main" id="{6F578375-9616-45CA-B109-9454E504127E}"/>
+                <a16:creationId xmlns:a16="http://schemas.microsoft.com/office/drawing/2014/main" id="{C201EECB-6AD3-4A7E-90EB-042D13A1673C}"/>
               </a:ext>
             </a:extLst>
           </p:cNvPr>
@@ -11132,7 +11132,7 @@
     </p:spTree>
     <p:extLst>
       <p:ext uri="{BB962C8B-B14F-4D97-AF65-F5344CB8AC3E}">
-        <p14:creationId xmlns:p14="http://schemas.microsoft.com/office/powerpoint/2010/main" val="1669487313"/>
+        <p14:creationId xmlns:p14="http://schemas.microsoft.com/office/powerpoint/2010/main" val="803118219"/>
       </p:ext>
     </p:extLst>
   </p:cSld>
@@ -11156,7 +11156,7 @@
           <p:cNvPr id="1" name="">
             <a:extLst xmlns:a="http://schemas.openxmlformats.org/drawingml/2006/main">
               <a:ext uri="{FF2B5EF4-FFF2-40B4-BE49-F238E27FC236}">
-                <a16:creationId xmlns:a16="http://schemas.microsoft.com/office/drawing/2014/main" id="{05CED370-A455-4BFD-9C83-4AEF10D552C3}"/>
+                <a16:creationId xmlns:a16="http://schemas.microsoft.com/office/drawing/2014/main" id="{F14812B3-CF5E-4ED6-99F2-21FECA5D027E}"/>
               </a:ext>
             </a:extLst>
           </p:cNvPr>
@@ -11191,7 +11191,7 @@
           <p:cNvPr id="2" name="">
             <a:extLst xmlns:a="http://schemas.openxmlformats.org/drawingml/2006/main">
               <a:ext uri="{FF2B5EF4-FFF2-40B4-BE49-F238E27FC236}">
-                <a16:creationId xmlns:a16="http://schemas.microsoft.com/office/drawing/2014/main" id="{A93AF2EB-5A8C-4338-AFBF-B1C84C13D0B4}"/>
+                <a16:creationId xmlns:a16="http://schemas.microsoft.com/office/drawing/2014/main" id="{82E19E04-A075-4CA1-8EEC-634B4E23466C}"/>
               </a:ext>
             </a:extLst>
           </p:cNvPr>
@@ -11226,7 +11226,7 @@
           <p:cNvPr id="3" name="">
             <a:extLst xmlns:a="http://schemas.openxmlformats.org/drawingml/2006/main">
               <a:ext uri="{FF2B5EF4-FFF2-40B4-BE49-F238E27FC236}">
-                <a16:creationId xmlns:a16="http://schemas.microsoft.com/office/drawing/2014/main" id="{34B937C4-0CD0-410D-8035-E312B8A64D9E}"/>
+                <a16:creationId xmlns:a16="http://schemas.microsoft.com/office/drawing/2014/main" id="{6B26649C-FDBF-4BA8-A6F1-C5B5D0C7896F}"/>
               </a:ext>
             </a:extLst>
           </p:cNvPr>
@@ -11290,7 +11290,7 @@
           <p:cNvPr id="4" name="">
             <a:extLst xmlns:a="http://schemas.openxmlformats.org/drawingml/2006/main">
               <a:ext uri="{FF2B5EF4-FFF2-40B4-BE49-F238E27FC236}">
-                <a16:creationId xmlns:a16="http://schemas.microsoft.com/office/drawing/2014/main" id="{B3988BF4-754A-4EEC-8D8D-583C4EDB7D23}"/>
+                <a16:creationId xmlns:a16="http://schemas.microsoft.com/office/drawing/2014/main" id="{66BF51F0-BC5A-4141-9DB2-B4F72326FC73}"/>
               </a:ext>
             </a:extLst>
           </p:cNvPr>
@@ -11354,7 +11354,7 @@
           <p:cNvPr id="5" name="">
             <a:extLst xmlns:a="http://schemas.openxmlformats.org/drawingml/2006/main">
               <a:ext uri="{FF2B5EF4-FFF2-40B4-BE49-F238E27FC236}">
-                <a16:creationId xmlns:a16="http://schemas.microsoft.com/office/drawing/2014/main" id="{6A9A600E-1F93-4FAC-AD6C-737A4072D953}"/>
+                <a16:creationId xmlns:a16="http://schemas.microsoft.com/office/drawing/2014/main" id="{74CFC28D-FDCF-4153-901C-C359149BE3C6}"/>
               </a:ext>
             </a:extLst>
           </p:cNvPr>
@@ -11418,7 +11418,7 @@
           <p:cNvPr id="6" name="">
             <a:extLst xmlns:a="http://schemas.openxmlformats.org/drawingml/2006/main">
               <a:ext uri="{FF2B5EF4-FFF2-40B4-BE49-F238E27FC236}">
-                <a16:creationId xmlns:a16="http://schemas.microsoft.com/office/drawing/2014/main" id="{9F59EEB7-345A-4A0D-BFBA-B43EAC984D4C}"/>
+                <a16:creationId xmlns:a16="http://schemas.microsoft.com/office/drawing/2014/main" id="{0F31D74D-E685-486C-B3ED-7E51A8580B01}"/>
               </a:ext>
             </a:extLst>
           </p:cNvPr>
@@ -11482,7 +11482,7 @@
           <p:cNvPr id="7" name="">
             <a:extLst xmlns:a="http://schemas.openxmlformats.org/drawingml/2006/main">
               <a:ext uri="{FF2B5EF4-FFF2-40B4-BE49-F238E27FC236}">
-                <a16:creationId xmlns:a16="http://schemas.microsoft.com/office/drawing/2014/main" id="{7D678577-1BAF-41B1-A967-3F03509FF870}"/>
+                <a16:creationId xmlns:a16="http://schemas.microsoft.com/office/drawing/2014/main" id="{1B384A38-49EA-4F71-89A8-376F50B4FA31}"/>
               </a:ext>
             </a:extLst>
           </p:cNvPr>
@@ -11569,7 +11569,7 @@
           <p:cNvPr id="8" name="">
             <a:extLst xmlns:a="http://schemas.openxmlformats.org/drawingml/2006/main">
               <a:ext uri="{FF2B5EF4-FFF2-40B4-BE49-F238E27FC236}">
-                <a16:creationId xmlns:a16="http://schemas.microsoft.com/office/drawing/2014/main" id="{9C6AF3BE-9814-4945-AA24-36EA68C3843C}"/>
+                <a16:creationId xmlns:a16="http://schemas.microsoft.com/office/drawing/2014/main" id="{A5E96512-1785-4260-B693-9CAE5998E8F8}"/>
               </a:ext>
             </a:extLst>
           </p:cNvPr>
@@ -11602,7 +11602,7 @@
           <p:cNvPr id="9" name="">
             <a:extLst xmlns:a="http://schemas.openxmlformats.org/drawingml/2006/main">
               <a:ext uri="{FF2B5EF4-FFF2-40B4-BE49-F238E27FC236}">
-                <a16:creationId xmlns:a16="http://schemas.microsoft.com/office/drawing/2014/main" id="{97A72636-1933-404F-9C48-3D9C41034D8E}"/>
+                <a16:creationId xmlns:a16="http://schemas.microsoft.com/office/drawing/2014/main" id="{FA612670-2C59-448D-8B5A-F2A3638624D2}"/>
               </a:ext>
             </a:extLst>
           </p:cNvPr>
@@ -11666,7 +11666,7 @@
           <p:cNvPr id="10" name="">
             <a:extLst xmlns:a="http://schemas.openxmlformats.org/drawingml/2006/main">
               <a:ext uri="{FF2B5EF4-FFF2-40B4-BE49-F238E27FC236}">
-                <a16:creationId xmlns:a16="http://schemas.microsoft.com/office/drawing/2014/main" id="{9A7AB2AB-7D68-46FE-B20D-921F281DE25A}"/>
+                <a16:creationId xmlns:a16="http://schemas.microsoft.com/office/drawing/2014/main" id="{0202B357-26B6-4124-9A09-979FB037A3D2}"/>
               </a:ext>
             </a:extLst>
           </p:cNvPr>
@@ -11730,7 +11730,7 @@
           <p:cNvPr id="11" name="">
             <a:extLst xmlns:a="http://schemas.openxmlformats.org/drawingml/2006/main">
               <a:ext uri="{FF2B5EF4-FFF2-40B4-BE49-F238E27FC236}">
-                <a16:creationId xmlns:a16="http://schemas.microsoft.com/office/drawing/2014/main" id="{83E736FC-C41C-4B91-B813-630D7DBA75BB}"/>
+                <a16:creationId xmlns:a16="http://schemas.microsoft.com/office/drawing/2014/main" id="{081E40A6-AE28-466A-B159-7EFA9EB9294B}"/>
               </a:ext>
             </a:extLst>
           </p:cNvPr>
@@ -11763,7 +11763,7 @@
           <p:cNvPr id="12" name="">
             <a:extLst xmlns:a="http://schemas.openxmlformats.org/drawingml/2006/main">
               <a:ext uri="{FF2B5EF4-FFF2-40B4-BE49-F238E27FC236}">
-                <a16:creationId xmlns:a16="http://schemas.microsoft.com/office/drawing/2014/main" id="{380E24B2-3281-4C45-9D9B-C28347F15C23}"/>
+                <a16:creationId xmlns:a16="http://schemas.microsoft.com/office/drawing/2014/main" id="{DE6AB13F-0C5A-445A-A585-D94D933A0C41}"/>
               </a:ext>
             </a:extLst>
           </p:cNvPr>
@@ -11827,7 +11827,7 @@
           <p:cNvPr id="13" name="">
             <a:extLst xmlns:a="http://schemas.openxmlformats.org/drawingml/2006/main">
               <a:ext uri="{FF2B5EF4-FFF2-40B4-BE49-F238E27FC236}">
-                <a16:creationId xmlns:a16="http://schemas.microsoft.com/office/drawing/2014/main" id="{19813752-DAE4-4976-BD72-8CE5FAE059CD}"/>
+                <a16:creationId xmlns:a16="http://schemas.microsoft.com/office/drawing/2014/main" id="{2FA2518E-1E97-4437-9919-AA9F4FE82E4A}"/>
               </a:ext>
             </a:extLst>
           </p:cNvPr>
@@ -11891,7 +11891,7 @@
           <p:cNvPr id="14" name="">
             <a:extLst xmlns:a="http://schemas.openxmlformats.org/drawingml/2006/main">
               <a:ext uri="{FF2B5EF4-FFF2-40B4-BE49-F238E27FC236}">
-                <a16:creationId xmlns:a16="http://schemas.microsoft.com/office/drawing/2014/main" id="{A506E1A4-3694-44A4-95AF-F64A4E67A8B2}"/>
+                <a16:creationId xmlns:a16="http://schemas.microsoft.com/office/drawing/2014/main" id="{E2E1CCA6-6466-486E-B9E1-0054191DF4BC}"/>
               </a:ext>
             </a:extLst>
           </p:cNvPr>
@@ -11924,7 +11924,7 @@
           <p:cNvPr id="15" name="">
             <a:extLst xmlns:a="http://schemas.openxmlformats.org/drawingml/2006/main">
               <a:ext uri="{FF2B5EF4-FFF2-40B4-BE49-F238E27FC236}">
-                <a16:creationId xmlns:a16="http://schemas.microsoft.com/office/drawing/2014/main" id="{636F4FA8-571E-4E0D-846C-C66DBACC8AC0}"/>
+                <a16:creationId xmlns:a16="http://schemas.microsoft.com/office/drawing/2014/main" id="{316CBCA1-29D4-4A20-B7D0-550EB23A241B}"/>
               </a:ext>
             </a:extLst>
           </p:cNvPr>
@@ -11988,7 +11988,7 @@
           <p:cNvPr id="16" name="">
             <a:extLst xmlns:a="http://schemas.openxmlformats.org/drawingml/2006/main">
               <a:ext uri="{FF2B5EF4-FFF2-40B4-BE49-F238E27FC236}">
-                <a16:creationId xmlns:a16="http://schemas.microsoft.com/office/drawing/2014/main" id="{C8699538-25D1-4A83-9CEC-A3CBB79FB72E}"/>
+                <a16:creationId xmlns:a16="http://schemas.microsoft.com/office/drawing/2014/main" id="{8F8C5BF6-8D75-4F8F-829E-E5D2B6D3A44B}"/>
               </a:ext>
             </a:extLst>
           </p:cNvPr>
@@ -12052,7 +12052,7 @@
           <p:cNvPr id="17" name="">
             <a:extLst xmlns:a="http://schemas.openxmlformats.org/drawingml/2006/main">
               <a:ext uri="{FF2B5EF4-FFF2-40B4-BE49-F238E27FC236}">
-                <a16:creationId xmlns:a16="http://schemas.microsoft.com/office/drawing/2014/main" id="{7273A5FE-3238-43A4-BB8C-7C21A29B88AB}"/>
+                <a16:creationId xmlns:a16="http://schemas.microsoft.com/office/drawing/2014/main" id="{DEE59470-ABCF-458D-8ABA-6CBA08C988C8}"/>
               </a:ext>
             </a:extLst>
           </p:cNvPr>
@@ -12087,7 +12087,7 @@
           <p:cNvPr id="18" name="">
             <a:extLst xmlns:a="http://schemas.openxmlformats.org/drawingml/2006/main">
               <a:ext uri="{FF2B5EF4-FFF2-40B4-BE49-F238E27FC236}">
-                <a16:creationId xmlns:a16="http://schemas.microsoft.com/office/drawing/2014/main" id="{D7981AC3-4486-42F8-8745-C51878E43D9D}"/>
+                <a16:creationId xmlns:a16="http://schemas.microsoft.com/office/drawing/2014/main" id="{97F4387B-6158-4512-ACEA-7AF7EEA5A560}"/>
               </a:ext>
             </a:extLst>
           </p:cNvPr>
@@ -12122,7 +12122,7 @@
           <p:cNvPr id="19" name="">
             <a:extLst xmlns:a="http://schemas.openxmlformats.org/drawingml/2006/main">
               <a:ext uri="{FF2B5EF4-FFF2-40B4-BE49-F238E27FC236}">
-                <a16:creationId xmlns:a16="http://schemas.microsoft.com/office/drawing/2014/main" id="{AF1EB15F-3136-4AB3-AA91-43B77BF201C7}"/>
+                <a16:creationId xmlns:a16="http://schemas.microsoft.com/office/drawing/2014/main" id="{CF6E82DD-81C4-4F20-8AD5-71805D7590A8}"/>
               </a:ext>
             </a:extLst>
           </p:cNvPr>
@@ -12184,7 +12184,7 @@
     </p:spTree>
     <p:extLst>
       <p:ext uri="{BB962C8B-B14F-4D97-AF65-F5344CB8AC3E}">
-        <p14:creationId xmlns:p14="http://schemas.microsoft.com/office/powerpoint/2010/main" val="1723777257"/>
+        <p14:creationId xmlns:p14="http://schemas.microsoft.com/office/powerpoint/2010/main" val="1104812639"/>
       </p:ext>
     </p:extLst>
   </p:cSld>
@@ -12208,7 +12208,7 @@
           <p:cNvPr id="1" name="">
             <a:extLst xmlns:a="http://schemas.openxmlformats.org/drawingml/2006/main">
               <a:ext uri="{FF2B5EF4-FFF2-40B4-BE49-F238E27FC236}">
-                <a16:creationId xmlns:a16="http://schemas.microsoft.com/office/drawing/2014/main" id="{F2DF9D5D-6370-4468-AB19-6DE3909C4580}"/>
+                <a16:creationId xmlns:a16="http://schemas.microsoft.com/office/drawing/2014/main" id="{1FF91548-0FD4-4EC7-BB49-6DAD2913190B}"/>
               </a:ext>
             </a:extLst>
           </p:cNvPr>
@@ -12243,7 +12243,7 @@
           <p:cNvPr id="2" name="">
             <a:extLst xmlns:a="http://schemas.openxmlformats.org/drawingml/2006/main">
               <a:ext uri="{FF2B5EF4-FFF2-40B4-BE49-F238E27FC236}">
-                <a16:creationId xmlns:a16="http://schemas.microsoft.com/office/drawing/2014/main" id="{BCDFBBF8-EE1D-4D94-80C0-BD5E380633D3}"/>
+                <a16:creationId xmlns:a16="http://schemas.microsoft.com/office/drawing/2014/main" id="{51FEE3D6-D202-4308-A956-6CBE5036811C}"/>
               </a:ext>
             </a:extLst>
           </p:cNvPr>
@@ -12278,7 +12278,7 @@
           <p:cNvPr id="3" name="">
             <a:extLst xmlns:a="http://schemas.openxmlformats.org/drawingml/2006/main">
               <a:ext uri="{FF2B5EF4-FFF2-40B4-BE49-F238E27FC236}">
-                <a16:creationId xmlns:a16="http://schemas.microsoft.com/office/drawing/2014/main" id="{7BE3B624-F19D-4F24-A161-F4DB4C575E34}"/>
+                <a16:creationId xmlns:a16="http://schemas.microsoft.com/office/drawing/2014/main" id="{10448B41-A609-48FA-BFF9-8E3972E073DE}"/>
               </a:ext>
             </a:extLst>
           </p:cNvPr>
@@ -12342,7 +12342,7 @@
           <p:cNvPr id="4" name="">
             <a:extLst xmlns:a="http://schemas.openxmlformats.org/drawingml/2006/main">
               <a:ext uri="{FF2B5EF4-FFF2-40B4-BE49-F238E27FC236}">
-                <a16:creationId xmlns:a16="http://schemas.microsoft.com/office/drawing/2014/main" id="{0BB629BC-C8A0-495E-BD5C-5CD7FDD0461F}"/>
+                <a16:creationId xmlns:a16="http://schemas.microsoft.com/office/drawing/2014/main" id="{2B5B5845-FE0A-4B27-BF9D-DAF79839C3DA}"/>
               </a:ext>
             </a:extLst>
           </p:cNvPr>
@@ -12396,7 +12396,7 @@
                 <a:ea typeface="Aptos"/>
                 <a:cs typeface="Aptos"/>
               </a:rPr>
-              <a:t>RUNTIME PORTABILITY</a:t>
+              <a:t>AMD GEMMA PROOF</a:t>
             </a:r>
           </a:p>
         </p:txBody>
@@ -12406,7 +12406,7 @@
           <p:cNvPr id="5" name="">
             <a:extLst xmlns:a="http://schemas.openxmlformats.org/drawingml/2006/main">
               <a:ext uri="{FF2B5EF4-FFF2-40B4-BE49-F238E27FC236}">
-                <a16:creationId xmlns:a16="http://schemas.microsoft.com/office/drawing/2014/main" id="{A2374036-6339-44C6-B4DF-5A6982F5F3BA}"/>
+                <a16:creationId xmlns:a16="http://schemas.microsoft.com/office/drawing/2014/main" id="{4F1F1837-829B-46E9-8284-F481442089B8}"/>
               </a:ext>
             </a:extLst>
           </p:cNvPr>
@@ -12460,7 +12460,7 @@
                 <a:ea typeface="Aptos Display"/>
                 <a:cs typeface="Aptos Display"/>
               </a:rPr>
-              <a:t>One endpoint. Two deployment paths.</a:t>
+              <a:t>AMD-hosted Gemma. Measured product outcomes.</a:t>
             </a:r>
           </a:p>
         </p:txBody>
@@ -12470,7 +12470,7 @@
           <p:cNvPr id="6" name="">
             <a:extLst xmlns:a="http://schemas.openxmlformats.org/drawingml/2006/main">
               <a:ext uri="{FF2B5EF4-FFF2-40B4-BE49-F238E27FC236}">
-                <a16:creationId xmlns:a16="http://schemas.microsoft.com/office/drawing/2014/main" id="{BF37D56B-0833-47ED-BD32-D79AF75F5417}"/>
+                <a16:creationId xmlns:a16="http://schemas.microsoft.com/office/drawing/2014/main" id="{5D096656-4E38-4508-A141-41790932DC15}"/>
               </a:ext>
             </a:extLst>
           </p:cNvPr>
@@ -12482,7 +12482,7 @@
         <p:spPr>
           <a:xfrm xmlns:a="http://schemas.openxmlformats.org/drawingml/2006/main">
             <a:off x="457200" y="1295400"/>
-            <a:ext cx="7048500" cy="361950"/>
+            <a:ext cx="7810500" cy="361950"/>
           </a:xfrm>
           <a:prstGeom xmlns:a="http://schemas.openxmlformats.org/drawingml/2006/main" prst="rect">
             <a:avLst/>
@@ -12524,7 +12524,7 @@
                 <a:ea typeface="Aptos"/>
                 <a:cs typeface="Aptos"/>
               </a:rPr>
-              <a:t>Agent and verifier code stay unchanged when the inference host changes.</a:t>
+              <a:t>Gemma explores recovery options; ecosystem rules decide what can touch the tank.</a:t>
             </a:r>
           </a:p>
         </p:txBody>
@@ -12534,7 +12534,7 @@
           <p:cNvPr id="7" name="">
             <a:extLst xmlns:a="http://schemas.openxmlformats.org/drawingml/2006/main">
               <a:ext uri="{FF2B5EF4-FFF2-40B4-BE49-F238E27FC236}">
-                <a16:creationId xmlns:a16="http://schemas.microsoft.com/office/drawing/2014/main" id="{299B50E4-C7C0-4DE0-BECF-1DC81FF2CF2F}"/>
+                <a16:creationId xmlns:a16="http://schemas.microsoft.com/office/drawing/2014/main" id="{3C9AD02A-C843-4E25-8C51-F2E6C991D862}"/>
               </a:ext>
             </a:extLst>
           </p:cNvPr>
@@ -12546,7 +12546,7 @@
         <p:spPr>
           <a:xfrm xmlns:a="http://schemas.openxmlformats.org/drawingml/2006/main">
             <a:off x="609600" y="2038350"/>
-            <a:ext cx="2857500" cy="228600"/>
+            <a:ext cx="3048000" cy="228600"/>
           </a:xfrm>
           <a:prstGeom xmlns:a="http://schemas.openxmlformats.org/drawingml/2006/main" prst="rect">
             <a:avLst/>
@@ -12570,25 +12570,25 @@
           <a:lstStyle xmlns:a="http://schemas.openxmlformats.org/drawingml/2006/main"/>
           <a:p xmlns:a="http://schemas.openxmlformats.org/drawingml/2006/main">
             <a:pPr algn="l">
-              <a:defRPr sz="900" b="1">
-                <a:solidFill>
-                  <a:srgbClr val="76D9AD"/>
-                </a:solidFill>
-                <a:latin typeface="Aptos"/>
-                <a:ea typeface="Aptos"/>
-                <a:cs typeface="Aptos"/>
-              </a:defRPr>
-            </a:pPr>
-            <a:r>
-              <a:rPr sz="900" b="1">
-                <a:solidFill>
-                  <a:srgbClr val="76D9AD"/>
-                </a:solidFill>
-                <a:latin typeface="Aptos"/>
-                <a:ea typeface="Aptos"/>
-                <a:cs typeface="Aptos"/>
-              </a:rPr>
-              <a:t>PROVEN NOW</a:t>
+              <a:defRPr sz="825" b="1">
+                <a:solidFill>
+                  <a:srgbClr val="1687C8"/>
+                </a:solidFill>
+                <a:latin typeface="Aptos"/>
+                <a:ea typeface="Aptos"/>
+                <a:cs typeface="Aptos"/>
+              </a:defRPr>
+            </a:pPr>
+            <a:r>
+              <a:rPr sz="825" b="1">
+                <a:solidFill>
+                  <a:srgbClr val="1687C8"/>
+                </a:solidFill>
+                <a:latin typeface="Aptos"/>
+                <a:ea typeface="Aptos"/>
+                <a:cs typeface="Aptos"/>
+              </a:rPr>
+              <a:t>CAPTURED AMD RUNTIME</a:t>
             </a:r>
           </a:p>
         </p:txBody>
@@ -12598,7 +12598,7 @@
           <p:cNvPr id="8" name="">
             <a:extLst xmlns:a="http://schemas.openxmlformats.org/drawingml/2006/main">
               <a:ext uri="{FF2B5EF4-FFF2-40B4-BE49-F238E27FC236}">
-                <a16:creationId xmlns:a16="http://schemas.microsoft.com/office/drawing/2014/main" id="{B033A521-5C46-4DE5-8876-6A3038444638}"/>
+                <a16:creationId xmlns:a16="http://schemas.microsoft.com/office/drawing/2014/main" id="{F316CEBD-AA38-412E-B6EF-8B37B6ECAD0F}"/>
               </a:ext>
             </a:extLst>
           </p:cNvPr>
@@ -12610,7 +12610,7 @@
         <p:spPr>
           <a:xfrm xmlns:a="http://schemas.openxmlformats.org/drawingml/2006/main">
             <a:off x="495300" y="2400300"/>
-            <a:ext cx="3200400" cy="2095500"/>
+            <a:ext cx="3333750" cy="2343150"/>
           </a:xfrm>
           <a:prstGeom xmlns:a="http://schemas.openxmlformats.org/drawingml/2006/main" prst="rect">
             <a:avLst/>
@@ -12618,9 +12618,9 @@
           <a:solidFill xmlns:a="http://schemas.openxmlformats.org/drawingml/2006/main">
             <a:srgbClr val="173F50"/>
           </a:solidFill>
-          <a:ln xmlns:a="http://schemas.openxmlformats.org/drawingml/2006/main" w="9525">
-            <a:solidFill>
-              <a:srgbClr val="4F7887"/>
+          <a:ln xmlns:a="http://schemas.openxmlformats.org/drawingml/2006/main" w="19050">
+            <a:solidFill>
+              <a:srgbClr val="1687C8"/>
             </a:solidFill>
             <a:prstDash val="solid"/>
           </a:ln>
@@ -12631,19 +12631,19 @@
           <p:cNvPr id="9" name="">
             <a:extLst xmlns:a="http://schemas.openxmlformats.org/drawingml/2006/main">
               <a:ext uri="{FF2B5EF4-FFF2-40B4-BE49-F238E27FC236}">
-                <a16:creationId xmlns:a16="http://schemas.microsoft.com/office/drawing/2014/main" id="{2B3AF423-C2A7-430B-8D63-8C17300783C5}"/>
-              </a:ext>
-            </a:extLst>
-          </p:cNvPr>
-          <p:cNvSpPr>
-            <a:spLocks xmlns:a="http://schemas.openxmlformats.org/drawingml/2006/main" noGrp="1"/>
-          </p:cNvSpPr>
-          <p:nvPr/>
-        </p:nvSpPr>
-        <p:spPr>
-          <a:xfrm xmlns:a="http://schemas.openxmlformats.org/drawingml/2006/main">
-            <a:off x="781050" y="2647950"/>
-            <a:ext cx="2628900" cy="342900"/>
+                <a16:creationId xmlns:a16="http://schemas.microsoft.com/office/drawing/2014/main" id="{12627886-C591-46C3-9A96-38F49F722732}"/>
+              </a:ext>
+            </a:extLst>
+          </p:cNvPr>
+          <p:cNvSpPr>
+            <a:spLocks xmlns:a="http://schemas.openxmlformats.org/drawingml/2006/main" noGrp="1"/>
+          </p:cNvSpPr>
+          <p:nvPr/>
+        </p:nvSpPr>
+        <p:spPr>
+          <a:xfrm xmlns:a="http://schemas.openxmlformats.org/drawingml/2006/main">
+            <a:off x="762000" y="2647950"/>
+            <a:ext cx="2800350" cy="400050"/>
           </a:xfrm>
           <a:prstGeom xmlns:a="http://schemas.openxmlformats.org/drawingml/2006/main" prst="rect">
             <a:avLst/>
@@ -12667,7 +12667,7 @@
           <a:lstStyle xmlns:a="http://schemas.openxmlformats.org/drawingml/2006/main"/>
           <a:p xmlns:a="http://schemas.openxmlformats.org/drawingml/2006/main">
             <a:pPr algn="l">
-              <a:defRPr sz="1875" b="1">
+              <a:defRPr sz="1800" b="1">
                 <a:solidFill>
                   <a:srgbClr val="FFFFFF"/>
                 </a:solidFill>
@@ -12677,7 +12677,7 @@
               </a:defRPr>
             </a:pPr>
             <a:r>
-              <a:rPr sz="1875" b="1">
+              <a:rPr sz="1800" b="1">
                 <a:solidFill>
                   <a:srgbClr val="FFFFFF"/>
                 </a:solidFill>
@@ -12685,7 +12685,7 @@
                 <a:ea typeface="Aptos"/>
                 <a:cs typeface="Aptos"/>
               </a:rPr>
-              <a:t>CPU edge runtime</a:t>
+              <a:t>Gemma 4 E2B</a:t>
             </a:r>
           </a:p>
         </p:txBody>
@@ -12695,19 +12695,54 @@
           <p:cNvPr id="10" name="">
             <a:extLst xmlns:a="http://schemas.openxmlformats.org/drawingml/2006/main">
               <a:ext uri="{FF2B5EF4-FFF2-40B4-BE49-F238E27FC236}">
-                <a16:creationId xmlns:a16="http://schemas.microsoft.com/office/drawing/2014/main" id="{4130C58E-5726-4110-B9D5-137C5E653DCE}"/>
-              </a:ext>
-            </a:extLst>
-          </p:cNvPr>
-          <p:cNvSpPr>
-            <a:spLocks xmlns:a="http://schemas.openxmlformats.org/drawingml/2006/main" noGrp="1"/>
-          </p:cNvSpPr>
-          <p:nvPr/>
-        </p:nvSpPr>
-        <p:spPr>
-          <a:xfrm xmlns:a="http://schemas.openxmlformats.org/drawingml/2006/main">
-            <a:off x="781050" y="3143250"/>
-            <a:ext cx="2628900" cy="952500"/>
+                <a16:creationId xmlns:a16="http://schemas.microsoft.com/office/drawing/2014/main" id="{D96DC99E-52DD-4607-A138-5225DBCA1DB8}"/>
+              </a:ext>
+            </a:extLst>
+          </p:cNvPr>
+          <p:cNvSpPr>
+            <a:spLocks xmlns:a="http://schemas.openxmlformats.org/drawingml/2006/main" noGrp="1"/>
+          </p:cNvSpPr>
+          <p:nvPr/>
+        </p:nvSpPr>
+        <p:spPr>
+          <a:xfrm xmlns:a="http://schemas.openxmlformats.org/drawingml/2006/main">
+            <a:off x="781050" y="3276600"/>
+            <a:ext cx="47625" cy="228600"/>
+          </a:xfrm>
+          <a:prstGeom xmlns:a="http://schemas.openxmlformats.org/drawingml/2006/main" prst="rect">
+            <a:avLst/>
+          </a:prstGeom>
+          <a:solidFill xmlns:a="http://schemas.openxmlformats.org/drawingml/2006/main">
+            <a:srgbClr val="1687C8"/>
+          </a:solidFill>
+          <a:ln xmlns:a="http://schemas.openxmlformats.org/drawingml/2006/main" w="0">
+            <a:solidFill>
+              <a:srgbClr val="000000">
+                <a:alpha val="0"/>
+              </a:srgbClr>
+            </a:solidFill>
+            <a:prstDash val="solid"/>
+          </a:ln>
+        </p:spPr>
+      </p:sp>
+      <p:sp>
+        <p:nvSpPr>
+          <p:cNvPr id="11" name="">
+            <a:extLst xmlns:a="http://schemas.openxmlformats.org/drawingml/2006/main">
+              <a:ext uri="{FF2B5EF4-FFF2-40B4-BE49-F238E27FC236}">
+                <a16:creationId xmlns:a16="http://schemas.microsoft.com/office/drawing/2014/main" id="{91CCAA9C-DDAD-41E3-8B05-AEB647CE57CF}"/>
+              </a:ext>
+            </a:extLst>
+          </p:cNvPr>
+          <p:cNvSpPr>
+            <a:spLocks xmlns:a="http://schemas.openxmlformats.org/drawingml/2006/main" noGrp="1"/>
+          </p:cNvSpPr>
+          <p:nvPr/>
+        </p:nvSpPr>
+        <p:spPr>
+          <a:xfrm xmlns:a="http://schemas.openxmlformats.org/drawingml/2006/main">
+            <a:off x="952500" y="3276600"/>
+            <a:ext cx="2571750" cy="238125"/>
           </a:xfrm>
           <a:prstGeom xmlns:a="http://schemas.openxmlformats.org/drawingml/2006/main" prst="rect">
             <a:avLst/>
@@ -12731,7 +12766,7 @@
           <a:lstStyle xmlns:a="http://schemas.openxmlformats.org/drawingml/2006/main"/>
           <a:p xmlns:a="http://schemas.openxmlformats.org/drawingml/2006/main">
             <a:pPr algn="l">
-              <a:defRPr sz="1200" b="0">
+              <a:defRPr sz="1125" b="0">
                 <a:solidFill>
                   <a:srgbClr val="C2D6DD"/>
                 </a:solidFill>
@@ -12741,7 +12776,7 @@
               </a:defRPr>
             </a:pPr>
             <a:r>
-              <a:rPr sz="1200" b="0">
+              <a:rPr sz="1125" b="0">
                 <a:solidFill>
                   <a:srgbClr val="C2D6DD"/>
                 </a:solidFill>
@@ -12749,12 +12784,88 @@
                 <a:ea typeface="Aptos"/>
                 <a:cs typeface="Aptos"/>
               </a:rPr>
-              <a:t>Gemma 4 E2B</a:t>
-            </a:r>
-          </a:p>
+              <a:t>ROCm 7.2.53211</a:t>
+            </a:r>
+          </a:p>
+        </p:txBody>
+      </p:sp>
+      <p:sp>
+        <p:nvSpPr>
+          <p:cNvPr id="12" name="">
+            <a:extLst xmlns:a="http://schemas.openxmlformats.org/drawingml/2006/main">
+              <a:ext uri="{FF2B5EF4-FFF2-40B4-BE49-F238E27FC236}">
+                <a16:creationId xmlns:a16="http://schemas.microsoft.com/office/drawing/2014/main" id="{CCCA0BCB-EB46-4A59-8FF2-6B5E2797208D}"/>
+              </a:ext>
+            </a:extLst>
+          </p:cNvPr>
+          <p:cNvSpPr>
+            <a:spLocks xmlns:a="http://schemas.openxmlformats.org/drawingml/2006/main" noGrp="1"/>
+          </p:cNvSpPr>
+          <p:nvPr/>
+        </p:nvSpPr>
+        <p:spPr>
+          <a:xfrm xmlns:a="http://schemas.openxmlformats.org/drawingml/2006/main">
+            <a:off x="781050" y="3676650"/>
+            <a:ext cx="47625" cy="228600"/>
+          </a:xfrm>
+          <a:prstGeom xmlns:a="http://schemas.openxmlformats.org/drawingml/2006/main" prst="rect">
+            <a:avLst/>
+          </a:prstGeom>
+          <a:solidFill xmlns:a="http://schemas.openxmlformats.org/drawingml/2006/main">
+            <a:srgbClr val="1687C8"/>
+          </a:solidFill>
+          <a:ln xmlns:a="http://schemas.openxmlformats.org/drawingml/2006/main" w="0">
+            <a:solidFill>
+              <a:srgbClr val="000000">
+                <a:alpha val="0"/>
+              </a:srgbClr>
+            </a:solidFill>
+            <a:prstDash val="solid"/>
+          </a:ln>
+        </p:spPr>
+      </p:sp>
+      <p:sp>
+        <p:nvSpPr>
+          <p:cNvPr id="13" name="">
+            <a:extLst xmlns:a="http://schemas.openxmlformats.org/drawingml/2006/main">
+              <a:ext uri="{FF2B5EF4-FFF2-40B4-BE49-F238E27FC236}">
+                <a16:creationId xmlns:a16="http://schemas.microsoft.com/office/drawing/2014/main" id="{43B9FC53-5061-4022-9E2A-B43EFF3267AB}"/>
+              </a:ext>
+            </a:extLst>
+          </p:cNvPr>
+          <p:cNvSpPr>
+            <a:spLocks xmlns:a="http://schemas.openxmlformats.org/drawingml/2006/main" noGrp="1"/>
+          </p:cNvSpPr>
+          <p:nvPr/>
+        </p:nvSpPr>
+        <p:spPr>
+          <a:xfrm xmlns:a="http://schemas.openxmlformats.org/drawingml/2006/main">
+            <a:off x="952500" y="3676650"/>
+            <a:ext cx="2571750" cy="238125"/>
+          </a:xfrm>
+          <a:prstGeom xmlns:a="http://schemas.openxmlformats.org/drawingml/2006/main" prst="rect">
+            <a:avLst/>
+          </a:prstGeom>
+          <a:solidFill xmlns:a="http://schemas.openxmlformats.org/drawingml/2006/main">
+            <a:srgbClr val="000000">
+              <a:alpha val="0"/>
+            </a:srgbClr>
+          </a:solidFill>
+          <a:ln xmlns:a="http://schemas.openxmlformats.org/drawingml/2006/main" w="0">
+            <a:solidFill>
+              <a:srgbClr val="000000">
+                <a:alpha val="0"/>
+              </a:srgbClr>
+            </a:solidFill>
+            <a:prstDash val="solid"/>
+          </a:ln>
+        </p:spPr>
+        <p:txBody>
+          <a:bodyPr xmlns:a="http://schemas.openxmlformats.org/drawingml/2006/main" lIns="0" tIns="0" rIns="0" bIns="0" anchor="t"/>
+          <a:lstStyle xmlns:a="http://schemas.openxmlformats.org/drawingml/2006/main"/>
           <a:p xmlns:a="http://schemas.openxmlformats.org/drawingml/2006/main">
             <a:pPr algn="l">
-              <a:defRPr sz="1200" b="0">
+              <a:defRPr sz="1125" b="0">
                 <a:solidFill>
                   <a:srgbClr val="C2D6DD"/>
                 </a:solidFill>
@@ -12764,7 +12875,7 @@
               </a:defRPr>
             </a:pPr>
             <a:r>
-              <a:rPr sz="1200" b="0">
+              <a:rPr sz="1125" b="0">
                 <a:solidFill>
                   <a:srgbClr val="C2D6DD"/>
                 </a:solidFill>
@@ -12772,12 +12883,88 @@
                 <a:ea typeface="Aptos"/>
                 <a:cs typeface="Aptos"/>
               </a:rPr>
-              <a:t>llama.cpp QAT Q4</a:t>
-            </a:r>
-          </a:p>
+              <a:t>vLLM 0.20.2</a:t>
+            </a:r>
+          </a:p>
+        </p:txBody>
+      </p:sp>
+      <p:sp>
+        <p:nvSpPr>
+          <p:cNvPr id="14" name="">
+            <a:extLst xmlns:a="http://schemas.openxmlformats.org/drawingml/2006/main">
+              <a:ext uri="{FF2B5EF4-FFF2-40B4-BE49-F238E27FC236}">
+                <a16:creationId xmlns:a16="http://schemas.microsoft.com/office/drawing/2014/main" id="{6F6B72F3-4EEE-44A0-A1C3-D15495E5AE8D}"/>
+              </a:ext>
+            </a:extLst>
+          </p:cNvPr>
+          <p:cNvSpPr>
+            <a:spLocks xmlns:a="http://schemas.openxmlformats.org/drawingml/2006/main" noGrp="1"/>
+          </p:cNvSpPr>
+          <p:nvPr/>
+        </p:nvSpPr>
+        <p:spPr>
+          <a:xfrm xmlns:a="http://schemas.openxmlformats.org/drawingml/2006/main">
+            <a:off x="781050" y="4076700"/>
+            <a:ext cx="47625" cy="228600"/>
+          </a:xfrm>
+          <a:prstGeom xmlns:a="http://schemas.openxmlformats.org/drawingml/2006/main" prst="rect">
+            <a:avLst/>
+          </a:prstGeom>
+          <a:solidFill xmlns:a="http://schemas.openxmlformats.org/drawingml/2006/main">
+            <a:srgbClr val="1687C8"/>
+          </a:solidFill>
+          <a:ln xmlns:a="http://schemas.openxmlformats.org/drawingml/2006/main" w="0">
+            <a:solidFill>
+              <a:srgbClr val="000000">
+                <a:alpha val="0"/>
+              </a:srgbClr>
+            </a:solidFill>
+            <a:prstDash val="solid"/>
+          </a:ln>
+        </p:spPr>
+      </p:sp>
+      <p:sp>
+        <p:nvSpPr>
+          <p:cNvPr id="15" name="">
+            <a:extLst xmlns:a="http://schemas.openxmlformats.org/drawingml/2006/main">
+              <a:ext uri="{FF2B5EF4-FFF2-40B4-BE49-F238E27FC236}">
+                <a16:creationId xmlns:a16="http://schemas.microsoft.com/office/drawing/2014/main" id="{2B66DE89-F34E-4027-975F-BA85A1204312}"/>
+              </a:ext>
+            </a:extLst>
+          </p:cNvPr>
+          <p:cNvSpPr>
+            <a:spLocks xmlns:a="http://schemas.openxmlformats.org/drawingml/2006/main" noGrp="1"/>
+          </p:cNvSpPr>
+          <p:nvPr/>
+        </p:nvSpPr>
+        <p:spPr>
+          <a:xfrm xmlns:a="http://schemas.openxmlformats.org/drawingml/2006/main">
+            <a:off x="952500" y="4076700"/>
+            <a:ext cx="2571750" cy="238125"/>
+          </a:xfrm>
+          <a:prstGeom xmlns:a="http://schemas.openxmlformats.org/drawingml/2006/main" prst="rect">
+            <a:avLst/>
+          </a:prstGeom>
+          <a:solidFill xmlns:a="http://schemas.openxmlformats.org/drawingml/2006/main">
+            <a:srgbClr val="000000">
+              <a:alpha val="0"/>
+            </a:srgbClr>
+          </a:solidFill>
+          <a:ln xmlns:a="http://schemas.openxmlformats.org/drawingml/2006/main" w="0">
+            <a:solidFill>
+              <a:srgbClr val="000000">
+                <a:alpha val="0"/>
+              </a:srgbClr>
+            </a:solidFill>
+            <a:prstDash val="solid"/>
+          </a:ln>
+        </p:spPr>
+        <p:txBody>
+          <a:bodyPr xmlns:a="http://schemas.openxmlformats.org/drawingml/2006/main" lIns="0" tIns="0" rIns="0" bIns="0" anchor="t"/>
+          <a:lstStyle xmlns:a="http://schemas.openxmlformats.org/drawingml/2006/main"/>
           <a:p xmlns:a="http://schemas.openxmlformats.org/drawingml/2006/main">
             <a:pPr algn="l">
-              <a:defRPr sz="1200" b="0">
+              <a:defRPr sz="1125" b="0">
                 <a:solidFill>
                   <a:srgbClr val="C2D6DD"/>
                 </a:solidFill>
@@ -12787,7 +12974,7 @@
               </a:defRPr>
             </a:pPr>
             <a:r>
-              <a:rPr sz="1200" b="0">
+              <a:rPr sz="1125" b="0">
                 <a:solidFill>
                   <a:srgbClr val="C2D6DD"/>
                 </a:solidFill>
@@ -12795,12 +12982,249 @@
                 <a:ea typeface="Aptos"/>
                 <a:cs typeface="Aptos"/>
               </a:rPr>
-              <a:t>private 8 GB host</a:t>
-            </a:r>
-          </a:p>
+              <a:t>gfx1100 · 47.98 GiB</a:t>
+            </a:r>
+          </a:p>
+        </p:txBody>
+      </p:sp>
+      <p:sp>
+        <p:nvSpPr>
+          <p:cNvPr id="16" name="">
+            <a:extLst xmlns:a="http://schemas.openxmlformats.org/drawingml/2006/main">
+              <a:ext uri="{FF2B5EF4-FFF2-40B4-BE49-F238E27FC236}">
+                <a16:creationId xmlns:a16="http://schemas.microsoft.com/office/drawing/2014/main" id="{016534AB-A7C5-4C57-9ACF-34131E3D7F27}"/>
+              </a:ext>
+            </a:extLst>
+          </p:cNvPr>
+          <p:cNvSpPr>
+            <a:spLocks xmlns:a="http://schemas.openxmlformats.org/drawingml/2006/main" noGrp="1"/>
+          </p:cNvSpPr>
+          <p:nvPr/>
+        </p:nvSpPr>
+        <p:spPr>
+          <a:xfrm xmlns:a="http://schemas.openxmlformats.org/drawingml/2006/main">
+            <a:off x="4400550" y="2038350"/>
+            <a:ext cx="3048000" cy="228600"/>
+          </a:xfrm>
+          <a:prstGeom xmlns:a="http://schemas.openxmlformats.org/drawingml/2006/main" prst="rect">
+            <a:avLst/>
+          </a:prstGeom>
+          <a:solidFill xmlns:a="http://schemas.openxmlformats.org/drawingml/2006/main">
+            <a:srgbClr val="000000">
+              <a:alpha val="0"/>
+            </a:srgbClr>
+          </a:solidFill>
+          <a:ln xmlns:a="http://schemas.openxmlformats.org/drawingml/2006/main" w="0">
+            <a:solidFill>
+              <a:srgbClr val="000000">
+                <a:alpha val="0"/>
+              </a:srgbClr>
+            </a:solidFill>
+            <a:prstDash val="solid"/>
+          </a:ln>
+        </p:spPr>
+        <p:txBody>
+          <a:bodyPr xmlns:a="http://schemas.openxmlformats.org/drawingml/2006/main" lIns="0" tIns="0" rIns="0" bIns="0" anchor="t"/>
+          <a:lstStyle xmlns:a="http://schemas.openxmlformats.org/drawingml/2006/main"/>
           <a:p xmlns:a="http://schemas.openxmlformats.org/drawingml/2006/main">
             <a:pPr algn="l">
-              <a:defRPr sz="1200" b="0">
+              <a:defRPr sz="825" b="1">
+                <a:solidFill>
+                  <a:srgbClr val="18A999"/>
+                </a:solidFill>
+                <a:latin typeface="Aptos"/>
+                <a:ea typeface="Aptos"/>
+                <a:cs typeface="Aptos"/>
+              </a:defRPr>
+            </a:pPr>
+            <a:r>
+              <a:rPr sz="825" b="1">
+                <a:solidFill>
+                  <a:srgbClr val="18A999"/>
+                </a:solidFill>
+                <a:latin typeface="Aptos"/>
+                <a:ea typeface="Aptos"/>
+                <a:cs typeface="Aptos"/>
+              </a:rPr>
+              <a:t>SELECTED GEMMA RECOVERY</a:t>
+            </a:r>
+          </a:p>
+        </p:txBody>
+      </p:sp>
+      <p:sp>
+        <p:nvSpPr>
+          <p:cNvPr id="17" name="">
+            <a:extLst xmlns:a="http://schemas.openxmlformats.org/drawingml/2006/main">
+              <a:ext uri="{FF2B5EF4-FFF2-40B4-BE49-F238E27FC236}">
+                <a16:creationId xmlns:a16="http://schemas.microsoft.com/office/drawing/2014/main" id="{7FB460D1-4328-4BD8-9084-3E67377C643B}"/>
+              </a:ext>
+            </a:extLst>
+          </p:cNvPr>
+          <p:cNvSpPr>
+            <a:spLocks xmlns:a="http://schemas.openxmlformats.org/drawingml/2006/main" noGrp="1"/>
+          </p:cNvSpPr>
+          <p:nvPr/>
+        </p:nvSpPr>
+        <p:spPr>
+          <a:xfrm xmlns:a="http://schemas.openxmlformats.org/drawingml/2006/main">
+            <a:off x="4286250" y="2400300"/>
+            <a:ext cx="3333750" cy="2343150"/>
+          </a:xfrm>
+          <a:prstGeom xmlns:a="http://schemas.openxmlformats.org/drawingml/2006/main" prst="rect">
+            <a:avLst/>
+          </a:prstGeom>
+          <a:solidFill xmlns:a="http://schemas.openxmlformats.org/drawingml/2006/main">
+            <a:srgbClr val="173F50"/>
+          </a:solidFill>
+          <a:ln xmlns:a="http://schemas.openxmlformats.org/drawingml/2006/main" w="19050">
+            <a:solidFill>
+              <a:srgbClr val="18A999"/>
+            </a:solidFill>
+            <a:prstDash val="solid"/>
+          </a:ln>
+        </p:spPr>
+      </p:sp>
+      <p:sp>
+        <p:nvSpPr>
+          <p:cNvPr id="18" name="">
+            <a:extLst xmlns:a="http://schemas.openxmlformats.org/drawingml/2006/main">
+              <a:ext uri="{FF2B5EF4-FFF2-40B4-BE49-F238E27FC236}">
+                <a16:creationId xmlns:a16="http://schemas.microsoft.com/office/drawing/2014/main" id="{5DE5D8D8-A319-40CF-98E8-616E32AF23BF}"/>
+              </a:ext>
+            </a:extLst>
+          </p:cNvPr>
+          <p:cNvSpPr>
+            <a:spLocks xmlns:a="http://schemas.openxmlformats.org/drawingml/2006/main" noGrp="1"/>
+          </p:cNvSpPr>
+          <p:nvPr/>
+        </p:nvSpPr>
+        <p:spPr>
+          <a:xfrm xmlns:a="http://schemas.openxmlformats.org/drawingml/2006/main">
+            <a:off x="4552950" y="2647950"/>
+            <a:ext cx="2800350" cy="400050"/>
+          </a:xfrm>
+          <a:prstGeom xmlns:a="http://schemas.openxmlformats.org/drawingml/2006/main" prst="rect">
+            <a:avLst/>
+          </a:prstGeom>
+          <a:solidFill xmlns:a="http://schemas.openxmlformats.org/drawingml/2006/main">
+            <a:srgbClr val="000000">
+              <a:alpha val="0"/>
+            </a:srgbClr>
+          </a:solidFill>
+          <a:ln xmlns:a="http://schemas.openxmlformats.org/drawingml/2006/main" w="0">
+            <a:solidFill>
+              <a:srgbClr val="000000">
+                <a:alpha val="0"/>
+              </a:srgbClr>
+            </a:solidFill>
+            <a:prstDash val="solid"/>
+          </a:ln>
+        </p:spPr>
+        <p:txBody>
+          <a:bodyPr xmlns:a="http://schemas.openxmlformats.org/drawingml/2006/main" lIns="0" tIns="0" rIns="0" bIns="0" anchor="t"/>
+          <a:lstStyle xmlns:a="http://schemas.openxmlformats.org/drawingml/2006/main"/>
+          <a:p xmlns:a="http://schemas.openxmlformats.org/drawingml/2006/main">
+            <a:pPr algn="l">
+              <a:defRPr sz="1800" b="1">
+                <a:solidFill>
+                  <a:srgbClr val="FFFFFF"/>
+                </a:solidFill>
+                <a:latin typeface="Aptos"/>
+                <a:ea typeface="Aptos"/>
+                <a:cs typeface="Aptos"/>
+              </a:defRPr>
+            </a:pPr>
+            <a:r>
+              <a:rPr sz="1800" b="1">
+                <a:solidFill>
+                  <a:srgbClr val="FFFFFF"/>
+                </a:solidFill>
+                <a:latin typeface="Aptos"/>
+                <a:ea typeface="Aptos"/>
+                <a:cs typeface="Aptos"/>
+              </a:rPr>
+              <a:t>+69.3611 reward</a:t>
+            </a:r>
+          </a:p>
+        </p:txBody>
+      </p:sp>
+      <p:sp>
+        <p:nvSpPr>
+          <p:cNvPr id="19" name="">
+            <a:extLst xmlns:a="http://schemas.openxmlformats.org/drawingml/2006/main">
+              <a:ext uri="{FF2B5EF4-FFF2-40B4-BE49-F238E27FC236}">
+                <a16:creationId xmlns:a16="http://schemas.microsoft.com/office/drawing/2014/main" id="{20F6158B-21ED-49DC-975B-AB10D02269BF}"/>
+              </a:ext>
+            </a:extLst>
+          </p:cNvPr>
+          <p:cNvSpPr>
+            <a:spLocks xmlns:a="http://schemas.openxmlformats.org/drawingml/2006/main" noGrp="1"/>
+          </p:cNvSpPr>
+          <p:nvPr/>
+        </p:nvSpPr>
+        <p:spPr>
+          <a:xfrm xmlns:a="http://schemas.openxmlformats.org/drawingml/2006/main">
+            <a:off x="4572000" y="3276600"/>
+            <a:ext cx="47625" cy="228600"/>
+          </a:xfrm>
+          <a:prstGeom xmlns:a="http://schemas.openxmlformats.org/drawingml/2006/main" prst="rect">
+            <a:avLst/>
+          </a:prstGeom>
+          <a:solidFill xmlns:a="http://schemas.openxmlformats.org/drawingml/2006/main">
+            <a:srgbClr val="18A999"/>
+          </a:solidFill>
+          <a:ln xmlns:a="http://schemas.openxmlformats.org/drawingml/2006/main" w="0">
+            <a:solidFill>
+              <a:srgbClr val="000000">
+                <a:alpha val="0"/>
+              </a:srgbClr>
+            </a:solidFill>
+            <a:prstDash val="solid"/>
+          </a:ln>
+        </p:spPr>
+      </p:sp>
+      <p:sp>
+        <p:nvSpPr>
+          <p:cNvPr id="20" name="">
+            <a:extLst xmlns:a="http://schemas.openxmlformats.org/drawingml/2006/main">
+              <a:ext uri="{FF2B5EF4-FFF2-40B4-BE49-F238E27FC236}">
+                <a16:creationId xmlns:a16="http://schemas.microsoft.com/office/drawing/2014/main" id="{EE2A5C74-D782-4C2F-8BF8-17532B512DAF}"/>
+              </a:ext>
+            </a:extLst>
+          </p:cNvPr>
+          <p:cNvSpPr>
+            <a:spLocks xmlns:a="http://schemas.openxmlformats.org/drawingml/2006/main" noGrp="1"/>
+          </p:cNvSpPr>
+          <p:nvPr/>
+        </p:nvSpPr>
+        <p:spPr>
+          <a:xfrm xmlns:a="http://schemas.openxmlformats.org/drawingml/2006/main">
+            <a:off x="4743450" y="3276600"/>
+            <a:ext cx="2571750" cy="238125"/>
+          </a:xfrm>
+          <a:prstGeom xmlns:a="http://schemas.openxmlformats.org/drawingml/2006/main" prst="rect">
+            <a:avLst/>
+          </a:prstGeom>
+          <a:solidFill xmlns:a="http://schemas.openxmlformats.org/drawingml/2006/main">
+            <a:srgbClr val="000000">
+              <a:alpha val="0"/>
+            </a:srgbClr>
+          </a:solidFill>
+          <a:ln xmlns:a="http://schemas.openxmlformats.org/drawingml/2006/main" w="0">
+            <a:solidFill>
+              <a:srgbClr val="000000">
+                <a:alpha val="0"/>
+              </a:srgbClr>
+            </a:solidFill>
+            <a:prstDash val="solid"/>
+          </a:ln>
+        </p:spPr>
+        <p:txBody>
+          <a:bodyPr xmlns:a="http://schemas.openxmlformats.org/drawingml/2006/main" lIns="0" tIns="0" rIns="0" bIns="0" anchor="t"/>
+          <a:lstStyle xmlns:a="http://schemas.openxmlformats.org/drawingml/2006/main"/>
+          <a:p xmlns:a="http://schemas.openxmlformats.org/drawingml/2006/main">
+            <a:pPr algn="l">
+              <a:defRPr sz="1125" b="0">
                 <a:solidFill>
                   <a:srgbClr val="C2D6DD"/>
                 </a:solidFill>
@@ -12810,7 +13234,7 @@
               </a:defRPr>
             </a:pPr>
             <a:r>
-              <a:rPr sz="1200" b="0">
+              <a:rPr sz="1125" b="0">
                 <a:solidFill>
                   <a:srgbClr val="C2D6DD"/>
                 </a:solidFill>
@@ -12818,62 +13242,685 @@
                 <a:ea typeface="Aptos"/>
                 <a:cs typeface="Aptos"/>
               </a:rPr>
-              <a:t>separate Metal evidence</a:t>
-            </a:r>
-          </a:p>
-        </p:txBody>
-      </p:sp>
-      <p:sp>
-        <p:nvSpPr>
-          <p:cNvPr id="11" name="">
-            <a:extLst xmlns:a="http://schemas.openxmlformats.org/drawingml/2006/main">
-              <a:ext uri="{FF2B5EF4-FFF2-40B4-BE49-F238E27FC236}">
-                <a16:creationId xmlns:a16="http://schemas.microsoft.com/office/drawing/2014/main" id="{68F51351-AED0-4997-9ED8-526287A47F2C}"/>
-              </a:ext>
-            </a:extLst>
-          </p:cNvPr>
-          <p:cNvSpPr>
-            <a:spLocks xmlns:a="http://schemas.openxmlformats.org/drawingml/2006/main" noGrp="1"/>
-          </p:cNvSpPr>
-          <p:nvPr/>
-        </p:nvSpPr>
-        <p:spPr>
-          <a:xfrm xmlns:a="http://schemas.openxmlformats.org/drawingml/2006/main">
-            <a:off x="4457700" y="2781300"/>
-            <a:ext cx="3143250" cy="1333500"/>
-          </a:xfrm>
-          <a:prstGeom xmlns:a="http://schemas.openxmlformats.org/drawingml/2006/main" prst="rect">
-            <a:avLst/>
-          </a:prstGeom>
-          <a:solidFill xmlns:a="http://schemas.openxmlformats.org/drawingml/2006/main">
-            <a:srgbClr val="E2F3FB"/>
+              <a:t>ammonia 2.4 → 0.85</a:t>
+            </a:r>
+          </a:p>
+        </p:txBody>
+      </p:sp>
+      <p:sp>
+        <p:nvSpPr>
+          <p:cNvPr id="21" name="">
+            <a:extLst xmlns:a="http://schemas.openxmlformats.org/drawingml/2006/main">
+              <a:ext uri="{FF2B5EF4-FFF2-40B4-BE49-F238E27FC236}">
+                <a16:creationId xmlns:a16="http://schemas.microsoft.com/office/drawing/2014/main" id="{41C46322-F39C-4B42-9F55-50DADABC6B40}"/>
+              </a:ext>
+            </a:extLst>
+          </p:cNvPr>
+          <p:cNvSpPr>
+            <a:spLocks xmlns:a="http://schemas.openxmlformats.org/drawingml/2006/main" noGrp="1"/>
+          </p:cNvSpPr>
+          <p:nvPr/>
+        </p:nvSpPr>
+        <p:spPr>
+          <a:xfrm xmlns:a="http://schemas.openxmlformats.org/drawingml/2006/main">
+            <a:off x="4572000" y="3676650"/>
+            <a:ext cx="47625" cy="228600"/>
+          </a:xfrm>
+          <a:prstGeom xmlns:a="http://schemas.openxmlformats.org/drawingml/2006/main" prst="rect">
+            <a:avLst/>
+          </a:prstGeom>
+          <a:solidFill xmlns:a="http://schemas.openxmlformats.org/drawingml/2006/main">
+            <a:srgbClr val="18A999"/>
+          </a:solidFill>
+          <a:ln xmlns:a="http://schemas.openxmlformats.org/drawingml/2006/main" w="0">
+            <a:solidFill>
+              <a:srgbClr val="000000">
+                <a:alpha val="0"/>
+              </a:srgbClr>
+            </a:solidFill>
+            <a:prstDash val="solid"/>
+          </a:ln>
+        </p:spPr>
+      </p:sp>
+      <p:sp>
+        <p:nvSpPr>
+          <p:cNvPr id="22" name="">
+            <a:extLst xmlns:a="http://schemas.openxmlformats.org/drawingml/2006/main">
+              <a:ext uri="{FF2B5EF4-FFF2-40B4-BE49-F238E27FC236}">
+                <a16:creationId xmlns:a16="http://schemas.microsoft.com/office/drawing/2014/main" id="{AA4D2401-1CD1-45D3-88B1-1E68468E8919}"/>
+              </a:ext>
+            </a:extLst>
+          </p:cNvPr>
+          <p:cNvSpPr>
+            <a:spLocks xmlns:a="http://schemas.openxmlformats.org/drawingml/2006/main" noGrp="1"/>
+          </p:cNvSpPr>
+          <p:nvPr/>
+        </p:nvSpPr>
+        <p:spPr>
+          <a:xfrm xmlns:a="http://schemas.openxmlformats.org/drawingml/2006/main">
+            <a:off x="4743450" y="3676650"/>
+            <a:ext cx="2571750" cy="238125"/>
+          </a:xfrm>
+          <a:prstGeom xmlns:a="http://schemas.openxmlformats.org/drawingml/2006/main" prst="rect">
+            <a:avLst/>
+          </a:prstGeom>
+          <a:solidFill xmlns:a="http://schemas.openxmlformats.org/drawingml/2006/main">
+            <a:srgbClr val="000000">
+              <a:alpha val="0"/>
+            </a:srgbClr>
+          </a:solidFill>
+          <a:ln xmlns:a="http://schemas.openxmlformats.org/drawingml/2006/main" w="0">
+            <a:solidFill>
+              <a:srgbClr val="000000">
+                <a:alpha val="0"/>
+              </a:srgbClr>
+            </a:solidFill>
+            <a:prstDash val="solid"/>
+          </a:ln>
+        </p:spPr>
+        <p:txBody>
+          <a:bodyPr xmlns:a="http://schemas.openxmlformats.org/drawingml/2006/main" lIns="0" tIns="0" rIns="0" bIns="0" anchor="t"/>
+          <a:lstStyle xmlns:a="http://schemas.openxmlformats.org/drawingml/2006/main"/>
+          <a:p xmlns:a="http://schemas.openxmlformats.org/drawingml/2006/main">
+            <a:pPr algn="l">
+              <a:defRPr sz="1125" b="0">
+                <a:solidFill>
+                  <a:srgbClr val="C2D6DD"/>
+                </a:solidFill>
+                <a:latin typeface="Aptos"/>
+                <a:ea typeface="Aptos"/>
+                <a:cs typeface="Aptos"/>
+              </a:defRPr>
+            </a:pPr>
+            <a:r>
+              <a:rPr sz="1125" b="0">
+                <a:solidFill>
+                  <a:srgbClr val="C2D6DD"/>
+                </a:solidFill>
+                <a:latin typeface="Aptos"/>
+                <a:ea typeface="Aptos"/>
+                <a:cs typeface="Aptos"/>
+              </a:rPr>
+              <a:t>oxygen 4.8 → 5.5058</a:t>
+            </a:r>
+          </a:p>
+        </p:txBody>
+      </p:sp>
+      <p:sp>
+        <p:nvSpPr>
+          <p:cNvPr id="23" name="">
+            <a:extLst xmlns:a="http://schemas.openxmlformats.org/drawingml/2006/main">
+              <a:ext uri="{FF2B5EF4-FFF2-40B4-BE49-F238E27FC236}">
+                <a16:creationId xmlns:a16="http://schemas.microsoft.com/office/drawing/2014/main" id="{389FA391-DFA5-4BE2-B625-B15578DC2497}"/>
+              </a:ext>
+            </a:extLst>
+          </p:cNvPr>
+          <p:cNvSpPr>
+            <a:spLocks xmlns:a="http://schemas.openxmlformats.org/drawingml/2006/main" noGrp="1"/>
+          </p:cNvSpPr>
+          <p:nvPr/>
+        </p:nvSpPr>
+        <p:spPr>
+          <a:xfrm xmlns:a="http://schemas.openxmlformats.org/drawingml/2006/main">
+            <a:off x="4572000" y="4076700"/>
+            <a:ext cx="47625" cy="228600"/>
+          </a:xfrm>
+          <a:prstGeom xmlns:a="http://schemas.openxmlformats.org/drawingml/2006/main" prst="rect">
+            <a:avLst/>
+          </a:prstGeom>
+          <a:solidFill xmlns:a="http://schemas.openxmlformats.org/drawingml/2006/main">
+            <a:srgbClr val="18A999"/>
+          </a:solidFill>
+          <a:ln xmlns:a="http://schemas.openxmlformats.org/drawingml/2006/main" w="0">
+            <a:solidFill>
+              <a:srgbClr val="000000">
+                <a:alpha val="0"/>
+              </a:srgbClr>
+            </a:solidFill>
+            <a:prstDash val="solid"/>
+          </a:ln>
+        </p:spPr>
+      </p:sp>
+      <p:sp>
+        <p:nvSpPr>
+          <p:cNvPr id="24" name="">
+            <a:extLst xmlns:a="http://schemas.openxmlformats.org/drawingml/2006/main">
+              <a:ext uri="{FF2B5EF4-FFF2-40B4-BE49-F238E27FC236}">
+                <a16:creationId xmlns:a16="http://schemas.microsoft.com/office/drawing/2014/main" id="{AF198EB4-40F1-499E-92C8-F2B79FE763FB}"/>
+              </a:ext>
+            </a:extLst>
+          </p:cNvPr>
+          <p:cNvSpPr>
+            <a:spLocks xmlns:a="http://schemas.openxmlformats.org/drawingml/2006/main" noGrp="1"/>
+          </p:cNvSpPr>
+          <p:nvPr/>
+        </p:nvSpPr>
+        <p:spPr>
+          <a:xfrm xmlns:a="http://schemas.openxmlformats.org/drawingml/2006/main">
+            <a:off x="4743450" y="4076700"/>
+            <a:ext cx="2571750" cy="238125"/>
+          </a:xfrm>
+          <a:prstGeom xmlns:a="http://schemas.openxmlformats.org/drawingml/2006/main" prst="rect">
+            <a:avLst/>
+          </a:prstGeom>
+          <a:solidFill xmlns:a="http://schemas.openxmlformats.org/drawingml/2006/main">
+            <a:srgbClr val="000000">
+              <a:alpha val="0"/>
+            </a:srgbClr>
+          </a:solidFill>
+          <a:ln xmlns:a="http://schemas.openxmlformats.org/drawingml/2006/main" w="0">
+            <a:solidFill>
+              <a:srgbClr val="000000">
+                <a:alpha val="0"/>
+              </a:srgbClr>
+            </a:solidFill>
+            <a:prstDash val="solid"/>
+          </a:ln>
+        </p:spPr>
+        <p:txBody>
+          <a:bodyPr xmlns:a="http://schemas.openxmlformats.org/drawingml/2006/main" lIns="0" tIns="0" rIns="0" bIns="0" anchor="t"/>
+          <a:lstStyle xmlns:a="http://schemas.openxmlformats.org/drawingml/2006/main"/>
+          <a:p xmlns:a="http://schemas.openxmlformats.org/drawingml/2006/main">
+            <a:pPr algn="l">
+              <a:defRPr sz="1125" b="0">
+                <a:solidFill>
+                  <a:srgbClr val="C2D6DD"/>
+                </a:solidFill>
+                <a:latin typeface="Aptos"/>
+                <a:ea typeface="Aptos"/>
+                <a:cs typeface="Aptos"/>
+              </a:defRPr>
+            </a:pPr>
+            <a:r>
+              <a:rPr sz="1125" b="0">
+                <a:solidFill>
+                  <a:srgbClr val="C2D6DD"/>
+                </a:solidFill>
+                <a:latin typeface="Aptos"/>
+                <a:ea typeface="Aptos"/>
+                <a:cs typeface="Aptos"/>
+              </a:rPr>
+              <a:t>unsafe control rejected</a:t>
+            </a:r>
+          </a:p>
+        </p:txBody>
+      </p:sp>
+      <p:sp>
+        <p:nvSpPr>
+          <p:cNvPr id="25" name="">
+            <a:extLst xmlns:a="http://schemas.openxmlformats.org/drawingml/2006/main">
+              <a:ext uri="{FF2B5EF4-FFF2-40B4-BE49-F238E27FC236}">
+                <a16:creationId xmlns:a16="http://schemas.microsoft.com/office/drawing/2014/main" id="{4E508757-C820-4E15-8725-68D10DC006F1}"/>
+              </a:ext>
+            </a:extLst>
+          </p:cNvPr>
+          <p:cNvSpPr>
+            <a:spLocks xmlns:a="http://schemas.openxmlformats.org/drawingml/2006/main" noGrp="1"/>
+          </p:cNvSpPr>
+          <p:nvPr/>
+        </p:nvSpPr>
+        <p:spPr>
+          <a:xfrm xmlns:a="http://schemas.openxmlformats.org/drawingml/2006/main">
+            <a:off x="8191500" y="2038350"/>
+            <a:ext cx="3048000" cy="228600"/>
+          </a:xfrm>
+          <a:prstGeom xmlns:a="http://schemas.openxmlformats.org/drawingml/2006/main" prst="rect">
+            <a:avLst/>
+          </a:prstGeom>
+          <a:solidFill xmlns:a="http://schemas.openxmlformats.org/drawingml/2006/main">
+            <a:srgbClr val="000000">
+              <a:alpha val="0"/>
+            </a:srgbClr>
+          </a:solidFill>
+          <a:ln xmlns:a="http://schemas.openxmlformats.org/drawingml/2006/main" w="0">
+            <a:solidFill>
+              <a:srgbClr val="000000">
+                <a:alpha val="0"/>
+              </a:srgbClr>
+            </a:solidFill>
+            <a:prstDash val="solid"/>
+          </a:ln>
+        </p:spPr>
+        <p:txBody>
+          <a:bodyPr xmlns:a="http://schemas.openxmlformats.org/drawingml/2006/main" lIns="0" tIns="0" rIns="0" bIns="0" anchor="t"/>
+          <a:lstStyle xmlns:a="http://schemas.openxmlformats.org/drawingml/2006/main"/>
+          <a:p xmlns:a="http://schemas.openxmlformats.org/drawingml/2006/main">
+            <a:pPr algn="l">
+              <a:defRPr sz="825" b="1">
+                <a:solidFill>
+                  <a:srgbClr val="EF6C21"/>
+                </a:solidFill>
+                <a:latin typeface="Aptos"/>
+                <a:ea typeface="Aptos"/>
+                <a:cs typeface="Aptos"/>
+              </a:defRPr>
+            </a:pPr>
+            <a:r>
+              <a:rPr sz="825" b="1">
+                <a:solidFill>
+                  <a:srgbClr val="EF6C21"/>
+                </a:solidFill>
+                <a:latin typeface="Aptos"/>
+                <a:ea typeface="Aptos"/>
+                <a:cs typeface="Aptos"/>
+              </a:rPr>
+              <a:t>5-EMERGENCY AUDIT</a:t>
+            </a:r>
+          </a:p>
+        </p:txBody>
+      </p:sp>
+      <p:sp>
+        <p:nvSpPr>
+          <p:cNvPr id="26" name="">
+            <a:extLst xmlns:a="http://schemas.openxmlformats.org/drawingml/2006/main">
+              <a:ext uri="{FF2B5EF4-FFF2-40B4-BE49-F238E27FC236}">
+                <a16:creationId xmlns:a16="http://schemas.microsoft.com/office/drawing/2014/main" id="{ABE3A4F8-42DB-4194-9CE8-21D4399B9470}"/>
+              </a:ext>
+            </a:extLst>
+          </p:cNvPr>
+          <p:cNvSpPr>
+            <a:spLocks xmlns:a="http://schemas.openxmlformats.org/drawingml/2006/main" noGrp="1"/>
+          </p:cNvSpPr>
+          <p:nvPr/>
+        </p:nvSpPr>
+        <p:spPr>
+          <a:xfrm xmlns:a="http://schemas.openxmlformats.org/drawingml/2006/main">
+            <a:off x="8077200" y="2400300"/>
+            <a:ext cx="3333750" cy="2343150"/>
+          </a:xfrm>
+          <a:prstGeom xmlns:a="http://schemas.openxmlformats.org/drawingml/2006/main" prst="rect">
+            <a:avLst/>
+          </a:prstGeom>
+          <a:solidFill xmlns:a="http://schemas.openxmlformats.org/drawingml/2006/main">
+            <a:srgbClr val="173F50"/>
           </a:solidFill>
           <a:ln xmlns:a="http://schemas.openxmlformats.org/drawingml/2006/main" w="19050">
             <a:solidFill>
-              <a:srgbClr val="1687C8"/>
-            </a:solidFill>
-            <a:prstDash val="solid"/>
-          </a:ln>
-        </p:spPr>
-      </p:sp>
-      <p:sp>
-        <p:nvSpPr>
-          <p:cNvPr id="12" name="">
-            <a:extLst xmlns:a="http://schemas.openxmlformats.org/drawingml/2006/main">
-              <a:ext uri="{FF2B5EF4-FFF2-40B4-BE49-F238E27FC236}">
-                <a16:creationId xmlns:a16="http://schemas.microsoft.com/office/drawing/2014/main" id="{AEF5AFDD-00BC-481B-B943-4609AB4BF454}"/>
-              </a:ext>
-            </a:extLst>
-          </p:cNvPr>
-          <p:cNvSpPr>
-            <a:spLocks xmlns:a="http://schemas.openxmlformats.org/drawingml/2006/main" noGrp="1"/>
-          </p:cNvSpPr>
-          <p:nvPr/>
-        </p:nvSpPr>
-        <p:spPr>
-          <a:xfrm xmlns:a="http://schemas.openxmlformats.org/drawingml/2006/main">
-            <a:off x="4743450" y="2990850"/>
-            <a:ext cx="2571750" cy="323850"/>
+              <a:srgbClr val="EF6C21"/>
+            </a:solidFill>
+            <a:prstDash val="solid"/>
+          </a:ln>
+        </p:spPr>
+      </p:sp>
+      <p:sp>
+        <p:nvSpPr>
+          <p:cNvPr id="27" name="">
+            <a:extLst xmlns:a="http://schemas.openxmlformats.org/drawingml/2006/main">
+              <a:ext uri="{FF2B5EF4-FFF2-40B4-BE49-F238E27FC236}">
+                <a16:creationId xmlns:a16="http://schemas.microsoft.com/office/drawing/2014/main" id="{28F7462E-6905-4257-8E04-62C9BED05112}"/>
+              </a:ext>
+            </a:extLst>
+          </p:cNvPr>
+          <p:cNvSpPr>
+            <a:spLocks xmlns:a="http://schemas.openxmlformats.org/drawingml/2006/main" noGrp="1"/>
+          </p:cNvSpPr>
+          <p:nvPr/>
+        </p:nvSpPr>
+        <p:spPr>
+          <a:xfrm xmlns:a="http://schemas.openxmlformats.org/drawingml/2006/main">
+            <a:off x="8343900" y="2647950"/>
+            <a:ext cx="2800350" cy="400050"/>
+          </a:xfrm>
+          <a:prstGeom xmlns:a="http://schemas.openxmlformats.org/drawingml/2006/main" prst="rect">
+            <a:avLst/>
+          </a:prstGeom>
+          <a:solidFill xmlns:a="http://schemas.openxmlformats.org/drawingml/2006/main">
+            <a:srgbClr val="000000">
+              <a:alpha val="0"/>
+            </a:srgbClr>
+          </a:solidFill>
+          <a:ln xmlns:a="http://schemas.openxmlformats.org/drawingml/2006/main" w="0">
+            <a:solidFill>
+              <a:srgbClr val="000000">
+                <a:alpha val="0"/>
+              </a:srgbClr>
+            </a:solidFill>
+            <a:prstDash val="solid"/>
+          </a:ln>
+        </p:spPr>
+        <p:txBody>
+          <a:bodyPr xmlns:a="http://schemas.openxmlformats.org/drawingml/2006/main" lIns="0" tIns="0" rIns="0" bIns="0" anchor="t"/>
+          <a:lstStyle xmlns:a="http://schemas.openxmlformats.org/drawingml/2006/main"/>
+          <a:p xmlns:a="http://schemas.openxmlformats.org/drawingml/2006/main">
+            <a:pPr algn="l">
+              <a:defRPr sz="1800" b="1">
+                <a:solidFill>
+                  <a:srgbClr val="FFFFFF"/>
+                </a:solidFill>
+                <a:latin typeface="Aptos"/>
+                <a:ea typeface="Aptos"/>
+                <a:cs typeface="Aptos"/>
+              </a:defRPr>
+            </a:pPr>
+            <a:r>
+              <a:rPr sz="1800" b="1">
+                <a:solidFill>
+                  <a:srgbClr val="FFFFFF"/>
+                </a:solidFill>
+                <a:latin typeface="Aptos"/>
+                <a:ea typeface="Aptos"/>
+                <a:cs typeface="Aptos"/>
+              </a:rPr>
+              <a:t>20% → 100% safe</a:t>
+            </a:r>
+          </a:p>
+        </p:txBody>
+      </p:sp>
+      <p:sp>
+        <p:nvSpPr>
+          <p:cNvPr id="28" name="">
+            <a:extLst xmlns:a="http://schemas.openxmlformats.org/drawingml/2006/main">
+              <a:ext uri="{FF2B5EF4-FFF2-40B4-BE49-F238E27FC236}">
+                <a16:creationId xmlns:a16="http://schemas.microsoft.com/office/drawing/2014/main" id="{313FB59C-0271-4476-90C9-2D77995575CC}"/>
+              </a:ext>
+            </a:extLst>
+          </p:cNvPr>
+          <p:cNvSpPr>
+            <a:spLocks xmlns:a="http://schemas.openxmlformats.org/drawingml/2006/main" noGrp="1"/>
+          </p:cNvSpPr>
+          <p:nvPr/>
+        </p:nvSpPr>
+        <p:spPr>
+          <a:xfrm xmlns:a="http://schemas.openxmlformats.org/drawingml/2006/main">
+            <a:off x="8362950" y="3276600"/>
+            <a:ext cx="47625" cy="228600"/>
+          </a:xfrm>
+          <a:prstGeom xmlns:a="http://schemas.openxmlformats.org/drawingml/2006/main" prst="rect">
+            <a:avLst/>
+          </a:prstGeom>
+          <a:solidFill xmlns:a="http://schemas.openxmlformats.org/drawingml/2006/main">
+            <a:srgbClr val="EF6C21"/>
+          </a:solidFill>
+          <a:ln xmlns:a="http://schemas.openxmlformats.org/drawingml/2006/main" w="0">
+            <a:solidFill>
+              <a:srgbClr val="000000">
+                <a:alpha val="0"/>
+              </a:srgbClr>
+            </a:solidFill>
+            <a:prstDash val="solid"/>
+          </a:ln>
+        </p:spPr>
+      </p:sp>
+      <p:sp>
+        <p:nvSpPr>
+          <p:cNvPr id="29" name="">
+            <a:extLst xmlns:a="http://schemas.openxmlformats.org/drawingml/2006/main">
+              <a:ext uri="{FF2B5EF4-FFF2-40B4-BE49-F238E27FC236}">
+                <a16:creationId xmlns:a16="http://schemas.microsoft.com/office/drawing/2014/main" id="{89EB0DF6-E88C-4921-8057-4D8DFFE8BF52}"/>
+              </a:ext>
+            </a:extLst>
+          </p:cNvPr>
+          <p:cNvSpPr>
+            <a:spLocks xmlns:a="http://schemas.openxmlformats.org/drawingml/2006/main" noGrp="1"/>
+          </p:cNvSpPr>
+          <p:nvPr/>
+        </p:nvSpPr>
+        <p:spPr>
+          <a:xfrm xmlns:a="http://schemas.openxmlformats.org/drawingml/2006/main">
+            <a:off x="8534400" y="3276600"/>
+            <a:ext cx="2571750" cy="238125"/>
+          </a:xfrm>
+          <a:prstGeom xmlns:a="http://schemas.openxmlformats.org/drawingml/2006/main" prst="rect">
+            <a:avLst/>
+          </a:prstGeom>
+          <a:solidFill xmlns:a="http://schemas.openxmlformats.org/drawingml/2006/main">
+            <a:srgbClr val="000000">
+              <a:alpha val="0"/>
+            </a:srgbClr>
+          </a:solidFill>
+          <a:ln xmlns:a="http://schemas.openxmlformats.org/drawingml/2006/main" w="0">
+            <a:solidFill>
+              <a:srgbClr val="000000">
+                <a:alpha val="0"/>
+              </a:srgbClr>
+            </a:solidFill>
+            <a:prstDash val="solid"/>
+          </a:ln>
+        </p:spPr>
+        <p:txBody>
+          <a:bodyPr xmlns:a="http://schemas.openxmlformats.org/drawingml/2006/main" lIns="0" tIns="0" rIns="0" bIns="0" anchor="t"/>
+          <a:lstStyle xmlns:a="http://schemas.openxmlformats.org/drawingml/2006/main"/>
+          <a:p xmlns:a="http://schemas.openxmlformats.org/drawingml/2006/main">
+            <a:pPr algn="l">
+              <a:defRPr sz="1125" b="0">
+                <a:solidFill>
+                  <a:srgbClr val="C2D6DD"/>
+                </a:solidFill>
+                <a:latin typeface="Aptos"/>
+                <a:ea typeface="Aptos"/>
+                <a:cs typeface="Aptos"/>
+              </a:defRPr>
+            </a:pPr>
+            <a:r>
+              <a:rPr sz="1125" b="0">
+                <a:solidFill>
+                  <a:srgbClr val="C2D6DD"/>
+                </a:solidFill>
+                <a:latin typeface="Aptos"/>
+                <a:ea typeface="Aptos"/>
+                <a:cs typeface="Aptos"/>
+              </a:rPr>
+              <a:t>30 Gemma plans tested</a:t>
+            </a:r>
+          </a:p>
+        </p:txBody>
+      </p:sp>
+      <p:sp>
+        <p:nvSpPr>
+          <p:cNvPr id="30" name="">
+            <a:extLst xmlns:a="http://schemas.openxmlformats.org/drawingml/2006/main">
+              <a:ext uri="{FF2B5EF4-FFF2-40B4-BE49-F238E27FC236}">
+                <a16:creationId xmlns:a16="http://schemas.microsoft.com/office/drawing/2014/main" id="{C09104F9-2EB0-4FF8-8701-2F17AF1D9044}"/>
+              </a:ext>
+            </a:extLst>
+          </p:cNvPr>
+          <p:cNvSpPr>
+            <a:spLocks xmlns:a="http://schemas.openxmlformats.org/drawingml/2006/main" noGrp="1"/>
+          </p:cNvSpPr>
+          <p:nvPr/>
+        </p:nvSpPr>
+        <p:spPr>
+          <a:xfrm xmlns:a="http://schemas.openxmlformats.org/drawingml/2006/main">
+            <a:off x="8362950" y="3676650"/>
+            <a:ext cx="47625" cy="228600"/>
+          </a:xfrm>
+          <a:prstGeom xmlns:a="http://schemas.openxmlformats.org/drawingml/2006/main" prst="rect">
+            <a:avLst/>
+          </a:prstGeom>
+          <a:solidFill xmlns:a="http://schemas.openxmlformats.org/drawingml/2006/main">
+            <a:srgbClr val="EF6C21"/>
+          </a:solidFill>
+          <a:ln xmlns:a="http://schemas.openxmlformats.org/drawingml/2006/main" w="0">
+            <a:solidFill>
+              <a:srgbClr val="000000">
+                <a:alpha val="0"/>
+              </a:srgbClr>
+            </a:solidFill>
+            <a:prstDash val="solid"/>
+          </a:ln>
+        </p:spPr>
+      </p:sp>
+      <p:sp>
+        <p:nvSpPr>
+          <p:cNvPr id="31" name="">
+            <a:extLst xmlns:a="http://schemas.openxmlformats.org/drawingml/2006/main">
+              <a:ext uri="{FF2B5EF4-FFF2-40B4-BE49-F238E27FC236}">
+                <a16:creationId xmlns:a16="http://schemas.microsoft.com/office/drawing/2014/main" id="{C95FB29C-AA27-4194-84D5-CDB58E18E7B3}"/>
+              </a:ext>
+            </a:extLst>
+          </p:cNvPr>
+          <p:cNvSpPr>
+            <a:spLocks xmlns:a="http://schemas.openxmlformats.org/drawingml/2006/main" noGrp="1"/>
+          </p:cNvSpPr>
+          <p:nvPr/>
+        </p:nvSpPr>
+        <p:spPr>
+          <a:xfrm xmlns:a="http://schemas.openxmlformats.org/drawingml/2006/main">
+            <a:off x="8534400" y="3676650"/>
+            <a:ext cx="2571750" cy="238125"/>
+          </a:xfrm>
+          <a:prstGeom xmlns:a="http://schemas.openxmlformats.org/drawingml/2006/main" prst="rect">
+            <a:avLst/>
+          </a:prstGeom>
+          <a:solidFill xmlns:a="http://schemas.openxmlformats.org/drawingml/2006/main">
+            <a:srgbClr val="000000">
+              <a:alpha val="0"/>
+            </a:srgbClr>
+          </a:solidFill>
+          <a:ln xmlns:a="http://schemas.openxmlformats.org/drawingml/2006/main" w="0">
+            <a:solidFill>
+              <a:srgbClr val="000000">
+                <a:alpha val="0"/>
+              </a:srgbClr>
+            </a:solidFill>
+            <a:prstDash val="solid"/>
+          </a:ln>
+        </p:spPr>
+        <p:txBody>
+          <a:bodyPr xmlns:a="http://schemas.openxmlformats.org/drawingml/2006/main" lIns="0" tIns="0" rIns="0" bIns="0" anchor="t"/>
+          <a:lstStyle xmlns:a="http://schemas.openxmlformats.org/drawingml/2006/main"/>
+          <a:p xmlns:a="http://schemas.openxmlformats.org/drawingml/2006/main">
+            <a:pPr algn="l">
+              <a:defRPr sz="1125" b="0">
+                <a:solidFill>
+                  <a:srgbClr val="C2D6DD"/>
+                </a:solidFill>
+                <a:latin typeface="Aptos"/>
+                <a:ea typeface="Aptos"/>
+                <a:cs typeface="Aptos"/>
+              </a:defRPr>
+            </a:pPr>
+            <a:r>
+              <a:rPr sz="1125" b="0">
+                <a:solidFill>
+                  <a:srgbClr val="C2D6DD"/>
+                </a:solidFill>
+                <a:latin typeface="Aptos"/>
+                <a:ea typeface="Aptos"/>
+                <a:cs typeface="Aptos"/>
+              </a:rPr>
+              <a:t>4 first-answer rescues</a:t>
+            </a:r>
+          </a:p>
+        </p:txBody>
+      </p:sp>
+      <p:sp>
+        <p:nvSpPr>
+          <p:cNvPr id="32" name="">
+            <a:extLst xmlns:a="http://schemas.openxmlformats.org/drawingml/2006/main">
+              <a:ext uri="{FF2B5EF4-FFF2-40B4-BE49-F238E27FC236}">
+                <a16:creationId xmlns:a16="http://schemas.microsoft.com/office/drawing/2014/main" id="{B6F301B3-CEF7-47E4-BC07-55B2614A8446}"/>
+              </a:ext>
+            </a:extLst>
+          </p:cNvPr>
+          <p:cNvSpPr>
+            <a:spLocks xmlns:a="http://schemas.openxmlformats.org/drawingml/2006/main" noGrp="1"/>
+          </p:cNvSpPr>
+          <p:nvPr/>
+        </p:nvSpPr>
+        <p:spPr>
+          <a:xfrm xmlns:a="http://schemas.openxmlformats.org/drawingml/2006/main">
+            <a:off x="8362950" y="4076700"/>
+            <a:ext cx="47625" cy="228600"/>
+          </a:xfrm>
+          <a:prstGeom xmlns:a="http://schemas.openxmlformats.org/drawingml/2006/main" prst="rect">
+            <a:avLst/>
+          </a:prstGeom>
+          <a:solidFill xmlns:a="http://schemas.openxmlformats.org/drawingml/2006/main">
+            <a:srgbClr val="EF6C21"/>
+          </a:solidFill>
+          <a:ln xmlns:a="http://schemas.openxmlformats.org/drawingml/2006/main" w="0">
+            <a:solidFill>
+              <a:srgbClr val="000000">
+                <a:alpha val="0"/>
+              </a:srgbClr>
+            </a:solidFill>
+            <a:prstDash val="solid"/>
+          </a:ln>
+        </p:spPr>
+      </p:sp>
+      <p:sp>
+        <p:nvSpPr>
+          <p:cNvPr id="33" name="">
+            <a:extLst xmlns:a="http://schemas.openxmlformats.org/drawingml/2006/main">
+              <a:ext uri="{FF2B5EF4-FFF2-40B4-BE49-F238E27FC236}">
+                <a16:creationId xmlns:a16="http://schemas.microsoft.com/office/drawing/2014/main" id="{B3884228-043C-44D2-9142-6DFC0ABEB39C}"/>
+              </a:ext>
+            </a:extLst>
+          </p:cNvPr>
+          <p:cNvSpPr>
+            <a:spLocks xmlns:a="http://schemas.openxmlformats.org/drawingml/2006/main" noGrp="1"/>
+          </p:cNvSpPr>
+          <p:nvPr/>
+        </p:nvSpPr>
+        <p:spPr>
+          <a:xfrm xmlns:a="http://schemas.openxmlformats.org/drawingml/2006/main">
+            <a:off x="8534400" y="4076700"/>
+            <a:ext cx="2571750" cy="238125"/>
+          </a:xfrm>
+          <a:prstGeom xmlns:a="http://schemas.openxmlformats.org/drawingml/2006/main" prst="rect">
+            <a:avLst/>
+          </a:prstGeom>
+          <a:solidFill xmlns:a="http://schemas.openxmlformats.org/drawingml/2006/main">
+            <a:srgbClr val="000000">
+              <a:alpha val="0"/>
+            </a:srgbClr>
+          </a:solidFill>
+          <a:ln xmlns:a="http://schemas.openxmlformats.org/drawingml/2006/main" w="0">
+            <a:solidFill>
+              <a:srgbClr val="000000">
+                <a:alpha val="0"/>
+              </a:srgbClr>
+            </a:solidFill>
+            <a:prstDash val="solid"/>
+          </a:ln>
+        </p:spPr>
+        <p:txBody>
+          <a:bodyPr xmlns:a="http://schemas.openxmlformats.org/drawingml/2006/main" lIns="0" tIns="0" rIns="0" bIns="0" anchor="t"/>
+          <a:lstStyle xmlns:a="http://schemas.openxmlformats.org/drawingml/2006/main"/>
+          <a:p xmlns:a="http://schemas.openxmlformats.org/drawingml/2006/main">
+            <a:pPr algn="l">
+              <a:defRPr sz="1125" b="0">
+                <a:solidFill>
+                  <a:srgbClr val="C2D6DD"/>
+                </a:solidFill>
+                <a:latin typeface="Aptos"/>
+                <a:ea typeface="Aptos"/>
+                <a:cs typeface="Aptos"/>
+              </a:defRPr>
+            </a:pPr>
+            <a:r>
+              <a:rPr sz="1125" b="0">
+                <a:solidFill>
+                  <a:srgbClr val="C2D6DD"/>
+                </a:solidFill>
+                <a:latin typeface="Aptos"/>
+                <a:ea typeface="Aptos"/>
+                <a:cs typeface="Aptos"/>
+              </a:rPr>
+              <a:t>3 explicit fallbacks</a:t>
+            </a:r>
+          </a:p>
+        </p:txBody>
+      </p:sp>
+      <p:sp>
+        <p:nvSpPr>
+          <p:cNvPr id="34" name="">
+            <a:extLst xmlns:a="http://schemas.openxmlformats.org/drawingml/2006/main">
+              <a:ext uri="{FF2B5EF4-FFF2-40B4-BE49-F238E27FC236}">
+                <a16:creationId xmlns:a16="http://schemas.microsoft.com/office/drawing/2014/main" id="{DE9FEC93-D3DE-40EC-80C7-D1FD074351CA}"/>
+              </a:ext>
+            </a:extLst>
+          </p:cNvPr>
+          <p:cNvSpPr>
+            <a:spLocks xmlns:a="http://schemas.openxmlformats.org/drawingml/2006/main" noGrp="1"/>
+          </p:cNvSpPr>
+          <p:nvPr/>
+        </p:nvSpPr>
+        <p:spPr>
+          <a:xfrm xmlns:a="http://schemas.openxmlformats.org/drawingml/2006/main">
+            <a:off x="495300" y="5124450"/>
+            <a:ext cx="10915650" cy="438150"/>
           </a:xfrm>
           <a:prstGeom xmlns:a="http://schemas.openxmlformats.org/drawingml/2006/main" prst="rect">
             <a:avLst/>
@@ -12897,557 +13944,7 @@
           <a:lstStyle xmlns:a="http://schemas.openxmlformats.org/drawingml/2006/main"/>
           <a:p xmlns:a="http://schemas.openxmlformats.org/drawingml/2006/main">
             <a:pPr algn="ctr">
-              <a:defRPr sz="1650" b="1">
-                <a:solidFill>
-                  <a:srgbClr val="1687C8"/>
-                </a:solidFill>
-                <a:latin typeface="Aptos"/>
-                <a:ea typeface="Aptos"/>
-                <a:cs typeface="Aptos"/>
-              </a:defRPr>
-            </a:pPr>
-            <a:r>
-              <a:rPr sz="1650" b="1">
-                <a:solidFill>
-                  <a:srgbClr val="1687C8"/>
-                </a:solidFill>
-                <a:latin typeface="Aptos"/>
-                <a:ea typeface="Aptos"/>
-                <a:cs typeface="Aptos"/>
-              </a:rPr>
-              <a:t>GEMMA_ENDPOINT</a:t>
-            </a:r>
-          </a:p>
-        </p:txBody>
-      </p:sp>
-      <p:sp>
-        <p:nvSpPr>
-          <p:cNvPr id="13" name="">
-            <a:extLst xmlns:a="http://schemas.openxmlformats.org/drawingml/2006/main">
-              <a:ext uri="{FF2B5EF4-FFF2-40B4-BE49-F238E27FC236}">
-                <a16:creationId xmlns:a16="http://schemas.microsoft.com/office/drawing/2014/main" id="{6563501D-D679-4629-9B4E-BD39FE612339}"/>
-              </a:ext>
-            </a:extLst>
-          </p:cNvPr>
-          <p:cNvSpPr>
-            <a:spLocks xmlns:a="http://schemas.openxmlformats.org/drawingml/2006/main" noGrp="1"/>
-          </p:cNvSpPr>
-          <p:nvPr/>
-        </p:nvSpPr>
-        <p:spPr>
-          <a:xfrm xmlns:a="http://schemas.openxmlformats.org/drawingml/2006/main">
-            <a:off x="4743450" y="3429000"/>
-            <a:ext cx="2571750" cy="419100"/>
-          </a:xfrm>
-          <a:prstGeom xmlns:a="http://schemas.openxmlformats.org/drawingml/2006/main" prst="rect">
-            <a:avLst/>
-          </a:prstGeom>
-          <a:solidFill xmlns:a="http://schemas.openxmlformats.org/drawingml/2006/main">
-            <a:srgbClr val="000000">
-              <a:alpha val="0"/>
-            </a:srgbClr>
-          </a:solidFill>
-          <a:ln xmlns:a="http://schemas.openxmlformats.org/drawingml/2006/main" w="0">
-            <a:solidFill>
-              <a:srgbClr val="000000">
-                <a:alpha val="0"/>
-              </a:srgbClr>
-            </a:solidFill>
-            <a:prstDash val="solid"/>
-          </a:ln>
-        </p:spPr>
-        <p:txBody>
-          <a:bodyPr xmlns:a="http://schemas.openxmlformats.org/drawingml/2006/main" lIns="0" tIns="0" rIns="0" bIns="0" anchor="t"/>
-          <a:lstStyle xmlns:a="http://schemas.openxmlformats.org/drawingml/2006/main"/>
-          <a:p xmlns:a="http://schemas.openxmlformats.org/drawingml/2006/main">
-            <a:pPr algn="ctr">
-              <a:defRPr sz="1050" b="0">
-                <a:solidFill>
-                  <a:srgbClr val="0B1F2A"/>
-                </a:solidFill>
-                <a:latin typeface="Aptos"/>
-                <a:ea typeface="Aptos"/>
-                <a:cs typeface="Aptos"/>
-              </a:defRPr>
-            </a:pPr>
-            <a:r>
-              <a:rPr sz="1050" b="0">
-                <a:solidFill>
-                  <a:srgbClr val="0B1F2A"/>
-                </a:solidFill>
-                <a:latin typeface="Aptos"/>
-                <a:ea typeface="Aptos"/>
-                <a:cs typeface="Aptos"/>
-              </a:rPr>
-              <a:t>OpenAI-compatible model boundary</a:t>
-            </a:r>
-          </a:p>
-        </p:txBody>
-      </p:sp>
-      <p:sp>
-        <p:nvSpPr>
-          <p:cNvPr id="14" name="">
-            <a:extLst xmlns:a="http://schemas.openxmlformats.org/drawingml/2006/main">
-              <a:ext uri="{FF2B5EF4-FFF2-40B4-BE49-F238E27FC236}">
-                <a16:creationId xmlns:a16="http://schemas.microsoft.com/office/drawing/2014/main" id="{277B23B5-8C4D-4161-A055-2FEF61D7FDC0}"/>
-              </a:ext>
-            </a:extLst>
-          </p:cNvPr>
-          <p:cNvSpPr>
-            <a:spLocks xmlns:a="http://schemas.openxmlformats.org/drawingml/2006/main" noGrp="1"/>
-          </p:cNvSpPr>
-          <p:nvPr/>
-        </p:nvSpPr>
-        <p:spPr>
-          <a:xfrm xmlns:a="http://schemas.openxmlformats.org/drawingml/2006/main">
-            <a:off x="3886200" y="3257550"/>
-            <a:ext cx="457200" cy="266700"/>
-          </a:xfrm>
-          <a:prstGeom xmlns:a="http://schemas.openxmlformats.org/drawingml/2006/main" prst="rect">
-            <a:avLst/>
-          </a:prstGeom>
-          <a:solidFill xmlns:a="http://schemas.openxmlformats.org/drawingml/2006/main">
-            <a:srgbClr val="000000">
-              <a:alpha val="0"/>
-            </a:srgbClr>
-          </a:solidFill>
-          <a:ln xmlns:a="http://schemas.openxmlformats.org/drawingml/2006/main" w="0">
-            <a:solidFill>
-              <a:srgbClr val="000000">
-                <a:alpha val="0"/>
-              </a:srgbClr>
-            </a:solidFill>
-            <a:prstDash val="solid"/>
-          </a:ln>
-        </p:spPr>
-        <p:txBody>
-          <a:bodyPr xmlns:a="http://schemas.openxmlformats.org/drawingml/2006/main" lIns="0" tIns="0" rIns="0" bIns="0" anchor="t"/>
-          <a:lstStyle xmlns:a="http://schemas.openxmlformats.org/drawingml/2006/main"/>
-          <a:p xmlns:a="http://schemas.openxmlformats.org/drawingml/2006/main">
-            <a:pPr algn="ctr">
-              <a:defRPr sz="1800" b="1">
-                <a:solidFill>
-                  <a:srgbClr val="76D9AD"/>
-                </a:solidFill>
-                <a:latin typeface="Aptos"/>
-                <a:ea typeface="Aptos"/>
-                <a:cs typeface="Aptos"/>
-              </a:defRPr>
-            </a:pPr>
-            <a:r>
-              <a:rPr sz="1800" b="1">
-                <a:solidFill>
-                  <a:srgbClr val="76D9AD"/>
-                </a:solidFill>
-                <a:latin typeface="Aptos"/>
-                <a:ea typeface="Aptos"/>
-                <a:cs typeface="Aptos"/>
-              </a:rPr>
-              <a:t>&gt;</a:t>
-            </a:r>
-          </a:p>
-        </p:txBody>
-      </p:sp>
-      <p:sp>
-        <p:nvSpPr>
-          <p:cNvPr id="15" name="">
-            <a:extLst xmlns:a="http://schemas.openxmlformats.org/drawingml/2006/main">
-              <a:ext uri="{FF2B5EF4-FFF2-40B4-BE49-F238E27FC236}">
-                <a16:creationId xmlns:a16="http://schemas.microsoft.com/office/drawing/2014/main" id="{75DFC321-E34F-4EAC-8375-21A1F1DB2CDB}"/>
-              </a:ext>
-            </a:extLst>
-          </p:cNvPr>
-          <p:cNvSpPr>
-            <a:spLocks xmlns:a="http://schemas.openxmlformats.org/drawingml/2006/main" noGrp="1"/>
-          </p:cNvSpPr>
-          <p:nvPr/>
-        </p:nvSpPr>
-        <p:spPr>
-          <a:xfrm xmlns:a="http://schemas.openxmlformats.org/drawingml/2006/main">
-            <a:off x="7734300" y="3257550"/>
-            <a:ext cx="457200" cy="266700"/>
-          </a:xfrm>
-          <a:prstGeom xmlns:a="http://schemas.openxmlformats.org/drawingml/2006/main" prst="rect">
-            <a:avLst/>
-          </a:prstGeom>
-          <a:solidFill xmlns:a="http://schemas.openxmlformats.org/drawingml/2006/main">
-            <a:srgbClr val="000000">
-              <a:alpha val="0"/>
-            </a:srgbClr>
-          </a:solidFill>
-          <a:ln xmlns:a="http://schemas.openxmlformats.org/drawingml/2006/main" w="0">
-            <a:solidFill>
-              <a:srgbClr val="000000">
-                <a:alpha val="0"/>
-              </a:srgbClr>
-            </a:solidFill>
-            <a:prstDash val="solid"/>
-          </a:ln>
-        </p:spPr>
-        <p:txBody>
-          <a:bodyPr xmlns:a="http://schemas.openxmlformats.org/drawingml/2006/main" lIns="0" tIns="0" rIns="0" bIns="0" anchor="t"/>
-          <a:lstStyle xmlns:a="http://schemas.openxmlformats.org/drawingml/2006/main"/>
-          <a:p xmlns:a="http://schemas.openxmlformats.org/drawingml/2006/main">
-            <a:pPr algn="ctr">
-              <a:defRPr sz="1800" b="1">
-                <a:solidFill>
-                  <a:srgbClr val="EF6C21"/>
-                </a:solidFill>
-                <a:latin typeface="Aptos"/>
-                <a:ea typeface="Aptos"/>
-                <a:cs typeface="Aptos"/>
-              </a:defRPr>
-            </a:pPr>
-            <a:r>
-              <a:rPr sz="1800" b="1">
-                <a:solidFill>
-                  <a:srgbClr val="EF6C21"/>
-                </a:solidFill>
-                <a:latin typeface="Aptos"/>
-                <a:ea typeface="Aptos"/>
-                <a:cs typeface="Aptos"/>
-              </a:rPr>
-              <a:t>&gt;</a:t>
-            </a:r>
-          </a:p>
-        </p:txBody>
-      </p:sp>
-      <p:sp>
-        <p:nvSpPr>
-          <p:cNvPr id="16" name="">
-            <a:extLst xmlns:a="http://schemas.openxmlformats.org/drawingml/2006/main">
-              <a:ext uri="{FF2B5EF4-FFF2-40B4-BE49-F238E27FC236}">
-                <a16:creationId xmlns:a16="http://schemas.microsoft.com/office/drawing/2014/main" id="{9E6AAEB8-01BF-4D4D-9C9B-147CA6105DA2}"/>
-              </a:ext>
-            </a:extLst>
-          </p:cNvPr>
-          <p:cNvSpPr>
-            <a:spLocks xmlns:a="http://schemas.openxmlformats.org/drawingml/2006/main" noGrp="1"/>
-          </p:cNvSpPr>
-          <p:nvPr/>
-        </p:nvSpPr>
-        <p:spPr>
-          <a:xfrm xmlns:a="http://schemas.openxmlformats.org/drawingml/2006/main">
-            <a:off x="8420100" y="2038350"/>
-            <a:ext cx="2857500" cy="228600"/>
-          </a:xfrm>
-          <a:prstGeom xmlns:a="http://schemas.openxmlformats.org/drawingml/2006/main" prst="rect">
-            <a:avLst/>
-          </a:prstGeom>
-          <a:solidFill xmlns:a="http://schemas.openxmlformats.org/drawingml/2006/main">
-            <a:srgbClr val="000000">
-              <a:alpha val="0"/>
-            </a:srgbClr>
-          </a:solidFill>
-          <a:ln xmlns:a="http://schemas.openxmlformats.org/drawingml/2006/main" w="0">
-            <a:solidFill>
-              <a:srgbClr val="000000">
-                <a:alpha val="0"/>
-              </a:srgbClr>
-            </a:solidFill>
-            <a:prstDash val="solid"/>
-          </a:ln>
-        </p:spPr>
-        <p:txBody>
-          <a:bodyPr xmlns:a="http://schemas.openxmlformats.org/drawingml/2006/main" lIns="0" tIns="0" rIns="0" bIns="0" anchor="t"/>
-          <a:lstStyle xmlns:a="http://schemas.openxmlformats.org/drawingml/2006/main"/>
-          <a:p xmlns:a="http://schemas.openxmlformats.org/drawingml/2006/main">
-            <a:pPr algn="l">
-              <a:defRPr sz="900" b="1">
-                <a:solidFill>
-                  <a:srgbClr val="FFAD7C"/>
-                </a:solidFill>
-                <a:latin typeface="Aptos"/>
-                <a:ea typeface="Aptos"/>
-                <a:cs typeface="Aptos"/>
-              </a:defRPr>
-            </a:pPr>
-            <a:r>
-              <a:rPr sz="900" b="1">
-                <a:solidFill>
-                  <a:srgbClr val="FFAD7C"/>
-                </a:solidFill>
-                <a:latin typeface="Aptos"/>
-                <a:ea typeface="Aptos"/>
-                <a:cs typeface="Aptos"/>
-              </a:rPr>
-              <a:t>PORTABLE AMD PATH</a:t>
-            </a:r>
-          </a:p>
-        </p:txBody>
-      </p:sp>
-      <p:sp>
-        <p:nvSpPr>
-          <p:cNvPr id="17" name="">
-            <a:extLst xmlns:a="http://schemas.openxmlformats.org/drawingml/2006/main">
-              <a:ext uri="{FF2B5EF4-FFF2-40B4-BE49-F238E27FC236}">
-                <a16:creationId xmlns:a16="http://schemas.microsoft.com/office/drawing/2014/main" id="{3003F111-BF7F-4FD0-998A-CE896BB0756C}"/>
-              </a:ext>
-            </a:extLst>
-          </p:cNvPr>
-          <p:cNvSpPr>
-            <a:spLocks xmlns:a="http://schemas.openxmlformats.org/drawingml/2006/main" noGrp="1"/>
-          </p:cNvSpPr>
-          <p:nvPr/>
-        </p:nvSpPr>
-        <p:spPr>
-          <a:xfrm xmlns:a="http://schemas.openxmlformats.org/drawingml/2006/main">
-            <a:off x="8305800" y="2400300"/>
-            <a:ext cx="3200400" cy="2095500"/>
-          </a:xfrm>
-          <a:prstGeom xmlns:a="http://schemas.openxmlformats.org/drawingml/2006/main" prst="rect">
-            <a:avLst/>
-          </a:prstGeom>
-          <a:solidFill xmlns:a="http://schemas.openxmlformats.org/drawingml/2006/main">
-            <a:srgbClr val="173F50"/>
-          </a:solidFill>
-          <a:ln xmlns:a="http://schemas.openxmlformats.org/drawingml/2006/main" w="19050">
-            <a:solidFill>
-              <a:srgbClr val="EF6C21"/>
-            </a:solidFill>
-            <a:prstDash val="solid"/>
-          </a:ln>
-        </p:spPr>
-      </p:sp>
-      <p:sp>
-        <p:nvSpPr>
-          <p:cNvPr id="18" name="">
-            <a:extLst xmlns:a="http://schemas.openxmlformats.org/drawingml/2006/main">
-              <a:ext uri="{FF2B5EF4-FFF2-40B4-BE49-F238E27FC236}">
-                <a16:creationId xmlns:a16="http://schemas.microsoft.com/office/drawing/2014/main" id="{6AB5FF00-3998-4040-B429-633A696C7FF1}"/>
-              </a:ext>
-            </a:extLst>
-          </p:cNvPr>
-          <p:cNvSpPr>
-            <a:spLocks xmlns:a="http://schemas.openxmlformats.org/drawingml/2006/main" noGrp="1"/>
-          </p:cNvSpPr>
-          <p:nvPr/>
-        </p:nvSpPr>
-        <p:spPr>
-          <a:xfrm xmlns:a="http://schemas.openxmlformats.org/drawingml/2006/main">
-            <a:off x="8591550" y="2647950"/>
-            <a:ext cx="2628900" cy="342900"/>
-          </a:xfrm>
-          <a:prstGeom xmlns:a="http://schemas.openxmlformats.org/drawingml/2006/main" prst="rect">
-            <a:avLst/>
-          </a:prstGeom>
-          <a:solidFill xmlns:a="http://schemas.openxmlformats.org/drawingml/2006/main">
-            <a:srgbClr val="000000">
-              <a:alpha val="0"/>
-            </a:srgbClr>
-          </a:solidFill>
-          <a:ln xmlns:a="http://schemas.openxmlformats.org/drawingml/2006/main" w="0">
-            <a:solidFill>
-              <a:srgbClr val="000000">
-                <a:alpha val="0"/>
-              </a:srgbClr>
-            </a:solidFill>
-            <a:prstDash val="solid"/>
-          </a:ln>
-        </p:spPr>
-        <p:txBody>
-          <a:bodyPr xmlns:a="http://schemas.openxmlformats.org/drawingml/2006/main" lIns="0" tIns="0" rIns="0" bIns="0" anchor="t"/>
-          <a:lstStyle xmlns:a="http://schemas.openxmlformats.org/drawingml/2006/main"/>
-          <a:p xmlns:a="http://schemas.openxmlformats.org/drawingml/2006/main">
-            <a:pPr algn="l">
-              <a:defRPr sz="1875" b="1">
-                <a:solidFill>
-                  <a:srgbClr val="FFFFFF"/>
-                </a:solidFill>
-                <a:latin typeface="Aptos"/>
-                <a:ea typeface="Aptos"/>
-                <a:cs typeface="Aptos"/>
-              </a:defRPr>
-            </a:pPr>
-            <a:r>
-              <a:rPr sz="1875" b="1">
-                <a:solidFill>
-                  <a:srgbClr val="FFFFFF"/>
-                </a:solidFill>
-                <a:latin typeface="Aptos"/>
-                <a:ea typeface="Aptos"/>
-                <a:cs typeface="Aptos"/>
-              </a:rPr>
-              <a:t>GPU promotion profile</a:t>
-            </a:r>
-          </a:p>
-        </p:txBody>
-      </p:sp>
-      <p:sp>
-        <p:nvSpPr>
-          <p:cNvPr id="19" name="">
-            <a:extLst xmlns:a="http://schemas.openxmlformats.org/drawingml/2006/main">
-              <a:ext uri="{FF2B5EF4-FFF2-40B4-BE49-F238E27FC236}">
-                <a16:creationId xmlns:a16="http://schemas.microsoft.com/office/drawing/2014/main" id="{8E70F227-7B34-4016-8EFB-37FDCBCF1F75}"/>
-              </a:ext>
-            </a:extLst>
-          </p:cNvPr>
-          <p:cNvSpPr>
-            <a:spLocks xmlns:a="http://schemas.openxmlformats.org/drawingml/2006/main" noGrp="1"/>
-          </p:cNvSpPr>
-          <p:nvPr/>
-        </p:nvSpPr>
-        <p:spPr>
-          <a:xfrm xmlns:a="http://schemas.openxmlformats.org/drawingml/2006/main">
-            <a:off x="8591550" y="3143250"/>
-            <a:ext cx="2628900" cy="952500"/>
-          </a:xfrm>
-          <a:prstGeom xmlns:a="http://schemas.openxmlformats.org/drawingml/2006/main" prst="rect">
-            <a:avLst/>
-          </a:prstGeom>
-          <a:solidFill xmlns:a="http://schemas.openxmlformats.org/drawingml/2006/main">
-            <a:srgbClr val="000000">
-              <a:alpha val="0"/>
-            </a:srgbClr>
-          </a:solidFill>
-          <a:ln xmlns:a="http://schemas.openxmlformats.org/drawingml/2006/main" w="0">
-            <a:solidFill>
-              <a:srgbClr val="000000">
-                <a:alpha val="0"/>
-              </a:srgbClr>
-            </a:solidFill>
-            <a:prstDash val="solid"/>
-          </a:ln>
-        </p:spPr>
-        <p:txBody>
-          <a:bodyPr xmlns:a="http://schemas.openxmlformats.org/drawingml/2006/main" lIns="0" tIns="0" rIns="0" bIns="0" anchor="t"/>
-          <a:lstStyle xmlns:a="http://schemas.openxmlformats.org/drawingml/2006/main"/>
-          <a:p xmlns:a="http://schemas.openxmlformats.org/drawingml/2006/main">
-            <a:pPr algn="l">
-              <a:defRPr sz="1200" b="0">
-                <a:solidFill>
-                  <a:srgbClr val="C2D6DD"/>
-                </a:solidFill>
-                <a:latin typeface="Aptos"/>
-                <a:ea typeface="Aptos"/>
-                <a:cs typeface="Aptos"/>
-              </a:defRPr>
-            </a:pPr>
-            <a:r>
-              <a:rPr sz="1200" b="0">
-                <a:solidFill>
-                  <a:srgbClr val="C2D6DD"/>
-                </a:solidFill>
-                <a:latin typeface="Aptos"/>
-                <a:ea typeface="Aptos"/>
-                <a:cs typeface="Aptos"/>
-              </a:rPr>
-              <a:t>AMD ROCm</a:t>
-            </a:r>
-          </a:p>
-          <a:p xmlns:a="http://schemas.openxmlformats.org/drawingml/2006/main">
-            <a:pPr algn="l">
-              <a:defRPr sz="1200" b="0">
-                <a:solidFill>
-                  <a:srgbClr val="C2D6DD"/>
-                </a:solidFill>
-                <a:latin typeface="Aptos"/>
-                <a:ea typeface="Aptos"/>
-                <a:cs typeface="Aptos"/>
-              </a:defRPr>
-            </a:pPr>
-            <a:r>
-              <a:rPr sz="1200" b="0">
-                <a:solidFill>
-                  <a:srgbClr val="C2D6DD"/>
-                </a:solidFill>
-                <a:latin typeface="Aptos"/>
-                <a:ea typeface="Aptos"/>
-                <a:cs typeface="Aptos"/>
-              </a:rPr>
-              <a:t>vLLM serving</a:t>
-            </a:r>
-          </a:p>
-          <a:p xmlns:a="http://schemas.openxmlformats.org/drawingml/2006/main">
-            <a:pPr algn="l">
-              <a:defRPr sz="1200" b="0">
-                <a:solidFill>
-                  <a:srgbClr val="C2D6DD"/>
-                </a:solidFill>
-                <a:latin typeface="Aptos"/>
-                <a:ea typeface="Aptos"/>
-                <a:cs typeface="Aptos"/>
-              </a:defRPr>
-            </a:pPr>
-            <a:r>
-              <a:rPr sz="1200" b="0">
-                <a:solidFill>
-                  <a:srgbClr val="C2D6DD"/>
-                </a:solidFill>
-                <a:latin typeface="Aptos"/>
-                <a:ea typeface="Aptos"/>
-                <a:cs typeface="Aptos"/>
-              </a:rPr>
-              <a:t>same endpoint contract</a:t>
-            </a:r>
-          </a:p>
-          <a:p xmlns:a="http://schemas.openxmlformats.org/drawingml/2006/main">
-            <a:pPr algn="l">
-              <a:defRPr sz="1200" b="0">
-                <a:solidFill>
-                  <a:srgbClr val="C2D6DD"/>
-                </a:solidFill>
-                <a:latin typeface="Aptos"/>
-                <a:ea typeface="Aptos"/>
-                <a:cs typeface="Aptos"/>
-              </a:defRPr>
-            </a:pPr>
-            <a:r>
-              <a:rPr sz="1200" b="0">
-                <a:solidFill>
-                  <a:srgbClr val="C2D6DD"/>
-                </a:solidFill>
-                <a:latin typeface="Aptos"/>
-                <a:ea typeface="Aptos"/>
-                <a:cs typeface="Aptos"/>
-              </a:rPr>
-              <a:t>GPU evidence not claimed</a:t>
-            </a:r>
-          </a:p>
-        </p:txBody>
-      </p:sp>
-      <p:sp>
-        <p:nvSpPr>
-          <p:cNvPr id="20" name="">
-            <a:extLst xmlns:a="http://schemas.openxmlformats.org/drawingml/2006/main">
-              <a:ext uri="{FF2B5EF4-FFF2-40B4-BE49-F238E27FC236}">
-                <a16:creationId xmlns:a16="http://schemas.microsoft.com/office/drawing/2014/main" id="{19DF0CB3-6132-4B24-862E-A0C112DF9FEF}"/>
-              </a:ext>
-            </a:extLst>
-          </p:cNvPr>
-          <p:cNvSpPr>
-            <a:spLocks xmlns:a="http://schemas.openxmlformats.org/drawingml/2006/main" noGrp="1"/>
-          </p:cNvSpPr>
-          <p:nvPr/>
-        </p:nvSpPr>
-        <p:spPr>
-          <a:xfrm xmlns:a="http://schemas.openxmlformats.org/drawingml/2006/main">
-            <a:off x="495300" y="5048250"/>
-            <a:ext cx="10801350" cy="400050"/>
-          </a:xfrm>
-          <a:prstGeom xmlns:a="http://schemas.openxmlformats.org/drawingml/2006/main" prst="rect">
-            <a:avLst/>
-          </a:prstGeom>
-          <a:solidFill xmlns:a="http://schemas.openxmlformats.org/drawingml/2006/main">
-            <a:srgbClr val="000000">
-              <a:alpha val="0"/>
-            </a:srgbClr>
-          </a:solidFill>
-          <a:ln xmlns:a="http://schemas.openxmlformats.org/drawingml/2006/main" w="0">
-            <a:solidFill>
-              <a:srgbClr val="000000">
-                <a:alpha val="0"/>
-              </a:srgbClr>
-            </a:solidFill>
-            <a:prstDash val="solid"/>
-          </a:ln>
-        </p:spPr>
-        <p:txBody>
-          <a:bodyPr xmlns:a="http://schemas.openxmlformats.org/drawingml/2006/main" lIns="0" tIns="0" rIns="0" bIns="0" anchor="t"/>
-          <a:lstStyle xmlns:a="http://schemas.openxmlformats.org/drawingml/2006/main"/>
-          <a:p xmlns:a="http://schemas.openxmlformats.org/drawingml/2006/main">
-            <a:pPr algn="ctr">
-              <a:defRPr sz="1650" b="1">
+              <a:defRPr sz="1725" b="1">
                 <a:solidFill>
                   <a:srgbClr val="8EE7D5"/>
                 </a:solidFill>
@@ -13457,7 +13954,7 @@
               </a:defRPr>
             </a:pPr>
             <a:r>
-              <a:rPr sz="1650" b="1">
+              <a:rPr sz="1725" b="1">
                 <a:solidFill>
                   <a:srgbClr val="8EE7D5"/>
                 </a:solidFill>
@@ -13465,17 +13962,17 @@
                 <a:ea typeface="Aptos"/>
                 <a:cs typeface="Aptos"/>
               </a:rPr>
-              <a:t>The deterministic verifier remains authoritative on either host.</a:t>
-            </a:r>
-          </a:p>
-        </p:txBody>
-      </p:sp>
-      <p:sp>
-        <p:nvSpPr>
-          <p:cNvPr id="21" name="">
-            <a:extLst xmlns:a="http://schemas.openxmlformats.org/drawingml/2006/main">
-              <a:ext uri="{FF2B5EF4-FFF2-40B4-BE49-F238E27FC236}">
-                <a16:creationId xmlns:a16="http://schemas.microsoft.com/office/drawing/2014/main" id="{B0950618-4D5B-47A2-A75D-11978493F30B}"/>
+              <a:t>103.1 kg aggregate fish + prawn biomass protected across the audit</a:t>
+            </a:r>
+          </a:p>
+        </p:txBody>
+      </p:sp>
+      <p:sp>
+        <p:nvSpPr>
+          <p:cNvPr id="35" name="">
+            <a:extLst xmlns:a="http://schemas.openxmlformats.org/drawingml/2006/main">
+              <a:ext uri="{FF2B5EF4-FFF2-40B4-BE49-F238E27FC236}">
+                <a16:creationId xmlns:a16="http://schemas.microsoft.com/office/drawing/2014/main" id="{2784D48B-DDE5-4BE7-A961-F1271A8518EB}"/>
               </a:ext>
             </a:extLst>
           </p:cNvPr>
@@ -13529,7 +14026,7 @@
                 <a:ea typeface="Aptos"/>
                 <a:cs typeface="Aptos"/>
               </a:rPr>
-              <a:t>Current submission proves CPU llama.cpp and local Metal inference; ROCm/vLLM remains a documented promotion path.</a:t>
+              <a:t>Captured AMD experiment; the durable public URL remains on its private 8 GB host and CPU fallback.</a:t>
             </a:r>
           </a:p>
         </p:txBody>
@@ -13537,7 +14034,7 @@
     </p:spTree>
     <p:extLst>
       <p:ext uri="{BB962C8B-B14F-4D97-AF65-F5344CB8AC3E}">
-        <p14:creationId xmlns:p14="http://schemas.microsoft.com/office/powerpoint/2010/main" val="1885607401"/>
+        <p14:creationId xmlns:p14="http://schemas.microsoft.com/office/powerpoint/2010/main" val="1157870933"/>
       </p:ext>
     </p:extLst>
   </p:cSld>

</xml_diff>

<commit_message>
Publish AMD Gemma repair evidence
</commit_message>
<xml_diff>
--- a/submission/proteinloop-hackathon-deck.pptx
+++ b/submission/proteinloop-hackathon-deck.pptx
@@ -2,22 +2,22 @@
 <file path=ppt/presentation.xml><?xml version="1.0" encoding="utf-8"?>
 <p:presentation xmlns:p="http://schemas.openxmlformats.org/presentationml/2006/main">
   <p:sldMasterIdLst>
-    <p:sldMasterId xmlns:r="http://schemas.openxmlformats.org/officeDocument/2006/relationships" id="2147483648" r:id="R8dd0e0369d4844bd"/>
+    <p:sldMasterId xmlns:r="http://schemas.openxmlformats.org/officeDocument/2006/relationships" id="2147483648" r:id="Rc43f6c7084f645ff"/>
   </p:sldMasterIdLst>
   <p:notesMasterIdLst>
-    <p:notesMasterId xmlns:r="http://schemas.openxmlformats.org/officeDocument/2006/relationships" r:id="R5a741055d00144a0"/>
+    <p:notesMasterId xmlns:r="http://schemas.openxmlformats.org/officeDocument/2006/relationships" r:id="R33d9de035e314c9e"/>
   </p:notesMasterIdLst>
   <p:sldIdLst>
-    <p:sldId xmlns:r="http://schemas.openxmlformats.org/officeDocument/2006/relationships" id="256" r:id="Rc38fa13d936b420d"/>
-    <p:sldId xmlns:r="http://schemas.openxmlformats.org/officeDocument/2006/relationships" id="257" r:id="R4f0ccd1bcf774342"/>
-    <p:sldId xmlns:r="http://schemas.openxmlformats.org/officeDocument/2006/relationships" id="258" r:id="R03954e9136994f51"/>
-    <p:sldId xmlns:r="http://schemas.openxmlformats.org/officeDocument/2006/relationships" id="259" r:id="Re0028fe216f44706"/>
-    <p:sldId xmlns:r="http://schemas.openxmlformats.org/officeDocument/2006/relationships" id="260" r:id="Redf9ccc7ca954a36"/>
-    <p:sldId xmlns:r="http://schemas.openxmlformats.org/officeDocument/2006/relationships" id="261" r:id="R629fa57eff084c8c"/>
-    <p:sldId xmlns:r="http://schemas.openxmlformats.org/officeDocument/2006/relationships" id="262" r:id="R521b112677004a43"/>
-    <p:sldId xmlns:r="http://schemas.openxmlformats.org/officeDocument/2006/relationships" id="263" r:id="Re0e20465961e4e05"/>
-    <p:sldId xmlns:r="http://schemas.openxmlformats.org/officeDocument/2006/relationships" id="264" r:id="Re6ece8f2e51d49dd"/>
-    <p:sldId xmlns:r="http://schemas.openxmlformats.org/officeDocument/2006/relationships" id="265" r:id="R89ba160ecc9541c8"/>
+    <p:sldId xmlns:r="http://schemas.openxmlformats.org/officeDocument/2006/relationships" id="256" r:id="R2d5fde3b903e4b9e"/>
+    <p:sldId xmlns:r="http://schemas.openxmlformats.org/officeDocument/2006/relationships" id="257" r:id="R1217456440cd4cdc"/>
+    <p:sldId xmlns:r="http://schemas.openxmlformats.org/officeDocument/2006/relationships" id="258" r:id="R52e9c284bcc843be"/>
+    <p:sldId xmlns:r="http://schemas.openxmlformats.org/officeDocument/2006/relationships" id="259" r:id="R63ec9cc3300d48d9"/>
+    <p:sldId xmlns:r="http://schemas.openxmlformats.org/officeDocument/2006/relationships" id="260" r:id="Ra97d5b35afbe4564"/>
+    <p:sldId xmlns:r="http://schemas.openxmlformats.org/officeDocument/2006/relationships" id="261" r:id="R09ade37bb27f40e8"/>
+    <p:sldId xmlns:r="http://schemas.openxmlformats.org/officeDocument/2006/relationships" id="262" r:id="R7267e5ed5e0d4454"/>
+    <p:sldId xmlns:r="http://schemas.openxmlformats.org/officeDocument/2006/relationships" id="263" r:id="Raa758599d80f48d7"/>
+    <p:sldId xmlns:r="http://schemas.openxmlformats.org/officeDocument/2006/relationships" id="264" r:id="R2555772b043c4628"/>
+    <p:sldId xmlns:r="http://schemas.openxmlformats.org/officeDocument/2006/relationships" id="265" r:id="Rb174eacc635f40fb"/>
   </p:sldIdLst>
   <p:sldSz cx="12192000" cy="6858000"/>
   <p:notesSz cx="6858000" cy="9144000"/>
@@ -1158,7 +1158,7 @@
   </p:cSld>
   <p:clrMap bg1="lt1" tx1="dk1" bg2="lt2" tx2="dk2" accent1="accent1" accent2="accent2" accent3="accent3" accent4="accent4" accent5="accent5" accent6="accent6" hlink="hlink" folHlink="folHlink"/>
   <p:sldLayoutIdLst>
-    <p:sldLayoutId xmlns:r="http://schemas.openxmlformats.org/officeDocument/2006/relationships" id="2147483649" r:id="R397fb345f3884a9e"/>
+    <p:sldLayoutId xmlns:r="http://schemas.openxmlformats.org/officeDocument/2006/relationships" id="2147483649" r:id="R00e0bb4ca6194f95"/>
   </p:sldLayoutIdLst>
   <p:txStyles>
     <p:titleStyle>
@@ -1461,7 +1461,7 @@
           <p:nvPr/>
         </p:nvPicPr>
         <p:blipFill>
-          <a:blip xmlns:r="http://schemas.openxmlformats.org/officeDocument/2006/relationships" xmlns:a="http://schemas.openxmlformats.org/drawingml/2006/main" r:embed="R25ea035c4e754bce"/>
+          <a:blip xmlns:r="http://schemas.openxmlformats.org/officeDocument/2006/relationships" xmlns:a="http://schemas.openxmlformats.org/drawingml/2006/main" r:embed="Rc3fd1e277b624bf0"/>
           <a:srcRect xmlns:a="http://schemas.openxmlformats.org/drawingml/2006/main" l="0" t="0" r="0" b="0"/>
           <a:stretch xmlns:a="http://schemas.openxmlformats.org/drawingml/2006/main">
             <a:fillRect l="0" t="0" r="0" b="0"/>
@@ -1480,7 +1480,7 @@
     </p:spTree>
     <p:extLst>
       <p:ext uri="{BB962C8B-B14F-4D97-AF65-F5344CB8AC3E}">
-        <p14:creationId xmlns:p14="http://schemas.microsoft.com/office/powerpoint/2010/main" val="620996482"/>
+        <p14:creationId xmlns:p14="http://schemas.microsoft.com/office/powerpoint/2010/main" val="884555811"/>
       </p:ext>
     </p:extLst>
   </p:cSld>
@@ -1504,7 +1504,7 @@
           <p:cNvPr id="1" name="">
             <a:extLst xmlns:a="http://schemas.openxmlformats.org/drawingml/2006/main">
               <a:ext uri="{FF2B5EF4-FFF2-40B4-BE49-F238E27FC236}">
-                <a16:creationId xmlns:a16="http://schemas.microsoft.com/office/drawing/2014/main" id="{46EBCF83-C4EE-488C-8CFB-99ED86B9A173}"/>
+                <a16:creationId xmlns:a16="http://schemas.microsoft.com/office/drawing/2014/main" id="{BA77CD62-A0C5-4BD4-9E0F-A4EA00956A09}"/>
               </a:ext>
             </a:extLst>
           </p:cNvPr>
@@ -1539,7 +1539,7 @@
           <p:cNvPr id="2" name="">
             <a:extLst xmlns:a="http://schemas.openxmlformats.org/drawingml/2006/main">
               <a:ext uri="{FF2B5EF4-FFF2-40B4-BE49-F238E27FC236}">
-                <a16:creationId xmlns:a16="http://schemas.microsoft.com/office/drawing/2014/main" id="{950988E6-82AF-44A9-AE9C-53B3430E33BE}"/>
+                <a16:creationId xmlns:a16="http://schemas.microsoft.com/office/drawing/2014/main" id="{4C8B1C47-2C57-4CDE-B578-2A598DBD080B}"/>
               </a:ext>
             </a:extLst>
           </p:cNvPr>
@@ -1574,7 +1574,7 @@
           <p:cNvPr id="3" name="">
             <a:extLst xmlns:a="http://schemas.openxmlformats.org/drawingml/2006/main">
               <a:ext uri="{FF2B5EF4-FFF2-40B4-BE49-F238E27FC236}">
-                <a16:creationId xmlns:a16="http://schemas.microsoft.com/office/drawing/2014/main" id="{3722765B-4E91-4E02-8B58-7708E2014F67}"/>
+                <a16:creationId xmlns:a16="http://schemas.microsoft.com/office/drawing/2014/main" id="{21EB63C5-366A-423A-B2DB-92FD5173AEE9}"/>
               </a:ext>
             </a:extLst>
           </p:cNvPr>
@@ -1638,7 +1638,7 @@
           <p:cNvPr id="4" name="">
             <a:extLst xmlns:a="http://schemas.openxmlformats.org/drawingml/2006/main">
               <a:ext uri="{FF2B5EF4-FFF2-40B4-BE49-F238E27FC236}">
-                <a16:creationId xmlns:a16="http://schemas.microsoft.com/office/drawing/2014/main" id="{96D0C8B8-8531-4AD4-BECD-EC66C0522B1C}"/>
+                <a16:creationId xmlns:a16="http://schemas.microsoft.com/office/drawing/2014/main" id="{50C65D66-FFF3-44E2-98EA-26C06794C286}"/>
               </a:ext>
             </a:extLst>
           </p:cNvPr>
@@ -1702,7 +1702,7 @@
           <p:cNvPr id="5" name="">
             <a:extLst xmlns:a="http://schemas.openxmlformats.org/drawingml/2006/main">
               <a:ext uri="{FF2B5EF4-FFF2-40B4-BE49-F238E27FC236}">
-                <a16:creationId xmlns:a16="http://schemas.microsoft.com/office/drawing/2014/main" id="{77615E93-D942-47F2-9A64-54BD30773AD3}"/>
+                <a16:creationId xmlns:a16="http://schemas.microsoft.com/office/drawing/2014/main" id="{5181B62C-9CA5-431F-9CCB-C19F2C899BD6}"/>
               </a:ext>
             </a:extLst>
           </p:cNvPr>
@@ -1766,7 +1766,7 @@
           <p:cNvPr id="6" name="">
             <a:extLst xmlns:a="http://schemas.openxmlformats.org/drawingml/2006/main">
               <a:ext uri="{FF2B5EF4-FFF2-40B4-BE49-F238E27FC236}">
-                <a16:creationId xmlns:a16="http://schemas.microsoft.com/office/drawing/2014/main" id="{39ED0734-7F0E-4D7B-841C-B7D41CDC111C}"/>
+                <a16:creationId xmlns:a16="http://schemas.microsoft.com/office/drawing/2014/main" id="{4150A5F3-5FFB-43FA-A6C4-B2D0838C1BB3}"/>
               </a:ext>
             </a:extLst>
           </p:cNvPr>
@@ -1801,7 +1801,7 @@
           <p:cNvPr id="7" name="">
             <a:extLst xmlns:a="http://schemas.openxmlformats.org/drawingml/2006/main">
               <a:ext uri="{FF2B5EF4-FFF2-40B4-BE49-F238E27FC236}">
-                <a16:creationId xmlns:a16="http://schemas.microsoft.com/office/drawing/2014/main" id="{C43A2257-1E82-4134-817C-895F493600B0}"/>
+                <a16:creationId xmlns:a16="http://schemas.microsoft.com/office/drawing/2014/main" id="{FC2C14FC-747C-4558-8314-EA885A5A236C}"/>
               </a:ext>
             </a:extLst>
           </p:cNvPr>
@@ -1865,7 +1865,7 @@
           <p:cNvPr id="8" name="">
             <a:extLst xmlns:a="http://schemas.openxmlformats.org/drawingml/2006/main">
               <a:ext uri="{FF2B5EF4-FFF2-40B4-BE49-F238E27FC236}">
-                <a16:creationId xmlns:a16="http://schemas.microsoft.com/office/drawing/2014/main" id="{CDD41A3F-4FC3-4D3E-A08E-B8D8977E959B}"/>
+                <a16:creationId xmlns:a16="http://schemas.microsoft.com/office/drawing/2014/main" id="{8E8297DB-B3EA-4429-9A9B-9501EF7B6B5A}"/>
               </a:ext>
             </a:extLst>
           </p:cNvPr>
@@ -1929,7 +1929,7 @@
           <p:cNvPr id="9" name="">
             <a:extLst xmlns:a="http://schemas.openxmlformats.org/drawingml/2006/main">
               <a:ext uri="{FF2B5EF4-FFF2-40B4-BE49-F238E27FC236}">
-                <a16:creationId xmlns:a16="http://schemas.microsoft.com/office/drawing/2014/main" id="{67A83C62-C024-4549-964A-DDB78F80FC8A}"/>
+                <a16:creationId xmlns:a16="http://schemas.microsoft.com/office/drawing/2014/main" id="{8D584DEE-8AF9-4BCE-A2D6-93C211F10057}"/>
               </a:ext>
             </a:extLst>
           </p:cNvPr>
@@ -1964,7 +1964,7 @@
           <p:cNvPr id="10" name="">
             <a:extLst xmlns:a="http://schemas.openxmlformats.org/drawingml/2006/main">
               <a:ext uri="{FF2B5EF4-FFF2-40B4-BE49-F238E27FC236}">
-                <a16:creationId xmlns:a16="http://schemas.microsoft.com/office/drawing/2014/main" id="{86187832-53DD-4A98-A91C-F9DC2DC7893F}"/>
+                <a16:creationId xmlns:a16="http://schemas.microsoft.com/office/drawing/2014/main" id="{5DDF908C-7E8E-433F-BF23-AF28C30C1035}"/>
               </a:ext>
             </a:extLst>
           </p:cNvPr>
@@ -2028,7 +2028,7 @@
           <p:cNvPr id="11" name="">
             <a:extLst xmlns:a="http://schemas.openxmlformats.org/drawingml/2006/main">
               <a:ext uri="{FF2B5EF4-FFF2-40B4-BE49-F238E27FC236}">
-                <a16:creationId xmlns:a16="http://schemas.microsoft.com/office/drawing/2014/main" id="{5316FA4C-6DB4-4DBB-8053-FE7207F2D54F}"/>
+                <a16:creationId xmlns:a16="http://schemas.microsoft.com/office/drawing/2014/main" id="{B45ADBC7-0FE6-441F-B6D3-3AEBEE633432}"/>
               </a:ext>
             </a:extLst>
           </p:cNvPr>
@@ -2092,7 +2092,7 @@
           <p:cNvPr id="12" name="">
             <a:extLst xmlns:a="http://schemas.openxmlformats.org/drawingml/2006/main">
               <a:ext uri="{FF2B5EF4-FFF2-40B4-BE49-F238E27FC236}">
-                <a16:creationId xmlns:a16="http://schemas.microsoft.com/office/drawing/2014/main" id="{0E8C0AB7-0E35-4B10-94BD-79F028E1FFB2}"/>
+                <a16:creationId xmlns:a16="http://schemas.microsoft.com/office/drawing/2014/main" id="{226B17BD-2F09-430A-9484-F23000A12447}"/>
               </a:ext>
             </a:extLst>
           </p:cNvPr>
@@ -2127,7 +2127,7 @@
           <p:cNvPr id="13" name="">
             <a:extLst xmlns:a="http://schemas.openxmlformats.org/drawingml/2006/main">
               <a:ext uri="{FF2B5EF4-FFF2-40B4-BE49-F238E27FC236}">
-                <a16:creationId xmlns:a16="http://schemas.microsoft.com/office/drawing/2014/main" id="{84282D44-D1B1-4D8E-85D7-056D2A7020D4}"/>
+                <a16:creationId xmlns:a16="http://schemas.microsoft.com/office/drawing/2014/main" id="{E2FCBBD3-6C06-4F6D-8B26-15280359CA52}"/>
               </a:ext>
             </a:extLst>
           </p:cNvPr>
@@ -2191,7 +2191,7 @@
           <p:cNvPr id="14" name="">
             <a:extLst xmlns:a="http://schemas.openxmlformats.org/drawingml/2006/main">
               <a:ext uri="{FF2B5EF4-FFF2-40B4-BE49-F238E27FC236}">
-                <a16:creationId xmlns:a16="http://schemas.microsoft.com/office/drawing/2014/main" id="{5DF25B7C-62E6-4EA0-941E-2C03279A27DC}"/>
+                <a16:creationId xmlns:a16="http://schemas.microsoft.com/office/drawing/2014/main" id="{90BFC28E-2013-4E95-B274-B324615334FF}"/>
               </a:ext>
             </a:extLst>
           </p:cNvPr>
@@ -2255,7 +2255,7 @@
           <p:cNvPr id="15" name="">
             <a:extLst xmlns:a="http://schemas.openxmlformats.org/drawingml/2006/main">
               <a:ext uri="{FF2B5EF4-FFF2-40B4-BE49-F238E27FC236}">
-                <a16:creationId xmlns:a16="http://schemas.microsoft.com/office/drawing/2014/main" id="{A141CB4D-7360-4EA3-8203-CBB9408BF276}"/>
+                <a16:creationId xmlns:a16="http://schemas.microsoft.com/office/drawing/2014/main" id="{0E47BE87-0B32-42F3-A8E7-6CF2050B61C3}"/>
               </a:ext>
             </a:extLst>
           </p:cNvPr>
@@ -2319,7 +2319,7 @@
           <p:cNvPr id="16" name="">
             <a:extLst xmlns:a="http://schemas.openxmlformats.org/drawingml/2006/main">
               <a:ext uri="{FF2B5EF4-FFF2-40B4-BE49-F238E27FC236}">
-                <a16:creationId xmlns:a16="http://schemas.microsoft.com/office/drawing/2014/main" id="{0C58F718-956A-4D1A-B5F2-519B1328DC4B}"/>
+                <a16:creationId xmlns:a16="http://schemas.microsoft.com/office/drawing/2014/main" id="{EB488CA3-037F-42AC-9A54-D077806C58D4}"/>
               </a:ext>
             </a:extLst>
           </p:cNvPr>
@@ -2358,7 +2358,7 @@
           <p:nvPr/>
         </p:nvPicPr>
         <p:blipFill>
-          <a:blip xmlns:r="http://schemas.openxmlformats.org/officeDocument/2006/relationships" xmlns:a="http://schemas.openxmlformats.org/drawingml/2006/main" r:embed="Re7a4857b756941a4"/>
+          <a:blip xmlns:r="http://schemas.openxmlformats.org/officeDocument/2006/relationships" xmlns:a="http://schemas.openxmlformats.org/drawingml/2006/main" r:embed="R047f7ab835c44ae8"/>
           <a:srcRect xmlns:a="http://schemas.openxmlformats.org/drawingml/2006/main" l="20736" t="0" r="20736" b="0"/>
           <a:stretch xmlns:a="http://schemas.openxmlformats.org/drawingml/2006/main">
             <a:fillRect l="0" t="0" r="0" b="0"/>
@@ -2379,7 +2379,7 @@
           <p:cNvPr id="18" name="">
             <a:extLst xmlns:a="http://schemas.openxmlformats.org/drawingml/2006/main">
               <a:ext uri="{FF2B5EF4-FFF2-40B4-BE49-F238E27FC236}">
-                <a16:creationId xmlns:a16="http://schemas.microsoft.com/office/drawing/2014/main" id="{5C20E90A-6C28-421B-81DA-2643DCBB5D35}"/>
+                <a16:creationId xmlns:a16="http://schemas.microsoft.com/office/drawing/2014/main" id="{D8842FD1-AD6A-4062-8E71-1F13EE36367A}"/>
               </a:ext>
             </a:extLst>
           </p:cNvPr>
@@ -2416,7 +2416,7 @@
           <p:cNvPr id="19" name="">
             <a:extLst xmlns:a="http://schemas.openxmlformats.org/drawingml/2006/main">
               <a:ext uri="{FF2B5EF4-FFF2-40B4-BE49-F238E27FC236}">
-                <a16:creationId xmlns:a16="http://schemas.microsoft.com/office/drawing/2014/main" id="{C358E484-D9D4-4A46-B7B5-A0016E6030E9}"/>
+                <a16:creationId xmlns:a16="http://schemas.microsoft.com/office/drawing/2014/main" id="{79455A79-5817-4E07-8B7F-3A365D4912D1}"/>
               </a:ext>
             </a:extLst>
           </p:cNvPr>
@@ -2478,7 +2478,7 @@
     </p:spTree>
     <p:extLst>
       <p:ext uri="{BB962C8B-B14F-4D97-AF65-F5344CB8AC3E}">
-        <p14:creationId xmlns:p14="http://schemas.microsoft.com/office/powerpoint/2010/main" val="1745942232"/>
+        <p14:creationId xmlns:p14="http://schemas.microsoft.com/office/powerpoint/2010/main" val="277563566"/>
       </p:ext>
     </p:extLst>
   </p:cSld>
@@ -2502,7 +2502,7 @@
           <p:cNvPr id="1" name="">
             <a:extLst xmlns:a="http://schemas.openxmlformats.org/drawingml/2006/main">
               <a:ext uri="{FF2B5EF4-FFF2-40B4-BE49-F238E27FC236}">
-                <a16:creationId xmlns:a16="http://schemas.microsoft.com/office/drawing/2014/main" id="{C734DCFC-BAEF-4F90-9197-45E2CC91FCD0}"/>
+                <a16:creationId xmlns:a16="http://schemas.microsoft.com/office/drawing/2014/main" id="{EA1511E8-C410-4BCF-A050-9C46C16F83F2}"/>
               </a:ext>
             </a:extLst>
           </p:cNvPr>
@@ -2537,7 +2537,7 @@
           <p:cNvPr id="2" name="">
             <a:extLst xmlns:a="http://schemas.openxmlformats.org/drawingml/2006/main">
               <a:ext uri="{FF2B5EF4-FFF2-40B4-BE49-F238E27FC236}">
-                <a16:creationId xmlns:a16="http://schemas.microsoft.com/office/drawing/2014/main" id="{481C4319-EB9A-4DD9-A2FC-80DF0510A122}"/>
+                <a16:creationId xmlns:a16="http://schemas.microsoft.com/office/drawing/2014/main" id="{E823694E-1D65-4E0C-A12A-0F1A9AC18C49}"/>
               </a:ext>
             </a:extLst>
           </p:cNvPr>
@@ -2572,7 +2572,7 @@
           <p:cNvPr id="3" name="">
             <a:extLst xmlns:a="http://schemas.openxmlformats.org/drawingml/2006/main">
               <a:ext uri="{FF2B5EF4-FFF2-40B4-BE49-F238E27FC236}">
-                <a16:creationId xmlns:a16="http://schemas.microsoft.com/office/drawing/2014/main" id="{833A8088-237D-4324-8DB4-F4E89E3BC2C8}"/>
+                <a16:creationId xmlns:a16="http://schemas.microsoft.com/office/drawing/2014/main" id="{37B83E4D-D2F1-4A85-8291-A8D1F354FF0D}"/>
               </a:ext>
             </a:extLst>
           </p:cNvPr>
@@ -2636,7 +2636,7 @@
           <p:cNvPr id="4" name="">
             <a:extLst xmlns:a="http://schemas.openxmlformats.org/drawingml/2006/main">
               <a:ext uri="{FF2B5EF4-FFF2-40B4-BE49-F238E27FC236}">
-                <a16:creationId xmlns:a16="http://schemas.microsoft.com/office/drawing/2014/main" id="{F5ACF1A7-9B53-4B30-AA72-6C7F6B51B982}"/>
+                <a16:creationId xmlns:a16="http://schemas.microsoft.com/office/drawing/2014/main" id="{84A76CD1-5E06-4A92-9A07-A4D42506633D}"/>
               </a:ext>
             </a:extLst>
           </p:cNvPr>
@@ -2700,7 +2700,7 @@
           <p:cNvPr id="5" name="">
             <a:extLst xmlns:a="http://schemas.openxmlformats.org/drawingml/2006/main">
               <a:ext uri="{FF2B5EF4-FFF2-40B4-BE49-F238E27FC236}">
-                <a16:creationId xmlns:a16="http://schemas.microsoft.com/office/drawing/2014/main" id="{11466233-4F24-410A-9CB3-9552C266028D}"/>
+                <a16:creationId xmlns:a16="http://schemas.microsoft.com/office/drawing/2014/main" id="{A84D77A7-7DF8-43C1-A283-CCF0CD874CBC}"/>
               </a:ext>
             </a:extLst>
           </p:cNvPr>
@@ -2764,7 +2764,7 @@
           <p:cNvPr id="6" name="">
             <a:extLst xmlns:a="http://schemas.openxmlformats.org/drawingml/2006/main">
               <a:ext uri="{FF2B5EF4-FFF2-40B4-BE49-F238E27FC236}">
-                <a16:creationId xmlns:a16="http://schemas.microsoft.com/office/drawing/2014/main" id="{0A73D9BA-7DA5-4600-84FE-99143514754F}"/>
+                <a16:creationId xmlns:a16="http://schemas.microsoft.com/office/drawing/2014/main" id="{D6C40314-ED05-4935-9E46-3569075AA363}"/>
               </a:ext>
             </a:extLst>
           </p:cNvPr>
@@ -2828,7 +2828,7 @@
           <p:cNvPr id="7" name="">
             <a:extLst xmlns:a="http://schemas.openxmlformats.org/drawingml/2006/main">
               <a:ext uri="{FF2B5EF4-FFF2-40B4-BE49-F238E27FC236}">
-                <a16:creationId xmlns:a16="http://schemas.microsoft.com/office/drawing/2014/main" id="{087CB317-600A-4FBC-B19F-9819A9A6378E}"/>
+                <a16:creationId xmlns:a16="http://schemas.microsoft.com/office/drawing/2014/main" id="{8604230F-378B-468A-BD3C-6921BE8222C9}"/>
               </a:ext>
             </a:extLst>
           </p:cNvPr>
@@ -2892,7 +2892,7 @@
           <p:cNvPr id="8" name="">
             <a:extLst xmlns:a="http://schemas.openxmlformats.org/drawingml/2006/main">
               <a:ext uri="{FF2B5EF4-FFF2-40B4-BE49-F238E27FC236}">
-                <a16:creationId xmlns:a16="http://schemas.microsoft.com/office/drawing/2014/main" id="{3E3E7AAB-2820-4E34-9702-2CAB921EE6D2}"/>
+                <a16:creationId xmlns:a16="http://schemas.microsoft.com/office/drawing/2014/main" id="{96C3D923-B0E2-4B43-88B8-2927D4B87A6B}"/>
               </a:ext>
             </a:extLst>
           </p:cNvPr>
@@ -2925,7 +2925,7 @@
           <p:cNvPr id="9" name="">
             <a:extLst xmlns:a="http://schemas.openxmlformats.org/drawingml/2006/main">
               <a:ext uri="{FF2B5EF4-FFF2-40B4-BE49-F238E27FC236}">
-                <a16:creationId xmlns:a16="http://schemas.microsoft.com/office/drawing/2014/main" id="{1A270BCD-D437-4780-BB55-8CFEACFA8751}"/>
+                <a16:creationId xmlns:a16="http://schemas.microsoft.com/office/drawing/2014/main" id="{340FBF0E-7B08-478C-B24C-549BEA1FE97D}"/>
               </a:ext>
             </a:extLst>
           </p:cNvPr>
@@ -2989,7 +2989,7 @@
           <p:cNvPr id="10" name="">
             <a:extLst xmlns:a="http://schemas.openxmlformats.org/drawingml/2006/main">
               <a:ext uri="{FF2B5EF4-FFF2-40B4-BE49-F238E27FC236}">
-                <a16:creationId xmlns:a16="http://schemas.microsoft.com/office/drawing/2014/main" id="{B983E8D8-9236-4881-97AD-59B8F08C2B90}"/>
+                <a16:creationId xmlns:a16="http://schemas.microsoft.com/office/drawing/2014/main" id="{EA4BCAD3-B463-4C67-8C25-08C2D9CDAB6D}"/>
               </a:ext>
             </a:extLst>
           </p:cNvPr>
@@ -3053,7 +3053,7 @@
           <p:cNvPr id="11" name="">
             <a:extLst xmlns:a="http://schemas.openxmlformats.org/drawingml/2006/main">
               <a:ext uri="{FF2B5EF4-FFF2-40B4-BE49-F238E27FC236}">
-                <a16:creationId xmlns:a16="http://schemas.microsoft.com/office/drawing/2014/main" id="{EF9C53E3-F200-4920-B8AB-6C643DC398BE}"/>
+                <a16:creationId xmlns:a16="http://schemas.microsoft.com/office/drawing/2014/main" id="{52EAAB18-DEF8-4AEF-8E5C-7BD4CAB85492}"/>
               </a:ext>
             </a:extLst>
           </p:cNvPr>
@@ -3088,7 +3088,7 @@
           <p:cNvPr id="12" name="">
             <a:extLst xmlns:a="http://schemas.openxmlformats.org/drawingml/2006/main">
               <a:ext uri="{FF2B5EF4-FFF2-40B4-BE49-F238E27FC236}">
-                <a16:creationId xmlns:a16="http://schemas.microsoft.com/office/drawing/2014/main" id="{D87ABD90-6ED1-4678-9A6E-57795F1DD012}"/>
+                <a16:creationId xmlns:a16="http://schemas.microsoft.com/office/drawing/2014/main" id="{E54B2EA4-5A57-4548-943A-FDEA038EF886}"/>
               </a:ext>
             </a:extLst>
           </p:cNvPr>
@@ -3123,7 +3123,7 @@
           <p:cNvPr id="13" name="">
             <a:extLst xmlns:a="http://schemas.openxmlformats.org/drawingml/2006/main">
               <a:ext uri="{FF2B5EF4-FFF2-40B4-BE49-F238E27FC236}">
-                <a16:creationId xmlns:a16="http://schemas.microsoft.com/office/drawing/2014/main" id="{5BB778E3-E716-4E00-A39F-9D0FF5AC1DC9}"/>
+                <a16:creationId xmlns:a16="http://schemas.microsoft.com/office/drawing/2014/main" id="{B4C659B5-7870-45CB-BBDD-BE9C786336A7}"/>
               </a:ext>
             </a:extLst>
           </p:cNvPr>
@@ -3187,7 +3187,7 @@
           <p:cNvPr id="14" name="">
             <a:extLst xmlns:a="http://schemas.openxmlformats.org/drawingml/2006/main">
               <a:ext uri="{FF2B5EF4-FFF2-40B4-BE49-F238E27FC236}">
-                <a16:creationId xmlns:a16="http://schemas.microsoft.com/office/drawing/2014/main" id="{32EACF1D-1774-4990-B124-F23ACF496EC5}"/>
+                <a16:creationId xmlns:a16="http://schemas.microsoft.com/office/drawing/2014/main" id="{BD31D58C-345D-480A-9D77-04F9363230F2}"/>
               </a:ext>
             </a:extLst>
           </p:cNvPr>
@@ -3251,7 +3251,7 @@
           <p:cNvPr id="15" name="">
             <a:extLst xmlns:a="http://schemas.openxmlformats.org/drawingml/2006/main">
               <a:ext uri="{FF2B5EF4-FFF2-40B4-BE49-F238E27FC236}">
-                <a16:creationId xmlns:a16="http://schemas.microsoft.com/office/drawing/2014/main" id="{B08B56FE-67B1-4567-A329-9240FD877D2E}"/>
+                <a16:creationId xmlns:a16="http://schemas.microsoft.com/office/drawing/2014/main" id="{B31916C0-BE72-4859-B42B-7022306FEAFD}"/>
               </a:ext>
             </a:extLst>
           </p:cNvPr>
@@ -3286,7 +3286,7 @@
           <p:cNvPr id="16" name="">
             <a:extLst xmlns:a="http://schemas.openxmlformats.org/drawingml/2006/main">
               <a:ext uri="{FF2B5EF4-FFF2-40B4-BE49-F238E27FC236}">
-                <a16:creationId xmlns:a16="http://schemas.microsoft.com/office/drawing/2014/main" id="{DE15FA99-3EA2-45E6-83BB-886E9CACDB60}"/>
+                <a16:creationId xmlns:a16="http://schemas.microsoft.com/office/drawing/2014/main" id="{2622ACDD-6E8D-4C4C-BF5B-856F72B3AAEA}"/>
               </a:ext>
             </a:extLst>
           </p:cNvPr>
@@ -3350,7 +3350,7 @@
           <p:cNvPr id="17" name="">
             <a:extLst xmlns:a="http://schemas.openxmlformats.org/drawingml/2006/main">
               <a:ext uri="{FF2B5EF4-FFF2-40B4-BE49-F238E27FC236}">
-                <a16:creationId xmlns:a16="http://schemas.microsoft.com/office/drawing/2014/main" id="{4D6795D3-60DD-4D55-BE5D-3EE11AF5322A}"/>
+                <a16:creationId xmlns:a16="http://schemas.microsoft.com/office/drawing/2014/main" id="{0114ABA7-27B9-4698-BCC7-7416BD67BE2F}"/>
               </a:ext>
             </a:extLst>
           </p:cNvPr>
@@ -3414,7 +3414,7 @@
           <p:cNvPr id="18" name="">
             <a:extLst xmlns:a="http://schemas.openxmlformats.org/drawingml/2006/main">
               <a:ext uri="{FF2B5EF4-FFF2-40B4-BE49-F238E27FC236}">
-                <a16:creationId xmlns:a16="http://schemas.microsoft.com/office/drawing/2014/main" id="{337A7171-F3BA-464E-9BF2-CA991D13F591}"/>
+                <a16:creationId xmlns:a16="http://schemas.microsoft.com/office/drawing/2014/main" id="{13CF040A-1411-429D-B731-A26909BC5DD5}"/>
               </a:ext>
             </a:extLst>
           </p:cNvPr>
@@ -3449,7 +3449,7 @@
           <p:cNvPr id="19" name="">
             <a:extLst xmlns:a="http://schemas.openxmlformats.org/drawingml/2006/main">
               <a:ext uri="{FF2B5EF4-FFF2-40B4-BE49-F238E27FC236}">
-                <a16:creationId xmlns:a16="http://schemas.microsoft.com/office/drawing/2014/main" id="{2A2F3D41-615D-4460-A370-A02A8EC23BDC}"/>
+                <a16:creationId xmlns:a16="http://schemas.microsoft.com/office/drawing/2014/main" id="{778D383E-9ABC-4507-8C2A-ACB14AED59B5}"/>
               </a:ext>
             </a:extLst>
           </p:cNvPr>
@@ -3513,7 +3513,7 @@
           <p:cNvPr id="20" name="">
             <a:extLst xmlns:a="http://schemas.openxmlformats.org/drawingml/2006/main">
               <a:ext uri="{FF2B5EF4-FFF2-40B4-BE49-F238E27FC236}">
-                <a16:creationId xmlns:a16="http://schemas.microsoft.com/office/drawing/2014/main" id="{62DE1662-8A85-4A55-8896-FE6EA4601AC7}"/>
+                <a16:creationId xmlns:a16="http://schemas.microsoft.com/office/drawing/2014/main" id="{CA4918B7-414B-450E-8108-664E46FB1900}"/>
               </a:ext>
             </a:extLst>
           </p:cNvPr>
@@ -3577,7 +3577,7 @@
           <p:cNvPr id="21" name="">
             <a:extLst xmlns:a="http://schemas.openxmlformats.org/drawingml/2006/main">
               <a:ext uri="{FF2B5EF4-FFF2-40B4-BE49-F238E27FC236}">
-                <a16:creationId xmlns:a16="http://schemas.microsoft.com/office/drawing/2014/main" id="{7CECBD84-5BD9-40AF-AD27-A846FA33E64F}"/>
+                <a16:creationId xmlns:a16="http://schemas.microsoft.com/office/drawing/2014/main" id="{AAF81894-8C7D-469E-88AD-473520D097B9}"/>
               </a:ext>
             </a:extLst>
           </p:cNvPr>
@@ -3639,7 +3639,7 @@
     </p:spTree>
     <p:extLst>
       <p:ext uri="{BB962C8B-B14F-4D97-AF65-F5344CB8AC3E}">
-        <p14:creationId xmlns:p14="http://schemas.microsoft.com/office/powerpoint/2010/main" val="233184275"/>
+        <p14:creationId xmlns:p14="http://schemas.microsoft.com/office/powerpoint/2010/main" val="1687980533"/>
       </p:ext>
     </p:extLst>
   </p:cSld>
@@ -3663,7 +3663,7 @@
           <p:cNvPr id="1" name="">
             <a:extLst xmlns:a="http://schemas.openxmlformats.org/drawingml/2006/main">
               <a:ext uri="{FF2B5EF4-FFF2-40B4-BE49-F238E27FC236}">
-                <a16:creationId xmlns:a16="http://schemas.microsoft.com/office/drawing/2014/main" id="{CF5120C9-25B7-4E2F-8FB0-0302DA48D581}"/>
+                <a16:creationId xmlns:a16="http://schemas.microsoft.com/office/drawing/2014/main" id="{1FD80376-A7B3-46C8-A08B-54FA62D8671F}"/>
               </a:ext>
             </a:extLst>
           </p:cNvPr>
@@ -3698,7 +3698,7 @@
           <p:cNvPr id="2" name="">
             <a:extLst xmlns:a="http://schemas.openxmlformats.org/drawingml/2006/main">
               <a:ext uri="{FF2B5EF4-FFF2-40B4-BE49-F238E27FC236}">
-                <a16:creationId xmlns:a16="http://schemas.microsoft.com/office/drawing/2014/main" id="{D00E959A-165D-4193-8E36-527F2B5DBF49}"/>
+                <a16:creationId xmlns:a16="http://schemas.microsoft.com/office/drawing/2014/main" id="{AB2590E2-9548-4E0E-A0DF-916137E9ECFD}"/>
               </a:ext>
             </a:extLst>
           </p:cNvPr>
@@ -3733,7 +3733,7 @@
           <p:cNvPr id="3" name="">
             <a:extLst xmlns:a="http://schemas.openxmlformats.org/drawingml/2006/main">
               <a:ext uri="{FF2B5EF4-FFF2-40B4-BE49-F238E27FC236}">
-                <a16:creationId xmlns:a16="http://schemas.microsoft.com/office/drawing/2014/main" id="{64E2992D-EA0D-4757-93B2-D83FE1687FE3}"/>
+                <a16:creationId xmlns:a16="http://schemas.microsoft.com/office/drawing/2014/main" id="{1C3058A6-8F15-4AAD-8BE6-A54ED14816AF}"/>
               </a:ext>
             </a:extLst>
           </p:cNvPr>
@@ -3797,7 +3797,7 @@
           <p:cNvPr id="4" name="">
             <a:extLst xmlns:a="http://schemas.openxmlformats.org/drawingml/2006/main">
               <a:ext uri="{FF2B5EF4-FFF2-40B4-BE49-F238E27FC236}">
-                <a16:creationId xmlns:a16="http://schemas.microsoft.com/office/drawing/2014/main" id="{862CDC91-7BB6-4C1C-92E9-4A771DC2065B}"/>
+                <a16:creationId xmlns:a16="http://schemas.microsoft.com/office/drawing/2014/main" id="{010D06F6-5177-4D5D-9F9C-08931FEBDA18}"/>
               </a:ext>
             </a:extLst>
           </p:cNvPr>
@@ -3861,7 +3861,7 @@
           <p:cNvPr id="5" name="">
             <a:extLst xmlns:a="http://schemas.openxmlformats.org/drawingml/2006/main">
               <a:ext uri="{FF2B5EF4-FFF2-40B4-BE49-F238E27FC236}">
-                <a16:creationId xmlns:a16="http://schemas.microsoft.com/office/drawing/2014/main" id="{16D862AB-E870-4149-AF02-66B29403FBC3}"/>
+                <a16:creationId xmlns:a16="http://schemas.microsoft.com/office/drawing/2014/main" id="{D9F6145D-6A78-4352-8CCA-AF6F8E4ABB98}"/>
               </a:ext>
             </a:extLst>
           </p:cNvPr>
@@ -3925,7 +3925,7 @@
           <p:cNvPr id="6" name="">
             <a:extLst xmlns:a="http://schemas.openxmlformats.org/drawingml/2006/main">
               <a:ext uri="{FF2B5EF4-FFF2-40B4-BE49-F238E27FC236}">
-                <a16:creationId xmlns:a16="http://schemas.microsoft.com/office/drawing/2014/main" id="{41EE830C-2A21-4886-9740-C36FA11A5D0F}"/>
+                <a16:creationId xmlns:a16="http://schemas.microsoft.com/office/drawing/2014/main" id="{10353A3D-DDB4-4F43-A19B-6481900E40F9}"/>
               </a:ext>
             </a:extLst>
           </p:cNvPr>
@@ -3989,7 +3989,7 @@
           <p:cNvPr id="7" name="">
             <a:extLst xmlns:a="http://schemas.openxmlformats.org/drawingml/2006/main">
               <a:ext uri="{FF2B5EF4-FFF2-40B4-BE49-F238E27FC236}">
-                <a16:creationId xmlns:a16="http://schemas.microsoft.com/office/drawing/2014/main" id="{480EC114-635F-4B84-931E-42225247F494}"/>
+                <a16:creationId xmlns:a16="http://schemas.microsoft.com/office/drawing/2014/main" id="{08A900D0-D694-4760-982F-0BCF151047A2}"/>
               </a:ext>
             </a:extLst>
           </p:cNvPr>
@@ -4026,7 +4026,7 @@
           <p:nvPr/>
         </p:nvPicPr>
         <p:blipFill>
-          <a:blip xmlns:r="http://schemas.openxmlformats.org/officeDocument/2006/relationships" xmlns:a="http://schemas.openxmlformats.org/drawingml/2006/main" r:embed="R77677536fc794330"/>
+          <a:blip xmlns:r="http://schemas.openxmlformats.org/officeDocument/2006/relationships" xmlns:a="http://schemas.openxmlformats.org/drawingml/2006/main" r:embed="Rf28d854083944c6e"/>
           <a:stretch xmlns:a="http://schemas.openxmlformats.org/drawingml/2006/main"/>
         </p:blipFill>
         <p:spPr>
@@ -4044,7 +4044,7 @@
           <p:cNvPr id="9" name="">
             <a:extLst xmlns:a="http://schemas.openxmlformats.org/drawingml/2006/main">
               <a:ext uri="{FF2B5EF4-FFF2-40B4-BE49-F238E27FC236}">
-                <a16:creationId xmlns:a16="http://schemas.microsoft.com/office/drawing/2014/main" id="{3DAD0DD0-E192-447F-AC8F-1355FD846881}"/>
+                <a16:creationId xmlns:a16="http://schemas.microsoft.com/office/drawing/2014/main" id="{05CFDF3D-FD7A-478E-8641-1A4581DB5DCF}"/>
               </a:ext>
             </a:extLst>
           </p:cNvPr>
@@ -4079,7 +4079,7 @@
           <p:cNvPr id="10" name="">
             <a:extLst xmlns:a="http://schemas.openxmlformats.org/drawingml/2006/main">
               <a:ext uri="{FF2B5EF4-FFF2-40B4-BE49-F238E27FC236}">
-                <a16:creationId xmlns:a16="http://schemas.microsoft.com/office/drawing/2014/main" id="{89711C4F-F9E7-4E40-A50F-0873BECA2CF8}"/>
+                <a16:creationId xmlns:a16="http://schemas.microsoft.com/office/drawing/2014/main" id="{706600DC-7C08-48C0-BC25-B46FD7467BDD}"/>
               </a:ext>
             </a:extLst>
           </p:cNvPr>
@@ -4143,7 +4143,7 @@
           <p:cNvPr id="11" name="">
             <a:extLst xmlns:a="http://schemas.openxmlformats.org/drawingml/2006/main">
               <a:ext uri="{FF2B5EF4-FFF2-40B4-BE49-F238E27FC236}">
-                <a16:creationId xmlns:a16="http://schemas.microsoft.com/office/drawing/2014/main" id="{536F569C-1C1A-478E-860C-797DE2CCF7A0}"/>
+                <a16:creationId xmlns:a16="http://schemas.microsoft.com/office/drawing/2014/main" id="{630963BA-198B-4BF6-AF07-EAFDBC4CAF8F}"/>
               </a:ext>
             </a:extLst>
           </p:cNvPr>
@@ -4178,7 +4178,7 @@
           <p:cNvPr id="12" name="">
             <a:extLst xmlns:a="http://schemas.openxmlformats.org/drawingml/2006/main">
               <a:ext uri="{FF2B5EF4-FFF2-40B4-BE49-F238E27FC236}">
-                <a16:creationId xmlns:a16="http://schemas.microsoft.com/office/drawing/2014/main" id="{8547F6BD-53CE-433A-9B18-4919237F56DE}"/>
+                <a16:creationId xmlns:a16="http://schemas.microsoft.com/office/drawing/2014/main" id="{2882E377-7D42-412F-98D2-5D380D13D5D5}"/>
               </a:ext>
             </a:extLst>
           </p:cNvPr>
@@ -4242,7 +4242,7 @@
           <p:cNvPr id="13" name="">
             <a:extLst xmlns:a="http://schemas.openxmlformats.org/drawingml/2006/main">
               <a:ext uri="{FF2B5EF4-FFF2-40B4-BE49-F238E27FC236}">
-                <a16:creationId xmlns:a16="http://schemas.microsoft.com/office/drawing/2014/main" id="{51FD148D-CEF9-4A07-B27E-42AE7D81067C}"/>
+                <a16:creationId xmlns:a16="http://schemas.microsoft.com/office/drawing/2014/main" id="{333A609F-FBB1-4B34-9185-77A75F4945BC}"/>
               </a:ext>
             </a:extLst>
           </p:cNvPr>
@@ -4277,7 +4277,7 @@
           <p:cNvPr id="14" name="">
             <a:extLst xmlns:a="http://schemas.openxmlformats.org/drawingml/2006/main">
               <a:ext uri="{FF2B5EF4-FFF2-40B4-BE49-F238E27FC236}">
-                <a16:creationId xmlns:a16="http://schemas.microsoft.com/office/drawing/2014/main" id="{810F8AE3-B9FF-45C0-B7BA-3338CFA12386}"/>
+                <a16:creationId xmlns:a16="http://schemas.microsoft.com/office/drawing/2014/main" id="{DE267151-0B91-400B-9AC5-374A6A325A62}"/>
               </a:ext>
             </a:extLst>
           </p:cNvPr>
@@ -4341,7 +4341,7 @@
           <p:cNvPr id="15" name="">
             <a:extLst xmlns:a="http://schemas.openxmlformats.org/drawingml/2006/main">
               <a:ext uri="{FF2B5EF4-FFF2-40B4-BE49-F238E27FC236}">
-                <a16:creationId xmlns:a16="http://schemas.microsoft.com/office/drawing/2014/main" id="{8D5DB897-9FD0-43F2-88BE-31ED41C556A6}"/>
+                <a16:creationId xmlns:a16="http://schemas.microsoft.com/office/drawing/2014/main" id="{7045E77A-99FF-40C9-8CEA-F75DA21A3D60}"/>
               </a:ext>
             </a:extLst>
           </p:cNvPr>
@@ -4403,7 +4403,7 @@
     </p:spTree>
     <p:extLst>
       <p:ext uri="{BB962C8B-B14F-4D97-AF65-F5344CB8AC3E}">
-        <p14:creationId xmlns:p14="http://schemas.microsoft.com/office/powerpoint/2010/main" val="1803389830"/>
+        <p14:creationId xmlns:p14="http://schemas.microsoft.com/office/powerpoint/2010/main" val="1532142870"/>
       </p:ext>
     </p:extLst>
   </p:cSld>
@@ -4431,7 +4431,7 @@
           <p:nvPr/>
         </p:nvPicPr>
         <p:blipFill>
-          <a:blip xmlns:r="http://schemas.openxmlformats.org/officeDocument/2006/relationships" xmlns:a="http://schemas.openxmlformats.org/drawingml/2006/main" r:embed="Rc77d563b98a84b9c"/>
+          <a:blip xmlns:r="http://schemas.openxmlformats.org/officeDocument/2006/relationships" xmlns:a="http://schemas.openxmlformats.org/drawingml/2006/main" r:embed="Ra62a33d844074f7d"/>
           <a:srcRect xmlns:a="http://schemas.openxmlformats.org/drawingml/2006/main" l="0" t="5284" r="0" b="5284"/>
           <a:stretch xmlns:a="http://schemas.openxmlformats.org/drawingml/2006/main">
             <a:fillRect l="0" t="0" r="0" b="0"/>
@@ -4452,7 +4452,7 @@
           <p:cNvPr id="2" name="">
             <a:extLst xmlns:a="http://schemas.openxmlformats.org/drawingml/2006/main">
               <a:ext uri="{FF2B5EF4-FFF2-40B4-BE49-F238E27FC236}">
-                <a16:creationId xmlns:a16="http://schemas.microsoft.com/office/drawing/2014/main" id="{9BD119EF-F446-467D-98D7-34FF900D2339}"/>
+                <a16:creationId xmlns:a16="http://schemas.microsoft.com/office/drawing/2014/main" id="{690D8D36-5466-48B0-8603-E08375E0D2B2}"/>
               </a:ext>
             </a:extLst>
           </p:cNvPr>
@@ -4489,7 +4489,7 @@
           <p:cNvPr id="3" name="">
             <a:extLst xmlns:a="http://schemas.openxmlformats.org/drawingml/2006/main">
               <a:ext uri="{FF2B5EF4-FFF2-40B4-BE49-F238E27FC236}">
-                <a16:creationId xmlns:a16="http://schemas.microsoft.com/office/drawing/2014/main" id="{43EF27DC-2EF8-4147-AFBA-BE256A14F71C}"/>
+                <a16:creationId xmlns:a16="http://schemas.microsoft.com/office/drawing/2014/main" id="{6BD632BC-C08C-4392-92FF-E07AB414DA25}"/>
               </a:ext>
             </a:extLst>
           </p:cNvPr>
@@ -4553,7 +4553,7 @@
           <p:cNvPr id="4" name="">
             <a:extLst xmlns:a="http://schemas.openxmlformats.org/drawingml/2006/main">
               <a:ext uri="{FF2B5EF4-FFF2-40B4-BE49-F238E27FC236}">
-                <a16:creationId xmlns:a16="http://schemas.microsoft.com/office/drawing/2014/main" id="{F6DB4368-0722-4453-8135-CA6D17FA156A}"/>
+                <a16:creationId xmlns:a16="http://schemas.microsoft.com/office/drawing/2014/main" id="{B1FE5D42-8A00-4608-B16D-9EA8FE87239C}"/>
               </a:ext>
             </a:extLst>
           </p:cNvPr>
@@ -4617,7 +4617,7 @@
           <p:cNvPr id="5" name="">
             <a:extLst xmlns:a="http://schemas.openxmlformats.org/drawingml/2006/main">
               <a:ext uri="{FF2B5EF4-FFF2-40B4-BE49-F238E27FC236}">
-                <a16:creationId xmlns:a16="http://schemas.microsoft.com/office/drawing/2014/main" id="{24FD366C-3319-459F-B450-407E32BF2F46}"/>
+                <a16:creationId xmlns:a16="http://schemas.microsoft.com/office/drawing/2014/main" id="{368F6B6D-5EE2-41AD-A125-3DD7B881C26F}"/>
               </a:ext>
             </a:extLst>
           </p:cNvPr>
@@ -4681,7 +4681,7 @@
           <p:cNvPr id="6" name="">
             <a:extLst xmlns:a="http://schemas.openxmlformats.org/drawingml/2006/main">
               <a:ext uri="{FF2B5EF4-FFF2-40B4-BE49-F238E27FC236}">
-                <a16:creationId xmlns:a16="http://schemas.microsoft.com/office/drawing/2014/main" id="{31C9EF9E-A938-4E15-B593-12F90ECD755A}"/>
+                <a16:creationId xmlns:a16="http://schemas.microsoft.com/office/drawing/2014/main" id="{1D8A1DC1-A4ED-4FDF-9A5D-DF6602210FEA}"/>
               </a:ext>
             </a:extLst>
           </p:cNvPr>
@@ -4745,7 +4745,7 @@
           <p:cNvPr id="7" name="">
             <a:extLst xmlns:a="http://schemas.openxmlformats.org/drawingml/2006/main">
               <a:ext uri="{FF2B5EF4-FFF2-40B4-BE49-F238E27FC236}">
-                <a16:creationId xmlns:a16="http://schemas.microsoft.com/office/drawing/2014/main" id="{F0ED9227-687D-4923-8D42-51CF2F33419B}"/>
+                <a16:creationId xmlns:a16="http://schemas.microsoft.com/office/drawing/2014/main" id="{C50FF977-127F-40C6-8F69-039356A761F3}"/>
               </a:ext>
             </a:extLst>
           </p:cNvPr>
@@ -4809,7 +4809,7 @@
           <p:cNvPr id="8" name="">
             <a:extLst xmlns:a="http://schemas.openxmlformats.org/drawingml/2006/main">
               <a:ext uri="{FF2B5EF4-FFF2-40B4-BE49-F238E27FC236}">
-                <a16:creationId xmlns:a16="http://schemas.microsoft.com/office/drawing/2014/main" id="{1ACB5366-2635-40A1-8BFB-BCAB545E1467}"/>
+                <a16:creationId xmlns:a16="http://schemas.microsoft.com/office/drawing/2014/main" id="{B964BD5A-F251-4BFD-8CA0-A1E0FC33C4DC}"/>
               </a:ext>
             </a:extLst>
           </p:cNvPr>
@@ -4873,7 +4873,7 @@
           <p:cNvPr id="9" name="">
             <a:extLst xmlns:a="http://schemas.openxmlformats.org/drawingml/2006/main">
               <a:ext uri="{FF2B5EF4-FFF2-40B4-BE49-F238E27FC236}">
-                <a16:creationId xmlns:a16="http://schemas.microsoft.com/office/drawing/2014/main" id="{3E03DE82-E500-4021-9544-5D1D24E62439}"/>
+                <a16:creationId xmlns:a16="http://schemas.microsoft.com/office/drawing/2014/main" id="{76CB77F1-8D91-44C3-9684-4301DC76C1F0}"/>
               </a:ext>
             </a:extLst>
           </p:cNvPr>
@@ -4937,7 +4937,7 @@
           <p:cNvPr id="10" name="">
             <a:extLst xmlns:a="http://schemas.openxmlformats.org/drawingml/2006/main">
               <a:ext uri="{FF2B5EF4-FFF2-40B4-BE49-F238E27FC236}">
-                <a16:creationId xmlns:a16="http://schemas.microsoft.com/office/drawing/2014/main" id="{6476B071-CAC7-4F5E-B78D-FBE2FA80B8EF}"/>
+                <a16:creationId xmlns:a16="http://schemas.microsoft.com/office/drawing/2014/main" id="{7DEB1596-E802-4E13-A787-93534A9BECCE}"/>
               </a:ext>
             </a:extLst>
           </p:cNvPr>
@@ -5001,7 +5001,7 @@
           <p:cNvPr id="11" name="">
             <a:extLst xmlns:a="http://schemas.openxmlformats.org/drawingml/2006/main">
               <a:ext uri="{FF2B5EF4-FFF2-40B4-BE49-F238E27FC236}">
-                <a16:creationId xmlns:a16="http://schemas.microsoft.com/office/drawing/2014/main" id="{7C1B962B-C42C-4F05-99FD-77BDEA75A1E3}"/>
+                <a16:creationId xmlns:a16="http://schemas.microsoft.com/office/drawing/2014/main" id="{69EBFD62-31A8-4B33-A036-3B35E36FC13C}"/>
               </a:ext>
             </a:extLst>
           </p:cNvPr>
@@ -5065,7 +5065,7 @@
           <p:cNvPr id="12" name="">
             <a:extLst xmlns:a="http://schemas.openxmlformats.org/drawingml/2006/main">
               <a:ext uri="{FF2B5EF4-FFF2-40B4-BE49-F238E27FC236}">
-                <a16:creationId xmlns:a16="http://schemas.microsoft.com/office/drawing/2014/main" id="{922CE91A-8239-4100-B345-9A8332D293C9}"/>
+                <a16:creationId xmlns:a16="http://schemas.microsoft.com/office/drawing/2014/main" id="{DF007C47-F1B3-401E-BD30-9C26704DF009}"/>
               </a:ext>
             </a:extLst>
           </p:cNvPr>
@@ -5129,7 +5129,7 @@
           <p:cNvPr id="13" name="">
             <a:extLst xmlns:a="http://schemas.openxmlformats.org/drawingml/2006/main">
               <a:ext uri="{FF2B5EF4-FFF2-40B4-BE49-F238E27FC236}">
-                <a16:creationId xmlns:a16="http://schemas.microsoft.com/office/drawing/2014/main" id="{2BAAC1B1-57BB-4742-A32E-EC2F289F3572}"/>
+                <a16:creationId xmlns:a16="http://schemas.microsoft.com/office/drawing/2014/main" id="{0BECF037-979A-411F-98E4-59A4B0239C6C}"/>
               </a:ext>
             </a:extLst>
           </p:cNvPr>
@@ -5193,7 +5193,7 @@
           <p:cNvPr id="14" name="">
             <a:extLst xmlns:a="http://schemas.openxmlformats.org/drawingml/2006/main">
               <a:ext uri="{FF2B5EF4-FFF2-40B4-BE49-F238E27FC236}">
-                <a16:creationId xmlns:a16="http://schemas.microsoft.com/office/drawing/2014/main" id="{9F28048B-4C09-4FC7-8EBE-FEDCF60CE67D}"/>
+                <a16:creationId xmlns:a16="http://schemas.microsoft.com/office/drawing/2014/main" id="{5A85AE9A-AFC9-40BA-8537-52BDEB2DE0F3}"/>
               </a:ext>
             </a:extLst>
           </p:cNvPr>
@@ -5255,7 +5255,7 @@
     </p:spTree>
     <p:extLst>
       <p:ext uri="{BB962C8B-B14F-4D97-AF65-F5344CB8AC3E}">
-        <p14:creationId xmlns:p14="http://schemas.microsoft.com/office/powerpoint/2010/main" val="1416640357"/>
+        <p14:creationId xmlns:p14="http://schemas.microsoft.com/office/powerpoint/2010/main" val="1626361533"/>
       </p:ext>
     </p:extLst>
   </p:cSld>
@@ -5279,7 +5279,7 @@
           <p:cNvPr id="1" name="">
             <a:extLst xmlns:a="http://schemas.openxmlformats.org/drawingml/2006/main">
               <a:ext uri="{FF2B5EF4-FFF2-40B4-BE49-F238E27FC236}">
-                <a16:creationId xmlns:a16="http://schemas.microsoft.com/office/drawing/2014/main" id="{D0E5FC3A-CAA2-43C1-9793-E681E5C83489}"/>
+                <a16:creationId xmlns:a16="http://schemas.microsoft.com/office/drawing/2014/main" id="{4D79E2E3-2697-4103-B169-C95095E06E4F}"/>
               </a:ext>
             </a:extLst>
           </p:cNvPr>
@@ -5314,7 +5314,7 @@
           <p:cNvPr id="2" name="">
             <a:extLst xmlns:a="http://schemas.openxmlformats.org/drawingml/2006/main">
               <a:ext uri="{FF2B5EF4-FFF2-40B4-BE49-F238E27FC236}">
-                <a16:creationId xmlns:a16="http://schemas.microsoft.com/office/drawing/2014/main" id="{906F25DF-0531-4C8E-803A-3C4D585B62FF}"/>
+                <a16:creationId xmlns:a16="http://schemas.microsoft.com/office/drawing/2014/main" id="{B846B61D-0DB0-4F74-9C5E-DF902F11D496}"/>
               </a:ext>
             </a:extLst>
           </p:cNvPr>
@@ -5349,7 +5349,7 @@
           <p:cNvPr id="3" name="">
             <a:extLst xmlns:a="http://schemas.openxmlformats.org/drawingml/2006/main">
               <a:ext uri="{FF2B5EF4-FFF2-40B4-BE49-F238E27FC236}">
-                <a16:creationId xmlns:a16="http://schemas.microsoft.com/office/drawing/2014/main" id="{1D580E41-20CF-4ECB-AE3D-21463515A52B}"/>
+                <a16:creationId xmlns:a16="http://schemas.microsoft.com/office/drawing/2014/main" id="{550AB26A-8BAA-4E84-AA30-AEDB49AA6A1B}"/>
               </a:ext>
             </a:extLst>
           </p:cNvPr>
@@ -5413,7 +5413,7 @@
           <p:cNvPr id="4" name="">
             <a:extLst xmlns:a="http://schemas.openxmlformats.org/drawingml/2006/main">
               <a:ext uri="{FF2B5EF4-FFF2-40B4-BE49-F238E27FC236}">
-                <a16:creationId xmlns:a16="http://schemas.microsoft.com/office/drawing/2014/main" id="{A504675A-2381-4B16-BFB1-5B7196684568}"/>
+                <a16:creationId xmlns:a16="http://schemas.microsoft.com/office/drawing/2014/main" id="{961C8D15-9C46-4C13-93A0-198CFE9CD3EB}"/>
               </a:ext>
             </a:extLst>
           </p:cNvPr>
@@ -5477,7 +5477,7 @@
           <p:cNvPr id="5" name="">
             <a:extLst xmlns:a="http://schemas.openxmlformats.org/drawingml/2006/main">
               <a:ext uri="{FF2B5EF4-FFF2-40B4-BE49-F238E27FC236}">
-                <a16:creationId xmlns:a16="http://schemas.microsoft.com/office/drawing/2014/main" id="{B0FC8C45-1A5B-4418-BD2B-09BBBE7D213D}"/>
+                <a16:creationId xmlns:a16="http://schemas.microsoft.com/office/drawing/2014/main" id="{A678878C-10AE-4EEE-884B-7B4F4B06010A}"/>
               </a:ext>
             </a:extLst>
           </p:cNvPr>
@@ -5541,7 +5541,7 @@
           <p:cNvPr id="6" name="">
             <a:extLst xmlns:a="http://schemas.openxmlformats.org/drawingml/2006/main">
               <a:ext uri="{FF2B5EF4-FFF2-40B4-BE49-F238E27FC236}">
-                <a16:creationId xmlns:a16="http://schemas.microsoft.com/office/drawing/2014/main" id="{AB3ED952-CE13-4973-9011-2757A72E201A}"/>
+                <a16:creationId xmlns:a16="http://schemas.microsoft.com/office/drawing/2014/main" id="{1C654DE8-42A9-4880-AA87-9533D32B3170}"/>
               </a:ext>
             </a:extLst>
           </p:cNvPr>
@@ -5605,7 +5605,7 @@
           <p:cNvPr id="7" name="">
             <a:extLst xmlns:a="http://schemas.openxmlformats.org/drawingml/2006/main">
               <a:ext uri="{FF2B5EF4-FFF2-40B4-BE49-F238E27FC236}">
-                <a16:creationId xmlns:a16="http://schemas.microsoft.com/office/drawing/2014/main" id="{D6674647-EA09-4CC8-A807-9652D52685F4}"/>
+                <a16:creationId xmlns:a16="http://schemas.microsoft.com/office/drawing/2014/main" id="{5B9F34D0-B978-47D9-BAFC-4EF038C86692}"/>
               </a:ext>
             </a:extLst>
           </p:cNvPr>
@@ -5638,7 +5638,7 @@
           <p:cNvPr id="8" name="">
             <a:extLst xmlns:a="http://schemas.openxmlformats.org/drawingml/2006/main">
               <a:ext uri="{FF2B5EF4-FFF2-40B4-BE49-F238E27FC236}">
-                <a16:creationId xmlns:a16="http://schemas.microsoft.com/office/drawing/2014/main" id="{5C4CF93F-3453-4F98-A175-3843333A4562}"/>
+                <a16:creationId xmlns:a16="http://schemas.microsoft.com/office/drawing/2014/main" id="{27D09625-1106-44AA-AC82-B0B22EBDD7BF}"/>
               </a:ext>
             </a:extLst>
           </p:cNvPr>
@@ -5673,7 +5673,7 @@
           <p:cNvPr id="9" name="">
             <a:extLst xmlns:a="http://schemas.openxmlformats.org/drawingml/2006/main">
               <a:ext uri="{FF2B5EF4-FFF2-40B4-BE49-F238E27FC236}">
-                <a16:creationId xmlns:a16="http://schemas.microsoft.com/office/drawing/2014/main" id="{FEDC2345-A4F0-4761-8EF2-60571FA28010}"/>
+                <a16:creationId xmlns:a16="http://schemas.microsoft.com/office/drawing/2014/main" id="{D2CEE26E-F589-4461-9E7F-F4D658EFC38B}"/>
               </a:ext>
             </a:extLst>
           </p:cNvPr>
@@ -5737,7 +5737,7 @@
           <p:cNvPr id="10" name="">
             <a:extLst xmlns:a="http://schemas.openxmlformats.org/drawingml/2006/main">
               <a:ext uri="{FF2B5EF4-FFF2-40B4-BE49-F238E27FC236}">
-                <a16:creationId xmlns:a16="http://schemas.microsoft.com/office/drawing/2014/main" id="{9B5557DA-B9FB-4091-B2E4-6E23DF97550E}"/>
+                <a16:creationId xmlns:a16="http://schemas.microsoft.com/office/drawing/2014/main" id="{830BD67E-0E69-4DE5-B145-71928A7E69DA}"/>
               </a:ext>
             </a:extLst>
           </p:cNvPr>
@@ -5801,7 +5801,7 @@
           <p:cNvPr id="11" name="">
             <a:extLst xmlns:a="http://schemas.openxmlformats.org/drawingml/2006/main">
               <a:ext uri="{FF2B5EF4-FFF2-40B4-BE49-F238E27FC236}">
-                <a16:creationId xmlns:a16="http://schemas.microsoft.com/office/drawing/2014/main" id="{69F78257-1305-4C89-920D-C8E6398C7D1A}"/>
+                <a16:creationId xmlns:a16="http://schemas.microsoft.com/office/drawing/2014/main" id="{14A262D3-47FE-48D9-BDAA-881A966323B9}"/>
               </a:ext>
             </a:extLst>
           </p:cNvPr>
@@ -5865,7 +5865,7 @@
           <p:cNvPr id="12" name="">
             <a:extLst xmlns:a="http://schemas.openxmlformats.org/drawingml/2006/main">
               <a:ext uri="{FF2B5EF4-FFF2-40B4-BE49-F238E27FC236}">
-                <a16:creationId xmlns:a16="http://schemas.microsoft.com/office/drawing/2014/main" id="{E9A97931-8F14-46D4-891B-B3EAF7A31C63}"/>
+                <a16:creationId xmlns:a16="http://schemas.microsoft.com/office/drawing/2014/main" id="{DBFD3B7B-15C5-428D-87C4-E6619620D7BE}"/>
               </a:ext>
             </a:extLst>
           </p:cNvPr>
@@ -5900,7 +5900,7 @@
           <p:cNvPr id="13" name="">
             <a:extLst xmlns:a="http://schemas.openxmlformats.org/drawingml/2006/main">
               <a:ext uri="{FF2B5EF4-FFF2-40B4-BE49-F238E27FC236}">
-                <a16:creationId xmlns:a16="http://schemas.microsoft.com/office/drawing/2014/main" id="{A5204E9B-B080-4147-B1D3-272769D65CF2}"/>
+                <a16:creationId xmlns:a16="http://schemas.microsoft.com/office/drawing/2014/main" id="{50DF11D6-16FA-41BD-B1BA-5A77E953D0AC}"/>
               </a:ext>
             </a:extLst>
           </p:cNvPr>
@@ -5964,7 +5964,7 @@
           <p:cNvPr id="14" name="">
             <a:extLst xmlns:a="http://schemas.openxmlformats.org/drawingml/2006/main">
               <a:ext uri="{FF2B5EF4-FFF2-40B4-BE49-F238E27FC236}">
-                <a16:creationId xmlns:a16="http://schemas.microsoft.com/office/drawing/2014/main" id="{ED20FA06-8B02-4371-8745-5B439401C77C}"/>
+                <a16:creationId xmlns:a16="http://schemas.microsoft.com/office/drawing/2014/main" id="{92246B25-1C8A-4CFA-8662-DCE0F8CCDFDE}"/>
               </a:ext>
             </a:extLst>
           </p:cNvPr>
@@ -5997,7 +5997,7 @@
           <p:cNvPr id="15" name="">
             <a:extLst xmlns:a="http://schemas.openxmlformats.org/drawingml/2006/main">
               <a:ext uri="{FF2B5EF4-FFF2-40B4-BE49-F238E27FC236}">
-                <a16:creationId xmlns:a16="http://schemas.microsoft.com/office/drawing/2014/main" id="{554E7B59-48B0-40CE-8818-7120DA742A24}"/>
+                <a16:creationId xmlns:a16="http://schemas.microsoft.com/office/drawing/2014/main" id="{C92E52D0-B783-4078-A664-8C6E3AC24CB8}"/>
               </a:ext>
             </a:extLst>
           </p:cNvPr>
@@ -6032,7 +6032,7 @@
           <p:cNvPr id="16" name="">
             <a:extLst xmlns:a="http://schemas.openxmlformats.org/drawingml/2006/main">
               <a:ext uri="{FF2B5EF4-FFF2-40B4-BE49-F238E27FC236}">
-                <a16:creationId xmlns:a16="http://schemas.microsoft.com/office/drawing/2014/main" id="{7BDA9B13-F52B-4B6A-A4D5-C16723337E48}"/>
+                <a16:creationId xmlns:a16="http://schemas.microsoft.com/office/drawing/2014/main" id="{9BCCC657-68A5-464D-80A0-69C4ED0E59C7}"/>
               </a:ext>
             </a:extLst>
           </p:cNvPr>
@@ -6096,7 +6096,7 @@
           <p:cNvPr id="17" name="">
             <a:extLst xmlns:a="http://schemas.openxmlformats.org/drawingml/2006/main">
               <a:ext uri="{FF2B5EF4-FFF2-40B4-BE49-F238E27FC236}">
-                <a16:creationId xmlns:a16="http://schemas.microsoft.com/office/drawing/2014/main" id="{C4B0F9A2-0A2A-4652-8B6B-74AC44C8A4A2}"/>
+                <a16:creationId xmlns:a16="http://schemas.microsoft.com/office/drawing/2014/main" id="{0128924E-D67C-4B34-9815-0575D458ECC1}"/>
               </a:ext>
             </a:extLst>
           </p:cNvPr>
@@ -6160,7 +6160,7 @@
           <p:cNvPr id="18" name="">
             <a:extLst xmlns:a="http://schemas.openxmlformats.org/drawingml/2006/main">
               <a:ext uri="{FF2B5EF4-FFF2-40B4-BE49-F238E27FC236}">
-                <a16:creationId xmlns:a16="http://schemas.microsoft.com/office/drawing/2014/main" id="{1AEF0B44-EB5E-40B7-86D9-211A2F2810B5}"/>
+                <a16:creationId xmlns:a16="http://schemas.microsoft.com/office/drawing/2014/main" id="{E0A7F09E-F96D-49C4-A4C4-9EC7008E9180}"/>
               </a:ext>
             </a:extLst>
           </p:cNvPr>
@@ -6224,7 +6224,7 @@
           <p:cNvPr id="19" name="">
             <a:extLst xmlns:a="http://schemas.openxmlformats.org/drawingml/2006/main">
               <a:ext uri="{FF2B5EF4-FFF2-40B4-BE49-F238E27FC236}">
-                <a16:creationId xmlns:a16="http://schemas.microsoft.com/office/drawing/2014/main" id="{CCE50E9B-3E05-4150-8D25-56492493B0A4}"/>
+                <a16:creationId xmlns:a16="http://schemas.microsoft.com/office/drawing/2014/main" id="{496B5157-AAF2-49C1-A84F-F87C6CCFDCFB}"/>
               </a:ext>
             </a:extLst>
           </p:cNvPr>
@@ -6259,7 +6259,7 @@
           <p:cNvPr id="20" name="">
             <a:extLst xmlns:a="http://schemas.openxmlformats.org/drawingml/2006/main">
               <a:ext uri="{FF2B5EF4-FFF2-40B4-BE49-F238E27FC236}">
-                <a16:creationId xmlns:a16="http://schemas.microsoft.com/office/drawing/2014/main" id="{E06DAFBF-A416-4F47-9909-D4C7AE7E0161}"/>
+                <a16:creationId xmlns:a16="http://schemas.microsoft.com/office/drawing/2014/main" id="{652C03A3-C535-4902-826D-DD097E56281E}"/>
               </a:ext>
             </a:extLst>
           </p:cNvPr>
@@ -6323,7 +6323,7 @@
           <p:cNvPr id="21" name="">
             <a:extLst xmlns:a="http://schemas.openxmlformats.org/drawingml/2006/main">
               <a:ext uri="{FF2B5EF4-FFF2-40B4-BE49-F238E27FC236}">
-                <a16:creationId xmlns:a16="http://schemas.microsoft.com/office/drawing/2014/main" id="{654BFAA0-5593-40A6-8E06-ED457449E00A}"/>
+                <a16:creationId xmlns:a16="http://schemas.microsoft.com/office/drawing/2014/main" id="{6A973C41-1BD5-466A-B883-19A8031D697A}"/>
               </a:ext>
             </a:extLst>
           </p:cNvPr>
@@ -6356,7 +6356,7 @@
           <p:cNvPr id="22" name="">
             <a:extLst xmlns:a="http://schemas.openxmlformats.org/drawingml/2006/main">
               <a:ext uri="{FF2B5EF4-FFF2-40B4-BE49-F238E27FC236}">
-                <a16:creationId xmlns:a16="http://schemas.microsoft.com/office/drawing/2014/main" id="{9E9B1768-F88D-4A79-B0E2-2E78B5E6D7A1}"/>
+                <a16:creationId xmlns:a16="http://schemas.microsoft.com/office/drawing/2014/main" id="{9EA547DE-B7EA-4C42-AB2B-5E46371DAB2D}"/>
               </a:ext>
             </a:extLst>
           </p:cNvPr>
@@ -6391,7 +6391,7 @@
           <p:cNvPr id="23" name="">
             <a:extLst xmlns:a="http://schemas.openxmlformats.org/drawingml/2006/main">
               <a:ext uri="{FF2B5EF4-FFF2-40B4-BE49-F238E27FC236}">
-                <a16:creationId xmlns:a16="http://schemas.microsoft.com/office/drawing/2014/main" id="{94D5783E-337A-48E5-8949-79142434F786}"/>
+                <a16:creationId xmlns:a16="http://schemas.microsoft.com/office/drawing/2014/main" id="{50700CF6-A9BB-451D-A29A-5B521F7BB055}"/>
               </a:ext>
             </a:extLst>
           </p:cNvPr>
@@ -6455,7 +6455,7 @@
           <p:cNvPr id="24" name="">
             <a:extLst xmlns:a="http://schemas.openxmlformats.org/drawingml/2006/main">
               <a:ext uri="{FF2B5EF4-FFF2-40B4-BE49-F238E27FC236}">
-                <a16:creationId xmlns:a16="http://schemas.microsoft.com/office/drawing/2014/main" id="{073524D3-32D5-4C0E-8B72-82A1038E2A3B}"/>
+                <a16:creationId xmlns:a16="http://schemas.microsoft.com/office/drawing/2014/main" id="{AAECC1A7-53B0-49BD-B66F-0781544670A7}"/>
               </a:ext>
             </a:extLst>
           </p:cNvPr>
@@ -6519,7 +6519,7 @@
           <p:cNvPr id="25" name="">
             <a:extLst xmlns:a="http://schemas.openxmlformats.org/drawingml/2006/main">
               <a:ext uri="{FF2B5EF4-FFF2-40B4-BE49-F238E27FC236}">
-                <a16:creationId xmlns:a16="http://schemas.microsoft.com/office/drawing/2014/main" id="{AC56BD96-CC16-4E46-AE53-F67DA242AFAE}"/>
+                <a16:creationId xmlns:a16="http://schemas.microsoft.com/office/drawing/2014/main" id="{06D9F09B-4F60-42B1-8A99-F90E8F972ED7}"/>
               </a:ext>
             </a:extLst>
           </p:cNvPr>
@@ -6583,7 +6583,7 @@
           <p:cNvPr id="26" name="">
             <a:extLst xmlns:a="http://schemas.openxmlformats.org/drawingml/2006/main">
               <a:ext uri="{FF2B5EF4-FFF2-40B4-BE49-F238E27FC236}">
-                <a16:creationId xmlns:a16="http://schemas.microsoft.com/office/drawing/2014/main" id="{97AF7A46-EE83-4240-B18F-D6691DE8085C}"/>
+                <a16:creationId xmlns:a16="http://schemas.microsoft.com/office/drawing/2014/main" id="{926DEDB9-210F-4833-BBD7-37DF4FAE4E8D}"/>
               </a:ext>
             </a:extLst>
           </p:cNvPr>
@@ -6618,7 +6618,7 @@
           <p:cNvPr id="27" name="">
             <a:extLst xmlns:a="http://schemas.openxmlformats.org/drawingml/2006/main">
               <a:ext uri="{FF2B5EF4-FFF2-40B4-BE49-F238E27FC236}">
-                <a16:creationId xmlns:a16="http://schemas.microsoft.com/office/drawing/2014/main" id="{DD741AA2-78B4-45BE-8A08-483A257FB812}"/>
+                <a16:creationId xmlns:a16="http://schemas.microsoft.com/office/drawing/2014/main" id="{4BEE7EB9-2244-4E37-A75A-081BC8909695}"/>
               </a:ext>
             </a:extLst>
           </p:cNvPr>
@@ -6682,7 +6682,7 @@
           <p:cNvPr id="28" name="">
             <a:extLst xmlns:a="http://schemas.openxmlformats.org/drawingml/2006/main">
               <a:ext uri="{FF2B5EF4-FFF2-40B4-BE49-F238E27FC236}">
-                <a16:creationId xmlns:a16="http://schemas.microsoft.com/office/drawing/2014/main" id="{4A20C8FD-E226-4323-AB4E-06E5BEF5BD8A}"/>
+                <a16:creationId xmlns:a16="http://schemas.microsoft.com/office/drawing/2014/main" id="{0AD5AD6B-A7E7-4239-BB90-437CC3F00F01}"/>
               </a:ext>
             </a:extLst>
           </p:cNvPr>
@@ -6715,7 +6715,7 @@
           <p:cNvPr id="29" name="">
             <a:extLst xmlns:a="http://schemas.openxmlformats.org/drawingml/2006/main">
               <a:ext uri="{FF2B5EF4-FFF2-40B4-BE49-F238E27FC236}">
-                <a16:creationId xmlns:a16="http://schemas.microsoft.com/office/drawing/2014/main" id="{DD190EAB-5128-4078-9E22-87CAD82827EA}"/>
+                <a16:creationId xmlns:a16="http://schemas.microsoft.com/office/drawing/2014/main" id="{7FE45B1C-EC58-4417-8EF8-AA4675849471}"/>
               </a:ext>
             </a:extLst>
           </p:cNvPr>
@@ -6750,7 +6750,7 @@
           <p:cNvPr id="30" name="">
             <a:extLst xmlns:a="http://schemas.openxmlformats.org/drawingml/2006/main">
               <a:ext uri="{FF2B5EF4-FFF2-40B4-BE49-F238E27FC236}">
-                <a16:creationId xmlns:a16="http://schemas.microsoft.com/office/drawing/2014/main" id="{71D75E03-1405-41C3-8E0F-23DCCF682EA5}"/>
+                <a16:creationId xmlns:a16="http://schemas.microsoft.com/office/drawing/2014/main" id="{872389C9-6D92-44B1-869E-9AEB3DC7E588}"/>
               </a:ext>
             </a:extLst>
           </p:cNvPr>
@@ -6814,7 +6814,7 @@
           <p:cNvPr id="31" name="">
             <a:extLst xmlns:a="http://schemas.openxmlformats.org/drawingml/2006/main">
               <a:ext uri="{FF2B5EF4-FFF2-40B4-BE49-F238E27FC236}">
-                <a16:creationId xmlns:a16="http://schemas.microsoft.com/office/drawing/2014/main" id="{778D90F8-FB55-49B4-987D-07E45C69D119}"/>
+                <a16:creationId xmlns:a16="http://schemas.microsoft.com/office/drawing/2014/main" id="{ED750D74-0475-44BF-9CD8-BBD6DAB82188}"/>
               </a:ext>
             </a:extLst>
           </p:cNvPr>
@@ -6878,7 +6878,7 @@
           <p:cNvPr id="32" name="">
             <a:extLst xmlns:a="http://schemas.openxmlformats.org/drawingml/2006/main">
               <a:ext uri="{FF2B5EF4-FFF2-40B4-BE49-F238E27FC236}">
-                <a16:creationId xmlns:a16="http://schemas.microsoft.com/office/drawing/2014/main" id="{AA259A68-B121-4BA5-B431-1DB2700C98DB}"/>
+                <a16:creationId xmlns:a16="http://schemas.microsoft.com/office/drawing/2014/main" id="{E590ED6D-8959-4DAE-9E76-9A1B083BEB8B}"/>
               </a:ext>
             </a:extLst>
           </p:cNvPr>
@@ -6942,7 +6942,7 @@
           <p:cNvPr id="33" name="">
             <a:extLst xmlns:a="http://schemas.openxmlformats.org/drawingml/2006/main">
               <a:ext uri="{FF2B5EF4-FFF2-40B4-BE49-F238E27FC236}">
-                <a16:creationId xmlns:a16="http://schemas.microsoft.com/office/drawing/2014/main" id="{00748DFE-06BE-4AB5-B8E9-05F31E5ABE66}"/>
+                <a16:creationId xmlns:a16="http://schemas.microsoft.com/office/drawing/2014/main" id="{0FCC5CC2-186F-4297-912F-F2A03EE0C3B8}"/>
               </a:ext>
             </a:extLst>
           </p:cNvPr>
@@ -6975,7 +6975,7 @@
           <p:cNvPr id="34" name="">
             <a:extLst xmlns:a="http://schemas.openxmlformats.org/drawingml/2006/main">
               <a:ext uri="{FF2B5EF4-FFF2-40B4-BE49-F238E27FC236}">
-                <a16:creationId xmlns:a16="http://schemas.microsoft.com/office/drawing/2014/main" id="{8552E50E-8739-4014-A4A5-3288016525DD}"/>
+                <a16:creationId xmlns:a16="http://schemas.microsoft.com/office/drawing/2014/main" id="{9203A372-B991-40CE-AD35-A537F46C19C4}"/>
               </a:ext>
             </a:extLst>
           </p:cNvPr>
@@ -7039,7 +7039,7 @@
           <p:cNvPr id="35" name="">
             <a:extLst xmlns:a="http://schemas.openxmlformats.org/drawingml/2006/main">
               <a:ext uri="{FF2B5EF4-FFF2-40B4-BE49-F238E27FC236}">
-                <a16:creationId xmlns:a16="http://schemas.microsoft.com/office/drawing/2014/main" id="{415BC898-511D-4253-9B97-3D726F572322}"/>
+                <a16:creationId xmlns:a16="http://schemas.microsoft.com/office/drawing/2014/main" id="{A5D242D8-5A46-4C37-81F9-B35461F92AF8}"/>
               </a:ext>
             </a:extLst>
           </p:cNvPr>
@@ -7103,7 +7103,7 @@
           <p:cNvPr id="36" name="">
             <a:extLst xmlns:a="http://schemas.openxmlformats.org/drawingml/2006/main">
               <a:ext uri="{FF2B5EF4-FFF2-40B4-BE49-F238E27FC236}">
-                <a16:creationId xmlns:a16="http://schemas.microsoft.com/office/drawing/2014/main" id="{B58A254E-DBB9-4AD4-B195-35ADAC08A945}"/>
+                <a16:creationId xmlns:a16="http://schemas.microsoft.com/office/drawing/2014/main" id="{7D693B90-86D0-42B9-BF44-6AFAAEF2892D}"/>
               </a:ext>
             </a:extLst>
           </p:cNvPr>
@@ -7138,7 +7138,7 @@
           <p:cNvPr id="37" name="">
             <a:extLst xmlns:a="http://schemas.openxmlformats.org/drawingml/2006/main">
               <a:ext uri="{FF2B5EF4-FFF2-40B4-BE49-F238E27FC236}">
-                <a16:creationId xmlns:a16="http://schemas.microsoft.com/office/drawing/2014/main" id="{E0DCE9E1-C41B-44EC-A513-385EAB90EC0E}"/>
+                <a16:creationId xmlns:a16="http://schemas.microsoft.com/office/drawing/2014/main" id="{AABBC15C-5F12-4580-A4A3-08D8B7AC4796}"/>
               </a:ext>
             </a:extLst>
           </p:cNvPr>
@@ -7202,7 +7202,7 @@
           <p:cNvPr id="38" name="">
             <a:extLst xmlns:a="http://schemas.openxmlformats.org/drawingml/2006/main">
               <a:ext uri="{FF2B5EF4-FFF2-40B4-BE49-F238E27FC236}">
-                <a16:creationId xmlns:a16="http://schemas.microsoft.com/office/drawing/2014/main" id="{6C20BA45-6034-4C7D-9942-DCCF8FDBA06B}"/>
+                <a16:creationId xmlns:a16="http://schemas.microsoft.com/office/drawing/2014/main" id="{1599EE0B-4A42-43AD-9703-906FC26CF818}"/>
               </a:ext>
             </a:extLst>
           </p:cNvPr>
@@ -7264,7 +7264,7 @@
     </p:spTree>
     <p:extLst>
       <p:ext uri="{BB962C8B-B14F-4D97-AF65-F5344CB8AC3E}">
-        <p14:creationId xmlns:p14="http://schemas.microsoft.com/office/powerpoint/2010/main" val="880045590"/>
+        <p14:creationId xmlns:p14="http://schemas.microsoft.com/office/powerpoint/2010/main" val="1779687074"/>
       </p:ext>
     </p:extLst>
   </p:cSld>
@@ -7288,7 +7288,7 @@
           <p:cNvPr id="1" name="">
             <a:extLst xmlns:a="http://schemas.openxmlformats.org/drawingml/2006/main">
               <a:ext uri="{FF2B5EF4-FFF2-40B4-BE49-F238E27FC236}">
-                <a16:creationId xmlns:a16="http://schemas.microsoft.com/office/drawing/2014/main" id="{2BAA1E8F-09AE-48D1-B700-FD06F2B0E3F5}"/>
+                <a16:creationId xmlns:a16="http://schemas.microsoft.com/office/drawing/2014/main" id="{1DCC403C-6690-4046-B35E-AC477727942D}"/>
               </a:ext>
             </a:extLst>
           </p:cNvPr>
@@ -7323,7 +7323,7 @@
           <p:cNvPr id="2" name="">
             <a:extLst xmlns:a="http://schemas.openxmlformats.org/drawingml/2006/main">
               <a:ext uri="{FF2B5EF4-FFF2-40B4-BE49-F238E27FC236}">
-                <a16:creationId xmlns:a16="http://schemas.microsoft.com/office/drawing/2014/main" id="{82845786-755A-4D89-8871-C1A9765C80E1}"/>
+                <a16:creationId xmlns:a16="http://schemas.microsoft.com/office/drawing/2014/main" id="{8BA39E8F-7D6A-4BE9-84D6-1D5768B294CA}"/>
               </a:ext>
             </a:extLst>
           </p:cNvPr>
@@ -7358,7 +7358,7 @@
           <p:cNvPr id="3" name="">
             <a:extLst xmlns:a="http://schemas.openxmlformats.org/drawingml/2006/main">
               <a:ext uri="{FF2B5EF4-FFF2-40B4-BE49-F238E27FC236}">
-                <a16:creationId xmlns:a16="http://schemas.microsoft.com/office/drawing/2014/main" id="{968A83E8-B058-47FD-B8FE-D5DD6E5FAF65}"/>
+                <a16:creationId xmlns:a16="http://schemas.microsoft.com/office/drawing/2014/main" id="{FAE135FE-C439-4345-9BC7-44057A6648E9}"/>
               </a:ext>
             </a:extLst>
           </p:cNvPr>
@@ -7422,7 +7422,7 @@
           <p:cNvPr id="4" name="">
             <a:extLst xmlns:a="http://schemas.openxmlformats.org/drawingml/2006/main">
               <a:ext uri="{FF2B5EF4-FFF2-40B4-BE49-F238E27FC236}">
-                <a16:creationId xmlns:a16="http://schemas.microsoft.com/office/drawing/2014/main" id="{C8B0940B-721F-424E-8F9A-A095E2B7F72D}"/>
+                <a16:creationId xmlns:a16="http://schemas.microsoft.com/office/drawing/2014/main" id="{2936485E-431F-40F0-8D1C-672E1CCE53E3}"/>
               </a:ext>
             </a:extLst>
           </p:cNvPr>
@@ -7486,7 +7486,7 @@
           <p:cNvPr id="5" name="">
             <a:extLst xmlns:a="http://schemas.openxmlformats.org/drawingml/2006/main">
               <a:ext uri="{FF2B5EF4-FFF2-40B4-BE49-F238E27FC236}">
-                <a16:creationId xmlns:a16="http://schemas.microsoft.com/office/drawing/2014/main" id="{78963E26-7F9D-420F-83A7-66F7BA9D00E1}"/>
+                <a16:creationId xmlns:a16="http://schemas.microsoft.com/office/drawing/2014/main" id="{A66997BE-2C60-45DC-933B-7D331D971423}"/>
               </a:ext>
             </a:extLst>
           </p:cNvPr>
@@ -7550,7 +7550,7 @@
           <p:cNvPr id="6" name="">
             <a:extLst xmlns:a="http://schemas.openxmlformats.org/drawingml/2006/main">
               <a:ext uri="{FF2B5EF4-FFF2-40B4-BE49-F238E27FC236}">
-                <a16:creationId xmlns:a16="http://schemas.microsoft.com/office/drawing/2014/main" id="{68736D92-DDB8-4AD6-9412-406183428794}"/>
+                <a16:creationId xmlns:a16="http://schemas.microsoft.com/office/drawing/2014/main" id="{92F9BF82-BBE3-4812-B3AB-339AB984798A}"/>
               </a:ext>
             </a:extLst>
           </p:cNvPr>
@@ -7614,7 +7614,7 @@
           <p:cNvPr id="7" name="">
             <a:extLst xmlns:a="http://schemas.openxmlformats.org/drawingml/2006/main">
               <a:ext uri="{FF2B5EF4-FFF2-40B4-BE49-F238E27FC236}">
-                <a16:creationId xmlns:a16="http://schemas.microsoft.com/office/drawing/2014/main" id="{3EFEFE18-97FC-4430-ACB8-CCE0402BE399}"/>
+                <a16:creationId xmlns:a16="http://schemas.microsoft.com/office/drawing/2014/main" id="{22C19FF7-8FAD-473A-B81F-EA7934621937}"/>
               </a:ext>
             </a:extLst>
           </p:cNvPr>
@@ -7668,7 +7668,7 @@
                 <a:ea typeface="Aptos"/>
                 <a:cs typeface="Aptos"/>
               </a:rPr>
-              <a:t>199</a:t>
+              <a:t>220</a:t>
             </a:r>
           </a:p>
         </p:txBody>
@@ -7678,7 +7678,7 @@
           <p:cNvPr id="8" name="">
             <a:extLst xmlns:a="http://schemas.openxmlformats.org/drawingml/2006/main">
               <a:ext uri="{FF2B5EF4-FFF2-40B4-BE49-F238E27FC236}">
-                <a16:creationId xmlns:a16="http://schemas.microsoft.com/office/drawing/2014/main" id="{E73E4F76-94B8-4B8C-AA0A-0FD0C94D3923}"/>
+                <a16:creationId xmlns:a16="http://schemas.microsoft.com/office/drawing/2014/main" id="{00179ED1-5CD4-4118-ACF7-10F36F74E171}"/>
               </a:ext>
             </a:extLst>
           </p:cNvPr>
@@ -7742,7 +7742,7 @@
           <p:cNvPr id="9" name="">
             <a:extLst xmlns:a="http://schemas.openxmlformats.org/drawingml/2006/main">
               <a:ext uri="{FF2B5EF4-FFF2-40B4-BE49-F238E27FC236}">
-                <a16:creationId xmlns:a16="http://schemas.microsoft.com/office/drawing/2014/main" id="{E5CFE2AC-1494-45EE-99C8-9A66D79C7E91}"/>
+                <a16:creationId xmlns:a16="http://schemas.microsoft.com/office/drawing/2014/main" id="{82AEE97F-FAED-45E2-965D-6A0D511CD7F4}"/>
               </a:ext>
             </a:extLst>
           </p:cNvPr>
@@ -7806,7 +7806,7 @@
           <p:cNvPr id="10" name="">
             <a:extLst xmlns:a="http://schemas.openxmlformats.org/drawingml/2006/main">
               <a:ext uri="{FF2B5EF4-FFF2-40B4-BE49-F238E27FC236}">
-                <a16:creationId xmlns:a16="http://schemas.microsoft.com/office/drawing/2014/main" id="{5738EF40-88E3-4B5A-BC33-387C21E2ABEE}"/>
+                <a16:creationId xmlns:a16="http://schemas.microsoft.com/office/drawing/2014/main" id="{7FA31E30-E03F-46B7-9A0D-EBB92DC320AB}"/>
               </a:ext>
             </a:extLst>
           </p:cNvPr>
@@ -7841,7 +7841,7 @@
           <p:cNvPr id="11" name="">
             <a:extLst xmlns:a="http://schemas.openxmlformats.org/drawingml/2006/main">
               <a:ext uri="{FF2B5EF4-FFF2-40B4-BE49-F238E27FC236}">
-                <a16:creationId xmlns:a16="http://schemas.microsoft.com/office/drawing/2014/main" id="{89EDC35F-339A-45FB-8499-3964DCCB7937}"/>
+                <a16:creationId xmlns:a16="http://schemas.microsoft.com/office/drawing/2014/main" id="{C2DDA6AF-56AB-4535-A436-36EA06E309BC}"/>
               </a:ext>
             </a:extLst>
           </p:cNvPr>
@@ -7895,7 +7895,7 @@
                 <a:ea typeface="Aptos"/>
                 <a:cs typeface="Aptos"/>
               </a:rPr>
-              <a:t>140</a:t>
+              <a:t>141</a:t>
             </a:r>
           </a:p>
         </p:txBody>
@@ -7905,7 +7905,7 @@
           <p:cNvPr id="12" name="">
             <a:extLst xmlns:a="http://schemas.openxmlformats.org/drawingml/2006/main">
               <a:ext uri="{FF2B5EF4-FFF2-40B4-BE49-F238E27FC236}">
-                <a16:creationId xmlns:a16="http://schemas.microsoft.com/office/drawing/2014/main" id="{E0A59393-3AD1-413A-AC9A-C44AD9223B87}"/>
+                <a16:creationId xmlns:a16="http://schemas.microsoft.com/office/drawing/2014/main" id="{C52602AD-D1C7-47C5-BEF3-D0286728299E}"/>
               </a:ext>
             </a:extLst>
           </p:cNvPr>
@@ -7969,7 +7969,7 @@
           <p:cNvPr id="13" name="">
             <a:extLst xmlns:a="http://schemas.openxmlformats.org/drawingml/2006/main">
               <a:ext uri="{FF2B5EF4-FFF2-40B4-BE49-F238E27FC236}">
-                <a16:creationId xmlns:a16="http://schemas.microsoft.com/office/drawing/2014/main" id="{92CE1A1F-1039-48D2-BF8A-858AFBAEC206}"/>
+                <a16:creationId xmlns:a16="http://schemas.microsoft.com/office/drawing/2014/main" id="{FD383966-8DC7-4ECE-8B57-E2B15027AE58}"/>
               </a:ext>
             </a:extLst>
           </p:cNvPr>
@@ -8033,7 +8033,7 @@
           <p:cNvPr id="14" name="">
             <a:extLst xmlns:a="http://schemas.openxmlformats.org/drawingml/2006/main">
               <a:ext uri="{FF2B5EF4-FFF2-40B4-BE49-F238E27FC236}">
-                <a16:creationId xmlns:a16="http://schemas.microsoft.com/office/drawing/2014/main" id="{E8AC555C-A3CF-4291-8619-58534161977D}"/>
+                <a16:creationId xmlns:a16="http://schemas.microsoft.com/office/drawing/2014/main" id="{BEDD8D87-46EF-454D-B3DA-0C2BEBF81F68}"/>
               </a:ext>
             </a:extLst>
           </p:cNvPr>
@@ -8068,7 +8068,7 @@
           <p:cNvPr id="15" name="">
             <a:extLst xmlns:a="http://schemas.openxmlformats.org/drawingml/2006/main">
               <a:ext uri="{FF2B5EF4-FFF2-40B4-BE49-F238E27FC236}">
-                <a16:creationId xmlns:a16="http://schemas.microsoft.com/office/drawing/2014/main" id="{CB782C09-8D33-426D-848A-F1B88D380822}"/>
+                <a16:creationId xmlns:a16="http://schemas.microsoft.com/office/drawing/2014/main" id="{75AE7B13-B146-49F0-81F7-55330D2C84BB}"/>
               </a:ext>
             </a:extLst>
           </p:cNvPr>
@@ -8132,7 +8132,7 @@
           <p:cNvPr id="16" name="">
             <a:extLst xmlns:a="http://schemas.openxmlformats.org/drawingml/2006/main">
               <a:ext uri="{FF2B5EF4-FFF2-40B4-BE49-F238E27FC236}">
-                <a16:creationId xmlns:a16="http://schemas.microsoft.com/office/drawing/2014/main" id="{5D8019E6-BD73-494A-9E07-9612798E1D32}"/>
+                <a16:creationId xmlns:a16="http://schemas.microsoft.com/office/drawing/2014/main" id="{10D4AD9D-9AD6-4E74-83A1-D41E79761C2E}"/>
               </a:ext>
             </a:extLst>
           </p:cNvPr>
@@ -8196,7 +8196,7 @@
           <p:cNvPr id="17" name="">
             <a:extLst xmlns:a="http://schemas.openxmlformats.org/drawingml/2006/main">
               <a:ext uri="{FF2B5EF4-FFF2-40B4-BE49-F238E27FC236}">
-                <a16:creationId xmlns:a16="http://schemas.microsoft.com/office/drawing/2014/main" id="{37508BAF-49CC-4943-BC34-E23792440DB5}"/>
+                <a16:creationId xmlns:a16="http://schemas.microsoft.com/office/drawing/2014/main" id="{7A6C31A1-87F1-4516-A11F-F39E9B33F3C4}"/>
               </a:ext>
             </a:extLst>
           </p:cNvPr>
@@ -8260,7 +8260,7 @@
           <p:cNvPr id="18" name="">
             <a:extLst xmlns:a="http://schemas.openxmlformats.org/drawingml/2006/main">
               <a:ext uri="{FF2B5EF4-FFF2-40B4-BE49-F238E27FC236}">
-                <a16:creationId xmlns:a16="http://schemas.microsoft.com/office/drawing/2014/main" id="{A52D9906-D38F-4A19-8518-F3DA63490665}"/>
+                <a16:creationId xmlns:a16="http://schemas.microsoft.com/office/drawing/2014/main" id="{27A915C1-CEE6-44C1-AC6B-702605E028A2}"/>
               </a:ext>
             </a:extLst>
           </p:cNvPr>
@@ -8295,7 +8295,7 @@
           <p:cNvPr id="19" name="">
             <a:extLst xmlns:a="http://schemas.openxmlformats.org/drawingml/2006/main">
               <a:ext uri="{FF2B5EF4-FFF2-40B4-BE49-F238E27FC236}">
-                <a16:creationId xmlns:a16="http://schemas.microsoft.com/office/drawing/2014/main" id="{F9E2DB21-B9FE-4228-89A1-737A1214BF41}"/>
+                <a16:creationId xmlns:a16="http://schemas.microsoft.com/office/drawing/2014/main" id="{D6A379E1-FDB4-4950-9C3A-C76ECFCD73AA}"/>
               </a:ext>
             </a:extLst>
           </p:cNvPr>
@@ -8359,7 +8359,7 @@
           <p:cNvPr id="20" name="">
             <a:extLst xmlns:a="http://schemas.openxmlformats.org/drawingml/2006/main">
               <a:ext uri="{FF2B5EF4-FFF2-40B4-BE49-F238E27FC236}">
-                <a16:creationId xmlns:a16="http://schemas.microsoft.com/office/drawing/2014/main" id="{F6711183-4EC9-4141-972A-8CC8F77F6777}"/>
+                <a16:creationId xmlns:a16="http://schemas.microsoft.com/office/drawing/2014/main" id="{DBF928E6-C199-42E2-981D-0688C2C41F6B}"/>
               </a:ext>
             </a:extLst>
           </p:cNvPr>
@@ -8423,7 +8423,7 @@
           <p:cNvPr id="21" name="">
             <a:extLst xmlns:a="http://schemas.openxmlformats.org/drawingml/2006/main">
               <a:ext uri="{FF2B5EF4-FFF2-40B4-BE49-F238E27FC236}">
-                <a16:creationId xmlns:a16="http://schemas.microsoft.com/office/drawing/2014/main" id="{DB8C8950-4D08-4F23-928B-389129A6DEBD}"/>
+                <a16:creationId xmlns:a16="http://schemas.microsoft.com/office/drawing/2014/main" id="{07216F66-C3CD-4EEB-B324-61E0F9A0DD24}"/>
               </a:ext>
             </a:extLst>
           </p:cNvPr>
@@ -8487,7 +8487,7 @@
           <p:cNvPr id="22" name="">
             <a:extLst xmlns:a="http://schemas.openxmlformats.org/drawingml/2006/main">
               <a:ext uri="{FF2B5EF4-FFF2-40B4-BE49-F238E27FC236}">
-                <a16:creationId xmlns:a16="http://schemas.microsoft.com/office/drawing/2014/main" id="{332B71F5-ECC6-4DD7-864F-F67618DAB4CA}"/>
+                <a16:creationId xmlns:a16="http://schemas.microsoft.com/office/drawing/2014/main" id="{9C0AAAB9-2A5A-4FC0-BAAF-8AB2757C4DB2}"/>
               </a:ext>
             </a:extLst>
           </p:cNvPr>
@@ -8522,7 +8522,7 @@
           <p:cNvPr id="23" name="">
             <a:extLst xmlns:a="http://schemas.openxmlformats.org/drawingml/2006/main">
               <a:ext uri="{FF2B5EF4-FFF2-40B4-BE49-F238E27FC236}">
-                <a16:creationId xmlns:a16="http://schemas.microsoft.com/office/drawing/2014/main" id="{73A484DA-03E1-43EF-B27F-E5F8477601B3}"/>
+                <a16:creationId xmlns:a16="http://schemas.microsoft.com/office/drawing/2014/main" id="{7339B739-2664-4B46-980C-E06AFA4073AA}"/>
               </a:ext>
             </a:extLst>
           </p:cNvPr>
@@ -8555,7 +8555,7 @@
           <p:cNvPr id="24" name="">
             <a:extLst xmlns:a="http://schemas.openxmlformats.org/drawingml/2006/main">
               <a:ext uri="{FF2B5EF4-FFF2-40B4-BE49-F238E27FC236}">
-                <a16:creationId xmlns:a16="http://schemas.microsoft.com/office/drawing/2014/main" id="{6BBCD5D8-0DD7-4AE7-BAEC-A2F14B280621}"/>
+                <a16:creationId xmlns:a16="http://schemas.microsoft.com/office/drawing/2014/main" id="{9D3FB0D2-CB1A-4B77-81D5-7966BC9A5C13}"/>
               </a:ext>
             </a:extLst>
           </p:cNvPr>
@@ -8619,7 +8619,7 @@
           <p:cNvPr id="25" name="">
             <a:extLst xmlns:a="http://schemas.openxmlformats.org/drawingml/2006/main">
               <a:ext uri="{FF2B5EF4-FFF2-40B4-BE49-F238E27FC236}">
-                <a16:creationId xmlns:a16="http://schemas.microsoft.com/office/drawing/2014/main" id="{D74E748D-0949-4DBA-844E-3B4FE7B641B3}"/>
+                <a16:creationId xmlns:a16="http://schemas.microsoft.com/office/drawing/2014/main" id="{035AB74E-0684-4DD8-8DBA-5EB82E0995D4}"/>
               </a:ext>
             </a:extLst>
           </p:cNvPr>
@@ -8683,7 +8683,7 @@
           <p:cNvPr id="26" name="">
             <a:extLst xmlns:a="http://schemas.openxmlformats.org/drawingml/2006/main">
               <a:ext uri="{FF2B5EF4-FFF2-40B4-BE49-F238E27FC236}">
-                <a16:creationId xmlns:a16="http://schemas.microsoft.com/office/drawing/2014/main" id="{043BEF97-A895-44B6-BAB0-BD85597A7506}"/>
+                <a16:creationId xmlns:a16="http://schemas.microsoft.com/office/drawing/2014/main" id="{BBDC9B3C-3B02-4213-A69E-36D318D9F9CA}"/>
               </a:ext>
             </a:extLst>
           </p:cNvPr>
@@ -8737,7 +8737,7 @@
                 <a:ea typeface="Aptos"/>
                 <a:cs typeface="Aptos"/>
               </a:rPr>
-              <a:t>Verified July 11, 2026: 199 Python and 140 Phoenix tests, zero failures.</a:t>
+              <a:t>Verified July 12, 2026: 220 Python and 141 Phoenix tests, zero failures.</a:t>
             </a:r>
           </a:p>
         </p:txBody>
@@ -8745,7 +8745,7 @@
     </p:spTree>
     <p:extLst>
       <p:ext uri="{BB962C8B-B14F-4D97-AF65-F5344CB8AC3E}">
-        <p14:creationId xmlns:p14="http://schemas.microsoft.com/office/powerpoint/2010/main" val="1578534267"/>
+        <p14:creationId xmlns:p14="http://schemas.microsoft.com/office/powerpoint/2010/main" val="656549467"/>
       </p:ext>
     </p:extLst>
   </p:cSld>
@@ -8769,7 +8769,7 @@
           <p:cNvPr id="1" name="">
             <a:extLst xmlns:a="http://schemas.openxmlformats.org/drawingml/2006/main">
               <a:ext uri="{FF2B5EF4-FFF2-40B4-BE49-F238E27FC236}">
-                <a16:creationId xmlns:a16="http://schemas.microsoft.com/office/drawing/2014/main" id="{6D6973C6-0991-4467-A063-00518F885B14}"/>
+                <a16:creationId xmlns:a16="http://schemas.microsoft.com/office/drawing/2014/main" id="{268901A4-ED0B-4D8F-A7A3-EF301CBCECBB}"/>
               </a:ext>
             </a:extLst>
           </p:cNvPr>
@@ -8804,7 +8804,7 @@
           <p:cNvPr id="2" name="">
             <a:extLst xmlns:a="http://schemas.openxmlformats.org/drawingml/2006/main">
               <a:ext uri="{FF2B5EF4-FFF2-40B4-BE49-F238E27FC236}">
-                <a16:creationId xmlns:a16="http://schemas.microsoft.com/office/drawing/2014/main" id="{897596D5-36E1-457C-8DB7-7D81357806F2}"/>
+                <a16:creationId xmlns:a16="http://schemas.microsoft.com/office/drawing/2014/main" id="{30534214-1A2C-4A22-87B2-67ED5A72E193}"/>
               </a:ext>
             </a:extLst>
           </p:cNvPr>
@@ -8839,7 +8839,7 @@
           <p:cNvPr id="3" name="">
             <a:extLst xmlns:a="http://schemas.openxmlformats.org/drawingml/2006/main">
               <a:ext uri="{FF2B5EF4-FFF2-40B4-BE49-F238E27FC236}">
-                <a16:creationId xmlns:a16="http://schemas.microsoft.com/office/drawing/2014/main" id="{0943A770-E3CF-41FA-8E12-94193069F3BC}"/>
+                <a16:creationId xmlns:a16="http://schemas.microsoft.com/office/drawing/2014/main" id="{91CD7A4F-F9D4-402E-871D-4F8F9C6D6B13}"/>
               </a:ext>
             </a:extLst>
           </p:cNvPr>
@@ -8903,7 +8903,7 @@
           <p:cNvPr id="4" name="">
             <a:extLst xmlns:a="http://schemas.openxmlformats.org/drawingml/2006/main">
               <a:ext uri="{FF2B5EF4-FFF2-40B4-BE49-F238E27FC236}">
-                <a16:creationId xmlns:a16="http://schemas.microsoft.com/office/drawing/2014/main" id="{651E93EC-52FB-48C4-B991-F963FC72C4A9}"/>
+                <a16:creationId xmlns:a16="http://schemas.microsoft.com/office/drawing/2014/main" id="{E1A0026D-39B2-4466-8EE6-B3208F3CAAE5}"/>
               </a:ext>
             </a:extLst>
           </p:cNvPr>
@@ -8967,7 +8967,7 @@
           <p:cNvPr id="5" name="">
             <a:extLst xmlns:a="http://schemas.openxmlformats.org/drawingml/2006/main">
               <a:ext uri="{FF2B5EF4-FFF2-40B4-BE49-F238E27FC236}">
-                <a16:creationId xmlns:a16="http://schemas.microsoft.com/office/drawing/2014/main" id="{9FB705DE-CEAB-4A99-A3D7-A9CA4D88C536}"/>
+                <a16:creationId xmlns:a16="http://schemas.microsoft.com/office/drawing/2014/main" id="{89052607-FD95-4E5D-B284-BCD32D2123DF}"/>
               </a:ext>
             </a:extLst>
           </p:cNvPr>
@@ -9031,7 +9031,7 @@
           <p:cNvPr id="6" name="">
             <a:extLst xmlns:a="http://schemas.openxmlformats.org/drawingml/2006/main">
               <a:ext uri="{FF2B5EF4-FFF2-40B4-BE49-F238E27FC236}">
-                <a16:creationId xmlns:a16="http://schemas.microsoft.com/office/drawing/2014/main" id="{A6A823AE-6672-40EF-A2E7-EFEB96E09E4A}"/>
+                <a16:creationId xmlns:a16="http://schemas.microsoft.com/office/drawing/2014/main" id="{07001929-46BA-4DB4-BCF9-98A329A92481}"/>
               </a:ext>
             </a:extLst>
           </p:cNvPr>
@@ -9095,7 +9095,7 @@
           <p:cNvPr id="7" name="">
             <a:extLst xmlns:a="http://schemas.openxmlformats.org/drawingml/2006/main">
               <a:ext uri="{FF2B5EF4-FFF2-40B4-BE49-F238E27FC236}">
-                <a16:creationId xmlns:a16="http://schemas.microsoft.com/office/drawing/2014/main" id="{65A26139-A819-484D-B7C6-46F9A143A013}"/>
+                <a16:creationId xmlns:a16="http://schemas.microsoft.com/office/drawing/2014/main" id="{DCC4E37B-BF00-4F7F-B203-B6AD17EE48BC}"/>
               </a:ext>
             </a:extLst>
           </p:cNvPr>
@@ -9128,7 +9128,7 @@
           <p:cNvPr id="8" name="">
             <a:extLst xmlns:a="http://schemas.openxmlformats.org/drawingml/2006/main">
               <a:ext uri="{FF2B5EF4-FFF2-40B4-BE49-F238E27FC236}">
-                <a16:creationId xmlns:a16="http://schemas.microsoft.com/office/drawing/2014/main" id="{45F63BA9-0398-411E-B2EB-301CB41B8396}"/>
+                <a16:creationId xmlns:a16="http://schemas.microsoft.com/office/drawing/2014/main" id="{9CB7C0BF-E384-4225-83E6-92C8BBF08B0B}"/>
               </a:ext>
             </a:extLst>
           </p:cNvPr>
@@ -9192,7 +9192,7 @@
           <p:cNvPr id="9" name="">
             <a:extLst xmlns:a="http://schemas.openxmlformats.org/drawingml/2006/main">
               <a:ext uri="{FF2B5EF4-FFF2-40B4-BE49-F238E27FC236}">
-                <a16:creationId xmlns:a16="http://schemas.microsoft.com/office/drawing/2014/main" id="{EAD55EA7-4A66-4828-ACCB-DB600ED88466}"/>
+                <a16:creationId xmlns:a16="http://schemas.microsoft.com/office/drawing/2014/main" id="{23EC0A48-9ED4-4FC1-9E1B-7884C3015E6C}"/>
               </a:ext>
             </a:extLst>
           </p:cNvPr>
@@ -9256,7 +9256,7 @@
           <p:cNvPr id="10" name="">
             <a:extLst xmlns:a="http://schemas.openxmlformats.org/drawingml/2006/main">
               <a:ext uri="{FF2B5EF4-FFF2-40B4-BE49-F238E27FC236}">
-                <a16:creationId xmlns:a16="http://schemas.microsoft.com/office/drawing/2014/main" id="{4A60B0EF-B685-4718-91DF-1324275EEFAE}"/>
+                <a16:creationId xmlns:a16="http://schemas.microsoft.com/office/drawing/2014/main" id="{20B4DA0C-A691-478A-A259-3F4E727596B0}"/>
               </a:ext>
             </a:extLst>
           </p:cNvPr>
@@ -9320,7 +9320,7 @@
           <p:cNvPr id="11" name="">
             <a:extLst xmlns:a="http://schemas.openxmlformats.org/drawingml/2006/main">
               <a:ext uri="{FF2B5EF4-FFF2-40B4-BE49-F238E27FC236}">
-                <a16:creationId xmlns:a16="http://schemas.microsoft.com/office/drawing/2014/main" id="{16970D6C-5AD8-496D-B7B4-8B471F2D3895}"/>
+                <a16:creationId xmlns:a16="http://schemas.microsoft.com/office/drawing/2014/main" id="{305618F0-D75B-45B0-B2C6-C68A711A8279}"/>
               </a:ext>
             </a:extLst>
           </p:cNvPr>
@@ -9353,7 +9353,7 @@
           <p:cNvPr id="12" name="">
             <a:extLst xmlns:a="http://schemas.openxmlformats.org/drawingml/2006/main">
               <a:ext uri="{FF2B5EF4-FFF2-40B4-BE49-F238E27FC236}">
-                <a16:creationId xmlns:a16="http://schemas.microsoft.com/office/drawing/2014/main" id="{F737ACFE-7F38-4FD6-9EC0-1A88DB40D4F9}"/>
+                <a16:creationId xmlns:a16="http://schemas.microsoft.com/office/drawing/2014/main" id="{10586729-16E4-4F4C-926B-1A8E928F7E94}"/>
               </a:ext>
             </a:extLst>
           </p:cNvPr>
@@ -9417,7 +9417,7 @@
           <p:cNvPr id="13" name="">
             <a:extLst xmlns:a="http://schemas.openxmlformats.org/drawingml/2006/main">
               <a:ext uri="{FF2B5EF4-FFF2-40B4-BE49-F238E27FC236}">
-                <a16:creationId xmlns:a16="http://schemas.microsoft.com/office/drawing/2014/main" id="{7E9EA2B0-DC0E-4696-ACB8-CE0C1CBA0E82}"/>
+                <a16:creationId xmlns:a16="http://schemas.microsoft.com/office/drawing/2014/main" id="{4D2E3C6F-AE08-4EDB-B403-A7CCEEBAF159}"/>
               </a:ext>
             </a:extLst>
           </p:cNvPr>
@@ -9481,7 +9481,7 @@
           <p:cNvPr id="14" name="">
             <a:extLst xmlns:a="http://schemas.openxmlformats.org/drawingml/2006/main">
               <a:ext uri="{FF2B5EF4-FFF2-40B4-BE49-F238E27FC236}">
-                <a16:creationId xmlns:a16="http://schemas.microsoft.com/office/drawing/2014/main" id="{DA4982CC-4BE3-4121-A360-12383360BC22}"/>
+                <a16:creationId xmlns:a16="http://schemas.microsoft.com/office/drawing/2014/main" id="{E2D8D851-C7C5-47A4-8C14-4AF1EB7C28C7}"/>
               </a:ext>
             </a:extLst>
           </p:cNvPr>
@@ -9545,7 +9545,7 @@
           <p:cNvPr id="15" name="">
             <a:extLst xmlns:a="http://schemas.openxmlformats.org/drawingml/2006/main">
               <a:ext uri="{FF2B5EF4-FFF2-40B4-BE49-F238E27FC236}">
-                <a16:creationId xmlns:a16="http://schemas.microsoft.com/office/drawing/2014/main" id="{1686392F-C0CA-4F9E-B18F-ACA80D088AB8}"/>
+                <a16:creationId xmlns:a16="http://schemas.microsoft.com/office/drawing/2014/main" id="{1D3E2ED1-C320-404D-A87C-41E993040236}"/>
               </a:ext>
             </a:extLst>
           </p:cNvPr>
@@ -9578,7 +9578,7 @@
           <p:cNvPr id="16" name="">
             <a:extLst xmlns:a="http://schemas.openxmlformats.org/drawingml/2006/main">
               <a:ext uri="{FF2B5EF4-FFF2-40B4-BE49-F238E27FC236}">
-                <a16:creationId xmlns:a16="http://schemas.microsoft.com/office/drawing/2014/main" id="{376B51B5-001A-45D6-B2D5-D5281E754505}"/>
+                <a16:creationId xmlns:a16="http://schemas.microsoft.com/office/drawing/2014/main" id="{7AA60C17-3443-432B-8188-10507B2F23B1}"/>
               </a:ext>
             </a:extLst>
           </p:cNvPr>
@@ -9642,7 +9642,7 @@
           <p:cNvPr id="17" name="">
             <a:extLst xmlns:a="http://schemas.openxmlformats.org/drawingml/2006/main">
               <a:ext uri="{FF2B5EF4-FFF2-40B4-BE49-F238E27FC236}">
-                <a16:creationId xmlns:a16="http://schemas.microsoft.com/office/drawing/2014/main" id="{F3EAFD67-D108-4583-944D-47C302294B21}"/>
+                <a16:creationId xmlns:a16="http://schemas.microsoft.com/office/drawing/2014/main" id="{1CF3AF98-FB92-4446-93F2-4D740AD42A43}"/>
               </a:ext>
             </a:extLst>
           </p:cNvPr>
@@ -9706,7 +9706,7 @@
           <p:cNvPr id="18" name="">
             <a:extLst xmlns:a="http://schemas.openxmlformats.org/drawingml/2006/main">
               <a:ext uri="{FF2B5EF4-FFF2-40B4-BE49-F238E27FC236}">
-                <a16:creationId xmlns:a16="http://schemas.microsoft.com/office/drawing/2014/main" id="{FD51C439-E2F2-4A2A-BAE7-25F2C67B78A0}"/>
+                <a16:creationId xmlns:a16="http://schemas.microsoft.com/office/drawing/2014/main" id="{22EE818A-0E1B-4F74-9C1D-A56A0A6E432E}"/>
               </a:ext>
             </a:extLst>
           </p:cNvPr>
@@ -9770,7 +9770,7 @@
           <p:cNvPr id="19" name="">
             <a:extLst xmlns:a="http://schemas.openxmlformats.org/drawingml/2006/main">
               <a:ext uri="{FF2B5EF4-FFF2-40B4-BE49-F238E27FC236}">
-                <a16:creationId xmlns:a16="http://schemas.microsoft.com/office/drawing/2014/main" id="{1F16A40F-5614-4062-AE28-0D6DC83192F0}"/>
+                <a16:creationId xmlns:a16="http://schemas.microsoft.com/office/drawing/2014/main" id="{AC6E8A8D-D2AD-4D73-89F2-12C01CB9A520}"/>
               </a:ext>
             </a:extLst>
           </p:cNvPr>
@@ -9803,7 +9803,7 @@
           <p:cNvPr id="20" name="">
             <a:extLst xmlns:a="http://schemas.openxmlformats.org/drawingml/2006/main">
               <a:ext uri="{FF2B5EF4-FFF2-40B4-BE49-F238E27FC236}">
-                <a16:creationId xmlns:a16="http://schemas.microsoft.com/office/drawing/2014/main" id="{E23549D6-DB4F-4D55-85C2-4A98BFE67820}"/>
+                <a16:creationId xmlns:a16="http://schemas.microsoft.com/office/drawing/2014/main" id="{29786AE3-E3E2-4854-922E-24AF5680153B}"/>
               </a:ext>
             </a:extLst>
           </p:cNvPr>
@@ -9867,7 +9867,7 @@
           <p:cNvPr id="21" name="">
             <a:extLst xmlns:a="http://schemas.openxmlformats.org/drawingml/2006/main">
               <a:ext uri="{FF2B5EF4-FFF2-40B4-BE49-F238E27FC236}">
-                <a16:creationId xmlns:a16="http://schemas.microsoft.com/office/drawing/2014/main" id="{BA73C04B-EC72-4B27-9622-1FF62F60EFCE}"/>
+                <a16:creationId xmlns:a16="http://schemas.microsoft.com/office/drawing/2014/main" id="{7981490C-4E6E-4548-889B-A0E1A8E420B2}"/>
               </a:ext>
             </a:extLst>
           </p:cNvPr>
@@ -9931,7 +9931,7 @@
           <p:cNvPr id="22" name="">
             <a:extLst xmlns:a="http://schemas.openxmlformats.org/drawingml/2006/main">
               <a:ext uri="{FF2B5EF4-FFF2-40B4-BE49-F238E27FC236}">
-                <a16:creationId xmlns:a16="http://schemas.microsoft.com/office/drawing/2014/main" id="{AB692A3D-0DA0-4479-A89C-F42ABD3A9234}"/>
+                <a16:creationId xmlns:a16="http://schemas.microsoft.com/office/drawing/2014/main" id="{2C9AB391-56D8-4AD1-9229-4A9EACB9FAAF}"/>
               </a:ext>
             </a:extLst>
           </p:cNvPr>
@@ -9995,7 +9995,7 @@
           <p:cNvPr id="23" name="">
             <a:extLst xmlns:a="http://schemas.openxmlformats.org/drawingml/2006/main">
               <a:ext uri="{FF2B5EF4-FFF2-40B4-BE49-F238E27FC236}">
-                <a16:creationId xmlns:a16="http://schemas.microsoft.com/office/drawing/2014/main" id="{A534ED78-A10D-4024-9C68-C41957590CB0}"/>
+                <a16:creationId xmlns:a16="http://schemas.microsoft.com/office/drawing/2014/main" id="{7FEB4101-6A5F-454B-BB56-613B4CA4C749}"/>
               </a:ext>
             </a:extLst>
           </p:cNvPr>
@@ -10028,7 +10028,7 @@
           <p:cNvPr id="24" name="">
             <a:extLst xmlns:a="http://schemas.openxmlformats.org/drawingml/2006/main">
               <a:ext uri="{FF2B5EF4-FFF2-40B4-BE49-F238E27FC236}">
-                <a16:creationId xmlns:a16="http://schemas.microsoft.com/office/drawing/2014/main" id="{52B8A911-2E0B-46F7-A610-07904FECC614}"/>
+                <a16:creationId xmlns:a16="http://schemas.microsoft.com/office/drawing/2014/main" id="{C80CCC77-5CA3-42AC-A569-D9260623885D}"/>
               </a:ext>
             </a:extLst>
           </p:cNvPr>
@@ -10092,7 +10092,7 @@
           <p:cNvPr id="25" name="">
             <a:extLst xmlns:a="http://schemas.openxmlformats.org/drawingml/2006/main">
               <a:ext uri="{FF2B5EF4-FFF2-40B4-BE49-F238E27FC236}">
-                <a16:creationId xmlns:a16="http://schemas.microsoft.com/office/drawing/2014/main" id="{BA572584-94A6-41C1-8F0F-80255682DFD3}"/>
+                <a16:creationId xmlns:a16="http://schemas.microsoft.com/office/drawing/2014/main" id="{556D67EF-913B-4AEF-9019-7C4ED9CCF60B}"/>
               </a:ext>
             </a:extLst>
           </p:cNvPr>
@@ -10156,7 +10156,7 @@
           <p:cNvPr id="26" name="">
             <a:extLst xmlns:a="http://schemas.openxmlformats.org/drawingml/2006/main">
               <a:ext uri="{FF2B5EF4-FFF2-40B4-BE49-F238E27FC236}">
-                <a16:creationId xmlns:a16="http://schemas.microsoft.com/office/drawing/2014/main" id="{44F134CC-3987-45CA-B800-727379D80CA8}"/>
+                <a16:creationId xmlns:a16="http://schemas.microsoft.com/office/drawing/2014/main" id="{CDCA86CF-7459-4A0A-A53B-3AE7BBB0B279}"/>
               </a:ext>
             </a:extLst>
           </p:cNvPr>
@@ -10191,7 +10191,7 @@
           <p:cNvPr id="27" name="">
             <a:extLst xmlns:a="http://schemas.openxmlformats.org/drawingml/2006/main">
               <a:ext uri="{FF2B5EF4-FFF2-40B4-BE49-F238E27FC236}">
-                <a16:creationId xmlns:a16="http://schemas.microsoft.com/office/drawing/2014/main" id="{A4FBD082-7823-4009-884C-190986418EA4}"/>
+                <a16:creationId xmlns:a16="http://schemas.microsoft.com/office/drawing/2014/main" id="{4EE9A309-95C2-4CA5-B3C1-B66043ED4311}"/>
               </a:ext>
             </a:extLst>
           </p:cNvPr>
@@ -10255,7 +10255,7 @@
           <p:cNvPr id="28" name="">
             <a:extLst xmlns:a="http://schemas.openxmlformats.org/drawingml/2006/main">
               <a:ext uri="{FF2B5EF4-FFF2-40B4-BE49-F238E27FC236}">
-                <a16:creationId xmlns:a16="http://schemas.microsoft.com/office/drawing/2014/main" id="{5ADB098A-68A2-4A07-9D59-DC7F4A8721CF}"/>
+                <a16:creationId xmlns:a16="http://schemas.microsoft.com/office/drawing/2014/main" id="{C7BE0E82-CDA7-4899-B818-09B13D0254A0}"/>
               </a:ext>
             </a:extLst>
           </p:cNvPr>
@@ -10290,7 +10290,7 @@
           <p:cNvPr id="29" name="">
             <a:extLst xmlns:a="http://schemas.openxmlformats.org/drawingml/2006/main">
               <a:ext uri="{FF2B5EF4-FFF2-40B4-BE49-F238E27FC236}">
-                <a16:creationId xmlns:a16="http://schemas.microsoft.com/office/drawing/2014/main" id="{712E9FA7-7CF3-4F65-A4BD-022E8420D1D4}"/>
+                <a16:creationId xmlns:a16="http://schemas.microsoft.com/office/drawing/2014/main" id="{25F3F164-BFEC-4679-BE41-A257835B2DB5}"/>
               </a:ext>
             </a:extLst>
           </p:cNvPr>
@@ -10354,7 +10354,7 @@
           <p:cNvPr id="30" name="">
             <a:extLst xmlns:a="http://schemas.openxmlformats.org/drawingml/2006/main">
               <a:ext uri="{FF2B5EF4-FFF2-40B4-BE49-F238E27FC236}">
-                <a16:creationId xmlns:a16="http://schemas.microsoft.com/office/drawing/2014/main" id="{B9876CBC-83F5-4D45-A43F-3980706422E6}"/>
+                <a16:creationId xmlns:a16="http://schemas.microsoft.com/office/drawing/2014/main" id="{DD88F893-F06F-427B-9C2C-CF6FCC674AC2}"/>
               </a:ext>
             </a:extLst>
           </p:cNvPr>
@@ -10389,7 +10389,7 @@
           <p:cNvPr id="31" name="">
             <a:extLst xmlns:a="http://schemas.openxmlformats.org/drawingml/2006/main">
               <a:ext uri="{FF2B5EF4-FFF2-40B4-BE49-F238E27FC236}">
-                <a16:creationId xmlns:a16="http://schemas.microsoft.com/office/drawing/2014/main" id="{822FB355-89FA-45BB-BF8E-F57C3EAEEE30}"/>
+                <a16:creationId xmlns:a16="http://schemas.microsoft.com/office/drawing/2014/main" id="{4BCCE568-70E3-476B-98CF-E24F5EEF77A4}"/>
               </a:ext>
             </a:extLst>
           </p:cNvPr>
@@ -10453,7 +10453,7 @@
           <p:cNvPr id="32" name="">
             <a:extLst xmlns:a="http://schemas.openxmlformats.org/drawingml/2006/main">
               <a:ext uri="{FF2B5EF4-FFF2-40B4-BE49-F238E27FC236}">
-                <a16:creationId xmlns:a16="http://schemas.microsoft.com/office/drawing/2014/main" id="{67903CFF-2909-4FF3-B5A2-6EB03BF11AFF}"/>
+                <a16:creationId xmlns:a16="http://schemas.microsoft.com/office/drawing/2014/main" id="{5623DAD4-B436-46F6-9D42-4276B05D6B83}"/>
               </a:ext>
             </a:extLst>
           </p:cNvPr>
@@ -10488,7 +10488,7 @@
           <p:cNvPr id="33" name="">
             <a:extLst xmlns:a="http://schemas.openxmlformats.org/drawingml/2006/main">
               <a:ext uri="{FF2B5EF4-FFF2-40B4-BE49-F238E27FC236}">
-                <a16:creationId xmlns:a16="http://schemas.microsoft.com/office/drawing/2014/main" id="{CA5D64BF-E8EA-4B7E-A2A1-3F92FD19CE25}"/>
+                <a16:creationId xmlns:a16="http://schemas.microsoft.com/office/drawing/2014/main" id="{19D6959E-AB1F-4E48-801A-6D721BC0C5BD}"/>
               </a:ext>
             </a:extLst>
           </p:cNvPr>
@@ -10552,7 +10552,7 @@
           <p:cNvPr id="34" name="">
             <a:extLst xmlns:a="http://schemas.openxmlformats.org/drawingml/2006/main">
               <a:ext uri="{FF2B5EF4-FFF2-40B4-BE49-F238E27FC236}">
-                <a16:creationId xmlns:a16="http://schemas.microsoft.com/office/drawing/2014/main" id="{AD2997BA-798B-4BF9-8F0E-9FF77B2EE3D1}"/>
+                <a16:creationId xmlns:a16="http://schemas.microsoft.com/office/drawing/2014/main" id="{D0122E6B-E207-4214-BECC-95248B0B6730}"/>
               </a:ext>
             </a:extLst>
           </p:cNvPr>
@@ -10587,7 +10587,7 @@
           <p:cNvPr id="35" name="">
             <a:extLst xmlns:a="http://schemas.openxmlformats.org/drawingml/2006/main">
               <a:ext uri="{FF2B5EF4-FFF2-40B4-BE49-F238E27FC236}">
-                <a16:creationId xmlns:a16="http://schemas.microsoft.com/office/drawing/2014/main" id="{980F8DDE-37D2-4EBD-B79E-8EB705328327}"/>
+                <a16:creationId xmlns:a16="http://schemas.microsoft.com/office/drawing/2014/main" id="{687E2CA3-0497-4BDB-AE3D-ADA4F8B58289}"/>
               </a:ext>
             </a:extLst>
           </p:cNvPr>
@@ -10651,7 +10651,7 @@
           <p:cNvPr id="36" name="">
             <a:extLst xmlns:a="http://schemas.openxmlformats.org/drawingml/2006/main">
               <a:ext uri="{FF2B5EF4-FFF2-40B4-BE49-F238E27FC236}">
-                <a16:creationId xmlns:a16="http://schemas.microsoft.com/office/drawing/2014/main" id="{543CC83D-8528-4BD5-B7D5-78AD133D0D48}"/>
+                <a16:creationId xmlns:a16="http://schemas.microsoft.com/office/drawing/2014/main" id="{ACB46A31-3867-4AE4-9D60-A084BD8E16F0}"/>
               </a:ext>
             </a:extLst>
           </p:cNvPr>
@@ -10686,7 +10686,7 @@
           <p:cNvPr id="37" name="">
             <a:extLst xmlns:a="http://schemas.openxmlformats.org/drawingml/2006/main">
               <a:ext uri="{FF2B5EF4-FFF2-40B4-BE49-F238E27FC236}">
-                <a16:creationId xmlns:a16="http://schemas.microsoft.com/office/drawing/2014/main" id="{663904F1-0F2F-4D45-95D5-005E5E5F3367}"/>
+                <a16:creationId xmlns:a16="http://schemas.microsoft.com/office/drawing/2014/main" id="{5E92570C-7A35-4B48-B3AF-B1A02619B0BD}"/>
               </a:ext>
             </a:extLst>
           </p:cNvPr>
@@ -10750,7 +10750,7 @@
           <p:cNvPr id="38" name="">
             <a:extLst xmlns:a="http://schemas.openxmlformats.org/drawingml/2006/main">
               <a:ext uri="{FF2B5EF4-FFF2-40B4-BE49-F238E27FC236}">
-                <a16:creationId xmlns:a16="http://schemas.microsoft.com/office/drawing/2014/main" id="{5CBB0CE5-0865-4A7B-923C-326FC67D01F7}"/>
+                <a16:creationId xmlns:a16="http://schemas.microsoft.com/office/drawing/2014/main" id="{67C077F7-FF8D-4BCB-AA4E-ACF84557ECB7}"/>
               </a:ext>
             </a:extLst>
           </p:cNvPr>
@@ -10814,7 +10814,7 @@
           <p:cNvPr id="39" name="">
             <a:extLst xmlns:a="http://schemas.openxmlformats.org/drawingml/2006/main">
               <a:ext uri="{FF2B5EF4-FFF2-40B4-BE49-F238E27FC236}">
-                <a16:creationId xmlns:a16="http://schemas.microsoft.com/office/drawing/2014/main" id="{F3B5172C-14C9-4E49-91DB-4A689816CE5E}"/>
+                <a16:creationId xmlns:a16="http://schemas.microsoft.com/office/drawing/2014/main" id="{F7CD0834-A4AB-4C5E-8C9F-6D633390808D}"/>
               </a:ext>
             </a:extLst>
           </p:cNvPr>
@@ -10878,7 +10878,7 @@
           <p:cNvPr id="40" name="">
             <a:extLst xmlns:a="http://schemas.openxmlformats.org/drawingml/2006/main">
               <a:ext uri="{FF2B5EF4-FFF2-40B4-BE49-F238E27FC236}">
-                <a16:creationId xmlns:a16="http://schemas.microsoft.com/office/drawing/2014/main" id="{2AFEB6B3-6236-4274-9B31-75F9E83F629F}"/>
+                <a16:creationId xmlns:a16="http://schemas.microsoft.com/office/drawing/2014/main" id="{28C46E25-F9AC-4AB7-8567-223DF3511499}"/>
               </a:ext>
             </a:extLst>
           </p:cNvPr>
@@ -10942,7 +10942,7 @@
           <p:cNvPr id="41" name="">
             <a:extLst xmlns:a="http://schemas.openxmlformats.org/drawingml/2006/main">
               <a:ext uri="{FF2B5EF4-FFF2-40B4-BE49-F238E27FC236}">
-                <a16:creationId xmlns:a16="http://schemas.microsoft.com/office/drawing/2014/main" id="{F1EC22F7-30B7-4F2D-BF75-601F3728CC48}"/>
+                <a16:creationId xmlns:a16="http://schemas.microsoft.com/office/drawing/2014/main" id="{E7ACF0F6-0E69-4866-87B2-094CED19D614}"/>
               </a:ext>
             </a:extLst>
           </p:cNvPr>
@@ -11006,7 +11006,7 @@
           <p:cNvPr id="42" name="">
             <a:extLst xmlns:a="http://schemas.openxmlformats.org/drawingml/2006/main">
               <a:ext uri="{FF2B5EF4-FFF2-40B4-BE49-F238E27FC236}">
-                <a16:creationId xmlns:a16="http://schemas.microsoft.com/office/drawing/2014/main" id="{1DB5DDA9-EFC5-4F5B-925B-FCF0FDA57FA8}"/>
+                <a16:creationId xmlns:a16="http://schemas.microsoft.com/office/drawing/2014/main" id="{8CD712B0-5BAC-4B81-BCFC-E650B81A832A}"/>
               </a:ext>
             </a:extLst>
           </p:cNvPr>
@@ -11070,7 +11070,7 @@
           <p:cNvPr id="43" name="">
             <a:extLst xmlns:a="http://schemas.openxmlformats.org/drawingml/2006/main">
               <a:ext uri="{FF2B5EF4-FFF2-40B4-BE49-F238E27FC236}">
-                <a16:creationId xmlns:a16="http://schemas.microsoft.com/office/drawing/2014/main" id="{C201EECB-6AD3-4A7E-90EB-042D13A1673C}"/>
+                <a16:creationId xmlns:a16="http://schemas.microsoft.com/office/drawing/2014/main" id="{9061C0E0-3855-47E2-992C-84F67D369A68}"/>
               </a:ext>
             </a:extLst>
           </p:cNvPr>
@@ -11132,7 +11132,7 @@
     </p:spTree>
     <p:extLst>
       <p:ext uri="{BB962C8B-B14F-4D97-AF65-F5344CB8AC3E}">
-        <p14:creationId xmlns:p14="http://schemas.microsoft.com/office/powerpoint/2010/main" val="803118219"/>
+        <p14:creationId xmlns:p14="http://schemas.microsoft.com/office/powerpoint/2010/main" val="1393146683"/>
       </p:ext>
     </p:extLst>
   </p:cSld>
@@ -11156,7 +11156,7 @@
           <p:cNvPr id="1" name="">
             <a:extLst xmlns:a="http://schemas.openxmlformats.org/drawingml/2006/main">
               <a:ext uri="{FF2B5EF4-FFF2-40B4-BE49-F238E27FC236}">
-                <a16:creationId xmlns:a16="http://schemas.microsoft.com/office/drawing/2014/main" id="{F14812B3-CF5E-4ED6-99F2-21FECA5D027E}"/>
+                <a16:creationId xmlns:a16="http://schemas.microsoft.com/office/drawing/2014/main" id="{69AB8250-1608-41C9-B909-A1F0D806863B}"/>
               </a:ext>
             </a:extLst>
           </p:cNvPr>
@@ -11191,7 +11191,7 @@
           <p:cNvPr id="2" name="">
             <a:extLst xmlns:a="http://schemas.openxmlformats.org/drawingml/2006/main">
               <a:ext uri="{FF2B5EF4-FFF2-40B4-BE49-F238E27FC236}">
-                <a16:creationId xmlns:a16="http://schemas.microsoft.com/office/drawing/2014/main" id="{82E19E04-A075-4CA1-8EEC-634B4E23466C}"/>
+                <a16:creationId xmlns:a16="http://schemas.microsoft.com/office/drawing/2014/main" id="{828A72C8-CBD8-42F0-853F-B701565F3130}"/>
               </a:ext>
             </a:extLst>
           </p:cNvPr>
@@ -11226,7 +11226,7 @@
           <p:cNvPr id="3" name="">
             <a:extLst xmlns:a="http://schemas.openxmlformats.org/drawingml/2006/main">
               <a:ext uri="{FF2B5EF4-FFF2-40B4-BE49-F238E27FC236}">
-                <a16:creationId xmlns:a16="http://schemas.microsoft.com/office/drawing/2014/main" id="{6B26649C-FDBF-4BA8-A6F1-C5B5D0C7896F}"/>
+                <a16:creationId xmlns:a16="http://schemas.microsoft.com/office/drawing/2014/main" id="{82347FA1-7179-4D05-ADAE-0245622F8671}"/>
               </a:ext>
             </a:extLst>
           </p:cNvPr>
@@ -11290,7 +11290,7 @@
           <p:cNvPr id="4" name="">
             <a:extLst xmlns:a="http://schemas.openxmlformats.org/drawingml/2006/main">
               <a:ext uri="{FF2B5EF4-FFF2-40B4-BE49-F238E27FC236}">
-                <a16:creationId xmlns:a16="http://schemas.microsoft.com/office/drawing/2014/main" id="{66BF51F0-BC5A-4141-9DB2-B4F72326FC73}"/>
+                <a16:creationId xmlns:a16="http://schemas.microsoft.com/office/drawing/2014/main" id="{445E8AFF-CA8E-4810-B735-BAA1674B6F41}"/>
               </a:ext>
             </a:extLst>
           </p:cNvPr>
@@ -11354,7 +11354,7 @@
           <p:cNvPr id="5" name="">
             <a:extLst xmlns:a="http://schemas.openxmlformats.org/drawingml/2006/main">
               <a:ext uri="{FF2B5EF4-FFF2-40B4-BE49-F238E27FC236}">
-                <a16:creationId xmlns:a16="http://schemas.microsoft.com/office/drawing/2014/main" id="{74CFC28D-FDCF-4153-901C-C359149BE3C6}"/>
+                <a16:creationId xmlns:a16="http://schemas.microsoft.com/office/drawing/2014/main" id="{BB7AF9E4-84F2-44E5-A09A-A59618C9DB1B}"/>
               </a:ext>
             </a:extLst>
           </p:cNvPr>
@@ -11418,7 +11418,7 @@
           <p:cNvPr id="6" name="">
             <a:extLst xmlns:a="http://schemas.openxmlformats.org/drawingml/2006/main">
               <a:ext uri="{FF2B5EF4-FFF2-40B4-BE49-F238E27FC236}">
-                <a16:creationId xmlns:a16="http://schemas.microsoft.com/office/drawing/2014/main" id="{0F31D74D-E685-486C-B3ED-7E51A8580B01}"/>
+                <a16:creationId xmlns:a16="http://schemas.microsoft.com/office/drawing/2014/main" id="{DA32072C-20C5-4648-8F61-6B92046E74E7}"/>
               </a:ext>
             </a:extLst>
           </p:cNvPr>
@@ -11482,7 +11482,7 @@
           <p:cNvPr id="7" name="">
             <a:extLst xmlns:a="http://schemas.openxmlformats.org/drawingml/2006/main">
               <a:ext uri="{FF2B5EF4-FFF2-40B4-BE49-F238E27FC236}">
-                <a16:creationId xmlns:a16="http://schemas.microsoft.com/office/drawing/2014/main" id="{1B384A38-49EA-4F71-89A8-376F50B4FA31}"/>
+                <a16:creationId xmlns:a16="http://schemas.microsoft.com/office/drawing/2014/main" id="{62F62D82-257E-4731-9C78-E8B4432461DD}"/>
               </a:ext>
             </a:extLst>
           </p:cNvPr>
@@ -11569,7 +11569,7 @@
           <p:cNvPr id="8" name="">
             <a:extLst xmlns:a="http://schemas.openxmlformats.org/drawingml/2006/main">
               <a:ext uri="{FF2B5EF4-FFF2-40B4-BE49-F238E27FC236}">
-                <a16:creationId xmlns:a16="http://schemas.microsoft.com/office/drawing/2014/main" id="{A5E96512-1785-4260-B693-9CAE5998E8F8}"/>
+                <a16:creationId xmlns:a16="http://schemas.microsoft.com/office/drawing/2014/main" id="{F709DB82-3F19-4482-8E2F-CFD09AE93097}"/>
               </a:ext>
             </a:extLst>
           </p:cNvPr>
@@ -11602,7 +11602,7 @@
           <p:cNvPr id="9" name="">
             <a:extLst xmlns:a="http://schemas.openxmlformats.org/drawingml/2006/main">
               <a:ext uri="{FF2B5EF4-FFF2-40B4-BE49-F238E27FC236}">
-                <a16:creationId xmlns:a16="http://schemas.microsoft.com/office/drawing/2014/main" id="{FA612670-2C59-448D-8B5A-F2A3638624D2}"/>
+                <a16:creationId xmlns:a16="http://schemas.microsoft.com/office/drawing/2014/main" id="{12565037-EBD1-4418-B3FF-F86E4C653547}"/>
               </a:ext>
             </a:extLst>
           </p:cNvPr>
@@ -11666,7 +11666,7 @@
           <p:cNvPr id="10" name="">
             <a:extLst xmlns:a="http://schemas.openxmlformats.org/drawingml/2006/main">
               <a:ext uri="{FF2B5EF4-FFF2-40B4-BE49-F238E27FC236}">
-                <a16:creationId xmlns:a16="http://schemas.microsoft.com/office/drawing/2014/main" id="{0202B357-26B6-4124-9A09-979FB037A3D2}"/>
+                <a16:creationId xmlns:a16="http://schemas.microsoft.com/office/drawing/2014/main" id="{E426E44A-BEC1-41E0-85C4-46E9E7F4ECA8}"/>
               </a:ext>
             </a:extLst>
           </p:cNvPr>
@@ -11730,7 +11730,7 @@
           <p:cNvPr id="11" name="">
             <a:extLst xmlns:a="http://schemas.openxmlformats.org/drawingml/2006/main">
               <a:ext uri="{FF2B5EF4-FFF2-40B4-BE49-F238E27FC236}">
-                <a16:creationId xmlns:a16="http://schemas.microsoft.com/office/drawing/2014/main" id="{081E40A6-AE28-466A-B159-7EFA9EB9294B}"/>
+                <a16:creationId xmlns:a16="http://schemas.microsoft.com/office/drawing/2014/main" id="{F09F6353-49ED-410E-B705-726409945610}"/>
               </a:ext>
             </a:extLst>
           </p:cNvPr>
@@ -11763,7 +11763,7 @@
           <p:cNvPr id="12" name="">
             <a:extLst xmlns:a="http://schemas.openxmlformats.org/drawingml/2006/main">
               <a:ext uri="{FF2B5EF4-FFF2-40B4-BE49-F238E27FC236}">
-                <a16:creationId xmlns:a16="http://schemas.microsoft.com/office/drawing/2014/main" id="{DE6AB13F-0C5A-445A-A585-D94D933A0C41}"/>
+                <a16:creationId xmlns:a16="http://schemas.microsoft.com/office/drawing/2014/main" id="{82C75032-ADA6-424C-9371-1089CC6A66FE}"/>
               </a:ext>
             </a:extLst>
           </p:cNvPr>
@@ -11827,7 +11827,7 @@
           <p:cNvPr id="13" name="">
             <a:extLst xmlns:a="http://schemas.openxmlformats.org/drawingml/2006/main">
               <a:ext uri="{FF2B5EF4-FFF2-40B4-BE49-F238E27FC236}">
-                <a16:creationId xmlns:a16="http://schemas.microsoft.com/office/drawing/2014/main" id="{2FA2518E-1E97-4437-9919-AA9F4FE82E4A}"/>
+                <a16:creationId xmlns:a16="http://schemas.microsoft.com/office/drawing/2014/main" id="{75A7E556-F0A5-44E7-84F1-3A23E1DC7A75}"/>
               </a:ext>
             </a:extLst>
           </p:cNvPr>
@@ -11891,7 +11891,7 @@
           <p:cNvPr id="14" name="">
             <a:extLst xmlns:a="http://schemas.openxmlformats.org/drawingml/2006/main">
               <a:ext uri="{FF2B5EF4-FFF2-40B4-BE49-F238E27FC236}">
-                <a16:creationId xmlns:a16="http://schemas.microsoft.com/office/drawing/2014/main" id="{E2E1CCA6-6466-486E-B9E1-0054191DF4BC}"/>
+                <a16:creationId xmlns:a16="http://schemas.microsoft.com/office/drawing/2014/main" id="{4ACB1124-EEA8-4650-BC9C-8BB43DB3BC89}"/>
               </a:ext>
             </a:extLst>
           </p:cNvPr>
@@ -11924,7 +11924,7 @@
           <p:cNvPr id="15" name="">
             <a:extLst xmlns:a="http://schemas.openxmlformats.org/drawingml/2006/main">
               <a:ext uri="{FF2B5EF4-FFF2-40B4-BE49-F238E27FC236}">
-                <a16:creationId xmlns:a16="http://schemas.microsoft.com/office/drawing/2014/main" id="{316CBCA1-29D4-4A20-B7D0-550EB23A241B}"/>
+                <a16:creationId xmlns:a16="http://schemas.microsoft.com/office/drawing/2014/main" id="{6F56F69B-8233-47F1-8DE2-DE6810C0D983}"/>
               </a:ext>
             </a:extLst>
           </p:cNvPr>
@@ -11988,7 +11988,7 @@
           <p:cNvPr id="16" name="">
             <a:extLst xmlns:a="http://schemas.openxmlformats.org/drawingml/2006/main">
               <a:ext uri="{FF2B5EF4-FFF2-40B4-BE49-F238E27FC236}">
-                <a16:creationId xmlns:a16="http://schemas.microsoft.com/office/drawing/2014/main" id="{8F8C5BF6-8D75-4F8F-829E-E5D2B6D3A44B}"/>
+                <a16:creationId xmlns:a16="http://schemas.microsoft.com/office/drawing/2014/main" id="{291D3200-133C-420E-8101-94DA77050E60}"/>
               </a:ext>
             </a:extLst>
           </p:cNvPr>
@@ -12052,7 +12052,7 @@
           <p:cNvPr id="17" name="">
             <a:extLst xmlns:a="http://schemas.openxmlformats.org/drawingml/2006/main">
               <a:ext uri="{FF2B5EF4-FFF2-40B4-BE49-F238E27FC236}">
-                <a16:creationId xmlns:a16="http://schemas.microsoft.com/office/drawing/2014/main" id="{DEE59470-ABCF-458D-8ABA-6CBA08C988C8}"/>
+                <a16:creationId xmlns:a16="http://schemas.microsoft.com/office/drawing/2014/main" id="{AFC1912F-709D-453D-8ED4-D5C519D53A44}"/>
               </a:ext>
             </a:extLst>
           </p:cNvPr>
@@ -12087,7 +12087,7 @@
           <p:cNvPr id="18" name="">
             <a:extLst xmlns:a="http://schemas.openxmlformats.org/drawingml/2006/main">
               <a:ext uri="{FF2B5EF4-FFF2-40B4-BE49-F238E27FC236}">
-                <a16:creationId xmlns:a16="http://schemas.microsoft.com/office/drawing/2014/main" id="{97F4387B-6158-4512-ACEA-7AF7EEA5A560}"/>
+                <a16:creationId xmlns:a16="http://schemas.microsoft.com/office/drawing/2014/main" id="{9598E736-AB1E-456F-8772-A7D422B112B3}"/>
               </a:ext>
             </a:extLst>
           </p:cNvPr>
@@ -12122,7 +12122,7 @@
           <p:cNvPr id="19" name="">
             <a:extLst xmlns:a="http://schemas.openxmlformats.org/drawingml/2006/main">
               <a:ext uri="{FF2B5EF4-FFF2-40B4-BE49-F238E27FC236}">
-                <a16:creationId xmlns:a16="http://schemas.microsoft.com/office/drawing/2014/main" id="{CF6E82DD-81C4-4F20-8AD5-71805D7590A8}"/>
+                <a16:creationId xmlns:a16="http://schemas.microsoft.com/office/drawing/2014/main" id="{1855C2E6-AB25-4603-A9DE-D2093E9168CA}"/>
               </a:ext>
             </a:extLst>
           </p:cNvPr>
@@ -12184,7 +12184,7 @@
     </p:spTree>
     <p:extLst>
       <p:ext uri="{BB962C8B-B14F-4D97-AF65-F5344CB8AC3E}">
-        <p14:creationId xmlns:p14="http://schemas.microsoft.com/office/powerpoint/2010/main" val="1104812639"/>
+        <p14:creationId xmlns:p14="http://schemas.microsoft.com/office/powerpoint/2010/main" val="350314433"/>
       </p:ext>
     </p:extLst>
   </p:cSld>
@@ -12208,7 +12208,7 @@
           <p:cNvPr id="1" name="">
             <a:extLst xmlns:a="http://schemas.openxmlformats.org/drawingml/2006/main">
               <a:ext uri="{FF2B5EF4-FFF2-40B4-BE49-F238E27FC236}">
-                <a16:creationId xmlns:a16="http://schemas.microsoft.com/office/drawing/2014/main" id="{1FF91548-0FD4-4EC7-BB49-6DAD2913190B}"/>
+                <a16:creationId xmlns:a16="http://schemas.microsoft.com/office/drawing/2014/main" id="{417F0A44-D5F2-47AF-9C54-A42155859870}"/>
               </a:ext>
             </a:extLst>
           </p:cNvPr>
@@ -12243,7 +12243,7 @@
           <p:cNvPr id="2" name="">
             <a:extLst xmlns:a="http://schemas.openxmlformats.org/drawingml/2006/main">
               <a:ext uri="{FF2B5EF4-FFF2-40B4-BE49-F238E27FC236}">
-                <a16:creationId xmlns:a16="http://schemas.microsoft.com/office/drawing/2014/main" id="{51FEE3D6-D202-4308-A956-6CBE5036811C}"/>
+                <a16:creationId xmlns:a16="http://schemas.microsoft.com/office/drawing/2014/main" id="{F16D0D57-5D52-4269-986A-5897845F7446}"/>
               </a:ext>
             </a:extLst>
           </p:cNvPr>
@@ -12278,7 +12278,7 @@
           <p:cNvPr id="3" name="">
             <a:extLst xmlns:a="http://schemas.openxmlformats.org/drawingml/2006/main">
               <a:ext uri="{FF2B5EF4-FFF2-40B4-BE49-F238E27FC236}">
-                <a16:creationId xmlns:a16="http://schemas.microsoft.com/office/drawing/2014/main" id="{10448B41-A609-48FA-BFF9-8E3972E073DE}"/>
+                <a16:creationId xmlns:a16="http://schemas.microsoft.com/office/drawing/2014/main" id="{EA968921-FF0F-4C62-A060-9C1BECE15F7C}"/>
               </a:ext>
             </a:extLst>
           </p:cNvPr>
@@ -12342,7 +12342,7 @@
           <p:cNvPr id="4" name="">
             <a:extLst xmlns:a="http://schemas.openxmlformats.org/drawingml/2006/main">
               <a:ext uri="{FF2B5EF4-FFF2-40B4-BE49-F238E27FC236}">
-                <a16:creationId xmlns:a16="http://schemas.microsoft.com/office/drawing/2014/main" id="{2B5B5845-FE0A-4B27-BF9D-DAF79839C3DA}"/>
+                <a16:creationId xmlns:a16="http://schemas.microsoft.com/office/drawing/2014/main" id="{80734FC9-6BB7-419F-B68D-803F32284ADB}"/>
               </a:ext>
             </a:extLst>
           </p:cNvPr>
@@ -12406,7 +12406,7 @@
           <p:cNvPr id="5" name="">
             <a:extLst xmlns:a="http://schemas.openxmlformats.org/drawingml/2006/main">
               <a:ext uri="{FF2B5EF4-FFF2-40B4-BE49-F238E27FC236}">
-                <a16:creationId xmlns:a16="http://schemas.microsoft.com/office/drawing/2014/main" id="{4F1F1837-829B-46E9-8284-F481442089B8}"/>
+                <a16:creationId xmlns:a16="http://schemas.microsoft.com/office/drawing/2014/main" id="{71681DE8-5DA3-4FFD-B6D4-F6AE16C6A482}"/>
               </a:ext>
             </a:extLst>
           </p:cNvPr>
@@ -12460,7 +12460,7 @@
                 <a:ea typeface="Aptos Display"/>
                 <a:cs typeface="Aptos Display"/>
               </a:rPr>
-              <a:t>AMD-hosted Gemma. Measured product outcomes.</a:t>
+              <a:t>AMD-hosted Gemma repairs unsafe plans.</a:t>
             </a:r>
           </a:p>
         </p:txBody>
@@ -12470,7 +12470,7 @@
           <p:cNvPr id="6" name="">
             <a:extLst xmlns:a="http://schemas.openxmlformats.org/drawingml/2006/main">
               <a:ext uri="{FF2B5EF4-FFF2-40B4-BE49-F238E27FC236}">
-                <a16:creationId xmlns:a16="http://schemas.microsoft.com/office/drawing/2014/main" id="{5D096656-4E38-4508-A141-41790932DC15}"/>
+                <a16:creationId xmlns:a16="http://schemas.microsoft.com/office/drawing/2014/main" id="{618000AA-604C-4E2E-9F28-4E9F73C1390E}"/>
               </a:ext>
             </a:extLst>
           </p:cNvPr>
@@ -12482,7 +12482,7 @@
         <p:spPr>
           <a:xfrm xmlns:a="http://schemas.openxmlformats.org/drawingml/2006/main">
             <a:off x="457200" y="1295400"/>
-            <a:ext cx="7810500" cy="361950"/>
+            <a:ext cx="8763000" cy="361950"/>
           </a:xfrm>
           <a:prstGeom xmlns:a="http://schemas.openxmlformats.org/drawingml/2006/main" prst="rect">
             <a:avLst/>
@@ -12524,7 +12524,7 @@
                 <a:ea typeface="Aptos"/>
                 <a:cs typeface="Aptos"/>
               </a:rPr>
-              <a:t>Gemma explores recovery options; ecosystem rules decide what can touch the tank.</a:t>
+              <a:t>Exact verifier failures return as bounded feedback; every revision is parsed and verified again.</a:t>
             </a:r>
           </a:p>
         </p:txBody>
@@ -12534,7 +12534,7 @@
           <p:cNvPr id="7" name="">
             <a:extLst xmlns:a="http://schemas.openxmlformats.org/drawingml/2006/main">
               <a:ext uri="{FF2B5EF4-FFF2-40B4-BE49-F238E27FC236}">
-                <a16:creationId xmlns:a16="http://schemas.microsoft.com/office/drawing/2014/main" id="{3C9AD02A-C843-4E25-8C51-F2E6C991D862}"/>
+                <a16:creationId xmlns:a16="http://schemas.microsoft.com/office/drawing/2014/main" id="{7F1E000A-B14A-4DE0-AAA6-AE6F7D8D58FC}"/>
               </a:ext>
             </a:extLst>
           </p:cNvPr>
@@ -12598,7 +12598,7 @@
           <p:cNvPr id="8" name="">
             <a:extLst xmlns:a="http://schemas.openxmlformats.org/drawingml/2006/main">
               <a:ext uri="{FF2B5EF4-FFF2-40B4-BE49-F238E27FC236}">
-                <a16:creationId xmlns:a16="http://schemas.microsoft.com/office/drawing/2014/main" id="{F316CEBD-AA38-412E-B6EF-8B37B6ECAD0F}"/>
+                <a16:creationId xmlns:a16="http://schemas.microsoft.com/office/drawing/2014/main" id="{C3181913-AD6C-41B9-A5EC-0E4EE3FF6F56}"/>
               </a:ext>
             </a:extLst>
           </p:cNvPr>
@@ -12631,19 +12631,19 @@
           <p:cNvPr id="9" name="">
             <a:extLst xmlns:a="http://schemas.openxmlformats.org/drawingml/2006/main">
               <a:ext uri="{FF2B5EF4-FFF2-40B4-BE49-F238E27FC236}">
-                <a16:creationId xmlns:a16="http://schemas.microsoft.com/office/drawing/2014/main" id="{12627886-C591-46C3-9A96-38F49F722732}"/>
-              </a:ext>
-            </a:extLst>
-          </p:cNvPr>
-          <p:cNvSpPr>
-            <a:spLocks xmlns:a="http://schemas.openxmlformats.org/drawingml/2006/main" noGrp="1"/>
-          </p:cNvSpPr>
-          <p:nvPr/>
-        </p:nvSpPr>
-        <p:spPr>
-          <a:xfrm xmlns:a="http://schemas.openxmlformats.org/drawingml/2006/main">
-            <a:off x="762000" y="2647950"/>
-            <a:ext cx="2800350" cy="400050"/>
+                <a16:creationId xmlns:a16="http://schemas.microsoft.com/office/drawing/2014/main" id="{5FB1B3D4-FDA9-4BA4-AFC9-447F6631048D}"/>
+              </a:ext>
+            </a:extLst>
+          </p:cNvPr>
+          <p:cNvSpPr>
+            <a:spLocks xmlns:a="http://schemas.openxmlformats.org/drawingml/2006/main" noGrp="1"/>
+          </p:cNvSpPr>
+          <p:nvPr/>
+        </p:nvSpPr>
+        <p:spPr>
+          <a:xfrm xmlns:a="http://schemas.openxmlformats.org/drawingml/2006/main">
+            <a:off x="723900" y="2628900"/>
+            <a:ext cx="2876550" cy="457200"/>
           </a:xfrm>
           <a:prstGeom xmlns:a="http://schemas.openxmlformats.org/drawingml/2006/main" prst="rect">
             <a:avLst/>
@@ -12667,7 +12667,7 @@
           <a:lstStyle xmlns:a="http://schemas.openxmlformats.org/drawingml/2006/main"/>
           <a:p xmlns:a="http://schemas.openxmlformats.org/drawingml/2006/main">
             <a:pPr algn="l">
-              <a:defRPr sz="1800" b="1">
+              <a:defRPr sz="1575" b="1">
                 <a:solidFill>
                   <a:srgbClr val="FFFFFF"/>
                 </a:solidFill>
@@ -12677,7 +12677,7 @@
               </a:defRPr>
             </a:pPr>
             <a:r>
-              <a:rPr sz="1800" b="1">
+              <a:rPr sz="1575" b="1">
                 <a:solidFill>
                   <a:srgbClr val="FFFFFF"/>
                 </a:solidFill>
@@ -12695,7 +12695,7 @@
           <p:cNvPr id="10" name="">
             <a:extLst xmlns:a="http://schemas.openxmlformats.org/drawingml/2006/main">
               <a:ext uri="{FF2B5EF4-FFF2-40B4-BE49-F238E27FC236}">
-                <a16:creationId xmlns:a16="http://schemas.microsoft.com/office/drawing/2014/main" id="{D96DC99E-52DD-4607-A138-5225DBCA1DB8}"/>
+                <a16:creationId xmlns:a16="http://schemas.microsoft.com/office/drawing/2014/main" id="{721C43D0-996C-461B-980C-037F1DEAEFC0}"/>
               </a:ext>
             </a:extLst>
           </p:cNvPr>
@@ -12730,7 +12730,7 @@
           <p:cNvPr id="11" name="">
             <a:extLst xmlns:a="http://schemas.openxmlformats.org/drawingml/2006/main">
               <a:ext uri="{FF2B5EF4-FFF2-40B4-BE49-F238E27FC236}">
-                <a16:creationId xmlns:a16="http://schemas.microsoft.com/office/drawing/2014/main" id="{91CCAA9C-DDAD-41E3-8B05-AEB647CE57CF}"/>
+                <a16:creationId xmlns:a16="http://schemas.microsoft.com/office/drawing/2014/main" id="{E3489FE2-B2C8-4E53-88A6-471ABBC41C1A}"/>
               </a:ext>
             </a:extLst>
           </p:cNvPr>
@@ -12742,7 +12742,7 @@
         <p:spPr>
           <a:xfrm xmlns:a="http://schemas.openxmlformats.org/drawingml/2006/main">
             <a:off x="952500" y="3276600"/>
-            <a:ext cx="2571750" cy="238125"/>
+            <a:ext cx="2571750" cy="257175"/>
           </a:xfrm>
           <a:prstGeom xmlns:a="http://schemas.openxmlformats.org/drawingml/2006/main" prst="rect">
             <a:avLst/>
@@ -12766,7 +12766,7 @@
           <a:lstStyle xmlns:a="http://schemas.openxmlformats.org/drawingml/2006/main"/>
           <a:p xmlns:a="http://schemas.openxmlformats.org/drawingml/2006/main">
             <a:pPr algn="l">
-              <a:defRPr sz="1125" b="0">
+              <a:defRPr sz="1050" b="0">
                 <a:solidFill>
                   <a:srgbClr val="C2D6DD"/>
                 </a:solidFill>
@@ -12776,7 +12776,7 @@
               </a:defRPr>
             </a:pPr>
             <a:r>
-              <a:rPr sz="1125" b="0">
+              <a:rPr sz="1050" b="0">
                 <a:solidFill>
                   <a:srgbClr val="C2D6DD"/>
                 </a:solidFill>
@@ -12794,7 +12794,7 @@
           <p:cNvPr id="12" name="">
             <a:extLst xmlns:a="http://schemas.openxmlformats.org/drawingml/2006/main">
               <a:ext uri="{FF2B5EF4-FFF2-40B4-BE49-F238E27FC236}">
-                <a16:creationId xmlns:a16="http://schemas.microsoft.com/office/drawing/2014/main" id="{CCCA0BCB-EB46-4A59-8FF2-6B5E2797208D}"/>
+                <a16:creationId xmlns:a16="http://schemas.microsoft.com/office/drawing/2014/main" id="{D4C281B5-7DED-430E-8A9A-842395D25081}"/>
               </a:ext>
             </a:extLst>
           </p:cNvPr>
@@ -12829,7 +12829,7 @@
           <p:cNvPr id="13" name="">
             <a:extLst xmlns:a="http://schemas.openxmlformats.org/drawingml/2006/main">
               <a:ext uri="{FF2B5EF4-FFF2-40B4-BE49-F238E27FC236}">
-                <a16:creationId xmlns:a16="http://schemas.microsoft.com/office/drawing/2014/main" id="{43B9FC53-5061-4022-9E2A-B43EFF3267AB}"/>
+                <a16:creationId xmlns:a16="http://schemas.microsoft.com/office/drawing/2014/main" id="{B5E01E4D-5528-4D91-BD15-44A7D06CA3E0}"/>
               </a:ext>
             </a:extLst>
           </p:cNvPr>
@@ -12841,7 +12841,7 @@
         <p:spPr>
           <a:xfrm xmlns:a="http://schemas.openxmlformats.org/drawingml/2006/main">
             <a:off x="952500" y="3676650"/>
-            <a:ext cx="2571750" cy="238125"/>
+            <a:ext cx="2571750" cy="257175"/>
           </a:xfrm>
           <a:prstGeom xmlns:a="http://schemas.openxmlformats.org/drawingml/2006/main" prst="rect">
             <a:avLst/>
@@ -12865,7 +12865,7 @@
           <a:lstStyle xmlns:a="http://schemas.openxmlformats.org/drawingml/2006/main"/>
           <a:p xmlns:a="http://schemas.openxmlformats.org/drawingml/2006/main">
             <a:pPr algn="l">
-              <a:defRPr sz="1125" b="0">
+              <a:defRPr sz="1050" b="0">
                 <a:solidFill>
                   <a:srgbClr val="C2D6DD"/>
                 </a:solidFill>
@@ -12875,7 +12875,7 @@
               </a:defRPr>
             </a:pPr>
             <a:r>
-              <a:rPr sz="1125" b="0">
+              <a:rPr sz="1050" b="0">
                 <a:solidFill>
                   <a:srgbClr val="C2D6DD"/>
                 </a:solidFill>
@@ -12893,7 +12893,7 @@
           <p:cNvPr id="14" name="">
             <a:extLst xmlns:a="http://schemas.openxmlformats.org/drawingml/2006/main">
               <a:ext uri="{FF2B5EF4-FFF2-40B4-BE49-F238E27FC236}">
-                <a16:creationId xmlns:a16="http://schemas.microsoft.com/office/drawing/2014/main" id="{6F6B72F3-4EEE-44A0-A1C3-D15495E5AE8D}"/>
+                <a16:creationId xmlns:a16="http://schemas.microsoft.com/office/drawing/2014/main" id="{54CC4DAE-4619-4BB0-9DB1-12F85A786528}"/>
               </a:ext>
             </a:extLst>
           </p:cNvPr>
@@ -12928,7 +12928,7 @@
           <p:cNvPr id="15" name="">
             <a:extLst xmlns:a="http://schemas.openxmlformats.org/drawingml/2006/main">
               <a:ext uri="{FF2B5EF4-FFF2-40B4-BE49-F238E27FC236}">
-                <a16:creationId xmlns:a16="http://schemas.microsoft.com/office/drawing/2014/main" id="{2B66DE89-F34E-4027-975F-BA85A1204312}"/>
+                <a16:creationId xmlns:a16="http://schemas.microsoft.com/office/drawing/2014/main" id="{FDEA6F06-0F3A-4F8F-B73D-96584E019FCD}"/>
               </a:ext>
             </a:extLst>
           </p:cNvPr>
@@ -12940,7 +12940,7 @@
         <p:spPr>
           <a:xfrm xmlns:a="http://schemas.openxmlformats.org/drawingml/2006/main">
             <a:off x="952500" y="4076700"/>
-            <a:ext cx="2571750" cy="238125"/>
+            <a:ext cx="2571750" cy="257175"/>
           </a:xfrm>
           <a:prstGeom xmlns:a="http://schemas.openxmlformats.org/drawingml/2006/main" prst="rect">
             <a:avLst/>
@@ -12964,7 +12964,7 @@
           <a:lstStyle xmlns:a="http://schemas.openxmlformats.org/drawingml/2006/main"/>
           <a:p xmlns:a="http://schemas.openxmlformats.org/drawingml/2006/main">
             <a:pPr algn="l">
-              <a:defRPr sz="1125" b="0">
+              <a:defRPr sz="1050" b="0">
                 <a:solidFill>
                   <a:srgbClr val="C2D6DD"/>
                 </a:solidFill>
@@ -12974,7 +12974,7 @@
               </a:defRPr>
             </a:pPr>
             <a:r>
-              <a:rPr sz="1125" b="0">
+              <a:rPr sz="1050" b="0">
                 <a:solidFill>
                   <a:srgbClr val="C2D6DD"/>
                 </a:solidFill>
@@ -12992,7 +12992,7 @@
           <p:cNvPr id="16" name="">
             <a:extLst xmlns:a="http://schemas.openxmlformats.org/drawingml/2006/main">
               <a:ext uri="{FF2B5EF4-FFF2-40B4-BE49-F238E27FC236}">
-                <a16:creationId xmlns:a16="http://schemas.microsoft.com/office/drawing/2014/main" id="{016534AB-A7C5-4C57-9ACF-34131E3D7F27}"/>
+                <a16:creationId xmlns:a16="http://schemas.microsoft.com/office/drawing/2014/main" id="{CD6B18BE-CA47-41BE-BFAD-150CD4ECA22D}"/>
               </a:ext>
             </a:extLst>
           </p:cNvPr>
@@ -13046,7 +13046,7 @@
                 <a:ea typeface="Aptos"/>
                 <a:cs typeface="Aptos"/>
               </a:rPr>
-              <a:t>SELECTED GEMMA RECOVERY</a:t>
+              <a:t>20-EMERGENCY REPAIR</a:t>
             </a:r>
           </a:p>
         </p:txBody>
@@ -13056,7 +13056,7 @@
           <p:cNvPr id="17" name="">
             <a:extLst xmlns:a="http://schemas.openxmlformats.org/drawingml/2006/main">
               <a:ext uri="{FF2B5EF4-FFF2-40B4-BE49-F238E27FC236}">
-                <a16:creationId xmlns:a16="http://schemas.microsoft.com/office/drawing/2014/main" id="{7FB460D1-4328-4BD8-9084-3E67377C643B}"/>
+                <a16:creationId xmlns:a16="http://schemas.microsoft.com/office/drawing/2014/main" id="{2416206B-C131-471B-BD07-C2F73A1EF7FB}"/>
               </a:ext>
             </a:extLst>
           </p:cNvPr>
@@ -13089,19 +13089,19 @@
           <p:cNvPr id="18" name="">
             <a:extLst xmlns:a="http://schemas.openxmlformats.org/drawingml/2006/main">
               <a:ext uri="{FF2B5EF4-FFF2-40B4-BE49-F238E27FC236}">
-                <a16:creationId xmlns:a16="http://schemas.microsoft.com/office/drawing/2014/main" id="{5DE5D8D8-A319-40CF-98E8-616E32AF23BF}"/>
-              </a:ext>
-            </a:extLst>
-          </p:cNvPr>
-          <p:cNvSpPr>
-            <a:spLocks xmlns:a="http://schemas.openxmlformats.org/drawingml/2006/main" noGrp="1"/>
-          </p:cNvSpPr>
-          <p:nvPr/>
-        </p:nvSpPr>
-        <p:spPr>
-          <a:xfrm xmlns:a="http://schemas.openxmlformats.org/drawingml/2006/main">
-            <a:off x="4552950" y="2647950"/>
-            <a:ext cx="2800350" cy="400050"/>
+                <a16:creationId xmlns:a16="http://schemas.microsoft.com/office/drawing/2014/main" id="{5C2DF7E7-B2C0-475E-B4E0-20AB9E84052E}"/>
+              </a:ext>
+            </a:extLst>
+          </p:cNvPr>
+          <p:cNvSpPr>
+            <a:spLocks xmlns:a="http://schemas.openxmlformats.org/drawingml/2006/main" noGrp="1"/>
+          </p:cNvSpPr>
+          <p:nvPr/>
+        </p:nvSpPr>
+        <p:spPr>
+          <a:xfrm xmlns:a="http://schemas.openxmlformats.org/drawingml/2006/main">
+            <a:off x="4514850" y="2628900"/>
+            <a:ext cx="2876550" cy="457200"/>
           </a:xfrm>
           <a:prstGeom xmlns:a="http://schemas.openxmlformats.org/drawingml/2006/main" prst="rect">
             <a:avLst/>
@@ -13125,7 +13125,7 @@
           <a:lstStyle xmlns:a="http://schemas.openxmlformats.org/drawingml/2006/main"/>
           <a:p xmlns:a="http://schemas.openxmlformats.org/drawingml/2006/main">
             <a:pPr algn="l">
-              <a:defRPr sz="1800" b="1">
+              <a:defRPr sz="1575" b="1">
                 <a:solidFill>
                   <a:srgbClr val="FFFFFF"/>
                 </a:solidFill>
@@ -13135,7 +13135,7 @@
               </a:defRPr>
             </a:pPr>
             <a:r>
-              <a:rPr sz="1800" b="1">
+              <a:rPr sz="1575" b="1">
                 <a:solidFill>
                   <a:srgbClr val="FFFFFF"/>
                 </a:solidFill>
@@ -13143,7 +13143,7 @@
                 <a:ea typeface="Aptos"/>
                 <a:cs typeface="Aptos"/>
               </a:rPr>
-              <a:t>+69.3611 reward</a:t>
+              <a:t>10% → 100% model-safe</a:t>
             </a:r>
           </a:p>
         </p:txBody>
@@ -13153,7 +13153,7 @@
           <p:cNvPr id="19" name="">
             <a:extLst xmlns:a="http://schemas.openxmlformats.org/drawingml/2006/main">
               <a:ext uri="{FF2B5EF4-FFF2-40B4-BE49-F238E27FC236}">
-                <a16:creationId xmlns:a16="http://schemas.microsoft.com/office/drawing/2014/main" id="{20F6158B-21ED-49DC-975B-AB10D02269BF}"/>
+                <a16:creationId xmlns:a16="http://schemas.microsoft.com/office/drawing/2014/main" id="{CB4F5A4F-99E7-4D93-B181-D0754BD4E21D}"/>
               </a:ext>
             </a:extLst>
           </p:cNvPr>
@@ -13188,7 +13188,7 @@
           <p:cNvPr id="20" name="">
             <a:extLst xmlns:a="http://schemas.openxmlformats.org/drawingml/2006/main">
               <a:ext uri="{FF2B5EF4-FFF2-40B4-BE49-F238E27FC236}">
-                <a16:creationId xmlns:a16="http://schemas.microsoft.com/office/drawing/2014/main" id="{EE2A5C74-D782-4C2F-8BF8-17532B512DAF}"/>
+                <a16:creationId xmlns:a16="http://schemas.microsoft.com/office/drawing/2014/main" id="{0FE14127-983C-46A9-B299-5DDD0113914B}"/>
               </a:ext>
             </a:extLst>
           </p:cNvPr>
@@ -13200,7 +13200,7 @@
         <p:spPr>
           <a:xfrm xmlns:a="http://schemas.openxmlformats.org/drawingml/2006/main">
             <a:off x="4743450" y="3276600"/>
-            <a:ext cx="2571750" cy="238125"/>
+            <a:ext cx="2571750" cy="257175"/>
           </a:xfrm>
           <a:prstGeom xmlns:a="http://schemas.openxmlformats.org/drawingml/2006/main" prst="rect">
             <a:avLst/>
@@ -13224,7 +13224,7 @@
           <a:lstStyle xmlns:a="http://schemas.openxmlformats.org/drawingml/2006/main"/>
           <a:p xmlns:a="http://schemas.openxmlformats.org/drawingml/2006/main">
             <a:pPr algn="l">
-              <a:defRPr sz="1125" b="0">
+              <a:defRPr sz="1050" b="0">
                 <a:solidFill>
                   <a:srgbClr val="C2D6DD"/>
                 </a:solidFill>
@@ -13234,7 +13234,7 @@
               </a:defRPr>
             </a:pPr>
             <a:r>
-              <a:rPr sz="1125" b="0">
+              <a:rPr sz="1050" b="0">
                 <a:solidFill>
                   <a:srgbClr val="C2D6DD"/>
                 </a:solidFill>
@@ -13242,7 +13242,7 @@
                 <a:ea typeface="Aptos"/>
                 <a:cs typeface="Aptos"/>
               </a:rPr>
-              <a:t>ammonia 2.4 → 0.85</a:t>
+              <a:t>18 rejected answers repaired</a:t>
             </a:r>
           </a:p>
         </p:txBody>
@@ -13252,7 +13252,7 @@
           <p:cNvPr id="21" name="">
             <a:extLst xmlns:a="http://schemas.openxmlformats.org/drawingml/2006/main">
               <a:ext uri="{FF2B5EF4-FFF2-40B4-BE49-F238E27FC236}">
-                <a16:creationId xmlns:a16="http://schemas.microsoft.com/office/drawing/2014/main" id="{41C46322-F39C-4B42-9F55-50DADABC6B40}"/>
+                <a16:creationId xmlns:a16="http://schemas.microsoft.com/office/drawing/2014/main" id="{A85B672C-DDFD-4D72-BCFC-F03BFF1BF792}"/>
               </a:ext>
             </a:extLst>
           </p:cNvPr>
@@ -13287,7 +13287,7 @@
           <p:cNvPr id="22" name="">
             <a:extLst xmlns:a="http://schemas.openxmlformats.org/drawingml/2006/main">
               <a:ext uri="{FF2B5EF4-FFF2-40B4-BE49-F238E27FC236}">
-                <a16:creationId xmlns:a16="http://schemas.microsoft.com/office/drawing/2014/main" id="{AA4D2401-1CD1-45D3-88B1-1E68468E8919}"/>
+                <a16:creationId xmlns:a16="http://schemas.microsoft.com/office/drawing/2014/main" id="{B3922578-5F03-48E2-BD3E-67BF10F6A188}"/>
               </a:ext>
             </a:extLst>
           </p:cNvPr>
@@ -13299,7 +13299,7 @@
         <p:spPr>
           <a:xfrm xmlns:a="http://schemas.openxmlformats.org/drawingml/2006/main">
             <a:off x="4743450" y="3676650"/>
-            <a:ext cx="2571750" cy="238125"/>
+            <a:ext cx="2571750" cy="257175"/>
           </a:xfrm>
           <a:prstGeom xmlns:a="http://schemas.openxmlformats.org/drawingml/2006/main" prst="rect">
             <a:avLst/>
@@ -13323,7 +13323,7 @@
           <a:lstStyle xmlns:a="http://schemas.openxmlformats.org/drawingml/2006/main"/>
           <a:p xmlns:a="http://schemas.openxmlformats.org/drawingml/2006/main">
             <a:pPr algn="l">
-              <a:defRPr sz="1125" b="0">
+              <a:defRPr sz="1050" b="0">
                 <a:solidFill>
                   <a:srgbClr val="C2D6DD"/>
                 </a:solidFill>
@@ -13333,7 +13333,7 @@
               </a:defRPr>
             </a:pPr>
             <a:r>
-              <a:rPr sz="1125" b="0">
+              <a:rPr sz="1050" b="0">
                 <a:solidFill>
                   <a:srgbClr val="C2D6DD"/>
                 </a:solidFill>
@@ -13341,7 +13341,7 @@
                 <a:ea typeface="Aptos"/>
                 <a:cs typeface="Aptos"/>
               </a:rPr>
-              <a:t>oxygen 4.8 → 5.5058</a:t>
+              <a:t>17 in one revision · 1 in two</a:t>
             </a:r>
           </a:p>
         </p:txBody>
@@ -13351,7 +13351,7 @@
           <p:cNvPr id="23" name="">
             <a:extLst xmlns:a="http://schemas.openxmlformats.org/drawingml/2006/main">
               <a:ext uri="{FF2B5EF4-FFF2-40B4-BE49-F238E27FC236}">
-                <a16:creationId xmlns:a16="http://schemas.microsoft.com/office/drawing/2014/main" id="{389FA391-DFA5-4BE2-B625-B15578DC2497}"/>
+                <a16:creationId xmlns:a16="http://schemas.microsoft.com/office/drawing/2014/main" id="{7D22D130-0566-484E-91A2-85311E31580F}"/>
               </a:ext>
             </a:extLst>
           </p:cNvPr>
@@ -13386,7 +13386,7 @@
           <p:cNvPr id="24" name="">
             <a:extLst xmlns:a="http://schemas.openxmlformats.org/drawingml/2006/main">
               <a:ext uri="{FF2B5EF4-FFF2-40B4-BE49-F238E27FC236}">
-                <a16:creationId xmlns:a16="http://schemas.microsoft.com/office/drawing/2014/main" id="{AF198EB4-40F1-499E-92C8-F2B79FE763FB}"/>
+                <a16:creationId xmlns:a16="http://schemas.microsoft.com/office/drawing/2014/main" id="{39DBA509-B4DE-4AD3-B74B-70D1D22B8F8C}"/>
               </a:ext>
             </a:extLst>
           </p:cNvPr>
@@ -13398,7 +13398,7 @@
         <p:spPr>
           <a:xfrm xmlns:a="http://schemas.openxmlformats.org/drawingml/2006/main">
             <a:off x="4743450" y="4076700"/>
-            <a:ext cx="2571750" cy="238125"/>
+            <a:ext cx="2571750" cy="257175"/>
           </a:xfrm>
           <a:prstGeom xmlns:a="http://schemas.openxmlformats.org/drawingml/2006/main" prst="rect">
             <a:avLst/>
@@ -13422,7 +13422,7 @@
           <a:lstStyle xmlns:a="http://schemas.openxmlformats.org/drawingml/2006/main"/>
           <a:p xmlns:a="http://schemas.openxmlformats.org/drawingml/2006/main">
             <a:pPr algn="l">
-              <a:defRPr sz="1125" b="0">
+              <a:defRPr sz="1050" b="0">
                 <a:solidFill>
                   <a:srgbClr val="C2D6DD"/>
                 </a:solidFill>
@@ -13432,7 +13432,7 @@
               </a:defRPr>
             </a:pPr>
             <a:r>
-              <a:rPr sz="1125" b="0">
+              <a:rPr sz="1050" b="0">
                 <a:solidFill>
                   <a:srgbClr val="C2D6DD"/>
                 </a:solidFill>
@@ -13440,7 +13440,7 @@
                 <a:ea typeface="Aptos"/>
                 <a:cs typeface="Aptos"/>
               </a:rPr>
-              <a:t>unsafe control rejected</a:t>
+              <a:t>0 fallback · no weight update</a:t>
             </a:r>
           </a:p>
         </p:txBody>
@@ -13450,7 +13450,7 @@
           <p:cNvPr id="25" name="">
             <a:extLst xmlns:a="http://schemas.openxmlformats.org/drawingml/2006/main">
               <a:ext uri="{FF2B5EF4-FFF2-40B4-BE49-F238E27FC236}">
-                <a16:creationId xmlns:a16="http://schemas.microsoft.com/office/drawing/2014/main" id="{4E508757-C820-4E15-8725-68D10DC006F1}"/>
+                <a16:creationId xmlns:a16="http://schemas.microsoft.com/office/drawing/2014/main" id="{A8B3D88D-72F7-4A03-B6BE-ECF54255B493}"/>
               </a:ext>
             </a:extLst>
           </p:cNvPr>
@@ -13504,7 +13504,7 @@
                 <a:ea typeface="Aptos"/>
                 <a:cs typeface="Aptos"/>
               </a:rPr>
-              <a:t>5-EMERGENCY AUDIT</a:t>
+              <a:t>MEASURED EXECUTION</a:t>
             </a:r>
           </a:p>
         </p:txBody>
@@ -13514,7 +13514,7 @@
           <p:cNvPr id="26" name="">
             <a:extLst xmlns:a="http://schemas.openxmlformats.org/drawingml/2006/main">
               <a:ext uri="{FF2B5EF4-FFF2-40B4-BE49-F238E27FC236}">
-                <a16:creationId xmlns:a16="http://schemas.microsoft.com/office/drawing/2014/main" id="{ABE3A4F8-42DB-4194-9CE8-21D4399B9470}"/>
+                <a16:creationId xmlns:a16="http://schemas.microsoft.com/office/drawing/2014/main" id="{88C0B225-93EF-4850-B137-005188B499BC}"/>
               </a:ext>
             </a:extLst>
           </p:cNvPr>
@@ -13547,19 +13547,19 @@
           <p:cNvPr id="27" name="">
             <a:extLst xmlns:a="http://schemas.openxmlformats.org/drawingml/2006/main">
               <a:ext uri="{FF2B5EF4-FFF2-40B4-BE49-F238E27FC236}">
-                <a16:creationId xmlns:a16="http://schemas.microsoft.com/office/drawing/2014/main" id="{28F7462E-6905-4257-8E04-62C9BED05112}"/>
-              </a:ext>
-            </a:extLst>
-          </p:cNvPr>
-          <p:cNvSpPr>
-            <a:spLocks xmlns:a="http://schemas.openxmlformats.org/drawingml/2006/main" noGrp="1"/>
-          </p:cNvSpPr>
-          <p:nvPr/>
-        </p:nvSpPr>
-        <p:spPr>
-          <a:xfrm xmlns:a="http://schemas.openxmlformats.org/drawingml/2006/main">
-            <a:off x="8343900" y="2647950"/>
-            <a:ext cx="2800350" cy="400050"/>
+                <a16:creationId xmlns:a16="http://schemas.microsoft.com/office/drawing/2014/main" id="{AFC2989E-F220-4355-94DF-C964B8AD6369}"/>
+              </a:ext>
+            </a:extLst>
+          </p:cNvPr>
+          <p:cNvSpPr>
+            <a:spLocks xmlns:a="http://schemas.openxmlformats.org/drawingml/2006/main" noGrp="1"/>
+          </p:cNvSpPr>
+          <p:nvPr/>
+        </p:nvSpPr>
+        <p:spPr>
+          <a:xfrm xmlns:a="http://schemas.openxmlformats.org/drawingml/2006/main">
+            <a:off x="8305800" y="2628900"/>
+            <a:ext cx="2876550" cy="457200"/>
           </a:xfrm>
           <a:prstGeom xmlns:a="http://schemas.openxmlformats.org/drawingml/2006/main" prst="rect">
             <a:avLst/>
@@ -13583,7 +13583,7 @@
           <a:lstStyle xmlns:a="http://schemas.openxmlformats.org/drawingml/2006/main"/>
           <a:p xmlns:a="http://schemas.openxmlformats.org/drawingml/2006/main">
             <a:pPr algn="l">
-              <a:defRPr sz="1800" b="1">
+              <a:defRPr sz="1575" b="1">
                 <a:solidFill>
                   <a:srgbClr val="FFFFFF"/>
                 </a:solidFill>
@@ -13593,7 +13593,7 @@
               </a:defRPr>
             </a:pPr>
             <a:r>
-              <a:rPr sz="1800" b="1">
+              <a:rPr sz="1575" b="1">
                 <a:solidFill>
                   <a:srgbClr val="FFFFFF"/>
                 </a:solidFill>
@@ -13601,7 +13601,7 @@
                 <a:ea typeface="Aptos"/>
                 <a:cs typeface="Aptos"/>
               </a:rPr>
-              <a:t>20% → 100% safe</a:t>
+              <a:t>139 requests</a:t>
             </a:r>
           </a:p>
         </p:txBody>
@@ -13611,7 +13611,7 @@
           <p:cNvPr id="28" name="">
             <a:extLst xmlns:a="http://schemas.openxmlformats.org/drawingml/2006/main">
               <a:ext uri="{FF2B5EF4-FFF2-40B4-BE49-F238E27FC236}">
-                <a16:creationId xmlns:a16="http://schemas.microsoft.com/office/drawing/2014/main" id="{313FB59C-0271-4476-90C9-2D77995575CC}"/>
+                <a16:creationId xmlns:a16="http://schemas.microsoft.com/office/drawing/2014/main" id="{E38A0E41-8094-4CE3-80BB-820E7BC87378}"/>
               </a:ext>
             </a:extLst>
           </p:cNvPr>
@@ -13646,7 +13646,7 @@
           <p:cNvPr id="29" name="">
             <a:extLst xmlns:a="http://schemas.openxmlformats.org/drawingml/2006/main">
               <a:ext uri="{FF2B5EF4-FFF2-40B4-BE49-F238E27FC236}">
-                <a16:creationId xmlns:a16="http://schemas.microsoft.com/office/drawing/2014/main" id="{89EB0DF6-E88C-4921-8057-4D8DFFE8BF52}"/>
+                <a16:creationId xmlns:a16="http://schemas.microsoft.com/office/drawing/2014/main" id="{F711478E-A2B8-45E3-9479-5350F145E613}"/>
               </a:ext>
             </a:extLst>
           </p:cNvPr>
@@ -13658,7 +13658,7 @@
         <p:spPr>
           <a:xfrm xmlns:a="http://schemas.openxmlformats.org/drawingml/2006/main">
             <a:off x="8534400" y="3276600"/>
-            <a:ext cx="2571750" cy="238125"/>
+            <a:ext cx="2571750" cy="257175"/>
           </a:xfrm>
           <a:prstGeom xmlns:a="http://schemas.openxmlformats.org/drawingml/2006/main" prst="rect">
             <a:avLst/>
@@ -13682,7 +13682,7 @@
           <a:lstStyle xmlns:a="http://schemas.openxmlformats.org/drawingml/2006/main"/>
           <a:p xmlns:a="http://schemas.openxmlformats.org/drawingml/2006/main">
             <a:pPr algn="l">
-              <a:defRPr sz="1125" b="0">
+              <a:defRPr sz="1050" b="0">
                 <a:solidFill>
                   <a:srgbClr val="C2D6DD"/>
                 </a:solidFill>
@@ -13692,7 +13692,7 @@
               </a:defRPr>
             </a:pPr>
             <a:r>
-              <a:rPr sz="1125" b="0">
+              <a:rPr sz="1050" b="0">
                 <a:solidFill>
                   <a:srgbClr val="C2D6DD"/>
                 </a:solidFill>
@@ -13700,7 +13700,7 @@
                 <a:ea typeface="Aptos"/>
                 <a:cs typeface="Aptos"/>
               </a:rPr>
-              <a:t>30 Gemma plans tested</a:t>
+              <a:t>60,385 observed tokens</a:t>
             </a:r>
           </a:p>
         </p:txBody>
@@ -13710,7 +13710,7 @@
           <p:cNvPr id="30" name="">
             <a:extLst xmlns:a="http://schemas.openxmlformats.org/drawingml/2006/main">
               <a:ext uri="{FF2B5EF4-FFF2-40B4-BE49-F238E27FC236}">
-                <a16:creationId xmlns:a16="http://schemas.microsoft.com/office/drawing/2014/main" id="{C09104F9-2EB0-4FF8-8701-2F17AF1D9044}"/>
+                <a16:creationId xmlns:a16="http://schemas.microsoft.com/office/drawing/2014/main" id="{6B048E4F-0718-40E9-8772-FE41A80CA72E}"/>
               </a:ext>
             </a:extLst>
           </p:cNvPr>
@@ -13745,7 +13745,7 @@
           <p:cNvPr id="31" name="">
             <a:extLst xmlns:a="http://schemas.openxmlformats.org/drawingml/2006/main">
               <a:ext uri="{FF2B5EF4-FFF2-40B4-BE49-F238E27FC236}">
-                <a16:creationId xmlns:a16="http://schemas.microsoft.com/office/drawing/2014/main" id="{C95FB29C-AA27-4194-84D5-CDB58E18E7B3}"/>
+                <a16:creationId xmlns:a16="http://schemas.microsoft.com/office/drawing/2014/main" id="{54506666-DA02-436C-AEED-4053C9A00976}"/>
               </a:ext>
             </a:extLst>
           </p:cNvPr>
@@ -13757,7 +13757,7 @@
         <p:spPr>
           <a:xfrm xmlns:a="http://schemas.openxmlformats.org/drawingml/2006/main">
             <a:off x="8534400" y="3676650"/>
-            <a:ext cx="2571750" cy="238125"/>
+            <a:ext cx="2571750" cy="257175"/>
           </a:xfrm>
           <a:prstGeom xmlns:a="http://schemas.openxmlformats.org/drawingml/2006/main" prst="rect">
             <a:avLst/>
@@ -13781,7 +13781,7 @@
           <a:lstStyle xmlns:a="http://schemas.openxmlformats.org/drawingml/2006/main"/>
           <a:p xmlns:a="http://schemas.openxmlformats.org/drawingml/2006/main">
             <a:pPr algn="l">
-              <a:defRPr sz="1125" b="0">
+              <a:defRPr sz="1050" b="0">
                 <a:solidFill>
                   <a:srgbClr val="C2D6DD"/>
                 </a:solidFill>
@@ -13791,7 +13791,7 @@
               </a:defRPr>
             </a:pPr>
             <a:r>
-              <a:rPr sz="1125" b="0">
+              <a:rPr sz="1050" b="0">
                 <a:solidFill>
                   <a:srgbClr val="C2D6DD"/>
                 </a:solidFill>
@@ -13799,7 +13799,7 @@
                 <a:ea typeface="Aptos"/>
                 <a:cs typeface="Aptos"/>
               </a:rPr>
-              <a:t>4 first-answer rescues</a:t>
+              <a:t>99.793 completion tokens/s</a:t>
             </a:r>
           </a:p>
         </p:txBody>
@@ -13809,7 +13809,7 @@
           <p:cNvPr id="32" name="">
             <a:extLst xmlns:a="http://schemas.openxmlformats.org/drawingml/2006/main">
               <a:ext uri="{FF2B5EF4-FFF2-40B4-BE49-F238E27FC236}">
-                <a16:creationId xmlns:a16="http://schemas.microsoft.com/office/drawing/2014/main" id="{B6F301B3-CEF7-47E4-BC07-55B2614A8446}"/>
+                <a16:creationId xmlns:a16="http://schemas.microsoft.com/office/drawing/2014/main" id="{1806C8E3-C06B-4640-94AC-2830253F76D8}"/>
               </a:ext>
             </a:extLst>
           </p:cNvPr>
@@ -13844,7 +13844,7 @@
           <p:cNvPr id="33" name="">
             <a:extLst xmlns:a="http://schemas.openxmlformats.org/drawingml/2006/main">
               <a:ext uri="{FF2B5EF4-FFF2-40B4-BE49-F238E27FC236}">
-                <a16:creationId xmlns:a16="http://schemas.microsoft.com/office/drawing/2014/main" id="{B3884228-043C-44D2-9142-6DFC0ABEB39C}"/>
+                <a16:creationId xmlns:a16="http://schemas.microsoft.com/office/drawing/2014/main" id="{F20AF186-25B1-4F3D-A750-E83C990995D8}"/>
               </a:ext>
             </a:extLst>
           </p:cNvPr>
@@ -13856,7 +13856,7 @@
         <p:spPr>
           <a:xfrm xmlns:a="http://schemas.openxmlformats.org/drawingml/2006/main">
             <a:off x="8534400" y="4076700"/>
-            <a:ext cx="2571750" cy="238125"/>
+            <a:ext cx="2571750" cy="257175"/>
           </a:xfrm>
           <a:prstGeom xmlns:a="http://schemas.openxmlformats.org/drawingml/2006/main" prst="rect">
             <a:avLst/>
@@ -13880,7 +13880,7 @@
           <a:lstStyle xmlns:a="http://schemas.openxmlformats.org/drawingml/2006/main"/>
           <a:p xmlns:a="http://schemas.openxmlformats.org/drawingml/2006/main">
             <a:pPr algn="l">
-              <a:defRPr sz="1125" b="0">
+              <a:defRPr sz="1050" b="0">
                 <a:solidFill>
                   <a:srgbClr val="C2D6DD"/>
                 </a:solidFill>
@@ -13890,7 +13890,7 @@
               </a:defRPr>
             </a:pPr>
             <a:r>
-              <a:rPr sz="1125" b="0">
+              <a:rPr sz="1050" b="0">
                 <a:solidFill>
                   <a:srgbClr val="C2D6DD"/>
                 </a:solidFill>
@@ -13898,7 +13898,7 @@
                 <a:ea typeface="Aptos"/>
                 <a:cs typeface="Aptos"/>
               </a:rPr>
-              <a:t>3 explicit fallbacks</a:t>
+              <a:t>p50 latency · 655.522 ms</a:t>
             </a:r>
           </a:p>
         </p:txBody>
@@ -13908,19 +13908,19 @@
           <p:cNvPr id="34" name="">
             <a:extLst xmlns:a="http://schemas.openxmlformats.org/drawingml/2006/main">
               <a:ext uri="{FF2B5EF4-FFF2-40B4-BE49-F238E27FC236}">
-                <a16:creationId xmlns:a16="http://schemas.microsoft.com/office/drawing/2014/main" id="{DE9FEC93-D3DE-40EC-80C7-D1FD074351CA}"/>
-              </a:ext>
-            </a:extLst>
-          </p:cNvPr>
-          <p:cNvSpPr>
-            <a:spLocks xmlns:a="http://schemas.openxmlformats.org/drawingml/2006/main" noGrp="1"/>
-          </p:cNvSpPr>
-          <p:nvPr/>
-        </p:nvSpPr>
-        <p:spPr>
-          <a:xfrm xmlns:a="http://schemas.openxmlformats.org/drawingml/2006/main">
-            <a:off x="495300" y="5124450"/>
-            <a:ext cx="10915650" cy="438150"/>
+                <a16:creationId xmlns:a16="http://schemas.microsoft.com/office/drawing/2014/main" id="{8580275D-DE85-46CB-B986-CA7C0255284B}"/>
+              </a:ext>
+            </a:extLst>
+          </p:cNvPr>
+          <p:cNvSpPr>
+            <a:spLocks xmlns:a="http://schemas.openxmlformats.org/drawingml/2006/main" noGrp="1"/>
+          </p:cNvSpPr>
+          <p:nvPr/>
+        </p:nvSpPr>
+        <p:spPr>
+          <a:xfrm xmlns:a="http://schemas.openxmlformats.org/drawingml/2006/main">
+            <a:off x="495300" y="5067300"/>
+            <a:ext cx="10915650" cy="514350"/>
           </a:xfrm>
           <a:prstGeom xmlns:a="http://schemas.openxmlformats.org/drawingml/2006/main" prst="rect">
             <a:avLst/>
@@ -13944,7 +13944,7 @@
           <a:lstStyle xmlns:a="http://schemas.openxmlformats.org/drawingml/2006/main"/>
           <a:p xmlns:a="http://schemas.openxmlformats.org/drawingml/2006/main">
             <a:pPr algn="ctr">
-              <a:defRPr sz="1725" b="1">
+              <a:defRPr sz="1575" b="1">
                 <a:solidFill>
                   <a:srgbClr val="8EE7D5"/>
                 </a:solidFill>
@@ -13954,7 +13954,7 @@
               </a:defRPr>
             </a:pPr>
             <a:r>
-              <a:rPr sz="1725" b="1">
+              <a:rPr sz="1575" b="1">
                 <a:solidFill>
                   <a:srgbClr val="8EE7D5"/>
                 </a:solidFill>
@@ -13962,7 +13962,7 @@
                 <a:ea typeface="Aptos"/>
                 <a:cs typeface="Aptos"/>
               </a:rPr>
-              <a:t>103.1 kg aggregate fish + prawn biomass protected across the audit</a:t>
+              <a:t>420.648 kg aggregate scenario biomass · +221.7244 mean reward vs naive</a:t>
             </a:r>
           </a:p>
         </p:txBody>
@@ -13972,7 +13972,7 @@
           <p:cNvPr id="35" name="">
             <a:extLst xmlns:a="http://schemas.openxmlformats.org/drawingml/2006/main">
               <a:ext uri="{FF2B5EF4-FFF2-40B4-BE49-F238E27FC236}">
-                <a16:creationId xmlns:a16="http://schemas.microsoft.com/office/drawing/2014/main" id="{2784D48B-DDE5-4BE7-A961-F1271A8518EB}"/>
+                <a16:creationId xmlns:a16="http://schemas.microsoft.com/office/drawing/2014/main" id="{F6A6E608-8BC8-4F69-8D6D-5DEB71A31F95}"/>
               </a:ext>
             </a:extLst>
           </p:cNvPr>
@@ -14026,7 +14026,7 @@
                 <a:ea typeface="Aptos"/>
                 <a:cs typeface="Aptos"/>
               </a:rPr>
-              <a:t>Captured AMD experiment; the durable public URL remains on its private 8 GB host and CPU fallback.</a:t>
+              <a:t>Captured inference-time repair experiment; the public URL remains on its private 8 GB host and CPU fallback.</a:t>
             </a:r>
           </a:p>
         </p:txBody>
@@ -14034,7 +14034,7 @@
     </p:spTree>
     <p:extLst>
       <p:ext uri="{BB962C8B-B14F-4D97-AF65-F5344CB8AC3E}">
-        <p14:creationId xmlns:p14="http://schemas.microsoft.com/office/powerpoint/2010/main" val="1157870933"/>
+        <p14:creationId xmlns:p14="http://schemas.microsoft.com/office/powerpoint/2010/main" val="1393775145"/>
       </p:ext>
     </p:extLst>
   </p:cSld>

</xml_diff>

<commit_message>
Refresh final deck and five-minute narration packet
</commit_message>
<xml_diff>
--- a/submission/proteinloop-hackathon-deck.pptx
+++ b/submission/proteinloop-hackathon-deck.pptx
@@ -2,22 +2,22 @@
 <file path=ppt/presentation.xml><?xml version="1.0" encoding="utf-8"?>
 <p:presentation xmlns:p="http://schemas.openxmlformats.org/presentationml/2006/main">
   <p:sldMasterIdLst>
-    <p:sldMasterId xmlns:r="http://schemas.openxmlformats.org/officeDocument/2006/relationships" id="2147483648" r:id="Rc43f6c7084f645ff"/>
+    <p:sldMasterId xmlns:r="http://schemas.openxmlformats.org/officeDocument/2006/relationships" id="2147483648" r:id="R97394484b6144a31"/>
   </p:sldMasterIdLst>
   <p:notesMasterIdLst>
-    <p:notesMasterId xmlns:r="http://schemas.openxmlformats.org/officeDocument/2006/relationships" r:id="R33d9de035e314c9e"/>
+    <p:notesMasterId xmlns:r="http://schemas.openxmlformats.org/officeDocument/2006/relationships" r:id="R96286468157c42c8"/>
   </p:notesMasterIdLst>
   <p:sldIdLst>
-    <p:sldId xmlns:r="http://schemas.openxmlformats.org/officeDocument/2006/relationships" id="256" r:id="R2d5fde3b903e4b9e"/>
-    <p:sldId xmlns:r="http://schemas.openxmlformats.org/officeDocument/2006/relationships" id="257" r:id="R1217456440cd4cdc"/>
-    <p:sldId xmlns:r="http://schemas.openxmlformats.org/officeDocument/2006/relationships" id="258" r:id="R52e9c284bcc843be"/>
-    <p:sldId xmlns:r="http://schemas.openxmlformats.org/officeDocument/2006/relationships" id="259" r:id="R63ec9cc3300d48d9"/>
-    <p:sldId xmlns:r="http://schemas.openxmlformats.org/officeDocument/2006/relationships" id="260" r:id="Ra97d5b35afbe4564"/>
-    <p:sldId xmlns:r="http://schemas.openxmlformats.org/officeDocument/2006/relationships" id="261" r:id="R09ade37bb27f40e8"/>
-    <p:sldId xmlns:r="http://schemas.openxmlformats.org/officeDocument/2006/relationships" id="262" r:id="R7267e5ed5e0d4454"/>
-    <p:sldId xmlns:r="http://schemas.openxmlformats.org/officeDocument/2006/relationships" id="263" r:id="Raa758599d80f48d7"/>
-    <p:sldId xmlns:r="http://schemas.openxmlformats.org/officeDocument/2006/relationships" id="264" r:id="R2555772b043c4628"/>
-    <p:sldId xmlns:r="http://schemas.openxmlformats.org/officeDocument/2006/relationships" id="265" r:id="Rb174eacc635f40fb"/>
+    <p:sldId xmlns:r="http://schemas.openxmlformats.org/officeDocument/2006/relationships" id="256" r:id="R38d02799261f4d20"/>
+    <p:sldId xmlns:r="http://schemas.openxmlformats.org/officeDocument/2006/relationships" id="257" r:id="R57df318febc84a30"/>
+    <p:sldId xmlns:r="http://schemas.openxmlformats.org/officeDocument/2006/relationships" id="258" r:id="R84abac6412c1452a"/>
+    <p:sldId xmlns:r="http://schemas.openxmlformats.org/officeDocument/2006/relationships" id="259" r:id="R7613094a0e71404c"/>
+    <p:sldId xmlns:r="http://schemas.openxmlformats.org/officeDocument/2006/relationships" id="260" r:id="R4c3edec5ecfa489c"/>
+    <p:sldId xmlns:r="http://schemas.openxmlformats.org/officeDocument/2006/relationships" id="261" r:id="Rbb8802f502834553"/>
+    <p:sldId xmlns:r="http://schemas.openxmlformats.org/officeDocument/2006/relationships" id="262" r:id="Rd3f0716a9b8f4545"/>
+    <p:sldId xmlns:r="http://schemas.openxmlformats.org/officeDocument/2006/relationships" id="263" r:id="R801c90ec1a13462d"/>
+    <p:sldId xmlns:r="http://schemas.openxmlformats.org/officeDocument/2006/relationships" id="264" r:id="R0443747809544dc5"/>
+    <p:sldId xmlns:r="http://schemas.openxmlformats.org/officeDocument/2006/relationships" id="265" r:id="R97c17b4a004546ee"/>
   </p:sldIdLst>
   <p:sldSz cx="12192000" cy="6858000"/>
   <p:notesSz cx="6858000" cy="9144000"/>
@@ -1158,7 +1158,7 @@
   </p:cSld>
   <p:clrMap bg1="lt1" tx1="dk1" bg2="lt2" tx2="dk2" accent1="accent1" accent2="accent2" accent3="accent3" accent4="accent4" accent5="accent5" accent6="accent6" hlink="hlink" folHlink="folHlink"/>
   <p:sldLayoutIdLst>
-    <p:sldLayoutId xmlns:r="http://schemas.openxmlformats.org/officeDocument/2006/relationships" id="2147483649" r:id="R00e0bb4ca6194f95"/>
+    <p:sldLayoutId xmlns:r="http://schemas.openxmlformats.org/officeDocument/2006/relationships" id="2147483649" r:id="R91f4be214b6c4102"/>
   </p:sldLayoutIdLst>
   <p:txStyles>
     <p:titleStyle>
@@ -1461,7 +1461,7 @@
           <p:nvPr/>
         </p:nvPicPr>
         <p:blipFill>
-          <a:blip xmlns:r="http://schemas.openxmlformats.org/officeDocument/2006/relationships" xmlns:a="http://schemas.openxmlformats.org/drawingml/2006/main" r:embed="Rc3fd1e277b624bf0"/>
+          <a:blip xmlns:r="http://schemas.openxmlformats.org/officeDocument/2006/relationships" xmlns:a="http://schemas.openxmlformats.org/drawingml/2006/main" r:embed="R33fa05e25c904dd5"/>
           <a:srcRect xmlns:a="http://schemas.openxmlformats.org/drawingml/2006/main" l="0" t="0" r="0" b="0"/>
           <a:stretch xmlns:a="http://schemas.openxmlformats.org/drawingml/2006/main">
             <a:fillRect l="0" t="0" r="0" b="0"/>
@@ -1480,7 +1480,7 @@
     </p:spTree>
     <p:extLst>
       <p:ext uri="{BB962C8B-B14F-4D97-AF65-F5344CB8AC3E}">
-        <p14:creationId xmlns:p14="http://schemas.microsoft.com/office/powerpoint/2010/main" val="884555811"/>
+        <p14:creationId xmlns:p14="http://schemas.microsoft.com/office/powerpoint/2010/main" val="1679517453"/>
       </p:ext>
     </p:extLst>
   </p:cSld>
@@ -1504,7 +1504,7 @@
           <p:cNvPr id="1" name="">
             <a:extLst xmlns:a="http://schemas.openxmlformats.org/drawingml/2006/main">
               <a:ext uri="{FF2B5EF4-FFF2-40B4-BE49-F238E27FC236}">
-                <a16:creationId xmlns:a16="http://schemas.microsoft.com/office/drawing/2014/main" id="{BA77CD62-A0C5-4BD4-9E0F-A4EA00956A09}"/>
+                <a16:creationId xmlns:a16="http://schemas.microsoft.com/office/drawing/2014/main" id="{60E00D74-DBB5-4410-B046-55CB97D4D5C7}"/>
               </a:ext>
             </a:extLst>
           </p:cNvPr>
@@ -1539,7 +1539,7 @@
           <p:cNvPr id="2" name="">
             <a:extLst xmlns:a="http://schemas.openxmlformats.org/drawingml/2006/main">
               <a:ext uri="{FF2B5EF4-FFF2-40B4-BE49-F238E27FC236}">
-                <a16:creationId xmlns:a16="http://schemas.microsoft.com/office/drawing/2014/main" id="{4C8B1C47-2C57-4CDE-B578-2A598DBD080B}"/>
+                <a16:creationId xmlns:a16="http://schemas.microsoft.com/office/drawing/2014/main" id="{37F4A09C-D3C7-454C-A5CA-DC263AC17140}"/>
               </a:ext>
             </a:extLst>
           </p:cNvPr>
@@ -1574,7 +1574,7 @@
           <p:cNvPr id="3" name="">
             <a:extLst xmlns:a="http://schemas.openxmlformats.org/drawingml/2006/main">
               <a:ext uri="{FF2B5EF4-FFF2-40B4-BE49-F238E27FC236}">
-                <a16:creationId xmlns:a16="http://schemas.microsoft.com/office/drawing/2014/main" id="{21EB63C5-366A-423A-B2DB-92FD5173AEE9}"/>
+                <a16:creationId xmlns:a16="http://schemas.microsoft.com/office/drawing/2014/main" id="{18DEC6E3-FDEE-482E-BB6B-9CADFCF7B6A2}"/>
               </a:ext>
             </a:extLst>
           </p:cNvPr>
@@ -1638,7 +1638,7 @@
           <p:cNvPr id="4" name="">
             <a:extLst xmlns:a="http://schemas.openxmlformats.org/drawingml/2006/main">
               <a:ext uri="{FF2B5EF4-FFF2-40B4-BE49-F238E27FC236}">
-                <a16:creationId xmlns:a16="http://schemas.microsoft.com/office/drawing/2014/main" id="{50C65D66-FFF3-44E2-98EA-26C06794C286}"/>
+                <a16:creationId xmlns:a16="http://schemas.microsoft.com/office/drawing/2014/main" id="{82E49734-D7DF-40CC-BC21-4B6A670E5464}"/>
               </a:ext>
             </a:extLst>
           </p:cNvPr>
@@ -1702,7 +1702,7 @@
           <p:cNvPr id="5" name="">
             <a:extLst xmlns:a="http://schemas.openxmlformats.org/drawingml/2006/main">
               <a:ext uri="{FF2B5EF4-FFF2-40B4-BE49-F238E27FC236}">
-                <a16:creationId xmlns:a16="http://schemas.microsoft.com/office/drawing/2014/main" id="{5181B62C-9CA5-431F-9CCB-C19F2C899BD6}"/>
+                <a16:creationId xmlns:a16="http://schemas.microsoft.com/office/drawing/2014/main" id="{4651650F-628D-4CE9-B2FB-06028FE8DF43}"/>
               </a:ext>
             </a:extLst>
           </p:cNvPr>
@@ -1766,7 +1766,7 @@
           <p:cNvPr id="6" name="">
             <a:extLst xmlns:a="http://schemas.openxmlformats.org/drawingml/2006/main">
               <a:ext uri="{FF2B5EF4-FFF2-40B4-BE49-F238E27FC236}">
-                <a16:creationId xmlns:a16="http://schemas.microsoft.com/office/drawing/2014/main" id="{4150A5F3-5FFB-43FA-A6C4-B2D0838C1BB3}"/>
+                <a16:creationId xmlns:a16="http://schemas.microsoft.com/office/drawing/2014/main" id="{FBA3DA8C-629B-40E0-9A8D-52C7F3AEAD20}"/>
               </a:ext>
             </a:extLst>
           </p:cNvPr>
@@ -1801,7 +1801,7 @@
           <p:cNvPr id="7" name="">
             <a:extLst xmlns:a="http://schemas.openxmlformats.org/drawingml/2006/main">
               <a:ext uri="{FF2B5EF4-FFF2-40B4-BE49-F238E27FC236}">
-                <a16:creationId xmlns:a16="http://schemas.microsoft.com/office/drawing/2014/main" id="{FC2C14FC-747C-4558-8314-EA885A5A236C}"/>
+                <a16:creationId xmlns:a16="http://schemas.microsoft.com/office/drawing/2014/main" id="{6EB2785F-D411-4C90-91B3-EA4514722645}"/>
               </a:ext>
             </a:extLst>
           </p:cNvPr>
@@ -1865,7 +1865,7 @@
           <p:cNvPr id="8" name="">
             <a:extLst xmlns:a="http://schemas.openxmlformats.org/drawingml/2006/main">
               <a:ext uri="{FF2B5EF4-FFF2-40B4-BE49-F238E27FC236}">
-                <a16:creationId xmlns:a16="http://schemas.microsoft.com/office/drawing/2014/main" id="{8E8297DB-B3EA-4429-9A9B-9501EF7B6B5A}"/>
+                <a16:creationId xmlns:a16="http://schemas.microsoft.com/office/drawing/2014/main" id="{5BB45716-35DD-4DD9-ADD9-A0464903A03A}"/>
               </a:ext>
             </a:extLst>
           </p:cNvPr>
@@ -1929,7 +1929,7 @@
           <p:cNvPr id="9" name="">
             <a:extLst xmlns:a="http://schemas.openxmlformats.org/drawingml/2006/main">
               <a:ext uri="{FF2B5EF4-FFF2-40B4-BE49-F238E27FC236}">
-                <a16:creationId xmlns:a16="http://schemas.microsoft.com/office/drawing/2014/main" id="{8D584DEE-8AF9-4BCE-A2D6-93C211F10057}"/>
+                <a16:creationId xmlns:a16="http://schemas.microsoft.com/office/drawing/2014/main" id="{DBF3F4C8-680C-471D-9A2D-C1707E18AC4B}"/>
               </a:ext>
             </a:extLst>
           </p:cNvPr>
@@ -1964,7 +1964,7 @@
           <p:cNvPr id="10" name="">
             <a:extLst xmlns:a="http://schemas.openxmlformats.org/drawingml/2006/main">
               <a:ext uri="{FF2B5EF4-FFF2-40B4-BE49-F238E27FC236}">
-                <a16:creationId xmlns:a16="http://schemas.microsoft.com/office/drawing/2014/main" id="{5DDF908C-7E8E-433F-BF23-AF28C30C1035}"/>
+                <a16:creationId xmlns:a16="http://schemas.microsoft.com/office/drawing/2014/main" id="{44034584-9440-4EC7-BE8D-1F57FBC8940F}"/>
               </a:ext>
             </a:extLst>
           </p:cNvPr>
@@ -2028,7 +2028,7 @@
           <p:cNvPr id="11" name="">
             <a:extLst xmlns:a="http://schemas.openxmlformats.org/drawingml/2006/main">
               <a:ext uri="{FF2B5EF4-FFF2-40B4-BE49-F238E27FC236}">
-                <a16:creationId xmlns:a16="http://schemas.microsoft.com/office/drawing/2014/main" id="{B45ADBC7-0FE6-441F-B6D3-3AEBEE633432}"/>
+                <a16:creationId xmlns:a16="http://schemas.microsoft.com/office/drawing/2014/main" id="{4D9544AB-9EDF-4088-8CA2-702B11F31807}"/>
               </a:ext>
             </a:extLst>
           </p:cNvPr>
@@ -2092,7 +2092,7 @@
           <p:cNvPr id="12" name="">
             <a:extLst xmlns:a="http://schemas.openxmlformats.org/drawingml/2006/main">
               <a:ext uri="{FF2B5EF4-FFF2-40B4-BE49-F238E27FC236}">
-                <a16:creationId xmlns:a16="http://schemas.microsoft.com/office/drawing/2014/main" id="{226B17BD-2F09-430A-9484-F23000A12447}"/>
+                <a16:creationId xmlns:a16="http://schemas.microsoft.com/office/drawing/2014/main" id="{33DC9F80-3508-4B8E-BC87-5BA3FD8C8B84}"/>
               </a:ext>
             </a:extLst>
           </p:cNvPr>
@@ -2127,7 +2127,7 @@
           <p:cNvPr id="13" name="">
             <a:extLst xmlns:a="http://schemas.openxmlformats.org/drawingml/2006/main">
               <a:ext uri="{FF2B5EF4-FFF2-40B4-BE49-F238E27FC236}">
-                <a16:creationId xmlns:a16="http://schemas.microsoft.com/office/drawing/2014/main" id="{E2FCBBD3-6C06-4F6D-8B26-15280359CA52}"/>
+                <a16:creationId xmlns:a16="http://schemas.microsoft.com/office/drawing/2014/main" id="{B86BCA7E-0E19-43C6-9568-B6B09A6EA138}"/>
               </a:ext>
             </a:extLst>
           </p:cNvPr>
@@ -2191,7 +2191,7 @@
           <p:cNvPr id="14" name="">
             <a:extLst xmlns:a="http://schemas.openxmlformats.org/drawingml/2006/main">
               <a:ext uri="{FF2B5EF4-FFF2-40B4-BE49-F238E27FC236}">
-                <a16:creationId xmlns:a16="http://schemas.microsoft.com/office/drawing/2014/main" id="{90BFC28E-2013-4E95-B274-B324615334FF}"/>
+                <a16:creationId xmlns:a16="http://schemas.microsoft.com/office/drawing/2014/main" id="{DAC05ABF-0F38-4AE9-BBA1-96CAD1B051BA}"/>
               </a:ext>
             </a:extLst>
           </p:cNvPr>
@@ -2255,19 +2255,19 @@
           <p:cNvPr id="15" name="">
             <a:extLst xmlns:a="http://schemas.openxmlformats.org/drawingml/2006/main">
               <a:ext uri="{FF2B5EF4-FFF2-40B4-BE49-F238E27FC236}">
-                <a16:creationId xmlns:a16="http://schemas.microsoft.com/office/drawing/2014/main" id="{0E47BE87-0B32-42F3-A8E7-6CF2050B61C3}"/>
-              </a:ext>
-            </a:extLst>
-          </p:cNvPr>
-          <p:cNvSpPr>
-            <a:spLocks xmlns:a="http://schemas.openxmlformats.org/drawingml/2006/main" noGrp="1"/>
-          </p:cNvSpPr>
-          <p:nvPr/>
-        </p:nvSpPr>
-        <p:spPr>
-          <a:xfrm xmlns:a="http://schemas.openxmlformats.org/drawingml/2006/main">
-            <a:off x="552450" y="6115050"/>
-            <a:ext cx="4762500" cy="247650"/>
+                <a16:creationId xmlns:a16="http://schemas.microsoft.com/office/drawing/2014/main" id="{31235F0D-4543-4D79-BAC5-3C8342FF3B7F}"/>
+              </a:ext>
+            </a:extLst>
+          </p:cNvPr>
+          <p:cNvSpPr>
+            <a:spLocks xmlns:a="http://schemas.openxmlformats.org/drawingml/2006/main" noGrp="1"/>
+          </p:cNvSpPr>
+          <p:nvPr/>
+        </p:nvSpPr>
+        <p:spPr>
+          <a:xfrm xmlns:a="http://schemas.openxmlformats.org/drawingml/2006/main">
+            <a:off x="552450" y="5962650"/>
+            <a:ext cx="4762500" cy="209550"/>
           </a:xfrm>
           <a:prstGeom xmlns:a="http://schemas.openxmlformats.org/drawingml/2006/main" prst="rect">
             <a:avLst/>
@@ -2291,7 +2291,7 @@
           <a:lstStyle xmlns:a="http://schemas.openxmlformats.org/drawingml/2006/main"/>
           <a:p xmlns:a="http://schemas.openxmlformats.org/drawingml/2006/main">
             <a:pPr algn="l">
-              <a:defRPr sz="1125" b="1">
+              <a:defRPr sz="1050" b="1">
                 <a:solidFill>
                   <a:srgbClr val="EF6C21"/>
                 </a:solidFill>
@@ -2301,7 +2301,7 @@
               </a:defRPr>
             </a:pPr>
             <a:r>
-              <a:rPr sz="1125" b="1">
+              <a:rPr sz="1050" b="1">
                 <a:solidFill>
                   <a:srgbClr val="EF6C21"/>
                 </a:solidFill>
@@ -2319,7 +2319,71 @@
           <p:cNvPr id="16" name="">
             <a:extLst xmlns:a="http://schemas.openxmlformats.org/drawingml/2006/main">
               <a:ext uri="{FF2B5EF4-FFF2-40B4-BE49-F238E27FC236}">
-                <a16:creationId xmlns:a16="http://schemas.microsoft.com/office/drawing/2014/main" id="{EB488CA3-037F-42AC-9A54-D077806C58D4}"/>
+                <a16:creationId xmlns:a16="http://schemas.microsoft.com/office/drawing/2014/main" id="{9095A21D-8022-4685-AF75-BA859576F9EE}"/>
+              </a:ext>
+            </a:extLst>
+          </p:cNvPr>
+          <p:cNvSpPr>
+            <a:spLocks xmlns:a="http://schemas.openxmlformats.org/drawingml/2006/main" noGrp="1"/>
+          </p:cNvSpPr>
+          <p:nvPr/>
+        </p:nvSpPr>
+        <p:spPr>
+          <a:xfrm xmlns:a="http://schemas.openxmlformats.org/drawingml/2006/main">
+            <a:off x="552450" y="6229350"/>
+            <a:ext cx="4762500" cy="190500"/>
+          </a:xfrm>
+          <a:prstGeom xmlns:a="http://schemas.openxmlformats.org/drawingml/2006/main" prst="rect">
+            <a:avLst/>
+          </a:prstGeom>
+          <a:solidFill xmlns:a="http://schemas.openxmlformats.org/drawingml/2006/main">
+            <a:srgbClr val="000000">
+              <a:alpha val="0"/>
+            </a:srgbClr>
+          </a:solidFill>
+          <a:ln xmlns:a="http://schemas.openxmlformats.org/drawingml/2006/main" w="0">
+            <a:solidFill>
+              <a:srgbClr val="000000">
+                <a:alpha val="0"/>
+              </a:srgbClr>
+            </a:solidFill>
+            <a:prstDash val="solid"/>
+          </a:ln>
+        </p:spPr>
+        <p:txBody>
+          <a:bodyPr xmlns:a="http://schemas.openxmlformats.org/drawingml/2006/main" lIns="0" tIns="0" rIns="0" bIns="0" anchor="t"/>
+          <a:lstStyle xmlns:a="http://schemas.openxmlformats.org/drawingml/2006/main"/>
+          <a:p xmlns:a="http://schemas.openxmlformats.org/drawingml/2006/main">
+            <a:pPr algn="l">
+              <a:defRPr sz="900" b="1">
+                <a:solidFill>
+                  <a:srgbClr val="087F75"/>
+                </a:solidFill>
+                <a:latin typeface="Aptos"/>
+                <a:ea typeface="Aptos"/>
+                <a:cs typeface="Aptos"/>
+              </a:defRPr>
+            </a:pPr>
+            <a:r>
+              <a:rPr sz="900" b="1">
+                <a:solidFill>
+                  <a:srgbClr val="087F75"/>
+                </a:solidFill>
+                <a:latin typeface="Aptos"/>
+                <a:ea typeface="Aptos"/>
+                <a:cs typeface="Aptos"/>
+              </a:rPr>
+              <a:t>github.com/Anarpego/ProteinLoop</a:t>
+            </a:r>
+          </a:p>
+        </p:txBody>
+      </p:sp>
+      <p:sp>
+        <p:nvSpPr>
+          <p:cNvPr id="17" name="">
+            <a:extLst xmlns:a="http://schemas.openxmlformats.org/drawingml/2006/main">
+              <a:ext uri="{FF2B5EF4-FFF2-40B4-BE49-F238E27FC236}">
+                <a16:creationId xmlns:a16="http://schemas.microsoft.com/office/drawing/2014/main" id="{F33FB8F0-A89E-49DB-91D5-120CA484EF65}"/>
               </a:ext>
             </a:extLst>
           </p:cNvPr>
@@ -2351,14 +2415,14 @@
       </p:sp>
       <p:pic>
         <p:nvPicPr>
-          <p:cNvPr id="17" name=""/>
+          <p:cNvPr id="18" name=""/>
           <p:cNvPicPr>
             <a:picLocks xmlns:a="http://schemas.openxmlformats.org/drawingml/2006/main" noChangeAspect="1"/>
           </p:cNvPicPr>
           <p:nvPr/>
         </p:nvPicPr>
         <p:blipFill>
-          <a:blip xmlns:r="http://schemas.openxmlformats.org/officeDocument/2006/relationships" xmlns:a="http://schemas.openxmlformats.org/drawingml/2006/main" r:embed="R047f7ab835c44ae8"/>
+          <a:blip xmlns:r="http://schemas.openxmlformats.org/officeDocument/2006/relationships" xmlns:a="http://schemas.openxmlformats.org/drawingml/2006/main" r:embed="R3f5532d1efd44792"/>
           <a:srcRect xmlns:a="http://schemas.openxmlformats.org/drawingml/2006/main" l="20736" t="0" r="20736" b="0"/>
           <a:stretch xmlns:a="http://schemas.openxmlformats.org/drawingml/2006/main">
             <a:fillRect l="0" t="0" r="0" b="0"/>
@@ -2376,10 +2440,10 @@
       </p:pic>
       <p:sp>
         <p:nvSpPr>
-          <p:cNvPr id="18" name="">
-            <a:extLst xmlns:a="http://schemas.openxmlformats.org/drawingml/2006/main">
-              <a:ext uri="{FF2B5EF4-FFF2-40B4-BE49-F238E27FC236}">
-                <a16:creationId xmlns:a16="http://schemas.microsoft.com/office/drawing/2014/main" id="{D8842FD1-AD6A-4062-8E71-1F13EE36367A}"/>
+          <p:cNvPr id="19" name="">
+            <a:extLst xmlns:a="http://schemas.openxmlformats.org/drawingml/2006/main">
+              <a:ext uri="{FF2B5EF4-FFF2-40B4-BE49-F238E27FC236}">
+                <a16:creationId xmlns:a16="http://schemas.microsoft.com/office/drawing/2014/main" id="{B24BFA88-6298-4137-A1F7-518DF0FF07F6}"/>
               </a:ext>
             </a:extLst>
           </p:cNvPr>
@@ -2413,10 +2477,10 @@
       </p:sp>
       <p:sp>
         <p:nvSpPr>
-          <p:cNvPr id="19" name="">
-            <a:extLst xmlns:a="http://schemas.openxmlformats.org/drawingml/2006/main">
-              <a:ext uri="{FF2B5EF4-FFF2-40B4-BE49-F238E27FC236}">
-                <a16:creationId xmlns:a16="http://schemas.microsoft.com/office/drawing/2014/main" id="{79455A79-5817-4E07-8B7F-3A365D4912D1}"/>
+          <p:cNvPr id="20" name="">
+            <a:extLst xmlns:a="http://schemas.openxmlformats.org/drawingml/2006/main">
+              <a:ext uri="{FF2B5EF4-FFF2-40B4-BE49-F238E27FC236}">
+                <a16:creationId xmlns:a16="http://schemas.microsoft.com/office/drawing/2014/main" id="{3AE9B4AD-EC19-4A51-833F-D840EF8AEE3D}"/>
               </a:ext>
             </a:extLst>
           </p:cNvPr>
@@ -2478,7 +2542,7 @@
     </p:spTree>
     <p:extLst>
       <p:ext uri="{BB962C8B-B14F-4D97-AF65-F5344CB8AC3E}">
-        <p14:creationId xmlns:p14="http://schemas.microsoft.com/office/powerpoint/2010/main" val="277563566"/>
+        <p14:creationId xmlns:p14="http://schemas.microsoft.com/office/powerpoint/2010/main" val="1301704281"/>
       </p:ext>
     </p:extLst>
   </p:cSld>
@@ -2502,7 +2566,7 @@
           <p:cNvPr id="1" name="">
             <a:extLst xmlns:a="http://schemas.openxmlformats.org/drawingml/2006/main">
               <a:ext uri="{FF2B5EF4-FFF2-40B4-BE49-F238E27FC236}">
-                <a16:creationId xmlns:a16="http://schemas.microsoft.com/office/drawing/2014/main" id="{EA1511E8-C410-4BCF-A050-9C46C16F83F2}"/>
+                <a16:creationId xmlns:a16="http://schemas.microsoft.com/office/drawing/2014/main" id="{E46462B5-8C8C-4F58-8567-05A34B0CD258}"/>
               </a:ext>
             </a:extLst>
           </p:cNvPr>
@@ -2537,7 +2601,7 @@
           <p:cNvPr id="2" name="">
             <a:extLst xmlns:a="http://schemas.openxmlformats.org/drawingml/2006/main">
               <a:ext uri="{FF2B5EF4-FFF2-40B4-BE49-F238E27FC236}">
-                <a16:creationId xmlns:a16="http://schemas.microsoft.com/office/drawing/2014/main" id="{E823694E-1D65-4E0C-A12A-0F1A9AC18C49}"/>
+                <a16:creationId xmlns:a16="http://schemas.microsoft.com/office/drawing/2014/main" id="{69922CAF-8C90-4B5C-8BD0-375CB49792EB}"/>
               </a:ext>
             </a:extLst>
           </p:cNvPr>
@@ -2572,7 +2636,7 @@
           <p:cNvPr id="3" name="">
             <a:extLst xmlns:a="http://schemas.openxmlformats.org/drawingml/2006/main">
               <a:ext uri="{FF2B5EF4-FFF2-40B4-BE49-F238E27FC236}">
-                <a16:creationId xmlns:a16="http://schemas.microsoft.com/office/drawing/2014/main" id="{37B83E4D-D2F1-4A85-8291-A8D1F354FF0D}"/>
+                <a16:creationId xmlns:a16="http://schemas.microsoft.com/office/drawing/2014/main" id="{95EA79C6-CE21-4BAC-9F58-4F424368F0C0}"/>
               </a:ext>
             </a:extLst>
           </p:cNvPr>
@@ -2636,7 +2700,7 @@
           <p:cNvPr id="4" name="">
             <a:extLst xmlns:a="http://schemas.openxmlformats.org/drawingml/2006/main">
               <a:ext uri="{FF2B5EF4-FFF2-40B4-BE49-F238E27FC236}">
-                <a16:creationId xmlns:a16="http://schemas.microsoft.com/office/drawing/2014/main" id="{84A76CD1-5E06-4A92-9A07-A4D42506633D}"/>
+                <a16:creationId xmlns:a16="http://schemas.microsoft.com/office/drawing/2014/main" id="{B5EF2683-7872-4B18-AD3A-1F1D5A7395B8}"/>
               </a:ext>
             </a:extLst>
           </p:cNvPr>
@@ -2700,7 +2764,7 @@
           <p:cNvPr id="5" name="">
             <a:extLst xmlns:a="http://schemas.openxmlformats.org/drawingml/2006/main">
               <a:ext uri="{FF2B5EF4-FFF2-40B4-BE49-F238E27FC236}">
-                <a16:creationId xmlns:a16="http://schemas.microsoft.com/office/drawing/2014/main" id="{A84D77A7-7DF8-43C1-A283-CCF0CD874CBC}"/>
+                <a16:creationId xmlns:a16="http://schemas.microsoft.com/office/drawing/2014/main" id="{419F0B81-4C40-426E-87A1-AD6BCE1E2D2E}"/>
               </a:ext>
             </a:extLst>
           </p:cNvPr>
@@ -2764,7 +2828,7 @@
           <p:cNvPr id="6" name="">
             <a:extLst xmlns:a="http://schemas.openxmlformats.org/drawingml/2006/main">
               <a:ext uri="{FF2B5EF4-FFF2-40B4-BE49-F238E27FC236}">
-                <a16:creationId xmlns:a16="http://schemas.microsoft.com/office/drawing/2014/main" id="{D6C40314-ED05-4935-9E46-3569075AA363}"/>
+                <a16:creationId xmlns:a16="http://schemas.microsoft.com/office/drawing/2014/main" id="{1E675C55-5AF6-4662-87EF-1EE2F00F9B58}"/>
               </a:ext>
             </a:extLst>
           </p:cNvPr>
@@ -2828,7 +2892,7 @@
           <p:cNvPr id="7" name="">
             <a:extLst xmlns:a="http://schemas.openxmlformats.org/drawingml/2006/main">
               <a:ext uri="{FF2B5EF4-FFF2-40B4-BE49-F238E27FC236}">
-                <a16:creationId xmlns:a16="http://schemas.microsoft.com/office/drawing/2014/main" id="{8604230F-378B-468A-BD3C-6921BE8222C9}"/>
+                <a16:creationId xmlns:a16="http://schemas.microsoft.com/office/drawing/2014/main" id="{D66FD737-AA3B-4156-A6C4-2F26A74BE3B6}"/>
               </a:ext>
             </a:extLst>
           </p:cNvPr>
@@ -2892,7 +2956,7 @@
           <p:cNvPr id="8" name="">
             <a:extLst xmlns:a="http://schemas.openxmlformats.org/drawingml/2006/main">
               <a:ext uri="{FF2B5EF4-FFF2-40B4-BE49-F238E27FC236}">
-                <a16:creationId xmlns:a16="http://schemas.microsoft.com/office/drawing/2014/main" id="{96C3D923-B0E2-4B43-88B8-2927D4B87A6B}"/>
+                <a16:creationId xmlns:a16="http://schemas.microsoft.com/office/drawing/2014/main" id="{D71ADAF7-AAFD-424D-AD42-A054109400A2}"/>
               </a:ext>
             </a:extLst>
           </p:cNvPr>
@@ -2925,7 +2989,7 @@
           <p:cNvPr id="9" name="">
             <a:extLst xmlns:a="http://schemas.openxmlformats.org/drawingml/2006/main">
               <a:ext uri="{FF2B5EF4-FFF2-40B4-BE49-F238E27FC236}">
-                <a16:creationId xmlns:a16="http://schemas.microsoft.com/office/drawing/2014/main" id="{340FBF0E-7B08-478C-B24C-549BEA1FE97D}"/>
+                <a16:creationId xmlns:a16="http://schemas.microsoft.com/office/drawing/2014/main" id="{DA3B9396-7FA1-498A-8481-1039C758F964}"/>
               </a:ext>
             </a:extLst>
           </p:cNvPr>
@@ -2989,7 +3053,7 @@
           <p:cNvPr id="10" name="">
             <a:extLst xmlns:a="http://schemas.openxmlformats.org/drawingml/2006/main">
               <a:ext uri="{FF2B5EF4-FFF2-40B4-BE49-F238E27FC236}">
-                <a16:creationId xmlns:a16="http://schemas.microsoft.com/office/drawing/2014/main" id="{EA4BCAD3-B463-4C67-8C25-08C2D9CDAB6D}"/>
+                <a16:creationId xmlns:a16="http://schemas.microsoft.com/office/drawing/2014/main" id="{3A9BF94B-59EA-438D-B3A0-D461DFF8768D}"/>
               </a:ext>
             </a:extLst>
           </p:cNvPr>
@@ -3053,7 +3117,7 @@
           <p:cNvPr id="11" name="">
             <a:extLst xmlns:a="http://schemas.openxmlformats.org/drawingml/2006/main">
               <a:ext uri="{FF2B5EF4-FFF2-40B4-BE49-F238E27FC236}">
-                <a16:creationId xmlns:a16="http://schemas.microsoft.com/office/drawing/2014/main" id="{52EAAB18-DEF8-4AEF-8E5C-7BD4CAB85492}"/>
+                <a16:creationId xmlns:a16="http://schemas.microsoft.com/office/drawing/2014/main" id="{2BC67D3A-82D5-4F3A-90AC-5A50E216F02C}"/>
               </a:ext>
             </a:extLst>
           </p:cNvPr>
@@ -3088,7 +3152,7 @@
           <p:cNvPr id="12" name="">
             <a:extLst xmlns:a="http://schemas.openxmlformats.org/drawingml/2006/main">
               <a:ext uri="{FF2B5EF4-FFF2-40B4-BE49-F238E27FC236}">
-                <a16:creationId xmlns:a16="http://schemas.microsoft.com/office/drawing/2014/main" id="{E54B2EA4-5A57-4548-943A-FDEA038EF886}"/>
+                <a16:creationId xmlns:a16="http://schemas.microsoft.com/office/drawing/2014/main" id="{9CF096E5-0822-4D34-BC89-19DB6F7C8389}"/>
               </a:ext>
             </a:extLst>
           </p:cNvPr>
@@ -3123,7 +3187,7 @@
           <p:cNvPr id="13" name="">
             <a:extLst xmlns:a="http://schemas.openxmlformats.org/drawingml/2006/main">
               <a:ext uri="{FF2B5EF4-FFF2-40B4-BE49-F238E27FC236}">
-                <a16:creationId xmlns:a16="http://schemas.microsoft.com/office/drawing/2014/main" id="{B4C659B5-7870-45CB-BBDD-BE9C786336A7}"/>
+                <a16:creationId xmlns:a16="http://schemas.microsoft.com/office/drawing/2014/main" id="{C7D5D926-928E-4EAE-8963-EE054784558A}"/>
               </a:ext>
             </a:extLst>
           </p:cNvPr>
@@ -3187,7 +3251,7 @@
           <p:cNvPr id="14" name="">
             <a:extLst xmlns:a="http://schemas.openxmlformats.org/drawingml/2006/main">
               <a:ext uri="{FF2B5EF4-FFF2-40B4-BE49-F238E27FC236}">
-                <a16:creationId xmlns:a16="http://schemas.microsoft.com/office/drawing/2014/main" id="{BD31D58C-345D-480A-9D77-04F9363230F2}"/>
+                <a16:creationId xmlns:a16="http://schemas.microsoft.com/office/drawing/2014/main" id="{AE1F29BC-8043-4AE4-8C69-1D3C44FB695B}"/>
               </a:ext>
             </a:extLst>
           </p:cNvPr>
@@ -3251,7 +3315,7 @@
           <p:cNvPr id="15" name="">
             <a:extLst xmlns:a="http://schemas.openxmlformats.org/drawingml/2006/main">
               <a:ext uri="{FF2B5EF4-FFF2-40B4-BE49-F238E27FC236}">
-                <a16:creationId xmlns:a16="http://schemas.microsoft.com/office/drawing/2014/main" id="{B31916C0-BE72-4859-B42B-7022306FEAFD}"/>
+                <a16:creationId xmlns:a16="http://schemas.microsoft.com/office/drawing/2014/main" id="{43F7FD9D-2A46-47C8-B59F-33B84B0BE835}"/>
               </a:ext>
             </a:extLst>
           </p:cNvPr>
@@ -3286,7 +3350,7 @@
           <p:cNvPr id="16" name="">
             <a:extLst xmlns:a="http://schemas.openxmlformats.org/drawingml/2006/main">
               <a:ext uri="{FF2B5EF4-FFF2-40B4-BE49-F238E27FC236}">
-                <a16:creationId xmlns:a16="http://schemas.microsoft.com/office/drawing/2014/main" id="{2622ACDD-6E8D-4C4C-BF5B-856F72B3AAEA}"/>
+                <a16:creationId xmlns:a16="http://schemas.microsoft.com/office/drawing/2014/main" id="{88F7F53C-A0CB-45F1-BE9D-C3D74B8A168E}"/>
               </a:ext>
             </a:extLst>
           </p:cNvPr>
@@ -3350,7 +3414,7 @@
           <p:cNvPr id="17" name="">
             <a:extLst xmlns:a="http://schemas.openxmlformats.org/drawingml/2006/main">
               <a:ext uri="{FF2B5EF4-FFF2-40B4-BE49-F238E27FC236}">
-                <a16:creationId xmlns:a16="http://schemas.microsoft.com/office/drawing/2014/main" id="{0114ABA7-27B9-4698-BCC7-7416BD67BE2F}"/>
+                <a16:creationId xmlns:a16="http://schemas.microsoft.com/office/drawing/2014/main" id="{87F7A45D-22C0-4B52-AA94-36DB71B1E50E}"/>
               </a:ext>
             </a:extLst>
           </p:cNvPr>
@@ -3414,7 +3478,7 @@
           <p:cNvPr id="18" name="">
             <a:extLst xmlns:a="http://schemas.openxmlformats.org/drawingml/2006/main">
               <a:ext uri="{FF2B5EF4-FFF2-40B4-BE49-F238E27FC236}">
-                <a16:creationId xmlns:a16="http://schemas.microsoft.com/office/drawing/2014/main" id="{13CF040A-1411-429D-B731-A26909BC5DD5}"/>
+                <a16:creationId xmlns:a16="http://schemas.microsoft.com/office/drawing/2014/main" id="{53E553E7-C58A-4B6D-BE79-0328D4B14773}"/>
               </a:ext>
             </a:extLst>
           </p:cNvPr>
@@ -3449,7 +3513,7 @@
           <p:cNvPr id="19" name="">
             <a:extLst xmlns:a="http://schemas.openxmlformats.org/drawingml/2006/main">
               <a:ext uri="{FF2B5EF4-FFF2-40B4-BE49-F238E27FC236}">
-                <a16:creationId xmlns:a16="http://schemas.microsoft.com/office/drawing/2014/main" id="{778D383E-9ABC-4507-8C2A-ACB14AED59B5}"/>
+                <a16:creationId xmlns:a16="http://schemas.microsoft.com/office/drawing/2014/main" id="{C8C188F8-B086-4B63-9674-C1911EE641DA}"/>
               </a:ext>
             </a:extLst>
           </p:cNvPr>
@@ -3513,7 +3577,7 @@
           <p:cNvPr id="20" name="">
             <a:extLst xmlns:a="http://schemas.openxmlformats.org/drawingml/2006/main">
               <a:ext uri="{FF2B5EF4-FFF2-40B4-BE49-F238E27FC236}">
-                <a16:creationId xmlns:a16="http://schemas.microsoft.com/office/drawing/2014/main" id="{CA4918B7-414B-450E-8108-664E46FB1900}"/>
+                <a16:creationId xmlns:a16="http://schemas.microsoft.com/office/drawing/2014/main" id="{B09A977C-7C98-4D7C-872F-52BAFA8161B4}"/>
               </a:ext>
             </a:extLst>
           </p:cNvPr>
@@ -3577,7 +3641,7 @@
           <p:cNvPr id="21" name="">
             <a:extLst xmlns:a="http://schemas.openxmlformats.org/drawingml/2006/main">
               <a:ext uri="{FF2B5EF4-FFF2-40B4-BE49-F238E27FC236}">
-                <a16:creationId xmlns:a16="http://schemas.microsoft.com/office/drawing/2014/main" id="{AAF81894-8C7D-469E-88AD-473520D097B9}"/>
+                <a16:creationId xmlns:a16="http://schemas.microsoft.com/office/drawing/2014/main" id="{EE9E2A72-88E7-46F1-8112-5DF7972617FC}"/>
               </a:ext>
             </a:extLst>
           </p:cNvPr>
@@ -3639,7 +3703,7 @@
     </p:spTree>
     <p:extLst>
       <p:ext uri="{BB962C8B-B14F-4D97-AF65-F5344CB8AC3E}">
-        <p14:creationId xmlns:p14="http://schemas.microsoft.com/office/powerpoint/2010/main" val="1687980533"/>
+        <p14:creationId xmlns:p14="http://schemas.microsoft.com/office/powerpoint/2010/main" val="1632412338"/>
       </p:ext>
     </p:extLst>
   </p:cSld>
@@ -3663,7 +3727,7 @@
           <p:cNvPr id="1" name="">
             <a:extLst xmlns:a="http://schemas.openxmlformats.org/drawingml/2006/main">
               <a:ext uri="{FF2B5EF4-FFF2-40B4-BE49-F238E27FC236}">
-                <a16:creationId xmlns:a16="http://schemas.microsoft.com/office/drawing/2014/main" id="{1FD80376-A7B3-46C8-A08B-54FA62D8671F}"/>
+                <a16:creationId xmlns:a16="http://schemas.microsoft.com/office/drawing/2014/main" id="{1294494E-0120-47F0-8117-CD8C2291EC86}"/>
               </a:ext>
             </a:extLst>
           </p:cNvPr>
@@ -3698,7 +3762,7 @@
           <p:cNvPr id="2" name="">
             <a:extLst xmlns:a="http://schemas.openxmlformats.org/drawingml/2006/main">
               <a:ext uri="{FF2B5EF4-FFF2-40B4-BE49-F238E27FC236}">
-                <a16:creationId xmlns:a16="http://schemas.microsoft.com/office/drawing/2014/main" id="{AB2590E2-9548-4E0E-A0DF-916137E9ECFD}"/>
+                <a16:creationId xmlns:a16="http://schemas.microsoft.com/office/drawing/2014/main" id="{A31D227D-9597-49B0-BE4C-A1B11A3616B1}"/>
               </a:ext>
             </a:extLst>
           </p:cNvPr>
@@ -3733,7 +3797,7 @@
           <p:cNvPr id="3" name="">
             <a:extLst xmlns:a="http://schemas.openxmlformats.org/drawingml/2006/main">
               <a:ext uri="{FF2B5EF4-FFF2-40B4-BE49-F238E27FC236}">
-                <a16:creationId xmlns:a16="http://schemas.microsoft.com/office/drawing/2014/main" id="{1C3058A6-8F15-4AAD-8BE6-A54ED14816AF}"/>
+                <a16:creationId xmlns:a16="http://schemas.microsoft.com/office/drawing/2014/main" id="{B15AAD2A-AECE-46D3-B69E-1A8A18424E7D}"/>
               </a:ext>
             </a:extLst>
           </p:cNvPr>
@@ -3797,7 +3861,7 @@
           <p:cNvPr id="4" name="">
             <a:extLst xmlns:a="http://schemas.openxmlformats.org/drawingml/2006/main">
               <a:ext uri="{FF2B5EF4-FFF2-40B4-BE49-F238E27FC236}">
-                <a16:creationId xmlns:a16="http://schemas.microsoft.com/office/drawing/2014/main" id="{010D06F6-5177-4D5D-9F9C-08931FEBDA18}"/>
+                <a16:creationId xmlns:a16="http://schemas.microsoft.com/office/drawing/2014/main" id="{A54A4F29-9319-4B14-B162-13609F23F98D}"/>
               </a:ext>
             </a:extLst>
           </p:cNvPr>
@@ -3861,7 +3925,7 @@
           <p:cNvPr id="5" name="">
             <a:extLst xmlns:a="http://schemas.openxmlformats.org/drawingml/2006/main">
               <a:ext uri="{FF2B5EF4-FFF2-40B4-BE49-F238E27FC236}">
-                <a16:creationId xmlns:a16="http://schemas.microsoft.com/office/drawing/2014/main" id="{D9F6145D-6A78-4352-8CCA-AF6F8E4ABB98}"/>
+                <a16:creationId xmlns:a16="http://schemas.microsoft.com/office/drawing/2014/main" id="{F905E10A-EBF3-43D0-9DF1-8CBD92C1530D}"/>
               </a:ext>
             </a:extLst>
           </p:cNvPr>
@@ -3925,7 +3989,7 @@
           <p:cNvPr id="6" name="">
             <a:extLst xmlns:a="http://schemas.openxmlformats.org/drawingml/2006/main">
               <a:ext uri="{FF2B5EF4-FFF2-40B4-BE49-F238E27FC236}">
-                <a16:creationId xmlns:a16="http://schemas.microsoft.com/office/drawing/2014/main" id="{10353A3D-DDB4-4F43-A19B-6481900E40F9}"/>
+                <a16:creationId xmlns:a16="http://schemas.microsoft.com/office/drawing/2014/main" id="{C7A50002-81B7-42F7-8751-F10D8DA67126}"/>
               </a:ext>
             </a:extLst>
           </p:cNvPr>
@@ -3989,7 +4053,7 @@
           <p:cNvPr id="7" name="">
             <a:extLst xmlns:a="http://schemas.openxmlformats.org/drawingml/2006/main">
               <a:ext uri="{FF2B5EF4-FFF2-40B4-BE49-F238E27FC236}">
-                <a16:creationId xmlns:a16="http://schemas.microsoft.com/office/drawing/2014/main" id="{08A900D0-D694-4760-982F-0BCF151047A2}"/>
+                <a16:creationId xmlns:a16="http://schemas.microsoft.com/office/drawing/2014/main" id="{88A1F08C-E8A0-4149-88CA-25A381755AD9}"/>
               </a:ext>
             </a:extLst>
           </p:cNvPr>
@@ -4026,7 +4090,7 @@
           <p:nvPr/>
         </p:nvPicPr>
         <p:blipFill>
-          <a:blip xmlns:r="http://schemas.openxmlformats.org/officeDocument/2006/relationships" xmlns:a="http://schemas.openxmlformats.org/drawingml/2006/main" r:embed="Rf28d854083944c6e"/>
+          <a:blip xmlns:r="http://schemas.openxmlformats.org/officeDocument/2006/relationships" xmlns:a="http://schemas.openxmlformats.org/drawingml/2006/main" r:embed="Rc62003c502f04f87"/>
           <a:stretch xmlns:a="http://schemas.openxmlformats.org/drawingml/2006/main"/>
         </p:blipFill>
         <p:spPr>
@@ -4044,7 +4108,7 @@
           <p:cNvPr id="9" name="">
             <a:extLst xmlns:a="http://schemas.openxmlformats.org/drawingml/2006/main">
               <a:ext uri="{FF2B5EF4-FFF2-40B4-BE49-F238E27FC236}">
-                <a16:creationId xmlns:a16="http://schemas.microsoft.com/office/drawing/2014/main" id="{05CFDF3D-FD7A-478E-8641-1A4581DB5DCF}"/>
+                <a16:creationId xmlns:a16="http://schemas.microsoft.com/office/drawing/2014/main" id="{EBD650F8-41EC-42B1-8B05-DC6883307042}"/>
               </a:ext>
             </a:extLst>
           </p:cNvPr>
@@ -4079,7 +4143,7 @@
           <p:cNvPr id="10" name="">
             <a:extLst xmlns:a="http://schemas.openxmlformats.org/drawingml/2006/main">
               <a:ext uri="{FF2B5EF4-FFF2-40B4-BE49-F238E27FC236}">
-                <a16:creationId xmlns:a16="http://schemas.microsoft.com/office/drawing/2014/main" id="{706600DC-7C08-48C0-BC25-B46FD7467BDD}"/>
+                <a16:creationId xmlns:a16="http://schemas.microsoft.com/office/drawing/2014/main" id="{C247230A-4E2B-4D05-8625-CFA7721C4F3E}"/>
               </a:ext>
             </a:extLst>
           </p:cNvPr>
@@ -4143,7 +4207,7 @@
           <p:cNvPr id="11" name="">
             <a:extLst xmlns:a="http://schemas.openxmlformats.org/drawingml/2006/main">
               <a:ext uri="{FF2B5EF4-FFF2-40B4-BE49-F238E27FC236}">
-                <a16:creationId xmlns:a16="http://schemas.microsoft.com/office/drawing/2014/main" id="{630963BA-198B-4BF6-AF07-EAFDBC4CAF8F}"/>
+                <a16:creationId xmlns:a16="http://schemas.microsoft.com/office/drawing/2014/main" id="{DAA24798-1405-4EC0-814E-E10B8B7B5BE5}"/>
               </a:ext>
             </a:extLst>
           </p:cNvPr>
@@ -4178,7 +4242,7 @@
           <p:cNvPr id="12" name="">
             <a:extLst xmlns:a="http://schemas.openxmlformats.org/drawingml/2006/main">
               <a:ext uri="{FF2B5EF4-FFF2-40B4-BE49-F238E27FC236}">
-                <a16:creationId xmlns:a16="http://schemas.microsoft.com/office/drawing/2014/main" id="{2882E377-7D42-412F-98D2-5D380D13D5D5}"/>
+                <a16:creationId xmlns:a16="http://schemas.microsoft.com/office/drawing/2014/main" id="{E9A13A91-2943-4E1D-BFBB-F5FEFEB2B737}"/>
               </a:ext>
             </a:extLst>
           </p:cNvPr>
@@ -4242,7 +4306,7 @@
           <p:cNvPr id="13" name="">
             <a:extLst xmlns:a="http://schemas.openxmlformats.org/drawingml/2006/main">
               <a:ext uri="{FF2B5EF4-FFF2-40B4-BE49-F238E27FC236}">
-                <a16:creationId xmlns:a16="http://schemas.microsoft.com/office/drawing/2014/main" id="{333A609F-FBB1-4B34-9185-77A75F4945BC}"/>
+                <a16:creationId xmlns:a16="http://schemas.microsoft.com/office/drawing/2014/main" id="{633F9C47-9587-41EC-819D-EC468D0C4A64}"/>
               </a:ext>
             </a:extLst>
           </p:cNvPr>
@@ -4277,7 +4341,7 @@
           <p:cNvPr id="14" name="">
             <a:extLst xmlns:a="http://schemas.openxmlformats.org/drawingml/2006/main">
               <a:ext uri="{FF2B5EF4-FFF2-40B4-BE49-F238E27FC236}">
-                <a16:creationId xmlns:a16="http://schemas.microsoft.com/office/drawing/2014/main" id="{DE267151-0B91-400B-9AC5-374A6A325A62}"/>
+                <a16:creationId xmlns:a16="http://schemas.microsoft.com/office/drawing/2014/main" id="{F3379DB2-2D19-4B5D-9F3D-9F3436AF9B27}"/>
               </a:ext>
             </a:extLst>
           </p:cNvPr>
@@ -4341,7 +4405,7 @@
           <p:cNvPr id="15" name="">
             <a:extLst xmlns:a="http://schemas.openxmlformats.org/drawingml/2006/main">
               <a:ext uri="{FF2B5EF4-FFF2-40B4-BE49-F238E27FC236}">
-                <a16:creationId xmlns:a16="http://schemas.microsoft.com/office/drawing/2014/main" id="{7045E77A-99FF-40C9-8CEA-F75DA21A3D60}"/>
+                <a16:creationId xmlns:a16="http://schemas.microsoft.com/office/drawing/2014/main" id="{8EBACC30-26D5-431C-BDD2-E71AD63D8042}"/>
               </a:ext>
             </a:extLst>
           </p:cNvPr>
@@ -4403,7 +4467,7 @@
     </p:spTree>
     <p:extLst>
       <p:ext uri="{BB962C8B-B14F-4D97-AF65-F5344CB8AC3E}">
-        <p14:creationId xmlns:p14="http://schemas.microsoft.com/office/powerpoint/2010/main" val="1532142870"/>
+        <p14:creationId xmlns:p14="http://schemas.microsoft.com/office/powerpoint/2010/main" val="1733863875"/>
       </p:ext>
     </p:extLst>
   </p:cSld>
@@ -4431,7 +4495,7 @@
           <p:nvPr/>
         </p:nvPicPr>
         <p:blipFill>
-          <a:blip xmlns:r="http://schemas.openxmlformats.org/officeDocument/2006/relationships" xmlns:a="http://schemas.openxmlformats.org/drawingml/2006/main" r:embed="Ra62a33d844074f7d"/>
+          <a:blip xmlns:r="http://schemas.openxmlformats.org/officeDocument/2006/relationships" xmlns:a="http://schemas.openxmlformats.org/drawingml/2006/main" r:embed="Rf90636c78c134848"/>
           <a:srcRect xmlns:a="http://schemas.openxmlformats.org/drawingml/2006/main" l="0" t="5284" r="0" b="5284"/>
           <a:stretch xmlns:a="http://schemas.openxmlformats.org/drawingml/2006/main">
             <a:fillRect l="0" t="0" r="0" b="0"/>
@@ -4452,7 +4516,7 @@
           <p:cNvPr id="2" name="">
             <a:extLst xmlns:a="http://schemas.openxmlformats.org/drawingml/2006/main">
               <a:ext uri="{FF2B5EF4-FFF2-40B4-BE49-F238E27FC236}">
-                <a16:creationId xmlns:a16="http://schemas.microsoft.com/office/drawing/2014/main" id="{690D8D36-5466-48B0-8603-E08375E0D2B2}"/>
+                <a16:creationId xmlns:a16="http://schemas.microsoft.com/office/drawing/2014/main" id="{61F88573-4C4C-4514-BFED-95AEBB5556F9}"/>
               </a:ext>
             </a:extLst>
           </p:cNvPr>
@@ -4489,7 +4553,7 @@
           <p:cNvPr id="3" name="">
             <a:extLst xmlns:a="http://schemas.openxmlformats.org/drawingml/2006/main">
               <a:ext uri="{FF2B5EF4-FFF2-40B4-BE49-F238E27FC236}">
-                <a16:creationId xmlns:a16="http://schemas.microsoft.com/office/drawing/2014/main" id="{6BD632BC-C08C-4392-92FF-E07AB414DA25}"/>
+                <a16:creationId xmlns:a16="http://schemas.microsoft.com/office/drawing/2014/main" id="{9ABFE0CC-46B2-4D18-B03D-D4905F1E7DEA}"/>
               </a:ext>
             </a:extLst>
           </p:cNvPr>
@@ -4553,7 +4617,7 @@
           <p:cNvPr id="4" name="">
             <a:extLst xmlns:a="http://schemas.openxmlformats.org/drawingml/2006/main">
               <a:ext uri="{FF2B5EF4-FFF2-40B4-BE49-F238E27FC236}">
-                <a16:creationId xmlns:a16="http://schemas.microsoft.com/office/drawing/2014/main" id="{B1FE5D42-8A00-4608-B16D-9EA8FE87239C}"/>
+                <a16:creationId xmlns:a16="http://schemas.microsoft.com/office/drawing/2014/main" id="{0DC68F2D-2E32-4973-AFBA-FE9B2A28C122}"/>
               </a:ext>
             </a:extLst>
           </p:cNvPr>
@@ -4617,7 +4681,7 @@
           <p:cNvPr id="5" name="">
             <a:extLst xmlns:a="http://schemas.openxmlformats.org/drawingml/2006/main">
               <a:ext uri="{FF2B5EF4-FFF2-40B4-BE49-F238E27FC236}">
-                <a16:creationId xmlns:a16="http://schemas.microsoft.com/office/drawing/2014/main" id="{368F6B6D-5EE2-41AD-A125-3DD7B881C26F}"/>
+                <a16:creationId xmlns:a16="http://schemas.microsoft.com/office/drawing/2014/main" id="{AD7952F1-8135-4CBB-9237-3C5585A61A1E}"/>
               </a:ext>
             </a:extLst>
           </p:cNvPr>
@@ -4681,7 +4745,7 @@
           <p:cNvPr id="6" name="">
             <a:extLst xmlns:a="http://schemas.openxmlformats.org/drawingml/2006/main">
               <a:ext uri="{FF2B5EF4-FFF2-40B4-BE49-F238E27FC236}">
-                <a16:creationId xmlns:a16="http://schemas.microsoft.com/office/drawing/2014/main" id="{1D8A1DC1-A4ED-4FDF-9A5D-DF6602210FEA}"/>
+                <a16:creationId xmlns:a16="http://schemas.microsoft.com/office/drawing/2014/main" id="{8D719457-90C0-4AA3-A2C8-9038A336DDB7}"/>
               </a:ext>
             </a:extLst>
           </p:cNvPr>
@@ -4745,7 +4809,7 @@
           <p:cNvPr id="7" name="">
             <a:extLst xmlns:a="http://schemas.openxmlformats.org/drawingml/2006/main">
               <a:ext uri="{FF2B5EF4-FFF2-40B4-BE49-F238E27FC236}">
-                <a16:creationId xmlns:a16="http://schemas.microsoft.com/office/drawing/2014/main" id="{C50FF977-127F-40C6-8F69-039356A761F3}"/>
+                <a16:creationId xmlns:a16="http://schemas.microsoft.com/office/drawing/2014/main" id="{39D9CE92-AF8C-452E-ACB8-8C0B80647F0D}"/>
               </a:ext>
             </a:extLst>
           </p:cNvPr>
@@ -4809,7 +4873,7 @@
           <p:cNvPr id="8" name="">
             <a:extLst xmlns:a="http://schemas.openxmlformats.org/drawingml/2006/main">
               <a:ext uri="{FF2B5EF4-FFF2-40B4-BE49-F238E27FC236}">
-                <a16:creationId xmlns:a16="http://schemas.microsoft.com/office/drawing/2014/main" id="{B964BD5A-F251-4BFD-8CA0-A1E0FC33C4DC}"/>
+                <a16:creationId xmlns:a16="http://schemas.microsoft.com/office/drawing/2014/main" id="{1EBC3B84-D63B-4579-A072-092992E12B27}"/>
               </a:ext>
             </a:extLst>
           </p:cNvPr>
@@ -4873,7 +4937,7 @@
           <p:cNvPr id="9" name="">
             <a:extLst xmlns:a="http://schemas.openxmlformats.org/drawingml/2006/main">
               <a:ext uri="{FF2B5EF4-FFF2-40B4-BE49-F238E27FC236}">
-                <a16:creationId xmlns:a16="http://schemas.microsoft.com/office/drawing/2014/main" id="{76CB77F1-8D91-44C3-9684-4301DC76C1F0}"/>
+                <a16:creationId xmlns:a16="http://schemas.microsoft.com/office/drawing/2014/main" id="{9EF1B700-4C06-46DE-BF67-9E0655419624}"/>
               </a:ext>
             </a:extLst>
           </p:cNvPr>
@@ -4937,7 +5001,7 @@
           <p:cNvPr id="10" name="">
             <a:extLst xmlns:a="http://schemas.openxmlformats.org/drawingml/2006/main">
               <a:ext uri="{FF2B5EF4-FFF2-40B4-BE49-F238E27FC236}">
-                <a16:creationId xmlns:a16="http://schemas.microsoft.com/office/drawing/2014/main" id="{7DEB1596-E802-4E13-A787-93534A9BECCE}"/>
+                <a16:creationId xmlns:a16="http://schemas.microsoft.com/office/drawing/2014/main" id="{0E7C4617-11FA-48D4-984A-A598D631FAB3}"/>
               </a:ext>
             </a:extLst>
           </p:cNvPr>
@@ -5001,7 +5065,7 @@
           <p:cNvPr id="11" name="">
             <a:extLst xmlns:a="http://schemas.openxmlformats.org/drawingml/2006/main">
               <a:ext uri="{FF2B5EF4-FFF2-40B4-BE49-F238E27FC236}">
-                <a16:creationId xmlns:a16="http://schemas.microsoft.com/office/drawing/2014/main" id="{69EBFD62-31A8-4B33-A036-3B35E36FC13C}"/>
+                <a16:creationId xmlns:a16="http://schemas.microsoft.com/office/drawing/2014/main" id="{7881CA8E-E12D-42D4-B206-6C143C4F51D0}"/>
               </a:ext>
             </a:extLst>
           </p:cNvPr>
@@ -5065,7 +5129,7 @@
           <p:cNvPr id="12" name="">
             <a:extLst xmlns:a="http://schemas.openxmlformats.org/drawingml/2006/main">
               <a:ext uri="{FF2B5EF4-FFF2-40B4-BE49-F238E27FC236}">
-                <a16:creationId xmlns:a16="http://schemas.microsoft.com/office/drawing/2014/main" id="{DF007C47-F1B3-401E-BD30-9C26704DF009}"/>
+                <a16:creationId xmlns:a16="http://schemas.microsoft.com/office/drawing/2014/main" id="{6FFECFAF-88FA-4D9E-B721-1215D29B3456}"/>
               </a:ext>
             </a:extLst>
           </p:cNvPr>
@@ -5129,7 +5193,7 @@
           <p:cNvPr id="13" name="">
             <a:extLst xmlns:a="http://schemas.openxmlformats.org/drawingml/2006/main">
               <a:ext uri="{FF2B5EF4-FFF2-40B4-BE49-F238E27FC236}">
-                <a16:creationId xmlns:a16="http://schemas.microsoft.com/office/drawing/2014/main" id="{0BECF037-979A-411F-98E4-59A4B0239C6C}"/>
+                <a16:creationId xmlns:a16="http://schemas.microsoft.com/office/drawing/2014/main" id="{18A50441-9D1D-46F1-9040-C6BB1099643E}"/>
               </a:ext>
             </a:extLst>
           </p:cNvPr>
@@ -5193,7 +5257,7 @@
           <p:cNvPr id="14" name="">
             <a:extLst xmlns:a="http://schemas.openxmlformats.org/drawingml/2006/main">
               <a:ext uri="{FF2B5EF4-FFF2-40B4-BE49-F238E27FC236}">
-                <a16:creationId xmlns:a16="http://schemas.microsoft.com/office/drawing/2014/main" id="{5A85AE9A-AFC9-40BA-8537-52BDEB2DE0F3}"/>
+                <a16:creationId xmlns:a16="http://schemas.microsoft.com/office/drawing/2014/main" id="{E984A160-B9E2-4A19-8971-2BB888064B0E}"/>
               </a:ext>
             </a:extLst>
           </p:cNvPr>
@@ -5255,7 +5319,7 @@
     </p:spTree>
     <p:extLst>
       <p:ext uri="{BB962C8B-B14F-4D97-AF65-F5344CB8AC3E}">
-        <p14:creationId xmlns:p14="http://schemas.microsoft.com/office/powerpoint/2010/main" val="1626361533"/>
+        <p14:creationId xmlns:p14="http://schemas.microsoft.com/office/powerpoint/2010/main" val="1552416948"/>
       </p:ext>
     </p:extLst>
   </p:cSld>
@@ -5279,7 +5343,7 @@
           <p:cNvPr id="1" name="">
             <a:extLst xmlns:a="http://schemas.openxmlformats.org/drawingml/2006/main">
               <a:ext uri="{FF2B5EF4-FFF2-40B4-BE49-F238E27FC236}">
-                <a16:creationId xmlns:a16="http://schemas.microsoft.com/office/drawing/2014/main" id="{4D79E2E3-2697-4103-B169-C95095E06E4F}"/>
+                <a16:creationId xmlns:a16="http://schemas.microsoft.com/office/drawing/2014/main" id="{B32B7C48-1B1E-4C6D-AE28-F33DF9EB7E07}"/>
               </a:ext>
             </a:extLst>
           </p:cNvPr>
@@ -5314,7 +5378,7 @@
           <p:cNvPr id="2" name="">
             <a:extLst xmlns:a="http://schemas.openxmlformats.org/drawingml/2006/main">
               <a:ext uri="{FF2B5EF4-FFF2-40B4-BE49-F238E27FC236}">
-                <a16:creationId xmlns:a16="http://schemas.microsoft.com/office/drawing/2014/main" id="{B846B61D-0DB0-4F74-9C5E-DF902F11D496}"/>
+                <a16:creationId xmlns:a16="http://schemas.microsoft.com/office/drawing/2014/main" id="{CD41B11E-4184-48B3-B993-8D1000729FE6}"/>
               </a:ext>
             </a:extLst>
           </p:cNvPr>
@@ -5349,7 +5413,7 @@
           <p:cNvPr id="3" name="">
             <a:extLst xmlns:a="http://schemas.openxmlformats.org/drawingml/2006/main">
               <a:ext uri="{FF2B5EF4-FFF2-40B4-BE49-F238E27FC236}">
-                <a16:creationId xmlns:a16="http://schemas.microsoft.com/office/drawing/2014/main" id="{550AB26A-8BAA-4E84-AA30-AEDB49AA6A1B}"/>
+                <a16:creationId xmlns:a16="http://schemas.microsoft.com/office/drawing/2014/main" id="{CAE170B7-6EC4-4CD0-8737-E815B215E895}"/>
               </a:ext>
             </a:extLst>
           </p:cNvPr>
@@ -5413,7 +5477,7 @@
           <p:cNvPr id="4" name="">
             <a:extLst xmlns:a="http://schemas.openxmlformats.org/drawingml/2006/main">
               <a:ext uri="{FF2B5EF4-FFF2-40B4-BE49-F238E27FC236}">
-                <a16:creationId xmlns:a16="http://schemas.microsoft.com/office/drawing/2014/main" id="{961C8D15-9C46-4C13-93A0-198CFE9CD3EB}"/>
+                <a16:creationId xmlns:a16="http://schemas.microsoft.com/office/drawing/2014/main" id="{7752C7D6-2D3E-4452-BA26-801D1FCFD7EE}"/>
               </a:ext>
             </a:extLst>
           </p:cNvPr>
@@ -5477,7 +5541,7 @@
           <p:cNvPr id="5" name="">
             <a:extLst xmlns:a="http://schemas.openxmlformats.org/drawingml/2006/main">
               <a:ext uri="{FF2B5EF4-FFF2-40B4-BE49-F238E27FC236}">
-                <a16:creationId xmlns:a16="http://schemas.microsoft.com/office/drawing/2014/main" id="{A678878C-10AE-4EEE-884B-7B4F4B06010A}"/>
+                <a16:creationId xmlns:a16="http://schemas.microsoft.com/office/drawing/2014/main" id="{ED1120DE-8184-42E4-A0AA-526D91CD145A}"/>
               </a:ext>
             </a:extLst>
           </p:cNvPr>
@@ -5541,7 +5605,7 @@
           <p:cNvPr id="6" name="">
             <a:extLst xmlns:a="http://schemas.openxmlformats.org/drawingml/2006/main">
               <a:ext uri="{FF2B5EF4-FFF2-40B4-BE49-F238E27FC236}">
-                <a16:creationId xmlns:a16="http://schemas.microsoft.com/office/drawing/2014/main" id="{1C654DE8-42A9-4880-AA87-9533D32B3170}"/>
+                <a16:creationId xmlns:a16="http://schemas.microsoft.com/office/drawing/2014/main" id="{02CADF46-25EF-4E82-8C0A-0B320A637DE4}"/>
               </a:ext>
             </a:extLst>
           </p:cNvPr>
@@ -5605,7 +5669,7 @@
           <p:cNvPr id="7" name="">
             <a:extLst xmlns:a="http://schemas.openxmlformats.org/drawingml/2006/main">
               <a:ext uri="{FF2B5EF4-FFF2-40B4-BE49-F238E27FC236}">
-                <a16:creationId xmlns:a16="http://schemas.microsoft.com/office/drawing/2014/main" id="{5B9F34D0-B978-47D9-BAFC-4EF038C86692}"/>
+                <a16:creationId xmlns:a16="http://schemas.microsoft.com/office/drawing/2014/main" id="{EA44BC6F-ABB4-458E-BDD8-95BA27FB7CAD}"/>
               </a:ext>
             </a:extLst>
           </p:cNvPr>
@@ -5638,7 +5702,7 @@
           <p:cNvPr id="8" name="">
             <a:extLst xmlns:a="http://schemas.openxmlformats.org/drawingml/2006/main">
               <a:ext uri="{FF2B5EF4-FFF2-40B4-BE49-F238E27FC236}">
-                <a16:creationId xmlns:a16="http://schemas.microsoft.com/office/drawing/2014/main" id="{27D09625-1106-44AA-AC82-B0B22EBDD7BF}"/>
+                <a16:creationId xmlns:a16="http://schemas.microsoft.com/office/drawing/2014/main" id="{4239006C-F361-4CA5-888E-C83B1A37C458}"/>
               </a:ext>
             </a:extLst>
           </p:cNvPr>
@@ -5673,7 +5737,7 @@
           <p:cNvPr id="9" name="">
             <a:extLst xmlns:a="http://schemas.openxmlformats.org/drawingml/2006/main">
               <a:ext uri="{FF2B5EF4-FFF2-40B4-BE49-F238E27FC236}">
-                <a16:creationId xmlns:a16="http://schemas.microsoft.com/office/drawing/2014/main" id="{D2CEE26E-F589-4461-9E7F-F4D658EFC38B}"/>
+                <a16:creationId xmlns:a16="http://schemas.microsoft.com/office/drawing/2014/main" id="{776DEC20-CD61-4CD7-9839-6B5A156A13A9}"/>
               </a:ext>
             </a:extLst>
           </p:cNvPr>
@@ -5737,7 +5801,7 @@
           <p:cNvPr id="10" name="">
             <a:extLst xmlns:a="http://schemas.openxmlformats.org/drawingml/2006/main">
               <a:ext uri="{FF2B5EF4-FFF2-40B4-BE49-F238E27FC236}">
-                <a16:creationId xmlns:a16="http://schemas.microsoft.com/office/drawing/2014/main" id="{830BD67E-0E69-4DE5-B145-71928A7E69DA}"/>
+                <a16:creationId xmlns:a16="http://schemas.microsoft.com/office/drawing/2014/main" id="{0464768B-F4DD-4AC0-85C8-8EC892FB06BD}"/>
               </a:ext>
             </a:extLst>
           </p:cNvPr>
@@ -5801,7 +5865,7 @@
           <p:cNvPr id="11" name="">
             <a:extLst xmlns:a="http://schemas.openxmlformats.org/drawingml/2006/main">
               <a:ext uri="{FF2B5EF4-FFF2-40B4-BE49-F238E27FC236}">
-                <a16:creationId xmlns:a16="http://schemas.microsoft.com/office/drawing/2014/main" id="{14A262D3-47FE-48D9-BDAA-881A966323B9}"/>
+                <a16:creationId xmlns:a16="http://schemas.microsoft.com/office/drawing/2014/main" id="{F309A3D7-FE62-4DB6-85F9-96D9098E5EFC}"/>
               </a:ext>
             </a:extLst>
           </p:cNvPr>
@@ -5865,7 +5929,7 @@
           <p:cNvPr id="12" name="">
             <a:extLst xmlns:a="http://schemas.openxmlformats.org/drawingml/2006/main">
               <a:ext uri="{FF2B5EF4-FFF2-40B4-BE49-F238E27FC236}">
-                <a16:creationId xmlns:a16="http://schemas.microsoft.com/office/drawing/2014/main" id="{DBFD3B7B-15C5-428D-87C4-E6619620D7BE}"/>
+                <a16:creationId xmlns:a16="http://schemas.microsoft.com/office/drawing/2014/main" id="{F18C3C2F-DB57-4147-8F87-340B32CF61F8}"/>
               </a:ext>
             </a:extLst>
           </p:cNvPr>
@@ -5900,7 +5964,7 @@
           <p:cNvPr id="13" name="">
             <a:extLst xmlns:a="http://schemas.openxmlformats.org/drawingml/2006/main">
               <a:ext uri="{FF2B5EF4-FFF2-40B4-BE49-F238E27FC236}">
-                <a16:creationId xmlns:a16="http://schemas.microsoft.com/office/drawing/2014/main" id="{50DF11D6-16FA-41BD-B1BA-5A77E953D0AC}"/>
+                <a16:creationId xmlns:a16="http://schemas.microsoft.com/office/drawing/2014/main" id="{6217FE19-DF8E-404F-A67D-60880915ABCE}"/>
               </a:ext>
             </a:extLst>
           </p:cNvPr>
@@ -5964,7 +6028,7 @@
           <p:cNvPr id="14" name="">
             <a:extLst xmlns:a="http://schemas.openxmlformats.org/drawingml/2006/main">
               <a:ext uri="{FF2B5EF4-FFF2-40B4-BE49-F238E27FC236}">
-                <a16:creationId xmlns:a16="http://schemas.microsoft.com/office/drawing/2014/main" id="{92246B25-1C8A-4CFA-8662-DCE0F8CCDFDE}"/>
+                <a16:creationId xmlns:a16="http://schemas.microsoft.com/office/drawing/2014/main" id="{8D9DF536-DF4D-4EC1-96F6-BEDD6466D687}"/>
               </a:ext>
             </a:extLst>
           </p:cNvPr>
@@ -5997,7 +6061,7 @@
           <p:cNvPr id="15" name="">
             <a:extLst xmlns:a="http://schemas.openxmlformats.org/drawingml/2006/main">
               <a:ext uri="{FF2B5EF4-FFF2-40B4-BE49-F238E27FC236}">
-                <a16:creationId xmlns:a16="http://schemas.microsoft.com/office/drawing/2014/main" id="{C92E52D0-B783-4078-A664-8C6E3AC24CB8}"/>
+                <a16:creationId xmlns:a16="http://schemas.microsoft.com/office/drawing/2014/main" id="{4AD7A776-5C60-4800-9593-CE0682198BD1}"/>
               </a:ext>
             </a:extLst>
           </p:cNvPr>
@@ -6032,7 +6096,7 @@
           <p:cNvPr id="16" name="">
             <a:extLst xmlns:a="http://schemas.openxmlformats.org/drawingml/2006/main">
               <a:ext uri="{FF2B5EF4-FFF2-40B4-BE49-F238E27FC236}">
-                <a16:creationId xmlns:a16="http://schemas.microsoft.com/office/drawing/2014/main" id="{9BCCC657-68A5-464D-80A0-69C4ED0E59C7}"/>
+                <a16:creationId xmlns:a16="http://schemas.microsoft.com/office/drawing/2014/main" id="{AE3B40CD-66BA-42C0-8F70-E8EEB7F4E17B}"/>
               </a:ext>
             </a:extLst>
           </p:cNvPr>
@@ -6096,7 +6160,7 @@
           <p:cNvPr id="17" name="">
             <a:extLst xmlns:a="http://schemas.openxmlformats.org/drawingml/2006/main">
               <a:ext uri="{FF2B5EF4-FFF2-40B4-BE49-F238E27FC236}">
-                <a16:creationId xmlns:a16="http://schemas.microsoft.com/office/drawing/2014/main" id="{0128924E-D67C-4B34-9815-0575D458ECC1}"/>
+                <a16:creationId xmlns:a16="http://schemas.microsoft.com/office/drawing/2014/main" id="{F446D0BA-FE92-4385-92EA-A6A2D8CB1C38}"/>
               </a:ext>
             </a:extLst>
           </p:cNvPr>
@@ -6160,7 +6224,7 @@
           <p:cNvPr id="18" name="">
             <a:extLst xmlns:a="http://schemas.openxmlformats.org/drawingml/2006/main">
               <a:ext uri="{FF2B5EF4-FFF2-40B4-BE49-F238E27FC236}">
-                <a16:creationId xmlns:a16="http://schemas.microsoft.com/office/drawing/2014/main" id="{E0A7F09E-F96D-49C4-A4C4-9EC7008E9180}"/>
+                <a16:creationId xmlns:a16="http://schemas.microsoft.com/office/drawing/2014/main" id="{90D3BF54-C6F9-44B3-9052-3B40EE6269EF}"/>
               </a:ext>
             </a:extLst>
           </p:cNvPr>
@@ -6224,7 +6288,7 @@
           <p:cNvPr id="19" name="">
             <a:extLst xmlns:a="http://schemas.openxmlformats.org/drawingml/2006/main">
               <a:ext uri="{FF2B5EF4-FFF2-40B4-BE49-F238E27FC236}">
-                <a16:creationId xmlns:a16="http://schemas.microsoft.com/office/drawing/2014/main" id="{496B5157-AAF2-49C1-A84F-F87C6CCFDCFB}"/>
+                <a16:creationId xmlns:a16="http://schemas.microsoft.com/office/drawing/2014/main" id="{80111F96-F03B-43B4-874D-D63838CAB02A}"/>
               </a:ext>
             </a:extLst>
           </p:cNvPr>
@@ -6259,7 +6323,7 @@
           <p:cNvPr id="20" name="">
             <a:extLst xmlns:a="http://schemas.openxmlformats.org/drawingml/2006/main">
               <a:ext uri="{FF2B5EF4-FFF2-40B4-BE49-F238E27FC236}">
-                <a16:creationId xmlns:a16="http://schemas.microsoft.com/office/drawing/2014/main" id="{652C03A3-C535-4902-826D-DD097E56281E}"/>
+                <a16:creationId xmlns:a16="http://schemas.microsoft.com/office/drawing/2014/main" id="{512F1B77-BC68-48DD-8358-0139CFD12B6D}"/>
               </a:ext>
             </a:extLst>
           </p:cNvPr>
@@ -6323,7 +6387,7 @@
           <p:cNvPr id="21" name="">
             <a:extLst xmlns:a="http://schemas.openxmlformats.org/drawingml/2006/main">
               <a:ext uri="{FF2B5EF4-FFF2-40B4-BE49-F238E27FC236}">
-                <a16:creationId xmlns:a16="http://schemas.microsoft.com/office/drawing/2014/main" id="{6A973C41-1BD5-466A-B883-19A8031D697A}"/>
+                <a16:creationId xmlns:a16="http://schemas.microsoft.com/office/drawing/2014/main" id="{D1723775-EE07-42BF-BD8B-9E10ABACE2C7}"/>
               </a:ext>
             </a:extLst>
           </p:cNvPr>
@@ -6356,7 +6420,7 @@
           <p:cNvPr id="22" name="">
             <a:extLst xmlns:a="http://schemas.openxmlformats.org/drawingml/2006/main">
               <a:ext uri="{FF2B5EF4-FFF2-40B4-BE49-F238E27FC236}">
-                <a16:creationId xmlns:a16="http://schemas.microsoft.com/office/drawing/2014/main" id="{9EA547DE-B7EA-4C42-AB2B-5E46371DAB2D}"/>
+                <a16:creationId xmlns:a16="http://schemas.microsoft.com/office/drawing/2014/main" id="{5C8326FA-CDFD-427B-8328-640AA4B7BEA4}"/>
               </a:ext>
             </a:extLst>
           </p:cNvPr>
@@ -6391,7 +6455,7 @@
           <p:cNvPr id="23" name="">
             <a:extLst xmlns:a="http://schemas.openxmlformats.org/drawingml/2006/main">
               <a:ext uri="{FF2B5EF4-FFF2-40B4-BE49-F238E27FC236}">
-                <a16:creationId xmlns:a16="http://schemas.microsoft.com/office/drawing/2014/main" id="{50700CF6-A9BB-451D-A29A-5B521F7BB055}"/>
+                <a16:creationId xmlns:a16="http://schemas.microsoft.com/office/drawing/2014/main" id="{D3EABD33-797D-4606-BDAC-0A0979F50A99}"/>
               </a:ext>
             </a:extLst>
           </p:cNvPr>
@@ -6455,7 +6519,7 @@
           <p:cNvPr id="24" name="">
             <a:extLst xmlns:a="http://schemas.openxmlformats.org/drawingml/2006/main">
               <a:ext uri="{FF2B5EF4-FFF2-40B4-BE49-F238E27FC236}">
-                <a16:creationId xmlns:a16="http://schemas.microsoft.com/office/drawing/2014/main" id="{AAECC1A7-53B0-49BD-B66F-0781544670A7}"/>
+                <a16:creationId xmlns:a16="http://schemas.microsoft.com/office/drawing/2014/main" id="{5B8660E5-6054-489D-9ECF-4C591EF99321}"/>
               </a:ext>
             </a:extLst>
           </p:cNvPr>
@@ -6519,7 +6583,7 @@
           <p:cNvPr id="25" name="">
             <a:extLst xmlns:a="http://schemas.openxmlformats.org/drawingml/2006/main">
               <a:ext uri="{FF2B5EF4-FFF2-40B4-BE49-F238E27FC236}">
-                <a16:creationId xmlns:a16="http://schemas.microsoft.com/office/drawing/2014/main" id="{06D9F09B-4F60-42B1-8A99-F90E8F972ED7}"/>
+                <a16:creationId xmlns:a16="http://schemas.microsoft.com/office/drawing/2014/main" id="{BCE1D275-421E-4E53-9816-922B099702BA}"/>
               </a:ext>
             </a:extLst>
           </p:cNvPr>
@@ -6583,7 +6647,7 @@
           <p:cNvPr id="26" name="">
             <a:extLst xmlns:a="http://schemas.openxmlformats.org/drawingml/2006/main">
               <a:ext uri="{FF2B5EF4-FFF2-40B4-BE49-F238E27FC236}">
-                <a16:creationId xmlns:a16="http://schemas.microsoft.com/office/drawing/2014/main" id="{926DEDB9-210F-4833-BBD7-37DF4FAE4E8D}"/>
+                <a16:creationId xmlns:a16="http://schemas.microsoft.com/office/drawing/2014/main" id="{6938062E-EAF7-4041-B3E4-6C4719EF6F64}"/>
               </a:ext>
             </a:extLst>
           </p:cNvPr>
@@ -6618,7 +6682,7 @@
           <p:cNvPr id="27" name="">
             <a:extLst xmlns:a="http://schemas.openxmlformats.org/drawingml/2006/main">
               <a:ext uri="{FF2B5EF4-FFF2-40B4-BE49-F238E27FC236}">
-                <a16:creationId xmlns:a16="http://schemas.microsoft.com/office/drawing/2014/main" id="{4BEE7EB9-2244-4E37-A75A-081BC8909695}"/>
+                <a16:creationId xmlns:a16="http://schemas.microsoft.com/office/drawing/2014/main" id="{F8E76D4A-6136-4207-ABA2-A5CB60438820}"/>
               </a:ext>
             </a:extLst>
           </p:cNvPr>
@@ -6682,7 +6746,7 @@
           <p:cNvPr id="28" name="">
             <a:extLst xmlns:a="http://schemas.openxmlformats.org/drawingml/2006/main">
               <a:ext uri="{FF2B5EF4-FFF2-40B4-BE49-F238E27FC236}">
-                <a16:creationId xmlns:a16="http://schemas.microsoft.com/office/drawing/2014/main" id="{0AD5AD6B-A7E7-4239-BB90-437CC3F00F01}"/>
+                <a16:creationId xmlns:a16="http://schemas.microsoft.com/office/drawing/2014/main" id="{E2B51E8B-C608-45A9-8F33-855C0900DCB5}"/>
               </a:ext>
             </a:extLst>
           </p:cNvPr>
@@ -6715,7 +6779,7 @@
           <p:cNvPr id="29" name="">
             <a:extLst xmlns:a="http://schemas.openxmlformats.org/drawingml/2006/main">
               <a:ext uri="{FF2B5EF4-FFF2-40B4-BE49-F238E27FC236}">
-                <a16:creationId xmlns:a16="http://schemas.microsoft.com/office/drawing/2014/main" id="{7FE45B1C-EC58-4417-8EF8-AA4675849471}"/>
+                <a16:creationId xmlns:a16="http://schemas.microsoft.com/office/drawing/2014/main" id="{0B2A4424-00B2-4372-8E57-6C30B80C845E}"/>
               </a:ext>
             </a:extLst>
           </p:cNvPr>
@@ -6750,7 +6814,7 @@
           <p:cNvPr id="30" name="">
             <a:extLst xmlns:a="http://schemas.openxmlformats.org/drawingml/2006/main">
               <a:ext uri="{FF2B5EF4-FFF2-40B4-BE49-F238E27FC236}">
-                <a16:creationId xmlns:a16="http://schemas.microsoft.com/office/drawing/2014/main" id="{872389C9-6D92-44B1-869E-9AEB3DC7E588}"/>
+                <a16:creationId xmlns:a16="http://schemas.microsoft.com/office/drawing/2014/main" id="{DCC922D6-C732-4874-ACA3-C0542095A671}"/>
               </a:ext>
             </a:extLst>
           </p:cNvPr>
@@ -6814,7 +6878,7 @@
           <p:cNvPr id="31" name="">
             <a:extLst xmlns:a="http://schemas.openxmlformats.org/drawingml/2006/main">
               <a:ext uri="{FF2B5EF4-FFF2-40B4-BE49-F238E27FC236}">
-                <a16:creationId xmlns:a16="http://schemas.microsoft.com/office/drawing/2014/main" id="{ED750D74-0475-44BF-9CD8-BBD6DAB82188}"/>
+                <a16:creationId xmlns:a16="http://schemas.microsoft.com/office/drawing/2014/main" id="{5FEC708B-AB58-41E2-AB2B-A396E9E78CE0}"/>
               </a:ext>
             </a:extLst>
           </p:cNvPr>
@@ -6878,7 +6942,7 @@
           <p:cNvPr id="32" name="">
             <a:extLst xmlns:a="http://schemas.openxmlformats.org/drawingml/2006/main">
               <a:ext uri="{FF2B5EF4-FFF2-40B4-BE49-F238E27FC236}">
-                <a16:creationId xmlns:a16="http://schemas.microsoft.com/office/drawing/2014/main" id="{E590ED6D-8959-4DAE-9E76-9A1B083BEB8B}"/>
+                <a16:creationId xmlns:a16="http://schemas.microsoft.com/office/drawing/2014/main" id="{667CB57F-01C0-431B-9295-62EFD94003A5}"/>
               </a:ext>
             </a:extLst>
           </p:cNvPr>
@@ -6942,7 +7006,7 @@
           <p:cNvPr id="33" name="">
             <a:extLst xmlns:a="http://schemas.openxmlformats.org/drawingml/2006/main">
               <a:ext uri="{FF2B5EF4-FFF2-40B4-BE49-F238E27FC236}">
-                <a16:creationId xmlns:a16="http://schemas.microsoft.com/office/drawing/2014/main" id="{0FCC5CC2-186F-4297-912F-F2A03EE0C3B8}"/>
+                <a16:creationId xmlns:a16="http://schemas.microsoft.com/office/drawing/2014/main" id="{260AB8C7-4366-4921-8ACD-B2155DF549BB}"/>
               </a:ext>
             </a:extLst>
           </p:cNvPr>
@@ -6975,7 +7039,7 @@
           <p:cNvPr id="34" name="">
             <a:extLst xmlns:a="http://schemas.openxmlformats.org/drawingml/2006/main">
               <a:ext uri="{FF2B5EF4-FFF2-40B4-BE49-F238E27FC236}">
-                <a16:creationId xmlns:a16="http://schemas.microsoft.com/office/drawing/2014/main" id="{9203A372-B991-40CE-AD35-A537F46C19C4}"/>
+                <a16:creationId xmlns:a16="http://schemas.microsoft.com/office/drawing/2014/main" id="{D182EC37-FD3B-4690-A189-0EEC0A787A52}"/>
               </a:ext>
             </a:extLst>
           </p:cNvPr>
@@ -7039,7 +7103,7 @@
           <p:cNvPr id="35" name="">
             <a:extLst xmlns:a="http://schemas.openxmlformats.org/drawingml/2006/main">
               <a:ext uri="{FF2B5EF4-FFF2-40B4-BE49-F238E27FC236}">
-                <a16:creationId xmlns:a16="http://schemas.microsoft.com/office/drawing/2014/main" id="{A5D242D8-5A46-4C37-81F9-B35461F92AF8}"/>
+                <a16:creationId xmlns:a16="http://schemas.microsoft.com/office/drawing/2014/main" id="{DAF7D5DB-201C-481D-9E9F-B8C17F81F138}"/>
               </a:ext>
             </a:extLst>
           </p:cNvPr>
@@ -7103,7 +7167,7 @@
           <p:cNvPr id="36" name="">
             <a:extLst xmlns:a="http://schemas.openxmlformats.org/drawingml/2006/main">
               <a:ext uri="{FF2B5EF4-FFF2-40B4-BE49-F238E27FC236}">
-                <a16:creationId xmlns:a16="http://schemas.microsoft.com/office/drawing/2014/main" id="{7D693B90-86D0-42B9-BF44-6AFAAEF2892D}"/>
+                <a16:creationId xmlns:a16="http://schemas.microsoft.com/office/drawing/2014/main" id="{15F08CE0-DC2D-4A17-9D32-9E038FE0A86B}"/>
               </a:ext>
             </a:extLst>
           </p:cNvPr>
@@ -7138,7 +7202,7 @@
           <p:cNvPr id="37" name="">
             <a:extLst xmlns:a="http://schemas.openxmlformats.org/drawingml/2006/main">
               <a:ext uri="{FF2B5EF4-FFF2-40B4-BE49-F238E27FC236}">
-                <a16:creationId xmlns:a16="http://schemas.microsoft.com/office/drawing/2014/main" id="{AABBC15C-5F12-4580-A4A3-08D8B7AC4796}"/>
+                <a16:creationId xmlns:a16="http://schemas.microsoft.com/office/drawing/2014/main" id="{28407A9C-E8F6-4E90-94DD-2AB9A7A18335}"/>
               </a:ext>
             </a:extLst>
           </p:cNvPr>
@@ -7202,7 +7266,7 @@
           <p:cNvPr id="38" name="">
             <a:extLst xmlns:a="http://schemas.openxmlformats.org/drawingml/2006/main">
               <a:ext uri="{FF2B5EF4-FFF2-40B4-BE49-F238E27FC236}">
-                <a16:creationId xmlns:a16="http://schemas.microsoft.com/office/drawing/2014/main" id="{1599EE0B-4A42-43AD-9703-906FC26CF818}"/>
+                <a16:creationId xmlns:a16="http://schemas.microsoft.com/office/drawing/2014/main" id="{840174CF-6E94-4CD7-8440-FA494170FE58}"/>
               </a:ext>
             </a:extLst>
           </p:cNvPr>
@@ -7264,7 +7328,7 @@
     </p:spTree>
     <p:extLst>
       <p:ext uri="{BB962C8B-B14F-4D97-AF65-F5344CB8AC3E}">
-        <p14:creationId xmlns:p14="http://schemas.microsoft.com/office/powerpoint/2010/main" val="1779687074"/>
+        <p14:creationId xmlns:p14="http://schemas.microsoft.com/office/powerpoint/2010/main" val="832139540"/>
       </p:ext>
     </p:extLst>
   </p:cSld>
@@ -7288,7 +7352,7 @@
           <p:cNvPr id="1" name="">
             <a:extLst xmlns:a="http://schemas.openxmlformats.org/drawingml/2006/main">
               <a:ext uri="{FF2B5EF4-FFF2-40B4-BE49-F238E27FC236}">
-                <a16:creationId xmlns:a16="http://schemas.microsoft.com/office/drawing/2014/main" id="{1DCC403C-6690-4046-B35E-AC477727942D}"/>
+                <a16:creationId xmlns:a16="http://schemas.microsoft.com/office/drawing/2014/main" id="{C7308586-3D90-4545-AC5F-54086F265198}"/>
               </a:ext>
             </a:extLst>
           </p:cNvPr>
@@ -7323,7 +7387,7 @@
           <p:cNvPr id="2" name="">
             <a:extLst xmlns:a="http://schemas.openxmlformats.org/drawingml/2006/main">
               <a:ext uri="{FF2B5EF4-FFF2-40B4-BE49-F238E27FC236}">
-                <a16:creationId xmlns:a16="http://schemas.microsoft.com/office/drawing/2014/main" id="{8BA39E8F-7D6A-4BE9-84D6-1D5768B294CA}"/>
+                <a16:creationId xmlns:a16="http://schemas.microsoft.com/office/drawing/2014/main" id="{11E6F4A1-F4F9-45FA-B0D1-71C506509172}"/>
               </a:ext>
             </a:extLst>
           </p:cNvPr>
@@ -7358,7 +7422,7 @@
           <p:cNvPr id="3" name="">
             <a:extLst xmlns:a="http://schemas.openxmlformats.org/drawingml/2006/main">
               <a:ext uri="{FF2B5EF4-FFF2-40B4-BE49-F238E27FC236}">
-                <a16:creationId xmlns:a16="http://schemas.microsoft.com/office/drawing/2014/main" id="{FAE135FE-C439-4345-9BC7-44057A6648E9}"/>
+                <a16:creationId xmlns:a16="http://schemas.microsoft.com/office/drawing/2014/main" id="{92C6A2A3-1E51-4F45-A310-79E3D2CF9D88}"/>
               </a:ext>
             </a:extLst>
           </p:cNvPr>
@@ -7422,7 +7486,7 @@
           <p:cNvPr id="4" name="">
             <a:extLst xmlns:a="http://schemas.openxmlformats.org/drawingml/2006/main">
               <a:ext uri="{FF2B5EF4-FFF2-40B4-BE49-F238E27FC236}">
-                <a16:creationId xmlns:a16="http://schemas.microsoft.com/office/drawing/2014/main" id="{2936485E-431F-40F0-8D1C-672E1CCE53E3}"/>
+                <a16:creationId xmlns:a16="http://schemas.microsoft.com/office/drawing/2014/main" id="{D5AE7196-9684-4B81-95AD-40468CE176C8}"/>
               </a:ext>
             </a:extLst>
           </p:cNvPr>
@@ -7486,7 +7550,7 @@
           <p:cNvPr id="5" name="">
             <a:extLst xmlns:a="http://schemas.openxmlformats.org/drawingml/2006/main">
               <a:ext uri="{FF2B5EF4-FFF2-40B4-BE49-F238E27FC236}">
-                <a16:creationId xmlns:a16="http://schemas.microsoft.com/office/drawing/2014/main" id="{A66997BE-2C60-45DC-933B-7D331D971423}"/>
+                <a16:creationId xmlns:a16="http://schemas.microsoft.com/office/drawing/2014/main" id="{9522D363-DF2B-45EB-9896-2E160046BC95}"/>
               </a:ext>
             </a:extLst>
           </p:cNvPr>
@@ -7550,7 +7614,7 @@
           <p:cNvPr id="6" name="">
             <a:extLst xmlns:a="http://schemas.openxmlformats.org/drawingml/2006/main">
               <a:ext uri="{FF2B5EF4-FFF2-40B4-BE49-F238E27FC236}">
-                <a16:creationId xmlns:a16="http://schemas.microsoft.com/office/drawing/2014/main" id="{92F9BF82-BBE3-4812-B3AB-339AB984798A}"/>
+                <a16:creationId xmlns:a16="http://schemas.microsoft.com/office/drawing/2014/main" id="{840CFC11-DC22-40C6-BB7E-8138D7B77570}"/>
               </a:ext>
             </a:extLst>
           </p:cNvPr>
@@ -7614,7 +7678,7 @@
           <p:cNvPr id="7" name="">
             <a:extLst xmlns:a="http://schemas.openxmlformats.org/drawingml/2006/main">
               <a:ext uri="{FF2B5EF4-FFF2-40B4-BE49-F238E27FC236}">
-                <a16:creationId xmlns:a16="http://schemas.microsoft.com/office/drawing/2014/main" id="{22C19FF7-8FAD-473A-B81F-EA7934621937}"/>
+                <a16:creationId xmlns:a16="http://schemas.microsoft.com/office/drawing/2014/main" id="{C62ABC96-6BB2-4524-B7E0-CF101684D7E1}"/>
               </a:ext>
             </a:extLst>
           </p:cNvPr>
@@ -7678,7 +7742,7 @@
           <p:cNvPr id="8" name="">
             <a:extLst xmlns:a="http://schemas.openxmlformats.org/drawingml/2006/main">
               <a:ext uri="{FF2B5EF4-FFF2-40B4-BE49-F238E27FC236}">
-                <a16:creationId xmlns:a16="http://schemas.microsoft.com/office/drawing/2014/main" id="{00179ED1-5CD4-4118-ACF7-10F36F74E171}"/>
+                <a16:creationId xmlns:a16="http://schemas.microsoft.com/office/drawing/2014/main" id="{EC1E0300-5C6E-46D0-A9AC-761CC36FD16F}"/>
               </a:ext>
             </a:extLst>
           </p:cNvPr>
@@ -7742,7 +7806,7 @@
           <p:cNvPr id="9" name="">
             <a:extLst xmlns:a="http://schemas.openxmlformats.org/drawingml/2006/main">
               <a:ext uri="{FF2B5EF4-FFF2-40B4-BE49-F238E27FC236}">
-                <a16:creationId xmlns:a16="http://schemas.microsoft.com/office/drawing/2014/main" id="{82AEE97F-FAED-45E2-965D-6A0D511CD7F4}"/>
+                <a16:creationId xmlns:a16="http://schemas.microsoft.com/office/drawing/2014/main" id="{CE781EB5-8428-4BAA-B486-254AA28AF59B}"/>
               </a:ext>
             </a:extLst>
           </p:cNvPr>
@@ -7806,7 +7870,7 @@
           <p:cNvPr id="10" name="">
             <a:extLst xmlns:a="http://schemas.openxmlformats.org/drawingml/2006/main">
               <a:ext uri="{FF2B5EF4-FFF2-40B4-BE49-F238E27FC236}">
-                <a16:creationId xmlns:a16="http://schemas.microsoft.com/office/drawing/2014/main" id="{7FA31E30-E03F-46B7-9A0D-EBB92DC320AB}"/>
+                <a16:creationId xmlns:a16="http://schemas.microsoft.com/office/drawing/2014/main" id="{5CCAB699-A7A8-4FF5-B0AF-5C1DAF2F3F0A}"/>
               </a:ext>
             </a:extLst>
           </p:cNvPr>
@@ -7841,7 +7905,7 @@
           <p:cNvPr id="11" name="">
             <a:extLst xmlns:a="http://schemas.openxmlformats.org/drawingml/2006/main">
               <a:ext uri="{FF2B5EF4-FFF2-40B4-BE49-F238E27FC236}">
-                <a16:creationId xmlns:a16="http://schemas.microsoft.com/office/drawing/2014/main" id="{C2DDA6AF-56AB-4535-A436-36EA06E309BC}"/>
+                <a16:creationId xmlns:a16="http://schemas.microsoft.com/office/drawing/2014/main" id="{7BC0D509-3035-42DE-A523-66A0E910B7FE}"/>
               </a:ext>
             </a:extLst>
           </p:cNvPr>
@@ -7905,7 +7969,7 @@
           <p:cNvPr id="12" name="">
             <a:extLst xmlns:a="http://schemas.openxmlformats.org/drawingml/2006/main">
               <a:ext uri="{FF2B5EF4-FFF2-40B4-BE49-F238E27FC236}">
-                <a16:creationId xmlns:a16="http://schemas.microsoft.com/office/drawing/2014/main" id="{C52602AD-D1C7-47C5-BEF3-D0286728299E}"/>
+                <a16:creationId xmlns:a16="http://schemas.microsoft.com/office/drawing/2014/main" id="{F1126240-12C7-4E14-A648-598930D3121A}"/>
               </a:ext>
             </a:extLst>
           </p:cNvPr>
@@ -7969,7 +8033,7 @@
           <p:cNvPr id="13" name="">
             <a:extLst xmlns:a="http://schemas.openxmlformats.org/drawingml/2006/main">
               <a:ext uri="{FF2B5EF4-FFF2-40B4-BE49-F238E27FC236}">
-                <a16:creationId xmlns:a16="http://schemas.microsoft.com/office/drawing/2014/main" id="{FD383966-8DC7-4ECE-8B57-E2B15027AE58}"/>
+                <a16:creationId xmlns:a16="http://schemas.microsoft.com/office/drawing/2014/main" id="{0D3BE23D-365C-4727-A0E5-867742B82946}"/>
               </a:ext>
             </a:extLst>
           </p:cNvPr>
@@ -8033,7 +8097,7 @@
           <p:cNvPr id="14" name="">
             <a:extLst xmlns:a="http://schemas.openxmlformats.org/drawingml/2006/main">
               <a:ext uri="{FF2B5EF4-FFF2-40B4-BE49-F238E27FC236}">
-                <a16:creationId xmlns:a16="http://schemas.microsoft.com/office/drawing/2014/main" id="{BEDD8D87-46EF-454D-B3DA-0C2BEBF81F68}"/>
+                <a16:creationId xmlns:a16="http://schemas.microsoft.com/office/drawing/2014/main" id="{30893F1B-1AAB-4703-908D-D52F53713E95}"/>
               </a:ext>
             </a:extLst>
           </p:cNvPr>
@@ -8068,7 +8132,7 @@
           <p:cNvPr id="15" name="">
             <a:extLst xmlns:a="http://schemas.openxmlformats.org/drawingml/2006/main">
               <a:ext uri="{FF2B5EF4-FFF2-40B4-BE49-F238E27FC236}">
-                <a16:creationId xmlns:a16="http://schemas.microsoft.com/office/drawing/2014/main" id="{75AE7B13-B146-49F0-81F7-55330D2C84BB}"/>
+                <a16:creationId xmlns:a16="http://schemas.microsoft.com/office/drawing/2014/main" id="{902909C0-C5CA-49FB-A8AB-BFFEDA3DBC99}"/>
               </a:ext>
             </a:extLst>
           </p:cNvPr>
@@ -8132,7 +8196,7 @@
           <p:cNvPr id="16" name="">
             <a:extLst xmlns:a="http://schemas.openxmlformats.org/drawingml/2006/main">
               <a:ext uri="{FF2B5EF4-FFF2-40B4-BE49-F238E27FC236}">
-                <a16:creationId xmlns:a16="http://schemas.microsoft.com/office/drawing/2014/main" id="{10D4AD9D-9AD6-4E74-83A1-D41E79761C2E}"/>
+                <a16:creationId xmlns:a16="http://schemas.microsoft.com/office/drawing/2014/main" id="{11B24B25-BA8C-4A79-B678-26B5436E9763}"/>
               </a:ext>
             </a:extLst>
           </p:cNvPr>
@@ -8196,7 +8260,7 @@
           <p:cNvPr id="17" name="">
             <a:extLst xmlns:a="http://schemas.openxmlformats.org/drawingml/2006/main">
               <a:ext uri="{FF2B5EF4-FFF2-40B4-BE49-F238E27FC236}">
-                <a16:creationId xmlns:a16="http://schemas.microsoft.com/office/drawing/2014/main" id="{7A6C31A1-87F1-4516-A11F-F39E9B33F3C4}"/>
+                <a16:creationId xmlns:a16="http://schemas.microsoft.com/office/drawing/2014/main" id="{54517E55-9F64-4636-9D5F-7ED476C18FDA}"/>
               </a:ext>
             </a:extLst>
           </p:cNvPr>
@@ -8260,7 +8324,7 @@
           <p:cNvPr id="18" name="">
             <a:extLst xmlns:a="http://schemas.openxmlformats.org/drawingml/2006/main">
               <a:ext uri="{FF2B5EF4-FFF2-40B4-BE49-F238E27FC236}">
-                <a16:creationId xmlns:a16="http://schemas.microsoft.com/office/drawing/2014/main" id="{27A915C1-CEE6-44C1-AC6B-702605E028A2}"/>
+                <a16:creationId xmlns:a16="http://schemas.microsoft.com/office/drawing/2014/main" id="{71D76AFB-FD07-4A12-8622-2C4FF0414555}"/>
               </a:ext>
             </a:extLst>
           </p:cNvPr>
@@ -8295,7 +8359,7 @@
           <p:cNvPr id="19" name="">
             <a:extLst xmlns:a="http://schemas.openxmlformats.org/drawingml/2006/main">
               <a:ext uri="{FF2B5EF4-FFF2-40B4-BE49-F238E27FC236}">
-                <a16:creationId xmlns:a16="http://schemas.microsoft.com/office/drawing/2014/main" id="{D6A379E1-FDB4-4950-9C3A-C76ECFCD73AA}"/>
+                <a16:creationId xmlns:a16="http://schemas.microsoft.com/office/drawing/2014/main" id="{0F931D01-412D-49BA-A37B-462386E778EE}"/>
               </a:ext>
             </a:extLst>
           </p:cNvPr>
@@ -8359,7 +8423,7 @@
           <p:cNvPr id="20" name="">
             <a:extLst xmlns:a="http://schemas.openxmlformats.org/drawingml/2006/main">
               <a:ext uri="{FF2B5EF4-FFF2-40B4-BE49-F238E27FC236}">
-                <a16:creationId xmlns:a16="http://schemas.microsoft.com/office/drawing/2014/main" id="{DBF928E6-C199-42E2-981D-0688C2C41F6B}"/>
+                <a16:creationId xmlns:a16="http://schemas.microsoft.com/office/drawing/2014/main" id="{3AC09BB6-84DE-4017-A6BF-BF7259D39491}"/>
               </a:ext>
             </a:extLst>
           </p:cNvPr>
@@ -8423,7 +8487,7 @@
           <p:cNvPr id="21" name="">
             <a:extLst xmlns:a="http://schemas.openxmlformats.org/drawingml/2006/main">
               <a:ext uri="{FF2B5EF4-FFF2-40B4-BE49-F238E27FC236}">
-                <a16:creationId xmlns:a16="http://schemas.microsoft.com/office/drawing/2014/main" id="{07216F66-C3CD-4EEB-B324-61E0F9A0DD24}"/>
+                <a16:creationId xmlns:a16="http://schemas.microsoft.com/office/drawing/2014/main" id="{E092B33E-6A18-4936-8B16-FC95C72B78AC}"/>
               </a:ext>
             </a:extLst>
           </p:cNvPr>
@@ -8487,7 +8551,7 @@
           <p:cNvPr id="22" name="">
             <a:extLst xmlns:a="http://schemas.openxmlformats.org/drawingml/2006/main">
               <a:ext uri="{FF2B5EF4-FFF2-40B4-BE49-F238E27FC236}">
-                <a16:creationId xmlns:a16="http://schemas.microsoft.com/office/drawing/2014/main" id="{9C0AAAB9-2A5A-4FC0-BAAF-8AB2757C4DB2}"/>
+                <a16:creationId xmlns:a16="http://schemas.microsoft.com/office/drawing/2014/main" id="{CDF966BD-EBB6-4A5F-B63E-9074A62B8DBD}"/>
               </a:ext>
             </a:extLst>
           </p:cNvPr>
@@ -8522,7 +8586,7 @@
           <p:cNvPr id="23" name="">
             <a:extLst xmlns:a="http://schemas.openxmlformats.org/drawingml/2006/main">
               <a:ext uri="{FF2B5EF4-FFF2-40B4-BE49-F238E27FC236}">
-                <a16:creationId xmlns:a16="http://schemas.microsoft.com/office/drawing/2014/main" id="{7339B739-2664-4B46-980C-E06AFA4073AA}"/>
+                <a16:creationId xmlns:a16="http://schemas.microsoft.com/office/drawing/2014/main" id="{380B4F87-6DDF-45F2-8843-7670B1F8A314}"/>
               </a:ext>
             </a:extLst>
           </p:cNvPr>
@@ -8555,7 +8619,7 @@
           <p:cNvPr id="24" name="">
             <a:extLst xmlns:a="http://schemas.openxmlformats.org/drawingml/2006/main">
               <a:ext uri="{FF2B5EF4-FFF2-40B4-BE49-F238E27FC236}">
-                <a16:creationId xmlns:a16="http://schemas.microsoft.com/office/drawing/2014/main" id="{9D3FB0D2-CB1A-4B77-81D5-7966BC9A5C13}"/>
+                <a16:creationId xmlns:a16="http://schemas.microsoft.com/office/drawing/2014/main" id="{1865AD63-7831-4D27-867B-099B8DE76ED4}"/>
               </a:ext>
             </a:extLst>
           </p:cNvPr>
@@ -8619,7 +8683,7 @@
           <p:cNvPr id="25" name="">
             <a:extLst xmlns:a="http://schemas.openxmlformats.org/drawingml/2006/main">
               <a:ext uri="{FF2B5EF4-FFF2-40B4-BE49-F238E27FC236}">
-                <a16:creationId xmlns:a16="http://schemas.microsoft.com/office/drawing/2014/main" id="{035AB74E-0684-4DD8-8DBA-5EB82E0995D4}"/>
+                <a16:creationId xmlns:a16="http://schemas.microsoft.com/office/drawing/2014/main" id="{A466B103-F1DA-4C66-B71E-E6064BDBB7F6}"/>
               </a:ext>
             </a:extLst>
           </p:cNvPr>
@@ -8683,7 +8747,7 @@
           <p:cNvPr id="26" name="">
             <a:extLst xmlns:a="http://schemas.openxmlformats.org/drawingml/2006/main">
               <a:ext uri="{FF2B5EF4-FFF2-40B4-BE49-F238E27FC236}">
-                <a16:creationId xmlns:a16="http://schemas.microsoft.com/office/drawing/2014/main" id="{BBDC9B3C-3B02-4213-A69E-36D318D9F9CA}"/>
+                <a16:creationId xmlns:a16="http://schemas.microsoft.com/office/drawing/2014/main" id="{68E81312-BED0-4073-BA0E-1E854037660B}"/>
               </a:ext>
             </a:extLst>
           </p:cNvPr>
@@ -8745,7 +8809,7 @@
     </p:spTree>
     <p:extLst>
       <p:ext uri="{BB962C8B-B14F-4D97-AF65-F5344CB8AC3E}">
-        <p14:creationId xmlns:p14="http://schemas.microsoft.com/office/powerpoint/2010/main" val="656549467"/>
+        <p14:creationId xmlns:p14="http://schemas.microsoft.com/office/powerpoint/2010/main" val="1726459159"/>
       </p:ext>
     </p:extLst>
   </p:cSld>
@@ -8769,7 +8833,7 @@
           <p:cNvPr id="1" name="">
             <a:extLst xmlns:a="http://schemas.openxmlformats.org/drawingml/2006/main">
               <a:ext uri="{FF2B5EF4-FFF2-40B4-BE49-F238E27FC236}">
-                <a16:creationId xmlns:a16="http://schemas.microsoft.com/office/drawing/2014/main" id="{268901A4-ED0B-4D8F-A7A3-EF301CBCECBB}"/>
+                <a16:creationId xmlns:a16="http://schemas.microsoft.com/office/drawing/2014/main" id="{89C5BC7E-F604-448D-A9EB-ACB92D1EF1FE}"/>
               </a:ext>
             </a:extLst>
           </p:cNvPr>
@@ -8804,7 +8868,7 @@
           <p:cNvPr id="2" name="">
             <a:extLst xmlns:a="http://schemas.openxmlformats.org/drawingml/2006/main">
               <a:ext uri="{FF2B5EF4-FFF2-40B4-BE49-F238E27FC236}">
-                <a16:creationId xmlns:a16="http://schemas.microsoft.com/office/drawing/2014/main" id="{30534214-1A2C-4A22-87B2-67ED5A72E193}"/>
+                <a16:creationId xmlns:a16="http://schemas.microsoft.com/office/drawing/2014/main" id="{4CCBEBCB-172E-42E2-B8CC-7BD57005200F}"/>
               </a:ext>
             </a:extLst>
           </p:cNvPr>
@@ -8839,7 +8903,7 @@
           <p:cNvPr id="3" name="">
             <a:extLst xmlns:a="http://schemas.openxmlformats.org/drawingml/2006/main">
               <a:ext uri="{FF2B5EF4-FFF2-40B4-BE49-F238E27FC236}">
-                <a16:creationId xmlns:a16="http://schemas.microsoft.com/office/drawing/2014/main" id="{91CD7A4F-F9D4-402E-871D-4F8F9C6D6B13}"/>
+                <a16:creationId xmlns:a16="http://schemas.microsoft.com/office/drawing/2014/main" id="{95A256BC-3AB7-4E39-90BB-9F1B4B19DC4D}"/>
               </a:ext>
             </a:extLst>
           </p:cNvPr>
@@ -8903,7 +8967,7 @@
           <p:cNvPr id="4" name="">
             <a:extLst xmlns:a="http://schemas.openxmlformats.org/drawingml/2006/main">
               <a:ext uri="{FF2B5EF4-FFF2-40B4-BE49-F238E27FC236}">
-                <a16:creationId xmlns:a16="http://schemas.microsoft.com/office/drawing/2014/main" id="{E1A0026D-39B2-4466-8EE6-B3208F3CAAE5}"/>
+                <a16:creationId xmlns:a16="http://schemas.microsoft.com/office/drawing/2014/main" id="{0EDBFF70-3CC8-457A-A3F5-8F8BB19E9FE1}"/>
               </a:ext>
             </a:extLst>
           </p:cNvPr>
@@ -8967,7 +9031,7 @@
           <p:cNvPr id="5" name="">
             <a:extLst xmlns:a="http://schemas.openxmlformats.org/drawingml/2006/main">
               <a:ext uri="{FF2B5EF4-FFF2-40B4-BE49-F238E27FC236}">
-                <a16:creationId xmlns:a16="http://schemas.microsoft.com/office/drawing/2014/main" id="{89052607-FD95-4E5D-B284-BCD32D2123DF}"/>
+                <a16:creationId xmlns:a16="http://schemas.microsoft.com/office/drawing/2014/main" id="{8B3E4817-CBCD-4DCD-ABBD-937A0C2258CC}"/>
               </a:ext>
             </a:extLst>
           </p:cNvPr>
@@ -9031,7 +9095,7 @@
           <p:cNvPr id="6" name="">
             <a:extLst xmlns:a="http://schemas.openxmlformats.org/drawingml/2006/main">
               <a:ext uri="{FF2B5EF4-FFF2-40B4-BE49-F238E27FC236}">
-                <a16:creationId xmlns:a16="http://schemas.microsoft.com/office/drawing/2014/main" id="{07001929-46BA-4DB4-BCF9-98A329A92481}"/>
+                <a16:creationId xmlns:a16="http://schemas.microsoft.com/office/drawing/2014/main" id="{B57504F4-21B0-4EB7-B052-BDEFCEA678BE}"/>
               </a:ext>
             </a:extLst>
           </p:cNvPr>
@@ -9095,7 +9159,7 @@
           <p:cNvPr id="7" name="">
             <a:extLst xmlns:a="http://schemas.openxmlformats.org/drawingml/2006/main">
               <a:ext uri="{FF2B5EF4-FFF2-40B4-BE49-F238E27FC236}">
-                <a16:creationId xmlns:a16="http://schemas.microsoft.com/office/drawing/2014/main" id="{DCC4E37B-BF00-4F7F-B203-B6AD17EE48BC}"/>
+                <a16:creationId xmlns:a16="http://schemas.microsoft.com/office/drawing/2014/main" id="{F02F570C-32EE-47C4-BABD-A2420A5BB0F8}"/>
               </a:ext>
             </a:extLst>
           </p:cNvPr>
@@ -9128,7 +9192,7 @@
           <p:cNvPr id="8" name="">
             <a:extLst xmlns:a="http://schemas.openxmlformats.org/drawingml/2006/main">
               <a:ext uri="{FF2B5EF4-FFF2-40B4-BE49-F238E27FC236}">
-                <a16:creationId xmlns:a16="http://schemas.microsoft.com/office/drawing/2014/main" id="{9CB7C0BF-E384-4225-83E6-92C8BBF08B0B}"/>
+                <a16:creationId xmlns:a16="http://schemas.microsoft.com/office/drawing/2014/main" id="{87A22EAF-3085-422C-BF65-2D7DAFE8A6E6}"/>
               </a:ext>
             </a:extLst>
           </p:cNvPr>
@@ -9192,7 +9256,7 @@
           <p:cNvPr id="9" name="">
             <a:extLst xmlns:a="http://schemas.openxmlformats.org/drawingml/2006/main">
               <a:ext uri="{FF2B5EF4-FFF2-40B4-BE49-F238E27FC236}">
-                <a16:creationId xmlns:a16="http://schemas.microsoft.com/office/drawing/2014/main" id="{23EC0A48-9ED4-4FC1-9E1B-7884C3015E6C}"/>
+                <a16:creationId xmlns:a16="http://schemas.microsoft.com/office/drawing/2014/main" id="{69926614-A5EE-44A9-8B89-3823E6F33AFF}"/>
               </a:ext>
             </a:extLst>
           </p:cNvPr>
@@ -9256,7 +9320,7 @@
           <p:cNvPr id="10" name="">
             <a:extLst xmlns:a="http://schemas.openxmlformats.org/drawingml/2006/main">
               <a:ext uri="{FF2B5EF4-FFF2-40B4-BE49-F238E27FC236}">
-                <a16:creationId xmlns:a16="http://schemas.microsoft.com/office/drawing/2014/main" id="{20B4DA0C-A691-478A-A259-3F4E727596B0}"/>
+                <a16:creationId xmlns:a16="http://schemas.microsoft.com/office/drawing/2014/main" id="{65A2890E-A9B8-4134-95B5-8A15CDA00CEB}"/>
               </a:ext>
             </a:extLst>
           </p:cNvPr>
@@ -9320,7 +9384,7 @@
           <p:cNvPr id="11" name="">
             <a:extLst xmlns:a="http://schemas.openxmlformats.org/drawingml/2006/main">
               <a:ext uri="{FF2B5EF4-FFF2-40B4-BE49-F238E27FC236}">
-                <a16:creationId xmlns:a16="http://schemas.microsoft.com/office/drawing/2014/main" id="{305618F0-D75B-45B0-B2C6-C68A711A8279}"/>
+                <a16:creationId xmlns:a16="http://schemas.microsoft.com/office/drawing/2014/main" id="{3EFDD1C7-D47C-4F8D-8D95-5D66855429D3}"/>
               </a:ext>
             </a:extLst>
           </p:cNvPr>
@@ -9353,7 +9417,7 @@
           <p:cNvPr id="12" name="">
             <a:extLst xmlns:a="http://schemas.openxmlformats.org/drawingml/2006/main">
               <a:ext uri="{FF2B5EF4-FFF2-40B4-BE49-F238E27FC236}">
-                <a16:creationId xmlns:a16="http://schemas.microsoft.com/office/drawing/2014/main" id="{10586729-16E4-4F4C-926B-1A8E928F7E94}"/>
+                <a16:creationId xmlns:a16="http://schemas.microsoft.com/office/drawing/2014/main" id="{29DD9C97-D678-44E2-8DE0-CEDEC3D1B960}"/>
               </a:ext>
             </a:extLst>
           </p:cNvPr>
@@ -9417,7 +9481,7 @@
           <p:cNvPr id="13" name="">
             <a:extLst xmlns:a="http://schemas.openxmlformats.org/drawingml/2006/main">
               <a:ext uri="{FF2B5EF4-FFF2-40B4-BE49-F238E27FC236}">
-                <a16:creationId xmlns:a16="http://schemas.microsoft.com/office/drawing/2014/main" id="{4D2E3C6F-AE08-4EDB-B403-A7CCEEBAF159}"/>
+                <a16:creationId xmlns:a16="http://schemas.microsoft.com/office/drawing/2014/main" id="{85681DA1-BBFC-483A-8F46-49CD757F4BA5}"/>
               </a:ext>
             </a:extLst>
           </p:cNvPr>
@@ -9481,7 +9545,7 @@
           <p:cNvPr id="14" name="">
             <a:extLst xmlns:a="http://schemas.openxmlformats.org/drawingml/2006/main">
               <a:ext uri="{FF2B5EF4-FFF2-40B4-BE49-F238E27FC236}">
-                <a16:creationId xmlns:a16="http://schemas.microsoft.com/office/drawing/2014/main" id="{E2D8D851-C7C5-47A4-8C14-4AF1EB7C28C7}"/>
+                <a16:creationId xmlns:a16="http://schemas.microsoft.com/office/drawing/2014/main" id="{C0AEB346-7F11-4DCC-B56D-BD833C68C87C}"/>
               </a:ext>
             </a:extLst>
           </p:cNvPr>
@@ -9545,7 +9609,7 @@
           <p:cNvPr id="15" name="">
             <a:extLst xmlns:a="http://schemas.openxmlformats.org/drawingml/2006/main">
               <a:ext uri="{FF2B5EF4-FFF2-40B4-BE49-F238E27FC236}">
-                <a16:creationId xmlns:a16="http://schemas.microsoft.com/office/drawing/2014/main" id="{1D3E2ED1-C320-404D-A87C-41E993040236}"/>
+                <a16:creationId xmlns:a16="http://schemas.microsoft.com/office/drawing/2014/main" id="{EA39E485-ACE9-437A-82FD-55FAF883FAB1}"/>
               </a:ext>
             </a:extLst>
           </p:cNvPr>
@@ -9578,7 +9642,7 @@
           <p:cNvPr id="16" name="">
             <a:extLst xmlns:a="http://schemas.openxmlformats.org/drawingml/2006/main">
               <a:ext uri="{FF2B5EF4-FFF2-40B4-BE49-F238E27FC236}">
-                <a16:creationId xmlns:a16="http://schemas.microsoft.com/office/drawing/2014/main" id="{7AA60C17-3443-432B-8188-10507B2F23B1}"/>
+                <a16:creationId xmlns:a16="http://schemas.microsoft.com/office/drawing/2014/main" id="{A37A5D78-D257-41F9-A5D5-17BF47E78A4A}"/>
               </a:ext>
             </a:extLst>
           </p:cNvPr>
@@ -9642,7 +9706,7 @@
           <p:cNvPr id="17" name="">
             <a:extLst xmlns:a="http://schemas.openxmlformats.org/drawingml/2006/main">
               <a:ext uri="{FF2B5EF4-FFF2-40B4-BE49-F238E27FC236}">
-                <a16:creationId xmlns:a16="http://schemas.microsoft.com/office/drawing/2014/main" id="{1CF3AF98-FB92-4446-93F2-4D740AD42A43}"/>
+                <a16:creationId xmlns:a16="http://schemas.microsoft.com/office/drawing/2014/main" id="{B06825AC-68D9-44E5-BCC4-9BFD9987C548}"/>
               </a:ext>
             </a:extLst>
           </p:cNvPr>
@@ -9706,7 +9770,7 @@
           <p:cNvPr id="18" name="">
             <a:extLst xmlns:a="http://schemas.openxmlformats.org/drawingml/2006/main">
               <a:ext uri="{FF2B5EF4-FFF2-40B4-BE49-F238E27FC236}">
-                <a16:creationId xmlns:a16="http://schemas.microsoft.com/office/drawing/2014/main" id="{22EE818A-0E1B-4F74-9C1D-A56A0A6E432E}"/>
+                <a16:creationId xmlns:a16="http://schemas.microsoft.com/office/drawing/2014/main" id="{DE161F36-72DB-4AD7-9D17-1051496373A5}"/>
               </a:ext>
             </a:extLst>
           </p:cNvPr>
@@ -9770,7 +9834,7 @@
           <p:cNvPr id="19" name="">
             <a:extLst xmlns:a="http://schemas.openxmlformats.org/drawingml/2006/main">
               <a:ext uri="{FF2B5EF4-FFF2-40B4-BE49-F238E27FC236}">
-                <a16:creationId xmlns:a16="http://schemas.microsoft.com/office/drawing/2014/main" id="{AC6E8A8D-D2AD-4D73-89F2-12C01CB9A520}"/>
+                <a16:creationId xmlns:a16="http://schemas.microsoft.com/office/drawing/2014/main" id="{BFA6FE88-91C6-4AEE-9F5A-35D4E94EDE63}"/>
               </a:ext>
             </a:extLst>
           </p:cNvPr>
@@ -9803,7 +9867,7 @@
           <p:cNvPr id="20" name="">
             <a:extLst xmlns:a="http://schemas.openxmlformats.org/drawingml/2006/main">
               <a:ext uri="{FF2B5EF4-FFF2-40B4-BE49-F238E27FC236}">
-                <a16:creationId xmlns:a16="http://schemas.microsoft.com/office/drawing/2014/main" id="{29786AE3-E3E2-4854-922E-24AF5680153B}"/>
+                <a16:creationId xmlns:a16="http://schemas.microsoft.com/office/drawing/2014/main" id="{FF64DBDF-0FA4-45F7-89E0-371DCC32E8D7}"/>
               </a:ext>
             </a:extLst>
           </p:cNvPr>
@@ -9867,7 +9931,7 @@
           <p:cNvPr id="21" name="">
             <a:extLst xmlns:a="http://schemas.openxmlformats.org/drawingml/2006/main">
               <a:ext uri="{FF2B5EF4-FFF2-40B4-BE49-F238E27FC236}">
-                <a16:creationId xmlns:a16="http://schemas.microsoft.com/office/drawing/2014/main" id="{7981490C-4E6E-4548-889B-A0E1A8E420B2}"/>
+                <a16:creationId xmlns:a16="http://schemas.microsoft.com/office/drawing/2014/main" id="{32132576-5B84-4B46-AF24-37F11E3CEC44}"/>
               </a:ext>
             </a:extLst>
           </p:cNvPr>
@@ -9931,7 +9995,7 @@
           <p:cNvPr id="22" name="">
             <a:extLst xmlns:a="http://schemas.openxmlformats.org/drawingml/2006/main">
               <a:ext uri="{FF2B5EF4-FFF2-40B4-BE49-F238E27FC236}">
-                <a16:creationId xmlns:a16="http://schemas.microsoft.com/office/drawing/2014/main" id="{2C9AB391-56D8-4AD1-9229-4A9EACB9FAAF}"/>
+                <a16:creationId xmlns:a16="http://schemas.microsoft.com/office/drawing/2014/main" id="{293A5CA6-2BA4-4E74-A935-F58561A6A89A}"/>
               </a:ext>
             </a:extLst>
           </p:cNvPr>
@@ -9995,7 +10059,7 @@
           <p:cNvPr id="23" name="">
             <a:extLst xmlns:a="http://schemas.openxmlformats.org/drawingml/2006/main">
               <a:ext uri="{FF2B5EF4-FFF2-40B4-BE49-F238E27FC236}">
-                <a16:creationId xmlns:a16="http://schemas.microsoft.com/office/drawing/2014/main" id="{7FEB4101-6A5F-454B-BB56-613B4CA4C749}"/>
+                <a16:creationId xmlns:a16="http://schemas.microsoft.com/office/drawing/2014/main" id="{AFFEB81C-6330-4398-BB42-66B7621AD65D}"/>
               </a:ext>
             </a:extLst>
           </p:cNvPr>
@@ -10028,7 +10092,7 @@
           <p:cNvPr id="24" name="">
             <a:extLst xmlns:a="http://schemas.openxmlformats.org/drawingml/2006/main">
               <a:ext uri="{FF2B5EF4-FFF2-40B4-BE49-F238E27FC236}">
-                <a16:creationId xmlns:a16="http://schemas.microsoft.com/office/drawing/2014/main" id="{C80CCC77-5CA3-42AC-A569-D9260623885D}"/>
+                <a16:creationId xmlns:a16="http://schemas.microsoft.com/office/drawing/2014/main" id="{6B8D6876-4C76-44F4-82A4-F9C58ECC9135}"/>
               </a:ext>
             </a:extLst>
           </p:cNvPr>
@@ -10092,7 +10156,7 @@
           <p:cNvPr id="25" name="">
             <a:extLst xmlns:a="http://schemas.openxmlformats.org/drawingml/2006/main">
               <a:ext uri="{FF2B5EF4-FFF2-40B4-BE49-F238E27FC236}">
-                <a16:creationId xmlns:a16="http://schemas.microsoft.com/office/drawing/2014/main" id="{556D67EF-913B-4AEF-9019-7C4ED9CCF60B}"/>
+                <a16:creationId xmlns:a16="http://schemas.microsoft.com/office/drawing/2014/main" id="{45530FBA-0CCC-4571-8FED-738251BDA33C}"/>
               </a:ext>
             </a:extLst>
           </p:cNvPr>
@@ -10156,7 +10220,7 @@
           <p:cNvPr id="26" name="">
             <a:extLst xmlns:a="http://schemas.openxmlformats.org/drawingml/2006/main">
               <a:ext uri="{FF2B5EF4-FFF2-40B4-BE49-F238E27FC236}">
-                <a16:creationId xmlns:a16="http://schemas.microsoft.com/office/drawing/2014/main" id="{CDCA86CF-7459-4A0A-A53B-3AE7BBB0B279}"/>
+                <a16:creationId xmlns:a16="http://schemas.microsoft.com/office/drawing/2014/main" id="{DAAF26D5-5C3A-461F-8E47-645C580994D9}"/>
               </a:ext>
             </a:extLst>
           </p:cNvPr>
@@ -10191,7 +10255,7 @@
           <p:cNvPr id="27" name="">
             <a:extLst xmlns:a="http://schemas.openxmlformats.org/drawingml/2006/main">
               <a:ext uri="{FF2B5EF4-FFF2-40B4-BE49-F238E27FC236}">
-                <a16:creationId xmlns:a16="http://schemas.microsoft.com/office/drawing/2014/main" id="{4EE9A309-95C2-4CA5-B3C1-B66043ED4311}"/>
+                <a16:creationId xmlns:a16="http://schemas.microsoft.com/office/drawing/2014/main" id="{1ABE54D0-CEC9-4158-8E8B-BF21BCB77545}"/>
               </a:ext>
             </a:extLst>
           </p:cNvPr>
@@ -10255,7 +10319,7 @@
           <p:cNvPr id="28" name="">
             <a:extLst xmlns:a="http://schemas.openxmlformats.org/drawingml/2006/main">
               <a:ext uri="{FF2B5EF4-FFF2-40B4-BE49-F238E27FC236}">
-                <a16:creationId xmlns:a16="http://schemas.microsoft.com/office/drawing/2014/main" id="{C7BE0E82-CDA7-4899-B818-09B13D0254A0}"/>
+                <a16:creationId xmlns:a16="http://schemas.microsoft.com/office/drawing/2014/main" id="{292D35EC-1727-42D0-9C1E-4A3B6A27FE30}"/>
               </a:ext>
             </a:extLst>
           </p:cNvPr>
@@ -10290,7 +10354,7 @@
           <p:cNvPr id="29" name="">
             <a:extLst xmlns:a="http://schemas.openxmlformats.org/drawingml/2006/main">
               <a:ext uri="{FF2B5EF4-FFF2-40B4-BE49-F238E27FC236}">
-                <a16:creationId xmlns:a16="http://schemas.microsoft.com/office/drawing/2014/main" id="{25F3F164-BFEC-4679-BE41-A257835B2DB5}"/>
+                <a16:creationId xmlns:a16="http://schemas.microsoft.com/office/drawing/2014/main" id="{385EBA9E-D457-4442-A366-FC9E9A42CD4C}"/>
               </a:ext>
             </a:extLst>
           </p:cNvPr>
@@ -10354,7 +10418,7 @@
           <p:cNvPr id="30" name="">
             <a:extLst xmlns:a="http://schemas.openxmlformats.org/drawingml/2006/main">
               <a:ext uri="{FF2B5EF4-FFF2-40B4-BE49-F238E27FC236}">
-                <a16:creationId xmlns:a16="http://schemas.microsoft.com/office/drawing/2014/main" id="{DD88F893-F06F-427B-9C2C-CF6FCC674AC2}"/>
+                <a16:creationId xmlns:a16="http://schemas.microsoft.com/office/drawing/2014/main" id="{86748F60-36C6-49AA-B578-BFA8E103F82C}"/>
               </a:ext>
             </a:extLst>
           </p:cNvPr>
@@ -10389,7 +10453,7 @@
           <p:cNvPr id="31" name="">
             <a:extLst xmlns:a="http://schemas.openxmlformats.org/drawingml/2006/main">
               <a:ext uri="{FF2B5EF4-FFF2-40B4-BE49-F238E27FC236}">
-                <a16:creationId xmlns:a16="http://schemas.microsoft.com/office/drawing/2014/main" id="{4BCCE568-70E3-476B-98CF-E24F5EEF77A4}"/>
+                <a16:creationId xmlns:a16="http://schemas.microsoft.com/office/drawing/2014/main" id="{C27574E2-2C9C-4E68-9A00-4F3E8864DBE3}"/>
               </a:ext>
             </a:extLst>
           </p:cNvPr>
@@ -10453,7 +10517,7 @@
           <p:cNvPr id="32" name="">
             <a:extLst xmlns:a="http://schemas.openxmlformats.org/drawingml/2006/main">
               <a:ext uri="{FF2B5EF4-FFF2-40B4-BE49-F238E27FC236}">
-                <a16:creationId xmlns:a16="http://schemas.microsoft.com/office/drawing/2014/main" id="{5623DAD4-B436-46F6-9D42-4276B05D6B83}"/>
+                <a16:creationId xmlns:a16="http://schemas.microsoft.com/office/drawing/2014/main" id="{04CE123A-E330-416C-B03F-BD210562C2D6}"/>
               </a:ext>
             </a:extLst>
           </p:cNvPr>
@@ -10488,7 +10552,7 @@
           <p:cNvPr id="33" name="">
             <a:extLst xmlns:a="http://schemas.openxmlformats.org/drawingml/2006/main">
               <a:ext uri="{FF2B5EF4-FFF2-40B4-BE49-F238E27FC236}">
-                <a16:creationId xmlns:a16="http://schemas.microsoft.com/office/drawing/2014/main" id="{19D6959E-AB1F-4E48-801A-6D721BC0C5BD}"/>
+                <a16:creationId xmlns:a16="http://schemas.microsoft.com/office/drawing/2014/main" id="{F90A8DF5-32B5-48CD-BA66-040102201FB8}"/>
               </a:ext>
             </a:extLst>
           </p:cNvPr>
@@ -10552,7 +10616,7 @@
           <p:cNvPr id="34" name="">
             <a:extLst xmlns:a="http://schemas.openxmlformats.org/drawingml/2006/main">
               <a:ext uri="{FF2B5EF4-FFF2-40B4-BE49-F238E27FC236}">
-                <a16:creationId xmlns:a16="http://schemas.microsoft.com/office/drawing/2014/main" id="{D0122E6B-E207-4214-BECC-95248B0B6730}"/>
+                <a16:creationId xmlns:a16="http://schemas.microsoft.com/office/drawing/2014/main" id="{79FC5B26-9B0D-4752-9C16-292574296B35}"/>
               </a:ext>
             </a:extLst>
           </p:cNvPr>
@@ -10587,7 +10651,7 @@
           <p:cNvPr id="35" name="">
             <a:extLst xmlns:a="http://schemas.openxmlformats.org/drawingml/2006/main">
               <a:ext uri="{FF2B5EF4-FFF2-40B4-BE49-F238E27FC236}">
-                <a16:creationId xmlns:a16="http://schemas.microsoft.com/office/drawing/2014/main" id="{687E2CA3-0497-4BDB-AE3D-ADA4F8B58289}"/>
+                <a16:creationId xmlns:a16="http://schemas.microsoft.com/office/drawing/2014/main" id="{6FBE4CF8-CDB4-4A0C-B6EB-AC2C5F261038}"/>
               </a:ext>
             </a:extLst>
           </p:cNvPr>
@@ -10651,7 +10715,7 @@
           <p:cNvPr id="36" name="">
             <a:extLst xmlns:a="http://schemas.openxmlformats.org/drawingml/2006/main">
               <a:ext uri="{FF2B5EF4-FFF2-40B4-BE49-F238E27FC236}">
-                <a16:creationId xmlns:a16="http://schemas.microsoft.com/office/drawing/2014/main" id="{ACB46A31-3867-4AE4-9D60-A084BD8E16F0}"/>
+                <a16:creationId xmlns:a16="http://schemas.microsoft.com/office/drawing/2014/main" id="{37A62D3B-EF56-4217-9A35-DB6DC7598A6C}"/>
               </a:ext>
             </a:extLst>
           </p:cNvPr>
@@ -10686,7 +10750,7 @@
           <p:cNvPr id="37" name="">
             <a:extLst xmlns:a="http://schemas.openxmlformats.org/drawingml/2006/main">
               <a:ext uri="{FF2B5EF4-FFF2-40B4-BE49-F238E27FC236}">
-                <a16:creationId xmlns:a16="http://schemas.microsoft.com/office/drawing/2014/main" id="{5E92570C-7A35-4B48-B3AF-B1A02619B0BD}"/>
+                <a16:creationId xmlns:a16="http://schemas.microsoft.com/office/drawing/2014/main" id="{74E56205-66AC-4D65-830A-B6E64123D860}"/>
               </a:ext>
             </a:extLst>
           </p:cNvPr>
@@ -10750,7 +10814,7 @@
           <p:cNvPr id="38" name="">
             <a:extLst xmlns:a="http://schemas.openxmlformats.org/drawingml/2006/main">
               <a:ext uri="{FF2B5EF4-FFF2-40B4-BE49-F238E27FC236}">
-                <a16:creationId xmlns:a16="http://schemas.microsoft.com/office/drawing/2014/main" id="{67C077F7-FF8D-4BCB-AA4E-ACF84557ECB7}"/>
+                <a16:creationId xmlns:a16="http://schemas.microsoft.com/office/drawing/2014/main" id="{4404ECB0-E01D-4612-8967-B6A1E7299A84}"/>
               </a:ext>
             </a:extLst>
           </p:cNvPr>
@@ -10814,7 +10878,7 @@
           <p:cNvPr id="39" name="">
             <a:extLst xmlns:a="http://schemas.openxmlformats.org/drawingml/2006/main">
               <a:ext uri="{FF2B5EF4-FFF2-40B4-BE49-F238E27FC236}">
-                <a16:creationId xmlns:a16="http://schemas.microsoft.com/office/drawing/2014/main" id="{F7CD0834-A4AB-4C5E-8C9F-6D633390808D}"/>
+                <a16:creationId xmlns:a16="http://schemas.microsoft.com/office/drawing/2014/main" id="{960BE7C3-1D54-4259-AE30-6C25C4B8D7CF}"/>
               </a:ext>
             </a:extLst>
           </p:cNvPr>
@@ -10878,7 +10942,7 @@
           <p:cNvPr id="40" name="">
             <a:extLst xmlns:a="http://schemas.openxmlformats.org/drawingml/2006/main">
               <a:ext uri="{FF2B5EF4-FFF2-40B4-BE49-F238E27FC236}">
-                <a16:creationId xmlns:a16="http://schemas.microsoft.com/office/drawing/2014/main" id="{28C46E25-F9AC-4AB7-8567-223DF3511499}"/>
+                <a16:creationId xmlns:a16="http://schemas.microsoft.com/office/drawing/2014/main" id="{3D170914-7D49-4BEC-BAE3-63AA2FCA9B8A}"/>
               </a:ext>
             </a:extLst>
           </p:cNvPr>
@@ -10942,7 +11006,7 @@
           <p:cNvPr id="41" name="">
             <a:extLst xmlns:a="http://schemas.openxmlformats.org/drawingml/2006/main">
               <a:ext uri="{FF2B5EF4-FFF2-40B4-BE49-F238E27FC236}">
-                <a16:creationId xmlns:a16="http://schemas.microsoft.com/office/drawing/2014/main" id="{E7ACF0F6-0E69-4866-87B2-094CED19D614}"/>
+                <a16:creationId xmlns:a16="http://schemas.microsoft.com/office/drawing/2014/main" id="{10C22A0C-1593-4B28-976A-53A060403346}"/>
               </a:ext>
             </a:extLst>
           </p:cNvPr>
@@ -11006,7 +11070,7 @@
           <p:cNvPr id="42" name="">
             <a:extLst xmlns:a="http://schemas.openxmlformats.org/drawingml/2006/main">
               <a:ext uri="{FF2B5EF4-FFF2-40B4-BE49-F238E27FC236}">
-                <a16:creationId xmlns:a16="http://schemas.microsoft.com/office/drawing/2014/main" id="{8CD712B0-5BAC-4B81-BCFC-E650B81A832A}"/>
+                <a16:creationId xmlns:a16="http://schemas.microsoft.com/office/drawing/2014/main" id="{24C48996-97EE-4489-AF0C-7A8872825720}"/>
               </a:ext>
             </a:extLst>
           </p:cNvPr>
@@ -11070,7 +11134,7 @@
           <p:cNvPr id="43" name="">
             <a:extLst xmlns:a="http://schemas.openxmlformats.org/drawingml/2006/main">
               <a:ext uri="{FF2B5EF4-FFF2-40B4-BE49-F238E27FC236}">
-                <a16:creationId xmlns:a16="http://schemas.microsoft.com/office/drawing/2014/main" id="{9061C0E0-3855-47E2-992C-84F67D369A68}"/>
+                <a16:creationId xmlns:a16="http://schemas.microsoft.com/office/drawing/2014/main" id="{5AC1BE02-8C30-49CD-87E6-C7D433FC33F7}"/>
               </a:ext>
             </a:extLst>
           </p:cNvPr>
@@ -11132,7 +11196,7 @@
     </p:spTree>
     <p:extLst>
       <p:ext uri="{BB962C8B-B14F-4D97-AF65-F5344CB8AC3E}">
-        <p14:creationId xmlns:p14="http://schemas.microsoft.com/office/powerpoint/2010/main" val="1393146683"/>
+        <p14:creationId xmlns:p14="http://schemas.microsoft.com/office/powerpoint/2010/main" val="930448575"/>
       </p:ext>
     </p:extLst>
   </p:cSld>
@@ -11156,7 +11220,7 @@
           <p:cNvPr id="1" name="">
             <a:extLst xmlns:a="http://schemas.openxmlformats.org/drawingml/2006/main">
               <a:ext uri="{FF2B5EF4-FFF2-40B4-BE49-F238E27FC236}">
-                <a16:creationId xmlns:a16="http://schemas.microsoft.com/office/drawing/2014/main" id="{69AB8250-1608-41C9-B909-A1F0D806863B}"/>
+                <a16:creationId xmlns:a16="http://schemas.microsoft.com/office/drawing/2014/main" id="{B8E81E29-C66E-4208-AD8F-64A0462102B7}"/>
               </a:ext>
             </a:extLst>
           </p:cNvPr>
@@ -11191,7 +11255,7 @@
           <p:cNvPr id="2" name="">
             <a:extLst xmlns:a="http://schemas.openxmlformats.org/drawingml/2006/main">
               <a:ext uri="{FF2B5EF4-FFF2-40B4-BE49-F238E27FC236}">
-                <a16:creationId xmlns:a16="http://schemas.microsoft.com/office/drawing/2014/main" id="{828A72C8-CBD8-42F0-853F-B701565F3130}"/>
+                <a16:creationId xmlns:a16="http://schemas.microsoft.com/office/drawing/2014/main" id="{329E803A-6FD8-4622-A0E8-A06B8C178B51}"/>
               </a:ext>
             </a:extLst>
           </p:cNvPr>
@@ -11226,7 +11290,7 @@
           <p:cNvPr id="3" name="">
             <a:extLst xmlns:a="http://schemas.openxmlformats.org/drawingml/2006/main">
               <a:ext uri="{FF2B5EF4-FFF2-40B4-BE49-F238E27FC236}">
-                <a16:creationId xmlns:a16="http://schemas.microsoft.com/office/drawing/2014/main" id="{82347FA1-7179-4D05-ADAE-0245622F8671}"/>
+                <a16:creationId xmlns:a16="http://schemas.microsoft.com/office/drawing/2014/main" id="{BC1A3A9D-50E4-4874-B5FD-99C872776D72}"/>
               </a:ext>
             </a:extLst>
           </p:cNvPr>
@@ -11290,7 +11354,7 @@
           <p:cNvPr id="4" name="">
             <a:extLst xmlns:a="http://schemas.openxmlformats.org/drawingml/2006/main">
               <a:ext uri="{FF2B5EF4-FFF2-40B4-BE49-F238E27FC236}">
-                <a16:creationId xmlns:a16="http://schemas.microsoft.com/office/drawing/2014/main" id="{445E8AFF-CA8E-4810-B735-BAA1674B6F41}"/>
+                <a16:creationId xmlns:a16="http://schemas.microsoft.com/office/drawing/2014/main" id="{EEA72932-C173-43D4-9BFA-5236847D44F2}"/>
               </a:ext>
             </a:extLst>
           </p:cNvPr>
@@ -11354,7 +11418,7 @@
           <p:cNvPr id="5" name="">
             <a:extLst xmlns:a="http://schemas.openxmlformats.org/drawingml/2006/main">
               <a:ext uri="{FF2B5EF4-FFF2-40B4-BE49-F238E27FC236}">
-                <a16:creationId xmlns:a16="http://schemas.microsoft.com/office/drawing/2014/main" id="{BB7AF9E4-84F2-44E5-A09A-A59618C9DB1B}"/>
+                <a16:creationId xmlns:a16="http://schemas.microsoft.com/office/drawing/2014/main" id="{56938493-8BB8-43CB-9249-921D99348440}"/>
               </a:ext>
             </a:extLst>
           </p:cNvPr>
@@ -11418,7 +11482,7 @@
           <p:cNvPr id="6" name="">
             <a:extLst xmlns:a="http://schemas.openxmlformats.org/drawingml/2006/main">
               <a:ext uri="{FF2B5EF4-FFF2-40B4-BE49-F238E27FC236}">
-                <a16:creationId xmlns:a16="http://schemas.microsoft.com/office/drawing/2014/main" id="{DA32072C-20C5-4648-8F61-6B92046E74E7}"/>
+                <a16:creationId xmlns:a16="http://schemas.microsoft.com/office/drawing/2014/main" id="{BB7D83CB-5C30-4B5C-ACA5-0A2EECCD1326}"/>
               </a:ext>
             </a:extLst>
           </p:cNvPr>
@@ -11482,7 +11546,7 @@
           <p:cNvPr id="7" name="">
             <a:extLst xmlns:a="http://schemas.openxmlformats.org/drawingml/2006/main">
               <a:ext uri="{FF2B5EF4-FFF2-40B4-BE49-F238E27FC236}">
-                <a16:creationId xmlns:a16="http://schemas.microsoft.com/office/drawing/2014/main" id="{62F62D82-257E-4731-9C78-E8B4432461DD}"/>
+                <a16:creationId xmlns:a16="http://schemas.microsoft.com/office/drawing/2014/main" id="{C6187B72-518F-4D96-BF7C-BB2132F52A17}"/>
               </a:ext>
             </a:extLst>
           </p:cNvPr>
@@ -11569,7 +11633,7 @@
           <p:cNvPr id="8" name="">
             <a:extLst xmlns:a="http://schemas.openxmlformats.org/drawingml/2006/main">
               <a:ext uri="{FF2B5EF4-FFF2-40B4-BE49-F238E27FC236}">
-                <a16:creationId xmlns:a16="http://schemas.microsoft.com/office/drawing/2014/main" id="{F709DB82-3F19-4482-8E2F-CFD09AE93097}"/>
+                <a16:creationId xmlns:a16="http://schemas.microsoft.com/office/drawing/2014/main" id="{404AFE48-93FD-4609-AF3E-133AF77C69FE}"/>
               </a:ext>
             </a:extLst>
           </p:cNvPr>
@@ -11602,7 +11666,7 @@
           <p:cNvPr id="9" name="">
             <a:extLst xmlns:a="http://schemas.openxmlformats.org/drawingml/2006/main">
               <a:ext uri="{FF2B5EF4-FFF2-40B4-BE49-F238E27FC236}">
-                <a16:creationId xmlns:a16="http://schemas.microsoft.com/office/drawing/2014/main" id="{12565037-EBD1-4418-B3FF-F86E4C653547}"/>
+                <a16:creationId xmlns:a16="http://schemas.microsoft.com/office/drawing/2014/main" id="{37AB7733-8ACA-4DC2-A273-594EB4A9F59D}"/>
               </a:ext>
             </a:extLst>
           </p:cNvPr>
@@ -11666,7 +11730,7 @@
           <p:cNvPr id="10" name="">
             <a:extLst xmlns:a="http://schemas.openxmlformats.org/drawingml/2006/main">
               <a:ext uri="{FF2B5EF4-FFF2-40B4-BE49-F238E27FC236}">
-                <a16:creationId xmlns:a16="http://schemas.microsoft.com/office/drawing/2014/main" id="{E426E44A-BEC1-41E0-85C4-46E9E7F4ECA8}"/>
+                <a16:creationId xmlns:a16="http://schemas.microsoft.com/office/drawing/2014/main" id="{F295E171-6308-45DB-A771-1CC21F63BA9B}"/>
               </a:ext>
             </a:extLst>
           </p:cNvPr>
@@ -11730,7 +11794,7 @@
           <p:cNvPr id="11" name="">
             <a:extLst xmlns:a="http://schemas.openxmlformats.org/drawingml/2006/main">
               <a:ext uri="{FF2B5EF4-FFF2-40B4-BE49-F238E27FC236}">
-                <a16:creationId xmlns:a16="http://schemas.microsoft.com/office/drawing/2014/main" id="{F09F6353-49ED-410E-B705-726409945610}"/>
+                <a16:creationId xmlns:a16="http://schemas.microsoft.com/office/drawing/2014/main" id="{A126C90A-1A0E-48F9-A398-46F1F1DBFA6B}"/>
               </a:ext>
             </a:extLst>
           </p:cNvPr>
@@ -11763,7 +11827,7 @@
           <p:cNvPr id="12" name="">
             <a:extLst xmlns:a="http://schemas.openxmlformats.org/drawingml/2006/main">
               <a:ext uri="{FF2B5EF4-FFF2-40B4-BE49-F238E27FC236}">
-                <a16:creationId xmlns:a16="http://schemas.microsoft.com/office/drawing/2014/main" id="{82C75032-ADA6-424C-9371-1089CC6A66FE}"/>
+                <a16:creationId xmlns:a16="http://schemas.microsoft.com/office/drawing/2014/main" id="{5CFEDED0-7A42-40C8-A3AC-2A8DC31CC82E}"/>
               </a:ext>
             </a:extLst>
           </p:cNvPr>
@@ -11827,7 +11891,7 @@
           <p:cNvPr id="13" name="">
             <a:extLst xmlns:a="http://schemas.openxmlformats.org/drawingml/2006/main">
               <a:ext uri="{FF2B5EF4-FFF2-40B4-BE49-F238E27FC236}">
-                <a16:creationId xmlns:a16="http://schemas.microsoft.com/office/drawing/2014/main" id="{75A7E556-F0A5-44E7-84F1-3A23E1DC7A75}"/>
+                <a16:creationId xmlns:a16="http://schemas.microsoft.com/office/drawing/2014/main" id="{F48A929D-4352-4AEE-8D80-5FD85058F257}"/>
               </a:ext>
             </a:extLst>
           </p:cNvPr>
@@ -11891,7 +11955,7 @@
           <p:cNvPr id="14" name="">
             <a:extLst xmlns:a="http://schemas.openxmlformats.org/drawingml/2006/main">
               <a:ext uri="{FF2B5EF4-FFF2-40B4-BE49-F238E27FC236}">
-                <a16:creationId xmlns:a16="http://schemas.microsoft.com/office/drawing/2014/main" id="{4ACB1124-EEA8-4650-BC9C-8BB43DB3BC89}"/>
+                <a16:creationId xmlns:a16="http://schemas.microsoft.com/office/drawing/2014/main" id="{47113D97-1AFA-4067-948E-040035DDBA05}"/>
               </a:ext>
             </a:extLst>
           </p:cNvPr>
@@ -11924,7 +11988,7 @@
           <p:cNvPr id="15" name="">
             <a:extLst xmlns:a="http://schemas.openxmlformats.org/drawingml/2006/main">
               <a:ext uri="{FF2B5EF4-FFF2-40B4-BE49-F238E27FC236}">
-                <a16:creationId xmlns:a16="http://schemas.microsoft.com/office/drawing/2014/main" id="{6F56F69B-8233-47F1-8DE2-DE6810C0D983}"/>
+                <a16:creationId xmlns:a16="http://schemas.microsoft.com/office/drawing/2014/main" id="{492FB81B-9AE0-47F7-BBFB-D6297FFDA090}"/>
               </a:ext>
             </a:extLst>
           </p:cNvPr>
@@ -11988,7 +12052,7 @@
           <p:cNvPr id="16" name="">
             <a:extLst xmlns:a="http://schemas.openxmlformats.org/drawingml/2006/main">
               <a:ext uri="{FF2B5EF4-FFF2-40B4-BE49-F238E27FC236}">
-                <a16:creationId xmlns:a16="http://schemas.microsoft.com/office/drawing/2014/main" id="{291D3200-133C-420E-8101-94DA77050E60}"/>
+                <a16:creationId xmlns:a16="http://schemas.microsoft.com/office/drawing/2014/main" id="{9B051CB5-0D0B-4BA6-9D4B-25380214D8B7}"/>
               </a:ext>
             </a:extLst>
           </p:cNvPr>
@@ -12052,7 +12116,7 @@
           <p:cNvPr id="17" name="">
             <a:extLst xmlns:a="http://schemas.openxmlformats.org/drawingml/2006/main">
               <a:ext uri="{FF2B5EF4-FFF2-40B4-BE49-F238E27FC236}">
-                <a16:creationId xmlns:a16="http://schemas.microsoft.com/office/drawing/2014/main" id="{AFC1912F-709D-453D-8ED4-D5C519D53A44}"/>
+                <a16:creationId xmlns:a16="http://schemas.microsoft.com/office/drawing/2014/main" id="{E32EC6F4-27B0-4A56-BA63-15B192FA354C}"/>
               </a:ext>
             </a:extLst>
           </p:cNvPr>
@@ -12087,7 +12151,7 @@
           <p:cNvPr id="18" name="">
             <a:extLst xmlns:a="http://schemas.openxmlformats.org/drawingml/2006/main">
               <a:ext uri="{FF2B5EF4-FFF2-40B4-BE49-F238E27FC236}">
-                <a16:creationId xmlns:a16="http://schemas.microsoft.com/office/drawing/2014/main" id="{9598E736-AB1E-456F-8772-A7D422B112B3}"/>
+                <a16:creationId xmlns:a16="http://schemas.microsoft.com/office/drawing/2014/main" id="{76E76B3B-572E-4695-9452-E77123B35C29}"/>
               </a:ext>
             </a:extLst>
           </p:cNvPr>
@@ -12122,7 +12186,7 @@
           <p:cNvPr id="19" name="">
             <a:extLst xmlns:a="http://schemas.openxmlformats.org/drawingml/2006/main">
               <a:ext uri="{FF2B5EF4-FFF2-40B4-BE49-F238E27FC236}">
-                <a16:creationId xmlns:a16="http://schemas.microsoft.com/office/drawing/2014/main" id="{1855C2E6-AB25-4603-A9DE-D2093E9168CA}"/>
+                <a16:creationId xmlns:a16="http://schemas.microsoft.com/office/drawing/2014/main" id="{875D5F6D-9652-4591-A299-1BE6DBA6F18E}"/>
               </a:ext>
             </a:extLst>
           </p:cNvPr>
@@ -12184,7 +12248,7 @@
     </p:spTree>
     <p:extLst>
       <p:ext uri="{BB962C8B-B14F-4D97-AF65-F5344CB8AC3E}">
-        <p14:creationId xmlns:p14="http://schemas.microsoft.com/office/powerpoint/2010/main" val="350314433"/>
+        <p14:creationId xmlns:p14="http://schemas.microsoft.com/office/powerpoint/2010/main" val="1531956245"/>
       </p:ext>
     </p:extLst>
   </p:cSld>
@@ -12208,7 +12272,7 @@
           <p:cNvPr id="1" name="">
             <a:extLst xmlns:a="http://schemas.openxmlformats.org/drawingml/2006/main">
               <a:ext uri="{FF2B5EF4-FFF2-40B4-BE49-F238E27FC236}">
-                <a16:creationId xmlns:a16="http://schemas.microsoft.com/office/drawing/2014/main" id="{417F0A44-D5F2-47AF-9C54-A42155859870}"/>
+                <a16:creationId xmlns:a16="http://schemas.microsoft.com/office/drawing/2014/main" id="{35870C32-DDF2-4CF5-91E0-AADF07F41961}"/>
               </a:ext>
             </a:extLst>
           </p:cNvPr>
@@ -12243,7 +12307,7 @@
           <p:cNvPr id="2" name="">
             <a:extLst xmlns:a="http://schemas.openxmlformats.org/drawingml/2006/main">
               <a:ext uri="{FF2B5EF4-FFF2-40B4-BE49-F238E27FC236}">
-                <a16:creationId xmlns:a16="http://schemas.microsoft.com/office/drawing/2014/main" id="{F16D0D57-5D52-4269-986A-5897845F7446}"/>
+                <a16:creationId xmlns:a16="http://schemas.microsoft.com/office/drawing/2014/main" id="{1D78258A-2290-46C5-8D5D-5BF52B5DB9D9}"/>
               </a:ext>
             </a:extLst>
           </p:cNvPr>
@@ -12278,7 +12342,7 @@
           <p:cNvPr id="3" name="">
             <a:extLst xmlns:a="http://schemas.openxmlformats.org/drawingml/2006/main">
               <a:ext uri="{FF2B5EF4-FFF2-40B4-BE49-F238E27FC236}">
-                <a16:creationId xmlns:a16="http://schemas.microsoft.com/office/drawing/2014/main" id="{EA968921-FF0F-4C62-A060-9C1BECE15F7C}"/>
+                <a16:creationId xmlns:a16="http://schemas.microsoft.com/office/drawing/2014/main" id="{BF37111E-03AB-4FDC-953C-C61D9E438327}"/>
               </a:ext>
             </a:extLst>
           </p:cNvPr>
@@ -12342,7 +12406,7 @@
           <p:cNvPr id="4" name="">
             <a:extLst xmlns:a="http://schemas.openxmlformats.org/drawingml/2006/main">
               <a:ext uri="{FF2B5EF4-FFF2-40B4-BE49-F238E27FC236}">
-                <a16:creationId xmlns:a16="http://schemas.microsoft.com/office/drawing/2014/main" id="{80734FC9-6BB7-419F-B68D-803F32284ADB}"/>
+                <a16:creationId xmlns:a16="http://schemas.microsoft.com/office/drawing/2014/main" id="{1E80A315-B1DB-43DC-A493-B89B3A5EAE16}"/>
               </a:ext>
             </a:extLst>
           </p:cNvPr>
@@ -12406,7 +12470,7 @@
           <p:cNvPr id="5" name="">
             <a:extLst xmlns:a="http://schemas.openxmlformats.org/drawingml/2006/main">
               <a:ext uri="{FF2B5EF4-FFF2-40B4-BE49-F238E27FC236}">
-                <a16:creationId xmlns:a16="http://schemas.microsoft.com/office/drawing/2014/main" id="{71681DE8-5DA3-4FFD-B6D4-F6AE16C6A482}"/>
+                <a16:creationId xmlns:a16="http://schemas.microsoft.com/office/drawing/2014/main" id="{47AADD7A-0BD5-46F5-B267-5503FBE0EBBA}"/>
               </a:ext>
             </a:extLst>
           </p:cNvPr>
@@ -12418,7 +12482,7 @@
         <p:spPr>
           <a:xfrm xmlns:a="http://schemas.openxmlformats.org/drawingml/2006/main">
             <a:off x="400050" y="590550"/>
-            <a:ext cx="10668000" cy="704850"/>
+            <a:ext cx="10668000" cy="781050"/>
           </a:xfrm>
           <a:prstGeom xmlns:a="http://schemas.openxmlformats.org/drawingml/2006/main" prst="rect">
             <a:avLst/>
@@ -12442,7 +12506,7 @@
           <a:lstStyle xmlns:a="http://schemas.openxmlformats.org/drawingml/2006/main"/>
           <a:p xmlns:a="http://schemas.openxmlformats.org/drawingml/2006/main">
             <a:pPr algn="l">
-              <a:defRPr sz="3000" b="1">
+              <a:defRPr sz="2775" b="1">
                 <a:solidFill>
                   <a:srgbClr val="FFFFFF"/>
                 </a:solidFill>
@@ -12452,7 +12516,7 @@
               </a:defRPr>
             </a:pPr>
             <a:r>
-              <a:rPr sz="3000" b="1">
+              <a:rPr sz="2775" b="1">
                 <a:solidFill>
                   <a:srgbClr val="FFFFFF"/>
                 </a:solidFill>
@@ -12460,7 +12524,7 @@
                 <a:ea typeface="Aptos Display"/>
                 <a:cs typeface="Aptos Display"/>
               </a:rPr>
-              <a:t>AMD-hosted Gemma repairs unsafe plans.</a:t>
+              <a:t>Verifier feedback turns 10% first-pass safety into 100%.</a:t>
             </a:r>
           </a:p>
         </p:txBody>
@@ -12470,7 +12534,7 @@
           <p:cNvPr id="6" name="">
             <a:extLst xmlns:a="http://schemas.openxmlformats.org/drawingml/2006/main">
               <a:ext uri="{FF2B5EF4-FFF2-40B4-BE49-F238E27FC236}">
-                <a16:creationId xmlns:a16="http://schemas.microsoft.com/office/drawing/2014/main" id="{618000AA-604C-4E2E-9F28-4E9F73C1390E}"/>
+                <a16:creationId xmlns:a16="http://schemas.microsoft.com/office/drawing/2014/main" id="{F116D72C-1B9F-4286-A435-54A4BB3D53AC}"/>
               </a:ext>
             </a:extLst>
           </p:cNvPr>
@@ -12534,7 +12598,7 @@
           <p:cNvPr id="7" name="">
             <a:extLst xmlns:a="http://schemas.openxmlformats.org/drawingml/2006/main">
               <a:ext uri="{FF2B5EF4-FFF2-40B4-BE49-F238E27FC236}">
-                <a16:creationId xmlns:a16="http://schemas.microsoft.com/office/drawing/2014/main" id="{7F1E000A-B14A-4DE0-AAA6-AE6F7D8D58FC}"/>
+                <a16:creationId xmlns:a16="http://schemas.microsoft.com/office/drawing/2014/main" id="{016869D3-8D1A-4B93-B0F3-066AC175F732}"/>
               </a:ext>
             </a:extLst>
           </p:cNvPr>
@@ -12598,7 +12662,7 @@
           <p:cNvPr id="8" name="">
             <a:extLst xmlns:a="http://schemas.openxmlformats.org/drawingml/2006/main">
               <a:ext uri="{FF2B5EF4-FFF2-40B4-BE49-F238E27FC236}">
-                <a16:creationId xmlns:a16="http://schemas.microsoft.com/office/drawing/2014/main" id="{C3181913-AD6C-41B9-A5EC-0E4EE3FF6F56}"/>
+                <a16:creationId xmlns:a16="http://schemas.microsoft.com/office/drawing/2014/main" id="{5EE13C56-353B-4964-B76F-1FC26E4F2CB5}"/>
               </a:ext>
             </a:extLst>
           </p:cNvPr>
@@ -12631,7 +12695,7 @@
           <p:cNvPr id="9" name="">
             <a:extLst xmlns:a="http://schemas.openxmlformats.org/drawingml/2006/main">
               <a:ext uri="{FF2B5EF4-FFF2-40B4-BE49-F238E27FC236}">
-                <a16:creationId xmlns:a16="http://schemas.microsoft.com/office/drawing/2014/main" id="{5FB1B3D4-FDA9-4BA4-AFC9-447F6631048D}"/>
+                <a16:creationId xmlns:a16="http://schemas.microsoft.com/office/drawing/2014/main" id="{A4EFEDE2-CA22-47E6-829B-E666C4C13B81}"/>
               </a:ext>
             </a:extLst>
           </p:cNvPr>
@@ -12695,7 +12759,7 @@
           <p:cNvPr id="10" name="">
             <a:extLst xmlns:a="http://schemas.openxmlformats.org/drawingml/2006/main">
               <a:ext uri="{FF2B5EF4-FFF2-40B4-BE49-F238E27FC236}">
-                <a16:creationId xmlns:a16="http://schemas.microsoft.com/office/drawing/2014/main" id="{721C43D0-996C-461B-980C-037F1DEAEFC0}"/>
+                <a16:creationId xmlns:a16="http://schemas.microsoft.com/office/drawing/2014/main" id="{D78E04EE-1D69-4CAD-94C7-44C949321B39}"/>
               </a:ext>
             </a:extLst>
           </p:cNvPr>
@@ -12730,7 +12794,7 @@
           <p:cNvPr id="11" name="">
             <a:extLst xmlns:a="http://schemas.openxmlformats.org/drawingml/2006/main">
               <a:ext uri="{FF2B5EF4-FFF2-40B4-BE49-F238E27FC236}">
-                <a16:creationId xmlns:a16="http://schemas.microsoft.com/office/drawing/2014/main" id="{E3489FE2-B2C8-4E53-88A6-471ABBC41C1A}"/>
+                <a16:creationId xmlns:a16="http://schemas.microsoft.com/office/drawing/2014/main" id="{F96F1717-1D1A-4311-86D6-2EA98391B08B}"/>
               </a:ext>
             </a:extLst>
           </p:cNvPr>
@@ -12784,7 +12848,7 @@
                 <a:ea typeface="Aptos"/>
                 <a:cs typeface="Aptos"/>
               </a:rPr>
-              <a:t>ROCm 7.2.53211</a:t>
+              <a:t>PyTorch 2.10 · ROCm 7.2</a:t>
             </a:r>
           </a:p>
         </p:txBody>
@@ -12794,7 +12858,7 @@
           <p:cNvPr id="12" name="">
             <a:extLst xmlns:a="http://schemas.openxmlformats.org/drawingml/2006/main">
               <a:ext uri="{FF2B5EF4-FFF2-40B4-BE49-F238E27FC236}">
-                <a16:creationId xmlns:a16="http://schemas.microsoft.com/office/drawing/2014/main" id="{D4C281B5-7DED-430E-8A9A-842395D25081}"/>
+                <a16:creationId xmlns:a16="http://schemas.microsoft.com/office/drawing/2014/main" id="{9F117C3E-31FE-4537-9A05-E26FF40200FD}"/>
               </a:ext>
             </a:extLst>
           </p:cNvPr>
@@ -12829,7 +12893,7 @@
           <p:cNvPr id="13" name="">
             <a:extLst xmlns:a="http://schemas.openxmlformats.org/drawingml/2006/main">
               <a:ext uri="{FF2B5EF4-FFF2-40B4-BE49-F238E27FC236}">
-                <a16:creationId xmlns:a16="http://schemas.microsoft.com/office/drawing/2014/main" id="{B5E01E4D-5528-4D91-BD15-44A7D06CA3E0}"/>
+                <a16:creationId xmlns:a16="http://schemas.microsoft.com/office/drawing/2014/main" id="{3C54A0CC-4517-4D0A-A8FC-241A65E77481}"/>
               </a:ext>
             </a:extLst>
           </p:cNvPr>
@@ -12883,7 +12947,7 @@
                 <a:ea typeface="Aptos"/>
                 <a:cs typeface="Aptos"/>
               </a:rPr>
-              <a:t>vLLM 0.20.2</a:t>
+              <a:t>vLLM 0.20.2 · gfx1100</a:t>
             </a:r>
           </a:p>
         </p:txBody>
@@ -12893,7 +12957,7 @@
           <p:cNvPr id="14" name="">
             <a:extLst xmlns:a="http://schemas.openxmlformats.org/drawingml/2006/main">
               <a:ext uri="{FF2B5EF4-FFF2-40B4-BE49-F238E27FC236}">
-                <a16:creationId xmlns:a16="http://schemas.microsoft.com/office/drawing/2014/main" id="{54CC4DAE-4619-4BB0-9DB1-12F85A786528}"/>
+                <a16:creationId xmlns:a16="http://schemas.microsoft.com/office/drawing/2014/main" id="{CF970371-DABB-4DA1-84E1-8F14CDE7B130}"/>
               </a:ext>
             </a:extLst>
           </p:cNvPr>
@@ -12928,7 +12992,7 @@
           <p:cNvPr id="15" name="">
             <a:extLst xmlns:a="http://schemas.openxmlformats.org/drawingml/2006/main">
               <a:ext uri="{FF2B5EF4-FFF2-40B4-BE49-F238E27FC236}">
-                <a16:creationId xmlns:a16="http://schemas.microsoft.com/office/drawing/2014/main" id="{FDEA6F06-0F3A-4F8F-B73D-96584E019FCD}"/>
+                <a16:creationId xmlns:a16="http://schemas.microsoft.com/office/drawing/2014/main" id="{AA03AAD6-6673-4C7F-B43D-4C849BF4391C}"/>
               </a:ext>
             </a:extLst>
           </p:cNvPr>
@@ -12982,7 +13046,7 @@
                 <a:ea typeface="Aptos"/>
                 <a:cs typeface="Aptos"/>
               </a:rPr>
-              <a:t>gfx1100 · 47.98 GiB</a:t>
+              <a:t>47.98 GiB AMD GPU memory</a:t>
             </a:r>
           </a:p>
         </p:txBody>
@@ -12992,7 +13056,7 @@
           <p:cNvPr id="16" name="">
             <a:extLst xmlns:a="http://schemas.openxmlformats.org/drawingml/2006/main">
               <a:ext uri="{FF2B5EF4-FFF2-40B4-BE49-F238E27FC236}">
-                <a16:creationId xmlns:a16="http://schemas.microsoft.com/office/drawing/2014/main" id="{CD6B18BE-CA47-41BE-BFAD-150CD4ECA22D}"/>
+                <a16:creationId xmlns:a16="http://schemas.microsoft.com/office/drawing/2014/main" id="{87AD706E-5A9F-4BF1-A0DD-6C2EB544CABD}"/>
               </a:ext>
             </a:extLst>
           </p:cNvPr>
@@ -13056,7 +13120,7 @@
           <p:cNvPr id="17" name="">
             <a:extLst xmlns:a="http://schemas.openxmlformats.org/drawingml/2006/main">
               <a:ext uri="{FF2B5EF4-FFF2-40B4-BE49-F238E27FC236}">
-                <a16:creationId xmlns:a16="http://schemas.microsoft.com/office/drawing/2014/main" id="{2416206B-C131-471B-BD07-C2F73A1EF7FB}"/>
+                <a16:creationId xmlns:a16="http://schemas.microsoft.com/office/drawing/2014/main" id="{3F98EE57-2D64-4DE8-A015-DB1D37C55930}"/>
               </a:ext>
             </a:extLst>
           </p:cNvPr>
@@ -13089,7 +13153,7 @@
           <p:cNvPr id="18" name="">
             <a:extLst xmlns:a="http://schemas.openxmlformats.org/drawingml/2006/main">
               <a:ext uri="{FF2B5EF4-FFF2-40B4-BE49-F238E27FC236}">
-                <a16:creationId xmlns:a16="http://schemas.microsoft.com/office/drawing/2014/main" id="{5C2DF7E7-B2C0-475E-B4E0-20AB9E84052E}"/>
+                <a16:creationId xmlns:a16="http://schemas.microsoft.com/office/drawing/2014/main" id="{02B996A5-0323-4F39-A30A-DDD25164B4A8}"/>
               </a:ext>
             </a:extLst>
           </p:cNvPr>
@@ -13143,7 +13207,7 @@
                 <a:ea typeface="Aptos"/>
                 <a:cs typeface="Aptos"/>
               </a:rPr>
-              <a:t>10% → 100% model-safe</a:t>
+              <a:t>18 repairs · zero fallback</a:t>
             </a:r>
           </a:p>
         </p:txBody>
@@ -13153,7 +13217,7 @@
           <p:cNvPr id="19" name="">
             <a:extLst xmlns:a="http://schemas.openxmlformats.org/drawingml/2006/main">
               <a:ext uri="{FF2B5EF4-FFF2-40B4-BE49-F238E27FC236}">
-                <a16:creationId xmlns:a16="http://schemas.microsoft.com/office/drawing/2014/main" id="{CB4F5A4F-99E7-4D93-B181-D0754BD4E21D}"/>
+                <a16:creationId xmlns:a16="http://schemas.microsoft.com/office/drawing/2014/main" id="{FDDEF7A8-2B43-4A34-9DE2-165AFF5D3D18}"/>
               </a:ext>
             </a:extLst>
           </p:cNvPr>
@@ -13188,7 +13252,7 @@
           <p:cNvPr id="20" name="">
             <a:extLst xmlns:a="http://schemas.openxmlformats.org/drawingml/2006/main">
               <a:ext uri="{FF2B5EF4-FFF2-40B4-BE49-F238E27FC236}">
-                <a16:creationId xmlns:a16="http://schemas.microsoft.com/office/drawing/2014/main" id="{0FE14127-983C-46A9-B299-5DDD0113914B}"/>
+                <a16:creationId xmlns:a16="http://schemas.microsoft.com/office/drawing/2014/main" id="{D15709A0-14CF-475C-A10E-36DB340118B8}"/>
               </a:ext>
             </a:extLst>
           </p:cNvPr>
@@ -13242,7 +13306,7 @@
                 <a:ea typeface="Aptos"/>
                 <a:cs typeface="Aptos"/>
               </a:rPr>
-              <a:t>18 rejected answers repaired</a:t>
+              <a:t>2/20 first answers safe</a:t>
             </a:r>
           </a:p>
         </p:txBody>
@@ -13252,7 +13316,7 @@
           <p:cNvPr id="21" name="">
             <a:extLst xmlns:a="http://schemas.openxmlformats.org/drawingml/2006/main">
               <a:ext uri="{FF2B5EF4-FFF2-40B4-BE49-F238E27FC236}">
-                <a16:creationId xmlns:a16="http://schemas.microsoft.com/office/drawing/2014/main" id="{A85B672C-DDFD-4D72-BCFC-F03BFF1BF792}"/>
+                <a16:creationId xmlns:a16="http://schemas.microsoft.com/office/drawing/2014/main" id="{58F7A3D0-3841-4A3F-B6BA-DD420BCF64A8}"/>
               </a:ext>
             </a:extLst>
           </p:cNvPr>
@@ -13287,7 +13351,7 @@
           <p:cNvPr id="22" name="">
             <a:extLst xmlns:a="http://schemas.openxmlformats.org/drawingml/2006/main">
               <a:ext uri="{FF2B5EF4-FFF2-40B4-BE49-F238E27FC236}">
-                <a16:creationId xmlns:a16="http://schemas.microsoft.com/office/drawing/2014/main" id="{B3922578-5F03-48E2-BD3E-67BF10F6A188}"/>
+                <a16:creationId xmlns:a16="http://schemas.microsoft.com/office/drawing/2014/main" id="{C379421A-10B7-4D5E-9DB5-720B276596BD}"/>
               </a:ext>
             </a:extLst>
           </p:cNvPr>
@@ -13341,7 +13405,7 @@
                 <a:ea typeface="Aptos"/>
                 <a:cs typeface="Aptos"/>
               </a:rPr>
-              <a:t>17 in one revision · 1 in two</a:t>
+              <a:t>17 repaired once · 1 twice</a:t>
             </a:r>
           </a:p>
         </p:txBody>
@@ -13351,7 +13415,7 @@
           <p:cNvPr id="23" name="">
             <a:extLst xmlns:a="http://schemas.openxmlformats.org/drawingml/2006/main">
               <a:ext uri="{FF2B5EF4-FFF2-40B4-BE49-F238E27FC236}">
-                <a16:creationId xmlns:a16="http://schemas.microsoft.com/office/drawing/2014/main" id="{7D22D130-0566-484E-91A2-85311E31580F}"/>
+                <a16:creationId xmlns:a16="http://schemas.microsoft.com/office/drawing/2014/main" id="{1B1627FE-1D0A-4EC7-83AB-AC0BFB7585B8}"/>
               </a:ext>
             </a:extLst>
           </p:cNvPr>
@@ -13386,7 +13450,7 @@
           <p:cNvPr id="24" name="">
             <a:extLst xmlns:a="http://schemas.openxmlformats.org/drawingml/2006/main">
               <a:ext uri="{FF2B5EF4-FFF2-40B4-BE49-F238E27FC236}">
-                <a16:creationId xmlns:a16="http://schemas.microsoft.com/office/drawing/2014/main" id="{39DBA509-B4DE-4AD3-B74B-70D1D22B8F8C}"/>
+                <a16:creationId xmlns:a16="http://schemas.microsoft.com/office/drawing/2014/main" id="{8C7837E8-B20E-48C9-968B-7A15982C905C}"/>
               </a:ext>
             </a:extLst>
           </p:cNvPr>
@@ -13440,7 +13504,7 @@
                 <a:ea typeface="Aptos"/>
                 <a:cs typeface="Aptos"/>
               </a:rPr>
-              <a:t>0 fallback · no weight update</a:t>
+              <a:t>20/20 model-safe · no weight update</a:t>
             </a:r>
           </a:p>
         </p:txBody>
@@ -13450,7 +13514,7 @@
           <p:cNvPr id="25" name="">
             <a:extLst xmlns:a="http://schemas.openxmlformats.org/drawingml/2006/main">
               <a:ext uri="{FF2B5EF4-FFF2-40B4-BE49-F238E27FC236}">
-                <a16:creationId xmlns:a16="http://schemas.microsoft.com/office/drawing/2014/main" id="{A8B3D88D-72F7-4A03-B6BE-ECF54255B493}"/>
+                <a16:creationId xmlns:a16="http://schemas.microsoft.com/office/drawing/2014/main" id="{CB184239-3C28-46B0-BE95-2821EC1DDCDE}"/>
               </a:ext>
             </a:extLst>
           </p:cNvPr>
@@ -13514,7 +13578,7 @@
           <p:cNvPr id="26" name="">
             <a:extLst xmlns:a="http://schemas.openxmlformats.org/drawingml/2006/main">
               <a:ext uri="{FF2B5EF4-FFF2-40B4-BE49-F238E27FC236}">
-                <a16:creationId xmlns:a16="http://schemas.microsoft.com/office/drawing/2014/main" id="{88C0B225-93EF-4850-B137-005188B499BC}"/>
+                <a16:creationId xmlns:a16="http://schemas.microsoft.com/office/drawing/2014/main" id="{73195627-C9E2-44AE-A25C-A02BDB0D44C0}"/>
               </a:ext>
             </a:extLst>
           </p:cNvPr>
@@ -13547,7 +13611,7 @@
           <p:cNvPr id="27" name="">
             <a:extLst xmlns:a="http://schemas.openxmlformats.org/drawingml/2006/main">
               <a:ext uri="{FF2B5EF4-FFF2-40B4-BE49-F238E27FC236}">
-                <a16:creationId xmlns:a16="http://schemas.microsoft.com/office/drawing/2014/main" id="{AFC2989E-F220-4355-94DF-C964B8AD6369}"/>
+                <a16:creationId xmlns:a16="http://schemas.microsoft.com/office/drawing/2014/main" id="{0307849A-4FC6-4639-A531-15B9F96B9B70}"/>
               </a:ext>
             </a:extLst>
           </p:cNvPr>
@@ -13611,7 +13675,7 @@
           <p:cNvPr id="28" name="">
             <a:extLst xmlns:a="http://schemas.openxmlformats.org/drawingml/2006/main">
               <a:ext uri="{FF2B5EF4-FFF2-40B4-BE49-F238E27FC236}">
-                <a16:creationId xmlns:a16="http://schemas.microsoft.com/office/drawing/2014/main" id="{E38A0E41-8094-4CE3-80BB-820E7BC87378}"/>
+                <a16:creationId xmlns:a16="http://schemas.microsoft.com/office/drawing/2014/main" id="{32D121FA-2082-4B00-BD9C-1F2AC5CCD560}"/>
               </a:ext>
             </a:extLst>
           </p:cNvPr>
@@ -13646,7 +13710,7 @@
           <p:cNvPr id="29" name="">
             <a:extLst xmlns:a="http://schemas.openxmlformats.org/drawingml/2006/main">
               <a:ext uri="{FF2B5EF4-FFF2-40B4-BE49-F238E27FC236}">
-                <a16:creationId xmlns:a16="http://schemas.microsoft.com/office/drawing/2014/main" id="{F711478E-A2B8-45E3-9479-5350F145E613}"/>
+                <a16:creationId xmlns:a16="http://schemas.microsoft.com/office/drawing/2014/main" id="{056FD630-759D-413C-9531-053F56474C36}"/>
               </a:ext>
             </a:extLst>
           </p:cNvPr>
@@ -13710,7 +13774,7 @@
           <p:cNvPr id="30" name="">
             <a:extLst xmlns:a="http://schemas.openxmlformats.org/drawingml/2006/main">
               <a:ext uri="{FF2B5EF4-FFF2-40B4-BE49-F238E27FC236}">
-                <a16:creationId xmlns:a16="http://schemas.microsoft.com/office/drawing/2014/main" id="{6B048E4F-0718-40E9-8772-FE41A80CA72E}"/>
+                <a16:creationId xmlns:a16="http://schemas.microsoft.com/office/drawing/2014/main" id="{41C30FD8-614C-488B-8321-90AA818A25B9}"/>
               </a:ext>
             </a:extLst>
           </p:cNvPr>
@@ -13745,7 +13809,7 @@
           <p:cNvPr id="31" name="">
             <a:extLst xmlns:a="http://schemas.openxmlformats.org/drawingml/2006/main">
               <a:ext uri="{FF2B5EF4-FFF2-40B4-BE49-F238E27FC236}">
-                <a16:creationId xmlns:a16="http://schemas.microsoft.com/office/drawing/2014/main" id="{54506666-DA02-436C-AEED-4053C9A00976}"/>
+                <a16:creationId xmlns:a16="http://schemas.microsoft.com/office/drawing/2014/main" id="{F95D3B7A-CB38-4038-9499-C347AC0C17CA}"/>
               </a:ext>
             </a:extLst>
           </p:cNvPr>
@@ -13809,7 +13873,7 @@
           <p:cNvPr id="32" name="">
             <a:extLst xmlns:a="http://schemas.openxmlformats.org/drawingml/2006/main">
               <a:ext uri="{FF2B5EF4-FFF2-40B4-BE49-F238E27FC236}">
-                <a16:creationId xmlns:a16="http://schemas.microsoft.com/office/drawing/2014/main" id="{1806C8E3-C06B-4640-94AC-2830253F76D8}"/>
+                <a16:creationId xmlns:a16="http://schemas.microsoft.com/office/drawing/2014/main" id="{14D7B187-C5E1-4ABC-8372-1274E4961F72}"/>
               </a:ext>
             </a:extLst>
           </p:cNvPr>
@@ -13844,7 +13908,7 @@
           <p:cNvPr id="33" name="">
             <a:extLst xmlns:a="http://schemas.openxmlformats.org/drawingml/2006/main">
               <a:ext uri="{FF2B5EF4-FFF2-40B4-BE49-F238E27FC236}">
-                <a16:creationId xmlns:a16="http://schemas.microsoft.com/office/drawing/2014/main" id="{F20AF186-25B1-4F3D-A750-E83C990995D8}"/>
+                <a16:creationId xmlns:a16="http://schemas.microsoft.com/office/drawing/2014/main" id="{6B6F3200-D700-4DB6-9918-E8BF6324C31B}"/>
               </a:ext>
             </a:extLst>
           </p:cNvPr>
@@ -13908,7 +13972,7 @@
           <p:cNvPr id="34" name="">
             <a:extLst xmlns:a="http://schemas.openxmlformats.org/drawingml/2006/main">
               <a:ext uri="{FF2B5EF4-FFF2-40B4-BE49-F238E27FC236}">
-                <a16:creationId xmlns:a16="http://schemas.microsoft.com/office/drawing/2014/main" id="{8580275D-DE85-46CB-B986-CA7C0255284B}"/>
+                <a16:creationId xmlns:a16="http://schemas.microsoft.com/office/drawing/2014/main" id="{E3DC69CC-23A2-4C68-A4FB-3DC5421BB7F5}"/>
               </a:ext>
             </a:extLst>
           </p:cNvPr>
@@ -13972,7 +14036,7 @@
           <p:cNvPr id="35" name="">
             <a:extLst xmlns:a="http://schemas.openxmlformats.org/drawingml/2006/main">
               <a:ext uri="{FF2B5EF4-FFF2-40B4-BE49-F238E27FC236}">
-                <a16:creationId xmlns:a16="http://schemas.microsoft.com/office/drawing/2014/main" id="{F6A6E608-8BC8-4F69-8D6D-5DEB71A31F95}"/>
+                <a16:creationId xmlns:a16="http://schemas.microsoft.com/office/drawing/2014/main" id="{6481EDA9-AEBF-4ED3-BCF9-6DD74A1ED39E}"/>
               </a:ext>
             </a:extLst>
           </p:cNvPr>
@@ -14034,7 +14098,7 @@
     </p:spTree>
     <p:extLst>
       <p:ext uri="{BB962C8B-B14F-4D97-AF65-F5344CB8AC3E}">
-        <p14:creationId xmlns:p14="http://schemas.microsoft.com/office/powerpoint/2010/main" val="1393775145"/>
+        <p14:creationId xmlns:p14="http://schemas.microsoft.com/office/powerpoint/2010/main" val="1004981935"/>
       </p:ext>
     </p:extLst>
   </p:cSld>

</xml_diff>